<commit_message>
feat(presentation): remediate NUMERIC_MAPPING_SCOPE with declarative numeric slot injection and remove causal phrases
- Implement declarative shape table map with 59 quantitative numeric metrics across Slides 4, 6, 7, 8, 9
- In artifact_tool_deck_updater.mjs, perform real numeric value injection and verify all 59 values in slide shapes
- Enforce strict separation between numeric_slot_edits (59) and disclaimer_edits
- Fail closed if numeric_slot_edits === 0 or actual_numeric_slots_count !== 59
- Clean up legacy causal/intrinsic phrases from Slide 8 shapes and speaker notes (nt/fu1gfa1s, nt/gnmp4jqx)
- Re-export candidate deck fixture_populated_slides.pptx and 12 slide PNGs
- Record full declarative mapping in deck_updater_fixture_audit.json
- Add regression and negative tests with 100% offline passing
</commit_message>
<xml_diff>
--- a/reports/evidence/fixture_populated_slides.pptx
+++ b/reports/evidence/fixture_populated_slides.pptx
@@ -2,24 +2,24 @@
 <file path=ppt/presentation.xml><?xml version="1.0" encoding="utf-8"?>
 <p:presentation xmlns:p="http://schemas.openxmlformats.org/presentationml/2006/main">
   <p:sldMasterIdLst>
-    <p:sldMasterId xmlns:r="http://schemas.openxmlformats.org/officeDocument/2006/relationships" id="2147483648" r:id="Rcaec1c4f5ea24083"/>
+    <p:sldMasterId xmlns:r="http://schemas.openxmlformats.org/officeDocument/2006/relationships" id="2147483648" r:id="R7cee1c6823394d87"/>
   </p:sldMasterIdLst>
   <p:notesMasterIdLst>
-    <p:notesMasterId xmlns:r="http://schemas.openxmlformats.org/officeDocument/2006/relationships" r:id="Rb19b4f6d21704601"/>
+    <p:notesMasterId xmlns:r="http://schemas.openxmlformats.org/officeDocument/2006/relationships" r:id="Ra2416668a3fe44a7"/>
   </p:notesMasterIdLst>
   <p:sldIdLst>
-    <p:sldId xmlns:r="http://schemas.openxmlformats.org/officeDocument/2006/relationships" id="256" r:id="Rb84dfa68d4ea4977"/>
-    <p:sldId xmlns:r="http://schemas.openxmlformats.org/officeDocument/2006/relationships" id="257" r:id="Rc6e739c881d94036"/>
-    <p:sldId xmlns:r="http://schemas.openxmlformats.org/officeDocument/2006/relationships" id="258" r:id="Ra192683ab4824700"/>
-    <p:sldId xmlns:r="http://schemas.openxmlformats.org/officeDocument/2006/relationships" id="259" r:id="Rd86e0f061d0c4c40"/>
-    <p:sldId xmlns:r="http://schemas.openxmlformats.org/officeDocument/2006/relationships" id="260" r:id="R03908c5ccd934f54"/>
-    <p:sldId xmlns:r="http://schemas.openxmlformats.org/officeDocument/2006/relationships" id="261" r:id="R440ef99eac0e47ef"/>
-    <p:sldId xmlns:r="http://schemas.openxmlformats.org/officeDocument/2006/relationships" id="262" r:id="R805091ce02ad4ed9"/>
-    <p:sldId xmlns:r="http://schemas.openxmlformats.org/officeDocument/2006/relationships" id="263" r:id="R86fd2f8ea8344e02"/>
-    <p:sldId xmlns:r="http://schemas.openxmlformats.org/officeDocument/2006/relationships" id="264" r:id="R487695d40b2940ef"/>
-    <p:sldId xmlns:r="http://schemas.openxmlformats.org/officeDocument/2006/relationships" id="265" r:id="R69a69f0c02f24892"/>
-    <p:sldId xmlns:r="http://schemas.openxmlformats.org/officeDocument/2006/relationships" id="266" r:id="R9cf9104ab04a4fd8"/>
-    <p:sldId xmlns:r="http://schemas.openxmlformats.org/officeDocument/2006/relationships" id="267" r:id="R1a3957f0ecdd4d7a"/>
+    <p:sldId xmlns:r="http://schemas.openxmlformats.org/officeDocument/2006/relationships" id="256" r:id="Ra7af2306692c4af8"/>
+    <p:sldId xmlns:r="http://schemas.openxmlformats.org/officeDocument/2006/relationships" id="257" r:id="Rd74caa48f91b49d3"/>
+    <p:sldId xmlns:r="http://schemas.openxmlformats.org/officeDocument/2006/relationships" id="258" r:id="R254c4558eb324a0a"/>
+    <p:sldId xmlns:r="http://schemas.openxmlformats.org/officeDocument/2006/relationships" id="259" r:id="R2f725f3658054dd6"/>
+    <p:sldId xmlns:r="http://schemas.openxmlformats.org/officeDocument/2006/relationships" id="260" r:id="R4a95e85158f04dea"/>
+    <p:sldId xmlns:r="http://schemas.openxmlformats.org/officeDocument/2006/relationships" id="261" r:id="Rca78a2290d9c47ee"/>
+    <p:sldId xmlns:r="http://schemas.openxmlformats.org/officeDocument/2006/relationships" id="262" r:id="R9da1207a6e1c405e"/>
+    <p:sldId xmlns:r="http://schemas.openxmlformats.org/officeDocument/2006/relationships" id="263" r:id="R4260f777b7fd4d7f"/>
+    <p:sldId xmlns:r="http://schemas.openxmlformats.org/officeDocument/2006/relationships" id="264" r:id="R7c94c5b2077c49f0"/>
+    <p:sldId xmlns:r="http://schemas.openxmlformats.org/officeDocument/2006/relationships" id="265" r:id="R724e469a62954b76"/>
+    <p:sldId xmlns:r="http://schemas.openxmlformats.org/officeDocument/2006/relationships" id="266" r:id="R1b79a6bba45b4f8a"/>
+    <p:sldId xmlns:r="http://schemas.openxmlformats.org/officeDocument/2006/relationships" id="267" r:id="R571ac6cdeaf64aa7"/>
   </p:sldIdLst>
   <p:sldSz cx="12191695" cy="6858000"/>
   <p:notesSz cx="6858000" cy="9144000"/>
@@ -1345,7 +1345,7 @@
           </a:p>
           <a:p xmlns:a="http://schemas.openxmlformats.org/drawingml/2006/main">
             <a:r>
-              <a:t>So sánh đối ứng trên 296 cặp anchor chuẩn chỉ ra rằng biểu diễn Single-event đạt thứ hạng tìm kiếm tốt hơn Contextual-event (65 cặp vs 23 cặp), và hơn 70% có thứ hạng tương đương (phần lớn do cả hai cùng trượt Top-10). Điều này cho thấy việc đưa thêm log nền gây hiện tượng benign drift. Chúng tôi thiết lập schema so sánh đối chứng scaffold giữa Zero-Shot No-RAG, Zero-Shot RAG và các prompt scaffold, hiện đang được gắn nhãn [PENDING EXECUTION] chờ toàn bộ ma trận TEST hoàn tất để đưa ra kết luận khoa học chính thức.</a:t>
+              <a:t>So sánh đối ứng trên 296 cặp anchor chuẩn chỉ ra rằng biểu diễn Single-event đạt thứ hạng tìm kiếm tốt hơn Contextual-event (65 cặp vs 23 cặp), và hơn 70% có thứ hạng tương đương (phần lớn do cả hai cùng trượt Top-10). Điều này cho thấy việc đưa thêm log nền gây hiện tượng benign drift. Chúng tôi thiết lập schema so sánh đối chứng scaffold giữa Zero-Shot No-RAG, Zero-Shot RAG và các prompt scaffold, hiện đang được gắn nhãn [DIAGNOSTIC TEST FIXTURE ONLY - NOT CANONICAL NUMERICAL RESULTS]; kết quả đối chứng trên diagnostic cohort (n=718 views across 440 clusters) ghi nhận quan sát mô tả độc lập.</a:t>
             </a:r>
           </a:p>
           <a:p xmlns:a="http://schemas.openxmlformats.org/drawingml/2006/main">
@@ -1425,7 +1425,7 @@
           </a:p>
           <a:p xmlns:a="http://schemas.openxmlformats.org/drawingml/2006/main">
             <a:r>
-              <a:t>Khung đánh giá RQ1 &amp; RQ2 được xây dựng trên định đề D2i (Independent Measurement Axes). Chúng tôi bác bỏ hoàn toàn công thức cộng xác suất rời rạc sai lầm, bởi retrieval failure và downstream generation failure không hề xung khắc nhau mà có phần giao thoa rõ ràng; chúng tôi cũng không giả định độc lập xác suất ngẫu nhiên. Các chỉ số có điều kiện P(Correct | GT in Top-k) và P(Correct | GT NOT in Top-k) cho phép định lượng xem LLM có bị đánh lừa bởi distractor hay có khả năng tự sửa sai. Toàn bộ ma trận chính thức 6,400 bản ghi đang chạy; tính đúng đắn toán học của Evaluator đã được chứng minh qua 5 test fixtures.</a:t>
+              <a:t>Khung đánh giá RQ1 &amp; RQ2 được xây dựng trên định đề D2i (Independent Measurement Axes). Chúng tôi bác bỏ hoàn toàn công thức cộng xác suất rời rạc sai lầm, bởi retrieval failure và downstream generation failure không hề xung khắc nhau mà có phần giao thoa rõ ràng; chúng tôi cũng không giả định độc lập xác suất ngẫu nhiên. Các chỉ số có điều kiện P(Correct | GT in Top-k) và P(Correct | GT NOT in Top-k) cho phép định lượng xem LLM có bị đánh lừa bởi distractor hay có thể gán đúng khi thiếu ngữ cảnh truy xuất (không giả định năng lực tự sửa sai nội tại). Toàn bộ ma trận chính thức 6,400 bản ghi đang chạy; tính đúng đắn toán học của Evaluator đã được chứng minh qua 5 test fixtures.</a:t>
             </a:r>
           </a:p>
           <a:p xmlns:a="http://schemas.openxmlformats.org/drawingml/2006/main">
@@ -1577,7 +1577,7 @@
           <p:cNvPr id="2" name="Title 1">
             <a:extLst xmlns:a="http://schemas.openxmlformats.org/drawingml/2006/main">
               <a:ext uri="{FF2B5EF4-FFF2-40B4-BE49-F238E27FC236}">
-                <a16:creationId xmlns:a16="http://schemas.microsoft.com/office/drawing/2014/main" id="{66115B39-4BF4-427F-91A2-F0B18D91BFE2}"/>
+                <a16:creationId xmlns:a16="http://schemas.microsoft.com/office/drawing/2014/main" id="{F9DA5CCA-EA78-4031-9D73-0552F79BBAE6}"/>
               </a:ext>
             </a:extLst>
           </p:cNvPr>
@@ -1610,7 +1610,7 @@
           <p:cNvPr id="3" name="Subtitle 2">
             <a:extLst xmlns:a="http://schemas.openxmlformats.org/drawingml/2006/main">
               <a:ext uri="{FF2B5EF4-FFF2-40B4-BE49-F238E27FC236}">
-                <a16:creationId xmlns:a16="http://schemas.microsoft.com/office/drawing/2014/main" id="{99955D96-19FA-4BC4-B906-B87CA7778380}"/>
+                <a16:creationId xmlns:a16="http://schemas.microsoft.com/office/drawing/2014/main" id="{19BB409A-C2F9-4FB0-8AA0-B4B9C228E823}"/>
               </a:ext>
             </a:extLst>
           </p:cNvPr>
@@ -1734,7 +1734,7 @@
           <p:cNvPr id="4" name="Date Placeholder 3">
             <a:extLst xmlns:a="http://schemas.openxmlformats.org/drawingml/2006/main">
               <a:ext uri="{FF2B5EF4-FFF2-40B4-BE49-F238E27FC236}">
-                <a16:creationId xmlns:a16="http://schemas.microsoft.com/office/drawing/2014/main" id="{05C18CD1-4F94-4E26-9336-C6BCE04277E0}"/>
+                <a16:creationId xmlns:a16="http://schemas.microsoft.com/office/drawing/2014/main" id="{B795B3B7-FE2B-49B6-B889-9C4E1EF39834}"/>
               </a:ext>
             </a:extLst>
           </p:cNvPr>
@@ -1762,7 +1762,7 @@
           <p:cNvPr id="5" name="Footer Placeholder 4">
             <a:extLst xmlns:a="http://schemas.openxmlformats.org/drawingml/2006/main">
               <a:ext uri="{FF2B5EF4-FFF2-40B4-BE49-F238E27FC236}">
-                <a16:creationId xmlns:a16="http://schemas.microsoft.com/office/drawing/2014/main" id="{58816743-5408-49B0-9E62-4D3A93D025BE}"/>
+                <a16:creationId xmlns:a16="http://schemas.microsoft.com/office/drawing/2014/main" id="{60D51D36-2399-4278-8013-E7F2535656E2}"/>
               </a:ext>
             </a:extLst>
           </p:cNvPr>
@@ -1787,7 +1787,7 @@
           <p:cNvPr id="6" name="Slide Number Placeholder 5">
             <a:extLst xmlns:a="http://schemas.openxmlformats.org/drawingml/2006/main">
               <a:ext uri="{FF2B5EF4-FFF2-40B4-BE49-F238E27FC236}">
-                <a16:creationId xmlns:a16="http://schemas.microsoft.com/office/drawing/2014/main" id="{FF406F3B-CB4C-49EC-BA8E-CABAF96D4B0D}"/>
+                <a16:creationId xmlns:a16="http://schemas.microsoft.com/office/drawing/2014/main" id="{70B92285-AB39-490B-84D3-AD549ED76BB9}"/>
               </a:ext>
             </a:extLst>
           </p:cNvPr>
@@ -1832,7 +1832,7 @@
           <p:cNvPr id="2" name="Title 1">
             <a:extLst xmlns:a="http://schemas.openxmlformats.org/drawingml/2006/main">
               <a:ext uri="{FF2B5EF4-FFF2-40B4-BE49-F238E27FC236}">
-                <a16:creationId xmlns:a16="http://schemas.microsoft.com/office/drawing/2014/main" id="{6503EEAC-502C-4364-9074-58E7B15E2ED9}"/>
+                <a16:creationId xmlns:a16="http://schemas.microsoft.com/office/drawing/2014/main" id="{FC0B20C2-F336-4475-8B13-B11457B3FFD2}"/>
               </a:ext>
             </a:extLst>
           </p:cNvPr>
@@ -1860,7 +1860,7 @@
           <p:cNvPr id="3" name="Vertical Text Placeholder 2">
             <a:extLst xmlns:a="http://schemas.openxmlformats.org/drawingml/2006/main">
               <a:ext uri="{FF2B5EF4-FFF2-40B4-BE49-F238E27FC236}">
-                <a16:creationId xmlns:a16="http://schemas.microsoft.com/office/drawing/2014/main" id="{BD92E5CE-42B4-450A-9319-72EB00806948}"/>
+                <a16:creationId xmlns:a16="http://schemas.microsoft.com/office/drawing/2014/main" id="{B841D65A-AEDB-4068-BA32-56A721BDDA10}"/>
               </a:ext>
             </a:extLst>
           </p:cNvPr>
@@ -1923,7 +1923,7 @@
           <p:cNvPr id="4" name="Date Placeholder 3">
             <a:extLst xmlns:a="http://schemas.openxmlformats.org/drawingml/2006/main">
               <a:ext uri="{FF2B5EF4-FFF2-40B4-BE49-F238E27FC236}">
-                <a16:creationId xmlns:a16="http://schemas.microsoft.com/office/drawing/2014/main" id="{1E561BB6-2D97-4D54-A190-076574022E28}"/>
+                <a16:creationId xmlns:a16="http://schemas.microsoft.com/office/drawing/2014/main" id="{3129638E-1C98-43F1-9D14-983C2C014E88}"/>
               </a:ext>
             </a:extLst>
           </p:cNvPr>
@@ -1951,7 +1951,7 @@
           <p:cNvPr id="5" name="Footer Placeholder 4">
             <a:extLst xmlns:a="http://schemas.openxmlformats.org/drawingml/2006/main">
               <a:ext uri="{FF2B5EF4-FFF2-40B4-BE49-F238E27FC236}">
-                <a16:creationId xmlns:a16="http://schemas.microsoft.com/office/drawing/2014/main" id="{56346C84-D21F-44B5-AAFF-2D4E00C7AA00}"/>
+                <a16:creationId xmlns:a16="http://schemas.microsoft.com/office/drawing/2014/main" id="{EBCBB96D-00A3-4182-AC99-C4AFD7861632}"/>
               </a:ext>
             </a:extLst>
           </p:cNvPr>
@@ -1976,7 +1976,7 @@
           <p:cNvPr id="6" name="Slide Number Placeholder 5">
             <a:extLst xmlns:a="http://schemas.openxmlformats.org/drawingml/2006/main">
               <a:ext uri="{FF2B5EF4-FFF2-40B4-BE49-F238E27FC236}">
-                <a16:creationId xmlns:a16="http://schemas.microsoft.com/office/drawing/2014/main" id="{F895712B-C0A2-47D6-86E8-E9C48F45F8C3}"/>
+                <a16:creationId xmlns:a16="http://schemas.microsoft.com/office/drawing/2014/main" id="{5FFFFC04-4E85-4F48-88FB-7F6CDE8FFE2B}"/>
               </a:ext>
             </a:extLst>
           </p:cNvPr>
@@ -2021,7 +2021,7 @@
           <p:cNvPr id="2" name="Vertical Title 1">
             <a:extLst xmlns:a="http://schemas.openxmlformats.org/drawingml/2006/main">
               <a:ext uri="{FF2B5EF4-FFF2-40B4-BE49-F238E27FC236}">
-                <a16:creationId xmlns:a16="http://schemas.microsoft.com/office/drawing/2014/main" id="{F210DD81-3944-41D9-B432-2A656F7E122F}"/>
+                <a16:creationId xmlns:a16="http://schemas.microsoft.com/office/drawing/2014/main" id="{6C77F7A5-C1F9-40A0-87F6-EEDE73A32E5A}"/>
               </a:ext>
             </a:extLst>
           </p:cNvPr>
@@ -2054,7 +2054,7 @@
           <p:cNvPr id="3" name="Vertical Text Placeholder 2">
             <a:extLst xmlns:a="http://schemas.openxmlformats.org/drawingml/2006/main">
               <a:ext uri="{FF2B5EF4-FFF2-40B4-BE49-F238E27FC236}">
-                <a16:creationId xmlns:a16="http://schemas.microsoft.com/office/drawing/2014/main" id="{ACE6C037-233D-4675-9AC0-53D7E231AEE2}"/>
+                <a16:creationId xmlns:a16="http://schemas.microsoft.com/office/drawing/2014/main" id="{3870C724-5260-4B31-93FA-A3D59056511D}"/>
               </a:ext>
             </a:extLst>
           </p:cNvPr>
@@ -2122,7 +2122,7 @@
           <p:cNvPr id="4" name="Date Placeholder 3">
             <a:extLst xmlns:a="http://schemas.openxmlformats.org/drawingml/2006/main">
               <a:ext uri="{FF2B5EF4-FFF2-40B4-BE49-F238E27FC236}">
-                <a16:creationId xmlns:a16="http://schemas.microsoft.com/office/drawing/2014/main" id="{632E594C-FD68-4A9A-AFBD-074A6B134803}"/>
+                <a16:creationId xmlns:a16="http://schemas.microsoft.com/office/drawing/2014/main" id="{6B57E13C-39E7-4676-9A74-B2774572B013}"/>
               </a:ext>
             </a:extLst>
           </p:cNvPr>
@@ -2150,7 +2150,7 @@
           <p:cNvPr id="5" name="Footer Placeholder 4">
             <a:extLst xmlns:a="http://schemas.openxmlformats.org/drawingml/2006/main">
               <a:ext uri="{FF2B5EF4-FFF2-40B4-BE49-F238E27FC236}">
-                <a16:creationId xmlns:a16="http://schemas.microsoft.com/office/drawing/2014/main" id="{E3201CC2-23D0-414A-9D2D-7D1AACCDDFC1}"/>
+                <a16:creationId xmlns:a16="http://schemas.microsoft.com/office/drawing/2014/main" id="{3A0C92E4-54E5-4082-8FE5-43822052E3E0}"/>
               </a:ext>
             </a:extLst>
           </p:cNvPr>
@@ -2175,7 +2175,7 @@
           <p:cNvPr id="6" name="Slide Number Placeholder 5">
             <a:extLst xmlns:a="http://schemas.openxmlformats.org/drawingml/2006/main">
               <a:ext uri="{FF2B5EF4-FFF2-40B4-BE49-F238E27FC236}">
-                <a16:creationId xmlns:a16="http://schemas.microsoft.com/office/drawing/2014/main" id="{804FFD6A-E215-449E-9F13-C8E294D6AAEB}"/>
+                <a16:creationId xmlns:a16="http://schemas.microsoft.com/office/drawing/2014/main" id="{352820C3-61BC-41A5-A209-4C282B022651}"/>
               </a:ext>
             </a:extLst>
           </p:cNvPr>
@@ -2220,7 +2220,7 @@
           <p:cNvPr id="2" name="Title 1">
             <a:extLst xmlns:a="http://schemas.openxmlformats.org/drawingml/2006/main">
               <a:ext uri="{FF2B5EF4-FFF2-40B4-BE49-F238E27FC236}">
-                <a16:creationId xmlns:a16="http://schemas.microsoft.com/office/drawing/2014/main" id="{98EEBC89-1365-4C48-AB8C-07095088448E}"/>
+                <a16:creationId xmlns:a16="http://schemas.microsoft.com/office/drawing/2014/main" id="{24E4A1B5-BCA2-4DAC-869F-ECD99F2D1B4F}"/>
               </a:ext>
             </a:extLst>
           </p:cNvPr>
@@ -2248,7 +2248,7 @@
           <p:cNvPr id="3" name="Content Placeholder 2">
             <a:extLst xmlns:a="http://schemas.openxmlformats.org/drawingml/2006/main">
               <a:ext uri="{FF2B5EF4-FFF2-40B4-BE49-F238E27FC236}">
-                <a16:creationId xmlns:a16="http://schemas.microsoft.com/office/drawing/2014/main" id="{CC240799-B26F-4D15-B631-BD59AE435E98}"/>
+                <a16:creationId xmlns:a16="http://schemas.microsoft.com/office/drawing/2014/main" id="{753D367C-C51F-4599-AD3E-7D0F59072ABE}"/>
               </a:ext>
             </a:extLst>
           </p:cNvPr>
@@ -2311,7 +2311,7 @@
           <p:cNvPr id="4" name="Date Placeholder 3">
             <a:extLst xmlns:a="http://schemas.openxmlformats.org/drawingml/2006/main">
               <a:ext uri="{FF2B5EF4-FFF2-40B4-BE49-F238E27FC236}">
-                <a16:creationId xmlns:a16="http://schemas.microsoft.com/office/drawing/2014/main" id="{0FC22687-28CB-4A3A-A65F-E4A24822854C}"/>
+                <a16:creationId xmlns:a16="http://schemas.microsoft.com/office/drawing/2014/main" id="{738ACF17-65E1-4465-A73B-CC1BCE9C5B86}"/>
               </a:ext>
             </a:extLst>
           </p:cNvPr>
@@ -2339,7 +2339,7 @@
           <p:cNvPr id="5" name="Footer Placeholder 4">
             <a:extLst xmlns:a="http://schemas.openxmlformats.org/drawingml/2006/main">
               <a:ext uri="{FF2B5EF4-FFF2-40B4-BE49-F238E27FC236}">
-                <a16:creationId xmlns:a16="http://schemas.microsoft.com/office/drawing/2014/main" id="{82B40110-934F-430A-9BD1-F5D3C3AA1295}"/>
+                <a16:creationId xmlns:a16="http://schemas.microsoft.com/office/drawing/2014/main" id="{DCF0738C-3456-4B4D-B8F8-89A0B4FC2F88}"/>
               </a:ext>
             </a:extLst>
           </p:cNvPr>
@@ -2364,7 +2364,7 @@
           <p:cNvPr id="6" name="Slide Number Placeholder 5">
             <a:extLst xmlns:a="http://schemas.openxmlformats.org/drawingml/2006/main">
               <a:ext uri="{FF2B5EF4-FFF2-40B4-BE49-F238E27FC236}">
-                <a16:creationId xmlns:a16="http://schemas.microsoft.com/office/drawing/2014/main" id="{56BAC69A-67F8-4F53-B7AE-D9820A7DE799}"/>
+                <a16:creationId xmlns:a16="http://schemas.microsoft.com/office/drawing/2014/main" id="{63CE349C-E386-4FE4-85DF-635982394CC4}"/>
               </a:ext>
             </a:extLst>
           </p:cNvPr>
@@ -2409,7 +2409,7 @@
           <p:cNvPr id="2" name="Title 1">
             <a:extLst xmlns:a="http://schemas.openxmlformats.org/drawingml/2006/main">
               <a:ext uri="{FF2B5EF4-FFF2-40B4-BE49-F238E27FC236}">
-                <a16:creationId xmlns:a16="http://schemas.microsoft.com/office/drawing/2014/main" id="{C80A8782-0932-4AD6-A8C8-BD7614C7CA01}"/>
+                <a16:creationId xmlns:a16="http://schemas.microsoft.com/office/drawing/2014/main" id="{391A7473-B3CE-4B50-B543-FA316761A063}"/>
               </a:ext>
             </a:extLst>
           </p:cNvPr>
@@ -2447,7 +2447,7 @@
           <p:cNvPr id="3" name="Text Placeholder 2">
             <a:extLst xmlns:a="http://schemas.openxmlformats.org/drawingml/2006/main">
               <a:ext uri="{FF2B5EF4-FFF2-40B4-BE49-F238E27FC236}">
-                <a16:creationId xmlns:a16="http://schemas.microsoft.com/office/drawing/2014/main" id="{8BCF0DF2-F242-49A1-8EA9-89D1957BE3C4}"/>
+                <a16:creationId xmlns:a16="http://schemas.microsoft.com/office/drawing/2014/main" id="{43154A4E-E1EB-49E4-AB50-E78B75B6CC2A}"/>
               </a:ext>
             </a:extLst>
           </p:cNvPr>
@@ -2573,7 +2573,7 @@
           <p:cNvPr id="4" name="Date Placeholder 3">
             <a:extLst xmlns:a="http://schemas.openxmlformats.org/drawingml/2006/main">
               <a:ext uri="{FF2B5EF4-FFF2-40B4-BE49-F238E27FC236}">
-                <a16:creationId xmlns:a16="http://schemas.microsoft.com/office/drawing/2014/main" id="{7B30EADA-363A-41EA-AFAD-C9049B007C4E}"/>
+                <a16:creationId xmlns:a16="http://schemas.microsoft.com/office/drawing/2014/main" id="{4D20F37B-A41F-4453-BE8A-F48B2FD17537}"/>
               </a:ext>
             </a:extLst>
           </p:cNvPr>
@@ -2601,7 +2601,7 @@
           <p:cNvPr id="5" name="Footer Placeholder 4">
             <a:extLst xmlns:a="http://schemas.openxmlformats.org/drawingml/2006/main">
               <a:ext uri="{FF2B5EF4-FFF2-40B4-BE49-F238E27FC236}">
-                <a16:creationId xmlns:a16="http://schemas.microsoft.com/office/drawing/2014/main" id="{615A5276-8A61-41E0-B4CA-3AD49296ED1E}"/>
+                <a16:creationId xmlns:a16="http://schemas.microsoft.com/office/drawing/2014/main" id="{C636DA3E-B9F2-41E4-ABF9-F2E7573C70EF}"/>
               </a:ext>
             </a:extLst>
           </p:cNvPr>
@@ -2626,7 +2626,7 @@
           <p:cNvPr id="6" name="Slide Number Placeholder 5">
             <a:extLst xmlns:a="http://schemas.openxmlformats.org/drawingml/2006/main">
               <a:ext uri="{FF2B5EF4-FFF2-40B4-BE49-F238E27FC236}">
-                <a16:creationId xmlns:a16="http://schemas.microsoft.com/office/drawing/2014/main" id="{593E4D0B-E498-4E27-94CC-6C852215B289}"/>
+                <a16:creationId xmlns:a16="http://schemas.microsoft.com/office/drawing/2014/main" id="{37455C70-17F0-4849-A404-8566E814A6E3}"/>
               </a:ext>
             </a:extLst>
           </p:cNvPr>
@@ -2671,7 +2671,7 @@
           <p:cNvPr id="2" name="Title 1">
             <a:extLst xmlns:a="http://schemas.openxmlformats.org/drawingml/2006/main">
               <a:ext uri="{FF2B5EF4-FFF2-40B4-BE49-F238E27FC236}">
-                <a16:creationId xmlns:a16="http://schemas.microsoft.com/office/drawing/2014/main" id="{7DEF39B7-B4CC-4E66-A409-99FB360FCBE4}"/>
+                <a16:creationId xmlns:a16="http://schemas.microsoft.com/office/drawing/2014/main" id="{C7D2D7A8-3141-4807-A9F0-4B848D847234}"/>
               </a:ext>
             </a:extLst>
           </p:cNvPr>
@@ -2699,7 +2699,7 @@
           <p:cNvPr id="3" name="Content Placeholder 2">
             <a:extLst xmlns:a="http://schemas.openxmlformats.org/drawingml/2006/main">
               <a:ext uri="{FF2B5EF4-FFF2-40B4-BE49-F238E27FC236}">
-                <a16:creationId xmlns:a16="http://schemas.microsoft.com/office/drawing/2014/main" id="{F1DE4C39-3975-45AB-831F-8F36413238F8}"/>
+                <a16:creationId xmlns:a16="http://schemas.microsoft.com/office/drawing/2014/main" id="{0FBA10AA-CACB-45D8-9A56-71563A20613B}"/>
               </a:ext>
             </a:extLst>
           </p:cNvPr>
@@ -2804,7 +2804,7 @@
           <p:cNvPr id="4" name="Content Placeholder 3">
             <a:extLst xmlns:a="http://schemas.openxmlformats.org/drawingml/2006/main">
               <a:ext uri="{FF2B5EF4-FFF2-40B4-BE49-F238E27FC236}">
-                <a16:creationId xmlns:a16="http://schemas.microsoft.com/office/drawing/2014/main" id="{8C0D8E01-8C25-442C-9AD7-C31A56F00E7A}"/>
+                <a16:creationId xmlns:a16="http://schemas.microsoft.com/office/drawing/2014/main" id="{8189375D-8C49-4840-AC8F-2FCCDF185DD4}"/>
               </a:ext>
             </a:extLst>
           </p:cNvPr>
@@ -2909,7 +2909,7 @@
           <p:cNvPr id="5" name="Date Placeholder 4">
             <a:extLst xmlns:a="http://schemas.openxmlformats.org/drawingml/2006/main">
               <a:ext uri="{FF2B5EF4-FFF2-40B4-BE49-F238E27FC236}">
-                <a16:creationId xmlns:a16="http://schemas.microsoft.com/office/drawing/2014/main" id="{EFC71855-D46E-4FB7-B641-353A6FBDC977}"/>
+                <a16:creationId xmlns:a16="http://schemas.microsoft.com/office/drawing/2014/main" id="{A1E705D8-EF4D-4D1B-95C5-3D68EF3E57A3}"/>
               </a:ext>
             </a:extLst>
           </p:cNvPr>
@@ -2937,7 +2937,7 @@
           <p:cNvPr id="6" name="Footer Placeholder 5">
             <a:extLst xmlns:a="http://schemas.openxmlformats.org/drawingml/2006/main">
               <a:ext uri="{FF2B5EF4-FFF2-40B4-BE49-F238E27FC236}">
-                <a16:creationId xmlns:a16="http://schemas.microsoft.com/office/drawing/2014/main" id="{B22541E1-B7CB-48BD-A46A-E371406654C3}"/>
+                <a16:creationId xmlns:a16="http://schemas.microsoft.com/office/drawing/2014/main" id="{3A04959D-E4AE-4CD7-BDC8-EB006D108012}"/>
               </a:ext>
             </a:extLst>
           </p:cNvPr>
@@ -2962,7 +2962,7 @@
           <p:cNvPr id="7" name="Slide Number Placeholder 6">
             <a:extLst xmlns:a="http://schemas.openxmlformats.org/drawingml/2006/main">
               <a:ext uri="{FF2B5EF4-FFF2-40B4-BE49-F238E27FC236}">
-                <a16:creationId xmlns:a16="http://schemas.microsoft.com/office/drawing/2014/main" id="{DDE05DB1-8B71-4F87-8111-252216F6D2CF}"/>
+                <a16:creationId xmlns:a16="http://schemas.microsoft.com/office/drawing/2014/main" id="{6ED017F7-9AAC-4EA3-B13B-301A7C105760}"/>
               </a:ext>
             </a:extLst>
           </p:cNvPr>
@@ -3007,7 +3007,7 @@
           <p:cNvPr id="2" name="Title 1">
             <a:extLst xmlns:a="http://schemas.openxmlformats.org/drawingml/2006/main">
               <a:ext uri="{FF2B5EF4-FFF2-40B4-BE49-F238E27FC236}">
-                <a16:creationId xmlns:a16="http://schemas.microsoft.com/office/drawing/2014/main" id="{8582D55D-3AE7-4F18-AF3E-60EB6F88A0F0}"/>
+                <a16:creationId xmlns:a16="http://schemas.microsoft.com/office/drawing/2014/main" id="{B73E4511-F503-4B48-B8EE-6B17183C6793}"/>
               </a:ext>
             </a:extLst>
           </p:cNvPr>
@@ -3040,7 +3040,7 @@
           <p:cNvPr id="3" name="Text Placeholder 2">
             <a:extLst xmlns:a="http://schemas.openxmlformats.org/drawingml/2006/main">
               <a:ext uri="{FF2B5EF4-FFF2-40B4-BE49-F238E27FC236}">
-                <a16:creationId xmlns:a16="http://schemas.microsoft.com/office/drawing/2014/main" id="{756F687E-5BEF-48B3-9AEF-E7374B98FBB0}"/>
+                <a16:creationId xmlns:a16="http://schemas.microsoft.com/office/drawing/2014/main" id="{AB4C551B-0350-4040-8C00-8BCA4062FFF8}"/>
               </a:ext>
             </a:extLst>
           </p:cNvPr>
@@ -3112,7 +3112,7 @@
           <p:cNvPr id="4" name="Content Placeholder 3">
             <a:extLst xmlns:a="http://schemas.openxmlformats.org/drawingml/2006/main">
               <a:ext uri="{FF2B5EF4-FFF2-40B4-BE49-F238E27FC236}">
-                <a16:creationId xmlns:a16="http://schemas.microsoft.com/office/drawing/2014/main" id="{51846547-ABFF-438E-AE82-15277977A4BD}"/>
+                <a16:creationId xmlns:a16="http://schemas.microsoft.com/office/drawing/2014/main" id="{F0DF20D8-2783-4830-98B4-2B8A435945E3}"/>
               </a:ext>
             </a:extLst>
           </p:cNvPr>
@@ -3217,7 +3217,7 @@
           <p:cNvPr id="5" name="Text Placeholder 4">
             <a:extLst xmlns:a="http://schemas.openxmlformats.org/drawingml/2006/main">
               <a:ext uri="{FF2B5EF4-FFF2-40B4-BE49-F238E27FC236}">
-                <a16:creationId xmlns:a16="http://schemas.microsoft.com/office/drawing/2014/main" id="{CECB1900-5599-41CB-88C6-C8BCC3DF9939}"/>
+                <a16:creationId xmlns:a16="http://schemas.microsoft.com/office/drawing/2014/main" id="{16DAFA06-5981-4A6A-BCB9-D8533DA2405C}"/>
               </a:ext>
             </a:extLst>
           </p:cNvPr>
@@ -3289,7 +3289,7 @@
           <p:cNvPr id="6" name="Content Placeholder 5">
             <a:extLst xmlns:a="http://schemas.openxmlformats.org/drawingml/2006/main">
               <a:ext uri="{FF2B5EF4-FFF2-40B4-BE49-F238E27FC236}">
-                <a16:creationId xmlns:a16="http://schemas.microsoft.com/office/drawing/2014/main" id="{81C00F89-B4D2-41B6-A27C-03D2C111F12F}"/>
+                <a16:creationId xmlns:a16="http://schemas.microsoft.com/office/drawing/2014/main" id="{15C8AA1E-B341-4598-837F-8951C6D9FA90}"/>
               </a:ext>
             </a:extLst>
           </p:cNvPr>
@@ -3394,7 +3394,7 @@
           <p:cNvPr id="7" name="Date Placeholder 6">
             <a:extLst xmlns:a="http://schemas.openxmlformats.org/drawingml/2006/main">
               <a:ext uri="{FF2B5EF4-FFF2-40B4-BE49-F238E27FC236}">
-                <a16:creationId xmlns:a16="http://schemas.microsoft.com/office/drawing/2014/main" id="{A33E7E51-182F-4F05-9243-B0ECF704B41A}"/>
+                <a16:creationId xmlns:a16="http://schemas.microsoft.com/office/drawing/2014/main" id="{A2A7B23B-0C6D-4889-BFA2-7B0C32AE926F}"/>
               </a:ext>
             </a:extLst>
           </p:cNvPr>
@@ -3422,7 +3422,7 @@
           <p:cNvPr id="8" name="Footer Placeholder 7">
             <a:extLst xmlns:a="http://schemas.openxmlformats.org/drawingml/2006/main">
               <a:ext uri="{FF2B5EF4-FFF2-40B4-BE49-F238E27FC236}">
-                <a16:creationId xmlns:a16="http://schemas.microsoft.com/office/drawing/2014/main" id="{B292B26E-0100-41A8-8460-137C79826229}"/>
+                <a16:creationId xmlns:a16="http://schemas.microsoft.com/office/drawing/2014/main" id="{96294E75-1ED2-4258-BCC2-79BC15773B9C}"/>
               </a:ext>
             </a:extLst>
           </p:cNvPr>
@@ -3447,7 +3447,7 @@
           <p:cNvPr id="9" name="Slide Number Placeholder 8">
             <a:extLst xmlns:a="http://schemas.openxmlformats.org/drawingml/2006/main">
               <a:ext uri="{FF2B5EF4-FFF2-40B4-BE49-F238E27FC236}">
-                <a16:creationId xmlns:a16="http://schemas.microsoft.com/office/drawing/2014/main" id="{19DAE829-DACF-413D-908C-B11A614DEE91}"/>
+                <a16:creationId xmlns:a16="http://schemas.microsoft.com/office/drawing/2014/main" id="{EC185C55-613E-490D-8F05-A90E1F642314}"/>
               </a:ext>
             </a:extLst>
           </p:cNvPr>
@@ -3492,7 +3492,7 @@
           <p:cNvPr id="2" name="Title 1">
             <a:extLst xmlns:a="http://schemas.openxmlformats.org/drawingml/2006/main">
               <a:ext uri="{FF2B5EF4-FFF2-40B4-BE49-F238E27FC236}">
-                <a16:creationId xmlns:a16="http://schemas.microsoft.com/office/drawing/2014/main" id="{16687D33-4EC7-4F7A-BC11-FE04D4A937AA}"/>
+                <a16:creationId xmlns:a16="http://schemas.microsoft.com/office/drawing/2014/main" id="{45B11051-4B00-4A84-8E8C-8301CCF13FF7}"/>
               </a:ext>
             </a:extLst>
           </p:cNvPr>
@@ -3520,7 +3520,7 @@
           <p:cNvPr id="3" name="Date Placeholder 2">
             <a:extLst xmlns:a="http://schemas.openxmlformats.org/drawingml/2006/main">
               <a:ext uri="{FF2B5EF4-FFF2-40B4-BE49-F238E27FC236}">
-                <a16:creationId xmlns:a16="http://schemas.microsoft.com/office/drawing/2014/main" id="{660E4E84-5ED9-4180-AF1B-4F4CE8F35C0A}"/>
+                <a16:creationId xmlns:a16="http://schemas.microsoft.com/office/drawing/2014/main" id="{66580038-F531-4C80-9AF5-286B661DAF57}"/>
               </a:ext>
             </a:extLst>
           </p:cNvPr>
@@ -3548,7 +3548,7 @@
           <p:cNvPr id="4" name="Footer Placeholder 3">
             <a:extLst xmlns:a="http://schemas.openxmlformats.org/drawingml/2006/main">
               <a:ext uri="{FF2B5EF4-FFF2-40B4-BE49-F238E27FC236}">
-                <a16:creationId xmlns:a16="http://schemas.microsoft.com/office/drawing/2014/main" id="{6764C247-252F-4B73-B608-6E01366DA550}"/>
+                <a16:creationId xmlns:a16="http://schemas.microsoft.com/office/drawing/2014/main" id="{AF98CB20-2155-4A8D-A513-4716A8A2D2A9}"/>
               </a:ext>
             </a:extLst>
           </p:cNvPr>
@@ -3573,7 +3573,7 @@
           <p:cNvPr id="5" name="Slide Number Placeholder 4">
             <a:extLst xmlns:a="http://schemas.openxmlformats.org/drawingml/2006/main">
               <a:ext uri="{FF2B5EF4-FFF2-40B4-BE49-F238E27FC236}">
-                <a16:creationId xmlns:a16="http://schemas.microsoft.com/office/drawing/2014/main" id="{764D05A9-9D94-4DDD-9278-4F83400A1D28}"/>
+                <a16:creationId xmlns:a16="http://schemas.microsoft.com/office/drawing/2014/main" id="{3F01E39A-C8D6-41E8-91D4-602408199D6A}"/>
               </a:ext>
             </a:extLst>
           </p:cNvPr>
@@ -3618,7 +3618,7 @@
           <p:cNvPr id="2" name="Date Placeholder 1">
             <a:extLst xmlns:a="http://schemas.openxmlformats.org/drawingml/2006/main">
               <a:ext uri="{FF2B5EF4-FFF2-40B4-BE49-F238E27FC236}">
-                <a16:creationId xmlns:a16="http://schemas.microsoft.com/office/drawing/2014/main" id="{49E9801F-BB9D-47CA-BF37-ECD58512E835}"/>
+                <a16:creationId xmlns:a16="http://schemas.microsoft.com/office/drawing/2014/main" id="{7B415D65-C11B-4E90-B2BD-2562E6B2806D}"/>
               </a:ext>
             </a:extLst>
           </p:cNvPr>
@@ -3646,7 +3646,7 @@
           <p:cNvPr id="3" name="Footer Placeholder 2">
             <a:extLst xmlns:a="http://schemas.openxmlformats.org/drawingml/2006/main">
               <a:ext uri="{FF2B5EF4-FFF2-40B4-BE49-F238E27FC236}">
-                <a16:creationId xmlns:a16="http://schemas.microsoft.com/office/drawing/2014/main" id="{76DB1823-5BEE-4684-B546-8EB6E39EEDF2}"/>
+                <a16:creationId xmlns:a16="http://schemas.microsoft.com/office/drawing/2014/main" id="{25462E44-65B4-4C79-A39C-AD5B0EDC47CD}"/>
               </a:ext>
             </a:extLst>
           </p:cNvPr>
@@ -3671,7 +3671,7 @@
           <p:cNvPr id="4" name="Slide Number Placeholder 3">
             <a:extLst xmlns:a="http://schemas.openxmlformats.org/drawingml/2006/main">
               <a:ext uri="{FF2B5EF4-FFF2-40B4-BE49-F238E27FC236}">
-                <a16:creationId xmlns:a16="http://schemas.microsoft.com/office/drawing/2014/main" id="{C77D3088-1104-42E7-AC87-ECBB12704DE7}"/>
+                <a16:creationId xmlns:a16="http://schemas.microsoft.com/office/drawing/2014/main" id="{65654616-2434-459C-8B21-C24C022146C4}"/>
               </a:ext>
             </a:extLst>
           </p:cNvPr>
@@ -3716,7 +3716,7 @@
           <p:cNvPr id="2" name="Title 1">
             <a:extLst xmlns:a="http://schemas.openxmlformats.org/drawingml/2006/main">
               <a:ext uri="{FF2B5EF4-FFF2-40B4-BE49-F238E27FC236}">
-                <a16:creationId xmlns:a16="http://schemas.microsoft.com/office/drawing/2014/main" id="{A40F882A-E128-421E-9A44-9992301B7425}"/>
+                <a16:creationId xmlns:a16="http://schemas.microsoft.com/office/drawing/2014/main" id="{20CA77EA-3EA4-46AD-995F-0FB295B3A923}"/>
               </a:ext>
             </a:extLst>
           </p:cNvPr>
@@ -3754,7 +3754,7 @@
           <p:cNvPr id="3" name="Content Placeholder 2">
             <a:extLst xmlns:a="http://schemas.openxmlformats.org/drawingml/2006/main">
               <a:ext uri="{FF2B5EF4-FFF2-40B4-BE49-F238E27FC236}">
-                <a16:creationId xmlns:a16="http://schemas.microsoft.com/office/drawing/2014/main" id="{7E3B5DC1-73AF-4487-9D73-8AA5C9F8D565}"/>
+                <a16:creationId xmlns:a16="http://schemas.microsoft.com/office/drawing/2014/main" id="{1C155570-8B66-4B86-A5B5-56E9051DC819}"/>
               </a:ext>
             </a:extLst>
           </p:cNvPr>
@@ -3859,7 +3859,7 @@
           <p:cNvPr id="4" name="Text Placeholder 3">
             <a:extLst xmlns:a="http://schemas.openxmlformats.org/drawingml/2006/main">
               <a:ext uri="{FF2B5EF4-FFF2-40B4-BE49-F238E27FC236}">
-                <a16:creationId xmlns:a16="http://schemas.microsoft.com/office/drawing/2014/main" id="{666848DC-7DB2-47B0-9D8A-B6CE290EE432}"/>
+                <a16:creationId xmlns:a16="http://schemas.microsoft.com/office/drawing/2014/main" id="{CCF51576-67CB-4797-82D9-EE3AF5FE9539}"/>
               </a:ext>
             </a:extLst>
           </p:cNvPr>
@@ -3931,7 +3931,7 @@
           <p:cNvPr id="5" name="Date Placeholder 4">
             <a:extLst xmlns:a="http://schemas.openxmlformats.org/drawingml/2006/main">
               <a:ext uri="{FF2B5EF4-FFF2-40B4-BE49-F238E27FC236}">
-                <a16:creationId xmlns:a16="http://schemas.microsoft.com/office/drawing/2014/main" id="{1C9AC24B-F871-4A37-8742-BB8D1AFDB9FE}"/>
+                <a16:creationId xmlns:a16="http://schemas.microsoft.com/office/drawing/2014/main" id="{33C64480-3E72-4EFD-B3FD-51D0455CCA2C}"/>
               </a:ext>
             </a:extLst>
           </p:cNvPr>
@@ -3959,7 +3959,7 @@
           <p:cNvPr id="6" name="Footer Placeholder 5">
             <a:extLst xmlns:a="http://schemas.openxmlformats.org/drawingml/2006/main">
               <a:ext uri="{FF2B5EF4-FFF2-40B4-BE49-F238E27FC236}">
-                <a16:creationId xmlns:a16="http://schemas.microsoft.com/office/drawing/2014/main" id="{ECAB1074-C623-4AE6-9D59-906E03792C3A}"/>
+                <a16:creationId xmlns:a16="http://schemas.microsoft.com/office/drawing/2014/main" id="{A42C85F0-F709-4D84-AC9B-19BEB13A9ACE}"/>
               </a:ext>
             </a:extLst>
           </p:cNvPr>
@@ -3984,7 +3984,7 @@
           <p:cNvPr id="7" name="Slide Number Placeholder 6">
             <a:extLst xmlns:a="http://schemas.openxmlformats.org/drawingml/2006/main">
               <a:ext uri="{FF2B5EF4-FFF2-40B4-BE49-F238E27FC236}">
-                <a16:creationId xmlns:a16="http://schemas.microsoft.com/office/drawing/2014/main" id="{08792E8D-A193-4494-8C2C-D1CF952DFACA}"/>
+                <a16:creationId xmlns:a16="http://schemas.microsoft.com/office/drawing/2014/main" id="{A78F0A22-B148-44C8-9F30-A9DB92E5F93A}"/>
               </a:ext>
             </a:extLst>
           </p:cNvPr>
@@ -4029,7 +4029,7 @@
           <p:cNvPr id="2" name="Title 1">
             <a:extLst xmlns:a="http://schemas.openxmlformats.org/drawingml/2006/main">
               <a:ext uri="{FF2B5EF4-FFF2-40B4-BE49-F238E27FC236}">
-                <a16:creationId xmlns:a16="http://schemas.microsoft.com/office/drawing/2014/main" id="{ED12ECCF-57AF-4222-8993-0193C2760570}"/>
+                <a16:creationId xmlns:a16="http://schemas.microsoft.com/office/drawing/2014/main" id="{7F596D1C-21AD-4258-BE2F-6414DA8E03F7}"/>
               </a:ext>
             </a:extLst>
           </p:cNvPr>
@@ -4067,7 +4067,7 @@
           <p:cNvPr id="3" name="Picture Placeholder 2">
             <a:extLst xmlns:a="http://schemas.openxmlformats.org/drawingml/2006/main">
               <a:ext uri="{FF2B5EF4-FFF2-40B4-BE49-F238E27FC236}">
-                <a16:creationId xmlns:a16="http://schemas.microsoft.com/office/drawing/2014/main" id="{0692F047-EF6B-49C5-B97F-F50F0AD6DDC8}"/>
+                <a16:creationId xmlns:a16="http://schemas.microsoft.com/office/drawing/2014/main" id="{BAB2646F-02B2-4BE4-B095-B4869D8F38AF}"/>
               </a:ext>
             </a:extLst>
           </p:cNvPr>
@@ -4134,7 +4134,7 @@
           <p:cNvPr id="4" name="Text Placeholder 3">
             <a:extLst xmlns:a="http://schemas.openxmlformats.org/drawingml/2006/main">
               <a:ext uri="{FF2B5EF4-FFF2-40B4-BE49-F238E27FC236}">
-                <a16:creationId xmlns:a16="http://schemas.microsoft.com/office/drawing/2014/main" id="{4B63FF5B-3A74-413A-AD67-02B50B55F67C}"/>
+                <a16:creationId xmlns:a16="http://schemas.microsoft.com/office/drawing/2014/main" id="{64953EE6-E8E6-469D-B7EF-CBB291FD70B3}"/>
               </a:ext>
             </a:extLst>
           </p:cNvPr>
@@ -4206,7 +4206,7 @@
           <p:cNvPr id="5" name="Date Placeholder 4">
             <a:extLst xmlns:a="http://schemas.openxmlformats.org/drawingml/2006/main">
               <a:ext uri="{FF2B5EF4-FFF2-40B4-BE49-F238E27FC236}">
-                <a16:creationId xmlns:a16="http://schemas.microsoft.com/office/drawing/2014/main" id="{894E0FAC-2B57-4349-9EF1-8CBF8D86D397}"/>
+                <a16:creationId xmlns:a16="http://schemas.microsoft.com/office/drawing/2014/main" id="{92A3EAE5-C48B-4858-88D9-D8035E8F30C1}"/>
               </a:ext>
             </a:extLst>
           </p:cNvPr>
@@ -4234,7 +4234,7 @@
           <p:cNvPr id="6" name="Footer Placeholder 5">
             <a:extLst xmlns:a="http://schemas.openxmlformats.org/drawingml/2006/main">
               <a:ext uri="{FF2B5EF4-FFF2-40B4-BE49-F238E27FC236}">
-                <a16:creationId xmlns:a16="http://schemas.microsoft.com/office/drawing/2014/main" id="{C1A8E8B5-225F-4B32-AE94-437D71D8688C}"/>
+                <a16:creationId xmlns:a16="http://schemas.microsoft.com/office/drawing/2014/main" id="{9C9A7009-E3FA-4330-BFA4-60E531C70F0B}"/>
               </a:ext>
             </a:extLst>
           </p:cNvPr>
@@ -4259,7 +4259,7 @@
           <p:cNvPr id="7" name="Slide Number Placeholder 6">
             <a:extLst xmlns:a="http://schemas.openxmlformats.org/drawingml/2006/main">
               <a:ext uri="{FF2B5EF4-FFF2-40B4-BE49-F238E27FC236}">
-                <a16:creationId xmlns:a16="http://schemas.microsoft.com/office/drawing/2014/main" id="{3F7B145C-C6D6-486B-81ED-C96BF6FB5D85}"/>
+                <a16:creationId xmlns:a16="http://schemas.microsoft.com/office/drawing/2014/main" id="{C12A5262-2ADD-4F2E-8F59-BB8FA878E29D}"/>
               </a:ext>
             </a:extLst>
           </p:cNvPr>
@@ -4309,7 +4309,7 @@
           <p:cNvPr id="2" name="Title Placeholder 1">
             <a:extLst xmlns:a="http://schemas.openxmlformats.org/drawingml/2006/main">
               <a:ext uri="{FF2B5EF4-FFF2-40B4-BE49-F238E27FC236}">
-                <a16:creationId xmlns:a16="http://schemas.microsoft.com/office/drawing/2014/main" id="{07632DBB-E786-446C-9EBF-418F78778C9D}"/>
+                <a16:creationId xmlns:a16="http://schemas.microsoft.com/office/drawing/2014/main" id="{A3C6A25A-B8E5-468E-B742-A65AB27A5FC7}"/>
               </a:ext>
             </a:extLst>
           </p:cNvPr>
@@ -4347,7 +4347,7 @@
           <p:cNvPr id="3" name="Text Placeholder 2">
             <a:extLst xmlns:a="http://schemas.openxmlformats.org/drawingml/2006/main">
               <a:ext uri="{FF2B5EF4-FFF2-40B4-BE49-F238E27FC236}">
-                <a16:creationId xmlns:a16="http://schemas.microsoft.com/office/drawing/2014/main" id="{8A1C53DD-7BC3-4246-BEDA-A1A31D35888C}"/>
+                <a16:creationId xmlns:a16="http://schemas.microsoft.com/office/drawing/2014/main" id="{104D107C-A998-4A33-9243-4DEBC6844D0E}"/>
               </a:ext>
             </a:extLst>
           </p:cNvPr>
@@ -4420,7 +4420,7 @@
           <p:cNvPr id="4" name="Date Placeholder 3">
             <a:extLst xmlns:a="http://schemas.openxmlformats.org/drawingml/2006/main">
               <a:ext uri="{FF2B5EF4-FFF2-40B4-BE49-F238E27FC236}">
-                <a16:creationId xmlns:a16="http://schemas.microsoft.com/office/drawing/2014/main" id="{14940797-FF52-4AA4-BD61-472A81FB936D}"/>
+                <a16:creationId xmlns:a16="http://schemas.microsoft.com/office/drawing/2014/main" id="{8AAA794E-2403-43D9-8758-10ED05BBB76E}"/>
               </a:ext>
             </a:extLst>
           </p:cNvPr>
@@ -4467,7 +4467,7 @@
           <p:cNvPr id="5" name="Footer Placeholder 4">
             <a:extLst xmlns:a="http://schemas.openxmlformats.org/drawingml/2006/main">
               <a:ext uri="{FF2B5EF4-FFF2-40B4-BE49-F238E27FC236}">
-                <a16:creationId xmlns:a16="http://schemas.microsoft.com/office/drawing/2014/main" id="{C4440656-AA96-4ECD-9CA7-86AC6ABDD56C}"/>
+                <a16:creationId xmlns:a16="http://schemas.microsoft.com/office/drawing/2014/main" id="{B0AFBE03-6F71-41B8-B971-3E3B7D61C144}"/>
               </a:ext>
             </a:extLst>
           </p:cNvPr>
@@ -4511,7 +4511,7 @@
           <p:cNvPr id="6" name="Slide Number Placeholder 5">
             <a:extLst xmlns:a="http://schemas.openxmlformats.org/drawingml/2006/main">
               <a:ext uri="{FF2B5EF4-FFF2-40B4-BE49-F238E27FC236}">
-                <a16:creationId xmlns:a16="http://schemas.microsoft.com/office/drawing/2014/main" id="{0FC8353A-F823-422F-BA6B-B7ADA30F783E}"/>
+                <a16:creationId xmlns:a16="http://schemas.microsoft.com/office/drawing/2014/main" id="{868DAED3-7EE6-42C4-B663-2671EE7903D8}"/>
               </a:ext>
             </a:extLst>
           </p:cNvPr>
@@ -4557,17 +4557,17 @@
   </p:cSld>
   <p:clrMap bg1="lt1" tx1="dk1" bg2="lt2" tx2="dk2" accent1="accent1" accent2="accent2" accent3="accent3" accent4="accent4" accent5="accent5" accent6="accent6" hlink="hlink" folHlink="folHlink"/>
   <p:sldLayoutIdLst>
-    <p:sldLayoutId xmlns:r="http://schemas.openxmlformats.org/officeDocument/2006/relationships" id="2147483649" r:id="R4565d13f48ee4a1b"/>
-    <p:sldLayoutId xmlns:r="http://schemas.openxmlformats.org/officeDocument/2006/relationships" id="2147483650" r:id="Rc9e6239ceda14da2"/>
-    <p:sldLayoutId xmlns:r="http://schemas.openxmlformats.org/officeDocument/2006/relationships" id="2147483651" r:id="Rdcbb042836734161"/>
-    <p:sldLayoutId xmlns:r="http://schemas.openxmlformats.org/officeDocument/2006/relationships" id="2147483652" r:id="R9bd003323cbf4ba7"/>
-    <p:sldLayoutId xmlns:r="http://schemas.openxmlformats.org/officeDocument/2006/relationships" id="2147483653" r:id="R5167636997394d49"/>
-    <p:sldLayoutId xmlns:r="http://schemas.openxmlformats.org/officeDocument/2006/relationships" id="2147483654" r:id="R632962e45a034f54"/>
-    <p:sldLayoutId xmlns:r="http://schemas.openxmlformats.org/officeDocument/2006/relationships" id="2147483655" r:id="R768d31555de34ae6"/>
-    <p:sldLayoutId xmlns:r="http://schemas.openxmlformats.org/officeDocument/2006/relationships" id="2147483656" r:id="Rd69aa002bd184511"/>
-    <p:sldLayoutId xmlns:r="http://schemas.openxmlformats.org/officeDocument/2006/relationships" id="2147483657" r:id="Rffc36d79f2b24373"/>
-    <p:sldLayoutId xmlns:r="http://schemas.openxmlformats.org/officeDocument/2006/relationships" id="2147483658" r:id="R27644c7f6d464d1e"/>
-    <p:sldLayoutId xmlns:r="http://schemas.openxmlformats.org/officeDocument/2006/relationships" id="2147483659" r:id="R78be9c4692994101"/>
+    <p:sldLayoutId xmlns:r="http://schemas.openxmlformats.org/officeDocument/2006/relationships" id="2147483649" r:id="R47b4fb8c496d46fa"/>
+    <p:sldLayoutId xmlns:r="http://schemas.openxmlformats.org/officeDocument/2006/relationships" id="2147483650" r:id="R1a69aab7c27a45a2"/>
+    <p:sldLayoutId xmlns:r="http://schemas.openxmlformats.org/officeDocument/2006/relationships" id="2147483651" r:id="R41b325aeea9547e1"/>
+    <p:sldLayoutId xmlns:r="http://schemas.openxmlformats.org/officeDocument/2006/relationships" id="2147483652" r:id="Re156f2cc6e3c4a79"/>
+    <p:sldLayoutId xmlns:r="http://schemas.openxmlformats.org/officeDocument/2006/relationships" id="2147483653" r:id="R87c065f581184828"/>
+    <p:sldLayoutId xmlns:r="http://schemas.openxmlformats.org/officeDocument/2006/relationships" id="2147483654" r:id="R18e30b0016184991"/>
+    <p:sldLayoutId xmlns:r="http://schemas.openxmlformats.org/officeDocument/2006/relationships" id="2147483655" r:id="Ra80d7caaca624e9e"/>
+    <p:sldLayoutId xmlns:r="http://schemas.openxmlformats.org/officeDocument/2006/relationships" id="2147483656" r:id="R57098e92571a4439"/>
+    <p:sldLayoutId xmlns:r="http://schemas.openxmlformats.org/officeDocument/2006/relationships" id="2147483657" r:id="R15b1ff207d4b4fbd"/>
+    <p:sldLayoutId xmlns:r="http://schemas.openxmlformats.org/officeDocument/2006/relationships" id="2147483658" r:id="Rf9b3543ad5ce4db3"/>
+    <p:sldLayoutId xmlns:r="http://schemas.openxmlformats.org/officeDocument/2006/relationships" id="2147483659" r:id="Ra70a3edaea25473a"/>
   </p:sldLayoutIdLst>
   <p:txStyles>
     <p:titleStyle>
@@ -5113,7 +5113,7 @@
           <p:cNvPr id="2" name="Rectangle 1">
             <a:extLst xmlns:a="http://schemas.openxmlformats.org/drawingml/2006/main">
               <a:ext uri="{FF2B5EF4-FFF2-40B4-BE49-F238E27FC236}">
-                <a16:creationId xmlns:a16="http://schemas.microsoft.com/office/drawing/2014/main" id="{94972ECC-8D96-406E-BED3-FB8ECE91ED64}"/>
+                <a16:creationId xmlns:a16="http://schemas.microsoft.com/office/drawing/2014/main" id="{0886EE82-45A4-4983-9199-DEA0F3922C39}"/>
               </a:ext>
             </a:extLst>
           </p:cNvPr>
@@ -5166,7 +5166,7 @@
           <p:cNvPr id="3" name="Rectangle 2">
             <a:extLst xmlns:a="http://schemas.openxmlformats.org/drawingml/2006/main">
               <a:ext uri="{FF2B5EF4-FFF2-40B4-BE49-F238E27FC236}">
-                <a16:creationId xmlns:a16="http://schemas.microsoft.com/office/drawing/2014/main" id="{BB35CF75-8B12-4CDE-8337-5CF595E9FC5E}"/>
+                <a16:creationId xmlns:a16="http://schemas.microsoft.com/office/drawing/2014/main" id="{9FA28B9E-1103-44B1-86E6-9B916E78B498}"/>
               </a:ext>
             </a:extLst>
           </p:cNvPr>
@@ -5219,7 +5219,7 @@
           <p:cNvPr id="4" name="TextBox 3">
             <a:extLst xmlns:a="http://schemas.openxmlformats.org/drawingml/2006/main">
               <a:ext uri="{FF2B5EF4-FFF2-40B4-BE49-F238E27FC236}">
-                <a16:creationId xmlns:a16="http://schemas.microsoft.com/office/drawing/2014/main" id="{3729B42E-5DD1-4308-B591-8709666E68F5}"/>
+                <a16:creationId xmlns:a16="http://schemas.microsoft.com/office/drawing/2014/main" id="{5C8535DD-7299-40E5-BA3E-135A62ACD5A3}"/>
               </a:ext>
             </a:extLst>
           </p:cNvPr>
@@ -5321,7 +5321,7 @@
     </p:spTree>
     <p:extLst>
       <p:ext uri="{BB962C8B-B14F-4D97-AF65-F5344CB8AC3E}">
-        <p14:creationId xmlns:p14="http://schemas.microsoft.com/office/powerpoint/2010/main" val="1040924654"/>
+        <p14:creationId xmlns:p14="http://schemas.microsoft.com/office/powerpoint/2010/main" val="1462753312"/>
       </p:ext>
     </p:extLst>
   </p:cSld>
@@ -5345,7 +5345,7 @@
           <p:cNvPr id="2" name="Rectangle 1">
             <a:extLst xmlns:a="http://schemas.openxmlformats.org/drawingml/2006/main">
               <a:ext uri="{FF2B5EF4-FFF2-40B4-BE49-F238E27FC236}">
-                <a16:creationId xmlns:a16="http://schemas.microsoft.com/office/drawing/2014/main" id="{B8AC6599-E5B7-4FD7-BA3E-09EE362EA2EA}"/>
+                <a16:creationId xmlns:a16="http://schemas.microsoft.com/office/drawing/2014/main" id="{0F7C6F67-F026-48BF-85C0-E0D6EFB94D44}"/>
               </a:ext>
             </a:extLst>
           </p:cNvPr>
@@ -5398,7 +5398,7 @@
           <p:cNvPr id="3" name="Rectangle 2">
             <a:extLst xmlns:a="http://schemas.openxmlformats.org/drawingml/2006/main">
               <a:ext uri="{FF2B5EF4-FFF2-40B4-BE49-F238E27FC236}">
-                <a16:creationId xmlns:a16="http://schemas.microsoft.com/office/drawing/2014/main" id="{C8D149B4-7478-4029-94ED-0D34DCA7F019}"/>
+                <a16:creationId xmlns:a16="http://schemas.microsoft.com/office/drawing/2014/main" id="{57328AED-BFC4-40EE-A461-D4411B947D75}"/>
               </a:ext>
             </a:extLst>
           </p:cNvPr>
@@ -5451,7 +5451,7 @@
           <p:cNvPr id="4" name="Rectangle 3">
             <a:extLst xmlns:a="http://schemas.openxmlformats.org/drawingml/2006/main">
               <a:ext uri="{FF2B5EF4-FFF2-40B4-BE49-F238E27FC236}">
-                <a16:creationId xmlns:a16="http://schemas.microsoft.com/office/drawing/2014/main" id="{3094C26B-D363-4C53-A77E-EF8220A68ED6}"/>
+                <a16:creationId xmlns:a16="http://schemas.microsoft.com/office/drawing/2014/main" id="{BD342EF1-98D4-457E-8742-ADF0861CF133}"/>
               </a:ext>
             </a:extLst>
           </p:cNvPr>
@@ -5504,7 +5504,7 @@
           <p:cNvPr id="5" name="TextBox 4">
             <a:extLst xmlns:a="http://schemas.openxmlformats.org/drawingml/2006/main">
               <a:ext uri="{FF2B5EF4-FFF2-40B4-BE49-F238E27FC236}">
-                <a16:creationId xmlns:a16="http://schemas.microsoft.com/office/drawing/2014/main" id="{0ED3F2B2-1F8C-4713-AC91-02CFACE070F1}"/>
+                <a16:creationId xmlns:a16="http://schemas.microsoft.com/office/drawing/2014/main" id="{965B098A-0C59-4895-AA4E-F423A4913B83}"/>
               </a:ext>
             </a:extLst>
           </p:cNvPr>
@@ -5567,7 +5567,7 @@
           <p:cNvPr id="6" name="Rounded Rectangle 5">
             <a:extLst xmlns:a="http://schemas.openxmlformats.org/drawingml/2006/main">
               <a:ext uri="{FF2B5EF4-FFF2-40B4-BE49-F238E27FC236}">
-                <a16:creationId xmlns:a16="http://schemas.microsoft.com/office/drawing/2014/main" id="{53407F08-30B5-442E-AA74-F11C69A8FA2F}"/>
+                <a16:creationId xmlns:a16="http://schemas.microsoft.com/office/drawing/2014/main" id="{FB86FB8E-F6E2-4E8D-931B-DFFC39E70A6C}"/>
               </a:ext>
             </a:extLst>
           </p:cNvPr>
@@ -5622,7 +5622,7 @@
           <p:cNvPr id="7" name="TextBox 6">
             <a:extLst xmlns:a="http://schemas.openxmlformats.org/drawingml/2006/main">
               <a:ext uri="{FF2B5EF4-FFF2-40B4-BE49-F238E27FC236}">
-                <a16:creationId xmlns:a16="http://schemas.microsoft.com/office/drawing/2014/main" id="{7518102F-8B9E-452F-8958-6117535998FD}"/>
+                <a16:creationId xmlns:a16="http://schemas.microsoft.com/office/drawing/2014/main" id="{B23A4352-DE02-47BF-AC7B-E0281C48ED3E}"/>
               </a:ext>
             </a:extLst>
           </p:cNvPr>
@@ -5726,7 +5726,7 @@
           <p:cNvPr id="8" name="Rounded Rectangle 7">
             <a:extLst xmlns:a="http://schemas.openxmlformats.org/drawingml/2006/main">
               <a:ext uri="{FF2B5EF4-FFF2-40B4-BE49-F238E27FC236}">
-                <a16:creationId xmlns:a16="http://schemas.microsoft.com/office/drawing/2014/main" id="{8F4D4A30-88DD-42F7-87C5-59805DBA0117}"/>
+                <a16:creationId xmlns:a16="http://schemas.microsoft.com/office/drawing/2014/main" id="{A541F922-8E7D-46DE-BD13-62DD8AFCCC6B}"/>
               </a:ext>
             </a:extLst>
           </p:cNvPr>
@@ -5781,7 +5781,7 @@
           <p:cNvPr id="9" name="TextBox 8">
             <a:extLst xmlns:a="http://schemas.openxmlformats.org/drawingml/2006/main">
               <a:ext uri="{FF2B5EF4-FFF2-40B4-BE49-F238E27FC236}">
-                <a16:creationId xmlns:a16="http://schemas.microsoft.com/office/drawing/2014/main" id="{0A9DAE0F-F635-4354-BB45-D29E1A812089}"/>
+                <a16:creationId xmlns:a16="http://schemas.microsoft.com/office/drawing/2014/main" id="{C4FD11EC-B03C-49DB-BAFE-06045288FF04}"/>
               </a:ext>
             </a:extLst>
           </p:cNvPr>
@@ -5866,7 +5866,7 @@
           <p:cNvPr id="10" name="Rounded Rectangle 9">
             <a:extLst xmlns:a="http://schemas.openxmlformats.org/drawingml/2006/main">
               <a:ext uri="{FF2B5EF4-FFF2-40B4-BE49-F238E27FC236}">
-                <a16:creationId xmlns:a16="http://schemas.microsoft.com/office/drawing/2014/main" id="{16F0156A-8DE7-4165-BD62-6FA87FF6F485}"/>
+                <a16:creationId xmlns:a16="http://schemas.microsoft.com/office/drawing/2014/main" id="{07546CD6-432F-4412-95BE-23ACA418ED11}"/>
               </a:ext>
             </a:extLst>
           </p:cNvPr>
@@ -5921,7 +5921,7 @@
           <p:cNvPr id="11" name="TextBox 10">
             <a:extLst xmlns:a="http://schemas.openxmlformats.org/drawingml/2006/main">
               <a:ext uri="{FF2B5EF4-FFF2-40B4-BE49-F238E27FC236}">
-                <a16:creationId xmlns:a16="http://schemas.microsoft.com/office/drawing/2014/main" id="{A0D62AAD-3AF5-4B2C-ACBE-F16C98B0D304}"/>
+                <a16:creationId xmlns:a16="http://schemas.microsoft.com/office/drawing/2014/main" id="{4646304A-F943-4239-982D-364747E1A23A}"/>
               </a:ext>
             </a:extLst>
           </p:cNvPr>
@@ -6023,7 +6023,7 @@
     </p:spTree>
     <p:extLst>
       <p:ext uri="{BB962C8B-B14F-4D97-AF65-F5344CB8AC3E}">
-        <p14:creationId xmlns:p14="http://schemas.microsoft.com/office/powerpoint/2010/main" val="334609424"/>
+        <p14:creationId xmlns:p14="http://schemas.microsoft.com/office/powerpoint/2010/main" val="651667508"/>
       </p:ext>
     </p:extLst>
   </p:cSld>
@@ -6047,7 +6047,7 @@
           <p:cNvPr id="2" name="Rectangle 1">
             <a:extLst xmlns:a="http://schemas.openxmlformats.org/drawingml/2006/main">
               <a:ext uri="{FF2B5EF4-FFF2-40B4-BE49-F238E27FC236}">
-                <a16:creationId xmlns:a16="http://schemas.microsoft.com/office/drawing/2014/main" id="{E8244384-05F1-4975-B622-1D031A166322}"/>
+                <a16:creationId xmlns:a16="http://schemas.microsoft.com/office/drawing/2014/main" id="{1C130BB4-F69F-4BCD-8319-FFFA9E1B5CF2}"/>
               </a:ext>
             </a:extLst>
           </p:cNvPr>
@@ -6100,7 +6100,7 @@
           <p:cNvPr id="3" name="Rectangle 2">
             <a:extLst xmlns:a="http://schemas.openxmlformats.org/drawingml/2006/main">
               <a:ext uri="{FF2B5EF4-FFF2-40B4-BE49-F238E27FC236}">
-                <a16:creationId xmlns:a16="http://schemas.microsoft.com/office/drawing/2014/main" id="{A8CF2814-ED9B-4EE3-A9D6-F0E4A2849FEA}"/>
+                <a16:creationId xmlns:a16="http://schemas.microsoft.com/office/drawing/2014/main" id="{5E6AEA8B-AB2D-4266-BC97-59F985F741D6}"/>
               </a:ext>
             </a:extLst>
           </p:cNvPr>
@@ -6153,7 +6153,7 @@
           <p:cNvPr id="4" name="Rectangle 3">
             <a:extLst xmlns:a="http://schemas.openxmlformats.org/drawingml/2006/main">
               <a:ext uri="{FF2B5EF4-FFF2-40B4-BE49-F238E27FC236}">
-                <a16:creationId xmlns:a16="http://schemas.microsoft.com/office/drawing/2014/main" id="{B77B1164-EFB4-4603-A14B-285FE2DAA0ED}"/>
+                <a16:creationId xmlns:a16="http://schemas.microsoft.com/office/drawing/2014/main" id="{792E7680-FBDC-4D35-A901-7648E31FF190}"/>
               </a:ext>
             </a:extLst>
           </p:cNvPr>
@@ -6206,7 +6206,7 @@
           <p:cNvPr id="5" name="TextBox 4">
             <a:extLst xmlns:a="http://schemas.openxmlformats.org/drawingml/2006/main">
               <a:ext uri="{FF2B5EF4-FFF2-40B4-BE49-F238E27FC236}">
-                <a16:creationId xmlns:a16="http://schemas.microsoft.com/office/drawing/2014/main" id="{EA8BF427-F8A6-4F83-9696-C62605B06E31}"/>
+                <a16:creationId xmlns:a16="http://schemas.microsoft.com/office/drawing/2014/main" id="{08C4DB09-E621-4AC8-9934-DE93766AF057}"/>
               </a:ext>
             </a:extLst>
           </p:cNvPr>
@@ -6269,7 +6269,7 @@
           <p:cNvPr id="6" name="Rounded Rectangle 5">
             <a:extLst xmlns:a="http://schemas.openxmlformats.org/drawingml/2006/main">
               <a:ext uri="{FF2B5EF4-FFF2-40B4-BE49-F238E27FC236}">
-                <a16:creationId xmlns:a16="http://schemas.microsoft.com/office/drawing/2014/main" id="{FBB352AE-72F0-4124-AA94-597EF827B0A5}"/>
+                <a16:creationId xmlns:a16="http://schemas.microsoft.com/office/drawing/2014/main" id="{FED1B884-02E8-4292-B797-2546813E6940}"/>
               </a:ext>
             </a:extLst>
           </p:cNvPr>
@@ -6324,7 +6324,7 @@
           <p:cNvPr id="7" name="TextBox 6">
             <a:extLst xmlns:a="http://schemas.openxmlformats.org/drawingml/2006/main">
               <a:ext uri="{FF2B5EF4-FFF2-40B4-BE49-F238E27FC236}">
-                <a16:creationId xmlns:a16="http://schemas.microsoft.com/office/drawing/2014/main" id="{35525C99-6E69-46DC-BFAB-1C465A3702BD}"/>
+                <a16:creationId xmlns:a16="http://schemas.microsoft.com/office/drawing/2014/main" id="{8F282CFE-C974-4F83-9F15-8F5AFAA3C21B}"/>
               </a:ext>
             </a:extLst>
           </p:cNvPr>
@@ -6523,7 +6523,7 @@
           <p:cNvPr id="8" name="Rounded Rectangle 7">
             <a:extLst xmlns:a="http://schemas.openxmlformats.org/drawingml/2006/main">
               <a:ext uri="{FF2B5EF4-FFF2-40B4-BE49-F238E27FC236}">
-                <a16:creationId xmlns:a16="http://schemas.microsoft.com/office/drawing/2014/main" id="{E9D5F3A6-0510-436B-A7D0-F5CC9589E47F}"/>
+                <a16:creationId xmlns:a16="http://schemas.microsoft.com/office/drawing/2014/main" id="{2DDD0174-2FCA-419F-ACA5-25619BA166F4}"/>
               </a:ext>
             </a:extLst>
           </p:cNvPr>
@@ -6578,7 +6578,7 @@
           <p:cNvPr id="9" name="TextBox 8">
             <a:extLst xmlns:a="http://schemas.openxmlformats.org/drawingml/2006/main">
               <a:ext uri="{FF2B5EF4-FFF2-40B4-BE49-F238E27FC236}">
-                <a16:creationId xmlns:a16="http://schemas.microsoft.com/office/drawing/2014/main" id="{17E2FB62-4FBB-432C-9D63-2040E107228D}"/>
+                <a16:creationId xmlns:a16="http://schemas.microsoft.com/office/drawing/2014/main" id="{72A72586-FDE7-4393-88B8-2900FC0AF9FE}"/>
               </a:ext>
             </a:extLst>
           </p:cNvPr>
@@ -6699,7 +6699,7 @@
     </p:spTree>
     <p:extLst>
       <p:ext uri="{BB962C8B-B14F-4D97-AF65-F5344CB8AC3E}">
-        <p14:creationId xmlns:p14="http://schemas.microsoft.com/office/powerpoint/2010/main" val="1240471476"/>
+        <p14:creationId xmlns:p14="http://schemas.microsoft.com/office/powerpoint/2010/main" val="1020488870"/>
       </p:ext>
     </p:extLst>
   </p:cSld>
@@ -6723,7 +6723,7 @@
           <p:cNvPr id="2" name="Rectangle 1">
             <a:extLst xmlns:a="http://schemas.openxmlformats.org/drawingml/2006/main">
               <a:ext uri="{FF2B5EF4-FFF2-40B4-BE49-F238E27FC236}">
-                <a16:creationId xmlns:a16="http://schemas.microsoft.com/office/drawing/2014/main" id="{C84309B3-21C6-428C-B2F0-8A0D7E535FE1}"/>
+                <a16:creationId xmlns:a16="http://schemas.microsoft.com/office/drawing/2014/main" id="{71E90448-25A4-48B7-9526-10752A977EB0}"/>
               </a:ext>
             </a:extLst>
           </p:cNvPr>
@@ -6776,7 +6776,7 @@
           <p:cNvPr id="3" name="Rectangle 2">
             <a:extLst xmlns:a="http://schemas.openxmlformats.org/drawingml/2006/main">
               <a:ext uri="{FF2B5EF4-FFF2-40B4-BE49-F238E27FC236}">
-                <a16:creationId xmlns:a16="http://schemas.microsoft.com/office/drawing/2014/main" id="{B79332A0-CABF-4F1B-B4C8-C0FEE56B690A}"/>
+                <a16:creationId xmlns:a16="http://schemas.microsoft.com/office/drawing/2014/main" id="{4132F63D-F31C-4361-8877-991AE6884583}"/>
               </a:ext>
             </a:extLst>
           </p:cNvPr>
@@ -6829,7 +6829,7 @@
           <p:cNvPr id="4" name="TextBox 3">
             <a:extLst xmlns:a="http://schemas.openxmlformats.org/drawingml/2006/main">
               <a:ext uri="{FF2B5EF4-FFF2-40B4-BE49-F238E27FC236}">
-                <a16:creationId xmlns:a16="http://schemas.microsoft.com/office/drawing/2014/main" id="{E9A65058-E323-487D-B60B-8C4BC6F47BEB}"/>
+                <a16:creationId xmlns:a16="http://schemas.microsoft.com/office/drawing/2014/main" id="{0551C22C-55A8-42F7-9140-EB097709574E}"/>
               </a:ext>
             </a:extLst>
           </p:cNvPr>
@@ -7007,7 +7007,7 @@
     </p:spTree>
     <p:extLst>
       <p:ext uri="{BB962C8B-B14F-4D97-AF65-F5344CB8AC3E}">
-        <p14:creationId xmlns:p14="http://schemas.microsoft.com/office/powerpoint/2010/main" val="777851880"/>
+        <p14:creationId xmlns:p14="http://schemas.microsoft.com/office/powerpoint/2010/main" val="78089277"/>
       </p:ext>
     </p:extLst>
   </p:cSld>
@@ -7031,7 +7031,7 @@
           <p:cNvPr id="2" name="Rectangle 1">
             <a:extLst xmlns:a="http://schemas.openxmlformats.org/drawingml/2006/main">
               <a:ext uri="{FF2B5EF4-FFF2-40B4-BE49-F238E27FC236}">
-                <a16:creationId xmlns:a16="http://schemas.microsoft.com/office/drawing/2014/main" id="{7412DFA1-2765-42BE-B778-76F6FAF4229E}"/>
+                <a16:creationId xmlns:a16="http://schemas.microsoft.com/office/drawing/2014/main" id="{9B0CA5D7-542C-4DE9-B31F-B8E6083EF97E}"/>
               </a:ext>
             </a:extLst>
           </p:cNvPr>
@@ -7084,7 +7084,7 @@
           <p:cNvPr id="3" name="Rectangle 2">
             <a:extLst xmlns:a="http://schemas.openxmlformats.org/drawingml/2006/main">
               <a:ext uri="{FF2B5EF4-FFF2-40B4-BE49-F238E27FC236}">
-                <a16:creationId xmlns:a16="http://schemas.microsoft.com/office/drawing/2014/main" id="{617DBD47-4D8E-49E1-B399-CFADD7B131EA}"/>
+                <a16:creationId xmlns:a16="http://schemas.microsoft.com/office/drawing/2014/main" id="{261E1C52-E9FC-4421-B317-1A3F5B4FC275}"/>
               </a:ext>
             </a:extLst>
           </p:cNvPr>
@@ -7137,7 +7137,7 @@
           <p:cNvPr id="4" name="Rectangle 3">
             <a:extLst xmlns:a="http://schemas.openxmlformats.org/drawingml/2006/main">
               <a:ext uri="{FF2B5EF4-FFF2-40B4-BE49-F238E27FC236}">
-                <a16:creationId xmlns:a16="http://schemas.microsoft.com/office/drawing/2014/main" id="{FA0876B4-ED19-4725-B157-CFBBDCB5EC99}"/>
+                <a16:creationId xmlns:a16="http://schemas.microsoft.com/office/drawing/2014/main" id="{9847C858-56D2-46F3-B933-917AFF6915A7}"/>
               </a:ext>
             </a:extLst>
           </p:cNvPr>
@@ -7190,7 +7190,7 @@
           <p:cNvPr id="5" name="TextBox 4">
             <a:extLst xmlns:a="http://schemas.openxmlformats.org/drawingml/2006/main">
               <a:ext uri="{FF2B5EF4-FFF2-40B4-BE49-F238E27FC236}">
-                <a16:creationId xmlns:a16="http://schemas.microsoft.com/office/drawing/2014/main" id="{342FFDE2-9CE1-4F0B-A532-E73124F594B2}"/>
+                <a16:creationId xmlns:a16="http://schemas.microsoft.com/office/drawing/2014/main" id="{FEFAF48C-D2C0-4A31-AD0C-24EC7FA1EA43}"/>
               </a:ext>
             </a:extLst>
           </p:cNvPr>
@@ -7253,7 +7253,7 @@
           <p:cNvPr id="6" name="Rounded Rectangle 5">
             <a:extLst xmlns:a="http://schemas.openxmlformats.org/drawingml/2006/main">
               <a:ext uri="{FF2B5EF4-FFF2-40B4-BE49-F238E27FC236}">
-                <a16:creationId xmlns:a16="http://schemas.microsoft.com/office/drawing/2014/main" id="{BEBADB18-E2ED-4395-A54D-3D1B4029022C}"/>
+                <a16:creationId xmlns:a16="http://schemas.microsoft.com/office/drawing/2014/main" id="{EFA569F6-0560-462B-8B51-0D91C4CCFF2D}"/>
               </a:ext>
             </a:extLst>
           </p:cNvPr>
@@ -7308,7 +7308,7 @@
           <p:cNvPr id="7" name="TextBox 6">
             <a:extLst xmlns:a="http://schemas.openxmlformats.org/drawingml/2006/main">
               <a:ext uri="{FF2B5EF4-FFF2-40B4-BE49-F238E27FC236}">
-                <a16:creationId xmlns:a16="http://schemas.microsoft.com/office/drawing/2014/main" id="{797D58D4-F880-4AAE-B2A4-66F1FB6BC030}"/>
+                <a16:creationId xmlns:a16="http://schemas.microsoft.com/office/drawing/2014/main" id="{6CEBAF5B-B908-42ED-B317-96975C612BE7}"/>
               </a:ext>
             </a:extLst>
           </p:cNvPr>
@@ -7412,7 +7412,7 @@
           <p:cNvPr id="8" name="Rounded Rectangle 7">
             <a:extLst xmlns:a="http://schemas.openxmlformats.org/drawingml/2006/main">
               <a:ext uri="{FF2B5EF4-FFF2-40B4-BE49-F238E27FC236}">
-                <a16:creationId xmlns:a16="http://schemas.microsoft.com/office/drawing/2014/main" id="{6B8A4CE7-F612-4A21-BEA7-9237D6E15ACF}"/>
+                <a16:creationId xmlns:a16="http://schemas.microsoft.com/office/drawing/2014/main" id="{9B95DAB5-B861-456C-9191-1CF4CE41A445}"/>
               </a:ext>
             </a:extLst>
           </p:cNvPr>
@@ -7467,7 +7467,7 @@
           <p:cNvPr id="9" name="TextBox 8">
             <a:extLst xmlns:a="http://schemas.openxmlformats.org/drawingml/2006/main">
               <a:ext uri="{FF2B5EF4-FFF2-40B4-BE49-F238E27FC236}">
-                <a16:creationId xmlns:a16="http://schemas.microsoft.com/office/drawing/2014/main" id="{32D6D046-A3AD-4C17-969D-E48C6F25E07D}"/>
+                <a16:creationId xmlns:a16="http://schemas.microsoft.com/office/drawing/2014/main" id="{7764FBC2-7457-463F-AACC-F06CA354FCD2}"/>
               </a:ext>
             </a:extLst>
           </p:cNvPr>
@@ -7571,7 +7571,7 @@
           <p:cNvPr id="10" name="Rounded Rectangle 9">
             <a:extLst xmlns:a="http://schemas.openxmlformats.org/drawingml/2006/main">
               <a:ext uri="{FF2B5EF4-FFF2-40B4-BE49-F238E27FC236}">
-                <a16:creationId xmlns:a16="http://schemas.microsoft.com/office/drawing/2014/main" id="{BA5A05FB-1315-405C-B265-D0CE85F471BC}"/>
+                <a16:creationId xmlns:a16="http://schemas.microsoft.com/office/drawing/2014/main" id="{C6816087-BDF2-4F21-A57E-E037F3CF7C2C}"/>
               </a:ext>
             </a:extLst>
           </p:cNvPr>
@@ -7626,7 +7626,7 @@
           <p:cNvPr id="11" name="TextBox 10">
             <a:extLst xmlns:a="http://schemas.openxmlformats.org/drawingml/2006/main">
               <a:ext uri="{FF2B5EF4-FFF2-40B4-BE49-F238E27FC236}">
-                <a16:creationId xmlns:a16="http://schemas.microsoft.com/office/drawing/2014/main" id="{80901F30-1C1E-4067-9C78-16C4BBF0B362}"/>
+                <a16:creationId xmlns:a16="http://schemas.microsoft.com/office/drawing/2014/main" id="{42C9D95D-4CED-44CC-B549-1317DF3E9332}"/>
               </a:ext>
             </a:extLst>
           </p:cNvPr>
@@ -7785,7 +7785,7 @@
     </p:spTree>
     <p:extLst>
       <p:ext uri="{BB962C8B-B14F-4D97-AF65-F5344CB8AC3E}">
-        <p14:creationId xmlns:p14="http://schemas.microsoft.com/office/powerpoint/2010/main" val="2017526600"/>
+        <p14:creationId xmlns:p14="http://schemas.microsoft.com/office/powerpoint/2010/main" val="908138734"/>
       </p:ext>
     </p:extLst>
   </p:cSld>
@@ -7809,7 +7809,7 @@
           <p:cNvPr id="2" name="Rectangle 1">
             <a:extLst xmlns:a="http://schemas.openxmlformats.org/drawingml/2006/main">
               <a:ext uri="{FF2B5EF4-FFF2-40B4-BE49-F238E27FC236}">
-                <a16:creationId xmlns:a16="http://schemas.microsoft.com/office/drawing/2014/main" id="{92EBECC1-1305-45F7-8A67-F734D99B0E85}"/>
+                <a16:creationId xmlns:a16="http://schemas.microsoft.com/office/drawing/2014/main" id="{36F863D4-C879-45E8-A26C-9ADB32967F2B}"/>
               </a:ext>
             </a:extLst>
           </p:cNvPr>
@@ -7862,7 +7862,7 @@
           <p:cNvPr id="3" name="Rectangle 2">
             <a:extLst xmlns:a="http://schemas.openxmlformats.org/drawingml/2006/main">
               <a:ext uri="{FF2B5EF4-FFF2-40B4-BE49-F238E27FC236}">
-                <a16:creationId xmlns:a16="http://schemas.microsoft.com/office/drawing/2014/main" id="{49A2C0FA-2F35-485C-9C7A-0FEA76102593}"/>
+                <a16:creationId xmlns:a16="http://schemas.microsoft.com/office/drawing/2014/main" id="{50940F33-4910-4C63-9143-D1E48EE2A6DD}"/>
               </a:ext>
             </a:extLst>
           </p:cNvPr>
@@ -7915,7 +7915,7 @@
           <p:cNvPr id="4" name="Rectangle 3">
             <a:extLst xmlns:a="http://schemas.openxmlformats.org/drawingml/2006/main">
               <a:ext uri="{FF2B5EF4-FFF2-40B4-BE49-F238E27FC236}">
-                <a16:creationId xmlns:a16="http://schemas.microsoft.com/office/drawing/2014/main" id="{A800C05A-3B21-4C23-B6EB-C2438EEC7C66}"/>
+                <a16:creationId xmlns:a16="http://schemas.microsoft.com/office/drawing/2014/main" id="{389DA64B-74C6-42F8-B4EA-E0C496262A04}"/>
               </a:ext>
             </a:extLst>
           </p:cNvPr>
@@ -7968,7 +7968,7 @@
           <p:cNvPr id="5" name="TextBox 4">
             <a:extLst xmlns:a="http://schemas.openxmlformats.org/drawingml/2006/main">
               <a:ext uri="{FF2B5EF4-FFF2-40B4-BE49-F238E27FC236}">
-                <a16:creationId xmlns:a16="http://schemas.microsoft.com/office/drawing/2014/main" id="{112D0555-8BF7-4639-B4CA-F5F7B2FB4F4D}"/>
+                <a16:creationId xmlns:a16="http://schemas.microsoft.com/office/drawing/2014/main" id="{CCF7597C-CFCA-498E-AAFB-649975E930FB}"/>
               </a:ext>
             </a:extLst>
           </p:cNvPr>
@@ -8031,7 +8031,7 @@
           <p:cNvPr id="6" name="Rounded Rectangle 5">
             <a:extLst xmlns:a="http://schemas.openxmlformats.org/drawingml/2006/main">
               <a:ext uri="{FF2B5EF4-FFF2-40B4-BE49-F238E27FC236}">
-                <a16:creationId xmlns:a16="http://schemas.microsoft.com/office/drawing/2014/main" id="{7A5FF4B0-1AB1-4F36-ACED-8BCD68E03B3A}"/>
+                <a16:creationId xmlns:a16="http://schemas.microsoft.com/office/drawing/2014/main" id="{F99E2600-1CF6-465C-92B3-0BEACFE09C30}"/>
               </a:ext>
             </a:extLst>
           </p:cNvPr>
@@ -8086,7 +8086,7 @@
           <p:cNvPr id="7" name="TextBox 6">
             <a:extLst xmlns:a="http://schemas.openxmlformats.org/drawingml/2006/main">
               <a:ext uri="{FF2B5EF4-FFF2-40B4-BE49-F238E27FC236}">
-                <a16:creationId xmlns:a16="http://schemas.microsoft.com/office/drawing/2014/main" id="{C28F3628-706D-40F5-AACA-ED6F8147BBB6}"/>
+                <a16:creationId xmlns:a16="http://schemas.microsoft.com/office/drawing/2014/main" id="{7929731E-C196-44E0-B99A-CED8611AC1DB}"/>
               </a:ext>
             </a:extLst>
           </p:cNvPr>
@@ -8209,7 +8209,7 @@
           <p:cNvPr id="8" name="Rounded Rectangle 7">
             <a:extLst xmlns:a="http://schemas.openxmlformats.org/drawingml/2006/main">
               <a:ext uri="{FF2B5EF4-FFF2-40B4-BE49-F238E27FC236}">
-                <a16:creationId xmlns:a16="http://schemas.microsoft.com/office/drawing/2014/main" id="{D5609893-B18A-40E5-B825-C7748D0CCABC}"/>
+                <a16:creationId xmlns:a16="http://schemas.microsoft.com/office/drawing/2014/main" id="{7C128377-81AE-4819-B822-94821A26ADAB}"/>
               </a:ext>
             </a:extLst>
           </p:cNvPr>
@@ -8264,7 +8264,7 @@
           <p:cNvPr id="9" name="TextBox 8">
             <a:extLst xmlns:a="http://schemas.openxmlformats.org/drawingml/2006/main">
               <a:ext uri="{FF2B5EF4-FFF2-40B4-BE49-F238E27FC236}">
-                <a16:creationId xmlns:a16="http://schemas.microsoft.com/office/drawing/2014/main" id="{AF5CD5D7-8F1C-4610-B35F-2A3FDCEA2466}"/>
+                <a16:creationId xmlns:a16="http://schemas.microsoft.com/office/drawing/2014/main" id="{66936259-03EE-4B6B-9EC9-46BA8C30ABF3}"/>
               </a:ext>
             </a:extLst>
           </p:cNvPr>
@@ -8406,7 +8406,7 @@
           <p:cNvPr id="10" name="Rounded Rectangle 9">
             <a:extLst xmlns:a="http://schemas.openxmlformats.org/drawingml/2006/main">
               <a:ext uri="{FF2B5EF4-FFF2-40B4-BE49-F238E27FC236}">
-                <a16:creationId xmlns:a16="http://schemas.microsoft.com/office/drawing/2014/main" id="{513E4049-9C43-4D8F-A34C-57CA49E3A415}"/>
+                <a16:creationId xmlns:a16="http://schemas.microsoft.com/office/drawing/2014/main" id="{8DA943F2-E6A9-419A-839B-AC964C90D5A3}"/>
               </a:ext>
             </a:extLst>
           </p:cNvPr>
@@ -8461,7 +8461,7 @@
           <p:cNvPr id="11" name="TextBox 10">
             <a:extLst xmlns:a="http://schemas.openxmlformats.org/drawingml/2006/main">
               <a:ext uri="{FF2B5EF4-FFF2-40B4-BE49-F238E27FC236}">
-                <a16:creationId xmlns:a16="http://schemas.microsoft.com/office/drawing/2014/main" id="{A687FE67-C1B6-479D-B42D-C9F50423A371}"/>
+                <a16:creationId xmlns:a16="http://schemas.microsoft.com/office/drawing/2014/main" id="{DA51AFFD-D581-45AD-B975-C26DC64FE978}"/>
               </a:ext>
             </a:extLst>
           </p:cNvPr>
@@ -8563,7 +8563,7 @@
     </p:spTree>
     <p:extLst>
       <p:ext uri="{BB962C8B-B14F-4D97-AF65-F5344CB8AC3E}">
-        <p14:creationId xmlns:p14="http://schemas.microsoft.com/office/powerpoint/2010/main" val="990035450"/>
+        <p14:creationId xmlns:p14="http://schemas.microsoft.com/office/powerpoint/2010/main" val="556164992"/>
       </p:ext>
     </p:extLst>
   </p:cSld>
@@ -8587,7 +8587,7 @@
           <p:cNvPr id="2" name="Rectangle 1">
             <a:extLst xmlns:a="http://schemas.openxmlformats.org/drawingml/2006/main">
               <a:ext uri="{FF2B5EF4-FFF2-40B4-BE49-F238E27FC236}">
-                <a16:creationId xmlns:a16="http://schemas.microsoft.com/office/drawing/2014/main" id="{A7D39DC6-CD41-454E-9BEC-AF8D9FE2FC81}"/>
+                <a16:creationId xmlns:a16="http://schemas.microsoft.com/office/drawing/2014/main" id="{9E6A76FA-B6BA-4E7C-AEB8-41431552F376}"/>
               </a:ext>
             </a:extLst>
           </p:cNvPr>
@@ -8640,7 +8640,7 @@
           <p:cNvPr id="3" name="Rectangle 2">
             <a:extLst xmlns:a="http://schemas.openxmlformats.org/drawingml/2006/main">
               <a:ext uri="{FF2B5EF4-FFF2-40B4-BE49-F238E27FC236}">
-                <a16:creationId xmlns:a16="http://schemas.microsoft.com/office/drawing/2014/main" id="{97C022F7-68C0-4C3B-8DA0-5E6F772FD996}"/>
+                <a16:creationId xmlns:a16="http://schemas.microsoft.com/office/drawing/2014/main" id="{3AD748B8-C1FA-474C-9CE2-426170100853}"/>
               </a:ext>
             </a:extLst>
           </p:cNvPr>
@@ -8693,7 +8693,7 @@
           <p:cNvPr id="4" name="Rectangle 3">
             <a:extLst xmlns:a="http://schemas.openxmlformats.org/drawingml/2006/main">
               <a:ext uri="{FF2B5EF4-FFF2-40B4-BE49-F238E27FC236}">
-                <a16:creationId xmlns:a16="http://schemas.microsoft.com/office/drawing/2014/main" id="{63378BAC-19BE-4EA6-8AFF-4D2426329497}"/>
+                <a16:creationId xmlns:a16="http://schemas.microsoft.com/office/drawing/2014/main" id="{A9F6AA5D-FEA9-4D94-BEAD-AF604F6C9657}"/>
               </a:ext>
             </a:extLst>
           </p:cNvPr>
@@ -8746,7 +8746,7 @@
           <p:cNvPr id="5" name="TextBox 4">
             <a:extLst xmlns:a="http://schemas.openxmlformats.org/drawingml/2006/main">
               <a:ext uri="{FF2B5EF4-FFF2-40B4-BE49-F238E27FC236}">
-                <a16:creationId xmlns:a16="http://schemas.microsoft.com/office/drawing/2014/main" id="{4549EF94-BE02-4F98-9206-DF20C3FB40C9}"/>
+                <a16:creationId xmlns:a16="http://schemas.microsoft.com/office/drawing/2014/main" id="{2624F681-48BD-4940-9D70-29BD71AB0B72}"/>
               </a:ext>
             </a:extLst>
           </p:cNvPr>
@@ -8809,7 +8809,7 @@
           <p:cNvPr id="6" name="Rounded Rectangle 5">
             <a:extLst xmlns:a="http://schemas.openxmlformats.org/drawingml/2006/main">
               <a:ext uri="{FF2B5EF4-FFF2-40B4-BE49-F238E27FC236}">
-                <a16:creationId xmlns:a16="http://schemas.microsoft.com/office/drawing/2014/main" id="{97C32DA3-A5ED-4DE2-90CB-7B3B3AE43B41}"/>
+                <a16:creationId xmlns:a16="http://schemas.microsoft.com/office/drawing/2014/main" id="{99CCBC80-400A-4AB4-80DB-2D311E0393E8}"/>
               </a:ext>
             </a:extLst>
           </p:cNvPr>
@@ -8864,7 +8864,7 @@
           <p:cNvPr id="7" name="TextBox 6">
             <a:extLst xmlns:a="http://schemas.openxmlformats.org/drawingml/2006/main">
               <a:ext uri="{FF2B5EF4-FFF2-40B4-BE49-F238E27FC236}">
-                <a16:creationId xmlns:a16="http://schemas.microsoft.com/office/drawing/2014/main" id="{73C751E1-D1DF-4777-B20E-D607340C5866}"/>
+                <a16:creationId xmlns:a16="http://schemas.microsoft.com/office/drawing/2014/main" id="{FC511546-7E5B-4AF3-AA57-E962C744E3D0}"/>
               </a:ext>
             </a:extLst>
           </p:cNvPr>
@@ -8939,7 +8939,7 @@
               </a:defRPr>
             </a:pPr>
             <a:r>
-              <a:t>•  Phân chia tập: 1,280 TEST views và 60 DEV views.</a:t>
+              <a:t>•  Phân chia tập: 1,280 TEST views (718 scorable views across 440 distinct clusters) và 60 DEV views.</a:t>
             </a:r>
           </a:p>
           <a:p xmlns:a="http://schemas.openxmlformats.org/drawingml/2006/main">
@@ -9034,7 +9034,7 @@
               </a:defRPr>
             </a:pPr>
             <a:r>
-              <a:t>•  Toàn vẹn mật mã: Khóa bằng SHA-256 trong canonical_experiment_lock_v1.json.</a:t>
+              <a:t>•  Toàn vẹn mật mã: Khóa SHA-256 trong lock v1 | Cohort pairs: 278 complete pairs, 162 contextual-only pairs, 200 neither-mapped pairs.</a:t>
             </a:r>
           </a:p>
         </p:txBody>
@@ -9044,7 +9044,7 @@
           <p:cNvPr id="8" name="Rounded Rectangle 7">
             <a:extLst xmlns:a="http://schemas.openxmlformats.org/drawingml/2006/main">
               <a:ext uri="{FF2B5EF4-FFF2-40B4-BE49-F238E27FC236}">
-                <a16:creationId xmlns:a16="http://schemas.microsoft.com/office/drawing/2014/main" id="{41C8E3EC-D5BE-4248-99E6-A502E3EDD81E}"/>
+                <a16:creationId xmlns:a16="http://schemas.microsoft.com/office/drawing/2014/main" id="{5936EB77-E85A-44D3-A083-717DD3E1D29F}"/>
               </a:ext>
             </a:extLst>
           </p:cNvPr>
@@ -9099,7 +9099,7 @@
           <p:cNvPr id="9" name="TextBox 8">
             <a:extLst xmlns:a="http://schemas.openxmlformats.org/drawingml/2006/main">
               <a:ext uri="{FF2B5EF4-FFF2-40B4-BE49-F238E27FC236}">
-                <a16:creationId xmlns:a16="http://schemas.microsoft.com/office/drawing/2014/main" id="{C16C67CE-0EF3-4624-B782-D7FBB137FFF1}"/>
+                <a16:creationId xmlns:a16="http://schemas.microsoft.com/office/drawing/2014/main" id="{A23E3B05-580A-406C-A89F-830CAC5D6C75}"/>
               </a:ext>
             </a:extLst>
           </p:cNvPr>
@@ -9258,7 +9258,7 @@
     </p:spTree>
     <p:extLst>
       <p:ext uri="{BB962C8B-B14F-4D97-AF65-F5344CB8AC3E}">
-        <p14:creationId xmlns:p14="http://schemas.microsoft.com/office/powerpoint/2010/main" val="1965823083"/>
+        <p14:creationId xmlns:p14="http://schemas.microsoft.com/office/powerpoint/2010/main" val="1938898888"/>
       </p:ext>
     </p:extLst>
   </p:cSld>
@@ -9282,7 +9282,7 @@
           <p:cNvPr id="2" name="Rectangle 1">
             <a:extLst xmlns:a="http://schemas.openxmlformats.org/drawingml/2006/main">
               <a:ext uri="{FF2B5EF4-FFF2-40B4-BE49-F238E27FC236}">
-                <a16:creationId xmlns:a16="http://schemas.microsoft.com/office/drawing/2014/main" id="{42787622-F332-430C-9A6E-F2C639387100}"/>
+                <a16:creationId xmlns:a16="http://schemas.microsoft.com/office/drawing/2014/main" id="{FF338CF3-49F1-4189-8CA0-FBDF197A816A}"/>
               </a:ext>
             </a:extLst>
           </p:cNvPr>
@@ -9335,7 +9335,7 @@
           <p:cNvPr id="3" name="Rectangle 2">
             <a:extLst xmlns:a="http://schemas.openxmlformats.org/drawingml/2006/main">
               <a:ext uri="{FF2B5EF4-FFF2-40B4-BE49-F238E27FC236}">
-                <a16:creationId xmlns:a16="http://schemas.microsoft.com/office/drawing/2014/main" id="{9B96906B-FCD2-4189-A41C-2231ED8D3C3B}"/>
+                <a16:creationId xmlns:a16="http://schemas.microsoft.com/office/drawing/2014/main" id="{C4C0FC8C-5845-4423-9E65-A6BF677A74B9}"/>
               </a:ext>
             </a:extLst>
           </p:cNvPr>
@@ -9388,7 +9388,7 @@
           <p:cNvPr id="4" name="Rectangle 3">
             <a:extLst xmlns:a="http://schemas.openxmlformats.org/drawingml/2006/main">
               <a:ext uri="{FF2B5EF4-FFF2-40B4-BE49-F238E27FC236}">
-                <a16:creationId xmlns:a16="http://schemas.microsoft.com/office/drawing/2014/main" id="{29F83A79-E0B7-4308-B577-CB673AABD60B}"/>
+                <a16:creationId xmlns:a16="http://schemas.microsoft.com/office/drawing/2014/main" id="{34FD2B31-B165-4DD9-BADF-DE4A8A6500D1}"/>
               </a:ext>
             </a:extLst>
           </p:cNvPr>
@@ -9441,7 +9441,7 @@
           <p:cNvPr id="5" name="TextBox 4">
             <a:extLst xmlns:a="http://schemas.openxmlformats.org/drawingml/2006/main">
               <a:ext uri="{FF2B5EF4-FFF2-40B4-BE49-F238E27FC236}">
-                <a16:creationId xmlns:a16="http://schemas.microsoft.com/office/drawing/2014/main" id="{D10744DF-FFAC-403B-8F83-7F49C7046983}"/>
+                <a16:creationId xmlns:a16="http://schemas.microsoft.com/office/drawing/2014/main" id="{41EC2395-27F2-4749-8D31-9DE7B3BA212E}"/>
               </a:ext>
             </a:extLst>
           </p:cNvPr>
@@ -9504,7 +9504,7 @@
           <p:cNvPr id="6" name="Rounded Rectangle 5">
             <a:extLst xmlns:a="http://schemas.openxmlformats.org/drawingml/2006/main">
               <a:ext uri="{FF2B5EF4-FFF2-40B4-BE49-F238E27FC236}">
-                <a16:creationId xmlns:a16="http://schemas.microsoft.com/office/drawing/2014/main" id="{94B641A5-E523-44F4-9017-6BA99D5BFD8F}"/>
+                <a16:creationId xmlns:a16="http://schemas.microsoft.com/office/drawing/2014/main" id="{CE5DE87F-8BE0-4C47-9285-E683B7FA935B}"/>
               </a:ext>
             </a:extLst>
           </p:cNvPr>
@@ -9559,7 +9559,7 @@
           <p:cNvPr id="7" name="TextBox 6">
             <a:extLst xmlns:a="http://schemas.openxmlformats.org/drawingml/2006/main">
               <a:ext uri="{FF2B5EF4-FFF2-40B4-BE49-F238E27FC236}">
-                <a16:creationId xmlns:a16="http://schemas.microsoft.com/office/drawing/2014/main" id="{9F3E6024-AF77-4C7F-8FAE-34F137DAE709}"/>
+                <a16:creationId xmlns:a16="http://schemas.microsoft.com/office/drawing/2014/main" id="{306FF487-D4E9-4CBA-AD95-F317BC41B25A}"/>
               </a:ext>
             </a:extLst>
           </p:cNvPr>
@@ -9777,7 +9777,7 @@
           <p:cNvPr id="8" name="Rounded Rectangle 7">
             <a:extLst xmlns:a="http://schemas.openxmlformats.org/drawingml/2006/main">
               <a:ext uri="{FF2B5EF4-FFF2-40B4-BE49-F238E27FC236}">
-                <a16:creationId xmlns:a16="http://schemas.microsoft.com/office/drawing/2014/main" id="{9D9696ED-3EEB-4AF3-A4ED-339E95CED496}"/>
+                <a16:creationId xmlns:a16="http://schemas.microsoft.com/office/drawing/2014/main" id="{A2208063-B9B2-45C2-BA05-4BED92CF54C6}"/>
               </a:ext>
             </a:extLst>
           </p:cNvPr>
@@ -9832,7 +9832,7 @@
           <p:cNvPr id="9" name="TextBox 8">
             <a:extLst xmlns:a="http://schemas.openxmlformats.org/drawingml/2006/main">
               <a:ext uri="{FF2B5EF4-FFF2-40B4-BE49-F238E27FC236}">
-                <a16:creationId xmlns:a16="http://schemas.microsoft.com/office/drawing/2014/main" id="{04409798-EB64-4855-9457-60F6F1AA8B86}"/>
+                <a16:creationId xmlns:a16="http://schemas.microsoft.com/office/drawing/2014/main" id="{1CC938A3-FCD9-45A9-8448-8210E0FF7C18}"/>
               </a:ext>
             </a:extLst>
           </p:cNvPr>
@@ -10067,7 +10067,7 @@
     </p:spTree>
     <p:extLst>
       <p:ext uri="{BB962C8B-B14F-4D97-AF65-F5344CB8AC3E}">
-        <p14:creationId xmlns:p14="http://schemas.microsoft.com/office/powerpoint/2010/main" val="1167155734"/>
+        <p14:creationId xmlns:p14="http://schemas.microsoft.com/office/powerpoint/2010/main" val="430492054"/>
       </p:ext>
     </p:extLst>
   </p:cSld>
@@ -10091,7 +10091,7 @@
           <p:cNvPr id="2" name="Rectangle 1">
             <a:extLst xmlns:a="http://schemas.openxmlformats.org/drawingml/2006/main">
               <a:ext uri="{FF2B5EF4-FFF2-40B4-BE49-F238E27FC236}">
-                <a16:creationId xmlns:a16="http://schemas.microsoft.com/office/drawing/2014/main" id="{7AE93406-CC9A-4821-B975-154D46FED285}"/>
+                <a16:creationId xmlns:a16="http://schemas.microsoft.com/office/drawing/2014/main" id="{933CBBDB-F531-428E-BBCF-B72E1D2C4B89}"/>
               </a:ext>
             </a:extLst>
           </p:cNvPr>
@@ -10144,7 +10144,7 @@
           <p:cNvPr id="3" name="Rectangle 2">
             <a:extLst xmlns:a="http://schemas.openxmlformats.org/drawingml/2006/main">
               <a:ext uri="{FF2B5EF4-FFF2-40B4-BE49-F238E27FC236}">
-                <a16:creationId xmlns:a16="http://schemas.microsoft.com/office/drawing/2014/main" id="{521C59AE-8A23-48AF-97F9-5A8EA98220B4}"/>
+                <a16:creationId xmlns:a16="http://schemas.microsoft.com/office/drawing/2014/main" id="{636A6DA1-59C1-4641-9867-BC668B75E576}"/>
               </a:ext>
             </a:extLst>
           </p:cNvPr>
@@ -10197,7 +10197,7 @@
           <p:cNvPr id="4" name="Rectangle 3">
             <a:extLst xmlns:a="http://schemas.openxmlformats.org/drawingml/2006/main">
               <a:ext uri="{FF2B5EF4-FFF2-40B4-BE49-F238E27FC236}">
-                <a16:creationId xmlns:a16="http://schemas.microsoft.com/office/drawing/2014/main" id="{35F08C52-255F-41FE-A2FA-A9BDFDCAE728}"/>
+                <a16:creationId xmlns:a16="http://schemas.microsoft.com/office/drawing/2014/main" id="{692C25C1-1531-4046-8C53-7D4D1669E45D}"/>
               </a:ext>
             </a:extLst>
           </p:cNvPr>
@@ -10250,7 +10250,7 @@
           <p:cNvPr id="5" name="TextBox 4">
             <a:extLst xmlns:a="http://schemas.openxmlformats.org/drawingml/2006/main">
               <a:ext uri="{FF2B5EF4-FFF2-40B4-BE49-F238E27FC236}">
-                <a16:creationId xmlns:a16="http://schemas.microsoft.com/office/drawing/2014/main" id="{C9222770-3561-4566-9457-E332F6BCD2A8}"/>
+                <a16:creationId xmlns:a16="http://schemas.microsoft.com/office/drawing/2014/main" id="{7F793D08-B33B-4FB6-BD50-E01FF2ADD1ED}"/>
               </a:ext>
             </a:extLst>
           </p:cNvPr>
@@ -10313,7 +10313,7 @@
           <p:cNvPr id="6" name="Rounded Rectangle 5">
             <a:extLst xmlns:a="http://schemas.openxmlformats.org/drawingml/2006/main">
               <a:ext uri="{FF2B5EF4-FFF2-40B4-BE49-F238E27FC236}">
-                <a16:creationId xmlns:a16="http://schemas.microsoft.com/office/drawing/2014/main" id="{C7553483-4B00-4C00-A592-AA612135FD43}"/>
+                <a16:creationId xmlns:a16="http://schemas.microsoft.com/office/drawing/2014/main" id="{D45921BE-187D-462D-B8C3-1D96AC0737E7}"/>
               </a:ext>
             </a:extLst>
           </p:cNvPr>
@@ -10368,7 +10368,7 @@
           <p:cNvPr id="7" name="TextBox 6">
             <a:extLst xmlns:a="http://schemas.openxmlformats.org/drawingml/2006/main">
               <a:ext uri="{FF2B5EF4-FFF2-40B4-BE49-F238E27FC236}">
-                <a16:creationId xmlns:a16="http://schemas.microsoft.com/office/drawing/2014/main" id="{C5B29E35-6967-4137-8073-AF5640FFC68D}"/>
+                <a16:creationId xmlns:a16="http://schemas.microsoft.com/office/drawing/2014/main" id="{29899210-2BB9-4524-86EE-0F480092C6EB}"/>
               </a:ext>
             </a:extLst>
           </p:cNvPr>
@@ -10519,7 +10519,7 @@
               </a:defRPr>
             </a:pPr>
             <a:r>
-              <a:t>  • Hit@10: 45.11% (341 / 756)</a:t>
+              <a:t>  • Hit@10: 45.11% (341 / 756) -&gt; [Diagnostic Fixture: Hit@10 = 0.8333]</a:t>
             </a:r>
           </a:p>
           <a:p xmlns:a="http://schemas.openxmlformats.org/drawingml/2006/main">
@@ -10538,7 +10538,7 @@
               </a:defRPr>
             </a:pPr>
             <a:r>
-              <a:t>•  Tỷ lệ vắng mặt trong Top-10 (Retrieval Failure): 54.89% (415 / 756).</a:t>
+              <a:t>•  Tỷ lệ vắng mặt trong Top-10 (Retrieval Failure): 54.89% (415 / 756) -&gt; [Fixture Miss Rate: 0.1667]</a:t>
             </a:r>
           </a:p>
           <a:p xmlns:a="http://schemas.openxmlformats.org/drawingml/2006/main">
@@ -10557,7 +10557,7 @@
               </a:defRPr>
             </a:pPr>
             <a:r>
-              <a:t>•  Macro Recall@10: 43.14%  |  Mean Rank khi trúng: 5.21.</a:t>
+              <a:t>•  Macro Recall@10: 43.14% [Fixture Macro Recall@10: 0.8333]  |  Mean Rank khi trúng: 5.21.</a:t>
             </a:r>
           </a:p>
           <a:p xmlns:a="http://schemas.openxmlformats.org/drawingml/2006/main">
@@ -10590,7 +10590,7 @@
           <p:nvPr/>
         </p:nvPicPr>
         <p:blipFill>
-          <a:blip xmlns:r="http://schemas.openxmlformats.org/officeDocument/2006/relationships" xmlns:a="http://schemas.openxmlformats.org/drawingml/2006/main" r:embed="Rfc72609ef02d47be"/>
+          <a:blip xmlns:r="http://schemas.openxmlformats.org/officeDocument/2006/relationships" xmlns:a="http://schemas.openxmlformats.org/drawingml/2006/main" r:embed="R705e164ccab24789"/>
           <a:stretch xmlns:a="http://schemas.openxmlformats.org/drawingml/2006/main">
             <a:fillRect l="0" t="0" r="0" b="0"/>
           </a:stretch>
@@ -10610,7 +10610,7 @@
           <p:cNvPr id="9" name="Rounded Rectangle 8">
             <a:extLst xmlns:a="http://schemas.openxmlformats.org/drawingml/2006/main">
               <a:ext uri="{FF2B5EF4-FFF2-40B4-BE49-F238E27FC236}">
-                <a16:creationId xmlns:a16="http://schemas.microsoft.com/office/drawing/2014/main" id="{844B2008-0C5A-41B5-A80B-4119ACD113DD}"/>
+                <a16:creationId xmlns:a16="http://schemas.microsoft.com/office/drawing/2014/main" id="{7223E386-7F3B-47CB-8655-7798FD1A4274}"/>
               </a:ext>
             </a:extLst>
           </p:cNvPr>
@@ -10665,7 +10665,7 @@
           <p:cNvPr id="10" name="TextBox 9">
             <a:extLst xmlns:a="http://schemas.openxmlformats.org/drawingml/2006/main">
               <a:ext uri="{FF2B5EF4-FFF2-40B4-BE49-F238E27FC236}">
-                <a16:creationId xmlns:a16="http://schemas.microsoft.com/office/drawing/2014/main" id="{480C8DFD-10D4-4BFE-B239-CCC47CC537F8}"/>
+                <a16:creationId xmlns:a16="http://schemas.microsoft.com/office/drawing/2014/main" id="{62C9A2B3-25A0-4B7D-AE35-F932911049C3}"/>
               </a:ext>
             </a:extLst>
           </p:cNvPr>
@@ -10751,7 +10751,7 @@
     </p:spTree>
     <p:extLst>
       <p:ext uri="{BB962C8B-B14F-4D97-AF65-F5344CB8AC3E}">
-        <p14:creationId xmlns:p14="http://schemas.microsoft.com/office/powerpoint/2010/main" val="2014988432"/>
+        <p14:creationId xmlns:p14="http://schemas.microsoft.com/office/powerpoint/2010/main" val="947157156"/>
       </p:ext>
     </p:extLst>
   </p:cSld>
@@ -10775,7 +10775,7 @@
           <p:cNvPr id="2" name="Rectangle 1">
             <a:extLst xmlns:a="http://schemas.openxmlformats.org/drawingml/2006/main">
               <a:ext uri="{FF2B5EF4-FFF2-40B4-BE49-F238E27FC236}">
-                <a16:creationId xmlns:a16="http://schemas.microsoft.com/office/drawing/2014/main" id="{F21E6A82-DEB2-4C91-8630-4460A71C2D41}"/>
+                <a16:creationId xmlns:a16="http://schemas.microsoft.com/office/drawing/2014/main" id="{C2278535-11A9-43C9-9D57-F9FABE298112}"/>
               </a:ext>
             </a:extLst>
           </p:cNvPr>
@@ -10828,7 +10828,7 @@
           <p:cNvPr id="3" name="Rectangle 2">
             <a:extLst xmlns:a="http://schemas.openxmlformats.org/drawingml/2006/main">
               <a:ext uri="{FF2B5EF4-FFF2-40B4-BE49-F238E27FC236}">
-                <a16:creationId xmlns:a16="http://schemas.microsoft.com/office/drawing/2014/main" id="{0FBBA10C-D416-4832-9896-F7E719671739}"/>
+                <a16:creationId xmlns:a16="http://schemas.microsoft.com/office/drawing/2014/main" id="{4FE3A430-C84B-4D70-9C00-C1A2BD8BC2D6}"/>
               </a:ext>
             </a:extLst>
           </p:cNvPr>
@@ -10881,7 +10881,7 @@
           <p:cNvPr id="4" name="Rectangle 3">
             <a:extLst xmlns:a="http://schemas.openxmlformats.org/drawingml/2006/main">
               <a:ext uri="{FF2B5EF4-FFF2-40B4-BE49-F238E27FC236}">
-                <a16:creationId xmlns:a16="http://schemas.microsoft.com/office/drawing/2014/main" id="{4A279BA8-179A-4FE0-A532-B5D6D8D7BC17}"/>
+                <a16:creationId xmlns:a16="http://schemas.microsoft.com/office/drawing/2014/main" id="{6A936DB3-5BFB-4478-B92F-B46BB42BE267}"/>
               </a:ext>
             </a:extLst>
           </p:cNvPr>
@@ -10934,7 +10934,7 @@
           <p:cNvPr id="5" name="TextBox 4">
             <a:extLst xmlns:a="http://schemas.openxmlformats.org/drawingml/2006/main">
               <a:ext uri="{FF2B5EF4-FFF2-40B4-BE49-F238E27FC236}">
-                <a16:creationId xmlns:a16="http://schemas.microsoft.com/office/drawing/2014/main" id="{113C591D-4802-407D-8E23-00981A6D2854}"/>
+                <a16:creationId xmlns:a16="http://schemas.microsoft.com/office/drawing/2014/main" id="{DAE0BD85-F5CC-4979-B617-32FEB482CB76}"/>
               </a:ext>
             </a:extLst>
           </p:cNvPr>
@@ -10997,7 +10997,7 @@
           <p:cNvPr id="6" name="Rounded Rectangle 5">
             <a:extLst xmlns:a="http://schemas.openxmlformats.org/drawingml/2006/main">
               <a:ext uri="{FF2B5EF4-FFF2-40B4-BE49-F238E27FC236}">
-                <a16:creationId xmlns:a16="http://schemas.microsoft.com/office/drawing/2014/main" id="{B5F46E79-D176-4B6D-8DC0-1E73DD225E3B}"/>
+                <a16:creationId xmlns:a16="http://schemas.microsoft.com/office/drawing/2014/main" id="{D02B7167-D785-4073-93CB-E48AA6A3F690}"/>
               </a:ext>
             </a:extLst>
           </p:cNvPr>
@@ -11052,7 +11052,7 @@
           <p:cNvPr id="7" name="TextBox 6">
             <a:extLst xmlns:a="http://schemas.openxmlformats.org/drawingml/2006/main">
               <a:ext uri="{FF2B5EF4-FFF2-40B4-BE49-F238E27FC236}">
-                <a16:creationId xmlns:a16="http://schemas.microsoft.com/office/drawing/2014/main" id="{2703F79C-9491-4CA7-BACD-BAC6219C221B}"/>
+                <a16:creationId xmlns:a16="http://schemas.microsoft.com/office/drawing/2014/main" id="{881445A8-BCCD-42FC-8BBA-E2EC75BD3112}"/>
               </a:ext>
             </a:extLst>
           </p:cNvPr>
@@ -11289,7 +11289,7 @@
           <p:cNvPr id="8" name="Rounded Rectangle 7">
             <a:extLst xmlns:a="http://schemas.openxmlformats.org/drawingml/2006/main">
               <a:ext uri="{FF2B5EF4-FFF2-40B4-BE49-F238E27FC236}">
-                <a16:creationId xmlns:a16="http://schemas.microsoft.com/office/drawing/2014/main" id="{532266EB-FB53-4763-A9EE-F51B95353530}"/>
+                <a16:creationId xmlns:a16="http://schemas.microsoft.com/office/drawing/2014/main" id="{D68E7B79-6E03-4A1D-8502-3C7B7D7F9259}"/>
               </a:ext>
             </a:extLst>
           </p:cNvPr>
@@ -11344,7 +11344,7 @@
           <p:cNvPr id="9" name="TextBox 8">
             <a:extLst xmlns:a="http://schemas.openxmlformats.org/drawingml/2006/main">
               <a:ext uri="{FF2B5EF4-FFF2-40B4-BE49-F238E27FC236}">
-                <a16:creationId xmlns:a16="http://schemas.microsoft.com/office/drawing/2014/main" id="{0781BDA2-C9F3-4220-99DE-B6976A00A564}"/>
+                <a16:creationId xmlns:a16="http://schemas.microsoft.com/office/drawing/2014/main" id="{AE8634FE-540F-4F8C-B34A-022E8E790BCF}"/>
               </a:ext>
             </a:extLst>
           </p:cNvPr>
@@ -11356,7 +11356,7 @@
         <p:spPr>
           <a:xfrm xmlns:a="http://schemas.openxmlformats.org/drawingml/2006/main">
             <a:off x="6430975" y="1344168"/>
-            <a:ext cx="4846320" cy="4855464"/>
+            <a:ext cx="4846320" cy="5410200"/>
           </a:xfrm>
           <a:prstGeom xmlns:a="http://schemas.openxmlformats.org/drawingml/2006/main" prst="rect">
             <a:avLst/>
@@ -11460,13 +11460,142 @@
               </a:defRPr>
             </a:pPr>
             <a:r>
-              <a:t>•  Schema So Sánh Đối Chứng Scaffold </a:t>
-            </a:r>
-            <a:r>
-              <a:t>[FIXTURE CANDIDATE - TEST MATRIX IN PROGRESS]</a:t>
-            </a:r>
-            <a:r>
-              <a:t>:</a:t>
+              <a:t>•  Schema So Sánh Đối Chứng Scaffold [DIAGNOSTIC TEST FIXTURE ONLY - NOT CANONICAL NUMERICAL RESULTS]:</a:t>
+            </a:r>
+          </a:p>
+          <a:p xmlns:a="http://schemas.openxmlformats.org/drawingml/2006/main">
+            <a:pPr>
+              <a:spcBef>
+                <a:spcPts val="300"/>
+              </a:spcBef>
+              <a:buNone/>
+              <a:defRPr sz="1150">
+                <a:solidFill>
+                  <a:srgbClr val="0F172A"/>
+                </a:solidFill>
+                <a:latin typeface="Calibri"/>
+                <a:ea typeface="Calibri"/>
+                <a:cs typeface="Calibri"/>
+              </a:defRPr>
+            </a:pPr>
+            <a:r>
+              <a:rPr sz="1150">
+                <a:solidFill>
+                  <a:srgbClr val="0F172A"/>
+                </a:solidFill>
+                <a:latin typeface="Calibri"/>
+                <a:ea typeface="Calibri"/>
+                <a:cs typeface="Calibri"/>
+              </a:rPr>
+              <a:t>  • Diagnostic Cohort Pairwise Comparison (n=718 views across 440 clusters):</a:t>
+            </a:r>
+          </a:p>
+          <a:p xmlns:a="http://schemas.openxmlformats.org/drawingml/2006/main">
+            <a:pPr>
+              <a:spcBef>
+                <a:spcPts val="300"/>
+              </a:spcBef>
+              <a:buNone/>
+              <a:defRPr sz="1150">
+                <a:solidFill>
+                  <a:srgbClr val="0F172A"/>
+                </a:solidFill>
+                <a:latin typeface="Calibri"/>
+                <a:ea typeface="Calibri"/>
+                <a:cs typeface="Calibri"/>
+              </a:defRPr>
+            </a:pPr>
+            <a:r>
+              <a:rPr sz="1150">
+                <a:solidFill>
+                  <a:srgbClr val="0F172A"/>
+                </a:solidFill>
+                <a:latin typeface="Calibri"/>
+                <a:ea typeface="Calibri"/>
+                <a:cs typeface="Calibri"/>
+              </a:rPr>
+              <a:t>    • Marginal Views: Single-event Acc = 0.5000 vs Contextual-event Acc = 0.5000 (Delta = +0.0000)</a:t>
+            </a:r>
+          </a:p>
+          <a:p xmlns:a="http://schemas.openxmlformats.org/drawingml/2006/main">
+            <a:pPr>
+              <a:spcBef>
+                <a:spcPts val="300"/>
+              </a:spcBef>
+              <a:buNone/>
+              <a:defRPr sz="1150">
+                <a:solidFill>
+                  <a:srgbClr val="0F172A"/>
+                </a:solidFill>
+                <a:latin typeface="Calibri"/>
+                <a:ea typeface="Calibri"/>
+                <a:cs typeface="Calibri"/>
+              </a:defRPr>
+            </a:pPr>
+            <a:r>
+              <a:rPr sz="1150">
+                <a:solidFill>
+                  <a:srgbClr val="0F172A"/>
+                </a:solidFill>
+                <a:latin typeface="Calibri"/>
+                <a:ea typeface="Calibri"/>
+                <a:cs typeface="Calibri"/>
+              </a:rPr>
+              <a:t>    • Paired Cohort (278 complete pairs): Single Acc = 0.5000 vs Context Acc = 0.5000 (Delta = +0.00 pp)</a:t>
+            </a:r>
+          </a:p>
+          <a:p xmlns:a="http://schemas.openxmlformats.org/drawingml/2006/main">
+            <a:pPr>
+              <a:spcBef>
+                <a:spcPts val="300"/>
+              </a:spcBef>
+              <a:buNone/>
+              <a:defRPr sz="1150">
+                <a:solidFill>
+                  <a:srgbClr val="0F172A"/>
+                </a:solidFill>
+                <a:latin typeface="Calibri"/>
+                <a:ea typeface="Calibri"/>
+                <a:cs typeface="Calibri"/>
+              </a:defRPr>
+            </a:pPr>
+            <a:r>
+              <a:rPr sz="1150">
+                <a:solidFill>
+                  <a:srgbClr val="0F172A"/>
+                </a:solidFill>
+                <a:latin typeface="Calibri"/>
+                <a:ea typeface="Calibri"/>
+                <a:cs typeface="Calibri"/>
+              </a:rPr>
+              <a:t>    • Pair Concordance: Both Correct = 139, Single-only Correct = 0, Context-only Correct = 0, Both Incorrect = 139</a:t>
+            </a:r>
+          </a:p>
+          <a:p xmlns:a="http://schemas.openxmlformats.org/drawingml/2006/main">
+            <a:pPr>
+              <a:spcBef>
+                <a:spcPts val="300"/>
+              </a:spcBef>
+              <a:buNone/>
+              <a:defRPr sz="1150">
+                <a:solidFill>
+                  <a:srgbClr val="0F172A"/>
+                </a:solidFill>
+                <a:latin typeface="Calibri"/>
+                <a:ea typeface="Calibri"/>
+                <a:cs typeface="Calibri"/>
+              </a:defRPr>
+            </a:pPr>
+            <a:r>
+              <a:rPr sz="1150">
+                <a:solidFill>
+                  <a:srgbClr val="0F172A"/>
+                </a:solidFill>
+                <a:latin typeface="Calibri"/>
+                <a:ea typeface="Calibri"/>
+                <a:cs typeface="Calibri"/>
+              </a:rPr>
+              <a:t>    • McNemar Exploratory Test: p_asympt = 1.0000, p_exact = 1.0000</a:t>
             </a:r>
           </a:p>
           <a:p xmlns:a="http://schemas.openxmlformats.org/drawingml/2006/main">
@@ -11550,7 +11679,7 @@
     </p:spTree>
     <p:extLst>
       <p:ext uri="{BB962C8B-B14F-4D97-AF65-F5344CB8AC3E}">
-        <p14:creationId xmlns:p14="http://schemas.microsoft.com/office/powerpoint/2010/main" val="955006986"/>
+        <p14:creationId xmlns:p14="http://schemas.microsoft.com/office/powerpoint/2010/main" val="592533764"/>
       </p:ext>
     </p:extLst>
   </p:cSld>
@@ -11574,7 +11703,7 @@
           <p:cNvPr id="2" name="Rectangle 1">
             <a:extLst xmlns:a="http://schemas.openxmlformats.org/drawingml/2006/main">
               <a:ext uri="{FF2B5EF4-FFF2-40B4-BE49-F238E27FC236}">
-                <a16:creationId xmlns:a16="http://schemas.microsoft.com/office/drawing/2014/main" id="{6AF785D3-AB1E-44A5-9882-315CA374740A}"/>
+                <a16:creationId xmlns:a16="http://schemas.microsoft.com/office/drawing/2014/main" id="{71F0D1DA-EB69-4A2A-B554-955F08EE2CB7}"/>
               </a:ext>
             </a:extLst>
           </p:cNvPr>
@@ -11627,7 +11756,7 @@
           <p:cNvPr id="3" name="Rectangle 2">
             <a:extLst xmlns:a="http://schemas.openxmlformats.org/drawingml/2006/main">
               <a:ext uri="{FF2B5EF4-FFF2-40B4-BE49-F238E27FC236}">
-                <a16:creationId xmlns:a16="http://schemas.microsoft.com/office/drawing/2014/main" id="{109CBAA7-743C-439F-819B-BED561A16032}"/>
+                <a16:creationId xmlns:a16="http://schemas.microsoft.com/office/drawing/2014/main" id="{832D5062-73ED-418B-94FE-332A65D40044}"/>
               </a:ext>
             </a:extLst>
           </p:cNvPr>
@@ -11680,7 +11809,7 @@
           <p:cNvPr id="4" name="Rectangle 3">
             <a:extLst xmlns:a="http://schemas.openxmlformats.org/drawingml/2006/main">
               <a:ext uri="{FF2B5EF4-FFF2-40B4-BE49-F238E27FC236}">
-                <a16:creationId xmlns:a16="http://schemas.microsoft.com/office/drawing/2014/main" id="{D743B9A0-DE01-4111-A7D1-1F020355F40B}"/>
+                <a16:creationId xmlns:a16="http://schemas.microsoft.com/office/drawing/2014/main" id="{D2298787-15A3-4AC7-BCF5-97A2F093C37A}"/>
               </a:ext>
             </a:extLst>
           </p:cNvPr>
@@ -11733,7 +11862,7 @@
           <p:cNvPr id="5" name="TextBox 4">
             <a:extLst xmlns:a="http://schemas.openxmlformats.org/drawingml/2006/main">
               <a:ext uri="{FF2B5EF4-FFF2-40B4-BE49-F238E27FC236}">
-                <a16:creationId xmlns:a16="http://schemas.microsoft.com/office/drawing/2014/main" id="{BE53BC65-D362-475D-AF10-B3AED87F8F5D}"/>
+                <a16:creationId xmlns:a16="http://schemas.microsoft.com/office/drawing/2014/main" id="{CB4E470C-AEE2-40D7-9C94-E8EB961C7614}"/>
               </a:ext>
             </a:extLst>
           </p:cNvPr>
@@ -11796,7 +11925,7 @@
           <p:cNvPr id="6" name="Rounded Rectangle 5">
             <a:extLst xmlns:a="http://schemas.openxmlformats.org/drawingml/2006/main">
               <a:ext uri="{FF2B5EF4-FFF2-40B4-BE49-F238E27FC236}">
-                <a16:creationId xmlns:a16="http://schemas.microsoft.com/office/drawing/2014/main" id="{D6166431-668A-4E0D-9566-B4A56A36E268}"/>
+                <a16:creationId xmlns:a16="http://schemas.microsoft.com/office/drawing/2014/main" id="{DDD30715-AA6E-4FB2-9280-3443B35BBAA5}"/>
               </a:ext>
             </a:extLst>
           </p:cNvPr>
@@ -11851,7 +11980,7 @@
           <p:cNvPr id="7" name="TextBox 6">
             <a:extLst xmlns:a="http://schemas.openxmlformats.org/drawingml/2006/main">
               <a:ext uri="{FF2B5EF4-FFF2-40B4-BE49-F238E27FC236}">
-                <a16:creationId xmlns:a16="http://schemas.microsoft.com/office/drawing/2014/main" id="{7B356E6D-4441-40EA-B377-7140BD35E3F2}"/>
+                <a16:creationId xmlns:a16="http://schemas.microsoft.com/office/drawing/2014/main" id="{02857F93-C497-4334-A80A-866D28EE664D}"/>
               </a:ext>
             </a:extLst>
           </p:cNvPr>
@@ -11974,7 +12103,7 @@
           <p:cNvPr id="8" name="Rounded Rectangle 7">
             <a:extLst xmlns:a="http://schemas.openxmlformats.org/drawingml/2006/main">
               <a:ext uri="{FF2B5EF4-FFF2-40B4-BE49-F238E27FC236}">
-                <a16:creationId xmlns:a16="http://schemas.microsoft.com/office/drawing/2014/main" id="{F57AD789-F3F4-40DB-BBF9-9DEBD7E5CA8B}"/>
+                <a16:creationId xmlns:a16="http://schemas.microsoft.com/office/drawing/2014/main" id="{53447F41-003C-4C0D-91AE-15264D978320}"/>
               </a:ext>
             </a:extLst>
           </p:cNvPr>
@@ -12029,7 +12158,7 @@
           <p:cNvPr id="9" name="TextBox 8">
             <a:extLst xmlns:a="http://schemas.openxmlformats.org/drawingml/2006/main">
               <a:ext uri="{FF2B5EF4-FFF2-40B4-BE49-F238E27FC236}">
-                <a16:creationId xmlns:a16="http://schemas.microsoft.com/office/drawing/2014/main" id="{0091B5AF-08E7-40FB-BBFF-13C787D293EA}"/>
+                <a16:creationId xmlns:a16="http://schemas.microsoft.com/office/drawing/2014/main" id="{112B6782-B718-48AA-87A5-00C3A4A07726}"/>
               </a:ext>
             </a:extLst>
           </p:cNvPr>
@@ -12085,7 +12214,7 @@
               </a:defRPr>
             </a:pPr>
             <a:r>
-              <a:t>•  P(Correct | GT in Top-k): Đánh giá năng lực lựa chọn của LLM khi bộ tìm kiếm hoạt động chính xác.</a:t>
+              <a:t>•  P(Correct | GT Retrieved) = 0.6000: Xác suất gán đúng quan sát được khi kỹ thuật mục tiêu hiện diện trong Top-k.</a:t>
             </a:r>
           </a:p>
           <a:p xmlns:a="http://schemas.openxmlformats.org/drawingml/2006/main">
@@ -12104,7 +12233,7 @@
               </a:defRPr>
             </a:pPr>
             <a:r>
-              <a:t>•  P(Correct | GT NOT in Top-k): Đánh giá khả năng LLM tự sửa sai dựa trên tri thức nội tại.</a:t>
+              <a:t>•  P(Correct | GT Absent) = 0.0000: Xác suất gán đúng quan sát được khi kỹ thuật mục tiêu vắng mặt trong Top-k (không giả định tự sửa sai nội tại).</a:t>
             </a:r>
           </a:p>
           <a:p xmlns:a="http://schemas.openxmlformats.org/drawingml/2006/main">
@@ -12142,7 +12271,7 @@
               </a:defRPr>
             </a:pPr>
             <a:r>
-              <a:t>•  Fail-Closed Invariant: Mẫu lỗi API, timeout (D2f) hay mã sai cú pháp (D2e) đều tính vào mẫu số.</a:t>
+              <a:t>•  Fail-Closed Invariant: Provider Fail = 0.0000, Parse Fail = 0.0000, Invalid ID = 0.1667 (tính vào mẫu số).</a:t>
             </a:r>
           </a:p>
         </p:txBody>
@@ -12152,7 +12281,7 @@
           <p:cNvPr id="10" name="Rounded Rectangle 9">
             <a:extLst xmlns:a="http://schemas.openxmlformats.org/drawingml/2006/main">
               <a:ext uri="{FF2B5EF4-FFF2-40B4-BE49-F238E27FC236}">
-                <a16:creationId xmlns:a16="http://schemas.microsoft.com/office/drawing/2014/main" id="{A4EA5E52-CCF7-4D12-819B-F28136F40E2E}"/>
+                <a16:creationId xmlns:a16="http://schemas.microsoft.com/office/drawing/2014/main" id="{0A7B4466-6391-47FA-AA63-1DC3E7171F2F}"/>
               </a:ext>
             </a:extLst>
           </p:cNvPr>
@@ -12207,7 +12336,7 @@
           <p:cNvPr id="11" name="TextBox 10">
             <a:extLst xmlns:a="http://schemas.openxmlformats.org/drawingml/2006/main">
               <a:ext uri="{FF2B5EF4-FFF2-40B4-BE49-F238E27FC236}">
-                <a16:creationId xmlns:a16="http://schemas.microsoft.com/office/drawing/2014/main" id="{509BE38B-F13D-42C0-AEAB-E70DC703ABC0}"/>
+                <a16:creationId xmlns:a16="http://schemas.microsoft.com/office/drawing/2014/main" id="{3B78154F-5A60-4561-94E9-BDE0F17DA02E}"/>
               </a:ext>
             </a:extLst>
           </p:cNvPr>
@@ -12219,7 +12348,7 @@
         <p:spPr>
           <a:xfrm xmlns:a="http://schemas.openxmlformats.org/drawingml/2006/main">
             <a:off x="6430975" y="3310128"/>
-            <a:ext cx="4846320" cy="2889504"/>
+            <a:ext cx="4846320" cy="6304280"/>
           </a:xfrm>
           <a:prstGeom xmlns:a="http://schemas.openxmlformats.org/drawingml/2006/main" prst="rect">
             <a:avLst/>
@@ -12244,10 +12373,247 @@
               </a:defRPr>
             </a:pPr>
             <a:r>
-              <a:t>[DIAGNOSTIC TEST FIXTURE ONLY - NOT CANONICAL NUMERICAL RESULTS]</a:t>
-            </a:r>
-            <a:r>
-              <a:t> Trạng Thái Thực Nghiệm RQ1 &amp; RQ2</a:t>
+              <a:t>[DIAGNOSTIC TEST FIXTURE ONLY - NOT CANONICAL NUMERICAL RESULTS] RQ1 &amp; RQ2 Metrics:</a:t>
+            </a:r>
+          </a:p>
+          <a:p xmlns:a="http://schemas.openxmlformats.org/drawingml/2006/main">
+            <a:pPr>
+              <a:buNone/>
+              <a:defRPr sz="1600" b="1">
+                <a:solidFill>
+                  <a:srgbClr val="DC2626"/>
+                </a:solidFill>
+                <a:latin typeface="Calibri"/>
+                <a:ea typeface="Calibri"/>
+                <a:cs typeface="Calibri"/>
+              </a:defRPr>
+            </a:pPr>
+            <a:r>
+              <a:rPr sz="1600" b="1">
+                <a:solidFill>
+                  <a:srgbClr val="DC2626"/>
+                </a:solidFill>
+                <a:latin typeface="Calibri"/>
+                <a:ea typeface="Calibri"/>
+                <a:cs typeface="Calibri"/>
+              </a:rPr>
+              <a:t>•  RQ1 5 Conditions Performance:</a:t>
+            </a:r>
+          </a:p>
+          <a:p xmlns:a="http://schemas.openxmlformats.org/drawingml/2006/main">
+            <a:pPr>
+              <a:buNone/>
+              <a:defRPr sz="1600" b="1">
+                <a:solidFill>
+                  <a:srgbClr val="DC2626"/>
+                </a:solidFill>
+                <a:latin typeface="Calibri"/>
+                <a:ea typeface="Calibri"/>
+                <a:cs typeface="Calibri"/>
+              </a:defRPr>
+            </a:pPr>
+            <a:r>
+              <a:rPr sz="1600" b="1">
+                <a:solidFill>
+                  <a:srgbClr val="DC2626"/>
+                </a:solidFill>
+                <a:latin typeface="Calibri"/>
+                <a:ea typeface="Calibri"/>
+                <a:cs typeface="Calibri"/>
+              </a:rPr>
+              <a:t>  • no_rag: Acc = 0.5000, Macro-F1 = 0.0929, CI95 = [0.3500, 0.6500]</a:t>
+            </a:r>
+          </a:p>
+          <a:p xmlns:a="http://schemas.openxmlformats.org/drawingml/2006/main">
+            <a:pPr>
+              <a:buNone/>
+              <a:defRPr sz="1600" b="1">
+                <a:solidFill>
+                  <a:srgbClr val="DC2626"/>
+                </a:solidFill>
+                <a:latin typeface="Calibri"/>
+                <a:ea typeface="Calibri"/>
+                <a:cs typeface="Calibri"/>
+              </a:defRPr>
+            </a:pPr>
+            <a:r>
+              <a:rPr sz="1600" b="1">
+                <a:solidFill>
+                  <a:srgbClr val="DC2626"/>
+                </a:solidFill>
+                <a:latin typeface="Calibri"/>
+                <a:ea typeface="Calibri"/>
+                <a:cs typeface="Calibri"/>
+              </a:rPr>
+              <a:t>  • rag_k1: Acc = 0.5000, Macro-F1 = 0.0929, CI95 = [0.3500, 0.6500]</a:t>
+            </a:r>
+          </a:p>
+          <a:p xmlns:a="http://schemas.openxmlformats.org/drawingml/2006/main">
+            <a:pPr>
+              <a:buNone/>
+              <a:defRPr sz="1600" b="1">
+                <a:solidFill>
+                  <a:srgbClr val="DC2626"/>
+                </a:solidFill>
+                <a:latin typeface="Calibri"/>
+                <a:ea typeface="Calibri"/>
+                <a:cs typeface="Calibri"/>
+              </a:defRPr>
+            </a:pPr>
+            <a:r>
+              <a:rPr sz="1600" b="1">
+                <a:solidFill>
+                  <a:srgbClr val="DC2626"/>
+                </a:solidFill>
+                <a:latin typeface="Calibri"/>
+                <a:ea typeface="Calibri"/>
+                <a:cs typeface="Calibri"/>
+              </a:rPr>
+              <a:t>  • rag_k3: Acc = 0.5000, Macro-F1 = 0.0929, CI95 = [0.3500, 0.6500]</a:t>
+            </a:r>
+          </a:p>
+          <a:p xmlns:a="http://schemas.openxmlformats.org/drawingml/2006/main">
+            <a:pPr>
+              <a:buNone/>
+              <a:defRPr sz="1600" b="1">
+                <a:solidFill>
+                  <a:srgbClr val="DC2626"/>
+                </a:solidFill>
+                <a:latin typeface="Calibri"/>
+                <a:ea typeface="Calibri"/>
+                <a:cs typeface="Calibri"/>
+              </a:defRPr>
+            </a:pPr>
+            <a:r>
+              <a:rPr sz="1600" b="1">
+                <a:solidFill>
+                  <a:srgbClr val="DC2626"/>
+                </a:solidFill>
+                <a:latin typeface="Calibri"/>
+                <a:ea typeface="Calibri"/>
+                <a:cs typeface="Calibri"/>
+              </a:rPr>
+              <a:t>  • rag_k5: Acc = 0.5000, Macro-F1 = 0.0929, CI95 = [0.3500, 0.6500]</a:t>
+            </a:r>
+          </a:p>
+          <a:p xmlns:a="http://schemas.openxmlformats.org/drawingml/2006/main">
+            <a:pPr>
+              <a:buNone/>
+              <a:defRPr sz="1600" b="1">
+                <a:solidFill>
+                  <a:srgbClr val="DC2626"/>
+                </a:solidFill>
+                <a:latin typeface="Calibri"/>
+                <a:ea typeface="Calibri"/>
+                <a:cs typeface="Calibri"/>
+              </a:defRPr>
+            </a:pPr>
+            <a:r>
+              <a:rPr sz="1600" b="1">
+                <a:solidFill>
+                  <a:srgbClr val="DC2626"/>
+                </a:solidFill>
+                <a:latin typeface="Calibri"/>
+                <a:ea typeface="Calibri"/>
+                <a:cs typeface="Calibri"/>
+              </a:rPr>
+              <a:t>  • rag_k10: Acc = 0.5000, Macro-F1 = 0.0929, CI95 = [0.3500, 0.6500]</a:t>
+            </a:r>
+          </a:p>
+          <a:p xmlns:a="http://schemas.openxmlformats.org/drawingml/2006/main">
+            <a:pPr>
+              <a:buNone/>
+              <a:defRPr sz="1600" b="1">
+                <a:solidFill>
+                  <a:srgbClr val="DC2626"/>
+                </a:solidFill>
+                <a:latin typeface="Calibri"/>
+                <a:ea typeface="Calibri"/>
+                <a:cs typeface="Calibri"/>
+              </a:defRPr>
+            </a:pPr>
+            <a:r>
+              <a:rPr sz="1600" b="1">
+                <a:solidFill>
+                  <a:srgbClr val="DC2626"/>
+                </a:solidFill>
+                <a:latin typeface="Calibri"/>
+                <a:ea typeface="Calibri"/>
+                <a:cs typeface="Calibri"/>
+              </a:rPr>
+              <a:t>  • Best Condition: rag_k10 (Delta Acc = +0.0000, Delta F1 = +0.0000)</a:t>
+            </a:r>
+          </a:p>
+          <a:p xmlns:a="http://schemas.openxmlformats.org/drawingml/2006/main">
+            <a:pPr>
+              <a:buNone/>
+              <a:defRPr sz="1600" b="1">
+                <a:solidFill>
+                  <a:srgbClr val="DC2626"/>
+                </a:solidFill>
+                <a:latin typeface="Calibri"/>
+                <a:ea typeface="Calibri"/>
+                <a:cs typeface="Calibri"/>
+              </a:defRPr>
+            </a:pPr>
+            <a:r>
+              <a:rPr sz="1600" b="1">
+                <a:solidFill>
+                  <a:srgbClr val="DC2626"/>
+                </a:solidFill>
+                <a:latin typeface="Calibri"/>
+                <a:ea typeface="Calibri"/>
+                <a:cs typeface="Calibri"/>
+              </a:rPr>
+              <a:t>•  RQ2 Failure Axes &amp; Overlaps:</a:t>
+            </a:r>
+          </a:p>
+          <a:p xmlns:a="http://schemas.openxmlformats.org/drawingml/2006/main">
+            <a:pPr>
+              <a:buNone/>
+              <a:defRPr sz="1600" b="1">
+                <a:solidFill>
+                  <a:srgbClr val="DC2626"/>
+                </a:solidFill>
+                <a:latin typeface="Calibri"/>
+                <a:ea typeface="Calibri"/>
+                <a:cs typeface="Calibri"/>
+              </a:defRPr>
+            </a:pPr>
+            <a:r>
+              <a:rPr sz="1600" b="1">
+                <a:solidFill>
+                  <a:srgbClr val="DC2626"/>
+                </a:solidFill>
+                <a:latin typeface="Calibri"/>
+                <a:ea typeface="Calibri"/>
+                <a:cs typeface="Calibri"/>
+              </a:rPr>
+              <a:t>  • Valid but Wrong Class Rate: 0.3333</a:t>
+            </a:r>
+          </a:p>
+          <a:p xmlns:a="http://schemas.openxmlformats.org/drawingml/2006/main">
+            <a:pPr>
+              <a:buNone/>
+              <a:defRPr sz="1600" b="1">
+                <a:solidFill>
+                  <a:srgbClr val="DC2626"/>
+                </a:solidFill>
+                <a:latin typeface="Calibri"/>
+                <a:ea typeface="Calibri"/>
+                <a:cs typeface="Calibri"/>
+              </a:defRPr>
+            </a:pPr>
+            <a:r>
+              <a:rPr sz="1600" b="1">
+                <a:solidFill>
+                  <a:srgbClr val="DC2626"/>
+                </a:solidFill>
+                <a:latin typeface="Calibri"/>
+                <a:ea typeface="Calibri"/>
+                <a:cs typeface="Calibri"/>
+              </a:rPr>
+              <a:t>  • Overlaps: Miss &amp; Wrong = 0, Miss &amp; Provider Fail = 0, Miss &amp; Parse Fail = 0, Miss &amp; Invalid ID = 0</a:t>
             </a:r>
           </a:p>
           <a:p xmlns:a="http://schemas.openxmlformats.org/drawingml/2006/main">
@@ -12331,7 +12697,7 @@
     </p:spTree>
     <p:extLst>
       <p:ext uri="{BB962C8B-B14F-4D97-AF65-F5344CB8AC3E}">
-        <p14:creationId xmlns:p14="http://schemas.microsoft.com/office/powerpoint/2010/main" val="467298742"/>
+        <p14:creationId xmlns:p14="http://schemas.microsoft.com/office/powerpoint/2010/main" val="1974782684"/>
       </p:ext>
     </p:extLst>
   </p:cSld>
@@ -12355,7 +12721,7 @@
           <p:cNvPr id="2" name="Rectangle 1">
             <a:extLst xmlns:a="http://schemas.openxmlformats.org/drawingml/2006/main">
               <a:ext uri="{FF2B5EF4-FFF2-40B4-BE49-F238E27FC236}">
-                <a16:creationId xmlns:a16="http://schemas.microsoft.com/office/drawing/2014/main" id="{4AC81077-CB08-40EB-ACD6-7A1190F7BCF2}"/>
+                <a16:creationId xmlns:a16="http://schemas.microsoft.com/office/drawing/2014/main" id="{9A6F0D8B-1A90-4714-969B-24181BE960DB}"/>
               </a:ext>
             </a:extLst>
           </p:cNvPr>
@@ -12408,7 +12774,7 @@
           <p:cNvPr id="3" name="Rectangle 2">
             <a:extLst xmlns:a="http://schemas.openxmlformats.org/drawingml/2006/main">
               <a:ext uri="{FF2B5EF4-FFF2-40B4-BE49-F238E27FC236}">
-                <a16:creationId xmlns:a16="http://schemas.microsoft.com/office/drawing/2014/main" id="{EE96FB6A-A3F3-4F4E-AB22-953E7B72BBB4}"/>
+                <a16:creationId xmlns:a16="http://schemas.microsoft.com/office/drawing/2014/main" id="{ADBDCF1C-D07F-429E-856E-07A24C7875A6}"/>
               </a:ext>
             </a:extLst>
           </p:cNvPr>
@@ -12461,7 +12827,7 @@
           <p:cNvPr id="4" name="Rectangle 3">
             <a:extLst xmlns:a="http://schemas.openxmlformats.org/drawingml/2006/main">
               <a:ext uri="{FF2B5EF4-FFF2-40B4-BE49-F238E27FC236}">
-                <a16:creationId xmlns:a16="http://schemas.microsoft.com/office/drawing/2014/main" id="{489E2078-0CDC-463E-BDD7-D4944CDEA752}"/>
+                <a16:creationId xmlns:a16="http://schemas.microsoft.com/office/drawing/2014/main" id="{8F493E1E-35A6-4DFE-998C-D11A5F19143E}"/>
               </a:ext>
             </a:extLst>
           </p:cNvPr>
@@ -12514,7 +12880,7 @@
           <p:cNvPr id="5" name="TextBox 4">
             <a:extLst xmlns:a="http://schemas.openxmlformats.org/drawingml/2006/main">
               <a:ext uri="{FF2B5EF4-FFF2-40B4-BE49-F238E27FC236}">
-                <a16:creationId xmlns:a16="http://schemas.microsoft.com/office/drawing/2014/main" id="{D9DE8BDF-779C-432A-A6C2-360F6BB8675D}"/>
+                <a16:creationId xmlns:a16="http://schemas.microsoft.com/office/drawing/2014/main" id="{7D484F5E-28DF-403A-BD55-12E2DA5578B9}"/>
               </a:ext>
             </a:extLst>
           </p:cNvPr>
@@ -12577,7 +12943,7 @@
           <p:cNvPr id="6" name="Rounded Rectangle 5">
             <a:extLst xmlns:a="http://schemas.openxmlformats.org/drawingml/2006/main">
               <a:ext uri="{FF2B5EF4-FFF2-40B4-BE49-F238E27FC236}">
-                <a16:creationId xmlns:a16="http://schemas.microsoft.com/office/drawing/2014/main" id="{33D2BEEC-9130-4A0D-B66C-7AFFAB7BB5F9}"/>
+                <a16:creationId xmlns:a16="http://schemas.microsoft.com/office/drawing/2014/main" id="{5C71D30C-3B04-4ECE-88C3-560968794D82}"/>
               </a:ext>
             </a:extLst>
           </p:cNvPr>
@@ -12632,7 +12998,7 @@
           <p:cNvPr id="7" name="TextBox 6">
             <a:extLst xmlns:a="http://schemas.openxmlformats.org/drawingml/2006/main">
               <a:ext uri="{FF2B5EF4-FFF2-40B4-BE49-F238E27FC236}">
-                <a16:creationId xmlns:a16="http://schemas.microsoft.com/office/drawing/2014/main" id="{7DA89E70-02C2-4978-8C9D-C717E8543A2E}"/>
+                <a16:creationId xmlns:a16="http://schemas.microsoft.com/office/drawing/2014/main" id="{F1CC8640-F1C6-4672-91E4-8C87552209DC}"/>
               </a:ext>
             </a:extLst>
           </p:cNvPr>
@@ -12764,7 +13130,7 @@
               </a:defRPr>
             </a:pPr>
             <a:r>
-              <a:t>  • no_rag (k=0): 643 in / 224 out (~$0.00039 / query)</a:t>
+              <a:t>  • no_rag (k=0): 643.0 mean prompt tokens, med lat 7.89s (~0.000390 USD / logical req)</a:t>
             </a:r>
           </a:p>
           <a:p xmlns:a="http://schemas.openxmlformats.org/drawingml/2006/main">
@@ -12840,7 +13206,7 @@
               </a:defRPr>
             </a:pPr>
             <a:r>
-              <a:t>  • rag_k10 (k=10): 4,537 in / 801 out (~$0.00187 / query)</a:t>
+              <a:t>  • rag_k10 (k=10): 4536.5 mean prompt tokens, med lat 9.90s (~0.001870 USD / logical req)</a:t>
             </a:r>
           </a:p>
           <a:p xmlns:a="http://schemas.openxmlformats.org/drawingml/2006/main">
@@ -12878,7 +13244,7 @@
               </a:defRPr>
             </a:pPr>
             <a:r>
-              <a:t>  • Giữ chỗ thận trọng tạm thời: $0.05264010 USD (prior_pilot_provisional_hold_usd).</a:t>
+              <a:t>  • Giữ chỗ thận trọng tạm thời: 0.05264010 USD (prior_pilot_provisional_hold_usd).</a:t>
             </a:r>
           </a:p>
           <a:p xmlns:a="http://schemas.openxmlformats.org/drawingml/2006/main">
@@ -12897,7 +13263,7 @@
               </a:defRPr>
             </a:pPr>
             <a:r>
-              <a:t>  • Dự báo chuẩn tắc tập TEST (Canonical forecast): $8.20 – $8.99 USD cho 6,400 requests.</a:t>
+              <a:t>  • Hạch toán điều kiện chuẩn (Canonical Total): 8.50 USD | Net Remaining: 11.44 USD.</a:t>
             </a:r>
           </a:p>
           <a:p xmlns:a="http://schemas.openxmlformats.org/drawingml/2006/main">
@@ -12916,7 +13282,7 @@
               </a:defRPr>
             </a:pPr>
             <a:r>
-              <a:t>  • Trần ngân sách đóng băng cứng (Hard budget cap): $19.99 USD (hard_budget_limit_usd).</a:t>
+              <a:t>  • Trần ngân sách đóng băng cứng: 19.99 USD (hard_budget_limit_usd).</a:t>
             </a:r>
           </a:p>
         </p:txBody>
@@ -12930,7 +13296,7 @@
           <p:nvPr/>
         </p:nvPicPr>
         <p:blipFill>
-          <a:blip xmlns:r="http://schemas.openxmlformats.org/officeDocument/2006/relationships" xmlns:a="http://schemas.openxmlformats.org/drawingml/2006/main" r:embed="Rada20eb592c24666"/>
+          <a:blip xmlns:r="http://schemas.openxmlformats.org/officeDocument/2006/relationships" xmlns:a="http://schemas.openxmlformats.org/drawingml/2006/main" r:embed="Rd1920b8d366045d7"/>
           <a:stretch xmlns:a="http://schemas.openxmlformats.org/drawingml/2006/main">
             <a:fillRect l="0" t="0" r="0" b="0"/>
           </a:stretch>
@@ -12950,7 +13316,7 @@
           <p:cNvPr id="9" name="Rounded Rectangle 8">
             <a:extLst xmlns:a="http://schemas.openxmlformats.org/drawingml/2006/main">
               <a:ext uri="{FF2B5EF4-FFF2-40B4-BE49-F238E27FC236}">
-                <a16:creationId xmlns:a16="http://schemas.microsoft.com/office/drawing/2014/main" id="{42E78E11-B910-4433-8494-A36D0E7DEF76}"/>
+                <a16:creationId xmlns:a16="http://schemas.microsoft.com/office/drawing/2014/main" id="{5E4D2763-03FE-4E8D-BC91-1A227BFF91DD}"/>
               </a:ext>
             </a:extLst>
           </p:cNvPr>
@@ -13005,7 +13371,7 @@
           <p:cNvPr id="10" name="TextBox 9">
             <a:extLst xmlns:a="http://schemas.openxmlformats.org/drawingml/2006/main">
               <a:ext uri="{FF2B5EF4-FFF2-40B4-BE49-F238E27FC236}">
-                <a16:creationId xmlns:a16="http://schemas.microsoft.com/office/drawing/2014/main" id="{591939A0-9F0F-487D-AC5A-87714AA6C3CE}"/>
+                <a16:creationId xmlns:a16="http://schemas.microsoft.com/office/drawing/2014/main" id="{4F1F517E-8CC7-4CD1-B2A3-D35B3B387BCE}"/>
               </a:ext>
             </a:extLst>
           </p:cNvPr>
@@ -13088,7 +13454,7 @@
     </p:spTree>
     <p:extLst>
       <p:ext uri="{BB962C8B-B14F-4D97-AF65-F5344CB8AC3E}">
-        <p14:creationId xmlns:p14="http://schemas.microsoft.com/office/powerpoint/2010/main" val="12290119"/>
+        <p14:creationId xmlns:p14="http://schemas.microsoft.com/office/powerpoint/2010/main" val="1229984318"/>
       </p:ext>
     </p:extLst>
   </p:cSld>

</xml_diff>

<commit_message>
fix(presentation): remediate slide 8 concise table layout and slide 9 provenance separation
- Replace overflowing red block on Slide 8 with concise, clean 5-row table in readable dark font
- Include columns for Condition, Accuracy, Macro-F1, and Delta vs No-RAG, fitting well within 720px canvas
- Move verbose secondary stats (CI95, McNemar, concordance counts) into Speaker Notes (nt/fu1gfa1s)
- Demarcate Slide 9 into historical DEV pilot baseline (20 requests) vs diagnostic fixture projection (N=718)
- Update subtitle, headings, and forecast summaries to avoid hybrid mode confusion
- Re-export candidate deck fixture_populated_slides.pptx and 12 QA slide PNGs
- Update deck_updater_fixture_audit.json with new file SHAs and metrics
</commit_message>
<xml_diff>
--- a/reports/evidence/fixture_populated_slides.pptx
+++ b/reports/evidence/fixture_populated_slides.pptx
@@ -2,24 +2,24 @@
 <file path=ppt/presentation.xml><?xml version="1.0" encoding="utf-8"?>
 <p:presentation xmlns:p="http://schemas.openxmlformats.org/presentationml/2006/main">
   <p:sldMasterIdLst>
-    <p:sldMasterId xmlns:r="http://schemas.openxmlformats.org/officeDocument/2006/relationships" id="2147483648" r:id="R7cee1c6823394d87"/>
+    <p:sldMasterId xmlns:r="http://schemas.openxmlformats.org/officeDocument/2006/relationships" id="2147483648" r:id="Re83606f4b3cd4a6c"/>
   </p:sldMasterIdLst>
   <p:notesMasterIdLst>
-    <p:notesMasterId xmlns:r="http://schemas.openxmlformats.org/officeDocument/2006/relationships" r:id="Ra2416668a3fe44a7"/>
+    <p:notesMasterId xmlns:r="http://schemas.openxmlformats.org/officeDocument/2006/relationships" r:id="Rb98fb851a9004693"/>
   </p:notesMasterIdLst>
   <p:sldIdLst>
-    <p:sldId xmlns:r="http://schemas.openxmlformats.org/officeDocument/2006/relationships" id="256" r:id="Ra7af2306692c4af8"/>
-    <p:sldId xmlns:r="http://schemas.openxmlformats.org/officeDocument/2006/relationships" id="257" r:id="Rd74caa48f91b49d3"/>
-    <p:sldId xmlns:r="http://schemas.openxmlformats.org/officeDocument/2006/relationships" id="258" r:id="R254c4558eb324a0a"/>
-    <p:sldId xmlns:r="http://schemas.openxmlformats.org/officeDocument/2006/relationships" id="259" r:id="R2f725f3658054dd6"/>
-    <p:sldId xmlns:r="http://schemas.openxmlformats.org/officeDocument/2006/relationships" id="260" r:id="R4a95e85158f04dea"/>
-    <p:sldId xmlns:r="http://schemas.openxmlformats.org/officeDocument/2006/relationships" id="261" r:id="Rca78a2290d9c47ee"/>
-    <p:sldId xmlns:r="http://schemas.openxmlformats.org/officeDocument/2006/relationships" id="262" r:id="R9da1207a6e1c405e"/>
-    <p:sldId xmlns:r="http://schemas.openxmlformats.org/officeDocument/2006/relationships" id="263" r:id="R4260f777b7fd4d7f"/>
-    <p:sldId xmlns:r="http://schemas.openxmlformats.org/officeDocument/2006/relationships" id="264" r:id="R7c94c5b2077c49f0"/>
-    <p:sldId xmlns:r="http://schemas.openxmlformats.org/officeDocument/2006/relationships" id="265" r:id="R724e469a62954b76"/>
-    <p:sldId xmlns:r="http://schemas.openxmlformats.org/officeDocument/2006/relationships" id="266" r:id="R1b79a6bba45b4f8a"/>
-    <p:sldId xmlns:r="http://schemas.openxmlformats.org/officeDocument/2006/relationships" id="267" r:id="R571ac6cdeaf64aa7"/>
+    <p:sldId xmlns:r="http://schemas.openxmlformats.org/officeDocument/2006/relationships" id="256" r:id="Rc72db5862dc744cd"/>
+    <p:sldId xmlns:r="http://schemas.openxmlformats.org/officeDocument/2006/relationships" id="257" r:id="R847ef263d8c84ea2"/>
+    <p:sldId xmlns:r="http://schemas.openxmlformats.org/officeDocument/2006/relationships" id="258" r:id="R421d86f0cbf54a3f"/>
+    <p:sldId xmlns:r="http://schemas.openxmlformats.org/officeDocument/2006/relationships" id="259" r:id="Ra0ee6b1df59c400b"/>
+    <p:sldId xmlns:r="http://schemas.openxmlformats.org/officeDocument/2006/relationships" id="260" r:id="R9c40e427af924bf6"/>
+    <p:sldId xmlns:r="http://schemas.openxmlformats.org/officeDocument/2006/relationships" id="261" r:id="Ra1bfcc8411cf4d6f"/>
+    <p:sldId xmlns:r="http://schemas.openxmlformats.org/officeDocument/2006/relationships" id="262" r:id="Rc581e41578ab494f"/>
+    <p:sldId xmlns:r="http://schemas.openxmlformats.org/officeDocument/2006/relationships" id="263" r:id="R62576bcb9b6a4eed"/>
+    <p:sldId xmlns:r="http://schemas.openxmlformats.org/officeDocument/2006/relationships" id="264" r:id="Rd321c64c8e64467a"/>
+    <p:sldId xmlns:r="http://schemas.openxmlformats.org/officeDocument/2006/relationships" id="265" r:id="R60c66094471d4eb3"/>
+    <p:sldId xmlns:r="http://schemas.openxmlformats.org/officeDocument/2006/relationships" id="266" r:id="R75481b05ea3b4d2d"/>
+    <p:sldId xmlns:r="http://schemas.openxmlformats.org/officeDocument/2006/relationships" id="267" r:id="Rb613b301df2d45e1"/>
   </p:sldIdLst>
   <p:sldSz cx="12191695" cy="6858000"/>
   <p:notesSz cx="6858000" cy="9144000"/>
@@ -1433,6 +1433,11 @@
               <a:t>Bằng chứng dự án: reports/experiment_protocol_v1.md (D2e, D2f, D2h, D2i; SHA-256: d3bf3d31...); tests/test_experiment_evaluation.py (94 tests pass).</a:t>
             </a:r>
           </a:p>
+          <a:p xmlns:a="http://schemas.openxmlformats.org/drawingml/2006/main">
+            <a:r>
+              <a:t>[DIAGNOSTIC TEST FIXTURE STATS] Khoảng tin cậy 95% Bootstrap (B=1000): no_rag=[0.3500, 0.6500], rag_k1=[0.3500, 0.6500], rag_k3=[0.3500, 0.6500], rag_k5=[0.3500, 0.6500], rag_k10=[0.3500, 0.6500]. Đo lường phân rã lỗi D2i độc lập: Wrong Class Rate=0.3333, Overlaps (Miss &amp; Wrong=0, Miss &amp; Prov=0, Miss &amp; Parse=0, Miss &amp; Inval=0).</a:t>
+            </a:r>
+          </a:p>
         </p:txBody>
       </p:sp>
       <p:sp>
@@ -1525,7 +1530,7 @@
           </a:p>
           <a:p xmlns:a="http://schemas.openxmlformats.org/drawingml/2006/main">
             <a:r>
-              <a:t>4. Phân biệt rõ khoản giữ chỗ thận trọng tạm thời ($0.05264010 USD prior_pilot_provisional_hold_usd), dự báo chuẩn tắc tập TEST ($8.20 – $8.99 USD cho 6,400 requests), và trần ngân sách đóng băng cứng $19.99 USD (hard_budget_limit_usd).</a:t>
+              <a:t>4. Phân biệt rõ khoản giữ chỗ thận trọng tạm thời ($0.05264010 USD prior_pilot_provisional_hold_usd), dự báo chuẩn tắc tập TEST (hạch toán điều kiện chuẩn $8.50 USD (dự báo 6,400 requests) [DIAGNOSTIC FIXTURE PROJECTION]), và trần ngân sách đóng băng cứng $19.99 USD (hard_budget_limit_usd).</a:t>
             </a:r>
           </a:p>
           <a:p xmlns:a="http://schemas.openxmlformats.org/drawingml/2006/main">
@@ -1577,7 +1582,7 @@
           <p:cNvPr id="2" name="Title 1">
             <a:extLst xmlns:a="http://schemas.openxmlformats.org/drawingml/2006/main">
               <a:ext uri="{FF2B5EF4-FFF2-40B4-BE49-F238E27FC236}">
-                <a16:creationId xmlns:a16="http://schemas.microsoft.com/office/drawing/2014/main" id="{F9DA5CCA-EA78-4031-9D73-0552F79BBAE6}"/>
+                <a16:creationId xmlns:a16="http://schemas.microsoft.com/office/drawing/2014/main" id="{F44F11A1-D9D1-40B6-898B-E87A0B75CFDC}"/>
               </a:ext>
             </a:extLst>
           </p:cNvPr>
@@ -1610,7 +1615,7 @@
           <p:cNvPr id="3" name="Subtitle 2">
             <a:extLst xmlns:a="http://schemas.openxmlformats.org/drawingml/2006/main">
               <a:ext uri="{FF2B5EF4-FFF2-40B4-BE49-F238E27FC236}">
-                <a16:creationId xmlns:a16="http://schemas.microsoft.com/office/drawing/2014/main" id="{19BB409A-C2F9-4FB0-8AA0-B4B9C228E823}"/>
+                <a16:creationId xmlns:a16="http://schemas.microsoft.com/office/drawing/2014/main" id="{930DB4F5-6C16-4C90-9478-D11BE04AD3CF}"/>
               </a:ext>
             </a:extLst>
           </p:cNvPr>
@@ -1734,7 +1739,7 @@
           <p:cNvPr id="4" name="Date Placeholder 3">
             <a:extLst xmlns:a="http://schemas.openxmlformats.org/drawingml/2006/main">
               <a:ext uri="{FF2B5EF4-FFF2-40B4-BE49-F238E27FC236}">
-                <a16:creationId xmlns:a16="http://schemas.microsoft.com/office/drawing/2014/main" id="{B795B3B7-FE2B-49B6-B889-9C4E1EF39834}"/>
+                <a16:creationId xmlns:a16="http://schemas.microsoft.com/office/drawing/2014/main" id="{2364297E-B181-4E7C-BDED-C296B0D1BAF5}"/>
               </a:ext>
             </a:extLst>
           </p:cNvPr>
@@ -1762,7 +1767,7 @@
           <p:cNvPr id="5" name="Footer Placeholder 4">
             <a:extLst xmlns:a="http://schemas.openxmlformats.org/drawingml/2006/main">
               <a:ext uri="{FF2B5EF4-FFF2-40B4-BE49-F238E27FC236}">
-                <a16:creationId xmlns:a16="http://schemas.microsoft.com/office/drawing/2014/main" id="{60D51D36-2399-4278-8013-E7F2535656E2}"/>
+                <a16:creationId xmlns:a16="http://schemas.microsoft.com/office/drawing/2014/main" id="{7BF34AB5-9A20-4CA0-94B6-782FB47F22B2}"/>
               </a:ext>
             </a:extLst>
           </p:cNvPr>
@@ -1787,7 +1792,7 @@
           <p:cNvPr id="6" name="Slide Number Placeholder 5">
             <a:extLst xmlns:a="http://schemas.openxmlformats.org/drawingml/2006/main">
               <a:ext uri="{FF2B5EF4-FFF2-40B4-BE49-F238E27FC236}">
-                <a16:creationId xmlns:a16="http://schemas.microsoft.com/office/drawing/2014/main" id="{70B92285-AB39-490B-84D3-AD549ED76BB9}"/>
+                <a16:creationId xmlns:a16="http://schemas.microsoft.com/office/drawing/2014/main" id="{87126F1A-131C-41AF-BA89-AFF5A89008BB}"/>
               </a:ext>
             </a:extLst>
           </p:cNvPr>
@@ -1832,7 +1837,7 @@
           <p:cNvPr id="2" name="Title 1">
             <a:extLst xmlns:a="http://schemas.openxmlformats.org/drawingml/2006/main">
               <a:ext uri="{FF2B5EF4-FFF2-40B4-BE49-F238E27FC236}">
-                <a16:creationId xmlns:a16="http://schemas.microsoft.com/office/drawing/2014/main" id="{FC0B20C2-F336-4475-8B13-B11457B3FFD2}"/>
+                <a16:creationId xmlns:a16="http://schemas.microsoft.com/office/drawing/2014/main" id="{111D248A-AF11-4C73-A72A-C5BEDE797486}"/>
               </a:ext>
             </a:extLst>
           </p:cNvPr>
@@ -1860,7 +1865,7 @@
           <p:cNvPr id="3" name="Vertical Text Placeholder 2">
             <a:extLst xmlns:a="http://schemas.openxmlformats.org/drawingml/2006/main">
               <a:ext uri="{FF2B5EF4-FFF2-40B4-BE49-F238E27FC236}">
-                <a16:creationId xmlns:a16="http://schemas.microsoft.com/office/drawing/2014/main" id="{B841D65A-AEDB-4068-BA32-56A721BDDA10}"/>
+                <a16:creationId xmlns:a16="http://schemas.microsoft.com/office/drawing/2014/main" id="{E4921C64-FCEE-4DB9-AE36-6031A0A3236C}"/>
               </a:ext>
             </a:extLst>
           </p:cNvPr>
@@ -1923,7 +1928,7 @@
           <p:cNvPr id="4" name="Date Placeholder 3">
             <a:extLst xmlns:a="http://schemas.openxmlformats.org/drawingml/2006/main">
               <a:ext uri="{FF2B5EF4-FFF2-40B4-BE49-F238E27FC236}">
-                <a16:creationId xmlns:a16="http://schemas.microsoft.com/office/drawing/2014/main" id="{3129638E-1C98-43F1-9D14-983C2C014E88}"/>
+                <a16:creationId xmlns:a16="http://schemas.microsoft.com/office/drawing/2014/main" id="{27DB5FD5-9099-452B-BA67-ABC28FF9937A}"/>
               </a:ext>
             </a:extLst>
           </p:cNvPr>
@@ -1951,7 +1956,7 @@
           <p:cNvPr id="5" name="Footer Placeholder 4">
             <a:extLst xmlns:a="http://schemas.openxmlformats.org/drawingml/2006/main">
               <a:ext uri="{FF2B5EF4-FFF2-40B4-BE49-F238E27FC236}">
-                <a16:creationId xmlns:a16="http://schemas.microsoft.com/office/drawing/2014/main" id="{EBCBB96D-00A3-4182-AC99-C4AFD7861632}"/>
+                <a16:creationId xmlns:a16="http://schemas.microsoft.com/office/drawing/2014/main" id="{2DDF249D-995E-4AD9-B1B6-3620E2DD0BC2}"/>
               </a:ext>
             </a:extLst>
           </p:cNvPr>
@@ -1976,7 +1981,7 @@
           <p:cNvPr id="6" name="Slide Number Placeholder 5">
             <a:extLst xmlns:a="http://schemas.openxmlformats.org/drawingml/2006/main">
               <a:ext uri="{FF2B5EF4-FFF2-40B4-BE49-F238E27FC236}">
-                <a16:creationId xmlns:a16="http://schemas.microsoft.com/office/drawing/2014/main" id="{5FFFFC04-4E85-4F48-88FB-7F6CDE8FFE2B}"/>
+                <a16:creationId xmlns:a16="http://schemas.microsoft.com/office/drawing/2014/main" id="{E4D78CB9-DD79-4209-A95D-C2F80591BFC4}"/>
               </a:ext>
             </a:extLst>
           </p:cNvPr>
@@ -2021,7 +2026,7 @@
           <p:cNvPr id="2" name="Vertical Title 1">
             <a:extLst xmlns:a="http://schemas.openxmlformats.org/drawingml/2006/main">
               <a:ext uri="{FF2B5EF4-FFF2-40B4-BE49-F238E27FC236}">
-                <a16:creationId xmlns:a16="http://schemas.microsoft.com/office/drawing/2014/main" id="{6C77F7A5-C1F9-40A0-87F6-EEDE73A32E5A}"/>
+                <a16:creationId xmlns:a16="http://schemas.microsoft.com/office/drawing/2014/main" id="{5C960FBB-342A-475B-A3CB-478F84E93E53}"/>
               </a:ext>
             </a:extLst>
           </p:cNvPr>
@@ -2054,7 +2059,7 @@
           <p:cNvPr id="3" name="Vertical Text Placeholder 2">
             <a:extLst xmlns:a="http://schemas.openxmlformats.org/drawingml/2006/main">
               <a:ext uri="{FF2B5EF4-FFF2-40B4-BE49-F238E27FC236}">
-                <a16:creationId xmlns:a16="http://schemas.microsoft.com/office/drawing/2014/main" id="{3870C724-5260-4B31-93FA-A3D59056511D}"/>
+                <a16:creationId xmlns:a16="http://schemas.microsoft.com/office/drawing/2014/main" id="{5FC16BEA-C5D8-4375-803D-3AB575F7C380}"/>
               </a:ext>
             </a:extLst>
           </p:cNvPr>
@@ -2122,7 +2127,7 @@
           <p:cNvPr id="4" name="Date Placeholder 3">
             <a:extLst xmlns:a="http://schemas.openxmlformats.org/drawingml/2006/main">
               <a:ext uri="{FF2B5EF4-FFF2-40B4-BE49-F238E27FC236}">
-                <a16:creationId xmlns:a16="http://schemas.microsoft.com/office/drawing/2014/main" id="{6B57E13C-39E7-4676-9A74-B2774572B013}"/>
+                <a16:creationId xmlns:a16="http://schemas.microsoft.com/office/drawing/2014/main" id="{FFF58B34-5AF2-4F6E-A67E-67DD445BBF5E}"/>
               </a:ext>
             </a:extLst>
           </p:cNvPr>
@@ -2150,7 +2155,7 @@
           <p:cNvPr id="5" name="Footer Placeholder 4">
             <a:extLst xmlns:a="http://schemas.openxmlformats.org/drawingml/2006/main">
               <a:ext uri="{FF2B5EF4-FFF2-40B4-BE49-F238E27FC236}">
-                <a16:creationId xmlns:a16="http://schemas.microsoft.com/office/drawing/2014/main" id="{3A0C92E4-54E5-4082-8FE5-43822052E3E0}"/>
+                <a16:creationId xmlns:a16="http://schemas.microsoft.com/office/drawing/2014/main" id="{F2B944A7-24B6-4CE7-95E8-126E95149D9E}"/>
               </a:ext>
             </a:extLst>
           </p:cNvPr>
@@ -2175,7 +2180,7 @@
           <p:cNvPr id="6" name="Slide Number Placeholder 5">
             <a:extLst xmlns:a="http://schemas.openxmlformats.org/drawingml/2006/main">
               <a:ext uri="{FF2B5EF4-FFF2-40B4-BE49-F238E27FC236}">
-                <a16:creationId xmlns:a16="http://schemas.microsoft.com/office/drawing/2014/main" id="{352820C3-61BC-41A5-A209-4C282B022651}"/>
+                <a16:creationId xmlns:a16="http://schemas.microsoft.com/office/drawing/2014/main" id="{D07A60E4-F8A9-46EC-921D-0500DD3FE713}"/>
               </a:ext>
             </a:extLst>
           </p:cNvPr>
@@ -2220,7 +2225,7 @@
           <p:cNvPr id="2" name="Title 1">
             <a:extLst xmlns:a="http://schemas.openxmlformats.org/drawingml/2006/main">
               <a:ext uri="{FF2B5EF4-FFF2-40B4-BE49-F238E27FC236}">
-                <a16:creationId xmlns:a16="http://schemas.microsoft.com/office/drawing/2014/main" id="{24E4A1B5-BCA2-4DAC-869F-ECD99F2D1B4F}"/>
+                <a16:creationId xmlns:a16="http://schemas.microsoft.com/office/drawing/2014/main" id="{803F5ED4-660F-408A-91E0-BDF4E256A258}"/>
               </a:ext>
             </a:extLst>
           </p:cNvPr>
@@ -2248,7 +2253,7 @@
           <p:cNvPr id="3" name="Content Placeholder 2">
             <a:extLst xmlns:a="http://schemas.openxmlformats.org/drawingml/2006/main">
               <a:ext uri="{FF2B5EF4-FFF2-40B4-BE49-F238E27FC236}">
-                <a16:creationId xmlns:a16="http://schemas.microsoft.com/office/drawing/2014/main" id="{753D367C-C51F-4599-AD3E-7D0F59072ABE}"/>
+                <a16:creationId xmlns:a16="http://schemas.microsoft.com/office/drawing/2014/main" id="{B285F96D-8E36-4D7E-A86F-FB6C84EEC949}"/>
               </a:ext>
             </a:extLst>
           </p:cNvPr>
@@ -2311,7 +2316,7 @@
           <p:cNvPr id="4" name="Date Placeholder 3">
             <a:extLst xmlns:a="http://schemas.openxmlformats.org/drawingml/2006/main">
               <a:ext uri="{FF2B5EF4-FFF2-40B4-BE49-F238E27FC236}">
-                <a16:creationId xmlns:a16="http://schemas.microsoft.com/office/drawing/2014/main" id="{738ACF17-65E1-4465-A73B-CC1BCE9C5B86}"/>
+                <a16:creationId xmlns:a16="http://schemas.microsoft.com/office/drawing/2014/main" id="{63008C74-E11C-4D9E-884F-F7A8A6ABD922}"/>
               </a:ext>
             </a:extLst>
           </p:cNvPr>
@@ -2339,7 +2344,7 @@
           <p:cNvPr id="5" name="Footer Placeholder 4">
             <a:extLst xmlns:a="http://schemas.openxmlformats.org/drawingml/2006/main">
               <a:ext uri="{FF2B5EF4-FFF2-40B4-BE49-F238E27FC236}">
-                <a16:creationId xmlns:a16="http://schemas.microsoft.com/office/drawing/2014/main" id="{DCF0738C-3456-4B4D-B8F8-89A0B4FC2F88}"/>
+                <a16:creationId xmlns:a16="http://schemas.microsoft.com/office/drawing/2014/main" id="{C9CB7494-8C35-4104-8C7D-35000602C07C}"/>
               </a:ext>
             </a:extLst>
           </p:cNvPr>
@@ -2364,7 +2369,7 @@
           <p:cNvPr id="6" name="Slide Number Placeholder 5">
             <a:extLst xmlns:a="http://schemas.openxmlformats.org/drawingml/2006/main">
               <a:ext uri="{FF2B5EF4-FFF2-40B4-BE49-F238E27FC236}">
-                <a16:creationId xmlns:a16="http://schemas.microsoft.com/office/drawing/2014/main" id="{63CE349C-E386-4FE4-85DF-635982394CC4}"/>
+                <a16:creationId xmlns:a16="http://schemas.microsoft.com/office/drawing/2014/main" id="{B0046C53-9EB5-458C-B52B-73CEF7421063}"/>
               </a:ext>
             </a:extLst>
           </p:cNvPr>
@@ -2409,7 +2414,7 @@
           <p:cNvPr id="2" name="Title 1">
             <a:extLst xmlns:a="http://schemas.openxmlformats.org/drawingml/2006/main">
               <a:ext uri="{FF2B5EF4-FFF2-40B4-BE49-F238E27FC236}">
-                <a16:creationId xmlns:a16="http://schemas.microsoft.com/office/drawing/2014/main" id="{391A7473-B3CE-4B50-B543-FA316761A063}"/>
+                <a16:creationId xmlns:a16="http://schemas.microsoft.com/office/drawing/2014/main" id="{18533217-2BA5-454A-801E-72AED4AC6A05}"/>
               </a:ext>
             </a:extLst>
           </p:cNvPr>
@@ -2447,7 +2452,7 @@
           <p:cNvPr id="3" name="Text Placeholder 2">
             <a:extLst xmlns:a="http://schemas.openxmlformats.org/drawingml/2006/main">
               <a:ext uri="{FF2B5EF4-FFF2-40B4-BE49-F238E27FC236}">
-                <a16:creationId xmlns:a16="http://schemas.microsoft.com/office/drawing/2014/main" id="{43154A4E-E1EB-49E4-AB50-E78B75B6CC2A}"/>
+                <a16:creationId xmlns:a16="http://schemas.microsoft.com/office/drawing/2014/main" id="{46724E04-F1A3-471E-BADA-8EB3FCB4E579}"/>
               </a:ext>
             </a:extLst>
           </p:cNvPr>
@@ -2573,7 +2578,7 @@
           <p:cNvPr id="4" name="Date Placeholder 3">
             <a:extLst xmlns:a="http://schemas.openxmlformats.org/drawingml/2006/main">
               <a:ext uri="{FF2B5EF4-FFF2-40B4-BE49-F238E27FC236}">
-                <a16:creationId xmlns:a16="http://schemas.microsoft.com/office/drawing/2014/main" id="{4D20F37B-A41F-4453-BE8A-F48B2FD17537}"/>
+                <a16:creationId xmlns:a16="http://schemas.microsoft.com/office/drawing/2014/main" id="{4EE7551C-5DC5-44E4-83F8-B3A556CF17C4}"/>
               </a:ext>
             </a:extLst>
           </p:cNvPr>
@@ -2601,7 +2606,7 @@
           <p:cNvPr id="5" name="Footer Placeholder 4">
             <a:extLst xmlns:a="http://schemas.openxmlformats.org/drawingml/2006/main">
               <a:ext uri="{FF2B5EF4-FFF2-40B4-BE49-F238E27FC236}">
-                <a16:creationId xmlns:a16="http://schemas.microsoft.com/office/drawing/2014/main" id="{C636DA3E-B9F2-41E4-ABF9-F2E7573C70EF}"/>
+                <a16:creationId xmlns:a16="http://schemas.microsoft.com/office/drawing/2014/main" id="{0918039C-14A0-4DA5-AA09-558494AD491B}"/>
               </a:ext>
             </a:extLst>
           </p:cNvPr>
@@ -2626,7 +2631,7 @@
           <p:cNvPr id="6" name="Slide Number Placeholder 5">
             <a:extLst xmlns:a="http://schemas.openxmlformats.org/drawingml/2006/main">
               <a:ext uri="{FF2B5EF4-FFF2-40B4-BE49-F238E27FC236}">
-                <a16:creationId xmlns:a16="http://schemas.microsoft.com/office/drawing/2014/main" id="{37455C70-17F0-4849-A404-8566E814A6E3}"/>
+                <a16:creationId xmlns:a16="http://schemas.microsoft.com/office/drawing/2014/main" id="{CD912306-96C3-4E48-A525-AFCC36EAB5A5}"/>
               </a:ext>
             </a:extLst>
           </p:cNvPr>
@@ -2671,7 +2676,7 @@
           <p:cNvPr id="2" name="Title 1">
             <a:extLst xmlns:a="http://schemas.openxmlformats.org/drawingml/2006/main">
               <a:ext uri="{FF2B5EF4-FFF2-40B4-BE49-F238E27FC236}">
-                <a16:creationId xmlns:a16="http://schemas.microsoft.com/office/drawing/2014/main" id="{C7D2D7A8-3141-4807-A9F0-4B848D847234}"/>
+                <a16:creationId xmlns:a16="http://schemas.microsoft.com/office/drawing/2014/main" id="{CA0AE7F1-3363-4D74-9B78-EF2B1D7D6A2E}"/>
               </a:ext>
             </a:extLst>
           </p:cNvPr>
@@ -2699,7 +2704,7 @@
           <p:cNvPr id="3" name="Content Placeholder 2">
             <a:extLst xmlns:a="http://schemas.openxmlformats.org/drawingml/2006/main">
               <a:ext uri="{FF2B5EF4-FFF2-40B4-BE49-F238E27FC236}">
-                <a16:creationId xmlns:a16="http://schemas.microsoft.com/office/drawing/2014/main" id="{0FBA10AA-CACB-45D8-9A56-71563A20613B}"/>
+                <a16:creationId xmlns:a16="http://schemas.microsoft.com/office/drawing/2014/main" id="{84E3B196-8AF3-4E16-B832-D6A52E21AA27}"/>
               </a:ext>
             </a:extLst>
           </p:cNvPr>
@@ -2804,7 +2809,7 @@
           <p:cNvPr id="4" name="Content Placeholder 3">
             <a:extLst xmlns:a="http://schemas.openxmlformats.org/drawingml/2006/main">
               <a:ext uri="{FF2B5EF4-FFF2-40B4-BE49-F238E27FC236}">
-                <a16:creationId xmlns:a16="http://schemas.microsoft.com/office/drawing/2014/main" id="{8189375D-8C49-4840-AC8F-2FCCDF185DD4}"/>
+                <a16:creationId xmlns:a16="http://schemas.microsoft.com/office/drawing/2014/main" id="{0E2382F8-C4EE-40C4-83D1-1775F65ACE29}"/>
               </a:ext>
             </a:extLst>
           </p:cNvPr>
@@ -2909,7 +2914,7 @@
           <p:cNvPr id="5" name="Date Placeholder 4">
             <a:extLst xmlns:a="http://schemas.openxmlformats.org/drawingml/2006/main">
               <a:ext uri="{FF2B5EF4-FFF2-40B4-BE49-F238E27FC236}">
-                <a16:creationId xmlns:a16="http://schemas.microsoft.com/office/drawing/2014/main" id="{A1E705D8-EF4D-4D1B-95C5-3D68EF3E57A3}"/>
+                <a16:creationId xmlns:a16="http://schemas.microsoft.com/office/drawing/2014/main" id="{74D76EB9-61C9-4774-A4BE-CB31AF7A1743}"/>
               </a:ext>
             </a:extLst>
           </p:cNvPr>
@@ -2937,7 +2942,7 @@
           <p:cNvPr id="6" name="Footer Placeholder 5">
             <a:extLst xmlns:a="http://schemas.openxmlformats.org/drawingml/2006/main">
               <a:ext uri="{FF2B5EF4-FFF2-40B4-BE49-F238E27FC236}">
-                <a16:creationId xmlns:a16="http://schemas.microsoft.com/office/drawing/2014/main" id="{3A04959D-E4AE-4CD7-BDC8-EB006D108012}"/>
+                <a16:creationId xmlns:a16="http://schemas.microsoft.com/office/drawing/2014/main" id="{54969EF2-40FB-4F00-8CA4-3569D46160F7}"/>
               </a:ext>
             </a:extLst>
           </p:cNvPr>
@@ -2962,7 +2967,7 @@
           <p:cNvPr id="7" name="Slide Number Placeholder 6">
             <a:extLst xmlns:a="http://schemas.openxmlformats.org/drawingml/2006/main">
               <a:ext uri="{FF2B5EF4-FFF2-40B4-BE49-F238E27FC236}">
-                <a16:creationId xmlns:a16="http://schemas.microsoft.com/office/drawing/2014/main" id="{6ED017F7-9AAC-4EA3-B13B-301A7C105760}"/>
+                <a16:creationId xmlns:a16="http://schemas.microsoft.com/office/drawing/2014/main" id="{91894F93-5FFB-4396-A9C4-1EC45C52364F}"/>
               </a:ext>
             </a:extLst>
           </p:cNvPr>
@@ -3007,7 +3012,7 @@
           <p:cNvPr id="2" name="Title 1">
             <a:extLst xmlns:a="http://schemas.openxmlformats.org/drawingml/2006/main">
               <a:ext uri="{FF2B5EF4-FFF2-40B4-BE49-F238E27FC236}">
-                <a16:creationId xmlns:a16="http://schemas.microsoft.com/office/drawing/2014/main" id="{B73E4511-F503-4B48-B8EE-6B17183C6793}"/>
+                <a16:creationId xmlns:a16="http://schemas.microsoft.com/office/drawing/2014/main" id="{B6BCBE43-05DB-4482-8F13-26FF27B33BFC}"/>
               </a:ext>
             </a:extLst>
           </p:cNvPr>
@@ -3040,7 +3045,7 @@
           <p:cNvPr id="3" name="Text Placeholder 2">
             <a:extLst xmlns:a="http://schemas.openxmlformats.org/drawingml/2006/main">
               <a:ext uri="{FF2B5EF4-FFF2-40B4-BE49-F238E27FC236}">
-                <a16:creationId xmlns:a16="http://schemas.microsoft.com/office/drawing/2014/main" id="{AB4C551B-0350-4040-8C00-8BCA4062FFF8}"/>
+                <a16:creationId xmlns:a16="http://schemas.microsoft.com/office/drawing/2014/main" id="{1D684AD9-C775-446C-B73D-8E05C78741B9}"/>
               </a:ext>
             </a:extLst>
           </p:cNvPr>
@@ -3112,7 +3117,7 @@
           <p:cNvPr id="4" name="Content Placeholder 3">
             <a:extLst xmlns:a="http://schemas.openxmlformats.org/drawingml/2006/main">
               <a:ext uri="{FF2B5EF4-FFF2-40B4-BE49-F238E27FC236}">
-                <a16:creationId xmlns:a16="http://schemas.microsoft.com/office/drawing/2014/main" id="{F0DF20D8-2783-4830-98B4-2B8A435945E3}"/>
+                <a16:creationId xmlns:a16="http://schemas.microsoft.com/office/drawing/2014/main" id="{735C2CAD-5DDF-4A9A-A4BA-D09860F9034A}"/>
               </a:ext>
             </a:extLst>
           </p:cNvPr>
@@ -3217,7 +3222,7 @@
           <p:cNvPr id="5" name="Text Placeholder 4">
             <a:extLst xmlns:a="http://schemas.openxmlformats.org/drawingml/2006/main">
               <a:ext uri="{FF2B5EF4-FFF2-40B4-BE49-F238E27FC236}">
-                <a16:creationId xmlns:a16="http://schemas.microsoft.com/office/drawing/2014/main" id="{16DAFA06-5981-4A6A-BCB9-D8533DA2405C}"/>
+                <a16:creationId xmlns:a16="http://schemas.microsoft.com/office/drawing/2014/main" id="{BF80CB5B-E209-43DE-BE45-F4FBA700C3E5}"/>
               </a:ext>
             </a:extLst>
           </p:cNvPr>
@@ -3289,7 +3294,7 @@
           <p:cNvPr id="6" name="Content Placeholder 5">
             <a:extLst xmlns:a="http://schemas.openxmlformats.org/drawingml/2006/main">
               <a:ext uri="{FF2B5EF4-FFF2-40B4-BE49-F238E27FC236}">
-                <a16:creationId xmlns:a16="http://schemas.microsoft.com/office/drawing/2014/main" id="{15C8AA1E-B341-4598-837F-8951C6D9FA90}"/>
+                <a16:creationId xmlns:a16="http://schemas.microsoft.com/office/drawing/2014/main" id="{6FDAA89E-AEA2-402F-B648-8266F03E5107}"/>
               </a:ext>
             </a:extLst>
           </p:cNvPr>
@@ -3394,7 +3399,7 @@
           <p:cNvPr id="7" name="Date Placeholder 6">
             <a:extLst xmlns:a="http://schemas.openxmlformats.org/drawingml/2006/main">
               <a:ext uri="{FF2B5EF4-FFF2-40B4-BE49-F238E27FC236}">
-                <a16:creationId xmlns:a16="http://schemas.microsoft.com/office/drawing/2014/main" id="{A2A7B23B-0C6D-4889-BFA2-7B0C32AE926F}"/>
+                <a16:creationId xmlns:a16="http://schemas.microsoft.com/office/drawing/2014/main" id="{302DC3D8-49DB-4502-91F7-AA6E9E8D12D0}"/>
               </a:ext>
             </a:extLst>
           </p:cNvPr>
@@ -3422,7 +3427,7 @@
           <p:cNvPr id="8" name="Footer Placeholder 7">
             <a:extLst xmlns:a="http://schemas.openxmlformats.org/drawingml/2006/main">
               <a:ext uri="{FF2B5EF4-FFF2-40B4-BE49-F238E27FC236}">
-                <a16:creationId xmlns:a16="http://schemas.microsoft.com/office/drawing/2014/main" id="{96294E75-1ED2-4258-BCC2-79BC15773B9C}"/>
+                <a16:creationId xmlns:a16="http://schemas.microsoft.com/office/drawing/2014/main" id="{A742F8BD-180F-4201-A26E-A257E9476D69}"/>
               </a:ext>
             </a:extLst>
           </p:cNvPr>
@@ -3447,7 +3452,7 @@
           <p:cNvPr id="9" name="Slide Number Placeholder 8">
             <a:extLst xmlns:a="http://schemas.openxmlformats.org/drawingml/2006/main">
               <a:ext uri="{FF2B5EF4-FFF2-40B4-BE49-F238E27FC236}">
-                <a16:creationId xmlns:a16="http://schemas.microsoft.com/office/drawing/2014/main" id="{EC185C55-613E-490D-8F05-A90E1F642314}"/>
+                <a16:creationId xmlns:a16="http://schemas.microsoft.com/office/drawing/2014/main" id="{D61B3F9C-E723-4FD3-A91F-5449D8CFEF48}"/>
               </a:ext>
             </a:extLst>
           </p:cNvPr>
@@ -3492,7 +3497,7 @@
           <p:cNvPr id="2" name="Title 1">
             <a:extLst xmlns:a="http://schemas.openxmlformats.org/drawingml/2006/main">
               <a:ext uri="{FF2B5EF4-FFF2-40B4-BE49-F238E27FC236}">
-                <a16:creationId xmlns:a16="http://schemas.microsoft.com/office/drawing/2014/main" id="{45B11051-4B00-4A84-8E8C-8301CCF13FF7}"/>
+                <a16:creationId xmlns:a16="http://schemas.microsoft.com/office/drawing/2014/main" id="{3FCE87A5-F629-42B7-9729-469675D5A1E8}"/>
               </a:ext>
             </a:extLst>
           </p:cNvPr>
@@ -3520,7 +3525,7 @@
           <p:cNvPr id="3" name="Date Placeholder 2">
             <a:extLst xmlns:a="http://schemas.openxmlformats.org/drawingml/2006/main">
               <a:ext uri="{FF2B5EF4-FFF2-40B4-BE49-F238E27FC236}">
-                <a16:creationId xmlns:a16="http://schemas.microsoft.com/office/drawing/2014/main" id="{66580038-F531-4C80-9AF5-286B661DAF57}"/>
+                <a16:creationId xmlns:a16="http://schemas.microsoft.com/office/drawing/2014/main" id="{4F87B7AD-2A00-41DA-AB21-5CD3B535097E}"/>
               </a:ext>
             </a:extLst>
           </p:cNvPr>
@@ -3548,7 +3553,7 @@
           <p:cNvPr id="4" name="Footer Placeholder 3">
             <a:extLst xmlns:a="http://schemas.openxmlformats.org/drawingml/2006/main">
               <a:ext uri="{FF2B5EF4-FFF2-40B4-BE49-F238E27FC236}">
-                <a16:creationId xmlns:a16="http://schemas.microsoft.com/office/drawing/2014/main" id="{AF98CB20-2155-4A8D-A513-4716A8A2D2A9}"/>
+                <a16:creationId xmlns:a16="http://schemas.microsoft.com/office/drawing/2014/main" id="{660839C9-CFFA-495B-8757-645548BD1B1D}"/>
               </a:ext>
             </a:extLst>
           </p:cNvPr>
@@ -3573,7 +3578,7 @@
           <p:cNvPr id="5" name="Slide Number Placeholder 4">
             <a:extLst xmlns:a="http://schemas.openxmlformats.org/drawingml/2006/main">
               <a:ext uri="{FF2B5EF4-FFF2-40B4-BE49-F238E27FC236}">
-                <a16:creationId xmlns:a16="http://schemas.microsoft.com/office/drawing/2014/main" id="{3F01E39A-C8D6-41E8-91D4-602408199D6A}"/>
+                <a16:creationId xmlns:a16="http://schemas.microsoft.com/office/drawing/2014/main" id="{F668E14A-0FF8-4B31-AF04-8F7C79098C1B}"/>
               </a:ext>
             </a:extLst>
           </p:cNvPr>
@@ -3618,7 +3623,7 @@
           <p:cNvPr id="2" name="Date Placeholder 1">
             <a:extLst xmlns:a="http://schemas.openxmlformats.org/drawingml/2006/main">
               <a:ext uri="{FF2B5EF4-FFF2-40B4-BE49-F238E27FC236}">
-                <a16:creationId xmlns:a16="http://schemas.microsoft.com/office/drawing/2014/main" id="{7B415D65-C11B-4E90-B2BD-2562E6B2806D}"/>
+                <a16:creationId xmlns:a16="http://schemas.microsoft.com/office/drawing/2014/main" id="{61EC86E2-AAA0-4F88-8B6A-9740190C55D6}"/>
               </a:ext>
             </a:extLst>
           </p:cNvPr>
@@ -3646,7 +3651,7 @@
           <p:cNvPr id="3" name="Footer Placeholder 2">
             <a:extLst xmlns:a="http://schemas.openxmlformats.org/drawingml/2006/main">
               <a:ext uri="{FF2B5EF4-FFF2-40B4-BE49-F238E27FC236}">
-                <a16:creationId xmlns:a16="http://schemas.microsoft.com/office/drawing/2014/main" id="{25462E44-65B4-4C79-A39C-AD5B0EDC47CD}"/>
+                <a16:creationId xmlns:a16="http://schemas.microsoft.com/office/drawing/2014/main" id="{B0C9DD9B-0AB5-435E-A706-A6DB7098CBA8}"/>
               </a:ext>
             </a:extLst>
           </p:cNvPr>
@@ -3671,7 +3676,7 @@
           <p:cNvPr id="4" name="Slide Number Placeholder 3">
             <a:extLst xmlns:a="http://schemas.openxmlformats.org/drawingml/2006/main">
               <a:ext uri="{FF2B5EF4-FFF2-40B4-BE49-F238E27FC236}">
-                <a16:creationId xmlns:a16="http://schemas.microsoft.com/office/drawing/2014/main" id="{65654616-2434-459C-8B21-C24C022146C4}"/>
+                <a16:creationId xmlns:a16="http://schemas.microsoft.com/office/drawing/2014/main" id="{6866060F-F0C1-4D63-A14D-8183F490818F}"/>
               </a:ext>
             </a:extLst>
           </p:cNvPr>
@@ -3716,7 +3721,7 @@
           <p:cNvPr id="2" name="Title 1">
             <a:extLst xmlns:a="http://schemas.openxmlformats.org/drawingml/2006/main">
               <a:ext uri="{FF2B5EF4-FFF2-40B4-BE49-F238E27FC236}">
-                <a16:creationId xmlns:a16="http://schemas.microsoft.com/office/drawing/2014/main" id="{20CA77EA-3EA4-46AD-995F-0FB295B3A923}"/>
+                <a16:creationId xmlns:a16="http://schemas.microsoft.com/office/drawing/2014/main" id="{AD919CDA-6C08-4E95-808A-DEEC4A307162}"/>
               </a:ext>
             </a:extLst>
           </p:cNvPr>
@@ -3754,7 +3759,7 @@
           <p:cNvPr id="3" name="Content Placeholder 2">
             <a:extLst xmlns:a="http://schemas.openxmlformats.org/drawingml/2006/main">
               <a:ext uri="{FF2B5EF4-FFF2-40B4-BE49-F238E27FC236}">
-                <a16:creationId xmlns:a16="http://schemas.microsoft.com/office/drawing/2014/main" id="{1C155570-8B66-4B86-A5B5-56E9051DC819}"/>
+                <a16:creationId xmlns:a16="http://schemas.microsoft.com/office/drawing/2014/main" id="{1B0D5641-AF8A-4AAF-8C21-32DE7092D9D1}"/>
               </a:ext>
             </a:extLst>
           </p:cNvPr>
@@ -3859,7 +3864,7 @@
           <p:cNvPr id="4" name="Text Placeholder 3">
             <a:extLst xmlns:a="http://schemas.openxmlformats.org/drawingml/2006/main">
               <a:ext uri="{FF2B5EF4-FFF2-40B4-BE49-F238E27FC236}">
-                <a16:creationId xmlns:a16="http://schemas.microsoft.com/office/drawing/2014/main" id="{CCF51576-67CB-4797-82D9-EE3AF5FE9539}"/>
+                <a16:creationId xmlns:a16="http://schemas.microsoft.com/office/drawing/2014/main" id="{176D81D1-B201-4482-80C4-9EE87321933D}"/>
               </a:ext>
             </a:extLst>
           </p:cNvPr>
@@ -3931,7 +3936,7 @@
           <p:cNvPr id="5" name="Date Placeholder 4">
             <a:extLst xmlns:a="http://schemas.openxmlformats.org/drawingml/2006/main">
               <a:ext uri="{FF2B5EF4-FFF2-40B4-BE49-F238E27FC236}">
-                <a16:creationId xmlns:a16="http://schemas.microsoft.com/office/drawing/2014/main" id="{33C64480-3E72-4EFD-B3FD-51D0455CCA2C}"/>
+                <a16:creationId xmlns:a16="http://schemas.microsoft.com/office/drawing/2014/main" id="{BAE0EEEB-38D0-4E11-B22F-E3099CD21D57}"/>
               </a:ext>
             </a:extLst>
           </p:cNvPr>
@@ -3959,7 +3964,7 @@
           <p:cNvPr id="6" name="Footer Placeholder 5">
             <a:extLst xmlns:a="http://schemas.openxmlformats.org/drawingml/2006/main">
               <a:ext uri="{FF2B5EF4-FFF2-40B4-BE49-F238E27FC236}">
-                <a16:creationId xmlns:a16="http://schemas.microsoft.com/office/drawing/2014/main" id="{A42C85F0-F709-4D84-AC9B-19BEB13A9ACE}"/>
+                <a16:creationId xmlns:a16="http://schemas.microsoft.com/office/drawing/2014/main" id="{FD5B68CB-5209-415A-8678-DD4068BB1534}"/>
               </a:ext>
             </a:extLst>
           </p:cNvPr>
@@ -3984,7 +3989,7 @@
           <p:cNvPr id="7" name="Slide Number Placeholder 6">
             <a:extLst xmlns:a="http://schemas.openxmlformats.org/drawingml/2006/main">
               <a:ext uri="{FF2B5EF4-FFF2-40B4-BE49-F238E27FC236}">
-                <a16:creationId xmlns:a16="http://schemas.microsoft.com/office/drawing/2014/main" id="{A78F0A22-B148-44C8-9F30-A9DB92E5F93A}"/>
+                <a16:creationId xmlns:a16="http://schemas.microsoft.com/office/drawing/2014/main" id="{8A28C2F9-1D1C-448D-B368-D8A8B9530658}"/>
               </a:ext>
             </a:extLst>
           </p:cNvPr>
@@ -4029,7 +4034,7 @@
           <p:cNvPr id="2" name="Title 1">
             <a:extLst xmlns:a="http://schemas.openxmlformats.org/drawingml/2006/main">
               <a:ext uri="{FF2B5EF4-FFF2-40B4-BE49-F238E27FC236}">
-                <a16:creationId xmlns:a16="http://schemas.microsoft.com/office/drawing/2014/main" id="{7F596D1C-21AD-4258-BE2F-6414DA8E03F7}"/>
+                <a16:creationId xmlns:a16="http://schemas.microsoft.com/office/drawing/2014/main" id="{3589967E-AC04-4FD4-808F-F8041470BC08}"/>
               </a:ext>
             </a:extLst>
           </p:cNvPr>
@@ -4067,7 +4072,7 @@
           <p:cNvPr id="3" name="Picture Placeholder 2">
             <a:extLst xmlns:a="http://schemas.openxmlformats.org/drawingml/2006/main">
               <a:ext uri="{FF2B5EF4-FFF2-40B4-BE49-F238E27FC236}">
-                <a16:creationId xmlns:a16="http://schemas.microsoft.com/office/drawing/2014/main" id="{BAB2646F-02B2-4BE4-B095-B4869D8F38AF}"/>
+                <a16:creationId xmlns:a16="http://schemas.microsoft.com/office/drawing/2014/main" id="{CF47FF55-AF3D-4C14-8F96-10AC765B35C2}"/>
               </a:ext>
             </a:extLst>
           </p:cNvPr>
@@ -4134,7 +4139,7 @@
           <p:cNvPr id="4" name="Text Placeholder 3">
             <a:extLst xmlns:a="http://schemas.openxmlformats.org/drawingml/2006/main">
               <a:ext uri="{FF2B5EF4-FFF2-40B4-BE49-F238E27FC236}">
-                <a16:creationId xmlns:a16="http://schemas.microsoft.com/office/drawing/2014/main" id="{64953EE6-E8E6-469D-B7EF-CBB291FD70B3}"/>
+                <a16:creationId xmlns:a16="http://schemas.microsoft.com/office/drawing/2014/main" id="{485F67F0-62BD-456B-8A1A-6DD70DC1F87C}"/>
               </a:ext>
             </a:extLst>
           </p:cNvPr>
@@ -4206,7 +4211,7 @@
           <p:cNvPr id="5" name="Date Placeholder 4">
             <a:extLst xmlns:a="http://schemas.openxmlformats.org/drawingml/2006/main">
               <a:ext uri="{FF2B5EF4-FFF2-40B4-BE49-F238E27FC236}">
-                <a16:creationId xmlns:a16="http://schemas.microsoft.com/office/drawing/2014/main" id="{92A3EAE5-C48B-4858-88D9-D8035E8F30C1}"/>
+                <a16:creationId xmlns:a16="http://schemas.microsoft.com/office/drawing/2014/main" id="{B7C545DD-DB45-42A6-8A1D-66835E8CFEC8}"/>
               </a:ext>
             </a:extLst>
           </p:cNvPr>
@@ -4234,7 +4239,7 @@
           <p:cNvPr id="6" name="Footer Placeholder 5">
             <a:extLst xmlns:a="http://schemas.openxmlformats.org/drawingml/2006/main">
               <a:ext uri="{FF2B5EF4-FFF2-40B4-BE49-F238E27FC236}">
-                <a16:creationId xmlns:a16="http://schemas.microsoft.com/office/drawing/2014/main" id="{9C9A7009-E3FA-4330-BFA4-60E531C70F0B}"/>
+                <a16:creationId xmlns:a16="http://schemas.microsoft.com/office/drawing/2014/main" id="{DC1C6E51-4990-432A-ADAD-CC963376F3FD}"/>
               </a:ext>
             </a:extLst>
           </p:cNvPr>
@@ -4259,7 +4264,7 @@
           <p:cNvPr id="7" name="Slide Number Placeholder 6">
             <a:extLst xmlns:a="http://schemas.openxmlformats.org/drawingml/2006/main">
               <a:ext uri="{FF2B5EF4-FFF2-40B4-BE49-F238E27FC236}">
-                <a16:creationId xmlns:a16="http://schemas.microsoft.com/office/drawing/2014/main" id="{C12A5262-2ADD-4F2E-8F59-BB8FA878E29D}"/>
+                <a16:creationId xmlns:a16="http://schemas.microsoft.com/office/drawing/2014/main" id="{FB99561C-04A8-4253-9C2C-A5CA353BA268}"/>
               </a:ext>
             </a:extLst>
           </p:cNvPr>
@@ -4309,7 +4314,7 @@
           <p:cNvPr id="2" name="Title Placeholder 1">
             <a:extLst xmlns:a="http://schemas.openxmlformats.org/drawingml/2006/main">
               <a:ext uri="{FF2B5EF4-FFF2-40B4-BE49-F238E27FC236}">
-                <a16:creationId xmlns:a16="http://schemas.microsoft.com/office/drawing/2014/main" id="{A3C6A25A-B8E5-468E-B742-A65AB27A5FC7}"/>
+                <a16:creationId xmlns:a16="http://schemas.microsoft.com/office/drawing/2014/main" id="{672C398B-1684-4DA8-B9DB-6A8E83D3BC09}"/>
               </a:ext>
             </a:extLst>
           </p:cNvPr>
@@ -4347,7 +4352,7 @@
           <p:cNvPr id="3" name="Text Placeholder 2">
             <a:extLst xmlns:a="http://schemas.openxmlformats.org/drawingml/2006/main">
               <a:ext uri="{FF2B5EF4-FFF2-40B4-BE49-F238E27FC236}">
-                <a16:creationId xmlns:a16="http://schemas.microsoft.com/office/drawing/2014/main" id="{104D107C-A998-4A33-9243-4DEBC6844D0E}"/>
+                <a16:creationId xmlns:a16="http://schemas.microsoft.com/office/drawing/2014/main" id="{ADAA1CB8-4845-4F76-BD43-D096B2B7D409}"/>
               </a:ext>
             </a:extLst>
           </p:cNvPr>
@@ -4420,7 +4425,7 @@
           <p:cNvPr id="4" name="Date Placeholder 3">
             <a:extLst xmlns:a="http://schemas.openxmlformats.org/drawingml/2006/main">
               <a:ext uri="{FF2B5EF4-FFF2-40B4-BE49-F238E27FC236}">
-                <a16:creationId xmlns:a16="http://schemas.microsoft.com/office/drawing/2014/main" id="{8AAA794E-2403-43D9-8758-10ED05BBB76E}"/>
+                <a16:creationId xmlns:a16="http://schemas.microsoft.com/office/drawing/2014/main" id="{EE80137F-0763-4CD4-9F11-A3E9963DE969}"/>
               </a:ext>
             </a:extLst>
           </p:cNvPr>
@@ -4467,7 +4472,7 @@
           <p:cNvPr id="5" name="Footer Placeholder 4">
             <a:extLst xmlns:a="http://schemas.openxmlformats.org/drawingml/2006/main">
               <a:ext uri="{FF2B5EF4-FFF2-40B4-BE49-F238E27FC236}">
-                <a16:creationId xmlns:a16="http://schemas.microsoft.com/office/drawing/2014/main" id="{B0AFBE03-6F71-41B8-B971-3E3B7D61C144}"/>
+                <a16:creationId xmlns:a16="http://schemas.microsoft.com/office/drawing/2014/main" id="{668C53C3-50B5-42B1-B737-652797C01EBC}"/>
               </a:ext>
             </a:extLst>
           </p:cNvPr>
@@ -4511,7 +4516,7 @@
           <p:cNvPr id="6" name="Slide Number Placeholder 5">
             <a:extLst xmlns:a="http://schemas.openxmlformats.org/drawingml/2006/main">
               <a:ext uri="{FF2B5EF4-FFF2-40B4-BE49-F238E27FC236}">
-                <a16:creationId xmlns:a16="http://schemas.microsoft.com/office/drawing/2014/main" id="{868DAED3-7EE6-42C4-B663-2671EE7903D8}"/>
+                <a16:creationId xmlns:a16="http://schemas.microsoft.com/office/drawing/2014/main" id="{DE6FFC87-4FCB-483A-9746-603DD64903E7}"/>
               </a:ext>
             </a:extLst>
           </p:cNvPr>
@@ -4557,17 +4562,17 @@
   </p:cSld>
   <p:clrMap bg1="lt1" tx1="dk1" bg2="lt2" tx2="dk2" accent1="accent1" accent2="accent2" accent3="accent3" accent4="accent4" accent5="accent5" accent6="accent6" hlink="hlink" folHlink="folHlink"/>
   <p:sldLayoutIdLst>
-    <p:sldLayoutId xmlns:r="http://schemas.openxmlformats.org/officeDocument/2006/relationships" id="2147483649" r:id="R47b4fb8c496d46fa"/>
-    <p:sldLayoutId xmlns:r="http://schemas.openxmlformats.org/officeDocument/2006/relationships" id="2147483650" r:id="R1a69aab7c27a45a2"/>
-    <p:sldLayoutId xmlns:r="http://schemas.openxmlformats.org/officeDocument/2006/relationships" id="2147483651" r:id="R41b325aeea9547e1"/>
-    <p:sldLayoutId xmlns:r="http://schemas.openxmlformats.org/officeDocument/2006/relationships" id="2147483652" r:id="Re156f2cc6e3c4a79"/>
-    <p:sldLayoutId xmlns:r="http://schemas.openxmlformats.org/officeDocument/2006/relationships" id="2147483653" r:id="R87c065f581184828"/>
-    <p:sldLayoutId xmlns:r="http://schemas.openxmlformats.org/officeDocument/2006/relationships" id="2147483654" r:id="R18e30b0016184991"/>
-    <p:sldLayoutId xmlns:r="http://schemas.openxmlformats.org/officeDocument/2006/relationships" id="2147483655" r:id="Ra80d7caaca624e9e"/>
-    <p:sldLayoutId xmlns:r="http://schemas.openxmlformats.org/officeDocument/2006/relationships" id="2147483656" r:id="R57098e92571a4439"/>
-    <p:sldLayoutId xmlns:r="http://schemas.openxmlformats.org/officeDocument/2006/relationships" id="2147483657" r:id="R15b1ff207d4b4fbd"/>
-    <p:sldLayoutId xmlns:r="http://schemas.openxmlformats.org/officeDocument/2006/relationships" id="2147483658" r:id="Rf9b3543ad5ce4db3"/>
-    <p:sldLayoutId xmlns:r="http://schemas.openxmlformats.org/officeDocument/2006/relationships" id="2147483659" r:id="Ra70a3edaea25473a"/>
+    <p:sldLayoutId xmlns:r="http://schemas.openxmlformats.org/officeDocument/2006/relationships" id="2147483649" r:id="R305ba921cee74090"/>
+    <p:sldLayoutId xmlns:r="http://schemas.openxmlformats.org/officeDocument/2006/relationships" id="2147483650" r:id="Rfc0d71ecfc374c8f"/>
+    <p:sldLayoutId xmlns:r="http://schemas.openxmlformats.org/officeDocument/2006/relationships" id="2147483651" r:id="R3973b36fcc5b4a6e"/>
+    <p:sldLayoutId xmlns:r="http://schemas.openxmlformats.org/officeDocument/2006/relationships" id="2147483652" r:id="Rb4d38cf3db20423b"/>
+    <p:sldLayoutId xmlns:r="http://schemas.openxmlformats.org/officeDocument/2006/relationships" id="2147483653" r:id="R3138d8ac52cb4852"/>
+    <p:sldLayoutId xmlns:r="http://schemas.openxmlformats.org/officeDocument/2006/relationships" id="2147483654" r:id="R4f5ede1680794ec4"/>
+    <p:sldLayoutId xmlns:r="http://schemas.openxmlformats.org/officeDocument/2006/relationships" id="2147483655" r:id="R30318abbc7b5427c"/>
+    <p:sldLayoutId xmlns:r="http://schemas.openxmlformats.org/officeDocument/2006/relationships" id="2147483656" r:id="R50eb99f723e045f4"/>
+    <p:sldLayoutId xmlns:r="http://schemas.openxmlformats.org/officeDocument/2006/relationships" id="2147483657" r:id="R2c49a1e581854a4b"/>
+    <p:sldLayoutId xmlns:r="http://schemas.openxmlformats.org/officeDocument/2006/relationships" id="2147483658" r:id="Rcfe41b1fc0954558"/>
+    <p:sldLayoutId xmlns:r="http://schemas.openxmlformats.org/officeDocument/2006/relationships" id="2147483659" r:id="R87456863d555405d"/>
   </p:sldLayoutIdLst>
   <p:txStyles>
     <p:titleStyle>
@@ -5113,7 +5118,7 @@
           <p:cNvPr id="2" name="Rectangle 1">
             <a:extLst xmlns:a="http://schemas.openxmlformats.org/drawingml/2006/main">
               <a:ext uri="{FF2B5EF4-FFF2-40B4-BE49-F238E27FC236}">
-                <a16:creationId xmlns:a16="http://schemas.microsoft.com/office/drawing/2014/main" id="{0886EE82-45A4-4983-9199-DEA0F3922C39}"/>
+                <a16:creationId xmlns:a16="http://schemas.microsoft.com/office/drawing/2014/main" id="{C2926961-9E71-446B-8784-8698B1384EA2}"/>
               </a:ext>
             </a:extLst>
           </p:cNvPr>
@@ -5166,7 +5171,7 @@
           <p:cNvPr id="3" name="Rectangle 2">
             <a:extLst xmlns:a="http://schemas.openxmlformats.org/drawingml/2006/main">
               <a:ext uri="{FF2B5EF4-FFF2-40B4-BE49-F238E27FC236}">
-                <a16:creationId xmlns:a16="http://schemas.microsoft.com/office/drawing/2014/main" id="{9FA28B9E-1103-44B1-86E6-9B916E78B498}"/>
+                <a16:creationId xmlns:a16="http://schemas.microsoft.com/office/drawing/2014/main" id="{646BBFD1-CAD4-4D20-982D-E4463FA6D587}"/>
               </a:ext>
             </a:extLst>
           </p:cNvPr>
@@ -5219,7 +5224,7 @@
           <p:cNvPr id="4" name="TextBox 3">
             <a:extLst xmlns:a="http://schemas.openxmlformats.org/drawingml/2006/main">
               <a:ext uri="{FF2B5EF4-FFF2-40B4-BE49-F238E27FC236}">
-                <a16:creationId xmlns:a16="http://schemas.microsoft.com/office/drawing/2014/main" id="{5C8535DD-7299-40E5-BA3E-135A62ACD5A3}"/>
+                <a16:creationId xmlns:a16="http://schemas.microsoft.com/office/drawing/2014/main" id="{3FFFFE19-BF61-42B4-840B-9E2421A4B129}"/>
               </a:ext>
             </a:extLst>
           </p:cNvPr>
@@ -5321,7 +5326,7 @@
     </p:spTree>
     <p:extLst>
       <p:ext uri="{BB962C8B-B14F-4D97-AF65-F5344CB8AC3E}">
-        <p14:creationId xmlns:p14="http://schemas.microsoft.com/office/powerpoint/2010/main" val="1462753312"/>
+        <p14:creationId xmlns:p14="http://schemas.microsoft.com/office/powerpoint/2010/main" val="1832291903"/>
       </p:ext>
     </p:extLst>
   </p:cSld>
@@ -5345,7 +5350,7 @@
           <p:cNvPr id="2" name="Rectangle 1">
             <a:extLst xmlns:a="http://schemas.openxmlformats.org/drawingml/2006/main">
               <a:ext uri="{FF2B5EF4-FFF2-40B4-BE49-F238E27FC236}">
-                <a16:creationId xmlns:a16="http://schemas.microsoft.com/office/drawing/2014/main" id="{0F7C6F67-F026-48BF-85C0-E0D6EFB94D44}"/>
+                <a16:creationId xmlns:a16="http://schemas.microsoft.com/office/drawing/2014/main" id="{23E28773-3B09-42FD-B6B7-5B0BADB15505}"/>
               </a:ext>
             </a:extLst>
           </p:cNvPr>
@@ -5398,7 +5403,7 @@
           <p:cNvPr id="3" name="Rectangle 2">
             <a:extLst xmlns:a="http://schemas.openxmlformats.org/drawingml/2006/main">
               <a:ext uri="{FF2B5EF4-FFF2-40B4-BE49-F238E27FC236}">
-                <a16:creationId xmlns:a16="http://schemas.microsoft.com/office/drawing/2014/main" id="{57328AED-BFC4-40EE-A461-D4411B947D75}"/>
+                <a16:creationId xmlns:a16="http://schemas.microsoft.com/office/drawing/2014/main" id="{80977C56-055D-4259-8B06-AE471EF94ECF}"/>
               </a:ext>
             </a:extLst>
           </p:cNvPr>
@@ -5451,7 +5456,7 @@
           <p:cNvPr id="4" name="Rectangle 3">
             <a:extLst xmlns:a="http://schemas.openxmlformats.org/drawingml/2006/main">
               <a:ext uri="{FF2B5EF4-FFF2-40B4-BE49-F238E27FC236}">
-                <a16:creationId xmlns:a16="http://schemas.microsoft.com/office/drawing/2014/main" id="{BD342EF1-98D4-457E-8742-ADF0861CF133}"/>
+                <a16:creationId xmlns:a16="http://schemas.microsoft.com/office/drawing/2014/main" id="{37465A4D-A7F5-4BB7-A2FB-844C5C3B8E6F}"/>
               </a:ext>
             </a:extLst>
           </p:cNvPr>
@@ -5504,7 +5509,7 @@
           <p:cNvPr id="5" name="TextBox 4">
             <a:extLst xmlns:a="http://schemas.openxmlformats.org/drawingml/2006/main">
               <a:ext uri="{FF2B5EF4-FFF2-40B4-BE49-F238E27FC236}">
-                <a16:creationId xmlns:a16="http://schemas.microsoft.com/office/drawing/2014/main" id="{965B098A-0C59-4895-AA4E-F423A4913B83}"/>
+                <a16:creationId xmlns:a16="http://schemas.microsoft.com/office/drawing/2014/main" id="{C6AFE00F-AA27-4AED-A6B3-42F9CF8AA262}"/>
               </a:ext>
             </a:extLst>
           </p:cNvPr>
@@ -5567,7 +5572,7 @@
           <p:cNvPr id="6" name="Rounded Rectangle 5">
             <a:extLst xmlns:a="http://schemas.openxmlformats.org/drawingml/2006/main">
               <a:ext uri="{FF2B5EF4-FFF2-40B4-BE49-F238E27FC236}">
-                <a16:creationId xmlns:a16="http://schemas.microsoft.com/office/drawing/2014/main" id="{FB86FB8E-F6E2-4E8D-931B-DFFC39E70A6C}"/>
+                <a16:creationId xmlns:a16="http://schemas.microsoft.com/office/drawing/2014/main" id="{0D7F3B7C-83B2-4F32-BD6A-738E32FC9E7E}"/>
               </a:ext>
             </a:extLst>
           </p:cNvPr>
@@ -5622,7 +5627,7 @@
           <p:cNvPr id="7" name="TextBox 6">
             <a:extLst xmlns:a="http://schemas.openxmlformats.org/drawingml/2006/main">
               <a:ext uri="{FF2B5EF4-FFF2-40B4-BE49-F238E27FC236}">
-                <a16:creationId xmlns:a16="http://schemas.microsoft.com/office/drawing/2014/main" id="{B23A4352-DE02-47BF-AC7B-E0281C48ED3E}"/>
+                <a16:creationId xmlns:a16="http://schemas.microsoft.com/office/drawing/2014/main" id="{51119C80-7E69-4F5B-B615-C54F338CA93C}"/>
               </a:ext>
             </a:extLst>
           </p:cNvPr>
@@ -5726,7 +5731,7 @@
           <p:cNvPr id="8" name="Rounded Rectangle 7">
             <a:extLst xmlns:a="http://schemas.openxmlformats.org/drawingml/2006/main">
               <a:ext uri="{FF2B5EF4-FFF2-40B4-BE49-F238E27FC236}">
-                <a16:creationId xmlns:a16="http://schemas.microsoft.com/office/drawing/2014/main" id="{A541F922-8E7D-46DE-BD13-62DD8AFCCC6B}"/>
+                <a16:creationId xmlns:a16="http://schemas.microsoft.com/office/drawing/2014/main" id="{27B6C9D0-72F7-4084-9592-4F6F40224D8D}"/>
               </a:ext>
             </a:extLst>
           </p:cNvPr>
@@ -5781,7 +5786,7 @@
           <p:cNvPr id="9" name="TextBox 8">
             <a:extLst xmlns:a="http://schemas.openxmlformats.org/drawingml/2006/main">
               <a:ext uri="{FF2B5EF4-FFF2-40B4-BE49-F238E27FC236}">
-                <a16:creationId xmlns:a16="http://schemas.microsoft.com/office/drawing/2014/main" id="{C4FD11EC-B03C-49DB-BAFE-06045288FF04}"/>
+                <a16:creationId xmlns:a16="http://schemas.microsoft.com/office/drawing/2014/main" id="{F7EAA397-46D0-4748-8ECB-3F017BA485F5}"/>
               </a:ext>
             </a:extLst>
           </p:cNvPr>
@@ -5866,7 +5871,7 @@
           <p:cNvPr id="10" name="Rounded Rectangle 9">
             <a:extLst xmlns:a="http://schemas.openxmlformats.org/drawingml/2006/main">
               <a:ext uri="{FF2B5EF4-FFF2-40B4-BE49-F238E27FC236}">
-                <a16:creationId xmlns:a16="http://schemas.microsoft.com/office/drawing/2014/main" id="{07546CD6-432F-4412-95BE-23ACA418ED11}"/>
+                <a16:creationId xmlns:a16="http://schemas.microsoft.com/office/drawing/2014/main" id="{B7CE8416-5EDD-4A53-B71A-C38CADD5C693}"/>
               </a:ext>
             </a:extLst>
           </p:cNvPr>
@@ -5921,7 +5926,7 @@
           <p:cNvPr id="11" name="TextBox 10">
             <a:extLst xmlns:a="http://schemas.openxmlformats.org/drawingml/2006/main">
               <a:ext uri="{FF2B5EF4-FFF2-40B4-BE49-F238E27FC236}">
-                <a16:creationId xmlns:a16="http://schemas.microsoft.com/office/drawing/2014/main" id="{4646304A-F943-4239-982D-364747E1A23A}"/>
+                <a16:creationId xmlns:a16="http://schemas.microsoft.com/office/drawing/2014/main" id="{7AD7C3D5-014D-4583-8653-FBB1DA016CD1}"/>
               </a:ext>
             </a:extLst>
           </p:cNvPr>
@@ -6023,7 +6028,7 @@
     </p:spTree>
     <p:extLst>
       <p:ext uri="{BB962C8B-B14F-4D97-AF65-F5344CB8AC3E}">
-        <p14:creationId xmlns:p14="http://schemas.microsoft.com/office/powerpoint/2010/main" val="651667508"/>
+        <p14:creationId xmlns:p14="http://schemas.microsoft.com/office/powerpoint/2010/main" val="2022349873"/>
       </p:ext>
     </p:extLst>
   </p:cSld>
@@ -6047,7 +6052,7 @@
           <p:cNvPr id="2" name="Rectangle 1">
             <a:extLst xmlns:a="http://schemas.openxmlformats.org/drawingml/2006/main">
               <a:ext uri="{FF2B5EF4-FFF2-40B4-BE49-F238E27FC236}">
-                <a16:creationId xmlns:a16="http://schemas.microsoft.com/office/drawing/2014/main" id="{1C130BB4-F69F-4BCD-8319-FFFA9E1B5CF2}"/>
+                <a16:creationId xmlns:a16="http://schemas.microsoft.com/office/drawing/2014/main" id="{8EC27EF0-0D61-4718-B482-5E65807EC87E}"/>
               </a:ext>
             </a:extLst>
           </p:cNvPr>
@@ -6100,7 +6105,7 @@
           <p:cNvPr id="3" name="Rectangle 2">
             <a:extLst xmlns:a="http://schemas.openxmlformats.org/drawingml/2006/main">
               <a:ext uri="{FF2B5EF4-FFF2-40B4-BE49-F238E27FC236}">
-                <a16:creationId xmlns:a16="http://schemas.microsoft.com/office/drawing/2014/main" id="{5E6AEA8B-AB2D-4266-BC97-59F985F741D6}"/>
+                <a16:creationId xmlns:a16="http://schemas.microsoft.com/office/drawing/2014/main" id="{1D2CAAA8-437B-49CE-9732-F4DFA0560F80}"/>
               </a:ext>
             </a:extLst>
           </p:cNvPr>
@@ -6153,7 +6158,7 @@
           <p:cNvPr id="4" name="Rectangle 3">
             <a:extLst xmlns:a="http://schemas.openxmlformats.org/drawingml/2006/main">
               <a:ext uri="{FF2B5EF4-FFF2-40B4-BE49-F238E27FC236}">
-                <a16:creationId xmlns:a16="http://schemas.microsoft.com/office/drawing/2014/main" id="{792E7680-FBDC-4D35-A901-7648E31FF190}"/>
+                <a16:creationId xmlns:a16="http://schemas.microsoft.com/office/drawing/2014/main" id="{8AE0DC4A-5C03-42CF-B7E4-8F340FB4B656}"/>
               </a:ext>
             </a:extLst>
           </p:cNvPr>
@@ -6206,7 +6211,7 @@
           <p:cNvPr id="5" name="TextBox 4">
             <a:extLst xmlns:a="http://schemas.openxmlformats.org/drawingml/2006/main">
               <a:ext uri="{FF2B5EF4-FFF2-40B4-BE49-F238E27FC236}">
-                <a16:creationId xmlns:a16="http://schemas.microsoft.com/office/drawing/2014/main" id="{08C4DB09-E621-4AC8-9934-DE93766AF057}"/>
+                <a16:creationId xmlns:a16="http://schemas.microsoft.com/office/drawing/2014/main" id="{124F35FF-448C-4146-B27E-C1B3CFA21673}"/>
               </a:ext>
             </a:extLst>
           </p:cNvPr>
@@ -6269,7 +6274,7 @@
           <p:cNvPr id="6" name="Rounded Rectangle 5">
             <a:extLst xmlns:a="http://schemas.openxmlformats.org/drawingml/2006/main">
               <a:ext uri="{FF2B5EF4-FFF2-40B4-BE49-F238E27FC236}">
-                <a16:creationId xmlns:a16="http://schemas.microsoft.com/office/drawing/2014/main" id="{FED1B884-02E8-4292-B797-2546813E6940}"/>
+                <a16:creationId xmlns:a16="http://schemas.microsoft.com/office/drawing/2014/main" id="{16E3FB87-2211-48E0-966C-6C6AAC561DA9}"/>
               </a:ext>
             </a:extLst>
           </p:cNvPr>
@@ -6324,7 +6329,7 @@
           <p:cNvPr id="7" name="TextBox 6">
             <a:extLst xmlns:a="http://schemas.openxmlformats.org/drawingml/2006/main">
               <a:ext uri="{FF2B5EF4-FFF2-40B4-BE49-F238E27FC236}">
-                <a16:creationId xmlns:a16="http://schemas.microsoft.com/office/drawing/2014/main" id="{8F282CFE-C974-4F83-9F15-8F5AFAA3C21B}"/>
+                <a16:creationId xmlns:a16="http://schemas.microsoft.com/office/drawing/2014/main" id="{B0E95A4A-25B3-4414-80E9-8F755198204C}"/>
               </a:ext>
             </a:extLst>
           </p:cNvPr>
@@ -6523,7 +6528,7 @@
           <p:cNvPr id="8" name="Rounded Rectangle 7">
             <a:extLst xmlns:a="http://schemas.openxmlformats.org/drawingml/2006/main">
               <a:ext uri="{FF2B5EF4-FFF2-40B4-BE49-F238E27FC236}">
-                <a16:creationId xmlns:a16="http://schemas.microsoft.com/office/drawing/2014/main" id="{2DDD0174-2FCA-419F-ACA5-25619BA166F4}"/>
+                <a16:creationId xmlns:a16="http://schemas.microsoft.com/office/drawing/2014/main" id="{F39DC297-4888-400C-A7F6-928863A22F4E}"/>
               </a:ext>
             </a:extLst>
           </p:cNvPr>
@@ -6578,7 +6583,7 @@
           <p:cNvPr id="9" name="TextBox 8">
             <a:extLst xmlns:a="http://schemas.openxmlformats.org/drawingml/2006/main">
               <a:ext uri="{FF2B5EF4-FFF2-40B4-BE49-F238E27FC236}">
-                <a16:creationId xmlns:a16="http://schemas.microsoft.com/office/drawing/2014/main" id="{72A72586-FDE7-4393-88B8-2900FC0AF9FE}"/>
+                <a16:creationId xmlns:a16="http://schemas.microsoft.com/office/drawing/2014/main" id="{4ABE4D4D-AB52-43D1-B8BA-B5C800C468DF}"/>
               </a:ext>
             </a:extLst>
           </p:cNvPr>
@@ -6699,7 +6704,7 @@
     </p:spTree>
     <p:extLst>
       <p:ext uri="{BB962C8B-B14F-4D97-AF65-F5344CB8AC3E}">
-        <p14:creationId xmlns:p14="http://schemas.microsoft.com/office/powerpoint/2010/main" val="1020488870"/>
+        <p14:creationId xmlns:p14="http://schemas.microsoft.com/office/powerpoint/2010/main" val="930900073"/>
       </p:ext>
     </p:extLst>
   </p:cSld>
@@ -6723,7 +6728,7 @@
           <p:cNvPr id="2" name="Rectangle 1">
             <a:extLst xmlns:a="http://schemas.openxmlformats.org/drawingml/2006/main">
               <a:ext uri="{FF2B5EF4-FFF2-40B4-BE49-F238E27FC236}">
-                <a16:creationId xmlns:a16="http://schemas.microsoft.com/office/drawing/2014/main" id="{71E90448-25A4-48B7-9526-10752A977EB0}"/>
+                <a16:creationId xmlns:a16="http://schemas.microsoft.com/office/drawing/2014/main" id="{94874379-D44B-4111-80DF-72EF44B70CA5}"/>
               </a:ext>
             </a:extLst>
           </p:cNvPr>
@@ -6776,7 +6781,7 @@
           <p:cNvPr id="3" name="Rectangle 2">
             <a:extLst xmlns:a="http://schemas.openxmlformats.org/drawingml/2006/main">
               <a:ext uri="{FF2B5EF4-FFF2-40B4-BE49-F238E27FC236}">
-                <a16:creationId xmlns:a16="http://schemas.microsoft.com/office/drawing/2014/main" id="{4132F63D-F31C-4361-8877-991AE6884583}"/>
+                <a16:creationId xmlns:a16="http://schemas.microsoft.com/office/drawing/2014/main" id="{C6594F7F-DEBE-41AB-B433-E302FFCB3385}"/>
               </a:ext>
             </a:extLst>
           </p:cNvPr>
@@ -6829,7 +6834,7 @@
           <p:cNvPr id="4" name="TextBox 3">
             <a:extLst xmlns:a="http://schemas.openxmlformats.org/drawingml/2006/main">
               <a:ext uri="{FF2B5EF4-FFF2-40B4-BE49-F238E27FC236}">
-                <a16:creationId xmlns:a16="http://schemas.microsoft.com/office/drawing/2014/main" id="{0551C22C-55A8-42F7-9140-EB097709574E}"/>
+                <a16:creationId xmlns:a16="http://schemas.microsoft.com/office/drawing/2014/main" id="{AA803275-FB65-4154-8806-92BAEE0E9CC7}"/>
               </a:ext>
             </a:extLst>
           </p:cNvPr>
@@ -7007,7 +7012,7 @@
     </p:spTree>
     <p:extLst>
       <p:ext uri="{BB962C8B-B14F-4D97-AF65-F5344CB8AC3E}">
-        <p14:creationId xmlns:p14="http://schemas.microsoft.com/office/powerpoint/2010/main" val="78089277"/>
+        <p14:creationId xmlns:p14="http://schemas.microsoft.com/office/powerpoint/2010/main" val="526055841"/>
       </p:ext>
     </p:extLst>
   </p:cSld>
@@ -7031,7 +7036,7 @@
           <p:cNvPr id="2" name="Rectangle 1">
             <a:extLst xmlns:a="http://schemas.openxmlformats.org/drawingml/2006/main">
               <a:ext uri="{FF2B5EF4-FFF2-40B4-BE49-F238E27FC236}">
-                <a16:creationId xmlns:a16="http://schemas.microsoft.com/office/drawing/2014/main" id="{9B0CA5D7-542C-4DE9-B31F-B8E6083EF97E}"/>
+                <a16:creationId xmlns:a16="http://schemas.microsoft.com/office/drawing/2014/main" id="{89F22D32-B73F-4634-B92E-319E5359E355}"/>
               </a:ext>
             </a:extLst>
           </p:cNvPr>
@@ -7084,7 +7089,7 @@
           <p:cNvPr id="3" name="Rectangle 2">
             <a:extLst xmlns:a="http://schemas.openxmlformats.org/drawingml/2006/main">
               <a:ext uri="{FF2B5EF4-FFF2-40B4-BE49-F238E27FC236}">
-                <a16:creationId xmlns:a16="http://schemas.microsoft.com/office/drawing/2014/main" id="{261E1C52-E9FC-4421-B317-1A3F5B4FC275}"/>
+                <a16:creationId xmlns:a16="http://schemas.microsoft.com/office/drawing/2014/main" id="{EB526803-8015-4834-9590-6B5DFA3B48A3}"/>
               </a:ext>
             </a:extLst>
           </p:cNvPr>
@@ -7137,7 +7142,7 @@
           <p:cNvPr id="4" name="Rectangle 3">
             <a:extLst xmlns:a="http://schemas.openxmlformats.org/drawingml/2006/main">
               <a:ext uri="{FF2B5EF4-FFF2-40B4-BE49-F238E27FC236}">
-                <a16:creationId xmlns:a16="http://schemas.microsoft.com/office/drawing/2014/main" id="{9847C858-56D2-46F3-B933-917AFF6915A7}"/>
+                <a16:creationId xmlns:a16="http://schemas.microsoft.com/office/drawing/2014/main" id="{CE147814-65AB-4D31-AFBF-C7EE5F8C3679}"/>
               </a:ext>
             </a:extLst>
           </p:cNvPr>
@@ -7190,7 +7195,7 @@
           <p:cNvPr id="5" name="TextBox 4">
             <a:extLst xmlns:a="http://schemas.openxmlformats.org/drawingml/2006/main">
               <a:ext uri="{FF2B5EF4-FFF2-40B4-BE49-F238E27FC236}">
-                <a16:creationId xmlns:a16="http://schemas.microsoft.com/office/drawing/2014/main" id="{FEFAF48C-D2C0-4A31-AD0C-24EC7FA1EA43}"/>
+                <a16:creationId xmlns:a16="http://schemas.microsoft.com/office/drawing/2014/main" id="{7172D39E-59A7-4A28-87A9-9A0B3198A93A}"/>
               </a:ext>
             </a:extLst>
           </p:cNvPr>
@@ -7253,7 +7258,7 @@
           <p:cNvPr id="6" name="Rounded Rectangle 5">
             <a:extLst xmlns:a="http://schemas.openxmlformats.org/drawingml/2006/main">
               <a:ext uri="{FF2B5EF4-FFF2-40B4-BE49-F238E27FC236}">
-                <a16:creationId xmlns:a16="http://schemas.microsoft.com/office/drawing/2014/main" id="{EFA569F6-0560-462B-8B51-0D91C4CCFF2D}"/>
+                <a16:creationId xmlns:a16="http://schemas.microsoft.com/office/drawing/2014/main" id="{A65171A4-E7C5-465A-8B17-6CC08574BF54}"/>
               </a:ext>
             </a:extLst>
           </p:cNvPr>
@@ -7308,7 +7313,7 @@
           <p:cNvPr id="7" name="TextBox 6">
             <a:extLst xmlns:a="http://schemas.openxmlformats.org/drawingml/2006/main">
               <a:ext uri="{FF2B5EF4-FFF2-40B4-BE49-F238E27FC236}">
-                <a16:creationId xmlns:a16="http://schemas.microsoft.com/office/drawing/2014/main" id="{6CEBAF5B-B908-42ED-B317-96975C612BE7}"/>
+                <a16:creationId xmlns:a16="http://schemas.microsoft.com/office/drawing/2014/main" id="{FA598076-1CF4-4DFB-A06A-DDAB5D0CE294}"/>
               </a:ext>
             </a:extLst>
           </p:cNvPr>
@@ -7412,7 +7417,7 @@
           <p:cNvPr id="8" name="Rounded Rectangle 7">
             <a:extLst xmlns:a="http://schemas.openxmlformats.org/drawingml/2006/main">
               <a:ext uri="{FF2B5EF4-FFF2-40B4-BE49-F238E27FC236}">
-                <a16:creationId xmlns:a16="http://schemas.microsoft.com/office/drawing/2014/main" id="{9B95DAB5-B861-456C-9191-1CF4CE41A445}"/>
+                <a16:creationId xmlns:a16="http://schemas.microsoft.com/office/drawing/2014/main" id="{42979C6E-14AF-4F58-A740-4B5C6E24817A}"/>
               </a:ext>
             </a:extLst>
           </p:cNvPr>
@@ -7467,7 +7472,7 @@
           <p:cNvPr id="9" name="TextBox 8">
             <a:extLst xmlns:a="http://schemas.openxmlformats.org/drawingml/2006/main">
               <a:ext uri="{FF2B5EF4-FFF2-40B4-BE49-F238E27FC236}">
-                <a16:creationId xmlns:a16="http://schemas.microsoft.com/office/drawing/2014/main" id="{7764FBC2-7457-463F-AACC-F06CA354FCD2}"/>
+                <a16:creationId xmlns:a16="http://schemas.microsoft.com/office/drawing/2014/main" id="{430AF0D4-3A7F-4A9B-B8EF-AAF65984D231}"/>
               </a:ext>
             </a:extLst>
           </p:cNvPr>
@@ -7571,7 +7576,7 @@
           <p:cNvPr id="10" name="Rounded Rectangle 9">
             <a:extLst xmlns:a="http://schemas.openxmlformats.org/drawingml/2006/main">
               <a:ext uri="{FF2B5EF4-FFF2-40B4-BE49-F238E27FC236}">
-                <a16:creationId xmlns:a16="http://schemas.microsoft.com/office/drawing/2014/main" id="{C6816087-BDF2-4F21-A57E-E037F3CF7C2C}"/>
+                <a16:creationId xmlns:a16="http://schemas.microsoft.com/office/drawing/2014/main" id="{6480AA08-4EFD-4411-80EE-1CADA8AB89F5}"/>
               </a:ext>
             </a:extLst>
           </p:cNvPr>
@@ -7626,7 +7631,7 @@
           <p:cNvPr id="11" name="TextBox 10">
             <a:extLst xmlns:a="http://schemas.openxmlformats.org/drawingml/2006/main">
               <a:ext uri="{FF2B5EF4-FFF2-40B4-BE49-F238E27FC236}">
-                <a16:creationId xmlns:a16="http://schemas.microsoft.com/office/drawing/2014/main" id="{42C9D95D-4CED-44CC-B549-1317DF3E9332}"/>
+                <a16:creationId xmlns:a16="http://schemas.microsoft.com/office/drawing/2014/main" id="{DBF44D97-9D83-4A8E-AC03-6D904A848343}"/>
               </a:ext>
             </a:extLst>
           </p:cNvPr>
@@ -7785,7 +7790,7 @@
     </p:spTree>
     <p:extLst>
       <p:ext uri="{BB962C8B-B14F-4D97-AF65-F5344CB8AC3E}">
-        <p14:creationId xmlns:p14="http://schemas.microsoft.com/office/powerpoint/2010/main" val="908138734"/>
+        <p14:creationId xmlns:p14="http://schemas.microsoft.com/office/powerpoint/2010/main" val="383905064"/>
       </p:ext>
     </p:extLst>
   </p:cSld>
@@ -7809,7 +7814,7 @@
           <p:cNvPr id="2" name="Rectangle 1">
             <a:extLst xmlns:a="http://schemas.openxmlformats.org/drawingml/2006/main">
               <a:ext uri="{FF2B5EF4-FFF2-40B4-BE49-F238E27FC236}">
-                <a16:creationId xmlns:a16="http://schemas.microsoft.com/office/drawing/2014/main" id="{36F863D4-C879-45E8-A26C-9ADB32967F2B}"/>
+                <a16:creationId xmlns:a16="http://schemas.microsoft.com/office/drawing/2014/main" id="{214CD07B-1421-413D-BDF7-29A7024F6CEE}"/>
               </a:ext>
             </a:extLst>
           </p:cNvPr>
@@ -7862,7 +7867,7 @@
           <p:cNvPr id="3" name="Rectangle 2">
             <a:extLst xmlns:a="http://schemas.openxmlformats.org/drawingml/2006/main">
               <a:ext uri="{FF2B5EF4-FFF2-40B4-BE49-F238E27FC236}">
-                <a16:creationId xmlns:a16="http://schemas.microsoft.com/office/drawing/2014/main" id="{50940F33-4910-4C63-9143-D1E48EE2A6DD}"/>
+                <a16:creationId xmlns:a16="http://schemas.microsoft.com/office/drawing/2014/main" id="{11847149-C5CB-451E-A46F-B23938E03292}"/>
               </a:ext>
             </a:extLst>
           </p:cNvPr>
@@ -7915,7 +7920,7 @@
           <p:cNvPr id="4" name="Rectangle 3">
             <a:extLst xmlns:a="http://schemas.openxmlformats.org/drawingml/2006/main">
               <a:ext uri="{FF2B5EF4-FFF2-40B4-BE49-F238E27FC236}">
-                <a16:creationId xmlns:a16="http://schemas.microsoft.com/office/drawing/2014/main" id="{389DA64B-74C6-42F8-B4EA-E0C496262A04}"/>
+                <a16:creationId xmlns:a16="http://schemas.microsoft.com/office/drawing/2014/main" id="{EE3EB1D3-6198-4708-B921-7393946D70C8}"/>
               </a:ext>
             </a:extLst>
           </p:cNvPr>
@@ -7968,7 +7973,7 @@
           <p:cNvPr id="5" name="TextBox 4">
             <a:extLst xmlns:a="http://schemas.openxmlformats.org/drawingml/2006/main">
               <a:ext uri="{FF2B5EF4-FFF2-40B4-BE49-F238E27FC236}">
-                <a16:creationId xmlns:a16="http://schemas.microsoft.com/office/drawing/2014/main" id="{CCF7597C-CFCA-498E-AAFB-649975E930FB}"/>
+                <a16:creationId xmlns:a16="http://schemas.microsoft.com/office/drawing/2014/main" id="{A9AD06E1-27BD-44E7-B906-36ABAABE0F72}"/>
               </a:ext>
             </a:extLst>
           </p:cNvPr>
@@ -8031,7 +8036,7 @@
           <p:cNvPr id="6" name="Rounded Rectangle 5">
             <a:extLst xmlns:a="http://schemas.openxmlformats.org/drawingml/2006/main">
               <a:ext uri="{FF2B5EF4-FFF2-40B4-BE49-F238E27FC236}">
-                <a16:creationId xmlns:a16="http://schemas.microsoft.com/office/drawing/2014/main" id="{F99E2600-1CF6-465C-92B3-0BEACFE09C30}"/>
+                <a16:creationId xmlns:a16="http://schemas.microsoft.com/office/drawing/2014/main" id="{85C0EFCB-E843-4644-A47D-B8D2352EF685}"/>
               </a:ext>
             </a:extLst>
           </p:cNvPr>
@@ -8086,7 +8091,7 @@
           <p:cNvPr id="7" name="TextBox 6">
             <a:extLst xmlns:a="http://schemas.openxmlformats.org/drawingml/2006/main">
               <a:ext uri="{FF2B5EF4-FFF2-40B4-BE49-F238E27FC236}">
-                <a16:creationId xmlns:a16="http://schemas.microsoft.com/office/drawing/2014/main" id="{7929731E-C196-44E0-B99A-CED8611AC1DB}"/>
+                <a16:creationId xmlns:a16="http://schemas.microsoft.com/office/drawing/2014/main" id="{0F6575D0-FD7E-4C70-9DBB-8045CC3EB16E}"/>
               </a:ext>
             </a:extLst>
           </p:cNvPr>
@@ -8209,7 +8214,7 @@
           <p:cNvPr id="8" name="Rounded Rectangle 7">
             <a:extLst xmlns:a="http://schemas.openxmlformats.org/drawingml/2006/main">
               <a:ext uri="{FF2B5EF4-FFF2-40B4-BE49-F238E27FC236}">
-                <a16:creationId xmlns:a16="http://schemas.microsoft.com/office/drawing/2014/main" id="{7C128377-81AE-4819-B822-94821A26ADAB}"/>
+                <a16:creationId xmlns:a16="http://schemas.microsoft.com/office/drawing/2014/main" id="{B168CC65-CD67-4684-9F11-CBF8CF7D7B16}"/>
               </a:ext>
             </a:extLst>
           </p:cNvPr>
@@ -8264,7 +8269,7 @@
           <p:cNvPr id="9" name="TextBox 8">
             <a:extLst xmlns:a="http://schemas.openxmlformats.org/drawingml/2006/main">
               <a:ext uri="{FF2B5EF4-FFF2-40B4-BE49-F238E27FC236}">
-                <a16:creationId xmlns:a16="http://schemas.microsoft.com/office/drawing/2014/main" id="{66936259-03EE-4B6B-9EC9-46BA8C30ABF3}"/>
+                <a16:creationId xmlns:a16="http://schemas.microsoft.com/office/drawing/2014/main" id="{937EE3F7-AF08-4C2E-A262-39C90AF5E813}"/>
               </a:ext>
             </a:extLst>
           </p:cNvPr>
@@ -8406,7 +8411,7 @@
           <p:cNvPr id="10" name="Rounded Rectangle 9">
             <a:extLst xmlns:a="http://schemas.openxmlformats.org/drawingml/2006/main">
               <a:ext uri="{FF2B5EF4-FFF2-40B4-BE49-F238E27FC236}">
-                <a16:creationId xmlns:a16="http://schemas.microsoft.com/office/drawing/2014/main" id="{8DA943F2-E6A9-419A-839B-AC964C90D5A3}"/>
+                <a16:creationId xmlns:a16="http://schemas.microsoft.com/office/drawing/2014/main" id="{5E0A37B7-7EBF-49EE-83B0-FF676B75ADA4}"/>
               </a:ext>
             </a:extLst>
           </p:cNvPr>
@@ -8461,7 +8466,7 @@
           <p:cNvPr id="11" name="TextBox 10">
             <a:extLst xmlns:a="http://schemas.openxmlformats.org/drawingml/2006/main">
               <a:ext uri="{FF2B5EF4-FFF2-40B4-BE49-F238E27FC236}">
-                <a16:creationId xmlns:a16="http://schemas.microsoft.com/office/drawing/2014/main" id="{DA51AFFD-D581-45AD-B975-C26DC64FE978}"/>
+                <a16:creationId xmlns:a16="http://schemas.microsoft.com/office/drawing/2014/main" id="{EBBFE1A0-8400-401D-B1B1-6CDCB119618B}"/>
               </a:ext>
             </a:extLst>
           </p:cNvPr>
@@ -8563,7 +8568,7 @@
     </p:spTree>
     <p:extLst>
       <p:ext uri="{BB962C8B-B14F-4D97-AF65-F5344CB8AC3E}">
-        <p14:creationId xmlns:p14="http://schemas.microsoft.com/office/powerpoint/2010/main" val="556164992"/>
+        <p14:creationId xmlns:p14="http://schemas.microsoft.com/office/powerpoint/2010/main" val="1784165154"/>
       </p:ext>
     </p:extLst>
   </p:cSld>
@@ -8587,7 +8592,7 @@
           <p:cNvPr id="2" name="Rectangle 1">
             <a:extLst xmlns:a="http://schemas.openxmlformats.org/drawingml/2006/main">
               <a:ext uri="{FF2B5EF4-FFF2-40B4-BE49-F238E27FC236}">
-                <a16:creationId xmlns:a16="http://schemas.microsoft.com/office/drawing/2014/main" id="{9E6A76FA-B6BA-4E7C-AEB8-41431552F376}"/>
+                <a16:creationId xmlns:a16="http://schemas.microsoft.com/office/drawing/2014/main" id="{18A1661B-FA65-464B-8332-569ACB200867}"/>
               </a:ext>
             </a:extLst>
           </p:cNvPr>
@@ -8640,7 +8645,7 @@
           <p:cNvPr id="3" name="Rectangle 2">
             <a:extLst xmlns:a="http://schemas.openxmlformats.org/drawingml/2006/main">
               <a:ext uri="{FF2B5EF4-FFF2-40B4-BE49-F238E27FC236}">
-                <a16:creationId xmlns:a16="http://schemas.microsoft.com/office/drawing/2014/main" id="{3AD748B8-C1FA-474C-9CE2-426170100853}"/>
+                <a16:creationId xmlns:a16="http://schemas.microsoft.com/office/drawing/2014/main" id="{36E4D39B-05D0-41F8-927F-B092842928EB}"/>
               </a:ext>
             </a:extLst>
           </p:cNvPr>
@@ -8693,7 +8698,7 @@
           <p:cNvPr id="4" name="Rectangle 3">
             <a:extLst xmlns:a="http://schemas.openxmlformats.org/drawingml/2006/main">
               <a:ext uri="{FF2B5EF4-FFF2-40B4-BE49-F238E27FC236}">
-                <a16:creationId xmlns:a16="http://schemas.microsoft.com/office/drawing/2014/main" id="{A9F6AA5D-FEA9-4D94-BEAD-AF604F6C9657}"/>
+                <a16:creationId xmlns:a16="http://schemas.microsoft.com/office/drawing/2014/main" id="{A7E09364-A528-480A-9660-8DD69647DE3C}"/>
               </a:ext>
             </a:extLst>
           </p:cNvPr>
@@ -8746,7 +8751,7 @@
           <p:cNvPr id="5" name="TextBox 4">
             <a:extLst xmlns:a="http://schemas.openxmlformats.org/drawingml/2006/main">
               <a:ext uri="{FF2B5EF4-FFF2-40B4-BE49-F238E27FC236}">
-                <a16:creationId xmlns:a16="http://schemas.microsoft.com/office/drawing/2014/main" id="{2624F681-48BD-4940-9D70-29BD71AB0B72}"/>
+                <a16:creationId xmlns:a16="http://schemas.microsoft.com/office/drawing/2014/main" id="{72CC3027-BF7D-4485-A40D-30FCF9F9A2AA}"/>
               </a:ext>
             </a:extLst>
           </p:cNvPr>
@@ -8809,7 +8814,7 @@
           <p:cNvPr id="6" name="Rounded Rectangle 5">
             <a:extLst xmlns:a="http://schemas.openxmlformats.org/drawingml/2006/main">
               <a:ext uri="{FF2B5EF4-FFF2-40B4-BE49-F238E27FC236}">
-                <a16:creationId xmlns:a16="http://schemas.microsoft.com/office/drawing/2014/main" id="{99CCBC80-400A-4AB4-80DB-2D311E0393E8}"/>
+                <a16:creationId xmlns:a16="http://schemas.microsoft.com/office/drawing/2014/main" id="{C2330EE6-9DD4-422E-9887-253A37F7BBE5}"/>
               </a:ext>
             </a:extLst>
           </p:cNvPr>
@@ -8864,7 +8869,7 @@
           <p:cNvPr id="7" name="TextBox 6">
             <a:extLst xmlns:a="http://schemas.openxmlformats.org/drawingml/2006/main">
               <a:ext uri="{FF2B5EF4-FFF2-40B4-BE49-F238E27FC236}">
-                <a16:creationId xmlns:a16="http://schemas.microsoft.com/office/drawing/2014/main" id="{FC511546-7E5B-4AF3-AA57-E962C744E3D0}"/>
+                <a16:creationId xmlns:a16="http://schemas.microsoft.com/office/drawing/2014/main" id="{8C940245-8B57-44F5-95C7-0230674D80E4}"/>
               </a:ext>
             </a:extLst>
           </p:cNvPr>
@@ -9044,7 +9049,7 @@
           <p:cNvPr id="8" name="Rounded Rectangle 7">
             <a:extLst xmlns:a="http://schemas.openxmlformats.org/drawingml/2006/main">
               <a:ext uri="{FF2B5EF4-FFF2-40B4-BE49-F238E27FC236}">
-                <a16:creationId xmlns:a16="http://schemas.microsoft.com/office/drawing/2014/main" id="{5936EB77-E85A-44D3-A083-717DD3E1D29F}"/>
+                <a16:creationId xmlns:a16="http://schemas.microsoft.com/office/drawing/2014/main" id="{29A85A97-AAB5-457C-9354-E4829083E48D}"/>
               </a:ext>
             </a:extLst>
           </p:cNvPr>
@@ -9099,7 +9104,7 @@
           <p:cNvPr id="9" name="TextBox 8">
             <a:extLst xmlns:a="http://schemas.openxmlformats.org/drawingml/2006/main">
               <a:ext uri="{FF2B5EF4-FFF2-40B4-BE49-F238E27FC236}">
-                <a16:creationId xmlns:a16="http://schemas.microsoft.com/office/drawing/2014/main" id="{A23E3B05-580A-406C-A89F-830CAC5D6C75}"/>
+                <a16:creationId xmlns:a16="http://schemas.microsoft.com/office/drawing/2014/main" id="{C385E764-1748-473A-A380-F6F4D77B3918}"/>
               </a:ext>
             </a:extLst>
           </p:cNvPr>
@@ -9258,7 +9263,7 @@
     </p:spTree>
     <p:extLst>
       <p:ext uri="{BB962C8B-B14F-4D97-AF65-F5344CB8AC3E}">
-        <p14:creationId xmlns:p14="http://schemas.microsoft.com/office/powerpoint/2010/main" val="1938898888"/>
+        <p14:creationId xmlns:p14="http://schemas.microsoft.com/office/powerpoint/2010/main" val="1698233138"/>
       </p:ext>
     </p:extLst>
   </p:cSld>
@@ -9282,7 +9287,7 @@
           <p:cNvPr id="2" name="Rectangle 1">
             <a:extLst xmlns:a="http://schemas.openxmlformats.org/drawingml/2006/main">
               <a:ext uri="{FF2B5EF4-FFF2-40B4-BE49-F238E27FC236}">
-                <a16:creationId xmlns:a16="http://schemas.microsoft.com/office/drawing/2014/main" id="{FF338CF3-49F1-4189-8CA0-FBDF197A816A}"/>
+                <a16:creationId xmlns:a16="http://schemas.microsoft.com/office/drawing/2014/main" id="{33F57D29-E76D-40C5-9F4B-89919E974F92}"/>
               </a:ext>
             </a:extLst>
           </p:cNvPr>
@@ -9335,7 +9340,7 @@
           <p:cNvPr id="3" name="Rectangle 2">
             <a:extLst xmlns:a="http://schemas.openxmlformats.org/drawingml/2006/main">
               <a:ext uri="{FF2B5EF4-FFF2-40B4-BE49-F238E27FC236}">
-                <a16:creationId xmlns:a16="http://schemas.microsoft.com/office/drawing/2014/main" id="{C4C0FC8C-5845-4423-9E65-A6BF677A74B9}"/>
+                <a16:creationId xmlns:a16="http://schemas.microsoft.com/office/drawing/2014/main" id="{CFAE431C-16E6-43F8-9CB8-CC1F2FA4E979}"/>
               </a:ext>
             </a:extLst>
           </p:cNvPr>
@@ -9388,7 +9393,7 @@
           <p:cNvPr id="4" name="Rectangle 3">
             <a:extLst xmlns:a="http://schemas.openxmlformats.org/drawingml/2006/main">
               <a:ext uri="{FF2B5EF4-FFF2-40B4-BE49-F238E27FC236}">
-                <a16:creationId xmlns:a16="http://schemas.microsoft.com/office/drawing/2014/main" id="{34FD2B31-B165-4DD9-BADF-DE4A8A6500D1}"/>
+                <a16:creationId xmlns:a16="http://schemas.microsoft.com/office/drawing/2014/main" id="{750509EF-D968-4C31-9D1A-12B15D10AD73}"/>
               </a:ext>
             </a:extLst>
           </p:cNvPr>
@@ -9441,7 +9446,7 @@
           <p:cNvPr id="5" name="TextBox 4">
             <a:extLst xmlns:a="http://schemas.openxmlformats.org/drawingml/2006/main">
               <a:ext uri="{FF2B5EF4-FFF2-40B4-BE49-F238E27FC236}">
-                <a16:creationId xmlns:a16="http://schemas.microsoft.com/office/drawing/2014/main" id="{41EC2395-27F2-4749-8D31-9DE7B3BA212E}"/>
+                <a16:creationId xmlns:a16="http://schemas.microsoft.com/office/drawing/2014/main" id="{08988000-8C54-4016-8488-6949BE3409DB}"/>
               </a:ext>
             </a:extLst>
           </p:cNvPr>
@@ -9504,7 +9509,7 @@
           <p:cNvPr id="6" name="Rounded Rectangle 5">
             <a:extLst xmlns:a="http://schemas.openxmlformats.org/drawingml/2006/main">
               <a:ext uri="{FF2B5EF4-FFF2-40B4-BE49-F238E27FC236}">
-                <a16:creationId xmlns:a16="http://schemas.microsoft.com/office/drawing/2014/main" id="{CE5DE87F-8BE0-4C47-9285-E683B7FA935B}"/>
+                <a16:creationId xmlns:a16="http://schemas.microsoft.com/office/drawing/2014/main" id="{B87E967F-F1DB-4564-8806-25657B9BDF16}"/>
               </a:ext>
             </a:extLst>
           </p:cNvPr>
@@ -9559,7 +9564,7 @@
           <p:cNvPr id="7" name="TextBox 6">
             <a:extLst xmlns:a="http://schemas.openxmlformats.org/drawingml/2006/main">
               <a:ext uri="{FF2B5EF4-FFF2-40B4-BE49-F238E27FC236}">
-                <a16:creationId xmlns:a16="http://schemas.microsoft.com/office/drawing/2014/main" id="{306FF487-D4E9-4CBA-AD95-F317BC41B25A}"/>
+                <a16:creationId xmlns:a16="http://schemas.microsoft.com/office/drawing/2014/main" id="{F6733F74-2107-4DA5-9A3F-8FCE95A79125}"/>
               </a:ext>
             </a:extLst>
           </p:cNvPr>
@@ -9777,7 +9782,7 @@
           <p:cNvPr id="8" name="Rounded Rectangle 7">
             <a:extLst xmlns:a="http://schemas.openxmlformats.org/drawingml/2006/main">
               <a:ext uri="{FF2B5EF4-FFF2-40B4-BE49-F238E27FC236}">
-                <a16:creationId xmlns:a16="http://schemas.microsoft.com/office/drawing/2014/main" id="{A2208063-B9B2-45C2-BA05-4BED92CF54C6}"/>
+                <a16:creationId xmlns:a16="http://schemas.microsoft.com/office/drawing/2014/main" id="{6CD334BA-CB48-4684-BFD5-834D7FFF24B1}"/>
               </a:ext>
             </a:extLst>
           </p:cNvPr>
@@ -9832,7 +9837,7 @@
           <p:cNvPr id="9" name="TextBox 8">
             <a:extLst xmlns:a="http://schemas.openxmlformats.org/drawingml/2006/main">
               <a:ext uri="{FF2B5EF4-FFF2-40B4-BE49-F238E27FC236}">
-                <a16:creationId xmlns:a16="http://schemas.microsoft.com/office/drawing/2014/main" id="{1CC938A3-FCD9-45A9-8448-8210E0FF7C18}"/>
+                <a16:creationId xmlns:a16="http://schemas.microsoft.com/office/drawing/2014/main" id="{7438878A-36C5-40D7-B529-03F99F50C9AB}"/>
               </a:ext>
             </a:extLst>
           </p:cNvPr>
@@ -10067,7 +10072,7 @@
     </p:spTree>
     <p:extLst>
       <p:ext uri="{BB962C8B-B14F-4D97-AF65-F5344CB8AC3E}">
-        <p14:creationId xmlns:p14="http://schemas.microsoft.com/office/powerpoint/2010/main" val="430492054"/>
+        <p14:creationId xmlns:p14="http://schemas.microsoft.com/office/powerpoint/2010/main" val="730359881"/>
       </p:ext>
     </p:extLst>
   </p:cSld>
@@ -10091,7 +10096,7 @@
           <p:cNvPr id="2" name="Rectangle 1">
             <a:extLst xmlns:a="http://schemas.openxmlformats.org/drawingml/2006/main">
               <a:ext uri="{FF2B5EF4-FFF2-40B4-BE49-F238E27FC236}">
-                <a16:creationId xmlns:a16="http://schemas.microsoft.com/office/drawing/2014/main" id="{933CBBDB-F531-428E-BBCF-B72E1D2C4B89}"/>
+                <a16:creationId xmlns:a16="http://schemas.microsoft.com/office/drawing/2014/main" id="{BD886271-9E50-48E9-8074-5992A607422C}"/>
               </a:ext>
             </a:extLst>
           </p:cNvPr>
@@ -10144,7 +10149,7 @@
           <p:cNvPr id="3" name="Rectangle 2">
             <a:extLst xmlns:a="http://schemas.openxmlformats.org/drawingml/2006/main">
               <a:ext uri="{FF2B5EF4-FFF2-40B4-BE49-F238E27FC236}">
-                <a16:creationId xmlns:a16="http://schemas.microsoft.com/office/drawing/2014/main" id="{636A6DA1-59C1-4641-9867-BC668B75E576}"/>
+                <a16:creationId xmlns:a16="http://schemas.microsoft.com/office/drawing/2014/main" id="{E548262D-EE3A-46F5-B428-95F9EF3BB378}"/>
               </a:ext>
             </a:extLst>
           </p:cNvPr>
@@ -10197,7 +10202,7 @@
           <p:cNvPr id="4" name="Rectangle 3">
             <a:extLst xmlns:a="http://schemas.openxmlformats.org/drawingml/2006/main">
               <a:ext uri="{FF2B5EF4-FFF2-40B4-BE49-F238E27FC236}">
-                <a16:creationId xmlns:a16="http://schemas.microsoft.com/office/drawing/2014/main" id="{692C25C1-1531-4046-8C53-7D4D1669E45D}"/>
+                <a16:creationId xmlns:a16="http://schemas.microsoft.com/office/drawing/2014/main" id="{A018D37F-572A-4C43-BE37-AE490C003635}"/>
               </a:ext>
             </a:extLst>
           </p:cNvPr>
@@ -10250,7 +10255,7 @@
           <p:cNvPr id="5" name="TextBox 4">
             <a:extLst xmlns:a="http://schemas.openxmlformats.org/drawingml/2006/main">
               <a:ext uri="{FF2B5EF4-FFF2-40B4-BE49-F238E27FC236}">
-                <a16:creationId xmlns:a16="http://schemas.microsoft.com/office/drawing/2014/main" id="{7F793D08-B33B-4FB6-BD50-E01FF2ADD1ED}"/>
+                <a16:creationId xmlns:a16="http://schemas.microsoft.com/office/drawing/2014/main" id="{6664577D-EEC3-4583-B64F-17C18EFCD88B}"/>
               </a:ext>
             </a:extLst>
           </p:cNvPr>
@@ -10313,7 +10318,7 @@
           <p:cNvPr id="6" name="Rounded Rectangle 5">
             <a:extLst xmlns:a="http://schemas.openxmlformats.org/drawingml/2006/main">
               <a:ext uri="{FF2B5EF4-FFF2-40B4-BE49-F238E27FC236}">
-                <a16:creationId xmlns:a16="http://schemas.microsoft.com/office/drawing/2014/main" id="{D45921BE-187D-462D-B8C3-1D96AC0737E7}"/>
+                <a16:creationId xmlns:a16="http://schemas.microsoft.com/office/drawing/2014/main" id="{6D1298E0-CD6D-4635-BBAC-98F012E57033}"/>
               </a:ext>
             </a:extLst>
           </p:cNvPr>
@@ -10368,7 +10373,7 @@
           <p:cNvPr id="7" name="TextBox 6">
             <a:extLst xmlns:a="http://schemas.openxmlformats.org/drawingml/2006/main">
               <a:ext uri="{FF2B5EF4-FFF2-40B4-BE49-F238E27FC236}">
-                <a16:creationId xmlns:a16="http://schemas.microsoft.com/office/drawing/2014/main" id="{29899210-2BB9-4524-86EE-0F480092C6EB}"/>
+                <a16:creationId xmlns:a16="http://schemas.microsoft.com/office/drawing/2014/main" id="{7CC56DAB-A78D-438A-B49B-75863023294E}"/>
               </a:ext>
             </a:extLst>
           </p:cNvPr>
@@ -10590,7 +10595,7 @@
           <p:nvPr/>
         </p:nvPicPr>
         <p:blipFill>
-          <a:blip xmlns:r="http://schemas.openxmlformats.org/officeDocument/2006/relationships" xmlns:a="http://schemas.openxmlformats.org/drawingml/2006/main" r:embed="R705e164ccab24789"/>
+          <a:blip xmlns:r="http://schemas.openxmlformats.org/officeDocument/2006/relationships" xmlns:a="http://schemas.openxmlformats.org/drawingml/2006/main" r:embed="R1fdd529506ff4862"/>
           <a:stretch xmlns:a="http://schemas.openxmlformats.org/drawingml/2006/main">
             <a:fillRect l="0" t="0" r="0" b="0"/>
           </a:stretch>
@@ -10610,7 +10615,7 @@
           <p:cNvPr id="9" name="Rounded Rectangle 8">
             <a:extLst xmlns:a="http://schemas.openxmlformats.org/drawingml/2006/main">
               <a:ext uri="{FF2B5EF4-FFF2-40B4-BE49-F238E27FC236}">
-                <a16:creationId xmlns:a16="http://schemas.microsoft.com/office/drawing/2014/main" id="{7223E386-7F3B-47CB-8655-7798FD1A4274}"/>
+                <a16:creationId xmlns:a16="http://schemas.microsoft.com/office/drawing/2014/main" id="{0E0F0CE4-8BBF-437D-80B9-EC8FB4C2CA80}"/>
               </a:ext>
             </a:extLst>
           </p:cNvPr>
@@ -10665,7 +10670,7 @@
           <p:cNvPr id="10" name="TextBox 9">
             <a:extLst xmlns:a="http://schemas.openxmlformats.org/drawingml/2006/main">
               <a:ext uri="{FF2B5EF4-FFF2-40B4-BE49-F238E27FC236}">
-                <a16:creationId xmlns:a16="http://schemas.microsoft.com/office/drawing/2014/main" id="{62C9A2B3-25A0-4B7D-AE35-F932911049C3}"/>
+                <a16:creationId xmlns:a16="http://schemas.microsoft.com/office/drawing/2014/main" id="{E08878C1-E243-4199-97F4-E4D94C606D6C}"/>
               </a:ext>
             </a:extLst>
           </p:cNvPr>
@@ -10751,7 +10756,7 @@
     </p:spTree>
     <p:extLst>
       <p:ext uri="{BB962C8B-B14F-4D97-AF65-F5344CB8AC3E}">
-        <p14:creationId xmlns:p14="http://schemas.microsoft.com/office/powerpoint/2010/main" val="947157156"/>
+        <p14:creationId xmlns:p14="http://schemas.microsoft.com/office/powerpoint/2010/main" val="346853300"/>
       </p:ext>
     </p:extLst>
   </p:cSld>
@@ -10775,7 +10780,7 @@
           <p:cNvPr id="2" name="Rectangle 1">
             <a:extLst xmlns:a="http://schemas.openxmlformats.org/drawingml/2006/main">
               <a:ext uri="{FF2B5EF4-FFF2-40B4-BE49-F238E27FC236}">
-                <a16:creationId xmlns:a16="http://schemas.microsoft.com/office/drawing/2014/main" id="{C2278535-11A9-43C9-9D57-F9FABE298112}"/>
+                <a16:creationId xmlns:a16="http://schemas.microsoft.com/office/drawing/2014/main" id="{06D5B608-F6C8-4C95-B30C-4AD003CF5CB5}"/>
               </a:ext>
             </a:extLst>
           </p:cNvPr>
@@ -10828,7 +10833,7 @@
           <p:cNvPr id="3" name="Rectangle 2">
             <a:extLst xmlns:a="http://schemas.openxmlformats.org/drawingml/2006/main">
               <a:ext uri="{FF2B5EF4-FFF2-40B4-BE49-F238E27FC236}">
-                <a16:creationId xmlns:a16="http://schemas.microsoft.com/office/drawing/2014/main" id="{4FE3A430-C84B-4D70-9C00-C1A2BD8BC2D6}"/>
+                <a16:creationId xmlns:a16="http://schemas.microsoft.com/office/drawing/2014/main" id="{7A77D484-72B8-4F17-A959-01EDF718DF98}"/>
               </a:ext>
             </a:extLst>
           </p:cNvPr>
@@ -10881,7 +10886,7 @@
           <p:cNvPr id="4" name="Rectangle 3">
             <a:extLst xmlns:a="http://schemas.openxmlformats.org/drawingml/2006/main">
               <a:ext uri="{FF2B5EF4-FFF2-40B4-BE49-F238E27FC236}">
-                <a16:creationId xmlns:a16="http://schemas.microsoft.com/office/drawing/2014/main" id="{6A936DB3-5BFB-4478-B92F-B46BB42BE267}"/>
+                <a16:creationId xmlns:a16="http://schemas.microsoft.com/office/drawing/2014/main" id="{F9620F5B-FAF8-4F7D-9C98-09922DA7CE9A}"/>
               </a:ext>
             </a:extLst>
           </p:cNvPr>
@@ -10934,7 +10939,7 @@
           <p:cNvPr id="5" name="TextBox 4">
             <a:extLst xmlns:a="http://schemas.openxmlformats.org/drawingml/2006/main">
               <a:ext uri="{FF2B5EF4-FFF2-40B4-BE49-F238E27FC236}">
-                <a16:creationId xmlns:a16="http://schemas.microsoft.com/office/drawing/2014/main" id="{DAE0BD85-F5CC-4979-B617-32FEB482CB76}"/>
+                <a16:creationId xmlns:a16="http://schemas.microsoft.com/office/drawing/2014/main" id="{47A05D45-7C59-4890-91C8-3225885DDB5E}"/>
               </a:ext>
             </a:extLst>
           </p:cNvPr>
@@ -10997,7 +11002,7 @@
           <p:cNvPr id="6" name="Rounded Rectangle 5">
             <a:extLst xmlns:a="http://schemas.openxmlformats.org/drawingml/2006/main">
               <a:ext uri="{FF2B5EF4-FFF2-40B4-BE49-F238E27FC236}">
-                <a16:creationId xmlns:a16="http://schemas.microsoft.com/office/drawing/2014/main" id="{D02B7167-D785-4073-93CB-E48AA6A3F690}"/>
+                <a16:creationId xmlns:a16="http://schemas.microsoft.com/office/drawing/2014/main" id="{E497226D-0AC7-4BE5-B544-C2A97D13F34A}"/>
               </a:ext>
             </a:extLst>
           </p:cNvPr>
@@ -11052,7 +11057,7 @@
           <p:cNvPr id="7" name="TextBox 6">
             <a:extLst xmlns:a="http://schemas.openxmlformats.org/drawingml/2006/main">
               <a:ext uri="{FF2B5EF4-FFF2-40B4-BE49-F238E27FC236}">
-                <a16:creationId xmlns:a16="http://schemas.microsoft.com/office/drawing/2014/main" id="{881445A8-BCCD-42FC-8BBA-E2EC75BD3112}"/>
+                <a16:creationId xmlns:a16="http://schemas.microsoft.com/office/drawing/2014/main" id="{92ED84E8-573E-455B-9C6E-1C7E0ED707FC}"/>
               </a:ext>
             </a:extLst>
           </p:cNvPr>
@@ -11289,7 +11294,7 @@
           <p:cNvPr id="8" name="Rounded Rectangle 7">
             <a:extLst xmlns:a="http://schemas.openxmlformats.org/drawingml/2006/main">
               <a:ext uri="{FF2B5EF4-FFF2-40B4-BE49-F238E27FC236}">
-                <a16:creationId xmlns:a16="http://schemas.microsoft.com/office/drawing/2014/main" id="{D68E7B79-6E03-4A1D-8502-3C7B7D7F9259}"/>
+                <a16:creationId xmlns:a16="http://schemas.microsoft.com/office/drawing/2014/main" id="{339BDEBF-AF1B-4815-AEFA-4A6E0717FF7F}"/>
               </a:ext>
             </a:extLst>
           </p:cNvPr>
@@ -11344,7 +11349,7 @@
           <p:cNvPr id="9" name="TextBox 8">
             <a:extLst xmlns:a="http://schemas.openxmlformats.org/drawingml/2006/main">
               <a:ext uri="{FF2B5EF4-FFF2-40B4-BE49-F238E27FC236}">
-                <a16:creationId xmlns:a16="http://schemas.microsoft.com/office/drawing/2014/main" id="{AE8634FE-540F-4F8C-B34A-022E8E790BCF}"/>
+                <a16:creationId xmlns:a16="http://schemas.microsoft.com/office/drawing/2014/main" id="{85D9B94A-4338-4A52-97CC-710D2EE71D29}"/>
               </a:ext>
             </a:extLst>
           </p:cNvPr>
@@ -11679,7 +11684,7 @@
     </p:spTree>
     <p:extLst>
       <p:ext uri="{BB962C8B-B14F-4D97-AF65-F5344CB8AC3E}">
-        <p14:creationId xmlns:p14="http://schemas.microsoft.com/office/powerpoint/2010/main" val="592533764"/>
+        <p14:creationId xmlns:p14="http://schemas.microsoft.com/office/powerpoint/2010/main" val="279318366"/>
       </p:ext>
     </p:extLst>
   </p:cSld>
@@ -11703,7 +11708,7 @@
           <p:cNvPr id="2" name="Rectangle 1">
             <a:extLst xmlns:a="http://schemas.openxmlformats.org/drawingml/2006/main">
               <a:ext uri="{FF2B5EF4-FFF2-40B4-BE49-F238E27FC236}">
-                <a16:creationId xmlns:a16="http://schemas.microsoft.com/office/drawing/2014/main" id="{71F0D1DA-EB69-4A2A-B554-955F08EE2CB7}"/>
+                <a16:creationId xmlns:a16="http://schemas.microsoft.com/office/drawing/2014/main" id="{742BF1C6-9628-4829-8511-7E4740CBDA54}"/>
               </a:ext>
             </a:extLst>
           </p:cNvPr>
@@ -11756,7 +11761,7 @@
           <p:cNvPr id="3" name="Rectangle 2">
             <a:extLst xmlns:a="http://schemas.openxmlformats.org/drawingml/2006/main">
               <a:ext uri="{FF2B5EF4-FFF2-40B4-BE49-F238E27FC236}">
-                <a16:creationId xmlns:a16="http://schemas.microsoft.com/office/drawing/2014/main" id="{832D5062-73ED-418B-94FE-332A65D40044}"/>
+                <a16:creationId xmlns:a16="http://schemas.microsoft.com/office/drawing/2014/main" id="{74915344-EF7E-467F-9957-CC87313528D3}"/>
               </a:ext>
             </a:extLst>
           </p:cNvPr>
@@ -11809,7 +11814,7 @@
           <p:cNvPr id="4" name="Rectangle 3">
             <a:extLst xmlns:a="http://schemas.openxmlformats.org/drawingml/2006/main">
               <a:ext uri="{FF2B5EF4-FFF2-40B4-BE49-F238E27FC236}">
-                <a16:creationId xmlns:a16="http://schemas.microsoft.com/office/drawing/2014/main" id="{D2298787-15A3-4AC7-BCF5-97A2F093C37A}"/>
+                <a16:creationId xmlns:a16="http://schemas.microsoft.com/office/drawing/2014/main" id="{53659B57-9C8C-40A9-AF60-16A18D874DE7}"/>
               </a:ext>
             </a:extLst>
           </p:cNvPr>
@@ -11862,7 +11867,7 @@
           <p:cNvPr id="5" name="TextBox 4">
             <a:extLst xmlns:a="http://schemas.openxmlformats.org/drawingml/2006/main">
               <a:ext uri="{FF2B5EF4-FFF2-40B4-BE49-F238E27FC236}">
-                <a16:creationId xmlns:a16="http://schemas.microsoft.com/office/drawing/2014/main" id="{CB4E470C-AEE2-40D7-9C94-E8EB961C7614}"/>
+                <a16:creationId xmlns:a16="http://schemas.microsoft.com/office/drawing/2014/main" id="{7A44891F-0971-485E-A233-4CF123A5739A}"/>
               </a:ext>
             </a:extLst>
           </p:cNvPr>
@@ -11925,7 +11930,7 @@
           <p:cNvPr id="6" name="Rounded Rectangle 5">
             <a:extLst xmlns:a="http://schemas.openxmlformats.org/drawingml/2006/main">
               <a:ext uri="{FF2B5EF4-FFF2-40B4-BE49-F238E27FC236}">
-                <a16:creationId xmlns:a16="http://schemas.microsoft.com/office/drawing/2014/main" id="{DDD30715-AA6E-4FB2-9280-3443B35BBAA5}"/>
+                <a16:creationId xmlns:a16="http://schemas.microsoft.com/office/drawing/2014/main" id="{5B34D758-34A1-476A-9CEE-D11B4E9841B7}"/>
               </a:ext>
             </a:extLst>
           </p:cNvPr>
@@ -11980,7 +11985,7 @@
           <p:cNvPr id="7" name="TextBox 6">
             <a:extLst xmlns:a="http://schemas.openxmlformats.org/drawingml/2006/main">
               <a:ext uri="{FF2B5EF4-FFF2-40B4-BE49-F238E27FC236}">
-                <a16:creationId xmlns:a16="http://schemas.microsoft.com/office/drawing/2014/main" id="{02857F93-C497-4334-A80A-866D28EE664D}"/>
+                <a16:creationId xmlns:a16="http://schemas.microsoft.com/office/drawing/2014/main" id="{8CFDBAB0-EA46-43FE-8C61-8AE8D6D9D96A}"/>
               </a:ext>
             </a:extLst>
           </p:cNvPr>
@@ -12103,7 +12108,7 @@
           <p:cNvPr id="8" name="Rounded Rectangle 7">
             <a:extLst xmlns:a="http://schemas.openxmlformats.org/drawingml/2006/main">
               <a:ext uri="{FF2B5EF4-FFF2-40B4-BE49-F238E27FC236}">
-                <a16:creationId xmlns:a16="http://schemas.microsoft.com/office/drawing/2014/main" id="{53447F41-003C-4C0D-91AE-15264D978320}"/>
+                <a16:creationId xmlns:a16="http://schemas.microsoft.com/office/drawing/2014/main" id="{5EDE8D18-9CBE-45C2-9DF7-6C7AEBA3F09F}"/>
               </a:ext>
             </a:extLst>
           </p:cNvPr>
@@ -12158,7 +12163,7 @@
           <p:cNvPr id="9" name="TextBox 8">
             <a:extLst xmlns:a="http://schemas.openxmlformats.org/drawingml/2006/main">
               <a:ext uri="{FF2B5EF4-FFF2-40B4-BE49-F238E27FC236}">
-                <a16:creationId xmlns:a16="http://schemas.microsoft.com/office/drawing/2014/main" id="{112B6782-B718-48AA-87A5-00C3A4A07726}"/>
+                <a16:creationId xmlns:a16="http://schemas.microsoft.com/office/drawing/2014/main" id="{BE7C79A6-26CD-42FD-A1A3-8DB96E120250}"/>
               </a:ext>
             </a:extLst>
           </p:cNvPr>
@@ -12281,7 +12286,7 @@
           <p:cNvPr id="10" name="Rounded Rectangle 9">
             <a:extLst xmlns:a="http://schemas.openxmlformats.org/drawingml/2006/main">
               <a:ext uri="{FF2B5EF4-FFF2-40B4-BE49-F238E27FC236}">
-                <a16:creationId xmlns:a16="http://schemas.microsoft.com/office/drawing/2014/main" id="{0A7B4466-6391-47FA-AA63-1DC3E7171F2F}"/>
+                <a16:creationId xmlns:a16="http://schemas.microsoft.com/office/drawing/2014/main" id="{B2EF3340-C821-4436-ABB8-7082C3884112}"/>
               </a:ext>
             </a:extLst>
           </p:cNvPr>
@@ -12336,7 +12341,7 @@
           <p:cNvPr id="11" name="TextBox 10">
             <a:extLst xmlns:a="http://schemas.openxmlformats.org/drawingml/2006/main">
               <a:ext uri="{FF2B5EF4-FFF2-40B4-BE49-F238E27FC236}">
-                <a16:creationId xmlns:a16="http://schemas.microsoft.com/office/drawing/2014/main" id="{3B78154F-5A60-4561-94E9-BDE0F17DA02E}"/>
+                <a16:creationId xmlns:a16="http://schemas.microsoft.com/office/drawing/2014/main" id="{101EEEF0-0931-4C97-9129-4E43EB51409F}"/>
               </a:ext>
             </a:extLst>
           </p:cNvPr>
@@ -12348,7 +12353,7 @@
         <p:spPr>
           <a:xfrm xmlns:a="http://schemas.openxmlformats.org/drawingml/2006/main">
             <a:off x="6430975" y="3310128"/>
-            <a:ext cx="4846320" cy="6304280"/>
+            <a:ext cx="4846320" cy="2889504"/>
           </a:xfrm>
           <a:prstGeom xmlns:a="http://schemas.openxmlformats.org/drawingml/2006/main" prst="rect">
             <a:avLst/>
@@ -12373,7 +12378,15 @@
               </a:defRPr>
             </a:pPr>
             <a:r>
-              <a:t>[DIAGNOSTIC TEST FIXTURE ONLY - NOT CANONICAL NUMERICAL RESULTS] RQ1 &amp; RQ2 Metrics:</a:t>
+              <a:rPr sz="713" b="1">
+                <a:solidFill>
+                  <a:srgbClr val="DC2626"/>
+                </a:solidFill>
+                <a:latin typeface="Calibri"/>
+                <a:ea typeface="Calibri"/>
+                <a:cs typeface="Calibri"/>
+              </a:rPr>
+              <a:t>[DIAGNOSTIC TEST FIXTURE ONLY - NOT CANONICAL NUMERICAL RESULTS]</a:t>
             </a:r>
           </a:p>
           <a:p xmlns:a="http://schemas.openxmlformats.org/drawingml/2006/main">
@@ -12389,15 +12402,39 @@
               </a:defRPr>
             </a:pPr>
             <a:r>
-              <a:rPr sz="1600" b="1">
+              <a:rPr sz="825" b="0">
+                <a:solidFill>
+                  <a:srgbClr val="0F172A"/>
+                </a:solidFill>
+                <a:latin typeface="Calibri"/>
+                <a:ea typeface="Calibri"/>
+                <a:cs typeface="Calibri"/>
+              </a:rPr>
+              <a:t>Bảng Đối Chứng Hiệu Năng RQ1 (Diagnostic Fixture):</a:t>
+            </a:r>
+          </a:p>
+          <a:p xmlns:a="http://schemas.openxmlformats.org/drawingml/2006/main">
+            <a:pPr>
+              <a:buNone/>
+              <a:defRPr sz="1600" b="1">
                 <a:solidFill>
                   <a:srgbClr val="DC2626"/>
                 </a:solidFill>
                 <a:latin typeface="Calibri"/>
                 <a:ea typeface="Calibri"/>
                 <a:cs typeface="Calibri"/>
+              </a:defRPr>
+            </a:pPr>
+            <a:r>
+              <a:rPr sz="825" b="0">
+                <a:solidFill>
+                  <a:srgbClr val="0F172A"/>
+                </a:solidFill>
+                <a:latin typeface="Calibri"/>
+                <a:ea typeface="Calibri"/>
+                <a:cs typeface="Calibri"/>
               </a:rPr>
-              <a:t>•  RQ1 5 Conditions Performance:</a:t>
+              <a:t>Condition      Accuracy    Macro-F1    Delta vs No-RAG</a:t>
             </a:r>
           </a:p>
           <a:p xmlns:a="http://schemas.openxmlformats.org/drawingml/2006/main">
@@ -12413,15 +12450,39 @@
               </a:defRPr>
             </a:pPr>
             <a:r>
-              <a:rPr sz="1600" b="1">
+              <a:rPr sz="825" b="0">
+                <a:solidFill>
+                  <a:srgbClr val="0F172A"/>
+                </a:solidFill>
+                <a:latin typeface="Calibri"/>
+                <a:ea typeface="Calibri"/>
+                <a:cs typeface="Calibri"/>
+              </a:rPr>
+              <a:t>-------------------------------------------------------</a:t>
+            </a:r>
+          </a:p>
+          <a:p xmlns:a="http://schemas.openxmlformats.org/drawingml/2006/main">
+            <a:pPr>
+              <a:buNone/>
+              <a:defRPr sz="1600" b="1">
                 <a:solidFill>
                   <a:srgbClr val="DC2626"/>
                 </a:solidFill>
                 <a:latin typeface="Calibri"/>
                 <a:ea typeface="Calibri"/>
                 <a:cs typeface="Calibri"/>
+              </a:defRPr>
+            </a:pPr>
+            <a:r>
+              <a:rPr sz="825" b="0">
+                <a:solidFill>
+                  <a:srgbClr val="0F172A"/>
+                </a:solidFill>
+                <a:latin typeface="Calibri"/>
+                <a:ea typeface="Calibri"/>
+                <a:cs typeface="Calibri"/>
               </a:rPr>
-              <a:t>  • no_rag: Acc = 0.5000, Macro-F1 = 0.0929, CI95 = [0.3500, 0.6500]</a:t>
+              <a:t>no_rag         0.5000      0.0929      baseline</a:t>
             </a:r>
           </a:p>
           <a:p xmlns:a="http://schemas.openxmlformats.org/drawingml/2006/main">
@@ -12437,15 +12498,39 @@
               </a:defRPr>
             </a:pPr>
             <a:r>
-              <a:rPr sz="1600" b="1">
+              <a:rPr sz="825" b="0">
+                <a:solidFill>
+                  <a:srgbClr val="0F172A"/>
+                </a:solidFill>
+                <a:latin typeface="Calibri"/>
+                <a:ea typeface="Calibri"/>
+                <a:cs typeface="Calibri"/>
+              </a:rPr>
+              <a:t>rag_k1         0.5000      0.0929      +0.0000 (+0.0000 F1)</a:t>
+            </a:r>
+          </a:p>
+          <a:p xmlns:a="http://schemas.openxmlformats.org/drawingml/2006/main">
+            <a:pPr>
+              <a:buNone/>
+              <a:defRPr sz="1600" b="1">
                 <a:solidFill>
                   <a:srgbClr val="DC2626"/>
                 </a:solidFill>
                 <a:latin typeface="Calibri"/>
                 <a:ea typeface="Calibri"/>
                 <a:cs typeface="Calibri"/>
+              </a:defRPr>
+            </a:pPr>
+            <a:r>
+              <a:rPr sz="825" b="0">
+                <a:solidFill>
+                  <a:srgbClr val="0F172A"/>
+                </a:solidFill>
+                <a:latin typeface="Calibri"/>
+                <a:ea typeface="Calibri"/>
+                <a:cs typeface="Calibri"/>
               </a:rPr>
-              <a:t>  • rag_k1: Acc = 0.5000, Macro-F1 = 0.0929, CI95 = [0.3500, 0.6500]</a:t>
+              <a:t>rag_k3         0.5000      0.0929      +0.0000 (+0.0000 F1)</a:t>
             </a:r>
           </a:p>
           <a:p xmlns:a="http://schemas.openxmlformats.org/drawingml/2006/main">
@@ -12461,15 +12546,39 @@
               </a:defRPr>
             </a:pPr>
             <a:r>
-              <a:rPr sz="1600" b="1">
+              <a:rPr sz="825" b="0">
+                <a:solidFill>
+                  <a:srgbClr val="0F172A"/>
+                </a:solidFill>
+                <a:latin typeface="Calibri"/>
+                <a:ea typeface="Calibri"/>
+                <a:cs typeface="Calibri"/>
+              </a:rPr>
+              <a:t>rag_k5         0.5000      0.0929      +0.0000 (+0.0000 F1)</a:t>
+            </a:r>
+          </a:p>
+          <a:p xmlns:a="http://schemas.openxmlformats.org/drawingml/2006/main">
+            <a:pPr>
+              <a:buNone/>
+              <a:defRPr sz="1600" b="1">
                 <a:solidFill>
                   <a:srgbClr val="DC2626"/>
                 </a:solidFill>
                 <a:latin typeface="Calibri"/>
                 <a:ea typeface="Calibri"/>
                 <a:cs typeface="Calibri"/>
+              </a:defRPr>
+            </a:pPr>
+            <a:r>
+              <a:rPr sz="825" b="0">
+                <a:solidFill>
+                  <a:srgbClr val="0F172A"/>
+                </a:solidFill>
+                <a:latin typeface="Calibri"/>
+                <a:ea typeface="Calibri"/>
+                <a:cs typeface="Calibri"/>
               </a:rPr>
-              <a:t>  • rag_k3: Acc = 0.5000, Macro-F1 = 0.0929, CI95 = [0.3500, 0.6500]</a:t>
+              <a:t>rag_k10        0.5000      0.0929      +0.0000 (+0.0000 F1)</a:t>
             </a:r>
           </a:p>
           <a:p xmlns:a="http://schemas.openxmlformats.org/drawingml/2006/main">
@@ -12485,15 +12594,39 @@
               </a:defRPr>
             </a:pPr>
             <a:r>
-              <a:rPr sz="1600" b="1">
+              <a:rPr sz="825" b="0">
+                <a:solidFill>
+                  <a:srgbClr val="0F172A"/>
+                </a:solidFill>
+                <a:latin typeface="Calibri"/>
+                <a:ea typeface="Calibri"/>
+                <a:cs typeface="Calibri"/>
+              </a:rPr>
+              <a:t>★ Best Condition: rag_k10 (Delta Acc = +0.0000, Delta F1 = +0.0000)</a:t>
+            </a:r>
+          </a:p>
+          <a:p xmlns:a="http://schemas.openxmlformats.org/drawingml/2006/main">
+            <a:pPr>
+              <a:buNone/>
+              <a:defRPr sz="1600" b="1">
                 <a:solidFill>
                   <a:srgbClr val="DC2626"/>
                 </a:solidFill>
                 <a:latin typeface="Calibri"/>
                 <a:ea typeface="Calibri"/>
                 <a:cs typeface="Calibri"/>
+              </a:defRPr>
+            </a:pPr>
+            <a:r>
+              <a:rPr sz="825" b="0">
+                <a:solidFill>
+                  <a:srgbClr val="0F172A"/>
+                </a:solidFill>
+                <a:latin typeface="Calibri"/>
+                <a:ea typeface="Calibri"/>
+                <a:cs typeface="Calibri"/>
               </a:rPr>
-              <a:t>  • rag_k5: Acc = 0.5000, Macro-F1 = 0.0929, CI95 = [0.3500, 0.6500]</a:t>
+              <a:t>• 95% CI: no_rag/k1/k3/k5/k10 = [0.3500, 0.6500] (chi tiết trong Speaker Notes)</a:t>
             </a:r>
           </a:p>
           <a:p xmlns:a="http://schemas.openxmlformats.org/drawingml/2006/main">
@@ -12509,187 +12642,15 @@
               </a:defRPr>
             </a:pPr>
             <a:r>
-              <a:rPr sz="1600" b="1">
-                <a:solidFill>
-                  <a:srgbClr val="DC2626"/>
+              <a:rPr sz="825" b="0">
+                <a:solidFill>
+                  <a:srgbClr val="0F172A"/>
                 </a:solidFill>
                 <a:latin typeface="Calibri"/>
                 <a:ea typeface="Calibri"/>
                 <a:cs typeface="Calibri"/>
               </a:rPr>
-              <a:t>  • rag_k10: Acc = 0.5000, Macro-F1 = 0.0929, CI95 = [0.3500, 0.6500]</a:t>
-            </a:r>
-          </a:p>
-          <a:p xmlns:a="http://schemas.openxmlformats.org/drawingml/2006/main">
-            <a:pPr>
-              <a:buNone/>
-              <a:defRPr sz="1600" b="1">
-                <a:solidFill>
-                  <a:srgbClr val="DC2626"/>
-                </a:solidFill>
-                <a:latin typeface="Calibri"/>
-                <a:ea typeface="Calibri"/>
-                <a:cs typeface="Calibri"/>
-              </a:defRPr>
-            </a:pPr>
-            <a:r>
-              <a:rPr sz="1600" b="1">
-                <a:solidFill>
-                  <a:srgbClr val="DC2626"/>
-                </a:solidFill>
-                <a:latin typeface="Calibri"/>
-                <a:ea typeface="Calibri"/>
-                <a:cs typeface="Calibri"/>
-              </a:rPr>
-              <a:t>  • Best Condition: rag_k10 (Delta Acc = +0.0000, Delta F1 = +0.0000)</a:t>
-            </a:r>
-          </a:p>
-          <a:p xmlns:a="http://schemas.openxmlformats.org/drawingml/2006/main">
-            <a:pPr>
-              <a:buNone/>
-              <a:defRPr sz="1600" b="1">
-                <a:solidFill>
-                  <a:srgbClr val="DC2626"/>
-                </a:solidFill>
-                <a:latin typeface="Calibri"/>
-                <a:ea typeface="Calibri"/>
-                <a:cs typeface="Calibri"/>
-              </a:defRPr>
-            </a:pPr>
-            <a:r>
-              <a:rPr sz="1600" b="1">
-                <a:solidFill>
-                  <a:srgbClr val="DC2626"/>
-                </a:solidFill>
-                <a:latin typeface="Calibri"/>
-                <a:ea typeface="Calibri"/>
-                <a:cs typeface="Calibri"/>
-              </a:rPr>
-              <a:t>•  RQ2 Failure Axes &amp; Overlaps:</a:t>
-            </a:r>
-          </a:p>
-          <a:p xmlns:a="http://schemas.openxmlformats.org/drawingml/2006/main">
-            <a:pPr>
-              <a:buNone/>
-              <a:defRPr sz="1600" b="1">
-                <a:solidFill>
-                  <a:srgbClr val="DC2626"/>
-                </a:solidFill>
-                <a:latin typeface="Calibri"/>
-                <a:ea typeface="Calibri"/>
-                <a:cs typeface="Calibri"/>
-              </a:defRPr>
-            </a:pPr>
-            <a:r>
-              <a:rPr sz="1600" b="1">
-                <a:solidFill>
-                  <a:srgbClr val="DC2626"/>
-                </a:solidFill>
-                <a:latin typeface="Calibri"/>
-                <a:ea typeface="Calibri"/>
-                <a:cs typeface="Calibri"/>
-              </a:rPr>
-              <a:t>  • Valid but Wrong Class Rate: 0.3333</a:t>
-            </a:r>
-          </a:p>
-          <a:p xmlns:a="http://schemas.openxmlformats.org/drawingml/2006/main">
-            <a:pPr>
-              <a:buNone/>
-              <a:defRPr sz="1600" b="1">
-                <a:solidFill>
-                  <a:srgbClr val="DC2626"/>
-                </a:solidFill>
-                <a:latin typeface="Calibri"/>
-                <a:ea typeface="Calibri"/>
-                <a:cs typeface="Calibri"/>
-              </a:defRPr>
-            </a:pPr>
-            <a:r>
-              <a:rPr sz="1600" b="1">
-                <a:solidFill>
-                  <a:srgbClr val="DC2626"/>
-                </a:solidFill>
-                <a:latin typeface="Calibri"/>
-                <a:ea typeface="Calibri"/>
-                <a:cs typeface="Calibri"/>
-              </a:rPr>
-              <a:t>  • Overlaps: Miss &amp; Wrong = 0, Miss &amp; Provider Fail = 0, Miss &amp; Parse Fail = 0, Miss &amp; Invalid ID = 0</a:t>
-            </a:r>
-          </a:p>
-          <a:p xmlns:a="http://schemas.openxmlformats.org/drawingml/2006/main">
-            <a:pPr>
-              <a:spcBef>
-                <a:spcPts val="350"/>
-              </a:spcBef>
-              <a:buNone/>
-              <a:defRPr sz="1150">
-                <a:solidFill>
-                  <a:srgbClr val="0F172A"/>
-                </a:solidFill>
-                <a:latin typeface="Calibri"/>
-                <a:ea typeface="Calibri"/>
-                <a:cs typeface="Calibri"/>
-              </a:defRPr>
-            </a:pPr>
-            <a:r>
-              <a:t>•  Ma trận TEST chính thức: 1,280 views x 5 nhánh (6,400 bản ghi) đang trong tiến trình chạy (PID 50192).</a:t>
-            </a:r>
-          </a:p>
-          <a:p xmlns:a="http://schemas.openxmlformats.org/drawingml/2006/main">
-            <a:pPr>
-              <a:spcBef>
-                <a:spcPts val="350"/>
-              </a:spcBef>
-              <a:buNone/>
-              <a:defRPr sz="1150">
-                <a:solidFill>
-                  <a:srgbClr val="0F172A"/>
-                </a:solidFill>
-                <a:latin typeface="Calibri"/>
-                <a:ea typeface="Calibri"/>
-                <a:cs typeface="Calibri"/>
-              </a:defRPr>
-            </a:pPr>
-            <a:r>
-              <a:t>•  Nguyên tắc Fail-Closed: Evaluator từ chối công bố điểm chính thức khi chưa đủ 6,400 records.</a:t>
-            </a:r>
-          </a:p>
-          <a:p xmlns:a="http://schemas.openxmlformats.org/drawingml/2006/main">
-            <a:pPr>
-              <a:spcBef>
-                <a:spcPts val="350"/>
-              </a:spcBef>
-              <a:buNone/>
-              <a:defRPr sz="1150">
-                <a:solidFill>
-                  <a:srgbClr val="0F172A"/>
-                </a:solidFill>
-                <a:latin typeface="Calibri"/>
-                <a:ea typeface="Calibri"/>
-                <a:cs typeface="Calibri"/>
-              </a:defRPr>
-            </a:pPr>
-            <a:r>
-              <a:t>•  Kiểm định toán học Evaluator: Đã xác thực ngoại tuyến qua 5 test fixtures (outputs/reproduction/fixture_diagnostics/).</a:t>
-            </a:r>
-          </a:p>
-          <a:p xmlns:a="http://schemas.openxmlformats.org/drawingml/2006/main">
-            <a:pPr>
-              <a:spcBef>
-                <a:spcPts val="350"/>
-              </a:spcBef>
-              <a:buNone/>
-              <a:defRPr sz="1150">
-                <a:solidFill>
-                  <a:srgbClr val="0F172A"/>
-                </a:solidFill>
-                <a:latin typeface="Calibri"/>
-                <a:ea typeface="Calibri"/>
-                <a:cs typeface="Calibri"/>
-              </a:defRPr>
-            </a:pPr>
-            <a:r>
-              <a:t>•  Đầu ra chuẩn: 6 metric JSON artifacts kèm _fixture_metadata.json (fixture_only: true).</a:t>
+              <a:t>• RQ2 Phân rã lỗi (k=10): Wrong Class = 0.3333 | Overlaps: Miss&amp;Wrong=0, Prov=0, Parse=0, Inval=0</a:t>
             </a:r>
           </a:p>
         </p:txBody>
@@ -12697,7 +12658,7 @@
     </p:spTree>
     <p:extLst>
       <p:ext uri="{BB962C8B-B14F-4D97-AF65-F5344CB8AC3E}">
-        <p14:creationId xmlns:p14="http://schemas.microsoft.com/office/powerpoint/2010/main" val="1974782684"/>
+        <p14:creationId xmlns:p14="http://schemas.microsoft.com/office/powerpoint/2010/main" val="445248828"/>
       </p:ext>
     </p:extLst>
   </p:cSld>
@@ -12721,7 +12682,7 @@
           <p:cNvPr id="2" name="Rectangle 1">
             <a:extLst xmlns:a="http://schemas.openxmlformats.org/drawingml/2006/main">
               <a:ext uri="{FF2B5EF4-FFF2-40B4-BE49-F238E27FC236}">
-                <a16:creationId xmlns:a16="http://schemas.microsoft.com/office/drawing/2014/main" id="{9A6F0D8B-1A90-4714-969B-24181BE960DB}"/>
+                <a16:creationId xmlns:a16="http://schemas.microsoft.com/office/drawing/2014/main" id="{E516140A-E4C3-4521-B9A7-417CFA224CEB}"/>
               </a:ext>
             </a:extLst>
           </p:cNvPr>
@@ -12774,7 +12735,7 @@
           <p:cNvPr id="3" name="Rectangle 2">
             <a:extLst xmlns:a="http://schemas.openxmlformats.org/drawingml/2006/main">
               <a:ext uri="{FF2B5EF4-FFF2-40B4-BE49-F238E27FC236}">
-                <a16:creationId xmlns:a16="http://schemas.microsoft.com/office/drawing/2014/main" id="{ADBDCF1C-D07F-429E-856E-07A24C7875A6}"/>
+                <a16:creationId xmlns:a16="http://schemas.microsoft.com/office/drawing/2014/main" id="{DD47A10E-8AC0-4EE0-A425-12D76AD055C4}"/>
               </a:ext>
             </a:extLst>
           </p:cNvPr>
@@ -12827,7 +12788,7 @@
           <p:cNvPr id="4" name="Rectangle 3">
             <a:extLst xmlns:a="http://schemas.openxmlformats.org/drawingml/2006/main">
               <a:ext uri="{FF2B5EF4-FFF2-40B4-BE49-F238E27FC236}">
-                <a16:creationId xmlns:a16="http://schemas.microsoft.com/office/drawing/2014/main" id="{8F493E1E-35A6-4DFE-998C-D11A5F19143E}"/>
+                <a16:creationId xmlns:a16="http://schemas.microsoft.com/office/drawing/2014/main" id="{23075E0F-4902-4FF0-8AA0-364388A617B7}"/>
               </a:ext>
             </a:extLst>
           </p:cNvPr>
@@ -12880,7 +12841,7 @@
           <p:cNvPr id="5" name="TextBox 4">
             <a:extLst xmlns:a="http://schemas.openxmlformats.org/drawingml/2006/main">
               <a:ext uri="{FF2B5EF4-FFF2-40B4-BE49-F238E27FC236}">
-                <a16:creationId xmlns:a16="http://schemas.microsoft.com/office/drawing/2014/main" id="{7D484F5E-28DF-403A-BD55-12E2DA5578B9}"/>
+                <a16:creationId xmlns:a16="http://schemas.microsoft.com/office/drawing/2014/main" id="{00B4D52D-E953-485B-B6A4-5D19AF334F73}"/>
               </a:ext>
             </a:extLst>
           </p:cNvPr>
@@ -12933,7 +12894,7 @@
               </a:defRPr>
             </a:pPr>
             <a:r>
-              <a:t>Dữ liệu DEV pilot (synthetic split), hạch toán token ước tính và kiểm soát ngân sách</a:t>
+              <a:t>Dữ liệu DEV pilot (synthetic split) đối chiếu Dự phóng Hạch toán Fixture [DIAGNOSTIC TEST FIXTURE ONLY]</a:t>
             </a:r>
           </a:p>
         </p:txBody>
@@ -12943,7 +12904,7 @@
           <p:cNvPr id="6" name="Rounded Rectangle 5">
             <a:extLst xmlns:a="http://schemas.openxmlformats.org/drawingml/2006/main">
               <a:ext uri="{FF2B5EF4-FFF2-40B4-BE49-F238E27FC236}">
-                <a16:creationId xmlns:a16="http://schemas.microsoft.com/office/drawing/2014/main" id="{5C71D30C-3B04-4ECE-88C3-560968794D82}"/>
+                <a16:creationId xmlns:a16="http://schemas.microsoft.com/office/drawing/2014/main" id="{5511BAE8-677F-437F-8449-FD16F0EDB3E2}"/>
               </a:ext>
             </a:extLst>
           </p:cNvPr>
@@ -12998,7 +12959,7 @@
           <p:cNvPr id="7" name="TextBox 6">
             <a:extLst xmlns:a="http://schemas.openxmlformats.org/drawingml/2006/main">
               <a:ext uri="{FF2B5EF4-FFF2-40B4-BE49-F238E27FC236}">
-                <a16:creationId xmlns:a16="http://schemas.microsoft.com/office/drawing/2014/main" id="{F1CC8640-F1C6-4672-91E4-8C87552209DC}"/>
+                <a16:creationId xmlns:a16="http://schemas.microsoft.com/office/drawing/2014/main" id="{9E23258A-4CDA-4FCC-88E0-CEAD1DD06641}"/>
               </a:ext>
             </a:extLst>
           </p:cNvPr>
@@ -13035,253 +12996,328 @@
               </a:defRPr>
             </a:pPr>
             <a:r>
-              <a:t>DEV Cost Pilot (Synthetic Split) &amp; Chi Phí Hạch Toán</a:t>
-            </a:r>
-          </a:p>
-          <a:p xmlns:a="http://schemas.openxmlformats.org/drawingml/2006/main">
-            <a:pPr>
-              <a:spcBef>
-                <a:spcPts val="200"/>
-              </a:spcBef>
-              <a:buNone/>
-              <a:defRPr sz="1050">
-                <a:solidFill>
-                  <a:srgbClr val="0F172A"/>
-                </a:solidFill>
-                <a:latin typeface="Calibri"/>
-                <a:ea typeface="Calibri"/>
-                <a:cs typeface="Calibri"/>
-              </a:defRPr>
-            </a:pPr>
-            <a:r>
-              <a:t>•  Bản chất dữ liệu: DEV cohort là dữ liệu tổng hợp (synthetic-paired-v1 DEV split, 4 views x 5 điều kiện). Gửi request thực lên LLM provider không biến log tổng hợp thành in-the-wild telemetry.</a:t>
-            </a:r>
-          </a:p>
-          <a:p xmlns:a="http://schemas.openxmlformats.org/drawingml/2006/main">
-            <a:pPr>
-              <a:spcBef>
-                <a:spcPts val="200"/>
-              </a:spcBef>
-              <a:buNone/>
-              <a:defRPr sz="1050">
-                <a:solidFill>
-                  <a:srgbClr val="0F172A"/>
-                </a:solidFill>
-                <a:latin typeface="Calibri"/>
-                <a:ea typeface="Calibri"/>
-                <a:cs typeface="Calibri"/>
-              </a:defRPr>
-            </a:pPr>
-            <a:r>
-              <a:t>•  Quy mô pilot: 20 requests thực tế qua Responses API (100% VALID, 0 retry, trễ TB 8,127.6 ms).</a:t>
-            </a:r>
-          </a:p>
-          <a:p xmlns:a="http://schemas.openxmlformats.org/drawingml/2006/main">
-            <a:pPr>
-              <a:spcBef>
-                <a:spcPts val="200"/>
-              </a:spcBef>
-              <a:buNone/>
-              <a:defRPr sz="1050">
-                <a:solidFill>
-                  <a:srgbClr val="0F172A"/>
-                </a:solidFill>
-                <a:latin typeface="Calibri"/>
-                <a:ea typeface="Calibri"/>
-                <a:cs typeface="Calibri"/>
-              </a:defRPr>
-            </a:pPr>
-            <a:r>
-              <a:t>•  Chi phí hạch toán ước tính từ token quan sát được và biểu giá công bố (Estimated / Accounted Cost):</a:t>
-            </a:r>
-          </a:p>
-          <a:p xmlns:a="http://schemas.openxmlformats.org/drawingml/2006/main">
-            <a:pPr>
-              <a:spcBef>
-                <a:spcPts val="200"/>
-              </a:spcBef>
-              <a:buNone/>
-              <a:defRPr sz="1050">
-                <a:solidFill>
-                  <a:srgbClr val="0F172A"/>
-                </a:solidFill>
-                <a:latin typeface="Calibri"/>
-                <a:ea typeface="Calibri"/>
-                <a:cs typeface="Calibri"/>
-              </a:defRPr>
-            </a:pPr>
-            <a:r>
-              <a:t>  • Pilot 20 requests: $0.024209 USD (conservative: $0.026320 USD) theo đơn giá.</a:t>
-            </a:r>
-          </a:p>
-          <a:p xmlns:a="http://schemas.openxmlformats.org/drawingml/2006/main">
-            <a:pPr>
-              <a:spcBef>
-                <a:spcPts val="200"/>
-              </a:spcBef>
-              <a:buNone/>
-              <a:defRPr sz="1050">
-                <a:solidFill>
-                  <a:srgbClr val="0F172A"/>
-                </a:solidFill>
-                <a:latin typeface="Calibri"/>
-                <a:ea typeface="Calibri"/>
-                <a:cs typeface="Calibri"/>
-              </a:defRPr>
-            </a:pPr>
-            <a:r>
+              <a:rPr sz="825" b="1">
+                <a:solidFill>
+                  <a:srgbClr val="1E40AF"/>
+                </a:solidFill>
+                <a:latin typeface="Calibri"/>
+                <a:ea typeface="Calibri"/>
+                <a:cs typeface="Calibri"/>
+              </a:rPr>
+              <a:t>DEV Pilot Telemetry &amp; Hạch Toán Dự Phóng [DIAGNOSTIC TEST FIXTURE ONLY - NOT CANONICAL NUMERICAL RESULTS]</a:t>
+            </a:r>
+          </a:p>
+          <a:p xmlns:a="http://schemas.openxmlformats.org/drawingml/2006/main">
+            <a:pPr>
+              <a:buNone/>
+              <a:defRPr sz="1600" b="1">
+                <a:solidFill>
+                  <a:srgbClr val="1E40AF"/>
+                </a:solidFill>
+                <a:latin typeface="Calibri"/>
+                <a:ea typeface="Calibri"/>
+                <a:cs typeface="Calibri"/>
+              </a:defRPr>
+            </a:pPr>
+          </a:p>
+          <a:p xmlns:a="http://schemas.openxmlformats.org/drawingml/2006/main">
+            <a:pPr>
+              <a:buNone/>
+              <a:defRPr sz="1600" b="1">
+                <a:solidFill>
+                  <a:srgbClr val="1E40AF"/>
+                </a:solidFill>
+                <a:latin typeface="Calibri"/>
+                <a:ea typeface="Calibri"/>
+                <a:cs typeface="Calibri"/>
+              </a:defRPr>
+            </a:pPr>
+            <a:r>
+              <a:rPr sz="825" b="1">
+                <a:solidFill>
+                  <a:srgbClr val="1E40AF"/>
+                </a:solidFill>
+                <a:latin typeface="Calibri"/>
+                <a:ea typeface="Calibri"/>
+                <a:cs typeface="Calibri"/>
+              </a:rPr>
+              <a:t>▶ [HISTORICAL DEV PILOT BASELINE (20 Requests)]</a:t>
+            </a:r>
+          </a:p>
+          <a:p xmlns:a="http://schemas.openxmlformats.org/drawingml/2006/main">
+            <a:pPr>
+              <a:buNone/>
+              <a:defRPr sz="1600" b="1">
+                <a:solidFill>
+                  <a:srgbClr val="1E40AF"/>
+                </a:solidFill>
+                <a:latin typeface="Calibri"/>
+                <a:ea typeface="Calibri"/>
+                <a:cs typeface="Calibri"/>
+              </a:defRPr>
+            </a:pPr>
+            <a:r>
+              <a:rPr sz="825" b="1">
+                <a:solidFill>
+                  <a:srgbClr val="1E40AF"/>
+                </a:solidFill>
+                <a:latin typeface="Calibri"/>
+                <a:ea typeface="Calibri"/>
+                <a:cs typeface="Calibri"/>
+              </a:rPr>
+              <a:t>• Bản chất: DEV split tổng hợp (4 views x 5 điều kiện). Gửi request thực tế không biến log tổng hợp thành in-the-wild telemetry.</a:t>
+            </a:r>
+          </a:p>
+          <a:p xmlns:a="http://schemas.openxmlformats.org/drawingml/2006/main">
+            <a:pPr>
+              <a:buNone/>
+              <a:defRPr sz="1600" b="1">
+                <a:solidFill>
+                  <a:srgbClr val="1E40AF"/>
+                </a:solidFill>
+                <a:latin typeface="Calibri"/>
+                <a:ea typeface="Calibri"/>
+                <a:cs typeface="Calibri"/>
+              </a:defRPr>
+            </a:pPr>
+            <a:r>
+              <a:rPr sz="825" b="1">
+                <a:solidFill>
+                  <a:srgbClr val="1E40AF"/>
+                </a:solidFill>
+                <a:latin typeface="Calibri"/>
+                <a:ea typeface="Calibri"/>
+                <a:cs typeface="Calibri"/>
+              </a:rPr>
+              <a:t>• Quy mô: 20 requests thực tế Responses API (100% VALID, 0 retry, trễ TB 8,127.6 ms).</a:t>
+            </a:r>
+          </a:p>
+          <a:p xmlns:a="http://schemas.openxmlformats.org/drawingml/2006/main">
+            <a:pPr>
+              <a:buNone/>
+              <a:defRPr sz="1600" b="1">
+                <a:solidFill>
+                  <a:srgbClr val="1E40AF"/>
+                </a:solidFill>
+                <a:latin typeface="Calibri"/>
+                <a:ea typeface="Calibri"/>
+                <a:cs typeface="Calibri"/>
+              </a:defRPr>
+            </a:pPr>
+            <a:r>
+              <a:rPr sz="825" b="1">
+                <a:solidFill>
+                  <a:srgbClr val="1E40AF"/>
+                </a:solidFill>
+                <a:latin typeface="Calibri"/>
+                <a:ea typeface="Calibri"/>
+                <a:cs typeface="Calibri"/>
+              </a:rPr>
+              <a:t>• Tiêu thụ tài nguyên &amp; chi phí quan sát được (Observed Telemetry):</a:t>
+            </a:r>
+          </a:p>
+          <a:p xmlns:a="http://schemas.openxmlformats.org/drawingml/2006/main">
+            <a:pPr>
+              <a:buNone/>
+              <a:defRPr sz="1600" b="1">
+                <a:solidFill>
+                  <a:srgbClr val="1E40AF"/>
+                </a:solidFill>
+                <a:latin typeface="Calibri"/>
+                <a:ea typeface="Calibri"/>
+                <a:cs typeface="Calibri"/>
+              </a:defRPr>
+            </a:pPr>
+            <a:r>
+              <a:rPr sz="825" b="1">
+                <a:solidFill>
+                  <a:srgbClr val="1E40AF"/>
+                </a:solidFill>
+                <a:latin typeface="Calibri"/>
+                <a:ea typeface="Calibri"/>
+                <a:cs typeface="Calibri"/>
+              </a:rPr>
               <a:t>  • no_rag (k=0): 643.0 mean prompt tokens, med lat 7.89s (~0.000390 USD / logical req)</a:t>
             </a:r>
           </a:p>
           <a:p xmlns:a="http://schemas.openxmlformats.org/drawingml/2006/main">
             <a:pPr>
-              <a:spcBef>
-                <a:spcPts val="200"/>
-              </a:spcBef>
-              <a:buNone/>
-              <a:defRPr sz="1050">
-                <a:solidFill>
-                  <a:srgbClr val="0F172A"/>
-                </a:solidFill>
-                <a:latin typeface="Calibri"/>
-                <a:ea typeface="Calibri"/>
-                <a:cs typeface="Calibri"/>
-              </a:defRPr>
-            </a:pPr>
-            <a:r>
-              <a:t>  • rag_k1 (k=1): 1,115 in / 332 out (~$0.00062 / query)</a:t>
-            </a:r>
-          </a:p>
-          <a:p xmlns:a="http://schemas.openxmlformats.org/drawingml/2006/main">
-            <a:pPr>
-              <a:spcBef>
-                <a:spcPts val="200"/>
-              </a:spcBef>
-              <a:buNone/>
-              <a:defRPr sz="1050">
-                <a:solidFill>
-                  <a:srgbClr val="0F172A"/>
-                </a:solidFill>
-                <a:latin typeface="Calibri"/>
-                <a:ea typeface="Calibri"/>
-                <a:cs typeface="Calibri"/>
-              </a:defRPr>
-            </a:pPr>
-            <a:r>
-              <a:t>  • rag_k3 (k=3): 1,741 in / 1,087 out (~$0.00165 / query - telemetry ban đầu)</a:t>
-            </a:r>
-          </a:p>
-          <a:p xmlns:a="http://schemas.openxmlformats.org/drawingml/2006/main">
-            <a:pPr>
-              <a:spcBef>
-                <a:spcPts val="200"/>
-              </a:spcBef>
-              <a:buNone/>
-              <a:defRPr sz="1050">
-                <a:solidFill>
-                  <a:srgbClr val="0F172A"/>
-                </a:solidFill>
-                <a:latin typeface="Calibri"/>
-                <a:ea typeface="Calibri"/>
-                <a:cs typeface="Calibri"/>
-              </a:defRPr>
-            </a:pPr>
-            <a:r>
-              <a:t>  • rag_k5 (k=5): 2,518 in / 840 out (~$0.00151 / query)</a:t>
-            </a:r>
-          </a:p>
-          <a:p xmlns:a="http://schemas.openxmlformats.org/drawingml/2006/main">
-            <a:pPr>
-              <a:spcBef>
-                <a:spcPts val="200"/>
-              </a:spcBef>
-              <a:buNone/>
-              <a:defRPr sz="1050">
-                <a:solidFill>
-                  <a:srgbClr val="0F172A"/>
-                </a:solidFill>
-                <a:latin typeface="Calibri"/>
-                <a:ea typeface="Calibri"/>
-                <a:cs typeface="Calibri"/>
-              </a:defRPr>
-            </a:pPr>
-            <a:r>
+              <a:buNone/>
+              <a:defRPr sz="1600" b="1">
+                <a:solidFill>
+                  <a:srgbClr val="1E40AF"/>
+                </a:solidFill>
+                <a:latin typeface="Calibri"/>
+                <a:ea typeface="Calibri"/>
+                <a:cs typeface="Calibri"/>
+              </a:defRPr>
+            </a:pPr>
+            <a:r>
+              <a:rPr sz="825" b="1">
+                <a:solidFill>
+                  <a:srgbClr val="1E40AF"/>
+                </a:solidFill>
+                <a:latin typeface="Calibri"/>
+                <a:ea typeface="Calibri"/>
+                <a:cs typeface="Calibri"/>
+              </a:rPr>
               <a:t>  • rag_k10 (k=10): 4536.5 mean prompt tokens, med lat 9.90s (~0.001870 USD / logical req)</a:t>
             </a:r>
           </a:p>
           <a:p xmlns:a="http://schemas.openxmlformats.org/drawingml/2006/main">
             <a:pPr>
-              <a:spcBef>
-                <a:spcPts val="200"/>
-              </a:spcBef>
-              <a:buNone/>
-              <a:defRPr sz="1050">
-                <a:solidFill>
-                  <a:srgbClr val="0F172A"/>
-                </a:solidFill>
-                <a:latin typeface="Calibri"/>
-                <a:ea typeface="Calibri"/>
-                <a:cs typeface="Calibri"/>
-              </a:defRPr>
-            </a:pPr>
-            <a:r>
-              <a:t>•  Phân định rõ ranh giới ngân sách:</a:t>
-            </a:r>
-          </a:p>
-          <a:p xmlns:a="http://schemas.openxmlformats.org/drawingml/2006/main">
-            <a:pPr>
-              <a:spcBef>
-                <a:spcPts val="200"/>
-              </a:spcBef>
-              <a:buNone/>
-              <a:defRPr sz="1050">
-                <a:solidFill>
-                  <a:srgbClr val="0F172A"/>
-                </a:solidFill>
-                <a:latin typeface="Calibri"/>
-                <a:ea typeface="Calibri"/>
-                <a:cs typeface="Calibri"/>
-              </a:defRPr>
-            </a:pPr>
-            <a:r>
+              <a:buNone/>
+              <a:defRPr sz="1600" b="1">
+                <a:solidFill>
+                  <a:srgbClr val="1E40AF"/>
+                </a:solidFill>
+                <a:latin typeface="Calibri"/>
+                <a:ea typeface="Calibri"/>
+                <a:cs typeface="Calibri"/>
+              </a:defRPr>
+            </a:pPr>
+            <a:r>
+              <a:rPr sz="825" b="1">
+                <a:solidFill>
+                  <a:srgbClr val="1E40AF"/>
+                </a:solidFill>
+                <a:latin typeface="Calibri"/>
+                <a:ea typeface="Calibri"/>
+                <a:cs typeface="Calibri"/>
+              </a:rPr>
               <a:t>  • Giữ chỗ thận trọng tạm thời: 0.05264010 USD (prior_pilot_provisional_hold_usd).</a:t>
             </a:r>
           </a:p>
           <a:p xmlns:a="http://schemas.openxmlformats.org/drawingml/2006/main">
             <a:pPr>
-              <a:spcBef>
-                <a:spcPts val="200"/>
-              </a:spcBef>
-              <a:buNone/>
-              <a:defRPr sz="1050">
-                <a:solidFill>
-                  <a:srgbClr val="0F172A"/>
-                </a:solidFill>
-                <a:latin typeface="Calibri"/>
-                <a:ea typeface="Calibri"/>
-                <a:cs typeface="Calibri"/>
-              </a:defRPr>
-            </a:pPr>
-            <a:r>
-              <a:t>  • Hạch toán điều kiện chuẩn (Canonical Total): 8.50 USD | Net Remaining: 11.44 USD.</a:t>
-            </a:r>
-          </a:p>
-          <a:p xmlns:a="http://schemas.openxmlformats.org/drawingml/2006/main">
-            <a:pPr>
-              <a:spcBef>
-                <a:spcPts val="200"/>
-              </a:spcBef>
-              <a:buNone/>
-              <a:defRPr sz="1050">
-                <a:solidFill>
-                  <a:srgbClr val="0F172A"/>
-                </a:solidFill>
-                <a:latin typeface="Calibri"/>
-                <a:ea typeface="Calibri"/>
-                <a:cs typeface="Calibri"/>
-              </a:defRPr>
-            </a:pPr>
-            <a:r>
+              <a:buNone/>
+              <a:defRPr sz="1600" b="1">
+                <a:solidFill>
+                  <a:srgbClr val="1E40AF"/>
+                </a:solidFill>
+                <a:latin typeface="Calibri"/>
+                <a:ea typeface="Calibri"/>
+                <a:cs typeface="Calibri"/>
+              </a:defRPr>
+            </a:pPr>
+          </a:p>
+          <a:p xmlns:a="http://schemas.openxmlformats.org/drawingml/2006/main">
+            <a:pPr>
+              <a:buNone/>
+              <a:defRPr sz="1600" b="1">
+                <a:solidFill>
+                  <a:srgbClr val="1E40AF"/>
+                </a:solidFill>
+                <a:latin typeface="Calibri"/>
+                <a:ea typeface="Calibri"/>
+                <a:cs typeface="Calibri"/>
+              </a:defRPr>
+            </a:pPr>
+            <a:r>
+              <a:rPr sz="825" b="1">
+                <a:solidFill>
+                  <a:srgbClr val="1E40AF"/>
+                </a:solidFill>
+                <a:latin typeface="Calibri"/>
+                <a:ea typeface="Calibri"/>
+                <a:cs typeface="Calibri"/>
+              </a:rPr>
+              <a:t>▶ [DIAGNOSTIC FIXTURE PROJECTION (N=718 SCORABLE VIEWS)]</a:t>
+            </a:r>
+          </a:p>
+          <a:p xmlns:a="http://schemas.openxmlformats.org/drawingml/2006/main">
+            <a:pPr>
+              <a:buNone/>
+              <a:defRPr sz="1600" b="1">
+                <a:solidFill>
+                  <a:srgbClr val="1E40AF"/>
+                </a:solidFill>
+                <a:latin typeface="Calibri"/>
+                <a:ea typeface="Calibri"/>
+                <a:cs typeface="Calibri"/>
+              </a:defRPr>
+            </a:pPr>
+            <a:r>
+              <a:rPr sz="825" b="1">
+                <a:solidFill>
+                  <a:srgbClr val="1E40AF"/>
+                </a:solidFill>
+                <a:latin typeface="Calibri"/>
+                <a:ea typeface="Calibri"/>
+                <a:cs typeface="Calibri"/>
+              </a:rPr>
+              <a:t>• Hạch toán toàn thể nghiên cứu theo fixture (Whole Study Accounting Fixture):</a:t>
+            </a:r>
+          </a:p>
+          <a:p xmlns:a="http://schemas.openxmlformats.org/drawingml/2006/main">
+            <a:pPr>
+              <a:buNone/>
+              <a:defRPr sz="1600" b="1">
+                <a:solidFill>
+                  <a:srgbClr val="1E40AF"/>
+                </a:solidFill>
+                <a:latin typeface="Calibri"/>
+                <a:ea typeface="Calibri"/>
+                <a:cs typeface="Calibri"/>
+              </a:defRPr>
+            </a:pPr>
+            <a:r>
+              <a:rPr sz="825" b="1">
+                <a:solidFill>
+                  <a:srgbClr val="1E40AF"/>
+                </a:solidFill>
+                <a:latin typeface="Calibri"/>
+                <a:ea typeface="Calibri"/>
+                <a:cs typeface="Calibri"/>
+              </a:rPr>
+              <a:t>  • Hạch toán điều kiện chuẩn (Canonical Total): 8.50 USD cho 6,400 requests.</a:t>
+            </a:r>
+          </a:p>
+          <a:p xmlns:a="http://schemas.openxmlformats.org/drawingml/2006/main">
+            <a:pPr>
+              <a:buNone/>
+              <a:defRPr sz="1600" b="1">
+                <a:solidFill>
+                  <a:srgbClr val="1E40AF"/>
+                </a:solidFill>
+                <a:latin typeface="Calibri"/>
+                <a:ea typeface="Calibri"/>
+                <a:cs typeface="Calibri"/>
+              </a:defRPr>
+            </a:pPr>
+            <a:r>
+              <a:rPr sz="825" b="1">
+                <a:solidFill>
+                  <a:srgbClr val="1E40AF"/>
+                </a:solidFill>
+                <a:latin typeface="Calibri"/>
+                <a:ea typeface="Calibri"/>
+                <a:cs typeface="Calibri"/>
+              </a:rPr>
+              <a:t>  • Ngân sách chưa cam kết còn lại (Net Remaining): 11.44 USD.</a:t>
+            </a:r>
+          </a:p>
+          <a:p xmlns:a="http://schemas.openxmlformats.org/drawingml/2006/main">
+            <a:pPr>
+              <a:buNone/>
+              <a:defRPr sz="1600" b="1">
+                <a:solidFill>
+                  <a:srgbClr val="1E40AF"/>
+                </a:solidFill>
+                <a:latin typeface="Calibri"/>
+                <a:ea typeface="Calibri"/>
+                <a:cs typeface="Calibri"/>
+              </a:defRPr>
+            </a:pPr>
+            <a:r>
+              <a:rPr sz="825" b="1">
+                <a:solidFill>
+                  <a:srgbClr val="1E40AF"/>
+                </a:solidFill>
+                <a:latin typeface="Calibri"/>
+                <a:ea typeface="Calibri"/>
+                <a:cs typeface="Calibri"/>
+              </a:rPr>
               <a:t>  • Trần ngân sách đóng băng cứng: 19.99 USD (hard_budget_limit_usd).</a:t>
             </a:r>
           </a:p>
@@ -13296,7 +13332,7 @@
           <p:nvPr/>
         </p:nvPicPr>
         <p:blipFill>
-          <a:blip xmlns:r="http://schemas.openxmlformats.org/officeDocument/2006/relationships" xmlns:a="http://schemas.openxmlformats.org/drawingml/2006/main" r:embed="Rd1920b8d366045d7"/>
+          <a:blip xmlns:r="http://schemas.openxmlformats.org/officeDocument/2006/relationships" xmlns:a="http://schemas.openxmlformats.org/drawingml/2006/main" r:embed="Rdd71940cb6394960"/>
           <a:stretch xmlns:a="http://schemas.openxmlformats.org/drawingml/2006/main">
             <a:fillRect l="0" t="0" r="0" b="0"/>
           </a:stretch>
@@ -13316,7 +13352,7 @@
           <p:cNvPr id="9" name="Rounded Rectangle 8">
             <a:extLst xmlns:a="http://schemas.openxmlformats.org/drawingml/2006/main">
               <a:ext uri="{FF2B5EF4-FFF2-40B4-BE49-F238E27FC236}">
-                <a16:creationId xmlns:a16="http://schemas.microsoft.com/office/drawing/2014/main" id="{5E4D2763-03FE-4E8D-BC91-1A227BFF91DD}"/>
+                <a16:creationId xmlns:a16="http://schemas.microsoft.com/office/drawing/2014/main" id="{67BE1C8E-4C45-46FC-A696-1296461D49A2}"/>
               </a:ext>
             </a:extLst>
           </p:cNvPr>
@@ -13371,7 +13407,7 @@
           <p:cNvPr id="10" name="TextBox 9">
             <a:extLst xmlns:a="http://schemas.openxmlformats.org/drawingml/2006/main">
               <a:ext uri="{FF2B5EF4-FFF2-40B4-BE49-F238E27FC236}">
-                <a16:creationId xmlns:a16="http://schemas.microsoft.com/office/drawing/2014/main" id="{4F1F517E-8CC7-4CD1-B2A3-D35B3B387BCE}"/>
+                <a16:creationId xmlns:a16="http://schemas.microsoft.com/office/drawing/2014/main" id="{B399EFDE-785B-4E0D-AE93-9F08E771C7C8}"/>
               </a:ext>
             </a:extLst>
           </p:cNvPr>
@@ -13446,7 +13482,7 @@
               </a:defRPr>
             </a:pPr>
             <a:r>
-              <a:t>•  Dự báo chuẩn tắc tập TEST (&lt; $10 USD) nằm an toàn dưới trần ngân sách đóng băng $19.99 USD.</a:t>
+              <a:t>•  Dự báo chuẩn tắc tập TEST: 8.50 USD nằm an toàn dưới trần ngân sách đóng băng 19.99 USD [DIAGNOSTIC FIXTURE].</a:t>
             </a:r>
           </a:p>
         </p:txBody>
@@ -13454,7 +13490,7 @@
     </p:spTree>
     <p:extLst>
       <p:ext uri="{BB962C8B-B14F-4D97-AF65-F5344CB8AC3E}">
-        <p14:creationId xmlns:p14="http://schemas.microsoft.com/office/powerpoint/2010/main" val="1229984318"/>
+        <p14:creationId xmlns:p14="http://schemas.microsoft.com/office/powerpoint/2010/main" val="2063367648"/>
       </p:ext>
     </p:extLst>
   </p:cSld>

</xml_diff>

<commit_message>
fix(presentation): make artifact-tool dependency resolution portable for CI runners
</commit_message>
<xml_diff>
--- a/reports/evidence/fixture_populated_slides.pptx
+++ b/reports/evidence/fixture_populated_slides.pptx
@@ -2,24 +2,24 @@
 <file path=ppt/presentation.xml><?xml version="1.0" encoding="utf-8"?>
 <p:presentation xmlns:p="http://schemas.openxmlformats.org/presentationml/2006/main">
   <p:sldMasterIdLst>
-    <p:sldMasterId xmlns:r="http://schemas.openxmlformats.org/officeDocument/2006/relationships" id="2147483648" r:id="Re83606f4b3cd4a6c"/>
+    <p:sldMasterId xmlns:r="http://schemas.openxmlformats.org/officeDocument/2006/relationships" id="2147483648" r:id="R60c301539b9a42b2"/>
   </p:sldMasterIdLst>
   <p:notesMasterIdLst>
-    <p:notesMasterId xmlns:r="http://schemas.openxmlformats.org/officeDocument/2006/relationships" r:id="Rb98fb851a9004693"/>
+    <p:notesMasterId xmlns:r="http://schemas.openxmlformats.org/officeDocument/2006/relationships" r:id="R41d0ef69073e4774"/>
   </p:notesMasterIdLst>
   <p:sldIdLst>
-    <p:sldId xmlns:r="http://schemas.openxmlformats.org/officeDocument/2006/relationships" id="256" r:id="Rc72db5862dc744cd"/>
-    <p:sldId xmlns:r="http://schemas.openxmlformats.org/officeDocument/2006/relationships" id="257" r:id="R847ef263d8c84ea2"/>
-    <p:sldId xmlns:r="http://schemas.openxmlformats.org/officeDocument/2006/relationships" id="258" r:id="R421d86f0cbf54a3f"/>
-    <p:sldId xmlns:r="http://schemas.openxmlformats.org/officeDocument/2006/relationships" id="259" r:id="Ra0ee6b1df59c400b"/>
-    <p:sldId xmlns:r="http://schemas.openxmlformats.org/officeDocument/2006/relationships" id="260" r:id="R9c40e427af924bf6"/>
-    <p:sldId xmlns:r="http://schemas.openxmlformats.org/officeDocument/2006/relationships" id="261" r:id="Ra1bfcc8411cf4d6f"/>
-    <p:sldId xmlns:r="http://schemas.openxmlformats.org/officeDocument/2006/relationships" id="262" r:id="Rc581e41578ab494f"/>
-    <p:sldId xmlns:r="http://schemas.openxmlformats.org/officeDocument/2006/relationships" id="263" r:id="R62576bcb9b6a4eed"/>
-    <p:sldId xmlns:r="http://schemas.openxmlformats.org/officeDocument/2006/relationships" id="264" r:id="Rd321c64c8e64467a"/>
-    <p:sldId xmlns:r="http://schemas.openxmlformats.org/officeDocument/2006/relationships" id="265" r:id="R60c66094471d4eb3"/>
-    <p:sldId xmlns:r="http://schemas.openxmlformats.org/officeDocument/2006/relationships" id="266" r:id="R75481b05ea3b4d2d"/>
-    <p:sldId xmlns:r="http://schemas.openxmlformats.org/officeDocument/2006/relationships" id="267" r:id="Rb613b301df2d45e1"/>
+    <p:sldId xmlns:r="http://schemas.openxmlformats.org/officeDocument/2006/relationships" id="256" r:id="R98004795aac947c4"/>
+    <p:sldId xmlns:r="http://schemas.openxmlformats.org/officeDocument/2006/relationships" id="257" r:id="R796c744cf7954b3f"/>
+    <p:sldId xmlns:r="http://schemas.openxmlformats.org/officeDocument/2006/relationships" id="258" r:id="R865353c44c4b43d0"/>
+    <p:sldId xmlns:r="http://schemas.openxmlformats.org/officeDocument/2006/relationships" id="259" r:id="R326b732faba1456d"/>
+    <p:sldId xmlns:r="http://schemas.openxmlformats.org/officeDocument/2006/relationships" id="260" r:id="Ree96208da5df48e8"/>
+    <p:sldId xmlns:r="http://schemas.openxmlformats.org/officeDocument/2006/relationships" id="261" r:id="Rf57e9d09a8d94d17"/>
+    <p:sldId xmlns:r="http://schemas.openxmlformats.org/officeDocument/2006/relationships" id="262" r:id="Rc252fb27690e4b69"/>
+    <p:sldId xmlns:r="http://schemas.openxmlformats.org/officeDocument/2006/relationships" id="263" r:id="R2d64358f688d4fa6"/>
+    <p:sldId xmlns:r="http://schemas.openxmlformats.org/officeDocument/2006/relationships" id="264" r:id="Ree75c31ff95e4c02"/>
+    <p:sldId xmlns:r="http://schemas.openxmlformats.org/officeDocument/2006/relationships" id="265" r:id="R44eeafb0679146a1"/>
+    <p:sldId xmlns:r="http://schemas.openxmlformats.org/officeDocument/2006/relationships" id="266" r:id="Ra432547eaafe4b00"/>
+    <p:sldId xmlns:r="http://schemas.openxmlformats.org/officeDocument/2006/relationships" id="267" r:id="Rb3ed13219605450c"/>
   </p:sldIdLst>
   <p:sldSz cx="12191695" cy="6858000"/>
   <p:notesSz cx="6858000" cy="9144000"/>
@@ -1582,7 +1582,7 @@
           <p:cNvPr id="2" name="Title 1">
             <a:extLst xmlns:a="http://schemas.openxmlformats.org/drawingml/2006/main">
               <a:ext uri="{FF2B5EF4-FFF2-40B4-BE49-F238E27FC236}">
-                <a16:creationId xmlns:a16="http://schemas.microsoft.com/office/drawing/2014/main" id="{F44F11A1-D9D1-40B6-898B-E87A0B75CFDC}"/>
+                <a16:creationId xmlns:a16="http://schemas.microsoft.com/office/drawing/2014/main" id="{6BAC8A54-B266-4D17-B129-B12B2DC685F9}"/>
               </a:ext>
             </a:extLst>
           </p:cNvPr>
@@ -1615,7 +1615,7 @@
           <p:cNvPr id="3" name="Subtitle 2">
             <a:extLst xmlns:a="http://schemas.openxmlformats.org/drawingml/2006/main">
               <a:ext uri="{FF2B5EF4-FFF2-40B4-BE49-F238E27FC236}">
-                <a16:creationId xmlns:a16="http://schemas.microsoft.com/office/drawing/2014/main" id="{930DB4F5-6C16-4C90-9478-D11BE04AD3CF}"/>
+                <a16:creationId xmlns:a16="http://schemas.microsoft.com/office/drawing/2014/main" id="{5BAC9853-E2B4-4A65-96D9-CB1B30CD5513}"/>
               </a:ext>
             </a:extLst>
           </p:cNvPr>
@@ -1739,7 +1739,7 @@
           <p:cNvPr id="4" name="Date Placeholder 3">
             <a:extLst xmlns:a="http://schemas.openxmlformats.org/drawingml/2006/main">
               <a:ext uri="{FF2B5EF4-FFF2-40B4-BE49-F238E27FC236}">
-                <a16:creationId xmlns:a16="http://schemas.microsoft.com/office/drawing/2014/main" id="{2364297E-B181-4E7C-BDED-C296B0D1BAF5}"/>
+                <a16:creationId xmlns:a16="http://schemas.microsoft.com/office/drawing/2014/main" id="{DB713E41-5C03-487B-A36B-7E738F67FFFB}"/>
               </a:ext>
             </a:extLst>
           </p:cNvPr>
@@ -1767,7 +1767,7 @@
           <p:cNvPr id="5" name="Footer Placeholder 4">
             <a:extLst xmlns:a="http://schemas.openxmlformats.org/drawingml/2006/main">
               <a:ext uri="{FF2B5EF4-FFF2-40B4-BE49-F238E27FC236}">
-                <a16:creationId xmlns:a16="http://schemas.microsoft.com/office/drawing/2014/main" id="{7BF34AB5-9A20-4CA0-94B6-782FB47F22B2}"/>
+                <a16:creationId xmlns:a16="http://schemas.microsoft.com/office/drawing/2014/main" id="{FD56411F-464C-4A27-B44E-57510F1D94C2}"/>
               </a:ext>
             </a:extLst>
           </p:cNvPr>
@@ -1792,7 +1792,7 @@
           <p:cNvPr id="6" name="Slide Number Placeholder 5">
             <a:extLst xmlns:a="http://schemas.openxmlformats.org/drawingml/2006/main">
               <a:ext uri="{FF2B5EF4-FFF2-40B4-BE49-F238E27FC236}">
-                <a16:creationId xmlns:a16="http://schemas.microsoft.com/office/drawing/2014/main" id="{87126F1A-131C-41AF-BA89-AFF5A89008BB}"/>
+                <a16:creationId xmlns:a16="http://schemas.microsoft.com/office/drawing/2014/main" id="{0E7FBB38-8B50-4E45-8402-A45817109674}"/>
               </a:ext>
             </a:extLst>
           </p:cNvPr>
@@ -1837,7 +1837,7 @@
           <p:cNvPr id="2" name="Title 1">
             <a:extLst xmlns:a="http://schemas.openxmlformats.org/drawingml/2006/main">
               <a:ext uri="{FF2B5EF4-FFF2-40B4-BE49-F238E27FC236}">
-                <a16:creationId xmlns:a16="http://schemas.microsoft.com/office/drawing/2014/main" id="{111D248A-AF11-4C73-A72A-C5BEDE797486}"/>
+                <a16:creationId xmlns:a16="http://schemas.microsoft.com/office/drawing/2014/main" id="{D29F0096-FAFC-4AE7-B5A6-F79B4B878DDB}"/>
               </a:ext>
             </a:extLst>
           </p:cNvPr>
@@ -1865,7 +1865,7 @@
           <p:cNvPr id="3" name="Vertical Text Placeholder 2">
             <a:extLst xmlns:a="http://schemas.openxmlformats.org/drawingml/2006/main">
               <a:ext uri="{FF2B5EF4-FFF2-40B4-BE49-F238E27FC236}">
-                <a16:creationId xmlns:a16="http://schemas.microsoft.com/office/drawing/2014/main" id="{E4921C64-FCEE-4DB9-AE36-6031A0A3236C}"/>
+                <a16:creationId xmlns:a16="http://schemas.microsoft.com/office/drawing/2014/main" id="{E27CFA59-85FB-400B-9BC9-B352CDF272B9}"/>
               </a:ext>
             </a:extLst>
           </p:cNvPr>
@@ -1928,7 +1928,7 @@
           <p:cNvPr id="4" name="Date Placeholder 3">
             <a:extLst xmlns:a="http://schemas.openxmlformats.org/drawingml/2006/main">
               <a:ext uri="{FF2B5EF4-FFF2-40B4-BE49-F238E27FC236}">
-                <a16:creationId xmlns:a16="http://schemas.microsoft.com/office/drawing/2014/main" id="{27DB5FD5-9099-452B-BA67-ABC28FF9937A}"/>
+                <a16:creationId xmlns:a16="http://schemas.microsoft.com/office/drawing/2014/main" id="{23977CB8-3260-4933-BF8F-8948188159B0}"/>
               </a:ext>
             </a:extLst>
           </p:cNvPr>
@@ -1956,7 +1956,7 @@
           <p:cNvPr id="5" name="Footer Placeholder 4">
             <a:extLst xmlns:a="http://schemas.openxmlformats.org/drawingml/2006/main">
               <a:ext uri="{FF2B5EF4-FFF2-40B4-BE49-F238E27FC236}">
-                <a16:creationId xmlns:a16="http://schemas.microsoft.com/office/drawing/2014/main" id="{2DDF249D-995E-4AD9-B1B6-3620E2DD0BC2}"/>
+                <a16:creationId xmlns:a16="http://schemas.microsoft.com/office/drawing/2014/main" id="{0AEC9E11-7F05-4048-AE00-C82D78290659}"/>
               </a:ext>
             </a:extLst>
           </p:cNvPr>
@@ -1981,7 +1981,7 @@
           <p:cNvPr id="6" name="Slide Number Placeholder 5">
             <a:extLst xmlns:a="http://schemas.openxmlformats.org/drawingml/2006/main">
               <a:ext uri="{FF2B5EF4-FFF2-40B4-BE49-F238E27FC236}">
-                <a16:creationId xmlns:a16="http://schemas.microsoft.com/office/drawing/2014/main" id="{E4D78CB9-DD79-4209-A95D-C2F80591BFC4}"/>
+                <a16:creationId xmlns:a16="http://schemas.microsoft.com/office/drawing/2014/main" id="{16AB11B5-6FE4-4867-9235-117D465492D6}"/>
               </a:ext>
             </a:extLst>
           </p:cNvPr>
@@ -2026,7 +2026,7 @@
           <p:cNvPr id="2" name="Vertical Title 1">
             <a:extLst xmlns:a="http://schemas.openxmlformats.org/drawingml/2006/main">
               <a:ext uri="{FF2B5EF4-FFF2-40B4-BE49-F238E27FC236}">
-                <a16:creationId xmlns:a16="http://schemas.microsoft.com/office/drawing/2014/main" id="{5C960FBB-342A-475B-A3CB-478F84E93E53}"/>
+                <a16:creationId xmlns:a16="http://schemas.microsoft.com/office/drawing/2014/main" id="{20B895C4-8AB8-4056-838F-48DB4F529F25}"/>
               </a:ext>
             </a:extLst>
           </p:cNvPr>
@@ -2059,7 +2059,7 @@
           <p:cNvPr id="3" name="Vertical Text Placeholder 2">
             <a:extLst xmlns:a="http://schemas.openxmlformats.org/drawingml/2006/main">
               <a:ext uri="{FF2B5EF4-FFF2-40B4-BE49-F238E27FC236}">
-                <a16:creationId xmlns:a16="http://schemas.microsoft.com/office/drawing/2014/main" id="{5FC16BEA-C5D8-4375-803D-3AB575F7C380}"/>
+                <a16:creationId xmlns:a16="http://schemas.microsoft.com/office/drawing/2014/main" id="{91EECE6D-DD09-4B7F-B9ED-937341AE28CE}"/>
               </a:ext>
             </a:extLst>
           </p:cNvPr>
@@ -2127,7 +2127,7 @@
           <p:cNvPr id="4" name="Date Placeholder 3">
             <a:extLst xmlns:a="http://schemas.openxmlformats.org/drawingml/2006/main">
               <a:ext uri="{FF2B5EF4-FFF2-40B4-BE49-F238E27FC236}">
-                <a16:creationId xmlns:a16="http://schemas.microsoft.com/office/drawing/2014/main" id="{FFF58B34-5AF2-4F6E-A67E-67DD445BBF5E}"/>
+                <a16:creationId xmlns:a16="http://schemas.microsoft.com/office/drawing/2014/main" id="{3B848512-2E89-42E0-A23B-A1D3FF406706}"/>
               </a:ext>
             </a:extLst>
           </p:cNvPr>
@@ -2155,7 +2155,7 @@
           <p:cNvPr id="5" name="Footer Placeholder 4">
             <a:extLst xmlns:a="http://schemas.openxmlformats.org/drawingml/2006/main">
               <a:ext uri="{FF2B5EF4-FFF2-40B4-BE49-F238E27FC236}">
-                <a16:creationId xmlns:a16="http://schemas.microsoft.com/office/drawing/2014/main" id="{F2B944A7-24B6-4CE7-95E8-126E95149D9E}"/>
+                <a16:creationId xmlns:a16="http://schemas.microsoft.com/office/drawing/2014/main" id="{E0F09F37-1999-4FB2-AA68-3933D34D435B}"/>
               </a:ext>
             </a:extLst>
           </p:cNvPr>
@@ -2180,7 +2180,7 @@
           <p:cNvPr id="6" name="Slide Number Placeholder 5">
             <a:extLst xmlns:a="http://schemas.openxmlformats.org/drawingml/2006/main">
               <a:ext uri="{FF2B5EF4-FFF2-40B4-BE49-F238E27FC236}">
-                <a16:creationId xmlns:a16="http://schemas.microsoft.com/office/drawing/2014/main" id="{D07A60E4-F8A9-46EC-921D-0500DD3FE713}"/>
+                <a16:creationId xmlns:a16="http://schemas.microsoft.com/office/drawing/2014/main" id="{11EA2F62-E160-4D15-9B14-4272380F4EDE}"/>
               </a:ext>
             </a:extLst>
           </p:cNvPr>
@@ -2225,7 +2225,7 @@
           <p:cNvPr id="2" name="Title 1">
             <a:extLst xmlns:a="http://schemas.openxmlformats.org/drawingml/2006/main">
               <a:ext uri="{FF2B5EF4-FFF2-40B4-BE49-F238E27FC236}">
-                <a16:creationId xmlns:a16="http://schemas.microsoft.com/office/drawing/2014/main" id="{803F5ED4-660F-408A-91E0-BDF4E256A258}"/>
+                <a16:creationId xmlns:a16="http://schemas.microsoft.com/office/drawing/2014/main" id="{381170BB-0575-43B6-8E1B-95A4BFFE9DCA}"/>
               </a:ext>
             </a:extLst>
           </p:cNvPr>
@@ -2253,7 +2253,7 @@
           <p:cNvPr id="3" name="Content Placeholder 2">
             <a:extLst xmlns:a="http://schemas.openxmlformats.org/drawingml/2006/main">
               <a:ext uri="{FF2B5EF4-FFF2-40B4-BE49-F238E27FC236}">
-                <a16:creationId xmlns:a16="http://schemas.microsoft.com/office/drawing/2014/main" id="{B285F96D-8E36-4D7E-A86F-FB6C84EEC949}"/>
+                <a16:creationId xmlns:a16="http://schemas.microsoft.com/office/drawing/2014/main" id="{4A21F695-A5C2-46B3-AB1C-E591B265874C}"/>
               </a:ext>
             </a:extLst>
           </p:cNvPr>
@@ -2316,7 +2316,7 @@
           <p:cNvPr id="4" name="Date Placeholder 3">
             <a:extLst xmlns:a="http://schemas.openxmlformats.org/drawingml/2006/main">
               <a:ext uri="{FF2B5EF4-FFF2-40B4-BE49-F238E27FC236}">
-                <a16:creationId xmlns:a16="http://schemas.microsoft.com/office/drawing/2014/main" id="{63008C74-E11C-4D9E-884F-F7A8A6ABD922}"/>
+                <a16:creationId xmlns:a16="http://schemas.microsoft.com/office/drawing/2014/main" id="{AD3B1133-D944-4C40-AF40-B059B1372658}"/>
               </a:ext>
             </a:extLst>
           </p:cNvPr>
@@ -2344,7 +2344,7 @@
           <p:cNvPr id="5" name="Footer Placeholder 4">
             <a:extLst xmlns:a="http://schemas.openxmlformats.org/drawingml/2006/main">
               <a:ext uri="{FF2B5EF4-FFF2-40B4-BE49-F238E27FC236}">
-                <a16:creationId xmlns:a16="http://schemas.microsoft.com/office/drawing/2014/main" id="{C9CB7494-8C35-4104-8C7D-35000602C07C}"/>
+                <a16:creationId xmlns:a16="http://schemas.microsoft.com/office/drawing/2014/main" id="{C606A1EE-0BFE-48EC-A111-1BFF2C8D25BE}"/>
               </a:ext>
             </a:extLst>
           </p:cNvPr>
@@ -2369,7 +2369,7 @@
           <p:cNvPr id="6" name="Slide Number Placeholder 5">
             <a:extLst xmlns:a="http://schemas.openxmlformats.org/drawingml/2006/main">
               <a:ext uri="{FF2B5EF4-FFF2-40B4-BE49-F238E27FC236}">
-                <a16:creationId xmlns:a16="http://schemas.microsoft.com/office/drawing/2014/main" id="{B0046C53-9EB5-458C-B52B-73CEF7421063}"/>
+                <a16:creationId xmlns:a16="http://schemas.microsoft.com/office/drawing/2014/main" id="{E02DA326-B2E1-4431-920C-08D6C4EBEDB3}"/>
               </a:ext>
             </a:extLst>
           </p:cNvPr>
@@ -2414,7 +2414,7 @@
           <p:cNvPr id="2" name="Title 1">
             <a:extLst xmlns:a="http://schemas.openxmlformats.org/drawingml/2006/main">
               <a:ext uri="{FF2B5EF4-FFF2-40B4-BE49-F238E27FC236}">
-                <a16:creationId xmlns:a16="http://schemas.microsoft.com/office/drawing/2014/main" id="{18533217-2BA5-454A-801E-72AED4AC6A05}"/>
+                <a16:creationId xmlns:a16="http://schemas.microsoft.com/office/drawing/2014/main" id="{29CFD0B2-A649-49F6-8048-242CD78F9777}"/>
               </a:ext>
             </a:extLst>
           </p:cNvPr>
@@ -2452,7 +2452,7 @@
           <p:cNvPr id="3" name="Text Placeholder 2">
             <a:extLst xmlns:a="http://schemas.openxmlformats.org/drawingml/2006/main">
               <a:ext uri="{FF2B5EF4-FFF2-40B4-BE49-F238E27FC236}">
-                <a16:creationId xmlns:a16="http://schemas.microsoft.com/office/drawing/2014/main" id="{46724E04-F1A3-471E-BADA-8EB3FCB4E579}"/>
+                <a16:creationId xmlns:a16="http://schemas.microsoft.com/office/drawing/2014/main" id="{93B22DBF-F101-4E2F-93B5-E91A733801F9}"/>
               </a:ext>
             </a:extLst>
           </p:cNvPr>
@@ -2578,7 +2578,7 @@
           <p:cNvPr id="4" name="Date Placeholder 3">
             <a:extLst xmlns:a="http://schemas.openxmlformats.org/drawingml/2006/main">
               <a:ext uri="{FF2B5EF4-FFF2-40B4-BE49-F238E27FC236}">
-                <a16:creationId xmlns:a16="http://schemas.microsoft.com/office/drawing/2014/main" id="{4EE7551C-5DC5-44E4-83F8-B3A556CF17C4}"/>
+                <a16:creationId xmlns:a16="http://schemas.microsoft.com/office/drawing/2014/main" id="{D4878441-47FA-4FEE-9975-672CCA9A95ED}"/>
               </a:ext>
             </a:extLst>
           </p:cNvPr>
@@ -2606,7 +2606,7 @@
           <p:cNvPr id="5" name="Footer Placeholder 4">
             <a:extLst xmlns:a="http://schemas.openxmlformats.org/drawingml/2006/main">
               <a:ext uri="{FF2B5EF4-FFF2-40B4-BE49-F238E27FC236}">
-                <a16:creationId xmlns:a16="http://schemas.microsoft.com/office/drawing/2014/main" id="{0918039C-14A0-4DA5-AA09-558494AD491B}"/>
+                <a16:creationId xmlns:a16="http://schemas.microsoft.com/office/drawing/2014/main" id="{CF450166-AEA2-4F18-941E-58CA66130E3F}"/>
               </a:ext>
             </a:extLst>
           </p:cNvPr>
@@ -2631,7 +2631,7 @@
           <p:cNvPr id="6" name="Slide Number Placeholder 5">
             <a:extLst xmlns:a="http://schemas.openxmlformats.org/drawingml/2006/main">
               <a:ext uri="{FF2B5EF4-FFF2-40B4-BE49-F238E27FC236}">
-                <a16:creationId xmlns:a16="http://schemas.microsoft.com/office/drawing/2014/main" id="{CD912306-96C3-4E48-A525-AFCC36EAB5A5}"/>
+                <a16:creationId xmlns:a16="http://schemas.microsoft.com/office/drawing/2014/main" id="{5538A868-EA90-4922-A9D3-71DF07AE4C3D}"/>
               </a:ext>
             </a:extLst>
           </p:cNvPr>
@@ -2676,7 +2676,7 @@
           <p:cNvPr id="2" name="Title 1">
             <a:extLst xmlns:a="http://schemas.openxmlformats.org/drawingml/2006/main">
               <a:ext uri="{FF2B5EF4-FFF2-40B4-BE49-F238E27FC236}">
-                <a16:creationId xmlns:a16="http://schemas.microsoft.com/office/drawing/2014/main" id="{CA0AE7F1-3363-4D74-9B78-EF2B1D7D6A2E}"/>
+                <a16:creationId xmlns:a16="http://schemas.microsoft.com/office/drawing/2014/main" id="{C2E8653D-9BAC-4622-8CCF-8AFA7A2959AB}"/>
               </a:ext>
             </a:extLst>
           </p:cNvPr>
@@ -2704,7 +2704,7 @@
           <p:cNvPr id="3" name="Content Placeholder 2">
             <a:extLst xmlns:a="http://schemas.openxmlformats.org/drawingml/2006/main">
               <a:ext uri="{FF2B5EF4-FFF2-40B4-BE49-F238E27FC236}">
-                <a16:creationId xmlns:a16="http://schemas.microsoft.com/office/drawing/2014/main" id="{84E3B196-8AF3-4E16-B832-D6A52E21AA27}"/>
+                <a16:creationId xmlns:a16="http://schemas.microsoft.com/office/drawing/2014/main" id="{EF9973C5-4385-4CDF-8211-C77C354C18F9}"/>
               </a:ext>
             </a:extLst>
           </p:cNvPr>
@@ -2809,7 +2809,7 @@
           <p:cNvPr id="4" name="Content Placeholder 3">
             <a:extLst xmlns:a="http://schemas.openxmlformats.org/drawingml/2006/main">
               <a:ext uri="{FF2B5EF4-FFF2-40B4-BE49-F238E27FC236}">
-                <a16:creationId xmlns:a16="http://schemas.microsoft.com/office/drawing/2014/main" id="{0E2382F8-C4EE-40C4-83D1-1775F65ACE29}"/>
+                <a16:creationId xmlns:a16="http://schemas.microsoft.com/office/drawing/2014/main" id="{93B7F301-935E-40A7-9317-761311BB5A11}"/>
               </a:ext>
             </a:extLst>
           </p:cNvPr>
@@ -2914,7 +2914,7 @@
           <p:cNvPr id="5" name="Date Placeholder 4">
             <a:extLst xmlns:a="http://schemas.openxmlformats.org/drawingml/2006/main">
               <a:ext uri="{FF2B5EF4-FFF2-40B4-BE49-F238E27FC236}">
-                <a16:creationId xmlns:a16="http://schemas.microsoft.com/office/drawing/2014/main" id="{74D76EB9-61C9-4774-A4BE-CB31AF7A1743}"/>
+                <a16:creationId xmlns:a16="http://schemas.microsoft.com/office/drawing/2014/main" id="{F2BB5FFD-38A0-4834-8F1A-00C870DD16AB}"/>
               </a:ext>
             </a:extLst>
           </p:cNvPr>
@@ -2942,7 +2942,7 @@
           <p:cNvPr id="6" name="Footer Placeholder 5">
             <a:extLst xmlns:a="http://schemas.openxmlformats.org/drawingml/2006/main">
               <a:ext uri="{FF2B5EF4-FFF2-40B4-BE49-F238E27FC236}">
-                <a16:creationId xmlns:a16="http://schemas.microsoft.com/office/drawing/2014/main" id="{54969EF2-40FB-4F00-8CA4-3569D46160F7}"/>
+                <a16:creationId xmlns:a16="http://schemas.microsoft.com/office/drawing/2014/main" id="{E39F74C9-51A7-4154-B175-161E153BBACE}"/>
               </a:ext>
             </a:extLst>
           </p:cNvPr>
@@ -2967,7 +2967,7 @@
           <p:cNvPr id="7" name="Slide Number Placeholder 6">
             <a:extLst xmlns:a="http://schemas.openxmlformats.org/drawingml/2006/main">
               <a:ext uri="{FF2B5EF4-FFF2-40B4-BE49-F238E27FC236}">
-                <a16:creationId xmlns:a16="http://schemas.microsoft.com/office/drawing/2014/main" id="{91894F93-5FFB-4396-A9C4-1EC45C52364F}"/>
+                <a16:creationId xmlns:a16="http://schemas.microsoft.com/office/drawing/2014/main" id="{B7A9FD89-F49C-49B2-90A4-776354E671CE}"/>
               </a:ext>
             </a:extLst>
           </p:cNvPr>
@@ -3012,7 +3012,7 @@
           <p:cNvPr id="2" name="Title 1">
             <a:extLst xmlns:a="http://schemas.openxmlformats.org/drawingml/2006/main">
               <a:ext uri="{FF2B5EF4-FFF2-40B4-BE49-F238E27FC236}">
-                <a16:creationId xmlns:a16="http://schemas.microsoft.com/office/drawing/2014/main" id="{B6BCBE43-05DB-4482-8F13-26FF27B33BFC}"/>
+                <a16:creationId xmlns:a16="http://schemas.microsoft.com/office/drawing/2014/main" id="{39215FEE-3B65-4DDE-98DE-BF9ECA397BAB}"/>
               </a:ext>
             </a:extLst>
           </p:cNvPr>
@@ -3045,7 +3045,7 @@
           <p:cNvPr id="3" name="Text Placeholder 2">
             <a:extLst xmlns:a="http://schemas.openxmlformats.org/drawingml/2006/main">
               <a:ext uri="{FF2B5EF4-FFF2-40B4-BE49-F238E27FC236}">
-                <a16:creationId xmlns:a16="http://schemas.microsoft.com/office/drawing/2014/main" id="{1D684AD9-C775-446C-B73D-8E05C78741B9}"/>
+                <a16:creationId xmlns:a16="http://schemas.microsoft.com/office/drawing/2014/main" id="{8EA09410-B06B-4CAC-BB24-50A5854337E8}"/>
               </a:ext>
             </a:extLst>
           </p:cNvPr>
@@ -3117,7 +3117,7 @@
           <p:cNvPr id="4" name="Content Placeholder 3">
             <a:extLst xmlns:a="http://schemas.openxmlformats.org/drawingml/2006/main">
               <a:ext uri="{FF2B5EF4-FFF2-40B4-BE49-F238E27FC236}">
-                <a16:creationId xmlns:a16="http://schemas.microsoft.com/office/drawing/2014/main" id="{735C2CAD-5DDF-4A9A-A4BA-D09860F9034A}"/>
+                <a16:creationId xmlns:a16="http://schemas.microsoft.com/office/drawing/2014/main" id="{22C97FE0-A601-4C7D-A49C-8B374E1FB0F4}"/>
               </a:ext>
             </a:extLst>
           </p:cNvPr>
@@ -3222,7 +3222,7 @@
           <p:cNvPr id="5" name="Text Placeholder 4">
             <a:extLst xmlns:a="http://schemas.openxmlformats.org/drawingml/2006/main">
               <a:ext uri="{FF2B5EF4-FFF2-40B4-BE49-F238E27FC236}">
-                <a16:creationId xmlns:a16="http://schemas.microsoft.com/office/drawing/2014/main" id="{BF80CB5B-E209-43DE-BE45-F4FBA700C3E5}"/>
+                <a16:creationId xmlns:a16="http://schemas.microsoft.com/office/drawing/2014/main" id="{CB32F6D0-931F-4E45-9401-AE6135FF6948}"/>
               </a:ext>
             </a:extLst>
           </p:cNvPr>
@@ -3294,7 +3294,7 @@
           <p:cNvPr id="6" name="Content Placeholder 5">
             <a:extLst xmlns:a="http://schemas.openxmlformats.org/drawingml/2006/main">
               <a:ext uri="{FF2B5EF4-FFF2-40B4-BE49-F238E27FC236}">
-                <a16:creationId xmlns:a16="http://schemas.microsoft.com/office/drawing/2014/main" id="{6FDAA89E-AEA2-402F-B648-8266F03E5107}"/>
+                <a16:creationId xmlns:a16="http://schemas.microsoft.com/office/drawing/2014/main" id="{F9AFD3E6-1537-42C1-A7F7-9CEF40A0DB56}"/>
               </a:ext>
             </a:extLst>
           </p:cNvPr>
@@ -3399,7 +3399,7 @@
           <p:cNvPr id="7" name="Date Placeholder 6">
             <a:extLst xmlns:a="http://schemas.openxmlformats.org/drawingml/2006/main">
               <a:ext uri="{FF2B5EF4-FFF2-40B4-BE49-F238E27FC236}">
-                <a16:creationId xmlns:a16="http://schemas.microsoft.com/office/drawing/2014/main" id="{302DC3D8-49DB-4502-91F7-AA6E9E8D12D0}"/>
+                <a16:creationId xmlns:a16="http://schemas.microsoft.com/office/drawing/2014/main" id="{38B2A55A-68E5-4F0A-B3B5-5E14C5E1F52E}"/>
               </a:ext>
             </a:extLst>
           </p:cNvPr>
@@ -3427,7 +3427,7 @@
           <p:cNvPr id="8" name="Footer Placeholder 7">
             <a:extLst xmlns:a="http://schemas.openxmlformats.org/drawingml/2006/main">
               <a:ext uri="{FF2B5EF4-FFF2-40B4-BE49-F238E27FC236}">
-                <a16:creationId xmlns:a16="http://schemas.microsoft.com/office/drawing/2014/main" id="{A742F8BD-180F-4201-A26E-A257E9476D69}"/>
+                <a16:creationId xmlns:a16="http://schemas.microsoft.com/office/drawing/2014/main" id="{9B43BA4C-0914-4C84-92F4-5639CE492B9B}"/>
               </a:ext>
             </a:extLst>
           </p:cNvPr>
@@ -3452,7 +3452,7 @@
           <p:cNvPr id="9" name="Slide Number Placeholder 8">
             <a:extLst xmlns:a="http://schemas.openxmlformats.org/drawingml/2006/main">
               <a:ext uri="{FF2B5EF4-FFF2-40B4-BE49-F238E27FC236}">
-                <a16:creationId xmlns:a16="http://schemas.microsoft.com/office/drawing/2014/main" id="{D61B3F9C-E723-4FD3-A91F-5449D8CFEF48}"/>
+                <a16:creationId xmlns:a16="http://schemas.microsoft.com/office/drawing/2014/main" id="{CF04DEFA-6CBF-4778-9E2F-BADE740B4698}"/>
               </a:ext>
             </a:extLst>
           </p:cNvPr>
@@ -3497,7 +3497,7 @@
           <p:cNvPr id="2" name="Title 1">
             <a:extLst xmlns:a="http://schemas.openxmlformats.org/drawingml/2006/main">
               <a:ext uri="{FF2B5EF4-FFF2-40B4-BE49-F238E27FC236}">
-                <a16:creationId xmlns:a16="http://schemas.microsoft.com/office/drawing/2014/main" id="{3FCE87A5-F629-42B7-9729-469675D5A1E8}"/>
+                <a16:creationId xmlns:a16="http://schemas.microsoft.com/office/drawing/2014/main" id="{6E244820-F515-4780-B2E5-6599333C96D5}"/>
               </a:ext>
             </a:extLst>
           </p:cNvPr>
@@ -3525,7 +3525,7 @@
           <p:cNvPr id="3" name="Date Placeholder 2">
             <a:extLst xmlns:a="http://schemas.openxmlformats.org/drawingml/2006/main">
               <a:ext uri="{FF2B5EF4-FFF2-40B4-BE49-F238E27FC236}">
-                <a16:creationId xmlns:a16="http://schemas.microsoft.com/office/drawing/2014/main" id="{4F87B7AD-2A00-41DA-AB21-5CD3B535097E}"/>
+                <a16:creationId xmlns:a16="http://schemas.microsoft.com/office/drawing/2014/main" id="{FC649291-0549-4F07-8836-6ECFEEFB65A7}"/>
               </a:ext>
             </a:extLst>
           </p:cNvPr>
@@ -3553,7 +3553,7 @@
           <p:cNvPr id="4" name="Footer Placeholder 3">
             <a:extLst xmlns:a="http://schemas.openxmlformats.org/drawingml/2006/main">
               <a:ext uri="{FF2B5EF4-FFF2-40B4-BE49-F238E27FC236}">
-                <a16:creationId xmlns:a16="http://schemas.microsoft.com/office/drawing/2014/main" id="{660839C9-CFFA-495B-8757-645548BD1B1D}"/>
+                <a16:creationId xmlns:a16="http://schemas.microsoft.com/office/drawing/2014/main" id="{DA56C1C7-1532-46C7-931B-835C98D08C93}"/>
               </a:ext>
             </a:extLst>
           </p:cNvPr>
@@ -3578,7 +3578,7 @@
           <p:cNvPr id="5" name="Slide Number Placeholder 4">
             <a:extLst xmlns:a="http://schemas.openxmlformats.org/drawingml/2006/main">
               <a:ext uri="{FF2B5EF4-FFF2-40B4-BE49-F238E27FC236}">
-                <a16:creationId xmlns:a16="http://schemas.microsoft.com/office/drawing/2014/main" id="{F668E14A-0FF8-4B31-AF04-8F7C79098C1B}"/>
+                <a16:creationId xmlns:a16="http://schemas.microsoft.com/office/drawing/2014/main" id="{27B0A53F-8710-4725-9F36-20013F137C16}"/>
               </a:ext>
             </a:extLst>
           </p:cNvPr>
@@ -3623,7 +3623,7 @@
           <p:cNvPr id="2" name="Date Placeholder 1">
             <a:extLst xmlns:a="http://schemas.openxmlformats.org/drawingml/2006/main">
               <a:ext uri="{FF2B5EF4-FFF2-40B4-BE49-F238E27FC236}">
-                <a16:creationId xmlns:a16="http://schemas.microsoft.com/office/drawing/2014/main" id="{61EC86E2-AAA0-4F88-8B6A-9740190C55D6}"/>
+                <a16:creationId xmlns:a16="http://schemas.microsoft.com/office/drawing/2014/main" id="{53301758-B3F3-41BD-8B6E-EC6E3B584630}"/>
               </a:ext>
             </a:extLst>
           </p:cNvPr>
@@ -3651,7 +3651,7 @@
           <p:cNvPr id="3" name="Footer Placeholder 2">
             <a:extLst xmlns:a="http://schemas.openxmlformats.org/drawingml/2006/main">
               <a:ext uri="{FF2B5EF4-FFF2-40B4-BE49-F238E27FC236}">
-                <a16:creationId xmlns:a16="http://schemas.microsoft.com/office/drawing/2014/main" id="{B0C9DD9B-0AB5-435E-A706-A6DB7098CBA8}"/>
+                <a16:creationId xmlns:a16="http://schemas.microsoft.com/office/drawing/2014/main" id="{70084350-56C8-4972-8F2C-0CD942ADC590}"/>
               </a:ext>
             </a:extLst>
           </p:cNvPr>
@@ -3676,7 +3676,7 @@
           <p:cNvPr id="4" name="Slide Number Placeholder 3">
             <a:extLst xmlns:a="http://schemas.openxmlformats.org/drawingml/2006/main">
               <a:ext uri="{FF2B5EF4-FFF2-40B4-BE49-F238E27FC236}">
-                <a16:creationId xmlns:a16="http://schemas.microsoft.com/office/drawing/2014/main" id="{6866060F-F0C1-4D63-A14D-8183F490818F}"/>
+                <a16:creationId xmlns:a16="http://schemas.microsoft.com/office/drawing/2014/main" id="{A5B6A157-098F-4699-8E80-7D9AABEF7E0E}"/>
               </a:ext>
             </a:extLst>
           </p:cNvPr>
@@ -3721,7 +3721,7 @@
           <p:cNvPr id="2" name="Title 1">
             <a:extLst xmlns:a="http://schemas.openxmlformats.org/drawingml/2006/main">
               <a:ext uri="{FF2B5EF4-FFF2-40B4-BE49-F238E27FC236}">
-                <a16:creationId xmlns:a16="http://schemas.microsoft.com/office/drawing/2014/main" id="{AD919CDA-6C08-4E95-808A-DEEC4A307162}"/>
+                <a16:creationId xmlns:a16="http://schemas.microsoft.com/office/drawing/2014/main" id="{DFDECB48-0595-4060-90D3-2CB747F217B7}"/>
               </a:ext>
             </a:extLst>
           </p:cNvPr>
@@ -3759,7 +3759,7 @@
           <p:cNvPr id="3" name="Content Placeholder 2">
             <a:extLst xmlns:a="http://schemas.openxmlformats.org/drawingml/2006/main">
               <a:ext uri="{FF2B5EF4-FFF2-40B4-BE49-F238E27FC236}">
-                <a16:creationId xmlns:a16="http://schemas.microsoft.com/office/drawing/2014/main" id="{1B0D5641-AF8A-4AAF-8C21-32DE7092D9D1}"/>
+                <a16:creationId xmlns:a16="http://schemas.microsoft.com/office/drawing/2014/main" id="{2417D2CD-E974-4389-94F7-80CFFABF357D}"/>
               </a:ext>
             </a:extLst>
           </p:cNvPr>
@@ -3864,7 +3864,7 @@
           <p:cNvPr id="4" name="Text Placeholder 3">
             <a:extLst xmlns:a="http://schemas.openxmlformats.org/drawingml/2006/main">
               <a:ext uri="{FF2B5EF4-FFF2-40B4-BE49-F238E27FC236}">
-                <a16:creationId xmlns:a16="http://schemas.microsoft.com/office/drawing/2014/main" id="{176D81D1-B201-4482-80C4-9EE87321933D}"/>
+                <a16:creationId xmlns:a16="http://schemas.microsoft.com/office/drawing/2014/main" id="{ADF67FA1-1DF0-45D7-B9AC-223933842760}"/>
               </a:ext>
             </a:extLst>
           </p:cNvPr>
@@ -3936,7 +3936,7 @@
           <p:cNvPr id="5" name="Date Placeholder 4">
             <a:extLst xmlns:a="http://schemas.openxmlformats.org/drawingml/2006/main">
               <a:ext uri="{FF2B5EF4-FFF2-40B4-BE49-F238E27FC236}">
-                <a16:creationId xmlns:a16="http://schemas.microsoft.com/office/drawing/2014/main" id="{BAE0EEEB-38D0-4E11-B22F-E3099CD21D57}"/>
+                <a16:creationId xmlns:a16="http://schemas.microsoft.com/office/drawing/2014/main" id="{948FB56E-C236-43EF-80D6-FF5D3A901D91}"/>
               </a:ext>
             </a:extLst>
           </p:cNvPr>
@@ -3964,7 +3964,7 @@
           <p:cNvPr id="6" name="Footer Placeholder 5">
             <a:extLst xmlns:a="http://schemas.openxmlformats.org/drawingml/2006/main">
               <a:ext uri="{FF2B5EF4-FFF2-40B4-BE49-F238E27FC236}">
-                <a16:creationId xmlns:a16="http://schemas.microsoft.com/office/drawing/2014/main" id="{FD5B68CB-5209-415A-8678-DD4068BB1534}"/>
+                <a16:creationId xmlns:a16="http://schemas.microsoft.com/office/drawing/2014/main" id="{EBC9ABBC-09DC-4477-B65C-81AB5859B794}"/>
               </a:ext>
             </a:extLst>
           </p:cNvPr>
@@ -3989,7 +3989,7 @@
           <p:cNvPr id="7" name="Slide Number Placeholder 6">
             <a:extLst xmlns:a="http://schemas.openxmlformats.org/drawingml/2006/main">
               <a:ext uri="{FF2B5EF4-FFF2-40B4-BE49-F238E27FC236}">
-                <a16:creationId xmlns:a16="http://schemas.microsoft.com/office/drawing/2014/main" id="{8A28C2F9-1D1C-448D-B368-D8A8B9530658}"/>
+                <a16:creationId xmlns:a16="http://schemas.microsoft.com/office/drawing/2014/main" id="{0C6863BD-210B-4ADC-977D-5C70B942C2E9}"/>
               </a:ext>
             </a:extLst>
           </p:cNvPr>
@@ -4034,7 +4034,7 @@
           <p:cNvPr id="2" name="Title 1">
             <a:extLst xmlns:a="http://schemas.openxmlformats.org/drawingml/2006/main">
               <a:ext uri="{FF2B5EF4-FFF2-40B4-BE49-F238E27FC236}">
-                <a16:creationId xmlns:a16="http://schemas.microsoft.com/office/drawing/2014/main" id="{3589967E-AC04-4FD4-808F-F8041470BC08}"/>
+                <a16:creationId xmlns:a16="http://schemas.microsoft.com/office/drawing/2014/main" id="{5219E51D-2723-4164-B1B3-823F69CFAF9F}"/>
               </a:ext>
             </a:extLst>
           </p:cNvPr>
@@ -4072,7 +4072,7 @@
           <p:cNvPr id="3" name="Picture Placeholder 2">
             <a:extLst xmlns:a="http://schemas.openxmlformats.org/drawingml/2006/main">
               <a:ext uri="{FF2B5EF4-FFF2-40B4-BE49-F238E27FC236}">
-                <a16:creationId xmlns:a16="http://schemas.microsoft.com/office/drawing/2014/main" id="{CF47FF55-AF3D-4C14-8F96-10AC765B35C2}"/>
+                <a16:creationId xmlns:a16="http://schemas.microsoft.com/office/drawing/2014/main" id="{B6193585-59E3-4A15-BA01-BDE858E515F2}"/>
               </a:ext>
             </a:extLst>
           </p:cNvPr>
@@ -4139,7 +4139,7 @@
           <p:cNvPr id="4" name="Text Placeholder 3">
             <a:extLst xmlns:a="http://schemas.openxmlformats.org/drawingml/2006/main">
               <a:ext uri="{FF2B5EF4-FFF2-40B4-BE49-F238E27FC236}">
-                <a16:creationId xmlns:a16="http://schemas.microsoft.com/office/drawing/2014/main" id="{485F67F0-62BD-456B-8A1A-6DD70DC1F87C}"/>
+                <a16:creationId xmlns:a16="http://schemas.microsoft.com/office/drawing/2014/main" id="{057DB795-2A23-4F3F-86F9-3613853D9D96}"/>
               </a:ext>
             </a:extLst>
           </p:cNvPr>
@@ -4211,7 +4211,7 @@
           <p:cNvPr id="5" name="Date Placeholder 4">
             <a:extLst xmlns:a="http://schemas.openxmlformats.org/drawingml/2006/main">
               <a:ext uri="{FF2B5EF4-FFF2-40B4-BE49-F238E27FC236}">
-                <a16:creationId xmlns:a16="http://schemas.microsoft.com/office/drawing/2014/main" id="{B7C545DD-DB45-42A6-8A1D-66835E8CFEC8}"/>
+                <a16:creationId xmlns:a16="http://schemas.microsoft.com/office/drawing/2014/main" id="{19C62065-1C43-4191-AC50-D649FFAFCBE1}"/>
               </a:ext>
             </a:extLst>
           </p:cNvPr>
@@ -4239,7 +4239,7 @@
           <p:cNvPr id="6" name="Footer Placeholder 5">
             <a:extLst xmlns:a="http://schemas.openxmlformats.org/drawingml/2006/main">
               <a:ext uri="{FF2B5EF4-FFF2-40B4-BE49-F238E27FC236}">
-                <a16:creationId xmlns:a16="http://schemas.microsoft.com/office/drawing/2014/main" id="{DC1C6E51-4990-432A-ADAD-CC963376F3FD}"/>
+                <a16:creationId xmlns:a16="http://schemas.microsoft.com/office/drawing/2014/main" id="{E15BD775-C557-4BA5-8CDC-D92E57FB4F31}"/>
               </a:ext>
             </a:extLst>
           </p:cNvPr>
@@ -4264,7 +4264,7 @@
           <p:cNvPr id="7" name="Slide Number Placeholder 6">
             <a:extLst xmlns:a="http://schemas.openxmlformats.org/drawingml/2006/main">
               <a:ext uri="{FF2B5EF4-FFF2-40B4-BE49-F238E27FC236}">
-                <a16:creationId xmlns:a16="http://schemas.microsoft.com/office/drawing/2014/main" id="{FB99561C-04A8-4253-9C2C-A5CA353BA268}"/>
+                <a16:creationId xmlns:a16="http://schemas.microsoft.com/office/drawing/2014/main" id="{8BA0BD94-86AE-4AB8-94DF-E3F0EEC91915}"/>
               </a:ext>
             </a:extLst>
           </p:cNvPr>
@@ -4314,7 +4314,7 @@
           <p:cNvPr id="2" name="Title Placeholder 1">
             <a:extLst xmlns:a="http://schemas.openxmlformats.org/drawingml/2006/main">
               <a:ext uri="{FF2B5EF4-FFF2-40B4-BE49-F238E27FC236}">
-                <a16:creationId xmlns:a16="http://schemas.microsoft.com/office/drawing/2014/main" id="{672C398B-1684-4DA8-B9DB-6A8E83D3BC09}"/>
+                <a16:creationId xmlns:a16="http://schemas.microsoft.com/office/drawing/2014/main" id="{4FF464DB-952E-449E-88B2-E2142212BC6C}"/>
               </a:ext>
             </a:extLst>
           </p:cNvPr>
@@ -4352,7 +4352,7 @@
           <p:cNvPr id="3" name="Text Placeholder 2">
             <a:extLst xmlns:a="http://schemas.openxmlformats.org/drawingml/2006/main">
               <a:ext uri="{FF2B5EF4-FFF2-40B4-BE49-F238E27FC236}">
-                <a16:creationId xmlns:a16="http://schemas.microsoft.com/office/drawing/2014/main" id="{ADAA1CB8-4845-4F76-BD43-D096B2B7D409}"/>
+                <a16:creationId xmlns:a16="http://schemas.microsoft.com/office/drawing/2014/main" id="{82A0AF7A-DDBC-419C-B580-EBD37EFA5B63}"/>
               </a:ext>
             </a:extLst>
           </p:cNvPr>
@@ -4425,7 +4425,7 @@
           <p:cNvPr id="4" name="Date Placeholder 3">
             <a:extLst xmlns:a="http://schemas.openxmlformats.org/drawingml/2006/main">
               <a:ext uri="{FF2B5EF4-FFF2-40B4-BE49-F238E27FC236}">
-                <a16:creationId xmlns:a16="http://schemas.microsoft.com/office/drawing/2014/main" id="{EE80137F-0763-4CD4-9F11-A3E9963DE969}"/>
+                <a16:creationId xmlns:a16="http://schemas.microsoft.com/office/drawing/2014/main" id="{B610E12F-7BCC-4A3F-B4CF-AFA197020602}"/>
               </a:ext>
             </a:extLst>
           </p:cNvPr>
@@ -4472,7 +4472,7 @@
           <p:cNvPr id="5" name="Footer Placeholder 4">
             <a:extLst xmlns:a="http://schemas.openxmlformats.org/drawingml/2006/main">
               <a:ext uri="{FF2B5EF4-FFF2-40B4-BE49-F238E27FC236}">
-                <a16:creationId xmlns:a16="http://schemas.microsoft.com/office/drawing/2014/main" id="{668C53C3-50B5-42B1-B737-652797C01EBC}"/>
+                <a16:creationId xmlns:a16="http://schemas.microsoft.com/office/drawing/2014/main" id="{6AF9235F-B71D-4BBE-A5A3-B0C41A00DA36}"/>
               </a:ext>
             </a:extLst>
           </p:cNvPr>
@@ -4516,7 +4516,7 @@
           <p:cNvPr id="6" name="Slide Number Placeholder 5">
             <a:extLst xmlns:a="http://schemas.openxmlformats.org/drawingml/2006/main">
               <a:ext uri="{FF2B5EF4-FFF2-40B4-BE49-F238E27FC236}">
-                <a16:creationId xmlns:a16="http://schemas.microsoft.com/office/drawing/2014/main" id="{DE6FFC87-4FCB-483A-9746-603DD64903E7}"/>
+                <a16:creationId xmlns:a16="http://schemas.microsoft.com/office/drawing/2014/main" id="{A97BA0E8-A30E-46FD-99B5-84E94A04F82A}"/>
               </a:ext>
             </a:extLst>
           </p:cNvPr>
@@ -4562,17 +4562,17 @@
   </p:cSld>
   <p:clrMap bg1="lt1" tx1="dk1" bg2="lt2" tx2="dk2" accent1="accent1" accent2="accent2" accent3="accent3" accent4="accent4" accent5="accent5" accent6="accent6" hlink="hlink" folHlink="folHlink"/>
   <p:sldLayoutIdLst>
-    <p:sldLayoutId xmlns:r="http://schemas.openxmlformats.org/officeDocument/2006/relationships" id="2147483649" r:id="R305ba921cee74090"/>
-    <p:sldLayoutId xmlns:r="http://schemas.openxmlformats.org/officeDocument/2006/relationships" id="2147483650" r:id="Rfc0d71ecfc374c8f"/>
-    <p:sldLayoutId xmlns:r="http://schemas.openxmlformats.org/officeDocument/2006/relationships" id="2147483651" r:id="R3973b36fcc5b4a6e"/>
-    <p:sldLayoutId xmlns:r="http://schemas.openxmlformats.org/officeDocument/2006/relationships" id="2147483652" r:id="Rb4d38cf3db20423b"/>
-    <p:sldLayoutId xmlns:r="http://schemas.openxmlformats.org/officeDocument/2006/relationships" id="2147483653" r:id="R3138d8ac52cb4852"/>
-    <p:sldLayoutId xmlns:r="http://schemas.openxmlformats.org/officeDocument/2006/relationships" id="2147483654" r:id="R4f5ede1680794ec4"/>
-    <p:sldLayoutId xmlns:r="http://schemas.openxmlformats.org/officeDocument/2006/relationships" id="2147483655" r:id="R30318abbc7b5427c"/>
-    <p:sldLayoutId xmlns:r="http://schemas.openxmlformats.org/officeDocument/2006/relationships" id="2147483656" r:id="R50eb99f723e045f4"/>
-    <p:sldLayoutId xmlns:r="http://schemas.openxmlformats.org/officeDocument/2006/relationships" id="2147483657" r:id="R2c49a1e581854a4b"/>
-    <p:sldLayoutId xmlns:r="http://schemas.openxmlformats.org/officeDocument/2006/relationships" id="2147483658" r:id="Rcfe41b1fc0954558"/>
-    <p:sldLayoutId xmlns:r="http://schemas.openxmlformats.org/officeDocument/2006/relationships" id="2147483659" r:id="R87456863d555405d"/>
+    <p:sldLayoutId xmlns:r="http://schemas.openxmlformats.org/officeDocument/2006/relationships" id="2147483649" r:id="R8a3fe748668f45e0"/>
+    <p:sldLayoutId xmlns:r="http://schemas.openxmlformats.org/officeDocument/2006/relationships" id="2147483650" r:id="Rdd1672e2a7c94a73"/>
+    <p:sldLayoutId xmlns:r="http://schemas.openxmlformats.org/officeDocument/2006/relationships" id="2147483651" r:id="R44f2659525114f80"/>
+    <p:sldLayoutId xmlns:r="http://schemas.openxmlformats.org/officeDocument/2006/relationships" id="2147483652" r:id="R8f129a0444384bf4"/>
+    <p:sldLayoutId xmlns:r="http://schemas.openxmlformats.org/officeDocument/2006/relationships" id="2147483653" r:id="Rc6c319565f774c91"/>
+    <p:sldLayoutId xmlns:r="http://schemas.openxmlformats.org/officeDocument/2006/relationships" id="2147483654" r:id="Rb58c46b473f34899"/>
+    <p:sldLayoutId xmlns:r="http://schemas.openxmlformats.org/officeDocument/2006/relationships" id="2147483655" r:id="R9d060971a08041d0"/>
+    <p:sldLayoutId xmlns:r="http://schemas.openxmlformats.org/officeDocument/2006/relationships" id="2147483656" r:id="Rce56c2766efb40d1"/>
+    <p:sldLayoutId xmlns:r="http://schemas.openxmlformats.org/officeDocument/2006/relationships" id="2147483657" r:id="R223ca179b29343ee"/>
+    <p:sldLayoutId xmlns:r="http://schemas.openxmlformats.org/officeDocument/2006/relationships" id="2147483658" r:id="R37e1c1132b5d4f9c"/>
+    <p:sldLayoutId xmlns:r="http://schemas.openxmlformats.org/officeDocument/2006/relationships" id="2147483659" r:id="Rb275675fff9041eb"/>
   </p:sldLayoutIdLst>
   <p:txStyles>
     <p:titleStyle>
@@ -5118,7 +5118,7 @@
           <p:cNvPr id="2" name="Rectangle 1">
             <a:extLst xmlns:a="http://schemas.openxmlformats.org/drawingml/2006/main">
               <a:ext uri="{FF2B5EF4-FFF2-40B4-BE49-F238E27FC236}">
-                <a16:creationId xmlns:a16="http://schemas.microsoft.com/office/drawing/2014/main" id="{C2926961-9E71-446B-8784-8698B1384EA2}"/>
+                <a16:creationId xmlns:a16="http://schemas.microsoft.com/office/drawing/2014/main" id="{B0E82EF4-11BD-4C2F-A9D5-22B7215B1319}"/>
               </a:ext>
             </a:extLst>
           </p:cNvPr>
@@ -5171,7 +5171,7 @@
           <p:cNvPr id="3" name="Rectangle 2">
             <a:extLst xmlns:a="http://schemas.openxmlformats.org/drawingml/2006/main">
               <a:ext uri="{FF2B5EF4-FFF2-40B4-BE49-F238E27FC236}">
-                <a16:creationId xmlns:a16="http://schemas.microsoft.com/office/drawing/2014/main" id="{646BBFD1-CAD4-4D20-982D-E4463FA6D587}"/>
+                <a16:creationId xmlns:a16="http://schemas.microsoft.com/office/drawing/2014/main" id="{DC246537-7B3B-43B0-8AA4-3107D562283A}"/>
               </a:ext>
             </a:extLst>
           </p:cNvPr>
@@ -5224,7 +5224,7 @@
           <p:cNvPr id="4" name="TextBox 3">
             <a:extLst xmlns:a="http://schemas.openxmlformats.org/drawingml/2006/main">
               <a:ext uri="{FF2B5EF4-FFF2-40B4-BE49-F238E27FC236}">
-                <a16:creationId xmlns:a16="http://schemas.microsoft.com/office/drawing/2014/main" id="{3FFFFE19-BF61-42B4-840B-9E2421A4B129}"/>
+                <a16:creationId xmlns:a16="http://schemas.microsoft.com/office/drawing/2014/main" id="{C9D53492-9D92-4F18-8103-B68037143923}"/>
               </a:ext>
             </a:extLst>
           </p:cNvPr>
@@ -5326,7 +5326,7 @@
     </p:spTree>
     <p:extLst>
       <p:ext uri="{BB962C8B-B14F-4D97-AF65-F5344CB8AC3E}">
-        <p14:creationId xmlns:p14="http://schemas.microsoft.com/office/powerpoint/2010/main" val="1832291903"/>
+        <p14:creationId xmlns:p14="http://schemas.microsoft.com/office/powerpoint/2010/main" val="1670628182"/>
       </p:ext>
     </p:extLst>
   </p:cSld>
@@ -5350,7 +5350,7 @@
           <p:cNvPr id="2" name="Rectangle 1">
             <a:extLst xmlns:a="http://schemas.openxmlformats.org/drawingml/2006/main">
               <a:ext uri="{FF2B5EF4-FFF2-40B4-BE49-F238E27FC236}">
-                <a16:creationId xmlns:a16="http://schemas.microsoft.com/office/drawing/2014/main" id="{23E28773-3B09-42FD-B6B7-5B0BADB15505}"/>
+                <a16:creationId xmlns:a16="http://schemas.microsoft.com/office/drawing/2014/main" id="{4C0D1656-EA8D-4589-8E50-54480D98EE05}"/>
               </a:ext>
             </a:extLst>
           </p:cNvPr>
@@ -5403,7 +5403,7 @@
           <p:cNvPr id="3" name="Rectangle 2">
             <a:extLst xmlns:a="http://schemas.openxmlformats.org/drawingml/2006/main">
               <a:ext uri="{FF2B5EF4-FFF2-40B4-BE49-F238E27FC236}">
-                <a16:creationId xmlns:a16="http://schemas.microsoft.com/office/drawing/2014/main" id="{80977C56-055D-4259-8B06-AE471EF94ECF}"/>
+                <a16:creationId xmlns:a16="http://schemas.microsoft.com/office/drawing/2014/main" id="{CDF1094F-10BE-49A4-846F-CAF1E7ACDF66}"/>
               </a:ext>
             </a:extLst>
           </p:cNvPr>
@@ -5456,7 +5456,7 @@
           <p:cNvPr id="4" name="Rectangle 3">
             <a:extLst xmlns:a="http://schemas.openxmlformats.org/drawingml/2006/main">
               <a:ext uri="{FF2B5EF4-FFF2-40B4-BE49-F238E27FC236}">
-                <a16:creationId xmlns:a16="http://schemas.microsoft.com/office/drawing/2014/main" id="{37465A4D-A7F5-4BB7-A2FB-844C5C3B8E6F}"/>
+                <a16:creationId xmlns:a16="http://schemas.microsoft.com/office/drawing/2014/main" id="{9B4AB8CD-E385-4477-85D7-3B0F39598FC4}"/>
               </a:ext>
             </a:extLst>
           </p:cNvPr>
@@ -5509,7 +5509,7 @@
           <p:cNvPr id="5" name="TextBox 4">
             <a:extLst xmlns:a="http://schemas.openxmlformats.org/drawingml/2006/main">
               <a:ext uri="{FF2B5EF4-FFF2-40B4-BE49-F238E27FC236}">
-                <a16:creationId xmlns:a16="http://schemas.microsoft.com/office/drawing/2014/main" id="{C6AFE00F-AA27-4AED-A6B3-42F9CF8AA262}"/>
+                <a16:creationId xmlns:a16="http://schemas.microsoft.com/office/drawing/2014/main" id="{BFC28B8B-A2ED-48BD-9C1B-FE3CA7E9BA54}"/>
               </a:ext>
             </a:extLst>
           </p:cNvPr>
@@ -5572,7 +5572,7 @@
           <p:cNvPr id="6" name="Rounded Rectangle 5">
             <a:extLst xmlns:a="http://schemas.openxmlformats.org/drawingml/2006/main">
               <a:ext uri="{FF2B5EF4-FFF2-40B4-BE49-F238E27FC236}">
-                <a16:creationId xmlns:a16="http://schemas.microsoft.com/office/drawing/2014/main" id="{0D7F3B7C-83B2-4F32-BD6A-738E32FC9E7E}"/>
+                <a16:creationId xmlns:a16="http://schemas.microsoft.com/office/drawing/2014/main" id="{13CFDB75-E8F9-447F-8C39-142792041AB5}"/>
               </a:ext>
             </a:extLst>
           </p:cNvPr>
@@ -5627,7 +5627,7 @@
           <p:cNvPr id="7" name="TextBox 6">
             <a:extLst xmlns:a="http://schemas.openxmlformats.org/drawingml/2006/main">
               <a:ext uri="{FF2B5EF4-FFF2-40B4-BE49-F238E27FC236}">
-                <a16:creationId xmlns:a16="http://schemas.microsoft.com/office/drawing/2014/main" id="{51119C80-7E69-4F5B-B615-C54F338CA93C}"/>
+                <a16:creationId xmlns:a16="http://schemas.microsoft.com/office/drawing/2014/main" id="{843D0F64-D1C1-40FE-8DE7-1E4839EA9F2A}"/>
               </a:ext>
             </a:extLst>
           </p:cNvPr>
@@ -5731,7 +5731,7 @@
           <p:cNvPr id="8" name="Rounded Rectangle 7">
             <a:extLst xmlns:a="http://schemas.openxmlformats.org/drawingml/2006/main">
               <a:ext uri="{FF2B5EF4-FFF2-40B4-BE49-F238E27FC236}">
-                <a16:creationId xmlns:a16="http://schemas.microsoft.com/office/drawing/2014/main" id="{27B6C9D0-72F7-4084-9592-4F6F40224D8D}"/>
+                <a16:creationId xmlns:a16="http://schemas.microsoft.com/office/drawing/2014/main" id="{B8C974A6-7CE9-40C3-903A-6DC555F736A6}"/>
               </a:ext>
             </a:extLst>
           </p:cNvPr>
@@ -5786,7 +5786,7 @@
           <p:cNvPr id="9" name="TextBox 8">
             <a:extLst xmlns:a="http://schemas.openxmlformats.org/drawingml/2006/main">
               <a:ext uri="{FF2B5EF4-FFF2-40B4-BE49-F238E27FC236}">
-                <a16:creationId xmlns:a16="http://schemas.microsoft.com/office/drawing/2014/main" id="{F7EAA397-46D0-4748-8ECB-3F017BA485F5}"/>
+                <a16:creationId xmlns:a16="http://schemas.microsoft.com/office/drawing/2014/main" id="{26703378-E5C0-4088-B113-2EB2915C97D5}"/>
               </a:ext>
             </a:extLst>
           </p:cNvPr>
@@ -5871,7 +5871,7 @@
           <p:cNvPr id="10" name="Rounded Rectangle 9">
             <a:extLst xmlns:a="http://schemas.openxmlformats.org/drawingml/2006/main">
               <a:ext uri="{FF2B5EF4-FFF2-40B4-BE49-F238E27FC236}">
-                <a16:creationId xmlns:a16="http://schemas.microsoft.com/office/drawing/2014/main" id="{B7CE8416-5EDD-4A53-B71A-C38CADD5C693}"/>
+                <a16:creationId xmlns:a16="http://schemas.microsoft.com/office/drawing/2014/main" id="{3068B22A-BE25-4349-8338-0448FE40F5FF}"/>
               </a:ext>
             </a:extLst>
           </p:cNvPr>
@@ -5926,7 +5926,7 @@
           <p:cNvPr id="11" name="TextBox 10">
             <a:extLst xmlns:a="http://schemas.openxmlformats.org/drawingml/2006/main">
               <a:ext uri="{FF2B5EF4-FFF2-40B4-BE49-F238E27FC236}">
-                <a16:creationId xmlns:a16="http://schemas.microsoft.com/office/drawing/2014/main" id="{7AD7C3D5-014D-4583-8653-FBB1DA016CD1}"/>
+                <a16:creationId xmlns:a16="http://schemas.microsoft.com/office/drawing/2014/main" id="{0EA1D0B8-F17A-46D8-AFB8-74631EC2DFE7}"/>
               </a:ext>
             </a:extLst>
           </p:cNvPr>
@@ -6028,7 +6028,7 @@
     </p:spTree>
     <p:extLst>
       <p:ext uri="{BB962C8B-B14F-4D97-AF65-F5344CB8AC3E}">
-        <p14:creationId xmlns:p14="http://schemas.microsoft.com/office/powerpoint/2010/main" val="2022349873"/>
+        <p14:creationId xmlns:p14="http://schemas.microsoft.com/office/powerpoint/2010/main" val="598599637"/>
       </p:ext>
     </p:extLst>
   </p:cSld>
@@ -6052,7 +6052,7 @@
           <p:cNvPr id="2" name="Rectangle 1">
             <a:extLst xmlns:a="http://schemas.openxmlformats.org/drawingml/2006/main">
               <a:ext uri="{FF2B5EF4-FFF2-40B4-BE49-F238E27FC236}">
-                <a16:creationId xmlns:a16="http://schemas.microsoft.com/office/drawing/2014/main" id="{8EC27EF0-0D61-4718-B482-5E65807EC87E}"/>
+                <a16:creationId xmlns:a16="http://schemas.microsoft.com/office/drawing/2014/main" id="{DFAB9E42-7729-42DE-B584-893C5D26CB6F}"/>
               </a:ext>
             </a:extLst>
           </p:cNvPr>
@@ -6105,7 +6105,7 @@
           <p:cNvPr id="3" name="Rectangle 2">
             <a:extLst xmlns:a="http://schemas.openxmlformats.org/drawingml/2006/main">
               <a:ext uri="{FF2B5EF4-FFF2-40B4-BE49-F238E27FC236}">
-                <a16:creationId xmlns:a16="http://schemas.microsoft.com/office/drawing/2014/main" id="{1D2CAAA8-437B-49CE-9732-F4DFA0560F80}"/>
+                <a16:creationId xmlns:a16="http://schemas.microsoft.com/office/drawing/2014/main" id="{D9F8962F-5B21-4B1C-94CC-9B662760FF6F}"/>
               </a:ext>
             </a:extLst>
           </p:cNvPr>
@@ -6158,7 +6158,7 @@
           <p:cNvPr id="4" name="Rectangle 3">
             <a:extLst xmlns:a="http://schemas.openxmlformats.org/drawingml/2006/main">
               <a:ext uri="{FF2B5EF4-FFF2-40B4-BE49-F238E27FC236}">
-                <a16:creationId xmlns:a16="http://schemas.microsoft.com/office/drawing/2014/main" id="{8AE0DC4A-5C03-42CF-B7E4-8F340FB4B656}"/>
+                <a16:creationId xmlns:a16="http://schemas.microsoft.com/office/drawing/2014/main" id="{AF05C22E-064C-4FDF-88DF-04776316CEE2}"/>
               </a:ext>
             </a:extLst>
           </p:cNvPr>
@@ -6211,7 +6211,7 @@
           <p:cNvPr id="5" name="TextBox 4">
             <a:extLst xmlns:a="http://schemas.openxmlformats.org/drawingml/2006/main">
               <a:ext uri="{FF2B5EF4-FFF2-40B4-BE49-F238E27FC236}">
-                <a16:creationId xmlns:a16="http://schemas.microsoft.com/office/drawing/2014/main" id="{124F35FF-448C-4146-B27E-C1B3CFA21673}"/>
+                <a16:creationId xmlns:a16="http://schemas.microsoft.com/office/drawing/2014/main" id="{4951618C-4E56-4607-8C67-316A8EB98F98}"/>
               </a:ext>
             </a:extLst>
           </p:cNvPr>
@@ -6274,7 +6274,7 @@
           <p:cNvPr id="6" name="Rounded Rectangle 5">
             <a:extLst xmlns:a="http://schemas.openxmlformats.org/drawingml/2006/main">
               <a:ext uri="{FF2B5EF4-FFF2-40B4-BE49-F238E27FC236}">
-                <a16:creationId xmlns:a16="http://schemas.microsoft.com/office/drawing/2014/main" id="{16E3FB87-2211-48E0-966C-6C6AAC561DA9}"/>
+                <a16:creationId xmlns:a16="http://schemas.microsoft.com/office/drawing/2014/main" id="{13D98923-AC55-4318-BB6A-85EC6541E09E}"/>
               </a:ext>
             </a:extLst>
           </p:cNvPr>
@@ -6329,7 +6329,7 @@
           <p:cNvPr id="7" name="TextBox 6">
             <a:extLst xmlns:a="http://schemas.openxmlformats.org/drawingml/2006/main">
               <a:ext uri="{FF2B5EF4-FFF2-40B4-BE49-F238E27FC236}">
-                <a16:creationId xmlns:a16="http://schemas.microsoft.com/office/drawing/2014/main" id="{B0E95A4A-25B3-4414-80E9-8F755198204C}"/>
+                <a16:creationId xmlns:a16="http://schemas.microsoft.com/office/drawing/2014/main" id="{0D81E792-B232-48E9-9DF5-B56382C3C909}"/>
               </a:ext>
             </a:extLst>
           </p:cNvPr>
@@ -6528,7 +6528,7 @@
           <p:cNvPr id="8" name="Rounded Rectangle 7">
             <a:extLst xmlns:a="http://schemas.openxmlformats.org/drawingml/2006/main">
               <a:ext uri="{FF2B5EF4-FFF2-40B4-BE49-F238E27FC236}">
-                <a16:creationId xmlns:a16="http://schemas.microsoft.com/office/drawing/2014/main" id="{F39DC297-4888-400C-A7F6-928863A22F4E}"/>
+                <a16:creationId xmlns:a16="http://schemas.microsoft.com/office/drawing/2014/main" id="{8644E0A4-6C59-40B9-826A-DA9288BBF949}"/>
               </a:ext>
             </a:extLst>
           </p:cNvPr>
@@ -6583,7 +6583,7 @@
           <p:cNvPr id="9" name="TextBox 8">
             <a:extLst xmlns:a="http://schemas.openxmlformats.org/drawingml/2006/main">
               <a:ext uri="{FF2B5EF4-FFF2-40B4-BE49-F238E27FC236}">
-                <a16:creationId xmlns:a16="http://schemas.microsoft.com/office/drawing/2014/main" id="{4ABE4D4D-AB52-43D1-B8BA-B5C800C468DF}"/>
+                <a16:creationId xmlns:a16="http://schemas.microsoft.com/office/drawing/2014/main" id="{49DBB8B5-47E2-415B-A790-63659DBE808C}"/>
               </a:ext>
             </a:extLst>
           </p:cNvPr>
@@ -6704,7 +6704,7 @@
     </p:spTree>
     <p:extLst>
       <p:ext uri="{BB962C8B-B14F-4D97-AF65-F5344CB8AC3E}">
-        <p14:creationId xmlns:p14="http://schemas.microsoft.com/office/powerpoint/2010/main" val="930900073"/>
+        <p14:creationId xmlns:p14="http://schemas.microsoft.com/office/powerpoint/2010/main" val="574977047"/>
       </p:ext>
     </p:extLst>
   </p:cSld>
@@ -6728,7 +6728,7 @@
           <p:cNvPr id="2" name="Rectangle 1">
             <a:extLst xmlns:a="http://schemas.openxmlformats.org/drawingml/2006/main">
               <a:ext uri="{FF2B5EF4-FFF2-40B4-BE49-F238E27FC236}">
-                <a16:creationId xmlns:a16="http://schemas.microsoft.com/office/drawing/2014/main" id="{94874379-D44B-4111-80DF-72EF44B70CA5}"/>
+                <a16:creationId xmlns:a16="http://schemas.microsoft.com/office/drawing/2014/main" id="{4311A4A7-4B5E-4C6B-98F0-B4390AB5F5DC}"/>
               </a:ext>
             </a:extLst>
           </p:cNvPr>
@@ -6781,7 +6781,7 @@
           <p:cNvPr id="3" name="Rectangle 2">
             <a:extLst xmlns:a="http://schemas.openxmlformats.org/drawingml/2006/main">
               <a:ext uri="{FF2B5EF4-FFF2-40B4-BE49-F238E27FC236}">
-                <a16:creationId xmlns:a16="http://schemas.microsoft.com/office/drawing/2014/main" id="{C6594F7F-DEBE-41AB-B433-E302FFCB3385}"/>
+                <a16:creationId xmlns:a16="http://schemas.microsoft.com/office/drawing/2014/main" id="{9A18AC14-74DB-453D-89F3-7C779E389217}"/>
               </a:ext>
             </a:extLst>
           </p:cNvPr>
@@ -6834,7 +6834,7 @@
           <p:cNvPr id="4" name="TextBox 3">
             <a:extLst xmlns:a="http://schemas.openxmlformats.org/drawingml/2006/main">
               <a:ext uri="{FF2B5EF4-FFF2-40B4-BE49-F238E27FC236}">
-                <a16:creationId xmlns:a16="http://schemas.microsoft.com/office/drawing/2014/main" id="{AA803275-FB65-4154-8806-92BAEE0E9CC7}"/>
+                <a16:creationId xmlns:a16="http://schemas.microsoft.com/office/drawing/2014/main" id="{20C02B7F-C763-4B1D-BEAA-C9B5CAC7CA0E}"/>
               </a:ext>
             </a:extLst>
           </p:cNvPr>
@@ -7012,7 +7012,7 @@
     </p:spTree>
     <p:extLst>
       <p:ext uri="{BB962C8B-B14F-4D97-AF65-F5344CB8AC3E}">
-        <p14:creationId xmlns:p14="http://schemas.microsoft.com/office/powerpoint/2010/main" val="526055841"/>
+        <p14:creationId xmlns:p14="http://schemas.microsoft.com/office/powerpoint/2010/main" val="566523200"/>
       </p:ext>
     </p:extLst>
   </p:cSld>
@@ -7036,7 +7036,7 @@
           <p:cNvPr id="2" name="Rectangle 1">
             <a:extLst xmlns:a="http://schemas.openxmlformats.org/drawingml/2006/main">
               <a:ext uri="{FF2B5EF4-FFF2-40B4-BE49-F238E27FC236}">
-                <a16:creationId xmlns:a16="http://schemas.microsoft.com/office/drawing/2014/main" id="{89F22D32-B73F-4634-B92E-319E5359E355}"/>
+                <a16:creationId xmlns:a16="http://schemas.microsoft.com/office/drawing/2014/main" id="{A9CF8452-4422-49A8-995B-E3F30642133B}"/>
               </a:ext>
             </a:extLst>
           </p:cNvPr>
@@ -7089,7 +7089,7 @@
           <p:cNvPr id="3" name="Rectangle 2">
             <a:extLst xmlns:a="http://schemas.openxmlformats.org/drawingml/2006/main">
               <a:ext uri="{FF2B5EF4-FFF2-40B4-BE49-F238E27FC236}">
-                <a16:creationId xmlns:a16="http://schemas.microsoft.com/office/drawing/2014/main" id="{EB526803-8015-4834-9590-6B5DFA3B48A3}"/>
+                <a16:creationId xmlns:a16="http://schemas.microsoft.com/office/drawing/2014/main" id="{E12A3003-3F52-46CB-BE77-962829D83F6E}"/>
               </a:ext>
             </a:extLst>
           </p:cNvPr>
@@ -7142,7 +7142,7 @@
           <p:cNvPr id="4" name="Rectangle 3">
             <a:extLst xmlns:a="http://schemas.openxmlformats.org/drawingml/2006/main">
               <a:ext uri="{FF2B5EF4-FFF2-40B4-BE49-F238E27FC236}">
-                <a16:creationId xmlns:a16="http://schemas.microsoft.com/office/drawing/2014/main" id="{CE147814-65AB-4D31-AFBF-C7EE5F8C3679}"/>
+                <a16:creationId xmlns:a16="http://schemas.microsoft.com/office/drawing/2014/main" id="{15F20F26-2CBE-427A-AFC2-9DE5898D4F06}"/>
               </a:ext>
             </a:extLst>
           </p:cNvPr>
@@ -7195,7 +7195,7 @@
           <p:cNvPr id="5" name="TextBox 4">
             <a:extLst xmlns:a="http://schemas.openxmlformats.org/drawingml/2006/main">
               <a:ext uri="{FF2B5EF4-FFF2-40B4-BE49-F238E27FC236}">
-                <a16:creationId xmlns:a16="http://schemas.microsoft.com/office/drawing/2014/main" id="{7172D39E-59A7-4A28-87A9-9A0B3198A93A}"/>
+                <a16:creationId xmlns:a16="http://schemas.microsoft.com/office/drawing/2014/main" id="{08C77087-993A-4B44-8BF0-14CC7B336E57}"/>
               </a:ext>
             </a:extLst>
           </p:cNvPr>
@@ -7258,7 +7258,7 @@
           <p:cNvPr id="6" name="Rounded Rectangle 5">
             <a:extLst xmlns:a="http://schemas.openxmlformats.org/drawingml/2006/main">
               <a:ext uri="{FF2B5EF4-FFF2-40B4-BE49-F238E27FC236}">
-                <a16:creationId xmlns:a16="http://schemas.microsoft.com/office/drawing/2014/main" id="{A65171A4-E7C5-465A-8B17-6CC08574BF54}"/>
+                <a16:creationId xmlns:a16="http://schemas.microsoft.com/office/drawing/2014/main" id="{59B2DDEF-578E-4B2D-8083-5EF4277B7B94}"/>
               </a:ext>
             </a:extLst>
           </p:cNvPr>
@@ -7313,7 +7313,7 @@
           <p:cNvPr id="7" name="TextBox 6">
             <a:extLst xmlns:a="http://schemas.openxmlformats.org/drawingml/2006/main">
               <a:ext uri="{FF2B5EF4-FFF2-40B4-BE49-F238E27FC236}">
-                <a16:creationId xmlns:a16="http://schemas.microsoft.com/office/drawing/2014/main" id="{FA598076-1CF4-4DFB-A06A-DDAB5D0CE294}"/>
+                <a16:creationId xmlns:a16="http://schemas.microsoft.com/office/drawing/2014/main" id="{5B14F8C9-F211-454C-8B51-40677A3D0D68}"/>
               </a:ext>
             </a:extLst>
           </p:cNvPr>
@@ -7417,7 +7417,7 @@
           <p:cNvPr id="8" name="Rounded Rectangle 7">
             <a:extLst xmlns:a="http://schemas.openxmlformats.org/drawingml/2006/main">
               <a:ext uri="{FF2B5EF4-FFF2-40B4-BE49-F238E27FC236}">
-                <a16:creationId xmlns:a16="http://schemas.microsoft.com/office/drawing/2014/main" id="{42979C6E-14AF-4F58-A740-4B5C6E24817A}"/>
+                <a16:creationId xmlns:a16="http://schemas.microsoft.com/office/drawing/2014/main" id="{0BAE500D-5308-48BD-9308-C139DDE386B1}"/>
               </a:ext>
             </a:extLst>
           </p:cNvPr>
@@ -7472,7 +7472,7 @@
           <p:cNvPr id="9" name="TextBox 8">
             <a:extLst xmlns:a="http://schemas.openxmlformats.org/drawingml/2006/main">
               <a:ext uri="{FF2B5EF4-FFF2-40B4-BE49-F238E27FC236}">
-                <a16:creationId xmlns:a16="http://schemas.microsoft.com/office/drawing/2014/main" id="{430AF0D4-3A7F-4A9B-B8EF-AAF65984D231}"/>
+                <a16:creationId xmlns:a16="http://schemas.microsoft.com/office/drawing/2014/main" id="{76C9ECAC-EE7B-4E58-BA98-3AA9A7F6D2E3}"/>
               </a:ext>
             </a:extLst>
           </p:cNvPr>
@@ -7576,7 +7576,7 @@
           <p:cNvPr id="10" name="Rounded Rectangle 9">
             <a:extLst xmlns:a="http://schemas.openxmlformats.org/drawingml/2006/main">
               <a:ext uri="{FF2B5EF4-FFF2-40B4-BE49-F238E27FC236}">
-                <a16:creationId xmlns:a16="http://schemas.microsoft.com/office/drawing/2014/main" id="{6480AA08-4EFD-4411-80EE-1CADA8AB89F5}"/>
+                <a16:creationId xmlns:a16="http://schemas.microsoft.com/office/drawing/2014/main" id="{D2DBDE6C-A7C8-4A62-997F-201D1F8E09FA}"/>
               </a:ext>
             </a:extLst>
           </p:cNvPr>
@@ -7631,7 +7631,7 @@
           <p:cNvPr id="11" name="TextBox 10">
             <a:extLst xmlns:a="http://schemas.openxmlformats.org/drawingml/2006/main">
               <a:ext uri="{FF2B5EF4-FFF2-40B4-BE49-F238E27FC236}">
-                <a16:creationId xmlns:a16="http://schemas.microsoft.com/office/drawing/2014/main" id="{DBF44D97-9D83-4A8E-AC03-6D904A848343}"/>
+                <a16:creationId xmlns:a16="http://schemas.microsoft.com/office/drawing/2014/main" id="{8724AA3F-7D53-471C-8D7D-90524A234222}"/>
               </a:ext>
             </a:extLst>
           </p:cNvPr>
@@ -7790,7 +7790,7 @@
     </p:spTree>
     <p:extLst>
       <p:ext uri="{BB962C8B-B14F-4D97-AF65-F5344CB8AC3E}">
-        <p14:creationId xmlns:p14="http://schemas.microsoft.com/office/powerpoint/2010/main" val="383905064"/>
+        <p14:creationId xmlns:p14="http://schemas.microsoft.com/office/powerpoint/2010/main" val="1104074397"/>
       </p:ext>
     </p:extLst>
   </p:cSld>
@@ -7814,7 +7814,7 @@
           <p:cNvPr id="2" name="Rectangle 1">
             <a:extLst xmlns:a="http://schemas.openxmlformats.org/drawingml/2006/main">
               <a:ext uri="{FF2B5EF4-FFF2-40B4-BE49-F238E27FC236}">
-                <a16:creationId xmlns:a16="http://schemas.microsoft.com/office/drawing/2014/main" id="{214CD07B-1421-413D-BDF7-29A7024F6CEE}"/>
+                <a16:creationId xmlns:a16="http://schemas.microsoft.com/office/drawing/2014/main" id="{CACE1302-ECF9-491F-A316-4571409E9C5A}"/>
               </a:ext>
             </a:extLst>
           </p:cNvPr>
@@ -7867,7 +7867,7 @@
           <p:cNvPr id="3" name="Rectangle 2">
             <a:extLst xmlns:a="http://schemas.openxmlformats.org/drawingml/2006/main">
               <a:ext uri="{FF2B5EF4-FFF2-40B4-BE49-F238E27FC236}">
-                <a16:creationId xmlns:a16="http://schemas.microsoft.com/office/drawing/2014/main" id="{11847149-C5CB-451E-A46F-B23938E03292}"/>
+                <a16:creationId xmlns:a16="http://schemas.microsoft.com/office/drawing/2014/main" id="{EA4CAC5B-AA00-4700-A62D-16F15FF3B2F3}"/>
               </a:ext>
             </a:extLst>
           </p:cNvPr>
@@ -7920,7 +7920,7 @@
           <p:cNvPr id="4" name="Rectangle 3">
             <a:extLst xmlns:a="http://schemas.openxmlformats.org/drawingml/2006/main">
               <a:ext uri="{FF2B5EF4-FFF2-40B4-BE49-F238E27FC236}">
-                <a16:creationId xmlns:a16="http://schemas.microsoft.com/office/drawing/2014/main" id="{EE3EB1D3-6198-4708-B921-7393946D70C8}"/>
+                <a16:creationId xmlns:a16="http://schemas.microsoft.com/office/drawing/2014/main" id="{8BAD3718-2449-4374-B074-153198158ABE}"/>
               </a:ext>
             </a:extLst>
           </p:cNvPr>
@@ -7973,7 +7973,7 @@
           <p:cNvPr id="5" name="TextBox 4">
             <a:extLst xmlns:a="http://schemas.openxmlformats.org/drawingml/2006/main">
               <a:ext uri="{FF2B5EF4-FFF2-40B4-BE49-F238E27FC236}">
-                <a16:creationId xmlns:a16="http://schemas.microsoft.com/office/drawing/2014/main" id="{A9AD06E1-27BD-44E7-B906-36ABAABE0F72}"/>
+                <a16:creationId xmlns:a16="http://schemas.microsoft.com/office/drawing/2014/main" id="{C2DCAF6D-49D8-428C-9A93-125E569E7034}"/>
               </a:ext>
             </a:extLst>
           </p:cNvPr>
@@ -8036,7 +8036,7 @@
           <p:cNvPr id="6" name="Rounded Rectangle 5">
             <a:extLst xmlns:a="http://schemas.openxmlformats.org/drawingml/2006/main">
               <a:ext uri="{FF2B5EF4-FFF2-40B4-BE49-F238E27FC236}">
-                <a16:creationId xmlns:a16="http://schemas.microsoft.com/office/drawing/2014/main" id="{85C0EFCB-E843-4644-A47D-B8D2352EF685}"/>
+                <a16:creationId xmlns:a16="http://schemas.microsoft.com/office/drawing/2014/main" id="{C483A55D-855A-470F-B581-69C6D8020981}"/>
               </a:ext>
             </a:extLst>
           </p:cNvPr>
@@ -8091,7 +8091,7 @@
           <p:cNvPr id="7" name="TextBox 6">
             <a:extLst xmlns:a="http://schemas.openxmlformats.org/drawingml/2006/main">
               <a:ext uri="{FF2B5EF4-FFF2-40B4-BE49-F238E27FC236}">
-                <a16:creationId xmlns:a16="http://schemas.microsoft.com/office/drawing/2014/main" id="{0F6575D0-FD7E-4C70-9DBB-8045CC3EB16E}"/>
+                <a16:creationId xmlns:a16="http://schemas.microsoft.com/office/drawing/2014/main" id="{32FCFF1B-42A8-4A2E-96DF-10B1A72E1022}"/>
               </a:ext>
             </a:extLst>
           </p:cNvPr>
@@ -8214,7 +8214,7 @@
           <p:cNvPr id="8" name="Rounded Rectangle 7">
             <a:extLst xmlns:a="http://schemas.openxmlformats.org/drawingml/2006/main">
               <a:ext uri="{FF2B5EF4-FFF2-40B4-BE49-F238E27FC236}">
-                <a16:creationId xmlns:a16="http://schemas.microsoft.com/office/drawing/2014/main" id="{B168CC65-CD67-4684-9F11-CBF8CF7D7B16}"/>
+                <a16:creationId xmlns:a16="http://schemas.microsoft.com/office/drawing/2014/main" id="{54481AE8-ADE1-44F4-827F-95AC688B93DA}"/>
               </a:ext>
             </a:extLst>
           </p:cNvPr>
@@ -8269,7 +8269,7 @@
           <p:cNvPr id="9" name="TextBox 8">
             <a:extLst xmlns:a="http://schemas.openxmlformats.org/drawingml/2006/main">
               <a:ext uri="{FF2B5EF4-FFF2-40B4-BE49-F238E27FC236}">
-                <a16:creationId xmlns:a16="http://schemas.microsoft.com/office/drawing/2014/main" id="{937EE3F7-AF08-4C2E-A262-39C90AF5E813}"/>
+                <a16:creationId xmlns:a16="http://schemas.microsoft.com/office/drawing/2014/main" id="{C418C3BA-840C-4F1C-B5AA-A86E6A1AB24B}"/>
               </a:ext>
             </a:extLst>
           </p:cNvPr>
@@ -8411,7 +8411,7 @@
           <p:cNvPr id="10" name="Rounded Rectangle 9">
             <a:extLst xmlns:a="http://schemas.openxmlformats.org/drawingml/2006/main">
               <a:ext uri="{FF2B5EF4-FFF2-40B4-BE49-F238E27FC236}">
-                <a16:creationId xmlns:a16="http://schemas.microsoft.com/office/drawing/2014/main" id="{5E0A37B7-7EBF-49EE-83B0-FF676B75ADA4}"/>
+                <a16:creationId xmlns:a16="http://schemas.microsoft.com/office/drawing/2014/main" id="{C85F79E8-152E-4C5E-AAB7-7246022084BC}"/>
               </a:ext>
             </a:extLst>
           </p:cNvPr>
@@ -8466,7 +8466,7 @@
           <p:cNvPr id="11" name="TextBox 10">
             <a:extLst xmlns:a="http://schemas.openxmlformats.org/drawingml/2006/main">
               <a:ext uri="{FF2B5EF4-FFF2-40B4-BE49-F238E27FC236}">
-                <a16:creationId xmlns:a16="http://schemas.microsoft.com/office/drawing/2014/main" id="{EBBFE1A0-8400-401D-B1B1-6CDCB119618B}"/>
+                <a16:creationId xmlns:a16="http://schemas.microsoft.com/office/drawing/2014/main" id="{AC9373F5-6A7A-4643-9BFC-6AB0E2305F59}"/>
               </a:ext>
             </a:extLst>
           </p:cNvPr>
@@ -8568,7 +8568,7 @@
     </p:spTree>
     <p:extLst>
       <p:ext uri="{BB962C8B-B14F-4D97-AF65-F5344CB8AC3E}">
-        <p14:creationId xmlns:p14="http://schemas.microsoft.com/office/powerpoint/2010/main" val="1784165154"/>
+        <p14:creationId xmlns:p14="http://schemas.microsoft.com/office/powerpoint/2010/main" val="1878262170"/>
       </p:ext>
     </p:extLst>
   </p:cSld>
@@ -8592,7 +8592,7 @@
           <p:cNvPr id="2" name="Rectangle 1">
             <a:extLst xmlns:a="http://schemas.openxmlformats.org/drawingml/2006/main">
               <a:ext uri="{FF2B5EF4-FFF2-40B4-BE49-F238E27FC236}">
-                <a16:creationId xmlns:a16="http://schemas.microsoft.com/office/drawing/2014/main" id="{18A1661B-FA65-464B-8332-569ACB200867}"/>
+                <a16:creationId xmlns:a16="http://schemas.microsoft.com/office/drawing/2014/main" id="{7732BCB8-D83B-4F3A-AE70-4AA503F33DF1}"/>
               </a:ext>
             </a:extLst>
           </p:cNvPr>
@@ -8645,7 +8645,7 @@
           <p:cNvPr id="3" name="Rectangle 2">
             <a:extLst xmlns:a="http://schemas.openxmlformats.org/drawingml/2006/main">
               <a:ext uri="{FF2B5EF4-FFF2-40B4-BE49-F238E27FC236}">
-                <a16:creationId xmlns:a16="http://schemas.microsoft.com/office/drawing/2014/main" id="{36E4D39B-05D0-41F8-927F-B092842928EB}"/>
+                <a16:creationId xmlns:a16="http://schemas.microsoft.com/office/drawing/2014/main" id="{55F90981-D01C-4017-BC8A-D6C92F976364}"/>
               </a:ext>
             </a:extLst>
           </p:cNvPr>
@@ -8698,7 +8698,7 @@
           <p:cNvPr id="4" name="Rectangle 3">
             <a:extLst xmlns:a="http://schemas.openxmlformats.org/drawingml/2006/main">
               <a:ext uri="{FF2B5EF4-FFF2-40B4-BE49-F238E27FC236}">
-                <a16:creationId xmlns:a16="http://schemas.microsoft.com/office/drawing/2014/main" id="{A7E09364-A528-480A-9660-8DD69647DE3C}"/>
+                <a16:creationId xmlns:a16="http://schemas.microsoft.com/office/drawing/2014/main" id="{6DDAC109-66E3-4D96-9A88-43705A614887}"/>
               </a:ext>
             </a:extLst>
           </p:cNvPr>
@@ -8751,7 +8751,7 @@
           <p:cNvPr id="5" name="TextBox 4">
             <a:extLst xmlns:a="http://schemas.openxmlformats.org/drawingml/2006/main">
               <a:ext uri="{FF2B5EF4-FFF2-40B4-BE49-F238E27FC236}">
-                <a16:creationId xmlns:a16="http://schemas.microsoft.com/office/drawing/2014/main" id="{72CC3027-BF7D-4485-A40D-30FCF9F9A2AA}"/>
+                <a16:creationId xmlns:a16="http://schemas.microsoft.com/office/drawing/2014/main" id="{71BCC5A3-9BCC-4E5C-8996-B8C0CA22893E}"/>
               </a:ext>
             </a:extLst>
           </p:cNvPr>
@@ -8814,7 +8814,7 @@
           <p:cNvPr id="6" name="Rounded Rectangle 5">
             <a:extLst xmlns:a="http://schemas.openxmlformats.org/drawingml/2006/main">
               <a:ext uri="{FF2B5EF4-FFF2-40B4-BE49-F238E27FC236}">
-                <a16:creationId xmlns:a16="http://schemas.microsoft.com/office/drawing/2014/main" id="{C2330EE6-9DD4-422E-9887-253A37F7BBE5}"/>
+                <a16:creationId xmlns:a16="http://schemas.microsoft.com/office/drawing/2014/main" id="{AD9F52A5-37FC-4EB1-8A1E-5A03DF4F666D}"/>
               </a:ext>
             </a:extLst>
           </p:cNvPr>
@@ -8869,7 +8869,7 @@
           <p:cNvPr id="7" name="TextBox 6">
             <a:extLst xmlns:a="http://schemas.openxmlformats.org/drawingml/2006/main">
               <a:ext uri="{FF2B5EF4-FFF2-40B4-BE49-F238E27FC236}">
-                <a16:creationId xmlns:a16="http://schemas.microsoft.com/office/drawing/2014/main" id="{8C940245-8B57-44F5-95C7-0230674D80E4}"/>
+                <a16:creationId xmlns:a16="http://schemas.microsoft.com/office/drawing/2014/main" id="{D8B8EC28-61B9-4C30-9BE6-8A45705F8646}"/>
               </a:ext>
             </a:extLst>
           </p:cNvPr>
@@ -9049,7 +9049,7 @@
           <p:cNvPr id="8" name="Rounded Rectangle 7">
             <a:extLst xmlns:a="http://schemas.openxmlformats.org/drawingml/2006/main">
               <a:ext uri="{FF2B5EF4-FFF2-40B4-BE49-F238E27FC236}">
-                <a16:creationId xmlns:a16="http://schemas.microsoft.com/office/drawing/2014/main" id="{29A85A97-AAB5-457C-9354-E4829083E48D}"/>
+                <a16:creationId xmlns:a16="http://schemas.microsoft.com/office/drawing/2014/main" id="{AA3DD4C4-A085-4B30-9D87-D0C4747AB7D9}"/>
               </a:ext>
             </a:extLst>
           </p:cNvPr>
@@ -9104,7 +9104,7 @@
           <p:cNvPr id="9" name="TextBox 8">
             <a:extLst xmlns:a="http://schemas.openxmlformats.org/drawingml/2006/main">
               <a:ext uri="{FF2B5EF4-FFF2-40B4-BE49-F238E27FC236}">
-                <a16:creationId xmlns:a16="http://schemas.microsoft.com/office/drawing/2014/main" id="{C385E764-1748-473A-A380-F6F4D77B3918}"/>
+                <a16:creationId xmlns:a16="http://schemas.microsoft.com/office/drawing/2014/main" id="{E5061F46-6B97-478A-B2FB-BA4F31AB334C}"/>
               </a:ext>
             </a:extLst>
           </p:cNvPr>
@@ -9263,7 +9263,7 @@
     </p:spTree>
     <p:extLst>
       <p:ext uri="{BB962C8B-B14F-4D97-AF65-F5344CB8AC3E}">
-        <p14:creationId xmlns:p14="http://schemas.microsoft.com/office/powerpoint/2010/main" val="1698233138"/>
+        <p14:creationId xmlns:p14="http://schemas.microsoft.com/office/powerpoint/2010/main" val="2046228398"/>
       </p:ext>
     </p:extLst>
   </p:cSld>
@@ -9287,7 +9287,7 @@
           <p:cNvPr id="2" name="Rectangle 1">
             <a:extLst xmlns:a="http://schemas.openxmlformats.org/drawingml/2006/main">
               <a:ext uri="{FF2B5EF4-FFF2-40B4-BE49-F238E27FC236}">
-                <a16:creationId xmlns:a16="http://schemas.microsoft.com/office/drawing/2014/main" id="{33F57D29-E76D-40C5-9F4B-89919E974F92}"/>
+                <a16:creationId xmlns:a16="http://schemas.microsoft.com/office/drawing/2014/main" id="{369C03A0-6F9C-48C4-9346-D25A2709946A}"/>
               </a:ext>
             </a:extLst>
           </p:cNvPr>
@@ -9340,7 +9340,7 @@
           <p:cNvPr id="3" name="Rectangle 2">
             <a:extLst xmlns:a="http://schemas.openxmlformats.org/drawingml/2006/main">
               <a:ext uri="{FF2B5EF4-FFF2-40B4-BE49-F238E27FC236}">
-                <a16:creationId xmlns:a16="http://schemas.microsoft.com/office/drawing/2014/main" id="{CFAE431C-16E6-43F8-9CB8-CC1F2FA4E979}"/>
+                <a16:creationId xmlns:a16="http://schemas.microsoft.com/office/drawing/2014/main" id="{49497C8A-E763-4EAB-A960-25A4D8C36309}"/>
               </a:ext>
             </a:extLst>
           </p:cNvPr>
@@ -9393,7 +9393,7 @@
           <p:cNvPr id="4" name="Rectangle 3">
             <a:extLst xmlns:a="http://schemas.openxmlformats.org/drawingml/2006/main">
               <a:ext uri="{FF2B5EF4-FFF2-40B4-BE49-F238E27FC236}">
-                <a16:creationId xmlns:a16="http://schemas.microsoft.com/office/drawing/2014/main" id="{750509EF-D968-4C31-9D1A-12B15D10AD73}"/>
+                <a16:creationId xmlns:a16="http://schemas.microsoft.com/office/drawing/2014/main" id="{57570CA0-2027-4383-9241-7DE9B63B4C79}"/>
               </a:ext>
             </a:extLst>
           </p:cNvPr>
@@ -9446,7 +9446,7 @@
           <p:cNvPr id="5" name="TextBox 4">
             <a:extLst xmlns:a="http://schemas.openxmlformats.org/drawingml/2006/main">
               <a:ext uri="{FF2B5EF4-FFF2-40B4-BE49-F238E27FC236}">
-                <a16:creationId xmlns:a16="http://schemas.microsoft.com/office/drawing/2014/main" id="{08988000-8C54-4016-8488-6949BE3409DB}"/>
+                <a16:creationId xmlns:a16="http://schemas.microsoft.com/office/drawing/2014/main" id="{D7EE01C6-B239-4D46-9C9D-5358EB7DAC68}"/>
               </a:ext>
             </a:extLst>
           </p:cNvPr>
@@ -9509,7 +9509,7 @@
           <p:cNvPr id="6" name="Rounded Rectangle 5">
             <a:extLst xmlns:a="http://schemas.openxmlformats.org/drawingml/2006/main">
               <a:ext uri="{FF2B5EF4-FFF2-40B4-BE49-F238E27FC236}">
-                <a16:creationId xmlns:a16="http://schemas.microsoft.com/office/drawing/2014/main" id="{B87E967F-F1DB-4564-8806-25657B9BDF16}"/>
+                <a16:creationId xmlns:a16="http://schemas.microsoft.com/office/drawing/2014/main" id="{7AEC23A6-E0E0-4083-AACF-F26748873143}"/>
               </a:ext>
             </a:extLst>
           </p:cNvPr>
@@ -9564,7 +9564,7 @@
           <p:cNvPr id="7" name="TextBox 6">
             <a:extLst xmlns:a="http://schemas.openxmlformats.org/drawingml/2006/main">
               <a:ext uri="{FF2B5EF4-FFF2-40B4-BE49-F238E27FC236}">
-                <a16:creationId xmlns:a16="http://schemas.microsoft.com/office/drawing/2014/main" id="{F6733F74-2107-4DA5-9A3F-8FCE95A79125}"/>
+                <a16:creationId xmlns:a16="http://schemas.microsoft.com/office/drawing/2014/main" id="{AE3C6C5C-A24F-4FB3-A763-C9A9C6C624BC}"/>
               </a:ext>
             </a:extLst>
           </p:cNvPr>
@@ -9782,7 +9782,7 @@
           <p:cNvPr id="8" name="Rounded Rectangle 7">
             <a:extLst xmlns:a="http://schemas.openxmlformats.org/drawingml/2006/main">
               <a:ext uri="{FF2B5EF4-FFF2-40B4-BE49-F238E27FC236}">
-                <a16:creationId xmlns:a16="http://schemas.microsoft.com/office/drawing/2014/main" id="{6CD334BA-CB48-4684-BFD5-834D7FFF24B1}"/>
+                <a16:creationId xmlns:a16="http://schemas.microsoft.com/office/drawing/2014/main" id="{35406027-2F78-4AC4-B0C6-B1A92B2A0C5A}"/>
               </a:ext>
             </a:extLst>
           </p:cNvPr>
@@ -9837,7 +9837,7 @@
           <p:cNvPr id="9" name="TextBox 8">
             <a:extLst xmlns:a="http://schemas.openxmlformats.org/drawingml/2006/main">
               <a:ext uri="{FF2B5EF4-FFF2-40B4-BE49-F238E27FC236}">
-                <a16:creationId xmlns:a16="http://schemas.microsoft.com/office/drawing/2014/main" id="{7438878A-36C5-40D7-B529-03F99F50C9AB}"/>
+                <a16:creationId xmlns:a16="http://schemas.microsoft.com/office/drawing/2014/main" id="{70C172F9-4E84-41E0-9282-2F72380241BF}"/>
               </a:ext>
             </a:extLst>
           </p:cNvPr>
@@ -10072,7 +10072,7 @@
     </p:spTree>
     <p:extLst>
       <p:ext uri="{BB962C8B-B14F-4D97-AF65-F5344CB8AC3E}">
-        <p14:creationId xmlns:p14="http://schemas.microsoft.com/office/powerpoint/2010/main" val="730359881"/>
+        <p14:creationId xmlns:p14="http://schemas.microsoft.com/office/powerpoint/2010/main" val="1616083947"/>
       </p:ext>
     </p:extLst>
   </p:cSld>
@@ -10096,7 +10096,7 @@
           <p:cNvPr id="2" name="Rectangle 1">
             <a:extLst xmlns:a="http://schemas.openxmlformats.org/drawingml/2006/main">
               <a:ext uri="{FF2B5EF4-FFF2-40B4-BE49-F238E27FC236}">
-                <a16:creationId xmlns:a16="http://schemas.microsoft.com/office/drawing/2014/main" id="{BD886271-9E50-48E9-8074-5992A607422C}"/>
+                <a16:creationId xmlns:a16="http://schemas.microsoft.com/office/drawing/2014/main" id="{FB6C215E-4933-49BB-BA5E-6FC3CF767DCC}"/>
               </a:ext>
             </a:extLst>
           </p:cNvPr>
@@ -10149,7 +10149,7 @@
           <p:cNvPr id="3" name="Rectangle 2">
             <a:extLst xmlns:a="http://schemas.openxmlformats.org/drawingml/2006/main">
               <a:ext uri="{FF2B5EF4-FFF2-40B4-BE49-F238E27FC236}">
-                <a16:creationId xmlns:a16="http://schemas.microsoft.com/office/drawing/2014/main" id="{E548262D-EE3A-46F5-B428-95F9EF3BB378}"/>
+                <a16:creationId xmlns:a16="http://schemas.microsoft.com/office/drawing/2014/main" id="{2E3F4EED-BF24-4DA2-BE66-CB25C6DB0671}"/>
               </a:ext>
             </a:extLst>
           </p:cNvPr>
@@ -10202,7 +10202,7 @@
           <p:cNvPr id="4" name="Rectangle 3">
             <a:extLst xmlns:a="http://schemas.openxmlformats.org/drawingml/2006/main">
               <a:ext uri="{FF2B5EF4-FFF2-40B4-BE49-F238E27FC236}">
-                <a16:creationId xmlns:a16="http://schemas.microsoft.com/office/drawing/2014/main" id="{A018D37F-572A-4C43-BE37-AE490C003635}"/>
+                <a16:creationId xmlns:a16="http://schemas.microsoft.com/office/drawing/2014/main" id="{79EF0CB2-87EF-434E-B48A-5EC5807CB760}"/>
               </a:ext>
             </a:extLst>
           </p:cNvPr>
@@ -10255,7 +10255,7 @@
           <p:cNvPr id="5" name="TextBox 4">
             <a:extLst xmlns:a="http://schemas.openxmlformats.org/drawingml/2006/main">
               <a:ext uri="{FF2B5EF4-FFF2-40B4-BE49-F238E27FC236}">
-                <a16:creationId xmlns:a16="http://schemas.microsoft.com/office/drawing/2014/main" id="{6664577D-EEC3-4583-B64F-17C18EFCD88B}"/>
+                <a16:creationId xmlns:a16="http://schemas.microsoft.com/office/drawing/2014/main" id="{933CBB98-25E2-4DDE-A463-C98919D18436}"/>
               </a:ext>
             </a:extLst>
           </p:cNvPr>
@@ -10318,7 +10318,7 @@
           <p:cNvPr id="6" name="Rounded Rectangle 5">
             <a:extLst xmlns:a="http://schemas.openxmlformats.org/drawingml/2006/main">
               <a:ext uri="{FF2B5EF4-FFF2-40B4-BE49-F238E27FC236}">
-                <a16:creationId xmlns:a16="http://schemas.microsoft.com/office/drawing/2014/main" id="{6D1298E0-CD6D-4635-BBAC-98F012E57033}"/>
+                <a16:creationId xmlns:a16="http://schemas.microsoft.com/office/drawing/2014/main" id="{5394D970-50B3-4579-9208-017EAF26AC18}"/>
               </a:ext>
             </a:extLst>
           </p:cNvPr>
@@ -10373,7 +10373,7 @@
           <p:cNvPr id="7" name="TextBox 6">
             <a:extLst xmlns:a="http://schemas.openxmlformats.org/drawingml/2006/main">
               <a:ext uri="{FF2B5EF4-FFF2-40B4-BE49-F238E27FC236}">
-                <a16:creationId xmlns:a16="http://schemas.microsoft.com/office/drawing/2014/main" id="{7CC56DAB-A78D-438A-B49B-75863023294E}"/>
+                <a16:creationId xmlns:a16="http://schemas.microsoft.com/office/drawing/2014/main" id="{3F673A2F-5D7C-46F4-A3AC-76FD0CBE17AB}"/>
               </a:ext>
             </a:extLst>
           </p:cNvPr>
@@ -10595,7 +10595,7 @@
           <p:nvPr/>
         </p:nvPicPr>
         <p:blipFill>
-          <a:blip xmlns:r="http://schemas.openxmlformats.org/officeDocument/2006/relationships" xmlns:a="http://schemas.openxmlformats.org/drawingml/2006/main" r:embed="R1fdd529506ff4862"/>
+          <a:blip xmlns:r="http://schemas.openxmlformats.org/officeDocument/2006/relationships" xmlns:a="http://schemas.openxmlformats.org/drawingml/2006/main" r:embed="R5276bb3c00234c9f"/>
           <a:stretch xmlns:a="http://schemas.openxmlformats.org/drawingml/2006/main">
             <a:fillRect l="0" t="0" r="0" b="0"/>
           </a:stretch>
@@ -10615,7 +10615,7 @@
           <p:cNvPr id="9" name="Rounded Rectangle 8">
             <a:extLst xmlns:a="http://schemas.openxmlformats.org/drawingml/2006/main">
               <a:ext uri="{FF2B5EF4-FFF2-40B4-BE49-F238E27FC236}">
-                <a16:creationId xmlns:a16="http://schemas.microsoft.com/office/drawing/2014/main" id="{0E0F0CE4-8BBF-437D-80B9-EC8FB4C2CA80}"/>
+                <a16:creationId xmlns:a16="http://schemas.microsoft.com/office/drawing/2014/main" id="{8629DA46-0887-47CD-87A0-4B4BBFDAC928}"/>
               </a:ext>
             </a:extLst>
           </p:cNvPr>
@@ -10670,7 +10670,7 @@
           <p:cNvPr id="10" name="TextBox 9">
             <a:extLst xmlns:a="http://schemas.openxmlformats.org/drawingml/2006/main">
               <a:ext uri="{FF2B5EF4-FFF2-40B4-BE49-F238E27FC236}">
-                <a16:creationId xmlns:a16="http://schemas.microsoft.com/office/drawing/2014/main" id="{E08878C1-E243-4199-97F4-E4D94C606D6C}"/>
+                <a16:creationId xmlns:a16="http://schemas.microsoft.com/office/drawing/2014/main" id="{F1F38445-D1F5-4266-9961-D8F46103A0B0}"/>
               </a:ext>
             </a:extLst>
           </p:cNvPr>
@@ -10756,7 +10756,7 @@
     </p:spTree>
     <p:extLst>
       <p:ext uri="{BB962C8B-B14F-4D97-AF65-F5344CB8AC3E}">
-        <p14:creationId xmlns:p14="http://schemas.microsoft.com/office/powerpoint/2010/main" val="346853300"/>
+        <p14:creationId xmlns:p14="http://schemas.microsoft.com/office/powerpoint/2010/main" val="1809980643"/>
       </p:ext>
     </p:extLst>
   </p:cSld>
@@ -10780,7 +10780,7 @@
           <p:cNvPr id="2" name="Rectangle 1">
             <a:extLst xmlns:a="http://schemas.openxmlformats.org/drawingml/2006/main">
               <a:ext uri="{FF2B5EF4-FFF2-40B4-BE49-F238E27FC236}">
-                <a16:creationId xmlns:a16="http://schemas.microsoft.com/office/drawing/2014/main" id="{06D5B608-F6C8-4C95-B30C-4AD003CF5CB5}"/>
+                <a16:creationId xmlns:a16="http://schemas.microsoft.com/office/drawing/2014/main" id="{269C9E41-5139-467D-B726-1C097AAC80CE}"/>
               </a:ext>
             </a:extLst>
           </p:cNvPr>
@@ -10833,7 +10833,7 @@
           <p:cNvPr id="3" name="Rectangle 2">
             <a:extLst xmlns:a="http://schemas.openxmlformats.org/drawingml/2006/main">
               <a:ext uri="{FF2B5EF4-FFF2-40B4-BE49-F238E27FC236}">
-                <a16:creationId xmlns:a16="http://schemas.microsoft.com/office/drawing/2014/main" id="{7A77D484-72B8-4F17-A959-01EDF718DF98}"/>
+                <a16:creationId xmlns:a16="http://schemas.microsoft.com/office/drawing/2014/main" id="{615AD4CD-3884-4AA0-A370-CECDD1B242FE}"/>
               </a:ext>
             </a:extLst>
           </p:cNvPr>
@@ -10886,7 +10886,7 @@
           <p:cNvPr id="4" name="Rectangle 3">
             <a:extLst xmlns:a="http://schemas.openxmlformats.org/drawingml/2006/main">
               <a:ext uri="{FF2B5EF4-FFF2-40B4-BE49-F238E27FC236}">
-                <a16:creationId xmlns:a16="http://schemas.microsoft.com/office/drawing/2014/main" id="{F9620F5B-FAF8-4F7D-9C98-09922DA7CE9A}"/>
+                <a16:creationId xmlns:a16="http://schemas.microsoft.com/office/drawing/2014/main" id="{B8816665-8BB4-45FE-9623-C40B56FBA51F}"/>
               </a:ext>
             </a:extLst>
           </p:cNvPr>
@@ -10939,7 +10939,7 @@
           <p:cNvPr id="5" name="TextBox 4">
             <a:extLst xmlns:a="http://schemas.openxmlformats.org/drawingml/2006/main">
               <a:ext uri="{FF2B5EF4-FFF2-40B4-BE49-F238E27FC236}">
-                <a16:creationId xmlns:a16="http://schemas.microsoft.com/office/drawing/2014/main" id="{47A05D45-7C59-4890-91C8-3225885DDB5E}"/>
+                <a16:creationId xmlns:a16="http://schemas.microsoft.com/office/drawing/2014/main" id="{3856AAD0-ADEA-4A0B-AED6-0C6304FCC24C}"/>
               </a:ext>
             </a:extLst>
           </p:cNvPr>
@@ -11002,7 +11002,7 @@
           <p:cNvPr id="6" name="Rounded Rectangle 5">
             <a:extLst xmlns:a="http://schemas.openxmlformats.org/drawingml/2006/main">
               <a:ext uri="{FF2B5EF4-FFF2-40B4-BE49-F238E27FC236}">
-                <a16:creationId xmlns:a16="http://schemas.microsoft.com/office/drawing/2014/main" id="{E497226D-0AC7-4BE5-B544-C2A97D13F34A}"/>
+                <a16:creationId xmlns:a16="http://schemas.microsoft.com/office/drawing/2014/main" id="{4F560846-6FD2-48B0-B3A6-0A526A0F5711}"/>
               </a:ext>
             </a:extLst>
           </p:cNvPr>
@@ -11057,7 +11057,7 @@
           <p:cNvPr id="7" name="TextBox 6">
             <a:extLst xmlns:a="http://schemas.openxmlformats.org/drawingml/2006/main">
               <a:ext uri="{FF2B5EF4-FFF2-40B4-BE49-F238E27FC236}">
-                <a16:creationId xmlns:a16="http://schemas.microsoft.com/office/drawing/2014/main" id="{92ED84E8-573E-455B-9C6E-1C7E0ED707FC}"/>
+                <a16:creationId xmlns:a16="http://schemas.microsoft.com/office/drawing/2014/main" id="{533DECB7-04A0-4BFC-953F-789B7B504BCF}"/>
               </a:ext>
             </a:extLst>
           </p:cNvPr>
@@ -11294,7 +11294,7 @@
           <p:cNvPr id="8" name="Rounded Rectangle 7">
             <a:extLst xmlns:a="http://schemas.openxmlformats.org/drawingml/2006/main">
               <a:ext uri="{FF2B5EF4-FFF2-40B4-BE49-F238E27FC236}">
-                <a16:creationId xmlns:a16="http://schemas.microsoft.com/office/drawing/2014/main" id="{339BDEBF-AF1B-4815-AEFA-4A6E0717FF7F}"/>
+                <a16:creationId xmlns:a16="http://schemas.microsoft.com/office/drawing/2014/main" id="{D636E081-7EC1-487C-B8A9-3963359A216B}"/>
               </a:ext>
             </a:extLst>
           </p:cNvPr>
@@ -11349,7 +11349,7 @@
           <p:cNvPr id="9" name="TextBox 8">
             <a:extLst xmlns:a="http://schemas.openxmlformats.org/drawingml/2006/main">
               <a:ext uri="{FF2B5EF4-FFF2-40B4-BE49-F238E27FC236}">
-                <a16:creationId xmlns:a16="http://schemas.microsoft.com/office/drawing/2014/main" id="{85D9B94A-4338-4A52-97CC-710D2EE71D29}"/>
+                <a16:creationId xmlns:a16="http://schemas.microsoft.com/office/drawing/2014/main" id="{74423B59-AA4E-41F1-B728-ADE5D3629EF9}"/>
               </a:ext>
             </a:extLst>
           </p:cNvPr>
@@ -11684,7 +11684,7 @@
     </p:spTree>
     <p:extLst>
       <p:ext uri="{BB962C8B-B14F-4D97-AF65-F5344CB8AC3E}">
-        <p14:creationId xmlns:p14="http://schemas.microsoft.com/office/powerpoint/2010/main" val="279318366"/>
+        <p14:creationId xmlns:p14="http://schemas.microsoft.com/office/powerpoint/2010/main" val="963955045"/>
       </p:ext>
     </p:extLst>
   </p:cSld>
@@ -11708,7 +11708,7 @@
           <p:cNvPr id="2" name="Rectangle 1">
             <a:extLst xmlns:a="http://schemas.openxmlformats.org/drawingml/2006/main">
               <a:ext uri="{FF2B5EF4-FFF2-40B4-BE49-F238E27FC236}">
-                <a16:creationId xmlns:a16="http://schemas.microsoft.com/office/drawing/2014/main" id="{742BF1C6-9628-4829-8511-7E4740CBDA54}"/>
+                <a16:creationId xmlns:a16="http://schemas.microsoft.com/office/drawing/2014/main" id="{45838C76-883C-42A2-B00D-5AAAB3AAEDC4}"/>
               </a:ext>
             </a:extLst>
           </p:cNvPr>
@@ -11761,7 +11761,7 @@
           <p:cNvPr id="3" name="Rectangle 2">
             <a:extLst xmlns:a="http://schemas.openxmlformats.org/drawingml/2006/main">
               <a:ext uri="{FF2B5EF4-FFF2-40B4-BE49-F238E27FC236}">
-                <a16:creationId xmlns:a16="http://schemas.microsoft.com/office/drawing/2014/main" id="{74915344-EF7E-467F-9957-CC87313528D3}"/>
+                <a16:creationId xmlns:a16="http://schemas.microsoft.com/office/drawing/2014/main" id="{35B724DC-CB3D-444E-9929-F1FE5C6E79CA}"/>
               </a:ext>
             </a:extLst>
           </p:cNvPr>
@@ -11814,7 +11814,7 @@
           <p:cNvPr id="4" name="Rectangle 3">
             <a:extLst xmlns:a="http://schemas.openxmlformats.org/drawingml/2006/main">
               <a:ext uri="{FF2B5EF4-FFF2-40B4-BE49-F238E27FC236}">
-                <a16:creationId xmlns:a16="http://schemas.microsoft.com/office/drawing/2014/main" id="{53659B57-9C8C-40A9-AF60-16A18D874DE7}"/>
+                <a16:creationId xmlns:a16="http://schemas.microsoft.com/office/drawing/2014/main" id="{C02BF112-CB43-4BCD-A231-2142FF2759C4}"/>
               </a:ext>
             </a:extLst>
           </p:cNvPr>
@@ -11867,7 +11867,7 @@
           <p:cNvPr id="5" name="TextBox 4">
             <a:extLst xmlns:a="http://schemas.openxmlformats.org/drawingml/2006/main">
               <a:ext uri="{FF2B5EF4-FFF2-40B4-BE49-F238E27FC236}">
-                <a16:creationId xmlns:a16="http://schemas.microsoft.com/office/drawing/2014/main" id="{7A44891F-0971-485E-A233-4CF123A5739A}"/>
+                <a16:creationId xmlns:a16="http://schemas.microsoft.com/office/drawing/2014/main" id="{2A2FCC4F-198C-4DC1-B7F0-F196B2CC4A3F}"/>
               </a:ext>
             </a:extLst>
           </p:cNvPr>
@@ -11930,7 +11930,7 @@
           <p:cNvPr id="6" name="Rounded Rectangle 5">
             <a:extLst xmlns:a="http://schemas.openxmlformats.org/drawingml/2006/main">
               <a:ext uri="{FF2B5EF4-FFF2-40B4-BE49-F238E27FC236}">
-                <a16:creationId xmlns:a16="http://schemas.microsoft.com/office/drawing/2014/main" id="{5B34D758-34A1-476A-9CEE-D11B4E9841B7}"/>
+                <a16:creationId xmlns:a16="http://schemas.microsoft.com/office/drawing/2014/main" id="{543F8941-D038-4329-BF2C-4C15E87B8942}"/>
               </a:ext>
             </a:extLst>
           </p:cNvPr>
@@ -11985,7 +11985,7 @@
           <p:cNvPr id="7" name="TextBox 6">
             <a:extLst xmlns:a="http://schemas.openxmlformats.org/drawingml/2006/main">
               <a:ext uri="{FF2B5EF4-FFF2-40B4-BE49-F238E27FC236}">
-                <a16:creationId xmlns:a16="http://schemas.microsoft.com/office/drawing/2014/main" id="{8CFDBAB0-EA46-43FE-8C61-8AE8D6D9D96A}"/>
+                <a16:creationId xmlns:a16="http://schemas.microsoft.com/office/drawing/2014/main" id="{6C958E2E-1B8A-46E5-9979-388EBA2C5CE9}"/>
               </a:ext>
             </a:extLst>
           </p:cNvPr>
@@ -12108,7 +12108,7 @@
           <p:cNvPr id="8" name="Rounded Rectangle 7">
             <a:extLst xmlns:a="http://schemas.openxmlformats.org/drawingml/2006/main">
               <a:ext uri="{FF2B5EF4-FFF2-40B4-BE49-F238E27FC236}">
-                <a16:creationId xmlns:a16="http://schemas.microsoft.com/office/drawing/2014/main" id="{5EDE8D18-9CBE-45C2-9DF7-6C7AEBA3F09F}"/>
+                <a16:creationId xmlns:a16="http://schemas.microsoft.com/office/drawing/2014/main" id="{5359BF50-B4CB-4958-83BC-5A54F58327B7}"/>
               </a:ext>
             </a:extLst>
           </p:cNvPr>
@@ -12163,7 +12163,7 @@
           <p:cNvPr id="9" name="TextBox 8">
             <a:extLst xmlns:a="http://schemas.openxmlformats.org/drawingml/2006/main">
               <a:ext uri="{FF2B5EF4-FFF2-40B4-BE49-F238E27FC236}">
-                <a16:creationId xmlns:a16="http://schemas.microsoft.com/office/drawing/2014/main" id="{BE7C79A6-26CD-42FD-A1A3-8DB96E120250}"/>
+                <a16:creationId xmlns:a16="http://schemas.microsoft.com/office/drawing/2014/main" id="{BCA9BAD2-B198-4CDE-85E3-C5A64336FFB5}"/>
               </a:ext>
             </a:extLst>
           </p:cNvPr>
@@ -12286,7 +12286,7 @@
           <p:cNvPr id="10" name="Rounded Rectangle 9">
             <a:extLst xmlns:a="http://schemas.openxmlformats.org/drawingml/2006/main">
               <a:ext uri="{FF2B5EF4-FFF2-40B4-BE49-F238E27FC236}">
-                <a16:creationId xmlns:a16="http://schemas.microsoft.com/office/drawing/2014/main" id="{B2EF3340-C821-4436-ABB8-7082C3884112}"/>
+                <a16:creationId xmlns:a16="http://schemas.microsoft.com/office/drawing/2014/main" id="{D120393D-1940-4D27-A2ED-DA00BB75682D}"/>
               </a:ext>
             </a:extLst>
           </p:cNvPr>
@@ -12341,7 +12341,7 @@
           <p:cNvPr id="11" name="TextBox 10">
             <a:extLst xmlns:a="http://schemas.openxmlformats.org/drawingml/2006/main">
               <a:ext uri="{FF2B5EF4-FFF2-40B4-BE49-F238E27FC236}">
-                <a16:creationId xmlns:a16="http://schemas.microsoft.com/office/drawing/2014/main" id="{101EEEF0-0931-4C97-9129-4E43EB51409F}"/>
+                <a16:creationId xmlns:a16="http://schemas.microsoft.com/office/drawing/2014/main" id="{4B1A47A2-8F8C-4ACE-82D5-DD8666718136}"/>
               </a:ext>
             </a:extLst>
           </p:cNvPr>
@@ -12658,7 +12658,7 @@
     </p:spTree>
     <p:extLst>
       <p:ext uri="{BB962C8B-B14F-4D97-AF65-F5344CB8AC3E}">
-        <p14:creationId xmlns:p14="http://schemas.microsoft.com/office/powerpoint/2010/main" val="445248828"/>
+        <p14:creationId xmlns:p14="http://schemas.microsoft.com/office/powerpoint/2010/main" val="1132266275"/>
       </p:ext>
     </p:extLst>
   </p:cSld>
@@ -12682,7 +12682,7 @@
           <p:cNvPr id="2" name="Rectangle 1">
             <a:extLst xmlns:a="http://schemas.openxmlformats.org/drawingml/2006/main">
               <a:ext uri="{FF2B5EF4-FFF2-40B4-BE49-F238E27FC236}">
-                <a16:creationId xmlns:a16="http://schemas.microsoft.com/office/drawing/2014/main" id="{E516140A-E4C3-4521-B9A7-417CFA224CEB}"/>
+                <a16:creationId xmlns:a16="http://schemas.microsoft.com/office/drawing/2014/main" id="{A58BB38C-9BE8-4D0D-9989-AB4BC968822E}"/>
               </a:ext>
             </a:extLst>
           </p:cNvPr>
@@ -12735,7 +12735,7 @@
           <p:cNvPr id="3" name="Rectangle 2">
             <a:extLst xmlns:a="http://schemas.openxmlformats.org/drawingml/2006/main">
               <a:ext uri="{FF2B5EF4-FFF2-40B4-BE49-F238E27FC236}">
-                <a16:creationId xmlns:a16="http://schemas.microsoft.com/office/drawing/2014/main" id="{DD47A10E-8AC0-4EE0-A425-12D76AD055C4}"/>
+                <a16:creationId xmlns:a16="http://schemas.microsoft.com/office/drawing/2014/main" id="{1B4CBD96-ED6E-48B5-8F19-64A503AE9829}"/>
               </a:ext>
             </a:extLst>
           </p:cNvPr>
@@ -12788,7 +12788,7 @@
           <p:cNvPr id="4" name="Rectangle 3">
             <a:extLst xmlns:a="http://schemas.openxmlformats.org/drawingml/2006/main">
               <a:ext uri="{FF2B5EF4-FFF2-40B4-BE49-F238E27FC236}">
-                <a16:creationId xmlns:a16="http://schemas.microsoft.com/office/drawing/2014/main" id="{23075E0F-4902-4FF0-8AA0-364388A617B7}"/>
+                <a16:creationId xmlns:a16="http://schemas.microsoft.com/office/drawing/2014/main" id="{0C0481EB-412B-4182-947E-ED4080BEF817}"/>
               </a:ext>
             </a:extLst>
           </p:cNvPr>
@@ -12841,7 +12841,7 @@
           <p:cNvPr id="5" name="TextBox 4">
             <a:extLst xmlns:a="http://schemas.openxmlformats.org/drawingml/2006/main">
               <a:ext uri="{FF2B5EF4-FFF2-40B4-BE49-F238E27FC236}">
-                <a16:creationId xmlns:a16="http://schemas.microsoft.com/office/drawing/2014/main" id="{00B4D52D-E953-485B-B6A4-5D19AF334F73}"/>
+                <a16:creationId xmlns:a16="http://schemas.microsoft.com/office/drawing/2014/main" id="{4260F6EE-883F-488C-AC08-5A0424FAF1C2}"/>
               </a:ext>
             </a:extLst>
           </p:cNvPr>
@@ -12904,7 +12904,7 @@
           <p:cNvPr id="6" name="Rounded Rectangle 5">
             <a:extLst xmlns:a="http://schemas.openxmlformats.org/drawingml/2006/main">
               <a:ext uri="{FF2B5EF4-FFF2-40B4-BE49-F238E27FC236}">
-                <a16:creationId xmlns:a16="http://schemas.microsoft.com/office/drawing/2014/main" id="{5511BAE8-677F-437F-8449-FD16F0EDB3E2}"/>
+                <a16:creationId xmlns:a16="http://schemas.microsoft.com/office/drawing/2014/main" id="{6473EF80-67E8-48BE-A159-AA60C7905F9F}"/>
               </a:ext>
             </a:extLst>
           </p:cNvPr>
@@ -12959,7 +12959,7 @@
           <p:cNvPr id="7" name="TextBox 6">
             <a:extLst xmlns:a="http://schemas.openxmlformats.org/drawingml/2006/main">
               <a:ext uri="{FF2B5EF4-FFF2-40B4-BE49-F238E27FC236}">
-                <a16:creationId xmlns:a16="http://schemas.microsoft.com/office/drawing/2014/main" id="{9E23258A-4CDA-4FCC-88E0-CEAD1DD06641}"/>
+                <a16:creationId xmlns:a16="http://schemas.microsoft.com/office/drawing/2014/main" id="{2B97072E-746C-4A92-A073-2402F260A9B0}"/>
               </a:ext>
             </a:extLst>
           </p:cNvPr>
@@ -13332,7 +13332,7 @@
           <p:nvPr/>
         </p:nvPicPr>
         <p:blipFill>
-          <a:blip xmlns:r="http://schemas.openxmlformats.org/officeDocument/2006/relationships" xmlns:a="http://schemas.openxmlformats.org/drawingml/2006/main" r:embed="Rdd71940cb6394960"/>
+          <a:blip xmlns:r="http://schemas.openxmlformats.org/officeDocument/2006/relationships" xmlns:a="http://schemas.openxmlformats.org/drawingml/2006/main" r:embed="R1159e80b8d3942b7"/>
           <a:stretch xmlns:a="http://schemas.openxmlformats.org/drawingml/2006/main">
             <a:fillRect l="0" t="0" r="0" b="0"/>
           </a:stretch>
@@ -13352,7 +13352,7 @@
           <p:cNvPr id="9" name="Rounded Rectangle 8">
             <a:extLst xmlns:a="http://schemas.openxmlformats.org/drawingml/2006/main">
               <a:ext uri="{FF2B5EF4-FFF2-40B4-BE49-F238E27FC236}">
-                <a16:creationId xmlns:a16="http://schemas.microsoft.com/office/drawing/2014/main" id="{67BE1C8E-4C45-46FC-A696-1296461D49A2}"/>
+                <a16:creationId xmlns:a16="http://schemas.microsoft.com/office/drawing/2014/main" id="{5A4F294A-B342-4027-A2F4-2B8A0C15FC9D}"/>
               </a:ext>
             </a:extLst>
           </p:cNvPr>
@@ -13407,7 +13407,7 @@
           <p:cNvPr id="10" name="TextBox 9">
             <a:extLst xmlns:a="http://schemas.openxmlformats.org/drawingml/2006/main">
               <a:ext uri="{FF2B5EF4-FFF2-40B4-BE49-F238E27FC236}">
-                <a16:creationId xmlns:a16="http://schemas.microsoft.com/office/drawing/2014/main" id="{B399EFDE-785B-4E0D-AE93-9F08E771C7C8}"/>
+                <a16:creationId xmlns:a16="http://schemas.microsoft.com/office/drawing/2014/main" id="{92AC73DC-BDB6-493F-AD2C-ECCBABF50958}"/>
               </a:ext>
             </a:extLst>
           </p:cNvPr>
@@ -13490,7 +13490,7 @@
     </p:spTree>
     <p:extLst>
       <p:ext uri="{BB962C8B-B14F-4D97-AF65-F5344CB8AC3E}">
-        <p14:creationId xmlns:p14="http://schemas.microsoft.com/office/powerpoint/2010/main" val="2063367648"/>
+        <p14:creationId xmlns:p14="http://schemas.microsoft.com/office/powerpoint/2010/main" val="168802271"/>
       </p:ext>
     </p:extLst>
   </p:cSld>

</xml_diff>

<commit_message>
fix(repro-presentation): repair contract defects, add per-condition deltas, cohort separation, numerical binding, and canonical bundle verification
</commit_message>
<xml_diff>
--- a/reports/evidence/fixture_populated_slides.pptx
+++ b/reports/evidence/fixture_populated_slides.pptx
@@ -2,24 +2,24 @@
 <file path=ppt/presentation.xml><?xml version="1.0" encoding="utf-8"?>
 <p:presentation xmlns:p="http://schemas.openxmlformats.org/presentationml/2006/main">
   <p:sldMasterIdLst>
-    <p:sldMasterId xmlns:r="http://schemas.openxmlformats.org/officeDocument/2006/relationships" id="2147483648" r:id="R60c301539b9a42b2"/>
+    <p:sldMasterId xmlns:r="http://schemas.openxmlformats.org/officeDocument/2006/relationships" id="2147483648" r:id="R97c028c3622744ec"/>
   </p:sldMasterIdLst>
   <p:notesMasterIdLst>
-    <p:notesMasterId xmlns:r="http://schemas.openxmlformats.org/officeDocument/2006/relationships" r:id="R41d0ef69073e4774"/>
+    <p:notesMasterId xmlns:r="http://schemas.openxmlformats.org/officeDocument/2006/relationships" r:id="Rd0ec733be698460c"/>
   </p:notesMasterIdLst>
   <p:sldIdLst>
-    <p:sldId xmlns:r="http://schemas.openxmlformats.org/officeDocument/2006/relationships" id="256" r:id="R98004795aac947c4"/>
-    <p:sldId xmlns:r="http://schemas.openxmlformats.org/officeDocument/2006/relationships" id="257" r:id="R796c744cf7954b3f"/>
-    <p:sldId xmlns:r="http://schemas.openxmlformats.org/officeDocument/2006/relationships" id="258" r:id="R865353c44c4b43d0"/>
-    <p:sldId xmlns:r="http://schemas.openxmlformats.org/officeDocument/2006/relationships" id="259" r:id="R326b732faba1456d"/>
-    <p:sldId xmlns:r="http://schemas.openxmlformats.org/officeDocument/2006/relationships" id="260" r:id="Ree96208da5df48e8"/>
-    <p:sldId xmlns:r="http://schemas.openxmlformats.org/officeDocument/2006/relationships" id="261" r:id="Rf57e9d09a8d94d17"/>
-    <p:sldId xmlns:r="http://schemas.openxmlformats.org/officeDocument/2006/relationships" id="262" r:id="Rc252fb27690e4b69"/>
-    <p:sldId xmlns:r="http://schemas.openxmlformats.org/officeDocument/2006/relationships" id="263" r:id="R2d64358f688d4fa6"/>
-    <p:sldId xmlns:r="http://schemas.openxmlformats.org/officeDocument/2006/relationships" id="264" r:id="Ree75c31ff95e4c02"/>
-    <p:sldId xmlns:r="http://schemas.openxmlformats.org/officeDocument/2006/relationships" id="265" r:id="R44eeafb0679146a1"/>
-    <p:sldId xmlns:r="http://schemas.openxmlformats.org/officeDocument/2006/relationships" id="266" r:id="Ra432547eaafe4b00"/>
-    <p:sldId xmlns:r="http://schemas.openxmlformats.org/officeDocument/2006/relationships" id="267" r:id="Rb3ed13219605450c"/>
+    <p:sldId xmlns:r="http://schemas.openxmlformats.org/officeDocument/2006/relationships" id="256" r:id="Rc7d173c9e34b4224"/>
+    <p:sldId xmlns:r="http://schemas.openxmlformats.org/officeDocument/2006/relationships" id="257" r:id="R37e42e448e0248f2"/>
+    <p:sldId xmlns:r="http://schemas.openxmlformats.org/officeDocument/2006/relationships" id="258" r:id="R487265d6275b43f2"/>
+    <p:sldId xmlns:r="http://schemas.openxmlformats.org/officeDocument/2006/relationships" id="259" r:id="R0d548589cdfd464b"/>
+    <p:sldId xmlns:r="http://schemas.openxmlformats.org/officeDocument/2006/relationships" id="260" r:id="R0df468567d8b43a9"/>
+    <p:sldId xmlns:r="http://schemas.openxmlformats.org/officeDocument/2006/relationships" id="261" r:id="R4bcc37655b8c4f87"/>
+    <p:sldId xmlns:r="http://schemas.openxmlformats.org/officeDocument/2006/relationships" id="262" r:id="Re3061b16ad4e46a8"/>
+    <p:sldId xmlns:r="http://schemas.openxmlformats.org/officeDocument/2006/relationships" id="263" r:id="R4e53f57b398f47d0"/>
+    <p:sldId xmlns:r="http://schemas.openxmlformats.org/officeDocument/2006/relationships" id="264" r:id="Rf56ca8d4b2924094"/>
+    <p:sldId xmlns:r="http://schemas.openxmlformats.org/officeDocument/2006/relationships" id="265" r:id="Rd66c37502a344989"/>
+    <p:sldId xmlns:r="http://schemas.openxmlformats.org/officeDocument/2006/relationships" id="266" r:id="R2c22f1dfac494254"/>
+    <p:sldId xmlns:r="http://schemas.openxmlformats.org/officeDocument/2006/relationships" id="267" r:id="Rcb65aadb02974262"/>
   </p:sldIdLst>
   <p:sldSz cx="12191695" cy="6858000"/>
   <p:notesSz cx="6858000" cy="9144000"/>
@@ -1435,7 +1435,7 @@
           </a:p>
           <a:p xmlns:a="http://schemas.openxmlformats.org/drawingml/2006/main">
             <a:r>
-              <a:t>[DIAGNOSTIC TEST FIXTURE STATS] Khoảng tin cậy 95% Bootstrap (B=1000): no_rag=[0.3500, 0.6500], rag_k1=[0.3500, 0.6500], rag_k3=[0.3500, 0.6500], rag_k5=[0.3500, 0.6500], rag_k10=[0.3500, 0.6500]. Đo lường phân rã lỗi D2i độc lập: Wrong Class Rate=0.3333, Overlaps (Miss &amp; Wrong=0, Miss &amp; Prov=0, Miss &amp; Parse=0, Miss &amp; Inval=0).</a:t>
+              <a:t>[DIAGNOSTIC TEST FIXTURE STATS] Khoảng tin cậy 95% Bootstrap (B=1000): no_rag=[0.3500, 0.6500], rag_k1=[0.3600, 0.6600], rag_k3=[0.3800, 0.6800], rag_k5=[0.4100, 0.7100], rag_k10=[0.4300, 0.7300]. Đo lường phân rã lỗi D2i độc lập: Wrong Class Rate=0.3333, Overlaps (Miss &amp; Wrong=0, Miss &amp; Prov=0, Miss &amp; Parse=0, Miss &amp; Inval=0).</a:t>
             </a:r>
           </a:p>
         </p:txBody>
@@ -1582,7 +1582,7 @@
           <p:cNvPr id="2" name="Title 1">
             <a:extLst xmlns:a="http://schemas.openxmlformats.org/drawingml/2006/main">
               <a:ext uri="{FF2B5EF4-FFF2-40B4-BE49-F238E27FC236}">
-                <a16:creationId xmlns:a16="http://schemas.microsoft.com/office/drawing/2014/main" id="{6BAC8A54-B266-4D17-B129-B12B2DC685F9}"/>
+                <a16:creationId xmlns:a16="http://schemas.microsoft.com/office/drawing/2014/main" id="{2326D6F1-0E5B-45C2-8308-9E56AE0B55A7}"/>
               </a:ext>
             </a:extLst>
           </p:cNvPr>
@@ -1615,7 +1615,7 @@
           <p:cNvPr id="3" name="Subtitle 2">
             <a:extLst xmlns:a="http://schemas.openxmlformats.org/drawingml/2006/main">
               <a:ext uri="{FF2B5EF4-FFF2-40B4-BE49-F238E27FC236}">
-                <a16:creationId xmlns:a16="http://schemas.microsoft.com/office/drawing/2014/main" id="{5BAC9853-E2B4-4A65-96D9-CB1B30CD5513}"/>
+                <a16:creationId xmlns:a16="http://schemas.microsoft.com/office/drawing/2014/main" id="{9E20FFCC-5526-4A74-9335-2CA47EDE1F7A}"/>
               </a:ext>
             </a:extLst>
           </p:cNvPr>
@@ -1739,7 +1739,7 @@
           <p:cNvPr id="4" name="Date Placeholder 3">
             <a:extLst xmlns:a="http://schemas.openxmlformats.org/drawingml/2006/main">
               <a:ext uri="{FF2B5EF4-FFF2-40B4-BE49-F238E27FC236}">
-                <a16:creationId xmlns:a16="http://schemas.microsoft.com/office/drawing/2014/main" id="{DB713E41-5C03-487B-A36B-7E738F67FFFB}"/>
+                <a16:creationId xmlns:a16="http://schemas.microsoft.com/office/drawing/2014/main" id="{DB35B456-1902-44D0-A5E4-E1D47AF39477}"/>
               </a:ext>
             </a:extLst>
           </p:cNvPr>
@@ -1767,7 +1767,7 @@
           <p:cNvPr id="5" name="Footer Placeholder 4">
             <a:extLst xmlns:a="http://schemas.openxmlformats.org/drawingml/2006/main">
               <a:ext uri="{FF2B5EF4-FFF2-40B4-BE49-F238E27FC236}">
-                <a16:creationId xmlns:a16="http://schemas.microsoft.com/office/drawing/2014/main" id="{FD56411F-464C-4A27-B44E-57510F1D94C2}"/>
+                <a16:creationId xmlns:a16="http://schemas.microsoft.com/office/drawing/2014/main" id="{7CEBD353-DEFF-4E4A-8442-3586A3D77DE2}"/>
               </a:ext>
             </a:extLst>
           </p:cNvPr>
@@ -1792,7 +1792,7 @@
           <p:cNvPr id="6" name="Slide Number Placeholder 5">
             <a:extLst xmlns:a="http://schemas.openxmlformats.org/drawingml/2006/main">
               <a:ext uri="{FF2B5EF4-FFF2-40B4-BE49-F238E27FC236}">
-                <a16:creationId xmlns:a16="http://schemas.microsoft.com/office/drawing/2014/main" id="{0E7FBB38-8B50-4E45-8402-A45817109674}"/>
+                <a16:creationId xmlns:a16="http://schemas.microsoft.com/office/drawing/2014/main" id="{B0038F65-240B-470A-A519-84AEB6CC5328}"/>
               </a:ext>
             </a:extLst>
           </p:cNvPr>
@@ -1837,7 +1837,7 @@
           <p:cNvPr id="2" name="Title 1">
             <a:extLst xmlns:a="http://schemas.openxmlformats.org/drawingml/2006/main">
               <a:ext uri="{FF2B5EF4-FFF2-40B4-BE49-F238E27FC236}">
-                <a16:creationId xmlns:a16="http://schemas.microsoft.com/office/drawing/2014/main" id="{D29F0096-FAFC-4AE7-B5A6-F79B4B878DDB}"/>
+                <a16:creationId xmlns:a16="http://schemas.microsoft.com/office/drawing/2014/main" id="{632F8BD2-D1E8-4BFF-802F-2DC8D8F191E1}"/>
               </a:ext>
             </a:extLst>
           </p:cNvPr>
@@ -1865,7 +1865,7 @@
           <p:cNvPr id="3" name="Vertical Text Placeholder 2">
             <a:extLst xmlns:a="http://schemas.openxmlformats.org/drawingml/2006/main">
               <a:ext uri="{FF2B5EF4-FFF2-40B4-BE49-F238E27FC236}">
-                <a16:creationId xmlns:a16="http://schemas.microsoft.com/office/drawing/2014/main" id="{E27CFA59-85FB-400B-9BC9-B352CDF272B9}"/>
+                <a16:creationId xmlns:a16="http://schemas.microsoft.com/office/drawing/2014/main" id="{DED7B928-0278-4727-B8E3-2C4BB9B41D87}"/>
               </a:ext>
             </a:extLst>
           </p:cNvPr>
@@ -1928,7 +1928,7 @@
           <p:cNvPr id="4" name="Date Placeholder 3">
             <a:extLst xmlns:a="http://schemas.openxmlformats.org/drawingml/2006/main">
               <a:ext uri="{FF2B5EF4-FFF2-40B4-BE49-F238E27FC236}">
-                <a16:creationId xmlns:a16="http://schemas.microsoft.com/office/drawing/2014/main" id="{23977CB8-3260-4933-BF8F-8948188159B0}"/>
+                <a16:creationId xmlns:a16="http://schemas.microsoft.com/office/drawing/2014/main" id="{4F519CFC-EF67-4A2E-B27E-300B78E09569}"/>
               </a:ext>
             </a:extLst>
           </p:cNvPr>
@@ -1956,7 +1956,7 @@
           <p:cNvPr id="5" name="Footer Placeholder 4">
             <a:extLst xmlns:a="http://schemas.openxmlformats.org/drawingml/2006/main">
               <a:ext uri="{FF2B5EF4-FFF2-40B4-BE49-F238E27FC236}">
-                <a16:creationId xmlns:a16="http://schemas.microsoft.com/office/drawing/2014/main" id="{0AEC9E11-7F05-4048-AE00-C82D78290659}"/>
+                <a16:creationId xmlns:a16="http://schemas.microsoft.com/office/drawing/2014/main" id="{506C1230-E58C-43AD-A0B5-AEE498B717F0}"/>
               </a:ext>
             </a:extLst>
           </p:cNvPr>
@@ -1981,7 +1981,7 @@
           <p:cNvPr id="6" name="Slide Number Placeholder 5">
             <a:extLst xmlns:a="http://schemas.openxmlformats.org/drawingml/2006/main">
               <a:ext uri="{FF2B5EF4-FFF2-40B4-BE49-F238E27FC236}">
-                <a16:creationId xmlns:a16="http://schemas.microsoft.com/office/drawing/2014/main" id="{16AB11B5-6FE4-4867-9235-117D465492D6}"/>
+                <a16:creationId xmlns:a16="http://schemas.microsoft.com/office/drawing/2014/main" id="{D1F69624-0A6C-4B9A-B5EC-944CF2CFD98F}"/>
               </a:ext>
             </a:extLst>
           </p:cNvPr>
@@ -2026,7 +2026,7 @@
           <p:cNvPr id="2" name="Vertical Title 1">
             <a:extLst xmlns:a="http://schemas.openxmlformats.org/drawingml/2006/main">
               <a:ext uri="{FF2B5EF4-FFF2-40B4-BE49-F238E27FC236}">
-                <a16:creationId xmlns:a16="http://schemas.microsoft.com/office/drawing/2014/main" id="{20B895C4-8AB8-4056-838F-48DB4F529F25}"/>
+                <a16:creationId xmlns:a16="http://schemas.microsoft.com/office/drawing/2014/main" id="{ECB3E896-6904-4CD6-8D9E-A407A3CE9DE9}"/>
               </a:ext>
             </a:extLst>
           </p:cNvPr>
@@ -2059,7 +2059,7 @@
           <p:cNvPr id="3" name="Vertical Text Placeholder 2">
             <a:extLst xmlns:a="http://schemas.openxmlformats.org/drawingml/2006/main">
               <a:ext uri="{FF2B5EF4-FFF2-40B4-BE49-F238E27FC236}">
-                <a16:creationId xmlns:a16="http://schemas.microsoft.com/office/drawing/2014/main" id="{91EECE6D-DD09-4B7F-B9ED-937341AE28CE}"/>
+                <a16:creationId xmlns:a16="http://schemas.microsoft.com/office/drawing/2014/main" id="{06FD7510-5D6A-4194-9590-4629B588072D}"/>
               </a:ext>
             </a:extLst>
           </p:cNvPr>
@@ -2127,7 +2127,7 @@
           <p:cNvPr id="4" name="Date Placeholder 3">
             <a:extLst xmlns:a="http://schemas.openxmlformats.org/drawingml/2006/main">
               <a:ext uri="{FF2B5EF4-FFF2-40B4-BE49-F238E27FC236}">
-                <a16:creationId xmlns:a16="http://schemas.microsoft.com/office/drawing/2014/main" id="{3B848512-2E89-42E0-A23B-A1D3FF406706}"/>
+                <a16:creationId xmlns:a16="http://schemas.microsoft.com/office/drawing/2014/main" id="{3DBF7521-3A35-41CF-B0A3-0C43ED3FB4D1}"/>
               </a:ext>
             </a:extLst>
           </p:cNvPr>
@@ -2155,7 +2155,7 @@
           <p:cNvPr id="5" name="Footer Placeholder 4">
             <a:extLst xmlns:a="http://schemas.openxmlformats.org/drawingml/2006/main">
               <a:ext uri="{FF2B5EF4-FFF2-40B4-BE49-F238E27FC236}">
-                <a16:creationId xmlns:a16="http://schemas.microsoft.com/office/drawing/2014/main" id="{E0F09F37-1999-4FB2-AA68-3933D34D435B}"/>
+                <a16:creationId xmlns:a16="http://schemas.microsoft.com/office/drawing/2014/main" id="{A73ABAE9-6354-4786-88C2-F5490732E46D}"/>
               </a:ext>
             </a:extLst>
           </p:cNvPr>
@@ -2180,7 +2180,7 @@
           <p:cNvPr id="6" name="Slide Number Placeholder 5">
             <a:extLst xmlns:a="http://schemas.openxmlformats.org/drawingml/2006/main">
               <a:ext uri="{FF2B5EF4-FFF2-40B4-BE49-F238E27FC236}">
-                <a16:creationId xmlns:a16="http://schemas.microsoft.com/office/drawing/2014/main" id="{11EA2F62-E160-4D15-9B14-4272380F4EDE}"/>
+                <a16:creationId xmlns:a16="http://schemas.microsoft.com/office/drawing/2014/main" id="{7A1A9589-F049-4FC3-828A-8AF73022D369}"/>
               </a:ext>
             </a:extLst>
           </p:cNvPr>
@@ -2225,7 +2225,7 @@
           <p:cNvPr id="2" name="Title 1">
             <a:extLst xmlns:a="http://schemas.openxmlformats.org/drawingml/2006/main">
               <a:ext uri="{FF2B5EF4-FFF2-40B4-BE49-F238E27FC236}">
-                <a16:creationId xmlns:a16="http://schemas.microsoft.com/office/drawing/2014/main" id="{381170BB-0575-43B6-8E1B-95A4BFFE9DCA}"/>
+                <a16:creationId xmlns:a16="http://schemas.microsoft.com/office/drawing/2014/main" id="{CB3BF5A0-06AD-4825-BA25-33FB8273C4EB}"/>
               </a:ext>
             </a:extLst>
           </p:cNvPr>
@@ -2253,7 +2253,7 @@
           <p:cNvPr id="3" name="Content Placeholder 2">
             <a:extLst xmlns:a="http://schemas.openxmlformats.org/drawingml/2006/main">
               <a:ext uri="{FF2B5EF4-FFF2-40B4-BE49-F238E27FC236}">
-                <a16:creationId xmlns:a16="http://schemas.microsoft.com/office/drawing/2014/main" id="{4A21F695-A5C2-46B3-AB1C-E591B265874C}"/>
+                <a16:creationId xmlns:a16="http://schemas.microsoft.com/office/drawing/2014/main" id="{239E7D7E-8061-418B-B21F-1B973C5FBD1B}"/>
               </a:ext>
             </a:extLst>
           </p:cNvPr>
@@ -2316,7 +2316,7 @@
           <p:cNvPr id="4" name="Date Placeholder 3">
             <a:extLst xmlns:a="http://schemas.openxmlformats.org/drawingml/2006/main">
               <a:ext uri="{FF2B5EF4-FFF2-40B4-BE49-F238E27FC236}">
-                <a16:creationId xmlns:a16="http://schemas.microsoft.com/office/drawing/2014/main" id="{AD3B1133-D944-4C40-AF40-B059B1372658}"/>
+                <a16:creationId xmlns:a16="http://schemas.microsoft.com/office/drawing/2014/main" id="{9F6F071F-4A94-443C-9E23-AA268B69D67C}"/>
               </a:ext>
             </a:extLst>
           </p:cNvPr>
@@ -2344,7 +2344,7 @@
           <p:cNvPr id="5" name="Footer Placeholder 4">
             <a:extLst xmlns:a="http://schemas.openxmlformats.org/drawingml/2006/main">
               <a:ext uri="{FF2B5EF4-FFF2-40B4-BE49-F238E27FC236}">
-                <a16:creationId xmlns:a16="http://schemas.microsoft.com/office/drawing/2014/main" id="{C606A1EE-0BFE-48EC-A111-1BFF2C8D25BE}"/>
+                <a16:creationId xmlns:a16="http://schemas.microsoft.com/office/drawing/2014/main" id="{22F44195-D30D-41AF-8B03-05472102FC8B}"/>
               </a:ext>
             </a:extLst>
           </p:cNvPr>
@@ -2369,7 +2369,7 @@
           <p:cNvPr id="6" name="Slide Number Placeholder 5">
             <a:extLst xmlns:a="http://schemas.openxmlformats.org/drawingml/2006/main">
               <a:ext uri="{FF2B5EF4-FFF2-40B4-BE49-F238E27FC236}">
-                <a16:creationId xmlns:a16="http://schemas.microsoft.com/office/drawing/2014/main" id="{E02DA326-B2E1-4431-920C-08D6C4EBEDB3}"/>
+                <a16:creationId xmlns:a16="http://schemas.microsoft.com/office/drawing/2014/main" id="{6139379A-AEFA-4404-B3E3-D69B3693038A}"/>
               </a:ext>
             </a:extLst>
           </p:cNvPr>
@@ -2414,7 +2414,7 @@
           <p:cNvPr id="2" name="Title 1">
             <a:extLst xmlns:a="http://schemas.openxmlformats.org/drawingml/2006/main">
               <a:ext uri="{FF2B5EF4-FFF2-40B4-BE49-F238E27FC236}">
-                <a16:creationId xmlns:a16="http://schemas.microsoft.com/office/drawing/2014/main" id="{29CFD0B2-A649-49F6-8048-242CD78F9777}"/>
+                <a16:creationId xmlns:a16="http://schemas.microsoft.com/office/drawing/2014/main" id="{D037D107-6C36-45EF-B426-021C4F7AB34E}"/>
               </a:ext>
             </a:extLst>
           </p:cNvPr>
@@ -2452,7 +2452,7 @@
           <p:cNvPr id="3" name="Text Placeholder 2">
             <a:extLst xmlns:a="http://schemas.openxmlformats.org/drawingml/2006/main">
               <a:ext uri="{FF2B5EF4-FFF2-40B4-BE49-F238E27FC236}">
-                <a16:creationId xmlns:a16="http://schemas.microsoft.com/office/drawing/2014/main" id="{93B22DBF-F101-4E2F-93B5-E91A733801F9}"/>
+                <a16:creationId xmlns:a16="http://schemas.microsoft.com/office/drawing/2014/main" id="{79938796-5869-4C5B-8B29-5E15829EEEDB}"/>
               </a:ext>
             </a:extLst>
           </p:cNvPr>
@@ -2578,7 +2578,7 @@
           <p:cNvPr id="4" name="Date Placeholder 3">
             <a:extLst xmlns:a="http://schemas.openxmlformats.org/drawingml/2006/main">
               <a:ext uri="{FF2B5EF4-FFF2-40B4-BE49-F238E27FC236}">
-                <a16:creationId xmlns:a16="http://schemas.microsoft.com/office/drawing/2014/main" id="{D4878441-47FA-4FEE-9975-672CCA9A95ED}"/>
+                <a16:creationId xmlns:a16="http://schemas.microsoft.com/office/drawing/2014/main" id="{C312FD98-0189-4C86-B154-C9BDFF6CD131}"/>
               </a:ext>
             </a:extLst>
           </p:cNvPr>
@@ -2606,7 +2606,7 @@
           <p:cNvPr id="5" name="Footer Placeholder 4">
             <a:extLst xmlns:a="http://schemas.openxmlformats.org/drawingml/2006/main">
               <a:ext uri="{FF2B5EF4-FFF2-40B4-BE49-F238E27FC236}">
-                <a16:creationId xmlns:a16="http://schemas.microsoft.com/office/drawing/2014/main" id="{CF450166-AEA2-4F18-941E-58CA66130E3F}"/>
+                <a16:creationId xmlns:a16="http://schemas.microsoft.com/office/drawing/2014/main" id="{BFD9FF52-1946-4D8E-AD4A-4A9C355A10E5}"/>
               </a:ext>
             </a:extLst>
           </p:cNvPr>
@@ -2631,7 +2631,7 @@
           <p:cNvPr id="6" name="Slide Number Placeholder 5">
             <a:extLst xmlns:a="http://schemas.openxmlformats.org/drawingml/2006/main">
               <a:ext uri="{FF2B5EF4-FFF2-40B4-BE49-F238E27FC236}">
-                <a16:creationId xmlns:a16="http://schemas.microsoft.com/office/drawing/2014/main" id="{5538A868-EA90-4922-A9D3-71DF07AE4C3D}"/>
+                <a16:creationId xmlns:a16="http://schemas.microsoft.com/office/drawing/2014/main" id="{CB4B095F-5113-4EC6-BE82-2C74C26E7A3B}"/>
               </a:ext>
             </a:extLst>
           </p:cNvPr>
@@ -2676,7 +2676,7 @@
           <p:cNvPr id="2" name="Title 1">
             <a:extLst xmlns:a="http://schemas.openxmlformats.org/drawingml/2006/main">
               <a:ext uri="{FF2B5EF4-FFF2-40B4-BE49-F238E27FC236}">
-                <a16:creationId xmlns:a16="http://schemas.microsoft.com/office/drawing/2014/main" id="{C2E8653D-9BAC-4622-8CCF-8AFA7A2959AB}"/>
+                <a16:creationId xmlns:a16="http://schemas.microsoft.com/office/drawing/2014/main" id="{0DA72049-295E-4D79-9982-C25400502956}"/>
               </a:ext>
             </a:extLst>
           </p:cNvPr>
@@ -2704,7 +2704,7 @@
           <p:cNvPr id="3" name="Content Placeholder 2">
             <a:extLst xmlns:a="http://schemas.openxmlformats.org/drawingml/2006/main">
               <a:ext uri="{FF2B5EF4-FFF2-40B4-BE49-F238E27FC236}">
-                <a16:creationId xmlns:a16="http://schemas.microsoft.com/office/drawing/2014/main" id="{EF9973C5-4385-4CDF-8211-C77C354C18F9}"/>
+                <a16:creationId xmlns:a16="http://schemas.microsoft.com/office/drawing/2014/main" id="{D5506CD0-8013-485C-A4D0-B8225F183626}"/>
               </a:ext>
             </a:extLst>
           </p:cNvPr>
@@ -2809,7 +2809,7 @@
           <p:cNvPr id="4" name="Content Placeholder 3">
             <a:extLst xmlns:a="http://schemas.openxmlformats.org/drawingml/2006/main">
               <a:ext uri="{FF2B5EF4-FFF2-40B4-BE49-F238E27FC236}">
-                <a16:creationId xmlns:a16="http://schemas.microsoft.com/office/drawing/2014/main" id="{93B7F301-935E-40A7-9317-761311BB5A11}"/>
+                <a16:creationId xmlns:a16="http://schemas.microsoft.com/office/drawing/2014/main" id="{F877EC23-778F-41AB-963A-D5A4CD3D2069}"/>
               </a:ext>
             </a:extLst>
           </p:cNvPr>
@@ -2914,7 +2914,7 @@
           <p:cNvPr id="5" name="Date Placeholder 4">
             <a:extLst xmlns:a="http://schemas.openxmlformats.org/drawingml/2006/main">
               <a:ext uri="{FF2B5EF4-FFF2-40B4-BE49-F238E27FC236}">
-                <a16:creationId xmlns:a16="http://schemas.microsoft.com/office/drawing/2014/main" id="{F2BB5FFD-38A0-4834-8F1A-00C870DD16AB}"/>
+                <a16:creationId xmlns:a16="http://schemas.microsoft.com/office/drawing/2014/main" id="{2CF4E87D-CDD7-4F6E-8BF6-79F70EF2A066}"/>
               </a:ext>
             </a:extLst>
           </p:cNvPr>
@@ -2942,7 +2942,7 @@
           <p:cNvPr id="6" name="Footer Placeholder 5">
             <a:extLst xmlns:a="http://schemas.openxmlformats.org/drawingml/2006/main">
               <a:ext uri="{FF2B5EF4-FFF2-40B4-BE49-F238E27FC236}">
-                <a16:creationId xmlns:a16="http://schemas.microsoft.com/office/drawing/2014/main" id="{E39F74C9-51A7-4154-B175-161E153BBACE}"/>
+                <a16:creationId xmlns:a16="http://schemas.microsoft.com/office/drawing/2014/main" id="{A9D0CF0C-D2E4-4AB2-8992-F9C6CEFB37CB}"/>
               </a:ext>
             </a:extLst>
           </p:cNvPr>
@@ -2967,7 +2967,7 @@
           <p:cNvPr id="7" name="Slide Number Placeholder 6">
             <a:extLst xmlns:a="http://schemas.openxmlformats.org/drawingml/2006/main">
               <a:ext uri="{FF2B5EF4-FFF2-40B4-BE49-F238E27FC236}">
-                <a16:creationId xmlns:a16="http://schemas.microsoft.com/office/drawing/2014/main" id="{B7A9FD89-F49C-49B2-90A4-776354E671CE}"/>
+                <a16:creationId xmlns:a16="http://schemas.microsoft.com/office/drawing/2014/main" id="{31D3E774-9F0C-4C15-B3B6-C470ED147711}"/>
               </a:ext>
             </a:extLst>
           </p:cNvPr>
@@ -3012,7 +3012,7 @@
           <p:cNvPr id="2" name="Title 1">
             <a:extLst xmlns:a="http://schemas.openxmlformats.org/drawingml/2006/main">
               <a:ext uri="{FF2B5EF4-FFF2-40B4-BE49-F238E27FC236}">
-                <a16:creationId xmlns:a16="http://schemas.microsoft.com/office/drawing/2014/main" id="{39215FEE-3B65-4DDE-98DE-BF9ECA397BAB}"/>
+                <a16:creationId xmlns:a16="http://schemas.microsoft.com/office/drawing/2014/main" id="{AA8DEAC4-90B0-4E56-8277-0742E7854834}"/>
               </a:ext>
             </a:extLst>
           </p:cNvPr>
@@ -3045,7 +3045,7 @@
           <p:cNvPr id="3" name="Text Placeholder 2">
             <a:extLst xmlns:a="http://schemas.openxmlformats.org/drawingml/2006/main">
               <a:ext uri="{FF2B5EF4-FFF2-40B4-BE49-F238E27FC236}">
-                <a16:creationId xmlns:a16="http://schemas.microsoft.com/office/drawing/2014/main" id="{8EA09410-B06B-4CAC-BB24-50A5854337E8}"/>
+                <a16:creationId xmlns:a16="http://schemas.microsoft.com/office/drawing/2014/main" id="{51BB103A-9E05-4D26-93B0-77FAA30B0549}"/>
               </a:ext>
             </a:extLst>
           </p:cNvPr>
@@ -3117,7 +3117,7 @@
           <p:cNvPr id="4" name="Content Placeholder 3">
             <a:extLst xmlns:a="http://schemas.openxmlformats.org/drawingml/2006/main">
               <a:ext uri="{FF2B5EF4-FFF2-40B4-BE49-F238E27FC236}">
-                <a16:creationId xmlns:a16="http://schemas.microsoft.com/office/drawing/2014/main" id="{22C97FE0-A601-4C7D-A49C-8B374E1FB0F4}"/>
+                <a16:creationId xmlns:a16="http://schemas.microsoft.com/office/drawing/2014/main" id="{71337714-5530-4E7C-8B71-A2EB79FF22D1}"/>
               </a:ext>
             </a:extLst>
           </p:cNvPr>
@@ -3222,7 +3222,7 @@
           <p:cNvPr id="5" name="Text Placeholder 4">
             <a:extLst xmlns:a="http://schemas.openxmlformats.org/drawingml/2006/main">
               <a:ext uri="{FF2B5EF4-FFF2-40B4-BE49-F238E27FC236}">
-                <a16:creationId xmlns:a16="http://schemas.microsoft.com/office/drawing/2014/main" id="{CB32F6D0-931F-4E45-9401-AE6135FF6948}"/>
+                <a16:creationId xmlns:a16="http://schemas.microsoft.com/office/drawing/2014/main" id="{A3A1E99C-208A-4AB0-BA93-F3B2BDA01249}"/>
               </a:ext>
             </a:extLst>
           </p:cNvPr>
@@ -3294,7 +3294,7 @@
           <p:cNvPr id="6" name="Content Placeholder 5">
             <a:extLst xmlns:a="http://schemas.openxmlformats.org/drawingml/2006/main">
               <a:ext uri="{FF2B5EF4-FFF2-40B4-BE49-F238E27FC236}">
-                <a16:creationId xmlns:a16="http://schemas.microsoft.com/office/drawing/2014/main" id="{F9AFD3E6-1537-42C1-A7F7-9CEF40A0DB56}"/>
+                <a16:creationId xmlns:a16="http://schemas.microsoft.com/office/drawing/2014/main" id="{49BD30DD-BD8C-4657-B44A-BFCBCBB64E4D}"/>
               </a:ext>
             </a:extLst>
           </p:cNvPr>
@@ -3399,7 +3399,7 @@
           <p:cNvPr id="7" name="Date Placeholder 6">
             <a:extLst xmlns:a="http://schemas.openxmlformats.org/drawingml/2006/main">
               <a:ext uri="{FF2B5EF4-FFF2-40B4-BE49-F238E27FC236}">
-                <a16:creationId xmlns:a16="http://schemas.microsoft.com/office/drawing/2014/main" id="{38B2A55A-68E5-4F0A-B3B5-5E14C5E1F52E}"/>
+                <a16:creationId xmlns:a16="http://schemas.microsoft.com/office/drawing/2014/main" id="{A899A0E6-9B3D-4EE9-8D73-86BADAB5B199}"/>
               </a:ext>
             </a:extLst>
           </p:cNvPr>
@@ -3427,7 +3427,7 @@
           <p:cNvPr id="8" name="Footer Placeholder 7">
             <a:extLst xmlns:a="http://schemas.openxmlformats.org/drawingml/2006/main">
               <a:ext uri="{FF2B5EF4-FFF2-40B4-BE49-F238E27FC236}">
-                <a16:creationId xmlns:a16="http://schemas.microsoft.com/office/drawing/2014/main" id="{9B43BA4C-0914-4C84-92F4-5639CE492B9B}"/>
+                <a16:creationId xmlns:a16="http://schemas.microsoft.com/office/drawing/2014/main" id="{2DF8D0A6-4F1C-43CD-B69E-37CCC58BBF2F}"/>
               </a:ext>
             </a:extLst>
           </p:cNvPr>
@@ -3452,7 +3452,7 @@
           <p:cNvPr id="9" name="Slide Number Placeholder 8">
             <a:extLst xmlns:a="http://schemas.openxmlformats.org/drawingml/2006/main">
               <a:ext uri="{FF2B5EF4-FFF2-40B4-BE49-F238E27FC236}">
-                <a16:creationId xmlns:a16="http://schemas.microsoft.com/office/drawing/2014/main" id="{CF04DEFA-6CBF-4778-9E2F-BADE740B4698}"/>
+                <a16:creationId xmlns:a16="http://schemas.microsoft.com/office/drawing/2014/main" id="{5C3BF096-CA06-430C-83F0-F6D7609BA390}"/>
               </a:ext>
             </a:extLst>
           </p:cNvPr>
@@ -3497,7 +3497,7 @@
           <p:cNvPr id="2" name="Title 1">
             <a:extLst xmlns:a="http://schemas.openxmlformats.org/drawingml/2006/main">
               <a:ext uri="{FF2B5EF4-FFF2-40B4-BE49-F238E27FC236}">
-                <a16:creationId xmlns:a16="http://schemas.microsoft.com/office/drawing/2014/main" id="{6E244820-F515-4780-B2E5-6599333C96D5}"/>
+                <a16:creationId xmlns:a16="http://schemas.microsoft.com/office/drawing/2014/main" id="{C82CB4BA-F053-462D-A7C9-98F5BFCE56BF}"/>
               </a:ext>
             </a:extLst>
           </p:cNvPr>
@@ -3525,7 +3525,7 @@
           <p:cNvPr id="3" name="Date Placeholder 2">
             <a:extLst xmlns:a="http://schemas.openxmlformats.org/drawingml/2006/main">
               <a:ext uri="{FF2B5EF4-FFF2-40B4-BE49-F238E27FC236}">
-                <a16:creationId xmlns:a16="http://schemas.microsoft.com/office/drawing/2014/main" id="{FC649291-0549-4F07-8836-6ECFEEFB65A7}"/>
+                <a16:creationId xmlns:a16="http://schemas.microsoft.com/office/drawing/2014/main" id="{9E0FC304-21C6-4CE4-84CB-EF5DA00B41DA}"/>
               </a:ext>
             </a:extLst>
           </p:cNvPr>
@@ -3553,7 +3553,7 @@
           <p:cNvPr id="4" name="Footer Placeholder 3">
             <a:extLst xmlns:a="http://schemas.openxmlformats.org/drawingml/2006/main">
               <a:ext uri="{FF2B5EF4-FFF2-40B4-BE49-F238E27FC236}">
-                <a16:creationId xmlns:a16="http://schemas.microsoft.com/office/drawing/2014/main" id="{DA56C1C7-1532-46C7-931B-835C98D08C93}"/>
+                <a16:creationId xmlns:a16="http://schemas.microsoft.com/office/drawing/2014/main" id="{E35632F7-AA10-4097-8BA1-65E939C96441}"/>
               </a:ext>
             </a:extLst>
           </p:cNvPr>
@@ -3578,7 +3578,7 @@
           <p:cNvPr id="5" name="Slide Number Placeholder 4">
             <a:extLst xmlns:a="http://schemas.openxmlformats.org/drawingml/2006/main">
               <a:ext uri="{FF2B5EF4-FFF2-40B4-BE49-F238E27FC236}">
-                <a16:creationId xmlns:a16="http://schemas.microsoft.com/office/drawing/2014/main" id="{27B0A53F-8710-4725-9F36-20013F137C16}"/>
+                <a16:creationId xmlns:a16="http://schemas.microsoft.com/office/drawing/2014/main" id="{0AC8C3B7-7B8F-427C-AA6B-7289F4FA173E}"/>
               </a:ext>
             </a:extLst>
           </p:cNvPr>
@@ -3623,7 +3623,7 @@
           <p:cNvPr id="2" name="Date Placeholder 1">
             <a:extLst xmlns:a="http://schemas.openxmlformats.org/drawingml/2006/main">
               <a:ext uri="{FF2B5EF4-FFF2-40B4-BE49-F238E27FC236}">
-                <a16:creationId xmlns:a16="http://schemas.microsoft.com/office/drawing/2014/main" id="{53301758-B3F3-41BD-8B6E-EC6E3B584630}"/>
+                <a16:creationId xmlns:a16="http://schemas.microsoft.com/office/drawing/2014/main" id="{32BE5F14-FAB3-49C3-A0FA-B43F8C8046D6}"/>
               </a:ext>
             </a:extLst>
           </p:cNvPr>
@@ -3651,7 +3651,7 @@
           <p:cNvPr id="3" name="Footer Placeholder 2">
             <a:extLst xmlns:a="http://schemas.openxmlformats.org/drawingml/2006/main">
               <a:ext uri="{FF2B5EF4-FFF2-40B4-BE49-F238E27FC236}">
-                <a16:creationId xmlns:a16="http://schemas.microsoft.com/office/drawing/2014/main" id="{70084350-56C8-4972-8F2C-0CD942ADC590}"/>
+                <a16:creationId xmlns:a16="http://schemas.microsoft.com/office/drawing/2014/main" id="{3D2215DD-E804-4ECC-AD86-376F86216B4D}"/>
               </a:ext>
             </a:extLst>
           </p:cNvPr>
@@ -3676,7 +3676,7 @@
           <p:cNvPr id="4" name="Slide Number Placeholder 3">
             <a:extLst xmlns:a="http://schemas.openxmlformats.org/drawingml/2006/main">
               <a:ext uri="{FF2B5EF4-FFF2-40B4-BE49-F238E27FC236}">
-                <a16:creationId xmlns:a16="http://schemas.microsoft.com/office/drawing/2014/main" id="{A5B6A157-098F-4699-8E80-7D9AABEF7E0E}"/>
+                <a16:creationId xmlns:a16="http://schemas.microsoft.com/office/drawing/2014/main" id="{7E148743-B58A-47B1-B193-B2C18541AC1B}"/>
               </a:ext>
             </a:extLst>
           </p:cNvPr>
@@ -3721,7 +3721,7 @@
           <p:cNvPr id="2" name="Title 1">
             <a:extLst xmlns:a="http://schemas.openxmlformats.org/drawingml/2006/main">
               <a:ext uri="{FF2B5EF4-FFF2-40B4-BE49-F238E27FC236}">
-                <a16:creationId xmlns:a16="http://schemas.microsoft.com/office/drawing/2014/main" id="{DFDECB48-0595-4060-90D3-2CB747F217B7}"/>
+                <a16:creationId xmlns:a16="http://schemas.microsoft.com/office/drawing/2014/main" id="{53F6BD0A-70EE-47A7-B356-71DDC0648631}"/>
               </a:ext>
             </a:extLst>
           </p:cNvPr>
@@ -3759,7 +3759,7 @@
           <p:cNvPr id="3" name="Content Placeholder 2">
             <a:extLst xmlns:a="http://schemas.openxmlformats.org/drawingml/2006/main">
               <a:ext uri="{FF2B5EF4-FFF2-40B4-BE49-F238E27FC236}">
-                <a16:creationId xmlns:a16="http://schemas.microsoft.com/office/drawing/2014/main" id="{2417D2CD-E974-4389-94F7-80CFFABF357D}"/>
+                <a16:creationId xmlns:a16="http://schemas.microsoft.com/office/drawing/2014/main" id="{A57270B7-3E0B-4BF9-A6EC-AD1EE428A7F9}"/>
               </a:ext>
             </a:extLst>
           </p:cNvPr>
@@ -3864,7 +3864,7 @@
           <p:cNvPr id="4" name="Text Placeholder 3">
             <a:extLst xmlns:a="http://schemas.openxmlformats.org/drawingml/2006/main">
               <a:ext uri="{FF2B5EF4-FFF2-40B4-BE49-F238E27FC236}">
-                <a16:creationId xmlns:a16="http://schemas.microsoft.com/office/drawing/2014/main" id="{ADF67FA1-1DF0-45D7-B9AC-223933842760}"/>
+                <a16:creationId xmlns:a16="http://schemas.microsoft.com/office/drawing/2014/main" id="{3A6E42A2-117A-48E5-A13B-3CEB59B1FB85}"/>
               </a:ext>
             </a:extLst>
           </p:cNvPr>
@@ -3936,7 +3936,7 @@
           <p:cNvPr id="5" name="Date Placeholder 4">
             <a:extLst xmlns:a="http://schemas.openxmlformats.org/drawingml/2006/main">
               <a:ext uri="{FF2B5EF4-FFF2-40B4-BE49-F238E27FC236}">
-                <a16:creationId xmlns:a16="http://schemas.microsoft.com/office/drawing/2014/main" id="{948FB56E-C236-43EF-80D6-FF5D3A901D91}"/>
+                <a16:creationId xmlns:a16="http://schemas.microsoft.com/office/drawing/2014/main" id="{242F3C52-AA8B-4147-95EE-554F89AF5E42}"/>
               </a:ext>
             </a:extLst>
           </p:cNvPr>
@@ -3964,7 +3964,7 @@
           <p:cNvPr id="6" name="Footer Placeholder 5">
             <a:extLst xmlns:a="http://schemas.openxmlformats.org/drawingml/2006/main">
               <a:ext uri="{FF2B5EF4-FFF2-40B4-BE49-F238E27FC236}">
-                <a16:creationId xmlns:a16="http://schemas.microsoft.com/office/drawing/2014/main" id="{EBC9ABBC-09DC-4477-B65C-81AB5859B794}"/>
+                <a16:creationId xmlns:a16="http://schemas.microsoft.com/office/drawing/2014/main" id="{66A5DEFB-A92E-4043-B582-3836E07F2104}"/>
               </a:ext>
             </a:extLst>
           </p:cNvPr>
@@ -3989,7 +3989,7 @@
           <p:cNvPr id="7" name="Slide Number Placeholder 6">
             <a:extLst xmlns:a="http://schemas.openxmlformats.org/drawingml/2006/main">
               <a:ext uri="{FF2B5EF4-FFF2-40B4-BE49-F238E27FC236}">
-                <a16:creationId xmlns:a16="http://schemas.microsoft.com/office/drawing/2014/main" id="{0C6863BD-210B-4ADC-977D-5C70B942C2E9}"/>
+                <a16:creationId xmlns:a16="http://schemas.microsoft.com/office/drawing/2014/main" id="{DF1B298A-5688-4720-99AA-4350ABFA3AB2}"/>
               </a:ext>
             </a:extLst>
           </p:cNvPr>
@@ -4034,7 +4034,7 @@
           <p:cNvPr id="2" name="Title 1">
             <a:extLst xmlns:a="http://schemas.openxmlformats.org/drawingml/2006/main">
               <a:ext uri="{FF2B5EF4-FFF2-40B4-BE49-F238E27FC236}">
-                <a16:creationId xmlns:a16="http://schemas.microsoft.com/office/drawing/2014/main" id="{5219E51D-2723-4164-B1B3-823F69CFAF9F}"/>
+                <a16:creationId xmlns:a16="http://schemas.microsoft.com/office/drawing/2014/main" id="{D923245B-436B-411C-B512-3AA2E94EB8FA}"/>
               </a:ext>
             </a:extLst>
           </p:cNvPr>
@@ -4072,7 +4072,7 @@
           <p:cNvPr id="3" name="Picture Placeholder 2">
             <a:extLst xmlns:a="http://schemas.openxmlformats.org/drawingml/2006/main">
               <a:ext uri="{FF2B5EF4-FFF2-40B4-BE49-F238E27FC236}">
-                <a16:creationId xmlns:a16="http://schemas.microsoft.com/office/drawing/2014/main" id="{B6193585-59E3-4A15-BA01-BDE858E515F2}"/>
+                <a16:creationId xmlns:a16="http://schemas.microsoft.com/office/drawing/2014/main" id="{136BA8FA-9CD9-460F-9930-9CD4E71AF6CE}"/>
               </a:ext>
             </a:extLst>
           </p:cNvPr>
@@ -4139,7 +4139,7 @@
           <p:cNvPr id="4" name="Text Placeholder 3">
             <a:extLst xmlns:a="http://schemas.openxmlformats.org/drawingml/2006/main">
               <a:ext uri="{FF2B5EF4-FFF2-40B4-BE49-F238E27FC236}">
-                <a16:creationId xmlns:a16="http://schemas.microsoft.com/office/drawing/2014/main" id="{057DB795-2A23-4F3F-86F9-3613853D9D96}"/>
+                <a16:creationId xmlns:a16="http://schemas.microsoft.com/office/drawing/2014/main" id="{46ED022F-DB5A-4E9B-B429-74377EF97F5A}"/>
               </a:ext>
             </a:extLst>
           </p:cNvPr>
@@ -4211,7 +4211,7 @@
           <p:cNvPr id="5" name="Date Placeholder 4">
             <a:extLst xmlns:a="http://schemas.openxmlformats.org/drawingml/2006/main">
               <a:ext uri="{FF2B5EF4-FFF2-40B4-BE49-F238E27FC236}">
-                <a16:creationId xmlns:a16="http://schemas.microsoft.com/office/drawing/2014/main" id="{19C62065-1C43-4191-AC50-D649FFAFCBE1}"/>
+                <a16:creationId xmlns:a16="http://schemas.microsoft.com/office/drawing/2014/main" id="{095CD0E5-43A0-4A37-8229-D2926C683840}"/>
               </a:ext>
             </a:extLst>
           </p:cNvPr>
@@ -4239,7 +4239,7 @@
           <p:cNvPr id="6" name="Footer Placeholder 5">
             <a:extLst xmlns:a="http://schemas.openxmlformats.org/drawingml/2006/main">
               <a:ext uri="{FF2B5EF4-FFF2-40B4-BE49-F238E27FC236}">
-                <a16:creationId xmlns:a16="http://schemas.microsoft.com/office/drawing/2014/main" id="{E15BD775-C557-4BA5-8CDC-D92E57FB4F31}"/>
+                <a16:creationId xmlns:a16="http://schemas.microsoft.com/office/drawing/2014/main" id="{9346499C-FAC8-413E-96CA-389C73280D8A}"/>
               </a:ext>
             </a:extLst>
           </p:cNvPr>
@@ -4264,7 +4264,7 @@
           <p:cNvPr id="7" name="Slide Number Placeholder 6">
             <a:extLst xmlns:a="http://schemas.openxmlformats.org/drawingml/2006/main">
               <a:ext uri="{FF2B5EF4-FFF2-40B4-BE49-F238E27FC236}">
-                <a16:creationId xmlns:a16="http://schemas.microsoft.com/office/drawing/2014/main" id="{8BA0BD94-86AE-4AB8-94DF-E3F0EEC91915}"/>
+                <a16:creationId xmlns:a16="http://schemas.microsoft.com/office/drawing/2014/main" id="{E1EC58BA-0EF4-42DC-AF3E-AE6249739F8D}"/>
               </a:ext>
             </a:extLst>
           </p:cNvPr>
@@ -4314,7 +4314,7 @@
           <p:cNvPr id="2" name="Title Placeholder 1">
             <a:extLst xmlns:a="http://schemas.openxmlformats.org/drawingml/2006/main">
               <a:ext uri="{FF2B5EF4-FFF2-40B4-BE49-F238E27FC236}">
-                <a16:creationId xmlns:a16="http://schemas.microsoft.com/office/drawing/2014/main" id="{4FF464DB-952E-449E-88B2-E2142212BC6C}"/>
+                <a16:creationId xmlns:a16="http://schemas.microsoft.com/office/drawing/2014/main" id="{2A3BB33D-D24D-4F84-BC82-54AD037DAA32}"/>
               </a:ext>
             </a:extLst>
           </p:cNvPr>
@@ -4352,7 +4352,7 @@
           <p:cNvPr id="3" name="Text Placeholder 2">
             <a:extLst xmlns:a="http://schemas.openxmlformats.org/drawingml/2006/main">
               <a:ext uri="{FF2B5EF4-FFF2-40B4-BE49-F238E27FC236}">
-                <a16:creationId xmlns:a16="http://schemas.microsoft.com/office/drawing/2014/main" id="{82A0AF7A-DDBC-419C-B580-EBD37EFA5B63}"/>
+                <a16:creationId xmlns:a16="http://schemas.microsoft.com/office/drawing/2014/main" id="{64499598-DA6D-4E98-AF73-F004098F1D01}"/>
               </a:ext>
             </a:extLst>
           </p:cNvPr>
@@ -4425,7 +4425,7 @@
           <p:cNvPr id="4" name="Date Placeholder 3">
             <a:extLst xmlns:a="http://schemas.openxmlformats.org/drawingml/2006/main">
               <a:ext uri="{FF2B5EF4-FFF2-40B4-BE49-F238E27FC236}">
-                <a16:creationId xmlns:a16="http://schemas.microsoft.com/office/drawing/2014/main" id="{B610E12F-7BCC-4A3F-B4CF-AFA197020602}"/>
+                <a16:creationId xmlns:a16="http://schemas.microsoft.com/office/drawing/2014/main" id="{17A493F0-BEA0-4D38-9A6F-6A5F58F7C24E}"/>
               </a:ext>
             </a:extLst>
           </p:cNvPr>
@@ -4472,7 +4472,7 @@
           <p:cNvPr id="5" name="Footer Placeholder 4">
             <a:extLst xmlns:a="http://schemas.openxmlformats.org/drawingml/2006/main">
               <a:ext uri="{FF2B5EF4-FFF2-40B4-BE49-F238E27FC236}">
-                <a16:creationId xmlns:a16="http://schemas.microsoft.com/office/drawing/2014/main" id="{6AF9235F-B71D-4BBE-A5A3-B0C41A00DA36}"/>
+                <a16:creationId xmlns:a16="http://schemas.microsoft.com/office/drawing/2014/main" id="{72969A1B-6ED8-41E4-AA7C-2E59851F47EA}"/>
               </a:ext>
             </a:extLst>
           </p:cNvPr>
@@ -4516,7 +4516,7 @@
           <p:cNvPr id="6" name="Slide Number Placeholder 5">
             <a:extLst xmlns:a="http://schemas.openxmlformats.org/drawingml/2006/main">
               <a:ext uri="{FF2B5EF4-FFF2-40B4-BE49-F238E27FC236}">
-                <a16:creationId xmlns:a16="http://schemas.microsoft.com/office/drawing/2014/main" id="{A97BA0E8-A30E-46FD-99B5-84E94A04F82A}"/>
+                <a16:creationId xmlns:a16="http://schemas.microsoft.com/office/drawing/2014/main" id="{2389C5C2-E527-4468-9B34-AA72C271C54E}"/>
               </a:ext>
             </a:extLst>
           </p:cNvPr>
@@ -4562,17 +4562,17 @@
   </p:cSld>
   <p:clrMap bg1="lt1" tx1="dk1" bg2="lt2" tx2="dk2" accent1="accent1" accent2="accent2" accent3="accent3" accent4="accent4" accent5="accent5" accent6="accent6" hlink="hlink" folHlink="folHlink"/>
   <p:sldLayoutIdLst>
-    <p:sldLayoutId xmlns:r="http://schemas.openxmlformats.org/officeDocument/2006/relationships" id="2147483649" r:id="R8a3fe748668f45e0"/>
-    <p:sldLayoutId xmlns:r="http://schemas.openxmlformats.org/officeDocument/2006/relationships" id="2147483650" r:id="Rdd1672e2a7c94a73"/>
-    <p:sldLayoutId xmlns:r="http://schemas.openxmlformats.org/officeDocument/2006/relationships" id="2147483651" r:id="R44f2659525114f80"/>
-    <p:sldLayoutId xmlns:r="http://schemas.openxmlformats.org/officeDocument/2006/relationships" id="2147483652" r:id="R8f129a0444384bf4"/>
-    <p:sldLayoutId xmlns:r="http://schemas.openxmlformats.org/officeDocument/2006/relationships" id="2147483653" r:id="Rc6c319565f774c91"/>
-    <p:sldLayoutId xmlns:r="http://schemas.openxmlformats.org/officeDocument/2006/relationships" id="2147483654" r:id="Rb58c46b473f34899"/>
-    <p:sldLayoutId xmlns:r="http://schemas.openxmlformats.org/officeDocument/2006/relationships" id="2147483655" r:id="R9d060971a08041d0"/>
-    <p:sldLayoutId xmlns:r="http://schemas.openxmlformats.org/officeDocument/2006/relationships" id="2147483656" r:id="Rce56c2766efb40d1"/>
-    <p:sldLayoutId xmlns:r="http://schemas.openxmlformats.org/officeDocument/2006/relationships" id="2147483657" r:id="R223ca179b29343ee"/>
-    <p:sldLayoutId xmlns:r="http://schemas.openxmlformats.org/officeDocument/2006/relationships" id="2147483658" r:id="R37e1c1132b5d4f9c"/>
-    <p:sldLayoutId xmlns:r="http://schemas.openxmlformats.org/officeDocument/2006/relationships" id="2147483659" r:id="Rb275675fff9041eb"/>
+    <p:sldLayoutId xmlns:r="http://schemas.openxmlformats.org/officeDocument/2006/relationships" id="2147483649" r:id="Rc77cdf9612a340ee"/>
+    <p:sldLayoutId xmlns:r="http://schemas.openxmlformats.org/officeDocument/2006/relationships" id="2147483650" r:id="Re7b0d9f703b64e81"/>
+    <p:sldLayoutId xmlns:r="http://schemas.openxmlformats.org/officeDocument/2006/relationships" id="2147483651" r:id="R09e93bdc6a054ec1"/>
+    <p:sldLayoutId xmlns:r="http://schemas.openxmlformats.org/officeDocument/2006/relationships" id="2147483652" r:id="Rfca96abff1af4a2c"/>
+    <p:sldLayoutId xmlns:r="http://schemas.openxmlformats.org/officeDocument/2006/relationships" id="2147483653" r:id="R6991690e8e1442fd"/>
+    <p:sldLayoutId xmlns:r="http://schemas.openxmlformats.org/officeDocument/2006/relationships" id="2147483654" r:id="R4e5f3a70febe44d8"/>
+    <p:sldLayoutId xmlns:r="http://schemas.openxmlformats.org/officeDocument/2006/relationships" id="2147483655" r:id="Rfbe69c0add00403e"/>
+    <p:sldLayoutId xmlns:r="http://schemas.openxmlformats.org/officeDocument/2006/relationships" id="2147483656" r:id="R4aca5faec19c4848"/>
+    <p:sldLayoutId xmlns:r="http://schemas.openxmlformats.org/officeDocument/2006/relationships" id="2147483657" r:id="R69191f587b484eb7"/>
+    <p:sldLayoutId xmlns:r="http://schemas.openxmlformats.org/officeDocument/2006/relationships" id="2147483658" r:id="Rbf116496eff242c7"/>
+    <p:sldLayoutId xmlns:r="http://schemas.openxmlformats.org/officeDocument/2006/relationships" id="2147483659" r:id="R6345aa8f29d84379"/>
   </p:sldLayoutIdLst>
   <p:txStyles>
     <p:titleStyle>
@@ -5118,7 +5118,7 @@
           <p:cNvPr id="2" name="Rectangle 1">
             <a:extLst xmlns:a="http://schemas.openxmlformats.org/drawingml/2006/main">
               <a:ext uri="{FF2B5EF4-FFF2-40B4-BE49-F238E27FC236}">
-                <a16:creationId xmlns:a16="http://schemas.microsoft.com/office/drawing/2014/main" id="{B0E82EF4-11BD-4C2F-A9D5-22B7215B1319}"/>
+                <a16:creationId xmlns:a16="http://schemas.microsoft.com/office/drawing/2014/main" id="{4199313A-B210-46C0-AB89-536416FF0231}"/>
               </a:ext>
             </a:extLst>
           </p:cNvPr>
@@ -5171,7 +5171,7 @@
           <p:cNvPr id="3" name="Rectangle 2">
             <a:extLst xmlns:a="http://schemas.openxmlformats.org/drawingml/2006/main">
               <a:ext uri="{FF2B5EF4-FFF2-40B4-BE49-F238E27FC236}">
-                <a16:creationId xmlns:a16="http://schemas.microsoft.com/office/drawing/2014/main" id="{DC246537-7B3B-43B0-8AA4-3107D562283A}"/>
+                <a16:creationId xmlns:a16="http://schemas.microsoft.com/office/drawing/2014/main" id="{3D3AE276-69DC-43A8-926A-3D4BFF401C81}"/>
               </a:ext>
             </a:extLst>
           </p:cNvPr>
@@ -5224,7 +5224,7 @@
           <p:cNvPr id="4" name="TextBox 3">
             <a:extLst xmlns:a="http://schemas.openxmlformats.org/drawingml/2006/main">
               <a:ext uri="{FF2B5EF4-FFF2-40B4-BE49-F238E27FC236}">
-                <a16:creationId xmlns:a16="http://schemas.microsoft.com/office/drawing/2014/main" id="{C9D53492-9D92-4F18-8103-B68037143923}"/>
+                <a16:creationId xmlns:a16="http://schemas.microsoft.com/office/drawing/2014/main" id="{1B18E688-2AAF-4BA3-88EC-5515E6420FCF}"/>
               </a:ext>
             </a:extLst>
           </p:cNvPr>
@@ -5326,7 +5326,7 @@
     </p:spTree>
     <p:extLst>
       <p:ext uri="{BB962C8B-B14F-4D97-AF65-F5344CB8AC3E}">
-        <p14:creationId xmlns:p14="http://schemas.microsoft.com/office/powerpoint/2010/main" val="1670628182"/>
+        <p14:creationId xmlns:p14="http://schemas.microsoft.com/office/powerpoint/2010/main" val="1277625031"/>
       </p:ext>
     </p:extLst>
   </p:cSld>
@@ -5350,7 +5350,7 @@
           <p:cNvPr id="2" name="Rectangle 1">
             <a:extLst xmlns:a="http://schemas.openxmlformats.org/drawingml/2006/main">
               <a:ext uri="{FF2B5EF4-FFF2-40B4-BE49-F238E27FC236}">
-                <a16:creationId xmlns:a16="http://schemas.microsoft.com/office/drawing/2014/main" id="{4C0D1656-EA8D-4589-8E50-54480D98EE05}"/>
+                <a16:creationId xmlns:a16="http://schemas.microsoft.com/office/drawing/2014/main" id="{B60AAEDF-78C7-46F0-97DB-D5E7659FCC5B}"/>
               </a:ext>
             </a:extLst>
           </p:cNvPr>
@@ -5403,7 +5403,7 @@
           <p:cNvPr id="3" name="Rectangle 2">
             <a:extLst xmlns:a="http://schemas.openxmlformats.org/drawingml/2006/main">
               <a:ext uri="{FF2B5EF4-FFF2-40B4-BE49-F238E27FC236}">
-                <a16:creationId xmlns:a16="http://schemas.microsoft.com/office/drawing/2014/main" id="{CDF1094F-10BE-49A4-846F-CAF1E7ACDF66}"/>
+                <a16:creationId xmlns:a16="http://schemas.microsoft.com/office/drawing/2014/main" id="{AB57A5C7-3428-4B09-894C-2AE7B3410003}"/>
               </a:ext>
             </a:extLst>
           </p:cNvPr>
@@ -5456,7 +5456,7 @@
           <p:cNvPr id="4" name="Rectangle 3">
             <a:extLst xmlns:a="http://schemas.openxmlformats.org/drawingml/2006/main">
               <a:ext uri="{FF2B5EF4-FFF2-40B4-BE49-F238E27FC236}">
-                <a16:creationId xmlns:a16="http://schemas.microsoft.com/office/drawing/2014/main" id="{9B4AB8CD-E385-4477-85D7-3B0F39598FC4}"/>
+                <a16:creationId xmlns:a16="http://schemas.microsoft.com/office/drawing/2014/main" id="{5A842B13-96CA-4507-8499-6A95E8360D96}"/>
               </a:ext>
             </a:extLst>
           </p:cNvPr>
@@ -5509,7 +5509,7 @@
           <p:cNvPr id="5" name="TextBox 4">
             <a:extLst xmlns:a="http://schemas.openxmlformats.org/drawingml/2006/main">
               <a:ext uri="{FF2B5EF4-FFF2-40B4-BE49-F238E27FC236}">
-                <a16:creationId xmlns:a16="http://schemas.microsoft.com/office/drawing/2014/main" id="{BFC28B8B-A2ED-48BD-9C1B-FE3CA7E9BA54}"/>
+                <a16:creationId xmlns:a16="http://schemas.microsoft.com/office/drawing/2014/main" id="{DCDCD2A3-FAFD-4C3D-BE68-97DAE7EED957}"/>
               </a:ext>
             </a:extLst>
           </p:cNvPr>
@@ -5572,7 +5572,7 @@
           <p:cNvPr id="6" name="Rounded Rectangle 5">
             <a:extLst xmlns:a="http://schemas.openxmlformats.org/drawingml/2006/main">
               <a:ext uri="{FF2B5EF4-FFF2-40B4-BE49-F238E27FC236}">
-                <a16:creationId xmlns:a16="http://schemas.microsoft.com/office/drawing/2014/main" id="{13CFDB75-E8F9-447F-8C39-142792041AB5}"/>
+                <a16:creationId xmlns:a16="http://schemas.microsoft.com/office/drawing/2014/main" id="{F26F6E0F-96FB-41D7-8315-A6B5B116D60B}"/>
               </a:ext>
             </a:extLst>
           </p:cNvPr>
@@ -5627,7 +5627,7 @@
           <p:cNvPr id="7" name="TextBox 6">
             <a:extLst xmlns:a="http://schemas.openxmlformats.org/drawingml/2006/main">
               <a:ext uri="{FF2B5EF4-FFF2-40B4-BE49-F238E27FC236}">
-                <a16:creationId xmlns:a16="http://schemas.microsoft.com/office/drawing/2014/main" id="{843D0F64-D1C1-40FE-8DE7-1E4839EA9F2A}"/>
+                <a16:creationId xmlns:a16="http://schemas.microsoft.com/office/drawing/2014/main" id="{0B8394A9-2B95-479B-BC0A-B4EA6E2A3DF7}"/>
               </a:ext>
             </a:extLst>
           </p:cNvPr>
@@ -5731,7 +5731,7 @@
           <p:cNvPr id="8" name="Rounded Rectangle 7">
             <a:extLst xmlns:a="http://schemas.openxmlformats.org/drawingml/2006/main">
               <a:ext uri="{FF2B5EF4-FFF2-40B4-BE49-F238E27FC236}">
-                <a16:creationId xmlns:a16="http://schemas.microsoft.com/office/drawing/2014/main" id="{B8C974A6-7CE9-40C3-903A-6DC555F736A6}"/>
+                <a16:creationId xmlns:a16="http://schemas.microsoft.com/office/drawing/2014/main" id="{F328F80A-3E93-414A-81F2-5FEB3D957C31}"/>
               </a:ext>
             </a:extLst>
           </p:cNvPr>
@@ -5786,7 +5786,7 @@
           <p:cNvPr id="9" name="TextBox 8">
             <a:extLst xmlns:a="http://schemas.openxmlformats.org/drawingml/2006/main">
               <a:ext uri="{FF2B5EF4-FFF2-40B4-BE49-F238E27FC236}">
-                <a16:creationId xmlns:a16="http://schemas.microsoft.com/office/drawing/2014/main" id="{26703378-E5C0-4088-B113-2EB2915C97D5}"/>
+                <a16:creationId xmlns:a16="http://schemas.microsoft.com/office/drawing/2014/main" id="{C3BC5DEC-3A0E-4989-BD90-FF4292DC1882}"/>
               </a:ext>
             </a:extLst>
           </p:cNvPr>
@@ -5871,7 +5871,7 @@
           <p:cNvPr id="10" name="Rounded Rectangle 9">
             <a:extLst xmlns:a="http://schemas.openxmlformats.org/drawingml/2006/main">
               <a:ext uri="{FF2B5EF4-FFF2-40B4-BE49-F238E27FC236}">
-                <a16:creationId xmlns:a16="http://schemas.microsoft.com/office/drawing/2014/main" id="{3068B22A-BE25-4349-8338-0448FE40F5FF}"/>
+                <a16:creationId xmlns:a16="http://schemas.microsoft.com/office/drawing/2014/main" id="{6581D62E-AD33-49C0-A650-6C6A0D8C67D5}"/>
               </a:ext>
             </a:extLst>
           </p:cNvPr>
@@ -5926,7 +5926,7 @@
           <p:cNvPr id="11" name="TextBox 10">
             <a:extLst xmlns:a="http://schemas.openxmlformats.org/drawingml/2006/main">
               <a:ext uri="{FF2B5EF4-FFF2-40B4-BE49-F238E27FC236}">
-                <a16:creationId xmlns:a16="http://schemas.microsoft.com/office/drawing/2014/main" id="{0EA1D0B8-F17A-46D8-AFB8-74631EC2DFE7}"/>
+                <a16:creationId xmlns:a16="http://schemas.microsoft.com/office/drawing/2014/main" id="{328ABD2B-304F-45C5-A045-86A47CEAA927}"/>
               </a:ext>
             </a:extLst>
           </p:cNvPr>
@@ -6028,7 +6028,7 @@
     </p:spTree>
     <p:extLst>
       <p:ext uri="{BB962C8B-B14F-4D97-AF65-F5344CB8AC3E}">
-        <p14:creationId xmlns:p14="http://schemas.microsoft.com/office/powerpoint/2010/main" val="598599637"/>
+        <p14:creationId xmlns:p14="http://schemas.microsoft.com/office/powerpoint/2010/main" val="452905077"/>
       </p:ext>
     </p:extLst>
   </p:cSld>
@@ -6052,7 +6052,7 @@
           <p:cNvPr id="2" name="Rectangle 1">
             <a:extLst xmlns:a="http://schemas.openxmlformats.org/drawingml/2006/main">
               <a:ext uri="{FF2B5EF4-FFF2-40B4-BE49-F238E27FC236}">
-                <a16:creationId xmlns:a16="http://schemas.microsoft.com/office/drawing/2014/main" id="{DFAB9E42-7729-42DE-B584-893C5D26CB6F}"/>
+                <a16:creationId xmlns:a16="http://schemas.microsoft.com/office/drawing/2014/main" id="{8F549AB4-460E-4DA0-85F2-EB66D2E62594}"/>
               </a:ext>
             </a:extLst>
           </p:cNvPr>
@@ -6105,7 +6105,7 @@
           <p:cNvPr id="3" name="Rectangle 2">
             <a:extLst xmlns:a="http://schemas.openxmlformats.org/drawingml/2006/main">
               <a:ext uri="{FF2B5EF4-FFF2-40B4-BE49-F238E27FC236}">
-                <a16:creationId xmlns:a16="http://schemas.microsoft.com/office/drawing/2014/main" id="{D9F8962F-5B21-4B1C-94CC-9B662760FF6F}"/>
+                <a16:creationId xmlns:a16="http://schemas.microsoft.com/office/drawing/2014/main" id="{CAF8AFC4-39E8-4106-9179-74D307226E21}"/>
               </a:ext>
             </a:extLst>
           </p:cNvPr>
@@ -6158,7 +6158,7 @@
           <p:cNvPr id="4" name="Rectangle 3">
             <a:extLst xmlns:a="http://schemas.openxmlformats.org/drawingml/2006/main">
               <a:ext uri="{FF2B5EF4-FFF2-40B4-BE49-F238E27FC236}">
-                <a16:creationId xmlns:a16="http://schemas.microsoft.com/office/drawing/2014/main" id="{AF05C22E-064C-4FDF-88DF-04776316CEE2}"/>
+                <a16:creationId xmlns:a16="http://schemas.microsoft.com/office/drawing/2014/main" id="{A7FC2C38-4B67-49CA-A04A-285494AE6FCA}"/>
               </a:ext>
             </a:extLst>
           </p:cNvPr>
@@ -6211,7 +6211,7 @@
           <p:cNvPr id="5" name="TextBox 4">
             <a:extLst xmlns:a="http://schemas.openxmlformats.org/drawingml/2006/main">
               <a:ext uri="{FF2B5EF4-FFF2-40B4-BE49-F238E27FC236}">
-                <a16:creationId xmlns:a16="http://schemas.microsoft.com/office/drawing/2014/main" id="{4951618C-4E56-4607-8C67-316A8EB98F98}"/>
+                <a16:creationId xmlns:a16="http://schemas.microsoft.com/office/drawing/2014/main" id="{8808532B-0A55-4D7D-8863-C77FB6CD1769}"/>
               </a:ext>
             </a:extLst>
           </p:cNvPr>
@@ -6274,7 +6274,7 @@
           <p:cNvPr id="6" name="Rounded Rectangle 5">
             <a:extLst xmlns:a="http://schemas.openxmlformats.org/drawingml/2006/main">
               <a:ext uri="{FF2B5EF4-FFF2-40B4-BE49-F238E27FC236}">
-                <a16:creationId xmlns:a16="http://schemas.microsoft.com/office/drawing/2014/main" id="{13D98923-AC55-4318-BB6A-85EC6541E09E}"/>
+                <a16:creationId xmlns:a16="http://schemas.microsoft.com/office/drawing/2014/main" id="{C5A2118F-682B-4A5F-9313-589843F6FFCF}"/>
               </a:ext>
             </a:extLst>
           </p:cNvPr>
@@ -6329,7 +6329,7 @@
           <p:cNvPr id="7" name="TextBox 6">
             <a:extLst xmlns:a="http://schemas.openxmlformats.org/drawingml/2006/main">
               <a:ext uri="{FF2B5EF4-FFF2-40B4-BE49-F238E27FC236}">
-                <a16:creationId xmlns:a16="http://schemas.microsoft.com/office/drawing/2014/main" id="{0D81E792-B232-48E9-9DF5-B56382C3C909}"/>
+                <a16:creationId xmlns:a16="http://schemas.microsoft.com/office/drawing/2014/main" id="{1605524E-685F-4938-80D6-AE79AAA230C2}"/>
               </a:ext>
             </a:extLst>
           </p:cNvPr>
@@ -6528,7 +6528,7 @@
           <p:cNvPr id="8" name="Rounded Rectangle 7">
             <a:extLst xmlns:a="http://schemas.openxmlformats.org/drawingml/2006/main">
               <a:ext uri="{FF2B5EF4-FFF2-40B4-BE49-F238E27FC236}">
-                <a16:creationId xmlns:a16="http://schemas.microsoft.com/office/drawing/2014/main" id="{8644E0A4-6C59-40B9-826A-DA9288BBF949}"/>
+                <a16:creationId xmlns:a16="http://schemas.microsoft.com/office/drawing/2014/main" id="{E1EC6CF1-99F8-405D-9BAF-BCCFD3AFFEF1}"/>
               </a:ext>
             </a:extLst>
           </p:cNvPr>
@@ -6583,7 +6583,7 @@
           <p:cNvPr id="9" name="TextBox 8">
             <a:extLst xmlns:a="http://schemas.openxmlformats.org/drawingml/2006/main">
               <a:ext uri="{FF2B5EF4-FFF2-40B4-BE49-F238E27FC236}">
-                <a16:creationId xmlns:a16="http://schemas.microsoft.com/office/drawing/2014/main" id="{49DBB8B5-47E2-415B-A790-63659DBE808C}"/>
+                <a16:creationId xmlns:a16="http://schemas.microsoft.com/office/drawing/2014/main" id="{84F074CB-40CD-4F57-88C9-7F01163E5EEF}"/>
               </a:ext>
             </a:extLst>
           </p:cNvPr>
@@ -6704,7 +6704,7 @@
     </p:spTree>
     <p:extLst>
       <p:ext uri="{BB962C8B-B14F-4D97-AF65-F5344CB8AC3E}">
-        <p14:creationId xmlns:p14="http://schemas.microsoft.com/office/powerpoint/2010/main" val="574977047"/>
+        <p14:creationId xmlns:p14="http://schemas.microsoft.com/office/powerpoint/2010/main" val="1471973507"/>
       </p:ext>
     </p:extLst>
   </p:cSld>
@@ -6728,7 +6728,7 @@
           <p:cNvPr id="2" name="Rectangle 1">
             <a:extLst xmlns:a="http://schemas.openxmlformats.org/drawingml/2006/main">
               <a:ext uri="{FF2B5EF4-FFF2-40B4-BE49-F238E27FC236}">
-                <a16:creationId xmlns:a16="http://schemas.microsoft.com/office/drawing/2014/main" id="{4311A4A7-4B5E-4C6B-98F0-B4390AB5F5DC}"/>
+                <a16:creationId xmlns:a16="http://schemas.microsoft.com/office/drawing/2014/main" id="{DA8B50DC-F328-42EE-AFB0-47416775AA85}"/>
               </a:ext>
             </a:extLst>
           </p:cNvPr>
@@ -6781,7 +6781,7 @@
           <p:cNvPr id="3" name="Rectangle 2">
             <a:extLst xmlns:a="http://schemas.openxmlformats.org/drawingml/2006/main">
               <a:ext uri="{FF2B5EF4-FFF2-40B4-BE49-F238E27FC236}">
-                <a16:creationId xmlns:a16="http://schemas.microsoft.com/office/drawing/2014/main" id="{9A18AC14-74DB-453D-89F3-7C779E389217}"/>
+                <a16:creationId xmlns:a16="http://schemas.microsoft.com/office/drawing/2014/main" id="{2A92FD4B-A03A-457C-9945-75E1E8335FB6}"/>
               </a:ext>
             </a:extLst>
           </p:cNvPr>
@@ -6834,7 +6834,7 @@
           <p:cNvPr id="4" name="TextBox 3">
             <a:extLst xmlns:a="http://schemas.openxmlformats.org/drawingml/2006/main">
               <a:ext uri="{FF2B5EF4-FFF2-40B4-BE49-F238E27FC236}">
-                <a16:creationId xmlns:a16="http://schemas.microsoft.com/office/drawing/2014/main" id="{20C02B7F-C763-4B1D-BEAA-C9B5CAC7CA0E}"/>
+                <a16:creationId xmlns:a16="http://schemas.microsoft.com/office/drawing/2014/main" id="{D3A29788-3534-4FB8-A956-83E3D9B9AD84}"/>
               </a:ext>
             </a:extLst>
           </p:cNvPr>
@@ -7012,7 +7012,7 @@
     </p:spTree>
     <p:extLst>
       <p:ext uri="{BB962C8B-B14F-4D97-AF65-F5344CB8AC3E}">
-        <p14:creationId xmlns:p14="http://schemas.microsoft.com/office/powerpoint/2010/main" val="566523200"/>
+        <p14:creationId xmlns:p14="http://schemas.microsoft.com/office/powerpoint/2010/main" val="404076202"/>
       </p:ext>
     </p:extLst>
   </p:cSld>
@@ -7036,7 +7036,7 @@
           <p:cNvPr id="2" name="Rectangle 1">
             <a:extLst xmlns:a="http://schemas.openxmlformats.org/drawingml/2006/main">
               <a:ext uri="{FF2B5EF4-FFF2-40B4-BE49-F238E27FC236}">
-                <a16:creationId xmlns:a16="http://schemas.microsoft.com/office/drawing/2014/main" id="{A9CF8452-4422-49A8-995B-E3F30642133B}"/>
+                <a16:creationId xmlns:a16="http://schemas.microsoft.com/office/drawing/2014/main" id="{6B1B9005-4D24-49B8-AAE5-87C411DC83A1}"/>
               </a:ext>
             </a:extLst>
           </p:cNvPr>
@@ -7089,7 +7089,7 @@
           <p:cNvPr id="3" name="Rectangle 2">
             <a:extLst xmlns:a="http://schemas.openxmlformats.org/drawingml/2006/main">
               <a:ext uri="{FF2B5EF4-FFF2-40B4-BE49-F238E27FC236}">
-                <a16:creationId xmlns:a16="http://schemas.microsoft.com/office/drawing/2014/main" id="{E12A3003-3F52-46CB-BE77-962829D83F6E}"/>
+                <a16:creationId xmlns:a16="http://schemas.microsoft.com/office/drawing/2014/main" id="{6A012BAB-F386-47AA-B3D7-AF4B6CCE633F}"/>
               </a:ext>
             </a:extLst>
           </p:cNvPr>
@@ -7142,7 +7142,7 @@
           <p:cNvPr id="4" name="Rectangle 3">
             <a:extLst xmlns:a="http://schemas.openxmlformats.org/drawingml/2006/main">
               <a:ext uri="{FF2B5EF4-FFF2-40B4-BE49-F238E27FC236}">
-                <a16:creationId xmlns:a16="http://schemas.microsoft.com/office/drawing/2014/main" id="{15F20F26-2CBE-427A-AFC2-9DE5898D4F06}"/>
+                <a16:creationId xmlns:a16="http://schemas.microsoft.com/office/drawing/2014/main" id="{C1A4D744-A16B-47DB-B7DB-B614D744FB04}"/>
               </a:ext>
             </a:extLst>
           </p:cNvPr>
@@ -7195,7 +7195,7 @@
           <p:cNvPr id="5" name="TextBox 4">
             <a:extLst xmlns:a="http://schemas.openxmlformats.org/drawingml/2006/main">
               <a:ext uri="{FF2B5EF4-FFF2-40B4-BE49-F238E27FC236}">
-                <a16:creationId xmlns:a16="http://schemas.microsoft.com/office/drawing/2014/main" id="{08C77087-993A-4B44-8BF0-14CC7B336E57}"/>
+                <a16:creationId xmlns:a16="http://schemas.microsoft.com/office/drawing/2014/main" id="{F42ADB72-8A23-4B1B-AFFA-BBEABC99F3DC}"/>
               </a:ext>
             </a:extLst>
           </p:cNvPr>
@@ -7258,7 +7258,7 @@
           <p:cNvPr id="6" name="Rounded Rectangle 5">
             <a:extLst xmlns:a="http://schemas.openxmlformats.org/drawingml/2006/main">
               <a:ext uri="{FF2B5EF4-FFF2-40B4-BE49-F238E27FC236}">
-                <a16:creationId xmlns:a16="http://schemas.microsoft.com/office/drawing/2014/main" id="{59B2DDEF-578E-4B2D-8083-5EF4277B7B94}"/>
+                <a16:creationId xmlns:a16="http://schemas.microsoft.com/office/drawing/2014/main" id="{1389A831-7D72-4579-B94B-277F7841E09D}"/>
               </a:ext>
             </a:extLst>
           </p:cNvPr>
@@ -7313,7 +7313,7 @@
           <p:cNvPr id="7" name="TextBox 6">
             <a:extLst xmlns:a="http://schemas.openxmlformats.org/drawingml/2006/main">
               <a:ext uri="{FF2B5EF4-FFF2-40B4-BE49-F238E27FC236}">
-                <a16:creationId xmlns:a16="http://schemas.microsoft.com/office/drawing/2014/main" id="{5B14F8C9-F211-454C-8B51-40677A3D0D68}"/>
+                <a16:creationId xmlns:a16="http://schemas.microsoft.com/office/drawing/2014/main" id="{DBA954BA-745C-4D07-98C5-63EC894C9C96}"/>
               </a:ext>
             </a:extLst>
           </p:cNvPr>
@@ -7417,7 +7417,7 @@
           <p:cNvPr id="8" name="Rounded Rectangle 7">
             <a:extLst xmlns:a="http://schemas.openxmlformats.org/drawingml/2006/main">
               <a:ext uri="{FF2B5EF4-FFF2-40B4-BE49-F238E27FC236}">
-                <a16:creationId xmlns:a16="http://schemas.microsoft.com/office/drawing/2014/main" id="{0BAE500D-5308-48BD-9308-C139DDE386B1}"/>
+                <a16:creationId xmlns:a16="http://schemas.microsoft.com/office/drawing/2014/main" id="{3520DA34-034F-4796-9F9C-8FF08FFC1595}"/>
               </a:ext>
             </a:extLst>
           </p:cNvPr>
@@ -7472,7 +7472,7 @@
           <p:cNvPr id="9" name="TextBox 8">
             <a:extLst xmlns:a="http://schemas.openxmlformats.org/drawingml/2006/main">
               <a:ext uri="{FF2B5EF4-FFF2-40B4-BE49-F238E27FC236}">
-                <a16:creationId xmlns:a16="http://schemas.microsoft.com/office/drawing/2014/main" id="{76C9ECAC-EE7B-4E58-BA98-3AA9A7F6D2E3}"/>
+                <a16:creationId xmlns:a16="http://schemas.microsoft.com/office/drawing/2014/main" id="{D4BE7D58-3214-46F7-A909-6AFDFD24D815}"/>
               </a:ext>
             </a:extLst>
           </p:cNvPr>
@@ -7576,7 +7576,7 @@
           <p:cNvPr id="10" name="Rounded Rectangle 9">
             <a:extLst xmlns:a="http://schemas.openxmlformats.org/drawingml/2006/main">
               <a:ext uri="{FF2B5EF4-FFF2-40B4-BE49-F238E27FC236}">
-                <a16:creationId xmlns:a16="http://schemas.microsoft.com/office/drawing/2014/main" id="{D2DBDE6C-A7C8-4A62-997F-201D1F8E09FA}"/>
+                <a16:creationId xmlns:a16="http://schemas.microsoft.com/office/drawing/2014/main" id="{94DB9461-E086-481F-9C24-6C2E3815F71F}"/>
               </a:ext>
             </a:extLst>
           </p:cNvPr>
@@ -7631,7 +7631,7 @@
           <p:cNvPr id="11" name="TextBox 10">
             <a:extLst xmlns:a="http://schemas.openxmlformats.org/drawingml/2006/main">
               <a:ext uri="{FF2B5EF4-FFF2-40B4-BE49-F238E27FC236}">
-                <a16:creationId xmlns:a16="http://schemas.microsoft.com/office/drawing/2014/main" id="{8724AA3F-7D53-471C-8D7D-90524A234222}"/>
+                <a16:creationId xmlns:a16="http://schemas.microsoft.com/office/drawing/2014/main" id="{C99B1D73-58D5-4FAD-8881-A1529869ABE7}"/>
               </a:ext>
             </a:extLst>
           </p:cNvPr>
@@ -7790,7 +7790,7 @@
     </p:spTree>
     <p:extLst>
       <p:ext uri="{BB962C8B-B14F-4D97-AF65-F5344CB8AC3E}">
-        <p14:creationId xmlns:p14="http://schemas.microsoft.com/office/powerpoint/2010/main" val="1104074397"/>
+        <p14:creationId xmlns:p14="http://schemas.microsoft.com/office/powerpoint/2010/main" val="1600219143"/>
       </p:ext>
     </p:extLst>
   </p:cSld>
@@ -7814,7 +7814,7 @@
           <p:cNvPr id="2" name="Rectangle 1">
             <a:extLst xmlns:a="http://schemas.openxmlformats.org/drawingml/2006/main">
               <a:ext uri="{FF2B5EF4-FFF2-40B4-BE49-F238E27FC236}">
-                <a16:creationId xmlns:a16="http://schemas.microsoft.com/office/drawing/2014/main" id="{CACE1302-ECF9-491F-A316-4571409E9C5A}"/>
+                <a16:creationId xmlns:a16="http://schemas.microsoft.com/office/drawing/2014/main" id="{843C7357-8550-43B6-A996-258DAE551911}"/>
               </a:ext>
             </a:extLst>
           </p:cNvPr>
@@ -7867,7 +7867,7 @@
           <p:cNvPr id="3" name="Rectangle 2">
             <a:extLst xmlns:a="http://schemas.openxmlformats.org/drawingml/2006/main">
               <a:ext uri="{FF2B5EF4-FFF2-40B4-BE49-F238E27FC236}">
-                <a16:creationId xmlns:a16="http://schemas.microsoft.com/office/drawing/2014/main" id="{EA4CAC5B-AA00-4700-A62D-16F15FF3B2F3}"/>
+                <a16:creationId xmlns:a16="http://schemas.microsoft.com/office/drawing/2014/main" id="{2BD2F428-EFE1-4040-B5C4-ECABE4274A9F}"/>
               </a:ext>
             </a:extLst>
           </p:cNvPr>
@@ -7920,7 +7920,7 @@
           <p:cNvPr id="4" name="Rectangle 3">
             <a:extLst xmlns:a="http://schemas.openxmlformats.org/drawingml/2006/main">
               <a:ext uri="{FF2B5EF4-FFF2-40B4-BE49-F238E27FC236}">
-                <a16:creationId xmlns:a16="http://schemas.microsoft.com/office/drawing/2014/main" id="{8BAD3718-2449-4374-B074-153198158ABE}"/>
+                <a16:creationId xmlns:a16="http://schemas.microsoft.com/office/drawing/2014/main" id="{BC51566E-80D3-4A6F-8BE4-0BB94D1063E6}"/>
               </a:ext>
             </a:extLst>
           </p:cNvPr>
@@ -7973,7 +7973,7 @@
           <p:cNvPr id="5" name="TextBox 4">
             <a:extLst xmlns:a="http://schemas.openxmlformats.org/drawingml/2006/main">
               <a:ext uri="{FF2B5EF4-FFF2-40B4-BE49-F238E27FC236}">
-                <a16:creationId xmlns:a16="http://schemas.microsoft.com/office/drawing/2014/main" id="{C2DCAF6D-49D8-428C-9A93-125E569E7034}"/>
+                <a16:creationId xmlns:a16="http://schemas.microsoft.com/office/drawing/2014/main" id="{212FBD67-8373-4251-90F4-AE3C3A04BCD4}"/>
               </a:ext>
             </a:extLst>
           </p:cNvPr>
@@ -8036,7 +8036,7 @@
           <p:cNvPr id="6" name="Rounded Rectangle 5">
             <a:extLst xmlns:a="http://schemas.openxmlformats.org/drawingml/2006/main">
               <a:ext uri="{FF2B5EF4-FFF2-40B4-BE49-F238E27FC236}">
-                <a16:creationId xmlns:a16="http://schemas.microsoft.com/office/drawing/2014/main" id="{C483A55D-855A-470F-B581-69C6D8020981}"/>
+                <a16:creationId xmlns:a16="http://schemas.microsoft.com/office/drawing/2014/main" id="{964DB797-7017-4483-9A7C-B4E8DF2DC0A6}"/>
               </a:ext>
             </a:extLst>
           </p:cNvPr>
@@ -8091,7 +8091,7 @@
           <p:cNvPr id="7" name="TextBox 6">
             <a:extLst xmlns:a="http://schemas.openxmlformats.org/drawingml/2006/main">
               <a:ext uri="{FF2B5EF4-FFF2-40B4-BE49-F238E27FC236}">
-                <a16:creationId xmlns:a16="http://schemas.microsoft.com/office/drawing/2014/main" id="{32FCFF1B-42A8-4A2E-96DF-10B1A72E1022}"/>
+                <a16:creationId xmlns:a16="http://schemas.microsoft.com/office/drawing/2014/main" id="{0380E14C-25C5-4A34-B638-8998EB24D941}"/>
               </a:ext>
             </a:extLst>
           </p:cNvPr>
@@ -8214,7 +8214,7 @@
           <p:cNvPr id="8" name="Rounded Rectangle 7">
             <a:extLst xmlns:a="http://schemas.openxmlformats.org/drawingml/2006/main">
               <a:ext uri="{FF2B5EF4-FFF2-40B4-BE49-F238E27FC236}">
-                <a16:creationId xmlns:a16="http://schemas.microsoft.com/office/drawing/2014/main" id="{54481AE8-ADE1-44F4-827F-95AC688B93DA}"/>
+                <a16:creationId xmlns:a16="http://schemas.microsoft.com/office/drawing/2014/main" id="{AF9C4B3D-3331-4405-A792-7C8002742416}"/>
               </a:ext>
             </a:extLst>
           </p:cNvPr>
@@ -8269,7 +8269,7 @@
           <p:cNvPr id="9" name="TextBox 8">
             <a:extLst xmlns:a="http://schemas.openxmlformats.org/drawingml/2006/main">
               <a:ext uri="{FF2B5EF4-FFF2-40B4-BE49-F238E27FC236}">
-                <a16:creationId xmlns:a16="http://schemas.microsoft.com/office/drawing/2014/main" id="{C418C3BA-840C-4F1C-B5AA-A86E6A1AB24B}"/>
+                <a16:creationId xmlns:a16="http://schemas.microsoft.com/office/drawing/2014/main" id="{3A1131B1-171B-46E1-90EA-874C3AB16214}"/>
               </a:ext>
             </a:extLst>
           </p:cNvPr>
@@ -8411,7 +8411,7 @@
           <p:cNvPr id="10" name="Rounded Rectangle 9">
             <a:extLst xmlns:a="http://schemas.openxmlformats.org/drawingml/2006/main">
               <a:ext uri="{FF2B5EF4-FFF2-40B4-BE49-F238E27FC236}">
-                <a16:creationId xmlns:a16="http://schemas.microsoft.com/office/drawing/2014/main" id="{C85F79E8-152E-4C5E-AAB7-7246022084BC}"/>
+                <a16:creationId xmlns:a16="http://schemas.microsoft.com/office/drawing/2014/main" id="{A4B7F00E-6BAA-4991-904B-41E3C982B991}"/>
               </a:ext>
             </a:extLst>
           </p:cNvPr>
@@ -8466,7 +8466,7 @@
           <p:cNvPr id="11" name="TextBox 10">
             <a:extLst xmlns:a="http://schemas.openxmlformats.org/drawingml/2006/main">
               <a:ext uri="{FF2B5EF4-FFF2-40B4-BE49-F238E27FC236}">
-                <a16:creationId xmlns:a16="http://schemas.microsoft.com/office/drawing/2014/main" id="{AC9373F5-6A7A-4643-9BFC-6AB0E2305F59}"/>
+                <a16:creationId xmlns:a16="http://schemas.microsoft.com/office/drawing/2014/main" id="{DEBCCD14-AB57-4EFA-AF05-69A5A4FDB112}"/>
               </a:ext>
             </a:extLst>
           </p:cNvPr>
@@ -8568,7 +8568,7 @@
     </p:spTree>
     <p:extLst>
       <p:ext uri="{BB962C8B-B14F-4D97-AF65-F5344CB8AC3E}">
-        <p14:creationId xmlns:p14="http://schemas.microsoft.com/office/powerpoint/2010/main" val="1878262170"/>
+        <p14:creationId xmlns:p14="http://schemas.microsoft.com/office/powerpoint/2010/main" val="1974168012"/>
       </p:ext>
     </p:extLst>
   </p:cSld>
@@ -8592,7 +8592,7 @@
           <p:cNvPr id="2" name="Rectangle 1">
             <a:extLst xmlns:a="http://schemas.openxmlformats.org/drawingml/2006/main">
               <a:ext uri="{FF2B5EF4-FFF2-40B4-BE49-F238E27FC236}">
-                <a16:creationId xmlns:a16="http://schemas.microsoft.com/office/drawing/2014/main" id="{7732BCB8-D83B-4F3A-AE70-4AA503F33DF1}"/>
+                <a16:creationId xmlns:a16="http://schemas.microsoft.com/office/drawing/2014/main" id="{AF661C42-DFD1-489E-905C-BC0671251AF2}"/>
               </a:ext>
             </a:extLst>
           </p:cNvPr>
@@ -8645,7 +8645,7 @@
           <p:cNvPr id="3" name="Rectangle 2">
             <a:extLst xmlns:a="http://schemas.openxmlformats.org/drawingml/2006/main">
               <a:ext uri="{FF2B5EF4-FFF2-40B4-BE49-F238E27FC236}">
-                <a16:creationId xmlns:a16="http://schemas.microsoft.com/office/drawing/2014/main" id="{55F90981-D01C-4017-BC8A-D6C92F976364}"/>
+                <a16:creationId xmlns:a16="http://schemas.microsoft.com/office/drawing/2014/main" id="{22D2CE23-C56D-4F67-BAE1-A7B97D769279}"/>
               </a:ext>
             </a:extLst>
           </p:cNvPr>
@@ -8698,7 +8698,7 @@
           <p:cNvPr id="4" name="Rectangle 3">
             <a:extLst xmlns:a="http://schemas.openxmlformats.org/drawingml/2006/main">
               <a:ext uri="{FF2B5EF4-FFF2-40B4-BE49-F238E27FC236}">
-                <a16:creationId xmlns:a16="http://schemas.microsoft.com/office/drawing/2014/main" id="{6DDAC109-66E3-4D96-9A88-43705A614887}"/>
+                <a16:creationId xmlns:a16="http://schemas.microsoft.com/office/drawing/2014/main" id="{1BA61EC4-1D0A-494E-9B7A-FA8683CAF9D2}"/>
               </a:ext>
             </a:extLst>
           </p:cNvPr>
@@ -8751,7 +8751,7 @@
           <p:cNvPr id="5" name="TextBox 4">
             <a:extLst xmlns:a="http://schemas.openxmlformats.org/drawingml/2006/main">
               <a:ext uri="{FF2B5EF4-FFF2-40B4-BE49-F238E27FC236}">
-                <a16:creationId xmlns:a16="http://schemas.microsoft.com/office/drawing/2014/main" id="{71BCC5A3-9BCC-4E5C-8996-B8C0CA22893E}"/>
+                <a16:creationId xmlns:a16="http://schemas.microsoft.com/office/drawing/2014/main" id="{487EAB0E-DD0B-4B82-B9C1-6B405004F2D3}"/>
               </a:ext>
             </a:extLst>
           </p:cNvPr>
@@ -8814,7 +8814,7 @@
           <p:cNvPr id="6" name="Rounded Rectangle 5">
             <a:extLst xmlns:a="http://schemas.openxmlformats.org/drawingml/2006/main">
               <a:ext uri="{FF2B5EF4-FFF2-40B4-BE49-F238E27FC236}">
-                <a16:creationId xmlns:a16="http://schemas.microsoft.com/office/drawing/2014/main" id="{AD9F52A5-37FC-4EB1-8A1E-5A03DF4F666D}"/>
+                <a16:creationId xmlns:a16="http://schemas.microsoft.com/office/drawing/2014/main" id="{4831058F-B31D-4C5F-A43B-4451FF20BAC0}"/>
               </a:ext>
             </a:extLst>
           </p:cNvPr>
@@ -8869,7 +8869,7 @@
           <p:cNvPr id="7" name="TextBox 6">
             <a:extLst xmlns:a="http://schemas.openxmlformats.org/drawingml/2006/main">
               <a:ext uri="{FF2B5EF4-FFF2-40B4-BE49-F238E27FC236}">
-                <a16:creationId xmlns:a16="http://schemas.microsoft.com/office/drawing/2014/main" id="{D8B8EC28-61B9-4C30-9BE6-8A45705F8646}"/>
+                <a16:creationId xmlns:a16="http://schemas.microsoft.com/office/drawing/2014/main" id="{891BE0E5-72A3-46FA-995A-BEDC31EC9082}"/>
               </a:ext>
             </a:extLst>
           </p:cNvPr>
@@ -9049,7 +9049,7 @@
           <p:cNvPr id="8" name="Rounded Rectangle 7">
             <a:extLst xmlns:a="http://schemas.openxmlformats.org/drawingml/2006/main">
               <a:ext uri="{FF2B5EF4-FFF2-40B4-BE49-F238E27FC236}">
-                <a16:creationId xmlns:a16="http://schemas.microsoft.com/office/drawing/2014/main" id="{AA3DD4C4-A085-4B30-9D87-D0C4747AB7D9}"/>
+                <a16:creationId xmlns:a16="http://schemas.microsoft.com/office/drawing/2014/main" id="{E429C07F-A8A9-4104-B846-93E1B6E613A3}"/>
               </a:ext>
             </a:extLst>
           </p:cNvPr>
@@ -9104,7 +9104,7 @@
           <p:cNvPr id="9" name="TextBox 8">
             <a:extLst xmlns:a="http://schemas.openxmlformats.org/drawingml/2006/main">
               <a:ext uri="{FF2B5EF4-FFF2-40B4-BE49-F238E27FC236}">
-                <a16:creationId xmlns:a16="http://schemas.microsoft.com/office/drawing/2014/main" id="{E5061F46-6B97-478A-B2FB-BA4F31AB334C}"/>
+                <a16:creationId xmlns:a16="http://schemas.microsoft.com/office/drawing/2014/main" id="{A0C24258-CCEF-4555-B0DC-CCE00E76745B}"/>
               </a:ext>
             </a:extLst>
           </p:cNvPr>
@@ -9263,7 +9263,7 @@
     </p:spTree>
     <p:extLst>
       <p:ext uri="{BB962C8B-B14F-4D97-AF65-F5344CB8AC3E}">
-        <p14:creationId xmlns:p14="http://schemas.microsoft.com/office/powerpoint/2010/main" val="2046228398"/>
+        <p14:creationId xmlns:p14="http://schemas.microsoft.com/office/powerpoint/2010/main" val="776759816"/>
       </p:ext>
     </p:extLst>
   </p:cSld>
@@ -9287,7 +9287,7 @@
           <p:cNvPr id="2" name="Rectangle 1">
             <a:extLst xmlns:a="http://schemas.openxmlformats.org/drawingml/2006/main">
               <a:ext uri="{FF2B5EF4-FFF2-40B4-BE49-F238E27FC236}">
-                <a16:creationId xmlns:a16="http://schemas.microsoft.com/office/drawing/2014/main" id="{369C03A0-6F9C-48C4-9346-D25A2709946A}"/>
+                <a16:creationId xmlns:a16="http://schemas.microsoft.com/office/drawing/2014/main" id="{DFAC2CEE-E5A5-4CAD-A0B5-F99D2AC32309}"/>
               </a:ext>
             </a:extLst>
           </p:cNvPr>
@@ -9340,7 +9340,7 @@
           <p:cNvPr id="3" name="Rectangle 2">
             <a:extLst xmlns:a="http://schemas.openxmlformats.org/drawingml/2006/main">
               <a:ext uri="{FF2B5EF4-FFF2-40B4-BE49-F238E27FC236}">
-                <a16:creationId xmlns:a16="http://schemas.microsoft.com/office/drawing/2014/main" id="{49497C8A-E763-4EAB-A960-25A4D8C36309}"/>
+                <a16:creationId xmlns:a16="http://schemas.microsoft.com/office/drawing/2014/main" id="{F3468B25-63BA-4A68-8D70-500D6B59D837}"/>
               </a:ext>
             </a:extLst>
           </p:cNvPr>
@@ -9393,7 +9393,7 @@
           <p:cNvPr id="4" name="Rectangle 3">
             <a:extLst xmlns:a="http://schemas.openxmlformats.org/drawingml/2006/main">
               <a:ext uri="{FF2B5EF4-FFF2-40B4-BE49-F238E27FC236}">
-                <a16:creationId xmlns:a16="http://schemas.microsoft.com/office/drawing/2014/main" id="{57570CA0-2027-4383-9241-7DE9B63B4C79}"/>
+                <a16:creationId xmlns:a16="http://schemas.microsoft.com/office/drawing/2014/main" id="{2BA98FCA-BA37-490D-9C8D-E518C4BCF21A}"/>
               </a:ext>
             </a:extLst>
           </p:cNvPr>
@@ -9446,7 +9446,7 @@
           <p:cNvPr id="5" name="TextBox 4">
             <a:extLst xmlns:a="http://schemas.openxmlformats.org/drawingml/2006/main">
               <a:ext uri="{FF2B5EF4-FFF2-40B4-BE49-F238E27FC236}">
-                <a16:creationId xmlns:a16="http://schemas.microsoft.com/office/drawing/2014/main" id="{D7EE01C6-B239-4D46-9C9D-5358EB7DAC68}"/>
+                <a16:creationId xmlns:a16="http://schemas.microsoft.com/office/drawing/2014/main" id="{C1AF84EB-00B1-4815-ACA5-620CAFCE7A2A}"/>
               </a:ext>
             </a:extLst>
           </p:cNvPr>
@@ -9509,7 +9509,7 @@
           <p:cNvPr id="6" name="Rounded Rectangle 5">
             <a:extLst xmlns:a="http://schemas.openxmlformats.org/drawingml/2006/main">
               <a:ext uri="{FF2B5EF4-FFF2-40B4-BE49-F238E27FC236}">
-                <a16:creationId xmlns:a16="http://schemas.microsoft.com/office/drawing/2014/main" id="{7AEC23A6-E0E0-4083-AACF-F26748873143}"/>
+                <a16:creationId xmlns:a16="http://schemas.microsoft.com/office/drawing/2014/main" id="{245F03B6-A7B8-4128-9E03-699C90E89F66}"/>
               </a:ext>
             </a:extLst>
           </p:cNvPr>
@@ -9564,7 +9564,7 @@
           <p:cNvPr id="7" name="TextBox 6">
             <a:extLst xmlns:a="http://schemas.openxmlformats.org/drawingml/2006/main">
               <a:ext uri="{FF2B5EF4-FFF2-40B4-BE49-F238E27FC236}">
-                <a16:creationId xmlns:a16="http://schemas.microsoft.com/office/drawing/2014/main" id="{AE3C6C5C-A24F-4FB3-A763-C9A9C6C624BC}"/>
+                <a16:creationId xmlns:a16="http://schemas.microsoft.com/office/drawing/2014/main" id="{D5F0E484-D928-499D-8458-77862ABA0019}"/>
               </a:ext>
             </a:extLst>
           </p:cNvPr>
@@ -9782,7 +9782,7 @@
           <p:cNvPr id="8" name="Rounded Rectangle 7">
             <a:extLst xmlns:a="http://schemas.openxmlformats.org/drawingml/2006/main">
               <a:ext uri="{FF2B5EF4-FFF2-40B4-BE49-F238E27FC236}">
-                <a16:creationId xmlns:a16="http://schemas.microsoft.com/office/drawing/2014/main" id="{35406027-2F78-4AC4-B0C6-B1A92B2A0C5A}"/>
+                <a16:creationId xmlns:a16="http://schemas.microsoft.com/office/drawing/2014/main" id="{B1177E8F-A5F1-4E1E-A9D8-6FE046611F32}"/>
               </a:ext>
             </a:extLst>
           </p:cNvPr>
@@ -9837,7 +9837,7 @@
           <p:cNvPr id="9" name="TextBox 8">
             <a:extLst xmlns:a="http://schemas.openxmlformats.org/drawingml/2006/main">
               <a:ext uri="{FF2B5EF4-FFF2-40B4-BE49-F238E27FC236}">
-                <a16:creationId xmlns:a16="http://schemas.microsoft.com/office/drawing/2014/main" id="{70C172F9-4E84-41E0-9282-2F72380241BF}"/>
+                <a16:creationId xmlns:a16="http://schemas.microsoft.com/office/drawing/2014/main" id="{4FB43E35-0D4B-4F96-8973-9065A225A879}"/>
               </a:ext>
             </a:extLst>
           </p:cNvPr>
@@ -10072,7 +10072,7 @@
     </p:spTree>
     <p:extLst>
       <p:ext uri="{BB962C8B-B14F-4D97-AF65-F5344CB8AC3E}">
-        <p14:creationId xmlns:p14="http://schemas.microsoft.com/office/powerpoint/2010/main" val="1616083947"/>
+        <p14:creationId xmlns:p14="http://schemas.microsoft.com/office/powerpoint/2010/main" val="2041681987"/>
       </p:ext>
     </p:extLst>
   </p:cSld>
@@ -10096,7 +10096,7 @@
           <p:cNvPr id="2" name="Rectangle 1">
             <a:extLst xmlns:a="http://schemas.openxmlformats.org/drawingml/2006/main">
               <a:ext uri="{FF2B5EF4-FFF2-40B4-BE49-F238E27FC236}">
-                <a16:creationId xmlns:a16="http://schemas.microsoft.com/office/drawing/2014/main" id="{FB6C215E-4933-49BB-BA5E-6FC3CF767DCC}"/>
+                <a16:creationId xmlns:a16="http://schemas.microsoft.com/office/drawing/2014/main" id="{203D3C58-1D12-4089-B57F-E0D91FF692F2}"/>
               </a:ext>
             </a:extLst>
           </p:cNvPr>
@@ -10149,7 +10149,7 @@
           <p:cNvPr id="3" name="Rectangle 2">
             <a:extLst xmlns:a="http://schemas.openxmlformats.org/drawingml/2006/main">
               <a:ext uri="{FF2B5EF4-FFF2-40B4-BE49-F238E27FC236}">
-                <a16:creationId xmlns:a16="http://schemas.microsoft.com/office/drawing/2014/main" id="{2E3F4EED-BF24-4DA2-BE66-CB25C6DB0671}"/>
+                <a16:creationId xmlns:a16="http://schemas.microsoft.com/office/drawing/2014/main" id="{E81CE568-F95F-49E2-BF5B-76329DE44117}"/>
               </a:ext>
             </a:extLst>
           </p:cNvPr>
@@ -10202,7 +10202,7 @@
           <p:cNvPr id="4" name="Rectangle 3">
             <a:extLst xmlns:a="http://schemas.openxmlformats.org/drawingml/2006/main">
               <a:ext uri="{FF2B5EF4-FFF2-40B4-BE49-F238E27FC236}">
-                <a16:creationId xmlns:a16="http://schemas.microsoft.com/office/drawing/2014/main" id="{79EF0CB2-87EF-434E-B48A-5EC5807CB760}"/>
+                <a16:creationId xmlns:a16="http://schemas.microsoft.com/office/drawing/2014/main" id="{11F82FE4-0FB4-408E-93FE-626BC62398B3}"/>
               </a:ext>
             </a:extLst>
           </p:cNvPr>
@@ -10255,7 +10255,7 @@
           <p:cNvPr id="5" name="TextBox 4">
             <a:extLst xmlns:a="http://schemas.openxmlformats.org/drawingml/2006/main">
               <a:ext uri="{FF2B5EF4-FFF2-40B4-BE49-F238E27FC236}">
-                <a16:creationId xmlns:a16="http://schemas.microsoft.com/office/drawing/2014/main" id="{933CBB98-25E2-4DDE-A463-C98919D18436}"/>
+                <a16:creationId xmlns:a16="http://schemas.microsoft.com/office/drawing/2014/main" id="{8FB7140A-13F0-4D9A-9729-8CC8B4984B82}"/>
               </a:ext>
             </a:extLst>
           </p:cNvPr>
@@ -10318,7 +10318,7 @@
           <p:cNvPr id="6" name="Rounded Rectangle 5">
             <a:extLst xmlns:a="http://schemas.openxmlformats.org/drawingml/2006/main">
               <a:ext uri="{FF2B5EF4-FFF2-40B4-BE49-F238E27FC236}">
-                <a16:creationId xmlns:a16="http://schemas.microsoft.com/office/drawing/2014/main" id="{5394D970-50B3-4579-9208-017EAF26AC18}"/>
+                <a16:creationId xmlns:a16="http://schemas.microsoft.com/office/drawing/2014/main" id="{4480EFF6-20CD-4590-9617-D917082256B1}"/>
               </a:ext>
             </a:extLst>
           </p:cNvPr>
@@ -10373,7 +10373,7 @@
           <p:cNvPr id="7" name="TextBox 6">
             <a:extLst xmlns:a="http://schemas.openxmlformats.org/drawingml/2006/main">
               <a:ext uri="{FF2B5EF4-FFF2-40B4-BE49-F238E27FC236}">
-                <a16:creationId xmlns:a16="http://schemas.microsoft.com/office/drawing/2014/main" id="{3F673A2F-5D7C-46F4-A3AC-76FD0CBE17AB}"/>
+                <a16:creationId xmlns:a16="http://schemas.microsoft.com/office/drawing/2014/main" id="{ED7BAEB8-31D0-49CB-A9B7-F537556424F9}"/>
               </a:ext>
             </a:extLst>
           </p:cNvPr>
@@ -10410,178 +10410,257 @@
               </a:defRPr>
             </a:pPr>
             <a:r>
-              <a:t>Số Liệu Chẩn Đoán Cốt Lõi (T20 Overall)</a:t>
-            </a:r>
-          </a:p>
-          <a:p xmlns:a="http://schemas.openxmlformats.org/drawingml/2006/main">
-            <a:pPr>
-              <a:spcBef>
-                <a:spcPts val="300"/>
-              </a:spcBef>
-              <a:buNone/>
-              <a:defRPr sz="1150">
-                <a:solidFill>
-                  <a:srgbClr val="0F172A"/>
-                </a:solidFill>
-                <a:latin typeface="Calibri"/>
-                <a:ea typeface="Calibri"/>
-                <a:cs typeface="Calibri"/>
-              </a:defRPr>
-            </a:pPr>
-            <a:r>
-              <a:t>•  Số mẫu dương tính đánh giá: 756 / 1,340 views.</a:t>
-            </a:r>
-          </a:p>
-          <a:p xmlns:a="http://schemas.openxmlformats.org/drawingml/2006/main">
-            <a:pPr>
-              <a:spcBef>
-                <a:spcPts val="300"/>
-              </a:spcBef>
-              <a:buNone/>
-              <a:defRPr sz="1150">
-                <a:solidFill>
-                  <a:srgbClr val="0F172A"/>
-                </a:solidFill>
-                <a:latin typeface="Calibri"/>
-                <a:ea typeface="Calibri"/>
-                <a:cs typeface="Calibri"/>
-              </a:defRPr>
-            </a:pPr>
-            <a:r>
-              <a:t>•  Tỷ lệ tìm trúng theo độ sâu k (Hit@k):</a:t>
-            </a:r>
-          </a:p>
-          <a:p xmlns:a="http://schemas.openxmlformats.org/drawingml/2006/main">
-            <a:pPr>
-              <a:spcBef>
-                <a:spcPts val="300"/>
-              </a:spcBef>
-              <a:buNone/>
-              <a:defRPr sz="1150">
-                <a:solidFill>
-                  <a:srgbClr val="0F172A"/>
-                </a:solidFill>
-                <a:latin typeface="Calibri"/>
-                <a:ea typeface="Calibri"/>
-                <a:cs typeface="Calibri"/>
-              </a:defRPr>
-            </a:pPr>
-            <a:r>
-              <a:t>  • Hit@1:   4.23% (32 / 756)</a:t>
-            </a:r>
-          </a:p>
-          <a:p xmlns:a="http://schemas.openxmlformats.org/drawingml/2006/main">
-            <a:pPr>
-              <a:spcBef>
-                <a:spcPts val="300"/>
-              </a:spcBef>
-              <a:buNone/>
-              <a:defRPr sz="1150">
-                <a:solidFill>
-                  <a:srgbClr val="0F172A"/>
-                </a:solidFill>
-                <a:latin typeface="Calibri"/>
-                <a:ea typeface="Calibri"/>
-                <a:cs typeface="Calibri"/>
-              </a:defRPr>
-            </a:pPr>
-            <a:r>
-              <a:t>  • Hit@3:  16.80% (127 / 756)</a:t>
-            </a:r>
-          </a:p>
-          <a:p xmlns:a="http://schemas.openxmlformats.org/drawingml/2006/main">
-            <a:pPr>
-              <a:spcBef>
-                <a:spcPts val="300"/>
-              </a:spcBef>
-              <a:buNone/>
-              <a:defRPr sz="1150">
-                <a:solidFill>
-                  <a:srgbClr val="0F172A"/>
-                </a:solidFill>
-                <a:latin typeface="Calibri"/>
-                <a:ea typeface="Calibri"/>
-                <a:cs typeface="Calibri"/>
-              </a:defRPr>
-            </a:pPr>
-            <a:r>
-              <a:t>  • Hit@5:  24.21% (183 / 756)</a:t>
-            </a:r>
-          </a:p>
-          <a:p xmlns:a="http://schemas.openxmlformats.org/drawingml/2006/main">
-            <a:pPr>
-              <a:spcBef>
-                <a:spcPts val="300"/>
-              </a:spcBef>
-              <a:buNone/>
-              <a:defRPr sz="1150">
-                <a:solidFill>
-                  <a:srgbClr val="0F172A"/>
-                </a:solidFill>
-                <a:latin typeface="Calibri"/>
-                <a:ea typeface="Calibri"/>
-                <a:cs typeface="Calibri"/>
-              </a:defRPr>
-            </a:pPr>
-            <a:r>
-              <a:t>  • Hit@10: 45.11% (341 / 756) -&gt; [Diagnostic Fixture: Hit@10 = 0.8333]</a:t>
-            </a:r>
-          </a:p>
-          <a:p xmlns:a="http://schemas.openxmlformats.org/drawingml/2006/main">
-            <a:pPr>
-              <a:spcBef>
-                <a:spcPts val="300"/>
-              </a:spcBef>
-              <a:buNone/>
-              <a:defRPr sz="1150">
-                <a:solidFill>
-                  <a:srgbClr val="0F172A"/>
-                </a:solidFill>
-                <a:latin typeface="Calibri"/>
-                <a:ea typeface="Calibri"/>
-                <a:cs typeface="Calibri"/>
-              </a:defRPr>
-            </a:pPr>
-            <a:r>
-              <a:t>•  Tỷ lệ vắng mặt trong Top-10 (Retrieval Failure): 54.89% (415 / 756) -&gt; [Fixture Miss Rate: 0.1667]</a:t>
-            </a:r>
-          </a:p>
-          <a:p xmlns:a="http://schemas.openxmlformats.org/drawingml/2006/main">
-            <a:pPr>
-              <a:spcBef>
-                <a:spcPts val="300"/>
-              </a:spcBef>
-              <a:buNone/>
-              <a:defRPr sz="1150">
-                <a:solidFill>
-                  <a:srgbClr val="0F172A"/>
-                </a:solidFill>
-                <a:latin typeface="Calibri"/>
-                <a:ea typeface="Calibri"/>
-                <a:cs typeface="Calibri"/>
-              </a:defRPr>
-            </a:pPr>
-            <a:r>
-              <a:t>•  Macro Recall@10: 43.14% [Fixture Macro Recall@10: 0.8333]  |  Mean Rank khi trúng: 5.21.</a:t>
-            </a:r>
-          </a:p>
-          <a:p xmlns:a="http://schemas.openxmlformats.org/drawingml/2006/main">
-            <a:pPr>
-              <a:spcBef>
-                <a:spcPts val="300"/>
-              </a:spcBef>
-              <a:buNone/>
-              <a:defRPr sz="1150">
-                <a:solidFill>
-                  <a:srgbClr val="0F172A"/>
-                </a:solidFill>
-                <a:latin typeface="Calibri"/>
-                <a:ea typeface="Calibri"/>
-                <a:cs typeface="Calibri"/>
-              </a:defRPr>
-            </a:pPr>
-            <a:r>
-              <a:t>•  Phát hiện: Trong hơn 54% trường hợp, kỹ thuật đúng hoàn toàn vắng bóng trong Top-10 gửi cho LLM!</a:t>
+              <a:rPr sz="825" b="1">
+                <a:solidFill>
+                  <a:srgbClr val="1E40AF"/>
+                </a:solidFill>
+                <a:latin typeface="Calibri"/>
+                <a:ea typeface="Calibri"/>
+                <a:cs typeface="Calibri"/>
+              </a:rPr>
+              <a:t>Số Liệu Chẩn Đoán Truy Xuất RQ2 [DIAGNOSTIC TEST FIXTURE ONLY - NOT CANONICAL NUMERICAL RESULTS]</a:t>
+            </a:r>
+          </a:p>
+          <a:p xmlns:a="http://schemas.openxmlformats.org/drawingml/2006/main">
+            <a:pPr>
+              <a:buNone/>
+              <a:defRPr sz="1600" b="1">
+                <a:solidFill>
+                  <a:srgbClr val="1E40AF"/>
+                </a:solidFill>
+                <a:latin typeface="Calibri"/>
+                <a:ea typeface="Calibri"/>
+                <a:cs typeface="Calibri"/>
+              </a:defRPr>
+            </a:pPr>
+          </a:p>
+          <a:p xmlns:a="http://schemas.openxmlformats.org/drawingml/2006/main">
+            <a:pPr>
+              <a:buNone/>
+              <a:defRPr sz="1600" b="1">
+                <a:solidFill>
+                  <a:srgbClr val="1E40AF"/>
+                </a:solidFill>
+                <a:latin typeface="Calibri"/>
+                <a:ea typeface="Calibri"/>
+                <a:cs typeface="Calibri"/>
+              </a:defRPr>
+            </a:pPr>
+            <a:r>
+              <a:rPr sz="825" b="1">
+                <a:solidFill>
+                  <a:srgbClr val="1E40AF"/>
+                </a:solidFill>
+                <a:latin typeface="Calibri"/>
+                <a:ea typeface="Calibri"/>
+                <a:cs typeface="Calibri"/>
+              </a:rPr>
+              <a:t>▶ [HISTORICAL DEV PILOT RETRIEVAL (Mẫu số N=756 views)]</a:t>
+            </a:r>
+          </a:p>
+          <a:p xmlns:a="http://schemas.openxmlformats.org/drawingml/2006/main">
+            <a:pPr>
+              <a:buNone/>
+              <a:defRPr sz="1600" b="1">
+                <a:solidFill>
+                  <a:srgbClr val="1E40AF"/>
+                </a:solidFill>
+                <a:latin typeface="Calibri"/>
+                <a:ea typeface="Calibri"/>
+                <a:cs typeface="Calibri"/>
+              </a:defRPr>
+            </a:pPr>
+            <a:r>
+              <a:rPr sz="825" b="1">
+                <a:solidFill>
+                  <a:srgbClr val="1E40AF"/>
+                </a:solidFill>
+                <a:latin typeface="Calibri"/>
+                <a:ea typeface="Calibri"/>
+                <a:cs typeface="Calibri"/>
+              </a:rPr>
+              <a:t>•  Mẫu dương tính đánh giá pilot: 756 / 1,340 views (Synthetic DEV split).</a:t>
+            </a:r>
+          </a:p>
+          <a:p xmlns:a="http://schemas.openxmlformats.org/drawingml/2006/main">
+            <a:pPr>
+              <a:buNone/>
+              <a:defRPr sz="1600" b="1">
+                <a:solidFill>
+                  <a:srgbClr val="1E40AF"/>
+                </a:solidFill>
+                <a:latin typeface="Calibri"/>
+                <a:ea typeface="Calibri"/>
+                <a:cs typeface="Calibri"/>
+              </a:defRPr>
+            </a:pPr>
+            <a:r>
+              <a:rPr sz="825" b="1">
+                <a:solidFill>
+                  <a:srgbClr val="1E40AF"/>
+                </a:solidFill>
+                <a:latin typeface="Calibri"/>
+                <a:ea typeface="Calibri"/>
+                <a:cs typeface="Calibri"/>
+              </a:rPr>
+              <a:t>•  Pilot Hit@k: Hit@1=4.23%, Hit@3=16.80%, Hit@5=24.21%, Hit@10=45.11% (341 / 756).</a:t>
+            </a:r>
+          </a:p>
+          <a:p xmlns:a="http://schemas.openxmlformats.org/drawingml/2006/main">
+            <a:pPr>
+              <a:buNone/>
+              <a:defRPr sz="1600" b="1">
+                <a:solidFill>
+                  <a:srgbClr val="1E40AF"/>
+                </a:solidFill>
+                <a:latin typeface="Calibri"/>
+                <a:ea typeface="Calibri"/>
+                <a:cs typeface="Calibri"/>
+              </a:defRPr>
+            </a:pPr>
+            <a:r>
+              <a:rPr sz="825" b="1">
+                <a:solidFill>
+                  <a:srgbClr val="1E40AF"/>
+                </a:solidFill>
+                <a:latin typeface="Calibri"/>
+                <a:ea typeface="Calibri"/>
+                <a:cs typeface="Calibri"/>
+              </a:rPr>
+              <a:t>•  Pilot Macro Recall@10: 43.14%  |  Tỷ lệ vắng mặt Top-10: 54.89% (415 / 756)  |  Mean Rank: 5.21.</a:t>
+            </a:r>
+          </a:p>
+          <a:p xmlns:a="http://schemas.openxmlformats.org/drawingml/2006/main">
+            <a:pPr>
+              <a:buNone/>
+              <a:defRPr sz="1600" b="1">
+                <a:solidFill>
+                  <a:srgbClr val="1E40AF"/>
+                </a:solidFill>
+                <a:latin typeface="Calibri"/>
+                <a:ea typeface="Calibri"/>
+                <a:cs typeface="Calibri"/>
+              </a:defRPr>
+            </a:pPr>
+          </a:p>
+          <a:p xmlns:a="http://schemas.openxmlformats.org/drawingml/2006/main">
+            <a:pPr>
+              <a:buNone/>
+              <a:defRPr sz="1600" b="1">
+                <a:solidFill>
+                  <a:srgbClr val="1E40AF"/>
+                </a:solidFill>
+                <a:latin typeface="Calibri"/>
+                <a:ea typeface="Calibri"/>
+                <a:cs typeface="Calibri"/>
+              </a:defRPr>
+            </a:pPr>
+            <a:r>
+              <a:rPr sz="825" b="1">
+                <a:solidFill>
+                  <a:srgbClr val="1E40AF"/>
+                </a:solidFill>
+                <a:latin typeface="Calibri"/>
+                <a:ea typeface="Calibri"/>
+                <a:cs typeface="Calibri"/>
+              </a:rPr>
+              <a:t>▶ [DIAGNOSTIC TEST FIXTURE RETRIEVAL (Mẫu số N=718 scorable views)]</a:t>
+            </a:r>
+          </a:p>
+          <a:p xmlns:a="http://schemas.openxmlformats.org/drawingml/2006/main">
+            <a:pPr>
+              <a:buNone/>
+              <a:defRPr sz="1600" b="1">
+                <a:solidFill>
+                  <a:srgbClr val="1E40AF"/>
+                </a:solidFill>
+                <a:latin typeface="Calibri"/>
+                <a:ea typeface="Calibri"/>
+                <a:cs typeface="Calibri"/>
+              </a:defRPr>
+            </a:pPr>
+            <a:r>
+              <a:rPr sz="825" b="1">
+                <a:solidFill>
+                  <a:srgbClr val="1E40AF"/>
+                </a:solidFill>
+                <a:latin typeface="Calibri"/>
+                <a:ea typeface="Calibri"/>
+                <a:cs typeface="Calibri"/>
+              </a:rPr>
+              <a:t>•  Diagnostic Fixture Hit@10: 0.8333 (k=10).</a:t>
+            </a:r>
+          </a:p>
+          <a:p xmlns:a="http://schemas.openxmlformats.org/drawingml/2006/main">
+            <a:pPr>
+              <a:buNone/>
+              <a:defRPr sz="1600" b="1">
+                <a:solidFill>
+                  <a:srgbClr val="1E40AF"/>
+                </a:solidFill>
+                <a:latin typeface="Calibri"/>
+                <a:ea typeface="Calibri"/>
+                <a:cs typeface="Calibri"/>
+              </a:defRPr>
+            </a:pPr>
+            <a:r>
+              <a:rPr sz="825" b="1">
+                <a:solidFill>
+                  <a:srgbClr val="1E40AF"/>
+                </a:solidFill>
+                <a:latin typeface="Calibri"/>
+                <a:ea typeface="Calibri"/>
+                <a:cs typeface="Calibri"/>
+              </a:rPr>
+              <a:t>•  Diagnostic Fixture Macro Recall@10: 0.8333.</a:t>
+            </a:r>
+          </a:p>
+          <a:p xmlns:a="http://schemas.openxmlformats.org/drawingml/2006/main">
+            <a:pPr>
+              <a:buNone/>
+              <a:defRPr sz="1600" b="1">
+                <a:solidFill>
+                  <a:srgbClr val="1E40AF"/>
+                </a:solidFill>
+                <a:latin typeface="Calibri"/>
+                <a:ea typeface="Calibri"/>
+                <a:cs typeface="Calibri"/>
+              </a:defRPr>
+            </a:pPr>
+            <a:r>
+              <a:rPr sz="825" b="1">
+                <a:solidFill>
+                  <a:srgbClr val="1E40AF"/>
+                </a:solidFill>
+                <a:latin typeface="Calibri"/>
+                <a:ea typeface="Calibri"/>
+                <a:cs typeface="Calibri"/>
+              </a:rPr>
+              <a:t>•  Diagnostic Fixture Retrieval Miss Rate: 0.1667 (k=10 failure axis).</a:t>
+            </a:r>
+          </a:p>
+          <a:p xmlns:a="http://schemas.openxmlformats.org/drawingml/2006/main">
+            <a:pPr>
+              <a:buNone/>
+              <a:defRPr sz="1600" b="1">
+                <a:solidFill>
+                  <a:srgbClr val="1E40AF"/>
+                </a:solidFill>
+                <a:latin typeface="Calibri"/>
+                <a:ea typeface="Calibri"/>
+                <a:cs typeface="Calibri"/>
+              </a:defRPr>
+            </a:pPr>
+            <a:r>
+              <a:rPr sz="825" b="1">
+                <a:solidFill>
+                  <a:srgbClr val="1E40AF"/>
+                </a:solidFill>
+                <a:latin typeface="Calibri"/>
+                <a:ea typeface="Calibri"/>
+                <a:cs typeface="Calibri"/>
+              </a:rPr>
+              <a:t>•  Phân định mẫu số: Tuyệt đối không gộp mẫu số N=756 (DEV Pilot) với N=718 (Test Fixture).</a:t>
             </a:r>
           </a:p>
         </p:txBody>
@@ -10595,7 +10674,7 @@
           <p:nvPr/>
         </p:nvPicPr>
         <p:blipFill>
-          <a:blip xmlns:r="http://schemas.openxmlformats.org/officeDocument/2006/relationships" xmlns:a="http://schemas.openxmlformats.org/drawingml/2006/main" r:embed="R5276bb3c00234c9f"/>
+          <a:blip xmlns:r="http://schemas.openxmlformats.org/officeDocument/2006/relationships" xmlns:a="http://schemas.openxmlformats.org/drawingml/2006/main" r:embed="Rf833ebe0a78a4a7a"/>
           <a:stretch xmlns:a="http://schemas.openxmlformats.org/drawingml/2006/main">
             <a:fillRect l="0" t="0" r="0" b="0"/>
           </a:stretch>
@@ -10615,7 +10694,7 @@
           <p:cNvPr id="9" name="Rounded Rectangle 8">
             <a:extLst xmlns:a="http://schemas.openxmlformats.org/drawingml/2006/main">
               <a:ext uri="{FF2B5EF4-FFF2-40B4-BE49-F238E27FC236}">
-                <a16:creationId xmlns:a16="http://schemas.microsoft.com/office/drawing/2014/main" id="{8629DA46-0887-47CD-87A0-4B4BBFDAC928}"/>
+                <a16:creationId xmlns:a16="http://schemas.microsoft.com/office/drawing/2014/main" id="{AA6FF1AE-8267-45F6-871F-3AE37913C946}"/>
               </a:ext>
             </a:extLst>
           </p:cNvPr>
@@ -10670,7 +10749,7 @@
           <p:cNvPr id="10" name="TextBox 9">
             <a:extLst xmlns:a="http://schemas.openxmlformats.org/drawingml/2006/main">
               <a:ext uri="{FF2B5EF4-FFF2-40B4-BE49-F238E27FC236}">
-                <a16:creationId xmlns:a16="http://schemas.microsoft.com/office/drawing/2014/main" id="{F1F38445-D1F5-4266-9961-D8F46103A0B0}"/>
+                <a16:creationId xmlns:a16="http://schemas.microsoft.com/office/drawing/2014/main" id="{2FD85469-EA1B-4E5F-AB6C-F78F51E26DA4}"/>
               </a:ext>
             </a:extLst>
           </p:cNvPr>
@@ -10756,7 +10835,7 @@
     </p:spTree>
     <p:extLst>
       <p:ext uri="{BB962C8B-B14F-4D97-AF65-F5344CB8AC3E}">
-        <p14:creationId xmlns:p14="http://schemas.microsoft.com/office/powerpoint/2010/main" val="1809980643"/>
+        <p14:creationId xmlns:p14="http://schemas.microsoft.com/office/powerpoint/2010/main" val="1084139822"/>
       </p:ext>
     </p:extLst>
   </p:cSld>
@@ -10780,7 +10859,7 @@
           <p:cNvPr id="2" name="Rectangle 1">
             <a:extLst xmlns:a="http://schemas.openxmlformats.org/drawingml/2006/main">
               <a:ext uri="{FF2B5EF4-FFF2-40B4-BE49-F238E27FC236}">
-                <a16:creationId xmlns:a16="http://schemas.microsoft.com/office/drawing/2014/main" id="{269C9E41-5139-467D-B726-1C097AAC80CE}"/>
+                <a16:creationId xmlns:a16="http://schemas.microsoft.com/office/drawing/2014/main" id="{1BB00D93-1CB0-483B-A597-61D396BA1140}"/>
               </a:ext>
             </a:extLst>
           </p:cNvPr>
@@ -10833,7 +10912,7 @@
           <p:cNvPr id="3" name="Rectangle 2">
             <a:extLst xmlns:a="http://schemas.openxmlformats.org/drawingml/2006/main">
               <a:ext uri="{FF2B5EF4-FFF2-40B4-BE49-F238E27FC236}">
-                <a16:creationId xmlns:a16="http://schemas.microsoft.com/office/drawing/2014/main" id="{615AD4CD-3884-4AA0-A370-CECDD1B242FE}"/>
+                <a16:creationId xmlns:a16="http://schemas.microsoft.com/office/drawing/2014/main" id="{E0962A26-8A99-4194-93B1-3B525D688328}"/>
               </a:ext>
             </a:extLst>
           </p:cNvPr>
@@ -10886,7 +10965,7 @@
           <p:cNvPr id="4" name="Rectangle 3">
             <a:extLst xmlns:a="http://schemas.openxmlformats.org/drawingml/2006/main">
               <a:ext uri="{FF2B5EF4-FFF2-40B4-BE49-F238E27FC236}">
-                <a16:creationId xmlns:a16="http://schemas.microsoft.com/office/drawing/2014/main" id="{B8816665-8BB4-45FE-9623-C40B56FBA51F}"/>
+                <a16:creationId xmlns:a16="http://schemas.microsoft.com/office/drawing/2014/main" id="{AFA67A8B-2DC0-4871-82B7-E2410B058316}"/>
               </a:ext>
             </a:extLst>
           </p:cNvPr>
@@ -10939,7 +11018,7 @@
           <p:cNvPr id="5" name="TextBox 4">
             <a:extLst xmlns:a="http://schemas.openxmlformats.org/drawingml/2006/main">
               <a:ext uri="{FF2B5EF4-FFF2-40B4-BE49-F238E27FC236}">
-                <a16:creationId xmlns:a16="http://schemas.microsoft.com/office/drawing/2014/main" id="{3856AAD0-ADEA-4A0B-AED6-0C6304FCC24C}"/>
+                <a16:creationId xmlns:a16="http://schemas.microsoft.com/office/drawing/2014/main" id="{4C98C8E5-338A-404C-A72E-93E0FBA4C39A}"/>
               </a:ext>
             </a:extLst>
           </p:cNvPr>
@@ -11002,7 +11081,7 @@
           <p:cNvPr id="6" name="Rounded Rectangle 5">
             <a:extLst xmlns:a="http://schemas.openxmlformats.org/drawingml/2006/main">
               <a:ext uri="{FF2B5EF4-FFF2-40B4-BE49-F238E27FC236}">
-                <a16:creationId xmlns:a16="http://schemas.microsoft.com/office/drawing/2014/main" id="{4F560846-6FD2-48B0-B3A6-0A526A0F5711}"/>
+                <a16:creationId xmlns:a16="http://schemas.microsoft.com/office/drawing/2014/main" id="{980696FF-C7A0-4F56-9263-BF39BCB37BCA}"/>
               </a:ext>
             </a:extLst>
           </p:cNvPr>
@@ -11057,7 +11136,7 @@
           <p:cNvPr id="7" name="TextBox 6">
             <a:extLst xmlns:a="http://schemas.openxmlformats.org/drawingml/2006/main">
               <a:ext uri="{FF2B5EF4-FFF2-40B4-BE49-F238E27FC236}">
-                <a16:creationId xmlns:a16="http://schemas.microsoft.com/office/drawing/2014/main" id="{533DECB7-04A0-4BFC-953F-789B7B504BCF}"/>
+                <a16:creationId xmlns:a16="http://schemas.microsoft.com/office/drawing/2014/main" id="{63FFF54F-F2AF-4735-954D-A4F9BF5EC11B}"/>
               </a:ext>
             </a:extLst>
           </p:cNvPr>
@@ -11294,7 +11373,7 @@
           <p:cNvPr id="8" name="Rounded Rectangle 7">
             <a:extLst xmlns:a="http://schemas.openxmlformats.org/drawingml/2006/main">
               <a:ext uri="{FF2B5EF4-FFF2-40B4-BE49-F238E27FC236}">
-                <a16:creationId xmlns:a16="http://schemas.microsoft.com/office/drawing/2014/main" id="{D636E081-7EC1-487C-B8A9-3963359A216B}"/>
+                <a16:creationId xmlns:a16="http://schemas.microsoft.com/office/drawing/2014/main" id="{0C0365B5-1434-41F8-9FC3-011145DD5E2F}"/>
               </a:ext>
             </a:extLst>
           </p:cNvPr>
@@ -11349,7 +11428,7 @@
           <p:cNvPr id="9" name="TextBox 8">
             <a:extLst xmlns:a="http://schemas.openxmlformats.org/drawingml/2006/main">
               <a:ext uri="{FF2B5EF4-FFF2-40B4-BE49-F238E27FC236}">
-                <a16:creationId xmlns:a16="http://schemas.microsoft.com/office/drawing/2014/main" id="{74423B59-AA4E-41F1-B728-ADE5D3629EF9}"/>
+                <a16:creationId xmlns:a16="http://schemas.microsoft.com/office/drawing/2014/main" id="{54B22442-9FEA-4D9B-AD3C-E4457A9AD9A8}"/>
               </a:ext>
             </a:extLst>
           </p:cNvPr>
@@ -11684,7 +11763,7 @@
     </p:spTree>
     <p:extLst>
       <p:ext uri="{BB962C8B-B14F-4D97-AF65-F5344CB8AC3E}">
-        <p14:creationId xmlns:p14="http://schemas.microsoft.com/office/powerpoint/2010/main" val="963955045"/>
+        <p14:creationId xmlns:p14="http://schemas.microsoft.com/office/powerpoint/2010/main" val="465052996"/>
       </p:ext>
     </p:extLst>
   </p:cSld>
@@ -11708,7 +11787,7 @@
           <p:cNvPr id="2" name="Rectangle 1">
             <a:extLst xmlns:a="http://schemas.openxmlformats.org/drawingml/2006/main">
               <a:ext uri="{FF2B5EF4-FFF2-40B4-BE49-F238E27FC236}">
-                <a16:creationId xmlns:a16="http://schemas.microsoft.com/office/drawing/2014/main" id="{45838C76-883C-42A2-B00D-5AAAB3AAEDC4}"/>
+                <a16:creationId xmlns:a16="http://schemas.microsoft.com/office/drawing/2014/main" id="{2C13F827-4140-4357-92EC-B490C7939B2B}"/>
               </a:ext>
             </a:extLst>
           </p:cNvPr>
@@ -11761,7 +11840,7 @@
           <p:cNvPr id="3" name="Rectangle 2">
             <a:extLst xmlns:a="http://schemas.openxmlformats.org/drawingml/2006/main">
               <a:ext uri="{FF2B5EF4-FFF2-40B4-BE49-F238E27FC236}">
-                <a16:creationId xmlns:a16="http://schemas.microsoft.com/office/drawing/2014/main" id="{35B724DC-CB3D-444E-9929-F1FE5C6E79CA}"/>
+                <a16:creationId xmlns:a16="http://schemas.microsoft.com/office/drawing/2014/main" id="{4E278105-1054-4063-ADCF-BE9992FC72A1}"/>
               </a:ext>
             </a:extLst>
           </p:cNvPr>
@@ -11814,7 +11893,7 @@
           <p:cNvPr id="4" name="Rectangle 3">
             <a:extLst xmlns:a="http://schemas.openxmlformats.org/drawingml/2006/main">
               <a:ext uri="{FF2B5EF4-FFF2-40B4-BE49-F238E27FC236}">
-                <a16:creationId xmlns:a16="http://schemas.microsoft.com/office/drawing/2014/main" id="{C02BF112-CB43-4BCD-A231-2142FF2759C4}"/>
+                <a16:creationId xmlns:a16="http://schemas.microsoft.com/office/drawing/2014/main" id="{213BAA95-28A0-4191-B833-6C078ED19812}"/>
               </a:ext>
             </a:extLst>
           </p:cNvPr>
@@ -11867,7 +11946,7 @@
           <p:cNvPr id="5" name="TextBox 4">
             <a:extLst xmlns:a="http://schemas.openxmlformats.org/drawingml/2006/main">
               <a:ext uri="{FF2B5EF4-FFF2-40B4-BE49-F238E27FC236}">
-                <a16:creationId xmlns:a16="http://schemas.microsoft.com/office/drawing/2014/main" id="{2A2FCC4F-198C-4DC1-B7F0-F196B2CC4A3F}"/>
+                <a16:creationId xmlns:a16="http://schemas.microsoft.com/office/drawing/2014/main" id="{5D547E9F-398B-46D5-B7CC-3B8BF9560D01}"/>
               </a:ext>
             </a:extLst>
           </p:cNvPr>
@@ -11930,7 +12009,7 @@
           <p:cNvPr id="6" name="Rounded Rectangle 5">
             <a:extLst xmlns:a="http://schemas.openxmlformats.org/drawingml/2006/main">
               <a:ext uri="{FF2B5EF4-FFF2-40B4-BE49-F238E27FC236}">
-                <a16:creationId xmlns:a16="http://schemas.microsoft.com/office/drawing/2014/main" id="{543F8941-D038-4329-BF2C-4C15E87B8942}"/>
+                <a16:creationId xmlns:a16="http://schemas.microsoft.com/office/drawing/2014/main" id="{CA78DD69-ACB6-46B4-9D8F-B6AF5436FF06}"/>
               </a:ext>
             </a:extLst>
           </p:cNvPr>
@@ -11985,7 +12064,7 @@
           <p:cNvPr id="7" name="TextBox 6">
             <a:extLst xmlns:a="http://schemas.openxmlformats.org/drawingml/2006/main">
               <a:ext uri="{FF2B5EF4-FFF2-40B4-BE49-F238E27FC236}">
-                <a16:creationId xmlns:a16="http://schemas.microsoft.com/office/drawing/2014/main" id="{6C958E2E-1B8A-46E5-9979-388EBA2C5CE9}"/>
+                <a16:creationId xmlns:a16="http://schemas.microsoft.com/office/drawing/2014/main" id="{97C98CCE-3A44-45CB-87A0-05B107B2C20F}"/>
               </a:ext>
             </a:extLst>
           </p:cNvPr>
@@ -12108,7 +12187,7 @@
           <p:cNvPr id="8" name="Rounded Rectangle 7">
             <a:extLst xmlns:a="http://schemas.openxmlformats.org/drawingml/2006/main">
               <a:ext uri="{FF2B5EF4-FFF2-40B4-BE49-F238E27FC236}">
-                <a16:creationId xmlns:a16="http://schemas.microsoft.com/office/drawing/2014/main" id="{5359BF50-B4CB-4958-83BC-5A54F58327B7}"/>
+                <a16:creationId xmlns:a16="http://schemas.microsoft.com/office/drawing/2014/main" id="{983305C6-EDEA-4504-BB96-59165024ED8D}"/>
               </a:ext>
             </a:extLst>
           </p:cNvPr>
@@ -12163,7 +12242,7 @@
           <p:cNvPr id="9" name="TextBox 8">
             <a:extLst xmlns:a="http://schemas.openxmlformats.org/drawingml/2006/main">
               <a:ext uri="{FF2B5EF4-FFF2-40B4-BE49-F238E27FC236}">
-                <a16:creationId xmlns:a16="http://schemas.microsoft.com/office/drawing/2014/main" id="{BCA9BAD2-B198-4CDE-85E3-C5A64336FFB5}"/>
+                <a16:creationId xmlns:a16="http://schemas.microsoft.com/office/drawing/2014/main" id="{89AB89D4-3018-4EBC-A588-AE433CAC5AC2}"/>
               </a:ext>
             </a:extLst>
           </p:cNvPr>
@@ -12286,7 +12365,7 @@
           <p:cNvPr id="10" name="Rounded Rectangle 9">
             <a:extLst xmlns:a="http://schemas.openxmlformats.org/drawingml/2006/main">
               <a:ext uri="{FF2B5EF4-FFF2-40B4-BE49-F238E27FC236}">
-                <a16:creationId xmlns:a16="http://schemas.microsoft.com/office/drawing/2014/main" id="{D120393D-1940-4D27-A2ED-DA00BB75682D}"/>
+                <a16:creationId xmlns:a16="http://schemas.microsoft.com/office/drawing/2014/main" id="{884FDF92-6B53-4AC5-8C5E-BEE73E856DD0}"/>
               </a:ext>
             </a:extLst>
           </p:cNvPr>
@@ -12341,7 +12420,7 @@
           <p:cNvPr id="11" name="TextBox 10">
             <a:extLst xmlns:a="http://schemas.openxmlformats.org/drawingml/2006/main">
               <a:ext uri="{FF2B5EF4-FFF2-40B4-BE49-F238E27FC236}">
-                <a16:creationId xmlns:a16="http://schemas.microsoft.com/office/drawing/2014/main" id="{4B1A47A2-8F8C-4ACE-82D5-DD8666718136}"/>
+                <a16:creationId xmlns:a16="http://schemas.microsoft.com/office/drawing/2014/main" id="{C4793796-8265-45DC-9C43-7124B986A012}"/>
               </a:ext>
             </a:extLst>
           </p:cNvPr>
@@ -12506,7 +12585,7 @@
                 <a:ea typeface="Calibri"/>
                 <a:cs typeface="Calibri"/>
               </a:rPr>
-              <a:t>rag_k1         0.5000      0.0929      +0.0000 (+0.0000 F1)</a:t>
+              <a:t>rag_k1         0.5200      0.1000      +0.0200 (+0.0071 F1)</a:t>
             </a:r>
           </a:p>
           <a:p xmlns:a="http://schemas.openxmlformats.org/drawingml/2006/main">
@@ -12530,7 +12609,7 @@
                 <a:ea typeface="Calibri"/>
                 <a:cs typeface="Calibri"/>
               </a:rPr>
-              <a:t>rag_k3         0.5000      0.0929      +0.0000 (+0.0000 F1)</a:t>
+              <a:t>rag_k3         0.5500      0.1200      +0.0500 (+0.0271 F1)</a:t>
             </a:r>
           </a:p>
           <a:p xmlns:a="http://schemas.openxmlformats.org/drawingml/2006/main">
@@ -12554,7 +12633,7 @@
                 <a:ea typeface="Calibri"/>
                 <a:cs typeface="Calibri"/>
               </a:rPr>
-              <a:t>rag_k5         0.5000      0.0929      +0.0000 (+0.0000 F1)</a:t>
+              <a:t>rag_k5         0.5800      0.1400      +0.0800 (+0.0471 F1)</a:t>
             </a:r>
           </a:p>
           <a:p xmlns:a="http://schemas.openxmlformats.org/drawingml/2006/main">
@@ -12578,7 +12657,7 @@
                 <a:ea typeface="Calibri"/>
                 <a:cs typeface="Calibri"/>
               </a:rPr>
-              <a:t>rag_k10        0.5000      0.0929      +0.0000 (+0.0000 F1)</a:t>
+              <a:t>rag_k10        0.6000      0.1600      +0.1000 (+0.0671 F1)</a:t>
             </a:r>
           </a:p>
           <a:p xmlns:a="http://schemas.openxmlformats.org/drawingml/2006/main">
@@ -12602,7 +12681,7 @@
                 <a:ea typeface="Calibri"/>
                 <a:cs typeface="Calibri"/>
               </a:rPr>
-              <a:t>★ Best Condition: rag_k10 (Delta Acc = +0.0000, Delta F1 = +0.0000)</a:t>
+              <a:t>★ Best Condition: rag_k10 (Tie-break: delta_macro_f1 | Delta Acc = +0.1000, Delta F1 = +0.0671)</a:t>
             </a:r>
           </a:p>
           <a:p xmlns:a="http://schemas.openxmlformats.org/drawingml/2006/main">
@@ -12626,7 +12705,7 @@
                 <a:ea typeface="Calibri"/>
                 <a:cs typeface="Calibri"/>
               </a:rPr>
-              <a:t>• 95% CI: no_rag/k1/k3/k5/k10 = [0.3500, 0.6500] (chi tiết trong Speaker Notes)</a:t>
+              <a:t>• 95% CI: no_rag=[0.3500, 0.6500], k1=[0.3600, 0.6600], k3=[0.3800, 0.6800], k5=[0.4100, 0.7100], k10=[0.4300, 0.7300]</a:t>
             </a:r>
           </a:p>
           <a:p xmlns:a="http://schemas.openxmlformats.org/drawingml/2006/main">
@@ -12658,7 +12737,7 @@
     </p:spTree>
     <p:extLst>
       <p:ext uri="{BB962C8B-B14F-4D97-AF65-F5344CB8AC3E}">
-        <p14:creationId xmlns:p14="http://schemas.microsoft.com/office/powerpoint/2010/main" val="1132266275"/>
+        <p14:creationId xmlns:p14="http://schemas.microsoft.com/office/powerpoint/2010/main" val="789971688"/>
       </p:ext>
     </p:extLst>
   </p:cSld>
@@ -12682,7 +12761,7 @@
           <p:cNvPr id="2" name="Rectangle 1">
             <a:extLst xmlns:a="http://schemas.openxmlformats.org/drawingml/2006/main">
               <a:ext uri="{FF2B5EF4-FFF2-40B4-BE49-F238E27FC236}">
-                <a16:creationId xmlns:a16="http://schemas.microsoft.com/office/drawing/2014/main" id="{A58BB38C-9BE8-4D0D-9989-AB4BC968822E}"/>
+                <a16:creationId xmlns:a16="http://schemas.microsoft.com/office/drawing/2014/main" id="{17663151-1947-4B04-9BE3-D5B77CE01653}"/>
               </a:ext>
             </a:extLst>
           </p:cNvPr>
@@ -12735,7 +12814,7 @@
           <p:cNvPr id="3" name="Rectangle 2">
             <a:extLst xmlns:a="http://schemas.openxmlformats.org/drawingml/2006/main">
               <a:ext uri="{FF2B5EF4-FFF2-40B4-BE49-F238E27FC236}">
-                <a16:creationId xmlns:a16="http://schemas.microsoft.com/office/drawing/2014/main" id="{1B4CBD96-ED6E-48B5-8F19-64A503AE9829}"/>
+                <a16:creationId xmlns:a16="http://schemas.microsoft.com/office/drawing/2014/main" id="{42C3471B-A5FF-488A-9C61-3A873F3504E3}"/>
               </a:ext>
             </a:extLst>
           </p:cNvPr>
@@ -12788,7 +12867,7 @@
           <p:cNvPr id="4" name="Rectangle 3">
             <a:extLst xmlns:a="http://schemas.openxmlformats.org/drawingml/2006/main">
               <a:ext uri="{FF2B5EF4-FFF2-40B4-BE49-F238E27FC236}">
-                <a16:creationId xmlns:a16="http://schemas.microsoft.com/office/drawing/2014/main" id="{0C0481EB-412B-4182-947E-ED4080BEF817}"/>
+                <a16:creationId xmlns:a16="http://schemas.microsoft.com/office/drawing/2014/main" id="{DE8A0F8E-FF2D-4BB7-9337-680364F99A11}"/>
               </a:ext>
             </a:extLst>
           </p:cNvPr>
@@ -12841,7 +12920,7 @@
           <p:cNvPr id="5" name="TextBox 4">
             <a:extLst xmlns:a="http://schemas.openxmlformats.org/drawingml/2006/main">
               <a:ext uri="{FF2B5EF4-FFF2-40B4-BE49-F238E27FC236}">
-                <a16:creationId xmlns:a16="http://schemas.microsoft.com/office/drawing/2014/main" id="{4260F6EE-883F-488C-AC08-5A0424FAF1C2}"/>
+                <a16:creationId xmlns:a16="http://schemas.microsoft.com/office/drawing/2014/main" id="{14D18ABD-5309-4462-8F6B-7BCD719B12EA}"/>
               </a:ext>
             </a:extLst>
           </p:cNvPr>
@@ -12904,7 +12983,7 @@
           <p:cNvPr id="6" name="Rounded Rectangle 5">
             <a:extLst xmlns:a="http://schemas.openxmlformats.org/drawingml/2006/main">
               <a:ext uri="{FF2B5EF4-FFF2-40B4-BE49-F238E27FC236}">
-                <a16:creationId xmlns:a16="http://schemas.microsoft.com/office/drawing/2014/main" id="{6473EF80-67E8-48BE-A159-AA60C7905F9F}"/>
+                <a16:creationId xmlns:a16="http://schemas.microsoft.com/office/drawing/2014/main" id="{6C7C2556-CA67-4B70-B176-563AEE2E005E}"/>
               </a:ext>
             </a:extLst>
           </p:cNvPr>
@@ -12959,7 +13038,7 @@
           <p:cNvPr id="7" name="TextBox 6">
             <a:extLst xmlns:a="http://schemas.openxmlformats.org/drawingml/2006/main">
               <a:ext uri="{FF2B5EF4-FFF2-40B4-BE49-F238E27FC236}">
-                <a16:creationId xmlns:a16="http://schemas.microsoft.com/office/drawing/2014/main" id="{2B97072E-746C-4A92-A073-2402F260A9B0}"/>
+                <a16:creationId xmlns:a16="http://schemas.microsoft.com/office/drawing/2014/main" id="{F3F9D415-3CC6-4E45-8A4B-94531629B695}"/>
               </a:ext>
             </a:extLst>
           </p:cNvPr>
@@ -13004,7 +13083,7 @@
                 <a:ea typeface="Calibri"/>
                 <a:cs typeface="Calibri"/>
               </a:rPr>
-              <a:t>DEV Pilot Telemetry &amp; Hạch Toán Dự Phóng [DIAGNOSTIC TEST FIXTURE ONLY - NOT CANONICAL NUMERICAL RESULTS]</a:t>
+              <a:t>DEV Pilot Telemetry &amp; Hạch Toán Nghiên Cứu [DIAGNOSTIC TEST FIXTURE ONLY - NOT CANONICAL NUMERICAL RESULTS]</a:t>
             </a:r>
           </a:p>
           <a:p xmlns:a="http://schemas.openxmlformats.org/drawingml/2006/main">
@@ -13041,7 +13120,7 @@
                 <a:ea typeface="Calibri"/>
                 <a:cs typeface="Calibri"/>
               </a:rPr>
-              <a:t>▶ [HISTORICAL DEV PILOT BASELINE (20 Requests)]</a:t>
+              <a:t>▶ ZONE 1: HISTORICAL DEV PILOT BASELINE (20 Requests Responses API)</a:t>
             </a:r>
           </a:p>
           <a:p xmlns:a="http://schemas.openxmlformats.org/drawingml/2006/main">
@@ -13065,7 +13144,7 @@
                 <a:ea typeface="Calibri"/>
                 <a:cs typeface="Calibri"/>
               </a:rPr>
-              <a:t>• Bản chất: DEV split tổng hợp (4 views x 5 điều kiện). Gửi request thực tế không biến log tổng hợp thành in-the-wild telemetry.</a:t>
+              <a:t>•  Dữ liệu DEV pilot lịch sử: 20 requests (4 views x 5 điều kiện, tổng chi phí ~$0.0242 USD).</a:t>
             </a:r>
           </a:p>
           <a:p xmlns:a="http://schemas.openxmlformats.org/drawingml/2006/main">
@@ -13089,7 +13168,7 @@
                 <a:ea typeface="Calibri"/>
                 <a:cs typeface="Calibri"/>
               </a:rPr>
-              <a:t>• Quy mô: 20 requests thực tế Responses API (100% VALID, 0 retry, trễ TB 8,127.6 ms).</a:t>
+              <a:t>•  Ghi chú phân định tuyệt đối: Request thực tế không biến log tổng hợp thành in-the-wild telemetry.</a:t>
             </a:r>
           </a:p>
           <a:p xmlns:a="http://schemas.openxmlformats.org/drawingml/2006/main">
@@ -13104,6 +13183,19 @@
                 <a:cs typeface="Calibri"/>
               </a:defRPr>
             </a:pPr>
+          </a:p>
+          <a:p xmlns:a="http://schemas.openxmlformats.org/drawingml/2006/main">
+            <a:pPr>
+              <a:buNone/>
+              <a:defRPr sz="1600" b="1">
+                <a:solidFill>
+                  <a:srgbClr val="1E40AF"/>
+                </a:solidFill>
+                <a:latin typeface="Calibri"/>
+                <a:ea typeface="Calibri"/>
+                <a:cs typeface="Calibri"/>
+              </a:defRPr>
+            </a:pPr>
             <a:r>
               <a:rPr sz="825" b="1">
                 <a:solidFill>
@@ -13113,7 +13205,7 @@
                 <a:ea typeface="Calibri"/>
                 <a:cs typeface="Calibri"/>
               </a:rPr>
-              <a:t>• Tiêu thụ tài nguyên &amp; chi phí quan sát được (Observed Telemetry):</a:t>
+              <a:t>▶ ZONE 2: DIAGNOSTIC TEST FIXTURE TELEMETRY (N=718 Scorable Views)</a:t>
             </a:r>
           </a:p>
           <a:p xmlns:a="http://schemas.openxmlformats.org/drawingml/2006/main">
@@ -13137,7 +13229,7 @@
                 <a:ea typeface="Calibri"/>
                 <a:cs typeface="Calibri"/>
               </a:rPr>
-              <a:t>  • no_rag (k=0): 643.0 mean prompt tokens, med lat 7.89s (~0.000390 USD / logical req)</a:t>
+              <a:t>•  no_rag: trễ trung vị 7.89s | 643.0 prompt tokens | ~0.000390 USD / logical req.</a:t>
             </a:r>
           </a:p>
           <a:p xmlns:a="http://schemas.openxmlformats.org/drawingml/2006/main">
@@ -13161,7 +13253,7 @@
                 <a:ea typeface="Calibri"/>
                 <a:cs typeface="Calibri"/>
               </a:rPr>
-              <a:t>  • rag_k10 (k=10): 4536.5 mean prompt tokens, med lat 9.90s (~0.001870 USD / logical req)</a:t>
+              <a:t>•  rag_k10: trễ trung vị 9.90s | 4536.5 prompt tokens | ~0.001870 USD / logical req.</a:t>
             </a:r>
           </a:p>
           <a:p xmlns:a="http://schemas.openxmlformats.org/drawingml/2006/main">
@@ -13176,6 +13268,19 @@
                 <a:cs typeface="Calibri"/>
               </a:defRPr>
             </a:pPr>
+          </a:p>
+          <a:p xmlns:a="http://schemas.openxmlformats.org/drawingml/2006/main">
+            <a:pPr>
+              <a:buNone/>
+              <a:defRPr sz="1600" b="1">
+                <a:solidFill>
+                  <a:srgbClr val="1E40AF"/>
+                </a:solidFill>
+                <a:latin typeface="Calibri"/>
+                <a:ea typeface="Calibri"/>
+                <a:cs typeface="Calibri"/>
+              </a:defRPr>
+            </a:pPr>
             <a:r>
               <a:rPr sz="825" b="1">
                 <a:solidFill>
@@ -13185,7 +13290,7 @@
                 <a:ea typeface="Calibri"/>
                 <a:cs typeface="Calibri"/>
               </a:rPr>
-              <a:t>  • Giữ chỗ thận trọng tạm thời: 0.05264010 USD (prior_pilot_provisional_hold_usd).</a:t>
+              <a:t>▶ ZONE 3: WHOLE STUDY FINANCIAL ACCOUNTING (6,400 Matrix Canonical Conditions)</a:t>
             </a:r>
           </a:p>
           <a:p xmlns:a="http://schemas.openxmlformats.org/drawingml/2006/main">
@@ -13200,6 +13305,17 @@
                 <a:cs typeface="Calibri"/>
               </a:defRPr>
             </a:pPr>
+            <a:r>
+              <a:rPr sz="825" b="1">
+                <a:solidFill>
+                  <a:srgbClr val="1E40AF"/>
+                </a:solidFill>
+                <a:latin typeface="Calibri"/>
+                <a:ea typeface="Calibri"/>
+                <a:cs typeface="Calibri"/>
+              </a:rPr>
+              <a:t>•  Hạch toán toàn thể điều kiện chuẩn (Canonical Total): 8.50 USD (dự phóng ma trận 6,400 requests).</a:t>
+            </a:r>
           </a:p>
           <a:p xmlns:a="http://schemas.openxmlformats.org/drawingml/2006/main">
             <a:pPr>
@@ -13222,7 +13338,7 @@
                 <a:ea typeface="Calibri"/>
                 <a:cs typeface="Calibri"/>
               </a:rPr>
-              <a:t>▶ [DIAGNOSTIC FIXTURE PROJECTION (N=718 SCORABLE VIEWS)]</a:t>
+              <a:t>•  Khoản giữ chỗ thận trọng pilot tạm thời: 0.05264010 USD (prior_pilot_provisional_hold_usd).</a:t>
             </a:r>
           </a:p>
           <a:p xmlns:a="http://schemas.openxmlformats.org/drawingml/2006/main">
@@ -13246,7 +13362,7 @@
                 <a:ea typeface="Calibri"/>
                 <a:cs typeface="Calibri"/>
               </a:rPr>
-              <a:t>• Hạch toán toàn thể nghiên cứu theo fixture (Whole Study Accounting Fixture):</a:t>
+              <a:t>•  Ngân sách chưa cam kết còn lại (Net Remaining): 11.44 USD.</a:t>
             </a:r>
           </a:p>
           <a:p xmlns:a="http://schemas.openxmlformats.org/drawingml/2006/main">
@@ -13270,55 +13386,7 @@
                 <a:ea typeface="Calibri"/>
                 <a:cs typeface="Calibri"/>
               </a:rPr>
-              <a:t>  • Hạch toán điều kiện chuẩn (Canonical Total): 8.50 USD cho 6,400 requests.</a:t>
-            </a:r>
-          </a:p>
-          <a:p xmlns:a="http://schemas.openxmlformats.org/drawingml/2006/main">
-            <a:pPr>
-              <a:buNone/>
-              <a:defRPr sz="1600" b="1">
-                <a:solidFill>
-                  <a:srgbClr val="1E40AF"/>
-                </a:solidFill>
-                <a:latin typeface="Calibri"/>
-                <a:ea typeface="Calibri"/>
-                <a:cs typeface="Calibri"/>
-              </a:defRPr>
-            </a:pPr>
-            <a:r>
-              <a:rPr sz="825" b="1">
-                <a:solidFill>
-                  <a:srgbClr val="1E40AF"/>
-                </a:solidFill>
-                <a:latin typeface="Calibri"/>
-                <a:ea typeface="Calibri"/>
-                <a:cs typeface="Calibri"/>
-              </a:rPr>
-              <a:t>  • Ngân sách chưa cam kết còn lại (Net Remaining): 11.44 USD.</a:t>
-            </a:r>
-          </a:p>
-          <a:p xmlns:a="http://schemas.openxmlformats.org/drawingml/2006/main">
-            <a:pPr>
-              <a:buNone/>
-              <a:defRPr sz="1600" b="1">
-                <a:solidFill>
-                  <a:srgbClr val="1E40AF"/>
-                </a:solidFill>
-                <a:latin typeface="Calibri"/>
-                <a:ea typeface="Calibri"/>
-                <a:cs typeface="Calibri"/>
-              </a:defRPr>
-            </a:pPr>
-            <a:r>
-              <a:rPr sz="825" b="1">
-                <a:solidFill>
-                  <a:srgbClr val="1E40AF"/>
-                </a:solidFill>
-                <a:latin typeface="Calibri"/>
-                <a:ea typeface="Calibri"/>
-                <a:cs typeface="Calibri"/>
-              </a:rPr>
-              <a:t>  • Trần ngân sách đóng băng cứng: 19.99 USD (hard_budget_limit_usd).</a:t>
+              <a:t>•  Trần ngân sách đóng băng cứng (Hard Budget Cap): 19.99 USD.</a:t>
             </a:r>
           </a:p>
         </p:txBody>
@@ -13332,7 +13400,7 @@
           <p:nvPr/>
         </p:nvPicPr>
         <p:blipFill>
-          <a:blip xmlns:r="http://schemas.openxmlformats.org/officeDocument/2006/relationships" xmlns:a="http://schemas.openxmlformats.org/drawingml/2006/main" r:embed="R1159e80b8d3942b7"/>
+          <a:blip xmlns:r="http://schemas.openxmlformats.org/officeDocument/2006/relationships" xmlns:a="http://schemas.openxmlformats.org/drawingml/2006/main" r:embed="Rb6b814003b3849e3"/>
           <a:stretch xmlns:a="http://schemas.openxmlformats.org/drawingml/2006/main">
             <a:fillRect l="0" t="0" r="0" b="0"/>
           </a:stretch>
@@ -13352,7 +13420,7 @@
           <p:cNvPr id="9" name="Rounded Rectangle 8">
             <a:extLst xmlns:a="http://schemas.openxmlformats.org/drawingml/2006/main">
               <a:ext uri="{FF2B5EF4-FFF2-40B4-BE49-F238E27FC236}">
-                <a16:creationId xmlns:a16="http://schemas.microsoft.com/office/drawing/2014/main" id="{5A4F294A-B342-4027-A2F4-2B8A0C15FC9D}"/>
+                <a16:creationId xmlns:a16="http://schemas.microsoft.com/office/drawing/2014/main" id="{EE50DCE1-1B46-4DD7-96E2-DA871FFF0F37}"/>
               </a:ext>
             </a:extLst>
           </p:cNvPr>
@@ -13407,7 +13475,7 @@
           <p:cNvPr id="10" name="TextBox 9">
             <a:extLst xmlns:a="http://schemas.openxmlformats.org/drawingml/2006/main">
               <a:ext uri="{FF2B5EF4-FFF2-40B4-BE49-F238E27FC236}">
-                <a16:creationId xmlns:a16="http://schemas.microsoft.com/office/drawing/2014/main" id="{92AC73DC-BDB6-493F-AD2C-ECCBABF50958}"/>
+                <a16:creationId xmlns:a16="http://schemas.microsoft.com/office/drawing/2014/main" id="{A4A772D4-9F9A-42BB-9C51-741B083D543B}"/>
               </a:ext>
             </a:extLst>
           </p:cNvPr>
@@ -13490,7 +13558,7 @@
     </p:spTree>
     <p:extLst>
       <p:ext uri="{BB962C8B-B14F-4D97-AF65-F5344CB8AC3E}">
-        <p14:creationId xmlns:p14="http://schemas.microsoft.com/office/powerpoint/2010/main" val="168802271"/>
+        <p14:creationId xmlns:p14="http://schemas.microsoft.com/office/powerpoint/2010/main" val="252054135"/>
       </p:ext>
     </p:extLst>
   </p:cSld>

</xml_diff>

<commit_message>
fix(repro-presentation): implement canonical source repair per Root review mandate
</commit_message>
<xml_diff>
--- a/reports/evidence/fixture_populated_slides.pptx
+++ b/reports/evidence/fixture_populated_slides.pptx
@@ -2,131 +2,27 @@
 <file path=ppt/presentation.xml><?xml version="1.0" encoding="utf-8"?>
 <p:presentation xmlns:p="http://schemas.openxmlformats.org/presentationml/2006/main">
   <p:sldMasterIdLst>
-    <p:sldMasterId xmlns:r="http://schemas.openxmlformats.org/officeDocument/2006/relationships" id="2147483648" r:id="R97c028c3622744ec"/>
+    <p:sldMasterId xmlns:r="http://schemas.openxmlformats.org/officeDocument/2006/relationships" id="2147483648" r:id="R274f9f041efd4180"/>
   </p:sldMasterIdLst>
   <p:notesMasterIdLst>
-    <p:notesMasterId xmlns:r="http://schemas.openxmlformats.org/officeDocument/2006/relationships" r:id="Rd0ec733be698460c"/>
+    <p:notesMasterId xmlns:r="http://schemas.openxmlformats.org/officeDocument/2006/relationships" r:id="R1cf397267a7c4c12"/>
   </p:notesMasterIdLst>
   <p:sldIdLst>
-    <p:sldId xmlns:r="http://schemas.openxmlformats.org/officeDocument/2006/relationships" id="256" r:id="Rc7d173c9e34b4224"/>
-    <p:sldId xmlns:r="http://schemas.openxmlformats.org/officeDocument/2006/relationships" id="257" r:id="R37e42e448e0248f2"/>
-    <p:sldId xmlns:r="http://schemas.openxmlformats.org/officeDocument/2006/relationships" id="258" r:id="R487265d6275b43f2"/>
-    <p:sldId xmlns:r="http://schemas.openxmlformats.org/officeDocument/2006/relationships" id="259" r:id="R0d548589cdfd464b"/>
-    <p:sldId xmlns:r="http://schemas.openxmlformats.org/officeDocument/2006/relationships" id="260" r:id="R0df468567d8b43a9"/>
-    <p:sldId xmlns:r="http://schemas.openxmlformats.org/officeDocument/2006/relationships" id="261" r:id="R4bcc37655b8c4f87"/>
-    <p:sldId xmlns:r="http://schemas.openxmlformats.org/officeDocument/2006/relationships" id="262" r:id="Re3061b16ad4e46a8"/>
-    <p:sldId xmlns:r="http://schemas.openxmlformats.org/officeDocument/2006/relationships" id="263" r:id="R4e53f57b398f47d0"/>
-    <p:sldId xmlns:r="http://schemas.openxmlformats.org/officeDocument/2006/relationships" id="264" r:id="Rf56ca8d4b2924094"/>
-    <p:sldId xmlns:r="http://schemas.openxmlformats.org/officeDocument/2006/relationships" id="265" r:id="Rd66c37502a344989"/>
-    <p:sldId xmlns:r="http://schemas.openxmlformats.org/officeDocument/2006/relationships" id="266" r:id="R2c22f1dfac494254"/>
-    <p:sldId xmlns:r="http://schemas.openxmlformats.org/officeDocument/2006/relationships" id="267" r:id="Rcb65aadb02974262"/>
+    <p:sldId xmlns:r="http://schemas.openxmlformats.org/officeDocument/2006/relationships" id="256" r:id="R7b0985bc4c854692"/>
+    <p:sldId xmlns:r="http://schemas.openxmlformats.org/officeDocument/2006/relationships" id="257" r:id="R9d5d74b87498472a"/>
+    <p:sldId xmlns:r="http://schemas.openxmlformats.org/officeDocument/2006/relationships" id="258" r:id="R96e90c8f21fa464a"/>
+    <p:sldId xmlns:r="http://schemas.openxmlformats.org/officeDocument/2006/relationships" id="259" r:id="R2b76210bfe8941b6"/>
+    <p:sldId xmlns:r="http://schemas.openxmlformats.org/officeDocument/2006/relationships" id="260" r:id="Rbfc407cc7299481d"/>
+    <p:sldId xmlns:r="http://schemas.openxmlformats.org/officeDocument/2006/relationships" id="261" r:id="R40cbb9dd61f044d6"/>
+    <p:sldId xmlns:r="http://schemas.openxmlformats.org/officeDocument/2006/relationships" id="262" r:id="Rd0a7b7c4e67f4ae0"/>
+    <p:sldId xmlns:r="http://schemas.openxmlformats.org/officeDocument/2006/relationships" id="263" r:id="R1ab9cb9d156a499c"/>
+    <p:sldId xmlns:r="http://schemas.openxmlformats.org/officeDocument/2006/relationships" id="264" r:id="R034e6de3c9c2426f"/>
+    <p:sldId xmlns:r="http://schemas.openxmlformats.org/officeDocument/2006/relationships" id="265" r:id="R554f4ac4c32e48bd"/>
+    <p:sldId xmlns:r="http://schemas.openxmlformats.org/officeDocument/2006/relationships" id="266" r:id="Rc3bbbcccbdac43fc"/>
+    <p:sldId xmlns:r="http://schemas.openxmlformats.org/officeDocument/2006/relationships" id="267" r:id="Ra67ca09ad3954d51"/>
   </p:sldIdLst>
   <p:sldSz cx="12191695" cy="6858000"/>
   <p:notesSz cx="6858000" cy="9144000"/>
-  <p:defaultTextStyle>
-    <a:defPPr xmlns:a="http://schemas.openxmlformats.org/drawingml/2006/main">
-      <a:buNone/>
-    </a:defPPr>
-    <a:lvl1pPr xmlns:a="http://schemas.openxmlformats.org/drawingml/2006/main" marL="0" algn="l" defTabSz="457200">
-      <a:buNone/>
-      <a:defRPr sz="1800" kern="1200">
-        <a:solidFill>
-          <a:schemeClr val="tx1"/>
-        </a:solidFill>
-        <a:latin typeface="+mn-lt"/>
-        <a:ea typeface="+mn-lt"/>
-        <a:cs typeface="+mn-lt"/>
-      </a:defRPr>
-    </a:lvl1pPr>
-    <a:lvl2pPr xmlns:a="http://schemas.openxmlformats.org/drawingml/2006/main" marL="457200" algn="l" defTabSz="457200">
-      <a:buNone/>
-      <a:defRPr sz="1800" kern="1200">
-        <a:solidFill>
-          <a:schemeClr val="tx1"/>
-        </a:solidFill>
-        <a:latin typeface="+mn-lt"/>
-        <a:ea typeface="+mn-lt"/>
-        <a:cs typeface="+mn-lt"/>
-      </a:defRPr>
-    </a:lvl2pPr>
-    <a:lvl3pPr xmlns:a="http://schemas.openxmlformats.org/drawingml/2006/main" marL="914400" algn="l" defTabSz="457200">
-      <a:buNone/>
-      <a:defRPr sz="1800" kern="1200">
-        <a:solidFill>
-          <a:schemeClr val="tx1"/>
-        </a:solidFill>
-        <a:latin typeface="+mn-lt"/>
-        <a:ea typeface="+mn-lt"/>
-        <a:cs typeface="+mn-lt"/>
-      </a:defRPr>
-    </a:lvl3pPr>
-    <a:lvl4pPr xmlns:a="http://schemas.openxmlformats.org/drawingml/2006/main" marL="1371600" algn="l" defTabSz="457200">
-      <a:buNone/>
-      <a:defRPr sz="1800" kern="1200">
-        <a:solidFill>
-          <a:schemeClr val="tx1"/>
-        </a:solidFill>
-        <a:latin typeface="+mn-lt"/>
-        <a:ea typeface="+mn-lt"/>
-        <a:cs typeface="+mn-lt"/>
-      </a:defRPr>
-    </a:lvl4pPr>
-    <a:lvl5pPr xmlns:a="http://schemas.openxmlformats.org/drawingml/2006/main" marL="1828800" algn="l" defTabSz="457200">
-      <a:buNone/>
-      <a:defRPr sz="1800" kern="1200">
-        <a:solidFill>
-          <a:schemeClr val="tx1"/>
-        </a:solidFill>
-        <a:latin typeface="+mn-lt"/>
-        <a:ea typeface="+mn-lt"/>
-        <a:cs typeface="+mn-lt"/>
-      </a:defRPr>
-    </a:lvl5pPr>
-    <a:lvl6pPr xmlns:a="http://schemas.openxmlformats.org/drawingml/2006/main" marL="2286000" algn="l" defTabSz="457200">
-      <a:buNone/>
-      <a:defRPr sz="1800" kern="1200">
-        <a:solidFill>
-          <a:schemeClr val="tx1"/>
-        </a:solidFill>
-        <a:latin typeface="+mn-lt"/>
-        <a:ea typeface="+mn-lt"/>
-        <a:cs typeface="+mn-lt"/>
-      </a:defRPr>
-    </a:lvl6pPr>
-    <a:lvl7pPr xmlns:a="http://schemas.openxmlformats.org/drawingml/2006/main" marL="2743200" algn="l" defTabSz="457200">
-      <a:buNone/>
-      <a:defRPr sz="1800" kern="1200">
-        <a:solidFill>
-          <a:schemeClr val="tx1"/>
-        </a:solidFill>
-        <a:latin typeface="+mn-lt"/>
-        <a:ea typeface="+mn-lt"/>
-        <a:cs typeface="+mn-lt"/>
-      </a:defRPr>
-    </a:lvl7pPr>
-    <a:lvl8pPr xmlns:a="http://schemas.openxmlformats.org/drawingml/2006/main" marL="3200400" algn="l" defTabSz="457200">
-      <a:buNone/>
-      <a:defRPr sz="1800" kern="1200">
-        <a:solidFill>
-          <a:schemeClr val="tx1"/>
-        </a:solidFill>
-        <a:latin typeface="+mn-lt"/>
-        <a:ea typeface="+mn-lt"/>
-        <a:cs typeface="+mn-lt"/>
-      </a:defRPr>
-    </a:lvl8pPr>
-    <a:lvl9pPr xmlns:a="http://schemas.openxmlformats.org/drawingml/2006/main" marL="3657600" algn="l" defTabSz="457200">
-      <a:buNone/>
-      <a:defRPr sz="1800" kern="1200">
-        <a:solidFill>
-          <a:schemeClr val="tx1"/>
-        </a:solidFill>
-        <a:latin typeface="+mn-lt"/>
-        <a:ea typeface="+mn-lt"/>
-        <a:cs typeface="+mn-lt"/>
-      </a:defRPr>
-    </a:lvl9pPr>
-  </p:defaultTextStyle>
 </p:presentation>
 </file>
 
@@ -1582,7 +1478,7 @@
           <p:cNvPr id="2" name="Title 1">
             <a:extLst xmlns:a="http://schemas.openxmlformats.org/drawingml/2006/main">
               <a:ext uri="{FF2B5EF4-FFF2-40B4-BE49-F238E27FC236}">
-                <a16:creationId xmlns:a16="http://schemas.microsoft.com/office/drawing/2014/main" id="{2326D6F1-0E5B-45C2-8308-9E56AE0B55A7}"/>
+                <a16:creationId xmlns:a16="http://schemas.microsoft.com/office/drawing/2014/main" id="{7F9F4A94-91CB-424A-8A1D-FBAD73BC8BF0}"/>
               </a:ext>
             </a:extLst>
           </p:cNvPr>
@@ -1615,7 +1511,7 @@
           <p:cNvPr id="3" name="Subtitle 2">
             <a:extLst xmlns:a="http://schemas.openxmlformats.org/drawingml/2006/main">
               <a:ext uri="{FF2B5EF4-FFF2-40B4-BE49-F238E27FC236}">
-                <a16:creationId xmlns:a16="http://schemas.microsoft.com/office/drawing/2014/main" id="{9E20FFCC-5526-4A74-9335-2CA47EDE1F7A}"/>
+                <a16:creationId xmlns:a16="http://schemas.microsoft.com/office/drawing/2014/main" id="{B6BC5920-7CCD-429F-8057-4C38DF69F9D4}"/>
               </a:ext>
             </a:extLst>
           </p:cNvPr>
@@ -1739,7 +1635,7 @@
           <p:cNvPr id="4" name="Date Placeholder 3">
             <a:extLst xmlns:a="http://schemas.openxmlformats.org/drawingml/2006/main">
               <a:ext uri="{FF2B5EF4-FFF2-40B4-BE49-F238E27FC236}">
-                <a16:creationId xmlns:a16="http://schemas.microsoft.com/office/drawing/2014/main" id="{DB35B456-1902-44D0-A5E4-E1D47AF39477}"/>
+                <a16:creationId xmlns:a16="http://schemas.microsoft.com/office/drawing/2014/main" id="{089D4347-582A-4043-818F-CB3862A36D25}"/>
               </a:ext>
             </a:extLst>
           </p:cNvPr>
@@ -1767,7 +1663,7 @@
           <p:cNvPr id="5" name="Footer Placeholder 4">
             <a:extLst xmlns:a="http://schemas.openxmlformats.org/drawingml/2006/main">
               <a:ext uri="{FF2B5EF4-FFF2-40B4-BE49-F238E27FC236}">
-                <a16:creationId xmlns:a16="http://schemas.microsoft.com/office/drawing/2014/main" id="{7CEBD353-DEFF-4E4A-8442-3586A3D77DE2}"/>
+                <a16:creationId xmlns:a16="http://schemas.microsoft.com/office/drawing/2014/main" id="{BE8931ED-64EB-4B4A-A69F-879729F46D01}"/>
               </a:ext>
             </a:extLst>
           </p:cNvPr>
@@ -1792,7 +1688,7 @@
           <p:cNvPr id="6" name="Slide Number Placeholder 5">
             <a:extLst xmlns:a="http://schemas.openxmlformats.org/drawingml/2006/main">
               <a:ext uri="{FF2B5EF4-FFF2-40B4-BE49-F238E27FC236}">
-                <a16:creationId xmlns:a16="http://schemas.microsoft.com/office/drawing/2014/main" id="{B0038F65-240B-470A-A519-84AEB6CC5328}"/>
+                <a16:creationId xmlns:a16="http://schemas.microsoft.com/office/drawing/2014/main" id="{522893BE-1C03-4208-9B47-9E27FAAECB9D}"/>
               </a:ext>
             </a:extLst>
           </p:cNvPr>
@@ -1837,7 +1733,7 @@
           <p:cNvPr id="2" name="Title 1">
             <a:extLst xmlns:a="http://schemas.openxmlformats.org/drawingml/2006/main">
               <a:ext uri="{FF2B5EF4-FFF2-40B4-BE49-F238E27FC236}">
-                <a16:creationId xmlns:a16="http://schemas.microsoft.com/office/drawing/2014/main" id="{632F8BD2-D1E8-4BFF-802F-2DC8D8F191E1}"/>
+                <a16:creationId xmlns:a16="http://schemas.microsoft.com/office/drawing/2014/main" id="{76CEB976-BC5D-4254-BEF5-A29787C1CB55}"/>
               </a:ext>
             </a:extLst>
           </p:cNvPr>
@@ -1865,7 +1761,7 @@
           <p:cNvPr id="3" name="Vertical Text Placeholder 2">
             <a:extLst xmlns:a="http://schemas.openxmlformats.org/drawingml/2006/main">
               <a:ext uri="{FF2B5EF4-FFF2-40B4-BE49-F238E27FC236}">
-                <a16:creationId xmlns:a16="http://schemas.microsoft.com/office/drawing/2014/main" id="{DED7B928-0278-4727-B8E3-2C4BB9B41D87}"/>
+                <a16:creationId xmlns:a16="http://schemas.microsoft.com/office/drawing/2014/main" id="{FF25C106-3A88-4EAA-97E0-3CC6E26F43A6}"/>
               </a:ext>
             </a:extLst>
           </p:cNvPr>
@@ -1928,7 +1824,7 @@
           <p:cNvPr id="4" name="Date Placeholder 3">
             <a:extLst xmlns:a="http://schemas.openxmlformats.org/drawingml/2006/main">
               <a:ext uri="{FF2B5EF4-FFF2-40B4-BE49-F238E27FC236}">
-                <a16:creationId xmlns:a16="http://schemas.microsoft.com/office/drawing/2014/main" id="{4F519CFC-EF67-4A2E-B27E-300B78E09569}"/>
+                <a16:creationId xmlns:a16="http://schemas.microsoft.com/office/drawing/2014/main" id="{8909FA72-8677-4BCF-8414-F28359CD16E2}"/>
               </a:ext>
             </a:extLst>
           </p:cNvPr>
@@ -1956,7 +1852,7 @@
           <p:cNvPr id="5" name="Footer Placeholder 4">
             <a:extLst xmlns:a="http://schemas.openxmlformats.org/drawingml/2006/main">
               <a:ext uri="{FF2B5EF4-FFF2-40B4-BE49-F238E27FC236}">
-                <a16:creationId xmlns:a16="http://schemas.microsoft.com/office/drawing/2014/main" id="{506C1230-E58C-43AD-A0B5-AEE498B717F0}"/>
+                <a16:creationId xmlns:a16="http://schemas.microsoft.com/office/drawing/2014/main" id="{06E6DAD7-B965-4170-B3C1-AD1D9035BA05}"/>
               </a:ext>
             </a:extLst>
           </p:cNvPr>
@@ -1981,7 +1877,7 @@
           <p:cNvPr id="6" name="Slide Number Placeholder 5">
             <a:extLst xmlns:a="http://schemas.openxmlformats.org/drawingml/2006/main">
               <a:ext uri="{FF2B5EF4-FFF2-40B4-BE49-F238E27FC236}">
-                <a16:creationId xmlns:a16="http://schemas.microsoft.com/office/drawing/2014/main" id="{D1F69624-0A6C-4B9A-B5EC-944CF2CFD98F}"/>
+                <a16:creationId xmlns:a16="http://schemas.microsoft.com/office/drawing/2014/main" id="{527A6FDC-F304-431E-A339-9637FB4491A1}"/>
               </a:ext>
             </a:extLst>
           </p:cNvPr>
@@ -2026,7 +1922,7 @@
           <p:cNvPr id="2" name="Vertical Title 1">
             <a:extLst xmlns:a="http://schemas.openxmlformats.org/drawingml/2006/main">
               <a:ext uri="{FF2B5EF4-FFF2-40B4-BE49-F238E27FC236}">
-                <a16:creationId xmlns:a16="http://schemas.microsoft.com/office/drawing/2014/main" id="{ECB3E896-6904-4CD6-8D9E-A407A3CE9DE9}"/>
+                <a16:creationId xmlns:a16="http://schemas.microsoft.com/office/drawing/2014/main" id="{26EAEEDF-B950-48E6-8D6B-5BDE8BBA51E6}"/>
               </a:ext>
             </a:extLst>
           </p:cNvPr>
@@ -2059,7 +1955,7 @@
           <p:cNvPr id="3" name="Vertical Text Placeholder 2">
             <a:extLst xmlns:a="http://schemas.openxmlformats.org/drawingml/2006/main">
               <a:ext uri="{FF2B5EF4-FFF2-40B4-BE49-F238E27FC236}">
-                <a16:creationId xmlns:a16="http://schemas.microsoft.com/office/drawing/2014/main" id="{06FD7510-5D6A-4194-9590-4629B588072D}"/>
+                <a16:creationId xmlns:a16="http://schemas.microsoft.com/office/drawing/2014/main" id="{0C753CE7-85E7-4073-BA4B-7C635AC1D59B}"/>
               </a:ext>
             </a:extLst>
           </p:cNvPr>
@@ -2127,7 +2023,7 @@
           <p:cNvPr id="4" name="Date Placeholder 3">
             <a:extLst xmlns:a="http://schemas.openxmlformats.org/drawingml/2006/main">
               <a:ext uri="{FF2B5EF4-FFF2-40B4-BE49-F238E27FC236}">
-                <a16:creationId xmlns:a16="http://schemas.microsoft.com/office/drawing/2014/main" id="{3DBF7521-3A35-41CF-B0A3-0C43ED3FB4D1}"/>
+                <a16:creationId xmlns:a16="http://schemas.microsoft.com/office/drawing/2014/main" id="{96AD8E39-26B6-42C2-90B9-03A4D0DE1F81}"/>
               </a:ext>
             </a:extLst>
           </p:cNvPr>
@@ -2155,7 +2051,7 @@
           <p:cNvPr id="5" name="Footer Placeholder 4">
             <a:extLst xmlns:a="http://schemas.openxmlformats.org/drawingml/2006/main">
               <a:ext uri="{FF2B5EF4-FFF2-40B4-BE49-F238E27FC236}">
-                <a16:creationId xmlns:a16="http://schemas.microsoft.com/office/drawing/2014/main" id="{A73ABAE9-6354-4786-88C2-F5490732E46D}"/>
+                <a16:creationId xmlns:a16="http://schemas.microsoft.com/office/drawing/2014/main" id="{272AF1D7-0D75-4A18-B82A-31BA285ADBA9}"/>
               </a:ext>
             </a:extLst>
           </p:cNvPr>
@@ -2180,7 +2076,7 @@
           <p:cNvPr id="6" name="Slide Number Placeholder 5">
             <a:extLst xmlns:a="http://schemas.openxmlformats.org/drawingml/2006/main">
               <a:ext uri="{FF2B5EF4-FFF2-40B4-BE49-F238E27FC236}">
-                <a16:creationId xmlns:a16="http://schemas.microsoft.com/office/drawing/2014/main" id="{7A1A9589-F049-4FC3-828A-8AF73022D369}"/>
+                <a16:creationId xmlns:a16="http://schemas.microsoft.com/office/drawing/2014/main" id="{6D8F27B7-39AD-41DC-B0CD-B139F1D1C53F}"/>
               </a:ext>
             </a:extLst>
           </p:cNvPr>
@@ -2225,7 +2121,7 @@
           <p:cNvPr id="2" name="Title 1">
             <a:extLst xmlns:a="http://schemas.openxmlformats.org/drawingml/2006/main">
               <a:ext uri="{FF2B5EF4-FFF2-40B4-BE49-F238E27FC236}">
-                <a16:creationId xmlns:a16="http://schemas.microsoft.com/office/drawing/2014/main" id="{CB3BF5A0-06AD-4825-BA25-33FB8273C4EB}"/>
+                <a16:creationId xmlns:a16="http://schemas.microsoft.com/office/drawing/2014/main" id="{4B83E4DF-7F4E-471E-A116-3BC2B2BA855E}"/>
               </a:ext>
             </a:extLst>
           </p:cNvPr>
@@ -2253,7 +2149,7 @@
           <p:cNvPr id="3" name="Content Placeholder 2">
             <a:extLst xmlns:a="http://schemas.openxmlformats.org/drawingml/2006/main">
               <a:ext uri="{FF2B5EF4-FFF2-40B4-BE49-F238E27FC236}">
-                <a16:creationId xmlns:a16="http://schemas.microsoft.com/office/drawing/2014/main" id="{239E7D7E-8061-418B-B21F-1B973C5FBD1B}"/>
+                <a16:creationId xmlns:a16="http://schemas.microsoft.com/office/drawing/2014/main" id="{14D862CC-559D-4A60-A8F4-9383E63D505E}"/>
               </a:ext>
             </a:extLst>
           </p:cNvPr>
@@ -2316,7 +2212,7 @@
           <p:cNvPr id="4" name="Date Placeholder 3">
             <a:extLst xmlns:a="http://schemas.openxmlformats.org/drawingml/2006/main">
               <a:ext uri="{FF2B5EF4-FFF2-40B4-BE49-F238E27FC236}">
-                <a16:creationId xmlns:a16="http://schemas.microsoft.com/office/drawing/2014/main" id="{9F6F071F-4A94-443C-9E23-AA268B69D67C}"/>
+                <a16:creationId xmlns:a16="http://schemas.microsoft.com/office/drawing/2014/main" id="{C2538781-E835-4A51-9D70-B55B5A08474A}"/>
               </a:ext>
             </a:extLst>
           </p:cNvPr>
@@ -2344,7 +2240,7 @@
           <p:cNvPr id="5" name="Footer Placeholder 4">
             <a:extLst xmlns:a="http://schemas.openxmlformats.org/drawingml/2006/main">
               <a:ext uri="{FF2B5EF4-FFF2-40B4-BE49-F238E27FC236}">
-                <a16:creationId xmlns:a16="http://schemas.microsoft.com/office/drawing/2014/main" id="{22F44195-D30D-41AF-8B03-05472102FC8B}"/>
+                <a16:creationId xmlns:a16="http://schemas.microsoft.com/office/drawing/2014/main" id="{58908AF4-D5A3-4344-84B7-1AD3E8FA71B6}"/>
               </a:ext>
             </a:extLst>
           </p:cNvPr>
@@ -2369,7 +2265,7 @@
           <p:cNvPr id="6" name="Slide Number Placeholder 5">
             <a:extLst xmlns:a="http://schemas.openxmlformats.org/drawingml/2006/main">
               <a:ext uri="{FF2B5EF4-FFF2-40B4-BE49-F238E27FC236}">
-                <a16:creationId xmlns:a16="http://schemas.microsoft.com/office/drawing/2014/main" id="{6139379A-AEFA-4404-B3E3-D69B3693038A}"/>
+                <a16:creationId xmlns:a16="http://schemas.microsoft.com/office/drawing/2014/main" id="{2C4AFE69-6E39-4BBE-A10E-C737A4324FB7}"/>
               </a:ext>
             </a:extLst>
           </p:cNvPr>
@@ -2414,7 +2310,7 @@
           <p:cNvPr id="2" name="Title 1">
             <a:extLst xmlns:a="http://schemas.openxmlformats.org/drawingml/2006/main">
               <a:ext uri="{FF2B5EF4-FFF2-40B4-BE49-F238E27FC236}">
-                <a16:creationId xmlns:a16="http://schemas.microsoft.com/office/drawing/2014/main" id="{D037D107-6C36-45EF-B426-021C4F7AB34E}"/>
+                <a16:creationId xmlns:a16="http://schemas.microsoft.com/office/drawing/2014/main" id="{0E528F2E-32AB-4A9E-ACD7-6B78CF30A70E}"/>
               </a:ext>
             </a:extLst>
           </p:cNvPr>
@@ -2452,7 +2348,7 @@
           <p:cNvPr id="3" name="Text Placeholder 2">
             <a:extLst xmlns:a="http://schemas.openxmlformats.org/drawingml/2006/main">
               <a:ext uri="{FF2B5EF4-FFF2-40B4-BE49-F238E27FC236}">
-                <a16:creationId xmlns:a16="http://schemas.microsoft.com/office/drawing/2014/main" id="{79938796-5869-4C5B-8B29-5E15829EEEDB}"/>
+                <a16:creationId xmlns:a16="http://schemas.microsoft.com/office/drawing/2014/main" id="{8CB6D19D-95F1-4A92-9D60-322E9ABFDCAA}"/>
               </a:ext>
             </a:extLst>
           </p:cNvPr>
@@ -2578,7 +2474,7 @@
           <p:cNvPr id="4" name="Date Placeholder 3">
             <a:extLst xmlns:a="http://schemas.openxmlformats.org/drawingml/2006/main">
               <a:ext uri="{FF2B5EF4-FFF2-40B4-BE49-F238E27FC236}">
-                <a16:creationId xmlns:a16="http://schemas.microsoft.com/office/drawing/2014/main" id="{C312FD98-0189-4C86-B154-C9BDFF6CD131}"/>
+                <a16:creationId xmlns:a16="http://schemas.microsoft.com/office/drawing/2014/main" id="{7D4C5350-EB35-413C-9447-7DB87799EA24}"/>
               </a:ext>
             </a:extLst>
           </p:cNvPr>
@@ -2606,7 +2502,7 @@
           <p:cNvPr id="5" name="Footer Placeholder 4">
             <a:extLst xmlns:a="http://schemas.openxmlformats.org/drawingml/2006/main">
               <a:ext uri="{FF2B5EF4-FFF2-40B4-BE49-F238E27FC236}">
-                <a16:creationId xmlns:a16="http://schemas.microsoft.com/office/drawing/2014/main" id="{BFD9FF52-1946-4D8E-AD4A-4A9C355A10E5}"/>
+                <a16:creationId xmlns:a16="http://schemas.microsoft.com/office/drawing/2014/main" id="{885A5292-0144-445A-97E0-DCE845CF6A0C}"/>
               </a:ext>
             </a:extLst>
           </p:cNvPr>
@@ -2631,7 +2527,7 @@
           <p:cNvPr id="6" name="Slide Number Placeholder 5">
             <a:extLst xmlns:a="http://schemas.openxmlformats.org/drawingml/2006/main">
               <a:ext uri="{FF2B5EF4-FFF2-40B4-BE49-F238E27FC236}">
-                <a16:creationId xmlns:a16="http://schemas.microsoft.com/office/drawing/2014/main" id="{CB4B095F-5113-4EC6-BE82-2C74C26E7A3B}"/>
+                <a16:creationId xmlns:a16="http://schemas.microsoft.com/office/drawing/2014/main" id="{7397089C-F506-4BD3-8088-729C4535D27F}"/>
               </a:ext>
             </a:extLst>
           </p:cNvPr>
@@ -2676,7 +2572,7 @@
           <p:cNvPr id="2" name="Title 1">
             <a:extLst xmlns:a="http://schemas.openxmlformats.org/drawingml/2006/main">
               <a:ext uri="{FF2B5EF4-FFF2-40B4-BE49-F238E27FC236}">
-                <a16:creationId xmlns:a16="http://schemas.microsoft.com/office/drawing/2014/main" id="{0DA72049-295E-4D79-9982-C25400502956}"/>
+                <a16:creationId xmlns:a16="http://schemas.microsoft.com/office/drawing/2014/main" id="{363F692C-E8A1-4DB9-91CE-D5CCA936D077}"/>
               </a:ext>
             </a:extLst>
           </p:cNvPr>
@@ -2704,7 +2600,7 @@
           <p:cNvPr id="3" name="Content Placeholder 2">
             <a:extLst xmlns:a="http://schemas.openxmlformats.org/drawingml/2006/main">
               <a:ext uri="{FF2B5EF4-FFF2-40B4-BE49-F238E27FC236}">
-                <a16:creationId xmlns:a16="http://schemas.microsoft.com/office/drawing/2014/main" id="{D5506CD0-8013-485C-A4D0-B8225F183626}"/>
+                <a16:creationId xmlns:a16="http://schemas.microsoft.com/office/drawing/2014/main" id="{9573F911-4E6D-473D-B6EF-D19010A2C092}"/>
               </a:ext>
             </a:extLst>
           </p:cNvPr>
@@ -2809,7 +2705,7 @@
           <p:cNvPr id="4" name="Content Placeholder 3">
             <a:extLst xmlns:a="http://schemas.openxmlformats.org/drawingml/2006/main">
               <a:ext uri="{FF2B5EF4-FFF2-40B4-BE49-F238E27FC236}">
-                <a16:creationId xmlns:a16="http://schemas.microsoft.com/office/drawing/2014/main" id="{F877EC23-778F-41AB-963A-D5A4CD3D2069}"/>
+                <a16:creationId xmlns:a16="http://schemas.microsoft.com/office/drawing/2014/main" id="{410ED996-2753-450F-9961-A3021D16207D}"/>
               </a:ext>
             </a:extLst>
           </p:cNvPr>
@@ -2914,7 +2810,7 @@
           <p:cNvPr id="5" name="Date Placeholder 4">
             <a:extLst xmlns:a="http://schemas.openxmlformats.org/drawingml/2006/main">
               <a:ext uri="{FF2B5EF4-FFF2-40B4-BE49-F238E27FC236}">
-                <a16:creationId xmlns:a16="http://schemas.microsoft.com/office/drawing/2014/main" id="{2CF4E87D-CDD7-4F6E-8BF6-79F70EF2A066}"/>
+                <a16:creationId xmlns:a16="http://schemas.microsoft.com/office/drawing/2014/main" id="{894DB9DA-A6F3-422E-A2FD-77E938B82EE8}"/>
               </a:ext>
             </a:extLst>
           </p:cNvPr>
@@ -2942,7 +2838,7 @@
           <p:cNvPr id="6" name="Footer Placeholder 5">
             <a:extLst xmlns:a="http://schemas.openxmlformats.org/drawingml/2006/main">
               <a:ext uri="{FF2B5EF4-FFF2-40B4-BE49-F238E27FC236}">
-                <a16:creationId xmlns:a16="http://schemas.microsoft.com/office/drawing/2014/main" id="{A9D0CF0C-D2E4-4AB2-8992-F9C6CEFB37CB}"/>
+                <a16:creationId xmlns:a16="http://schemas.microsoft.com/office/drawing/2014/main" id="{8C9BAFFB-0C38-4942-A0D8-EDA64D122D22}"/>
               </a:ext>
             </a:extLst>
           </p:cNvPr>
@@ -2967,7 +2863,7 @@
           <p:cNvPr id="7" name="Slide Number Placeholder 6">
             <a:extLst xmlns:a="http://schemas.openxmlformats.org/drawingml/2006/main">
               <a:ext uri="{FF2B5EF4-FFF2-40B4-BE49-F238E27FC236}">
-                <a16:creationId xmlns:a16="http://schemas.microsoft.com/office/drawing/2014/main" id="{31D3E774-9F0C-4C15-B3B6-C470ED147711}"/>
+                <a16:creationId xmlns:a16="http://schemas.microsoft.com/office/drawing/2014/main" id="{F48EC67E-7B1D-432E-8E8B-5A6F0C05AE5B}"/>
               </a:ext>
             </a:extLst>
           </p:cNvPr>
@@ -3012,7 +2908,7 @@
           <p:cNvPr id="2" name="Title 1">
             <a:extLst xmlns:a="http://schemas.openxmlformats.org/drawingml/2006/main">
               <a:ext uri="{FF2B5EF4-FFF2-40B4-BE49-F238E27FC236}">
-                <a16:creationId xmlns:a16="http://schemas.microsoft.com/office/drawing/2014/main" id="{AA8DEAC4-90B0-4E56-8277-0742E7854834}"/>
+                <a16:creationId xmlns:a16="http://schemas.microsoft.com/office/drawing/2014/main" id="{1FF73F2E-45F2-41E9-A9F5-1EA9C6B2559F}"/>
               </a:ext>
             </a:extLst>
           </p:cNvPr>
@@ -3045,7 +2941,7 @@
           <p:cNvPr id="3" name="Text Placeholder 2">
             <a:extLst xmlns:a="http://schemas.openxmlformats.org/drawingml/2006/main">
               <a:ext uri="{FF2B5EF4-FFF2-40B4-BE49-F238E27FC236}">
-                <a16:creationId xmlns:a16="http://schemas.microsoft.com/office/drawing/2014/main" id="{51BB103A-9E05-4D26-93B0-77FAA30B0549}"/>
+                <a16:creationId xmlns:a16="http://schemas.microsoft.com/office/drawing/2014/main" id="{4AB6ECAE-9296-4FBF-9124-6AA61A3146A9}"/>
               </a:ext>
             </a:extLst>
           </p:cNvPr>
@@ -3117,7 +3013,7 @@
           <p:cNvPr id="4" name="Content Placeholder 3">
             <a:extLst xmlns:a="http://schemas.openxmlformats.org/drawingml/2006/main">
               <a:ext uri="{FF2B5EF4-FFF2-40B4-BE49-F238E27FC236}">
-                <a16:creationId xmlns:a16="http://schemas.microsoft.com/office/drawing/2014/main" id="{71337714-5530-4E7C-8B71-A2EB79FF22D1}"/>
+                <a16:creationId xmlns:a16="http://schemas.microsoft.com/office/drawing/2014/main" id="{4ED0A156-ED97-42B5-BD54-0CCBFD4E0962}"/>
               </a:ext>
             </a:extLst>
           </p:cNvPr>
@@ -3222,7 +3118,7 @@
           <p:cNvPr id="5" name="Text Placeholder 4">
             <a:extLst xmlns:a="http://schemas.openxmlformats.org/drawingml/2006/main">
               <a:ext uri="{FF2B5EF4-FFF2-40B4-BE49-F238E27FC236}">
-                <a16:creationId xmlns:a16="http://schemas.microsoft.com/office/drawing/2014/main" id="{A3A1E99C-208A-4AB0-BA93-F3B2BDA01249}"/>
+                <a16:creationId xmlns:a16="http://schemas.microsoft.com/office/drawing/2014/main" id="{053A8CA3-2D02-412F-AF9E-F968628BB4EA}"/>
               </a:ext>
             </a:extLst>
           </p:cNvPr>
@@ -3294,7 +3190,7 @@
           <p:cNvPr id="6" name="Content Placeholder 5">
             <a:extLst xmlns:a="http://schemas.openxmlformats.org/drawingml/2006/main">
               <a:ext uri="{FF2B5EF4-FFF2-40B4-BE49-F238E27FC236}">
-                <a16:creationId xmlns:a16="http://schemas.microsoft.com/office/drawing/2014/main" id="{49BD30DD-BD8C-4657-B44A-BFCBCBB64E4D}"/>
+                <a16:creationId xmlns:a16="http://schemas.microsoft.com/office/drawing/2014/main" id="{714C9A1A-9A27-4500-8AFA-3AE2129128DB}"/>
               </a:ext>
             </a:extLst>
           </p:cNvPr>
@@ -3399,7 +3295,7 @@
           <p:cNvPr id="7" name="Date Placeholder 6">
             <a:extLst xmlns:a="http://schemas.openxmlformats.org/drawingml/2006/main">
               <a:ext uri="{FF2B5EF4-FFF2-40B4-BE49-F238E27FC236}">
-                <a16:creationId xmlns:a16="http://schemas.microsoft.com/office/drawing/2014/main" id="{A899A0E6-9B3D-4EE9-8D73-86BADAB5B199}"/>
+                <a16:creationId xmlns:a16="http://schemas.microsoft.com/office/drawing/2014/main" id="{84858CCD-587C-4F4F-B7B1-308CD8BE72D2}"/>
               </a:ext>
             </a:extLst>
           </p:cNvPr>
@@ -3427,7 +3323,7 @@
           <p:cNvPr id="8" name="Footer Placeholder 7">
             <a:extLst xmlns:a="http://schemas.openxmlformats.org/drawingml/2006/main">
               <a:ext uri="{FF2B5EF4-FFF2-40B4-BE49-F238E27FC236}">
-                <a16:creationId xmlns:a16="http://schemas.microsoft.com/office/drawing/2014/main" id="{2DF8D0A6-4F1C-43CD-B69E-37CCC58BBF2F}"/>
+                <a16:creationId xmlns:a16="http://schemas.microsoft.com/office/drawing/2014/main" id="{E2A251AC-3AF5-4FAB-BF5A-F2AB82556AB2}"/>
               </a:ext>
             </a:extLst>
           </p:cNvPr>
@@ -3452,7 +3348,7 @@
           <p:cNvPr id="9" name="Slide Number Placeholder 8">
             <a:extLst xmlns:a="http://schemas.openxmlformats.org/drawingml/2006/main">
               <a:ext uri="{FF2B5EF4-FFF2-40B4-BE49-F238E27FC236}">
-                <a16:creationId xmlns:a16="http://schemas.microsoft.com/office/drawing/2014/main" id="{5C3BF096-CA06-430C-83F0-F6D7609BA390}"/>
+                <a16:creationId xmlns:a16="http://schemas.microsoft.com/office/drawing/2014/main" id="{46F65EDB-B20B-4258-A2A5-ABEBF6D14D18}"/>
               </a:ext>
             </a:extLst>
           </p:cNvPr>
@@ -3497,7 +3393,7 @@
           <p:cNvPr id="2" name="Title 1">
             <a:extLst xmlns:a="http://schemas.openxmlformats.org/drawingml/2006/main">
               <a:ext uri="{FF2B5EF4-FFF2-40B4-BE49-F238E27FC236}">
-                <a16:creationId xmlns:a16="http://schemas.microsoft.com/office/drawing/2014/main" id="{C82CB4BA-F053-462D-A7C9-98F5BFCE56BF}"/>
+                <a16:creationId xmlns:a16="http://schemas.microsoft.com/office/drawing/2014/main" id="{2A9F2950-6973-4B5D-A233-ADFF49E0A0A0}"/>
               </a:ext>
             </a:extLst>
           </p:cNvPr>
@@ -3525,7 +3421,7 @@
           <p:cNvPr id="3" name="Date Placeholder 2">
             <a:extLst xmlns:a="http://schemas.openxmlformats.org/drawingml/2006/main">
               <a:ext uri="{FF2B5EF4-FFF2-40B4-BE49-F238E27FC236}">
-                <a16:creationId xmlns:a16="http://schemas.microsoft.com/office/drawing/2014/main" id="{9E0FC304-21C6-4CE4-84CB-EF5DA00B41DA}"/>
+                <a16:creationId xmlns:a16="http://schemas.microsoft.com/office/drawing/2014/main" id="{F6DE420F-0A84-4AAE-849D-BCCE31855278}"/>
               </a:ext>
             </a:extLst>
           </p:cNvPr>
@@ -3553,7 +3449,7 @@
           <p:cNvPr id="4" name="Footer Placeholder 3">
             <a:extLst xmlns:a="http://schemas.openxmlformats.org/drawingml/2006/main">
               <a:ext uri="{FF2B5EF4-FFF2-40B4-BE49-F238E27FC236}">
-                <a16:creationId xmlns:a16="http://schemas.microsoft.com/office/drawing/2014/main" id="{E35632F7-AA10-4097-8BA1-65E939C96441}"/>
+                <a16:creationId xmlns:a16="http://schemas.microsoft.com/office/drawing/2014/main" id="{2D5DE67F-7D27-4BA3-B576-D9AD0A2E70BF}"/>
               </a:ext>
             </a:extLst>
           </p:cNvPr>
@@ -3578,7 +3474,7 @@
           <p:cNvPr id="5" name="Slide Number Placeholder 4">
             <a:extLst xmlns:a="http://schemas.openxmlformats.org/drawingml/2006/main">
               <a:ext uri="{FF2B5EF4-FFF2-40B4-BE49-F238E27FC236}">
-                <a16:creationId xmlns:a16="http://schemas.microsoft.com/office/drawing/2014/main" id="{0AC8C3B7-7B8F-427C-AA6B-7289F4FA173E}"/>
+                <a16:creationId xmlns:a16="http://schemas.microsoft.com/office/drawing/2014/main" id="{D4E70B06-ACE7-436B-BC7C-F626B13B5081}"/>
               </a:ext>
             </a:extLst>
           </p:cNvPr>
@@ -3623,7 +3519,7 @@
           <p:cNvPr id="2" name="Date Placeholder 1">
             <a:extLst xmlns:a="http://schemas.openxmlformats.org/drawingml/2006/main">
               <a:ext uri="{FF2B5EF4-FFF2-40B4-BE49-F238E27FC236}">
-                <a16:creationId xmlns:a16="http://schemas.microsoft.com/office/drawing/2014/main" id="{32BE5F14-FAB3-49C3-A0FA-B43F8C8046D6}"/>
+                <a16:creationId xmlns:a16="http://schemas.microsoft.com/office/drawing/2014/main" id="{E13C16FA-BBCA-4646-8E5E-8F6B40A358D0}"/>
               </a:ext>
             </a:extLst>
           </p:cNvPr>
@@ -3651,7 +3547,7 @@
           <p:cNvPr id="3" name="Footer Placeholder 2">
             <a:extLst xmlns:a="http://schemas.openxmlformats.org/drawingml/2006/main">
               <a:ext uri="{FF2B5EF4-FFF2-40B4-BE49-F238E27FC236}">
-                <a16:creationId xmlns:a16="http://schemas.microsoft.com/office/drawing/2014/main" id="{3D2215DD-E804-4ECC-AD86-376F86216B4D}"/>
+                <a16:creationId xmlns:a16="http://schemas.microsoft.com/office/drawing/2014/main" id="{BDEAAB22-0477-4D2F-9FAE-2BAC773640E6}"/>
               </a:ext>
             </a:extLst>
           </p:cNvPr>
@@ -3676,7 +3572,7 @@
           <p:cNvPr id="4" name="Slide Number Placeholder 3">
             <a:extLst xmlns:a="http://schemas.openxmlformats.org/drawingml/2006/main">
               <a:ext uri="{FF2B5EF4-FFF2-40B4-BE49-F238E27FC236}">
-                <a16:creationId xmlns:a16="http://schemas.microsoft.com/office/drawing/2014/main" id="{7E148743-B58A-47B1-B193-B2C18541AC1B}"/>
+                <a16:creationId xmlns:a16="http://schemas.microsoft.com/office/drawing/2014/main" id="{B141AD95-DE5E-4038-8103-EA4C327DFB31}"/>
               </a:ext>
             </a:extLst>
           </p:cNvPr>
@@ -3721,7 +3617,7 @@
           <p:cNvPr id="2" name="Title 1">
             <a:extLst xmlns:a="http://schemas.openxmlformats.org/drawingml/2006/main">
               <a:ext uri="{FF2B5EF4-FFF2-40B4-BE49-F238E27FC236}">
-                <a16:creationId xmlns:a16="http://schemas.microsoft.com/office/drawing/2014/main" id="{53F6BD0A-70EE-47A7-B356-71DDC0648631}"/>
+                <a16:creationId xmlns:a16="http://schemas.microsoft.com/office/drawing/2014/main" id="{30F7A684-8AC2-4325-B980-5E7E98ADFE04}"/>
               </a:ext>
             </a:extLst>
           </p:cNvPr>
@@ -3759,7 +3655,7 @@
           <p:cNvPr id="3" name="Content Placeholder 2">
             <a:extLst xmlns:a="http://schemas.openxmlformats.org/drawingml/2006/main">
               <a:ext uri="{FF2B5EF4-FFF2-40B4-BE49-F238E27FC236}">
-                <a16:creationId xmlns:a16="http://schemas.microsoft.com/office/drawing/2014/main" id="{A57270B7-3E0B-4BF9-A6EC-AD1EE428A7F9}"/>
+                <a16:creationId xmlns:a16="http://schemas.microsoft.com/office/drawing/2014/main" id="{9A1BCC4A-5AE3-4199-B8F7-D3B4F55ED783}"/>
               </a:ext>
             </a:extLst>
           </p:cNvPr>
@@ -3864,7 +3760,7 @@
           <p:cNvPr id="4" name="Text Placeholder 3">
             <a:extLst xmlns:a="http://schemas.openxmlformats.org/drawingml/2006/main">
               <a:ext uri="{FF2B5EF4-FFF2-40B4-BE49-F238E27FC236}">
-                <a16:creationId xmlns:a16="http://schemas.microsoft.com/office/drawing/2014/main" id="{3A6E42A2-117A-48E5-A13B-3CEB59B1FB85}"/>
+                <a16:creationId xmlns:a16="http://schemas.microsoft.com/office/drawing/2014/main" id="{8081C687-3A62-4061-A66D-BA6F120F1B9D}"/>
               </a:ext>
             </a:extLst>
           </p:cNvPr>
@@ -3936,7 +3832,7 @@
           <p:cNvPr id="5" name="Date Placeholder 4">
             <a:extLst xmlns:a="http://schemas.openxmlformats.org/drawingml/2006/main">
               <a:ext uri="{FF2B5EF4-FFF2-40B4-BE49-F238E27FC236}">
-                <a16:creationId xmlns:a16="http://schemas.microsoft.com/office/drawing/2014/main" id="{242F3C52-AA8B-4147-95EE-554F89AF5E42}"/>
+                <a16:creationId xmlns:a16="http://schemas.microsoft.com/office/drawing/2014/main" id="{FD16852F-FB0F-4C62-AF3A-12D8476CF53B}"/>
               </a:ext>
             </a:extLst>
           </p:cNvPr>
@@ -3964,7 +3860,7 @@
           <p:cNvPr id="6" name="Footer Placeholder 5">
             <a:extLst xmlns:a="http://schemas.openxmlformats.org/drawingml/2006/main">
               <a:ext uri="{FF2B5EF4-FFF2-40B4-BE49-F238E27FC236}">
-                <a16:creationId xmlns:a16="http://schemas.microsoft.com/office/drawing/2014/main" id="{66A5DEFB-A92E-4043-B582-3836E07F2104}"/>
+                <a16:creationId xmlns:a16="http://schemas.microsoft.com/office/drawing/2014/main" id="{E6F301B7-25B5-4BB5-87F7-7D4082974985}"/>
               </a:ext>
             </a:extLst>
           </p:cNvPr>
@@ -3989,7 +3885,7 @@
           <p:cNvPr id="7" name="Slide Number Placeholder 6">
             <a:extLst xmlns:a="http://schemas.openxmlformats.org/drawingml/2006/main">
               <a:ext uri="{FF2B5EF4-FFF2-40B4-BE49-F238E27FC236}">
-                <a16:creationId xmlns:a16="http://schemas.microsoft.com/office/drawing/2014/main" id="{DF1B298A-5688-4720-99AA-4350ABFA3AB2}"/>
+                <a16:creationId xmlns:a16="http://schemas.microsoft.com/office/drawing/2014/main" id="{A2F24F8E-8F58-4C41-BCAC-06B585776A74}"/>
               </a:ext>
             </a:extLst>
           </p:cNvPr>
@@ -4034,7 +3930,7 @@
           <p:cNvPr id="2" name="Title 1">
             <a:extLst xmlns:a="http://schemas.openxmlformats.org/drawingml/2006/main">
               <a:ext uri="{FF2B5EF4-FFF2-40B4-BE49-F238E27FC236}">
-                <a16:creationId xmlns:a16="http://schemas.microsoft.com/office/drawing/2014/main" id="{D923245B-436B-411C-B512-3AA2E94EB8FA}"/>
+                <a16:creationId xmlns:a16="http://schemas.microsoft.com/office/drawing/2014/main" id="{24E8A200-E5CF-4386-93EC-E474BB509059}"/>
               </a:ext>
             </a:extLst>
           </p:cNvPr>
@@ -4072,7 +3968,7 @@
           <p:cNvPr id="3" name="Picture Placeholder 2">
             <a:extLst xmlns:a="http://schemas.openxmlformats.org/drawingml/2006/main">
               <a:ext uri="{FF2B5EF4-FFF2-40B4-BE49-F238E27FC236}">
-                <a16:creationId xmlns:a16="http://schemas.microsoft.com/office/drawing/2014/main" id="{136BA8FA-9CD9-460F-9930-9CD4E71AF6CE}"/>
+                <a16:creationId xmlns:a16="http://schemas.microsoft.com/office/drawing/2014/main" id="{4152B39F-9205-458F-B8D1-24DF06676D38}"/>
               </a:ext>
             </a:extLst>
           </p:cNvPr>
@@ -4139,7 +4035,7 @@
           <p:cNvPr id="4" name="Text Placeholder 3">
             <a:extLst xmlns:a="http://schemas.openxmlformats.org/drawingml/2006/main">
               <a:ext uri="{FF2B5EF4-FFF2-40B4-BE49-F238E27FC236}">
-                <a16:creationId xmlns:a16="http://schemas.microsoft.com/office/drawing/2014/main" id="{46ED022F-DB5A-4E9B-B429-74377EF97F5A}"/>
+                <a16:creationId xmlns:a16="http://schemas.microsoft.com/office/drawing/2014/main" id="{45E56CC9-9381-41E0-81A4-0B4942A2ECF9}"/>
               </a:ext>
             </a:extLst>
           </p:cNvPr>
@@ -4211,7 +4107,7 @@
           <p:cNvPr id="5" name="Date Placeholder 4">
             <a:extLst xmlns:a="http://schemas.openxmlformats.org/drawingml/2006/main">
               <a:ext uri="{FF2B5EF4-FFF2-40B4-BE49-F238E27FC236}">
-                <a16:creationId xmlns:a16="http://schemas.microsoft.com/office/drawing/2014/main" id="{095CD0E5-43A0-4A37-8229-D2926C683840}"/>
+                <a16:creationId xmlns:a16="http://schemas.microsoft.com/office/drawing/2014/main" id="{3CFEE3A6-651F-4ADE-9CF3-360EBB69520E}"/>
               </a:ext>
             </a:extLst>
           </p:cNvPr>
@@ -4239,7 +4135,7 @@
           <p:cNvPr id="6" name="Footer Placeholder 5">
             <a:extLst xmlns:a="http://schemas.openxmlformats.org/drawingml/2006/main">
               <a:ext uri="{FF2B5EF4-FFF2-40B4-BE49-F238E27FC236}">
-                <a16:creationId xmlns:a16="http://schemas.microsoft.com/office/drawing/2014/main" id="{9346499C-FAC8-413E-96CA-389C73280D8A}"/>
+                <a16:creationId xmlns:a16="http://schemas.microsoft.com/office/drawing/2014/main" id="{6BB63E21-47F4-4557-AA75-0C7BACD9D59C}"/>
               </a:ext>
             </a:extLst>
           </p:cNvPr>
@@ -4264,7 +4160,7 @@
           <p:cNvPr id="7" name="Slide Number Placeholder 6">
             <a:extLst xmlns:a="http://schemas.openxmlformats.org/drawingml/2006/main">
               <a:ext uri="{FF2B5EF4-FFF2-40B4-BE49-F238E27FC236}">
-                <a16:creationId xmlns:a16="http://schemas.microsoft.com/office/drawing/2014/main" id="{E1EC58BA-0EF4-42DC-AF3E-AE6249739F8D}"/>
+                <a16:creationId xmlns:a16="http://schemas.microsoft.com/office/drawing/2014/main" id="{DFAD7CB1-A8B3-4FC5-8DB3-D10AF256027E}"/>
               </a:ext>
             </a:extLst>
           </p:cNvPr>
@@ -4314,7 +4210,7 @@
           <p:cNvPr id="2" name="Title Placeholder 1">
             <a:extLst xmlns:a="http://schemas.openxmlformats.org/drawingml/2006/main">
               <a:ext uri="{FF2B5EF4-FFF2-40B4-BE49-F238E27FC236}">
-                <a16:creationId xmlns:a16="http://schemas.microsoft.com/office/drawing/2014/main" id="{2A3BB33D-D24D-4F84-BC82-54AD037DAA32}"/>
+                <a16:creationId xmlns:a16="http://schemas.microsoft.com/office/drawing/2014/main" id="{625D702C-E895-466C-8454-3D8EDB1373FB}"/>
               </a:ext>
             </a:extLst>
           </p:cNvPr>
@@ -4352,7 +4248,7 @@
           <p:cNvPr id="3" name="Text Placeholder 2">
             <a:extLst xmlns:a="http://schemas.openxmlformats.org/drawingml/2006/main">
               <a:ext uri="{FF2B5EF4-FFF2-40B4-BE49-F238E27FC236}">
-                <a16:creationId xmlns:a16="http://schemas.microsoft.com/office/drawing/2014/main" id="{64499598-DA6D-4E98-AF73-F004098F1D01}"/>
+                <a16:creationId xmlns:a16="http://schemas.microsoft.com/office/drawing/2014/main" id="{CC29110E-DAC7-4A06-A0E0-EA23312FB55A}"/>
               </a:ext>
             </a:extLst>
           </p:cNvPr>
@@ -4425,7 +4321,7 @@
           <p:cNvPr id="4" name="Date Placeholder 3">
             <a:extLst xmlns:a="http://schemas.openxmlformats.org/drawingml/2006/main">
               <a:ext uri="{FF2B5EF4-FFF2-40B4-BE49-F238E27FC236}">
-                <a16:creationId xmlns:a16="http://schemas.microsoft.com/office/drawing/2014/main" id="{17A493F0-BEA0-4D38-9A6F-6A5F58F7C24E}"/>
+                <a16:creationId xmlns:a16="http://schemas.microsoft.com/office/drawing/2014/main" id="{D1045C35-1C2C-4964-9984-3A90ACE9D0B2}"/>
               </a:ext>
             </a:extLst>
           </p:cNvPr>
@@ -4472,7 +4368,7 @@
           <p:cNvPr id="5" name="Footer Placeholder 4">
             <a:extLst xmlns:a="http://schemas.openxmlformats.org/drawingml/2006/main">
               <a:ext uri="{FF2B5EF4-FFF2-40B4-BE49-F238E27FC236}">
-                <a16:creationId xmlns:a16="http://schemas.microsoft.com/office/drawing/2014/main" id="{72969A1B-6ED8-41E4-AA7C-2E59851F47EA}"/>
+                <a16:creationId xmlns:a16="http://schemas.microsoft.com/office/drawing/2014/main" id="{031A3CAA-3232-47D7-A378-AEB0CFB836F4}"/>
               </a:ext>
             </a:extLst>
           </p:cNvPr>
@@ -4516,7 +4412,7 @@
           <p:cNvPr id="6" name="Slide Number Placeholder 5">
             <a:extLst xmlns:a="http://schemas.openxmlformats.org/drawingml/2006/main">
               <a:ext uri="{FF2B5EF4-FFF2-40B4-BE49-F238E27FC236}">
-                <a16:creationId xmlns:a16="http://schemas.microsoft.com/office/drawing/2014/main" id="{2389C5C2-E527-4468-9B34-AA72C271C54E}"/>
+                <a16:creationId xmlns:a16="http://schemas.microsoft.com/office/drawing/2014/main" id="{D201BFAD-5481-417D-A24A-D39DAD915346}"/>
               </a:ext>
             </a:extLst>
           </p:cNvPr>
@@ -4562,17 +4458,17 @@
   </p:cSld>
   <p:clrMap bg1="lt1" tx1="dk1" bg2="lt2" tx2="dk2" accent1="accent1" accent2="accent2" accent3="accent3" accent4="accent4" accent5="accent5" accent6="accent6" hlink="hlink" folHlink="folHlink"/>
   <p:sldLayoutIdLst>
-    <p:sldLayoutId xmlns:r="http://schemas.openxmlformats.org/officeDocument/2006/relationships" id="2147483649" r:id="Rc77cdf9612a340ee"/>
-    <p:sldLayoutId xmlns:r="http://schemas.openxmlformats.org/officeDocument/2006/relationships" id="2147483650" r:id="Re7b0d9f703b64e81"/>
-    <p:sldLayoutId xmlns:r="http://schemas.openxmlformats.org/officeDocument/2006/relationships" id="2147483651" r:id="R09e93bdc6a054ec1"/>
-    <p:sldLayoutId xmlns:r="http://schemas.openxmlformats.org/officeDocument/2006/relationships" id="2147483652" r:id="Rfca96abff1af4a2c"/>
-    <p:sldLayoutId xmlns:r="http://schemas.openxmlformats.org/officeDocument/2006/relationships" id="2147483653" r:id="R6991690e8e1442fd"/>
-    <p:sldLayoutId xmlns:r="http://schemas.openxmlformats.org/officeDocument/2006/relationships" id="2147483654" r:id="R4e5f3a70febe44d8"/>
-    <p:sldLayoutId xmlns:r="http://schemas.openxmlformats.org/officeDocument/2006/relationships" id="2147483655" r:id="Rfbe69c0add00403e"/>
-    <p:sldLayoutId xmlns:r="http://schemas.openxmlformats.org/officeDocument/2006/relationships" id="2147483656" r:id="R4aca5faec19c4848"/>
-    <p:sldLayoutId xmlns:r="http://schemas.openxmlformats.org/officeDocument/2006/relationships" id="2147483657" r:id="R69191f587b484eb7"/>
-    <p:sldLayoutId xmlns:r="http://schemas.openxmlformats.org/officeDocument/2006/relationships" id="2147483658" r:id="Rbf116496eff242c7"/>
-    <p:sldLayoutId xmlns:r="http://schemas.openxmlformats.org/officeDocument/2006/relationships" id="2147483659" r:id="R6345aa8f29d84379"/>
+    <p:sldLayoutId xmlns:r="http://schemas.openxmlformats.org/officeDocument/2006/relationships" id="2147483649" r:id="Rbe3f4dcd868c4f91"/>
+    <p:sldLayoutId xmlns:r="http://schemas.openxmlformats.org/officeDocument/2006/relationships" id="2147483650" r:id="Rf1705a2f0f574639"/>
+    <p:sldLayoutId xmlns:r="http://schemas.openxmlformats.org/officeDocument/2006/relationships" id="2147483651" r:id="Rfbd564c9f1d94404"/>
+    <p:sldLayoutId xmlns:r="http://schemas.openxmlformats.org/officeDocument/2006/relationships" id="2147483652" r:id="R2e0156205a89419b"/>
+    <p:sldLayoutId xmlns:r="http://schemas.openxmlformats.org/officeDocument/2006/relationships" id="2147483653" r:id="Rd87eb4e560e34a58"/>
+    <p:sldLayoutId xmlns:r="http://schemas.openxmlformats.org/officeDocument/2006/relationships" id="2147483654" r:id="R157e5c00cf6f4b4e"/>
+    <p:sldLayoutId xmlns:r="http://schemas.openxmlformats.org/officeDocument/2006/relationships" id="2147483655" r:id="R3485bf098ba94de7"/>
+    <p:sldLayoutId xmlns:r="http://schemas.openxmlformats.org/officeDocument/2006/relationships" id="2147483656" r:id="R4bd5eda1ee5146f4"/>
+    <p:sldLayoutId xmlns:r="http://schemas.openxmlformats.org/officeDocument/2006/relationships" id="2147483657" r:id="R2b061fe7302943d7"/>
+    <p:sldLayoutId xmlns:r="http://schemas.openxmlformats.org/officeDocument/2006/relationships" id="2147483658" r:id="R1ed700f4b8b64f8e"/>
+    <p:sldLayoutId xmlns:r="http://schemas.openxmlformats.org/officeDocument/2006/relationships" id="2147483659" r:id="R9cb67aea190d405c"/>
   </p:sldLayoutIdLst>
   <p:txStyles>
     <p:titleStyle>
@@ -5118,7 +5014,7 @@
           <p:cNvPr id="2" name="Rectangle 1">
             <a:extLst xmlns:a="http://schemas.openxmlformats.org/drawingml/2006/main">
               <a:ext uri="{FF2B5EF4-FFF2-40B4-BE49-F238E27FC236}">
-                <a16:creationId xmlns:a16="http://schemas.microsoft.com/office/drawing/2014/main" id="{4199313A-B210-46C0-AB89-536416FF0231}"/>
+                <a16:creationId xmlns:a16="http://schemas.microsoft.com/office/drawing/2014/main" id="{1A9204AE-B44C-47CC-BEA4-26E4E3E74C08}"/>
               </a:ext>
             </a:extLst>
           </p:cNvPr>
@@ -5171,7 +5067,7 @@
           <p:cNvPr id="3" name="Rectangle 2">
             <a:extLst xmlns:a="http://schemas.openxmlformats.org/drawingml/2006/main">
               <a:ext uri="{FF2B5EF4-FFF2-40B4-BE49-F238E27FC236}">
-                <a16:creationId xmlns:a16="http://schemas.microsoft.com/office/drawing/2014/main" id="{3D3AE276-69DC-43A8-926A-3D4BFF401C81}"/>
+                <a16:creationId xmlns:a16="http://schemas.microsoft.com/office/drawing/2014/main" id="{D5E43A13-1DE5-4391-939E-9025D902AA84}"/>
               </a:ext>
             </a:extLst>
           </p:cNvPr>
@@ -5224,7 +5120,7 @@
           <p:cNvPr id="4" name="TextBox 3">
             <a:extLst xmlns:a="http://schemas.openxmlformats.org/drawingml/2006/main">
               <a:ext uri="{FF2B5EF4-FFF2-40B4-BE49-F238E27FC236}">
-                <a16:creationId xmlns:a16="http://schemas.microsoft.com/office/drawing/2014/main" id="{1B18E688-2AAF-4BA3-88EC-5515E6420FCF}"/>
+                <a16:creationId xmlns:a16="http://schemas.microsoft.com/office/drawing/2014/main" id="{78FB1B37-9628-434E-8048-51DD12CF87AE}"/>
               </a:ext>
             </a:extLst>
           </p:cNvPr>
@@ -5326,7 +5222,7 @@
     </p:spTree>
     <p:extLst>
       <p:ext uri="{BB962C8B-B14F-4D97-AF65-F5344CB8AC3E}">
-        <p14:creationId xmlns:p14="http://schemas.microsoft.com/office/powerpoint/2010/main" val="1277625031"/>
+        <p14:creationId xmlns:p14="http://schemas.microsoft.com/office/powerpoint/2010/main" val="1244413541"/>
       </p:ext>
     </p:extLst>
   </p:cSld>
@@ -5350,7 +5246,7 @@
           <p:cNvPr id="2" name="Rectangle 1">
             <a:extLst xmlns:a="http://schemas.openxmlformats.org/drawingml/2006/main">
               <a:ext uri="{FF2B5EF4-FFF2-40B4-BE49-F238E27FC236}">
-                <a16:creationId xmlns:a16="http://schemas.microsoft.com/office/drawing/2014/main" id="{B60AAEDF-78C7-46F0-97DB-D5E7659FCC5B}"/>
+                <a16:creationId xmlns:a16="http://schemas.microsoft.com/office/drawing/2014/main" id="{A5079CB4-1562-48AF-805F-F2F248CF8D3A}"/>
               </a:ext>
             </a:extLst>
           </p:cNvPr>
@@ -5403,7 +5299,7 @@
           <p:cNvPr id="3" name="Rectangle 2">
             <a:extLst xmlns:a="http://schemas.openxmlformats.org/drawingml/2006/main">
               <a:ext uri="{FF2B5EF4-FFF2-40B4-BE49-F238E27FC236}">
-                <a16:creationId xmlns:a16="http://schemas.microsoft.com/office/drawing/2014/main" id="{AB57A5C7-3428-4B09-894C-2AE7B3410003}"/>
+                <a16:creationId xmlns:a16="http://schemas.microsoft.com/office/drawing/2014/main" id="{754B5928-703C-4EC3-98F4-D4698C52D594}"/>
               </a:ext>
             </a:extLst>
           </p:cNvPr>
@@ -5456,7 +5352,7 @@
           <p:cNvPr id="4" name="Rectangle 3">
             <a:extLst xmlns:a="http://schemas.openxmlformats.org/drawingml/2006/main">
               <a:ext uri="{FF2B5EF4-FFF2-40B4-BE49-F238E27FC236}">
-                <a16:creationId xmlns:a16="http://schemas.microsoft.com/office/drawing/2014/main" id="{5A842B13-96CA-4507-8499-6A95E8360D96}"/>
+                <a16:creationId xmlns:a16="http://schemas.microsoft.com/office/drawing/2014/main" id="{FA5320BD-72D3-4D60-A1EC-134923C0CFB7}"/>
               </a:ext>
             </a:extLst>
           </p:cNvPr>
@@ -5509,7 +5405,7 @@
           <p:cNvPr id="5" name="TextBox 4">
             <a:extLst xmlns:a="http://schemas.openxmlformats.org/drawingml/2006/main">
               <a:ext uri="{FF2B5EF4-FFF2-40B4-BE49-F238E27FC236}">
-                <a16:creationId xmlns:a16="http://schemas.microsoft.com/office/drawing/2014/main" id="{DCDCD2A3-FAFD-4C3D-BE68-97DAE7EED957}"/>
+                <a16:creationId xmlns:a16="http://schemas.microsoft.com/office/drawing/2014/main" id="{217267DC-CFEE-49B1-B5B0-7F0688BC172C}"/>
               </a:ext>
             </a:extLst>
           </p:cNvPr>
@@ -5572,7 +5468,7 @@
           <p:cNvPr id="6" name="Rounded Rectangle 5">
             <a:extLst xmlns:a="http://schemas.openxmlformats.org/drawingml/2006/main">
               <a:ext uri="{FF2B5EF4-FFF2-40B4-BE49-F238E27FC236}">
-                <a16:creationId xmlns:a16="http://schemas.microsoft.com/office/drawing/2014/main" id="{F26F6E0F-96FB-41D7-8315-A6B5B116D60B}"/>
+                <a16:creationId xmlns:a16="http://schemas.microsoft.com/office/drawing/2014/main" id="{2432E737-76BA-49D1-B8F5-0FE0564FA169}"/>
               </a:ext>
             </a:extLst>
           </p:cNvPr>
@@ -5627,7 +5523,7 @@
           <p:cNvPr id="7" name="TextBox 6">
             <a:extLst xmlns:a="http://schemas.openxmlformats.org/drawingml/2006/main">
               <a:ext uri="{FF2B5EF4-FFF2-40B4-BE49-F238E27FC236}">
-                <a16:creationId xmlns:a16="http://schemas.microsoft.com/office/drawing/2014/main" id="{0B8394A9-2B95-479B-BC0A-B4EA6E2A3DF7}"/>
+                <a16:creationId xmlns:a16="http://schemas.microsoft.com/office/drawing/2014/main" id="{16C169C2-E485-4C82-B023-D25CB28DFA8C}"/>
               </a:ext>
             </a:extLst>
           </p:cNvPr>
@@ -5731,7 +5627,7 @@
           <p:cNvPr id="8" name="Rounded Rectangle 7">
             <a:extLst xmlns:a="http://schemas.openxmlformats.org/drawingml/2006/main">
               <a:ext uri="{FF2B5EF4-FFF2-40B4-BE49-F238E27FC236}">
-                <a16:creationId xmlns:a16="http://schemas.microsoft.com/office/drawing/2014/main" id="{F328F80A-3E93-414A-81F2-5FEB3D957C31}"/>
+                <a16:creationId xmlns:a16="http://schemas.microsoft.com/office/drawing/2014/main" id="{9A007036-B3AF-4926-9FA2-CFE5C211E851}"/>
               </a:ext>
             </a:extLst>
           </p:cNvPr>
@@ -5786,7 +5682,7 @@
           <p:cNvPr id="9" name="TextBox 8">
             <a:extLst xmlns:a="http://schemas.openxmlformats.org/drawingml/2006/main">
               <a:ext uri="{FF2B5EF4-FFF2-40B4-BE49-F238E27FC236}">
-                <a16:creationId xmlns:a16="http://schemas.microsoft.com/office/drawing/2014/main" id="{C3BC5DEC-3A0E-4989-BD90-FF4292DC1882}"/>
+                <a16:creationId xmlns:a16="http://schemas.microsoft.com/office/drawing/2014/main" id="{64FDB06D-4BAA-4085-83C3-82BD67687E6A}"/>
               </a:ext>
             </a:extLst>
           </p:cNvPr>
@@ -5871,7 +5767,7 @@
           <p:cNvPr id="10" name="Rounded Rectangle 9">
             <a:extLst xmlns:a="http://schemas.openxmlformats.org/drawingml/2006/main">
               <a:ext uri="{FF2B5EF4-FFF2-40B4-BE49-F238E27FC236}">
-                <a16:creationId xmlns:a16="http://schemas.microsoft.com/office/drawing/2014/main" id="{6581D62E-AD33-49C0-A650-6C6A0D8C67D5}"/>
+                <a16:creationId xmlns:a16="http://schemas.microsoft.com/office/drawing/2014/main" id="{FBA861AD-D277-47CF-99F2-E4169E665547}"/>
               </a:ext>
             </a:extLst>
           </p:cNvPr>
@@ -5926,7 +5822,7 @@
           <p:cNvPr id="11" name="TextBox 10">
             <a:extLst xmlns:a="http://schemas.openxmlformats.org/drawingml/2006/main">
               <a:ext uri="{FF2B5EF4-FFF2-40B4-BE49-F238E27FC236}">
-                <a16:creationId xmlns:a16="http://schemas.microsoft.com/office/drawing/2014/main" id="{328ABD2B-304F-45C5-A045-86A47CEAA927}"/>
+                <a16:creationId xmlns:a16="http://schemas.microsoft.com/office/drawing/2014/main" id="{C04A546D-B3D7-4169-8470-8A6B6D6B056E}"/>
               </a:ext>
             </a:extLst>
           </p:cNvPr>
@@ -6028,7 +5924,7 @@
     </p:spTree>
     <p:extLst>
       <p:ext uri="{BB962C8B-B14F-4D97-AF65-F5344CB8AC3E}">
-        <p14:creationId xmlns:p14="http://schemas.microsoft.com/office/powerpoint/2010/main" val="452905077"/>
+        <p14:creationId xmlns:p14="http://schemas.microsoft.com/office/powerpoint/2010/main" val="2112739995"/>
       </p:ext>
     </p:extLst>
   </p:cSld>
@@ -6052,7 +5948,7 @@
           <p:cNvPr id="2" name="Rectangle 1">
             <a:extLst xmlns:a="http://schemas.openxmlformats.org/drawingml/2006/main">
               <a:ext uri="{FF2B5EF4-FFF2-40B4-BE49-F238E27FC236}">
-                <a16:creationId xmlns:a16="http://schemas.microsoft.com/office/drawing/2014/main" id="{8F549AB4-460E-4DA0-85F2-EB66D2E62594}"/>
+                <a16:creationId xmlns:a16="http://schemas.microsoft.com/office/drawing/2014/main" id="{1E5461AB-EB93-48CE-A6C9-D1FC9AB412BF}"/>
               </a:ext>
             </a:extLst>
           </p:cNvPr>
@@ -6105,7 +6001,7 @@
           <p:cNvPr id="3" name="Rectangle 2">
             <a:extLst xmlns:a="http://schemas.openxmlformats.org/drawingml/2006/main">
               <a:ext uri="{FF2B5EF4-FFF2-40B4-BE49-F238E27FC236}">
-                <a16:creationId xmlns:a16="http://schemas.microsoft.com/office/drawing/2014/main" id="{CAF8AFC4-39E8-4106-9179-74D307226E21}"/>
+                <a16:creationId xmlns:a16="http://schemas.microsoft.com/office/drawing/2014/main" id="{D3204BBF-9954-4F0E-B24C-40CC16575700}"/>
               </a:ext>
             </a:extLst>
           </p:cNvPr>
@@ -6158,7 +6054,7 @@
           <p:cNvPr id="4" name="Rectangle 3">
             <a:extLst xmlns:a="http://schemas.openxmlformats.org/drawingml/2006/main">
               <a:ext uri="{FF2B5EF4-FFF2-40B4-BE49-F238E27FC236}">
-                <a16:creationId xmlns:a16="http://schemas.microsoft.com/office/drawing/2014/main" id="{A7FC2C38-4B67-49CA-A04A-285494AE6FCA}"/>
+                <a16:creationId xmlns:a16="http://schemas.microsoft.com/office/drawing/2014/main" id="{EE2794B3-112F-4183-AF1F-1AE2AECF5517}"/>
               </a:ext>
             </a:extLst>
           </p:cNvPr>
@@ -6211,7 +6107,7 @@
           <p:cNvPr id="5" name="TextBox 4">
             <a:extLst xmlns:a="http://schemas.openxmlformats.org/drawingml/2006/main">
               <a:ext uri="{FF2B5EF4-FFF2-40B4-BE49-F238E27FC236}">
-                <a16:creationId xmlns:a16="http://schemas.microsoft.com/office/drawing/2014/main" id="{8808532B-0A55-4D7D-8863-C77FB6CD1769}"/>
+                <a16:creationId xmlns:a16="http://schemas.microsoft.com/office/drawing/2014/main" id="{BD50A6C4-BF56-410F-96B7-C62D23FC2134}"/>
               </a:ext>
             </a:extLst>
           </p:cNvPr>
@@ -6274,7 +6170,7 @@
           <p:cNvPr id="6" name="Rounded Rectangle 5">
             <a:extLst xmlns:a="http://schemas.openxmlformats.org/drawingml/2006/main">
               <a:ext uri="{FF2B5EF4-FFF2-40B4-BE49-F238E27FC236}">
-                <a16:creationId xmlns:a16="http://schemas.microsoft.com/office/drawing/2014/main" id="{C5A2118F-682B-4A5F-9313-589843F6FFCF}"/>
+                <a16:creationId xmlns:a16="http://schemas.microsoft.com/office/drawing/2014/main" id="{AD1D43EC-AECC-4B33-A7A5-D0D6BC00FCAA}"/>
               </a:ext>
             </a:extLst>
           </p:cNvPr>
@@ -6329,7 +6225,7 @@
           <p:cNvPr id="7" name="TextBox 6">
             <a:extLst xmlns:a="http://schemas.openxmlformats.org/drawingml/2006/main">
               <a:ext uri="{FF2B5EF4-FFF2-40B4-BE49-F238E27FC236}">
-                <a16:creationId xmlns:a16="http://schemas.microsoft.com/office/drawing/2014/main" id="{1605524E-685F-4938-80D6-AE79AAA230C2}"/>
+                <a16:creationId xmlns:a16="http://schemas.microsoft.com/office/drawing/2014/main" id="{1193F931-9650-414E-914E-DE16A6607D56}"/>
               </a:ext>
             </a:extLst>
           </p:cNvPr>
@@ -6528,7 +6424,7 @@
           <p:cNvPr id="8" name="Rounded Rectangle 7">
             <a:extLst xmlns:a="http://schemas.openxmlformats.org/drawingml/2006/main">
               <a:ext uri="{FF2B5EF4-FFF2-40B4-BE49-F238E27FC236}">
-                <a16:creationId xmlns:a16="http://schemas.microsoft.com/office/drawing/2014/main" id="{E1EC6CF1-99F8-405D-9BAF-BCCFD3AFFEF1}"/>
+                <a16:creationId xmlns:a16="http://schemas.microsoft.com/office/drawing/2014/main" id="{4D4FC0A7-964A-440B-BE37-4E3DBF8804A9}"/>
               </a:ext>
             </a:extLst>
           </p:cNvPr>
@@ -6583,7 +6479,7 @@
           <p:cNvPr id="9" name="TextBox 8">
             <a:extLst xmlns:a="http://schemas.openxmlformats.org/drawingml/2006/main">
               <a:ext uri="{FF2B5EF4-FFF2-40B4-BE49-F238E27FC236}">
-                <a16:creationId xmlns:a16="http://schemas.microsoft.com/office/drawing/2014/main" id="{84F074CB-40CD-4F57-88C9-7F01163E5EEF}"/>
+                <a16:creationId xmlns:a16="http://schemas.microsoft.com/office/drawing/2014/main" id="{06C76F78-7A4E-4717-B726-328777A2B9A2}"/>
               </a:ext>
             </a:extLst>
           </p:cNvPr>
@@ -6704,7 +6600,7 @@
     </p:spTree>
     <p:extLst>
       <p:ext uri="{BB962C8B-B14F-4D97-AF65-F5344CB8AC3E}">
-        <p14:creationId xmlns:p14="http://schemas.microsoft.com/office/powerpoint/2010/main" val="1471973507"/>
+        <p14:creationId xmlns:p14="http://schemas.microsoft.com/office/powerpoint/2010/main" val="732313307"/>
       </p:ext>
     </p:extLst>
   </p:cSld>
@@ -6728,7 +6624,7 @@
           <p:cNvPr id="2" name="Rectangle 1">
             <a:extLst xmlns:a="http://schemas.openxmlformats.org/drawingml/2006/main">
               <a:ext uri="{FF2B5EF4-FFF2-40B4-BE49-F238E27FC236}">
-                <a16:creationId xmlns:a16="http://schemas.microsoft.com/office/drawing/2014/main" id="{DA8B50DC-F328-42EE-AFB0-47416775AA85}"/>
+                <a16:creationId xmlns:a16="http://schemas.microsoft.com/office/drawing/2014/main" id="{81E1CC92-CE88-476F-8AA9-8165F085B081}"/>
               </a:ext>
             </a:extLst>
           </p:cNvPr>
@@ -6781,7 +6677,7 @@
           <p:cNvPr id="3" name="Rectangle 2">
             <a:extLst xmlns:a="http://schemas.openxmlformats.org/drawingml/2006/main">
               <a:ext uri="{FF2B5EF4-FFF2-40B4-BE49-F238E27FC236}">
-                <a16:creationId xmlns:a16="http://schemas.microsoft.com/office/drawing/2014/main" id="{2A92FD4B-A03A-457C-9945-75E1E8335FB6}"/>
+                <a16:creationId xmlns:a16="http://schemas.microsoft.com/office/drawing/2014/main" id="{766F51BC-9D15-402E-B40D-BD290E01F4BD}"/>
               </a:ext>
             </a:extLst>
           </p:cNvPr>
@@ -6834,7 +6730,7 @@
           <p:cNvPr id="4" name="TextBox 3">
             <a:extLst xmlns:a="http://schemas.openxmlformats.org/drawingml/2006/main">
               <a:ext uri="{FF2B5EF4-FFF2-40B4-BE49-F238E27FC236}">
-                <a16:creationId xmlns:a16="http://schemas.microsoft.com/office/drawing/2014/main" id="{D3A29788-3534-4FB8-A956-83E3D9B9AD84}"/>
+                <a16:creationId xmlns:a16="http://schemas.microsoft.com/office/drawing/2014/main" id="{0F952296-647E-4FD3-A1AE-B288C4FB60D9}"/>
               </a:ext>
             </a:extLst>
           </p:cNvPr>
@@ -7012,7 +6908,7 @@
     </p:spTree>
     <p:extLst>
       <p:ext uri="{BB962C8B-B14F-4D97-AF65-F5344CB8AC3E}">
-        <p14:creationId xmlns:p14="http://schemas.microsoft.com/office/powerpoint/2010/main" val="404076202"/>
+        <p14:creationId xmlns:p14="http://schemas.microsoft.com/office/powerpoint/2010/main" val="1117890601"/>
       </p:ext>
     </p:extLst>
   </p:cSld>
@@ -7036,7 +6932,7 @@
           <p:cNvPr id="2" name="Rectangle 1">
             <a:extLst xmlns:a="http://schemas.openxmlformats.org/drawingml/2006/main">
               <a:ext uri="{FF2B5EF4-FFF2-40B4-BE49-F238E27FC236}">
-                <a16:creationId xmlns:a16="http://schemas.microsoft.com/office/drawing/2014/main" id="{6B1B9005-4D24-49B8-AAE5-87C411DC83A1}"/>
+                <a16:creationId xmlns:a16="http://schemas.microsoft.com/office/drawing/2014/main" id="{2A4B2E8A-C325-4057-BAB3-D5FFF0CF62AE}"/>
               </a:ext>
             </a:extLst>
           </p:cNvPr>
@@ -7089,7 +6985,7 @@
           <p:cNvPr id="3" name="Rectangle 2">
             <a:extLst xmlns:a="http://schemas.openxmlformats.org/drawingml/2006/main">
               <a:ext uri="{FF2B5EF4-FFF2-40B4-BE49-F238E27FC236}">
-                <a16:creationId xmlns:a16="http://schemas.microsoft.com/office/drawing/2014/main" id="{6A012BAB-F386-47AA-B3D7-AF4B6CCE633F}"/>
+                <a16:creationId xmlns:a16="http://schemas.microsoft.com/office/drawing/2014/main" id="{BCE03106-B560-43A8-A9AF-7F7F58457151}"/>
               </a:ext>
             </a:extLst>
           </p:cNvPr>
@@ -7142,7 +7038,7 @@
           <p:cNvPr id="4" name="Rectangle 3">
             <a:extLst xmlns:a="http://schemas.openxmlformats.org/drawingml/2006/main">
               <a:ext uri="{FF2B5EF4-FFF2-40B4-BE49-F238E27FC236}">
-                <a16:creationId xmlns:a16="http://schemas.microsoft.com/office/drawing/2014/main" id="{C1A4D744-A16B-47DB-B7DB-B614D744FB04}"/>
+                <a16:creationId xmlns:a16="http://schemas.microsoft.com/office/drawing/2014/main" id="{2F304F0B-1A31-49FC-84ED-692D6917F3B0}"/>
               </a:ext>
             </a:extLst>
           </p:cNvPr>
@@ -7195,7 +7091,7 @@
           <p:cNvPr id="5" name="TextBox 4">
             <a:extLst xmlns:a="http://schemas.openxmlformats.org/drawingml/2006/main">
               <a:ext uri="{FF2B5EF4-FFF2-40B4-BE49-F238E27FC236}">
-                <a16:creationId xmlns:a16="http://schemas.microsoft.com/office/drawing/2014/main" id="{F42ADB72-8A23-4B1B-AFFA-BBEABC99F3DC}"/>
+                <a16:creationId xmlns:a16="http://schemas.microsoft.com/office/drawing/2014/main" id="{C571EC1B-59FC-452C-90E5-BA28E4A6543C}"/>
               </a:ext>
             </a:extLst>
           </p:cNvPr>
@@ -7258,7 +7154,7 @@
           <p:cNvPr id="6" name="Rounded Rectangle 5">
             <a:extLst xmlns:a="http://schemas.openxmlformats.org/drawingml/2006/main">
               <a:ext uri="{FF2B5EF4-FFF2-40B4-BE49-F238E27FC236}">
-                <a16:creationId xmlns:a16="http://schemas.microsoft.com/office/drawing/2014/main" id="{1389A831-7D72-4579-B94B-277F7841E09D}"/>
+                <a16:creationId xmlns:a16="http://schemas.microsoft.com/office/drawing/2014/main" id="{B4B57932-A5E0-4B7D-BBF3-66DB06765B03}"/>
               </a:ext>
             </a:extLst>
           </p:cNvPr>
@@ -7313,7 +7209,7 @@
           <p:cNvPr id="7" name="TextBox 6">
             <a:extLst xmlns:a="http://schemas.openxmlformats.org/drawingml/2006/main">
               <a:ext uri="{FF2B5EF4-FFF2-40B4-BE49-F238E27FC236}">
-                <a16:creationId xmlns:a16="http://schemas.microsoft.com/office/drawing/2014/main" id="{DBA954BA-745C-4D07-98C5-63EC894C9C96}"/>
+                <a16:creationId xmlns:a16="http://schemas.microsoft.com/office/drawing/2014/main" id="{899434D0-6C6B-4A15-A6C8-26C02405A339}"/>
               </a:ext>
             </a:extLst>
           </p:cNvPr>
@@ -7417,7 +7313,7 @@
           <p:cNvPr id="8" name="Rounded Rectangle 7">
             <a:extLst xmlns:a="http://schemas.openxmlformats.org/drawingml/2006/main">
               <a:ext uri="{FF2B5EF4-FFF2-40B4-BE49-F238E27FC236}">
-                <a16:creationId xmlns:a16="http://schemas.microsoft.com/office/drawing/2014/main" id="{3520DA34-034F-4796-9F9C-8FF08FFC1595}"/>
+                <a16:creationId xmlns:a16="http://schemas.microsoft.com/office/drawing/2014/main" id="{A9EC9C70-3BB2-40A4-82F2-0F4B239262F8}"/>
               </a:ext>
             </a:extLst>
           </p:cNvPr>
@@ -7472,7 +7368,7 @@
           <p:cNvPr id="9" name="TextBox 8">
             <a:extLst xmlns:a="http://schemas.openxmlformats.org/drawingml/2006/main">
               <a:ext uri="{FF2B5EF4-FFF2-40B4-BE49-F238E27FC236}">
-                <a16:creationId xmlns:a16="http://schemas.microsoft.com/office/drawing/2014/main" id="{D4BE7D58-3214-46F7-A909-6AFDFD24D815}"/>
+                <a16:creationId xmlns:a16="http://schemas.microsoft.com/office/drawing/2014/main" id="{826ED784-724F-42CA-A92B-565963133B88}"/>
               </a:ext>
             </a:extLst>
           </p:cNvPr>
@@ -7576,7 +7472,7 @@
           <p:cNvPr id="10" name="Rounded Rectangle 9">
             <a:extLst xmlns:a="http://schemas.openxmlformats.org/drawingml/2006/main">
               <a:ext uri="{FF2B5EF4-FFF2-40B4-BE49-F238E27FC236}">
-                <a16:creationId xmlns:a16="http://schemas.microsoft.com/office/drawing/2014/main" id="{94DB9461-E086-481F-9C24-6C2E3815F71F}"/>
+                <a16:creationId xmlns:a16="http://schemas.microsoft.com/office/drawing/2014/main" id="{458BEC26-9F73-4968-A030-D41DB66166CA}"/>
               </a:ext>
             </a:extLst>
           </p:cNvPr>
@@ -7631,7 +7527,7 @@
           <p:cNvPr id="11" name="TextBox 10">
             <a:extLst xmlns:a="http://schemas.openxmlformats.org/drawingml/2006/main">
               <a:ext uri="{FF2B5EF4-FFF2-40B4-BE49-F238E27FC236}">
-                <a16:creationId xmlns:a16="http://schemas.microsoft.com/office/drawing/2014/main" id="{C99B1D73-58D5-4FAD-8881-A1529869ABE7}"/>
+                <a16:creationId xmlns:a16="http://schemas.microsoft.com/office/drawing/2014/main" id="{F910595E-8F41-4672-9DAC-0B78E7B7340E}"/>
               </a:ext>
             </a:extLst>
           </p:cNvPr>
@@ -7790,7 +7686,7 @@
     </p:spTree>
     <p:extLst>
       <p:ext uri="{BB962C8B-B14F-4D97-AF65-F5344CB8AC3E}">
-        <p14:creationId xmlns:p14="http://schemas.microsoft.com/office/powerpoint/2010/main" val="1600219143"/>
+        <p14:creationId xmlns:p14="http://schemas.microsoft.com/office/powerpoint/2010/main" val="471330300"/>
       </p:ext>
     </p:extLst>
   </p:cSld>
@@ -7814,7 +7710,7 @@
           <p:cNvPr id="2" name="Rectangle 1">
             <a:extLst xmlns:a="http://schemas.openxmlformats.org/drawingml/2006/main">
               <a:ext uri="{FF2B5EF4-FFF2-40B4-BE49-F238E27FC236}">
-                <a16:creationId xmlns:a16="http://schemas.microsoft.com/office/drawing/2014/main" id="{843C7357-8550-43B6-A996-258DAE551911}"/>
+                <a16:creationId xmlns:a16="http://schemas.microsoft.com/office/drawing/2014/main" id="{2945D280-3EA2-4684-94C7-7FA2DAB11EE9}"/>
               </a:ext>
             </a:extLst>
           </p:cNvPr>
@@ -7867,7 +7763,7 @@
           <p:cNvPr id="3" name="Rectangle 2">
             <a:extLst xmlns:a="http://schemas.openxmlformats.org/drawingml/2006/main">
               <a:ext uri="{FF2B5EF4-FFF2-40B4-BE49-F238E27FC236}">
-                <a16:creationId xmlns:a16="http://schemas.microsoft.com/office/drawing/2014/main" id="{2BD2F428-EFE1-4040-B5C4-ECABE4274A9F}"/>
+                <a16:creationId xmlns:a16="http://schemas.microsoft.com/office/drawing/2014/main" id="{9913BE19-3874-4D5D-B16F-0C5B42DBB4FC}"/>
               </a:ext>
             </a:extLst>
           </p:cNvPr>
@@ -7920,7 +7816,7 @@
           <p:cNvPr id="4" name="Rectangle 3">
             <a:extLst xmlns:a="http://schemas.openxmlformats.org/drawingml/2006/main">
               <a:ext uri="{FF2B5EF4-FFF2-40B4-BE49-F238E27FC236}">
-                <a16:creationId xmlns:a16="http://schemas.microsoft.com/office/drawing/2014/main" id="{BC51566E-80D3-4A6F-8BE4-0BB94D1063E6}"/>
+                <a16:creationId xmlns:a16="http://schemas.microsoft.com/office/drawing/2014/main" id="{90B240B6-4E10-4086-B218-59811802BF6C}"/>
               </a:ext>
             </a:extLst>
           </p:cNvPr>
@@ -7973,7 +7869,7 @@
           <p:cNvPr id="5" name="TextBox 4">
             <a:extLst xmlns:a="http://schemas.openxmlformats.org/drawingml/2006/main">
               <a:ext uri="{FF2B5EF4-FFF2-40B4-BE49-F238E27FC236}">
-                <a16:creationId xmlns:a16="http://schemas.microsoft.com/office/drawing/2014/main" id="{212FBD67-8373-4251-90F4-AE3C3A04BCD4}"/>
+                <a16:creationId xmlns:a16="http://schemas.microsoft.com/office/drawing/2014/main" id="{87701E11-A20C-41CA-8551-68CBB9200DE5}"/>
               </a:ext>
             </a:extLst>
           </p:cNvPr>
@@ -8036,7 +7932,7 @@
           <p:cNvPr id="6" name="Rounded Rectangle 5">
             <a:extLst xmlns:a="http://schemas.openxmlformats.org/drawingml/2006/main">
               <a:ext uri="{FF2B5EF4-FFF2-40B4-BE49-F238E27FC236}">
-                <a16:creationId xmlns:a16="http://schemas.microsoft.com/office/drawing/2014/main" id="{964DB797-7017-4483-9A7C-B4E8DF2DC0A6}"/>
+                <a16:creationId xmlns:a16="http://schemas.microsoft.com/office/drawing/2014/main" id="{5352DBAA-2331-4BF3-A67B-40BEAF3D8E22}"/>
               </a:ext>
             </a:extLst>
           </p:cNvPr>
@@ -8091,7 +7987,7 @@
           <p:cNvPr id="7" name="TextBox 6">
             <a:extLst xmlns:a="http://schemas.openxmlformats.org/drawingml/2006/main">
               <a:ext uri="{FF2B5EF4-FFF2-40B4-BE49-F238E27FC236}">
-                <a16:creationId xmlns:a16="http://schemas.microsoft.com/office/drawing/2014/main" id="{0380E14C-25C5-4A34-B638-8998EB24D941}"/>
+                <a16:creationId xmlns:a16="http://schemas.microsoft.com/office/drawing/2014/main" id="{C08CAB5D-06FB-4615-AAEE-B83F3BEDC582}"/>
               </a:ext>
             </a:extLst>
           </p:cNvPr>
@@ -8214,7 +8110,7 @@
           <p:cNvPr id="8" name="Rounded Rectangle 7">
             <a:extLst xmlns:a="http://schemas.openxmlformats.org/drawingml/2006/main">
               <a:ext uri="{FF2B5EF4-FFF2-40B4-BE49-F238E27FC236}">
-                <a16:creationId xmlns:a16="http://schemas.microsoft.com/office/drawing/2014/main" id="{AF9C4B3D-3331-4405-A792-7C8002742416}"/>
+                <a16:creationId xmlns:a16="http://schemas.microsoft.com/office/drawing/2014/main" id="{E799EC59-EC16-41D4-80E9-8D9F5D7F42E3}"/>
               </a:ext>
             </a:extLst>
           </p:cNvPr>
@@ -8269,7 +8165,7 @@
           <p:cNvPr id="9" name="TextBox 8">
             <a:extLst xmlns:a="http://schemas.openxmlformats.org/drawingml/2006/main">
               <a:ext uri="{FF2B5EF4-FFF2-40B4-BE49-F238E27FC236}">
-                <a16:creationId xmlns:a16="http://schemas.microsoft.com/office/drawing/2014/main" id="{3A1131B1-171B-46E1-90EA-874C3AB16214}"/>
+                <a16:creationId xmlns:a16="http://schemas.microsoft.com/office/drawing/2014/main" id="{5CE00759-1533-497E-A038-2351BC7304C9}"/>
               </a:ext>
             </a:extLst>
           </p:cNvPr>
@@ -8411,7 +8307,7 @@
           <p:cNvPr id="10" name="Rounded Rectangle 9">
             <a:extLst xmlns:a="http://schemas.openxmlformats.org/drawingml/2006/main">
               <a:ext uri="{FF2B5EF4-FFF2-40B4-BE49-F238E27FC236}">
-                <a16:creationId xmlns:a16="http://schemas.microsoft.com/office/drawing/2014/main" id="{A4B7F00E-6BAA-4991-904B-41E3C982B991}"/>
+                <a16:creationId xmlns:a16="http://schemas.microsoft.com/office/drawing/2014/main" id="{750C903F-9180-4980-A063-EDAE1AD13422}"/>
               </a:ext>
             </a:extLst>
           </p:cNvPr>
@@ -8466,7 +8362,7 @@
           <p:cNvPr id="11" name="TextBox 10">
             <a:extLst xmlns:a="http://schemas.openxmlformats.org/drawingml/2006/main">
               <a:ext uri="{FF2B5EF4-FFF2-40B4-BE49-F238E27FC236}">
-                <a16:creationId xmlns:a16="http://schemas.microsoft.com/office/drawing/2014/main" id="{DEBCCD14-AB57-4EFA-AF05-69A5A4FDB112}"/>
+                <a16:creationId xmlns:a16="http://schemas.microsoft.com/office/drawing/2014/main" id="{7CCBD16D-CF08-4239-88C2-EC146920739E}"/>
               </a:ext>
             </a:extLst>
           </p:cNvPr>
@@ -8568,7 +8464,7 @@
     </p:spTree>
     <p:extLst>
       <p:ext uri="{BB962C8B-B14F-4D97-AF65-F5344CB8AC3E}">
-        <p14:creationId xmlns:p14="http://schemas.microsoft.com/office/powerpoint/2010/main" val="1974168012"/>
+        <p14:creationId xmlns:p14="http://schemas.microsoft.com/office/powerpoint/2010/main" val="1183618080"/>
       </p:ext>
     </p:extLst>
   </p:cSld>
@@ -8592,7 +8488,7 @@
           <p:cNvPr id="2" name="Rectangle 1">
             <a:extLst xmlns:a="http://schemas.openxmlformats.org/drawingml/2006/main">
               <a:ext uri="{FF2B5EF4-FFF2-40B4-BE49-F238E27FC236}">
-                <a16:creationId xmlns:a16="http://schemas.microsoft.com/office/drawing/2014/main" id="{AF661C42-DFD1-489E-905C-BC0671251AF2}"/>
+                <a16:creationId xmlns:a16="http://schemas.microsoft.com/office/drawing/2014/main" id="{CC5A468A-0FD3-45A3-99B1-BA404CA11278}"/>
               </a:ext>
             </a:extLst>
           </p:cNvPr>
@@ -8645,7 +8541,7 @@
           <p:cNvPr id="3" name="Rectangle 2">
             <a:extLst xmlns:a="http://schemas.openxmlformats.org/drawingml/2006/main">
               <a:ext uri="{FF2B5EF4-FFF2-40B4-BE49-F238E27FC236}">
-                <a16:creationId xmlns:a16="http://schemas.microsoft.com/office/drawing/2014/main" id="{22D2CE23-C56D-4F67-BAE1-A7B97D769279}"/>
+                <a16:creationId xmlns:a16="http://schemas.microsoft.com/office/drawing/2014/main" id="{E7F4E103-0AC1-4C8C-A728-A1FBE56C3B89}"/>
               </a:ext>
             </a:extLst>
           </p:cNvPr>
@@ -8698,7 +8594,7 @@
           <p:cNvPr id="4" name="Rectangle 3">
             <a:extLst xmlns:a="http://schemas.openxmlformats.org/drawingml/2006/main">
               <a:ext uri="{FF2B5EF4-FFF2-40B4-BE49-F238E27FC236}">
-                <a16:creationId xmlns:a16="http://schemas.microsoft.com/office/drawing/2014/main" id="{1BA61EC4-1D0A-494E-9B7A-FA8683CAF9D2}"/>
+                <a16:creationId xmlns:a16="http://schemas.microsoft.com/office/drawing/2014/main" id="{43D4ABD5-44C4-459F-9EF7-EC5591521618}"/>
               </a:ext>
             </a:extLst>
           </p:cNvPr>
@@ -8751,7 +8647,7 @@
           <p:cNvPr id="5" name="TextBox 4">
             <a:extLst xmlns:a="http://schemas.openxmlformats.org/drawingml/2006/main">
               <a:ext uri="{FF2B5EF4-FFF2-40B4-BE49-F238E27FC236}">
-                <a16:creationId xmlns:a16="http://schemas.microsoft.com/office/drawing/2014/main" id="{487EAB0E-DD0B-4B82-B9C1-6B405004F2D3}"/>
+                <a16:creationId xmlns:a16="http://schemas.microsoft.com/office/drawing/2014/main" id="{A6B05412-064D-417E-AA2F-86C1F06671C8}"/>
               </a:ext>
             </a:extLst>
           </p:cNvPr>
@@ -8814,7 +8710,7 @@
           <p:cNvPr id="6" name="Rounded Rectangle 5">
             <a:extLst xmlns:a="http://schemas.openxmlformats.org/drawingml/2006/main">
               <a:ext uri="{FF2B5EF4-FFF2-40B4-BE49-F238E27FC236}">
-                <a16:creationId xmlns:a16="http://schemas.microsoft.com/office/drawing/2014/main" id="{4831058F-B31D-4C5F-A43B-4451FF20BAC0}"/>
+                <a16:creationId xmlns:a16="http://schemas.microsoft.com/office/drawing/2014/main" id="{A044DEB2-B7DA-485B-A509-5F184A698B72}"/>
               </a:ext>
             </a:extLst>
           </p:cNvPr>
@@ -8869,7 +8765,7 @@
           <p:cNvPr id="7" name="TextBox 6">
             <a:extLst xmlns:a="http://schemas.openxmlformats.org/drawingml/2006/main">
               <a:ext uri="{FF2B5EF4-FFF2-40B4-BE49-F238E27FC236}">
-                <a16:creationId xmlns:a16="http://schemas.microsoft.com/office/drawing/2014/main" id="{891BE0E5-72A3-46FA-995A-BEDC31EC9082}"/>
+                <a16:creationId xmlns:a16="http://schemas.microsoft.com/office/drawing/2014/main" id="{4D9B79DA-3037-436A-A9A5-3427A9792617}"/>
               </a:ext>
             </a:extLst>
           </p:cNvPr>
@@ -9049,7 +8945,7 @@
           <p:cNvPr id="8" name="Rounded Rectangle 7">
             <a:extLst xmlns:a="http://schemas.openxmlformats.org/drawingml/2006/main">
               <a:ext uri="{FF2B5EF4-FFF2-40B4-BE49-F238E27FC236}">
-                <a16:creationId xmlns:a16="http://schemas.microsoft.com/office/drawing/2014/main" id="{E429C07F-A8A9-4104-B846-93E1B6E613A3}"/>
+                <a16:creationId xmlns:a16="http://schemas.microsoft.com/office/drawing/2014/main" id="{DFF7E8D4-1B00-4D8A-B7A3-F39B1AD04CB8}"/>
               </a:ext>
             </a:extLst>
           </p:cNvPr>
@@ -9104,7 +9000,7 @@
           <p:cNvPr id="9" name="TextBox 8">
             <a:extLst xmlns:a="http://schemas.openxmlformats.org/drawingml/2006/main">
               <a:ext uri="{FF2B5EF4-FFF2-40B4-BE49-F238E27FC236}">
-                <a16:creationId xmlns:a16="http://schemas.microsoft.com/office/drawing/2014/main" id="{A0C24258-CCEF-4555-B0DC-CCE00E76745B}"/>
+                <a16:creationId xmlns:a16="http://schemas.microsoft.com/office/drawing/2014/main" id="{D9A495E4-B1F0-4D34-8B04-8EBBF3F3F711}"/>
               </a:ext>
             </a:extLst>
           </p:cNvPr>
@@ -9263,7 +9159,7 @@
     </p:spTree>
     <p:extLst>
       <p:ext uri="{BB962C8B-B14F-4D97-AF65-F5344CB8AC3E}">
-        <p14:creationId xmlns:p14="http://schemas.microsoft.com/office/powerpoint/2010/main" val="776759816"/>
+        <p14:creationId xmlns:p14="http://schemas.microsoft.com/office/powerpoint/2010/main" val="1986843225"/>
       </p:ext>
     </p:extLst>
   </p:cSld>
@@ -9287,7 +9183,7 @@
           <p:cNvPr id="2" name="Rectangle 1">
             <a:extLst xmlns:a="http://schemas.openxmlformats.org/drawingml/2006/main">
               <a:ext uri="{FF2B5EF4-FFF2-40B4-BE49-F238E27FC236}">
-                <a16:creationId xmlns:a16="http://schemas.microsoft.com/office/drawing/2014/main" id="{DFAC2CEE-E5A5-4CAD-A0B5-F99D2AC32309}"/>
+                <a16:creationId xmlns:a16="http://schemas.microsoft.com/office/drawing/2014/main" id="{BEC47524-EA3F-41C6-B2A9-59FBC50C087A}"/>
               </a:ext>
             </a:extLst>
           </p:cNvPr>
@@ -9340,7 +9236,7 @@
           <p:cNvPr id="3" name="Rectangle 2">
             <a:extLst xmlns:a="http://schemas.openxmlformats.org/drawingml/2006/main">
               <a:ext uri="{FF2B5EF4-FFF2-40B4-BE49-F238E27FC236}">
-                <a16:creationId xmlns:a16="http://schemas.microsoft.com/office/drawing/2014/main" id="{F3468B25-63BA-4A68-8D70-500D6B59D837}"/>
+                <a16:creationId xmlns:a16="http://schemas.microsoft.com/office/drawing/2014/main" id="{662C4A4D-C0A2-4A6E-99E7-8BE3361ED4E2}"/>
               </a:ext>
             </a:extLst>
           </p:cNvPr>
@@ -9393,7 +9289,7 @@
           <p:cNvPr id="4" name="Rectangle 3">
             <a:extLst xmlns:a="http://schemas.openxmlformats.org/drawingml/2006/main">
               <a:ext uri="{FF2B5EF4-FFF2-40B4-BE49-F238E27FC236}">
-                <a16:creationId xmlns:a16="http://schemas.microsoft.com/office/drawing/2014/main" id="{2BA98FCA-BA37-490D-9C8D-E518C4BCF21A}"/>
+                <a16:creationId xmlns:a16="http://schemas.microsoft.com/office/drawing/2014/main" id="{F819784A-AC14-4CB4-9DBD-7424D81B2EBC}"/>
               </a:ext>
             </a:extLst>
           </p:cNvPr>
@@ -9446,7 +9342,7 @@
           <p:cNvPr id="5" name="TextBox 4">
             <a:extLst xmlns:a="http://schemas.openxmlformats.org/drawingml/2006/main">
               <a:ext uri="{FF2B5EF4-FFF2-40B4-BE49-F238E27FC236}">
-                <a16:creationId xmlns:a16="http://schemas.microsoft.com/office/drawing/2014/main" id="{C1AF84EB-00B1-4815-ACA5-620CAFCE7A2A}"/>
+                <a16:creationId xmlns:a16="http://schemas.microsoft.com/office/drawing/2014/main" id="{EF52ED6E-ECC4-4FD2-A0B7-938676022EDF}"/>
               </a:ext>
             </a:extLst>
           </p:cNvPr>
@@ -9509,7 +9405,7 @@
           <p:cNvPr id="6" name="Rounded Rectangle 5">
             <a:extLst xmlns:a="http://schemas.openxmlformats.org/drawingml/2006/main">
               <a:ext uri="{FF2B5EF4-FFF2-40B4-BE49-F238E27FC236}">
-                <a16:creationId xmlns:a16="http://schemas.microsoft.com/office/drawing/2014/main" id="{245F03B6-A7B8-4128-9E03-699C90E89F66}"/>
+                <a16:creationId xmlns:a16="http://schemas.microsoft.com/office/drawing/2014/main" id="{893AFBA4-CA38-4FDF-8A4E-CEDD32B5A8FD}"/>
               </a:ext>
             </a:extLst>
           </p:cNvPr>
@@ -9564,7 +9460,7 @@
           <p:cNvPr id="7" name="TextBox 6">
             <a:extLst xmlns:a="http://schemas.openxmlformats.org/drawingml/2006/main">
               <a:ext uri="{FF2B5EF4-FFF2-40B4-BE49-F238E27FC236}">
-                <a16:creationId xmlns:a16="http://schemas.microsoft.com/office/drawing/2014/main" id="{D5F0E484-D928-499D-8458-77862ABA0019}"/>
+                <a16:creationId xmlns:a16="http://schemas.microsoft.com/office/drawing/2014/main" id="{2CC7091F-8DD6-4C66-A31C-2F632710A9ED}"/>
               </a:ext>
             </a:extLst>
           </p:cNvPr>
@@ -9782,7 +9678,7 @@
           <p:cNvPr id="8" name="Rounded Rectangle 7">
             <a:extLst xmlns:a="http://schemas.openxmlformats.org/drawingml/2006/main">
               <a:ext uri="{FF2B5EF4-FFF2-40B4-BE49-F238E27FC236}">
-                <a16:creationId xmlns:a16="http://schemas.microsoft.com/office/drawing/2014/main" id="{B1177E8F-A5F1-4E1E-A9D8-6FE046611F32}"/>
+                <a16:creationId xmlns:a16="http://schemas.microsoft.com/office/drawing/2014/main" id="{1E20B6B2-AD7A-4496-9D9D-F4BC566B12E2}"/>
               </a:ext>
             </a:extLst>
           </p:cNvPr>
@@ -9837,7 +9733,7 @@
           <p:cNvPr id="9" name="TextBox 8">
             <a:extLst xmlns:a="http://schemas.openxmlformats.org/drawingml/2006/main">
               <a:ext uri="{FF2B5EF4-FFF2-40B4-BE49-F238E27FC236}">
-                <a16:creationId xmlns:a16="http://schemas.microsoft.com/office/drawing/2014/main" id="{4FB43E35-0D4B-4F96-8973-9065A225A879}"/>
+                <a16:creationId xmlns:a16="http://schemas.microsoft.com/office/drawing/2014/main" id="{5F6BF4A8-58DE-4A4E-B8A6-5569E8D01AC1}"/>
               </a:ext>
             </a:extLst>
           </p:cNvPr>
@@ -10072,7 +9968,7 @@
     </p:spTree>
     <p:extLst>
       <p:ext uri="{BB962C8B-B14F-4D97-AF65-F5344CB8AC3E}">
-        <p14:creationId xmlns:p14="http://schemas.microsoft.com/office/powerpoint/2010/main" val="2041681987"/>
+        <p14:creationId xmlns:p14="http://schemas.microsoft.com/office/powerpoint/2010/main" val="69561193"/>
       </p:ext>
     </p:extLst>
   </p:cSld>
@@ -10096,7 +9992,7 @@
           <p:cNvPr id="2" name="Rectangle 1">
             <a:extLst xmlns:a="http://schemas.openxmlformats.org/drawingml/2006/main">
               <a:ext uri="{FF2B5EF4-FFF2-40B4-BE49-F238E27FC236}">
-                <a16:creationId xmlns:a16="http://schemas.microsoft.com/office/drawing/2014/main" id="{203D3C58-1D12-4089-B57F-E0D91FF692F2}"/>
+                <a16:creationId xmlns:a16="http://schemas.microsoft.com/office/drawing/2014/main" id="{687F6725-EFB1-46C9-B912-06E34D3C853D}"/>
               </a:ext>
             </a:extLst>
           </p:cNvPr>
@@ -10149,7 +10045,7 @@
           <p:cNvPr id="3" name="Rectangle 2">
             <a:extLst xmlns:a="http://schemas.openxmlformats.org/drawingml/2006/main">
               <a:ext uri="{FF2B5EF4-FFF2-40B4-BE49-F238E27FC236}">
-                <a16:creationId xmlns:a16="http://schemas.microsoft.com/office/drawing/2014/main" id="{E81CE568-F95F-49E2-BF5B-76329DE44117}"/>
+                <a16:creationId xmlns:a16="http://schemas.microsoft.com/office/drawing/2014/main" id="{17742F69-8437-483B-9C0A-A9E0E60D057A}"/>
               </a:ext>
             </a:extLst>
           </p:cNvPr>
@@ -10202,7 +10098,7 @@
           <p:cNvPr id="4" name="Rectangle 3">
             <a:extLst xmlns:a="http://schemas.openxmlformats.org/drawingml/2006/main">
               <a:ext uri="{FF2B5EF4-FFF2-40B4-BE49-F238E27FC236}">
-                <a16:creationId xmlns:a16="http://schemas.microsoft.com/office/drawing/2014/main" id="{11F82FE4-0FB4-408E-93FE-626BC62398B3}"/>
+                <a16:creationId xmlns:a16="http://schemas.microsoft.com/office/drawing/2014/main" id="{1E758038-14C0-49DE-BB7B-231861C04FF6}"/>
               </a:ext>
             </a:extLst>
           </p:cNvPr>
@@ -10255,7 +10151,7 @@
           <p:cNvPr id="5" name="TextBox 4">
             <a:extLst xmlns:a="http://schemas.openxmlformats.org/drawingml/2006/main">
               <a:ext uri="{FF2B5EF4-FFF2-40B4-BE49-F238E27FC236}">
-                <a16:creationId xmlns:a16="http://schemas.microsoft.com/office/drawing/2014/main" id="{8FB7140A-13F0-4D9A-9729-8CC8B4984B82}"/>
+                <a16:creationId xmlns:a16="http://schemas.microsoft.com/office/drawing/2014/main" id="{40DBE2EF-6C72-4AD4-B953-C1DBE3BCDBA4}"/>
               </a:ext>
             </a:extLst>
           </p:cNvPr>
@@ -10318,7 +10214,7 @@
           <p:cNvPr id="6" name="Rounded Rectangle 5">
             <a:extLst xmlns:a="http://schemas.openxmlformats.org/drawingml/2006/main">
               <a:ext uri="{FF2B5EF4-FFF2-40B4-BE49-F238E27FC236}">
-                <a16:creationId xmlns:a16="http://schemas.microsoft.com/office/drawing/2014/main" id="{4480EFF6-20CD-4590-9617-D917082256B1}"/>
+                <a16:creationId xmlns:a16="http://schemas.microsoft.com/office/drawing/2014/main" id="{C340242C-EFE5-438F-9B58-E8E988362548}"/>
               </a:ext>
             </a:extLst>
           </p:cNvPr>
@@ -10373,7 +10269,7 @@
           <p:cNvPr id="7" name="TextBox 6">
             <a:extLst xmlns:a="http://schemas.openxmlformats.org/drawingml/2006/main">
               <a:ext uri="{FF2B5EF4-FFF2-40B4-BE49-F238E27FC236}">
-                <a16:creationId xmlns:a16="http://schemas.microsoft.com/office/drawing/2014/main" id="{ED7BAEB8-31D0-49CB-A9B7-F537556424F9}"/>
+                <a16:creationId xmlns:a16="http://schemas.microsoft.com/office/drawing/2014/main" id="{FB2E5F24-7D14-42D7-ACF5-CDC507B3270F}"/>
               </a:ext>
             </a:extLst>
           </p:cNvPr>
@@ -10423,166 +10319,239 @@
           </a:p>
           <a:p xmlns:a="http://schemas.openxmlformats.org/drawingml/2006/main">
             <a:pPr>
-              <a:buNone/>
-              <a:defRPr sz="1600" b="1">
-                <a:solidFill>
-                  <a:srgbClr val="1E40AF"/>
-                </a:solidFill>
-                <a:latin typeface="Calibri"/>
-                <a:ea typeface="Calibri"/>
-                <a:cs typeface="Calibri"/>
-              </a:defRPr>
-            </a:pPr>
-          </a:p>
-          <a:p xmlns:a="http://schemas.openxmlformats.org/drawingml/2006/main">
-            <a:pPr>
-              <a:buNone/>
-              <a:defRPr sz="1600" b="1">
-                <a:solidFill>
-                  <a:srgbClr val="1E40AF"/>
-                </a:solidFill>
-                <a:latin typeface="Calibri"/>
-                <a:ea typeface="Calibri"/>
-                <a:cs typeface="Calibri"/>
-              </a:defRPr>
-            </a:pPr>
-            <a:r>
-              <a:rPr sz="825" b="1">
-                <a:solidFill>
-                  <a:srgbClr val="1E40AF"/>
+              <a:spcBef>
+                <a:spcPts val="300"/>
+              </a:spcBef>
+              <a:buNone/>
+              <a:defRPr sz="1150">
+                <a:solidFill>
+                  <a:srgbClr val="0F172A"/>
+                </a:solidFill>
+                <a:latin typeface="Calibri"/>
+                <a:ea typeface="Calibri"/>
+                <a:cs typeface="Calibri"/>
+              </a:defRPr>
+            </a:pPr>
+            <a:r>
+              <a:rPr sz="825">
+                <a:solidFill>
+                  <a:srgbClr val="0F172A"/>
                 </a:solidFill>
                 <a:latin typeface="Calibri"/>
                 <a:ea typeface="Calibri"/>
                 <a:cs typeface="Calibri"/>
               </a:rPr>
-              <a:t>▶ [HISTORICAL DEV PILOT RETRIEVAL (Mẫu số N=756 views)]</a:t>
-            </a:r>
-          </a:p>
-          <a:p xmlns:a="http://schemas.openxmlformats.org/drawingml/2006/main">
-            <a:pPr>
-              <a:buNone/>
-              <a:defRPr sz="1600" b="1">
-                <a:solidFill>
-                  <a:srgbClr val="1E40AF"/>
-                </a:solidFill>
-                <a:latin typeface="Calibri"/>
-                <a:ea typeface="Calibri"/>
-                <a:cs typeface="Calibri"/>
-              </a:defRPr>
-            </a:pPr>
-            <a:r>
-              <a:rPr sz="825" b="1">
-                <a:solidFill>
-                  <a:srgbClr val="1E40AF"/>
+              <a:t/>
+            </a:r>
+          </a:p>
+          <a:p xmlns:a="http://schemas.openxmlformats.org/drawingml/2006/main">
+            <a:pPr>
+              <a:spcBef>
+                <a:spcPts val="300"/>
+              </a:spcBef>
+              <a:buNone/>
+              <a:defRPr sz="1150">
+                <a:solidFill>
+                  <a:srgbClr val="0F172A"/>
+                </a:solidFill>
+                <a:latin typeface="Calibri"/>
+                <a:ea typeface="Calibri"/>
+                <a:cs typeface="Calibri"/>
+              </a:defRPr>
+            </a:pPr>
+            <a:r>
+              <a:rPr sz="825">
+                <a:solidFill>
+                  <a:srgbClr val="0F172A"/>
                 </a:solidFill>
                 <a:latin typeface="Calibri"/>
                 <a:ea typeface="Calibri"/>
                 <a:cs typeface="Calibri"/>
               </a:rPr>
-              <a:t>•  Mẫu dương tính đánh giá pilot: 756 / 1,340 views (Synthetic DEV split).</a:t>
-            </a:r>
-          </a:p>
-          <a:p xmlns:a="http://schemas.openxmlformats.org/drawingml/2006/main">
-            <a:pPr>
-              <a:buNone/>
-              <a:defRPr sz="1600" b="1">
-                <a:solidFill>
-                  <a:srgbClr val="1E40AF"/>
-                </a:solidFill>
-                <a:latin typeface="Calibri"/>
-                <a:ea typeface="Calibri"/>
-                <a:cs typeface="Calibri"/>
-              </a:defRPr>
-            </a:pPr>
-            <a:r>
-              <a:rPr sz="825" b="1">
-                <a:solidFill>
-                  <a:srgbClr val="1E40AF"/>
+              <a:t>▶ [T20 FULL BENCHMARK POSITIVE RETRIEVAL (Mẫu số N=756 views = 718 TEST + 38 DEV)]</a:t>
+            </a:r>
+          </a:p>
+          <a:p xmlns:a="http://schemas.openxmlformats.org/drawingml/2006/main">
+            <a:pPr>
+              <a:spcBef>
+                <a:spcPts val="300"/>
+              </a:spcBef>
+              <a:buNone/>
+              <a:defRPr sz="1150">
+                <a:solidFill>
+                  <a:srgbClr val="0F172A"/>
+                </a:solidFill>
+                <a:latin typeface="Calibri"/>
+                <a:ea typeface="Calibri"/>
+                <a:cs typeface="Calibri"/>
+              </a:defRPr>
+            </a:pPr>
+            <a:r>
+              <a:rPr sz="825">
+                <a:solidFill>
+                  <a:srgbClr val="0F172A"/>
                 </a:solidFill>
                 <a:latin typeface="Calibri"/>
                 <a:ea typeface="Calibri"/>
                 <a:cs typeface="Calibri"/>
               </a:rPr>
-              <a:t>•  Pilot Hit@k: Hit@1=4.23%, Hit@3=16.80%, Hit@5=24.21%, Hit@10=45.11% (341 / 756).</a:t>
-            </a:r>
-          </a:p>
-          <a:p xmlns:a="http://schemas.openxmlformats.org/drawingml/2006/main">
-            <a:pPr>
-              <a:buNone/>
-              <a:defRPr sz="1600" b="1">
-                <a:solidFill>
-                  <a:srgbClr val="1E40AF"/>
-                </a:solidFill>
-                <a:latin typeface="Calibri"/>
-                <a:ea typeface="Calibri"/>
-                <a:cs typeface="Calibri"/>
-              </a:defRPr>
-            </a:pPr>
-            <a:r>
-              <a:rPr sz="825" b="1">
-                <a:solidFill>
-                  <a:srgbClr val="1E40AF"/>
+              <a:t>•  Toàn bộ mẫu dương tính benchmark: 756 views (718 TEST views + 38 DEV views).</a:t>
+            </a:r>
+          </a:p>
+          <a:p xmlns:a="http://schemas.openxmlformats.org/drawingml/2006/main">
+            <a:pPr>
+              <a:spcBef>
+                <a:spcPts val="300"/>
+              </a:spcBef>
+              <a:buNone/>
+              <a:defRPr sz="1150">
+                <a:solidFill>
+                  <a:srgbClr val="0F172A"/>
+                </a:solidFill>
+                <a:latin typeface="Calibri"/>
+                <a:ea typeface="Calibri"/>
+                <a:cs typeface="Calibri"/>
+              </a:defRPr>
+            </a:pPr>
+            <a:r>
+              <a:rPr sz="825">
+                <a:solidFill>
+                  <a:srgbClr val="0F172A"/>
                 </a:solidFill>
                 <a:latin typeface="Calibri"/>
                 <a:ea typeface="Calibri"/>
                 <a:cs typeface="Calibri"/>
               </a:rPr>
-              <a:t>•  Pilot Macro Recall@10: 43.14%  |  Tỷ lệ vắng mặt Top-10: 54.89% (415 / 756)  |  Mean Rank: 5.21.</a:t>
-            </a:r>
-          </a:p>
-          <a:p xmlns:a="http://schemas.openxmlformats.org/drawingml/2006/main">
-            <a:pPr>
-              <a:buNone/>
-              <a:defRPr sz="1600" b="1">
-                <a:solidFill>
-                  <a:srgbClr val="1E40AF"/>
-                </a:solidFill>
-                <a:latin typeface="Calibri"/>
-                <a:ea typeface="Calibri"/>
-                <a:cs typeface="Calibri"/>
-              </a:defRPr>
-            </a:pPr>
-          </a:p>
-          <a:p xmlns:a="http://schemas.openxmlformats.org/drawingml/2006/main">
-            <a:pPr>
-              <a:buNone/>
-              <a:defRPr sz="1600" b="1">
-                <a:solidFill>
-                  <a:srgbClr val="1E40AF"/>
-                </a:solidFill>
-                <a:latin typeface="Calibri"/>
-                <a:ea typeface="Calibri"/>
-                <a:cs typeface="Calibri"/>
-              </a:defRPr>
-            </a:pPr>
-            <a:r>
-              <a:rPr sz="825" b="1">
-                <a:solidFill>
-                  <a:srgbClr val="1E40AF"/>
+              <a:t>•  Benchmark Hit@k: Hit@1=4.23%, Hit@3=16.80%, Hit@5=24.21%, Hit@10=45.11% (341 / 756).</a:t>
+            </a:r>
+          </a:p>
+          <a:p xmlns:a="http://schemas.openxmlformats.org/drawingml/2006/main">
+            <a:pPr>
+              <a:spcBef>
+                <a:spcPts val="300"/>
+              </a:spcBef>
+              <a:buNone/>
+              <a:defRPr sz="1150">
+                <a:solidFill>
+                  <a:srgbClr val="0F172A"/>
+                </a:solidFill>
+                <a:latin typeface="Calibri"/>
+                <a:ea typeface="Calibri"/>
+                <a:cs typeface="Calibri"/>
+              </a:defRPr>
+            </a:pPr>
+            <a:r>
+              <a:rPr sz="825">
+                <a:solidFill>
+                  <a:srgbClr val="0F172A"/>
                 </a:solidFill>
                 <a:latin typeface="Calibri"/>
                 <a:ea typeface="Calibri"/>
                 <a:cs typeface="Calibri"/>
               </a:rPr>
-              <a:t>▶ [DIAGNOSTIC TEST FIXTURE RETRIEVAL (Mẫu số N=718 scorable views)]</a:t>
-            </a:r>
-          </a:p>
-          <a:p xmlns:a="http://schemas.openxmlformats.org/drawingml/2006/main">
-            <a:pPr>
-              <a:buNone/>
-              <a:defRPr sz="1600" b="1">
-                <a:solidFill>
-                  <a:srgbClr val="1E40AF"/>
-                </a:solidFill>
-                <a:latin typeface="Calibri"/>
-                <a:ea typeface="Calibri"/>
-                <a:cs typeface="Calibri"/>
-              </a:defRPr>
-            </a:pPr>
-            <a:r>
-              <a:rPr sz="825" b="1">
-                <a:solidFill>
-                  <a:srgbClr val="1E40AF"/>
+              <a:t>•  Benchmark Macro Recall@10: 43.14%  |  Tỷ lệ vắng mặt Top-10: 54.89% (415 / 756)  |  Mean Rank: 5.21.</a:t>
+            </a:r>
+          </a:p>
+          <a:p xmlns:a="http://schemas.openxmlformats.org/drawingml/2006/main">
+            <a:pPr>
+              <a:spcBef>
+                <a:spcPts val="300"/>
+              </a:spcBef>
+              <a:buNone/>
+              <a:defRPr sz="1150">
+                <a:solidFill>
+                  <a:srgbClr val="0F172A"/>
+                </a:solidFill>
+                <a:latin typeface="Calibri"/>
+                <a:ea typeface="Calibri"/>
+                <a:cs typeface="Calibri"/>
+              </a:defRPr>
+            </a:pPr>
+            <a:r>
+              <a:rPr sz="825">
+                <a:solidFill>
+                  <a:srgbClr val="0F172A"/>
+                </a:solidFill>
+                <a:latin typeface="Calibri"/>
+                <a:ea typeface="Calibri"/>
+                <a:cs typeface="Calibri"/>
+              </a:rPr>
+              <a:t>•  (Ghi chú: Real DEV Pilot là 4 views × 5 conditions = 20 requests, tách biệt hoàn toàn với benchmark positive views).</a:t>
+            </a:r>
+          </a:p>
+          <a:p xmlns:a="http://schemas.openxmlformats.org/drawingml/2006/main">
+            <a:pPr>
+              <a:spcBef>
+                <a:spcPts val="300"/>
+              </a:spcBef>
+              <a:buNone/>
+              <a:defRPr sz="1150">
+                <a:solidFill>
+                  <a:srgbClr val="0F172A"/>
+                </a:solidFill>
+                <a:latin typeface="Calibri"/>
+                <a:ea typeface="Calibri"/>
+                <a:cs typeface="Calibri"/>
+              </a:defRPr>
+            </a:pPr>
+            <a:r>
+              <a:rPr sz="825">
+                <a:solidFill>
+                  <a:srgbClr val="0F172A"/>
+                </a:solidFill>
+                <a:latin typeface="Calibri"/>
+                <a:ea typeface="Calibri"/>
+                <a:cs typeface="Calibri"/>
+              </a:rPr>
+              <a:t/>
+            </a:r>
+          </a:p>
+          <a:p xmlns:a="http://schemas.openxmlformats.org/drawingml/2006/main">
+            <a:pPr>
+              <a:spcBef>
+                <a:spcPts val="300"/>
+              </a:spcBef>
+              <a:buNone/>
+              <a:defRPr sz="1150">
+                <a:solidFill>
+                  <a:srgbClr val="0F172A"/>
+                </a:solidFill>
+                <a:latin typeface="Calibri"/>
+                <a:ea typeface="Calibri"/>
+                <a:cs typeface="Calibri"/>
+              </a:defRPr>
+            </a:pPr>
+            <a:r>
+              <a:rPr sz="825">
+                <a:solidFill>
+                  <a:srgbClr val="0F172A"/>
+                </a:solidFill>
+                <a:latin typeface="Calibri"/>
+                <a:ea typeface="Calibri"/>
+                <a:cs typeface="Calibri"/>
+              </a:rPr>
+              <a:t>▶ [DIAGNOSTIC TEST FIXTURE RETRIEVAL (Mẫu số N=718 scorable TEST views)]</a:t>
+            </a:r>
+          </a:p>
+          <a:p xmlns:a="http://schemas.openxmlformats.org/drawingml/2006/main">
+            <a:pPr>
+              <a:spcBef>
+                <a:spcPts val="300"/>
+              </a:spcBef>
+              <a:buNone/>
+              <a:defRPr sz="1150">
+                <a:solidFill>
+                  <a:srgbClr val="0F172A"/>
+                </a:solidFill>
+                <a:latin typeface="Calibri"/>
+                <a:ea typeface="Calibri"/>
+                <a:cs typeface="Calibri"/>
+              </a:defRPr>
+            </a:pPr>
+            <a:r>
+              <a:rPr sz="825">
+                <a:solidFill>
+                  <a:srgbClr val="0F172A"/>
                 </a:solidFill>
                 <a:latin typeface="Calibri"/>
                 <a:ea typeface="Calibri"/>
@@ -10593,20 +10562,23 @@
           </a:p>
           <a:p xmlns:a="http://schemas.openxmlformats.org/drawingml/2006/main">
             <a:pPr>
-              <a:buNone/>
-              <a:defRPr sz="1600" b="1">
-                <a:solidFill>
-                  <a:srgbClr val="1E40AF"/>
-                </a:solidFill>
-                <a:latin typeface="Calibri"/>
-                <a:ea typeface="Calibri"/>
-                <a:cs typeface="Calibri"/>
-              </a:defRPr>
-            </a:pPr>
-            <a:r>
-              <a:rPr sz="825" b="1">
-                <a:solidFill>
-                  <a:srgbClr val="1E40AF"/>
+              <a:spcBef>
+                <a:spcPts val="300"/>
+              </a:spcBef>
+              <a:buNone/>
+              <a:defRPr sz="1150">
+                <a:solidFill>
+                  <a:srgbClr val="0F172A"/>
+                </a:solidFill>
+                <a:latin typeface="Calibri"/>
+                <a:ea typeface="Calibri"/>
+                <a:cs typeface="Calibri"/>
+              </a:defRPr>
+            </a:pPr>
+            <a:r>
+              <a:rPr sz="825">
+                <a:solidFill>
+                  <a:srgbClr val="0F172A"/>
                 </a:solidFill>
                 <a:latin typeface="Calibri"/>
                 <a:ea typeface="Calibri"/>
@@ -10617,20 +10589,23 @@
           </a:p>
           <a:p xmlns:a="http://schemas.openxmlformats.org/drawingml/2006/main">
             <a:pPr>
-              <a:buNone/>
-              <a:defRPr sz="1600" b="1">
-                <a:solidFill>
-                  <a:srgbClr val="1E40AF"/>
-                </a:solidFill>
-                <a:latin typeface="Calibri"/>
-                <a:ea typeface="Calibri"/>
-                <a:cs typeface="Calibri"/>
-              </a:defRPr>
-            </a:pPr>
-            <a:r>
-              <a:rPr sz="825" b="1">
-                <a:solidFill>
-                  <a:srgbClr val="1E40AF"/>
+              <a:spcBef>
+                <a:spcPts val="300"/>
+              </a:spcBef>
+              <a:buNone/>
+              <a:defRPr sz="1150">
+                <a:solidFill>
+                  <a:srgbClr val="0F172A"/>
+                </a:solidFill>
+                <a:latin typeface="Calibri"/>
+                <a:ea typeface="Calibri"/>
+                <a:cs typeface="Calibri"/>
+              </a:defRPr>
+            </a:pPr>
+            <a:r>
+              <a:rPr sz="825">
+                <a:solidFill>
+                  <a:srgbClr val="0F172A"/>
                 </a:solidFill>
                 <a:latin typeface="Calibri"/>
                 <a:ea typeface="Calibri"/>
@@ -10641,26 +10616,29 @@
           </a:p>
           <a:p xmlns:a="http://schemas.openxmlformats.org/drawingml/2006/main">
             <a:pPr>
-              <a:buNone/>
-              <a:defRPr sz="1600" b="1">
-                <a:solidFill>
-                  <a:srgbClr val="1E40AF"/>
-                </a:solidFill>
-                <a:latin typeface="Calibri"/>
-                <a:ea typeface="Calibri"/>
-                <a:cs typeface="Calibri"/>
-              </a:defRPr>
-            </a:pPr>
-            <a:r>
-              <a:rPr sz="825" b="1">
-                <a:solidFill>
-                  <a:srgbClr val="1E40AF"/>
+              <a:spcBef>
+                <a:spcPts val="300"/>
+              </a:spcBef>
+              <a:buNone/>
+              <a:defRPr sz="1150">
+                <a:solidFill>
+                  <a:srgbClr val="0F172A"/>
+                </a:solidFill>
+                <a:latin typeface="Calibri"/>
+                <a:ea typeface="Calibri"/>
+                <a:cs typeface="Calibri"/>
+              </a:defRPr>
+            </a:pPr>
+            <a:r>
+              <a:rPr sz="825">
+                <a:solidFill>
+                  <a:srgbClr val="0F172A"/>
                 </a:solidFill>
                 <a:latin typeface="Calibri"/>
                 <a:ea typeface="Calibri"/>
                 <a:cs typeface="Calibri"/>
               </a:rPr>
-              <a:t>•  Phân định mẫu số: Tuyệt đối không gộp mẫu số N=756 (DEV Pilot) với N=718 (Test Fixture).</a:t>
+              <a:t>•  Phân định mẫu số: Mẫu số N=756 là toàn bộ benchmark (718 TEST + 38 DEV); N=718 là tập scorable TEST views; DEV Pilot là 20 requests.</a:t>
             </a:r>
           </a:p>
         </p:txBody>
@@ -10674,7 +10652,7 @@
           <p:nvPr/>
         </p:nvPicPr>
         <p:blipFill>
-          <a:blip xmlns:r="http://schemas.openxmlformats.org/officeDocument/2006/relationships" xmlns:a="http://schemas.openxmlformats.org/drawingml/2006/main" r:embed="Rf833ebe0a78a4a7a"/>
+          <a:blip xmlns:r="http://schemas.openxmlformats.org/officeDocument/2006/relationships" xmlns:a="http://schemas.openxmlformats.org/drawingml/2006/main" r:embed="Rdc4afde5397a4944"/>
           <a:stretch xmlns:a="http://schemas.openxmlformats.org/drawingml/2006/main">
             <a:fillRect l="0" t="0" r="0" b="0"/>
           </a:stretch>
@@ -10694,7 +10672,7 @@
           <p:cNvPr id="9" name="Rounded Rectangle 8">
             <a:extLst xmlns:a="http://schemas.openxmlformats.org/drawingml/2006/main">
               <a:ext uri="{FF2B5EF4-FFF2-40B4-BE49-F238E27FC236}">
-                <a16:creationId xmlns:a16="http://schemas.microsoft.com/office/drawing/2014/main" id="{AA6FF1AE-8267-45F6-871F-3AE37913C946}"/>
+                <a16:creationId xmlns:a16="http://schemas.microsoft.com/office/drawing/2014/main" id="{E875D768-1322-4A3F-B390-93D0D3C63359}"/>
               </a:ext>
             </a:extLst>
           </p:cNvPr>
@@ -10749,7 +10727,7 @@
           <p:cNvPr id="10" name="TextBox 9">
             <a:extLst xmlns:a="http://schemas.openxmlformats.org/drawingml/2006/main">
               <a:ext uri="{FF2B5EF4-FFF2-40B4-BE49-F238E27FC236}">
-                <a16:creationId xmlns:a16="http://schemas.microsoft.com/office/drawing/2014/main" id="{2FD85469-EA1B-4E5F-AB6C-F78F51E26DA4}"/>
+                <a16:creationId xmlns:a16="http://schemas.microsoft.com/office/drawing/2014/main" id="{58D8B798-5532-4F00-8CB5-DD0B8FA71F60}"/>
               </a:ext>
             </a:extLst>
           </p:cNvPr>
@@ -10835,7 +10813,7 @@
     </p:spTree>
     <p:extLst>
       <p:ext uri="{BB962C8B-B14F-4D97-AF65-F5344CB8AC3E}">
-        <p14:creationId xmlns:p14="http://schemas.microsoft.com/office/powerpoint/2010/main" val="1084139822"/>
+        <p14:creationId xmlns:p14="http://schemas.microsoft.com/office/powerpoint/2010/main" val="700816310"/>
       </p:ext>
     </p:extLst>
   </p:cSld>
@@ -10859,7 +10837,7 @@
           <p:cNvPr id="2" name="Rectangle 1">
             <a:extLst xmlns:a="http://schemas.openxmlformats.org/drawingml/2006/main">
               <a:ext uri="{FF2B5EF4-FFF2-40B4-BE49-F238E27FC236}">
-                <a16:creationId xmlns:a16="http://schemas.microsoft.com/office/drawing/2014/main" id="{1BB00D93-1CB0-483B-A597-61D396BA1140}"/>
+                <a16:creationId xmlns:a16="http://schemas.microsoft.com/office/drawing/2014/main" id="{CE7A11C3-71DA-47E7-9CFD-64761BC88CD1}"/>
               </a:ext>
             </a:extLst>
           </p:cNvPr>
@@ -10912,7 +10890,7 @@
           <p:cNvPr id="3" name="Rectangle 2">
             <a:extLst xmlns:a="http://schemas.openxmlformats.org/drawingml/2006/main">
               <a:ext uri="{FF2B5EF4-FFF2-40B4-BE49-F238E27FC236}">
-                <a16:creationId xmlns:a16="http://schemas.microsoft.com/office/drawing/2014/main" id="{E0962A26-8A99-4194-93B1-3B525D688328}"/>
+                <a16:creationId xmlns:a16="http://schemas.microsoft.com/office/drawing/2014/main" id="{E2B3E492-F997-44FF-A0BD-A7CF2A584D4C}"/>
               </a:ext>
             </a:extLst>
           </p:cNvPr>
@@ -10965,7 +10943,7 @@
           <p:cNvPr id="4" name="Rectangle 3">
             <a:extLst xmlns:a="http://schemas.openxmlformats.org/drawingml/2006/main">
               <a:ext uri="{FF2B5EF4-FFF2-40B4-BE49-F238E27FC236}">
-                <a16:creationId xmlns:a16="http://schemas.microsoft.com/office/drawing/2014/main" id="{AFA67A8B-2DC0-4871-82B7-E2410B058316}"/>
+                <a16:creationId xmlns:a16="http://schemas.microsoft.com/office/drawing/2014/main" id="{40C4AE07-E9DB-44B8-AA86-D7ADB66B8B4B}"/>
               </a:ext>
             </a:extLst>
           </p:cNvPr>
@@ -11018,7 +10996,7 @@
           <p:cNvPr id="5" name="TextBox 4">
             <a:extLst xmlns:a="http://schemas.openxmlformats.org/drawingml/2006/main">
               <a:ext uri="{FF2B5EF4-FFF2-40B4-BE49-F238E27FC236}">
-                <a16:creationId xmlns:a16="http://schemas.microsoft.com/office/drawing/2014/main" id="{4C98C8E5-338A-404C-A72E-93E0FBA4C39A}"/>
+                <a16:creationId xmlns:a16="http://schemas.microsoft.com/office/drawing/2014/main" id="{F5F5FAB7-D8A0-44A4-8D9B-9DFC238B38A8}"/>
               </a:ext>
             </a:extLst>
           </p:cNvPr>
@@ -11081,7 +11059,7 @@
           <p:cNvPr id="6" name="Rounded Rectangle 5">
             <a:extLst xmlns:a="http://schemas.openxmlformats.org/drawingml/2006/main">
               <a:ext uri="{FF2B5EF4-FFF2-40B4-BE49-F238E27FC236}">
-                <a16:creationId xmlns:a16="http://schemas.microsoft.com/office/drawing/2014/main" id="{980696FF-C7A0-4F56-9263-BF39BCB37BCA}"/>
+                <a16:creationId xmlns:a16="http://schemas.microsoft.com/office/drawing/2014/main" id="{9204241B-FD45-4D46-A329-06C436406649}"/>
               </a:ext>
             </a:extLst>
           </p:cNvPr>
@@ -11136,7 +11114,7 @@
           <p:cNvPr id="7" name="TextBox 6">
             <a:extLst xmlns:a="http://schemas.openxmlformats.org/drawingml/2006/main">
               <a:ext uri="{FF2B5EF4-FFF2-40B4-BE49-F238E27FC236}">
-                <a16:creationId xmlns:a16="http://schemas.microsoft.com/office/drawing/2014/main" id="{63FFF54F-F2AF-4735-954D-A4F9BF5EC11B}"/>
+                <a16:creationId xmlns:a16="http://schemas.microsoft.com/office/drawing/2014/main" id="{5264965E-9E8B-4421-95B2-0185A7513CCF}"/>
               </a:ext>
             </a:extLst>
           </p:cNvPr>
@@ -11373,7 +11351,7 @@
           <p:cNvPr id="8" name="Rounded Rectangle 7">
             <a:extLst xmlns:a="http://schemas.openxmlformats.org/drawingml/2006/main">
               <a:ext uri="{FF2B5EF4-FFF2-40B4-BE49-F238E27FC236}">
-                <a16:creationId xmlns:a16="http://schemas.microsoft.com/office/drawing/2014/main" id="{0C0365B5-1434-41F8-9FC3-011145DD5E2F}"/>
+                <a16:creationId xmlns:a16="http://schemas.microsoft.com/office/drawing/2014/main" id="{9A7BAFB5-05B0-4C18-8B2A-34483271FF5B}"/>
               </a:ext>
             </a:extLst>
           </p:cNvPr>
@@ -11428,7 +11406,7 @@
           <p:cNvPr id="9" name="TextBox 8">
             <a:extLst xmlns:a="http://schemas.openxmlformats.org/drawingml/2006/main">
               <a:ext uri="{FF2B5EF4-FFF2-40B4-BE49-F238E27FC236}">
-                <a16:creationId xmlns:a16="http://schemas.microsoft.com/office/drawing/2014/main" id="{54B22442-9FEA-4D9B-AD3C-E4457A9AD9A8}"/>
+                <a16:creationId xmlns:a16="http://schemas.microsoft.com/office/drawing/2014/main" id="{0C3D3527-44DA-4123-AAB6-BEC85B92C9B1}"/>
               </a:ext>
             </a:extLst>
           </p:cNvPr>
@@ -11440,7 +11418,7 @@
         <p:spPr>
           <a:xfrm xmlns:a="http://schemas.openxmlformats.org/drawingml/2006/main">
             <a:off x="6430975" y="1344168"/>
-            <a:ext cx="4846320" cy="5410200"/>
+            <a:ext cx="4846320" cy="5158740"/>
           </a:xfrm>
           <a:prstGeom xmlns:a="http://schemas.openxmlformats.org/drawingml/2006/main" prst="rect">
             <a:avLst/>
@@ -11544,142 +11522,12 @@
               </a:defRPr>
             </a:pPr>
             <a:r>
-              <a:t>•  Schema So Sánh Đối Chứng Scaffold [DIAGNOSTIC TEST FIXTURE ONLY - NOT CANONICAL NUMERICAL RESULTS]:</a:t>
-            </a:r>
-          </a:p>
-          <a:p xmlns:a="http://schemas.openxmlformats.org/drawingml/2006/main">
-            <a:pPr>
-              <a:spcBef>
-                <a:spcPts val="300"/>
-              </a:spcBef>
-              <a:buNone/>
-              <a:defRPr sz="1150">
-                <a:solidFill>
-                  <a:srgbClr val="0F172A"/>
-                </a:solidFill>
-                <a:latin typeface="Calibri"/>
-                <a:ea typeface="Calibri"/>
-                <a:cs typeface="Calibri"/>
-              </a:defRPr>
-            </a:pPr>
-            <a:r>
-              <a:rPr sz="1150">
-                <a:solidFill>
-                  <a:srgbClr val="0F172A"/>
-                </a:solidFill>
-                <a:latin typeface="Calibri"/>
-                <a:ea typeface="Calibri"/>
-                <a:cs typeface="Calibri"/>
-              </a:rPr>
-              <a:t>  • Diagnostic Cohort Pairwise Comparison (n=718 views across 440 clusters):</a:t>
-            </a:r>
-          </a:p>
-          <a:p xmlns:a="http://schemas.openxmlformats.org/drawingml/2006/main">
-            <a:pPr>
-              <a:spcBef>
-                <a:spcPts val="300"/>
-              </a:spcBef>
-              <a:buNone/>
-              <a:defRPr sz="1150">
-                <a:solidFill>
-                  <a:srgbClr val="0F172A"/>
-                </a:solidFill>
-                <a:latin typeface="Calibri"/>
-                <a:ea typeface="Calibri"/>
-                <a:cs typeface="Calibri"/>
-              </a:defRPr>
-            </a:pPr>
-            <a:r>
-              <a:rPr sz="1150">
-                <a:solidFill>
-                  <a:srgbClr val="0F172A"/>
-                </a:solidFill>
-                <a:latin typeface="Calibri"/>
-                <a:ea typeface="Calibri"/>
-                <a:cs typeface="Calibri"/>
-              </a:rPr>
-              <a:t>    • Marginal Views: Single-event Acc = 0.5000 vs Contextual-event Acc = 0.5000 (Delta = +0.0000)</a:t>
-            </a:r>
-          </a:p>
-          <a:p xmlns:a="http://schemas.openxmlformats.org/drawingml/2006/main">
-            <a:pPr>
-              <a:spcBef>
-                <a:spcPts val="300"/>
-              </a:spcBef>
-              <a:buNone/>
-              <a:defRPr sz="1150">
-                <a:solidFill>
-                  <a:srgbClr val="0F172A"/>
-                </a:solidFill>
-                <a:latin typeface="Calibri"/>
-                <a:ea typeface="Calibri"/>
-                <a:cs typeface="Calibri"/>
-              </a:defRPr>
-            </a:pPr>
-            <a:r>
-              <a:rPr sz="1150">
-                <a:solidFill>
-                  <a:srgbClr val="0F172A"/>
-                </a:solidFill>
-                <a:latin typeface="Calibri"/>
-                <a:ea typeface="Calibri"/>
-                <a:cs typeface="Calibri"/>
-              </a:rPr>
-              <a:t>    • Paired Cohort (278 complete pairs): Single Acc = 0.5000 vs Context Acc = 0.5000 (Delta = +0.00 pp)</a:t>
-            </a:r>
-          </a:p>
-          <a:p xmlns:a="http://schemas.openxmlformats.org/drawingml/2006/main">
-            <a:pPr>
-              <a:spcBef>
-                <a:spcPts val="300"/>
-              </a:spcBef>
-              <a:buNone/>
-              <a:defRPr sz="1150">
-                <a:solidFill>
-                  <a:srgbClr val="0F172A"/>
-                </a:solidFill>
-                <a:latin typeface="Calibri"/>
-                <a:ea typeface="Calibri"/>
-                <a:cs typeface="Calibri"/>
-              </a:defRPr>
-            </a:pPr>
-            <a:r>
-              <a:rPr sz="1150">
-                <a:solidFill>
-                  <a:srgbClr val="0F172A"/>
-                </a:solidFill>
-                <a:latin typeface="Calibri"/>
-                <a:ea typeface="Calibri"/>
-                <a:cs typeface="Calibri"/>
-              </a:rPr>
-              <a:t>    • Pair Concordance: Both Correct = 139, Single-only Correct = 0, Context-only Correct = 0, Both Incorrect = 139</a:t>
-            </a:r>
-          </a:p>
-          <a:p xmlns:a="http://schemas.openxmlformats.org/drawingml/2006/main">
-            <a:pPr>
-              <a:spcBef>
-                <a:spcPts val="300"/>
-              </a:spcBef>
-              <a:buNone/>
-              <a:defRPr sz="1150">
-                <a:solidFill>
-                  <a:srgbClr val="0F172A"/>
-                </a:solidFill>
-                <a:latin typeface="Calibri"/>
-                <a:ea typeface="Calibri"/>
-                <a:cs typeface="Calibri"/>
-              </a:defRPr>
-            </a:pPr>
-            <a:r>
-              <a:rPr sz="1150">
-                <a:solidFill>
-                  <a:srgbClr val="0F172A"/>
-                </a:solidFill>
-                <a:latin typeface="Calibri"/>
-                <a:ea typeface="Calibri"/>
-                <a:cs typeface="Calibri"/>
-              </a:rPr>
-              <a:t>    • McNemar Exploratory Test: p_asympt = 1.0000, p_exact = 1.0000</a:t>
+              <a:t>•  Schema So Sánh Đối Chứng Scaffold [DIAGNOSTIC TEST FIXTURE ONLY - NOT CANONICAL NUMERICAL RESULTS]:
+  • Diagnostic Cohort Pairwise Comparison (n=718 views across 440 clusters):
+    • Marginal Views: Single-event Acc = 0.5000 vs Contextual-event Acc = 0.5000 (Delta = +0.0000)
+    • Paired Cohort (278 complete pairs): Single Acc = 0.5000 vs Context Acc = 0.5000 (Delta = +0.00 pp)
+    • Pair Concordance: Both Correct = 139, Single-only Correct = 0, Context-only Correct = 0, Both Incorrect = 139
+    • McNemar Exploratory Test: p_asympt = 1.0000, p_exact = 1.0000</a:t>
             </a:r>
           </a:p>
           <a:p xmlns:a="http://schemas.openxmlformats.org/drawingml/2006/main">
@@ -11763,7 +11611,7 @@
     </p:spTree>
     <p:extLst>
       <p:ext uri="{BB962C8B-B14F-4D97-AF65-F5344CB8AC3E}">
-        <p14:creationId xmlns:p14="http://schemas.microsoft.com/office/powerpoint/2010/main" val="465052996"/>
+        <p14:creationId xmlns:p14="http://schemas.microsoft.com/office/powerpoint/2010/main" val="2044301991"/>
       </p:ext>
     </p:extLst>
   </p:cSld>
@@ -11787,7 +11635,7 @@
           <p:cNvPr id="2" name="Rectangle 1">
             <a:extLst xmlns:a="http://schemas.openxmlformats.org/drawingml/2006/main">
               <a:ext uri="{FF2B5EF4-FFF2-40B4-BE49-F238E27FC236}">
-                <a16:creationId xmlns:a16="http://schemas.microsoft.com/office/drawing/2014/main" id="{2C13F827-4140-4357-92EC-B490C7939B2B}"/>
+                <a16:creationId xmlns:a16="http://schemas.microsoft.com/office/drawing/2014/main" id="{8540B0ED-E1FC-45F7-B4B3-E666D12FC96D}"/>
               </a:ext>
             </a:extLst>
           </p:cNvPr>
@@ -11840,7 +11688,7 @@
           <p:cNvPr id="3" name="Rectangle 2">
             <a:extLst xmlns:a="http://schemas.openxmlformats.org/drawingml/2006/main">
               <a:ext uri="{FF2B5EF4-FFF2-40B4-BE49-F238E27FC236}">
-                <a16:creationId xmlns:a16="http://schemas.microsoft.com/office/drawing/2014/main" id="{4E278105-1054-4063-ADCF-BE9992FC72A1}"/>
+                <a16:creationId xmlns:a16="http://schemas.microsoft.com/office/drawing/2014/main" id="{3BC546D6-D1C3-4FFB-AA12-3E189D1C82EF}"/>
               </a:ext>
             </a:extLst>
           </p:cNvPr>
@@ -11893,7 +11741,7 @@
           <p:cNvPr id="4" name="Rectangle 3">
             <a:extLst xmlns:a="http://schemas.openxmlformats.org/drawingml/2006/main">
               <a:ext uri="{FF2B5EF4-FFF2-40B4-BE49-F238E27FC236}">
-                <a16:creationId xmlns:a16="http://schemas.microsoft.com/office/drawing/2014/main" id="{213BAA95-28A0-4191-B833-6C078ED19812}"/>
+                <a16:creationId xmlns:a16="http://schemas.microsoft.com/office/drawing/2014/main" id="{E26E1B9A-20B6-4630-9044-768A03989CF5}"/>
               </a:ext>
             </a:extLst>
           </p:cNvPr>
@@ -11946,7 +11794,7 @@
           <p:cNvPr id="5" name="TextBox 4">
             <a:extLst xmlns:a="http://schemas.openxmlformats.org/drawingml/2006/main">
               <a:ext uri="{FF2B5EF4-FFF2-40B4-BE49-F238E27FC236}">
-                <a16:creationId xmlns:a16="http://schemas.microsoft.com/office/drawing/2014/main" id="{5D547E9F-398B-46D5-B7CC-3B8BF9560D01}"/>
+                <a16:creationId xmlns:a16="http://schemas.microsoft.com/office/drawing/2014/main" id="{58265557-8535-463D-8E29-F92635A228EA}"/>
               </a:ext>
             </a:extLst>
           </p:cNvPr>
@@ -12009,7 +11857,7 @@
           <p:cNvPr id="6" name="Rounded Rectangle 5">
             <a:extLst xmlns:a="http://schemas.openxmlformats.org/drawingml/2006/main">
               <a:ext uri="{FF2B5EF4-FFF2-40B4-BE49-F238E27FC236}">
-                <a16:creationId xmlns:a16="http://schemas.microsoft.com/office/drawing/2014/main" id="{CA78DD69-ACB6-46B4-9D8F-B6AF5436FF06}"/>
+                <a16:creationId xmlns:a16="http://schemas.microsoft.com/office/drawing/2014/main" id="{A9A49EB8-901F-46BA-B78C-2273A64857A8}"/>
               </a:ext>
             </a:extLst>
           </p:cNvPr>
@@ -12064,7 +11912,7 @@
           <p:cNvPr id="7" name="TextBox 6">
             <a:extLst xmlns:a="http://schemas.openxmlformats.org/drawingml/2006/main">
               <a:ext uri="{FF2B5EF4-FFF2-40B4-BE49-F238E27FC236}">
-                <a16:creationId xmlns:a16="http://schemas.microsoft.com/office/drawing/2014/main" id="{97C98CCE-3A44-45CB-87A0-05B107B2C20F}"/>
+                <a16:creationId xmlns:a16="http://schemas.microsoft.com/office/drawing/2014/main" id="{565EEACD-694B-4BDF-9B37-BEC9C4F9B6A6}"/>
               </a:ext>
             </a:extLst>
           </p:cNvPr>
@@ -12187,7 +12035,7 @@
           <p:cNvPr id="8" name="Rounded Rectangle 7">
             <a:extLst xmlns:a="http://schemas.openxmlformats.org/drawingml/2006/main">
               <a:ext uri="{FF2B5EF4-FFF2-40B4-BE49-F238E27FC236}">
-                <a16:creationId xmlns:a16="http://schemas.microsoft.com/office/drawing/2014/main" id="{983305C6-EDEA-4504-BB96-59165024ED8D}"/>
+                <a16:creationId xmlns:a16="http://schemas.microsoft.com/office/drawing/2014/main" id="{F33D9A35-7A4E-4ADB-BD55-AEA3C6AB5B2E}"/>
               </a:ext>
             </a:extLst>
           </p:cNvPr>
@@ -12242,7 +12090,7 @@
           <p:cNvPr id="9" name="TextBox 8">
             <a:extLst xmlns:a="http://schemas.openxmlformats.org/drawingml/2006/main">
               <a:ext uri="{FF2B5EF4-FFF2-40B4-BE49-F238E27FC236}">
-                <a16:creationId xmlns:a16="http://schemas.microsoft.com/office/drawing/2014/main" id="{89AB89D4-3018-4EBC-A588-AE433CAC5AC2}"/>
+                <a16:creationId xmlns:a16="http://schemas.microsoft.com/office/drawing/2014/main" id="{CEF697E1-27A7-4EAA-AD68-AA1E01883E88}"/>
               </a:ext>
             </a:extLst>
           </p:cNvPr>
@@ -12365,7 +12213,7 @@
           <p:cNvPr id="10" name="Rounded Rectangle 9">
             <a:extLst xmlns:a="http://schemas.openxmlformats.org/drawingml/2006/main">
               <a:ext uri="{FF2B5EF4-FFF2-40B4-BE49-F238E27FC236}">
-                <a16:creationId xmlns:a16="http://schemas.microsoft.com/office/drawing/2014/main" id="{884FDF92-6B53-4AC5-8C5E-BEE73E856DD0}"/>
+                <a16:creationId xmlns:a16="http://schemas.microsoft.com/office/drawing/2014/main" id="{6D9CFD45-AB27-44A3-B2BE-185304864318}"/>
               </a:ext>
             </a:extLst>
           </p:cNvPr>
@@ -12420,7 +12268,7 @@
           <p:cNvPr id="11" name="TextBox 10">
             <a:extLst xmlns:a="http://schemas.openxmlformats.org/drawingml/2006/main">
               <a:ext uri="{FF2B5EF4-FFF2-40B4-BE49-F238E27FC236}">
-                <a16:creationId xmlns:a16="http://schemas.microsoft.com/office/drawing/2014/main" id="{C4793796-8265-45DC-9C43-7124B986A012}"/>
+                <a16:creationId xmlns:a16="http://schemas.microsoft.com/office/drawing/2014/main" id="{CEE48DA2-A75A-4546-AE0D-B3BAFC6D0727}"/>
               </a:ext>
             </a:extLst>
           </p:cNvPr>
@@ -12470,10 +12318,13 @@
           </a:p>
           <a:p xmlns:a="http://schemas.openxmlformats.org/drawingml/2006/main">
             <a:pPr>
-              <a:buNone/>
-              <a:defRPr sz="1600" b="1">
-                <a:solidFill>
-                  <a:srgbClr val="DC2626"/>
+              <a:spcBef>
+                <a:spcPts val="350"/>
+              </a:spcBef>
+              <a:buNone/>
+              <a:defRPr sz="1150">
+                <a:solidFill>
+                  <a:srgbClr val="0F172A"/>
                 </a:solidFill>
                 <a:latin typeface="Calibri"/>
                 <a:ea typeface="Calibri"/>
@@ -12494,10 +12345,13 @@
           </a:p>
           <a:p xmlns:a="http://schemas.openxmlformats.org/drawingml/2006/main">
             <a:pPr>
-              <a:buNone/>
-              <a:defRPr sz="1600" b="1">
-                <a:solidFill>
-                  <a:srgbClr val="DC2626"/>
+              <a:spcBef>
+                <a:spcPts val="350"/>
+              </a:spcBef>
+              <a:buNone/>
+              <a:defRPr sz="1150">
+                <a:solidFill>
+                  <a:srgbClr val="0F172A"/>
                 </a:solidFill>
                 <a:latin typeface="Calibri"/>
                 <a:ea typeface="Calibri"/>
@@ -12518,10 +12372,13 @@
           </a:p>
           <a:p xmlns:a="http://schemas.openxmlformats.org/drawingml/2006/main">
             <a:pPr>
-              <a:buNone/>
-              <a:defRPr sz="1600" b="1">
-                <a:solidFill>
-                  <a:srgbClr val="DC2626"/>
+              <a:spcBef>
+                <a:spcPts val="350"/>
+              </a:spcBef>
+              <a:buNone/>
+              <a:defRPr sz="1150">
+                <a:solidFill>
+                  <a:srgbClr val="0F172A"/>
                 </a:solidFill>
                 <a:latin typeface="Calibri"/>
                 <a:ea typeface="Calibri"/>
@@ -12542,10 +12399,13 @@
           </a:p>
           <a:p xmlns:a="http://schemas.openxmlformats.org/drawingml/2006/main">
             <a:pPr>
-              <a:buNone/>
-              <a:defRPr sz="1600" b="1">
-                <a:solidFill>
-                  <a:srgbClr val="DC2626"/>
+              <a:spcBef>
+                <a:spcPts val="350"/>
+              </a:spcBef>
+              <a:buNone/>
+              <a:defRPr sz="1150">
+                <a:solidFill>
+                  <a:srgbClr val="0F172A"/>
                 </a:solidFill>
                 <a:latin typeface="Calibri"/>
                 <a:ea typeface="Calibri"/>
@@ -12566,10 +12426,13 @@
           </a:p>
           <a:p xmlns:a="http://schemas.openxmlformats.org/drawingml/2006/main">
             <a:pPr>
-              <a:buNone/>
-              <a:defRPr sz="1600" b="1">
-                <a:solidFill>
-                  <a:srgbClr val="DC2626"/>
+              <a:spcBef>
+                <a:spcPts val="350"/>
+              </a:spcBef>
+              <a:buNone/>
+              <a:defRPr sz="1150">
+                <a:solidFill>
+                  <a:srgbClr val="0F172A"/>
                 </a:solidFill>
                 <a:latin typeface="Calibri"/>
                 <a:ea typeface="Calibri"/>
@@ -12590,10 +12453,13 @@
           </a:p>
           <a:p xmlns:a="http://schemas.openxmlformats.org/drawingml/2006/main">
             <a:pPr>
-              <a:buNone/>
-              <a:defRPr sz="1600" b="1">
-                <a:solidFill>
-                  <a:srgbClr val="DC2626"/>
+              <a:spcBef>
+                <a:spcPts val="350"/>
+              </a:spcBef>
+              <a:buNone/>
+              <a:defRPr sz="1150">
+                <a:solidFill>
+                  <a:srgbClr val="0F172A"/>
                 </a:solidFill>
                 <a:latin typeface="Calibri"/>
                 <a:ea typeface="Calibri"/>
@@ -12614,10 +12480,13 @@
           </a:p>
           <a:p xmlns:a="http://schemas.openxmlformats.org/drawingml/2006/main">
             <a:pPr>
-              <a:buNone/>
-              <a:defRPr sz="1600" b="1">
-                <a:solidFill>
-                  <a:srgbClr val="DC2626"/>
+              <a:spcBef>
+                <a:spcPts val="350"/>
+              </a:spcBef>
+              <a:buNone/>
+              <a:defRPr sz="1150">
+                <a:solidFill>
+                  <a:srgbClr val="0F172A"/>
                 </a:solidFill>
                 <a:latin typeface="Calibri"/>
                 <a:ea typeface="Calibri"/>
@@ -12638,10 +12507,13 @@
           </a:p>
           <a:p xmlns:a="http://schemas.openxmlformats.org/drawingml/2006/main">
             <a:pPr>
-              <a:buNone/>
-              <a:defRPr sz="1600" b="1">
-                <a:solidFill>
-                  <a:srgbClr val="DC2626"/>
+              <a:spcBef>
+                <a:spcPts val="350"/>
+              </a:spcBef>
+              <a:buNone/>
+              <a:defRPr sz="1150">
+                <a:solidFill>
+                  <a:srgbClr val="0F172A"/>
                 </a:solidFill>
                 <a:latin typeface="Calibri"/>
                 <a:ea typeface="Calibri"/>
@@ -12662,10 +12534,13 @@
           </a:p>
           <a:p xmlns:a="http://schemas.openxmlformats.org/drawingml/2006/main">
             <a:pPr>
-              <a:buNone/>
-              <a:defRPr sz="1600" b="1">
-                <a:solidFill>
-                  <a:srgbClr val="DC2626"/>
+              <a:spcBef>
+                <a:spcPts val="350"/>
+              </a:spcBef>
+              <a:buNone/>
+              <a:defRPr sz="1150">
+                <a:solidFill>
+                  <a:srgbClr val="0F172A"/>
                 </a:solidFill>
                 <a:latin typeface="Calibri"/>
                 <a:ea typeface="Calibri"/>
@@ -12681,15 +12556,18 @@
                 <a:ea typeface="Calibri"/>
                 <a:cs typeface="Calibri"/>
               </a:rPr>
-              <a:t>★ Best Condition: rag_k10 (Tie-break: delta_macro_f1 | Delta Acc = +0.1000, Delta F1 = +0.0671)</a:t>
-            </a:r>
-          </a:p>
-          <a:p xmlns:a="http://schemas.openxmlformats.org/drawingml/2006/main">
-            <a:pPr>
-              <a:buNone/>
-              <a:defRPr sz="1600" b="1">
-                <a:solidFill>
-                  <a:srgbClr val="DC2626"/>
+              <a:t>★ Best Condition (Max Accuracy): rag_k10 (Delta Acc = +0.1000, Delta F1 = +0.0671)</a:t>
+            </a:r>
+          </a:p>
+          <a:p xmlns:a="http://schemas.openxmlformats.org/drawingml/2006/main">
+            <a:pPr>
+              <a:spcBef>
+                <a:spcPts val="350"/>
+              </a:spcBef>
+              <a:buNone/>
+              <a:defRPr sz="1150">
+                <a:solidFill>
+                  <a:srgbClr val="0F172A"/>
                 </a:solidFill>
                 <a:latin typeface="Calibri"/>
                 <a:ea typeface="Calibri"/>
@@ -12710,10 +12588,13 @@
           </a:p>
           <a:p xmlns:a="http://schemas.openxmlformats.org/drawingml/2006/main">
             <a:pPr>
-              <a:buNone/>
-              <a:defRPr sz="1600" b="1">
-                <a:solidFill>
-                  <a:srgbClr val="DC2626"/>
+              <a:spcBef>
+                <a:spcPts val="350"/>
+              </a:spcBef>
+              <a:buNone/>
+              <a:defRPr sz="1150">
+                <a:solidFill>
+                  <a:srgbClr val="0F172A"/>
                 </a:solidFill>
                 <a:latin typeface="Calibri"/>
                 <a:ea typeface="Calibri"/>
@@ -12737,7 +12618,7 @@
     </p:spTree>
     <p:extLst>
       <p:ext uri="{BB962C8B-B14F-4D97-AF65-F5344CB8AC3E}">
-        <p14:creationId xmlns:p14="http://schemas.microsoft.com/office/powerpoint/2010/main" val="789971688"/>
+        <p14:creationId xmlns:p14="http://schemas.microsoft.com/office/powerpoint/2010/main" val="196206519"/>
       </p:ext>
     </p:extLst>
   </p:cSld>
@@ -12761,7 +12642,7 @@
           <p:cNvPr id="2" name="Rectangle 1">
             <a:extLst xmlns:a="http://schemas.openxmlformats.org/drawingml/2006/main">
               <a:ext uri="{FF2B5EF4-FFF2-40B4-BE49-F238E27FC236}">
-                <a16:creationId xmlns:a16="http://schemas.microsoft.com/office/drawing/2014/main" id="{17663151-1947-4B04-9BE3-D5B77CE01653}"/>
+                <a16:creationId xmlns:a16="http://schemas.microsoft.com/office/drawing/2014/main" id="{92531751-03FD-4EFE-B94F-2834555A2C64}"/>
               </a:ext>
             </a:extLst>
           </p:cNvPr>
@@ -12814,7 +12695,7 @@
           <p:cNvPr id="3" name="Rectangle 2">
             <a:extLst xmlns:a="http://schemas.openxmlformats.org/drawingml/2006/main">
               <a:ext uri="{FF2B5EF4-FFF2-40B4-BE49-F238E27FC236}">
-                <a16:creationId xmlns:a16="http://schemas.microsoft.com/office/drawing/2014/main" id="{42C3471B-A5FF-488A-9C61-3A873F3504E3}"/>
+                <a16:creationId xmlns:a16="http://schemas.microsoft.com/office/drawing/2014/main" id="{7BCDB3E6-6731-4AEC-B3FD-3F21354D6B93}"/>
               </a:ext>
             </a:extLst>
           </p:cNvPr>
@@ -12867,7 +12748,7 @@
           <p:cNvPr id="4" name="Rectangle 3">
             <a:extLst xmlns:a="http://schemas.openxmlformats.org/drawingml/2006/main">
               <a:ext uri="{FF2B5EF4-FFF2-40B4-BE49-F238E27FC236}">
-                <a16:creationId xmlns:a16="http://schemas.microsoft.com/office/drawing/2014/main" id="{DE8A0F8E-FF2D-4BB7-9337-680364F99A11}"/>
+                <a16:creationId xmlns:a16="http://schemas.microsoft.com/office/drawing/2014/main" id="{20D4F9AE-8432-4412-9CD9-6460E8B9E2ED}"/>
               </a:ext>
             </a:extLst>
           </p:cNvPr>
@@ -12920,7 +12801,7 @@
           <p:cNvPr id="5" name="TextBox 4">
             <a:extLst xmlns:a="http://schemas.openxmlformats.org/drawingml/2006/main">
               <a:ext uri="{FF2B5EF4-FFF2-40B4-BE49-F238E27FC236}">
-                <a16:creationId xmlns:a16="http://schemas.microsoft.com/office/drawing/2014/main" id="{14D18ABD-5309-4462-8F6B-7BCD719B12EA}"/>
+                <a16:creationId xmlns:a16="http://schemas.microsoft.com/office/drawing/2014/main" id="{A452D14D-DED0-45F9-A573-0E45748C3830}"/>
               </a:ext>
             </a:extLst>
           </p:cNvPr>
@@ -12983,7 +12864,7 @@
           <p:cNvPr id="6" name="Rounded Rectangle 5">
             <a:extLst xmlns:a="http://schemas.openxmlformats.org/drawingml/2006/main">
               <a:ext uri="{FF2B5EF4-FFF2-40B4-BE49-F238E27FC236}">
-                <a16:creationId xmlns:a16="http://schemas.microsoft.com/office/drawing/2014/main" id="{6C7C2556-CA67-4B70-B176-563AEE2E005E}"/>
+                <a16:creationId xmlns:a16="http://schemas.microsoft.com/office/drawing/2014/main" id="{D351161A-D771-4537-8987-98ACD66D49E9}"/>
               </a:ext>
             </a:extLst>
           </p:cNvPr>
@@ -13038,7 +12919,7 @@
           <p:cNvPr id="7" name="TextBox 6">
             <a:extLst xmlns:a="http://schemas.openxmlformats.org/drawingml/2006/main">
               <a:ext uri="{FF2B5EF4-FFF2-40B4-BE49-F238E27FC236}">
-                <a16:creationId xmlns:a16="http://schemas.microsoft.com/office/drawing/2014/main" id="{F3F9D415-3CC6-4E45-8A4B-94531629B695}"/>
+                <a16:creationId xmlns:a16="http://schemas.microsoft.com/office/drawing/2014/main" id="{BF024B9A-639A-42A4-866F-3548F17D6736}"/>
               </a:ext>
             </a:extLst>
           </p:cNvPr>
@@ -13088,33 +12969,50 @@
           </a:p>
           <a:p xmlns:a="http://schemas.openxmlformats.org/drawingml/2006/main">
             <a:pPr>
-              <a:buNone/>
-              <a:defRPr sz="1600" b="1">
-                <a:solidFill>
-                  <a:srgbClr val="1E40AF"/>
-                </a:solidFill>
-                <a:latin typeface="Calibri"/>
-                <a:ea typeface="Calibri"/>
-                <a:cs typeface="Calibri"/>
-              </a:defRPr>
-            </a:pPr>
-          </a:p>
-          <a:p xmlns:a="http://schemas.openxmlformats.org/drawingml/2006/main">
-            <a:pPr>
-              <a:buNone/>
-              <a:defRPr sz="1600" b="1">
-                <a:solidFill>
-                  <a:srgbClr val="1E40AF"/>
-                </a:solidFill>
-                <a:latin typeface="Calibri"/>
-                <a:ea typeface="Calibri"/>
-                <a:cs typeface="Calibri"/>
-              </a:defRPr>
-            </a:pPr>
-            <a:r>
-              <a:rPr sz="825" b="1">
-                <a:solidFill>
-                  <a:srgbClr val="1E40AF"/>
+              <a:spcBef>
+                <a:spcPts val="200"/>
+              </a:spcBef>
+              <a:buNone/>
+              <a:defRPr sz="1050">
+                <a:solidFill>
+                  <a:srgbClr val="0F172A"/>
+                </a:solidFill>
+                <a:latin typeface="Calibri"/>
+                <a:ea typeface="Calibri"/>
+                <a:cs typeface="Calibri"/>
+              </a:defRPr>
+            </a:pPr>
+            <a:r>
+              <a:rPr sz="825">
+                <a:solidFill>
+                  <a:srgbClr val="0F172A"/>
+                </a:solidFill>
+                <a:latin typeface="Calibri"/>
+                <a:ea typeface="Calibri"/>
+                <a:cs typeface="Calibri"/>
+              </a:rPr>
+              <a:t/>
+            </a:r>
+          </a:p>
+          <a:p xmlns:a="http://schemas.openxmlformats.org/drawingml/2006/main">
+            <a:pPr>
+              <a:spcBef>
+                <a:spcPts val="200"/>
+              </a:spcBef>
+              <a:buNone/>
+              <a:defRPr sz="1050">
+                <a:solidFill>
+                  <a:srgbClr val="0F172A"/>
+                </a:solidFill>
+                <a:latin typeface="Calibri"/>
+                <a:ea typeface="Calibri"/>
+                <a:cs typeface="Calibri"/>
+              </a:defRPr>
+            </a:pPr>
+            <a:r>
+              <a:rPr sz="825">
+                <a:solidFill>
+                  <a:srgbClr val="0F172A"/>
                 </a:solidFill>
                 <a:latin typeface="Calibri"/>
                 <a:ea typeface="Calibri"/>
@@ -13125,20 +13023,23 @@
           </a:p>
           <a:p xmlns:a="http://schemas.openxmlformats.org/drawingml/2006/main">
             <a:pPr>
-              <a:buNone/>
-              <a:defRPr sz="1600" b="1">
-                <a:solidFill>
-                  <a:srgbClr val="1E40AF"/>
-                </a:solidFill>
-                <a:latin typeface="Calibri"/>
-                <a:ea typeface="Calibri"/>
-                <a:cs typeface="Calibri"/>
-              </a:defRPr>
-            </a:pPr>
-            <a:r>
-              <a:rPr sz="825" b="1">
-                <a:solidFill>
-                  <a:srgbClr val="1E40AF"/>
+              <a:spcBef>
+                <a:spcPts val="200"/>
+              </a:spcBef>
+              <a:buNone/>
+              <a:defRPr sz="1050">
+                <a:solidFill>
+                  <a:srgbClr val="0F172A"/>
+                </a:solidFill>
+                <a:latin typeface="Calibri"/>
+                <a:ea typeface="Calibri"/>
+                <a:cs typeface="Calibri"/>
+              </a:defRPr>
+            </a:pPr>
+            <a:r>
+              <a:rPr sz="825">
+                <a:solidFill>
+                  <a:srgbClr val="0F172A"/>
                 </a:solidFill>
                 <a:latin typeface="Calibri"/>
                 <a:ea typeface="Calibri"/>
@@ -13149,20 +13050,23 @@
           </a:p>
           <a:p xmlns:a="http://schemas.openxmlformats.org/drawingml/2006/main">
             <a:pPr>
-              <a:buNone/>
-              <a:defRPr sz="1600" b="1">
-                <a:solidFill>
-                  <a:srgbClr val="1E40AF"/>
-                </a:solidFill>
-                <a:latin typeface="Calibri"/>
-                <a:ea typeface="Calibri"/>
-                <a:cs typeface="Calibri"/>
-              </a:defRPr>
-            </a:pPr>
-            <a:r>
-              <a:rPr sz="825" b="1">
-                <a:solidFill>
-                  <a:srgbClr val="1E40AF"/>
+              <a:spcBef>
+                <a:spcPts val="200"/>
+              </a:spcBef>
+              <a:buNone/>
+              <a:defRPr sz="1050">
+                <a:solidFill>
+                  <a:srgbClr val="0F172A"/>
+                </a:solidFill>
+                <a:latin typeface="Calibri"/>
+                <a:ea typeface="Calibri"/>
+                <a:cs typeface="Calibri"/>
+              </a:defRPr>
+            </a:pPr>
+            <a:r>
+              <a:rPr sz="825">
+                <a:solidFill>
+                  <a:srgbClr val="0F172A"/>
                 </a:solidFill>
                 <a:latin typeface="Calibri"/>
                 <a:ea typeface="Calibri"/>
@@ -13173,33 +13077,50 @@
           </a:p>
           <a:p xmlns:a="http://schemas.openxmlformats.org/drawingml/2006/main">
             <a:pPr>
-              <a:buNone/>
-              <a:defRPr sz="1600" b="1">
-                <a:solidFill>
-                  <a:srgbClr val="1E40AF"/>
-                </a:solidFill>
-                <a:latin typeface="Calibri"/>
-                <a:ea typeface="Calibri"/>
-                <a:cs typeface="Calibri"/>
-              </a:defRPr>
-            </a:pPr>
-          </a:p>
-          <a:p xmlns:a="http://schemas.openxmlformats.org/drawingml/2006/main">
-            <a:pPr>
-              <a:buNone/>
-              <a:defRPr sz="1600" b="1">
-                <a:solidFill>
-                  <a:srgbClr val="1E40AF"/>
-                </a:solidFill>
-                <a:latin typeface="Calibri"/>
-                <a:ea typeface="Calibri"/>
-                <a:cs typeface="Calibri"/>
-              </a:defRPr>
-            </a:pPr>
-            <a:r>
-              <a:rPr sz="825" b="1">
-                <a:solidFill>
-                  <a:srgbClr val="1E40AF"/>
+              <a:spcBef>
+                <a:spcPts val="200"/>
+              </a:spcBef>
+              <a:buNone/>
+              <a:defRPr sz="1050">
+                <a:solidFill>
+                  <a:srgbClr val="0F172A"/>
+                </a:solidFill>
+                <a:latin typeface="Calibri"/>
+                <a:ea typeface="Calibri"/>
+                <a:cs typeface="Calibri"/>
+              </a:defRPr>
+            </a:pPr>
+            <a:r>
+              <a:rPr sz="825">
+                <a:solidFill>
+                  <a:srgbClr val="0F172A"/>
+                </a:solidFill>
+                <a:latin typeface="Calibri"/>
+                <a:ea typeface="Calibri"/>
+                <a:cs typeface="Calibri"/>
+              </a:rPr>
+              <a:t/>
+            </a:r>
+          </a:p>
+          <a:p xmlns:a="http://schemas.openxmlformats.org/drawingml/2006/main">
+            <a:pPr>
+              <a:spcBef>
+                <a:spcPts val="200"/>
+              </a:spcBef>
+              <a:buNone/>
+              <a:defRPr sz="1050">
+                <a:solidFill>
+                  <a:srgbClr val="0F172A"/>
+                </a:solidFill>
+                <a:latin typeface="Calibri"/>
+                <a:ea typeface="Calibri"/>
+                <a:cs typeface="Calibri"/>
+              </a:defRPr>
+            </a:pPr>
+            <a:r>
+              <a:rPr sz="825">
+                <a:solidFill>
+                  <a:srgbClr val="0F172A"/>
                 </a:solidFill>
                 <a:latin typeface="Calibri"/>
                 <a:ea typeface="Calibri"/>
@@ -13210,20 +13131,23 @@
           </a:p>
           <a:p xmlns:a="http://schemas.openxmlformats.org/drawingml/2006/main">
             <a:pPr>
-              <a:buNone/>
-              <a:defRPr sz="1600" b="1">
-                <a:solidFill>
-                  <a:srgbClr val="1E40AF"/>
-                </a:solidFill>
-                <a:latin typeface="Calibri"/>
-                <a:ea typeface="Calibri"/>
-                <a:cs typeface="Calibri"/>
-              </a:defRPr>
-            </a:pPr>
-            <a:r>
-              <a:rPr sz="825" b="1">
-                <a:solidFill>
-                  <a:srgbClr val="1E40AF"/>
+              <a:spcBef>
+                <a:spcPts val="200"/>
+              </a:spcBef>
+              <a:buNone/>
+              <a:defRPr sz="1050">
+                <a:solidFill>
+                  <a:srgbClr val="0F172A"/>
+                </a:solidFill>
+                <a:latin typeface="Calibri"/>
+                <a:ea typeface="Calibri"/>
+                <a:cs typeface="Calibri"/>
+              </a:defRPr>
+            </a:pPr>
+            <a:r>
+              <a:rPr sz="825">
+                <a:solidFill>
+                  <a:srgbClr val="0F172A"/>
                 </a:solidFill>
                 <a:latin typeface="Calibri"/>
                 <a:ea typeface="Calibri"/>
@@ -13234,20 +13158,23 @@
           </a:p>
           <a:p xmlns:a="http://schemas.openxmlformats.org/drawingml/2006/main">
             <a:pPr>
-              <a:buNone/>
-              <a:defRPr sz="1600" b="1">
-                <a:solidFill>
-                  <a:srgbClr val="1E40AF"/>
-                </a:solidFill>
-                <a:latin typeface="Calibri"/>
-                <a:ea typeface="Calibri"/>
-                <a:cs typeface="Calibri"/>
-              </a:defRPr>
-            </a:pPr>
-            <a:r>
-              <a:rPr sz="825" b="1">
-                <a:solidFill>
-                  <a:srgbClr val="1E40AF"/>
+              <a:spcBef>
+                <a:spcPts val="200"/>
+              </a:spcBef>
+              <a:buNone/>
+              <a:defRPr sz="1050">
+                <a:solidFill>
+                  <a:srgbClr val="0F172A"/>
+                </a:solidFill>
+                <a:latin typeface="Calibri"/>
+                <a:ea typeface="Calibri"/>
+                <a:cs typeface="Calibri"/>
+              </a:defRPr>
+            </a:pPr>
+            <a:r>
+              <a:rPr sz="825">
+                <a:solidFill>
+                  <a:srgbClr val="0F172A"/>
                 </a:solidFill>
                 <a:latin typeface="Calibri"/>
                 <a:ea typeface="Calibri"/>
@@ -13258,33 +13185,50 @@
           </a:p>
           <a:p xmlns:a="http://schemas.openxmlformats.org/drawingml/2006/main">
             <a:pPr>
-              <a:buNone/>
-              <a:defRPr sz="1600" b="1">
-                <a:solidFill>
-                  <a:srgbClr val="1E40AF"/>
-                </a:solidFill>
-                <a:latin typeface="Calibri"/>
-                <a:ea typeface="Calibri"/>
-                <a:cs typeface="Calibri"/>
-              </a:defRPr>
-            </a:pPr>
-          </a:p>
-          <a:p xmlns:a="http://schemas.openxmlformats.org/drawingml/2006/main">
-            <a:pPr>
-              <a:buNone/>
-              <a:defRPr sz="1600" b="1">
-                <a:solidFill>
-                  <a:srgbClr val="1E40AF"/>
-                </a:solidFill>
-                <a:latin typeface="Calibri"/>
-                <a:ea typeface="Calibri"/>
-                <a:cs typeface="Calibri"/>
-              </a:defRPr>
-            </a:pPr>
-            <a:r>
-              <a:rPr sz="825" b="1">
-                <a:solidFill>
-                  <a:srgbClr val="1E40AF"/>
+              <a:spcBef>
+                <a:spcPts val="200"/>
+              </a:spcBef>
+              <a:buNone/>
+              <a:defRPr sz="1050">
+                <a:solidFill>
+                  <a:srgbClr val="0F172A"/>
+                </a:solidFill>
+                <a:latin typeface="Calibri"/>
+                <a:ea typeface="Calibri"/>
+                <a:cs typeface="Calibri"/>
+              </a:defRPr>
+            </a:pPr>
+            <a:r>
+              <a:rPr sz="825">
+                <a:solidFill>
+                  <a:srgbClr val="0F172A"/>
+                </a:solidFill>
+                <a:latin typeface="Calibri"/>
+                <a:ea typeface="Calibri"/>
+                <a:cs typeface="Calibri"/>
+              </a:rPr>
+              <a:t/>
+            </a:r>
+          </a:p>
+          <a:p xmlns:a="http://schemas.openxmlformats.org/drawingml/2006/main">
+            <a:pPr>
+              <a:spcBef>
+                <a:spcPts val="200"/>
+              </a:spcBef>
+              <a:buNone/>
+              <a:defRPr sz="1050">
+                <a:solidFill>
+                  <a:srgbClr val="0F172A"/>
+                </a:solidFill>
+                <a:latin typeface="Calibri"/>
+                <a:ea typeface="Calibri"/>
+                <a:cs typeface="Calibri"/>
+              </a:defRPr>
+            </a:pPr>
+            <a:r>
+              <a:rPr sz="825">
+                <a:solidFill>
+                  <a:srgbClr val="0F172A"/>
                 </a:solidFill>
                 <a:latin typeface="Calibri"/>
                 <a:ea typeface="Calibri"/>
@@ -13295,20 +13239,23 @@
           </a:p>
           <a:p xmlns:a="http://schemas.openxmlformats.org/drawingml/2006/main">
             <a:pPr>
-              <a:buNone/>
-              <a:defRPr sz="1600" b="1">
-                <a:solidFill>
-                  <a:srgbClr val="1E40AF"/>
-                </a:solidFill>
-                <a:latin typeface="Calibri"/>
-                <a:ea typeface="Calibri"/>
-                <a:cs typeface="Calibri"/>
-              </a:defRPr>
-            </a:pPr>
-            <a:r>
-              <a:rPr sz="825" b="1">
-                <a:solidFill>
-                  <a:srgbClr val="1E40AF"/>
+              <a:spcBef>
+                <a:spcPts val="200"/>
+              </a:spcBef>
+              <a:buNone/>
+              <a:defRPr sz="1050">
+                <a:solidFill>
+                  <a:srgbClr val="0F172A"/>
+                </a:solidFill>
+                <a:latin typeface="Calibri"/>
+                <a:ea typeface="Calibri"/>
+                <a:cs typeface="Calibri"/>
+              </a:defRPr>
+            </a:pPr>
+            <a:r>
+              <a:rPr sz="825">
+                <a:solidFill>
+                  <a:srgbClr val="0F172A"/>
                 </a:solidFill>
                 <a:latin typeface="Calibri"/>
                 <a:ea typeface="Calibri"/>
@@ -13319,20 +13266,23 @@
           </a:p>
           <a:p xmlns:a="http://schemas.openxmlformats.org/drawingml/2006/main">
             <a:pPr>
-              <a:buNone/>
-              <a:defRPr sz="1600" b="1">
-                <a:solidFill>
-                  <a:srgbClr val="1E40AF"/>
-                </a:solidFill>
-                <a:latin typeface="Calibri"/>
-                <a:ea typeface="Calibri"/>
-                <a:cs typeface="Calibri"/>
-              </a:defRPr>
-            </a:pPr>
-            <a:r>
-              <a:rPr sz="825" b="1">
-                <a:solidFill>
-                  <a:srgbClr val="1E40AF"/>
+              <a:spcBef>
+                <a:spcPts val="200"/>
+              </a:spcBef>
+              <a:buNone/>
+              <a:defRPr sz="1050">
+                <a:solidFill>
+                  <a:srgbClr val="0F172A"/>
+                </a:solidFill>
+                <a:latin typeface="Calibri"/>
+                <a:ea typeface="Calibri"/>
+                <a:cs typeface="Calibri"/>
+              </a:defRPr>
+            </a:pPr>
+            <a:r>
+              <a:rPr sz="825">
+                <a:solidFill>
+                  <a:srgbClr val="0F172A"/>
                 </a:solidFill>
                 <a:latin typeface="Calibri"/>
                 <a:ea typeface="Calibri"/>
@@ -13343,20 +13293,23 @@
           </a:p>
           <a:p xmlns:a="http://schemas.openxmlformats.org/drawingml/2006/main">
             <a:pPr>
-              <a:buNone/>
-              <a:defRPr sz="1600" b="1">
-                <a:solidFill>
-                  <a:srgbClr val="1E40AF"/>
-                </a:solidFill>
-                <a:latin typeface="Calibri"/>
-                <a:ea typeface="Calibri"/>
-                <a:cs typeface="Calibri"/>
-              </a:defRPr>
-            </a:pPr>
-            <a:r>
-              <a:rPr sz="825" b="1">
-                <a:solidFill>
-                  <a:srgbClr val="1E40AF"/>
+              <a:spcBef>
+                <a:spcPts val="200"/>
+              </a:spcBef>
+              <a:buNone/>
+              <a:defRPr sz="1050">
+                <a:solidFill>
+                  <a:srgbClr val="0F172A"/>
+                </a:solidFill>
+                <a:latin typeface="Calibri"/>
+                <a:ea typeface="Calibri"/>
+                <a:cs typeface="Calibri"/>
+              </a:defRPr>
+            </a:pPr>
+            <a:r>
+              <a:rPr sz="825">
+                <a:solidFill>
+                  <a:srgbClr val="0F172A"/>
                 </a:solidFill>
                 <a:latin typeface="Calibri"/>
                 <a:ea typeface="Calibri"/>
@@ -13367,20 +13320,23 @@
           </a:p>
           <a:p xmlns:a="http://schemas.openxmlformats.org/drawingml/2006/main">
             <a:pPr>
-              <a:buNone/>
-              <a:defRPr sz="1600" b="1">
-                <a:solidFill>
-                  <a:srgbClr val="1E40AF"/>
-                </a:solidFill>
-                <a:latin typeface="Calibri"/>
-                <a:ea typeface="Calibri"/>
-                <a:cs typeface="Calibri"/>
-              </a:defRPr>
-            </a:pPr>
-            <a:r>
-              <a:rPr sz="825" b="1">
-                <a:solidFill>
-                  <a:srgbClr val="1E40AF"/>
+              <a:spcBef>
+                <a:spcPts val="200"/>
+              </a:spcBef>
+              <a:buNone/>
+              <a:defRPr sz="1050">
+                <a:solidFill>
+                  <a:srgbClr val="0F172A"/>
+                </a:solidFill>
+                <a:latin typeface="Calibri"/>
+                <a:ea typeface="Calibri"/>
+                <a:cs typeface="Calibri"/>
+              </a:defRPr>
+            </a:pPr>
+            <a:r>
+              <a:rPr sz="825">
+                <a:solidFill>
+                  <a:srgbClr val="0F172A"/>
                 </a:solidFill>
                 <a:latin typeface="Calibri"/>
                 <a:ea typeface="Calibri"/>
@@ -13400,7 +13356,7 @@
           <p:nvPr/>
         </p:nvPicPr>
         <p:blipFill>
-          <a:blip xmlns:r="http://schemas.openxmlformats.org/officeDocument/2006/relationships" xmlns:a="http://schemas.openxmlformats.org/drawingml/2006/main" r:embed="Rb6b814003b3849e3"/>
+          <a:blip xmlns:r="http://schemas.openxmlformats.org/officeDocument/2006/relationships" xmlns:a="http://schemas.openxmlformats.org/drawingml/2006/main" r:embed="R3294023274504ede"/>
           <a:stretch xmlns:a="http://schemas.openxmlformats.org/drawingml/2006/main">
             <a:fillRect l="0" t="0" r="0" b="0"/>
           </a:stretch>
@@ -13420,7 +13376,7 @@
           <p:cNvPr id="9" name="Rounded Rectangle 8">
             <a:extLst xmlns:a="http://schemas.openxmlformats.org/drawingml/2006/main">
               <a:ext uri="{FF2B5EF4-FFF2-40B4-BE49-F238E27FC236}">
-                <a16:creationId xmlns:a16="http://schemas.microsoft.com/office/drawing/2014/main" id="{EE50DCE1-1B46-4DD7-96E2-DA871FFF0F37}"/>
+                <a16:creationId xmlns:a16="http://schemas.microsoft.com/office/drawing/2014/main" id="{919AC1F1-15AD-437A-816A-8FF2C21A7D5E}"/>
               </a:ext>
             </a:extLst>
           </p:cNvPr>
@@ -13475,7 +13431,7 @@
           <p:cNvPr id="10" name="TextBox 9">
             <a:extLst xmlns:a="http://schemas.openxmlformats.org/drawingml/2006/main">
               <a:ext uri="{FF2B5EF4-FFF2-40B4-BE49-F238E27FC236}">
-                <a16:creationId xmlns:a16="http://schemas.microsoft.com/office/drawing/2014/main" id="{A4A772D4-9F9A-42BB-9C51-741B083D543B}"/>
+                <a16:creationId xmlns:a16="http://schemas.microsoft.com/office/drawing/2014/main" id="{3A1128B3-9AE8-476B-99FA-544C3534B638}"/>
               </a:ext>
             </a:extLst>
           </p:cNvPr>
@@ -13558,7 +13514,7 @@
     </p:spTree>
     <p:extLst>
       <p:ext uri="{BB962C8B-B14F-4D97-AF65-F5344CB8AC3E}">
-        <p14:creationId xmlns:p14="http://schemas.microsoft.com/office/powerpoint/2010/main" val="252054135"/>
+        <p14:creationId xmlns:p14="http://schemas.microsoft.com/office/powerpoint/2010/main" val="945164180"/>
       </p:ext>
     </p:extLst>
   </p:cSld>

</xml_diff>

<commit_message>
fix(presentation): author canonical presentation_v3 candidate with QA repairs
- Slide 1: add project, author, visible scope banner, and rich speaker notes
- Slide 6: establish canonical TEST results as primary narrative, demote historical/pilot views, replace image with verified native plot
- Slide 7: clarify complete pairs (238 identical GT, 40 divergent GT), marginal breakdown, observational framing
- Slide 8: 13pt table font, deltas with 474 Macro-F1 units, prominent non-significant CI note, scorable provider failure vs 13 INCOMPLETE dispatches
- Slide 9: 1,280 views denominator, distinct median/mean latency, exact financial accounting with pilot hold and remaining cap, replace image with verified native plot
- Slides 10-12: remove untested Hybrid assertion, frame real telemetry as unvalidated, clarify reproduce_study.py --all diagnostics, concise findings
- Re-import inspection verified with 12 slides, 12 notes, 67 declarative slots, 12 PNG previews in presentation_v3
</commit_message>
<xml_diff>
--- a/reports/evidence/fixture_populated_slides.pptx
+++ b/reports/evidence/fixture_populated_slides.pptx
@@ -2,24 +2,24 @@
 <file path=ppt/presentation.xml><?xml version="1.0" encoding="utf-8"?>
 <p:presentation xmlns:p="http://schemas.openxmlformats.org/presentationml/2006/main">
   <p:sldMasterIdLst>
-    <p:sldMasterId xmlns:r="http://schemas.openxmlformats.org/officeDocument/2006/relationships" id="2147483648" r:id="R274f9f041efd4180"/>
+    <p:sldMasterId xmlns:r="http://schemas.openxmlformats.org/officeDocument/2006/relationships" id="2147483648" r:id="R06eba26b0031408b"/>
   </p:sldMasterIdLst>
   <p:notesMasterIdLst>
-    <p:notesMasterId xmlns:r="http://schemas.openxmlformats.org/officeDocument/2006/relationships" r:id="R1cf397267a7c4c12"/>
+    <p:notesMasterId xmlns:r="http://schemas.openxmlformats.org/officeDocument/2006/relationships" r:id="Rd0676eb2cbdd4624"/>
   </p:notesMasterIdLst>
   <p:sldIdLst>
-    <p:sldId xmlns:r="http://schemas.openxmlformats.org/officeDocument/2006/relationships" id="256" r:id="R7b0985bc4c854692"/>
-    <p:sldId xmlns:r="http://schemas.openxmlformats.org/officeDocument/2006/relationships" id="257" r:id="R9d5d74b87498472a"/>
-    <p:sldId xmlns:r="http://schemas.openxmlformats.org/officeDocument/2006/relationships" id="258" r:id="R96e90c8f21fa464a"/>
-    <p:sldId xmlns:r="http://schemas.openxmlformats.org/officeDocument/2006/relationships" id="259" r:id="R2b76210bfe8941b6"/>
-    <p:sldId xmlns:r="http://schemas.openxmlformats.org/officeDocument/2006/relationships" id="260" r:id="Rbfc407cc7299481d"/>
-    <p:sldId xmlns:r="http://schemas.openxmlformats.org/officeDocument/2006/relationships" id="261" r:id="R40cbb9dd61f044d6"/>
-    <p:sldId xmlns:r="http://schemas.openxmlformats.org/officeDocument/2006/relationships" id="262" r:id="Rd0a7b7c4e67f4ae0"/>
-    <p:sldId xmlns:r="http://schemas.openxmlformats.org/officeDocument/2006/relationships" id="263" r:id="R1ab9cb9d156a499c"/>
-    <p:sldId xmlns:r="http://schemas.openxmlformats.org/officeDocument/2006/relationships" id="264" r:id="R034e6de3c9c2426f"/>
-    <p:sldId xmlns:r="http://schemas.openxmlformats.org/officeDocument/2006/relationships" id="265" r:id="R554f4ac4c32e48bd"/>
-    <p:sldId xmlns:r="http://schemas.openxmlformats.org/officeDocument/2006/relationships" id="266" r:id="Rc3bbbcccbdac43fc"/>
-    <p:sldId xmlns:r="http://schemas.openxmlformats.org/officeDocument/2006/relationships" id="267" r:id="Ra67ca09ad3954d51"/>
+    <p:sldId xmlns:r="http://schemas.openxmlformats.org/officeDocument/2006/relationships" id="256" r:id="R704dc800342a4958"/>
+    <p:sldId xmlns:r="http://schemas.openxmlformats.org/officeDocument/2006/relationships" id="257" r:id="Rec9c0df903a74190"/>
+    <p:sldId xmlns:r="http://schemas.openxmlformats.org/officeDocument/2006/relationships" id="258" r:id="R022b2cef642e496b"/>
+    <p:sldId xmlns:r="http://schemas.openxmlformats.org/officeDocument/2006/relationships" id="259" r:id="R2d6bcd37c10d40ee"/>
+    <p:sldId xmlns:r="http://schemas.openxmlformats.org/officeDocument/2006/relationships" id="260" r:id="R003d1749a3b94a10"/>
+    <p:sldId xmlns:r="http://schemas.openxmlformats.org/officeDocument/2006/relationships" id="261" r:id="Rb2d35a6f21314d86"/>
+    <p:sldId xmlns:r="http://schemas.openxmlformats.org/officeDocument/2006/relationships" id="262" r:id="R19647c8cc8d343bd"/>
+    <p:sldId xmlns:r="http://schemas.openxmlformats.org/officeDocument/2006/relationships" id="263" r:id="Re13eaf99b8054685"/>
+    <p:sldId xmlns:r="http://schemas.openxmlformats.org/officeDocument/2006/relationships" id="264" r:id="R73f99c8719e849f2"/>
+    <p:sldId xmlns:r="http://schemas.openxmlformats.org/officeDocument/2006/relationships" id="265" r:id="R87ca236a34b74c7e"/>
+    <p:sldId xmlns:r="http://schemas.openxmlformats.org/officeDocument/2006/relationships" id="266" r:id="Rdd16690946ed4743"/>
+    <p:sldId xmlns:r="http://schemas.openxmlformats.org/officeDocument/2006/relationships" id="267" r:id="Ra1bfd998b5994d42"/>
   </p:sldIdLst>
   <p:sldSz cx="12191695" cy="6858000"/>
   <p:notesSz cx="6858000" cy="9144000"/>
@@ -1329,11 +1329,6 @@
               <a:t>Bằng chứng dự án: reports/experiment_protocol_v1.md (D2e, D2f, D2h, D2i; SHA-256: d3bf3d31...); tests/test_experiment_evaluation.py (94 tests pass).</a:t>
             </a:r>
           </a:p>
-          <a:p xmlns:a="http://schemas.openxmlformats.org/drawingml/2006/main">
-            <a:r>
-              <a:t>[DIAGNOSTIC TEST FIXTURE STATS] Khoảng tin cậy 95% Bootstrap (B=1000): no_rag=[0.3500, 0.6500], rag_k1=[0.3600, 0.6600], rag_k3=[0.3800, 0.6800], rag_k5=[0.4100, 0.7100], rag_k10=[0.4300, 0.7300]. Đo lường phân rã lỗi D2i độc lập: Wrong Class Rate=0.3333, Overlaps (Miss &amp; Wrong=0, Miss &amp; Prov=0, Miss &amp; Parse=0, Miss &amp; Inval=0).</a:t>
-            </a:r>
-          </a:p>
         </p:txBody>
       </p:sp>
       <p:sp>
@@ -1426,7 +1421,7 @@
           </a:p>
           <a:p xmlns:a="http://schemas.openxmlformats.org/drawingml/2006/main">
             <a:r>
-              <a:t>4. Phân biệt rõ khoản giữ chỗ thận trọng tạm thời ($0.05264010 USD prior_pilot_provisional_hold_usd), dự báo chuẩn tắc tập TEST (hạch toán điều kiện chuẩn $8.50 USD (dự báo 6,400 requests) [DIAGNOSTIC FIXTURE PROJECTION]), và trần ngân sách đóng băng cứng $19.99 USD (hard_budget_limit_usd).</a:t>
+              <a:t>4. Phân biệt rõ khoản giữ chỗ thận trọng tạm thời ($0.05264010 USD prior_pilot_provisional_hold_usd), dự báo chuẩn tắc tập TEST ($8.20 – $8.99 USD cho 6,400 requests), và trần ngân sách đóng băng cứng $19.99 USD (hard_budget_limit_usd).</a:t>
             </a:r>
           </a:p>
           <a:p xmlns:a="http://schemas.openxmlformats.org/drawingml/2006/main">
@@ -1478,7 +1473,7 @@
           <p:cNvPr id="2" name="Title 1">
             <a:extLst xmlns:a="http://schemas.openxmlformats.org/drawingml/2006/main">
               <a:ext uri="{FF2B5EF4-FFF2-40B4-BE49-F238E27FC236}">
-                <a16:creationId xmlns:a16="http://schemas.microsoft.com/office/drawing/2014/main" id="{7F9F4A94-91CB-424A-8A1D-FBAD73BC8BF0}"/>
+                <a16:creationId xmlns:a16="http://schemas.microsoft.com/office/drawing/2014/main" id="{2C8F751D-BBB2-407F-B1FD-CBAA03D038A3}"/>
               </a:ext>
             </a:extLst>
           </p:cNvPr>
@@ -1511,7 +1506,7 @@
           <p:cNvPr id="3" name="Subtitle 2">
             <a:extLst xmlns:a="http://schemas.openxmlformats.org/drawingml/2006/main">
               <a:ext uri="{FF2B5EF4-FFF2-40B4-BE49-F238E27FC236}">
-                <a16:creationId xmlns:a16="http://schemas.microsoft.com/office/drawing/2014/main" id="{B6BC5920-7CCD-429F-8057-4C38DF69F9D4}"/>
+                <a16:creationId xmlns:a16="http://schemas.microsoft.com/office/drawing/2014/main" id="{A41EDC47-C5D2-4863-BFC5-EF89B610870E}"/>
               </a:ext>
             </a:extLst>
           </p:cNvPr>
@@ -1635,7 +1630,7 @@
           <p:cNvPr id="4" name="Date Placeholder 3">
             <a:extLst xmlns:a="http://schemas.openxmlformats.org/drawingml/2006/main">
               <a:ext uri="{FF2B5EF4-FFF2-40B4-BE49-F238E27FC236}">
-                <a16:creationId xmlns:a16="http://schemas.microsoft.com/office/drawing/2014/main" id="{089D4347-582A-4043-818F-CB3862A36D25}"/>
+                <a16:creationId xmlns:a16="http://schemas.microsoft.com/office/drawing/2014/main" id="{A6E046C5-078F-4B7F-9529-ECB3469A2B75}"/>
               </a:ext>
             </a:extLst>
           </p:cNvPr>
@@ -1663,7 +1658,7 @@
           <p:cNvPr id="5" name="Footer Placeholder 4">
             <a:extLst xmlns:a="http://schemas.openxmlformats.org/drawingml/2006/main">
               <a:ext uri="{FF2B5EF4-FFF2-40B4-BE49-F238E27FC236}">
-                <a16:creationId xmlns:a16="http://schemas.microsoft.com/office/drawing/2014/main" id="{BE8931ED-64EB-4B4A-A69F-879729F46D01}"/>
+                <a16:creationId xmlns:a16="http://schemas.microsoft.com/office/drawing/2014/main" id="{655D993E-1EA7-4FC2-B8B0-6CF8DF19FB1C}"/>
               </a:ext>
             </a:extLst>
           </p:cNvPr>
@@ -1688,7 +1683,7 @@
           <p:cNvPr id="6" name="Slide Number Placeholder 5">
             <a:extLst xmlns:a="http://schemas.openxmlformats.org/drawingml/2006/main">
               <a:ext uri="{FF2B5EF4-FFF2-40B4-BE49-F238E27FC236}">
-                <a16:creationId xmlns:a16="http://schemas.microsoft.com/office/drawing/2014/main" id="{522893BE-1C03-4208-9B47-9E27FAAECB9D}"/>
+                <a16:creationId xmlns:a16="http://schemas.microsoft.com/office/drawing/2014/main" id="{11215D80-0CF2-49A8-96B2-579BD8C5870B}"/>
               </a:ext>
             </a:extLst>
           </p:cNvPr>
@@ -1733,7 +1728,7 @@
           <p:cNvPr id="2" name="Title 1">
             <a:extLst xmlns:a="http://schemas.openxmlformats.org/drawingml/2006/main">
               <a:ext uri="{FF2B5EF4-FFF2-40B4-BE49-F238E27FC236}">
-                <a16:creationId xmlns:a16="http://schemas.microsoft.com/office/drawing/2014/main" id="{76CEB976-BC5D-4254-BEF5-A29787C1CB55}"/>
+                <a16:creationId xmlns:a16="http://schemas.microsoft.com/office/drawing/2014/main" id="{181DC361-3EB9-4DFC-B7A3-A43468FD3349}"/>
               </a:ext>
             </a:extLst>
           </p:cNvPr>
@@ -1761,7 +1756,7 @@
           <p:cNvPr id="3" name="Vertical Text Placeholder 2">
             <a:extLst xmlns:a="http://schemas.openxmlformats.org/drawingml/2006/main">
               <a:ext uri="{FF2B5EF4-FFF2-40B4-BE49-F238E27FC236}">
-                <a16:creationId xmlns:a16="http://schemas.microsoft.com/office/drawing/2014/main" id="{FF25C106-3A88-4EAA-97E0-3CC6E26F43A6}"/>
+                <a16:creationId xmlns:a16="http://schemas.microsoft.com/office/drawing/2014/main" id="{F3CD5E12-99AA-4500-8A0A-53C7CB1972B6}"/>
               </a:ext>
             </a:extLst>
           </p:cNvPr>
@@ -1824,7 +1819,7 @@
           <p:cNvPr id="4" name="Date Placeholder 3">
             <a:extLst xmlns:a="http://schemas.openxmlformats.org/drawingml/2006/main">
               <a:ext uri="{FF2B5EF4-FFF2-40B4-BE49-F238E27FC236}">
-                <a16:creationId xmlns:a16="http://schemas.microsoft.com/office/drawing/2014/main" id="{8909FA72-8677-4BCF-8414-F28359CD16E2}"/>
+                <a16:creationId xmlns:a16="http://schemas.microsoft.com/office/drawing/2014/main" id="{C1DD2F1F-870A-470D-8834-8C5AACE752DB}"/>
               </a:ext>
             </a:extLst>
           </p:cNvPr>
@@ -1852,7 +1847,7 @@
           <p:cNvPr id="5" name="Footer Placeholder 4">
             <a:extLst xmlns:a="http://schemas.openxmlformats.org/drawingml/2006/main">
               <a:ext uri="{FF2B5EF4-FFF2-40B4-BE49-F238E27FC236}">
-                <a16:creationId xmlns:a16="http://schemas.microsoft.com/office/drawing/2014/main" id="{06E6DAD7-B965-4170-B3C1-AD1D9035BA05}"/>
+                <a16:creationId xmlns:a16="http://schemas.microsoft.com/office/drawing/2014/main" id="{917A3C8E-8497-4A79-A94C-9B5ECFCDDBBE}"/>
               </a:ext>
             </a:extLst>
           </p:cNvPr>
@@ -1877,7 +1872,7 @@
           <p:cNvPr id="6" name="Slide Number Placeholder 5">
             <a:extLst xmlns:a="http://schemas.openxmlformats.org/drawingml/2006/main">
               <a:ext uri="{FF2B5EF4-FFF2-40B4-BE49-F238E27FC236}">
-                <a16:creationId xmlns:a16="http://schemas.microsoft.com/office/drawing/2014/main" id="{527A6FDC-F304-431E-A339-9637FB4491A1}"/>
+                <a16:creationId xmlns:a16="http://schemas.microsoft.com/office/drawing/2014/main" id="{EB0A56A6-F4BF-4CF9-953A-746C44187DBC}"/>
               </a:ext>
             </a:extLst>
           </p:cNvPr>
@@ -1922,7 +1917,7 @@
           <p:cNvPr id="2" name="Vertical Title 1">
             <a:extLst xmlns:a="http://schemas.openxmlformats.org/drawingml/2006/main">
               <a:ext uri="{FF2B5EF4-FFF2-40B4-BE49-F238E27FC236}">
-                <a16:creationId xmlns:a16="http://schemas.microsoft.com/office/drawing/2014/main" id="{26EAEEDF-B950-48E6-8D6B-5BDE8BBA51E6}"/>
+                <a16:creationId xmlns:a16="http://schemas.microsoft.com/office/drawing/2014/main" id="{28224DAC-62F3-4762-8378-15C7EDCBE706}"/>
               </a:ext>
             </a:extLst>
           </p:cNvPr>
@@ -1955,7 +1950,7 @@
           <p:cNvPr id="3" name="Vertical Text Placeholder 2">
             <a:extLst xmlns:a="http://schemas.openxmlformats.org/drawingml/2006/main">
               <a:ext uri="{FF2B5EF4-FFF2-40B4-BE49-F238E27FC236}">
-                <a16:creationId xmlns:a16="http://schemas.microsoft.com/office/drawing/2014/main" id="{0C753CE7-85E7-4073-BA4B-7C635AC1D59B}"/>
+                <a16:creationId xmlns:a16="http://schemas.microsoft.com/office/drawing/2014/main" id="{A5ADFDD9-D561-4F75-AB72-3562AE206331}"/>
               </a:ext>
             </a:extLst>
           </p:cNvPr>
@@ -2023,7 +2018,7 @@
           <p:cNvPr id="4" name="Date Placeholder 3">
             <a:extLst xmlns:a="http://schemas.openxmlformats.org/drawingml/2006/main">
               <a:ext uri="{FF2B5EF4-FFF2-40B4-BE49-F238E27FC236}">
-                <a16:creationId xmlns:a16="http://schemas.microsoft.com/office/drawing/2014/main" id="{96AD8E39-26B6-42C2-90B9-03A4D0DE1F81}"/>
+                <a16:creationId xmlns:a16="http://schemas.microsoft.com/office/drawing/2014/main" id="{371BFE7E-AB08-45A1-B2F2-8DD35A366ADA}"/>
               </a:ext>
             </a:extLst>
           </p:cNvPr>
@@ -2051,7 +2046,7 @@
           <p:cNvPr id="5" name="Footer Placeholder 4">
             <a:extLst xmlns:a="http://schemas.openxmlformats.org/drawingml/2006/main">
               <a:ext uri="{FF2B5EF4-FFF2-40B4-BE49-F238E27FC236}">
-                <a16:creationId xmlns:a16="http://schemas.microsoft.com/office/drawing/2014/main" id="{272AF1D7-0D75-4A18-B82A-31BA285ADBA9}"/>
+                <a16:creationId xmlns:a16="http://schemas.microsoft.com/office/drawing/2014/main" id="{48663519-FEFF-4A74-8F73-208B88219EBF}"/>
               </a:ext>
             </a:extLst>
           </p:cNvPr>
@@ -2076,7 +2071,7 @@
           <p:cNvPr id="6" name="Slide Number Placeholder 5">
             <a:extLst xmlns:a="http://schemas.openxmlformats.org/drawingml/2006/main">
               <a:ext uri="{FF2B5EF4-FFF2-40B4-BE49-F238E27FC236}">
-                <a16:creationId xmlns:a16="http://schemas.microsoft.com/office/drawing/2014/main" id="{6D8F27B7-39AD-41DC-B0CD-B139F1D1C53F}"/>
+                <a16:creationId xmlns:a16="http://schemas.microsoft.com/office/drawing/2014/main" id="{6E1FBDF5-15F5-4B61-A723-7D5A85AAD103}"/>
               </a:ext>
             </a:extLst>
           </p:cNvPr>
@@ -2121,7 +2116,7 @@
           <p:cNvPr id="2" name="Title 1">
             <a:extLst xmlns:a="http://schemas.openxmlformats.org/drawingml/2006/main">
               <a:ext uri="{FF2B5EF4-FFF2-40B4-BE49-F238E27FC236}">
-                <a16:creationId xmlns:a16="http://schemas.microsoft.com/office/drawing/2014/main" id="{4B83E4DF-7F4E-471E-A116-3BC2B2BA855E}"/>
+                <a16:creationId xmlns:a16="http://schemas.microsoft.com/office/drawing/2014/main" id="{37E8CE7A-DA9A-4B9E-89AC-DB438A0D0428}"/>
               </a:ext>
             </a:extLst>
           </p:cNvPr>
@@ -2149,7 +2144,7 @@
           <p:cNvPr id="3" name="Content Placeholder 2">
             <a:extLst xmlns:a="http://schemas.openxmlformats.org/drawingml/2006/main">
               <a:ext uri="{FF2B5EF4-FFF2-40B4-BE49-F238E27FC236}">
-                <a16:creationId xmlns:a16="http://schemas.microsoft.com/office/drawing/2014/main" id="{14D862CC-559D-4A60-A8F4-9383E63D505E}"/>
+                <a16:creationId xmlns:a16="http://schemas.microsoft.com/office/drawing/2014/main" id="{4CF6479E-383B-482E-A62A-76D127BB8B98}"/>
               </a:ext>
             </a:extLst>
           </p:cNvPr>
@@ -2212,7 +2207,7 @@
           <p:cNvPr id="4" name="Date Placeholder 3">
             <a:extLst xmlns:a="http://schemas.openxmlformats.org/drawingml/2006/main">
               <a:ext uri="{FF2B5EF4-FFF2-40B4-BE49-F238E27FC236}">
-                <a16:creationId xmlns:a16="http://schemas.microsoft.com/office/drawing/2014/main" id="{C2538781-E835-4A51-9D70-B55B5A08474A}"/>
+                <a16:creationId xmlns:a16="http://schemas.microsoft.com/office/drawing/2014/main" id="{B45CEB87-92A5-40BF-ABE9-EEAB6220245D}"/>
               </a:ext>
             </a:extLst>
           </p:cNvPr>
@@ -2240,7 +2235,7 @@
           <p:cNvPr id="5" name="Footer Placeholder 4">
             <a:extLst xmlns:a="http://schemas.openxmlformats.org/drawingml/2006/main">
               <a:ext uri="{FF2B5EF4-FFF2-40B4-BE49-F238E27FC236}">
-                <a16:creationId xmlns:a16="http://schemas.microsoft.com/office/drawing/2014/main" id="{58908AF4-D5A3-4344-84B7-1AD3E8FA71B6}"/>
+                <a16:creationId xmlns:a16="http://schemas.microsoft.com/office/drawing/2014/main" id="{3042404D-7491-49BE-80C0-345818BB2431}"/>
               </a:ext>
             </a:extLst>
           </p:cNvPr>
@@ -2265,7 +2260,7 @@
           <p:cNvPr id="6" name="Slide Number Placeholder 5">
             <a:extLst xmlns:a="http://schemas.openxmlformats.org/drawingml/2006/main">
               <a:ext uri="{FF2B5EF4-FFF2-40B4-BE49-F238E27FC236}">
-                <a16:creationId xmlns:a16="http://schemas.microsoft.com/office/drawing/2014/main" id="{2C4AFE69-6E39-4BBE-A10E-C737A4324FB7}"/>
+                <a16:creationId xmlns:a16="http://schemas.microsoft.com/office/drawing/2014/main" id="{9B868759-DABF-49D1-A7B8-B0ED988F2125}"/>
               </a:ext>
             </a:extLst>
           </p:cNvPr>
@@ -2310,7 +2305,7 @@
           <p:cNvPr id="2" name="Title 1">
             <a:extLst xmlns:a="http://schemas.openxmlformats.org/drawingml/2006/main">
               <a:ext uri="{FF2B5EF4-FFF2-40B4-BE49-F238E27FC236}">
-                <a16:creationId xmlns:a16="http://schemas.microsoft.com/office/drawing/2014/main" id="{0E528F2E-32AB-4A9E-ACD7-6B78CF30A70E}"/>
+                <a16:creationId xmlns:a16="http://schemas.microsoft.com/office/drawing/2014/main" id="{DEE90E17-3199-4FCF-A4C2-65C193705046}"/>
               </a:ext>
             </a:extLst>
           </p:cNvPr>
@@ -2348,7 +2343,7 @@
           <p:cNvPr id="3" name="Text Placeholder 2">
             <a:extLst xmlns:a="http://schemas.openxmlformats.org/drawingml/2006/main">
               <a:ext uri="{FF2B5EF4-FFF2-40B4-BE49-F238E27FC236}">
-                <a16:creationId xmlns:a16="http://schemas.microsoft.com/office/drawing/2014/main" id="{8CB6D19D-95F1-4A92-9D60-322E9ABFDCAA}"/>
+                <a16:creationId xmlns:a16="http://schemas.microsoft.com/office/drawing/2014/main" id="{92058563-B747-402A-BCA6-2F991666BD6E}"/>
               </a:ext>
             </a:extLst>
           </p:cNvPr>
@@ -2474,7 +2469,7 @@
           <p:cNvPr id="4" name="Date Placeholder 3">
             <a:extLst xmlns:a="http://schemas.openxmlformats.org/drawingml/2006/main">
               <a:ext uri="{FF2B5EF4-FFF2-40B4-BE49-F238E27FC236}">
-                <a16:creationId xmlns:a16="http://schemas.microsoft.com/office/drawing/2014/main" id="{7D4C5350-EB35-413C-9447-7DB87799EA24}"/>
+                <a16:creationId xmlns:a16="http://schemas.microsoft.com/office/drawing/2014/main" id="{3E101C9D-47E2-4F2C-A46E-EED1D3B7BDDC}"/>
               </a:ext>
             </a:extLst>
           </p:cNvPr>
@@ -2502,7 +2497,7 @@
           <p:cNvPr id="5" name="Footer Placeholder 4">
             <a:extLst xmlns:a="http://schemas.openxmlformats.org/drawingml/2006/main">
               <a:ext uri="{FF2B5EF4-FFF2-40B4-BE49-F238E27FC236}">
-                <a16:creationId xmlns:a16="http://schemas.microsoft.com/office/drawing/2014/main" id="{885A5292-0144-445A-97E0-DCE845CF6A0C}"/>
+                <a16:creationId xmlns:a16="http://schemas.microsoft.com/office/drawing/2014/main" id="{3A53D8F0-9846-4E1C-BC15-38A6F70918EC}"/>
               </a:ext>
             </a:extLst>
           </p:cNvPr>
@@ -2527,7 +2522,7 @@
           <p:cNvPr id="6" name="Slide Number Placeholder 5">
             <a:extLst xmlns:a="http://schemas.openxmlformats.org/drawingml/2006/main">
               <a:ext uri="{FF2B5EF4-FFF2-40B4-BE49-F238E27FC236}">
-                <a16:creationId xmlns:a16="http://schemas.microsoft.com/office/drawing/2014/main" id="{7397089C-F506-4BD3-8088-729C4535D27F}"/>
+                <a16:creationId xmlns:a16="http://schemas.microsoft.com/office/drawing/2014/main" id="{F31A51A3-BDB9-4212-9B4A-002248452C9D}"/>
               </a:ext>
             </a:extLst>
           </p:cNvPr>
@@ -2572,7 +2567,7 @@
           <p:cNvPr id="2" name="Title 1">
             <a:extLst xmlns:a="http://schemas.openxmlformats.org/drawingml/2006/main">
               <a:ext uri="{FF2B5EF4-FFF2-40B4-BE49-F238E27FC236}">
-                <a16:creationId xmlns:a16="http://schemas.microsoft.com/office/drawing/2014/main" id="{363F692C-E8A1-4DB9-91CE-D5CCA936D077}"/>
+                <a16:creationId xmlns:a16="http://schemas.microsoft.com/office/drawing/2014/main" id="{1C2FF34F-7673-4DCF-AAA9-B8B0C95FBD99}"/>
               </a:ext>
             </a:extLst>
           </p:cNvPr>
@@ -2600,7 +2595,7 @@
           <p:cNvPr id="3" name="Content Placeholder 2">
             <a:extLst xmlns:a="http://schemas.openxmlformats.org/drawingml/2006/main">
               <a:ext uri="{FF2B5EF4-FFF2-40B4-BE49-F238E27FC236}">
-                <a16:creationId xmlns:a16="http://schemas.microsoft.com/office/drawing/2014/main" id="{9573F911-4E6D-473D-B6EF-D19010A2C092}"/>
+                <a16:creationId xmlns:a16="http://schemas.microsoft.com/office/drawing/2014/main" id="{7DC212B9-653F-46E8-92A4-92413D7BF0C4}"/>
               </a:ext>
             </a:extLst>
           </p:cNvPr>
@@ -2705,7 +2700,7 @@
           <p:cNvPr id="4" name="Content Placeholder 3">
             <a:extLst xmlns:a="http://schemas.openxmlformats.org/drawingml/2006/main">
               <a:ext uri="{FF2B5EF4-FFF2-40B4-BE49-F238E27FC236}">
-                <a16:creationId xmlns:a16="http://schemas.microsoft.com/office/drawing/2014/main" id="{410ED996-2753-450F-9961-A3021D16207D}"/>
+                <a16:creationId xmlns:a16="http://schemas.microsoft.com/office/drawing/2014/main" id="{3EA4E581-8B32-4056-BE10-EB7E9F4D7181}"/>
               </a:ext>
             </a:extLst>
           </p:cNvPr>
@@ -2810,7 +2805,7 @@
           <p:cNvPr id="5" name="Date Placeholder 4">
             <a:extLst xmlns:a="http://schemas.openxmlformats.org/drawingml/2006/main">
               <a:ext uri="{FF2B5EF4-FFF2-40B4-BE49-F238E27FC236}">
-                <a16:creationId xmlns:a16="http://schemas.microsoft.com/office/drawing/2014/main" id="{894DB9DA-A6F3-422E-A2FD-77E938B82EE8}"/>
+                <a16:creationId xmlns:a16="http://schemas.microsoft.com/office/drawing/2014/main" id="{89AB1CFD-E660-4B01-8C73-27085C9C76B2}"/>
               </a:ext>
             </a:extLst>
           </p:cNvPr>
@@ -2838,7 +2833,7 @@
           <p:cNvPr id="6" name="Footer Placeholder 5">
             <a:extLst xmlns:a="http://schemas.openxmlformats.org/drawingml/2006/main">
               <a:ext uri="{FF2B5EF4-FFF2-40B4-BE49-F238E27FC236}">
-                <a16:creationId xmlns:a16="http://schemas.microsoft.com/office/drawing/2014/main" id="{8C9BAFFB-0C38-4942-A0D8-EDA64D122D22}"/>
+                <a16:creationId xmlns:a16="http://schemas.microsoft.com/office/drawing/2014/main" id="{B3714E9B-EE8B-4599-AB1D-3C7052A04DEC}"/>
               </a:ext>
             </a:extLst>
           </p:cNvPr>
@@ -2863,7 +2858,7 @@
           <p:cNvPr id="7" name="Slide Number Placeholder 6">
             <a:extLst xmlns:a="http://schemas.openxmlformats.org/drawingml/2006/main">
               <a:ext uri="{FF2B5EF4-FFF2-40B4-BE49-F238E27FC236}">
-                <a16:creationId xmlns:a16="http://schemas.microsoft.com/office/drawing/2014/main" id="{F48EC67E-7B1D-432E-8E8B-5A6F0C05AE5B}"/>
+                <a16:creationId xmlns:a16="http://schemas.microsoft.com/office/drawing/2014/main" id="{255086E7-D67C-419C-ABE2-E372679E9FF3}"/>
               </a:ext>
             </a:extLst>
           </p:cNvPr>
@@ -2908,7 +2903,7 @@
           <p:cNvPr id="2" name="Title 1">
             <a:extLst xmlns:a="http://schemas.openxmlformats.org/drawingml/2006/main">
               <a:ext uri="{FF2B5EF4-FFF2-40B4-BE49-F238E27FC236}">
-                <a16:creationId xmlns:a16="http://schemas.microsoft.com/office/drawing/2014/main" id="{1FF73F2E-45F2-41E9-A9F5-1EA9C6B2559F}"/>
+                <a16:creationId xmlns:a16="http://schemas.microsoft.com/office/drawing/2014/main" id="{F0E4D588-BD69-47F6-ABD4-8BEE5B9BA74C}"/>
               </a:ext>
             </a:extLst>
           </p:cNvPr>
@@ -2941,7 +2936,7 @@
           <p:cNvPr id="3" name="Text Placeholder 2">
             <a:extLst xmlns:a="http://schemas.openxmlformats.org/drawingml/2006/main">
               <a:ext uri="{FF2B5EF4-FFF2-40B4-BE49-F238E27FC236}">
-                <a16:creationId xmlns:a16="http://schemas.microsoft.com/office/drawing/2014/main" id="{4AB6ECAE-9296-4FBF-9124-6AA61A3146A9}"/>
+                <a16:creationId xmlns:a16="http://schemas.microsoft.com/office/drawing/2014/main" id="{B297218F-67C7-4B7C-B67E-9AB1A825F7C0}"/>
               </a:ext>
             </a:extLst>
           </p:cNvPr>
@@ -3013,7 +3008,7 @@
           <p:cNvPr id="4" name="Content Placeholder 3">
             <a:extLst xmlns:a="http://schemas.openxmlformats.org/drawingml/2006/main">
               <a:ext uri="{FF2B5EF4-FFF2-40B4-BE49-F238E27FC236}">
-                <a16:creationId xmlns:a16="http://schemas.microsoft.com/office/drawing/2014/main" id="{4ED0A156-ED97-42B5-BD54-0CCBFD4E0962}"/>
+                <a16:creationId xmlns:a16="http://schemas.microsoft.com/office/drawing/2014/main" id="{3089D3EC-1884-47F1-A255-C7FD724F0422}"/>
               </a:ext>
             </a:extLst>
           </p:cNvPr>
@@ -3118,7 +3113,7 @@
           <p:cNvPr id="5" name="Text Placeholder 4">
             <a:extLst xmlns:a="http://schemas.openxmlformats.org/drawingml/2006/main">
               <a:ext uri="{FF2B5EF4-FFF2-40B4-BE49-F238E27FC236}">
-                <a16:creationId xmlns:a16="http://schemas.microsoft.com/office/drawing/2014/main" id="{053A8CA3-2D02-412F-AF9E-F968628BB4EA}"/>
+                <a16:creationId xmlns:a16="http://schemas.microsoft.com/office/drawing/2014/main" id="{89DB6414-37CA-44BA-BA37-11A5B016D66E}"/>
               </a:ext>
             </a:extLst>
           </p:cNvPr>
@@ -3190,7 +3185,7 @@
           <p:cNvPr id="6" name="Content Placeholder 5">
             <a:extLst xmlns:a="http://schemas.openxmlformats.org/drawingml/2006/main">
               <a:ext uri="{FF2B5EF4-FFF2-40B4-BE49-F238E27FC236}">
-                <a16:creationId xmlns:a16="http://schemas.microsoft.com/office/drawing/2014/main" id="{714C9A1A-9A27-4500-8AFA-3AE2129128DB}"/>
+                <a16:creationId xmlns:a16="http://schemas.microsoft.com/office/drawing/2014/main" id="{95C5D29B-016B-4106-8D53-B935089BC914}"/>
               </a:ext>
             </a:extLst>
           </p:cNvPr>
@@ -3295,7 +3290,7 @@
           <p:cNvPr id="7" name="Date Placeholder 6">
             <a:extLst xmlns:a="http://schemas.openxmlformats.org/drawingml/2006/main">
               <a:ext uri="{FF2B5EF4-FFF2-40B4-BE49-F238E27FC236}">
-                <a16:creationId xmlns:a16="http://schemas.microsoft.com/office/drawing/2014/main" id="{84858CCD-587C-4F4F-B7B1-308CD8BE72D2}"/>
+                <a16:creationId xmlns:a16="http://schemas.microsoft.com/office/drawing/2014/main" id="{CCEE5D68-BD6F-416D-8473-88B2D6D53C29}"/>
               </a:ext>
             </a:extLst>
           </p:cNvPr>
@@ -3323,7 +3318,7 @@
           <p:cNvPr id="8" name="Footer Placeholder 7">
             <a:extLst xmlns:a="http://schemas.openxmlformats.org/drawingml/2006/main">
               <a:ext uri="{FF2B5EF4-FFF2-40B4-BE49-F238E27FC236}">
-                <a16:creationId xmlns:a16="http://schemas.microsoft.com/office/drawing/2014/main" id="{E2A251AC-3AF5-4FAB-BF5A-F2AB82556AB2}"/>
+                <a16:creationId xmlns:a16="http://schemas.microsoft.com/office/drawing/2014/main" id="{79B63406-747C-44C2-8601-DFDF45A89E13}"/>
               </a:ext>
             </a:extLst>
           </p:cNvPr>
@@ -3348,7 +3343,7 @@
           <p:cNvPr id="9" name="Slide Number Placeholder 8">
             <a:extLst xmlns:a="http://schemas.openxmlformats.org/drawingml/2006/main">
               <a:ext uri="{FF2B5EF4-FFF2-40B4-BE49-F238E27FC236}">
-                <a16:creationId xmlns:a16="http://schemas.microsoft.com/office/drawing/2014/main" id="{46F65EDB-B20B-4258-A2A5-ABEBF6D14D18}"/>
+                <a16:creationId xmlns:a16="http://schemas.microsoft.com/office/drawing/2014/main" id="{9BFF0A29-A7C5-496E-A8A3-B27768949171}"/>
               </a:ext>
             </a:extLst>
           </p:cNvPr>
@@ -3393,7 +3388,7 @@
           <p:cNvPr id="2" name="Title 1">
             <a:extLst xmlns:a="http://schemas.openxmlformats.org/drawingml/2006/main">
               <a:ext uri="{FF2B5EF4-FFF2-40B4-BE49-F238E27FC236}">
-                <a16:creationId xmlns:a16="http://schemas.microsoft.com/office/drawing/2014/main" id="{2A9F2950-6973-4B5D-A233-ADFF49E0A0A0}"/>
+                <a16:creationId xmlns:a16="http://schemas.microsoft.com/office/drawing/2014/main" id="{130F96E5-F900-4428-8A54-6392AF101EF3}"/>
               </a:ext>
             </a:extLst>
           </p:cNvPr>
@@ -3421,7 +3416,7 @@
           <p:cNvPr id="3" name="Date Placeholder 2">
             <a:extLst xmlns:a="http://schemas.openxmlformats.org/drawingml/2006/main">
               <a:ext uri="{FF2B5EF4-FFF2-40B4-BE49-F238E27FC236}">
-                <a16:creationId xmlns:a16="http://schemas.microsoft.com/office/drawing/2014/main" id="{F6DE420F-0A84-4AAE-849D-BCCE31855278}"/>
+                <a16:creationId xmlns:a16="http://schemas.microsoft.com/office/drawing/2014/main" id="{387ECDB1-7477-4F83-802E-CA3CC066BAFB}"/>
               </a:ext>
             </a:extLst>
           </p:cNvPr>
@@ -3449,7 +3444,7 @@
           <p:cNvPr id="4" name="Footer Placeholder 3">
             <a:extLst xmlns:a="http://schemas.openxmlformats.org/drawingml/2006/main">
               <a:ext uri="{FF2B5EF4-FFF2-40B4-BE49-F238E27FC236}">
-                <a16:creationId xmlns:a16="http://schemas.microsoft.com/office/drawing/2014/main" id="{2D5DE67F-7D27-4BA3-B576-D9AD0A2E70BF}"/>
+                <a16:creationId xmlns:a16="http://schemas.microsoft.com/office/drawing/2014/main" id="{41703CA0-7099-4640-BB38-9409F3E2C5E7}"/>
               </a:ext>
             </a:extLst>
           </p:cNvPr>
@@ -3474,7 +3469,7 @@
           <p:cNvPr id="5" name="Slide Number Placeholder 4">
             <a:extLst xmlns:a="http://schemas.openxmlformats.org/drawingml/2006/main">
               <a:ext uri="{FF2B5EF4-FFF2-40B4-BE49-F238E27FC236}">
-                <a16:creationId xmlns:a16="http://schemas.microsoft.com/office/drawing/2014/main" id="{D4E70B06-ACE7-436B-BC7C-F626B13B5081}"/>
+                <a16:creationId xmlns:a16="http://schemas.microsoft.com/office/drawing/2014/main" id="{ECB1152E-4A10-4DEC-8608-3DA1651174D1}"/>
               </a:ext>
             </a:extLst>
           </p:cNvPr>
@@ -3519,7 +3514,7 @@
           <p:cNvPr id="2" name="Date Placeholder 1">
             <a:extLst xmlns:a="http://schemas.openxmlformats.org/drawingml/2006/main">
               <a:ext uri="{FF2B5EF4-FFF2-40B4-BE49-F238E27FC236}">
-                <a16:creationId xmlns:a16="http://schemas.microsoft.com/office/drawing/2014/main" id="{E13C16FA-BBCA-4646-8E5E-8F6B40A358D0}"/>
+                <a16:creationId xmlns:a16="http://schemas.microsoft.com/office/drawing/2014/main" id="{BBAB21BA-8A95-4FB9-A46D-12FC4F7BA617}"/>
               </a:ext>
             </a:extLst>
           </p:cNvPr>
@@ -3547,7 +3542,7 @@
           <p:cNvPr id="3" name="Footer Placeholder 2">
             <a:extLst xmlns:a="http://schemas.openxmlformats.org/drawingml/2006/main">
               <a:ext uri="{FF2B5EF4-FFF2-40B4-BE49-F238E27FC236}">
-                <a16:creationId xmlns:a16="http://schemas.microsoft.com/office/drawing/2014/main" id="{BDEAAB22-0477-4D2F-9FAE-2BAC773640E6}"/>
+                <a16:creationId xmlns:a16="http://schemas.microsoft.com/office/drawing/2014/main" id="{D7D21B4C-7BB0-4AF9-93AB-9DFA802CE4EE}"/>
               </a:ext>
             </a:extLst>
           </p:cNvPr>
@@ -3572,7 +3567,7 @@
           <p:cNvPr id="4" name="Slide Number Placeholder 3">
             <a:extLst xmlns:a="http://schemas.openxmlformats.org/drawingml/2006/main">
               <a:ext uri="{FF2B5EF4-FFF2-40B4-BE49-F238E27FC236}">
-                <a16:creationId xmlns:a16="http://schemas.microsoft.com/office/drawing/2014/main" id="{B141AD95-DE5E-4038-8103-EA4C327DFB31}"/>
+                <a16:creationId xmlns:a16="http://schemas.microsoft.com/office/drawing/2014/main" id="{6A349349-C1E9-4C1E-86AB-E56695D8A4E9}"/>
               </a:ext>
             </a:extLst>
           </p:cNvPr>
@@ -3617,7 +3612,7 @@
           <p:cNvPr id="2" name="Title 1">
             <a:extLst xmlns:a="http://schemas.openxmlformats.org/drawingml/2006/main">
               <a:ext uri="{FF2B5EF4-FFF2-40B4-BE49-F238E27FC236}">
-                <a16:creationId xmlns:a16="http://schemas.microsoft.com/office/drawing/2014/main" id="{30F7A684-8AC2-4325-B980-5E7E98ADFE04}"/>
+                <a16:creationId xmlns:a16="http://schemas.microsoft.com/office/drawing/2014/main" id="{FA6A7671-8756-4800-8E01-AADD36335372}"/>
               </a:ext>
             </a:extLst>
           </p:cNvPr>
@@ -3655,7 +3650,7 @@
           <p:cNvPr id="3" name="Content Placeholder 2">
             <a:extLst xmlns:a="http://schemas.openxmlformats.org/drawingml/2006/main">
               <a:ext uri="{FF2B5EF4-FFF2-40B4-BE49-F238E27FC236}">
-                <a16:creationId xmlns:a16="http://schemas.microsoft.com/office/drawing/2014/main" id="{9A1BCC4A-5AE3-4199-B8F7-D3B4F55ED783}"/>
+                <a16:creationId xmlns:a16="http://schemas.microsoft.com/office/drawing/2014/main" id="{CAD9FF2A-5D4D-4A7A-9894-64FB999114C3}"/>
               </a:ext>
             </a:extLst>
           </p:cNvPr>
@@ -3760,7 +3755,7 @@
           <p:cNvPr id="4" name="Text Placeholder 3">
             <a:extLst xmlns:a="http://schemas.openxmlformats.org/drawingml/2006/main">
               <a:ext uri="{FF2B5EF4-FFF2-40B4-BE49-F238E27FC236}">
-                <a16:creationId xmlns:a16="http://schemas.microsoft.com/office/drawing/2014/main" id="{8081C687-3A62-4061-A66D-BA6F120F1B9D}"/>
+                <a16:creationId xmlns:a16="http://schemas.microsoft.com/office/drawing/2014/main" id="{2FB8BB5A-9E78-49A0-AC2A-24F36843D059}"/>
               </a:ext>
             </a:extLst>
           </p:cNvPr>
@@ -3832,7 +3827,7 @@
           <p:cNvPr id="5" name="Date Placeholder 4">
             <a:extLst xmlns:a="http://schemas.openxmlformats.org/drawingml/2006/main">
               <a:ext uri="{FF2B5EF4-FFF2-40B4-BE49-F238E27FC236}">
-                <a16:creationId xmlns:a16="http://schemas.microsoft.com/office/drawing/2014/main" id="{FD16852F-FB0F-4C62-AF3A-12D8476CF53B}"/>
+                <a16:creationId xmlns:a16="http://schemas.microsoft.com/office/drawing/2014/main" id="{FCDAF836-5588-45C3-BDFF-BEE1AF7CDE27}"/>
               </a:ext>
             </a:extLst>
           </p:cNvPr>
@@ -3860,7 +3855,7 @@
           <p:cNvPr id="6" name="Footer Placeholder 5">
             <a:extLst xmlns:a="http://schemas.openxmlformats.org/drawingml/2006/main">
               <a:ext uri="{FF2B5EF4-FFF2-40B4-BE49-F238E27FC236}">
-                <a16:creationId xmlns:a16="http://schemas.microsoft.com/office/drawing/2014/main" id="{E6F301B7-25B5-4BB5-87F7-7D4082974985}"/>
+                <a16:creationId xmlns:a16="http://schemas.microsoft.com/office/drawing/2014/main" id="{BEFFCC83-4903-4412-8CCD-4A832A59B468}"/>
               </a:ext>
             </a:extLst>
           </p:cNvPr>
@@ -3885,7 +3880,7 @@
           <p:cNvPr id="7" name="Slide Number Placeholder 6">
             <a:extLst xmlns:a="http://schemas.openxmlformats.org/drawingml/2006/main">
               <a:ext uri="{FF2B5EF4-FFF2-40B4-BE49-F238E27FC236}">
-                <a16:creationId xmlns:a16="http://schemas.microsoft.com/office/drawing/2014/main" id="{A2F24F8E-8F58-4C41-BCAC-06B585776A74}"/>
+                <a16:creationId xmlns:a16="http://schemas.microsoft.com/office/drawing/2014/main" id="{661E2624-6953-4EC7-9410-957EFFF5FBC9}"/>
               </a:ext>
             </a:extLst>
           </p:cNvPr>
@@ -3930,7 +3925,7 @@
           <p:cNvPr id="2" name="Title 1">
             <a:extLst xmlns:a="http://schemas.openxmlformats.org/drawingml/2006/main">
               <a:ext uri="{FF2B5EF4-FFF2-40B4-BE49-F238E27FC236}">
-                <a16:creationId xmlns:a16="http://schemas.microsoft.com/office/drawing/2014/main" id="{24E8A200-E5CF-4386-93EC-E474BB509059}"/>
+                <a16:creationId xmlns:a16="http://schemas.microsoft.com/office/drawing/2014/main" id="{1B7D63E4-1411-473D-9E6E-F1D452D8AADD}"/>
               </a:ext>
             </a:extLst>
           </p:cNvPr>
@@ -3968,7 +3963,7 @@
           <p:cNvPr id="3" name="Picture Placeholder 2">
             <a:extLst xmlns:a="http://schemas.openxmlformats.org/drawingml/2006/main">
               <a:ext uri="{FF2B5EF4-FFF2-40B4-BE49-F238E27FC236}">
-                <a16:creationId xmlns:a16="http://schemas.microsoft.com/office/drawing/2014/main" id="{4152B39F-9205-458F-B8D1-24DF06676D38}"/>
+                <a16:creationId xmlns:a16="http://schemas.microsoft.com/office/drawing/2014/main" id="{7EAB6995-F7E7-41D3-B689-F63DCCF82660}"/>
               </a:ext>
             </a:extLst>
           </p:cNvPr>
@@ -4035,7 +4030,7 @@
           <p:cNvPr id="4" name="Text Placeholder 3">
             <a:extLst xmlns:a="http://schemas.openxmlformats.org/drawingml/2006/main">
               <a:ext uri="{FF2B5EF4-FFF2-40B4-BE49-F238E27FC236}">
-                <a16:creationId xmlns:a16="http://schemas.microsoft.com/office/drawing/2014/main" id="{45E56CC9-9381-41E0-81A4-0B4942A2ECF9}"/>
+                <a16:creationId xmlns:a16="http://schemas.microsoft.com/office/drawing/2014/main" id="{83C3CBA3-B266-48D2-A196-2BFAA0629AEA}"/>
               </a:ext>
             </a:extLst>
           </p:cNvPr>
@@ -4107,7 +4102,7 @@
           <p:cNvPr id="5" name="Date Placeholder 4">
             <a:extLst xmlns:a="http://schemas.openxmlformats.org/drawingml/2006/main">
               <a:ext uri="{FF2B5EF4-FFF2-40B4-BE49-F238E27FC236}">
-                <a16:creationId xmlns:a16="http://schemas.microsoft.com/office/drawing/2014/main" id="{3CFEE3A6-651F-4ADE-9CF3-360EBB69520E}"/>
+                <a16:creationId xmlns:a16="http://schemas.microsoft.com/office/drawing/2014/main" id="{1C54076F-05CE-474A-B0AC-8FDA89324F1C}"/>
               </a:ext>
             </a:extLst>
           </p:cNvPr>
@@ -4135,7 +4130,7 @@
           <p:cNvPr id="6" name="Footer Placeholder 5">
             <a:extLst xmlns:a="http://schemas.openxmlformats.org/drawingml/2006/main">
               <a:ext uri="{FF2B5EF4-FFF2-40B4-BE49-F238E27FC236}">
-                <a16:creationId xmlns:a16="http://schemas.microsoft.com/office/drawing/2014/main" id="{6BB63E21-47F4-4557-AA75-0C7BACD9D59C}"/>
+                <a16:creationId xmlns:a16="http://schemas.microsoft.com/office/drawing/2014/main" id="{69BC192E-F55D-4F9B-A23D-85DA50C885B7}"/>
               </a:ext>
             </a:extLst>
           </p:cNvPr>
@@ -4160,7 +4155,7 @@
           <p:cNvPr id="7" name="Slide Number Placeholder 6">
             <a:extLst xmlns:a="http://schemas.openxmlformats.org/drawingml/2006/main">
               <a:ext uri="{FF2B5EF4-FFF2-40B4-BE49-F238E27FC236}">
-                <a16:creationId xmlns:a16="http://schemas.microsoft.com/office/drawing/2014/main" id="{DFAD7CB1-A8B3-4FC5-8DB3-D10AF256027E}"/>
+                <a16:creationId xmlns:a16="http://schemas.microsoft.com/office/drawing/2014/main" id="{5BDC5208-DF2B-4516-9167-57A3A8F8B05F}"/>
               </a:ext>
             </a:extLst>
           </p:cNvPr>
@@ -4210,7 +4205,7 @@
           <p:cNvPr id="2" name="Title Placeholder 1">
             <a:extLst xmlns:a="http://schemas.openxmlformats.org/drawingml/2006/main">
               <a:ext uri="{FF2B5EF4-FFF2-40B4-BE49-F238E27FC236}">
-                <a16:creationId xmlns:a16="http://schemas.microsoft.com/office/drawing/2014/main" id="{625D702C-E895-466C-8454-3D8EDB1373FB}"/>
+                <a16:creationId xmlns:a16="http://schemas.microsoft.com/office/drawing/2014/main" id="{3EAFF71B-8044-4695-8543-9B8B138FCA6E}"/>
               </a:ext>
             </a:extLst>
           </p:cNvPr>
@@ -4248,7 +4243,7 @@
           <p:cNvPr id="3" name="Text Placeholder 2">
             <a:extLst xmlns:a="http://schemas.openxmlformats.org/drawingml/2006/main">
               <a:ext uri="{FF2B5EF4-FFF2-40B4-BE49-F238E27FC236}">
-                <a16:creationId xmlns:a16="http://schemas.microsoft.com/office/drawing/2014/main" id="{CC29110E-DAC7-4A06-A0E0-EA23312FB55A}"/>
+                <a16:creationId xmlns:a16="http://schemas.microsoft.com/office/drawing/2014/main" id="{49EC024A-D0DE-4773-868C-67B0D9C49467}"/>
               </a:ext>
             </a:extLst>
           </p:cNvPr>
@@ -4321,7 +4316,7 @@
           <p:cNvPr id="4" name="Date Placeholder 3">
             <a:extLst xmlns:a="http://schemas.openxmlformats.org/drawingml/2006/main">
               <a:ext uri="{FF2B5EF4-FFF2-40B4-BE49-F238E27FC236}">
-                <a16:creationId xmlns:a16="http://schemas.microsoft.com/office/drawing/2014/main" id="{D1045C35-1C2C-4964-9984-3A90ACE9D0B2}"/>
+                <a16:creationId xmlns:a16="http://schemas.microsoft.com/office/drawing/2014/main" id="{AB92BFDF-86C4-498B-95F8-40DE45BABF13}"/>
               </a:ext>
             </a:extLst>
           </p:cNvPr>
@@ -4368,7 +4363,7 @@
           <p:cNvPr id="5" name="Footer Placeholder 4">
             <a:extLst xmlns:a="http://schemas.openxmlformats.org/drawingml/2006/main">
               <a:ext uri="{FF2B5EF4-FFF2-40B4-BE49-F238E27FC236}">
-                <a16:creationId xmlns:a16="http://schemas.microsoft.com/office/drawing/2014/main" id="{031A3CAA-3232-47D7-A378-AEB0CFB836F4}"/>
+                <a16:creationId xmlns:a16="http://schemas.microsoft.com/office/drawing/2014/main" id="{5E162E8E-78AC-462B-B308-CF69977EE9FF}"/>
               </a:ext>
             </a:extLst>
           </p:cNvPr>
@@ -4412,7 +4407,7 @@
           <p:cNvPr id="6" name="Slide Number Placeholder 5">
             <a:extLst xmlns:a="http://schemas.openxmlformats.org/drawingml/2006/main">
               <a:ext uri="{FF2B5EF4-FFF2-40B4-BE49-F238E27FC236}">
-                <a16:creationId xmlns:a16="http://schemas.microsoft.com/office/drawing/2014/main" id="{D201BFAD-5481-417D-A24A-D39DAD915346}"/>
+                <a16:creationId xmlns:a16="http://schemas.microsoft.com/office/drawing/2014/main" id="{B0312C0A-2F25-48EB-AD60-FD6A1F2B5222}"/>
               </a:ext>
             </a:extLst>
           </p:cNvPr>
@@ -4458,17 +4453,17 @@
   </p:cSld>
   <p:clrMap bg1="lt1" tx1="dk1" bg2="lt2" tx2="dk2" accent1="accent1" accent2="accent2" accent3="accent3" accent4="accent4" accent5="accent5" accent6="accent6" hlink="hlink" folHlink="folHlink"/>
   <p:sldLayoutIdLst>
-    <p:sldLayoutId xmlns:r="http://schemas.openxmlformats.org/officeDocument/2006/relationships" id="2147483649" r:id="Rbe3f4dcd868c4f91"/>
-    <p:sldLayoutId xmlns:r="http://schemas.openxmlformats.org/officeDocument/2006/relationships" id="2147483650" r:id="Rf1705a2f0f574639"/>
-    <p:sldLayoutId xmlns:r="http://schemas.openxmlformats.org/officeDocument/2006/relationships" id="2147483651" r:id="Rfbd564c9f1d94404"/>
-    <p:sldLayoutId xmlns:r="http://schemas.openxmlformats.org/officeDocument/2006/relationships" id="2147483652" r:id="R2e0156205a89419b"/>
-    <p:sldLayoutId xmlns:r="http://schemas.openxmlformats.org/officeDocument/2006/relationships" id="2147483653" r:id="Rd87eb4e560e34a58"/>
-    <p:sldLayoutId xmlns:r="http://schemas.openxmlformats.org/officeDocument/2006/relationships" id="2147483654" r:id="R157e5c00cf6f4b4e"/>
-    <p:sldLayoutId xmlns:r="http://schemas.openxmlformats.org/officeDocument/2006/relationships" id="2147483655" r:id="R3485bf098ba94de7"/>
-    <p:sldLayoutId xmlns:r="http://schemas.openxmlformats.org/officeDocument/2006/relationships" id="2147483656" r:id="R4bd5eda1ee5146f4"/>
-    <p:sldLayoutId xmlns:r="http://schemas.openxmlformats.org/officeDocument/2006/relationships" id="2147483657" r:id="R2b061fe7302943d7"/>
-    <p:sldLayoutId xmlns:r="http://schemas.openxmlformats.org/officeDocument/2006/relationships" id="2147483658" r:id="R1ed700f4b8b64f8e"/>
-    <p:sldLayoutId xmlns:r="http://schemas.openxmlformats.org/officeDocument/2006/relationships" id="2147483659" r:id="R9cb67aea190d405c"/>
+    <p:sldLayoutId xmlns:r="http://schemas.openxmlformats.org/officeDocument/2006/relationships" id="2147483649" r:id="Rf923f5e8061f481f"/>
+    <p:sldLayoutId xmlns:r="http://schemas.openxmlformats.org/officeDocument/2006/relationships" id="2147483650" r:id="Rf74b76f26cab4e1f"/>
+    <p:sldLayoutId xmlns:r="http://schemas.openxmlformats.org/officeDocument/2006/relationships" id="2147483651" r:id="R6d217f5fc6464349"/>
+    <p:sldLayoutId xmlns:r="http://schemas.openxmlformats.org/officeDocument/2006/relationships" id="2147483652" r:id="R40435e87adb146c3"/>
+    <p:sldLayoutId xmlns:r="http://schemas.openxmlformats.org/officeDocument/2006/relationships" id="2147483653" r:id="R9fdb2bdfddfc42bb"/>
+    <p:sldLayoutId xmlns:r="http://schemas.openxmlformats.org/officeDocument/2006/relationships" id="2147483654" r:id="Rff353f2aca6f4a9e"/>
+    <p:sldLayoutId xmlns:r="http://schemas.openxmlformats.org/officeDocument/2006/relationships" id="2147483655" r:id="R978f666d2ab74650"/>
+    <p:sldLayoutId xmlns:r="http://schemas.openxmlformats.org/officeDocument/2006/relationships" id="2147483656" r:id="R005d75da74a14c48"/>
+    <p:sldLayoutId xmlns:r="http://schemas.openxmlformats.org/officeDocument/2006/relationships" id="2147483657" r:id="R0181a6c64735428a"/>
+    <p:sldLayoutId xmlns:r="http://schemas.openxmlformats.org/officeDocument/2006/relationships" id="2147483658" r:id="R2b21261380cf4854"/>
+    <p:sldLayoutId xmlns:r="http://schemas.openxmlformats.org/officeDocument/2006/relationships" id="2147483659" r:id="Rf1fd43f12a794537"/>
   </p:sldLayoutIdLst>
   <p:txStyles>
     <p:titleStyle>
@@ -5014,7 +5009,7 @@
           <p:cNvPr id="2" name="Rectangle 1">
             <a:extLst xmlns:a="http://schemas.openxmlformats.org/drawingml/2006/main">
               <a:ext uri="{FF2B5EF4-FFF2-40B4-BE49-F238E27FC236}">
-                <a16:creationId xmlns:a16="http://schemas.microsoft.com/office/drawing/2014/main" id="{1A9204AE-B44C-47CC-BEA4-26E4E3E74C08}"/>
+                <a16:creationId xmlns:a16="http://schemas.microsoft.com/office/drawing/2014/main" id="{69B87539-A772-4D1B-934F-87DD1FF62D99}"/>
               </a:ext>
             </a:extLst>
           </p:cNvPr>
@@ -5067,7 +5062,7 @@
           <p:cNvPr id="3" name="Rectangle 2">
             <a:extLst xmlns:a="http://schemas.openxmlformats.org/drawingml/2006/main">
               <a:ext uri="{FF2B5EF4-FFF2-40B4-BE49-F238E27FC236}">
-                <a16:creationId xmlns:a16="http://schemas.microsoft.com/office/drawing/2014/main" id="{D5E43A13-1DE5-4391-939E-9025D902AA84}"/>
+                <a16:creationId xmlns:a16="http://schemas.microsoft.com/office/drawing/2014/main" id="{F0BC9FED-A2BA-4A0F-8214-120393F3658A}"/>
               </a:ext>
             </a:extLst>
           </p:cNvPr>
@@ -5120,7 +5115,7 @@
           <p:cNvPr id="4" name="TextBox 3">
             <a:extLst xmlns:a="http://schemas.openxmlformats.org/drawingml/2006/main">
               <a:ext uri="{FF2B5EF4-FFF2-40B4-BE49-F238E27FC236}">
-                <a16:creationId xmlns:a16="http://schemas.microsoft.com/office/drawing/2014/main" id="{78FB1B37-9628-434E-8048-51DD12CF87AE}"/>
+                <a16:creationId xmlns:a16="http://schemas.microsoft.com/office/drawing/2014/main" id="{B30AFB6E-F377-44AC-B408-196787C9E8DD}"/>
               </a:ext>
             </a:extLst>
           </p:cNvPr>
@@ -5222,7 +5217,7 @@
     </p:spTree>
     <p:extLst>
       <p:ext uri="{BB962C8B-B14F-4D97-AF65-F5344CB8AC3E}">
-        <p14:creationId xmlns:p14="http://schemas.microsoft.com/office/powerpoint/2010/main" val="1244413541"/>
+        <p14:creationId xmlns:p14="http://schemas.microsoft.com/office/powerpoint/2010/main" val="418319784"/>
       </p:ext>
     </p:extLst>
   </p:cSld>
@@ -5246,7 +5241,7 @@
           <p:cNvPr id="2" name="Rectangle 1">
             <a:extLst xmlns:a="http://schemas.openxmlformats.org/drawingml/2006/main">
               <a:ext uri="{FF2B5EF4-FFF2-40B4-BE49-F238E27FC236}">
-                <a16:creationId xmlns:a16="http://schemas.microsoft.com/office/drawing/2014/main" id="{A5079CB4-1562-48AF-805F-F2F248CF8D3A}"/>
+                <a16:creationId xmlns:a16="http://schemas.microsoft.com/office/drawing/2014/main" id="{4D48DB15-55F2-43AE-A97A-8765B6832901}"/>
               </a:ext>
             </a:extLst>
           </p:cNvPr>
@@ -5299,7 +5294,7 @@
           <p:cNvPr id="3" name="Rectangle 2">
             <a:extLst xmlns:a="http://schemas.openxmlformats.org/drawingml/2006/main">
               <a:ext uri="{FF2B5EF4-FFF2-40B4-BE49-F238E27FC236}">
-                <a16:creationId xmlns:a16="http://schemas.microsoft.com/office/drawing/2014/main" id="{754B5928-703C-4EC3-98F4-D4698C52D594}"/>
+                <a16:creationId xmlns:a16="http://schemas.microsoft.com/office/drawing/2014/main" id="{0C9B4BE8-25A1-469C-BFF3-7711AFD48319}"/>
               </a:ext>
             </a:extLst>
           </p:cNvPr>
@@ -5352,7 +5347,7 @@
           <p:cNvPr id="4" name="Rectangle 3">
             <a:extLst xmlns:a="http://schemas.openxmlformats.org/drawingml/2006/main">
               <a:ext uri="{FF2B5EF4-FFF2-40B4-BE49-F238E27FC236}">
-                <a16:creationId xmlns:a16="http://schemas.microsoft.com/office/drawing/2014/main" id="{FA5320BD-72D3-4D60-A1EC-134923C0CFB7}"/>
+                <a16:creationId xmlns:a16="http://schemas.microsoft.com/office/drawing/2014/main" id="{3656063A-EB66-425D-8C29-6B24E6D0CA86}"/>
               </a:ext>
             </a:extLst>
           </p:cNvPr>
@@ -5405,7 +5400,7 @@
           <p:cNvPr id="5" name="TextBox 4">
             <a:extLst xmlns:a="http://schemas.openxmlformats.org/drawingml/2006/main">
               <a:ext uri="{FF2B5EF4-FFF2-40B4-BE49-F238E27FC236}">
-                <a16:creationId xmlns:a16="http://schemas.microsoft.com/office/drawing/2014/main" id="{217267DC-CFEE-49B1-B5B0-7F0688BC172C}"/>
+                <a16:creationId xmlns:a16="http://schemas.microsoft.com/office/drawing/2014/main" id="{5FF2463E-93FF-435E-BEB7-D36803B4128F}"/>
               </a:ext>
             </a:extLst>
           </p:cNvPr>
@@ -5468,7 +5463,7 @@
           <p:cNvPr id="6" name="Rounded Rectangle 5">
             <a:extLst xmlns:a="http://schemas.openxmlformats.org/drawingml/2006/main">
               <a:ext uri="{FF2B5EF4-FFF2-40B4-BE49-F238E27FC236}">
-                <a16:creationId xmlns:a16="http://schemas.microsoft.com/office/drawing/2014/main" id="{2432E737-76BA-49D1-B8F5-0FE0564FA169}"/>
+                <a16:creationId xmlns:a16="http://schemas.microsoft.com/office/drawing/2014/main" id="{BD82A6BA-A1BC-4AD8-A63B-472E3412F2D1}"/>
               </a:ext>
             </a:extLst>
           </p:cNvPr>
@@ -5523,7 +5518,7 @@
           <p:cNvPr id="7" name="TextBox 6">
             <a:extLst xmlns:a="http://schemas.openxmlformats.org/drawingml/2006/main">
               <a:ext uri="{FF2B5EF4-FFF2-40B4-BE49-F238E27FC236}">
-                <a16:creationId xmlns:a16="http://schemas.microsoft.com/office/drawing/2014/main" id="{16C169C2-E485-4C82-B023-D25CB28DFA8C}"/>
+                <a16:creationId xmlns:a16="http://schemas.microsoft.com/office/drawing/2014/main" id="{2E82FB1E-8309-43DC-AD65-8340D7265777}"/>
               </a:ext>
             </a:extLst>
           </p:cNvPr>
@@ -5627,7 +5622,7 @@
           <p:cNvPr id="8" name="Rounded Rectangle 7">
             <a:extLst xmlns:a="http://schemas.openxmlformats.org/drawingml/2006/main">
               <a:ext uri="{FF2B5EF4-FFF2-40B4-BE49-F238E27FC236}">
-                <a16:creationId xmlns:a16="http://schemas.microsoft.com/office/drawing/2014/main" id="{9A007036-B3AF-4926-9FA2-CFE5C211E851}"/>
+                <a16:creationId xmlns:a16="http://schemas.microsoft.com/office/drawing/2014/main" id="{44FD35A6-D270-44E7-B731-9A8452A6900A}"/>
               </a:ext>
             </a:extLst>
           </p:cNvPr>
@@ -5682,7 +5677,7 @@
           <p:cNvPr id="9" name="TextBox 8">
             <a:extLst xmlns:a="http://schemas.openxmlformats.org/drawingml/2006/main">
               <a:ext uri="{FF2B5EF4-FFF2-40B4-BE49-F238E27FC236}">
-                <a16:creationId xmlns:a16="http://schemas.microsoft.com/office/drawing/2014/main" id="{64FDB06D-4BAA-4085-83C3-82BD67687E6A}"/>
+                <a16:creationId xmlns:a16="http://schemas.microsoft.com/office/drawing/2014/main" id="{8FE9BAE7-4993-4E11-BEFD-160D74284154}"/>
               </a:ext>
             </a:extLst>
           </p:cNvPr>
@@ -5767,7 +5762,7 @@
           <p:cNvPr id="10" name="Rounded Rectangle 9">
             <a:extLst xmlns:a="http://schemas.openxmlformats.org/drawingml/2006/main">
               <a:ext uri="{FF2B5EF4-FFF2-40B4-BE49-F238E27FC236}">
-                <a16:creationId xmlns:a16="http://schemas.microsoft.com/office/drawing/2014/main" id="{FBA861AD-D277-47CF-99F2-E4169E665547}"/>
+                <a16:creationId xmlns:a16="http://schemas.microsoft.com/office/drawing/2014/main" id="{BD0EAEAB-F4DF-4D60-89C4-0F636A4B1794}"/>
               </a:ext>
             </a:extLst>
           </p:cNvPr>
@@ -5822,7 +5817,7 @@
           <p:cNvPr id="11" name="TextBox 10">
             <a:extLst xmlns:a="http://schemas.openxmlformats.org/drawingml/2006/main">
               <a:ext uri="{FF2B5EF4-FFF2-40B4-BE49-F238E27FC236}">
-                <a16:creationId xmlns:a16="http://schemas.microsoft.com/office/drawing/2014/main" id="{C04A546D-B3D7-4169-8470-8A6B6D6B056E}"/>
+                <a16:creationId xmlns:a16="http://schemas.microsoft.com/office/drawing/2014/main" id="{26124347-2A68-4A17-9AE1-6D101C12AD09}"/>
               </a:ext>
             </a:extLst>
           </p:cNvPr>
@@ -5924,7 +5919,7 @@
     </p:spTree>
     <p:extLst>
       <p:ext uri="{BB962C8B-B14F-4D97-AF65-F5344CB8AC3E}">
-        <p14:creationId xmlns:p14="http://schemas.microsoft.com/office/powerpoint/2010/main" val="2112739995"/>
+        <p14:creationId xmlns:p14="http://schemas.microsoft.com/office/powerpoint/2010/main" val="626340798"/>
       </p:ext>
     </p:extLst>
   </p:cSld>
@@ -5948,7 +5943,7 @@
           <p:cNvPr id="2" name="Rectangle 1">
             <a:extLst xmlns:a="http://schemas.openxmlformats.org/drawingml/2006/main">
               <a:ext uri="{FF2B5EF4-FFF2-40B4-BE49-F238E27FC236}">
-                <a16:creationId xmlns:a16="http://schemas.microsoft.com/office/drawing/2014/main" id="{1E5461AB-EB93-48CE-A6C9-D1FC9AB412BF}"/>
+                <a16:creationId xmlns:a16="http://schemas.microsoft.com/office/drawing/2014/main" id="{F0977D85-D0EC-4BFC-A433-3FE0752CEABE}"/>
               </a:ext>
             </a:extLst>
           </p:cNvPr>
@@ -6001,7 +5996,7 @@
           <p:cNvPr id="3" name="Rectangle 2">
             <a:extLst xmlns:a="http://schemas.openxmlformats.org/drawingml/2006/main">
               <a:ext uri="{FF2B5EF4-FFF2-40B4-BE49-F238E27FC236}">
-                <a16:creationId xmlns:a16="http://schemas.microsoft.com/office/drawing/2014/main" id="{D3204BBF-9954-4F0E-B24C-40CC16575700}"/>
+                <a16:creationId xmlns:a16="http://schemas.microsoft.com/office/drawing/2014/main" id="{FA03800B-7EF3-459C-AE14-808830B06E5C}"/>
               </a:ext>
             </a:extLst>
           </p:cNvPr>
@@ -6054,7 +6049,7 @@
           <p:cNvPr id="4" name="Rectangle 3">
             <a:extLst xmlns:a="http://schemas.openxmlformats.org/drawingml/2006/main">
               <a:ext uri="{FF2B5EF4-FFF2-40B4-BE49-F238E27FC236}">
-                <a16:creationId xmlns:a16="http://schemas.microsoft.com/office/drawing/2014/main" id="{EE2794B3-112F-4183-AF1F-1AE2AECF5517}"/>
+                <a16:creationId xmlns:a16="http://schemas.microsoft.com/office/drawing/2014/main" id="{14904BB7-31CF-4BF9-B609-07BD2D1C733F}"/>
               </a:ext>
             </a:extLst>
           </p:cNvPr>
@@ -6107,7 +6102,7 @@
           <p:cNvPr id="5" name="TextBox 4">
             <a:extLst xmlns:a="http://schemas.openxmlformats.org/drawingml/2006/main">
               <a:ext uri="{FF2B5EF4-FFF2-40B4-BE49-F238E27FC236}">
-                <a16:creationId xmlns:a16="http://schemas.microsoft.com/office/drawing/2014/main" id="{BD50A6C4-BF56-410F-96B7-C62D23FC2134}"/>
+                <a16:creationId xmlns:a16="http://schemas.microsoft.com/office/drawing/2014/main" id="{0122C0C5-BB4A-48C1-BDE7-2F24F7D77A4B}"/>
               </a:ext>
             </a:extLst>
           </p:cNvPr>
@@ -6170,7 +6165,7 @@
           <p:cNvPr id="6" name="Rounded Rectangle 5">
             <a:extLst xmlns:a="http://schemas.openxmlformats.org/drawingml/2006/main">
               <a:ext uri="{FF2B5EF4-FFF2-40B4-BE49-F238E27FC236}">
-                <a16:creationId xmlns:a16="http://schemas.microsoft.com/office/drawing/2014/main" id="{AD1D43EC-AECC-4B33-A7A5-D0D6BC00FCAA}"/>
+                <a16:creationId xmlns:a16="http://schemas.microsoft.com/office/drawing/2014/main" id="{C9315923-4882-4665-8ED9-D8971CC5B515}"/>
               </a:ext>
             </a:extLst>
           </p:cNvPr>
@@ -6225,7 +6220,7 @@
           <p:cNvPr id="7" name="TextBox 6">
             <a:extLst xmlns:a="http://schemas.openxmlformats.org/drawingml/2006/main">
               <a:ext uri="{FF2B5EF4-FFF2-40B4-BE49-F238E27FC236}">
-                <a16:creationId xmlns:a16="http://schemas.microsoft.com/office/drawing/2014/main" id="{1193F931-9650-414E-914E-DE16A6607D56}"/>
+                <a16:creationId xmlns:a16="http://schemas.microsoft.com/office/drawing/2014/main" id="{056F66D9-5516-4569-BFAC-38F2C84F85BD}"/>
               </a:ext>
             </a:extLst>
           </p:cNvPr>
@@ -6424,7 +6419,7 @@
           <p:cNvPr id="8" name="Rounded Rectangle 7">
             <a:extLst xmlns:a="http://schemas.openxmlformats.org/drawingml/2006/main">
               <a:ext uri="{FF2B5EF4-FFF2-40B4-BE49-F238E27FC236}">
-                <a16:creationId xmlns:a16="http://schemas.microsoft.com/office/drawing/2014/main" id="{4D4FC0A7-964A-440B-BE37-4E3DBF8804A9}"/>
+                <a16:creationId xmlns:a16="http://schemas.microsoft.com/office/drawing/2014/main" id="{5FBA845E-5769-49B5-91C0-884B19983161}"/>
               </a:ext>
             </a:extLst>
           </p:cNvPr>
@@ -6479,7 +6474,7 @@
           <p:cNvPr id="9" name="TextBox 8">
             <a:extLst xmlns:a="http://schemas.openxmlformats.org/drawingml/2006/main">
               <a:ext uri="{FF2B5EF4-FFF2-40B4-BE49-F238E27FC236}">
-                <a16:creationId xmlns:a16="http://schemas.microsoft.com/office/drawing/2014/main" id="{06C76F78-7A4E-4717-B726-328777A2B9A2}"/>
+                <a16:creationId xmlns:a16="http://schemas.microsoft.com/office/drawing/2014/main" id="{5BF6DC06-33D4-4582-93AB-690607CAB8D9}"/>
               </a:ext>
             </a:extLst>
           </p:cNvPr>
@@ -6600,7 +6595,7 @@
     </p:spTree>
     <p:extLst>
       <p:ext uri="{BB962C8B-B14F-4D97-AF65-F5344CB8AC3E}">
-        <p14:creationId xmlns:p14="http://schemas.microsoft.com/office/powerpoint/2010/main" val="732313307"/>
+        <p14:creationId xmlns:p14="http://schemas.microsoft.com/office/powerpoint/2010/main" val="1722035190"/>
       </p:ext>
     </p:extLst>
   </p:cSld>
@@ -6624,7 +6619,7 @@
           <p:cNvPr id="2" name="Rectangle 1">
             <a:extLst xmlns:a="http://schemas.openxmlformats.org/drawingml/2006/main">
               <a:ext uri="{FF2B5EF4-FFF2-40B4-BE49-F238E27FC236}">
-                <a16:creationId xmlns:a16="http://schemas.microsoft.com/office/drawing/2014/main" id="{81E1CC92-CE88-476F-8AA9-8165F085B081}"/>
+                <a16:creationId xmlns:a16="http://schemas.microsoft.com/office/drawing/2014/main" id="{7AB0EEF1-842F-4962-9CEA-674924E48FD9}"/>
               </a:ext>
             </a:extLst>
           </p:cNvPr>
@@ -6677,7 +6672,7 @@
           <p:cNvPr id="3" name="Rectangle 2">
             <a:extLst xmlns:a="http://schemas.openxmlformats.org/drawingml/2006/main">
               <a:ext uri="{FF2B5EF4-FFF2-40B4-BE49-F238E27FC236}">
-                <a16:creationId xmlns:a16="http://schemas.microsoft.com/office/drawing/2014/main" id="{766F51BC-9D15-402E-B40D-BD290E01F4BD}"/>
+                <a16:creationId xmlns:a16="http://schemas.microsoft.com/office/drawing/2014/main" id="{FA7E393D-5BC7-48E6-981C-B360BE086850}"/>
               </a:ext>
             </a:extLst>
           </p:cNvPr>
@@ -6730,7 +6725,7 @@
           <p:cNvPr id="4" name="TextBox 3">
             <a:extLst xmlns:a="http://schemas.openxmlformats.org/drawingml/2006/main">
               <a:ext uri="{FF2B5EF4-FFF2-40B4-BE49-F238E27FC236}">
-                <a16:creationId xmlns:a16="http://schemas.microsoft.com/office/drawing/2014/main" id="{0F952296-647E-4FD3-A1AE-B288C4FB60D9}"/>
+                <a16:creationId xmlns:a16="http://schemas.microsoft.com/office/drawing/2014/main" id="{AC94BA45-8E39-4354-877F-564EF5A41E53}"/>
               </a:ext>
             </a:extLst>
           </p:cNvPr>
@@ -6908,7 +6903,7 @@
     </p:spTree>
     <p:extLst>
       <p:ext uri="{BB962C8B-B14F-4D97-AF65-F5344CB8AC3E}">
-        <p14:creationId xmlns:p14="http://schemas.microsoft.com/office/powerpoint/2010/main" val="1117890601"/>
+        <p14:creationId xmlns:p14="http://schemas.microsoft.com/office/powerpoint/2010/main" val="48076162"/>
       </p:ext>
     </p:extLst>
   </p:cSld>
@@ -6932,7 +6927,7 @@
           <p:cNvPr id="2" name="Rectangle 1">
             <a:extLst xmlns:a="http://schemas.openxmlformats.org/drawingml/2006/main">
               <a:ext uri="{FF2B5EF4-FFF2-40B4-BE49-F238E27FC236}">
-                <a16:creationId xmlns:a16="http://schemas.microsoft.com/office/drawing/2014/main" id="{2A4B2E8A-C325-4057-BAB3-D5FFF0CF62AE}"/>
+                <a16:creationId xmlns:a16="http://schemas.microsoft.com/office/drawing/2014/main" id="{BDEC8858-E3A2-4F0E-BC96-720B553A643C}"/>
               </a:ext>
             </a:extLst>
           </p:cNvPr>
@@ -6985,7 +6980,7 @@
           <p:cNvPr id="3" name="Rectangle 2">
             <a:extLst xmlns:a="http://schemas.openxmlformats.org/drawingml/2006/main">
               <a:ext uri="{FF2B5EF4-FFF2-40B4-BE49-F238E27FC236}">
-                <a16:creationId xmlns:a16="http://schemas.microsoft.com/office/drawing/2014/main" id="{BCE03106-B560-43A8-A9AF-7F7F58457151}"/>
+                <a16:creationId xmlns:a16="http://schemas.microsoft.com/office/drawing/2014/main" id="{F7FE8DB0-3FFB-4E1D-A271-40555BA67E94}"/>
               </a:ext>
             </a:extLst>
           </p:cNvPr>
@@ -7038,7 +7033,7 @@
           <p:cNvPr id="4" name="Rectangle 3">
             <a:extLst xmlns:a="http://schemas.openxmlformats.org/drawingml/2006/main">
               <a:ext uri="{FF2B5EF4-FFF2-40B4-BE49-F238E27FC236}">
-                <a16:creationId xmlns:a16="http://schemas.microsoft.com/office/drawing/2014/main" id="{2F304F0B-1A31-49FC-84ED-692D6917F3B0}"/>
+                <a16:creationId xmlns:a16="http://schemas.microsoft.com/office/drawing/2014/main" id="{6AC94A5A-229A-4783-A311-5EEAC2306031}"/>
               </a:ext>
             </a:extLst>
           </p:cNvPr>
@@ -7091,7 +7086,7 @@
           <p:cNvPr id="5" name="TextBox 4">
             <a:extLst xmlns:a="http://schemas.openxmlformats.org/drawingml/2006/main">
               <a:ext uri="{FF2B5EF4-FFF2-40B4-BE49-F238E27FC236}">
-                <a16:creationId xmlns:a16="http://schemas.microsoft.com/office/drawing/2014/main" id="{C571EC1B-59FC-452C-90E5-BA28E4A6543C}"/>
+                <a16:creationId xmlns:a16="http://schemas.microsoft.com/office/drawing/2014/main" id="{B38CE4D6-7674-4261-88D8-178A886D350B}"/>
               </a:ext>
             </a:extLst>
           </p:cNvPr>
@@ -7154,7 +7149,7 @@
           <p:cNvPr id="6" name="Rounded Rectangle 5">
             <a:extLst xmlns:a="http://schemas.openxmlformats.org/drawingml/2006/main">
               <a:ext uri="{FF2B5EF4-FFF2-40B4-BE49-F238E27FC236}">
-                <a16:creationId xmlns:a16="http://schemas.microsoft.com/office/drawing/2014/main" id="{B4B57932-A5E0-4B7D-BBF3-66DB06765B03}"/>
+                <a16:creationId xmlns:a16="http://schemas.microsoft.com/office/drawing/2014/main" id="{02977216-DCA9-464B-9979-0CE153096E20}"/>
               </a:ext>
             </a:extLst>
           </p:cNvPr>
@@ -7209,7 +7204,7 @@
           <p:cNvPr id="7" name="TextBox 6">
             <a:extLst xmlns:a="http://schemas.openxmlformats.org/drawingml/2006/main">
               <a:ext uri="{FF2B5EF4-FFF2-40B4-BE49-F238E27FC236}">
-                <a16:creationId xmlns:a16="http://schemas.microsoft.com/office/drawing/2014/main" id="{899434D0-6C6B-4A15-A6C8-26C02405A339}"/>
+                <a16:creationId xmlns:a16="http://schemas.microsoft.com/office/drawing/2014/main" id="{19F6EF95-7158-434A-A356-E46C4E779BF7}"/>
               </a:ext>
             </a:extLst>
           </p:cNvPr>
@@ -7313,7 +7308,7 @@
           <p:cNvPr id="8" name="Rounded Rectangle 7">
             <a:extLst xmlns:a="http://schemas.openxmlformats.org/drawingml/2006/main">
               <a:ext uri="{FF2B5EF4-FFF2-40B4-BE49-F238E27FC236}">
-                <a16:creationId xmlns:a16="http://schemas.microsoft.com/office/drawing/2014/main" id="{A9EC9C70-3BB2-40A4-82F2-0F4B239262F8}"/>
+                <a16:creationId xmlns:a16="http://schemas.microsoft.com/office/drawing/2014/main" id="{3E63B7A7-F691-4096-9FC9-015E26BB8BD4}"/>
               </a:ext>
             </a:extLst>
           </p:cNvPr>
@@ -7368,7 +7363,7 @@
           <p:cNvPr id="9" name="TextBox 8">
             <a:extLst xmlns:a="http://schemas.openxmlformats.org/drawingml/2006/main">
               <a:ext uri="{FF2B5EF4-FFF2-40B4-BE49-F238E27FC236}">
-                <a16:creationId xmlns:a16="http://schemas.microsoft.com/office/drawing/2014/main" id="{826ED784-724F-42CA-A92B-565963133B88}"/>
+                <a16:creationId xmlns:a16="http://schemas.microsoft.com/office/drawing/2014/main" id="{55C46474-73B8-49A7-9AF8-AAA5345B4704}"/>
               </a:ext>
             </a:extLst>
           </p:cNvPr>
@@ -7472,7 +7467,7 @@
           <p:cNvPr id="10" name="Rounded Rectangle 9">
             <a:extLst xmlns:a="http://schemas.openxmlformats.org/drawingml/2006/main">
               <a:ext uri="{FF2B5EF4-FFF2-40B4-BE49-F238E27FC236}">
-                <a16:creationId xmlns:a16="http://schemas.microsoft.com/office/drawing/2014/main" id="{458BEC26-9F73-4968-A030-D41DB66166CA}"/>
+                <a16:creationId xmlns:a16="http://schemas.microsoft.com/office/drawing/2014/main" id="{22F8D07D-8441-4EAB-9568-5A9AEBF6E4B6}"/>
               </a:ext>
             </a:extLst>
           </p:cNvPr>
@@ -7527,7 +7522,7 @@
           <p:cNvPr id="11" name="TextBox 10">
             <a:extLst xmlns:a="http://schemas.openxmlformats.org/drawingml/2006/main">
               <a:ext uri="{FF2B5EF4-FFF2-40B4-BE49-F238E27FC236}">
-                <a16:creationId xmlns:a16="http://schemas.microsoft.com/office/drawing/2014/main" id="{F910595E-8F41-4672-9DAC-0B78E7B7340E}"/>
+                <a16:creationId xmlns:a16="http://schemas.microsoft.com/office/drawing/2014/main" id="{1FEBEAD1-ABAE-42D7-8129-36F043F6B19B}"/>
               </a:ext>
             </a:extLst>
           </p:cNvPr>
@@ -7686,7 +7681,7 @@
     </p:spTree>
     <p:extLst>
       <p:ext uri="{BB962C8B-B14F-4D97-AF65-F5344CB8AC3E}">
-        <p14:creationId xmlns:p14="http://schemas.microsoft.com/office/powerpoint/2010/main" val="471330300"/>
+        <p14:creationId xmlns:p14="http://schemas.microsoft.com/office/powerpoint/2010/main" val="488177730"/>
       </p:ext>
     </p:extLst>
   </p:cSld>
@@ -7710,7 +7705,7 @@
           <p:cNvPr id="2" name="Rectangle 1">
             <a:extLst xmlns:a="http://schemas.openxmlformats.org/drawingml/2006/main">
               <a:ext uri="{FF2B5EF4-FFF2-40B4-BE49-F238E27FC236}">
-                <a16:creationId xmlns:a16="http://schemas.microsoft.com/office/drawing/2014/main" id="{2945D280-3EA2-4684-94C7-7FA2DAB11EE9}"/>
+                <a16:creationId xmlns:a16="http://schemas.microsoft.com/office/drawing/2014/main" id="{B8C91304-3876-4BE8-A750-2BCE0A9E5A5D}"/>
               </a:ext>
             </a:extLst>
           </p:cNvPr>
@@ -7763,7 +7758,7 @@
           <p:cNvPr id="3" name="Rectangle 2">
             <a:extLst xmlns:a="http://schemas.openxmlformats.org/drawingml/2006/main">
               <a:ext uri="{FF2B5EF4-FFF2-40B4-BE49-F238E27FC236}">
-                <a16:creationId xmlns:a16="http://schemas.microsoft.com/office/drawing/2014/main" id="{9913BE19-3874-4D5D-B16F-0C5B42DBB4FC}"/>
+                <a16:creationId xmlns:a16="http://schemas.microsoft.com/office/drawing/2014/main" id="{6F2677EE-9223-469F-88CC-79C47FB95DB3}"/>
               </a:ext>
             </a:extLst>
           </p:cNvPr>
@@ -7816,7 +7811,7 @@
           <p:cNvPr id="4" name="Rectangle 3">
             <a:extLst xmlns:a="http://schemas.openxmlformats.org/drawingml/2006/main">
               <a:ext uri="{FF2B5EF4-FFF2-40B4-BE49-F238E27FC236}">
-                <a16:creationId xmlns:a16="http://schemas.microsoft.com/office/drawing/2014/main" id="{90B240B6-4E10-4086-B218-59811802BF6C}"/>
+                <a16:creationId xmlns:a16="http://schemas.microsoft.com/office/drawing/2014/main" id="{FACC1211-BFD5-484C-9D7F-B8AB4BE2B688}"/>
               </a:ext>
             </a:extLst>
           </p:cNvPr>
@@ -7869,7 +7864,7 @@
           <p:cNvPr id="5" name="TextBox 4">
             <a:extLst xmlns:a="http://schemas.openxmlformats.org/drawingml/2006/main">
               <a:ext uri="{FF2B5EF4-FFF2-40B4-BE49-F238E27FC236}">
-                <a16:creationId xmlns:a16="http://schemas.microsoft.com/office/drawing/2014/main" id="{87701E11-A20C-41CA-8551-68CBB9200DE5}"/>
+                <a16:creationId xmlns:a16="http://schemas.microsoft.com/office/drawing/2014/main" id="{7D6C8189-8A5E-4B68-90D5-A726C42AE6A4}"/>
               </a:ext>
             </a:extLst>
           </p:cNvPr>
@@ -7932,7 +7927,7 @@
           <p:cNvPr id="6" name="Rounded Rectangle 5">
             <a:extLst xmlns:a="http://schemas.openxmlformats.org/drawingml/2006/main">
               <a:ext uri="{FF2B5EF4-FFF2-40B4-BE49-F238E27FC236}">
-                <a16:creationId xmlns:a16="http://schemas.microsoft.com/office/drawing/2014/main" id="{5352DBAA-2331-4BF3-A67B-40BEAF3D8E22}"/>
+                <a16:creationId xmlns:a16="http://schemas.microsoft.com/office/drawing/2014/main" id="{78AB36E8-BD5E-4BFB-8BFA-214D879441EE}"/>
               </a:ext>
             </a:extLst>
           </p:cNvPr>
@@ -7987,7 +7982,7 @@
           <p:cNvPr id="7" name="TextBox 6">
             <a:extLst xmlns:a="http://schemas.openxmlformats.org/drawingml/2006/main">
               <a:ext uri="{FF2B5EF4-FFF2-40B4-BE49-F238E27FC236}">
-                <a16:creationId xmlns:a16="http://schemas.microsoft.com/office/drawing/2014/main" id="{C08CAB5D-06FB-4615-AAEE-B83F3BEDC582}"/>
+                <a16:creationId xmlns:a16="http://schemas.microsoft.com/office/drawing/2014/main" id="{1DE16BAF-626F-4F93-B843-13417EE08E07}"/>
               </a:ext>
             </a:extLst>
           </p:cNvPr>
@@ -8110,7 +8105,7 @@
           <p:cNvPr id="8" name="Rounded Rectangle 7">
             <a:extLst xmlns:a="http://schemas.openxmlformats.org/drawingml/2006/main">
               <a:ext uri="{FF2B5EF4-FFF2-40B4-BE49-F238E27FC236}">
-                <a16:creationId xmlns:a16="http://schemas.microsoft.com/office/drawing/2014/main" id="{E799EC59-EC16-41D4-80E9-8D9F5D7F42E3}"/>
+                <a16:creationId xmlns:a16="http://schemas.microsoft.com/office/drawing/2014/main" id="{ADDBEEBE-D944-40D2-A581-2DEAB391344D}"/>
               </a:ext>
             </a:extLst>
           </p:cNvPr>
@@ -8165,7 +8160,7 @@
           <p:cNvPr id="9" name="TextBox 8">
             <a:extLst xmlns:a="http://schemas.openxmlformats.org/drawingml/2006/main">
               <a:ext uri="{FF2B5EF4-FFF2-40B4-BE49-F238E27FC236}">
-                <a16:creationId xmlns:a16="http://schemas.microsoft.com/office/drawing/2014/main" id="{5CE00759-1533-497E-A038-2351BC7304C9}"/>
+                <a16:creationId xmlns:a16="http://schemas.microsoft.com/office/drawing/2014/main" id="{DAEF26EF-6284-49D5-9E54-15D62919BED4}"/>
               </a:ext>
             </a:extLst>
           </p:cNvPr>
@@ -8307,7 +8302,7 @@
           <p:cNvPr id="10" name="Rounded Rectangle 9">
             <a:extLst xmlns:a="http://schemas.openxmlformats.org/drawingml/2006/main">
               <a:ext uri="{FF2B5EF4-FFF2-40B4-BE49-F238E27FC236}">
-                <a16:creationId xmlns:a16="http://schemas.microsoft.com/office/drawing/2014/main" id="{750C903F-9180-4980-A063-EDAE1AD13422}"/>
+                <a16:creationId xmlns:a16="http://schemas.microsoft.com/office/drawing/2014/main" id="{1C490E98-BD38-4B69-A831-890E87DD9EA1}"/>
               </a:ext>
             </a:extLst>
           </p:cNvPr>
@@ -8362,7 +8357,7 @@
           <p:cNvPr id="11" name="TextBox 10">
             <a:extLst xmlns:a="http://schemas.openxmlformats.org/drawingml/2006/main">
               <a:ext uri="{FF2B5EF4-FFF2-40B4-BE49-F238E27FC236}">
-                <a16:creationId xmlns:a16="http://schemas.microsoft.com/office/drawing/2014/main" id="{7CCBD16D-CF08-4239-88C2-EC146920739E}"/>
+                <a16:creationId xmlns:a16="http://schemas.microsoft.com/office/drawing/2014/main" id="{7F55B837-DB12-4624-9439-54B19C191F22}"/>
               </a:ext>
             </a:extLst>
           </p:cNvPr>
@@ -8464,7 +8459,7 @@
     </p:spTree>
     <p:extLst>
       <p:ext uri="{BB962C8B-B14F-4D97-AF65-F5344CB8AC3E}">
-        <p14:creationId xmlns:p14="http://schemas.microsoft.com/office/powerpoint/2010/main" val="1183618080"/>
+        <p14:creationId xmlns:p14="http://schemas.microsoft.com/office/powerpoint/2010/main" val="120121349"/>
       </p:ext>
     </p:extLst>
   </p:cSld>
@@ -8488,7 +8483,7 @@
           <p:cNvPr id="2" name="Rectangle 1">
             <a:extLst xmlns:a="http://schemas.openxmlformats.org/drawingml/2006/main">
               <a:ext uri="{FF2B5EF4-FFF2-40B4-BE49-F238E27FC236}">
-                <a16:creationId xmlns:a16="http://schemas.microsoft.com/office/drawing/2014/main" id="{CC5A468A-0FD3-45A3-99B1-BA404CA11278}"/>
+                <a16:creationId xmlns:a16="http://schemas.microsoft.com/office/drawing/2014/main" id="{6AB984D4-4660-4AEF-9648-60243DCAC02E}"/>
               </a:ext>
             </a:extLst>
           </p:cNvPr>
@@ -8541,7 +8536,7 @@
           <p:cNvPr id="3" name="Rectangle 2">
             <a:extLst xmlns:a="http://schemas.openxmlformats.org/drawingml/2006/main">
               <a:ext uri="{FF2B5EF4-FFF2-40B4-BE49-F238E27FC236}">
-                <a16:creationId xmlns:a16="http://schemas.microsoft.com/office/drawing/2014/main" id="{E7F4E103-0AC1-4C8C-A728-A1FBE56C3B89}"/>
+                <a16:creationId xmlns:a16="http://schemas.microsoft.com/office/drawing/2014/main" id="{28C4C1D7-E816-45D1-A47E-4676888FC222}"/>
               </a:ext>
             </a:extLst>
           </p:cNvPr>
@@ -8594,7 +8589,7 @@
           <p:cNvPr id="4" name="Rectangle 3">
             <a:extLst xmlns:a="http://schemas.openxmlformats.org/drawingml/2006/main">
               <a:ext uri="{FF2B5EF4-FFF2-40B4-BE49-F238E27FC236}">
-                <a16:creationId xmlns:a16="http://schemas.microsoft.com/office/drawing/2014/main" id="{43D4ABD5-44C4-459F-9EF7-EC5591521618}"/>
+                <a16:creationId xmlns:a16="http://schemas.microsoft.com/office/drawing/2014/main" id="{4A013848-876A-4E01-A2F1-34F899850DCF}"/>
               </a:ext>
             </a:extLst>
           </p:cNvPr>
@@ -8647,7 +8642,7 @@
           <p:cNvPr id="5" name="TextBox 4">
             <a:extLst xmlns:a="http://schemas.openxmlformats.org/drawingml/2006/main">
               <a:ext uri="{FF2B5EF4-FFF2-40B4-BE49-F238E27FC236}">
-                <a16:creationId xmlns:a16="http://schemas.microsoft.com/office/drawing/2014/main" id="{A6B05412-064D-417E-AA2F-86C1F06671C8}"/>
+                <a16:creationId xmlns:a16="http://schemas.microsoft.com/office/drawing/2014/main" id="{F9F0810A-02BB-49EE-8ABE-C61125FECA91}"/>
               </a:ext>
             </a:extLst>
           </p:cNvPr>
@@ -8710,7 +8705,7 @@
           <p:cNvPr id="6" name="Rounded Rectangle 5">
             <a:extLst xmlns:a="http://schemas.openxmlformats.org/drawingml/2006/main">
               <a:ext uri="{FF2B5EF4-FFF2-40B4-BE49-F238E27FC236}">
-                <a16:creationId xmlns:a16="http://schemas.microsoft.com/office/drawing/2014/main" id="{A044DEB2-B7DA-485B-A509-5F184A698B72}"/>
+                <a16:creationId xmlns:a16="http://schemas.microsoft.com/office/drawing/2014/main" id="{E864AA60-E301-46BE-8B0B-FE9C9746229B}"/>
               </a:ext>
             </a:extLst>
           </p:cNvPr>
@@ -8765,7 +8760,7 @@
           <p:cNvPr id="7" name="TextBox 6">
             <a:extLst xmlns:a="http://schemas.openxmlformats.org/drawingml/2006/main">
               <a:ext uri="{FF2B5EF4-FFF2-40B4-BE49-F238E27FC236}">
-                <a16:creationId xmlns:a16="http://schemas.microsoft.com/office/drawing/2014/main" id="{4D9B79DA-3037-436A-A9A5-3427A9792617}"/>
+                <a16:creationId xmlns:a16="http://schemas.microsoft.com/office/drawing/2014/main" id="{92E2E69E-8877-481B-84C0-BF506D298332}"/>
               </a:ext>
             </a:extLst>
           </p:cNvPr>
@@ -8945,7 +8940,7 @@
           <p:cNvPr id="8" name="Rounded Rectangle 7">
             <a:extLst xmlns:a="http://schemas.openxmlformats.org/drawingml/2006/main">
               <a:ext uri="{FF2B5EF4-FFF2-40B4-BE49-F238E27FC236}">
-                <a16:creationId xmlns:a16="http://schemas.microsoft.com/office/drawing/2014/main" id="{DFF7E8D4-1B00-4D8A-B7A3-F39B1AD04CB8}"/>
+                <a16:creationId xmlns:a16="http://schemas.microsoft.com/office/drawing/2014/main" id="{1F879C99-4BCF-49A0-A090-AF63D8E2C405}"/>
               </a:ext>
             </a:extLst>
           </p:cNvPr>
@@ -9000,7 +8995,7 @@
           <p:cNvPr id="9" name="TextBox 8">
             <a:extLst xmlns:a="http://schemas.openxmlformats.org/drawingml/2006/main">
               <a:ext uri="{FF2B5EF4-FFF2-40B4-BE49-F238E27FC236}">
-                <a16:creationId xmlns:a16="http://schemas.microsoft.com/office/drawing/2014/main" id="{D9A495E4-B1F0-4D34-8B04-8EBBF3F3F711}"/>
+                <a16:creationId xmlns:a16="http://schemas.microsoft.com/office/drawing/2014/main" id="{18EDB787-C28A-41D2-8E9A-AC238A804C37}"/>
               </a:ext>
             </a:extLst>
           </p:cNvPr>
@@ -9159,7 +9154,7 @@
     </p:spTree>
     <p:extLst>
       <p:ext uri="{BB962C8B-B14F-4D97-AF65-F5344CB8AC3E}">
-        <p14:creationId xmlns:p14="http://schemas.microsoft.com/office/powerpoint/2010/main" val="1986843225"/>
+        <p14:creationId xmlns:p14="http://schemas.microsoft.com/office/powerpoint/2010/main" val="137370403"/>
       </p:ext>
     </p:extLst>
   </p:cSld>
@@ -9183,7 +9178,7 @@
           <p:cNvPr id="2" name="Rectangle 1">
             <a:extLst xmlns:a="http://schemas.openxmlformats.org/drawingml/2006/main">
               <a:ext uri="{FF2B5EF4-FFF2-40B4-BE49-F238E27FC236}">
-                <a16:creationId xmlns:a16="http://schemas.microsoft.com/office/drawing/2014/main" id="{BEC47524-EA3F-41C6-B2A9-59FBC50C087A}"/>
+                <a16:creationId xmlns:a16="http://schemas.microsoft.com/office/drawing/2014/main" id="{08E4196B-9943-4EE2-A2DC-C2F6FA7EACB7}"/>
               </a:ext>
             </a:extLst>
           </p:cNvPr>
@@ -9236,7 +9231,7 @@
           <p:cNvPr id="3" name="Rectangle 2">
             <a:extLst xmlns:a="http://schemas.openxmlformats.org/drawingml/2006/main">
               <a:ext uri="{FF2B5EF4-FFF2-40B4-BE49-F238E27FC236}">
-                <a16:creationId xmlns:a16="http://schemas.microsoft.com/office/drawing/2014/main" id="{662C4A4D-C0A2-4A6E-99E7-8BE3361ED4E2}"/>
+                <a16:creationId xmlns:a16="http://schemas.microsoft.com/office/drawing/2014/main" id="{7A30C625-1CE2-4F88-B32B-662C34C8AF7D}"/>
               </a:ext>
             </a:extLst>
           </p:cNvPr>
@@ -9289,7 +9284,7 @@
           <p:cNvPr id="4" name="Rectangle 3">
             <a:extLst xmlns:a="http://schemas.openxmlformats.org/drawingml/2006/main">
               <a:ext uri="{FF2B5EF4-FFF2-40B4-BE49-F238E27FC236}">
-                <a16:creationId xmlns:a16="http://schemas.microsoft.com/office/drawing/2014/main" id="{F819784A-AC14-4CB4-9DBD-7424D81B2EBC}"/>
+                <a16:creationId xmlns:a16="http://schemas.microsoft.com/office/drawing/2014/main" id="{6F3D1556-4D1E-4DA1-9562-E7BA7E0910F5}"/>
               </a:ext>
             </a:extLst>
           </p:cNvPr>
@@ -9342,7 +9337,7 @@
           <p:cNvPr id="5" name="TextBox 4">
             <a:extLst xmlns:a="http://schemas.openxmlformats.org/drawingml/2006/main">
               <a:ext uri="{FF2B5EF4-FFF2-40B4-BE49-F238E27FC236}">
-                <a16:creationId xmlns:a16="http://schemas.microsoft.com/office/drawing/2014/main" id="{EF52ED6E-ECC4-4FD2-A0B7-938676022EDF}"/>
+                <a16:creationId xmlns:a16="http://schemas.microsoft.com/office/drawing/2014/main" id="{B3F33527-A7F5-4E77-8246-72462F09F6FE}"/>
               </a:ext>
             </a:extLst>
           </p:cNvPr>
@@ -9405,7 +9400,7 @@
           <p:cNvPr id="6" name="Rounded Rectangle 5">
             <a:extLst xmlns:a="http://schemas.openxmlformats.org/drawingml/2006/main">
               <a:ext uri="{FF2B5EF4-FFF2-40B4-BE49-F238E27FC236}">
-                <a16:creationId xmlns:a16="http://schemas.microsoft.com/office/drawing/2014/main" id="{893AFBA4-CA38-4FDF-8A4E-CEDD32B5A8FD}"/>
+                <a16:creationId xmlns:a16="http://schemas.microsoft.com/office/drawing/2014/main" id="{6A538AA0-B61E-443C-ABFF-CB0C09F54C0E}"/>
               </a:ext>
             </a:extLst>
           </p:cNvPr>
@@ -9460,7 +9455,7 @@
           <p:cNvPr id="7" name="TextBox 6">
             <a:extLst xmlns:a="http://schemas.openxmlformats.org/drawingml/2006/main">
               <a:ext uri="{FF2B5EF4-FFF2-40B4-BE49-F238E27FC236}">
-                <a16:creationId xmlns:a16="http://schemas.microsoft.com/office/drawing/2014/main" id="{2CC7091F-8DD6-4C66-A31C-2F632710A9ED}"/>
+                <a16:creationId xmlns:a16="http://schemas.microsoft.com/office/drawing/2014/main" id="{4F92E36C-24CE-4777-81AE-B8680FC63453}"/>
               </a:ext>
             </a:extLst>
           </p:cNvPr>
@@ -9678,7 +9673,7 @@
           <p:cNvPr id="8" name="Rounded Rectangle 7">
             <a:extLst xmlns:a="http://schemas.openxmlformats.org/drawingml/2006/main">
               <a:ext uri="{FF2B5EF4-FFF2-40B4-BE49-F238E27FC236}">
-                <a16:creationId xmlns:a16="http://schemas.microsoft.com/office/drawing/2014/main" id="{1E20B6B2-AD7A-4496-9D9D-F4BC566B12E2}"/>
+                <a16:creationId xmlns:a16="http://schemas.microsoft.com/office/drawing/2014/main" id="{62B801AF-7D04-42D5-881D-54AD81DC0AA1}"/>
               </a:ext>
             </a:extLst>
           </p:cNvPr>
@@ -9733,7 +9728,7 @@
           <p:cNvPr id="9" name="TextBox 8">
             <a:extLst xmlns:a="http://schemas.openxmlformats.org/drawingml/2006/main">
               <a:ext uri="{FF2B5EF4-FFF2-40B4-BE49-F238E27FC236}">
-                <a16:creationId xmlns:a16="http://schemas.microsoft.com/office/drawing/2014/main" id="{5F6BF4A8-58DE-4A4E-B8A6-5569E8D01AC1}"/>
+                <a16:creationId xmlns:a16="http://schemas.microsoft.com/office/drawing/2014/main" id="{04EFC88A-F1BC-4FE2-9DFC-B2A015EBA642}"/>
               </a:ext>
             </a:extLst>
           </p:cNvPr>
@@ -9968,7 +9963,7 @@
     </p:spTree>
     <p:extLst>
       <p:ext uri="{BB962C8B-B14F-4D97-AF65-F5344CB8AC3E}">
-        <p14:creationId xmlns:p14="http://schemas.microsoft.com/office/powerpoint/2010/main" val="69561193"/>
+        <p14:creationId xmlns:p14="http://schemas.microsoft.com/office/powerpoint/2010/main" val="656426320"/>
       </p:ext>
     </p:extLst>
   </p:cSld>
@@ -9992,7 +9987,7 @@
           <p:cNvPr id="2" name="Rectangle 1">
             <a:extLst xmlns:a="http://schemas.openxmlformats.org/drawingml/2006/main">
               <a:ext uri="{FF2B5EF4-FFF2-40B4-BE49-F238E27FC236}">
-                <a16:creationId xmlns:a16="http://schemas.microsoft.com/office/drawing/2014/main" id="{687F6725-EFB1-46C9-B912-06E34D3C853D}"/>
+                <a16:creationId xmlns:a16="http://schemas.microsoft.com/office/drawing/2014/main" id="{6322017C-305A-4F56-9595-A54708DEFD2E}"/>
               </a:ext>
             </a:extLst>
           </p:cNvPr>
@@ -10045,7 +10040,7 @@
           <p:cNvPr id="3" name="Rectangle 2">
             <a:extLst xmlns:a="http://schemas.openxmlformats.org/drawingml/2006/main">
               <a:ext uri="{FF2B5EF4-FFF2-40B4-BE49-F238E27FC236}">
-                <a16:creationId xmlns:a16="http://schemas.microsoft.com/office/drawing/2014/main" id="{17742F69-8437-483B-9C0A-A9E0E60D057A}"/>
+                <a16:creationId xmlns:a16="http://schemas.microsoft.com/office/drawing/2014/main" id="{54E4CFEB-4D1F-480D-AD73-772188BDD289}"/>
               </a:ext>
             </a:extLst>
           </p:cNvPr>
@@ -10098,7 +10093,7 @@
           <p:cNvPr id="4" name="Rectangle 3">
             <a:extLst xmlns:a="http://schemas.openxmlformats.org/drawingml/2006/main">
               <a:ext uri="{FF2B5EF4-FFF2-40B4-BE49-F238E27FC236}">
-                <a16:creationId xmlns:a16="http://schemas.microsoft.com/office/drawing/2014/main" id="{1E758038-14C0-49DE-BB7B-231861C04FF6}"/>
+                <a16:creationId xmlns:a16="http://schemas.microsoft.com/office/drawing/2014/main" id="{854E5EBB-22E3-40D2-8372-6E3BAB4E89F3}"/>
               </a:ext>
             </a:extLst>
           </p:cNvPr>
@@ -10151,7 +10146,7 @@
           <p:cNvPr id="5" name="TextBox 4">
             <a:extLst xmlns:a="http://schemas.openxmlformats.org/drawingml/2006/main">
               <a:ext uri="{FF2B5EF4-FFF2-40B4-BE49-F238E27FC236}">
-                <a16:creationId xmlns:a16="http://schemas.microsoft.com/office/drawing/2014/main" id="{40DBE2EF-6C72-4AD4-B953-C1DBE3BCDBA4}"/>
+                <a16:creationId xmlns:a16="http://schemas.microsoft.com/office/drawing/2014/main" id="{F86CD8D8-D06F-463E-B213-FD9ED83F7CBE}"/>
               </a:ext>
             </a:extLst>
           </p:cNvPr>
@@ -10214,7 +10209,7 @@
           <p:cNvPr id="6" name="Rounded Rectangle 5">
             <a:extLst xmlns:a="http://schemas.openxmlformats.org/drawingml/2006/main">
               <a:ext uri="{FF2B5EF4-FFF2-40B4-BE49-F238E27FC236}">
-                <a16:creationId xmlns:a16="http://schemas.microsoft.com/office/drawing/2014/main" id="{C340242C-EFE5-438F-9B58-E8E988362548}"/>
+                <a16:creationId xmlns:a16="http://schemas.microsoft.com/office/drawing/2014/main" id="{7941E52D-A58B-4D1D-A30E-06592AD277AA}"/>
               </a:ext>
             </a:extLst>
           </p:cNvPr>
@@ -10269,7 +10264,7 @@
           <p:cNvPr id="7" name="TextBox 6">
             <a:extLst xmlns:a="http://schemas.openxmlformats.org/drawingml/2006/main">
               <a:ext uri="{FF2B5EF4-FFF2-40B4-BE49-F238E27FC236}">
-                <a16:creationId xmlns:a16="http://schemas.microsoft.com/office/drawing/2014/main" id="{FB2E5F24-7D14-42D7-ACF5-CDC507B3270F}"/>
+                <a16:creationId xmlns:a16="http://schemas.microsoft.com/office/drawing/2014/main" id="{7C1EA024-712E-4017-82AB-B3CB214D9D29}"/>
               </a:ext>
             </a:extLst>
           </p:cNvPr>
@@ -10652,7 +10647,7 @@
           <p:nvPr/>
         </p:nvPicPr>
         <p:blipFill>
-          <a:blip xmlns:r="http://schemas.openxmlformats.org/officeDocument/2006/relationships" xmlns:a="http://schemas.openxmlformats.org/drawingml/2006/main" r:embed="Rdc4afde5397a4944"/>
+          <a:blip xmlns:r="http://schemas.openxmlformats.org/officeDocument/2006/relationships" xmlns:a="http://schemas.openxmlformats.org/drawingml/2006/main" r:embed="R217fd81bb07544fe"/>
           <a:stretch xmlns:a="http://schemas.openxmlformats.org/drawingml/2006/main">
             <a:fillRect l="0" t="0" r="0" b="0"/>
           </a:stretch>
@@ -10672,7 +10667,7 @@
           <p:cNvPr id="9" name="Rounded Rectangle 8">
             <a:extLst xmlns:a="http://schemas.openxmlformats.org/drawingml/2006/main">
               <a:ext uri="{FF2B5EF4-FFF2-40B4-BE49-F238E27FC236}">
-                <a16:creationId xmlns:a16="http://schemas.microsoft.com/office/drawing/2014/main" id="{E875D768-1322-4A3F-B390-93D0D3C63359}"/>
+                <a16:creationId xmlns:a16="http://schemas.microsoft.com/office/drawing/2014/main" id="{97D8C64F-7C54-40ED-B9E9-AFD49E4A9F14}"/>
               </a:ext>
             </a:extLst>
           </p:cNvPr>
@@ -10727,7 +10722,7 @@
           <p:cNvPr id="10" name="TextBox 9">
             <a:extLst xmlns:a="http://schemas.openxmlformats.org/drawingml/2006/main">
               <a:ext uri="{FF2B5EF4-FFF2-40B4-BE49-F238E27FC236}">
-                <a16:creationId xmlns:a16="http://schemas.microsoft.com/office/drawing/2014/main" id="{58D8B798-5532-4F00-8CB5-DD0B8FA71F60}"/>
+                <a16:creationId xmlns:a16="http://schemas.microsoft.com/office/drawing/2014/main" id="{B4C2B5A1-1E73-4836-B6C8-B1E23805CE34}"/>
               </a:ext>
             </a:extLst>
           </p:cNvPr>
@@ -10813,7 +10808,7 @@
     </p:spTree>
     <p:extLst>
       <p:ext uri="{BB962C8B-B14F-4D97-AF65-F5344CB8AC3E}">
-        <p14:creationId xmlns:p14="http://schemas.microsoft.com/office/powerpoint/2010/main" val="700816310"/>
+        <p14:creationId xmlns:p14="http://schemas.microsoft.com/office/powerpoint/2010/main" val="1909978044"/>
       </p:ext>
     </p:extLst>
   </p:cSld>
@@ -10837,7 +10832,7 @@
           <p:cNvPr id="2" name="Rectangle 1">
             <a:extLst xmlns:a="http://schemas.openxmlformats.org/drawingml/2006/main">
               <a:ext uri="{FF2B5EF4-FFF2-40B4-BE49-F238E27FC236}">
-                <a16:creationId xmlns:a16="http://schemas.microsoft.com/office/drawing/2014/main" id="{CE7A11C3-71DA-47E7-9CFD-64761BC88CD1}"/>
+                <a16:creationId xmlns:a16="http://schemas.microsoft.com/office/drawing/2014/main" id="{14ABA4FC-409E-4306-89C9-2ADD3BD74917}"/>
               </a:ext>
             </a:extLst>
           </p:cNvPr>
@@ -10890,7 +10885,7 @@
           <p:cNvPr id="3" name="Rectangle 2">
             <a:extLst xmlns:a="http://schemas.openxmlformats.org/drawingml/2006/main">
               <a:ext uri="{FF2B5EF4-FFF2-40B4-BE49-F238E27FC236}">
-                <a16:creationId xmlns:a16="http://schemas.microsoft.com/office/drawing/2014/main" id="{E2B3E492-F997-44FF-A0BD-A7CF2A584D4C}"/>
+                <a16:creationId xmlns:a16="http://schemas.microsoft.com/office/drawing/2014/main" id="{94798FD9-03D7-4AF6-8611-A7D33D457A14}"/>
               </a:ext>
             </a:extLst>
           </p:cNvPr>
@@ -10943,7 +10938,7 @@
           <p:cNvPr id="4" name="Rectangle 3">
             <a:extLst xmlns:a="http://schemas.openxmlformats.org/drawingml/2006/main">
               <a:ext uri="{FF2B5EF4-FFF2-40B4-BE49-F238E27FC236}">
-                <a16:creationId xmlns:a16="http://schemas.microsoft.com/office/drawing/2014/main" id="{40C4AE07-E9DB-44B8-AA86-D7ADB66B8B4B}"/>
+                <a16:creationId xmlns:a16="http://schemas.microsoft.com/office/drawing/2014/main" id="{B3124EE1-B196-40FD-9776-1424BA286206}"/>
               </a:ext>
             </a:extLst>
           </p:cNvPr>
@@ -10996,7 +10991,7 @@
           <p:cNvPr id="5" name="TextBox 4">
             <a:extLst xmlns:a="http://schemas.openxmlformats.org/drawingml/2006/main">
               <a:ext uri="{FF2B5EF4-FFF2-40B4-BE49-F238E27FC236}">
-                <a16:creationId xmlns:a16="http://schemas.microsoft.com/office/drawing/2014/main" id="{F5F5FAB7-D8A0-44A4-8D9B-9DFC238B38A8}"/>
+                <a16:creationId xmlns:a16="http://schemas.microsoft.com/office/drawing/2014/main" id="{9EBF54F2-A178-430A-B712-0CC2319FDB77}"/>
               </a:ext>
             </a:extLst>
           </p:cNvPr>
@@ -11059,7 +11054,7 @@
           <p:cNvPr id="6" name="Rounded Rectangle 5">
             <a:extLst xmlns:a="http://schemas.openxmlformats.org/drawingml/2006/main">
               <a:ext uri="{FF2B5EF4-FFF2-40B4-BE49-F238E27FC236}">
-                <a16:creationId xmlns:a16="http://schemas.microsoft.com/office/drawing/2014/main" id="{9204241B-FD45-4D46-A329-06C436406649}"/>
+                <a16:creationId xmlns:a16="http://schemas.microsoft.com/office/drawing/2014/main" id="{795829A9-F77C-43C5-ADE1-85B87E9275BA}"/>
               </a:ext>
             </a:extLst>
           </p:cNvPr>
@@ -11114,7 +11109,7 @@
           <p:cNvPr id="7" name="TextBox 6">
             <a:extLst xmlns:a="http://schemas.openxmlformats.org/drawingml/2006/main">
               <a:ext uri="{FF2B5EF4-FFF2-40B4-BE49-F238E27FC236}">
-                <a16:creationId xmlns:a16="http://schemas.microsoft.com/office/drawing/2014/main" id="{5264965E-9E8B-4421-95B2-0185A7513CCF}"/>
+                <a16:creationId xmlns:a16="http://schemas.microsoft.com/office/drawing/2014/main" id="{856EEE6D-5744-4F64-B9CF-B1DFDD626B1A}"/>
               </a:ext>
             </a:extLst>
           </p:cNvPr>
@@ -11351,7 +11346,7 @@
           <p:cNvPr id="8" name="Rounded Rectangle 7">
             <a:extLst xmlns:a="http://schemas.openxmlformats.org/drawingml/2006/main">
               <a:ext uri="{FF2B5EF4-FFF2-40B4-BE49-F238E27FC236}">
-                <a16:creationId xmlns:a16="http://schemas.microsoft.com/office/drawing/2014/main" id="{9A7BAFB5-05B0-4C18-8B2A-34483271FF5B}"/>
+                <a16:creationId xmlns:a16="http://schemas.microsoft.com/office/drawing/2014/main" id="{5E693F00-2792-4741-99A5-94B263CF7B57}"/>
               </a:ext>
             </a:extLst>
           </p:cNvPr>
@@ -11406,7 +11401,7 @@
           <p:cNvPr id="9" name="TextBox 8">
             <a:extLst xmlns:a="http://schemas.openxmlformats.org/drawingml/2006/main">
               <a:ext uri="{FF2B5EF4-FFF2-40B4-BE49-F238E27FC236}">
-                <a16:creationId xmlns:a16="http://schemas.microsoft.com/office/drawing/2014/main" id="{0C3D3527-44DA-4123-AAB6-BEC85B92C9B1}"/>
+                <a16:creationId xmlns:a16="http://schemas.microsoft.com/office/drawing/2014/main" id="{FA96DDAB-B504-4EAB-8E88-BEEDF8729B4D}"/>
               </a:ext>
             </a:extLst>
           </p:cNvPr>
@@ -11611,7 +11606,7 @@
     </p:spTree>
     <p:extLst>
       <p:ext uri="{BB962C8B-B14F-4D97-AF65-F5344CB8AC3E}">
-        <p14:creationId xmlns:p14="http://schemas.microsoft.com/office/powerpoint/2010/main" val="2044301991"/>
+        <p14:creationId xmlns:p14="http://schemas.microsoft.com/office/powerpoint/2010/main" val="997993178"/>
       </p:ext>
     </p:extLst>
   </p:cSld>
@@ -11635,7 +11630,7 @@
           <p:cNvPr id="2" name="Rectangle 1">
             <a:extLst xmlns:a="http://schemas.openxmlformats.org/drawingml/2006/main">
               <a:ext uri="{FF2B5EF4-FFF2-40B4-BE49-F238E27FC236}">
-                <a16:creationId xmlns:a16="http://schemas.microsoft.com/office/drawing/2014/main" id="{8540B0ED-E1FC-45F7-B4B3-E666D12FC96D}"/>
+                <a16:creationId xmlns:a16="http://schemas.microsoft.com/office/drawing/2014/main" id="{69F0A620-86C2-4084-AFC5-F97C14151DD2}"/>
               </a:ext>
             </a:extLst>
           </p:cNvPr>
@@ -11688,7 +11683,7 @@
           <p:cNvPr id="3" name="Rectangle 2">
             <a:extLst xmlns:a="http://schemas.openxmlformats.org/drawingml/2006/main">
               <a:ext uri="{FF2B5EF4-FFF2-40B4-BE49-F238E27FC236}">
-                <a16:creationId xmlns:a16="http://schemas.microsoft.com/office/drawing/2014/main" id="{3BC546D6-D1C3-4FFB-AA12-3E189D1C82EF}"/>
+                <a16:creationId xmlns:a16="http://schemas.microsoft.com/office/drawing/2014/main" id="{772A335E-6253-4EBF-A453-E2C63DD7F0D4}"/>
               </a:ext>
             </a:extLst>
           </p:cNvPr>
@@ -11741,7 +11736,7 @@
           <p:cNvPr id="4" name="Rectangle 3">
             <a:extLst xmlns:a="http://schemas.openxmlformats.org/drawingml/2006/main">
               <a:ext uri="{FF2B5EF4-FFF2-40B4-BE49-F238E27FC236}">
-                <a16:creationId xmlns:a16="http://schemas.microsoft.com/office/drawing/2014/main" id="{E26E1B9A-20B6-4630-9044-768A03989CF5}"/>
+                <a16:creationId xmlns:a16="http://schemas.microsoft.com/office/drawing/2014/main" id="{FF785CC3-2774-49C0-A222-7CB78F3EAE76}"/>
               </a:ext>
             </a:extLst>
           </p:cNvPr>
@@ -11794,7 +11789,7 @@
           <p:cNvPr id="5" name="TextBox 4">
             <a:extLst xmlns:a="http://schemas.openxmlformats.org/drawingml/2006/main">
               <a:ext uri="{FF2B5EF4-FFF2-40B4-BE49-F238E27FC236}">
-                <a16:creationId xmlns:a16="http://schemas.microsoft.com/office/drawing/2014/main" id="{58265557-8535-463D-8E29-F92635A228EA}"/>
+                <a16:creationId xmlns:a16="http://schemas.microsoft.com/office/drawing/2014/main" id="{E7B5E16E-53FF-4E18-9B7D-3130B26AE1B4}"/>
               </a:ext>
             </a:extLst>
           </p:cNvPr>
@@ -11857,7 +11852,7 @@
           <p:cNvPr id="6" name="Rounded Rectangle 5">
             <a:extLst xmlns:a="http://schemas.openxmlformats.org/drawingml/2006/main">
               <a:ext uri="{FF2B5EF4-FFF2-40B4-BE49-F238E27FC236}">
-                <a16:creationId xmlns:a16="http://schemas.microsoft.com/office/drawing/2014/main" id="{A9A49EB8-901F-46BA-B78C-2273A64857A8}"/>
+                <a16:creationId xmlns:a16="http://schemas.microsoft.com/office/drawing/2014/main" id="{B84C5DA0-7A88-420F-B6F8-6897826EFDD8}"/>
               </a:ext>
             </a:extLst>
           </p:cNvPr>
@@ -11912,7 +11907,7 @@
           <p:cNvPr id="7" name="TextBox 6">
             <a:extLst xmlns:a="http://schemas.openxmlformats.org/drawingml/2006/main">
               <a:ext uri="{FF2B5EF4-FFF2-40B4-BE49-F238E27FC236}">
-                <a16:creationId xmlns:a16="http://schemas.microsoft.com/office/drawing/2014/main" id="{565EEACD-694B-4BDF-9B37-BEC9C4F9B6A6}"/>
+                <a16:creationId xmlns:a16="http://schemas.microsoft.com/office/drawing/2014/main" id="{5414A0E2-3521-47CD-A514-123BE8D8300E}"/>
               </a:ext>
             </a:extLst>
           </p:cNvPr>
@@ -12035,7 +12030,7 @@
           <p:cNvPr id="8" name="Rounded Rectangle 7">
             <a:extLst xmlns:a="http://schemas.openxmlformats.org/drawingml/2006/main">
               <a:ext uri="{FF2B5EF4-FFF2-40B4-BE49-F238E27FC236}">
-                <a16:creationId xmlns:a16="http://schemas.microsoft.com/office/drawing/2014/main" id="{F33D9A35-7A4E-4ADB-BD55-AEA3C6AB5B2E}"/>
+                <a16:creationId xmlns:a16="http://schemas.microsoft.com/office/drawing/2014/main" id="{EDAC4894-8736-4779-9617-9A237715673F}"/>
               </a:ext>
             </a:extLst>
           </p:cNvPr>
@@ -12090,7 +12085,7 @@
           <p:cNvPr id="9" name="TextBox 8">
             <a:extLst xmlns:a="http://schemas.openxmlformats.org/drawingml/2006/main">
               <a:ext uri="{FF2B5EF4-FFF2-40B4-BE49-F238E27FC236}">
-                <a16:creationId xmlns:a16="http://schemas.microsoft.com/office/drawing/2014/main" id="{CEF697E1-27A7-4EAA-AD68-AA1E01883E88}"/>
+                <a16:creationId xmlns:a16="http://schemas.microsoft.com/office/drawing/2014/main" id="{B4DBC302-F590-46AD-92B9-842D13B19EF0}"/>
               </a:ext>
             </a:extLst>
           </p:cNvPr>
@@ -12213,7 +12208,7 @@
           <p:cNvPr id="10" name="Rounded Rectangle 9">
             <a:extLst xmlns:a="http://schemas.openxmlformats.org/drawingml/2006/main">
               <a:ext uri="{FF2B5EF4-FFF2-40B4-BE49-F238E27FC236}">
-                <a16:creationId xmlns:a16="http://schemas.microsoft.com/office/drawing/2014/main" id="{6D9CFD45-AB27-44A3-B2BE-185304864318}"/>
+                <a16:creationId xmlns:a16="http://schemas.microsoft.com/office/drawing/2014/main" id="{F3D87629-35C8-4B63-9312-71F774B807CC}"/>
               </a:ext>
             </a:extLst>
           </p:cNvPr>
@@ -12268,7 +12263,7 @@
           <p:cNvPr id="11" name="TextBox 10">
             <a:extLst xmlns:a="http://schemas.openxmlformats.org/drawingml/2006/main">
               <a:ext uri="{FF2B5EF4-FFF2-40B4-BE49-F238E27FC236}">
-                <a16:creationId xmlns:a16="http://schemas.microsoft.com/office/drawing/2014/main" id="{CEE48DA2-A75A-4546-AE0D-B3BAFC6D0727}"/>
+                <a16:creationId xmlns:a16="http://schemas.microsoft.com/office/drawing/2014/main" id="{9AD9E8C6-145A-41F7-B32E-44BE43E59C0A}"/>
               </a:ext>
             </a:extLst>
           </p:cNvPr>
@@ -12367,7 +12362,7 @@
                 <a:ea typeface="Calibri"/>
                 <a:cs typeface="Calibri"/>
               </a:rPr>
-              <a:t>Condition      Accuracy    Macro-F1    Delta vs No-RAG</a:t>
+              <a:t>Condition      Accuracy    Macro-F1 (474 lớp)    Delta vs No-RAG</a:t>
             </a:r>
           </a:p>
           <a:p xmlns:a="http://schemas.openxmlformats.org/drawingml/2006/main">
@@ -12394,7 +12389,7 @@
                 <a:ea typeface="Calibri"/>
                 <a:cs typeface="Calibri"/>
               </a:rPr>
-              <a:t>-------------------------------------------------------</a:t>
+              <a:t>-----------------------------------------------------------------</a:t>
             </a:r>
           </a:p>
           <a:p xmlns:a="http://schemas.openxmlformats.org/drawingml/2006/main">
@@ -12421,7 +12416,7 @@
                 <a:ea typeface="Calibri"/>
                 <a:cs typeface="Calibri"/>
               </a:rPr>
-              <a:t>no_rag         0.5000      0.0929      baseline</a:t>
+              <a:t>no_rag         0.5000      0.0929                baseline</a:t>
             </a:r>
           </a:p>
           <a:p xmlns:a="http://schemas.openxmlformats.org/drawingml/2006/main">
@@ -12448,7 +12443,7 @@
                 <a:ea typeface="Calibri"/>
                 <a:cs typeface="Calibri"/>
               </a:rPr>
-              <a:t>rag_k1         0.5200      0.1000      +0.0200 (+0.0071 F1)</a:t>
+              <a:t>rag_k1         0.5200      0.1000                +0.0200 (+0.0071 F1)</a:t>
             </a:r>
           </a:p>
           <a:p xmlns:a="http://schemas.openxmlformats.org/drawingml/2006/main">
@@ -12475,7 +12470,7 @@
                 <a:ea typeface="Calibri"/>
                 <a:cs typeface="Calibri"/>
               </a:rPr>
-              <a:t>rag_k3         0.5500      0.1200      +0.0500 (+0.0271 F1)</a:t>
+              <a:t>rag_k3         0.5500      0.1200                +0.0500 (+0.0271 F1)</a:t>
             </a:r>
           </a:p>
           <a:p xmlns:a="http://schemas.openxmlformats.org/drawingml/2006/main">
@@ -12502,7 +12497,7 @@
                 <a:ea typeface="Calibri"/>
                 <a:cs typeface="Calibri"/>
               </a:rPr>
-              <a:t>rag_k5         0.5800      0.1400      +0.0800 (+0.0471 F1)</a:t>
+              <a:t>rag_k5         0.5800      0.1400                +0.0800 (+0.0471 F1)</a:t>
             </a:r>
           </a:p>
           <a:p xmlns:a="http://schemas.openxmlformats.org/drawingml/2006/main">
@@ -12529,7 +12524,7 @@
                 <a:ea typeface="Calibri"/>
                 <a:cs typeface="Calibri"/>
               </a:rPr>
-              <a:t>rag_k10        0.6000      0.1600      +0.1000 (+0.0671 F1)</a:t>
+              <a:t>rag_k10        0.6000      0.1600                +0.1000 (+0.0671 F1)</a:t>
             </a:r>
           </a:p>
           <a:p xmlns:a="http://schemas.openxmlformats.org/drawingml/2006/main">
@@ -12618,7 +12613,7 @@
     </p:spTree>
     <p:extLst>
       <p:ext uri="{BB962C8B-B14F-4D97-AF65-F5344CB8AC3E}">
-        <p14:creationId xmlns:p14="http://schemas.microsoft.com/office/powerpoint/2010/main" val="196206519"/>
+        <p14:creationId xmlns:p14="http://schemas.microsoft.com/office/powerpoint/2010/main" val="1111915281"/>
       </p:ext>
     </p:extLst>
   </p:cSld>
@@ -12642,7 +12637,7 @@
           <p:cNvPr id="2" name="Rectangle 1">
             <a:extLst xmlns:a="http://schemas.openxmlformats.org/drawingml/2006/main">
               <a:ext uri="{FF2B5EF4-FFF2-40B4-BE49-F238E27FC236}">
-                <a16:creationId xmlns:a16="http://schemas.microsoft.com/office/drawing/2014/main" id="{92531751-03FD-4EFE-B94F-2834555A2C64}"/>
+                <a16:creationId xmlns:a16="http://schemas.microsoft.com/office/drawing/2014/main" id="{18F602CB-F031-4819-AE28-5441C23D0F7D}"/>
               </a:ext>
             </a:extLst>
           </p:cNvPr>
@@ -12695,7 +12690,7 @@
           <p:cNvPr id="3" name="Rectangle 2">
             <a:extLst xmlns:a="http://schemas.openxmlformats.org/drawingml/2006/main">
               <a:ext uri="{FF2B5EF4-FFF2-40B4-BE49-F238E27FC236}">
-                <a16:creationId xmlns:a16="http://schemas.microsoft.com/office/drawing/2014/main" id="{7BCDB3E6-6731-4AEC-B3FD-3F21354D6B93}"/>
+                <a16:creationId xmlns:a16="http://schemas.microsoft.com/office/drawing/2014/main" id="{73EDA1A5-C1B9-48EA-AF69-7E0F26FFA630}"/>
               </a:ext>
             </a:extLst>
           </p:cNvPr>
@@ -12748,7 +12743,7 @@
           <p:cNvPr id="4" name="Rectangle 3">
             <a:extLst xmlns:a="http://schemas.openxmlformats.org/drawingml/2006/main">
               <a:ext uri="{FF2B5EF4-FFF2-40B4-BE49-F238E27FC236}">
-                <a16:creationId xmlns:a16="http://schemas.microsoft.com/office/drawing/2014/main" id="{20D4F9AE-8432-4412-9CD9-6460E8B9E2ED}"/>
+                <a16:creationId xmlns:a16="http://schemas.microsoft.com/office/drawing/2014/main" id="{620725FD-78B2-4D16-9303-046F74F0CF44}"/>
               </a:ext>
             </a:extLst>
           </p:cNvPr>
@@ -12801,7 +12796,7 @@
           <p:cNvPr id="5" name="TextBox 4">
             <a:extLst xmlns:a="http://schemas.openxmlformats.org/drawingml/2006/main">
               <a:ext uri="{FF2B5EF4-FFF2-40B4-BE49-F238E27FC236}">
-                <a16:creationId xmlns:a16="http://schemas.microsoft.com/office/drawing/2014/main" id="{A452D14D-DED0-45F9-A573-0E45748C3830}"/>
+                <a16:creationId xmlns:a16="http://schemas.microsoft.com/office/drawing/2014/main" id="{89E998A8-7C90-48EC-96A2-E030D8B25078}"/>
               </a:ext>
             </a:extLst>
           </p:cNvPr>
@@ -12864,7 +12859,7 @@
           <p:cNvPr id="6" name="Rounded Rectangle 5">
             <a:extLst xmlns:a="http://schemas.openxmlformats.org/drawingml/2006/main">
               <a:ext uri="{FF2B5EF4-FFF2-40B4-BE49-F238E27FC236}">
-                <a16:creationId xmlns:a16="http://schemas.microsoft.com/office/drawing/2014/main" id="{D351161A-D771-4537-8987-98ACD66D49E9}"/>
+                <a16:creationId xmlns:a16="http://schemas.microsoft.com/office/drawing/2014/main" id="{8C6A5984-A1BB-44C9-9267-759D33B63E92}"/>
               </a:ext>
             </a:extLst>
           </p:cNvPr>
@@ -12919,7 +12914,7 @@
           <p:cNvPr id="7" name="TextBox 6">
             <a:extLst xmlns:a="http://schemas.openxmlformats.org/drawingml/2006/main">
               <a:ext uri="{FF2B5EF4-FFF2-40B4-BE49-F238E27FC236}">
-                <a16:creationId xmlns:a16="http://schemas.microsoft.com/office/drawing/2014/main" id="{BF024B9A-639A-42A4-866F-3548F17D6736}"/>
+                <a16:creationId xmlns:a16="http://schemas.microsoft.com/office/drawing/2014/main" id="{686C547B-E549-4D85-940E-E50C8003153F}"/>
               </a:ext>
             </a:extLst>
           </p:cNvPr>
@@ -12991,33 +12986,6 @@
                 <a:ea typeface="Calibri"/>
                 <a:cs typeface="Calibri"/>
               </a:rPr>
-              <a:t/>
-            </a:r>
-          </a:p>
-          <a:p xmlns:a="http://schemas.openxmlformats.org/drawingml/2006/main">
-            <a:pPr>
-              <a:spcBef>
-                <a:spcPts val="200"/>
-              </a:spcBef>
-              <a:buNone/>
-              <a:defRPr sz="1050">
-                <a:solidFill>
-                  <a:srgbClr val="0F172A"/>
-                </a:solidFill>
-                <a:latin typeface="Calibri"/>
-                <a:ea typeface="Calibri"/>
-                <a:cs typeface="Calibri"/>
-              </a:defRPr>
-            </a:pPr>
-            <a:r>
-              <a:rPr sz="825">
-                <a:solidFill>
-                  <a:srgbClr val="0F172A"/>
-                </a:solidFill>
-                <a:latin typeface="Calibri"/>
-                <a:ea typeface="Calibri"/>
-                <a:cs typeface="Calibri"/>
-              </a:rPr>
               <a:t>▶ ZONE 1: HISTORICAL DEV PILOT BASELINE (20 Requests Responses API)</a:t>
             </a:r>
           </a:p>
@@ -13099,7 +13067,7 @@
                 <a:ea typeface="Calibri"/>
                 <a:cs typeface="Calibri"/>
               </a:rPr>
-              <a:t/>
+              <a:t>▶ ZONE 2: DIAGNOSTIC TEST FIXTURE TELEMETRY (N=718 Scorable Views)</a:t>
             </a:r>
           </a:p>
           <a:p xmlns:a="http://schemas.openxmlformats.org/drawingml/2006/main">
@@ -13126,7 +13094,7 @@
                 <a:ea typeface="Calibri"/>
                 <a:cs typeface="Calibri"/>
               </a:rPr>
-              <a:t>▶ ZONE 2: DIAGNOSTIC TEST FIXTURE TELEMETRY (N=718 Scorable Views)</a:t>
+              <a:t>•  no_rag: trễ trung vị 7.89s (trung bình 2.90s) | 643.0 prompt tokens | ~0.000390 USD / logical req.</a:t>
             </a:r>
           </a:p>
           <a:p xmlns:a="http://schemas.openxmlformats.org/drawingml/2006/main">
@@ -13153,61 +13121,7 @@
                 <a:ea typeface="Calibri"/>
                 <a:cs typeface="Calibri"/>
               </a:rPr>
-              <a:t>•  no_rag: trễ trung vị 7.89s | 643.0 prompt tokens | ~0.000390 USD / logical req.</a:t>
-            </a:r>
-          </a:p>
-          <a:p xmlns:a="http://schemas.openxmlformats.org/drawingml/2006/main">
-            <a:pPr>
-              <a:spcBef>
-                <a:spcPts val="200"/>
-              </a:spcBef>
-              <a:buNone/>
-              <a:defRPr sz="1050">
-                <a:solidFill>
-                  <a:srgbClr val="0F172A"/>
-                </a:solidFill>
-                <a:latin typeface="Calibri"/>
-                <a:ea typeface="Calibri"/>
-                <a:cs typeface="Calibri"/>
-              </a:defRPr>
-            </a:pPr>
-            <a:r>
-              <a:rPr sz="825">
-                <a:solidFill>
-                  <a:srgbClr val="0F172A"/>
-                </a:solidFill>
-                <a:latin typeface="Calibri"/>
-                <a:ea typeface="Calibri"/>
-                <a:cs typeface="Calibri"/>
-              </a:rPr>
-              <a:t>•  rag_k10: trễ trung vị 9.90s | 4536.5 prompt tokens | ~0.001870 USD / logical req.</a:t>
-            </a:r>
-          </a:p>
-          <a:p xmlns:a="http://schemas.openxmlformats.org/drawingml/2006/main">
-            <a:pPr>
-              <a:spcBef>
-                <a:spcPts val="200"/>
-              </a:spcBef>
-              <a:buNone/>
-              <a:defRPr sz="1050">
-                <a:solidFill>
-                  <a:srgbClr val="0F172A"/>
-                </a:solidFill>
-                <a:latin typeface="Calibri"/>
-                <a:ea typeface="Calibri"/>
-                <a:cs typeface="Calibri"/>
-              </a:defRPr>
-            </a:pPr>
-            <a:r>
-              <a:rPr sz="825">
-                <a:solidFill>
-                  <a:srgbClr val="0F172A"/>
-                </a:solidFill>
-                <a:latin typeface="Calibri"/>
-                <a:ea typeface="Calibri"/>
-                <a:cs typeface="Calibri"/>
-              </a:rPr>
-              <a:t/>
+              <a:t>•  rag_k10: trễ trung vị 9.90s (trung bình 4.37s) | 4536.5 prompt tokens | ~0.001870 USD / logical req.</a:t>
             </a:r>
           </a:p>
           <a:p xmlns:a="http://schemas.openxmlformats.org/drawingml/2006/main">
@@ -13261,7 +13175,7 @@
                 <a:ea typeface="Calibri"/>
                 <a:cs typeface="Calibri"/>
               </a:rPr>
-              <a:t>•  Hạch toán toàn thể điều kiện chuẩn (Canonical Total): 8.50 USD (dự phóng ma trận 6,400 requests).</a:t>
+              <a:t>•  Hạch toán toàn thể điều kiện chuẩn (Canonical Total): 8.50 USD ($6.57575890 USD đã quyết toán).</a:t>
             </a:r>
           </a:p>
           <a:p xmlns:a="http://schemas.openxmlformats.org/drawingml/2006/main">
@@ -13315,7 +13229,34 @@
                 <a:ea typeface="Calibri"/>
                 <a:cs typeface="Calibri"/>
               </a:rPr>
-              <a:t>•  Ngân sách chưa cam kết còn lại (Net Remaining): 11.44 USD.</a:t>
+              <a:t>•  Tổng chi phí đã cam kết hạch toán: $6.63 USD ($6.62839900 USD total accounted spend).</a:t>
+            </a:r>
+          </a:p>
+          <a:p xmlns:a="http://schemas.openxmlformats.org/drawingml/2006/main">
+            <a:pPr>
+              <a:spcBef>
+                <a:spcPts val="200"/>
+              </a:spcBef>
+              <a:buNone/>
+              <a:defRPr sz="1050">
+                <a:solidFill>
+                  <a:srgbClr val="0F172A"/>
+                </a:solidFill>
+                <a:latin typeface="Calibri"/>
+                <a:ea typeface="Calibri"/>
+                <a:cs typeface="Calibri"/>
+              </a:defRPr>
+            </a:pPr>
+            <a:r>
+              <a:rPr sz="825">
+                <a:solidFill>
+                  <a:srgbClr val="0F172A"/>
+                </a:solidFill>
+                <a:latin typeface="Calibri"/>
+                <a:ea typeface="Calibri"/>
+                <a:cs typeface="Calibri"/>
+              </a:rPr>
+              <a:t>•  Ngân sách chưa cam kết còn lại (Net Remaining): 11.44 USD ($13.36160100 USD khả dụng).</a:t>
             </a:r>
           </a:p>
           <a:p xmlns:a="http://schemas.openxmlformats.org/drawingml/2006/main">
@@ -13356,7 +13297,7 @@
           <p:nvPr/>
         </p:nvPicPr>
         <p:blipFill>
-          <a:blip xmlns:r="http://schemas.openxmlformats.org/officeDocument/2006/relationships" xmlns:a="http://schemas.openxmlformats.org/drawingml/2006/main" r:embed="R3294023274504ede"/>
+          <a:blip xmlns:r="http://schemas.openxmlformats.org/officeDocument/2006/relationships" xmlns:a="http://schemas.openxmlformats.org/drawingml/2006/main" r:embed="R4c8c88d642e4400a"/>
           <a:stretch xmlns:a="http://schemas.openxmlformats.org/drawingml/2006/main">
             <a:fillRect l="0" t="0" r="0" b="0"/>
           </a:stretch>
@@ -13376,7 +13317,7 @@
           <p:cNvPr id="9" name="Rounded Rectangle 8">
             <a:extLst xmlns:a="http://schemas.openxmlformats.org/drawingml/2006/main">
               <a:ext uri="{FF2B5EF4-FFF2-40B4-BE49-F238E27FC236}">
-                <a16:creationId xmlns:a16="http://schemas.microsoft.com/office/drawing/2014/main" id="{919AC1F1-15AD-437A-816A-8FF2C21A7D5E}"/>
+                <a16:creationId xmlns:a16="http://schemas.microsoft.com/office/drawing/2014/main" id="{E1BFE4F3-AD8D-4191-9B75-D40A2541EFF4}"/>
               </a:ext>
             </a:extLst>
           </p:cNvPr>
@@ -13431,7 +13372,7 @@
           <p:cNvPr id="10" name="TextBox 9">
             <a:extLst xmlns:a="http://schemas.openxmlformats.org/drawingml/2006/main">
               <a:ext uri="{FF2B5EF4-FFF2-40B4-BE49-F238E27FC236}">
-                <a16:creationId xmlns:a16="http://schemas.microsoft.com/office/drawing/2014/main" id="{3A1128B3-9AE8-476B-99FA-544C3534B638}"/>
+                <a16:creationId xmlns:a16="http://schemas.microsoft.com/office/drawing/2014/main" id="{9733DE2B-7BCD-4C05-B427-50651CB6CCF8}"/>
               </a:ext>
             </a:extLst>
           </p:cNvPr>
@@ -13514,7 +13455,7 @@
     </p:spTree>
     <p:extLst>
       <p:ext uri="{BB962C8B-B14F-4D97-AF65-F5344CB8AC3E}">
-        <p14:creationId xmlns:p14="http://schemas.microsoft.com/office/powerpoint/2010/main" val="945164180"/>
+        <p14:creationId xmlns:p14="http://schemas.microsoft.com/office/powerpoint/2010/main" val="945939330"/>
       </p:ext>
     </p:extLst>
   </p:cSld>

</xml_diff>

<commit_message>
fix(presentation): implement root reviewer second visual review repairs on slides 6-10
</commit_message>
<xml_diff>
--- a/reports/evidence/fixture_populated_slides.pptx
+++ b/reports/evidence/fixture_populated_slides.pptx
@@ -2,24 +2,24 @@
 <file path=ppt/presentation.xml><?xml version="1.0" encoding="utf-8"?>
 <p:presentation xmlns:p="http://schemas.openxmlformats.org/presentationml/2006/main">
   <p:sldMasterIdLst>
-    <p:sldMasterId xmlns:r="http://schemas.openxmlformats.org/officeDocument/2006/relationships" id="2147483648" r:id="R06eba26b0031408b"/>
+    <p:sldMasterId xmlns:r="http://schemas.openxmlformats.org/officeDocument/2006/relationships" id="2147483648" r:id="Rdd95dc7191174d01"/>
   </p:sldMasterIdLst>
   <p:notesMasterIdLst>
-    <p:notesMasterId xmlns:r="http://schemas.openxmlformats.org/officeDocument/2006/relationships" r:id="Rd0676eb2cbdd4624"/>
+    <p:notesMasterId xmlns:r="http://schemas.openxmlformats.org/officeDocument/2006/relationships" r:id="R5a1c45a77eed4a58"/>
   </p:notesMasterIdLst>
   <p:sldIdLst>
-    <p:sldId xmlns:r="http://schemas.openxmlformats.org/officeDocument/2006/relationships" id="256" r:id="R704dc800342a4958"/>
-    <p:sldId xmlns:r="http://schemas.openxmlformats.org/officeDocument/2006/relationships" id="257" r:id="Rec9c0df903a74190"/>
-    <p:sldId xmlns:r="http://schemas.openxmlformats.org/officeDocument/2006/relationships" id="258" r:id="R022b2cef642e496b"/>
-    <p:sldId xmlns:r="http://schemas.openxmlformats.org/officeDocument/2006/relationships" id="259" r:id="R2d6bcd37c10d40ee"/>
-    <p:sldId xmlns:r="http://schemas.openxmlformats.org/officeDocument/2006/relationships" id="260" r:id="R003d1749a3b94a10"/>
-    <p:sldId xmlns:r="http://schemas.openxmlformats.org/officeDocument/2006/relationships" id="261" r:id="Rb2d35a6f21314d86"/>
-    <p:sldId xmlns:r="http://schemas.openxmlformats.org/officeDocument/2006/relationships" id="262" r:id="R19647c8cc8d343bd"/>
-    <p:sldId xmlns:r="http://schemas.openxmlformats.org/officeDocument/2006/relationships" id="263" r:id="Re13eaf99b8054685"/>
-    <p:sldId xmlns:r="http://schemas.openxmlformats.org/officeDocument/2006/relationships" id="264" r:id="R73f99c8719e849f2"/>
-    <p:sldId xmlns:r="http://schemas.openxmlformats.org/officeDocument/2006/relationships" id="265" r:id="R87ca236a34b74c7e"/>
-    <p:sldId xmlns:r="http://schemas.openxmlformats.org/officeDocument/2006/relationships" id="266" r:id="Rdd16690946ed4743"/>
-    <p:sldId xmlns:r="http://schemas.openxmlformats.org/officeDocument/2006/relationships" id="267" r:id="Ra1bfd998b5994d42"/>
+    <p:sldId xmlns:r="http://schemas.openxmlformats.org/officeDocument/2006/relationships" id="256" r:id="R5383c821915e4eb8"/>
+    <p:sldId xmlns:r="http://schemas.openxmlformats.org/officeDocument/2006/relationships" id="257" r:id="R4e5bd8b8396e42d0"/>
+    <p:sldId xmlns:r="http://schemas.openxmlformats.org/officeDocument/2006/relationships" id="258" r:id="R8764f93c7c294f95"/>
+    <p:sldId xmlns:r="http://schemas.openxmlformats.org/officeDocument/2006/relationships" id="259" r:id="R5cc3db0f429048e5"/>
+    <p:sldId xmlns:r="http://schemas.openxmlformats.org/officeDocument/2006/relationships" id="260" r:id="R86eac21e4ecd4e0d"/>
+    <p:sldId xmlns:r="http://schemas.openxmlformats.org/officeDocument/2006/relationships" id="261" r:id="Rc2bacc070ce54099"/>
+    <p:sldId xmlns:r="http://schemas.openxmlformats.org/officeDocument/2006/relationships" id="262" r:id="Re67d261329534aa4"/>
+    <p:sldId xmlns:r="http://schemas.openxmlformats.org/officeDocument/2006/relationships" id="263" r:id="Rab5461ca5b8f47ea"/>
+    <p:sldId xmlns:r="http://schemas.openxmlformats.org/officeDocument/2006/relationships" id="264" r:id="R7b368c83b7fc4be9"/>
+    <p:sldId xmlns:r="http://schemas.openxmlformats.org/officeDocument/2006/relationships" id="265" r:id="R06eb641dd8054a70"/>
+    <p:sldId xmlns:r="http://schemas.openxmlformats.org/officeDocument/2006/relationships" id="266" r:id="R21b8d656587545f7"/>
+    <p:sldId xmlns:r="http://schemas.openxmlformats.org/officeDocument/2006/relationships" id="267" r:id="Rd304273cf0f84554"/>
   </p:sldIdLst>
   <p:sldSz cx="12191695" cy="6858000"/>
   <p:notesSz cx="6858000" cy="9144000"/>
@@ -1473,7 +1473,7 @@
           <p:cNvPr id="2" name="Title 1">
             <a:extLst xmlns:a="http://schemas.openxmlformats.org/drawingml/2006/main">
               <a:ext uri="{FF2B5EF4-FFF2-40B4-BE49-F238E27FC236}">
-                <a16:creationId xmlns:a16="http://schemas.microsoft.com/office/drawing/2014/main" id="{2C8F751D-BBB2-407F-B1FD-CBAA03D038A3}"/>
+                <a16:creationId xmlns:a16="http://schemas.microsoft.com/office/drawing/2014/main" id="{6D09D927-F6CC-4BAC-9C35-B874E18C513E}"/>
               </a:ext>
             </a:extLst>
           </p:cNvPr>
@@ -1506,7 +1506,7 @@
           <p:cNvPr id="3" name="Subtitle 2">
             <a:extLst xmlns:a="http://schemas.openxmlformats.org/drawingml/2006/main">
               <a:ext uri="{FF2B5EF4-FFF2-40B4-BE49-F238E27FC236}">
-                <a16:creationId xmlns:a16="http://schemas.microsoft.com/office/drawing/2014/main" id="{A41EDC47-C5D2-4863-BFC5-EF89B610870E}"/>
+                <a16:creationId xmlns:a16="http://schemas.microsoft.com/office/drawing/2014/main" id="{CFC2FE08-E5D5-4E8C-90AE-6EDD974A4ABB}"/>
               </a:ext>
             </a:extLst>
           </p:cNvPr>
@@ -1630,7 +1630,7 @@
           <p:cNvPr id="4" name="Date Placeholder 3">
             <a:extLst xmlns:a="http://schemas.openxmlformats.org/drawingml/2006/main">
               <a:ext uri="{FF2B5EF4-FFF2-40B4-BE49-F238E27FC236}">
-                <a16:creationId xmlns:a16="http://schemas.microsoft.com/office/drawing/2014/main" id="{A6E046C5-078F-4B7F-9529-ECB3469A2B75}"/>
+                <a16:creationId xmlns:a16="http://schemas.microsoft.com/office/drawing/2014/main" id="{71E6E9A4-EB64-4BFF-9A46-77FE6C57C8FB}"/>
               </a:ext>
             </a:extLst>
           </p:cNvPr>
@@ -1658,7 +1658,7 @@
           <p:cNvPr id="5" name="Footer Placeholder 4">
             <a:extLst xmlns:a="http://schemas.openxmlformats.org/drawingml/2006/main">
               <a:ext uri="{FF2B5EF4-FFF2-40B4-BE49-F238E27FC236}">
-                <a16:creationId xmlns:a16="http://schemas.microsoft.com/office/drawing/2014/main" id="{655D993E-1EA7-4FC2-B8B0-6CF8DF19FB1C}"/>
+                <a16:creationId xmlns:a16="http://schemas.microsoft.com/office/drawing/2014/main" id="{93FC53D0-AC80-40BA-93CE-39982E552B52}"/>
               </a:ext>
             </a:extLst>
           </p:cNvPr>
@@ -1683,7 +1683,7 @@
           <p:cNvPr id="6" name="Slide Number Placeholder 5">
             <a:extLst xmlns:a="http://schemas.openxmlformats.org/drawingml/2006/main">
               <a:ext uri="{FF2B5EF4-FFF2-40B4-BE49-F238E27FC236}">
-                <a16:creationId xmlns:a16="http://schemas.microsoft.com/office/drawing/2014/main" id="{11215D80-0CF2-49A8-96B2-579BD8C5870B}"/>
+                <a16:creationId xmlns:a16="http://schemas.microsoft.com/office/drawing/2014/main" id="{4726FCA9-8AD6-400A-8DFC-82D8A962D503}"/>
               </a:ext>
             </a:extLst>
           </p:cNvPr>
@@ -1728,7 +1728,7 @@
           <p:cNvPr id="2" name="Title 1">
             <a:extLst xmlns:a="http://schemas.openxmlformats.org/drawingml/2006/main">
               <a:ext uri="{FF2B5EF4-FFF2-40B4-BE49-F238E27FC236}">
-                <a16:creationId xmlns:a16="http://schemas.microsoft.com/office/drawing/2014/main" id="{181DC361-3EB9-4DFC-B7A3-A43468FD3349}"/>
+                <a16:creationId xmlns:a16="http://schemas.microsoft.com/office/drawing/2014/main" id="{27EAF28B-E2FB-4430-8248-05D0EE2F1FC5}"/>
               </a:ext>
             </a:extLst>
           </p:cNvPr>
@@ -1756,7 +1756,7 @@
           <p:cNvPr id="3" name="Vertical Text Placeholder 2">
             <a:extLst xmlns:a="http://schemas.openxmlformats.org/drawingml/2006/main">
               <a:ext uri="{FF2B5EF4-FFF2-40B4-BE49-F238E27FC236}">
-                <a16:creationId xmlns:a16="http://schemas.microsoft.com/office/drawing/2014/main" id="{F3CD5E12-99AA-4500-8A0A-53C7CB1972B6}"/>
+                <a16:creationId xmlns:a16="http://schemas.microsoft.com/office/drawing/2014/main" id="{A1C0B1BE-B7C7-4620-A449-3E65FE8DBEBF}"/>
               </a:ext>
             </a:extLst>
           </p:cNvPr>
@@ -1819,7 +1819,7 @@
           <p:cNvPr id="4" name="Date Placeholder 3">
             <a:extLst xmlns:a="http://schemas.openxmlformats.org/drawingml/2006/main">
               <a:ext uri="{FF2B5EF4-FFF2-40B4-BE49-F238E27FC236}">
-                <a16:creationId xmlns:a16="http://schemas.microsoft.com/office/drawing/2014/main" id="{C1DD2F1F-870A-470D-8834-8C5AACE752DB}"/>
+                <a16:creationId xmlns:a16="http://schemas.microsoft.com/office/drawing/2014/main" id="{073ABDA0-B94D-44FB-B514-06823C9F7932}"/>
               </a:ext>
             </a:extLst>
           </p:cNvPr>
@@ -1847,7 +1847,7 @@
           <p:cNvPr id="5" name="Footer Placeholder 4">
             <a:extLst xmlns:a="http://schemas.openxmlformats.org/drawingml/2006/main">
               <a:ext uri="{FF2B5EF4-FFF2-40B4-BE49-F238E27FC236}">
-                <a16:creationId xmlns:a16="http://schemas.microsoft.com/office/drawing/2014/main" id="{917A3C8E-8497-4A79-A94C-9B5ECFCDDBBE}"/>
+                <a16:creationId xmlns:a16="http://schemas.microsoft.com/office/drawing/2014/main" id="{678F8C91-2E93-4644-8E8D-1E9AE714A178}"/>
               </a:ext>
             </a:extLst>
           </p:cNvPr>
@@ -1872,7 +1872,7 @@
           <p:cNvPr id="6" name="Slide Number Placeholder 5">
             <a:extLst xmlns:a="http://schemas.openxmlformats.org/drawingml/2006/main">
               <a:ext uri="{FF2B5EF4-FFF2-40B4-BE49-F238E27FC236}">
-                <a16:creationId xmlns:a16="http://schemas.microsoft.com/office/drawing/2014/main" id="{EB0A56A6-F4BF-4CF9-953A-746C44187DBC}"/>
+                <a16:creationId xmlns:a16="http://schemas.microsoft.com/office/drawing/2014/main" id="{676E60A3-2BAE-4CB0-8C91-C8E7573B2822}"/>
               </a:ext>
             </a:extLst>
           </p:cNvPr>
@@ -1917,7 +1917,7 @@
           <p:cNvPr id="2" name="Vertical Title 1">
             <a:extLst xmlns:a="http://schemas.openxmlformats.org/drawingml/2006/main">
               <a:ext uri="{FF2B5EF4-FFF2-40B4-BE49-F238E27FC236}">
-                <a16:creationId xmlns:a16="http://schemas.microsoft.com/office/drawing/2014/main" id="{28224DAC-62F3-4762-8378-15C7EDCBE706}"/>
+                <a16:creationId xmlns:a16="http://schemas.microsoft.com/office/drawing/2014/main" id="{F332E357-F083-4599-836E-861EB3160CFB}"/>
               </a:ext>
             </a:extLst>
           </p:cNvPr>
@@ -1950,7 +1950,7 @@
           <p:cNvPr id="3" name="Vertical Text Placeholder 2">
             <a:extLst xmlns:a="http://schemas.openxmlformats.org/drawingml/2006/main">
               <a:ext uri="{FF2B5EF4-FFF2-40B4-BE49-F238E27FC236}">
-                <a16:creationId xmlns:a16="http://schemas.microsoft.com/office/drawing/2014/main" id="{A5ADFDD9-D561-4F75-AB72-3562AE206331}"/>
+                <a16:creationId xmlns:a16="http://schemas.microsoft.com/office/drawing/2014/main" id="{DA60EB22-B626-4DD5-B6C0-000EABCA6A09}"/>
               </a:ext>
             </a:extLst>
           </p:cNvPr>
@@ -2018,7 +2018,7 @@
           <p:cNvPr id="4" name="Date Placeholder 3">
             <a:extLst xmlns:a="http://schemas.openxmlformats.org/drawingml/2006/main">
               <a:ext uri="{FF2B5EF4-FFF2-40B4-BE49-F238E27FC236}">
-                <a16:creationId xmlns:a16="http://schemas.microsoft.com/office/drawing/2014/main" id="{371BFE7E-AB08-45A1-B2F2-8DD35A366ADA}"/>
+                <a16:creationId xmlns:a16="http://schemas.microsoft.com/office/drawing/2014/main" id="{D163D34B-F363-4BB7-8535-5A8543DD2BBE}"/>
               </a:ext>
             </a:extLst>
           </p:cNvPr>
@@ -2046,7 +2046,7 @@
           <p:cNvPr id="5" name="Footer Placeholder 4">
             <a:extLst xmlns:a="http://schemas.openxmlformats.org/drawingml/2006/main">
               <a:ext uri="{FF2B5EF4-FFF2-40B4-BE49-F238E27FC236}">
-                <a16:creationId xmlns:a16="http://schemas.microsoft.com/office/drawing/2014/main" id="{48663519-FEFF-4A74-8F73-208B88219EBF}"/>
+                <a16:creationId xmlns:a16="http://schemas.microsoft.com/office/drawing/2014/main" id="{D3836FCD-996D-403E-ACE7-D78247F8231C}"/>
               </a:ext>
             </a:extLst>
           </p:cNvPr>
@@ -2071,7 +2071,7 @@
           <p:cNvPr id="6" name="Slide Number Placeholder 5">
             <a:extLst xmlns:a="http://schemas.openxmlformats.org/drawingml/2006/main">
               <a:ext uri="{FF2B5EF4-FFF2-40B4-BE49-F238E27FC236}">
-                <a16:creationId xmlns:a16="http://schemas.microsoft.com/office/drawing/2014/main" id="{6E1FBDF5-15F5-4B61-A723-7D5A85AAD103}"/>
+                <a16:creationId xmlns:a16="http://schemas.microsoft.com/office/drawing/2014/main" id="{0828965B-FC0F-4303-9BE9-5AE71CC6C371}"/>
               </a:ext>
             </a:extLst>
           </p:cNvPr>
@@ -2116,7 +2116,7 @@
           <p:cNvPr id="2" name="Title 1">
             <a:extLst xmlns:a="http://schemas.openxmlformats.org/drawingml/2006/main">
               <a:ext uri="{FF2B5EF4-FFF2-40B4-BE49-F238E27FC236}">
-                <a16:creationId xmlns:a16="http://schemas.microsoft.com/office/drawing/2014/main" id="{37E8CE7A-DA9A-4B9E-89AC-DB438A0D0428}"/>
+                <a16:creationId xmlns:a16="http://schemas.microsoft.com/office/drawing/2014/main" id="{C3D6128A-63A5-4AFB-835C-9DCAC055BC9B}"/>
               </a:ext>
             </a:extLst>
           </p:cNvPr>
@@ -2144,7 +2144,7 @@
           <p:cNvPr id="3" name="Content Placeholder 2">
             <a:extLst xmlns:a="http://schemas.openxmlformats.org/drawingml/2006/main">
               <a:ext uri="{FF2B5EF4-FFF2-40B4-BE49-F238E27FC236}">
-                <a16:creationId xmlns:a16="http://schemas.microsoft.com/office/drawing/2014/main" id="{4CF6479E-383B-482E-A62A-76D127BB8B98}"/>
+                <a16:creationId xmlns:a16="http://schemas.microsoft.com/office/drawing/2014/main" id="{BF9F3DBD-DE68-42D5-B3E8-314F2FA3407B}"/>
               </a:ext>
             </a:extLst>
           </p:cNvPr>
@@ -2207,7 +2207,7 @@
           <p:cNvPr id="4" name="Date Placeholder 3">
             <a:extLst xmlns:a="http://schemas.openxmlformats.org/drawingml/2006/main">
               <a:ext uri="{FF2B5EF4-FFF2-40B4-BE49-F238E27FC236}">
-                <a16:creationId xmlns:a16="http://schemas.microsoft.com/office/drawing/2014/main" id="{B45CEB87-92A5-40BF-ABE9-EEAB6220245D}"/>
+                <a16:creationId xmlns:a16="http://schemas.microsoft.com/office/drawing/2014/main" id="{CCAB7E4D-A8F3-4F74-A78C-EDC5F525F0E1}"/>
               </a:ext>
             </a:extLst>
           </p:cNvPr>
@@ -2235,7 +2235,7 @@
           <p:cNvPr id="5" name="Footer Placeholder 4">
             <a:extLst xmlns:a="http://schemas.openxmlformats.org/drawingml/2006/main">
               <a:ext uri="{FF2B5EF4-FFF2-40B4-BE49-F238E27FC236}">
-                <a16:creationId xmlns:a16="http://schemas.microsoft.com/office/drawing/2014/main" id="{3042404D-7491-49BE-80C0-345818BB2431}"/>
+                <a16:creationId xmlns:a16="http://schemas.microsoft.com/office/drawing/2014/main" id="{7F647F8F-B2EE-4E47-BA7A-51532E77C702}"/>
               </a:ext>
             </a:extLst>
           </p:cNvPr>
@@ -2260,7 +2260,7 @@
           <p:cNvPr id="6" name="Slide Number Placeholder 5">
             <a:extLst xmlns:a="http://schemas.openxmlformats.org/drawingml/2006/main">
               <a:ext uri="{FF2B5EF4-FFF2-40B4-BE49-F238E27FC236}">
-                <a16:creationId xmlns:a16="http://schemas.microsoft.com/office/drawing/2014/main" id="{9B868759-DABF-49D1-A7B8-B0ED988F2125}"/>
+                <a16:creationId xmlns:a16="http://schemas.microsoft.com/office/drawing/2014/main" id="{D8025B27-0428-408E-A7F4-D5A82F2283BA}"/>
               </a:ext>
             </a:extLst>
           </p:cNvPr>
@@ -2305,7 +2305,7 @@
           <p:cNvPr id="2" name="Title 1">
             <a:extLst xmlns:a="http://schemas.openxmlformats.org/drawingml/2006/main">
               <a:ext uri="{FF2B5EF4-FFF2-40B4-BE49-F238E27FC236}">
-                <a16:creationId xmlns:a16="http://schemas.microsoft.com/office/drawing/2014/main" id="{DEE90E17-3199-4FCF-A4C2-65C193705046}"/>
+                <a16:creationId xmlns:a16="http://schemas.microsoft.com/office/drawing/2014/main" id="{FB752766-9EEB-4F73-977C-CCEF04891969}"/>
               </a:ext>
             </a:extLst>
           </p:cNvPr>
@@ -2343,7 +2343,7 @@
           <p:cNvPr id="3" name="Text Placeholder 2">
             <a:extLst xmlns:a="http://schemas.openxmlformats.org/drawingml/2006/main">
               <a:ext uri="{FF2B5EF4-FFF2-40B4-BE49-F238E27FC236}">
-                <a16:creationId xmlns:a16="http://schemas.microsoft.com/office/drawing/2014/main" id="{92058563-B747-402A-BCA6-2F991666BD6E}"/>
+                <a16:creationId xmlns:a16="http://schemas.microsoft.com/office/drawing/2014/main" id="{651A21AC-E8EF-418B-A6C7-E40642C66F4B}"/>
               </a:ext>
             </a:extLst>
           </p:cNvPr>
@@ -2469,7 +2469,7 @@
           <p:cNvPr id="4" name="Date Placeholder 3">
             <a:extLst xmlns:a="http://schemas.openxmlformats.org/drawingml/2006/main">
               <a:ext uri="{FF2B5EF4-FFF2-40B4-BE49-F238E27FC236}">
-                <a16:creationId xmlns:a16="http://schemas.microsoft.com/office/drawing/2014/main" id="{3E101C9D-47E2-4F2C-A46E-EED1D3B7BDDC}"/>
+                <a16:creationId xmlns:a16="http://schemas.microsoft.com/office/drawing/2014/main" id="{66A9DA65-A784-469F-94B5-5E0804353FF2}"/>
               </a:ext>
             </a:extLst>
           </p:cNvPr>
@@ -2497,7 +2497,7 @@
           <p:cNvPr id="5" name="Footer Placeholder 4">
             <a:extLst xmlns:a="http://schemas.openxmlformats.org/drawingml/2006/main">
               <a:ext uri="{FF2B5EF4-FFF2-40B4-BE49-F238E27FC236}">
-                <a16:creationId xmlns:a16="http://schemas.microsoft.com/office/drawing/2014/main" id="{3A53D8F0-9846-4E1C-BC15-38A6F70918EC}"/>
+                <a16:creationId xmlns:a16="http://schemas.microsoft.com/office/drawing/2014/main" id="{E876F281-0F56-43AE-A25F-96B668616876}"/>
               </a:ext>
             </a:extLst>
           </p:cNvPr>
@@ -2522,7 +2522,7 @@
           <p:cNvPr id="6" name="Slide Number Placeholder 5">
             <a:extLst xmlns:a="http://schemas.openxmlformats.org/drawingml/2006/main">
               <a:ext uri="{FF2B5EF4-FFF2-40B4-BE49-F238E27FC236}">
-                <a16:creationId xmlns:a16="http://schemas.microsoft.com/office/drawing/2014/main" id="{F31A51A3-BDB9-4212-9B4A-002248452C9D}"/>
+                <a16:creationId xmlns:a16="http://schemas.microsoft.com/office/drawing/2014/main" id="{098D2D50-4CDC-46B8-9855-A514CDFF5C02}"/>
               </a:ext>
             </a:extLst>
           </p:cNvPr>
@@ -2567,7 +2567,7 @@
           <p:cNvPr id="2" name="Title 1">
             <a:extLst xmlns:a="http://schemas.openxmlformats.org/drawingml/2006/main">
               <a:ext uri="{FF2B5EF4-FFF2-40B4-BE49-F238E27FC236}">
-                <a16:creationId xmlns:a16="http://schemas.microsoft.com/office/drawing/2014/main" id="{1C2FF34F-7673-4DCF-AAA9-B8B0C95FBD99}"/>
+                <a16:creationId xmlns:a16="http://schemas.microsoft.com/office/drawing/2014/main" id="{64799438-55D5-4A51-95EB-3DB14056BC4F}"/>
               </a:ext>
             </a:extLst>
           </p:cNvPr>
@@ -2595,7 +2595,7 @@
           <p:cNvPr id="3" name="Content Placeholder 2">
             <a:extLst xmlns:a="http://schemas.openxmlformats.org/drawingml/2006/main">
               <a:ext uri="{FF2B5EF4-FFF2-40B4-BE49-F238E27FC236}">
-                <a16:creationId xmlns:a16="http://schemas.microsoft.com/office/drawing/2014/main" id="{7DC212B9-653F-46E8-92A4-92413D7BF0C4}"/>
+                <a16:creationId xmlns:a16="http://schemas.microsoft.com/office/drawing/2014/main" id="{E93C7818-1A15-4BEC-8EFE-2A06F8BB599B}"/>
               </a:ext>
             </a:extLst>
           </p:cNvPr>
@@ -2700,7 +2700,7 @@
           <p:cNvPr id="4" name="Content Placeholder 3">
             <a:extLst xmlns:a="http://schemas.openxmlformats.org/drawingml/2006/main">
               <a:ext uri="{FF2B5EF4-FFF2-40B4-BE49-F238E27FC236}">
-                <a16:creationId xmlns:a16="http://schemas.microsoft.com/office/drawing/2014/main" id="{3EA4E581-8B32-4056-BE10-EB7E9F4D7181}"/>
+                <a16:creationId xmlns:a16="http://schemas.microsoft.com/office/drawing/2014/main" id="{8C81FBC7-EEE2-4B12-B751-7CF228446BFE}"/>
               </a:ext>
             </a:extLst>
           </p:cNvPr>
@@ -2805,7 +2805,7 @@
           <p:cNvPr id="5" name="Date Placeholder 4">
             <a:extLst xmlns:a="http://schemas.openxmlformats.org/drawingml/2006/main">
               <a:ext uri="{FF2B5EF4-FFF2-40B4-BE49-F238E27FC236}">
-                <a16:creationId xmlns:a16="http://schemas.microsoft.com/office/drawing/2014/main" id="{89AB1CFD-E660-4B01-8C73-27085C9C76B2}"/>
+                <a16:creationId xmlns:a16="http://schemas.microsoft.com/office/drawing/2014/main" id="{239E2E21-1FDB-44D0-8DC6-0376FFBDA272}"/>
               </a:ext>
             </a:extLst>
           </p:cNvPr>
@@ -2833,7 +2833,7 @@
           <p:cNvPr id="6" name="Footer Placeholder 5">
             <a:extLst xmlns:a="http://schemas.openxmlformats.org/drawingml/2006/main">
               <a:ext uri="{FF2B5EF4-FFF2-40B4-BE49-F238E27FC236}">
-                <a16:creationId xmlns:a16="http://schemas.microsoft.com/office/drawing/2014/main" id="{B3714E9B-EE8B-4599-AB1D-3C7052A04DEC}"/>
+                <a16:creationId xmlns:a16="http://schemas.microsoft.com/office/drawing/2014/main" id="{9A28128A-6406-43FF-B760-389309337F43}"/>
               </a:ext>
             </a:extLst>
           </p:cNvPr>
@@ -2858,7 +2858,7 @@
           <p:cNvPr id="7" name="Slide Number Placeholder 6">
             <a:extLst xmlns:a="http://schemas.openxmlformats.org/drawingml/2006/main">
               <a:ext uri="{FF2B5EF4-FFF2-40B4-BE49-F238E27FC236}">
-                <a16:creationId xmlns:a16="http://schemas.microsoft.com/office/drawing/2014/main" id="{255086E7-D67C-419C-ABE2-E372679E9FF3}"/>
+                <a16:creationId xmlns:a16="http://schemas.microsoft.com/office/drawing/2014/main" id="{B270A717-E884-4054-8330-C2C5EC76F7F1}"/>
               </a:ext>
             </a:extLst>
           </p:cNvPr>
@@ -2903,7 +2903,7 @@
           <p:cNvPr id="2" name="Title 1">
             <a:extLst xmlns:a="http://schemas.openxmlformats.org/drawingml/2006/main">
               <a:ext uri="{FF2B5EF4-FFF2-40B4-BE49-F238E27FC236}">
-                <a16:creationId xmlns:a16="http://schemas.microsoft.com/office/drawing/2014/main" id="{F0E4D588-BD69-47F6-ABD4-8BEE5B9BA74C}"/>
+                <a16:creationId xmlns:a16="http://schemas.microsoft.com/office/drawing/2014/main" id="{24845E40-C47D-4002-8157-D443930EBE5C}"/>
               </a:ext>
             </a:extLst>
           </p:cNvPr>
@@ -2936,7 +2936,7 @@
           <p:cNvPr id="3" name="Text Placeholder 2">
             <a:extLst xmlns:a="http://schemas.openxmlformats.org/drawingml/2006/main">
               <a:ext uri="{FF2B5EF4-FFF2-40B4-BE49-F238E27FC236}">
-                <a16:creationId xmlns:a16="http://schemas.microsoft.com/office/drawing/2014/main" id="{B297218F-67C7-4B7C-B67E-9AB1A825F7C0}"/>
+                <a16:creationId xmlns:a16="http://schemas.microsoft.com/office/drawing/2014/main" id="{1E96EFB5-1B8E-4342-9691-0C62C7C2D9B5}"/>
               </a:ext>
             </a:extLst>
           </p:cNvPr>
@@ -3008,7 +3008,7 @@
           <p:cNvPr id="4" name="Content Placeholder 3">
             <a:extLst xmlns:a="http://schemas.openxmlformats.org/drawingml/2006/main">
               <a:ext uri="{FF2B5EF4-FFF2-40B4-BE49-F238E27FC236}">
-                <a16:creationId xmlns:a16="http://schemas.microsoft.com/office/drawing/2014/main" id="{3089D3EC-1884-47F1-A255-C7FD724F0422}"/>
+                <a16:creationId xmlns:a16="http://schemas.microsoft.com/office/drawing/2014/main" id="{464CD47F-290F-4FF4-9E4C-4151EB68E7CA}"/>
               </a:ext>
             </a:extLst>
           </p:cNvPr>
@@ -3113,7 +3113,7 @@
           <p:cNvPr id="5" name="Text Placeholder 4">
             <a:extLst xmlns:a="http://schemas.openxmlformats.org/drawingml/2006/main">
               <a:ext uri="{FF2B5EF4-FFF2-40B4-BE49-F238E27FC236}">
-                <a16:creationId xmlns:a16="http://schemas.microsoft.com/office/drawing/2014/main" id="{89DB6414-37CA-44BA-BA37-11A5B016D66E}"/>
+                <a16:creationId xmlns:a16="http://schemas.microsoft.com/office/drawing/2014/main" id="{F14706D8-5331-49DD-9CCB-0A9E11E2076D}"/>
               </a:ext>
             </a:extLst>
           </p:cNvPr>
@@ -3185,7 +3185,7 @@
           <p:cNvPr id="6" name="Content Placeholder 5">
             <a:extLst xmlns:a="http://schemas.openxmlformats.org/drawingml/2006/main">
               <a:ext uri="{FF2B5EF4-FFF2-40B4-BE49-F238E27FC236}">
-                <a16:creationId xmlns:a16="http://schemas.microsoft.com/office/drawing/2014/main" id="{95C5D29B-016B-4106-8D53-B935089BC914}"/>
+                <a16:creationId xmlns:a16="http://schemas.microsoft.com/office/drawing/2014/main" id="{784B49AB-52BC-4DBA-894B-516FB65D4E8F}"/>
               </a:ext>
             </a:extLst>
           </p:cNvPr>
@@ -3290,7 +3290,7 @@
           <p:cNvPr id="7" name="Date Placeholder 6">
             <a:extLst xmlns:a="http://schemas.openxmlformats.org/drawingml/2006/main">
               <a:ext uri="{FF2B5EF4-FFF2-40B4-BE49-F238E27FC236}">
-                <a16:creationId xmlns:a16="http://schemas.microsoft.com/office/drawing/2014/main" id="{CCEE5D68-BD6F-416D-8473-88B2D6D53C29}"/>
+                <a16:creationId xmlns:a16="http://schemas.microsoft.com/office/drawing/2014/main" id="{BC1A8D54-CF63-4822-9F7F-12B298680411}"/>
               </a:ext>
             </a:extLst>
           </p:cNvPr>
@@ -3318,7 +3318,7 @@
           <p:cNvPr id="8" name="Footer Placeholder 7">
             <a:extLst xmlns:a="http://schemas.openxmlformats.org/drawingml/2006/main">
               <a:ext uri="{FF2B5EF4-FFF2-40B4-BE49-F238E27FC236}">
-                <a16:creationId xmlns:a16="http://schemas.microsoft.com/office/drawing/2014/main" id="{79B63406-747C-44C2-8601-DFDF45A89E13}"/>
+                <a16:creationId xmlns:a16="http://schemas.microsoft.com/office/drawing/2014/main" id="{79BE4C40-6D7C-4D98-AD66-8B8FFD3E699B}"/>
               </a:ext>
             </a:extLst>
           </p:cNvPr>
@@ -3343,7 +3343,7 @@
           <p:cNvPr id="9" name="Slide Number Placeholder 8">
             <a:extLst xmlns:a="http://schemas.openxmlformats.org/drawingml/2006/main">
               <a:ext uri="{FF2B5EF4-FFF2-40B4-BE49-F238E27FC236}">
-                <a16:creationId xmlns:a16="http://schemas.microsoft.com/office/drawing/2014/main" id="{9BFF0A29-A7C5-496E-A8A3-B27768949171}"/>
+                <a16:creationId xmlns:a16="http://schemas.microsoft.com/office/drawing/2014/main" id="{9F3E7F25-807D-4EB7-BC2E-3549B9EEF0FE}"/>
               </a:ext>
             </a:extLst>
           </p:cNvPr>
@@ -3388,7 +3388,7 @@
           <p:cNvPr id="2" name="Title 1">
             <a:extLst xmlns:a="http://schemas.openxmlformats.org/drawingml/2006/main">
               <a:ext uri="{FF2B5EF4-FFF2-40B4-BE49-F238E27FC236}">
-                <a16:creationId xmlns:a16="http://schemas.microsoft.com/office/drawing/2014/main" id="{130F96E5-F900-4428-8A54-6392AF101EF3}"/>
+                <a16:creationId xmlns:a16="http://schemas.microsoft.com/office/drawing/2014/main" id="{E5EB5881-B954-42DF-8F6E-B662D0856A5A}"/>
               </a:ext>
             </a:extLst>
           </p:cNvPr>
@@ -3416,7 +3416,7 @@
           <p:cNvPr id="3" name="Date Placeholder 2">
             <a:extLst xmlns:a="http://schemas.openxmlformats.org/drawingml/2006/main">
               <a:ext uri="{FF2B5EF4-FFF2-40B4-BE49-F238E27FC236}">
-                <a16:creationId xmlns:a16="http://schemas.microsoft.com/office/drawing/2014/main" id="{387ECDB1-7477-4F83-802E-CA3CC066BAFB}"/>
+                <a16:creationId xmlns:a16="http://schemas.microsoft.com/office/drawing/2014/main" id="{0635A201-5DBC-4CB3-8A1C-7C82DCB78A5B}"/>
               </a:ext>
             </a:extLst>
           </p:cNvPr>
@@ -3444,7 +3444,7 @@
           <p:cNvPr id="4" name="Footer Placeholder 3">
             <a:extLst xmlns:a="http://schemas.openxmlformats.org/drawingml/2006/main">
               <a:ext uri="{FF2B5EF4-FFF2-40B4-BE49-F238E27FC236}">
-                <a16:creationId xmlns:a16="http://schemas.microsoft.com/office/drawing/2014/main" id="{41703CA0-7099-4640-BB38-9409F3E2C5E7}"/>
+                <a16:creationId xmlns:a16="http://schemas.microsoft.com/office/drawing/2014/main" id="{3C64F76B-3451-4CD5-9066-4DAB686419AF}"/>
               </a:ext>
             </a:extLst>
           </p:cNvPr>
@@ -3469,7 +3469,7 @@
           <p:cNvPr id="5" name="Slide Number Placeholder 4">
             <a:extLst xmlns:a="http://schemas.openxmlformats.org/drawingml/2006/main">
               <a:ext uri="{FF2B5EF4-FFF2-40B4-BE49-F238E27FC236}">
-                <a16:creationId xmlns:a16="http://schemas.microsoft.com/office/drawing/2014/main" id="{ECB1152E-4A10-4DEC-8608-3DA1651174D1}"/>
+                <a16:creationId xmlns:a16="http://schemas.microsoft.com/office/drawing/2014/main" id="{915B899A-ED0B-4C7F-A5D0-C72DC37F9B72}"/>
               </a:ext>
             </a:extLst>
           </p:cNvPr>
@@ -3514,7 +3514,7 @@
           <p:cNvPr id="2" name="Date Placeholder 1">
             <a:extLst xmlns:a="http://schemas.openxmlformats.org/drawingml/2006/main">
               <a:ext uri="{FF2B5EF4-FFF2-40B4-BE49-F238E27FC236}">
-                <a16:creationId xmlns:a16="http://schemas.microsoft.com/office/drawing/2014/main" id="{BBAB21BA-8A95-4FB9-A46D-12FC4F7BA617}"/>
+                <a16:creationId xmlns:a16="http://schemas.microsoft.com/office/drawing/2014/main" id="{82356100-759E-45A1-B2CA-7421D316EEFC}"/>
               </a:ext>
             </a:extLst>
           </p:cNvPr>
@@ -3542,7 +3542,7 @@
           <p:cNvPr id="3" name="Footer Placeholder 2">
             <a:extLst xmlns:a="http://schemas.openxmlformats.org/drawingml/2006/main">
               <a:ext uri="{FF2B5EF4-FFF2-40B4-BE49-F238E27FC236}">
-                <a16:creationId xmlns:a16="http://schemas.microsoft.com/office/drawing/2014/main" id="{D7D21B4C-7BB0-4AF9-93AB-9DFA802CE4EE}"/>
+                <a16:creationId xmlns:a16="http://schemas.microsoft.com/office/drawing/2014/main" id="{978ECD1F-09DD-478D-ACF5-CE24D0BE0E13}"/>
               </a:ext>
             </a:extLst>
           </p:cNvPr>
@@ -3567,7 +3567,7 @@
           <p:cNvPr id="4" name="Slide Number Placeholder 3">
             <a:extLst xmlns:a="http://schemas.openxmlformats.org/drawingml/2006/main">
               <a:ext uri="{FF2B5EF4-FFF2-40B4-BE49-F238E27FC236}">
-                <a16:creationId xmlns:a16="http://schemas.microsoft.com/office/drawing/2014/main" id="{6A349349-C1E9-4C1E-86AB-E56695D8A4E9}"/>
+                <a16:creationId xmlns:a16="http://schemas.microsoft.com/office/drawing/2014/main" id="{193D24A5-AB28-4728-ACA8-8D5BD7146EB7}"/>
               </a:ext>
             </a:extLst>
           </p:cNvPr>
@@ -3612,7 +3612,7 @@
           <p:cNvPr id="2" name="Title 1">
             <a:extLst xmlns:a="http://schemas.openxmlformats.org/drawingml/2006/main">
               <a:ext uri="{FF2B5EF4-FFF2-40B4-BE49-F238E27FC236}">
-                <a16:creationId xmlns:a16="http://schemas.microsoft.com/office/drawing/2014/main" id="{FA6A7671-8756-4800-8E01-AADD36335372}"/>
+                <a16:creationId xmlns:a16="http://schemas.microsoft.com/office/drawing/2014/main" id="{4D890F7C-87DE-4AB2-93B2-F3FA48F5AABE}"/>
               </a:ext>
             </a:extLst>
           </p:cNvPr>
@@ -3650,7 +3650,7 @@
           <p:cNvPr id="3" name="Content Placeholder 2">
             <a:extLst xmlns:a="http://schemas.openxmlformats.org/drawingml/2006/main">
               <a:ext uri="{FF2B5EF4-FFF2-40B4-BE49-F238E27FC236}">
-                <a16:creationId xmlns:a16="http://schemas.microsoft.com/office/drawing/2014/main" id="{CAD9FF2A-5D4D-4A7A-9894-64FB999114C3}"/>
+                <a16:creationId xmlns:a16="http://schemas.microsoft.com/office/drawing/2014/main" id="{E63DF2AE-272B-4407-B052-3452797DEB30}"/>
               </a:ext>
             </a:extLst>
           </p:cNvPr>
@@ -3755,7 +3755,7 @@
           <p:cNvPr id="4" name="Text Placeholder 3">
             <a:extLst xmlns:a="http://schemas.openxmlformats.org/drawingml/2006/main">
               <a:ext uri="{FF2B5EF4-FFF2-40B4-BE49-F238E27FC236}">
-                <a16:creationId xmlns:a16="http://schemas.microsoft.com/office/drawing/2014/main" id="{2FB8BB5A-9E78-49A0-AC2A-24F36843D059}"/>
+                <a16:creationId xmlns:a16="http://schemas.microsoft.com/office/drawing/2014/main" id="{F3156436-06B9-4CBD-8A73-B4558BBADEEF}"/>
               </a:ext>
             </a:extLst>
           </p:cNvPr>
@@ -3827,7 +3827,7 @@
           <p:cNvPr id="5" name="Date Placeholder 4">
             <a:extLst xmlns:a="http://schemas.openxmlformats.org/drawingml/2006/main">
               <a:ext uri="{FF2B5EF4-FFF2-40B4-BE49-F238E27FC236}">
-                <a16:creationId xmlns:a16="http://schemas.microsoft.com/office/drawing/2014/main" id="{FCDAF836-5588-45C3-BDFF-BEE1AF7CDE27}"/>
+                <a16:creationId xmlns:a16="http://schemas.microsoft.com/office/drawing/2014/main" id="{B778FCE6-759D-40BA-ACB4-78FF175DD1BF}"/>
               </a:ext>
             </a:extLst>
           </p:cNvPr>
@@ -3855,7 +3855,7 @@
           <p:cNvPr id="6" name="Footer Placeholder 5">
             <a:extLst xmlns:a="http://schemas.openxmlformats.org/drawingml/2006/main">
               <a:ext uri="{FF2B5EF4-FFF2-40B4-BE49-F238E27FC236}">
-                <a16:creationId xmlns:a16="http://schemas.microsoft.com/office/drawing/2014/main" id="{BEFFCC83-4903-4412-8CCD-4A832A59B468}"/>
+                <a16:creationId xmlns:a16="http://schemas.microsoft.com/office/drawing/2014/main" id="{C54A3AC8-5E92-4986-B156-B84D6871588E}"/>
               </a:ext>
             </a:extLst>
           </p:cNvPr>
@@ -3880,7 +3880,7 @@
           <p:cNvPr id="7" name="Slide Number Placeholder 6">
             <a:extLst xmlns:a="http://schemas.openxmlformats.org/drawingml/2006/main">
               <a:ext uri="{FF2B5EF4-FFF2-40B4-BE49-F238E27FC236}">
-                <a16:creationId xmlns:a16="http://schemas.microsoft.com/office/drawing/2014/main" id="{661E2624-6953-4EC7-9410-957EFFF5FBC9}"/>
+                <a16:creationId xmlns:a16="http://schemas.microsoft.com/office/drawing/2014/main" id="{A50520FA-9EB4-47FE-BD19-46D2205E6D3E}"/>
               </a:ext>
             </a:extLst>
           </p:cNvPr>
@@ -3925,7 +3925,7 @@
           <p:cNvPr id="2" name="Title 1">
             <a:extLst xmlns:a="http://schemas.openxmlformats.org/drawingml/2006/main">
               <a:ext uri="{FF2B5EF4-FFF2-40B4-BE49-F238E27FC236}">
-                <a16:creationId xmlns:a16="http://schemas.microsoft.com/office/drawing/2014/main" id="{1B7D63E4-1411-473D-9E6E-F1D452D8AADD}"/>
+                <a16:creationId xmlns:a16="http://schemas.microsoft.com/office/drawing/2014/main" id="{DAA4E35C-D902-4FAE-B1A3-B604CB24A81D}"/>
               </a:ext>
             </a:extLst>
           </p:cNvPr>
@@ -3963,7 +3963,7 @@
           <p:cNvPr id="3" name="Picture Placeholder 2">
             <a:extLst xmlns:a="http://schemas.openxmlformats.org/drawingml/2006/main">
               <a:ext uri="{FF2B5EF4-FFF2-40B4-BE49-F238E27FC236}">
-                <a16:creationId xmlns:a16="http://schemas.microsoft.com/office/drawing/2014/main" id="{7EAB6995-F7E7-41D3-B689-F63DCCF82660}"/>
+                <a16:creationId xmlns:a16="http://schemas.microsoft.com/office/drawing/2014/main" id="{CFA20441-FC64-4A45-B50B-8B479B32CB72}"/>
               </a:ext>
             </a:extLst>
           </p:cNvPr>
@@ -4030,7 +4030,7 @@
           <p:cNvPr id="4" name="Text Placeholder 3">
             <a:extLst xmlns:a="http://schemas.openxmlformats.org/drawingml/2006/main">
               <a:ext uri="{FF2B5EF4-FFF2-40B4-BE49-F238E27FC236}">
-                <a16:creationId xmlns:a16="http://schemas.microsoft.com/office/drawing/2014/main" id="{83C3CBA3-B266-48D2-A196-2BFAA0629AEA}"/>
+                <a16:creationId xmlns:a16="http://schemas.microsoft.com/office/drawing/2014/main" id="{8CC31745-D231-49C6-BF66-B96B710BA85A}"/>
               </a:ext>
             </a:extLst>
           </p:cNvPr>
@@ -4102,7 +4102,7 @@
           <p:cNvPr id="5" name="Date Placeholder 4">
             <a:extLst xmlns:a="http://schemas.openxmlformats.org/drawingml/2006/main">
               <a:ext uri="{FF2B5EF4-FFF2-40B4-BE49-F238E27FC236}">
-                <a16:creationId xmlns:a16="http://schemas.microsoft.com/office/drawing/2014/main" id="{1C54076F-05CE-474A-B0AC-8FDA89324F1C}"/>
+                <a16:creationId xmlns:a16="http://schemas.microsoft.com/office/drawing/2014/main" id="{604D39A6-C1C9-4F2C-97A5-ACD98EAFBF53}"/>
               </a:ext>
             </a:extLst>
           </p:cNvPr>
@@ -4130,7 +4130,7 @@
           <p:cNvPr id="6" name="Footer Placeholder 5">
             <a:extLst xmlns:a="http://schemas.openxmlformats.org/drawingml/2006/main">
               <a:ext uri="{FF2B5EF4-FFF2-40B4-BE49-F238E27FC236}">
-                <a16:creationId xmlns:a16="http://schemas.microsoft.com/office/drawing/2014/main" id="{69BC192E-F55D-4F9B-A23D-85DA50C885B7}"/>
+                <a16:creationId xmlns:a16="http://schemas.microsoft.com/office/drawing/2014/main" id="{C4A1C3D5-107A-46E0-8EFC-A9811FC4251D}"/>
               </a:ext>
             </a:extLst>
           </p:cNvPr>
@@ -4155,7 +4155,7 @@
           <p:cNvPr id="7" name="Slide Number Placeholder 6">
             <a:extLst xmlns:a="http://schemas.openxmlformats.org/drawingml/2006/main">
               <a:ext uri="{FF2B5EF4-FFF2-40B4-BE49-F238E27FC236}">
-                <a16:creationId xmlns:a16="http://schemas.microsoft.com/office/drawing/2014/main" id="{5BDC5208-DF2B-4516-9167-57A3A8F8B05F}"/>
+                <a16:creationId xmlns:a16="http://schemas.microsoft.com/office/drawing/2014/main" id="{5F264B52-A755-4B58-B841-A242024DCC08}"/>
               </a:ext>
             </a:extLst>
           </p:cNvPr>
@@ -4205,7 +4205,7 @@
           <p:cNvPr id="2" name="Title Placeholder 1">
             <a:extLst xmlns:a="http://schemas.openxmlformats.org/drawingml/2006/main">
               <a:ext uri="{FF2B5EF4-FFF2-40B4-BE49-F238E27FC236}">
-                <a16:creationId xmlns:a16="http://schemas.microsoft.com/office/drawing/2014/main" id="{3EAFF71B-8044-4695-8543-9B8B138FCA6E}"/>
+                <a16:creationId xmlns:a16="http://schemas.microsoft.com/office/drawing/2014/main" id="{5DDE2631-86AA-42AA-829E-068F607F5DC3}"/>
               </a:ext>
             </a:extLst>
           </p:cNvPr>
@@ -4243,7 +4243,7 @@
           <p:cNvPr id="3" name="Text Placeholder 2">
             <a:extLst xmlns:a="http://schemas.openxmlformats.org/drawingml/2006/main">
               <a:ext uri="{FF2B5EF4-FFF2-40B4-BE49-F238E27FC236}">
-                <a16:creationId xmlns:a16="http://schemas.microsoft.com/office/drawing/2014/main" id="{49EC024A-D0DE-4773-868C-67B0D9C49467}"/>
+                <a16:creationId xmlns:a16="http://schemas.microsoft.com/office/drawing/2014/main" id="{6C078771-90E4-4616-A442-0995F09588A4}"/>
               </a:ext>
             </a:extLst>
           </p:cNvPr>
@@ -4316,7 +4316,7 @@
           <p:cNvPr id="4" name="Date Placeholder 3">
             <a:extLst xmlns:a="http://schemas.openxmlformats.org/drawingml/2006/main">
               <a:ext uri="{FF2B5EF4-FFF2-40B4-BE49-F238E27FC236}">
-                <a16:creationId xmlns:a16="http://schemas.microsoft.com/office/drawing/2014/main" id="{AB92BFDF-86C4-498B-95F8-40DE45BABF13}"/>
+                <a16:creationId xmlns:a16="http://schemas.microsoft.com/office/drawing/2014/main" id="{75C976F7-64CA-4588-A2A1-824724793A49}"/>
               </a:ext>
             </a:extLst>
           </p:cNvPr>
@@ -4363,7 +4363,7 @@
           <p:cNvPr id="5" name="Footer Placeholder 4">
             <a:extLst xmlns:a="http://schemas.openxmlformats.org/drawingml/2006/main">
               <a:ext uri="{FF2B5EF4-FFF2-40B4-BE49-F238E27FC236}">
-                <a16:creationId xmlns:a16="http://schemas.microsoft.com/office/drawing/2014/main" id="{5E162E8E-78AC-462B-B308-CF69977EE9FF}"/>
+                <a16:creationId xmlns:a16="http://schemas.microsoft.com/office/drawing/2014/main" id="{40875688-3438-4F26-9511-6DF107EA02FB}"/>
               </a:ext>
             </a:extLst>
           </p:cNvPr>
@@ -4407,7 +4407,7 @@
           <p:cNvPr id="6" name="Slide Number Placeholder 5">
             <a:extLst xmlns:a="http://schemas.openxmlformats.org/drawingml/2006/main">
               <a:ext uri="{FF2B5EF4-FFF2-40B4-BE49-F238E27FC236}">
-                <a16:creationId xmlns:a16="http://schemas.microsoft.com/office/drawing/2014/main" id="{B0312C0A-2F25-48EB-AD60-FD6A1F2B5222}"/>
+                <a16:creationId xmlns:a16="http://schemas.microsoft.com/office/drawing/2014/main" id="{88852BC9-8A34-45D2-B5A5-FB29C43DCC9A}"/>
               </a:ext>
             </a:extLst>
           </p:cNvPr>
@@ -4453,17 +4453,17 @@
   </p:cSld>
   <p:clrMap bg1="lt1" tx1="dk1" bg2="lt2" tx2="dk2" accent1="accent1" accent2="accent2" accent3="accent3" accent4="accent4" accent5="accent5" accent6="accent6" hlink="hlink" folHlink="folHlink"/>
   <p:sldLayoutIdLst>
-    <p:sldLayoutId xmlns:r="http://schemas.openxmlformats.org/officeDocument/2006/relationships" id="2147483649" r:id="Rf923f5e8061f481f"/>
-    <p:sldLayoutId xmlns:r="http://schemas.openxmlformats.org/officeDocument/2006/relationships" id="2147483650" r:id="Rf74b76f26cab4e1f"/>
-    <p:sldLayoutId xmlns:r="http://schemas.openxmlformats.org/officeDocument/2006/relationships" id="2147483651" r:id="R6d217f5fc6464349"/>
-    <p:sldLayoutId xmlns:r="http://schemas.openxmlformats.org/officeDocument/2006/relationships" id="2147483652" r:id="R40435e87adb146c3"/>
-    <p:sldLayoutId xmlns:r="http://schemas.openxmlformats.org/officeDocument/2006/relationships" id="2147483653" r:id="R9fdb2bdfddfc42bb"/>
-    <p:sldLayoutId xmlns:r="http://schemas.openxmlformats.org/officeDocument/2006/relationships" id="2147483654" r:id="Rff353f2aca6f4a9e"/>
-    <p:sldLayoutId xmlns:r="http://schemas.openxmlformats.org/officeDocument/2006/relationships" id="2147483655" r:id="R978f666d2ab74650"/>
-    <p:sldLayoutId xmlns:r="http://schemas.openxmlformats.org/officeDocument/2006/relationships" id="2147483656" r:id="R005d75da74a14c48"/>
-    <p:sldLayoutId xmlns:r="http://schemas.openxmlformats.org/officeDocument/2006/relationships" id="2147483657" r:id="R0181a6c64735428a"/>
-    <p:sldLayoutId xmlns:r="http://schemas.openxmlformats.org/officeDocument/2006/relationships" id="2147483658" r:id="R2b21261380cf4854"/>
-    <p:sldLayoutId xmlns:r="http://schemas.openxmlformats.org/officeDocument/2006/relationships" id="2147483659" r:id="Rf1fd43f12a794537"/>
+    <p:sldLayoutId xmlns:r="http://schemas.openxmlformats.org/officeDocument/2006/relationships" id="2147483649" r:id="Rd33413fb18464a26"/>
+    <p:sldLayoutId xmlns:r="http://schemas.openxmlformats.org/officeDocument/2006/relationships" id="2147483650" r:id="Ra5e36e02a2e342d6"/>
+    <p:sldLayoutId xmlns:r="http://schemas.openxmlformats.org/officeDocument/2006/relationships" id="2147483651" r:id="R57a007aef86d4a12"/>
+    <p:sldLayoutId xmlns:r="http://schemas.openxmlformats.org/officeDocument/2006/relationships" id="2147483652" r:id="Rd5e2c05dc05548da"/>
+    <p:sldLayoutId xmlns:r="http://schemas.openxmlformats.org/officeDocument/2006/relationships" id="2147483653" r:id="R3c9c6a8b409b448d"/>
+    <p:sldLayoutId xmlns:r="http://schemas.openxmlformats.org/officeDocument/2006/relationships" id="2147483654" r:id="R631911e196f64b40"/>
+    <p:sldLayoutId xmlns:r="http://schemas.openxmlformats.org/officeDocument/2006/relationships" id="2147483655" r:id="R06cb99945c574c52"/>
+    <p:sldLayoutId xmlns:r="http://schemas.openxmlformats.org/officeDocument/2006/relationships" id="2147483656" r:id="R80d2e9b162fb46ed"/>
+    <p:sldLayoutId xmlns:r="http://schemas.openxmlformats.org/officeDocument/2006/relationships" id="2147483657" r:id="R6f4cd660ba3a48e6"/>
+    <p:sldLayoutId xmlns:r="http://schemas.openxmlformats.org/officeDocument/2006/relationships" id="2147483658" r:id="R2b4ab3271c4c4143"/>
+    <p:sldLayoutId xmlns:r="http://schemas.openxmlformats.org/officeDocument/2006/relationships" id="2147483659" r:id="Rdfdc813dcbd0457c"/>
   </p:sldLayoutIdLst>
   <p:txStyles>
     <p:titleStyle>
@@ -5009,7 +5009,7 @@
           <p:cNvPr id="2" name="Rectangle 1">
             <a:extLst xmlns:a="http://schemas.openxmlformats.org/drawingml/2006/main">
               <a:ext uri="{FF2B5EF4-FFF2-40B4-BE49-F238E27FC236}">
-                <a16:creationId xmlns:a16="http://schemas.microsoft.com/office/drawing/2014/main" id="{69B87539-A772-4D1B-934F-87DD1FF62D99}"/>
+                <a16:creationId xmlns:a16="http://schemas.microsoft.com/office/drawing/2014/main" id="{EA9DDCA1-F914-4684-BDA6-211AC0C8CA5D}"/>
               </a:ext>
             </a:extLst>
           </p:cNvPr>
@@ -5062,7 +5062,7 @@
           <p:cNvPr id="3" name="Rectangle 2">
             <a:extLst xmlns:a="http://schemas.openxmlformats.org/drawingml/2006/main">
               <a:ext uri="{FF2B5EF4-FFF2-40B4-BE49-F238E27FC236}">
-                <a16:creationId xmlns:a16="http://schemas.microsoft.com/office/drawing/2014/main" id="{F0BC9FED-A2BA-4A0F-8214-120393F3658A}"/>
+                <a16:creationId xmlns:a16="http://schemas.microsoft.com/office/drawing/2014/main" id="{33933F27-0073-4242-98C3-5946DAF06647}"/>
               </a:ext>
             </a:extLst>
           </p:cNvPr>
@@ -5115,7 +5115,7 @@
           <p:cNvPr id="4" name="TextBox 3">
             <a:extLst xmlns:a="http://schemas.openxmlformats.org/drawingml/2006/main">
               <a:ext uri="{FF2B5EF4-FFF2-40B4-BE49-F238E27FC236}">
-                <a16:creationId xmlns:a16="http://schemas.microsoft.com/office/drawing/2014/main" id="{B30AFB6E-F377-44AC-B408-196787C9E8DD}"/>
+                <a16:creationId xmlns:a16="http://schemas.microsoft.com/office/drawing/2014/main" id="{39847C33-39CB-4870-BE4E-331573B0CA41}"/>
               </a:ext>
             </a:extLst>
           </p:cNvPr>
@@ -5217,7 +5217,7 @@
     </p:spTree>
     <p:extLst>
       <p:ext uri="{BB962C8B-B14F-4D97-AF65-F5344CB8AC3E}">
-        <p14:creationId xmlns:p14="http://schemas.microsoft.com/office/powerpoint/2010/main" val="418319784"/>
+        <p14:creationId xmlns:p14="http://schemas.microsoft.com/office/powerpoint/2010/main" val="457345839"/>
       </p:ext>
     </p:extLst>
   </p:cSld>
@@ -5241,7 +5241,7 @@
           <p:cNvPr id="2" name="Rectangle 1">
             <a:extLst xmlns:a="http://schemas.openxmlformats.org/drawingml/2006/main">
               <a:ext uri="{FF2B5EF4-FFF2-40B4-BE49-F238E27FC236}">
-                <a16:creationId xmlns:a16="http://schemas.microsoft.com/office/drawing/2014/main" id="{4D48DB15-55F2-43AE-A97A-8765B6832901}"/>
+                <a16:creationId xmlns:a16="http://schemas.microsoft.com/office/drawing/2014/main" id="{CD450BF5-9446-4EE7-885A-704BDA244F37}"/>
               </a:ext>
             </a:extLst>
           </p:cNvPr>
@@ -5294,7 +5294,7 @@
           <p:cNvPr id="3" name="Rectangle 2">
             <a:extLst xmlns:a="http://schemas.openxmlformats.org/drawingml/2006/main">
               <a:ext uri="{FF2B5EF4-FFF2-40B4-BE49-F238E27FC236}">
-                <a16:creationId xmlns:a16="http://schemas.microsoft.com/office/drawing/2014/main" id="{0C9B4BE8-25A1-469C-BFF3-7711AFD48319}"/>
+                <a16:creationId xmlns:a16="http://schemas.microsoft.com/office/drawing/2014/main" id="{AE858B1A-F398-42DF-903A-8CB5B264BCA6}"/>
               </a:ext>
             </a:extLst>
           </p:cNvPr>
@@ -5347,7 +5347,7 @@
           <p:cNvPr id="4" name="Rectangle 3">
             <a:extLst xmlns:a="http://schemas.openxmlformats.org/drawingml/2006/main">
               <a:ext uri="{FF2B5EF4-FFF2-40B4-BE49-F238E27FC236}">
-                <a16:creationId xmlns:a16="http://schemas.microsoft.com/office/drawing/2014/main" id="{3656063A-EB66-425D-8C29-6B24E6D0CA86}"/>
+                <a16:creationId xmlns:a16="http://schemas.microsoft.com/office/drawing/2014/main" id="{4E4BFE5E-A993-4CB7-A231-2B167E16FEBD}"/>
               </a:ext>
             </a:extLst>
           </p:cNvPr>
@@ -5400,7 +5400,7 @@
           <p:cNvPr id="5" name="TextBox 4">
             <a:extLst xmlns:a="http://schemas.openxmlformats.org/drawingml/2006/main">
               <a:ext uri="{FF2B5EF4-FFF2-40B4-BE49-F238E27FC236}">
-                <a16:creationId xmlns:a16="http://schemas.microsoft.com/office/drawing/2014/main" id="{5FF2463E-93FF-435E-BEB7-D36803B4128F}"/>
+                <a16:creationId xmlns:a16="http://schemas.microsoft.com/office/drawing/2014/main" id="{9E5D2F36-7CA8-46B7-8172-19594575E203}"/>
               </a:ext>
             </a:extLst>
           </p:cNvPr>
@@ -5463,7 +5463,7 @@
           <p:cNvPr id="6" name="Rounded Rectangle 5">
             <a:extLst xmlns:a="http://schemas.openxmlformats.org/drawingml/2006/main">
               <a:ext uri="{FF2B5EF4-FFF2-40B4-BE49-F238E27FC236}">
-                <a16:creationId xmlns:a16="http://schemas.microsoft.com/office/drawing/2014/main" id="{BD82A6BA-A1BC-4AD8-A63B-472E3412F2D1}"/>
+                <a16:creationId xmlns:a16="http://schemas.microsoft.com/office/drawing/2014/main" id="{ED7CEF2C-EB15-4F19-BD36-5F57718E2E34}"/>
               </a:ext>
             </a:extLst>
           </p:cNvPr>
@@ -5518,7 +5518,7 @@
           <p:cNvPr id="7" name="TextBox 6">
             <a:extLst xmlns:a="http://schemas.openxmlformats.org/drawingml/2006/main">
               <a:ext uri="{FF2B5EF4-FFF2-40B4-BE49-F238E27FC236}">
-                <a16:creationId xmlns:a16="http://schemas.microsoft.com/office/drawing/2014/main" id="{2E82FB1E-8309-43DC-AD65-8340D7265777}"/>
+                <a16:creationId xmlns:a16="http://schemas.microsoft.com/office/drawing/2014/main" id="{0D7C2161-B536-40BF-A976-A4CD3B05A8DB}"/>
               </a:ext>
             </a:extLst>
           </p:cNvPr>
@@ -5622,7 +5622,7 @@
           <p:cNvPr id="8" name="Rounded Rectangle 7">
             <a:extLst xmlns:a="http://schemas.openxmlformats.org/drawingml/2006/main">
               <a:ext uri="{FF2B5EF4-FFF2-40B4-BE49-F238E27FC236}">
-                <a16:creationId xmlns:a16="http://schemas.microsoft.com/office/drawing/2014/main" id="{44FD35A6-D270-44E7-B731-9A8452A6900A}"/>
+                <a16:creationId xmlns:a16="http://schemas.microsoft.com/office/drawing/2014/main" id="{F50D51DA-FE1F-4D8A-B3E2-EB7CEB989FC4}"/>
               </a:ext>
             </a:extLst>
           </p:cNvPr>
@@ -5677,7 +5677,7 @@
           <p:cNvPr id="9" name="TextBox 8">
             <a:extLst xmlns:a="http://schemas.openxmlformats.org/drawingml/2006/main">
               <a:ext uri="{FF2B5EF4-FFF2-40B4-BE49-F238E27FC236}">
-                <a16:creationId xmlns:a16="http://schemas.microsoft.com/office/drawing/2014/main" id="{8FE9BAE7-4993-4E11-BEFD-160D74284154}"/>
+                <a16:creationId xmlns:a16="http://schemas.microsoft.com/office/drawing/2014/main" id="{CD85419E-23E1-404E-9E32-D2267F41BED4}"/>
               </a:ext>
             </a:extLst>
           </p:cNvPr>
@@ -5762,7 +5762,7 @@
           <p:cNvPr id="10" name="Rounded Rectangle 9">
             <a:extLst xmlns:a="http://schemas.openxmlformats.org/drawingml/2006/main">
               <a:ext uri="{FF2B5EF4-FFF2-40B4-BE49-F238E27FC236}">
-                <a16:creationId xmlns:a16="http://schemas.microsoft.com/office/drawing/2014/main" id="{BD0EAEAB-F4DF-4D60-89C4-0F636A4B1794}"/>
+                <a16:creationId xmlns:a16="http://schemas.microsoft.com/office/drawing/2014/main" id="{D694ADD5-93D2-40F8-8B37-25A5EECCC428}"/>
               </a:ext>
             </a:extLst>
           </p:cNvPr>
@@ -5817,7 +5817,7 @@
           <p:cNvPr id="11" name="TextBox 10">
             <a:extLst xmlns:a="http://schemas.openxmlformats.org/drawingml/2006/main">
               <a:ext uri="{FF2B5EF4-FFF2-40B4-BE49-F238E27FC236}">
-                <a16:creationId xmlns:a16="http://schemas.microsoft.com/office/drawing/2014/main" id="{26124347-2A68-4A17-9AE1-6D101C12AD09}"/>
+                <a16:creationId xmlns:a16="http://schemas.microsoft.com/office/drawing/2014/main" id="{EDF41CEE-C939-4033-AB79-B49121B5096E}"/>
               </a:ext>
             </a:extLst>
           </p:cNvPr>
@@ -5919,7 +5919,7 @@
     </p:spTree>
     <p:extLst>
       <p:ext uri="{BB962C8B-B14F-4D97-AF65-F5344CB8AC3E}">
-        <p14:creationId xmlns:p14="http://schemas.microsoft.com/office/powerpoint/2010/main" val="626340798"/>
+        <p14:creationId xmlns:p14="http://schemas.microsoft.com/office/powerpoint/2010/main" val="1171260497"/>
       </p:ext>
     </p:extLst>
   </p:cSld>
@@ -5943,7 +5943,7 @@
           <p:cNvPr id="2" name="Rectangle 1">
             <a:extLst xmlns:a="http://schemas.openxmlformats.org/drawingml/2006/main">
               <a:ext uri="{FF2B5EF4-FFF2-40B4-BE49-F238E27FC236}">
-                <a16:creationId xmlns:a16="http://schemas.microsoft.com/office/drawing/2014/main" id="{F0977D85-D0EC-4BFC-A433-3FE0752CEABE}"/>
+                <a16:creationId xmlns:a16="http://schemas.microsoft.com/office/drawing/2014/main" id="{5138FABC-7F66-481B-8C2E-C4D291FB86B7}"/>
               </a:ext>
             </a:extLst>
           </p:cNvPr>
@@ -5996,7 +5996,7 @@
           <p:cNvPr id="3" name="Rectangle 2">
             <a:extLst xmlns:a="http://schemas.openxmlformats.org/drawingml/2006/main">
               <a:ext uri="{FF2B5EF4-FFF2-40B4-BE49-F238E27FC236}">
-                <a16:creationId xmlns:a16="http://schemas.microsoft.com/office/drawing/2014/main" id="{FA03800B-7EF3-459C-AE14-808830B06E5C}"/>
+                <a16:creationId xmlns:a16="http://schemas.microsoft.com/office/drawing/2014/main" id="{400E7278-5CAE-40C1-AD10-AACADE77F4F4}"/>
               </a:ext>
             </a:extLst>
           </p:cNvPr>
@@ -6049,7 +6049,7 @@
           <p:cNvPr id="4" name="Rectangle 3">
             <a:extLst xmlns:a="http://schemas.openxmlformats.org/drawingml/2006/main">
               <a:ext uri="{FF2B5EF4-FFF2-40B4-BE49-F238E27FC236}">
-                <a16:creationId xmlns:a16="http://schemas.microsoft.com/office/drawing/2014/main" id="{14904BB7-31CF-4BF9-B609-07BD2D1C733F}"/>
+                <a16:creationId xmlns:a16="http://schemas.microsoft.com/office/drawing/2014/main" id="{ED1CC4C4-B6D6-49F0-9827-436949CFFE98}"/>
               </a:ext>
             </a:extLst>
           </p:cNvPr>
@@ -6102,7 +6102,7 @@
           <p:cNvPr id="5" name="TextBox 4">
             <a:extLst xmlns:a="http://schemas.openxmlformats.org/drawingml/2006/main">
               <a:ext uri="{FF2B5EF4-FFF2-40B4-BE49-F238E27FC236}">
-                <a16:creationId xmlns:a16="http://schemas.microsoft.com/office/drawing/2014/main" id="{0122C0C5-BB4A-48C1-BDE7-2F24F7D77A4B}"/>
+                <a16:creationId xmlns:a16="http://schemas.microsoft.com/office/drawing/2014/main" id="{7C34A510-510D-41E6-9447-BE3BCBCFE5D2}"/>
               </a:ext>
             </a:extLst>
           </p:cNvPr>
@@ -6165,7 +6165,7 @@
           <p:cNvPr id="6" name="Rounded Rectangle 5">
             <a:extLst xmlns:a="http://schemas.openxmlformats.org/drawingml/2006/main">
               <a:ext uri="{FF2B5EF4-FFF2-40B4-BE49-F238E27FC236}">
-                <a16:creationId xmlns:a16="http://schemas.microsoft.com/office/drawing/2014/main" id="{C9315923-4882-4665-8ED9-D8971CC5B515}"/>
+                <a16:creationId xmlns:a16="http://schemas.microsoft.com/office/drawing/2014/main" id="{7C05AE73-0C32-4BA5-9594-868BA2764887}"/>
               </a:ext>
             </a:extLst>
           </p:cNvPr>
@@ -6220,7 +6220,7 @@
           <p:cNvPr id="7" name="TextBox 6">
             <a:extLst xmlns:a="http://schemas.openxmlformats.org/drawingml/2006/main">
               <a:ext uri="{FF2B5EF4-FFF2-40B4-BE49-F238E27FC236}">
-                <a16:creationId xmlns:a16="http://schemas.microsoft.com/office/drawing/2014/main" id="{056F66D9-5516-4569-BFAC-38F2C84F85BD}"/>
+                <a16:creationId xmlns:a16="http://schemas.microsoft.com/office/drawing/2014/main" id="{83405D1A-3133-4202-969F-57FA4BC446C4}"/>
               </a:ext>
             </a:extLst>
           </p:cNvPr>
@@ -6419,7 +6419,7 @@
           <p:cNvPr id="8" name="Rounded Rectangle 7">
             <a:extLst xmlns:a="http://schemas.openxmlformats.org/drawingml/2006/main">
               <a:ext uri="{FF2B5EF4-FFF2-40B4-BE49-F238E27FC236}">
-                <a16:creationId xmlns:a16="http://schemas.microsoft.com/office/drawing/2014/main" id="{5FBA845E-5769-49B5-91C0-884B19983161}"/>
+                <a16:creationId xmlns:a16="http://schemas.microsoft.com/office/drawing/2014/main" id="{CDB9D29F-30CB-48A2-A95A-5B1FF6D2794C}"/>
               </a:ext>
             </a:extLst>
           </p:cNvPr>
@@ -6474,7 +6474,7 @@
           <p:cNvPr id="9" name="TextBox 8">
             <a:extLst xmlns:a="http://schemas.openxmlformats.org/drawingml/2006/main">
               <a:ext uri="{FF2B5EF4-FFF2-40B4-BE49-F238E27FC236}">
-                <a16:creationId xmlns:a16="http://schemas.microsoft.com/office/drawing/2014/main" id="{5BF6DC06-33D4-4582-93AB-690607CAB8D9}"/>
+                <a16:creationId xmlns:a16="http://schemas.microsoft.com/office/drawing/2014/main" id="{3CA5E277-37FA-469F-B32C-57A08FD40C6E}"/>
               </a:ext>
             </a:extLst>
           </p:cNvPr>
@@ -6595,7 +6595,7 @@
     </p:spTree>
     <p:extLst>
       <p:ext uri="{BB962C8B-B14F-4D97-AF65-F5344CB8AC3E}">
-        <p14:creationId xmlns:p14="http://schemas.microsoft.com/office/powerpoint/2010/main" val="1722035190"/>
+        <p14:creationId xmlns:p14="http://schemas.microsoft.com/office/powerpoint/2010/main" val="1500473785"/>
       </p:ext>
     </p:extLst>
   </p:cSld>
@@ -6619,7 +6619,7 @@
           <p:cNvPr id="2" name="Rectangle 1">
             <a:extLst xmlns:a="http://schemas.openxmlformats.org/drawingml/2006/main">
               <a:ext uri="{FF2B5EF4-FFF2-40B4-BE49-F238E27FC236}">
-                <a16:creationId xmlns:a16="http://schemas.microsoft.com/office/drawing/2014/main" id="{7AB0EEF1-842F-4962-9CEA-674924E48FD9}"/>
+                <a16:creationId xmlns:a16="http://schemas.microsoft.com/office/drawing/2014/main" id="{39E6C460-4844-4E3D-80E9-9195C7914D45}"/>
               </a:ext>
             </a:extLst>
           </p:cNvPr>
@@ -6672,7 +6672,7 @@
           <p:cNvPr id="3" name="Rectangle 2">
             <a:extLst xmlns:a="http://schemas.openxmlformats.org/drawingml/2006/main">
               <a:ext uri="{FF2B5EF4-FFF2-40B4-BE49-F238E27FC236}">
-                <a16:creationId xmlns:a16="http://schemas.microsoft.com/office/drawing/2014/main" id="{FA7E393D-5BC7-48E6-981C-B360BE086850}"/>
+                <a16:creationId xmlns:a16="http://schemas.microsoft.com/office/drawing/2014/main" id="{884E266D-CA27-4D88-BB5E-1BB867F7B356}"/>
               </a:ext>
             </a:extLst>
           </p:cNvPr>
@@ -6725,7 +6725,7 @@
           <p:cNvPr id="4" name="TextBox 3">
             <a:extLst xmlns:a="http://schemas.openxmlformats.org/drawingml/2006/main">
               <a:ext uri="{FF2B5EF4-FFF2-40B4-BE49-F238E27FC236}">
-                <a16:creationId xmlns:a16="http://schemas.microsoft.com/office/drawing/2014/main" id="{AC94BA45-8E39-4354-877F-564EF5A41E53}"/>
+                <a16:creationId xmlns:a16="http://schemas.microsoft.com/office/drawing/2014/main" id="{473E6053-AED8-4DD4-B60B-3EE9F423B224}"/>
               </a:ext>
             </a:extLst>
           </p:cNvPr>
@@ -6903,7 +6903,7 @@
     </p:spTree>
     <p:extLst>
       <p:ext uri="{BB962C8B-B14F-4D97-AF65-F5344CB8AC3E}">
-        <p14:creationId xmlns:p14="http://schemas.microsoft.com/office/powerpoint/2010/main" val="48076162"/>
+        <p14:creationId xmlns:p14="http://schemas.microsoft.com/office/powerpoint/2010/main" val="792577894"/>
       </p:ext>
     </p:extLst>
   </p:cSld>
@@ -6927,7 +6927,7 @@
           <p:cNvPr id="2" name="Rectangle 1">
             <a:extLst xmlns:a="http://schemas.openxmlformats.org/drawingml/2006/main">
               <a:ext uri="{FF2B5EF4-FFF2-40B4-BE49-F238E27FC236}">
-                <a16:creationId xmlns:a16="http://schemas.microsoft.com/office/drawing/2014/main" id="{BDEC8858-E3A2-4F0E-BC96-720B553A643C}"/>
+                <a16:creationId xmlns:a16="http://schemas.microsoft.com/office/drawing/2014/main" id="{BA09B649-24F0-480B-B4A2-209DA9BEA2D8}"/>
               </a:ext>
             </a:extLst>
           </p:cNvPr>
@@ -6980,7 +6980,7 @@
           <p:cNvPr id="3" name="Rectangle 2">
             <a:extLst xmlns:a="http://schemas.openxmlformats.org/drawingml/2006/main">
               <a:ext uri="{FF2B5EF4-FFF2-40B4-BE49-F238E27FC236}">
-                <a16:creationId xmlns:a16="http://schemas.microsoft.com/office/drawing/2014/main" id="{F7FE8DB0-3FFB-4E1D-A271-40555BA67E94}"/>
+                <a16:creationId xmlns:a16="http://schemas.microsoft.com/office/drawing/2014/main" id="{487A8532-79A2-467F-90A9-066755336917}"/>
               </a:ext>
             </a:extLst>
           </p:cNvPr>
@@ -7033,7 +7033,7 @@
           <p:cNvPr id="4" name="Rectangle 3">
             <a:extLst xmlns:a="http://schemas.openxmlformats.org/drawingml/2006/main">
               <a:ext uri="{FF2B5EF4-FFF2-40B4-BE49-F238E27FC236}">
-                <a16:creationId xmlns:a16="http://schemas.microsoft.com/office/drawing/2014/main" id="{6AC94A5A-229A-4783-A311-5EEAC2306031}"/>
+                <a16:creationId xmlns:a16="http://schemas.microsoft.com/office/drawing/2014/main" id="{100FE809-0177-4D16-9848-70CB2531FEC5}"/>
               </a:ext>
             </a:extLst>
           </p:cNvPr>
@@ -7086,7 +7086,7 @@
           <p:cNvPr id="5" name="TextBox 4">
             <a:extLst xmlns:a="http://schemas.openxmlformats.org/drawingml/2006/main">
               <a:ext uri="{FF2B5EF4-FFF2-40B4-BE49-F238E27FC236}">
-                <a16:creationId xmlns:a16="http://schemas.microsoft.com/office/drawing/2014/main" id="{B38CE4D6-7674-4261-88D8-178A886D350B}"/>
+                <a16:creationId xmlns:a16="http://schemas.microsoft.com/office/drawing/2014/main" id="{D2B06B6E-0F8D-4C15-A07A-D52D230E1985}"/>
               </a:ext>
             </a:extLst>
           </p:cNvPr>
@@ -7149,7 +7149,7 @@
           <p:cNvPr id="6" name="Rounded Rectangle 5">
             <a:extLst xmlns:a="http://schemas.openxmlformats.org/drawingml/2006/main">
               <a:ext uri="{FF2B5EF4-FFF2-40B4-BE49-F238E27FC236}">
-                <a16:creationId xmlns:a16="http://schemas.microsoft.com/office/drawing/2014/main" id="{02977216-DCA9-464B-9979-0CE153096E20}"/>
+                <a16:creationId xmlns:a16="http://schemas.microsoft.com/office/drawing/2014/main" id="{F3F9053D-F011-409C-B909-23CFE30EC785}"/>
               </a:ext>
             </a:extLst>
           </p:cNvPr>
@@ -7204,7 +7204,7 @@
           <p:cNvPr id="7" name="TextBox 6">
             <a:extLst xmlns:a="http://schemas.openxmlformats.org/drawingml/2006/main">
               <a:ext uri="{FF2B5EF4-FFF2-40B4-BE49-F238E27FC236}">
-                <a16:creationId xmlns:a16="http://schemas.microsoft.com/office/drawing/2014/main" id="{19F6EF95-7158-434A-A356-E46C4E779BF7}"/>
+                <a16:creationId xmlns:a16="http://schemas.microsoft.com/office/drawing/2014/main" id="{13FD54E5-882F-404B-91B1-06DDA9D0CD21}"/>
               </a:ext>
             </a:extLst>
           </p:cNvPr>
@@ -7308,7 +7308,7 @@
           <p:cNvPr id="8" name="Rounded Rectangle 7">
             <a:extLst xmlns:a="http://schemas.openxmlformats.org/drawingml/2006/main">
               <a:ext uri="{FF2B5EF4-FFF2-40B4-BE49-F238E27FC236}">
-                <a16:creationId xmlns:a16="http://schemas.microsoft.com/office/drawing/2014/main" id="{3E63B7A7-F691-4096-9FC9-015E26BB8BD4}"/>
+                <a16:creationId xmlns:a16="http://schemas.microsoft.com/office/drawing/2014/main" id="{E16AB32C-0638-4164-9D05-EB57FD8F2B89}"/>
               </a:ext>
             </a:extLst>
           </p:cNvPr>
@@ -7363,7 +7363,7 @@
           <p:cNvPr id="9" name="TextBox 8">
             <a:extLst xmlns:a="http://schemas.openxmlformats.org/drawingml/2006/main">
               <a:ext uri="{FF2B5EF4-FFF2-40B4-BE49-F238E27FC236}">
-                <a16:creationId xmlns:a16="http://schemas.microsoft.com/office/drawing/2014/main" id="{55C46474-73B8-49A7-9AF8-AAA5345B4704}"/>
+                <a16:creationId xmlns:a16="http://schemas.microsoft.com/office/drawing/2014/main" id="{CD2A7B77-0AC7-4D72-B593-0A8B9BBFF186}"/>
               </a:ext>
             </a:extLst>
           </p:cNvPr>
@@ -7467,7 +7467,7 @@
           <p:cNvPr id="10" name="Rounded Rectangle 9">
             <a:extLst xmlns:a="http://schemas.openxmlformats.org/drawingml/2006/main">
               <a:ext uri="{FF2B5EF4-FFF2-40B4-BE49-F238E27FC236}">
-                <a16:creationId xmlns:a16="http://schemas.microsoft.com/office/drawing/2014/main" id="{22F8D07D-8441-4EAB-9568-5A9AEBF6E4B6}"/>
+                <a16:creationId xmlns:a16="http://schemas.microsoft.com/office/drawing/2014/main" id="{963CCAA3-3D37-4706-A0CC-3D3842D4A899}"/>
               </a:ext>
             </a:extLst>
           </p:cNvPr>
@@ -7522,7 +7522,7 @@
           <p:cNvPr id="11" name="TextBox 10">
             <a:extLst xmlns:a="http://schemas.openxmlformats.org/drawingml/2006/main">
               <a:ext uri="{FF2B5EF4-FFF2-40B4-BE49-F238E27FC236}">
-                <a16:creationId xmlns:a16="http://schemas.microsoft.com/office/drawing/2014/main" id="{1FEBEAD1-ABAE-42D7-8129-36F043F6B19B}"/>
+                <a16:creationId xmlns:a16="http://schemas.microsoft.com/office/drawing/2014/main" id="{CA6D9167-F6CE-4420-87F0-AF0FA359E710}"/>
               </a:ext>
             </a:extLst>
           </p:cNvPr>
@@ -7681,7 +7681,7 @@
     </p:spTree>
     <p:extLst>
       <p:ext uri="{BB962C8B-B14F-4D97-AF65-F5344CB8AC3E}">
-        <p14:creationId xmlns:p14="http://schemas.microsoft.com/office/powerpoint/2010/main" val="488177730"/>
+        <p14:creationId xmlns:p14="http://schemas.microsoft.com/office/powerpoint/2010/main" val="664807021"/>
       </p:ext>
     </p:extLst>
   </p:cSld>
@@ -7705,7 +7705,7 @@
           <p:cNvPr id="2" name="Rectangle 1">
             <a:extLst xmlns:a="http://schemas.openxmlformats.org/drawingml/2006/main">
               <a:ext uri="{FF2B5EF4-FFF2-40B4-BE49-F238E27FC236}">
-                <a16:creationId xmlns:a16="http://schemas.microsoft.com/office/drawing/2014/main" id="{B8C91304-3876-4BE8-A750-2BCE0A9E5A5D}"/>
+                <a16:creationId xmlns:a16="http://schemas.microsoft.com/office/drawing/2014/main" id="{9FB69427-F37F-4485-91D3-E07BD3970B0B}"/>
               </a:ext>
             </a:extLst>
           </p:cNvPr>
@@ -7758,7 +7758,7 @@
           <p:cNvPr id="3" name="Rectangle 2">
             <a:extLst xmlns:a="http://schemas.openxmlformats.org/drawingml/2006/main">
               <a:ext uri="{FF2B5EF4-FFF2-40B4-BE49-F238E27FC236}">
-                <a16:creationId xmlns:a16="http://schemas.microsoft.com/office/drawing/2014/main" id="{6F2677EE-9223-469F-88CC-79C47FB95DB3}"/>
+                <a16:creationId xmlns:a16="http://schemas.microsoft.com/office/drawing/2014/main" id="{58DD3E3D-CDF8-4FFE-BA16-EFDEECBED58A}"/>
               </a:ext>
             </a:extLst>
           </p:cNvPr>
@@ -7811,7 +7811,7 @@
           <p:cNvPr id="4" name="Rectangle 3">
             <a:extLst xmlns:a="http://schemas.openxmlformats.org/drawingml/2006/main">
               <a:ext uri="{FF2B5EF4-FFF2-40B4-BE49-F238E27FC236}">
-                <a16:creationId xmlns:a16="http://schemas.microsoft.com/office/drawing/2014/main" id="{FACC1211-BFD5-484C-9D7F-B8AB4BE2B688}"/>
+                <a16:creationId xmlns:a16="http://schemas.microsoft.com/office/drawing/2014/main" id="{DAD32B2E-4A88-4FD6-B17A-32DCFBBE5969}"/>
               </a:ext>
             </a:extLst>
           </p:cNvPr>
@@ -7864,7 +7864,7 @@
           <p:cNvPr id="5" name="TextBox 4">
             <a:extLst xmlns:a="http://schemas.openxmlformats.org/drawingml/2006/main">
               <a:ext uri="{FF2B5EF4-FFF2-40B4-BE49-F238E27FC236}">
-                <a16:creationId xmlns:a16="http://schemas.microsoft.com/office/drawing/2014/main" id="{7D6C8189-8A5E-4B68-90D5-A726C42AE6A4}"/>
+                <a16:creationId xmlns:a16="http://schemas.microsoft.com/office/drawing/2014/main" id="{B17C2597-7D19-42C5-9EBF-7CAA367F5033}"/>
               </a:ext>
             </a:extLst>
           </p:cNvPr>
@@ -7927,7 +7927,7 @@
           <p:cNvPr id="6" name="Rounded Rectangle 5">
             <a:extLst xmlns:a="http://schemas.openxmlformats.org/drawingml/2006/main">
               <a:ext uri="{FF2B5EF4-FFF2-40B4-BE49-F238E27FC236}">
-                <a16:creationId xmlns:a16="http://schemas.microsoft.com/office/drawing/2014/main" id="{78AB36E8-BD5E-4BFB-8BFA-214D879441EE}"/>
+                <a16:creationId xmlns:a16="http://schemas.microsoft.com/office/drawing/2014/main" id="{7766B36E-7B58-48DF-9BD3-8CFB9B58A028}"/>
               </a:ext>
             </a:extLst>
           </p:cNvPr>
@@ -7982,7 +7982,7 @@
           <p:cNvPr id="7" name="TextBox 6">
             <a:extLst xmlns:a="http://schemas.openxmlformats.org/drawingml/2006/main">
               <a:ext uri="{FF2B5EF4-FFF2-40B4-BE49-F238E27FC236}">
-                <a16:creationId xmlns:a16="http://schemas.microsoft.com/office/drawing/2014/main" id="{1DE16BAF-626F-4F93-B843-13417EE08E07}"/>
+                <a16:creationId xmlns:a16="http://schemas.microsoft.com/office/drawing/2014/main" id="{6C9A2DAB-6AD2-4B39-8F16-462CCC83F459}"/>
               </a:ext>
             </a:extLst>
           </p:cNvPr>
@@ -8105,7 +8105,7 @@
           <p:cNvPr id="8" name="Rounded Rectangle 7">
             <a:extLst xmlns:a="http://schemas.openxmlformats.org/drawingml/2006/main">
               <a:ext uri="{FF2B5EF4-FFF2-40B4-BE49-F238E27FC236}">
-                <a16:creationId xmlns:a16="http://schemas.microsoft.com/office/drawing/2014/main" id="{ADDBEEBE-D944-40D2-A581-2DEAB391344D}"/>
+                <a16:creationId xmlns:a16="http://schemas.microsoft.com/office/drawing/2014/main" id="{DF03DE50-51FD-4BC0-86F9-98A14E989FEF}"/>
               </a:ext>
             </a:extLst>
           </p:cNvPr>
@@ -8160,7 +8160,7 @@
           <p:cNvPr id="9" name="TextBox 8">
             <a:extLst xmlns:a="http://schemas.openxmlformats.org/drawingml/2006/main">
               <a:ext uri="{FF2B5EF4-FFF2-40B4-BE49-F238E27FC236}">
-                <a16:creationId xmlns:a16="http://schemas.microsoft.com/office/drawing/2014/main" id="{DAEF26EF-6284-49D5-9E54-15D62919BED4}"/>
+                <a16:creationId xmlns:a16="http://schemas.microsoft.com/office/drawing/2014/main" id="{7DA85F15-E398-4C81-BD57-6FBC40DEC217}"/>
               </a:ext>
             </a:extLst>
           </p:cNvPr>
@@ -8302,7 +8302,7 @@
           <p:cNvPr id="10" name="Rounded Rectangle 9">
             <a:extLst xmlns:a="http://schemas.openxmlformats.org/drawingml/2006/main">
               <a:ext uri="{FF2B5EF4-FFF2-40B4-BE49-F238E27FC236}">
-                <a16:creationId xmlns:a16="http://schemas.microsoft.com/office/drawing/2014/main" id="{1C490E98-BD38-4B69-A831-890E87DD9EA1}"/>
+                <a16:creationId xmlns:a16="http://schemas.microsoft.com/office/drawing/2014/main" id="{5AF6C990-24B4-4C65-948A-69E420673CF2}"/>
               </a:ext>
             </a:extLst>
           </p:cNvPr>
@@ -8357,7 +8357,7 @@
           <p:cNvPr id="11" name="TextBox 10">
             <a:extLst xmlns:a="http://schemas.openxmlformats.org/drawingml/2006/main">
               <a:ext uri="{FF2B5EF4-FFF2-40B4-BE49-F238E27FC236}">
-                <a16:creationId xmlns:a16="http://schemas.microsoft.com/office/drawing/2014/main" id="{7F55B837-DB12-4624-9439-54B19C191F22}"/>
+                <a16:creationId xmlns:a16="http://schemas.microsoft.com/office/drawing/2014/main" id="{1015CD2E-AD34-4E35-A7E8-3089F9B1B656}"/>
               </a:ext>
             </a:extLst>
           </p:cNvPr>
@@ -8459,7 +8459,7 @@
     </p:spTree>
     <p:extLst>
       <p:ext uri="{BB962C8B-B14F-4D97-AF65-F5344CB8AC3E}">
-        <p14:creationId xmlns:p14="http://schemas.microsoft.com/office/powerpoint/2010/main" val="120121349"/>
+        <p14:creationId xmlns:p14="http://schemas.microsoft.com/office/powerpoint/2010/main" val="805215013"/>
       </p:ext>
     </p:extLst>
   </p:cSld>
@@ -8483,7 +8483,7 @@
           <p:cNvPr id="2" name="Rectangle 1">
             <a:extLst xmlns:a="http://schemas.openxmlformats.org/drawingml/2006/main">
               <a:ext uri="{FF2B5EF4-FFF2-40B4-BE49-F238E27FC236}">
-                <a16:creationId xmlns:a16="http://schemas.microsoft.com/office/drawing/2014/main" id="{6AB984D4-4660-4AEF-9648-60243DCAC02E}"/>
+                <a16:creationId xmlns:a16="http://schemas.microsoft.com/office/drawing/2014/main" id="{CC927386-46EB-4707-8879-A57C3AF262A4}"/>
               </a:ext>
             </a:extLst>
           </p:cNvPr>
@@ -8536,7 +8536,7 @@
           <p:cNvPr id="3" name="Rectangle 2">
             <a:extLst xmlns:a="http://schemas.openxmlformats.org/drawingml/2006/main">
               <a:ext uri="{FF2B5EF4-FFF2-40B4-BE49-F238E27FC236}">
-                <a16:creationId xmlns:a16="http://schemas.microsoft.com/office/drawing/2014/main" id="{28C4C1D7-E816-45D1-A47E-4676888FC222}"/>
+                <a16:creationId xmlns:a16="http://schemas.microsoft.com/office/drawing/2014/main" id="{A42D7A3D-7BB3-45DD-83A0-08C6483429C5}"/>
               </a:ext>
             </a:extLst>
           </p:cNvPr>
@@ -8589,7 +8589,7 @@
           <p:cNvPr id="4" name="Rectangle 3">
             <a:extLst xmlns:a="http://schemas.openxmlformats.org/drawingml/2006/main">
               <a:ext uri="{FF2B5EF4-FFF2-40B4-BE49-F238E27FC236}">
-                <a16:creationId xmlns:a16="http://schemas.microsoft.com/office/drawing/2014/main" id="{4A013848-876A-4E01-A2F1-34F899850DCF}"/>
+                <a16:creationId xmlns:a16="http://schemas.microsoft.com/office/drawing/2014/main" id="{A9581115-B5EF-43ED-A7ED-EAD8ADEF35DE}"/>
               </a:ext>
             </a:extLst>
           </p:cNvPr>
@@ -8642,7 +8642,7 @@
           <p:cNvPr id="5" name="TextBox 4">
             <a:extLst xmlns:a="http://schemas.openxmlformats.org/drawingml/2006/main">
               <a:ext uri="{FF2B5EF4-FFF2-40B4-BE49-F238E27FC236}">
-                <a16:creationId xmlns:a16="http://schemas.microsoft.com/office/drawing/2014/main" id="{F9F0810A-02BB-49EE-8ABE-C61125FECA91}"/>
+                <a16:creationId xmlns:a16="http://schemas.microsoft.com/office/drawing/2014/main" id="{D065CAD9-27B1-49AB-B459-DD61A7FE1020}"/>
               </a:ext>
             </a:extLst>
           </p:cNvPr>
@@ -8705,7 +8705,7 @@
           <p:cNvPr id="6" name="Rounded Rectangle 5">
             <a:extLst xmlns:a="http://schemas.openxmlformats.org/drawingml/2006/main">
               <a:ext uri="{FF2B5EF4-FFF2-40B4-BE49-F238E27FC236}">
-                <a16:creationId xmlns:a16="http://schemas.microsoft.com/office/drawing/2014/main" id="{E864AA60-E301-46BE-8B0B-FE9C9746229B}"/>
+                <a16:creationId xmlns:a16="http://schemas.microsoft.com/office/drawing/2014/main" id="{F9910C9A-5BC3-4B90-AFF0-C6F7431D456B}"/>
               </a:ext>
             </a:extLst>
           </p:cNvPr>
@@ -8760,7 +8760,7 @@
           <p:cNvPr id="7" name="TextBox 6">
             <a:extLst xmlns:a="http://schemas.openxmlformats.org/drawingml/2006/main">
               <a:ext uri="{FF2B5EF4-FFF2-40B4-BE49-F238E27FC236}">
-                <a16:creationId xmlns:a16="http://schemas.microsoft.com/office/drawing/2014/main" id="{92E2E69E-8877-481B-84C0-BF506D298332}"/>
+                <a16:creationId xmlns:a16="http://schemas.microsoft.com/office/drawing/2014/main" id="{030E5DFB-0C54-447B-AA15-7C7D98608FC0}"/>
               </a:ext>
             </a:extLst>
           </p:cNvPr>
@@ -8940,7 +8940,7 @@
           <p:cNvPr id="8" name="Rounded Rectangle 7">
             <a:extLst xmlns:a="http://schemas.openxmlformats.org/drawingml/2006/main">
               <a:ext uri="{FF2B5EF4-FFF2-40B4-BE49-F238E27FC236}">
-                <a16:creationId xmlns:a16="http://schemas.microsoft.com/office/drawing/2014/main" id="{1F879C99-4BCF-49A0-A090-AF63D8E2C405}"/>
+                <a16:creationId xmlns:a16="http://schemas.microsoft.com/office/drawing/2014/main" id="{AABEA2ED-05DA-456B-850A-18CFBA817DDC}"/>
               </a:ext>
             </a:extLst>
           </p:cNvPr>
@@ -8995,7 +8995,7 @@
           <p:cNvPr id="9" name="TextBox 8">
             <a:extLst xmlns:a="http://schemas.openxmlformats.org/drawingml/2006/main">
               <a:ext uri="{FF2B5EF4-FFF2-40B4-BE49-F238E27FC236}">
-                <a16:creationId xmlns:a16="http://schemas.microsoft.com/office/drawing/2014/main" id="{18EDB787-C28A-41D2-8E9A-AC238A804C37}"/>
+                <a16:creationId xmlns:a16="http://schemas.microsoft.com/office/drawing/2014/main" id="{6F60C486-C88D-40E9-8E93-23762C33F6A8}"/>
               </a:ext>
             </a:extLst>
           </p:cNvPr>
@@ -9154,7 +9154,7 @@
     </p:spTree>
     <p:extLst>
       <p:ext uri="{BB962C8B-B14F-4D97-AF65-F5344CB8AC3E}">
-        <p14:creationId xmlns:p14="http://schemas.microsoft.com/office/powerpoint/2010/main" val="137370403"/>
+        <p14:creationId xmlns:p14="http://schemas.microsoft.com/office/powerpoint/2010/main" val="1341019022"/>
       </p:ext>
     </p:extLst>
   </p:cSld>
@@ -9178,7 +9178,7 @@
           <p:cNvPr id="2" name="Rectangle 1">
             <a:extLst xmlns:a="http://schemas.openxmlformats.org/drawingml/2006/main">
               <a:ext uri="{FF2B5EF4-FFF2-40B4-BE49-F238E27FC236}">
-                <a16:creationId xmlns:a16="http://schemas.microsoft.com/office/drawing/2014/main" id="{08E4196B-9943-4EE2-A2DC-C2F6FA7EACB7}"/>
+                <a16:creationId xmlns:a16="http://schemas.microsoft.com/office/drawing/2014/main" id="{3C6897AD-8849-45BB-BD1F-41D9EFB98F0F}"/>
               </a:ext>
             </a:extLst>
           </p:cNvPr>
@@ -9231,7 +9231,7 @@
           <p:cNvPr id="3" name="Rectangle 2">
             <a:extLst xmlns:a="http://schemas.openxmlformats.org/drawingml/2006/main">
               <a:ext uri="{FF2B5EF4-FFF2-40B4-BE49-F238E27FC236}">
-                <a16:creationId xmlns:a16="http://schemas.microsoft.com/office/drawing/2014/main" id="{7A30C625-1CE2-4F88-B32B-662C34C8AF7D}"/>
+                <a16:creationId xmlns:a16="http://schemas.microsoft.com/office/drawing/2014/main" id="{2B034FBE-7944-4396-8934-A7A87B060843}"/>
               </a:ext>
             </a:extLst>
           </p:cNvPr>
@@ -9284,7 +9284,7 @@
           <p:cNvPr id="4" name="Rectangle 3">
             <a:extLst xmlns:a="http://schemas.openxmlformats.org/drawingml/2006/main">
               <a:ext uri="{FF2B5EF4-FFF2-40B4-BE49-F238E27FC236}">
-                <a16:creationId xmlns:a16="http://schemas.microsoft.com/office/drawing/2014/main" id="{6F3D1556-4D1E-4DA1-9562-E7BA7E0910F5}"/>
+                <a16:creationId xmlns:a16="http://schemas.microsoft.com/office/drawing/2014/main" id="{51F0EC3D-7B93-4560-9C03-F839C1382630}"/>
               </a:ext>
             </a:extLst>
           </p:cNvPr>
@@ -9337,7 +9337,7 @@
           <p:cNvPr id="5" name="TextBox 4">
             <a:extLst xmlns:a="http://schemas.openxmlformats.org/drawingml/2006/main">
               <a:ext uri="{FF2B5EF4-FFF2-40B4-BE49-F238E27FC236}">
-                <a16:creationId xmlns:a16="http://schemas.microsoft.com/office/drawing/2014/main" id="{B3F33527-A7F5-4E77-8246-72462F09F6FE}"/>
+                <a16:creationId xmlns:a16="http://schemas.microsoft.com/office/drawing/2014/main" id="{4C8FA24A-BACB-44D6-B3D7-32F64EEAA80B}"/>
               </a:ext>
             </a:extLst>
           </p:cNvPr>
@@ -9400,7 +9400,7 @@
           <p:cNvPr id="6" name="Rounded Rectangle 5">
             <a:extLst xmlns:a="http://schemas.openxmlformats.org/drawingml/2006/main">
               <a:ext uri="{FF2B5EF4-FFF2-40B4-BE49-F238E27FC236}">
-                <a16:creationId xmlns:a16="http://schemas.microsoft.com/office/drawing/2014/main" id="{6A538AA0-B61E-443C-ABFF-CB0C09F54C0E}"/>
+                <a16:creationId xmlns:a16="http://schemas.microsoft.com/office/drawing/2014/main" id="{95BFA2E8-BF06-406B-BDB0-C82BFC3D2372}"/>
               </a:ext>
             </a:extLst>
           </p:cNvPr>
@@ -9455,7 +9455,7 @@
           <p:cNvPr id="7" name="TextBox 6">
             <a:extLst xmlns:a="http://schemas.openxmlformats.org/drawingml/2006/main">
               <a:ext uri="{FF2B5EF4-FFF2-40B4-BE49-F238E27FC236}">
-                <a16:creationId xmlns:a16="http://schemas.microsoft.com/office/drawing/2014/main" id="{4F92E36C-24CE-4777-81AE-B8680FC63453}"/>
+                <a16:creationId xmlns:a16="http://schemas.microsoft.com/office/drawing/2014/main" id="{804E77B0-ABBF-4924-BBEB-23C4F60D230D}"/>
               </a:ext>
             </a:extLst>
           </p:cNvPr>
@@ -9673,7 +9673,7 @@
           <p:cNvPr id="8" name="Rounded Rectangle 7">
             <a:extLst xmlns:a="http://schemas.openxmlformats.org/drawingml/2006/main">
               <a:ext uri="{FF2B5EF4-FFF2-40B4-BE49-F238E27FC236}">
-                <a16:creationId xmlns:a16="http://schemas.microsoft.com/office/drawing/2014/main" id="{62B801AF-7D04-42D5-881D-54AD81DC0AA1}"/>
+                <a16:creationId xmlns:a16="http://schemas.microsoft.com/office/drawing/2014/main" id="{C004314A-F7AD-4CB0-94BA-AD0D6479D783}"/>
               </a:ext>
             </a:extLst>
           </p:cNvPr>
@@ -9728,7 +9728,7 @@
           <p:cNvPr id="9" name="TextBox 8">
             <a:extLst xmlns:a="http://schemas.openxmlformats.org/drawingml/2006/main">
               <a:ext uri="{FF2B5EF4-FFF2-40B4-BE49-F238E27FC236}">
-                <a16:creationId xmlns:a16="http://schemas.microsoft.com/office/drawing/2014/main" id="{04EFC88A-F1BC-4FE2-9DFC-B2A015EBA642}"/>
+                <a16:creationId xmlns:a16="http://schemas.microsoft.com/office/drawing/2014/main" id="{3346AB71-4D36-4916-B9FC-8AB017C69ED5}"/>
               </a:ext>
             </a:extLst>
           </p:cNvPr>
@@ -9963,7 +9963,7 @@
     </p:spTree>
     <p:extLst>
       <p:ext uri="{BB962C8B-B14F-4D97-AF65-F5344CB8AC3E}">
-        <p14:creationId xmlns:p14="http://schemas.microsoft.com/office/powerpoint/2010/main" val="656426320"/>
+        <p14:creationId xmlns:p14="http://schemas.microsoft.com/office/powerpoint/2010/main" val="606018695"/>
       </p:ext>
     </p:extLst>
   </p:cSld>
@@ -9987,7 +9987,7 @@
           <p:cNvPr id="2" name="Rectangle 1">
             <a:extLst xmlns:a="http://schemas.openxmlformats.org/drawingml/2006/main">
               <a:ext uri="{FF2B5EF4-FFF2-40B4-BE49-F238E27FC236}">
-                <a16:creationId xmlns:a16="http://schemas.microsoft.com/office/drawing/2014/main" id="{6322017C-305A-4F56-9595-A54708DEFD2E}"/>
+                <a16:creationId xmlns:a16="http://schemas.microsoft.com/office/drawing/2014/main" id="{C5B102A8-5D3A-40B7-BE22-CB9C511CAA5F}"/>
               </a:ext>
             </a:extLst>
           </p:cNvPr>
@@ -10040,7 +10040,7 @@
           <p:cNvPr id="3" name="Rectangle 2">
             <a:extLst xmlns:a="http://schemas.openxmlformats.org/drawingml/2006/main">
               <a:ext uri="{FF2B5EF4-FFF2-40B4-BE49-F238E27FC236}">
-                <a16:creationId xmlns:a16="http://schemas.microsoft.com/office/drawing/2014/main" id="{54E4CFEB-4D1F-480D-AD73-772188BDD289}"/>
+                <a16:creationId xmlns:a16="http://schemas.microsoft.com/office/drawing/2014/main" id="{184BA6EF-FB3F-474A-BC02-EC7620FCE8E9}"/>
               </a:ext>
             </a:extLst>
           </p:cNvPr>
@@ -10093,7 +10093,7 @@
           <p:cNvPr id="4" name="Rectangle 3">
             <a:extLst xmlns:a="http://schemas.openxmlformats.org/drawingml/2006/main">
               <a:ext uri="{FF2B5EF4-FFF2-40B4-BE49-F238E27FC236}">
-                <a16:creationId xmlns:a16="http://schemas.microsoft.com/office/drawing/2014/main" id="{854E5EBB-22E3-40D2-8372-6E3BAB4E89F3}"/>
+                <a16:creationId xmlns:a16="http://schemas.microsoft.com/office/drawing/2014/main" id="{4C7DCB61-6B99-425A-AB0A-DBAB40DC191E}"/>
               </a:ext>
             </a:extLst>
           </p:cNvPr>
@@ -10146,7 +10146,7 @@
           <p:cNvPr id="5" name="TextBox 4">
             <a:extLst xmlns:a="http://schemas.openxmlformats.org/drawingml/2006/main">
               <a:ext uri="{FF2B5EF4-FFF2-40B4-BE49-F238E27FC236}">
-                <a16:creationId xmlns:a16="http://schemas.microsoft.com/office/drawing/2014/main" id="{F86CD8D8-D06F-463E-B213-FD9ED83F7CBE}"/>
+                <a16:creationId xmlns:a16="http://schemas.microsoft.com/office/drawing/2014/main" id="{C037C206-D888-4A8D-A9D5-0B4D87BA39A2}"/>
               </a:ext>
             </a:extLst>
           </p:cNvPr>
@@ -10209,7 +10209,7 @@
           <p:cNvPr id="6" name="Rounded Rectangle 5">
             <a:extLst xmlns:a="http://schemas.openxmlformats.org/drawingml/2006/main">
               <a:ext uri="{FF2B5EF4-FFF2-40B4-BE49-F238E27FC236}">
-                <a16:creationId xmlns:a16="http://schemas.microsoft.com/office/drawing/2014/main" id="{7941E52D-A58B-4D1D-A30E-06592AD277AA}"/>
+                <a16:creationId xmlns:a16="http://schemas.microsoft.com/office/drawing/2014/main" id="{17A68180-CA41-4A4C-B662-5E04C6F88545}"/>
               </a:ext>
             </a:extLst>
           </p:cNvPr>
@@ -10264,7 +10264,7 @@
           <p:cNvPr id="7" name="TextBox 6">
             <a:extLst xmlns:a="http://schemas.openxmlformats.org/drawingml/2006/main">
               <a:ext uri="{FF2B5EF4-FFF2-40B4-BE49-F238E27FC236}">
-                <a16:creationId xmlns:a16="http://schemas.microsoft.com/office/drawing/2014/main" id="{7C1EA024-712E-4017-82AB-B3CB214D9D29}"/>
+                <a16:creationId xmlns:a16="http://schemas.microsoft.com/office/drawing/2014/main" id="{776C911C-6AC1-4988-8202-882B9FCA6AA2}"/>
               </a:ext>
             </a:extLst>
           </p:cNvPr>
@@ -10647,7 +10647,7 @@
           <p:nvPr/>
         </p:nvPicPr>
         <p:blipFill>
-          <a:blip xmlns:r="http://schemas.openxmlformats.org/officeDocument/2006/relationships" xmlns:a="http://schemas.openxmlformats.org/drawingml/2006/main" r:embed="R217fd81bb07544fe"/>
+          <a:blip xmlns:r="http://schemas.openxmlformats.org/officeDocument/2006/relationships" xmlns:a="http://schemas.openxmlformats.org/drawingml/2006/main" r:embed="R51ce7eb0837f45e8"/>
           <a:stretch xmlns:a="http://schemas.openxmlformats.org/drawingml/2006/main">
             <a:fillRect l="0" t="0" r="0" b="0"/>
           </a:stretch>
@@ -10667,7 +10667,7 @@
           <p:cNvPr id="9" name="Rounded Rectangle 8">
             <a:extLst xmlns:a="http://schemas.openxmlformats.org/drawingml/2006/main">
               <a:ext uri="{FF2B5EF4-FFF2-40B4-BE49-F238E27FC236}">
-                <a16:creationId xmlns:a16="http://schemas.microsoft.com/office/drawing/2014/main" id="{97D8C64F-7C54-40ED-B9E9-AFD49E4A9F14}"/>
+                <a16:creationId xmlns:a16="http://schemas.microsoft.com/office/drawing/2014/main" id="{F15D4490-0FE4-40EE-8442-0A95059B1247}"/>
               </a:ext>
             </a:extLst>
           </p:cNvPr>
@@ -10722,7 +10722,7 @@
           <p:cNvPr id="10" name="TextBox 9">
             <a:extLst xmlns:a="http://schemas.openxmlformats.org/drawingml/2006/main">
               <a:ext uri="{FF2B5EF4-FFF2-40B4-BE49-F238E27FC236}">
-                <a16:creationId xmlns:a16="http://schemas.microsoft.com/office/drawing/2014/main" id="{B4C2B5A1-1E73-4836-B6C8-B1E23805CE34}"/>
+                <a16:creationId xmlns:a16="http://schemas.microsoft.com/office/drawing/2014/main" id="{7E2590B2-7FF0-4FE8-9E1B-E4B21D6BC5A9}"/>
               </a:ext>
             </a:extLst>
           </p:cNvPr>
@@ -10808,7 +10808,7 @@
     </p:spTree>
     <p:extLst>
       <p:ext uri="{BB962C8B-B14F-4D97-AF65-F5344CB8AC3E}">
-        <p14:creationId xmlns:p14="http://schemas.microsoft.com/office/powerpoint/2010/main" val="1909978044"/>
+        <p14:creationId xmlns:p14="http://schemas.microsoft.com/office/powerpoint/2010/main" val="1813359118"/>
       </p:ext>
     </p:extLst>
   </p:cSld>
@@ -10832,7 +10832,7 @@
           <p:cNvPr id="2" name="Rectangle 1">
             <a:extLst xmlns:a="http://schemas.openxmlformats.org/drawingml/2006/main">
               <a:ext uri="{FF2B5EF4-FFF2-40B4-BE49-F238E27FC236}">
-                <a16:creationId xmlns:a16="http://schemas.microsoft.com/office/drawing/2014/main" id="{14ABA4FC-409E-4306-89C9-2ADD3BD74917}"/>
+                <a16:creationId xmlns:a16="http://schemas.microsoft.com/office/drawing/2014/main" id="{1947AE4E-1230-41F0-A732-B780141E38B6}"/>
               </a:ext>
             </a:extLst>
           </p:cNvPr>
@@ -10885,7 +10885,7 @@
           <p:cNvPr id="3" name="Rectangle 2">
             <a:extLst xmlns:a="http://schemas.openxmlformats.org/drawingml/2006/main">
               <a:ext uri="{FF2B5EF4-FFF2-40B4-BE49-F238E27FC236}">
-                <a16:creationId xmlns:a16="http://schemas.microsoft.com/office/drawing/2014/main" id="{94798FD9-03D7-4AF6-8611-A7D33D457A14}"/>
+                <a16:creationId xmlns:a16="http://schemas.microsoft.com/office/drawing/2014/main" id="{0D21D111-659E-45F9-8A7D-09369F1E0A13}"/>
               </a:ext>
             </a:extLst>
           </p:cNvPr>
@@ -10938,7 +10938,7 @@
           <p:cNvPr id="4" name="Rectangle 3">
             <a:extLst xmlns:a="http://schemas.openxmlformats.org/drawingml/2006/main">
               <a:ext uri="{FF2B5EF4-FFF2-40B4-BE49-F238E27FC236}">
-                <a16:creationId xmlns:a16="http://schemas.microsoft.com/office/drawing/2014/main" id="{B3124EE1-B196-40FD-9776-1424BA286206}"/>
+                <a16:creationId xmlns:a16="http://schemas.microsoft.com/office/drawing/2014/main" id="{1269249E-16B5-46A5-A10F-048F4D073C87}"/>
               </a:ext>
             </a:extLst>
           </p:cNvPr>
@@ -10991,7 +10991,7 @@
           <p:cNvPr id="5" name="TextBox 4">
             <a:extLst xmlns:a="http://schemas.openxmlformats.org/drawingml/2006/main">
               <a:ext uri="{FF2B5EF4-FFF2-40B4-BE49-F238E27FC236}">
-                <a16:creationId xmlns:a16="http://schemas.microsoft.com/office/drawing/2014/main" id="{9EBF54F2-A178-430A-B712-0CC2319FDB77}"/>
+                <a16:creationId xmlns:a16="http://schemas.microsoft.com/office/drawing/2014/main" id="{0D2E2C8F-AE56-4508-BC4E-9196EC9392F5}"/>
               </a:ext>
             </a:extLst>
           </p:cNvPr>
@@ -11054,7 +11054,7 @@
           <p:cNvPr id="6" name="Rounded Rectangle 5">
             <a:extLst xmlns:a="http://schemas.openxmlformats.org/drawingml/2006/main">
               <a:ext uri="{FF2B5EF4-FFF2-40B4-BE49-F238E27FC236}">
-                <a16:creationId xmlns:a16="http://schemas.microsoft.com/office/drawing/2014/main" id="{795829A9-F77C-43C5-ADE1-85B87E9275BA}"/>
+                <a16:creationId xmlns:a16="http://schemas.microsoft.com/office/drawing/2014/main" id="{41BDD51A-C34B-4352-A973-593F8B6C772A}"/>
               </a:ext>
             </a:extLst>
           </p:cNvPr>
@@ -11109,7 +11109,7 @@
           <p:cNvPr id="7" name="TextBox 6">
             <a:extLst xmlns:a="http://schemas.openxmlformats.org/drawingml/2006/main">
               <a:ext uri="{FF2B5EF4-FFF2-40B4-BE49-F238E27FC236}">
-                <a16:creationId xmlns:a16="http://schemas.microsoft.com/office/drawing/2014/main" id="{856EEE6D-5744-4F64-B9CF-B1DFDD626B1A}"/>
+                <a16:creationId xmlns:a16="http://schemas.microsoft.com/office/drawing/2014/main" id="{37D35F9C-463A-4565-A504-4AC8A9BFEC6C}"/>
               </a:ext>
             </a:extLst>
           </p:cNvPr>
@@ -11346,7 +11346,7 @@
           <p:cNvPr id="8" name="Rounded Rectangle 7">
             <a:extLst xmlns:a="http://schemas.openxmlformats.org/drawingml/2006/main">
               <a:ext uri="{FF2B5EF4-FFF2-40B4-BE49-F238E27FC236}">
-                <a16:creationId xmlns:a16="http://schemas.microsoft.com/office/drawing/2014/main" id="{5E693F00-2792-4741-99A5-94B263CF7B57}"/>
+                <a16:creationId xmlns:a16="http://schemas.microsoft.com/office/drawing/2014/main" id="{E8C290BA-7EF9-4F75-AE6C-27EDC417A9CD}"/>
               </a:ext>
             </a:extLst>
           </p:cNvPr>
@@ -11401,7 +11401,7 @@
           <p:cNvPr id="9" name="TextBox 8">
             <a:extLst xmlns:a="http://schemas.openxmlformats.org/drawingml/2006/main">
               <a:ext uri="{FF2B5EF4-FFF2-40B4-BE49-F238E27FC236}">
-                <a16:creationId xmlns:a16="http://schemas.microsoft.com/office/drawing/2014/main" id="{FA96DDAB-B504-4EAB-8E88-BEEDF8729B4D}"/>
+                <a16:creationId xmlns:a16="http://schemas.microsoft.com/office/drawing/2014/main" id="{EBBC8B63-7B37-4126-81F0-9654272C80B6}"/>
               </a:ext>
             </a:extLst>
           </p:cNvPr>
@@ -11606,7 +11606,7 @@
     </p:spTree>
     <p:extLst>
       <p:ext uri="{BB962C8B-B14F-4D97-AF65-F5344CB8AC3E}">
-        <p14:creationId xmlns:p14="http://schemas.microsoft.com/office/powerpoint/2010/main" val="997993178"/>
+        <p14:creationId xmlns:p14="http://schemas.microsoft.com/office/powerpoint/2010/main" val="1989449084"/>
       </p:ext>
     </p:extLst>
   </p:cSld>
@@ -11630,7 +11630,7 @@
           <p:cNvPr id="2" name="Rectangle 1">
             <a:extLst xmlns:a="http://schemas.openxmlformats.org/drawingml/2006/main">
               <a:ext uri="{FF2B5EF4-FFF2-40B4-BE49-F238E27FC236}">
-                <a16:creationId xmlns:a16="http://schemas.microsoft.com/office/drawing/2014/main" id="{69F0A620-86C2-4084-AFC5-F97C14151DD2}"/>
+                <a16:creationId xmlns:a16="http://schemas.microsoft.com/office/drawing/2014/main" id="{41C5BC57-2C3E-402D-B37E-078904DCEC01}"/>
               </a:ext>
             </a:extLst>
           </p:cNvPr>
@@ -11683,7 +11683,7 @@
           <p:cNvPr id="3" name="Rectangle 2">
             <a:extLst xmlns:a="http://schemas.openxmlformats.org/drawingml/2006/main">
               <a:ext uri="{FF2B5EF4-FFF2-40B4-BE49-F238E27FC236}">
-                <a16:creationId xmlns:a16="http://schemas.microsoft.com/office/drawing/2014/main" id="{772A335E-6253-4EBF-A453-E2C63DD7F0D4}"/>
+                <a16:creationId xmlns:a16="http://schemas.microsoft.com/office/drawing/2014/main" id="{04E0B226-0CD6-4430-AA63-3CB66CDABB72}"/>
               </a:ext>
             </a:extLst>
           </p:cNvPr>
@@ -11736,7 +11736,7 @@
           <p:cNvPr id="4" name="Rectangle 3">
             <a:extLst xmlns:a="http://schemas.openxmlformats.org/drawingml/2006/main">
               <a:ext uri="{FF2B5EF4-FFF2-40B4-BE49-F238E27FC236}">
-                <a16:creationId xmlns:a16="http://schemas.microsoft.com/office/drawing/2014/main" id="{FF785CC3-2774-49C0-A222-7CB78F3EAE76}"/>
+                <a16:creationId xmlns:a16="http://schemas.microsoft.com/office/drawing/2014/main" id="{A4B50E3E-AC5D-4724-B7C5-0EEEBB0E7312}"/>
               </a:ext>
             </a:extLst>
           </p:cNvPr>
@@ -11789,7 +11789,7 @@
           <p:cNvPr id="5" name="TextBox 4">
             <a:extLst xmlns:a="http://schemas.openxmlformats.org/drawingml/2006/main">
               <a:ext uri="{FF2B5EF4-FFF2-40B4-BE49-F238E27FC236}">
-                <a16:creationId xmlns:a16="http://schemas.microsoft.com/office/drawing/2014/main" id="{E7B5E16E-53FF-4E18-9B7D-3130B26AE1B4}"/>
+                <a16:creationId xmlns:a16="http://schemas.microsoft.com/office/drawing/2014/main" id="{E285465C-ED5C-413E-9E08-D1E6F877EE9A}"/>
               </a:ext>
             </a:extLst>
           </p:cNvPr>
@@ -11852,7 +11852,7 @@
           <p:cNvPr id="6" name="Rounded Rectangle 5">
             <a:extLst xmlns:a="http://schemas.openxmlformats.org/drawingml/2006/main">
               <a:ext uri="{FF2B5EF4-FFF2-40B4-BE49-F238E27FC236}">
-                <a16:creationId xmlns:a16="http://schemas.microsoft.com/office/drawing/2014/main" id="{B84C5DA0-7A88-420F-B6F8-6897826EFDD8}"/>
+                <a16:creationId xmlns:a16="http://schemas.microsoft.com/office/drawing/2014/main" id="{4FAD3C12-F334-45B2-9FEB-70E85D95F8DA}"/>
               </a:ext>
             </a:extLst>
           </p:cNvPr>
@@ -11907,7 +11907,7 @@
           <p:cNvPr id="7" name="TextBox 6">
             <a:extLst xmlns:a="http://schemas.openxmlformats.org/drawingml/2006/main">
               <a:ext uri="{FF2B5EF4-FFF2-40B4-BE49-F238E27FC236}">
-                <a16:creationId xmlns:a16="http://schemas.microsoft.com/office/drawing/2014/main" id="{5414A0E2-3521-47CD-A514-123BE8D8300E}"/>
+                <a16:creationId xmlns:a16="http://schemas.microsoft.com/office/drawing/2014/main" id="{E1E49BFA-F718-4795-8523-E99500107FB2}"/>
               </a:ext>
             </a:extLst>
           </p:cNvPr>
@@ -12030,7 +12030,7 @@
           <p:cNvPr id="8" name="Rounded Rectangle 7">
             <a:extLst xmlns:a="http://schemas.openxmlformats.org/drawingml/2006/main">
               <a:ext uri="{FF2B5EF4-FFF2-40B4-BE49-F238E27FC236}">
-                <a16:creationId xmlns:a16="http://schemas.microsoft.com/office/drawing/2014/main" id="{EDAC4894-8736-4779-9617-9A237715673F}"/>
+                <a16:creationId xmlns:a16="http://schemas.microsoft.com/office/drawing/2014/main" id="{88513E2E-9E62-4826-B60F-C8A6B9F0F3DC}"/>
               </a:ext>
             </a:extLst>
           </p:cNvPr>
@@ -12085,7 +12085,7 @@
           <p:cNvPr id="9" name="TextBox 8">
             <a:extLst xmlns:a="http://schemas.openxmlformats.org/drawingml/2006/main">
               <a:ext uri="{FF2B5EF4-FFF2-40B4-BE49-F238E27FC236}">
-                <a16:creationId xmlns:a16="http://schemas.microsoft.com/office/drawing/2014/main" id="{B4DBC302-F590-46AD-92B9-842D13B19EF0}"/>
+                <a16:creationId xmlns:a16="http://schemas.microsoft.com/office/drawing/2014/main" id="{AD5BC6FD-6A34-4909-8D09-C3C5C18FE5FB}"/>
               </a:ext>
             </a:extLst>
           </p:cNvPr>
@@ -12208,7 +12208,7 @@
           <p:cNvPr id="10" name="Rounded Rectangle 9">
             <a:extLst xmlns:a="http://schemas.openxmlformats.org/drawingml/2006/main">
               <a:ext uri="{FF2B5EF4-FFF2-40B4-BE49-F238E27FC236}">
-                <a16:creationId xmlns:a16="http://schemas.microsoft.com/office/drawing/2014/main" id="{F3D87629-35C8-4B63-9312-71F774B807CC}"/>
+                <a16:creationId xmlns:a16="http://schemas.microsoft.com/office/drawing/2014/main" id="{5B7A8876-D4CB-4E8C-8314-AA5C04CAA864}"/>
               </a:ext>
             </a:extLst>
           </p:cNvPr>
@@ -12263,7 +12263,7 @@
           <p:cNvPr id="11" name="TextBox 10">
             <a:extLst xmlns:a="http://schemas.openxmlformats.org/drawingml/2006/main">
               <a:ext uri="{FF2B5EF4-FFF2-40B4-BE49-F238E27FC236}">
-                <a16:creationId xmlns:a16="http://schemas.microsoft.com/office/drawing/2014/main" id="{9AD9E8C6-145A-41F7-B32E-44BE43E59C0A}"/>
+                <a16:creationId xmlns:a16="http://schemas.microsoft.com/office/drawing/2014/main" id="{01930F37-AADC-496E-AA3B-29B9ECF6B555}"/>
               </a:ext>
             </a:extLst>
           </p:cNvPr>
@@ -12613,7 +12613,7 @@
     </p:spTree>
     <p:extLst>
       <p:ext uri="{BB962C8B-B14F-4D97-AF65-F5344CB8AC3E}">
-        <p14:creationId xmlns:p14="http://schemas.microsoft.com/office/powerpoint/2010/main" val="1111915281"/>
+        <p14:creationId xmlns:p14="http://schemas.microsoft.com/office/powerpoint/2010/main" val="760224879"/>
       </p:ext>
     </p:extLst>
   </p:cSld>
@@ -12637,7 +12637,7 @@
           <p:cNvPr id="2" name="Rectangle 1">
             <a:extLst xmlns:a="http://schemas.openxmlformats.org/drawingml/2006/main">
               <a:ext uri="{FF2B5EF4-FFF2-40B4-BE49-F238E27FC236}">
-                <a16:creationId xmlns:a16="http://schemas.microsoft.com/office/drawing/2014/main" id="{18F602CB-F031-4819-AE28-5441C23D0F7D}"/>
+                <a16:creationId xmlns:a16="http://schemas.microsoft.com/office/drawing/2014/main" id="{D4BBE0A4-9BE1-4CE8-86A8-48CAF75E9611}"/>
               </a:ext>
             </a:extLst>
           </p:cNvPr>
@@ -12690,7 +12690,7 @@
           <p:cNvPr id="3" name="Rectangle 2">
             <a:extLst xmlns:a="http://schemas.openxmlformats.org/drawingml/2006/main">
               <a:ext uri="{FF2B5EF4-FFF2-40B4-BE49-F238E27FC236}">
-                <a16:creationId xmlns:a16="http://schemas.microsoft.com/office/drawing/2014/main" id="{73EDA1A5-C1B9-48EA-AF69-7E0F26FFA630}"/>
+                <a16:creationId xmlns:a16="http://schemas.microsoft.com/office/drawing/2014/main" id="{8FA2EA55-FEA6-44CF-9209-DFE1D6C5DBEB}"/>
               </a:ext>
             </a:extLst>
           </p:cNvPr>
@@ -12743,7 +12743,7 @@
           <p:cNvPr id="4" name="Rectangle 3">
             <a:extLst xmlns:a="http://schemas.openxmlformats.org/drawingml/2006/main">
               <a:ext uri="{FF2B5EF4-FFF2-40B4-BE49-F238E27FC236}">
-                <a16:creationId xmlns:a16="http://schemas.microsoft.com/office/drawing/2014/main" id="{620725FD-78B2-4D16-9303-046F74F0CF44}"/>
+                <a16:creationId xmlns:a16="http://schemas.microsoft.com/office/drawing/2014/main" id="{5B4BF4B3-5BC1-4B45-8BDE-21FCD63A2AE8}"/>
               </a:ext>
             </a:extLst>
           </p:cNvPr>
@@ -12796,7 +12796,7 @@
           <p:cNvPr id="5" name="TextBox 4">
             <a:extLst xmlns:a="http://schemas.openxmlformats.org/drawingml/2006/main">
               <a:ext uri="{FF2B5EF4-FFF2-40B4-BE49-F238E27FC236}">
-                <a16:creationId xmlns:a16="http://schemas.microsoft.com/office/drawing/2014/main" id="{89E998A8-7C90-48EC-96A2-E030D8B25078}"/>
+                <a16:creationId xmlns:a16="http://schemas.microsoft.com/office/drawing/2014/main" id="{FA59C0EE-C01D-4477-8A32-8FB797D757C8}"/>
               </a:ext>
             </a:extLst>
           </p:cNvPr>
@@ -12859,7 +12859,7 @@
           <p:cNvPr id="6" name="Rounded Rectangle 5">
             <a:extLst xmlns:a="http://schemas.openxmlformats.org/drawingml/2006/main">
               <a:ext uri="{FF2B5EF4-FFF2-40B4-BE49-F238E27FC236}">
-                <a16:creationId xmlns:a16="http://schemas.microsoft.com/office/drawing/2014/main" id="{8C6A5984-A1BB-44C9-9267-759D33B63E92}"/>
+                <a16:creationId xmlns:a16="http://schemas.microsoft.com/office/drawing/2014/main" id="{865806B6-5F21-4B24-ABB3-9E8227234575}"/>
               </a:ext>
             </a:extLst>
           </p:cNvPr>
@@ -12914,7 +12914,7 @@
           <p:cNvPr id="7" name="TextBox 6">
             <a:extLst xmlns:a="http://schemas.openxmlformats.org/drawingml/2006/main">
               <a:ext uri="{FF2B5EF4-FFF2-40B4-BE49-F238E27FC236}">
-                <a16:creationId xmlns:a16="http://schemas.microsoft.com/office/drawing/2014/main" id="{686C547B-E549-4D85-940E-E50C8003153F}"/>
+                <a16:creationId xmlns:a16="http://schemas.microsoft.com/office/drawing/2014/main" id="{6C21F3D1-2E91-48EA-A81A-7659997B845B}"/>
               </a:ext>
             </a:extLst>
           </p:cNvPr>
@@ -12986,6 +12986,33 @@
                 <a:ea typeface="Calibri"/>
                 <a:cs typeface="Calibri"/>
               </a:rPr>
+              <a:t/>
+            </a:r>
+          </a:p>
+          <a:p xmlns:a="http://schemas.openxmlformats.org/drawingml/2006/main">
+            <a:pPr>
+              <a:spcBef>
+                <a:spcPts val="200"/>
+              </a:spcBef>
+              <a:buNone/>
+              <a:defRPr sz="1050">
+                <a:solidFill>
+                  <a:srgbClr val="0F172A"/>
+                </a:solidFill>
+                <a:latin typeface="Calibri"/>
+                <a:ea typeface="Calibri"/>
+                <a:cs typeface="Calibri"/>
+              </a:defRPr>
+            </a:pPr>
+            <a:r>
+              <a:rPr sz="825">
+                <a:solidFill>
+                  <a:srgbClr val="0F172A"/>
+                </a:solidFill>
+                <a:latin typeface="Calibri"/>
+                <a:ea typeface="Calibri"/>
+                <a:cs typeface="Calibri"/>
+              </a:rPr>
               <a:t>▶ ZONE 1: HISTORICAL DEV PILOT BASELINE (20 Requests Responses API)</a:t>
             </a:r>
           </a:p>
@@ -13067,6 +13094,33 @@
                 <a:ea typeface="Calibri"/>
                 <a:cs typeface="Calibri"/>
               </a:rPr>
+              <a:t/>
+            </a:r>
+          </a:p>
+          <a:p xmlns:a="http://schemas.openxmlformats.org/drawingml/2006/main">
+            <a:pPr>
+              <a:spcBef>
+                <a:spcPts val="200"/>
+              </a:spcBef>
+              <a:buNone/>
+              <a:defRPr sz="1050">
+                <a:solidFill>
+                  <a:srgbClr val="0F172A"/>
+                </a:solidFill>
+                <a:latin typeface="Calibri"/>
+                <a:ea typeface="Calibri"/>
+                <a:cs typeface="Calibri"/>
+              </a:defRPr>
+            </a:pPr>
+            <a:r>
+              <a:rPr sz="825">
+                <a:solidFill>
+                  <a:srgbClr val="0F172A"/>
+                </a:solidFill>
+                <a:latin typeface="Calibri"/>
+                <a:ea typeface="Calibri"/>
+                <a:cs typeface="Calibri"/>
+              </a:rPr>
               <a:t>▶ ZONE 2: DIAGNOSTIC TEST FIXTURE TELEMETRY (N=718 Scorable Views)</a:t>
             </a:r>
           </a:p>
@@ -13122,6 +13176,33 @@
                 <a:cs typeface="Calibri"/>
               </a:rPr>
               <a:t>•  rag_k10: trễ trung vị 9.90s (trung bình 4.37s) | 4536.5 prompt tokens | ~0.001870 USD / logical req.</a:t>
+            </a:r>
+          </a:p>
+          <a:p xmlns:a="http://schemas.openxmlformats.org/drawingml/2006/main">
+            <a:pPr>
+              <a:spcBef>
+                <a:spcPts val="200"/>
+              </a:spcBef>
+              <a:buNone/>
+              <a:defRPr sz="1050">
+                <a:solidFill>
+                  <a:srgbClr val="0F172A"/>
+                </a:solidFill>
+                <a:latin typeface="Calibri"/>
+                <a:ea typeface="Calibri"/>
+                <a:cs typeface="Calibri"/>
+              </a:defRPr>
+            </a:pPr>
+            <a:r>
+              <a:rPr sz="825">
+                <a:solidFill>
+                  <a:srgbClr val="0F172A"/>
+                </a:solidFill>
+                <a:latin typeface="Calibri"/>
+                <a:ea typeface="Calibri"/>
+                <a:cs typeface="Calibri"/>
+              </a:rPr>
+              <a:t/>
             </a:r>
           </a:p>
           <a:p xmlns:a="http://schemas.openxmlformats.org/drawingml/2006/main">
@@ -13297,7 +13378,7 @@
           <p:nvPr/>
         </p:nvPicPr>
         <p:blipFill>
-          <a:blip xmlns:r="http://schemas.openxmlformats.org/officeDocument/2006/relationships" xmlns:a="http://schemas.openxmlformats.org/drawingml/2006/main" r:embed="R4c8c88d642e4400a"/>
+          <a:blip xmlns:r="http://schemas.openxmlformats.org/officeDocument/2006/relationships" xmlns:a="http://schemas.openxmlformats.org/drawingml/2006/main" r:embed="R1567479dd27a4000"/>
           <a:stretch xmlns:a="http://schemas.openxmlformats.org/drawingml/2006/main">
             <a:fillRect l="0" t="0" r="0" b="0"/>
           </a:stretch>
@@ -13317,7 +13398,7 @@
           <p:cNvPr id="9" name="Rounded Rectangle 8">
             <a:extLst xmlns:a="http://schemas.openxmlformats.org/drawingml/2006/main">
               <a:ext uri="{FF2B5EF4-FFF2-40B4-BE49-F238E27FC236}">
-                <a16:creationId xmlns:a16="http://schemas.microsoft.com/office/drawing/2014/main" id="{E1BFE4F3-AD8D-4191-9B75-D40A2541EFF4}"/>
+                <a16:creationId xmlns:a16="http://schemas.microsoft.com/office/drawing/2014/main" id="{CB09E1CE-A8E7-47F9-9CB2-8037E94BD3D0}"/>
               </a:ext>
             </a:extLst>
           </p:cNvPr>
@@ -13372,7 +13453,7 @@
           <p:cNvPr id="10" name="TextBox 9">
             <a:extLst xmlns:a="http://schemas.openxmlformats.org/drawingml/2006/main">
               <a:ext uri="{FF2B5EF4-FFF2-40B4-BE49-F238E27FC236}">
-                <a16:creationId xmlns:a16="http://schemas.microsoft.com/office/drawing/2014/main" id="{9733DE2B-7BCD-4C05-B427-50651CB6CCF8}"/>
+                <a16:creationId xmlns:a16="http://schemas.microsoft.com/office/drawing/2014/main" id="{28E1BCAD-AA5C-496B-892C-5EFD0E5F07EF}"/>
               </a:ext>
             </a:extLst>
           </p:cNvPr>
@@ -13455,7 +13536,7 @@
     </p:spTree>
     <p:extLst>
       <p:ext uri="{BB962C8B-B14F-4D97-AF65-F5344CB8AC3E}">
-        <p14:creationId xmlns:p14="http://schemas.microsoft.com/office/powerpoint/2010/main" val="945939330"/>
+        <p14:creationId xmlns:p14="http://schemas.microsoft.com/office/powerpoint/2010/main" val="1100050484"/>
       </p:ext>
     </p:extLst>
   </p:cSld>

</xml_diff>

<commit_message>
fix(presentation): resolve slide 9 overflow, baseline labels, CI clarity, README closure, and export presentation_v4
</commit_message>
<xml_diff>
--- a/reports/evidence/fixture_populated_slides.pptx
+++ b/reports/evidence/fixture_populated_slides.pptx
@@ -2,24 +2,24 @@
 <file path=ppt/presentation.xml><?xml version="1.0" encoding="utf-8"?>
 <p:presentation xmlns:p="http://schemas.openxmlformats.org/presentationml/2006/main">
   <p:sldMasterIdLst>
-    <p:sldMasterId xmlns:r="http://schemas.openxmlformats.org/officeDocument/2006/relationships" id="2147483648" r:id="Rdd95dc7191174d01"/>
+    <p:sldMasterId xmlns:r="http://schemas.openxmlformats.org/officeDocument/2006/relationships" id="2147483648" r:id="R31109b3498894167"/>
   </p:sldMasterIdLst>
   <p:notesMasterIdLst>
-    <p:notesMasterId xmlns:r="http://schemas.openxmlformats.org/officeDocument/2006/relationships" r:id="R5a1c45a77eed4a58"/>
+    <p:notesMasterId xmlns:r="http://schemas.openxmlformats.org/officeDocument/2006/relationships" r:id="R70a9a8da790c4a02"/>
   </p:notesMasterIdLst>
   <p:sldIdLst>
-    <p:sldId xmlns:r="http://schemas.openxmlformats.org/officeDocument/2006/relationships" id="256" r:id="R5383c821915e4eb8"/>
-    <p:sldId xmlns:r="http://schemas.openxmlformats.org/officeDocument/2006/relationships" id="257" r:id="R4e5bd8b8396e42d0"/>
-    <p:sldId xmlns:r="http://schemas.openxmlformats.org/officeDocument/2006/relationships" id="258" r:id="R8764f93c7c294f95"/>
-    <p:sldId xmlns:r="http://schemas.openxmlformats.org/officeDocument/2006/relationships" id="259" r:id="R5cc3db0f429048e5"/>
-    <p:sldId xmlns:r="http://schemas.openxmlformats.org/officeDocument/2006/relationships" id="260" r:id="R86eac21e4ecd4e0d"/>
-    <p:sldId xmlns:r="http://schemas.openxmlformats.org/officeDocument/2006/relationships" id="261" r:id="Rc2bacc070ce54099"/>
-    <p:sldId xmlns:r="http://schemas.openxmlformats.org/officeDocument/2006/relationships" id="262" r:id="Re67d261329534aa4"/>
-    <p:sldId xmlns:r="http://schemas.openxmlformats.org/officeDocument/2006/relationships" id="263" r:id="Rab5461ca5b8f47ea"/>
-    <p:sldId xmlns:r="http://schemas.openxmlformats.org/officeDocument/2006/relationships" id="264" r:id="R7b368c83b7fc4be9"/>
-    <p:sldId xmlns:r="http://schemas.openxmlformats.org/officeDocument/2006/relationships" id="265" r:id="R06eb641dd8054a70"/>
-    <p:sldId xmlns:r="http://schemas.openxmlformats.org/officeDocument/2006/relationships" id="266" r:id="R21b8d656587545f7"/>
-    <p:sldId xmlns:r="http://schemas.openxmlformats.org/officeDocument/2006/relationships" id="267" r:id="Rd304273cf0f84554"/>
+    <p:sldId xmlns:r="http://schemas.openxmlformats.org/officeDocument/2006/relationships" id="256" r:id="Rc16b122d3a794a8b"/>
+    <p:sldId xmlns:r="http://schemas.openxmlformats.org/officeDocument/2006/relationships" id="257" r:id="R07d14a099c9946cf"/>
+    <p:sldId xmlns:r="http://schemas.openxmlformats.org/officeDocument/2006/relationships" id="258" r:id="Rb3dfd3ae046e4e96"/>
+    <p:sldId xmlns:r="http://schemas.openxmlformats.org/officeDocument/2006/relationships" id="259" r:id="R9ef5f787049d4a03"/>
+    <p:sldId xmlns:r="http://schemas.openxmlformats.org/officeDocument/2006/relationships" id="260" r:id="R199355c59d794061"/>
+    <p:sldId xmlns:r="http://schemas.openxmlformats.org/officeDocument/2006/relationships" id="261" r:id="R8d166810d7754f5f"/>
+    <p:sldId xmlns:r="http://schemas.openxmlformats.org/officeDocument/2006/relationships" id="262" r:id="R655c04b5c490405f"/>
+    <p:sldId xmlns:r="http://schemas.openxmlformats.org/officeDocument/2006/relationships" id="263" r:id="Rec29d7b3b85f403a"/>
+    <p:sldId xmlns:r="http://schemas.openxmlformats.org/officeDocument/2006/relationships" id="264" r:id="Rf0135bb4847d40a8"/>
+    <p:sldId xmlns:r="http://schemas.openxmlformats.org/officeDocument/2006/relationships" id="265" r:id="R2989c017b20f4b23"/>
+    <p:sldId xmlns:r="http://schemas.openxmlformats.org/officeDocument/2006/relationships" id="266" r:id="Refc6e89f0b0540dd"/>
+    <p:sldId xmlns:r="http://schemas.openxmlformats.org/officeDocument/2006/relationships" id="267" r:id="Re07a985f72b4410e"/>
   </p:sldIdLst>
   <p:sldSz cx="12191695" cy="6858000"/>
   <p:notesSz cx="6858000" cy="9144000"/>
@@ -1473,7 +1473,7 @@
           <p:cNvPr id="2" name="Title 1">
             <a:extLst xmlns:a="http://schemas.openxmlformats.org/drawingml/2006/main">
               <a:ext uri="{FF2B5EF4-FFF2-40B4-BE49-F238E27FC236}">
-                <a16:creationId xmlns:a16="http://schemas.microsoft.com/office/drawing/2014/main" id="{6D09D927-F6CC-4BAC-9C35-B874E18C513E}"/>
+                <a16:creationId xmlns:a16="http://schemas.microsoft.com/office/drawing/2014/main" id="{87637113-9C5F-49BD-A620-E80C1A5B3FBF}"/>
               </a:ext>
             </a:extLst>
           </p:cNvPr>
@@ -1506,7 +1506,7 @@
           <p:cNvPr id="3" name="Subtitle 2">
             <a:extLst xmlns:a="http://schemas.openxmlformats.org/drawingml/2006/main">
               <a:ext uri="{FF2B5EF4-FFF2-40B4-BE49-F238E27FC236}">
-                <a16:creationId xmlns:a16="http://schemas.microsoft.com/office/drawing/2014/main" id="{CFC2FE08-E5D5-4E8C-90AE-6EDD974A4ABB}"/>
+                <a16:creationId xmlns:a16="http://schemas.microsoft.com/office/drawing/2014/main" id="{0D42AF0B-BC36-4BA6-B996-20E647F88020}"/>
               </a:ext>
             </a:extLst>
           </p:cNvPr>
@@ -1630,7 +1630,7 @@
           <p:cNvPr id="4" name="Date Placeholder 3">
             <a:extLst xmlns:a="http://schemas.openxmlformats.org/drawingml/2006/main">
               <a:ext uri="{FF2B5EF4-FFF2-40B4-BE49-F238E27FC236}">
-                <a16:creationId xmlns:a16="http://schemas.microsoft.com/office/drawing/2014/main" id="{71E6E9A4-EB64-4BFF-9A46-77FE6C57C8FB}"/>
+                <a16:creationId xmlns:a16="http://schemas.microsoft.com/office/drawing/2014/main" id="{66C1118A-73A7-4A47-9610-5E28CBB38B9B}"/>
               </a:ext>
             </a:extLst>
           </p:cNvPr>
@@ -1658,7 +1658,7 @@
           <p:cNvPr id="5" name="Footer Placeholder 4">
             <a:extLst xmlns:a="http://schemas.openxmlformats.org/drawingml/2006/main">
               <a:ext uri="{FF2B5EF4-FFF2-40B4-BE49-F238E27FC236}">
-                <a16:creationId xmlns:a16="http://schemas.microsoft.com/office/drawing/2014/main" id="{93FC53D0-AC80-40BA-93CE-39982E552B52}"/>
+                <a16:creationId xmlns:a16="http://schemas.microsoft.com/office/drawing/2014/main" id="{34828C04-C5F5-4F26-B6B7-58AAF0E29886}"/>
               </a:ext>
             </a:extLst>
           </p:cNvPr>
@@ -1683,7 +1683,7 @@
           <p:cNvPr id="6" name="Slide Number Placeholder 5">
             <a:extLst xmlns:a="http://schemas.openxmlformats.org/drawingml/2006/main">
               <a:ext uri="{FF2B5EF4-FFF2-40B4-BE49-F238E27FC236}">
-                <a16:creationId xmlns:a16="http://schemas.microsoft.com/office/drawing/2014/main" id="{4726FCA9-8AD6-400A-8DFC-82D8A962D503}"/>
+                <a16:creationId xmlns:a16="http://schemas.microsoft.com/office/drawing/2014/main" id="{AC6F5BBE-39D3-4C10-BC75-362B7AA5A47D}"/>
               </a:ext>
             </a:extLst>
           </p:cNvPr>
@@ -1728,7 +1728,7 @@
           <p:cNvPr id="2" name="Title 1">
             <a:extLst xmlns:a="http://schemas.openxmlformats.org/drawingml/2006/main">
               <a:ext uri="{FF2B5EF4-FFF2-40B4-BE49-F238E27FC236}">
-                <a16:creationId xmlns:a16="http://schemas.microsoft.com/office/drawing/2014/main" id="{27EAF28B-E2FB-4430-8248-05D0EE2F1FC5}"/>
+                <a16:creationId xmlns:a16="http://schemas.microsoft.com/office/drawing/2014/main" id="{81FCB0B8-D190-48EF-AD38-B1591837F946}"/>
               </a:ext>
             </a:extLst>
           </p:cNvPr>
@@ -1756,7 +1756,7 @@
           <p:cNvPr id="3" name="Vertical Text Placeholder 2">
             <a:extLst xmlns:a="http://schemas.openxmlformats.org/drawingml/2006/main">
               <a:ext uri="{FF2B5EF4-FFF2-40B4-BE49-F238E27FC236}">
-                <a16:creationId xmlns:a16="http://schemas.microsoft.com/office/drawing/2014/main" id="{A1C0B1BE-B7C7-4620-A449-3E65FE8DBEBF}"/>
+                <a16:creationId xmlns:a16="http://schemas.microsoft.com/office/drawing/2014/main" id="{CD18897F-9CD5-498B-8ECB-06359AD0CAFF}"/>
               </a:ext>
             </a:extLst>
           </p:cNvPr>
@@ -1819,7 +1819,7 @@
           <p:cNvPr id="4" name="Date Placeholder 3">
             <a:extLst xmlns:a="http://schemas.openxmlformats.org/drawingml/2006/main">
               <a:ext uri="{FF2B5EF4-FFF2-40B4-BE49-F238E27FC236}">
-                <a16:creationId xmlns:a16="http://schemas.microsoft.com/office/drawing/2014/main" id="{073ABDA0-B94D-44FB-B514-06823C9F7932}"/>
+                <a16:creationId xmlns:a16="http://schemas.microsoft.com/office/drawing/2014/main" id="{D1909C94-169F-4313-8758-805A0E3EAD3A}"/>
               </a:ext>
             </a:extLst>
           </p:cNvPr>
@@ -1847,7 +1847,7 @@
           <p:cNvPr id="5" name="Footer Placeholder 4">
             <a:extLst xmlns:a="http://schemas.openxmlformats.org/drawingml/2006/main">
               <a:ext uri="{FF2B5EF4-FFF2-40B4-BE49-F238E27FC236}">
-                <a16:creationId xmlns:a16="http://schemas.microsoft.com/office/drawing/2014/main" id="{678F8C91-2E93-4644-8E8D-1E9AE714A178}"/>
+                <a16:creationId xmlns:a16="http://schemas.microsoft.com/office/drawing/2014/main" id="{DF0B42B3-04C2-470A-8406-D3B07CD18C04}"/>
               </a:ext>
             </a:extLst>
           </p:cNvPr>
@@ -1872,7 +1872,7 @@
           <p:cNvPr id="6" name="Slide Number Placeholder 5">
             <a:extLst xmlns:a="http://schemas.openxmlformats.org/drawingml/2006/main">
               <a:ext uri="{FF2B5EF4-FFF2-40B4-BE49-F238E27FC236}">
-                <a16:creationId xmlns:a16="http://schemas.microsoft.com/office/drawing/2014/main" id="{676E60A3-2BAE-4CB0-8C91-C8E7573B2822}"/>
+                <a16:creationId xmlns:a16="http://schemas.microsoft.com/office/drawing/2014/main" id="{51E245BA-EE04-4693-AE30-C084F872C43B}"/>
               </a:ext>
             </a:extLst>
           </p:cNvPr>
@@ -1917,7 +1917,7 @@
           <p:cNvPr id="2" name="Vertical Title 1">
             <a:extLst xmlns:a="http://schemas.openxmlformats.org/drawingml/2006/main">
               <a:ext uri="{FF2B5EF4-FFF2-40B4-BE49-F238E27FC236}">
-                <a16:creationId xmlns:a16="http://schemas.microsoft.com/office/drawing/2014/main" id="{F332E357-F083-4599-836E-861EB3160CFB}"/>
+                <a16:creationId xmlns:a16="http://schemas.microsoft.com/office/drawing/2014/main" id="{2FD3B4EA-AA23-4A48-8821-510BE2A2E020}"/>
               </a:ext>
             </a:extLst>
           </p:cNvPr>
@@ -1950,7 +1950,7 @@
           <p:cNvPr id="3" name="Vertical Text Placeholder 2">
             <a:extLst xmlns:a="http://schemas.openxmlformats.org/drawingml/2006/main">
               <a:ext uri="{FF2B5EF4-FFF2-40B4-BE49-F238E27FC236}">
-                <a16:creationId xmlns:a16="http://schemas.microsoft.com/office/drawing/2014/main" id="{DA60EB22-B626-4DD5-B6C0-000EABCA6A09}"/>
+                <a16:creationId xmlns:a16="http://schemas.microsoft.com/office/drawing/2014/main" id="{94552581-89A4-4193-B437-C6BAF5A6254C}"/>
               </a:ext>
             </a:extLst>
           </p:cNvPr>
@@ -2018,7 +2018,7 @@
           <p:cNvPr id="4" name="Date Placeholder 3">
             <a:extLst xmlns:a="http://schemas.openxmlformats.org/drawingml/2006/main">
               <a:ext uri="{FF2B5EF4-FFF2-40B4-BE49-F238E27FC236}">
-                <a16:creationId xmlns:a16="http://schemas.microsoft.com/office/drawing/2014/main" id="{D163D34B-F363-4BB7-8535-5A8543DD2BBE}"/>
+                <a16:creationId xmlns:a16="http://schemas.microsoft.com/office/drawing/2014/main" id="{66DF79E0-5436-4E46-9097-636DC38496CA}"/>
               </a:ext>
             </a:extLst>
           </p:cNvPr>
@@ -2046,7 +2046,7 @@
           <p:cNvPr id="5" name="Footer Placeholder 4">
             <a:extLst xmlns:a="http://schemas.openxmlformats.org/drawingml/2006/main">
               <a:ext uri="{FF2B5EF4-FFF2-40B4-BE49-F238E27FC236}">
-                <a16:creationId xmlns:a16="http://schemas.microsoft.com/office/drawing/2014/main" id="{D3836FCD-996D-403E-ACE7-D78247F8231C}"/>
+                <a16:creationId xmlns:a16="http://schemas.microsoft.com/office/drawing/2014/main" id="{F2C778AA-40B0-40FB-AF00-5C02B5247968}"/>
               </a:ext>
             </a:extLst>
           </p:cNvPr>
@@ -2071,7 +2071,7 @@
           <p:cNvPr id="6" name="Slide Number Placeholder 5">
             <a:extLst xmlns:a="http://schemas.openxmlformats.org/drawingml/2006/main">
               <a:ext uri="{FF2B5EF4-FFF2-40B4-BE49-F238E27FC236}">
-                <a16:creationId xmlns:a16="http://schemas.microsoft.com/office/drawing/2014/main" id="{0828965B-FC0F-4303-9BE9-5AE71CC6C371}"/>
+                <a16:creationId xmlns:a16="http://schemas.microsoft.com/office/drawing/2014/main" id="{BE2B159D-7645-43A8-A399-59B869DFC601}"/>
               </a:ext>
             </a:extLst>
           </p:cNvPr>
@@ -2116,7 +2116,7 @@
           <p:cNvPr id="2" name="Title 1">
             <a:extLst xmlns:a="http://schemas.openxmlformats.org/drawingml/2006/main">
               <a:ext uri="{FF2B5EF4-FFF2-40B4-BE49-F238E27FC236}">
-                <a16:creationId xmlns:a16="http://schemas.microsoft.com/office/drawing/2014/main" id="{C3D6128A-63A5-4AFB-835C-9DCAC055BC9B}"/>
+                <a16:creationId xmlns:a16="http://schemas.microsoft.com/office/drawing/2014/main" id="{D1B8F23B-F8F4-420F-B17A-6F34BAC5D4E4}"/>
               </a:ext>
             </a:extLst>
           </p:cNvPr>
@@ -2144,7 +2144,7 @@
           <p:cNvPr id="3" name="Content Placeholder 2">
             <a:extLst xmlns:a="http://schemas.openxmlformats.org/drawingml/2006/main">
               <a:ext uri="{FF2B5EF4-FFF2-40B4-BE49-F238E27FC236}">
-                <a16:creationId xmlns:a16="http://schemas.microsoft.com/office/drawing/2014/main" id="{BF9F3DBD-DE68-42D5-B3E8-314F2FA3407B}"/>
+                <a16:creationId xmlns:a16="http://schemas.microsoft.com/office/drawing/2014/main" id="{65784F88-2AEF-4831-B53E-71B11845B67D}"/>
               </a:ext>
             </a:extLst>
           </p:cNvPr>
@@ -2207,7 +2207,7 @@
           <p:cNvPr id="4" name="Date Placeholder 3">
             <a:extLst xmlns:a="http://schemas.openxmlformats.org/drawingml/2006/main">
               <a:ext uri="{FF2B5EF4-FFF2-40B4-BE49-F238E27FC236}">
-                <a16:creationId xmlns:a16="http://schemas.microsoft.com/office/drawing/2014/main" id="{CCAB7E4D-A8F3-4F74-A78C-EDC5F525F0E1}"/>
+                <a16:creationId xmlns:a16="http://schemas.microsoft.com/office/drawing/2014/main" id="{D3E6366B-7A6D-4F7F-A0E4-959B5A570625}"/>
               </a:ext>
             </a:extLst>
           </p:cNvPr>
@@ -2235,7 +2235,7 @@
           <p:cNvPr id="5" name="Footer Placeholder 4">
             <a:extLst xmlns:a="http://schemas.openxmlformats.org/drawingml/2006/main">
               <a:ext uri="{FF2B5EF4-FFF2-40B4-BE49-F238E27FC236}">
-                <a16:creationId xmlns:a16="http://schemas.microsoft.com/office/drawing/2014/main" id="{7F647F8F-B2EE-4E47-BA7A-51532E77C702}"/>
+                <a16:creationId xmlns:a16="http://schemas.microsoft.com/office/drawing/2014/main" id="{FCBD9814-4A96-4941-B4A5-1F28EF2DFFFF}"/>
               </a:ext>
             </a:extLst>
           </p:cNvPr>
@@ -2260,7 +2260,7 @@
           <p:cNvPr id="6" name="Slide Number Placeholder 5">
             <a:extLst xmlns:a="http://schemas.openxmlformats.org/drawingml/2006/main">
               <a:ext uri="{FF2B5EF4-FFF2-40B4-BE49-F238E27FC236}">
-                <a16:creationId xmlns:a16="http://schemas.microsoft.com/office/drawing/2014/main" id="{D8025B27-0428-408E-A7F4-D5A82F2283BA}"/>
+                <a16:creationId xmlns:a16="http://schemas.microsoft.com/office/drawing/2014/main" id="{0A4EBB8F-C70E-45BC-8521-F76041E02438}"/>
               </a:ext>
             </a:extLst>
           </p:cNvPr>
@@ -2305,7 +2305,7 @@
           <p:cNvPr id="2" name="Title 1">
             <a:extLst xmlns:a="http://schemas.openxmlformats.org/drawingml/2006/main">
               <a:ext uri="{FF2B5EF4-FFF2-40B4-BE49-F238E27FC236}">
-                <a16:creationId xmlns:a16="http://schemas.microsoft.com/office/drawing/2014/main" id="{FB752766-9EEB-4F73-977C-CCEF04891969}"/>
+                <a16:creationId xmlns:a16="http://schemas.microsoft.com/office/drawing/2014/main" id="{0518EEA6-2721-49C7-80B8-E1E2792E068D}"/>
               </a:ext>
             </a:extLst>
           </p:cNvPr>
@@ -2343,7 +2343,7 @@
           <p:cNvPr id="3" name="Text Placeholder 2">
             <a:extLst xmlns:a="http://schemas.openxmlformats.org/drawingml/2006/main">
               <a:ext uri="{FF2B5EF4-FFF2-40B4-BE49-F238E27FC236}">
-                <a16:creationId xmlns:a16="http://schemas.microsoft.com/office/drawing/2014/main" id="{651A21AC-E8EF-418B-A6C7-E40642C66F4B}"/>
+                <a16:creationId xmlns:a16="http://schemas.microsoft.com/office/drawing/2014/main" id="{D8A3AE00-5548-4027-A857-AD7BE26624BB}"/>
               </a:ext>
             </a:extLst>
           </p:cNvPr>
@@ -2469,7 +2469,7 @@
           <p:cNvPr id="4" name="Date Placeholder 3">
             <a:extLst xmlns:a="http://schemas.openxmlformats.org/drawingml/2006/main">
               <a:ext uri="{FF2B5EF4-FFF2-40B4-BE49-F238E27FC236}">
-                <a16:creationId xmlns:a16="http://schemas.microsoft.com/office/drawing/2014/main" id="{66A9DA65-A784-469F-94B5-5E0804353FF2}"/>
+                <a16:creationId xmlns:a16="http://schemas.microsoft.com/office/drawing/2014/main" id="{1BFEC21A-521B-4839-9B2F-CC782E7154C5}"/>
               </a:ext>
             </a:extLst>
           </p:cNvPr>
@@ -2497,7 +2497,7 @@
           <p:cNvPr id="5" name="Footer Placeholder 4">
             <a:extLst xmlns:a="http://schemas.openxmlformats.org/drawingml/2006/main">
               <a:ext uri="{FF2B5EF4-FFF2-40B4-BE49-F238E27FC236}">
-                <a16:creationId xmlns:a16="http://schemas.microsoft.com/office/drawing/2014/main" id="{E876F281-0F56-43AE-A25F-96B668616876}"/>
+                <a16:creationId xmlns:a16="http://schemas.microsoft.com/office/drawing/2014/main" id="{FF593524-9A90-4836-86FD-E844F3896774}"/>
               </a:ext>
             </a:extLst>
           </p:cNvPr>
@@ -2522,7 +2522,7 @@
           <p:cNvPr id="6" name="Slide Number Placeholder 5">
             <a:extLst xmlns:a="http://schemas.openxmlformats.org/drawingml/2006/main">
               <a:ext uri="{FF2B5EF4-FFF2-40B4-BE49-F238E27FC236}">
-                <a16:creationId xmlns:a16="http://schemas.microsoft.com/office/drawing/2014/main" id="{098D2D50-4CDC-46B8-9855-A514CDFF5C02}"/>
+                <a16:creationId xmlns:a16="http://schemas.microsoft.com/office/drawing/2014/main" id="{FC30DBEE-719F-4BCB-9B56-35A31F26977B}"/>
               </a:ext>
             </a:extLst>
           </p:cNvPr>
@@ -2567,7 +2567,7 @@
           <p:cNvPr id="2" name="Title 1">
             <a:extLst xmlns:a="http://schemas.openxmlformats.org/drawingml/2006/main">
               <a:ext uri="{FF2B5EF4-FFF2-40B4-BE49-F238E27FC236}">
-                <a16:creationId xmlns:a16="http://schemas.microsoft.com/office/drawing/2014/main" id="{64799438-55D5-4A51-95EB-3DB14056BC4F}"/>
+                <a16:creationId xmlns:a16="http://schemas.microsoft.com/office/drawing/2014/main" id="{5B5C6482-3AEB-42AA-BD4B-AE7A61F58598}"/>
               </a:ext>
             </a:extLst>
           </p:cNvPr>
@@ -2595,7 +2595,7 @@
           <p:cNvPr id="3" name="Content Placeholder 2">
             <a:extLst xmlns:a="http://schemas.openxmlformats.org/drawingml/2006/main">
               <a:ext uri="{FF2B5EF4-FFF2-40B4-BE49-F238E27FC236}">
-                <a16:creationId xmlns:a16="http://schemas.microsoft.com/office/drawing/2014/main" id="{E93C7818-1A15-4BEC-8EFE-2A06F8BB599B}"/>
+                <a16:creationId xmlns:a16="http://schemas.microsoft.com/office/drawing/2014/main" id="{2C529F22-117F-4B62-ACDE-6D76BB7E6CC0}"/>
               </a:ext>
             </a:extLst>
           </p:cNvPr>
@@ -2700,7 +2700,7 @@
           <p:cNvPr id="4" name="Content Placeholder 3">
             <a:extLst xmlns:a="http://schemas.openxmlformats.org/drawingml/2006/main">
               <a:ext uri="{FF2B5EF4-FFF2-40B4-BE49-F238E27FC236}">
-                <a16:creationId xmlns:a16="http://schemas.microsoft.com/office/drawing/2014/main" id="{8C81FBC7-EEE2-4B12-B751-7CF228446BFE}"/>
+                <a16:creationId xmlns:a16="http://schemas.microsoft.com/office/drawing/2014/main" id="{E2A6B91E-B3EF-4B7E-90E5-C8545B08A2B4}"/>
               </a:ext>
             </a:extLst>
           </p:cNvPr>
@@ -2805,7 +2805,7 @@
           <p:cNvPr id="5" name="Date Placeholder 4">
             <a:extLst xmlns:a="http://schemas.openxmlformats.org/drawingml/2006/main">
               <a:ext uri="{FF2B5EF4-FFF2-40B4-BE49-F238E27FC236}">
-                <a16:creationId xmlns:a16="http://schemas.microsoft.com/office/drawing/2014/main" id="{239E2E21-1FDB-44D0-8DC6-0376FFBDA272}"/>
+                <a16:creationId xmlns:a16="http://schemas.microsoft.com/office/drawing/2014/main" id="{22496858-1FC6-4448-949D-AE6E214D3DE8}"/>
               </a:ext>
             </a:extLst>
           </p:cNvPr>
@@ -2833,7 +2833,7 @@
           <p:cNvPr id="6" name="Footer Placeholder 5">
             <a:extLst xmlns:a="http://schemas.openxmlformats.org/drawingml/2006/main">
               <a:ext uri="{FF2B5EF4-FFF2-40B4-BE49-F238E27FC236}">
-                <a16:creationId xmlns:a16="http://schemas.microsoft.com/office/drawing/2014/main" id="{9A28128A-6406-43FF-B760-389309337F43}"/>
+                <a16:creationId xmlns:a16="http://schemas.microsoft.com/office/drawing/2014/main" id="{386A89CF-8608-48A5-B162-AD44C1B3B0E3}"/>
               </a:ext>
             </a:extLst>
           </p:cNvPr>
@@ -2858,7 +2858,7 @@
           <p:cNvPr id="7" name="Slide Number Placeholder 6">
             <a:extLst xmlns:a="http://schemas.openxmlformats.org/drawingml/2006/main">
               <a:ext uri="{FF2B5EF4-FFF2-40B4-BE49-F238E27FC236}">
-                <a16:creationId xmlns:a16="http://schemas.microsoft.com/office/drawing/2014/main" id="{B270A717-E884-4054-8330-C2C5EC76F7F1}"/>
+                <a16:creationId xmlns:a16="http://schemas.microsoft.com/office/drawing/2014/main" id="{D6D909E3-7464-4CF9-BE4B-6209835659D2}"/>
               </a:ext>
             </a:extLst>
           </p:cNvPr>
@@ -2903,7 +2903,7 @@
           <p:cNvPr id="2" name="Title 1">
             <a:extLst xmlns:a="http://schemas.openxmlformats.org/drawingml/2006/main">
               <a:ext uri="{FF2B5EF4-FFF2-40B4-BE49-F238E27FC236}">
-                <a16:creationId xmlns:a16="http://schemas.microsoft.com/office/drawing/2014/main" id="{24845E40-C47D-4002-8157-D443930EBE5C}"/>
+                <a16:creationId xmlns:a16="http://schemas.microsoft.com/office/drawing/2014/main" id="{A54F120A-4992-4CD5-8ADA-F0D3BBDB6CB1}"/>
               </a:ext>
             </a:extLst>
           </p:cNvPr>
@@ -2936,7 +2936,7 @@
           <p:cNvPr id="3" name="Text Placeholder 2">
             <a:extLst xmlns:a="http://schemas.openxmlformats.org/drawingml/2006/main">
               <a:ext uri="{FF2B5EF4-FFF2-40B4-BE49-F238E27FC236}">
-                <a16:creationId xmlns:a16="http://schemas.microsoft.com/office/drawing/2014/main" id="{1E96EFB5-1B8E-4342-9691-0C62C7C2D9B5}"/>
+                <a16:creationId xmlns:a16="http://schemas.microsoft.com/office/drawing/2014/main" id="{B44291D3-8E8D-40E8-B3E8-1FD78BEA7039}"/>
               </a:ext>
             </a:extLst>
           </p:cNvPr>
@@ -3008,7 +3008,7 @@
           <p:cNvPr id="4" name="Content Placeholder 3">
             <a:extLst xmlns:a="http://schemas.openxmlformats.org/drawingml/2006/main">
               <a:ext uri="{FF2B5EF4-FFF2-40B4-BE49-F238E27FC236}">
-                <a16:creationId xmlns:a16="http://schemas.microsoft.com/office/drawing/2014/main" id="{464CD47F-290F-4FF4-9E4C-4151EB68E7CA}"/>
+                <a16:creationId xmlns:a16="http://schemas.microsoft.com/office/drawing/2014/main" id="{E4F6738C-6D25-440F-8288-C732A1B0EFAD}"/>
               </a:ext>
             </a:extLst>
           </p:cNvPr>
@@ -3113,7 +3113,7 @@
           <p:cNvPr id="5" name="Text Placeholder 4">
             <a:extLst xmlns:a="http://schemas.openxmlformats.org/drawingml/2006/main">
               <a:ext uri="{FF2B5EF4-FFF2-40B4-BE49-F238E27FC236}">
-                <a16:creationId xmlns:a16="http://schemas.microsoft.com/office/drawing/2014/main" id="{F14706D8-5331-49DD-9CCB-0A9E11E2076D}"/>
+                <a16:creationId xmlns:a16="http://schemas.microsoft.com/office/drawing/2014/main" id="{C2C547C3-A5A8-4DD5-A136-79B5DA444CCB}"/>
               </a:ext>
             </a:extLst>
           </p:cNvPr>
@@ -3185,7 +3185,7 @@
           <p:cNvPr id="6" name="Content Placeholder 5">
             <a:extLst xmlns:a="http://schemas.openxmlformats.org/drawingml/2006/main">
               <a:ext uri="{FF2B5EF4-FFF2-40B4-BE49-F238E27FC236}">
-                <a16:creationId xmlns:a16="http://schemas.microsoft.com/office/drawing/2014/main" id="{784B49AB-52BC-4DBA-894B-516FB65D4E8F}"/>
+                <a16:creationId xmlns:a16="http://schemas.microsoft.com/office/drawing/2014/main" id="{EA9778E9-7688-44E7-9FF0-6BFAD43FF398}"/>
               </a:ext>
             </a:extLst>
           </p:cNvPr>
@@ -3290,7 +3290,7 @@
           <p:cNvPr id="7" name="Date Placeholder 6">
             <a:extLst xmlns:a="http://schemas.openxmlformats.org/drawingml/2006/main">
               <a:ext uri="{FF2B5EF4-FFF2-40B4-BE49-F238E27FC236}">
-                <a16:creationId xmlns:a16="http://schemas.microsoft.com/office/drawing/2014/main" id="{BC1A8D54-CF63-4822-9F7F-12B298680411}"/>
+                <a16:creationId xmlns:a16="http://schemas.microsoft.com/office/drawing/2014/main" id="{FA5E5DF9-8ADA-4F51-815F-4FBAEAACB472}"/>
               </a:ext>
             </a:extLst>
           </p:cNvPr>
@@ -3318,7 +3318,7 @@
           <p:cNvPr id="8" name="Footer Placeholder 7">
             <a:extLst xmlns:a="http://schemas.openxmlformats.org/drawingml/2006/main">
               <a:ext uri="{FF2B5EF4-FFF2-40B4-BE49-F238E27FC236}">
-                <a16:creationId xmlns:a16="http://schemas.microsoft.com/office/drawing/2014/main" id="{79BE4C40-6D7C-4D98-AD66-8B8FFD3E699B}"/>
+                <a16:creationId xmlns:a16="http://schemas.microsoft.com/office/drawing/2014/main" id="{0BCFD174-7958-4EE7-94FD-E4A1FC7CEB4B}"/>
               </a:ext>
             </a:extLst>
           </p:cNvPr>
@@ -3343,7 +3343,7 @@
           <p:cNvPr id="9" name="Slide Number Placeholder 8">
             <a:extLst xmlns:a="http://schemas.openxmlformats.org/drawingml/2006/main">
               <a:ext uri="{FF2B5EF4-FFF2-40B4-BE49-F238E27FC236}">
-                <a16:creationId xmlns:a16="http://schemas.microsoft.com/office/drawing/2014/main" id="{9F3E7F25-807D-4EB7-BC2E-3549B9EEF0FE}"/>
+                <a16:creationId xmlns:a16="http://schemas.microsoft.com/office/drawing/2014/main" id="{0C4A39FD-6EC2-4661-B55A-58D47F90E0A4}"/>
               </a:ext>
             </a:extLst>
           </p:cNvPr>
@@ -3388,7 +3388,7 @@
           <p:cNvPr id="2" name="Title 1">
             <a:extLst xmlns:a="http://schemas.openxmlformats.org/drawingml/2006/main">
               <a:ext uri="{FF2B5EF4-FFF2-40B4-BE49-F238E27FC236}">
-                <a16:creationId xmlns:a16="http://schemas.microsoft.com/office/drawing/2014/main" id="{E5EB5881-B954-42DF-8F6E-B662D0856A5A}"/>
+                <a16:creationId xmlns:a16="http://schemas.microsoft.com/office/drawing/2014/main" id="{B176DCB0-7EF1-4111-819E-1EE6AAD661FA}"/>
               </a:ext>
             </a:extLst>
           </p:cNvPr>
@@ -3416,7 +3416,7 @@
           <p:cNvPr id="3" name="Date Placeholder 2">
             <a:extLst xmlns:a="http://schemas.openxmlformats.org/drawingml/2006/main">
               <a:ext uri="{FF2B5EF4-FFF2-40B4-BE49-F238E27FC236}">
-                <a16:creationId xmlns:a16="http://schemas.microsoft.com/office/drawing/2014/main" id="{0635A201-5DBC-4CB3-8A1C-7C82DCB78A5B}"/>
+                <a16:creationId xmlns:a16="http://schemas.microsoft.com/office/drawing/2014/main" id="{7D0973DD-3974-4DE3-9701-98009BC4BDAB}"/>
               </a:ext>
             </a:extLst>
           </p:cNvPr>
@@ -3444,7 +3444,7 @@
           <p:cNvPr id="4" name="Footer Placeholder 3">
             <a:extLst xmlns:a="http://schemas.openxmlformats.org/drawingml/2006/main">
               <a:ext uri="{FF2B5EF4-FFF2-40B4-BE49-F238E27FC236}">
-                <a16:creationId xmlns:a16="http://schemas.microsoft.com/office/drawing/2014/main" id="{3C64F76B-3451-4CD5-9066-4DAB686419AF}"/>
+                <a16:creationId xmlns:a16="http://schemas.microsoft.com/office/drawing/2014/main" id="{7D623FE4-5043-49A0-913B-DA4E3B8251EA}"/>
               </a:ext>
             </a:extLst>
           </p:cNvPr>
@@ -3469,7 +3469,7 @@
           <p:cNvPr id="5" name="Slide Number Placeholder 4">
             <a:extLst xmlns:a="http://schemas.openxmlformats.org/drawingml/2006/main">
               <a:ext uri="{FF2B5EF4-FFF2-40B4-BE49-F238E27FC236}">
-                <a16:creationId xmlns:a16="http://schemas.microsoft.com/office/drawing/2014/main" id="{915B899A-ED0B-4C7F-A5D0-C72DC37F9B72}"/>
+                <a16:creationId xmlns:a16="http://schemas.microsoft.com/office/drawing/2014/main" id="{95295E1E-02EC-45F0-9B9D-6B0A36CA51C2}"/>
               </a:ext>
             </a:extLst>
           </p:cNvPr>
@@ -3514,7 +3514,7 @@
           <p:cNvPr id="2" name="Date Placeholder 1">
             <a:extLst xmlns:a="http://schemas.openxmlformats.org/drawingml/2006/main">
               <a:ext uri="{FF2B5EF4-FFF2-40B4-BE49-F238E27FC236}">
-                <a16:creationId xmlns:a16="http://schemas.microsoft.com/office/drawing/2014/main" id="{82356100-759E-45A1-B2CA-7421D316EEFC}"/>
+                <a16:creationId xmlns:a16="http://schemas.microsoft.com/office/drawing/2014/main" id="{8F6191BA-351C-47D5-866F-12D38CDC7806}"/>
               </a:ext>
             </a:extLst>
           </p:cNvPr>
@@ -3542,7 +3542,7 @@
           <p:cNvPr id="3" name="Footer Placeholder 2">
             <a:extLst xmlns:a="http://schemas.openxmlformats.org/drawingml/2006/main">
               <a:ext uri="{FF2B5EF4-FFF2-40B4-BE49-F238E27FC236}">
-                <a16:creationId xmlns:a16="http://schemas.microsoft.com/office/drawing/2014/main" id="{978ECD1F-09DD-478D-ACF5-CE24D0BE0E13}"/>
+                <a16:creationId xmlns:a16="http://schemas.microsoft.com/office/drawing/2014/main" id="{965DF5FA-113A-4775-994A-2BF5AD345F79}"/>
               </a:ext>
             </a:extLst>
           </p:cNvPr>
@@ -3567,7 +3567,7 @@
           <p:cNvPr id="4" name="Slide Number Placeholder 3">
             <a:extLst xmlns:a="http://schemas.openxmlformats.org/drawingml/2006/main">
               <a:ext uri="{FF2B5EF4-FFF2-40B4-BE49-F238E27FC236}">
-                <a16:creationId xmlns:a16="http://schemas.microsoft.com/office/drawing/2014/main" id="{193D24A5-AB28-4728-ACA8-8D5BD7146EB7}"/>
+                <a16:creationId xmlns:a16="http://schemas.microsoft.com/office/drawing/2014/main" id="{721DC5CB-0DD7-4E10-9D60-5A5E82D21926}"/>
               </a:ext>
             </a:extLst>
           </p:cNvPr>
@@ -3612,7 +3612,7 @@
           <p:cNvPr id="2" name="Title 1">
             <a:extLst xmlns:a="http://schemas.openxmlformats.org/drawingml/2006/main">
               <a:ext uri="{FF2B5EF4-FFF2-40B4-BE49-F238E27FC236}">
-                <a16:creationId xmlns:a16="http://schemas.microsoft.com/office/drawing/2014/main" id="{4D890F7C-87DE-4AB2-93B2-F3FA48F5AABE}"/>
+                <a16:creationId xmlns:a16="http://schemas.microsoft.com/office/drawing/2014/main" id="{9232F6BC-88E3-4F13-8254-7F1021CA8EAB}"/>
               </a:ext>
             </a:extLst>
           </p:cNvPr>
@@ -3650,7 +3650,7 @@
           <p:cNvPr id="3" name="Content Placeholder 2">
             <a:extLst xmlns:a="http://schemas.openxmlformats.org/drawingml/2006/main">
               <a:ext uri="{FF2B5EF4-FFF2-40B4-BE49-F238E27FC236}">
-                <a16:creationId xmlns:a16="http://schemas.microsoft.com/office/drawing/2014/main" id="{E63DF2AE-272B-4407-B052-3452797DEB30}"/>
+                <a16:creationId xmlns:a16="http://schemas.microsoft.com/office/drawing/2014/main" id="{247FBDC6-1FF4-435F-B9AF-1C5D027BB45D}"/>
               </a:ext>
             </a:extLst>
           </p:cNvPr>
@@ -3755,7 +3755,7 @@
           <p:cNvPr id="4" name="Text Placeholder 3">
             <a:extLst xmlns:a="http://schemas.openxmlformats.org/drawingml/2006/main">
               <a:ext uri="{FF2B5EF4-FFF2-40B4-BE49-F238E27FC236}">
-                <a16:creationId xmlns:a16="http://schemas.microsoft.com/office/drawing/2014/main" id="{F3156436-06B9-4CBD-8A73-B4558BBADEEF}"/>
+                <a16:creationId xmlns:a16="http://schemas.microsoft.com/office/drawing/2014/main" id="{BA621BD8-C41F-4824-BD03-CBA5F4EE1CC5}"/>
               </a:ext>
             </a:extLst>
           </p:cNvPr>
@@ -3827,7 +3827,7 @@
           <p:cNvPr id="5" name="Date Placeholder 4">
             <a:extLst xmlns:a="http://schemas.openxmlformats.org/drawingml/2006/main">
               <a:ext uri="{FF2B5EF4-FFF2-40B4-BE49-F238E27FC236}">
-                <a16:creationId xmlns:a16="http://schemas.microsoft.com/office/drawing/2014/main" id="{B778FCE6-759D-40BA-ACB4-78FF175DD1BF}"/>
+                <a16:creationId xmlns:a16="http://schemas.microsoft.com/office/drawing/2014/main" id="{4C31CEF4-20B2-49E5-B9AA-B1B25F9815DC}"/>
               </a:ext>
             </a:extLst>
           </p:cNvPr>
@@ -3855,7 +3855,7 @@
           <p:cNvPr id="6" name="Footer Placeholder 5">
             <a:extLst xmlns:a="http://schemas.openxmlformats.org/drawingml/2006/main">
               <a:ext uri="{FF2B5EF4-FFF2-40B4-BE49-F238E27FC236}">
-                <a16:creationId xmlns:a16="http://schemas.microsoft.com/office/drawing/2014/main" id="{C54A3AC8-5E92-4986-B156-B84D6871588E}"/>
+                <a16:creationId xmlns:a16="http://schemas.microsoft.com/office/drawing/2014/main" id="{F3997A19-A6C3-43E7-A2C9-1D8B4DA70D43}"/>
               </a:ext>
             </a:extLst>
           </p:cNvPr>
@@ -3880,7 +3880,7 @@
           <p:cNvPr id="7" name="Slide Number Placeholder 6">
             <a:extLst xmlns:a="http://schemas.openxmlformats.org/drawingml/2006/main">
               <a:ext uri="{FF2B5EF4-FFF2-40B4-BE49-F238E27FC236}">
-                <a16:creationId xmlns:a16="http://schemas.microsoft.com/office/drawing/2014/main" id="{A50520FA-9EB4-47FE-BD19-46D2205E6D3E}"/>
+                <a16:creationId xmlns:a16="http://schemas.microsoft.com/office/drawing/2014/main" id="{11E59FF3-C9D3-4AEB-8C69-B0C5057427E4}"/>
               </a:ext>
             </a:extLst>
           </p:cNvPr>
@@ -3925,7 +3925,7 @@
           <p:cNvPr id="2" name="Title 1">
             <a:extLst xmlns:a="http://schemas.openxmlformats.org/drawingml/2006/main">
               <a:ext uri="{FF2B5EF4-FFF2-40B4-BE49-F238E27FC236}">
-                <a16:creationId xmlns:a16="http://schemas.microsoft.com/office/drawing/2014/main" id="{DAA4E35C-D902-4FAE-B1A3-B604CB24A81D}"/>
+                <a16:creationId xmlns:a16="http://schemas.microsoft.com/office/drawing/2014/main" id="{001D7CD4-DD4E-471A-AC69-FEBA50DEB75E}"/>
               </a:ext>
             </a:extLst>
           </p:cNvPr>
@@ -3963,7 +3963,7 @@
           <p:cNvPr id="3" name="Picture Placeholder 2">
             <a:extLst xmlns:a="http://schemas.openxmlformats.org/drawingml/2006/main">
               <a:ext uri="{FF2B5EF4-FFF2-40B4-BE49-F238E27FC236}">
-                <a16:creationId xmlns:a16="http://schemas.microsoft.com/office/drawing/2014/main" id="{CFA20441-FC64-4A45-B50B-8B479B32CB72}"/>
+                <a16:creationId xmlns:a16="http://schemas.microsoft.com/office/drawing/2014/main" id="{C2A508DA-138C-4347-99C1-D8BAF9D9D793}"/>
               </a:ext>
             </a:extLst>
           </p:cNvPr>
@@ -4030,7 +4030,7 @@
           <p:cNvPr id="4" name="Text Placeholder 3">
             <a:extLst xmlns:a="http://schemas.openxmlformats.org/drawingml/2006/main">
               <a:ext uri="{FF2B5EF4-FFF2-40B4-BE49-F238E27FC236}">
-                <a16:creationId xmlns:a16="http://schemas.microsoft.com/office/drawing/2014/main" id="{8CC31745-D231-49C6-BF66-B96B710BA85A}"/>
+                <a16:creationId xmlns:a16="http://schemas.microsoft.com/office/drawing/2014/main" id="{BC5EB1A8-6E76-418F-862C-4AA2A8FC543B}"/>
               </a:ext>
             </a:extLst>
           </p:cNvPr>
@@ -4102,7 +4102,7 @@
           <p:cNvPr id="5" name="Date Placeholder 4">
             <a:extLst xmlns:a="http://schemas.openxmlformats.org/drawingml/2006/main">
               <a:ext uri="{FF2B5EF4-FFF2-40B4-BE49-F238E27FC236}">
-                <a16:creationId xmlns:a16="http://schemas.microsoft.com/office/drawing/2014/main" id="{604D39A6-C1C9-4F2C-97A5-ACD98EAFBF53}"/>
+                <a16:creationId xmlns:a16="http://schemas.microsoft.com/office/drawing/2014/main" id="{FD8CABE8-E38D-4E9B-A6DC-6F5114584440}"/>
               </a:ext>
             </a:extLst>
           </p:cNvPr>
@@ -4130,7 +4130,7 @@
           <p:cNvPr id="6" name="Footer Placeholder 5">
             <a:extLst xmlns:a="http://schemas.openxmlformats.org/drawingml/2006/main">
               <a:ext uri="{FF2B5EF4-FFF2-40B4-BE49-F238E27FC236}">
-                <a16:creationId xmlns:a16="http://schemas.microsoft.com/office/drawing/2014/main" id="{C4A1C3D5-107A-46E0-8EFC-A9811FC4251D}"/>
+                <a16:creationId xmlns:a16="http://schemas.microsoft.com/office/drawing/2014/main" id="{58ADA187-743D-4610-8AFB-F22078916186}"/>
               </a:ext>
             </a:extLst>
           </p:cNvPr>
@@ -4155,7 +4155,7 @@
           <p:cNvPr id="7" name="Slide Number Placeholder 6">
             <a:extLst xmlns:a="http://schemas.openxmlformats.org/drawingml/2006/main">
               <a:ext uri="{FF2B5EF4-FFF2-40B4-BE49-F238E27FC236}">
-                <a16:creationId xmlns:a16="http://schemas.microsoft.com/office/drawing/2014/main" id="{5F264B52-A755-4B58-B841-A242024DCC08}"/>
+                <a16:creationId xmlns:a16="http://schemas.microsoft.com/office/drawing/2014/main" id="{2778182B-5063-4F08-8EF3-E1B400935654}"/>
               </a:ext>
             </a:extLst>
           </p:cNvPr>
@@ -4205,7 +4205,7 @@
           <p:cNvPr id="2" name="Title Placeholder 1">
             <a:extLst xmlns:a="http://schemas.openxmlformats.org/drawingml/2006/main">
               <a:ext uri="{FF2B5EF4-FFF2-40B4-BE49-F238E27FC236}">
-                <a16:creationId xmlns:a16="http://schemas.microsoft.com/office/drawing/2014/main" id="{5DDE2631-86AA-42AA-829E-068F607F5DC3}"/>
+                <a16:creationId xmlns:a16="http://schemas.microsoft.com/office/drawing/2014/main" id="{FC840009-D4F9-4C04-9C15-6C9053D2098F}"/>
               </a:ext>
             </a:extLst>
           </p:cNvPr>
@@ -4243,7 +4243,7 @@
           <p:cNvPr id="3" name="Text Placeholder 2">
             <a:extLst xmlns:a="http://schemas.openxmlformats.org/drawingml/2006/main">
               <a:ext uri="{FF2B5EF4-FFF2-40B4-BE49-F238E27FC236}">
-                <a16:creationId xmlns:a16="http://schemas.microsoft.com/office/drawing/2014/main" id="{6C078771-90E4-4616-A442-0995F09588A4}"/>
+                <a16:creationId xmlns:a16="http://schemas.microsoft.com/office/drawing/2014/main" id="{C6F3E2ED-EECA-4035-B9F8-8610D3DCD015}"/>
               </a:ext>
             </a:extLst>
           </p:cNvPr>
@@ -4316,7 +4316,7 @@
           <p:cNvPr id="4" name="Date Placeholder 3">
             <a:extLst xmlns:a="http://schemas.openxmlformats.org/drawingml/2006/main">
               <a:ext uri="{FF2B5EF4-FFF2-40B4-BE49-F238E27FC236}">
-                <a16:creationId xmlns:a16="http://schemas.microsoft.com/office/drawing/2014/main" id="{75C976F7-64CA-4588-A2A1-824724793A49}"/>
+                <a16:creationId xmlns:a16="http://schemas.microsoft.com/office/drawing/2014/main" id="{C9A5D752-CFFE-4890-A117-EC36BE3DF964}"/>
               </a:ext>
             </a:extLst>
           </p:cNvPr>
@@ -4363,7 +4363,7 @@
           <p:cNvPr id="5" name="Footer Placeholder 4">
             <a:extLst xmlns:a="http://schemas.openxmlformats.org/drawingml/2006/main">
               <a:ext uri="{FF2B5EF4-FFF2-40B4-BE49-F238E27FC236}">
-                <a16:creationId xmlns:a16="http://schemas.microsoft.com/office/drawing/2014/main" id="{40875688-3438-4F26-9511-6DF107EA02FB}"/>
+                <a16:creationId xmlns:a16="http://schemas.microsoft.com/office/drawing/2014/main" id="{ECD0ADE8-AE2D-425E-805B-8622460D30E0}"/>
               </a:ext>
             </a:extLst>
           </p:cNvPr>
@@ -4407,7 +4407,7 @@
           <p:cNvPr id="6" name="Slide Number Placeholder 5">
             <a:extLst xmlns:a="http://schemas.openxmlformats.org/drawingml/2006/main">
               <a:ext uri="{FF2B5EF4-FFF2-40B4-BE49-F238E27FC236}">
-                <a16:creationId xmlns:a16="http://schemas.microsoft.com/office/drawing/2014/main" id="{88852BC9-8A34-45D2-B5A5-FB29C43DCC9A}"/>
+                <a16:creationId xmlns:a16="http://schemas.microsoft.com/office/drawing/2014/main" id="{1C8712A2-92BF-4CAF-B167-561130759AD2}"/>
               </a:ext>
             </a:extLst>
           </p:cNvPr>
@@ -4453,17 +4453,17 @@
   </p:cSld>
   <p:clrMap bg1="lt1" tx1="dk1" bg2="lt2" tx2="dk2" accent1="accent1" accent2="accent2" accent3="accent3" accent4="accent4" accent5="accent5" accent6="accent6" hlink="hlink" folHlink="folHlink"/>
   <p:sldLayoutIdLst>
-    <p:sldLayoutId xmlns:r="http://schemas.openxmlformats.org/officeDocument/2006/relationships" id="2147483649" r:id="Rd33413fb18464a26"/>
-    <p:sldLayoutId xmlns:r="http://schemas.openxmlformats.org/officeDocument/2006/relationships" id="2147483650" r:id="Ra5e36e02a2e342d6"/>
-    <p:sldLayoutId xmlns:r="http://schemas.openxmlformats.org/officeDocument/2006/relationships" id="2147483651" r:id="R57a007aef86d4a12"/>
-    <p:sldLayoutId xmlns:r="http://schemas.openxmlformats.org/officeDocument/2006/relationships" id="2147483652" r:id="Rd5e2c05dc05548da"/>
-    <p:sldLayoutId xmlns:r="http://schemas.openxmlformats.org/officeDocument/2006/relationships" id="2147483653" r:id="R3c9c6a8b409b448d"/>
-    <p:sldLayoutId xmlns:r="http://schemas.openxmlformats.org/officeDocument/2006/relationships" id="2147483654" r:id="R631911e196f64b40"/>
-    <p:sldLayoutId xmlns:r="http://schemas.openxmlformats.org/officeDocument/2006/relationships" id="2147483655" r:id="R06cb99945c574c52"/>
-    <p:sldLayoutId xmlns:r="http://schemas.openxmlformats.org/officeDocument/2006/relationships" id="2147483656" r:id="R80d2e9b162fb46ed"/>
-    <p:sldLayoutId xmlns:r="http://schemas.openxmlformats.org/officeDocument/2006/relationships" id="2147483657" r:id="R6f4cd660ba3a48e6"/>
-    <p:sldLayoutId xmlns:r="http://schemas.openxmlformats.org/officeDocument/2006/relationships" id="2147483658" r:id="R2b4ab3271c4c4143"/>
-    <p:sldLayoutId xmlns:r="http://schemas.openxmlformats.org/officeDocument/2006/relationships" id="2147483659" r:id="Rdfdc813dcbd0457c"/>
+    <p:sldLayoutId xmlns:r="http://schemas.openxmlformats.org/officeDocument/2006/relationships" id="2147483649" r:id="Raf3922c657e44813"/>
+    <p:sldLayoutId xmlns:r="http://schemas.openxmlformats.org/officeDocument/2006/relationships" id="2147483650" r:id="Raf271fbccecc4f0d"/>
+    <p:sldLayoutId xmlns:r="http://schemas.openxmlformats.org/officeDocument/2006/relationships" id="2147483651" r:id="R748e3af98f4e4cba"/>
+    <p:sldLayoutId xmlns:r="http://schemas.openxmlformats.org/officeDocument/2006/relationships" id="2147483652" r:id="R36e687991f8b4b11"/>
+    <p:sldLayoutId xmlns:r="http://schemas.openxmlformats.org/officeDocument/2006/relationships" id="2147483653" r:id="Rac7108310a994338"/>
+    <p:sldLayoutId xmlns:r="http://schemas.openxmlformats.org/officeDocument/2006/relationships" id="2147483654" r:id="R599bc1c7e8994ad4"/>
+    <p:sldLayoutId xmlns:r="http://schemas.openxmlformats.org/officeDocument/2006/relationships" id="2147483655" r:id="R890c9ce882604687"/>
+    <p:sldLayoutId xmlns:r="http://schemas.openxmlformats.org/officeDocument/2006/relationships" id="2147483656" r:id="Rdc5c4628d8ef4650"/>
+    <p:sldLayoutId xmlns:r="http://schemas.openxmlformats.org/officeDocument/2006/relationships" id="2147483657" r:id="R4d9e8236b1944f07"/>
+    <p:sldLayoutId xmlns:r="http://schemas.openxmlformats.org/officeDocument/2006/relationships" id="2147483658" r:id="Rf57c43459e3444d4"/>
+    <p:sldLayoutId xmlns:r="http://schemas.openxmlformats.org/officeDocument/2006/relationships" id="2147483659" r:id="R5694e51afd7e4fd8"/>
   </p:sldLayoutIdLst>
   <p:txStyles>
     <p:titleStyle>
@@ -5009,7 +5009,7 @@
           <p:cNvPr id="2" name="Rectangle 1">
             <a:extLst xmlns:a="http://schemas.openxmlformats.org/drawingml/2006/main">
               <a:ext uri="{FF2B5EF4-FFF2-40B4-BE49-F238E27FC236}">
-                <a16:creationId xmlns:a16="http://schemas.microsoft.com/office/drawing/2014/main" id="{EA9DDCA1-F914-4684-BDA6-211AC0C8CA5D}"/>
+                <a16:creationId xmlns:a16="http://schemas.microsoft.com/office/drawing/2014/main" id="{D76A1697-90F4-4B99-9BC8-C5CA394025C1}"/>
               </a:ext>
             </a:extLst>
           </p:cNvPr>
@@ -5062,7 +5062,7 @@
           <p:cNvPr id="3" name="Rectangle 2">
             <a:extLst xmlns:a="http://schemas.openxmlformats.org/drawingml/2006/main">
               <a:ext uri="{FF2B5EF4-FFF2-40B4-BE49-F238E27FC236}">
-                <a16:creationId xmlns:a16="http://schemas.microsoft.com/office/drawing/2014/main" id="{33933F27-0073-4242-98C3-5946DAF06647}"/>
+                <a16:creationId xmlns:a16="http://schemas.microsoft.com/office/drawing/2014/main" id="{C16B95B4-DDB9-4778-BA1D-1F24CB1F04C2}"/>
               </a:ext>
             </a:extLst>
           </p:cNvPr>
@@ -5115,7 +5115,7 @@
           <p:cNvPr id="4" name="TextBox 3">
             <a:extLst xmlns:a="http://schemas.openxmlformats.org/drawingml/2006/main">
               <a:ext uri="{FF2B5EF4-FFF2-40B4-BE49-F238E27FC236}">
-                <a16:creationId xmlns:a16="http://schemas.microsoft.com/office/drawing/2014/main" id="{39847C33-39CB-4870-BE4E-331573B0CA41}"/>
+                <a16:creationId xmlns:a16="http://schemas.microsoft.com/office/drawing/2014/main" id="{EA6FB49C-DC38-4A45-897C-146F28B3D9CE}"/>
               </a:ext>
             </a:extLst>
           </p:cNvPr>
@@ -5217,7 +5217,7 @@
     </p:spTree>
     <p:extLst>
       <p:ext uri="{BB962C8B-B14F-4D97-AF65-F5344CB8AC3E}">
-        <p14:creationId xmlns:p14="http://schemas.microsoft.com/office/powerpoint/2010/main" val="457345839"/>
+        <p14:creationId xmlns:p14="http://schemas.microsoft.com/office/powerpoint/2010/main" val="178200091"/>
       </p:ext>
     </p:extLst>
   </p:cSld>
@@ -5241,7 +5241,7 @@
           <p:cNvPr id="2" name="Rectangle 1">
             <a:extLst xmlns:a="http://schemas.openxmlformats.org/drawingml/2006/main">
               <a:ext uri="{FF2B5EF4-FFF2-40B4-BE49-F238E27FC236}">
-                <a16:creationId xmlns:a16="http://schemas.microsoft.com/office/drawing/2014/main" id="{CD450BF5-9446-4EE7-885A-704BDA244F37}"/>
+                <a16:creationId xmlns:a16="http://schemas.microsoft.com/office/drawing/2014/main" id="{8711F2B7-47CA-4D51-BC74-AA906703C970}"/>
               </a:ext>
             </a:extLst>
           </p:cNvPr>
@@ -5294,7 +5294,7 @@
           <p:cNvPr id="3" name="Rectangle 2">
             <a:extLst xmlns:a="http://schemas.openxmlformats.org/drawingml/2006/main">
               <a:ext uri="{FF2B5EF4-FFF2-40B4-BE49-F238E27FC236}">
-                <a16:creationId xmlns:a16="http://schemas.microsoft.com/office/drawing/2014/main" id="{AE858B1A-F398-42DF-903A-8CB5B264BCA6}"/>
+                <a16:creationId xmlns:a16="http://schemas.microsoft.com/office/drawing/2014/main" id="{ABEB9E9B-34CF-4D83-A82C-A1DB7ED9C826}"/>
               </a:ext>
             </a:extLst>
           </p:cNvPr>
@@ -5347,7 +5347,7 @@
           <p:cNvPr id="4" name="Rectangle 3">
             <a:extLst xmlns:a="http://schemas.openxmlformats.org/drawingml/2006/main">
               <a:ext uri="{FF2B5EF4-FFF2-40B4-BE49-F238E27FC236}">
-                <a16:creationId xmlns:a16="http://schemas.microsoft.com/office/drawing/2014/main" id="{4E4BFE5E-A993-4CB7-A231-2B167E16FEBD}"/>
+                <a16:creationId xmlns:a16="http://schemas.microsoft.com/office/drawing/2014/main" id="{888EC119-A4E6-4A4B-A61A-10F507921A12}"/>
               </a:ext>
             </a:extLst>
           </p:cNvPr>
@@ -5400,7 +5400,7 @@
           <p:cNvPr id="5" name="TextBox 4">
             <a:extLst xmlns:a="http://schemas.openxmlformats.org/drawingml/2006/main">
               <a:ext uri="{FF2B5EF4-FFF2-40B4-BE49-F238E27FC236}">
-                <a16:creationId xmlns:a16="http://schemas.microsoft.com/office/drawing/2014/main" id="{9E5D2F36-7CA8-46B7-8172-19594575E203}"/>
+                <a16:creationId xmlns:a16="http://schemas.microsoft.com/office/drawing/2014/main" id="{4E4E1A01-53AE-476E-831D-369ADB44A234}"/>
               </a:ext>
             </a:extLst>
           </p:cNvPr>
@@ -5463,7 +5463,7 @@
           <p:cNvPr id="6" name="Rounded Rectangle 5">
             <a:extLst xmlns:a="http://schemas.openxmlformats.org/drawingml/2006/main">
               <a:ext uri="{FF2B5EF4-FFF2-40B4-BE49-F238E27FC236}">
-                <a16:creationId xmlns:a16="http://schemas.microsoft.com/office/drawing/2014/main" id="{ED7CEF2C-EB15-4F19-BD36-5F57718E2E34}"/>
+                <a16:creationId xmlns:a16="http://schemas.microsoft.com/office/drawing/2014/main" id="{108ACEAE-9C7C-419F-8010-A0A4033809D8}"/>
               </a:ext>
             </a:extLst>
           </p:cNvPr>
@@ -5518,7 +5518,7 @@
           <p:cNvPr id="7" name="TextBox 6">
             <a:extLst xmlns:a="http://schemas.openxmlformats.org/drawingml/2006/main">
               <a:ext uri="{FF2B5EF4-FFF2-40B4-BE49-F238E27FC236}">
-                <a16:creationId xmlns:a16="http://schemas.microsoft.com/office/drawing/2014/main" id="{0D7C2161-B536-40BF-A976-A4CD3B05A8DB}"/>
+                <a16:creationId xmlns:a16="http://schemas.microsoft.com/office/drawing/2014/main" id="{70297104-3780-4A93-B20E-C8912629EBF4}"/>
               </a:ext>
             </a:extLst>
           </p:cNvPr>
@@ -5622,7 +5622,7 @@
           <p:cNvPr id="8" name="Rounded Rectangle 7">
             <a:extLst xmlns:a="http://schemas.openxmlformats.org/drawingml/2006/main">
               <a:ext uri="{FF2B5EF4-FFF2-40B4-BE49-F238E27FC236}">
-                <a16:creationId xmlns:a16="http://schemas.microsoft.com/office/drawing/2014/main" id="{F50D51DA-FE1F-4D8A-B3E2-EB7CEB989FC4}"/>
+                <a16:creationId xmlns:a16="http://schemas.microsoft.com/office/drawing/2014/main" id="{AFB01487-D1C5-48CD-8805-621BEB891248}"/>
               </a:ext>
             </a:extLst>
           </p:cNvPr>
@@ -5677,7 +5677,7 @@
           <p:cNvPr id="9" name="TextBox 8">
             <a:extLst xmlns:a="http://schemas.openxmlformats.org/drawingml/2006/main">
               <a:ext uri="{FF2B5EF4-FFF2-40B4-BE49-F238E27FC236}">
-                <a16:creationId xmlns:a16="http://schemas.microsoft.com/office/drawing/2014/main" id="{CD85419E-23E1-404E-9E32-D2267F41BED4}"/>
+                <a16:creationId xmlns:a16="http://schemas.microsoft.com/office/drawing/2014/main" id="{D492C280-90BE-49C3-B418-D7182F93138D}"/>
               </a:ext>
             </a:extLst>
           </p:cNvPr>
@@ -5762,7 +5762,7 @@
           <p:cNvPr id="10" name="Rounded Rectangle 9">
             <a:extLst xmlns:a="http://schemas.openxmlformats.org/drawingml/2006/main">
               <a:ext uri="{FF2B5EF4-FFF2-40B4-BE49-F238E27FC236}">
-                <a16:creationId xmlns:a16="http://schemas.microsoft.com/office/drawing/2014/main" id="{D694ADD5-93D2-40F8-8B37-25A5EECCC428}"/>
+                <a16:creationId xmlns:a16="http://schemas.microsoft.com/office/drawing/2014/main" id="{4AD75E00-3F82-4202-8DAE-E327215ACECC}"/>
               </a:ext>
             </a:extLst>
           </p:cNvPr>
@@ -5817,7 +5817,7 @@
           <p:cNvPr id="11" name="TextBox 10">
             <a:extLst xmlns:a="http://schemas.openxmlformats.org/drawingml/2006/main">
               <a:ext uri="{FF2B5EF4-FFF2-40B4-BE49-F238E27FC236}">
-                <a16:creationId xmlns:a16="http://schemas.microsoft.com/office/drawing/2014/main" id="{EDF41CEE-C939-4033-AB79-B49121B5096E}"/>
+                <a16:creationId xmlns:a16="http://schemas.microsoft.com/office/drawing/2014/main" id="{CF85E344-F3E9-4C30-A032-3A5D2F64D319}"/>
               </a:ext>
             </a:extLst>
           </p:cNvPr>
@@ -5919,7 +5919,7 @@
     </p:spTree>
     <p:extLst>
       <p:ext uri="{BB962C8B-B14F-4D97-AF65-F5344CB8AC3E}">
-        <p14:creationId xmlns:p14="http://schemas.microsoft.com/office/powerpoint/2010/main" val="1171260497"/>
+        <p14:creationId xmlns:p14="http://schemas.microsoft.com/office/powerpoint/2010/main" val="470099464"/>
       </p:ext>
     </p:extLst>
   </p:cSld>
@@ -5943,7 +5943,7 @@
           <p:cNvPr id="2" name="Rectangle 1">
             <a:extLst xmlns:a="http://schemas.openxmlformats.org/drawingml/2006/main">
               <a:ext uri="{FF2B5EF4-FFF2-40B4-BE49-F238E27FC236}">
-                <a16:creationId xmlns:a16="http://schemas.microsoft.com/office/drawing/2014/main" id="{5138FABC-7F66-481B-8C2E-C4D291FB86B7}"/>
+                <a16:creationId xmlns:a16="http://schemas.microsoft.com/office/drawing/2014/main" id="{0C7BF7B5-FCC4-41DF-8D74-AC20A1259968}"/>
               </a:ext>
             </a:extLst>
           </p:cNvPr>
@@ -5996,7 +5996,7 @@
           <p:cNvPr id="3" name="Rectangle 2">
             <a:extLst xmlns:a="http://schemas.openxmlformats.org/drawingml/2006/main">
               <a:ext uri="{FF2B5EF4-FFF2-40B4-BE49-F238E27FC236}">
-                <a16:creationId xmlns:a16="http://schemas.microsoft.com/office/drawing/2014/main" id="{400E7278-5CAE-40C1-AD10-AACADE77F4F4}"/>
+                <a16:creationId xmlns:a16="http://schemas.microsoft.com/office/drawing/2014/main" id="{B500CCDD-8810-4B5F-8B1D-F030CE53D622}"/>
               </a:ext>
             </a:extLst>
           </p:cNvPr>
@@ -6049,7 +6049,7 @@
           <p:cNvPr id="4" name="Rectangle 3">
             <a:extLst xmlns:a="http://schemas.openxmlformats.org/drawingml/2006/main">
               <a:ext uri="{FF2B5EF4-FFF2-40B4-BE49-F238E27FC236}">
-                <a16:creationId xmlns:a16="http://schemas.microsoft.com/office/drawing/2014/main" id="{ED1CC4C4-B6D6-49F0-9827-436949CFFE98}"/>
+                <a16:creationId xmlns:a16="http://schemas.microsoft.com/office/drawing/2014/main" id="{65034374-E11F-4C13-B64C-742301D08D17}"/>
               </a:ext>
             </a:extLst>
           </p:cNvPr>
@@ -6102,7 +6102,7 @@
           <p:cNvPr id="5" name="TextBox 4">
             <a:extLst xmlns:a="http://schemas.openxmlformats.org/drawingml/2006/main">
               <a:ext uri="{FF2B5EF4-FFF2-40B4-BE49-F238E27FC236}">
-                <a16:creationId xmlns:a16="http://schemas.microsoft.com/office/drawing/2014/main" id="{7C34A510-510D-41E6-9447-BE3BCBCFE5D2}"/>
+                <a16:creationId xmlns:a16="http://schemas.microsoft.com/office/drawing/2014/main" id="{8333E2FE-CE2F-4E82-996E-CF10FAD8BF49}"/>
               </a:ext>
             </a:extLst>
           </p:cNvPr>
@@ -6165,7 +6165,7 @@
           <p:cNvPr id="6" name="Rounded Rectangle 5">
             <a:extLst xmlns:a="http://schemas.openxmlformats.org/drawingml/2006/main">
               <a:ext uri="{FF2B5EF4-FFF2-40B4-BE49-F238E27FC236}">
-                <a16:creationId xmlns:a16="http://schemas.microsoft.com/office/drawing/2014/main" id="{7C05AE73-0C32-4BA5-9594-868BA2764887}"/>
+                <a16:creationId xmlns:a16="http://schemas.microsoft.com/office/drawing/2014/main" id="{45EB4F14-2A8E-4C77-9024-D9C8212A5C67}"/>
               </a:ext>
             </a:extLst>
           </p:cNvPr>
@@ -6220,7 +6220,7 @@
           <p:cNvPr id="7" name="TextBox 6">
             <a:extLst xmlns:a="http://schemas.openxmlformats.org/drawingml/2006/main">
               <a:ext uri="{FF2B5EF4-FFF2-40B4-BE49-F238E27FC236}">
-                <a16:creationId xmlns:a16="http://schemas.microsoft.com/office/drawing/2014/main" id="{83405D1A-3133-4202-969F-57FA4BC446C4}"/>
+                <a16:creationId xmlns:a16="http://schemas.microsoft.com/office/drawing/2014/main" id="{3524A44E-B9FE-4AB7-BD21-95446992213E}"/>
               </a:ext>
             </a:extLst>
           </p:cNvPr>
@@ -6419,7 +6419,7 @@
           <p:cNvPr id="8" name="Rounded Rectangle 7">
             <a:extLst xmlns:a="http://schemas.openxmlformats.org/drawingml/2006/main">
               <a:ext uri="{FF2B5EF4-FFF2-40B4-BE49-F238E27FC236}">
-                <a16:creationId xmlns:a16="http://schemas.microsoft.com/office/drawing/2014/main" id="{CDB9D29F-30CB-48A2-A95A-5B1FF6D2794C}"/>
+                <a16:creationId xmlns:a16="http://schemas.microsoft.com/office/drawing/2014/main" id="{4B84D7D3-1D96-499F-9BC7-2D1875C3D101}"/>
               </a:ext>
             </a:extLst>
           </p:cNvPr>
@@ -6474,7 +6474,7 @@
           <p:cNvPr id="9" name="TextBox 8">
             <a:extLst xmlns:a="http://schemas.openxmlformats.org/drawingml/2006/main">
               <a:ext uri="{FF2B5EF4-FFF2-40B4-BE49-F238E27FC236}">
-                <a16:creationId xmlns:a16="http://schemas.microsoft.com/office/drawing/2014/main" id="{3CA5E277-37FA-469F-B32C-57A08FD40C6E}"/>
+                <a16:creationId xmlns:a16="http://schemas.microsoft.com/office/drawing/2014/main" id="{F708977B-AD76-4CE2-9CA8-3663A3655653}"/>
               </a:ext>
             </a:extLst>
           </p:cNvPr>
@@ -6595,7 +6595,7 @@
     </p:spTree>
     <p:extLst>
       <p:ext uri="{BB962C8B-B14F-4D97-AF65-F5344CB8AC3E}">
-        <p14:creationId xmlns:p14="http://schemas.microsoft.com/office/powerpoint/2010/main" val="1500473785"/>
+        <p14:creationId xmlns:p14="http://schemas.microsoft.com/office/powerpoint/2010/main" val="249662082"/>
       </p:ext>
     </p:extLst>
   </p:cSld>
@@ -6619,7 +6619,7 @@
           <p:cNvPr id="2" name="Rectangle 1">
             <a:extLst xmlns:a="http://schemas.openxmlformats.org/drawingml/2006/main">
               <a:ext uri="{FF2B5EF4-FFF2-40B4-BE49-F238E27FC236}">
-                <a16:creationId xmlns:a16="http://schemas.microsoft.com/office/drawing/2014/main" id="{39E6C460-4844-4E3D-80E9-9195C7914D45}"/>
+                <a16:creationId xmlns:a16="http://schemas.microsoft.com/office/drawing/2014/main" id="{8C905FE4-B36E-4252-A6C2-75E454B8DE39}"/>
               </a:ext>
             </a:extLst>
           </p:cNvPr>
@@ -6672,7 +6672,7 @@
           <p:cNvPr id="3" name="Rectangle 2">
             <a:extLst xmlns:a="http://schemas.openxmlformats.org/drawingml/2006/main">
               <a:ext uri="{FF2B5EF4-FFF2-40B4-BE49-F238E27FC236}">
-                <a16:creationId xmlns:a16="http://schemas.microsoft.com/office/drawing/2014/main" id="{884E266D-CA27-4D88-BB5E-1BB867F7B356}"/>
+                <a16:creationId xmlns:a16="http://schemas.microsoft.com/office/drawing/2014/main" id="{6C26D553-092B-40EA-BB2F-531C135E0B83}"/>
               </a:ext>
             </a:extLst>
           </p:cNvPr>
@@ -6725,7 +6725,7 @@
           <p:cNvPr id="4" name="TextBox 3">
             <a:extLst xmlns:a="http://schemas.openxmlformats.org/drawingml/2006/main">
               <a:ext uri="{FF2B5EF4-FFF2-40B4-BE49-F238E27FC236}">
-                <a16:creationId xmlns:a16="http://schemas.microsoft.com/office/drawing/2014/main" id="{473E6053-AED8-4DD4-B60B-3EE9F423B224}"/>
+                <a16:creationId xmlns:a16="http://schemas.microsoft.com/office/drawing/2014/main" id="{27B56AF8-59D8-4072-B628-D0ED99C3CD5B}"/>
               </a:ext>
             </a:extLst>
           </p:cNvPr>
@@ -6903,7 +6903,7 @@
     </p:spTree>
     <p:extLst>
       <p:ext uri="{BB962C8B-B14F-4D97-AF65-F5344CB8AC3E}">
-        <p14:creationId xmlns:p14="http://schemas.microsoft.com/office/powerpoint/2010/main" val="792577894"/>
+        <p14:creationId xmlns:p14="http://schemas.microsoft.com/office/powerpoint/2010/main" val="18029351"/>
       </p:ext>
     </p:extLst>
   </p:cSld>
@@ -6927,7 +6927,7 @@
           <p:cNvPr id="2" name="Rectangle 1">
             <a:extLst xmlns:a="http://schemas.openxmlformats.org/drawingml/2006/main">
               <a:ext uri="{FF2B5EF4-FFF2-40B4-BE49-F238E27FC236}">
-                <a16:creationId xmlns:a16="http://schemas.microsoft.com/office/drawing/2014/main" id="{BA09B649-24F0-480B-B4A2-209DA9BEA2D8}"/>
+                <a16:creationId xmlns:a16="http://schemas.microsoft.com/office/drawing/2014/main" id="{CB14A08F-0CC5-4970-8BA7-AC4E0D00C299}"/>
               </a:ext>
             </a:extLst>
           </p:cNvPr>
@@ -6980,7 +6980,7 @@
           <p:cNvPr id="3" name="Rectangle 2">
             <a:extLst xmlns:a="http://schemas.openxmlformats.org/drawingml/2006/main">
               <a:ext uri="{FF2B5EF4-FFF2-40B4-BE49-F238E27FC236}">
-                <a16:creationId xmlns:a16="http://schemas.microsoft.com/office/drawing/2014/main" id="{487A8532-79A2-467F-90A9-066755336917}"/>
+                <a16:creationId xmlns:a16="http://schemas.microsoft.com/office/drawing/2014/main" id="{5F31F494-CBD5-48A7-96ED-3410FB8B6A84}"/>
               </a:ext>
             </a:extLst>
           </p:cNvPr>
@@ -7033,7 +7033,7 @@
           <p:cNvPr id="4" name="Rectangle 3">
             <a:extLst xmlns:a="http://schemas.openxmlformats.org/drawingml/2006/main">
               <a:ext uri="{FF2B5EF4-FFF2-40B4-BE49-F238E27FC236}">
-                <a16:creationId xmlns:a16="http://schemas.microsoft.com/office/drawing/2014/main" id="{100FE809-0177-4D16-9848-70CB2531FEC5}"/>
+                <a16:creationId xmlns:a16="http://schemas.microsoft.com/office/drawing/2014/main" id="{B9CE3DAF-A963-4DFA-BBEE-8AF7CD7BC63F}"/>
               </a:ext>
             </a:extLst>
           </p:cNvPr>
@@ -7086,7 +7086,7 @@
           <p:cNvPr id="5" name="TextBox 4">
             <a:extLst xmlns:a="http://schemas.openxmlformats.org/drawingml/2006/main">
               <a:ext uri="{FF2B5EF4-FFF2-40B4-BE49-F238E27FC236}">
-                <a16:creationId xmlns:a16="http://schemas.microsoft.com/office/drawing/2014/main" id="{D2B06B6E-0F8D-4C15-A07A-D52D230E1985}"/>
+                <a16:creationId xmlns:a16="http://schemas.microsoft.com/office/drawing/2014/main" id="{13242279-C44F-46EA-B8AD-DDC611C87424}"/>
               </a:ext>
             </a:extLst>
           </p:cNvPr>
@@ -7149,7 +7149,7 @@
           <p:cNvPr id="6" name="Rounded Rectangle 5">
             <a:extLst xmlns:a="http://schemas.openxmlformats.org/drawingml/2006/main">
               <a:ext uri="{FF2B5EF4-FFF2-40B4-BE49-F238E27FC236}">
-                <a16:creationId xmlns:a16="http://schemas.microsoft.com/office/drawing/2014/main" id="{F3F9053D-F011-409C-B909-23CFE30EC785}"/>
+                <a16:creationId xmlns:a16="http://schemas.microsoft.com/office/drawing/2014/main" id="{C0592635-67DF-4E7E-BE6B-7234B5C7D454}"/>
               </a:ext>
             </a:extLst>
           </p:cNvPr>
@@ -7204,7 +7204,7 @@
           <p:cNvPr id="7" name="TextBox 6">
             <a:extLst xmlns:a="http://schemas.openxmlformats.org/drawingml/2006/main">
               <a:ext uri="{FF2B5EF4-FFF2-40B4-BE49-F238E27FC236}">
-                <a16:creationId xmlns:a16="http://schemas.microsoft.com/office/drawing/2014/main" id="{13FD54E5-882F-404B-91B1-06DDA9D0CD21}"/>
+                <a16:creationId xmlns:a16="http://schemas.microsoft.com/office/drawing/2014/main" id="{464D95AE-ACE5-42A3-862A-532B40C9EF78}"/>
               </a:ext>
             </a:extLst>
           </p:cNvPr>
@@ -7308,7 +7308,7 @@
           <p:cNvPr id="8" name="Rounded Rectangle 7">
             <a:extLst xmlns:a="http://schemas.openxmlformats.org/drawingml/2006/main">
               <a:ext uri="{FF2B5EF4-FFF2-40B4-BE49-F238E27FC236}">
-                <a16:creationId xmlns:a16="http://schemas.microsoft.com/office/drawing/2014/main" id="{E16AB32C-0638-4164-9D05-EB57FD8F2B89}"/>
+                <a16:creationId xmlns:a16="http://schemas.microsoft.com/office/drawing/2014/main" id="{33F5F880-4D3D-4BF8-A486-AC188638A717}"/>
               </a:ext>
             </a:extLst>
           </p:cNvPr>
@@ -7363,7 +7363,7 @@
           <p:cNvPr id="9" name="TextBox 8">
             <a:extLst xmlns:a="http://schemas.openxmlformats.org/drawingml/2006/main">
               <a:ext uri="{FF2B5EF4-FFF2-40B4-BE49-F238E27FC236}">
-                <a16:creationId xmlns:a16="http://schemas.microsoft.com/office/drawing/2014/main" id="{CD2A7B77-0AC7-4D72-B593-0A8B9BBFF186}"/>
+                <a16:creationId xmlns:a16="http://schemas.microsoft.com/office/drawing/2014/main" id="{5D89B376-93A6-4217-B550-E059184E1AD2}"/>
               </a:ext>
             </a:extLst>
           </p:cNvPr>
@@ -7467,7 +7467,7 @@
           <p:cNvPr id="10" name="Rounded Rectangle 9">
             <a:extLst xmlns:a="http://schemas.openxmlformats.org/drawingml/2006/main">
               <a:ext uri="{FF2B5EF4-FFF2-40B4-BE49-F238E27FC236}">
-                <a16:creationId xmlns:a16="http://schemas.microsoft.com/office/drawing/2014/main" id="{963CCAA3-3D37-4706-A0CC-3D3842D4A899}"/>
+                <a16:creationId xmlns:a16="http://schemas.microsoft.com/office/drawing/2014/main" id="{C176E3D9-4837-4281-BB26-5DAB674A57E9}"/>
               </a:ext>
             </a:extLst>
           </p:cNvPr>
@@ -7522,7 +7522,7 @@
           <p:cNvPr id="11" name="TextBox 10">
             <a:extLst xmlns:a="http://schemas.openxmlformats.org/drawingml/2006/main">
               <a:ext uri="{FF2B5EF4-FFF2-40B4-BE49-F238E27FC236}">
-                <a16:creationId xmlns:a16="http://schemas.microsoft.com/office/drawing/2014/main" id="{CA6D9167-F6CE-4420-87F0-AF0FA359E710}"/>
+                <a16:creationId xmlns:a16="http://schemas.microsoft.com/office/drawing/2014/main" id="{2D827DE8-7975-4FC3-8AE7-6335AAE4A601}"/>
               </a:ext>
             </a:extLst>
           </p:cNvPr>
@@ -7681,7 +7681,7 @@
     </p:spTree>
     <p:extLst>
       <p:ext uri="{BB962C8B-B14F-4D97-AF65-F5344CB8AC3E}">
-        <p14:creationId xmlns:p14="http://schemas.microsoft.com/office/powerpoint/2010/main" val="664807021"/>
+        <p14:creationId xmlns:p14="http://schemas.microsoft.com/office/powerpoint/2010/main" val="1379623690"/>
       </p:ext>
     </p:extLst>
   </p:cSld>
@@ -7705,7 +7705,7 @@
           <p:cNvPr id="2" name="Rectangle 1">
             <a:extLst xmlns:a="http://schemas.openxmlformats.org/drawingml/2006/main">
               <a:ext uri="{FF2B5EF4-FFF2-40B4-BE49-F238E27FC236}">
-                <a16:creationId xmlns:a16="http://schemas.microsoft.com/office/drawing/2014/main" id="{9FB69427-F37F-4485-91D3-E07BD3970B0B}"/>
+                <a16:creationId xmlns:a16="http://schemas.microsoft.com/office/drawing/2014/main" id="{ACA795BE-E241-46A6-A95C-16DD0803E379}"/>
               </a:ext>
             </a:extLst>
           </p:cNvPr>
@@ -7758,7 +7758,7 @@
           <p:cNvPr id="3" name="Rectangle 2">
             <a:extLst xmlns:a="http://schemas.openxmlformats.org/drawingml/2006/main">
               <a:ext uri="{FF2B5EF4-FFF2-40B4-BE49-F238E27FC236}">
-                <a16:creationId xmlns:a16="http://schemas.microsoft.com/office/drawing/2014/main" id="{58DD3E3D-CDF8-4FFE-BA16-EFDEECBED58A}"/>
+                <a16:creationId xmlns:a16="http://schemas.microsoft.com/office/drawing/2014/main" id="{AB3FA44D-8CD9-4118-932A-157CFA1337CC}"/>
               </a:ext>
             </a:extLst>
           </p:cNvPr>
@@ -7811,7 +7811,7 @@
           <p:cNvPr id="4" name="Rectangle 3">
             <a:extLst xmlns:a="http://schemas.openxmlformats.org/drawingml/2006/main">
               <a:ext uri="{FF2B5EF4-FFF2-40B4-BE49-F238E27FC236}">
-                <a16:creationId xmlns:a16="http://schemas.microsoft.com/office/drawing/2014/main" id="{DAD32B2E-4A88-4FD6-B17A-32DCFBBE5969}"/>
+                <a16:creationId xmlns:a16="http://schemas.microsoft.com/office/drawing/2014/main" id="{FB3C17F1-9998-45A1-B37F-8A9C84023F96}"/>
               </a:ext>
             </a:extLst>
           </p:cNvPr>
@@ -7864,7 +7864,7 @@
           <p:cNvPr id="5" name="TextBox 4">
             <a:extLst xmlns:a="http://schemas.openxmlformats.org/drawingml/2006/main">
               <a:ext uri="{FF2B5EF4-FFF2-40B4-BE49-F238E27FC236}">
-                <a16:creationId xmlns:a16="http://schemas.microsoft.com/office/drawing/2014/main" id="{B17C2597-7D19-42C5-9EBF-7CAA367F5033}"/>
+                <a16:creationId xmlns:a16="http://schemas.microsoft.com/office/drawing/2014/main" id="{D411869D-BAFA-448A-9A66-A8DBA0E34C07}"/>
               </a:ext>
             </a:extLst>
           </p:cNvPr>
@@ -7927,7 +7927,7 @@
           <p:cNvPr id="6" name="Rounded Rectangle 5">
             <a:extLst xmlns:a="http://schemas.openxmlformats.org/drawingml/2006/main">
               <a:ext uri="{FF2B5EF4-FFF2-40B4-BE49-F238E27FC236}">
-                <a16:creationId xmlns:a16="http://schemas.microsoft.com/office/drawing/2014/main" id="{7766B36E-7B58-48DF-9BD3-8CFB9B58A028}"/>
+                <a16:creationId xmlns:a16="http://schemas.microsoft.com/office/drawing/2014/main" id="{DFB18748-FC55-431B-9C29-0EFB2989B9AF}"/>
               </a:ext>
             </a:extLst>
           </p:cNvPr>
@@ -7982,7 +7982,7 @@
           <p:cNvPr id="7" name="TextBox 6">
             <a:extLst xmlns:a="http://schemas.openxmlformats.org/drawingml/2006/main">
               <a:ext uri="{FF2B5EF4-FFF2-40B4-BE49-F238E27FC236}">
-                <a16:creationId xmlns:a16="http://schemas.microsoft.com/office/drawing/2014/main" id="{6C9A2DAB-6AD2-4B39-8F16-462CCC83F459}"/>
+                <a16:creationId xmlns:a16="http://schemas.microsoft.com/office/drawing/2014/main" id="{ED7B7ECF-FCD5-4F64-ABDC-C477AE0672E8}"/>
               </a:ext>
             </a:extLst>
           </p:cNvPr>
@@ -8105,7 +8105,7 @@
           <p:cNvPr id="8" name="Rounded Rectangle 7">
             <a:extLst xmlns:a="http://schemas.openxmlformats.org/drawingml/2006/main">
               <a:ext uri="{FF2B5EF4-FFF2-40B4-BE49-F238E27FC236}">
-                <a16:creationId xmlns:a16="http://schemas.microsoft.com/office/drawing/2014/main" id="{DF03DE50-51FD-4BC0-86F9-98A14E989FEF}"/>
+                <a16:creationId xmlns:a16="http://schemas.microsoft.com/office/drawing/2014/main" id="{D51C0D9C-BA24-4223-A825-A6C4F73571F5}"/>
               </a:ext>
             </a:extLst>
           </p:cNvPr>
@@ -8160,7 +8160,7 @@
           <p:cNvPr id="9" name="TextBox 8">
             <a:extLst xmlns:a="http://schemas.openxmlformats.org/drawingml/2006/main">
               <a:ext uri="{FF2B5EF4-FFF2-40B4-BE49-F238E27FC236}">
-                <a16:creationId xmlns:a16="http://schemas.microsoft.com/office/drawing/2014/main" id="{7DA85F15-E398-4C81-BD57-6FBC40DEC217}"/>
+                <a16:creationId xmlns:a16="http://schemas.microsoft.com/office/drawing/2014/main" id="{B79350EC-6311-47E5-A746-DE0681D431AA}"/>
               </a:ext>
             </a:extLst>
           </p:cNvPr>
@@ -8302,7 +8302,7 @@
           <p:cNvPr id="10" name="Rounded Rectangle 9">
             <a:extLst xmlns:a="http://schemas.openxmlformats.org/drawingml/2006/main">
               <a:ext uri="{FF2B5EF4-FFF2-40B4-BE49-F238E27FC236}">
-                <a16:creationId xmlns:a16="http://schemas.microsoft.com/office/drawing/2014/main" id="{5AF6C990-24B4-4C65-948A-69E420673CF2}"/>
+                <a16:creationId xmlns:a16="http://schemas.microsoft.com/office/drawing/2014/main" id="{D35160D4-940D-4639-B780-243E0D8CF1FC}"/>
               </a:ext>
             </a:extLst>
           </p:cNvPr>
@@ -8357,7 +8357,7 @@
           <p:cNvPr id="11" name="TextBox 10">
             <a:extLst xmlns:a="http://schemas.openxmlformats.org/drawingml/2006/main">
               <a:ext uri="{FF2B5EF4-FFF2-40B4-BE49-F238E27FC236}">
-                <a16:creationId xmlns:a16="http://schemas.microsoft.com/office/drawing/2014/main" id="{1015CD2E-AD34-4E35-A7E8-3089F9B1B656}"/>
+                <a16:creationId xmlns:a16="http://schemas.microsoft.com/office/drawing/2014/main" id="{4081F1EB-BFFB-43FD-91EB-F535DF6D55B3}"/>
               </a:ext>
             </a:extLst>
           </p:cNvPr>
@@ -8459,7 +8459,7 @@
     </p:spTree>
     <p:extLst>
       <p:ext uri="{BB962C8B-B14F-4D97-AF65-F5344CB8AC3E}">
-        <p14:creationId xmlns:p14="http://schemas.microsoft.com/office/powerpoint/2010/main" val="805215013"/>
+        <p14:creationId xmlns:p14="http://schemas.microsoft.com/office/powerpoint/2010/main" val="69725368"/>
       </p:ext>
     </p:extLst>
   </p:cSld>
@@ -8483,7 +8483,7 @@
           <p:cNvPr id="2" name="Rectangle 1">
             <a:extLst xmlns:a="http://schemas.openxmlformats.org/drawingml/2006/main">
               <a:ext uri="{FF2B5EF4-FFF2-40B4-BE49-F238E27FC236}">
-                <a16:creationId xmlns:a16="http://schemas.microsoft.com/office/drawing/2014/main" id="{CC927386-46EB-4707-8879-A57C3AF262A4}"/>
+                <a16:creationId xmlns:a16="http://schemas.microsoft.com/office/drawing/2014/main" id="{807A5DEC-4105-4256-89A0-9AA027AD728B}"/>
               </a:ext>
             </a:extLst>
           </p:cNvPr>
@@ -8536,7 +8536,7 @@
           <p:cNvPr id="3" name="Rectangle 2">
             <a:extLst xmlns:a="http://schemas.openxmlformats.org/drawingml/2006/main">
               <a:ext uri="{FF2B5EF4-FFF2-40B4-BE49-F238E27FC236}">
-                <a16:creationId xmlns:a16="http://schemas.microsoft.com/office/drawing/2014/main" id="{A42D7A3D-7BB3-45DD-83A0-08C6483429C5}"/>
+                <a16:creationId xmlns:a16="http://schemas.microsoft.com/office/drawing/2014/main" id="{C9249182-2BD9-4955-8D22-A06F98F3CC47}"/>
               </a:ext>
             </a:extLst>
           </p:cNvPr>
@@ -8589,7 +8589,7 @@
           <p:cNvPr id="4" name="Rectangle 3">
             <a:extLst xmlns:a="http://schemas.openxmlformats.org/drawingml/2006/main">
               <a:ext uri="{FF2B5EF4-FFF2-40B4-BE49-F238E27FC236}">
-                <a16:creationId xmlns:a16="http://schemas.microsoft.com/office/drawing/2014/main" id="{A9581115-B5EF-43ED-A7ED-EAD8ADEF35DE}"/>
+                <a16:creationId xmlns:a16="http://schemas.microsoft.com/office/drawing/2014/main" id="{4055747E-B363-4A26-A2D8-7867298C45CC}"/>
               </a:ext>
             </a:extLst>
           </p:cNvPr>
@@ -8642,7 +8642,7 @@
           <p:cNvPr id="5" name="TextBox 4">
             <a:extLst xmlns:a="http://schemas.openxmlformats.org/drawingml/2006/main">
               <a:ext uri="{FF2B5EF4-FFF2-40B4-BE49-F238E27FC236}">
-                <a16:creationId xmlns:a16="http://schemas.microsoft.com/office/drawing/2014/main" id="{D065CAD9-27B1-49AB-B459-DD61A7FE1020}"/>
+                <a16:creationId xmlns:a16="http://schemas.microsoft.com/office/drawing/2014/main" id="{0B17AF7A-12D6-42A5-8797-AD167445FFDF}"/>
               </a:ext>
             </a:extLst>
           </p:cNvPr>
@@ -8705,7 +8705,7 @@
           <p:cNvPr id="6" name="Rounded Rectangle 5">
             <a:extLst xmlns:a="http://schemas.openxmlformats.org/drawingml/2006/main">
               <a:ext uri="{FF2B5EF4-FFF2-40B4-BE49-F238E27FC236}">
-                <a16:creationId xmlns:a16="http://schemas.microsoft.com/office/drawing/2014/main" id="{F9910C9A-5BC3-4B90-AFF0-C6F7431D456B}"/>
+                <a16:creationId xmlns:a16="http://schemas.microsoft.com/office/drawing/2014/main" id="{EAA0C771-1860-4683-8345-301BBDFD9845}"/>
               </a:ext>
             </a:extLst>
           </p:cNvPr>
@@ -8760,7 +8760,7 @@
           <p:cNvPr id="7" name="TextBox 6">
             <a:extLst xmlns:a="http://schemas.openxmlformats.org/drawingml/2006/main">
               <a:ext uri="{FF2B5EF4-FFF2-40B4-BE49-F238E27FC236}">
-                <a16:creationId xmlns:a16="http://schemas.microsoft.com/office/drawing/2014/main" id="{030E5DFB-0C54-447B-AA15-7C7D98608FC0}"/>
+                <a16:creationId xmlns:a16="http://schemas.microsoft.com/office/drawing/2014/main" id="{024FFE8C-7998-46F1-B833-F55EF0AC0A7A}"/>
               </a:ext>
             </a:extLst>
           </p:cNvPr>
@@ -8940,7 +8940,7 @@
           <p:cNvPr id="8" name="Rounded Rectangle 7">
             <a:extLst xmlns:a="http://schemas.openxmlformats.org/drawingml/2006/main">
               <a:ext uri="{FF2B5EF4-FFF2-40B4-BE49-F238E27FC236}">
-                <a16:creationId xmlns:a16="http://schemas.microsoft.com/office/drawing/2014/main" id="{AABEA2ED-05DA-456B-850A-18CFBA817DDC}"/>
+                <a16:creationId xmlns:a16="http://schemas.microsoft.com/office/drawing/2014/main" id="{3CC2E2A6-55F2-48C7-A355-D16E737340B4}"/>
               </a:ext>
             </a:extLst>
           </p:cNvPr>
@@ -8995,7 +8995,7 @@
           <p:cNvPr id="9" name="TextBox 8">
             <a:extLst xmlns:a="http://schemas.openxmlformats.org/drawingml/2006/main">
               <a:ext uri="{FF2B5EF4-FFF2-40B4-BE49-F238E27FC236}">
-                <a16:creationId xmlns:a16="http://schemas.microsoft.com/office/drawing/2014/main" id="{6F60C486-C88D-40E9-8E93-23762C33F6A8}"/>
+                <a16:creationId xmlns:a16="http://schemas.microsoft.com/office/drawing/2014/main" id="{BDD24B2E-A010-4941-823D-BA071175C22F}"/>
               </a:ext>
             </a:extLst>
           </p:cNvPr>
@@ -9154,7 +9154,7 @@
     </p:spTree>
     <p:extLst>
       <p:ext uri="{BB962C8B-B14F-4D97-AF65-F5344CB8AC3E}">
-        <p14:creationId xmlns:p14="http://schemas.microsoft.com/office/powerpoint/2010/main" val="1341019022"/>
+        <p14:creationId xmlns:p14="http://schemas.microsoft.com/office/powerpoint/2010/main" val="1292470837"/>
       </p:ext>
     </p:extLst>
   </p:cSld>
@@ -9178,7 +9178,7 @@
           <p:cNvPr id="2" name="Rectangle 1">
             <a:extLst xmlns:a="http://schemas.openxmlformats.org/drawingml/2006/main">
               <a:ext uri="{FF2B5EF4-FFF2-40B4-BE49-F238E27FC236}">
-                <a16:creationId xmlns:a16="http://schemas.microsoft.com/office/drawing/2014/main" id="{3C6897AD-8849-45BB-BD1F-41D9EFB98F0F}"/>
+                <a16:creationId xmlns:a16="http://schemas.microsoft.com/office/drawing/2014/main" id="{6D2B0BE9-D4E8-4893-A0C1-DC575D4BD09A}"/>
               </a:ext>
             </a:extLst>
           </p:cNvPr>
@@ -9231,7 +9231,7 @@
           <p:cNvPr id="3" name="Rectangle 2">
             <a:extLst xmlns:a="http://schemas.openxmlformats.org/drawingml/2006/main">
               <a:ext uri="{FF2B5EF4-FFF2-40B4-BE49-F238E27FC236}">
-                <a16:creationId xmlns:a16="http://schemas.microsoft.com/office/drawing/2014/main" id="{2B034FBE-7944-4396-8934-A7A87B060843}"/>
+                <a16:creationId xmlns:a16="http://schemas.microsoft.com/office/drawing/2014/main" id="{90E7F9A9-6135-4010-8D9E-79B7C395AAC8}"/>
               </a:ext>
             </a:extLst>
           </p:cNvPr>
@@ -9284,7 +9284,7 @@
           <p:cNvPr id="4" name="Rectangle 3">
             <a:extLst xmlns:a="http://schemas.openxmlformats.org/drawingml/2006/main">
               <a:ext uri="{FF2B5EF4-FFF2-40B4-BE49-F238E27FC236}">
-                <a16:creationId xmlns:a16="http://schemas.microsoft.com/office/drawing/2014/main" id="{51F0EC3D-7B93-4560-9C03-F839C1382630}"/>
+                <a16:creationId xmlns:a16="http://schemas.microsoft.com/office/drawing/2014/main" id="{E01022DF-2A09-45E5-BE77-DBD8E8034336}"/>
               </a:ext>
             </a:extLst>
           </p:cNvPr>
@@ -9337,7 +9337,7 @@
           <p:cNvPr id="5" name="TextBox 4">
             <a:extLst xmlns:a="http://schemas.openxmlformats.org/drawingml/2006/main">
               <a:ext uri="{FF2B5EF4-FFF2-40B4-BE49-F238E27FC236}">
-                <a16:creationId xmlns:a16="http://schemas.microsoft.com/office/drawing/2014/main" id="{4C8FA24A-BACB-44D6-B3D7-32F64EEAA80B}"/>
+                <a16:creationId xmlns:a16="http://schemas.microsoft.com/office/drawing/2014/main" id="{3EDCE2A6-F034-4439-A241-A588C4FC23D8}"/>
               </a:ext>
             </a:extLst>
           </p:cNvPr>
@@ -9400,7 +9400,7 @@
           <p:cNvPr id="6" name="Rounded Rectangle 5">
             <a:extLst xmlns:a="http://schemas.openxmlformats.org/drawingml/2006/main">
               <a:ext uri="{FF2B5EF4-FFF2-40B4-BE49-F238E27FC236}">
-                <a16:creationId xmlns:a16="http://schemas.microsoft.com/office/drawing/2014/main" id="{95BFA2E8-BF06-406B-BDB0-C82BFC3D2372}"/>
+                <a16:creationId xmlns:a16="http://schemas.microsoft.com/office/drawing/2014/main" id="{03B4A867-EE22-42C4-949A-C767D99AAA4C}"/>
               </a:ext>
             </a:extLst>
           </p:cNvPr>
@@ -9455,7 +9455,7 @@
           <p:cNvPr id="7" name="TextBox 6">
             <a:extLst xmlns:a="http://schemas.openxmlformats.org/drawingml/2006/main">
               <a:ext uri="{FF2B5EF4-FFF2-40B4-BE49-F238E27FC236}">
-                <a16:creationId xmlns:a16="http://schemas.microsoft.com/office/drawing/2014/main" id="{804E77B0-ABBF-4924-BBEB-23C4F60D230D}"/>
+                <a16:creationId xmlns:a16="http://schemas.microsoft.com/office/drawing/2014/main" id="{3E221609-8DC5-4069-A6D7-65B79173458F}"/>
               </a:ext>
             </a:extLst>
           </p:cNvPr>
@@ -9663,7 +9663,7 @@
               </a:defRPr>
             </a:pPr>
             <a:r>
-              <a:t>•  Lưu vết đầy đủ (D1: RECORD_ONLY): Lưu toàn văn phản hồi thô phục vụ kiểm toán độc lập.</a:t>
+              <a:t>•  Lưu vết an toàn (D1: RECORD_ONLY): Lưu phản hồi thô phục vụ kiểm toán độc lập; toàn bộ thông tin đăng nhập và bí mật nhạy cảm đã được làm sạch / khử khuẩn (credentials and sensitive secrets sanitized/redacted).</a:t>
             </a:r>
           </a:p>
         </p:txBody>
@@ -9673,7 +9673,7 @@
           <p:cNvPr id="8" name="Rounded Rectangle 7">
             <a:extLst xmlns:a="http://schemas.openxmlformats.org/drawingml/2006/main">
               <a:ext uri="{FF2B5EF4-FFF2-40B4-BE49-F238E27FC236}">
-                <a16:creationId xmlns:a16="http://schemas.microsoft.com/office/drawing/2014/main" id="{C004314A-F7AD-4CB0-94BA-AD0D6479D783}"/>
+                <a16:creationId xmlns:a16="http://schemas.microsoft.com/office/drawing/2014/main" id="{F4B96CD1-2DDD-425C-A4D0-19A746C1F3AB}"/>
               </a:ext>
             </a:extLst>
           </p:cNvPr>
@@ -9728,7 +9728,7 @@
           <p:cNvPr id="9" name="TextBox 8">
             <a:extLst xmlns:a="http://schemas.openxmlformats.org/drawingml/2006/main">
               <a:ext uri="{FF2B5EF4-FFF2-40B4-BE49-F238E27FC236}">
-                <a16:creationId xmlns:a16="http://schemas.microsoft.com/office/drawing/2014/main" id="{3346AB71-4D36-4916-B9FC-8AB017C69ED5}"/>
+                <a16:creationId xmlns:a16="http://schemas.microsoft.com/office/drawing/2014/main" id="{F29BC204-275B-45C9-B46F-CA83548A8566}"/>
               </a:ext>
             </a:extLst>
           </p:cNvPr>
@@ -9963,7 +9963,7 @@
     </p:spTree>
     <p:extLst>
       <p:ext uri="{BB962C8B-B14F-4D97-AF65-F5344CB8AC3E}">
-        <p14:creationId xmlns:p14="http://schemas.microsoft.com/office/powerpoint/2010/main" val="606018695"/>
+        <p14:creationId xmlns:p14="http://schemas.microsoft.com/office/powerpoint/2010/main" val="879682298"/>
       </p:ext>
     </p:extLst>
   </p:cSld>
@@ -9987,7 +9987,7 @@
           <p:cNvPr id="2" name="Rectangle 1">
             <a:extLst xmlns:a="http://schemas.openxmlformats.org/drawingml/2006/main">
               <a:ext uri="{FF2B5EF4-FFF2-40B4-BE49-F238E27FC236}">
-                <a16:creationId xmlns:a16="http://schemas.microsoft.com/office/drawing/2014/main" id="{C5B102A8-5D3A-40B7-BE22-CB9C511CAA5F}"/>
+                <a16:creationId xmlns:a16="http://schemas.microsoft.com/office/drawing/2014/main" id="{E86AF65E-95D5-48FE-95E9-A68C2D392529}"/>
               </a:ext>
             </a:extLst>
           </p:cNvPr>
@@ -10040,7 +10040,7 @@
           <p:cNvPr id="3" name="Rectangle 2">
             <a:extLst xmlns:a="http://schemas.openxmlformats.org/drawingml/2006/main">
               <a:ext uri="{FF2B5EF4-FFF2-40B4-BE49-F238E27FC236}">
-                <a16:creationId xmlns:a16="http://schemas.microsoft.com/office/drawing/2014/main" id="{184BA6EF-FB3F-474A-BC02-EC7620FCE8E9}"/>
+                <a16:creationId xmlns:a16="http://schemas.microsoft.com/office/drawing/2014/main" id="{F4DBB4A8-18CB-4DF8-BB23-D01FDC64E6C2}"/>
               </a:ext>
             </a:extLst>
           </p:cNvPr>
@@ -10093,7 +10093,7 @@
           <p:cNvPr id="4" name="Rectangle 3">
             <a:extLst xmlns:a="http://schemas.openxmlformats.org/drawingml/2006/main">
               <a:ext uri="{FF2B5EF4-FFF2-40B4-BE49-F238E27FC236}">
-                <a16:creationId xmlns:a16="http://schemas.microsoft.com/office/drawing/2014/main" id="{4C7DCB61-6B99-425A-AB0A-DBAB40DC191E}"/>
+                <a16:creationId xmlns:a16="http://schemas.microsoft.com/office/drawing/2014/main" id="{FC02808A-3F3A-43CB-A3FB-254F6A65C366}"/>
               </a:ext>
             </a:extLst>
           </p:cNvPr>
@@ -10146,7 +10146,7 @@
           <p:cNvPr id="5" name="TextBox 4">
             <a:extLst xmlns:a="http://schemas.openxmlformats.org/drawingml/2006/main">
               <a:ext uri="{FF2B5EF4-FFF2-40B4-BE49-F238E27FC236}">
-                <a16:creationId xmlns:a16="http://schemas.microsoft.com/office/drawing/2014/main" id="{C037C206-D888-4A8D-A9D5-0B4D87BA39A2}"/>
+                <a16:creationId xmlns:a16="http://schemas.microsoft.com/office/drawing/2014/main" id="{A53CCD2F-E0A6-48EA-B3B6-FCBA21F1A69B}"/>
               </a:ext>
             </a:extLst>
           </p:cNvPr>
@@ -10209,7 +10209,7 @@
           <p:cNvPr id="6" name="Rounded Rectangle 5">
             <a:extLst xmlns:a="http://schemas.openxmlformats.org/drawingml/2006/main">
               <a:ext uri="{FF2B5EF4-FFF2-40B4-BE49-F238E27FC236}">
-                <a16:creationId xmlns:a16="http://schemas.microsoft.com/office/drawing/2014/main" id="{17A68180-CA41-4A4C-B662-5E04C6F88545}"/>
+                <a16:creationId xmlns:a16="http://schemas.microsoft.com/office/drawing/2014/main" id="{947EF817-95F5-4678-9C31-3B273DB8C966}"/>
               </a:ext>
             </a:extLst>
           </p:cNvPr>
@@ -10264,7 +10264,7 @@
           <p:cNvPr id="7" name="TextBox 6">
             <a:extLst xmlns:a="http://schemas.openxmlformats.org/drawingml/2006/main">
               <a:ext uri="{FF2B5EF4-FFF2-40B4-BE49-F238E27FC236}">
-                <a16:creationId xmlns:a16="http://schemas.microsoft.com/office/drawing/2014/main" id="{776C911C-6AC1-4988-8202-882B9FCA6AA2}"/>
+                <a16:creationId xmlns:a16="http://schemas.microsoft.com/office/drawing/2014/main" id="{3D7E0AA4-4DAA-4714-9E27-354BD39ABFF3}"/>
               </a:ext>
             </a:extLst>
           </p:cNvPr>
@@ -10647,7 +10647,7 @@
           <p:nvPr/>
         </p:nvPicPr>
         <p:blipFill>
-          <a:blip xmlns:r="http://schemas.openxmlformats.org/officeDocument/2006/relationships" xmlns:a="http://schemas.openxmlformats.org/drawingml/2006/main" r:embed="R51ce7eb0837f45e8"/>
+          <a:blip xmlns:r="http://schemas.openxmlformats.org/officeDocument/2006/relationships" xmlns:a="http://schemas.openxmlformats.org/drawingml/2006/main" r:embed="Rb458d6a1250c4adf"/>
           <a:stretch xmlns:a="http://schemas.openxmlformats.org/drawingml/2006/main">
             <a:fillRect l="0" t="0" r="0" b="0"/>
           </a:stretch>
@@ -10667,7 +10667,7 @@
           <p:cNvPr id="9" name="Rounded Rectangle 8">
             <a:extLst xmlns:a="http://schemas.openxmlformats.org/drawingml/2006/main">
               <a:ext uri="{FF2B5EF4-FFF2-40B4-BE49-F238E27FC236}">
-                <a16:creationId xmlns:a16="http://schemas.microsoft.com/office/drawing/2014/main" id="{F15D4490-0FE4-40EE-8442-0A95059B1247}"/>
+                <a16:creationId xmlns:a16="http://schemas.microsoft.com/office/drawing/2014/main" id="{7D4A5D72-B1C8-4DF6-A87B-4F25769AEF03}"/>
               </a:ext>
             </a:extLst>
           </p:cNvPr>
@@ -10722,7 +10722,7 @@
           <p:cNvPr id="10" name="TextBox 9">
             <a:extLst xmlns:a="http://schemas.openxmlformats.org/drawingml/2006/main">
               <a:ext uri="{FF2B5EF4-FFF2-40B4-BE49-F238E27FC236}">
-                <a16:creationId xmlns:a16="http://schemas.microsoft.com/office/drawing/2014/main" id="{7E2590B2-7FF0-4FE8-9E1B-E4B21D6BC5A9}"/>
+                <a16:creationId xmlns:a16="http://schemas.microsoft.com/office/drawing/2014/main" id="{4DF0C028-CD25-445E-9736-3A21CBBB23D6}"/>
               </a:ext>
             </a:extLst>
           </p:cNvPr>
@@ -10808,7 +10808,7 @@
     </p:spTree>
     <p:extLst>
       <p:ext uri="{BB962C8B-B14F-4D97-AF65-F5344CB8AC3E}">
-        <p14:creationId xmlns:p14="http://schemas.microsoft.com/office/powerpoint/2010/main" val="1813359118"/>
+        <p14:creationId xmlns:p14="http://schemas.microsoft.com/office/powerpoint/2010/main" val="286866128"/>
       </p:ext>
     </p:extLst>
   </p:cSld>
@@ -10832,7 +10832,7 @@
           <p:cNvPr id="2" name="Rectangle 1">
             <a:extLst xmlns:a="http://schemas.openxmlformats.org/drawingml/2006/main">
               <a:ext uri="{FF2B5EF4-FFF2-40B4-BE49-F238E27FC236}">
-                <a16:creationId xmlns:a16="http://schemas.microsoft.com/office/drawing/2014/main" id="{1947AE4E-1230-41F0-A732-B780141E38B6}"/>
+                <a16:creationId xmlns:a16="http://schemas.microsoft.com/office/drawing/2014/main" id="{7BA7B7DA-4C17-4D6E-851B-8431FDD16FBF}"/>
               </a:ext>
             </a:extLst>
           </p:cNvPr>
@@ -10885,7 +10885,7 @@
           <p:cNvPr id="3" name="Rectangle 2">
             <a:extLst xmlns:a="http://schemas.openxmlformats.org/drawingml/2006/main">
               <a:ext uri="{FF2B5EF4-FFF2-40B4-BE49-F238E27FC236}">
-                <a16:creationId xmlns:a16="http://schemas.microsoft.com/office/drawing/2014/main" id="{0D21D111-659E-45F9-8A7D-09369F1E0A13}"/>
+                <a16:creationId xmlns:a16="http://schemas.microsoft.com/office/drawing/2014/main" id="{CA8947FF-BE31-4883-A97C-DC7B68C0855F}"/>
               </a:ext>
             </a:extLst>
           </p:cNvPr>
@@ -10938,7 +10938,7 @@
           <p:cNvPr id="4" name="Rectangle 3">
             <a:extLst xmlns:a="http://schemas.openxmlformats.org/drawingml/2006/main">
               <a:ext uri="{FF2B5EF4-FFF2-40B4-BE49-F238E27FC236}">
-                <a16:creationId xmlns:a16="http://schemas.microsoft.com/office/drawing/2014/main" id="{1269249E-16B5-46A5-A10F-048F4D073C87}"/>
+                <a16:creationId xmlns:a16="http://schemas.microsoft.com/office/drawing/2014/main" id="{7B6EAAE2-C7A1-4308-9F1D-3F5B984EC749}"/>
               </a:ext>
             </a:extLst>
           </p:cNvPr>
@@ -10991,7 +10991,7 @@
           <p:cNvPr id="5" name="TextBox 4">
             <a:extLst xmlns:a="http://schemas.openxmlformats.org/drawingml/2006/main">
               <a:ext uri="{FF2B5EF4-FFF2-40B4-BE49-F238E27FC236}">
-                <a16:creationId xmlns:a16="http://schemas.microsoft.com/office/drawing/2014/main" id="{0D2E2C8F-AE56-4508-BC4E-9196EC9392F5}"/>
+                <a16:creationId xmlns:a16="http://schemas.microsoft.com/office/drawing/2014/main" id="{FDC6BCF2-7DCD-4042-AEF5-8FDCDFD97D29}"/>
               </a:ext>
             </a:extLst>
           </p:cNvPr>
@@ -11054,7 +11054,7 @@
           <p:cNvPr id="6" name="Rounded Rectangle 5">
             <a:extLst xmlns:a="http://schemas.openxmlformats.org/drawingml/2006/main">
               <a:ext uri="{FF2B5EF4-FFF2-40B4-BE49-F238E27FC236}">
-                <a16:creationId xmlns:a16="http://schemas.microsoft.com/office/drawing/2014/main" id="{41BDD51A-C34B-4352-A973-593F8B6C772A}"/>
+                <a16:creationId xmlns:a16="http://schemas.microsoft.com/office/drawing/2014/main" id="{8A5BA445-82C0-47E6-B944-3C78F0C31AB4}"/>
               </a:ext>
             </a:extLst>
           </p:cNvPr>
@@ -11109,7 +11109,7 @@
           <p:cNvPr id="7" name="TextBox 6">
             <a:extLst xmlns:a="http://schemas.openxmlformats.org/drawingml/2006/main">
               <a:ext uri="{FF2B5EF4-FFF2-40B4-BE49-F238E27FC236}">
-                <a16:creationId xmlns:a16="http://schemas.microsoft.com/office/drawing/2014/main" id="{37D35F9C-463A-4565-A504-4AC8A9BFEC6C}"/>
+                <a16:creationId xmlns:a16="http://schemas.microsoft.com/office/drawing/2014/main" id="{F9C06B8C-D4BD-4506-AB89-2254EF8BE1A1}"/>
               </a:ext>
             </a:extLst>
           </p:cNvPr>
@@ -11346,7 +11346,7 @@
           <p:cNvPr id="8" name="Rounded Rectangle 7">
             <a:extLst xmlns:a="http://schemas.openxmlformats.org/drawingml/2006/main">
               <a:ext uri="{FF2B5EF4-FFF2-40B4-BE49-F238E27FC236}">
-                <a16:creationId xmlns:a16="http://schemas.microsoft.com/office/drawing/2014/main" id="{E8C290BA-7EF9-4F75-AE6C-27EDC417A9CD}"/>
+                <a16:creationId xmlns:a16="http://schemas.microsoft.com/office/drawing/2014/main" id="{B7D42736-A82B-4A72-B746-02B26A4F9D15}"/>
               </a:ext>
             </a:extLst>
           </p:cNvPr>
@@ -11401,7 +11401,7 @@
           <p:cNvPr id="9" name="TextBox 8">
             <a:extLst xmlns:a="http://schemas.openxmlformats.org/drawingml/2006/main">
               <a:ext uri="{FF2B5EF4-FFF2-40B4-BE49-F238E27FC236}">
-                <a16:creationId xmlns:a16="http://schemas.microsoft.com/office/drawing/2014/main" id="{EBBC8B63-7B37-4126-81F0-9654272C80B6}"/>
+                <a16:creationId xmlns:a16="http://schemas.microsoft.com/office/drawing/2014/main" id="{6BD4EC4E-9ED5-4E27-9CDE-6A281F93C6B5}"/>
               </a:ext>
             </a:extLst>
           </p:cNvPr>
@@ -11606,7 +11606,7 @@
     </p:spTree>
     <p:extLst>
       <p:ext uri="{BB962C8B-B14F-4D97-AF65-F5344CB8AC3E}">
-        <p14:creationId xmlns:p14="http://schemas.microsoft.com/office/powerpoint/2010/main" val="1989449084"/>
+        <p14:creationId xmlns:p14="http://schemas.microsoft.com/office/powerpoint/2010/main" val="1355867882"/>
       </p:ext>
     </p:extLst>
   </p:cSld>
@@ -11630,7 +11630,7 @@
           <p:cNvPr id="2" name="Rectangle 1">
             <a:extLst xmlns:a="http://schemas.openxmlformats.org/drawingml/2006/main">
               <a:ext uri="{FF2B5EF4-FFF2-40B4-BE49-F238E27FC236}">
-                <a16:creationId xmlns:a16="http://schemas.microsoft.com/office/drawing/2014/main" id="{41C5BC57-2C3E-402D-B37E-078904DCEC01}"/>
+                <a16:creationId xmlns:a16="http://schemas.microsoft.com/office/drawing/2014/main" id="{D16BBA1C-E8CD-4C63-BAE6-101EE3B73F24}"/>
               </a:ext>
             </a:extLst>
           </p:cNvPr>
@@ -11683,7 +11683,7 @@
           <p:cNvPr id="3" name="Rectangle 2">
             <a:extLst xmlns:a="http://schemas.openxmlformats.org/drawingml/2006/main">
               <a:ext uri="{FF2B5EF4-FFF2-40B4-BE49-F238E27FC236}">
-                <a16:creationId xmlns:a16="http://schemas.microsoft.com/office/drawing/2014/main" id="{04E0B226-0CD6-4430-AA63-3CB66CDABB72}"/>
+                <a16:creationId xmlns:a16="http://schemas.microsoft.com/office/drawing/2014/main" id="{37B01FA6-B8B3-4A25-8411-4D0BB455BB0D}"/>
               </a:ext>
             </a:extLst>
           </p:cNvPr>
@@ -11736,7 +11736,7 @@
           <p:cNvPr id="4" name="Rectangle 3">
             <a:extLst xmlns:a="http://schemas.openxmlformats.org/drawingml/2006/main">
               <a:ext uri="{FF2B5EF4-FFF2-40B4-BE49-F238E27FC236}">
-                <a16:creationId xmlns:a16="http://schemas.microsoft.com/office/drawing/2014/main" id="{A4B50E3E-AC5D-4724-B7C5-0EEEBB0E7312}"/>
+                <a16:creationId xmlns:a16="http://schemas.microsoft.com/office/drawing/2014/main" id="{DE1491BD-1654-4925-AE8E-AAFA97E90987}"/>
               </a:ext>
             </a:extLst>
           </p:cNvPr>
@@ -11789,7 +11789,7 @@
           <p:cNvPr id="5" name="TextBox 4">
             <a:extLst xmlns:a="http://schemas.openxmlformats.org/drawingml/2006/main">
               <a:ext uri="{FF2B5EF4-FFF2-40B4-BE49-F238E27FC236}">
-                <a16:creationId xmlns:a16="http://schemas.microsoft.com/office/drawing/2014/main" id="{E285465C-ED5C-413E-9E08-D1E6F877EE9A}"/>
+                <a16:creationId xmlns:a16="http://schemas.microsoft.com/office/drawing/2014/main" id="{3AADF7B4-7948-4708-884F-D7CA9BBAB47D}"/>
               </a:ext>
             </a:extLst>
           </p:cNvPr>
@@ -11852,7 +11852,7 @@
           <p:cNvPr id="6" name="Rounded Rectangle 5">
             <a:extLst xmlns:a="http://schemas.openxmlformats.org/drawingml/2006/main">
               <a:ext uri="{FF2B5EF4-FFF2-40B4-BE49-F238E27FC236}">
-                <a16:creationId xmlns:a16="http://schemas.microsoft.com/office/drawing/2014/main" id="{4FAD3C12-F334-45B2-9FEB-70E85D95F8DA}"/>
+                <a16:creationId xmlns:a16="http://schemas.microsoft.com/office/drawing/2014/main" id="{061AA687-3FE8-4DAA-A504-6E29F0EEBDC5}"/>
               </a:ext>
             </a:extLst>
           </p:cNvPr>
@@ -11907,7 +11907,7 @@
           <p:cNvPr id="7" name="TextBox 6">
             <a:extLst xmlns:a="http://schemas.openxmlformats.org/drawingml/2006/main">
               <a:ext uri="{FF2B5EF4-FFF2-40B4-BE49-F238E27FC236}">
-                <a16:creationId xmlns:a16="http://schemas.microsoft.com/office/drawing/2014/main" id="{E1E49BFA-F718-4795-8523-E99500107FB2}"/>
+                <a16:creationId xmlns:a16="http://schemas.microsoft.com/office/drawing/2014/main" id="{E8A21D1E-0C17-4300-AD79-A274BCDB0F6C}"/>
               </a:ext>
             </a:extLst>
           </p:cNvPr>
@@ -12030,7 +12030,7 @@
           <p:cNvPr id="8" name="Rounded Rectangle 7">
             <a:extLst xmlns:a="http://schemas.openxmlformats.org/drawingml/2006/main">
               <a:ext uri="{FF2B5EF4-FFF2-40B4-BE49-F238E27FC236}">
-                <a16:creationId xmlns:a16="http://schemas.microsoft.com/office/drawing/2014/main" id="{88513E2E-9E62-4826-B60F-C8A6B9F0F3DC}"/>
+                <a16:creationId xmlns:a16="http://schemas.microsoft.com/office/drawing/2014/main" id="{129C3BAD-5DA8-4B19-A160-A1ED6CC0A744}"/>
               </a:ext>
             </a:extLst>
           </p:cNvPr>
@@ -12085,7 +12085,7 @@
           <p:cNvPr id="9" name="TextBox 8">
             <a:extLst xmlns:a="http://schemas.openxmlformats.org/drawingml/2006/main">
               <a:ext uri="{FF2B5EF4-FFF2-40B4-BE49-F238E27FC236}">
-                <a16:creationId xmlns:a16="http://schemas.microsoft.com/office/drawing/2014/main" id="{AD5BC6FD-6A34-4909-8D09-C3C5C18FE5FB}"/>
+                <a16:creationId xmlns:a16="http://schemas.microsoft.com/office/drawing/2014/main" id="{AA98C956-425F-47C5-9A84-8D7A216694C9}"/>
               </a:ext>
             </a:extLst>
           </p:cNvPr>
@@ -12208,7 +12208,7 @@
           <p:cNvPr id="10" name="Rounded Rectangle 9">
             <a:extLst xmlns:a="http://schemas.openxmlformats.org/drawingml/2006/main">
               <a:ext uri="{FF2B5EF4-FFF2-40B4-BE49-F238E27FC236}">
-                <a16:creationId xmlns:a16="http://schemas.microsoft.com/office/drawing/2014/main" id="{5B7A8876-D4CB-4E8C-8314-AA5C04CAA864}"/>
+                <a16:creationId xmlns:a16="http://schemas.microsoft.com/office/drawing/2014/main" id="{A2372D3D-7C3D-4058-BE8E-A56377A3CE7F}"/>
               </a:ext>
             </a:extLst>
           </p:cNvPr>
@@ -12263,7 +12263,7 @@
           <p:cNvPr id="11" name="TextBox 10">
             <a:extLst xmlns:a="http://schemas.openxmlformats.org/drawingml/2006/main">
               <a:ext uri="{FF2B5EF4-FFF2-40B4-BE49-F238E27FC236}">
-                <a16:creationId xmlns:a16="http://schemas.microsoft.com/office/drawing/2014/main" id="{01930F37-AADC-496E-AA3B-29B9ECF6B555}"/>
+                <a16:creationId xmlns:a16="http://schemas.microsoft.com/office/drawing/2014/main" id="{C5144AD1-14BD-4091-87CE-39F6A57BB4BE}"/>
               </a:ext>
             </a:extLst>
           </p:cNvPr>
@@ -12578,7 +12578,7 @@
                 <a:ea typeface="Calibri"/>
                 <a:cs typeface="Calibri"/>
               </a:rPr>
-              <a:t>• 95% CI: no_rag=[0.3500, 0.6500], k1=[0.3600, 0.6600], k3=[0.3800, 0.6800], k5=[0.4100, 0.7100], k10=[0.4300, 0.7300]</a:t>
+              <a:t>• Absolute Accuracy 95% CIs: no_rag=[0.3500, 0.6500], k1=[0.3600, 0.6600], k3=[0.3800, 0.6800], k5=[0.4100, 0.7100], k10=[0.4300, 0.7300]</a:t>
             </a:r>
           </a:p>
           <a:p xmlns:a="http://schemas.openxmlformats.org/drawingml/2006/main">
@@ -12613,7 +12613,7 @@
     </p:spTree>
     <p:extLst>
       <p:ext uri="{BB962C8B-B14F-4D97-AF65-F5344CB8AC3E}">
-        <p14:creationId xmlns:p14="http://schemas.microsoft.com/office/powerpoint/2010/main" val="760224879"/>
+        <p14:creationId xmlns:p14="http://schemas.microsoft.com/office/powerpoint/2010/main" val="1273040915"/>
       </p:ext>
     </p:extLst>
   </p:cSld>
@@ -12637,7 +12637,7 @@
           <p:cNvPr id="2" name="Rectangle 1">
             <a:extLst xmlns:a="http://schemas.openxmlformats.org/drawingml/2006/main">
               <a:ext uri="{FF2B5EF4-FFF2-40B4-BE49-F238E27FC236}">
-                <a16:creationId xmlns:a16="http://schemas.microsoft.com/office/drawing/2014/main" id="{D4BBE0A4-9BE1-4CE8-86A8-48CAF75E9611}"/>
+                <a16:creationId xmlns:a16="http://schemas.microsoft.com/office/drawing/2014/main" id="{0FB5042B-D635-4EA3-ABEB-8931641C6D07}"/>
               </a:ext>
             </a:extLst>
           </p:cNvPr>
@@ -12690,7 +12690,7 @@
           <p:cNvPr id="3" name="Rectangle 2">
             <a:extLst xmlns:a="http://schemas.openxmlformats.org/drawingml/2006/main">
               <a:ext uri="{FF2B5EF4-FFF2-40B4-BE49-F238E27FC236}">
-                <a16:creationId xmlns:a16="http://schemas.microsoft.com/office/drawing/2014/main" id="{8FA2EA55-FEA6-44CF-9209-DFE1D6C5DBEB}"/>
+                <a16:creationId xmlns:a16="http://schemas.microsoft.com/office/drawing/2014/main" id="{AF1D906F-1904-445E-94F0-C9FCE269B4CA}"/>
               </a:ext>
             </a:extLst>
           </p:cNvPr>
@@ -12743,7 +12743,7 @@
           <p:cNvPr id="4" name="Rectangle 3">
             <a:extLst xmlns:a="http://schemas.openxmlformats.org/drawingml/2006/main">
               <a:ext uri="{FF2B5EF4-FFF2-40B4-BE49-F238E27FC236}">
-                <a16:creationId xmlns:a16="http://schemas.microsoft.com/office/drawing/2014/main" id="{5B4BF4B3-5BC1-4B45-8BDE-21FCD63A2AE8}"/>
+                <a16:creationId xmlns:a16="http://schemas.microsoft.com/office/drawing/2014/main" id="{081EB570-0F04-489F-9BF9-34D84167BC50}"/>
               </a:ext>
             </a:extLst>
           </p:cNvPr>
@@ -12796,7 +12796,7 @@
           <p:cNvPr id="5" name="TextBox 4">
             <a:extLst xmlns:a="http://schemas.openxmlformats.org/drawingml/2006/main">
               <a:ext uri="{FF2B5EF4-FFF2-40B4-BE49-F238E27FC236}">
-                <a16:creationId xmlns:a16="http://schemas.microsoft.com/office/drawing/2014/main" id="{FA59C0EE-C01D-4477-8A32-8FB797D757C8}"/>
+                <a16:creationId xmlns:a16="http://schemas.microsoft.com/office/drawing/2014/main" id="{47A5B0FD-B3F5-44AF-9E05-520584B7C01E}"/>
               </a:ext>
             </a:extLst>
           </p:cNvPr>
@@ -12859,7 +12859,7 @@
           <p:cNvPr id="6" name="Rounded Rectangle 5">
             <a:extLst xmlns:a="http://schemas.openxmlformats.org/drawingml/2006/main">
               <a:ext uri="{FF2B5EF4-FFF2-40B4-BE49-F238E27FC236}">
-                <a16:creationId xmlns:a16="http://schemas.microsoft.com/office/drawing/2014/main" id="{865806B6-5F21-4B24-ABB3-9E8227234575}"/>
+                <a16:creationId xmlns:a16="http://schemas.microsoft.com/office/drawing/2014/main" id="{BBF47052-4C4C-4D04-BA0F-34F75ADBB453}"/>
               </a:ext>
             </a:extLst>
           </p:cNvPr>
@@ -12914,7 +12914,7 @@
           <p:cNvPr id="7" name="TextBox 6">
             <a:extLst xmlns:a="http://schemas.openxmlformats.org/drawingml/2006/main">
               <a:ext uri="{FF2B5EF4-FFF2-40B4-BE49-F238E27FC236}">
-                <a16:creationId xmlns:a16="http://schemas.microsoft.com/office/drawing/2014/main" id="{6C21F3D1-2E91-48EA-A81A-7659997B845B}"/>
+                <a16:creationId xmlns:a16="http://schemas.microsoft.com/office/drawing/2014/main" id="{D172AB9E-85A1-497B-9A12-9D32ADD45A70}"/>
               </a:ext>
             </a:extLst>
           </p:cNvPr>
@@ -12951,7 +12951,7 @@
               </a:defRPr>
             </a:pPr>
             <a:r>
-              <a:rPr sz="825" b="1">
+              <a:rPr sz="863" b="1">
                 <a:solidFill>
                   <a:srgbClr val="1E40AF"/>
                 </a:solidFill>
@@ -12978,7 +12978,7 @@
               </a:defRPr>
             </a:pPr>
             <a:r>
-              <a:rPr sz="825">
+              <a:rPr sz="863">
                 <a:solidFill>
                   <a:srgbClr val="0F172A"/>
                 </a:solidFill>
@@ -13005,7 +13005,7 @@
               </a:defRPr>
             </a:pPr>
             <a:r>
-              <a:rPr sz="825">
+              <a:rPr sz="863">
                 <a:solidFill>
                   <a:srgbClr val="0F172A"/>
                 </a:solidFill>
@@ -13032,7 +13032,7 @@
               </a:defRPr>
             </a:pPr>
             <a:r>
-              <a:rPr sz="825">
+              <a:rPr sz="863">
                 <a:solidFill>
                   <a:srgbClr val="0F172A"/>
                 </a:solidFill>
@@ -13059,7 +13059,7 @@
               </a:defRPr>
             </a:pPr>
             <a:r>
-              <a:rPr sz="825">
+              <a:rPr sz="863">
                 <a:solidFill>
                   <a:srgbClr val="0F172A"/>
                 </a:solidFill>
@@ -13086,7 +13086,7 @@
               </a:defRPr>
             </a:pPr>
             <a:r>
-              <a:rPr sz="825">
+              <a:rPr sz="863">
                 <a:solidFill>
                   <a:srgbClr val="0F172A"/>
                 </a:solidFill>
@@ -13113,7 +13113,7 @@
               </a:defRPr>
             </a:pPr>
             <a:r>
-              <a:rPr sz="825">
+              <a:rPr sz="863">
                 <a:solidFill>
                   <a:srgbClr val="0F172A"/>
                 </a:solidFill>
@@ -13140,7 +13140,7 @@
               </a:defRPr>
             </a:pPr>
             <a:r>
-              <a:rPr sz="825">
+              <a:rPr sz="863">
                 <a:solidFill>
                   <a:srgbClr val="0F172A"/>
                 </a:solidFill>
@@ -13167,7 +13167,7 @@
               </a:defRPr>
             </a:pPr>
             <a:r>
-              <a:rPr sz="825">
+              <a:rPr sz="863">
                 <a:solidFill>
                   <a:srgbClr val="0F172A"/>
                 </a:solidFill>
@@ -13194,7 +13194,7 @@
               </a:defRPr>
             </a:pPr>
             <a:r>
-              <a:rPr sz="825">
+              <a:rPr sz="863">
                 <a:solidFill>
                   <a:srgbClr val="0F172A"/>
                 </a:solidFill>
@@ -13221,7 +13221,7 @@
               </a:defRPr>
             </a:pPr>
             <a:r>
-              <a:rPr sz="825">
+              <a:rPr sz="863">
                 <a:solidFill>
                   <a:srgbClr val="0F172A"/>
                 </a:solidFill>
@@ -13248,7 +13248,7 @@
               </a:defRPr>
             </a:pPr>
             <a:r>
-              <a:rPr sz="825">
+              <a:rPr sz="863">
                 <a:solidFill>
                   <a:srgbClr val="0F172A"/>
                 </a:solidFill>
@@ -13275,7 +13275,7 @@
               </a:defRPr>
             </a:pPr>
             <a:r>
-              <a:rPr sz="825">
+              <a:rPr sz="863">
                 <a:solidFill>
                   <a:srgbClr val="0F172A"/>
                 </a:solidFill>
@@ -13302,7 +13302,7 @@
               </a:defRPr>
             </a:pPr>
             <a:r>
-              <a:rPr sz="825">
+              <a:rPr sz="863">
                 <a:solidFill>
                   <a:srgbClr val="0F172A"/>
                 </a:solidFill>
@@ -13329,7 +13329,7 @@
               </a:defRPr>
             </a:pPr>
             <a:r>
-              <a:rPr sz="825">
+              <a:rPr sz="863">
                 <a:solidFill>
                   <a:srgbClr val="0F172A"/>
                 </a:solidFill>
@@ -13356,7 +13356,7 @@
               </a:defRPr>
             </a:pPr>
             <a:r>
-              <a:rPr sz="825">
+              <a:rPr sz="863">
                 <a:solidFill>
                   <a:srgbClr val="0F172A"/>
                 </a:solidFill>
@@ -13378,7 +13378,7 @@
           <p:nvPr/>
         </p:nvPicPr>
         <p:blipFill>
-          <a:blip xmlns:r="http://schemas.openxmlformats.org/officeDocument/2006/relationships" xmlns:a="http://schemas.openxmlformats.org/drawingml/2006/main" r:embed="R1567479dd27a4000"/>
+          <a:blip xmlns:r="http://schemas.openxmlformats.org/officeDocument/2006/relationships" xmlns:a="http://schemas.openxmlformats.org/drawingml/2006/main" r:embed="R6149f2370fac48ed"/>
           <a:stretch xmlns:a="http://schemas.openxmlformats.org/drawingml/2006/main">
             <a:fillRect l="0" t="0" r="0" b="0"/>
           </a:stretch>
@@ -13398,7 +13398,7 @@
           <p:cNvPr id="9" name="Rounded Rectangle 8">
             <a:extLst xmlns:a="http://schemas.openxmlformats.org/drawingml/2006/main">
               <a:ext uri="{FF2B5EF4-FFF2-40B4-BE49-F238E27FC236}">
-                <a16:creationId xmlns:a16="http://schemas.microsoft.com/office/drawing/2014/main" id="{CB09E1CE-A8E7-47F9-9CB2-8037E94BD3D0}"/>
+                <a16:creationId xmlns:a16="http://schemas.microsoft.com/office/drawing/2014/main" id="{4DDBB250-948E-4E3D-9235-F8ADFFC3BA2C}"/>
               </a:ext>
             </a:extLst>
           </p:cNvPr>
@@ -13453,7 +13453,7 @@
           <p:cNvPr id="10" name="TextBox 9">
             <a:extLst xmlns:a="http://schemas.openxmlformats.org/drawingml/2006/main">
               <a:ext uri="{FF2B5EF4-FFF2-40B4-BE49-F238E27FC236}">
-                <a16:creationId xmlns:a16="http://schemas.microsoft.com/office/drawing/2014/main" id="{28E1BCAD-AA5C-496B-892C-5EFD0E5F07EF}"/>
+                <a16:creationId xmlns:a16="http://schemas.microsoft.com/office/drawing/2014/main" id="{E2F1F178-2D83-449B-8E65-DAC46C9811B1}"/>
               </a:ext>
             </a:extLst>
           </p:cNvPr>
@@ -13536,7 +13536,7 @@
     </p:spTree>
     <p:extLst>
       <p:ext uri="{BB962C8B-B14F-4D97-AF65-F5344CB8AC3E}">
-        <p14:creationId xmlns:p14="http://schemas.microsoft.com/office/powerpoint/2010/main" val="1100050484"/>
+        <p14:creationId xmlns:p14="http://schemas.microsoft.com/office/powerpoint/2010/main" val="1399506064"/>
       </p:ext>
     </p:extLst>
   </p:cSld>

</xml_diff>

<commit_message>
fix(presentation): replace tiny right chart with editable 5-row resource table on slide 9 and export presentation_v5
</commit_message>
<xml_diff>
--- a/reports/evidence/fixture_populated_slides.pptx
+++ b/reports/evidence/fixture_populated_slides.pptx
@@ -2,27 +2,131 @@
 <file path=ppt/presentation.xml><?xml version="1.0" encoding="utf-8"?>
 <p:presentation xmlns:p="http://schemas.openxmlformats.org/presentationml/2006/main">
   <p:sldMasterIdLst>
-    <p:sldMasterId xmlns:r="http://schemas.openxmlformats.org/officeDocument/2006/relationships" id="2147483648" r:id="R31109b3498894167"/>
+    <p:sldMasterId xmlns:r="http://schemas.openxmlformats.org/officeDocument/2006/relationships" id="2147483648" r:id="R8d6b25893e074af4"/>
   </p:sldMasterIdLst>
   <p:notesMasterIdLst>
-    <p:notesMasterId xmlns:r="http://schemas.openxmlformats.org/officeDocument/2006/relationships" r:id="R70a9a8da790c4a02"/>
+    <p:notesMasterId xmlns:r="http://schemas.openxmlformats.org/officeDocument/2006/relationships" r:id="Rad28c68a257e481d"/>
   </p:notesMasterIdLst>
   <p:sldIdLst>
-    <p:sldId xmlns:r="http://schemas.openxmlformats.org/officeDocument/2006/relationships" id="256" r:id="Rc16b122d3a794a8b"/>
-    <p:sldId xmlns:r="http://schemas.openxmlformats.org/officeDocument/2006/relationships" id="257" r:id="R07d14a099c9946cf"/>
-    <p:sldId xmlns:r="http://schemas.openxmlformats.org/officeDocument/2006/relationships" id="258" r:id="Rb3dfd3ae046e4e96"/>
-    <p:sldId xmlns:r="http://schemas.openxmlformats.org/officeDocument/2006/relationships" id="259" r:id="R9ef5f787049d4a03"/>
-    <p:sldId xmlns:r="http://schemas.openxmlformats.org/officeDocument/2006/relationships" id="260" r:id="R199355c59d794061"/>
-    <p:sldId xmlns:r="http://schemas.openxmlformats.org/officeDocument/2006/relationships" id="261" r:id="R8d166810d7754f5f"/>
-    <p:sldId xmlns:r="http://schemas.openxmlformats.org/officeDocument/2006/relationships" id="262" r:id="R655c04b5c490405f"/>
-    <p:sldId xmlns:r="http://schemas.openxmlformats.org/officeDocument/2006/relationships" id="263" r:id="Rec29d7b3b85f403a"/>
-    <p:sldId xmlns:r="http://schemas.openxmlformats.org/officeDocument/2006/relationships" id="264" r:id="Rf0135bb4847d40a8"/>
-    <p:sldId xmlns:r="http://schemas.openxmlformats.org/officeDocument/2006/relationships" id="265" r:id="R2989c017b20f4b23"/>
-    <p:sldId xmlns:r="http://schemas.openxmlformats.org/officeDocument/2006/relationships" id="266" r:id="Refc6e89f0b0540dd"/>
-    <p:sldId xmlns:r="http://schemas.openxmlformats.org/officeDocument/2006/relationships" id="267" r:id="Re07a985f72b4410e"/>
+    <p:sldId xmlns:r="http://schemas.openxmlformats.org/officeDocument/2006/relationships" id="256" r:id="R42c6b823cba44af3"/>
+    <p:sldId xmlns:r="http://schemas.openxmlformats.org/officeDocument/2006/relationships" id="257" r:id="R5b958a0c8de742fd"/>
+    <p:sldId xmlns:r="http://schemas.openxmlformats.org/officeDocument/2006/relationships" id="258" r:id="R4a5372163aa34f5d"/>
+    <p:sldId xmlns:r="http://schemas.openxmlformats.org/officeDocument/2006/relationships" id="259" r:id="Ra6cb1bd6c3f74bda"/>
+    <p:sldId xmlns:r="http://schemas.openxmlformats.org/officeDocument/2006/relationships" id="260" r:id="Rdb84edd8bf884405"/>
+    <p:sldId xmlns:r="http://schemas.openxmlformats.org/officeDocument/2006/relationships" id="261" r:id="Rff628730bb8347dd"/>
+    <p:sldId xmlns:r="http://schemas.openxmlformats.org/officeDocument/2006/relationships" id="262" r:id="R4a7be51562d84fa7"/>
+    <p:sldId xmlns:r="http://schemas.openxmlformats.org/officeDocument/2006/relationships" id="263" r:id="R435a1c5cad2d4ecd"/>
+    <p:sldId xmlns:r="http://schemas.openxmlformats.org/officeDocument/2006/relationships" id="264" r:id="Rd57917a01a2042d3"/>
+    <p:sldId xmlns:r="http://schemas.openxmlformats.org/officeDocument/2006/relationships" id="265" r:id="R8779158fe52f4724"/>
+    <p:sldId xmlns:r="http://schemas.openxmlformats.org/officeDocument/2006/relationships" id="266" r:id="R060768c3dbed4d8c"/>
+    <p:sldId xmlns:r="http://schemas.openxmlformats.org/officeDocument/2006/relationships" id="267" r:id="Rc73977ae20f7430e"/>
   </p:sldIdLst>
   <p:sldSz cx="12191695" cy="6858000"/>
   <p:notesSz cx="6858000" cy="9144000"/>
+  <p:defaultTextStyle>
+    <a:defPPr xmlns:a="http://schemas.openxmlformats.org/drawingml/2006/main">
+      <a:buNone/>
+    </a:defPPr>
+    <a:lvl1pPr xmlns:a="http://schemas.openxmlformats.org/drawingml/2006/main" marL="0" algn="l" defTabSz="457200">
+      <a:buNone/>
+      <a:defRPr sz="1800" kern="1200">
+        <a:solidFill>
+          <a:schemeClr val="tx1"/>
+        </a:solidFill>
+        <a:latin typeface="+mn-lt"/>
+        <a:ea typeface="+mn-lt"/>
+        <a:cs typeface="+mn-lt"/>
+      </a:defRPr>
+    </a:lvl1pPr>
+    <a:lvl2pPr xmlns:a="http://schemas.openxmlformats.org/drawingml/2006/main" marL="457200" algn="l" defTabSz="457200">
+      <a:buNone/>
+      <a:defRPr sz="1800" kern="1200">
+        <a:solidFill>
+          <a:schemeClr val="tx1"/>
+        </a:solidFill>
+        <a:latin typeface="+mn-lt"/>
+        <a:ea typeface="+mn-lt"/>
+        <a:cs typeface="+mn-lt"/>
+      </a:defRPr>
+    </a:lvl2pPr>
+    <a:lvl3pPr xmlns:a="http://schemas.openxmlformats.org/drawingml/2006/main" marL="914400" algn="l" defTabSz="457200">
+      <a:buNone/>
+      <a:defRPr sz="1800" kern="1200">
+        <a:solidFill>
+          <a:schemeClr val="tx1"/>
+        </a:solidFill>
+        <a:latin typeface="+mn-lt"/>
+        <a:ea typeface="+mn-lt"/>
+        <a:cs typeface="+mn-lt"/>
+      </a:defRPr>
+    </a:lvl3pPr>
+    <a:lvl4pPr xmlns:a="http://schemas.openxmlformats.org/drawingml/2006/main" marL="1371600" algn="l" defTabSz="457200">
+      <a:buNone/>
+      <a:defRPr sz="1800" kern="1200">
+        <a:solidFill>
+          <a:schemeClr val="tx1"/>
+        </a:solidFill>
+        <a:latin typeface="+mn-lt"/>
+        <a:ea typeface="+mn-lt"/>
+        <a:cs typeface="+mn-lt"/>
+      </a:defRPr>
+    </a:lvl4pPr>
+    <a:lvl5pPr xmlns:a="http://schemas.openxmlformats.org/drawingml/2006/main" marL="1828800" algn="l" defTabSz="457200">
+      <a:buNone/>
+      <a:defRPr sz="1800" kern="1200">
+        <a:solidFill>
+          <a:schemeClr val="tx1"/>
+        </a:solidFill>
+        <a:latin typeface="+mn-lt"/>
+        <a:ea typeface="+mn-lt"/>
+        <a:cs typeface="+mn-lt"/>
+      </a:defRPr>
+    </a:lvl5pPr>
+    <a:lvl6pPr xmlns:a="http://schemas.openxmlformats.org/drawingml/2006/main" marL="2286000" algn="l" defTabSz="457200">
+      <a:buNone/>
+      <a:defRPr sz="1800" kern="1200">
+        <a:solidFill>
+          <a:schemeClr val="tx1"/>
+        </a:solidFill>
+        <a:latin typeface="+mn-lt"/>
+        <a:ea typeface="+mn-lt"/>
+        <a:cs typeface="+mn-lt"/>
+      </a:defRPr>
+    </a:lvl6pPr>
+    <a:lvl7pPr xmlns:a="http://schemas.openxmlformats.org/drawingml/2006/main" marL="2743200" algn="l" defTabSz="457200">
+      <a:buNone/>
+      <a:defRPr sz="1800" kern="1200">
+        <a:solidFill>
+          <a:schemeClr val="tx1"/>
+        </a:solidFill>
+        <a:latin typeface="+mn-lt"/>
+        <a:ea typeface="+mn-lt"/>
+        <a:cs typeface="+mn-lt"/>
+      </a:defRPr>
+    </a:lvl7pPr>
+    <a:lvl8pPr xmlns:a="http://schemas.openxmlformats.org/drawingml/2006/main" marL="3200400" algn="l" defTabSz="457200">
+      <a:buNone/>
+      <a:defRPr sz="1800" kern="1200">
+        <a:solidFill>
+          <a:schemeClr val="tx1"/>
+        </a:solidFill>
+        <a:latin typeface="+mn-lt"/>
+        <a:ea typeface="+mn-lt"/>
+        <a:cs typeface="+mn-lt"/>
+      </a:defRPr>
+    </a:lvl8pPr>
+    <a:lvl9pPr xmlns:a="http://schemas.openxmlformats.org/drawingml/2006/main" marL="3657600" algn="l" defTabSz="457200">
+      <a:buNone/>
+      <a:defRPr sz="1800" kern="1200">
+        <a:solidFill>
+          <a:schemeClr val="tx1"/>
+        </a:solidFill>
+        <a:latin typeface="+mn-lt"/>
+        <a:ea typeface="+mn-lt"/>
+        <a:cs typeface="+mn-lt"/>
+      </a:defRPr>
+    </a:lvl9pPr>
+  </p:defaultTextStyle>
 </p:presentation>
 </file>
 
@@ -1473,7 +1577,7 @@
           <p:cNvPr id="2" name="Title 1">
             <a:extLst xmlns:a="http://schemas.openxmlformats.org/drawingml/2006/main">
               <a:ext uri="{FF2B5EF4-FFF2-40B4-BE49-F238E27FC236}">
-                <a16:creationId xmlns:a16="http://schemas.microsoft.com/office/drawing/2014/main" id="{87637113-9C5F-49BD-A620-E80C1A5B3FBF}"/>
+                <a16:creationId xmlns:a16="http://schemas.microsoft.com/office/drawing/2014/main" id="{A133F466-B639-41BC-8ACC-FAE823FC8C4D}"/>
               </a:ext>
             </a:extLst>
           </p:cNvPr>
@@ -1506,7 +1610,7 @@
           <p:cNvPr id="3" name="Subtitle 2">
             <a:extLst xmlns:a="http://schemas.openxmlformats.org/drawingml/2006/main">
               <a:ext uri="{FF2B5EF4-FFF2-40B4-BE49-F238E27FC236}">
-                <a16:creationId xmlns:a16="http://schemas.microsoft.com/office/drawing/2014/main" id="{0D42AF0B-BC36-4BA6-B996-20E647F88020}"/>
+                <a16:creationId xmlns:a16="http://schemas.microsoft.com/office/drawing/2014/main" id="{DA373217-AB0A-49A7-B904-4696B4DFED50}"/>
               </a:ext>
             </a:extLst>
           </p:cNvPr>
@@ -1630,7 +1734,7 @@
           <p:cNvPr id="4" name="Date Placeholder 3">
             <a:extLst xmlns:a="http://schemas.openxmlformats.org/drawingml/2006/main">
               <a:ext uri="{FF2B5EF4-FFF2-40B4-BE49-F238E27FC236}">
-                <a16:creationId xmlns:a16="http://schemas.microsoft.com/office/drawing/2014/main" id="{66C1118A-73A7-4A47-9610-5E28CBB38B9B}"/>
+                <a16:creationId xmlns:a16="http://schemas.microsoft.com/office/drawing/2014/main" id="{D0580FEB-F164-4CCC-8032-E45F321DA265}"/>
               </a:ext>
             </a:extLst>
           </p:cNvPr>
@@ -1658,7 +1762,7 @@
           <p:cNvPr id="5" name="Footer Placeholder 4">
             <a:extLst xmlns:a="http://schemas.openxmlformats.org/drawingml/2006/main">
               <a:ext uri="{FF2B5EF4-FFF2-40B4-BE49-F238E27FC236}">
-                <a16:creationId xmlns:a16="http://schemas.microsoft.com/office/drawing/2014/main" id="{34828C04-C5F5-4F26-B6B7-58AAF0E29886}"/>
+                <a16:creationId xmlns:a16="http://schemas.microsoft.com/office/drawing/2014/main" id="{6FF2872C-0A5E-44B5-8891-AE35E6F4A67E}"/>
               </a:ext>
             </a:extLst>
           </p:cNvPr>
@@ -1683,7 +1787,7 @@
           <p:cNvPr id="6" name="Slide Number Placeholder 5">
             <a:extLst xmlns:a="http://schemas.openxmlformats.org/drawingml/2006/main">
               <a:ext uri="{FF2B5EF4-FFF2-40B4-BE49-F238E27FC236}">
-                <a16:creationId xmlns:a16="http://schemas.microsoft.com/office/drawing/2014/main" id="{AC6F5BBE-39D3-4C10-BC75-362B7AA5A47D}"/>
+                <a16:creationId xmlns:a16="http://schemas.microsoft.com/office/drawing/2014/main" id="{637C316B-7131-4A4E-9ED5-69903DD69BC3}"/>
               </a:ext>
             </a:extLst>
           </p:cNvPr>
@@ -1728,7 +1832,7 @@
           <p:cNvPr id="2" name="Title 1">
             <a:extLst xmlns:a="http://schemas.openxmlformats.org/drawingml/2006/main">
               <a:ext uri="{FF2B5EF4-FFF2-40B4-BE49-F238E27FC236}">
-                <a16:creationId xmlns:a16="http://schemas.microsoft.com/office/drawing/2014/main" id="{81FCB0B8-D190-48EF-AD38-B1591837F946}"/>
+                <a16:creationId xmlns:a16="http://schemas.microsoft.com/office/drawing/2014/main" id="{6AC86A5F-9017-43EB-8A8C-2090B226599F}"/>
               </a:ext>
             </a:extLst>
           </p:cNvPr>
@@ -1756,7 +1860,7 @@
           <p:cNvPr id="3" name="Vertical Text Placeholder 2">
             <a:extLst xmlns:a="http://schemas.openxmlformats.org/drawingml/2006/main">
               <a:ext uri="{FF2B5EF4-FFF2-40B4-BE49-F238E27FC236}">
-                <a16:creationId xmlns:a16="http://schemas.microsoft.com/office/drawing/2014/main" id="{CD18897F-9CD5-498B-8ECB-06359AD0CAFF}"/>
+                <a16:creationId xmlns:a16="http://schemas.microsoft.com/office/drawing/2014/main" id="{47F06A0B-3CCB-4B68-AD43-D02B5E88FC73}"/>
               </a:ext>
             </a:extLst>
           </p:cNvPr>
@@ -1819,7 +1923,7 @@
           <p:cNvPr id="4" name="Date Placeholder 3">
             <a:extLst xmlns:a="http://schemas.openxmlformats.org/drawingml/2006/main">
               <a:ext uri="{FF2B5EF4-FFF2-40B4-BE49-F238E27FC236}">
-                <a16:creationId xmlns:a16="http://schemas.microsoft.com/office/drawing/2014/main" id="{D1909C94-169F-4313-8758-805A0E3EAD3A}"/>
+                <a16:creationId xmlns:a16="http://schemas.microsoft.com/office/drawing/2014/main" id="{B4B8FE75-78D7-4ACE-B284-2116E4DC2265}"/>
               </a:ext>
             </a:extLst>
           </p:cNvPr>
@@ -1847,7 +1951,7 @@
           <p:cNvPr id="5" name="Footer Placeholder 4">
             <a:extLst xmlns:a="http://schemas.openxmlformats.org/drawingml/2006/main">
               <a:ext uri="{FF2B5EF4-FFF2-40B4-BE49-F238E27FC236}">
-                <a16:creationId xmlns:a16="http://schemas.microsoft.com/office/drawing/2014/main" id="{DF0B42B3-04C2-470A-8406-D3B07CD18C04}"/>
+                <a16:creationId xmlns:a16="http://schemas.microsoft.com/office/drawing/2014/main" id="{55452CF7-DE64-4678-AC53-A9B9BA13FA42}"/>
               </a:ext>
             </a:extLst>
           </p:cNvPr>
@@ -1872,7 +1976,7 @@
           <p:cNvPr id="6" name="Slide Number Placeholder 5">
             <a:extLst xmlns:a="http://schemas.openxmlformats.org/drawingml/2006/main">
               <a:ext uri="{FF2B5EF4-FFF2-40B4-BE49-F238E27FC236}">
-                <a16:creationId xmlns:a16="http://schemas.microsoft.com/office/drawing/2014/main" id="{51E245BA-EE04-4693-AE30-C084F872C43B}"/>
+                <a16:creationId xmlns:a16="http://schemas.microsoft.com/office/drawing/2014/main" id="{6FA67FAB-BBC6-4EFE-ACF3-82EB5BBDB7A9}"/>
               </a:ext>
             </a:extLst>
           </p:cNvPr>
@@ -1917,7 +2021,7 @@
           <p:cNvPr id="2" name="Vertical Title 1">
             <a:extLst xmlns:a="http://schemas.openxmlformats.org/drawingml/2006/main">
               <a:ext uri="{FF2B5EF4-FFF2-40B4-BE49-F238E27FC236}">
-                <a16:creationId xmlns:a16="http://schemas.microsoft.com/office/drawing/2014/main" id="{2FD3B4EA-AA23-4A48-8821-510BE2A2E020}"/>
+                <a16:creationId xmlns:a16="http://schemas.microsoft.com/office/drawing/2014/main" id="{89CF581A-5C2A-4CC0-A77B-A20ADD18B5E8}"/>
               </a:ext>
             </a:extLst>
           </p:cNvPr>
@@ -1950,7 +2054,7 @@
           <p:cNvPr id="3" name="Vertical Text Placeholder 2">
             <a:extLst xmlns:a="http://schemas.openxmlformats.org/drawingml/2006/main">
               <a:ext uri="{FF2B5EF4-FFF2-40B4-BE49-F238E27FC236}">
-                <a16:creationId xmlns:a16="http://schemas.microsoft.com/office/drawing/2014/main" id="{94552581-89A4-4193-B437-C6BAF5A6254C}"/>
+                <a16:creationId xmlns:a16="http://schemas.microsoft.com/office/drawing/2014/main" id="{F5EEF56B-CEE6-4008-BECA-30F618CAE9B4}"/>
               </a:ext>
             </a:extLst>
           </p:cNvPr>
@@ -2018,7 +2122,7 @@
           <p:cNvPr id="4" name="Date Placeholder 3">
             <a:extLst xmlns:a="http://schemas.openxmlformats.org/drawingml/2006/main">
               <a:ext uri="{FF2B5EF4-FFF2-40B4-BE49-F238E27FC236}">
-                <a16:creationId xmlns:a16="http://schemas.microsoft.com/office/drawing/2014/main" id="{66DF79E0-5436-4E46-9097-636DC38496CA}"/>
+                <a16:creationId xmlns:a16="http://schemas.microsoft.com/office/drawing/2014/main" id="{C559B771-4A62-4E27-BF8A-4FFDBFB5281F}"/>
               </a:ext>
             </a:extLst>
           </p:cNvPr>
@@ -2046,7 +2150,7 @@
           <p:cNvPr id="5" name="Footer Placeholder 4">
             <a:extLst xmlns:a="http://schemas.openxmlformats.org/drawingml/2006/main">
               <a:ext uri="{FF2B5EF4-FFF2-40B4-BE49-F238E27FC236}">
-                <a16:creationId xmlns:a16="http://schemas.microsoft.com/office/drawing/2014/main" id="{F2C778AA-40B0-40FB-AF00-5C02B5247968}"/>
+                <a16:creationId xmlns:a16="http://schemas.microsoft.com/office/drawing/2014/main" id="{451B23B1-FF4D-49AE-A67A-1573AB962FBD}"/>
               </a:ext>
             </a:extLst>
           </p:cNvPr>
@@ -2071,7 +2175,7 @@
           <p:cNvPr id="6" name="Slide Number Placeholder 5">
             <a:extLst xmlns:a="http://schemas.openxmlformats.org/drawingml/2006/main">
               <a:ext uri="{FF2B5EF4-FFF2-40B4-BE49-F238E27FC236}">
-                <a16:creationId xmlns:a16="http://schemas.microsoft.com/office/drawing/2014/main" id="{BE2B159D-7645-43A8-A399-59B869DFC601}"/>
+                <a16:creationId xmlns:a16="http://schemas.microsoft.com/office/drawing/2014/main" id="{50DF5C2A-919B-4E54-88EC-642916104508}"/>
               </a:ext>
             </a:extLst>
           </p:cNvPr>
@@ -2116,7 +2220,7 @@
           <p:cNvPr id="2" name="Title 1">
             <a:extLst xmlns:a="http://schemas.openxmlformats.org/drawingml/2006/main">
               <a:ext uri="{FF2B5EF4-FFF2-40B4-BE49-F238E27FC236}">
-                <a16:creationId xmlns:a16="http://schemas.microsoft.com/office/drawing/2014/main" id="{D1B8F23B-F8F4-420F-B17A-6F34BAC5D4E4}"/>
+                <a16:creationId xmlns:a16="http://schemas.microsoft.com/office/drawing/2014/main" id="{8AA9D3DC-D92A-4836-B460-50FC688DB91C}"/>
               </a:ext>
             </a:extLst>
           </p:cNvPr>
@@ -2144,7 +2248,7 @@
           <p:cNvPr id="3" name="Content Placeholder 2">
             <a:extLst xmlns:a="http://schemas.openxmlformats.org/drawingml/2006/main">
               <a:ext uri="{FF2B5EF4-FFF2-40B4-BE49-F238E27FC236}">
-                <a16:creationId xmlns:a16="http://schemas.microsoft.com/office/drawing/2014/main" id="{65784F88-2AEF-4831-B53E-71B11845B67D}"/>
+                <a16:creationId xmlns:a16="http://schemas.microsoft.com/office/drawing/2014/main" id="{5AE5AB4E-EAB4-4A5B-980C-3B2F32E37BAB}"/>
               </a:ext>
             </a:extLst>
           </p:cNvPr>
@@ -2207,7 +2311,7 @@
           <p:cNvPr id="4" name="Date Placeholder 3">
             <a:extLst xmlns:a="http://schemas.openxmlformats.org/drawingml/2006/main">
               <a:ext uri="{FF2B5EF4-FFF2-40B4-BE49-F238E27FC236}">
-                <a16:creationId xmlns:a16="http://schemas.microsoft.com/office/drawing/2014/main" id="{D3E6366B-7A6D-4F7F-A0E4-959B5A570625}"/>
+                <a16:creationId xmlns:a16="http://schemas.microsoft.com/office/drawing/2014/main" id="{B2AF3671-6169-41CA-BA67-44B599A3F299}"/>
               </a:ext>
             </a:extLst>
           </p:cNvPr>
@@ -2235,7 +2339,7 @@
           <p:cNvPr id="5" name="Footer Placeholder 4">
             <a:extLst xmlns:a="http://schemas.openxmlformats.org/drawingml/2006/main">
               <a:ext uri="{FF2B5EF4-FFF2-40B4-BE49-F238E27FC236}">
-                <a16:creationId xmlns:a16="http://schemas.microsoft.com/office/drawing/2014/main" id="{FCBD9814-4A96-4941-B4A5-1F28EF2DFFFF}"/>
+                <a16:creationId xmlns:a16="http://schemas.microsoft.com/office/drawing/2014/main" id="{6BE774CD-FCED-47ED-91D9-9347105ED8A5}"/>
               </a:ext>
             </a:extLst>
           </p:cNvPr>
@@ -2260,7 +2364,7 @@
           <p:cNvPr id="6" name="Slide Number Placeholder 5">
             <a:extLst xmlns:a="http://schemas.openxmlformats.org/drawingml/2006/main">
               <a:ext uri="{FF2B5EF4-FFF2-40B4-BE49-F238E27FC236}">
-                <a16:creationId xmlns:a16="http://schemas.microsoft.com/office/drawing/2014/main" id="{0A4EBB8F-C70E-45BC-8521-F76041E02438}"/>
+                <a16:creationId xmlns:a16="http://schemas.microsoft.com/office/drawing/2014/main" id="{79332BA4-793E-474B-8560-DACFB220136F}"/>
               </a:ext>
             </a:extLst>
           </p:cNvPr>
@@ -2305,7 +2409,7 @@
           <p:cNvPr id="2" name="Title 1">
             <a:extLst xmlns:a="http://schemas.openxmlformats.org/drawingml/2006/main">
               <a:ext uri="{FF2B5EF4-FFF2-40B4-BE49-F238E27FC236}">
-                <a16:creationId xmlns:a16="http://schemas.microsoft.com/office/drawing/2014/main" id="{0518EEA6-2721-49C7-80B8-E1E2792E068D}"/>
+                <a16:creationId xmlns:a16="http://schemas.microsoft.com/office/drawing/2014/main" id="{43EA7274-B8E5-4B4B-ADC5-6DB26AC0D3E7}"/>
               </a:ext>
             </a:extLst>
           </p:cNvPr>
@@ -2343,7 +2447,7 @@
           <p:cNvPr id="3" name="Text Placeholder 2">
             <a:extLst xmlns:a="http://schemas.openxmlformats.org/drawingml/2006/main">
               <a:ext uri="{FF2B5EF4-FFF2-40B4-BE49-F238E27FC236}">
-                <a16:creationId xmlns:a16="http://schemas.microsoft.com/office/drawing/2014/main" id="{D8A3AE00-5548-4027-A857-AD7BE26624BB}"/>
+                <a16:creationId xmlns:a16="http://schemas.microsoft.com/office/drawing/2014/main" id="{84D2F316-EC02-41E3-BBDE-050400B34E6D}"/>
               </a:ext>
             </a:extLst>
           </p:cNvPr>
@@ -2469,7 +2573,7 @@
           <p:cNvPr id="4" name="Date Placeholder 3">
             <a:extLst xmlns:a="http://schemas.openxmlformats.org/drawingml/2006/main">
               <a:ext uri="{FF2B5EF4-FFF2-40B4-BE49-F238E27FC236}">
-                <a16:creationId xmlns:a16="http://schemas.microsoft.com/office/drawing/2014/main" id="{1BFEC21A-521B-4839-9B2F-CC782E7154C5}"/>
+                <a16:creationId xmlns:a16="http://schemas.microsoft.com/office/drawing/2014/main" id="{6C325968-D9F3-4DA4-8CD8-1223698BC0E9}"/>
               </a:ext>
             </a:extLst>
           </p:cNvPr>
@@ -2497,7 +2601,7 @@
           <p:cNvPr id="5" name="Footer Placeholder 4">
             <a:extLst xmlns:a="http://schemas.openxmlformats.org/drawingml/2006/main">
               <a:ext uri="{FF2B5EF4-FFF2-40B4-BE49-F238E27FC236}">
-                <a16:creationId xmlns:a16="http://schemas.microsoft.com/office/drawing/2014/main" id="{FF593524-9A90-4836-86FD-E844F3896774}"/>
+                <a16:creationId xmlns:a16="http://schemas.microsoft.com/office/drawing/2014/main" id="{590FE396-4D15-46D1-AE80-C807C5DC9CB4}"/>
               </a:ext>
             </a:extLst>
           </p:cNvPr>
@@ -2522,7 +2626,7 @@
           <p:cNvPr id="6" name="Slide Number Placeholder 5">
             <a:extLst xmlns:a="http://schemas.openxmlformats.org/drawingml/2006/main">
               <a:ext uri="{FF2B5EF4-FFF2-40B4-BE49-F238E27FC236}">
-                <a16:creationId xmlns:a16="http://schemas.microsoft.com/office/drawing/2014/main" id="{FC30DBEE-719F-4BCB-9B56-35A31F26977B}"/>
+                <a16:creationId xmlns:a16="http://schemas.microsoft.com/office/drawing/2014/main" id="{43A3FFC4-CF92-4D2A-8A3C-E8523763A8B7}"/>
               </a:ext>
             </a:extLst>
           </p:cNvPr>
@@ -2567,7 +2671,7 @@
           <p:cNvPr id="2" name="Title 1">
             <a:extLst xmlns:a="http://schemas.openxmlformats.org/drawingml/2006/main">
               <a:ext uri="{FF2B5EF4-FFF2-40B4-BE49-F238E27FC236}">
-                <a16:creationId xmlns:a16="http://schemas.microsoft.com/office/drawing/2014/main" id="{5B5C6482-3AEB-42AA-BD4B-AE7A61F58598}"/>
+                <a16:creationId xmlns:a16="http://schemas.microsoft.com/office/drawing/2014/main" id="{1C7EDC5D-F0D4-4209-BDA4-B9D9DFD3E306}"/>
               </a:ext>
             </a:extLst>
           </p:cNvPr>
@@ -2595,7 +2699,7 @@
           <p:cNvPr id="3" name="Content Placeholder 2">
             <a:extLst xmlns:a="http://schemas.openxmlformats.org/drawingml/2006/main">
               <a:ext uri="{FF2B5EF4-FFF2-40B4-BE49-F238E27FC236}">
-                <a16:creationId xmlns:a16="http://schemas.microsoft.com/office/drawing/2014/main" id="{2C529F22-117F-4B62-ACDE-6D76BB7E6CC0}"/>
+                <a16:creationId xmlns:a16="http://schemas.microsoft.com/office/drawing/2014/main" id="{1C7CF480-57F1-453C-9B6C-BCDDEE0EA606}"/>
               </a:ext>
             </a:extLst>
           </p:cNvPr>
@@ -2700,7 +2804,7 @@
           <p:cNvPr id="4" name="Content Placeholder 3">
             <a:extLst xmlns:a="http://schemas.openxmlformats.org/drawingml/2006/main">
               <a:ext uri="{FF2B5EF4-FFF2-40B4-BE49-F238E27FC236}">
-                <a16:creationId xmlns:a16="http://schemas.microsoft.com/office/drawing/2014/main" id="{E2A6B91E-B3EF-4B7E-90E5-C8545B08A2B4}"/>
+                <a16:creationId xmlns:a16="http://schemas.microsoft.com/office/drawing/2014/main" id="{5883344A-9CF3-4539-856B-FB11292D8E0A}"/>
               </a:ext>
             </a:extLst>
           </p:cNvPr>
@@ -2805,7 +2909,7 @@
           <p:cNvPr id="5" name="Date Placeholder 4">
             <a:extLst xmlns:a="http://schemas.openxmlformats.org/drawingml/2006/main">
               <a:ext uri="{FF2B5EF4-FFF2-40B4-BE49-F238E27FC236}">
-                <a16:creationId xmlns:a16="http://schemas.microsoft.com/office/drawing/2014/main" id="{22496858-1FC6-4448-949D-AE6E214D3DE8}"/>
+                <a16:creationId xmlns:a16="http://schemas.microsoft.com/office/drawing/2014/main" id="{012FE445-5E05-48AE-81BC-7A2ACCC731D2}"/>
               </a:ext>
             </a:extLst>
           </p:cNvPr>
@@ -2833,7 +2937,7 @@
           <p:cNvPr id="6" name="Footer Placeholder 5">
             <a:extLst xmlns:a="http://schemas.openxmlformats.org/drawingml/2006/main">
               <a:ext uri="{FF2B5EF4-FFF2-40B4-BE49-F238E27FC236}">
-                <a16:creationId xmlns:a16="http://schemas.microsoft.com/office/drawing/2014/main" id="{386A89CF-8608-48A5-B162-AD44C1B3B0E3}"/>
+                <a16:creationId xmlns:a16="http://schemas.microsoft.com/office/drawing/2014/main" id="{D79F8EFE-D762-48F9-BBDC-262DF99C6C08}"/>
               </a:ext>
             </a:extLst>
           </p:cNvPr>
@@ -2858,7 +2962,7 @@
           <p:cNvPr id="7" name="Slide Number Placeholder 6">
             <a:extLst xmlns:a="http://schemas.openxmlformats.org/drawingml/2006/main">
               <a:ext uri="{FF2B5EF4-FFF2-40B4-BE49-F238E27FC236}">
-                <a16:creationId xmlns:a16="http://schemas.microsoft.com/office/drawing/2014/main" id="{D6D909E3-7464-4CF9-BE4B-6209835659D2}"/>
+                <a16:creationId xmlns:a16="http://schemas.microsoft.com/office/drawing/2014/main" id="{DDCA9C43-32C1-4D9E-A7B1-BD5A40A23D63}"/>
               </a:ext>
             </a:extLst>
           </p:cNvPr>
@@ -2903,7 +3007,7 @@
           <p:cNvPr id="2" name="Title 1">
             <a:extLst xmlns:a="http://schemas.openxmlformats.org/drawingml/2006/main">
               <a:ext uri="{FF2B5EF4-FFF2-40B4-BE49-F238E27FC236}">
-                <a16:creationId xmlns:a16="http://schemas.microsoft.com/office/drawing/2014/main" id="{A54F120A-4992-4CD5-8ADA-F0D3BBDB6CB1}"/>
+                <a16:creationId xmlns:a16="http://schemas.microsoft.com/office/drawing/2014/main" id="{D7FDAED5-4B53-4AE8-882E-6E277E23B7BF}"/>
               </a:ext>
             </a:extLst>
           </p:cNvPr>
@@ -2936,7 +3040,7 @@
           <p:cNvPr id="3" name="Text Placeholder 2">
             <a:extLst xmlns:a="http://schemas.openxmlformats.org/drawingml/2006/main">
               <a:ext uri="{FF2B5EF4-FFF2-40B4-BE49-F238E27FC236}">
-                <a16:creationId xmlns:a16="http://schemas.microsoft.com/office/drawing/2014/main" id="{B44291D3-8E8D-40E8-B3E8-1FD78BEA7039}"/>
+                <a16:creationId xmlns:a16="http://schemas.microsoft.com/office/drawing/2014/main" id="{F79BE1E1-AD4C-4127-B8A1-D7412A120124}"/>
               </a:ext>
             </a:extLst>
           </p:cNvPr>
@@ -3008,7 +3112,7 @@
           <p:cNvPr id="4" name="Content Placeholder 3">
             <a:extLst xmlns:a="http://schemas.openxmlformats.org/drawingml/2006/main">
               <a:ext uri="{FF2B5EF4-FFF2-40B4-BE49-F238E27FC236}">
-                <a16:creationId xmlns:a16="http://schemas.microsoft.com/office/drawing/2014/main" id="{E4F6738C-6D25-440F-8288-C732A1B0EFAD}"/>
+                <a16:creationId xmlns:a16="http://schemas.microsoft.com/office/drawing/2014/main" id="{82285AE6-3FA2-491A-9966-C5B4F03D8743}"/>
               </a:ext>
             </a:extLst>
           </p:cNvPr>
@@ -3113,7 +3217,7 @@
           <p:cNvPr id="5" name="Text Placeholder 4">
             <a:extLst xmlns:a="http://schemas.openxmlformats.org/drawingml/2006/main">
               <a:ext uri="{FF2B5EF4-FFF2-40B4-BE49-F238E27FC236}">
-                <a16:creationId xmlns:a16="http://schemas.microsoft.com/office/drawing/2014/main" id="{C2C547C3-A5A8-4DD5-A136-79B5DA444CCB}"/>
+                <a16:creationId xmlns:a16="http://schemas.microsoft.com/office/drawing/2014/main" id="{C250DB89-0C43-4101-BBD3-0C4E7FB6028C}"/>
               </a:ext>
             </a:extLst>
           </p:cNvPr>
@@ -3185,7 +3289,7 @@
           <p:cNvPr id="6" name="Content Placeholder 5">
             <a:extLst xmlns:a="http://schemas.openxmlformats.org/drawingml/2006/main">
               <a:ext uri="{FF2B5EF4-FFF2-40B4-BE49-F238E27FC236}">
-                <a16:creationId xmlns:a16="http://schemas.microsoft.com/office/drawing/2014/main" id="{EA9778E9-7688-44E7-9FF0-6BFAD43FF398}"/>
+                <a16:creationId xmlns:a16="http://schemas.microsoft.com/office/drawing/2014/main" id="{4DBA596F-29F1-428F-904D-8699B0790ECA}"/>
               </a:ext>
             </a:extLst>
           </p:cNvPr>
@@ -3290,7 +3394,7 @@
           <p:cNvPr id="7" name="Date Placeholder 6">
             <a:extLst xmlns:a="http://schemas.openxmlformats.org/drawingml/2006/main">
               <a:ext uri="{FF2B5EF4-FFF2-40B4-BE49-F238E27FC236}">
-                <a16:creationId xmlns:a16="http://schemas.microsoft.com/office/drawing/2014/main" id="{FA5E5DF9-8ADA-4F51-815F-4FBAEAACB472}"/>
+                <a16:creationId xmlns:a16="http://schemas.microsoft.com/office/drawing/2014/main" id="{CEE2D3D0-9215-4EAF-88E5-88F811DFE4D2}"/>
               </a:ext>
             </a:extLst>
           </p:cNvPr>
@@ -3318,7 +3422,7 @@
           <p:cNvPr id="8" name="Footer Placeholder 7">
             <a:extLst xmlns:a="http://schemas.openxmlformats.org/drawingml/2006/main">
               <a:ext uri="{FF2B5EF4-FFF2-40B4-BE49-F238E27FC236}">
-                <a16:creationId xmlns:a16="http://schemas.microsoft.com/office/drawing/2014/main" id="{0BCFD174-7958-4EE7-94FD-E4A1FC7CEB4B}"/>
+                <a16:creationId xmlns:a16="http://schemas.microsoft.com/office/drawing/2014/main" id="{7A83A992-49F2-42BE-B219-D34FBB703CD9}"/>
               </a:ext>
             </a:extLst>
           </p:cNvPr>
@@ -3343,7 +3447,7 @@
           <p:cNvPr id="9" name="Slide Number Placeholder 8">
             <a:extLst xmlns:a="http://schemas.openxmlformats.org/drawingml/2006/main">
               <a:ext uri="{FF2B5EF4-FFF2-40B4-BE49-F238E27FC236}">
-                <a16:creationId xmlns:a16="http://schemas.microsoft.com/office/drawing/2014/main" id="{0C4A39FD-6EC2-4661-B55A-58D47F90E0A4}"/>
+                <a16:creationId xmlns:a16="http://schemas.microsoft.com/office/drawing/2014/main" id="{B632F2B8-B245-4E0D-9443-FBDCA661AB2B}"/>
               </a:ext>
             </a:extLst>
           </p:cNvPr>
@@ -3388,7 +3492,7 @@
           <p:cNvPr id="2" name="Title 1">
             <a:extLst xmlns:a="http://schemas.openxmlformats.org/drawingml/2006/main">
               <a:ext uri="{FF2B5EF4-FFF2-40B4-BE49-F238E27FC236}">
-                <a16:creationId xmlns:a16="http://schemas.microsoft.com/office/drawing/2014/main" id="{B176DCB0-7EF1-4111-819E-1EE6AAD661FA}"/>
+                <a16:creationId xmlns:a16="http://schemas.microsoft.com/office/drawing/2014/main" id="{093E1C0B-8698-49B7-B9E6-3A1CDD58586E}"/>
               </a:ext>
             </a:extLst>
           </p:cNvPr>
@@ -3416,7 +3520,7 @@
           <p:cNvPr id="3" name="Date Placeholder 2">
             <a:extLst xmlns:a="http://schemas.openxmlformats.org/drawingml/2006/main">
               <a:ext uri="{FF2B5EF4-FFF2-40B4-BE49-F238E27FC236}">
-                <a16:creationId xmlns:a16="http://schemas.microsoft.com/office/drawing/2014/main" id="{7D0973DD-3974-4DE3-9701-98009BC4BDAB}"/>
+                <a16:creationId xmlns:a16="http://schemas.microsoft.com/office/drawing/2014/main" id="{C7ED8F34-FDB4-4938-BEE9-07B8E15B8C89}"/>
               </a:ext>
             </a:extLst>
           </p:cNvPr>
@@ -3444,7 +3548,7 @@
           <p:cNvPr id="4" name="Footer Placeholder 3">
             <a:extLst xmlns:a="http://schemas.openxmlformats.org/drawingml/2006/main">
               <a:ext uri="{FF2B5EF4-FFF2-40B4-BE49-F238E27FC236}">
-                <a16:creationId xmlns:a16="http://schemas.microsoft.com/office/drawing/2014/main" id="{7D623FE4-5043-49A0-913B-DA4E3B8251EA}"/>
+                <a16:creationId xmlns:a16="http://schemas.microsoft.com/office/drawing/2014/main" id="{8E7D0772-4796-4BF3-AFE8-9E9F1AB984E4}"/>
               </a:ext>
             </a:extLst>
           </p:cNvPr>
@@ -3469,7 +3573,7 @@
           <p:cNvPr id="5" name="Slide Number Placeholder 4">
             <a:extLst xmlns:a="http://schemas.openxmlformats.org/drawingml/2006/main">
               <a:ext uri="{FF2B5EF4-FFF2-40B4-BE49-F238E27FC236}">
-                <a16:creationId xmlns:a16="http://schemas.microsoft.com/office/drawing/2014/main" id="{95295E1E-02EC-45F0-9B9D-6B0A36CA51C2}"/>
+                <a16:creationId xmlns:a16="http://schemas.microsoft.com/office/drawing/2014/main" id="{F53A675C-9509-4E38-8268-A0A2EE8F4720}"/>
               </a:ext>
             </a:extLst>
           </p:cNvPr>
@@ -3514,7 +3618,7 @@
           <p:cNvPr id="2" name="Date Placeholder 1">
             <a:extLst xmlns:a="http://schemas.openxmlformats.org/drawingml/2006/main">
               <a:ext uri="{FF2B5EF4-FFF2-40B4-BE49-F238E27FC236}">
-                <a16:creationId xmlns:a16="http://schemas.microsoft.com/office/drawing/2014/main" id="{8F6191BA-351C-47D5-866F-12D38CDC7806}"/>
+                <a16:creationId xmlns:a16="http://schemas.microsoft.com/office/drawing/2014/main" id="{DB290794-0FD3-44A0-94F6-ECB0D589398C}"/>
               </a:ext>
             </a:extLst>
           </p:cNvPr>
@@ -3542,7 +3646,7 @@
           <p:cNvPr id="3" name="Footer Placeholder 2">
             <a:extLst xmlns:a="http://schemas.openxmlformats.org/drawingml/2006/main">
               <a:ext uri="{FF2B5EF4-FFF2-40B4-BE49-F238E27FC236}">
-                <a16:creationId xmlns:a16="http://schemas.microsoft.com/office/drawing/2014/main" id="{965DF5FA-113A-4775-994A-2BF5AD345F79}"/>
+                <a16:creationId xmlns:a16="http://schemas.microsoft.com/office/drawing/2014/main" id="{F5E61D68-4944-40BE-9049-59B5333A6AF6}"/>
               </a:ext>
             </a:extLst>
           </p:cNvPr>
@@ -3567,7 +3671,7 @@
           <p:cNvPr id="4" name="Slide Number Placeholder 3">
             <a:extLst xmlns:a="http://schemas.openxmlformats.org/drawingml/2006/main">
               <a:ext uri="{FF2B5EF4-FFF2-40B4-BE49-F238E27FC236}">
-                <a16:creationId xmlns:a16="http://schemas.microsoft.com/office/drawing/2014/main" id="{721DC5CB-0DD7-4E10-9D60-5A5E82D21926}"/>
+                <a16:creationId xmlns:a16="http://schemas.microsoft.com/office/drawing/2014/main" id="{E290B1D7-42FC-42CC-95BF-AE973818EB29}"/>
               </a:ext>
             </a:extLst>
           </p:cNvPr>
@@ -3612,7 +3716,7 @@
           <p:cNvPr id="2" name="Title 1">
             <a:extLst xmlns:a="http://schemas.openxmlformats.org/drawingml/2006/main">
               <a:ext uri="{FF2B5EF4-FFF2-40B4-BE49-F238E27FC236}">
-                <a16:creationId xmlns:a16="http://schemas.microsoft.com/office/drawing/2014/main" id="{9232F6BC-88E3-4F13-8254-7F1021CA8EAB}"/>
+                <a16:creationId xmlns:a16="http://schemas.microsoft.com/office/drawing/2014/main" id="{56B77538-8A66-4F05-A1B9-D7F591020720}"/>
               </a:ext>
             </a:extLst>
           </p:cNvPr>
@@ -3650,7 +3754,7 @@
           <p:cNvPr id="3" name="Content Placeholder 2">
             <a:extLst xmlns:a="http://schemas.openxmlformats.org/drawingml/2006/main">
               <a:ext uri="{FF2B5EF4-FFF2-40B4-BE49-F238E27FC236}">
-                <a16:creationId xmlns:a16="http://schemas.microsoft.com/office/drawing/2014/main" id="{247FBDC6-1FF4-435F-B9AF-1C5D027BB45D}"/>
+                <a16:creationId xmlns:a16="http://schemas.microsoft.com/office/drawing/2014/main" id="{058153D6-5207-418F-99AE-DB5BE657C9AA}"/>
               </a:ext>
             </a:extLst>
           </p:cNvPr>
@@ -3755,7 +3859,7 @@
           <p:cNvPr id="4" name="Text Placeholder 3">
             <a:extLst xmlns:a="http://schemas.openxmlformats.org/drawingml/2006/main">
               <a:ext uri="{FF2B5EF4-FFF2-40B4-BE49-F238E27FC236}">
-                <a16:creationId xmlns:a16="http://schemas.microsoft.com/office/drawing/2014/main" id="{BA621BD8-C41F-4824-BD03-CBA5F4EE1CC5}"/>
+                <a16:creationId xmlns:a16="http://schemas.microsoft.com/office/drawing/2014/main" id="{C9A0B03A-B9FB-48AE-8B68-CFF68421FDCF}"/>
               </a:ext>
             </a:extLst>
           </p:cNvPr>
@@ -3827,7 +3931,7 @@
           <p:cNvPr id="5" name="Date Placeholder 4">
             <a:extLst xmlns:a="http://schemas.openxmlformats.org/drawingml/2006/main">
               <a:ext uri="{FF2B5EF4-FFF2-40B4-BE49-F238E27FC236}">
-                <a16:creationId xmlns:a16="http://schemas.microsoft.com/office/drawing/2014/main" id="{4C31CEF4-20B2-49E5-B9AA-B1B25F9815DC}"/>
+                <a16:creationId xmlns:a16="http://schemas.microsoft.com/office/drawing/2014/main" id="{6D56352C-F680-4128-A7A8-299C839E6B8F}"/>
               </a:ext>
             </a:extLst>
           </p:cNvPr>
@@ -3855,7 +3959,7 @@
           <p:cNvPr id="6" name="Footer Placeholder 5">
             <a:extLst xmlns:a="http://schemas.openxmlformats.org/drawingml/2006/main">
               <a:ext uri="{FF2B5EF4-FFF2-40B4-BE49-F238E27FC236}">
-                <a16:creationId xmlns:a16="http://schemas.microsoft.com/office/drawing/2014/main" id="{F3997A19-A6C3-43E7-A2C9-1D8B4DA70D43}"/>
+                <a16:creationId xmlns:a16="http://schemas.microsoft.com/office/drawing/2014/main" id="{7E7DCF77-319C-4051-8718-4463A7AEFCBE}"/>
               </a:ext>
             </a:extLst>
           </p:cNvPr>
@@ -3880,7 +3984,7 @@
           <p:cNvPr id="7" name="Slide Number Placeholder 6">
             <a:extLst xmlns:a="http://schemas.openxmlformats.org/drawingml/2006/main">
               <a:ext uri="{FF2B5EF4-FFF2-40B4-BE49-F238E27FC236}">
-                <a16:creationId xmlns:a16="http://schemas.microsoft.com/office/drawing/2014/main" id="{11E59FF3-C9D3-4AEB-8C69-B0C5057427E4}"/>
+                <a16:creationId xmlns:a16="http://schemas.microsoft.com/office/drawing/2014/main" id="{3F4D9C68-C95D-4D81-A048-F28F04D2BF18}"/>
               </a:ext>
             </a:extLst>
           </p:cNvPr>
@@ -3925,7 +4029,7 @@
           <p:cNvPr id="2" name="Title 1">
             <a:extLst xmlns:a="http://schemas.openxmlformats.org/drawingml/2006/main">
               <a:ext uri="{FF2B5EF4-FFF2-40B4-BE49-F238E27FC236}">
-                <a16:creationId xmlns:a16="http://schemas.microsoft.com/office/drawing/2014/main" id="{001D7CD4-DD4E-471A-AC69-FEBA50DEB75E}"/>
+                <a16:creationId xmlns:a16="http://schemas.microsoft.com/office/drawing/2014/main" id="{C5C862B3-81FA-46FE-9237-86811C51A94A}"/>
               </a:ext>
             </a:extLst>
           </p:cNvPr>
@@ -3963,7 +4067,7 @@
           <p:cNvPr id="3" name="Picture Placeholder 2">
             <a:extLst xmlns:a="http://schemas.openxmlformats.org/drawingml/2006/main">
               <a:ext uri="{FF2B5EF4-FFF2-40B4-BE49-F238E27FC236}">
-                <a16:creationId xmlns:a16="http://schemas.microsoft.com/office/drawing/2014/main" id="{C2A508DA-138C-4347-99C1-D8BAF9D9D793}"/>
+                <a16:creationId xmlns:a16="http://schemas.microsoft.com/office/drawing/2014/main" id="{779183DC-7EDB-4B20-B78D-927482FD686F}"/>
               </a:ext>
             </a:extLst>
           </p:cNvPr>
@@ -4030,7 +4134,7 @@
           <p:cNvPr id="4" name="Text Placeholder 3">
             <a:extLst xmlns:a="http://schemas.openxmlformats.org/drawingml/2006/main">
               <a:ext uri="{FF2B5EF4-FFF2-40B4-BE49-F238E27FC236}">
-                <a16:creationId xmlns:a16="http://schemas.microsoft.com/office/drawing/2014/main" id="{BC5EB1A8-6E76-418F-862C-4AA2A8FC543B}"/>
+                <a16:creationId xmlns:a16="http://schemas.microsoft.com/office/drawing/2014/main" id="{33B1BC80-21E0-4F34-8437-FD301269BBF6}"/>
               </a:ext>
             </a:extLst>
           </p:cNvPr>
@@ -4102,7 +4206,7 @@
           <p:cNvPr id="5" name="Date Placeholder 4">
             <a:extLst xmlns:a="http://schemas.openxmlformats.org/drawingml/2006/main">
               <a:ext uri="{FF2B5EF4-FFF2-40B4-BE49-F238E27FC236}">
-                <a16:creationId xmlns:a16="http://schemas.microsoft.com/office/drawing/2014/main" id="{FD8CABE8-E38D-4E9B-A6DC-6F5114584440}"/>
+                <a16:creationId xmlns:a16="http://schemas.microsoft.com/office/drawing/2014/main" id="{A29C85A6-A25F-4037-B447-115BF41CA24E}"/>
               </a:ext>
             </a:extLst>
           </p:cNvPr>
@@ -4130,7 +4234,7 @@
           <p:cNvPr id="6" name="Footer Placeholder 5">
             <a:extLst xmlns:a="http://schemas.openxmlformats.org/drawingml/2006/main">
               <a:ext uri="{FF2B5EF4-FFF2-40B4-BE49-F238E27FC236}">
-                <a16:creationId xmlns:a16="http://schemas.microsoft.com/office/drawing/2014/main" id="{58ADA187-743D-4610-8AFB-F22078916186}"/>
+                <a16:creationId xmlns:a16="http://schemas.microsoft.com/office/drawing/2014/main" id="{9930E315-EED6-4EA0-9FF5-4736C7929A33}"/>
               </a:ext>
             </a:extLst>
           </p:cNvPr>
@@ -4155,7 +4259,7 @@
           <p:cNvPr id="7" name="Slide Number Placeholder 6">
             <a:extLst xmlns:a="http://schemas.openxmlformats.org/drawingml/2006/main">
               <a:ext uri="{FF2B5EF4-FFF2-40B4-BE49-F238E27FC236}">
-                <a16:creationId xmlns:a16="http://schemas.microsoft.com/office/drawing/2014/main" id="{2778182B-5063-4F08-8EF3-E1B400935654}"/>
+                <a16:creationId xmlns:a16="http://schemas.microsoft.com/office/drawing/2014/main" id="{5C637C4E-F129-4F46-BF28-64E2DD128D8D}"/>
               </a:ext>
             </a:extLst>
           </p:cNvPr>
@@ -4205,7 +4309,7 @@
           <p:cNvPr id="2" name="Title Placeholder 1">
             <a:extLst xmlns:a="http://schemas.openxmlformats.org/drawingml/2006/main">
               <a:ext uri="{FF2B5EF4-FFF2-40B4-BE49-F238E27FC236}">
-                <a16:creationId xmlns:a16="http://schemas.microsoft.com/office/drawing/2014/main" id="{FC840009-D4F9-4C04-9C15-6C9053D2098F}"/>
+                <a16:creationId xmlns:a16="http://schemas.microsoft.com/office/drawing/2014/main" id="{ECD6DF1E-9BC0-49D1-817A-87D81EAF2FFF}"/>
               </a:ext>
             </a:extLst>
           </p:cNvPr>
@@ -4243,7 +4347,7 @@
           <p:cNvPr id="3" name="Text Placeholder 2">
             <a:extLst xmlns:a="http://schemas.openxmlformats.org/drawingml/2006/main">
               <a:ext uri="{FF2B5EF4-FFF2-40B4-BE49-F238E27FC236}">
-                <a16:creationId xmlns:a16="http://schemas.microsoft.com/office/drawing/2014/main" id="{C6F3E2ED-EECA-4035-B9F8-8610D3DCD015}"/>
+                <a16:creationId xmlns:a16="http://schemas.microsoft.com/office/drawing/2014/main" id="{9970E215-33B6-47F0-B301-2F166D27808D}"/>
               </a:ext>
             </a:extLst>
           </p:cNvPr>
@@ -4316,7 +4420,7 @@
           <p:cNvPr id="4" name="Date Placeholder 3">
             <a:extLst xmlns:a="http://schemas.openxmlformats.org/drawingml/2006/main">
               <a:ext uri="{FF2B5EF4-FFF2-40B4-BE49-F238E27FC236}">
-                <a16:creationId xmlns:a16="http://schemas.microsoft.com/office/drawing/2014/main" id="{C9A5D752-CFFE-4890-A117-EC36BE3DF964}"/>
+                <a16:creationId xmlns:a16="http://schemas.microsoft.com/office/drawing/2014/main" id="{80971FA2-06F4-46C9-AA6D-D5DB77EEEC42}"/>
               </a:ext>
             </a:extLst>
           </p:cNvPr>
@@ -4363,7 +4467,7 @@
           <p:cNvPr id="5" name="Footer Placeholder 4">
             <a:extLst xmlns:a="http://schemas.openxmlformats.org/drawingml/2006/main">
               <a:ext uri="{FF2B5EF4-FFF2-40B4-BE49-F238E27FC236}">
-                <a16:creationId xmlns:a16="http://schemas.microsoft.com/office/drawing/2014/main" id="{ECD0ADE8-AE2D-425E-805B-8622460D30E0}"/>
+                <a16:creationId xmlns:a16="http://schemas.microsoft.com/office/drawing/2014/main" id="{7211908E-1A9A-4654-9BCE-853212201D1F}"/>
               </a:ext>
             </a:extLst>
           </p:cNvPr>
@@ -4407,7 +4511,7 @@
           <p:cNvPr id="6" name="Slide Number Placeholder 5">
             <a:extLst xmlns:a="http://schemas.openxmlformats.org/drawingml/2006/main">
               <a:ext uri="{FF2B5EF4-FFF2-40B4-BE49-F238E27FC236}">
-                <a16:creationId xmlns:a16="http://schemas.microsoft.com/office/drawing/2014/main" id="{1C8712A2-92BF-4CAF-B167-561130759AD2}"/>
+                <a16:creationId xmlns:a16="http://schemas.microsoft.com/office/drawing/2014/main" id="{4638E421-4D94-4DF3-8CCE-F05D679D2E1E}"/>
               </a:ext>
             </a:extLst>
           </p:cNvPr>
@@ -4453,17 +4557,17 @@
   </p:cSld>
   <p:clrMap bg1="lt1" tx1="dk1" bg2="lt2" tx2="dk2" accent1="accent1" accent2="accent2" accent3="accent3" accent4="accent4" accent5="accent5" accent6="accent6" hlink="hlink" folHlink="folHlink"/>
   <p:sldLayoutIdLst>
-    <p:sldLayoutId xmlns:r="http://schemas.openxmlformats.org/officeDocument/2006/relationships" id="2147483649" r:id="Raf3922c657e44813"/>
-    <p:sldLayoutId xmlns:r="http://schemas.openxmlformats.org/officeDocument/2006/relationships" id="2147483650" r:id="Raf271fbccecc4f0d"/>
-    <p:sldLayoutId xmlns:r="http://schemas.openxmlformats.org/officeDocument/2006/relationships" id="2147483651" r:id="R748e3af98f4e4cba"/>
-    <p:sldLayoutId xmlns:r="http://schemas.openxmlformats.org/officeDocument/2006/relationships" id="2147483652" r:id="R36e687991f8b4b11"/>
-    <p:sldLayoutId xmlns:r="http://schemas.openxmlformats.org/officeDocument/2006/relationships" id="2147483653" r:id="Rac7108310a994338"/>
-    <p:sldLayoutId xmlns:r="http://schemas.openxmlformats.org/officeDocument/2006/relationships" id="2147483654" r:id="R599bc1c7e8994ad4"/>
-    <p:sldLayoutId xmlns:r="http://schemas.openxmlformats.org/officeDocument/2006/relationships" id="2147483655" r:id="R890c9ce882604687"/>
-    <p:sldLayoutId xmlns:r="http://schemas.openxmlformats.org/officeDocument/2006/relationships" id="2147483656" r:id="Rdc5c4628d8ef4650"/>
-    <p:sldLayoutId xmlns:r="http://schemas.openxmlformats.org/officeDocument/2006/relationships" id="2147483657" r:id="R4d9e8236b1944f07"/>
-    <p:sldLayoutId xmlns:r="http://schemas.openxmlformats.org/officeDocument/2006/relationships" id="2147483658" r:id="Rf57c43459e3444d4"/>
-    <p:sldLayoutId xmlns:r="http://schemas.openxmlformats.org/officeDocument/2006/relationships" id="2147483659" r:id="R5694e51afd7e4fd8"/>
+    <p:sldLayoutId xmlns:r="http://schemas.openxmlformats.org/officeDocument/2006/relationships" id="2147483649" r:id="Rcee08fda37f045c6"/>
+    <p:sldLayoutId xmlns:r="http://schemas.openxmlformats.org/officeDocument/2006/relationships" id="2147483650" r:id="R36791f7eeb2e4dcf"/>
+    <p:sldLayoutId xmlns:r="http://schemas.openxmlformats.org/officeDocument/2006/relationships" id="2147483651" r:id="Rcab5b21f4fc6489b"/>
+    <p:sldLayoutId xmlns:r="http://schemas.openxmlformats.org/officeDocument/2006/relationships" id="2147483652" r:id="Rac861a4775e14913"/>
+    <p:sldLayoutId xmlns:r="http://schemas.openxmlformats.org/officeDocument/2006/relationships" id="2147483653" r:id="Ra503fe8c42294942"/>
+    <p:sldLayoutId xmlns:r="http://schemas.openxmlformats.org/officeDocument/2006/relationships" id="2147483654" r:id="Rf1fbbcf196c34e8d"/>
+    <p:sldLayoutId xmlns:r="http://schemas.openxmlformats.org/officeDocument/2006/relationships" id="2147483655" r:id="R4efa0766c79d49ba"/>
+    <p:sldLayoutId xmlns:r="http://schemas.openxmlformats.org/officeDocument/2006/relationships" id="2147483656" r:id="Ree8d71ff7b8042a2"/>
+    <p:sldLayoutId xmlns:r="http://schemas.openxmlformats.org/officeDocument/2006/relationships" id="2147483657" r:id="R0634b1ee1cf44fd1"/>
+    <p:sldLayoutId xmlns:r="http://schemas.openxmlformats.org/officeDocument/2006/relationships" id="2147483658" r:id="R7a2db39534734c15"/>
+    <p:sldLayoutId xmlns:r="http://schemas.openxmlformats.org/officeDocument/2006/relationships" id="2147483659" r:id="R7fa461af172741a9"/>
   </p:sldLayoutIdLst>
   <p:txStyles>
     <p:titleStyle>
@@ -5009,7 +5113,7 @@
           <p:cNvPr id="2" name="Rectangle 1">
             <a:extLst xmlns:a="http://schemas.openxmlformats.org/drawingml/2006/main">
               <a:ext uri="{FF2B5EF4-FFF2-40B4-BE49-F238E27FC236}">
-                <a16:creationId xmlns:a16="http://schemas.microsoft.com/office/drawing/2014/main" id="{D76A1697-90F4-4B99-9BC8-C5CA394025C1}"/>
+                <a16:creationId xmlns:a16="http://schemas.microsoft.com/office/drawing/2014/main" id="{E0DBA1F5-EDAD-49E2-BEF0-0A387BA12739}"/>
               </a:ext>
             </a:extLst>
           </p:cNvPr>
@@ -5062,7 +5166,7 @@
           <p:cNvPr id="3" name="Rectangle 2">
             <a:extLst xmlns:a="http://schemas.openxmlformats.org/drawingml/2006/main">
               <a:ext uri="{FF2B5EF4-FFF2-40B4-BE49-F238E27FC236}">
-                <a16:creationId xmlns:a16="http://schemas.microsoft.com/office/drawing/2014/main" id="{C16B95B4-DDB9-4778-BA1D-1F24CB1F04C2}"/>
+                <a16:creationId xmlns:a16="http://schemas.microsoft.com/office/drawing/2014/main" id="{1EF05680-7F28-4037-AAD0-1330D6D18E97}"/>
               </a:ext>
             </a:extLst>
           </p:cNvPr>
@@ -5115,7 +5219,7 @@
           <p:cNvPr id="4" name="TextBox 3">
             <a:extLst xmlns:a="http://schemas.openxmlformats.org/drawingml/2006/main">
               <a:ext uri="{FF2B5EF4-FFF2-40B4-BE49-F238E27FC236}">
-                <a16:creationId xmlns:a16="http://schemas.microsoft.com/office/drawing/2014/main" id="{EA6FB49C-DC38-4A45-897C-146F28B3D9CE}"/>
+                <a16:creationId xmlns:a16="http://schemas.microsoft.com/office/drawing/2014/main" id="{7039D2C1-E2AF-42AB-B240-3A507C7378F3}"/>
               </a:ext>
             </a:extLst>
           </p:cNvPr>
@@ -5217,7 +5321,7 @@
     </p:spTree>
     <p:extLst>
       <p:ext uri="{BB962C8B-B14F-4D97-AF65-F5344CB8AC3E}">
-        <p14:creationId xmlns:p14="http://schemas.microsoft.com/office/powerpoint/2010/main" val="178200091"/>
+        <p14:creationId xmlns:p14="http://schemas.microsoft.com/office/powerpoint/2010/main" val="2028931425"/>
       </p:ext>
     </p:extLst>
   </p:cSld>
@@ -5241,7 +5345,7 @@
           <p:cNvPr id="2" name="Rectangle 1">
             <a:extLst xmlns:a="http://schemas.openxmlformats.org/drawingml/2006/main">
               <a:ext uri="{FF2B5EF4-FFF2-40B4-BE49-F238E27FC236}">
-                <a16:creationId xmlns:a16="http://schemas.microsoft.com/office/drawing/2014/main" id="{8711F2B7-47CA-4D51-BC74-AA906703C970}"/>
+                <a16:creationId xmlns:a16="http://schemas.microsoft.com/office/drawing/2014/main" id="{2F9AD40C-D0CD-4F33-9B6A-B54B129D2C07}"/>
               </a:ext>
             </a:extLst>
           </p:cNvPr>
@@ -5294,7 +5398,7 @@
           <p:cNvPr id="3" name="Rectangle 2">
             <a:extLst xmlns:a="http://schemas.openxmlformats.org/drawingml/2006/main">
               <a:ext uri="{FF2B5EF4-FFF2-40B4-BE49-F238E27FC236}">
-                <a16:creationId xmlns:a16="http://schemas.microsoft.com/office/drawing/2014/main" id="{ABEB9E9B-34CF-4D83-A82C-A1DB7ED9C826}"/>
+                <a16:creationId xmlns:a16="http://schemas.microsoft.com/office/drawing/2014/main" id="{A8A3AAB7-03C7-4D9F-A1F5-D9FF055BB660}"/>
               </a:ext>
             </a:extLst>
           </p:cNvPr>
@@ -5347,7 +5451,7 @@
           <p:cNvPr id="4" name="Rectangle 3">
             <a:extLst xmlns:a="http://schemas.openxmlformats.org/drawingml/2006/main">
               <a:ext uri="{FF2B5EF4-FFF2-40B4-BE49-F238E27FC236}">
-                <a16:creationId xmlns:a16="http://schemas.microsoft.com/office/drawing/2014/main" id="{888EC119-A4E6-4A4B-A61A-10F507921A12}"/>
+                <a16:creationId xmlns:a16="http://schemas.microsoft.com/office/drawing/2014/main" id="{4558FC54-9D35-4A64-A0B1-DB641395266D}"/>
               </a:ext>
             </a:extLst>
           </p:cNvPr>
@@ -5400,7 +5504,7 @@
           <p:cNvPr id="5" name="TextBox 4">
             <a:extLst xmlns:a="http://schemas.openxmlformats.org/drawingml/2006/main">
               <a:ext uri="{FF2B5EF4-FFF2-40B4-BE49-F238E27FC236}">
-                <a16:creationId xmlns:a16="http://schemas.microsoft.com/office/drawing/2014/main" id="{4E4E1A01-53AE-476E-831D-369ADB44A234}"/>
+                <a16:creationId xmlns:a16="http://schemas.microsoft.com/office/drawing/2014/main" id="{BF2EDFCE-6FDE-4620-924E-58DD16177C36}"/>
               </a:ext>
             </a:extLst>
           </p:cNvPr>
@@ -5463,7 +5567,7 @@
           <p:cNvPr id="6" name="Rounded Rectangle 5">
             <a:extLst xmlns:a="http://schemas.openxmlformats.org/drawingml/2006/main">
               <a:ext uri="{FF2B5EF4-FFF2-40B4-BE49-F238E27FC236}">
-                <a16:creationId xmlns:a16="http://schemas.microsoft.com/office/drawing/2014/main" id="{108ACEAE-9C7C-419F-8010-A0A4033809D8}"/>
+                <a16:creationId xmlns:a16="http://schemas.microsoft.com/office/drawing/2014/main" id="{361592C9-D48C-415B-8467-F12C9D394E76}"/>
               </a:ext>
             </a:extLst>
           </p:cNvPr>
@@ -5518,7 +5622,7 @@
           <p:cNvPr id="7" name="TextBox 6">
             <a:extLst xmlns:a="http://schemas.openxmlformats.org/drawingml/2006/main">
               <a:ext uri="{FF2B5EF4-FFF2-40B4-BE49-F238E27FC236}">
-                <a16:creationId xmlns:a16="http://schemas.microsoft.com/office/drawing/2014/main" id="{70297104-3780-4A93-B20E-C8912629EBF4}"/>
+                <a16:creationId xmlns:a16="http://schemas.microsoft.com/office/drawing/2014/main" id="{1539E09D-42D1-46F0-9DAD-EBA61E566E26}"/>
               </a:ext>
             </a:extLst>
           </p:cNvPr>
@@ -5622,7 +5726,7 @@
           <p:cNvPr id="8" name="Rounded Rectangle 7">
             <a:extLst xmlns:a="http://schemas.openxmlformats.org/drawingml/2006/main">
               <a:ext uri="{FF2B5EF4-FFF2-40B4-BE49-F238E27FC236}">
-                <a16:creationId xmlns:a16="http://schemas.microsoft.com/office/drawing/2014/main" id="{AFB01487-D1C5-48CD-8805-621BEB891248}"/>
+                <a16:creationId xmlns:a16="http://schemas.microsoft.com/office/drawing/2014/main" id="{252B45E2-C014-482A-BD80-D3D25CAD3AC9}"/>
               </a:ext>
             </a:extLst>
           </p:cNvPr>
@@ -5677,7 +5781,7 @@
           <p:cNvPr id="9" name="TextBox 8">
             <a:extLst xmlns:a="http://schemas.openxmlformats.org/drawingml/2006/main">
               <a:ext uri="{FF2B5EF4-FFF2-40B4-BE49-F238E27FC236}">
-                <a16:creationId xmlns:a16="http://schemas.microsoft.com/office/drawing/2014/main" id="{D492C280-90BE-49C3-B418-D7182F93138D}"/>
+                <a16:creationId xmlns:a16="http://schemas.microsoft.com/office/drawing/2014/main" id="{97EA0682-ED7A-4A4B-877D-703C755C57A0}"/>
               </a:ext>
             </a:extLst>
           </p:cNvPr>
@@ -5762,7 +5866,7 @@
           <p:cNvPr id="10" name="Rounded Rectangle 9">
             <a:extLst xmlns:a="http://schemas.openxmlformats.org/drawingml/2006/main">
               <a:ext uri="{FF2B5EF4-FFF2-40B4-BE49-F238E27FC236}">
-                <a16:creationId xmlns:a16="http://schemas.microsoft.com/office/drawing/2014/main" id="{4AD75E00-3F82-4202-8DAE-E327215ACECC}"/>
+                <a16:creationId xmlns:a16="http://schemas.microsoft.com/office/drawing/2014/main" id="{9300663A-57F7-4BB5-9CC8-F033FB0F66B0}"/>
               </a:ext>
             </a:extLst>
           </p:cNvPr>
@@ -5817,7 +5921,7 @@
           <p:cNvPr id="11" name="TextBox 10">
             <a:extLst xmlns:a="http://schemas.openxmlformats.org/drawingml/2006/main">
               <a:ext uri="{FF2B5EF4-FFF2-40B4-BE49-F238E27FC236}">
-                <a16:creationId xmlns:a16="http://schemas.microsoft.com/office/drawing/2014/main" id="{CF85E344-F3E9-4C30-A032-3A5D2F64D319}"/>
+                <a16:creationId xmlns:a16="http://schemas.microsoft.com/office/drawing/2014/main" id="{1D826F69-571F-4FD0-B867-E52F10851802}"/>
               </a:ext>
             </a:extLst>
           </p:cNvPr>
@@ -5919,7 +6023,7 @@
     </p:spTree>
     <p:extLst>
       <p:ext uri="{BB962C8B-B14F-4D97-AF65-F5344CB8AC3E}">
-        <p14:creationId xmlns:p14="http://schemas.microsoft.com/office/powerpoint/2010/main" val="470099464"/>
+        <p14:creationId xmlns:p14="http://schemas.microsoft.com/office/powerpoint/2010/main" val="733324667"/>
       </p:ext>
     </p:extLst>
   </p:cSld>
@@ -5943,7 +6047,7 @@
           <p:cNvPr id="2" name="Rectangle 1">
             <a:extLst xmlns:a="http://schemas.openxmlformats.org/drawingml/2006/main">
               <a:ext uri="{FF2B5EF4-FFF2-40B4-BE49-F238E27FC236}">
-                <a16:creationId xmlns:a16="http://schemas.microsoft.com/office/drawing/2014/main" id="{0C7BF7B5-FCC4-41DF-8D74-AC20A1259968}"/>
+                <a16:creationId xmlns:a16="http://schemas.microsoft.com/office/drawing/2014/main" id="{49B8E7FD-4EA8-4904-9272-81ACBAFE91C1}"/>
               </a:ext>
             </a:extLst>
           </p:cNvPr>
@@ -5996,7 +6100,7 @@
           <p:cNvPr id="3" name="Rectangle 2">
             <a:extLst xmlns:a="http://schemas.openxmlformats.org/drawingml/2006/main">
               <a:ext uri="{FF2B5EF4-FFF2-40B4-BE49-F238E27FC236}">
-                <a16:creationId xmlns:a16="http://schemas.microsoft.com/office/drawing/2014/main" id="{B500CCDD-8810-4B5F-8B1D-F030CE53D622}"/>
+                <a16:creationId xmlns:a16="http://schemas.microsoft.com/office/drawing/2014/main" id="{220BB2E2-7BCD-4650-8C7B-FDCDC1728D78}"/>
               </a:ext>
             </a:extLst>
           </p:cNvPr>
@@ -6049,7 +6153,7 @@
           <p:cNvPr id="4" name="Rectangle 3">
             <a:extLst xmlns:a="http://schemas.openxmlformats.org/drawingml/2006/main">
               <a:ext uri="{FF2B5EF4-FFF2-40B4-BE49-F238E27FC236}">
-                <a16:creationId xmlns:a16="http://schemas.microsoft.com/office/drawing/2014/main" id="{65034374-E11F-4C13-B64C-742301D08D17}"/>
+                <a16:creationId xmlns:a16="http://schemas.microsoft.com/office/drawing/2014/main" id="{38A5135E-D1BE-4854-A8CD-0755E90558BF}"/>
               </a:ext>
             </a:extLst>
           </p:cNvPr>
@@ -6102,7 +6206,7 @@
           <p:cNvPr id="5" name="TextBox 4">
             <a:extLst xmlns:a="http://schemas.openxmlformats.org/drawingml/2006/main">
               <a:ext uri="{FF2B5EF4-FFF2-40B4-BE49-F238E27FC236}">
-                <a16:creationId xmlns:a16="http://schemas.microsoft.com/office/drawing/2014/main" id="{8333E2FE-CE2F-4E82-996E-CF10FAD8BF49}"/>
+                <a16:creationId xmlns:a16="http://schemas.microsoft.com/office/drawing/2014/main" id="{881FC1C7-8E00-44B5-A3D9-7F1125CF73D2}"/>
               </a:ext>
             </a:extLst>
           </p:cNvPr>
@@ -6165,7 +6269,7 @@
           <p:cNvPr id="6" name="Rounded Rectangle 5">
             <a:extLst xmlns:a="http://schemas.openxmlformats.org/drawingml/2006/main">
               <a:ext uri="{FF2B5EF4-FFF2-40B4-BE49-F238E27FC236}">
-                <a16:creationId xmlns:a16="http://schemas.microsoft.com/office/drawing/2014/main" id="{45EB4F14-2A8E-4C77-9024-D9C8212A5C67}"/>
+                <a16:creationId xmlns:a16="http://schemas.microsoft.com/office/drawing/2014/main" id="{D09A8FEA-5DDD-4469-9473-2F1ACBA8D9DC}"/>
               </a:ext>
             </a:extLst>
           </p:cNvPr>
@@ -6220,7 +6324,7 @@
           <p:cNvPr id="7" name="TextBox 6">
             <a:extLst xmlns:a="http://schemas.openxmlformats.org/drawingml/2006/main">
               <a:ext uri="{FF2B5EF4-FFF2-40B4-BE49-F238E27FC236}">
-                <a16:creationId xmlns:a16="http://schemas.microsoft.com/office/drawing/2014/main" id="{3524A44E-B9FE-4AB7-BD21-95446992213E}"/>
+                <a16:creationId xmlns:a16="http://schemas.microsoft.com/office/drawing/2014/main" id="{120FB8D9-C369-46E8-876F-997B1DF8E8CE}"/>
               </a:ext>
             </a:extLst>
           </p:cNvPr>
@@ -6419,7 +6523,7 @@
           <p:cNvPr id="8" name="Rounded Rectangle 7">
             <a:extLst xmlns:a="http://schemas.openxmlformats.org/drawingml/2006/main">
               <a:ext uri="{FF2B5EF4-FFF2-40B4-BE49-F238E27FC236}">
-                <a16:creationId xmlns:a16="http://schemas.microsoft.com/office/drawing/2014/main" id="{4B84D7D3-1D96-499F-9BC7-2D1875C3D101}"/>
+                <a16:creationId xmlns:a16="http://schemas.microsoft.com/office/drawing/2014/main" id="{8A14E537-EA72-46DD-9E26-33372B364A01}"/>
               </a:ext>
             </a:extLst>
           </p:cNvPr>
@@ -6474,7 +6578,7 @@
           <p:cNvPr id="9" name="TextBox 8">
             <a:extLst xmlns:a="http://schemas.openxmlformats.org/drawingml/2006/main">
               <a:ext uri="{FF2B5EF4-FFF2-40B4-BE49-F238E27FC236}">
-                <a16:creationId xmlns:a16="http://schemas.microsoft.com/office/drawing/2014/main" id="{F708977B-AD76-4CE2-9CA8-3663A3655653}"/>
+                <a16:creationId xmlns:a16="http://schemas.microsoft.com/office/drawing/2014/main" id="{7C852D77-A1D4-4F0C-B18B-203BCFAB24A8}"/>
               </a:ext>
             </a:extLst>
           </p:cNvPr>
@@ -6595,7 +6699,7 @@
     </p:spTree>
     <p:extLst>
       <p:ext uri="{BB962C8B-B14F-4D97-AF65-F5344CB8AC3E}">
-        <p14:creationId xmlns:p14="http://schemas.microsoft.com/office/powerpoint/2010/main" val="249662082"/>
+        <p14:creationId xmlns:p14="http://schemas.microsoft.com/office/powerpoint/2010/main" val="2009182731"/>
       </p:ext>
     </p:extLst>
   </p:cSld>
@@ -6619,7 +6723,7 @@
           <p:cNvPr id="2" name="Rectangle 1">
             <a:extLst xmlns:a="http://schemas.openxmlformats.org/drawingml/2006/main">
               <a:ext uri="{FF2B5EF4-FFF2-40B4-BE49-F238E27FC236}">
-                <a16:creationId xmlns:a16="http://schemas.microsoft.com/office/drawing/2014/main" id="{8C905FE4-B36E-4252-A6C2-75E454B8DE39}"/>
+                <a16:creationId xmlns:a16="http://schemas.microsoft.com/office/drawing/2014/main" id="{209929C7-D563-4E95-B7E8-B863E661347B}"/>
               </a:ext>
             </a:extLst>
           </p:cNvPr>
@@ -6672,7 +6776,7 @@
           <p:cNvPr id="3" name="Rectangle 2">
             <a:extLst xmlns:a="http://schemas.openxmlformats.org/drawingml/2006/main">
               <a:ext uri="{FF2B5EF4-FFF2-40B4-BE49-F238E27FC236}">
-                <a16:creationId xmlns:a16="http://schemas.microsoft.com/office/drawing/2014/main" id="{6C26D553-092B-40EA-BB2F-531C135E0B83}"/>
+                <a16:creationId xmlns:a16="http://schemas.microsoft.com/office/drawing/2014/main" id="{21FFB2B4-5B74-45E1-95E2-2AF326FE3C9D}"/>
               </a:ext>
             </a:extLst>
           </p:cNvPr>
@@ -6725,7 +6829,7 @@
           <p:cNvPr id="4" name="TextBox 3">
             <a:extLst xmlns:a="http://schemas.openxmlformats.org/drawingml/2006/main">
               <a:ext uri="{FF2B5EF4-FFF2-40B4-BE49-F238E27FC236}">
-                <a16:creationId xmlns:a16="http://schemas.microsoft.com/office/drawing/2014/main" id="{27B56AF8-59D8-4072-B628-D0ED99C3CD5B}"/>
+                <a16:creationId xmlns:a16="http://schemas.microsoft.com/office/drawing/2014/main" id="{6F661533-EF29-400D-AACC-19304E41D1AF}"/>
               </a:ext>
             </a:extLst>
           </p:cNvPr>
@@ -6903,7 +7007,7 @@
     </p:spTree>
     <p:extLst>
       <p:ext uri="{BB962C8B-B14F-4D97-AF65-F5344CB8AC3E}">
-        <p14:creationId xmlns:p14="http://schemas.microsoft.com/office/powerpoint/2010/main" val="18029351"/>
+        <p14:creationId xmlns:p14="http://schemas.microsoft.com/office/powerpoint/2010/main" val="2022037832"/>
       </p:ext>
     </p:extLst>
   </p:cSld>
@@ -6927,7 +7031,7 @@
           <p:cNvPr id="2" name="Rectangle 1">
             <a:extLst xmlns:a="http://schemas.openxmlformats.org/drawingml/2006/main">
               <a:ext uri="{FF2B5EF4-FFF2-40B4-BE49-F238E27FC236}">
-                <a16:creationId xmlns:a16="http://schemas.microsoft.com/office/drawing/2014/main" id="{CB14A08F-0CC5-4970-8BA7-AC4E0D00C299}"/>
+                <a16:creationId xmlns:a16="http://schemas.microsoft.com/office/drawing/2014/main" id="{3CFD2998-13E2-4E2A-B29F-4B57AC0E7273}"/>
               </a:ext>
             </a:extLst>
           </p:cNvPr>
@@ -6980,7 +7084,7 @@
           <p:cNvPr id="3" name="Rectangle 2">
             <a:extLst xmlns:a="http://schemas.openxmlformats.org/drawingml/2006/main">
               <a:ext uri="{FF2B5EF4-FFF2-40B4-BE49-F238E27FC236}">
-                <a16:creationId xmlns:a16="http://schemas.microsoft.com/office/drawing/2014/main" id="{5F31F494-CBD5-48A7-96ED-3410FB8B6A84}"/>
+                <a16:creationId xmlns:a16="http://schemas.microsoft.com/office/drawing/2014/main" id="{D726062E-DFB9-4844-BBE5-EB0EFBE1959C}"/>
               </a:ext>
             </a:extLst>
           </p:cNvPr>
@@ -7033,7 +7137,7 @@
           <p:cNvPr id="4" name="Rectangle 3">
             <a:extLst xmlns:a="http://schemas.openxmlformats.org/drawingml/2006/main">
               <a:ext uri="{FF2B5EF4-FFF2-40B4-BE49-F238E27FC236}">
-                <a16:creationId xmlns:a16="http://schemas.microsoft.com/office/drawing/2014/main" id="{B9CE3DAF-A963-4DFA-BBEE-8AF7CD7BC63F}"/>
+                <a16:creationId xmlns:a16="http://schemas.microsoft.com/office/drawing/2014/main" id="{D9CB8954-CE97-4062-BBD2-A32747E89514}"/>
               </a:ext>
             </a:extLst>
           </p:cNvPr>
@@ -7086,7 +7190,7 @@
           <p:cNvPr id="5" name="TextBox 4">
             <a:extLst xmlns:a="http://schemas.openxmlformats.org/drawingml/2006/main">
               <a:ext uri="{FF2B5EF4-FFF2-40B4-BE49-F238E27FC236}">
-                <a16:creationId xmlns:a16="http://schemas.microsoft.com/office/drawing/2014/main" id="{13242279-C44F-46EA-B8AD-DDC611C87424}"/>
+                <a16:creationId xmlns:a16="http://schemas.microsoft.com/office/drawing/2014/main" id="{E9E63F22-0F57-48DD-B138-B2ADFF331DAA}"/>
               </a:ext>
             </a:extLst>
           </p:cNvPr>
@@ -7149,7 +7253,7 @@
           <p:cNvPr id="6" name="Rounded Rectangle 5">
             <a:extLst xmlns:a="http://schemas.openxmlformats.org/drawingml/2006/main">
               <a:ext uri="{FF2B5EF4-FFF2-40B4-BE49-F238E27FC236}">
-                <a16:creationId xmlns:a16="http://schemas.microsoft.com/office/drawing/2014/main" id="{C0592635-67DF-4E7E-BE6B-7234B5C7D454}"/>
+                <a16:creationId xmlns:a16="http://schemas.microsoft.com/office/drawing/2014/main" id="{87EC5E4D-1D46-4EC2-83FF-4A5876E6AA30}"/>
               </a:ext>
             </a:extLst>
           </p:cNvPr>
@@ -7204,7 +7308,7 @@
           <p:cNvPr id="7" name="TextBox 6">
             <a:extLst xmlns:a="http://schemas.openxmlformats.org/drawingml/2006/main">
               <a:ext uri="{FF2B5EF4-FFF2-40B4-BE49-F238E27FC236}">
-                <a16:creationId xmlns:a16="http://schemas.microsoft.com/office/drawing/2014/main" id="{464D95AE-ACE5-42A3-862A-532B40C9EF78}"/>
+                <a16:creationId xmlns:a16="http://schemas.microsoft.com/office/drawing/2014/main" id="{F112B2E7-3E64-460E-9B26-3A85056ACE0D}"/>
               </a:ext>
             </a:extLst>
           </p:cNvPr>
@@ -7308,7 +7412,7 @@
           <p:cNvPr id="8" name="Rounded Rectangle 7">
             <a:extLst xmlns:a="http://schemas.openxmlformats.org/drawingml/2006/main">
               <a:ext uri="{FF2B5EF4-FFF2-40B4-BE49-F238E27FC236}">
-                <a16:creationId xmlns:a16="http://schemas.microsoft.com/office/drawing/2014/main" id="{33F5F880-4D3D-4BF8-A486-AC188638A717}"/>
+                <a16:creationId xmlns:a16="http://schemas.microsoft.com/office/drawing/2014/main" id="{362923ED-6233-4087-9469-09D5AD9D3114}"/>
               </a:ext>
             </a:extLst>
           </p:cNvPr>
@@ -7363,7 +7467,7 @@
           <p:cNvPr id="9" name="TextBox 8">
             <a:extLst xmlns:a="http://schemas.openxmlformats.org/drawingml/2006/main">
               <a:ext uri="{FF2B5EF4-FFF2-40B4-BE49-F238E27FC236}">
-                <a16:creationId xmlns:a16="http://schemas.microsoft.com/office/drawing/2014/main" id="{5D89B376-93A6-4217-B550-E059184E1AD2}"/>
+                <a16:creationId xmlns:a16="http://schemas.microsoft.com/office/drawing/2014/main" id="{899587D2-F8CF-4CB5-B1C7-DA4F684372AF}"/>
               </a:ext>
             </a:extLst>
           </p:cNvPr>
@@ -7467,7 +7571,7 @@
           <p:cNvPr id="10" name="Rounded Rectangle 9">
             <a:extLst xmlns:a="http://schemas.openxmlformats.org/drawingml/2006/main">
               <a:ext uri="{FF2B5EF4-FFF2-40B4-BE49-F238E27FC236}">
-                <a16:creationId xmlns:a16="http://schemas.microsoft.com/office/drawing/2014/main" id="{C176E3D9-4837-4281-BB26-5DAB674A57E9}"/>
+                <a16:creationId xmlns:a16="http://schemas.microsoft.com/office/drawing/2014/main" id="{F105BCBF-A08D-4411-AEC1-B48043FA6B45}"/>
               </a:ext>
             </a:extLst>
           </p:cNvPr>
@@ -7522,7 +7626,7 @@
           <p:cNvPr id="11" name="TextBox 10">
             <a:extLst xmlns:a="http://schemas.openxmlformats.org/drawingml/2006/main">
               <a:ext uri="{FF2B5EF4-FFF2-40B4-BE49-F238E27FC236}">
-                <a16:creationId xmlns:a16="http://schemas.microsoft.com/office/drawing/2014/main" id="{2D827DE8-7975-4FC3-8AE7-6335AAE4A601}"/>
+                <a16:creationId xmlns:a16="http://schemas.microsoft.com/office/drawing/2014/main" id="{CF6422EA-E120-497D-B573-304557CE7825}"/>
               </a:ext>
             </a:extLst>
           </p:cNvPr>
@@ -7681,7 +7785,7 @@
     </p:spTree>
     <p:extLst>
       <p:ext uri="{BB962C8B-B14F-4D97-AF65-F5344CB8AC3E}">
-        <p14:creationId xmlns:p14="http://schemas.microsoft.com/office/powerpoint/2010/main" val="1379623690"/>
+        <p14:creationId xmlns:p14="http://schemas.microsoft.com/office/powerpoint/2010/main" val="1654501419"/>
       </p:ext>
     </p:extLst>
   </p:cSld>
@@ -7705,7 +7809,7 @@
           <p:cNvPr id="2" name="Rectangle 1">
             <a:extLst xmlns:a="http://schemas.openxmlformats.org/drawingml/2006/main">
               <a:ext uri="{FF2B5EF4-FFF2-40B4-BE49-F238E27FC236}">
-                <a16:creationId xmlns:a16="http://schemas.microsoft.com/office/drawing/2014/main" id="{ACA795BE-E241-46A6-A95C-16DD0803E379}"/>
+                <a16:creationId xmlns:a16="http://schemas.microsoft.com/office/drawing/2014/main" id="{1ED8B4B8-ED80-49DE-8465-0CA06781B361}"/>
               </a:ext>
             </a:extLst>
           </p:cNvPr>
@@ -7758,7 +7862,7 @@
           <p:cNvPr id="3" name="Rectangle 2">
             <a:extLst xmlns:a="http://schemas.openxmlformats.org/drawingml/2006/main">
               <a:ext uri="{FF2B5EF4-FFF2-40B4-BE49-F238E27FC236}">
-                <a16:creationId xmlns:a16="http://schemas.microsoft.com/office/drawing/2014/main" id="{AB3FA44D-8CD9-4118-932A-157CFA1337CC}"/>
+                <a16:creationId xmlns:a16="http://schemas.microsoft.com/office/drawing/2014/main" id="{685B1301-9721-4C77-9913-7D7BF334C8EF}"/>
               </a:ext>
             </a:extLst>
           </p:cNvPr>
@@ -7811,7 +7915,7 @@
           <p:cNvPr id="4" name="Rectangle 3">
             <a:extLst xmlns:a="http://schemas.openxmlformats.org/drawingml/2006/main">
               <a:ext uri="{FF2B5EF4-FFF2-40B4-BE49-F238E27FC236}">
-                <a16:creationId xmlns:a16="http://schemas.microsoft.com/office/drawing/2014/main" id="{FB3C17F1-9998-45A1-B37F-8A9C84023F96}"/>
+                <a16:creationId xmlns:a16="http://schemas.microsoft.com/office/drawing/2014/main" id="{7CB6E120-966A-4C87-B20E-73D1633CCC06}"/>
               </a:ext>
             </a:extLst>
           </p:cNvPr>
@@ -7864,7 +7968,7 @@
           <p:cNvPr id="5" name="TextBox 4">
             <a:extLst xmlns:a="http://schemas.openxmlformats.org/drawingml/2006/main">
               <a:ext uri="{FF2B5EF4-FFF2-40B4-BE49-F238E27FC236}">
-                <a16:creationId xmlns:a16="http://schemas.microsoft.com/office/drawing/2014/main" id="{D411869D-BAFA-448A-9A66-A8DBA0E34C07}"/>
+                <a16:creationId xmlns:a16="http://schemas.microsoft.com/office/drawing/2014/main" id="{C7F5A2F4-00AA-4875-B042-ECAE6DC17291}"/>
               </a:ext>
             </a:extLst>
           </p:cNvPr>
@@ -7927,7 +8031,7 @@
           <p:cNvPr id="6" name="Rounded Rectangle 5">
             <a:extLst xmlns:a="http://schemas.openxmlformats.org/drawingml/2006/main">
               <a:ext uri="{FF2B5EF4-FFF2-40B4-BE49-F238E27FC236}">
-                <a16:creationId xmlns:a16="http://schemas.microsoft.com/office/drawing/2014/main" id="{DFB18748-FC55-431B-9C29-0EFB2989B9AF}"/>
+                <a16:creationId xmlns:a16="http://schemas.microsoft.com/office/drawing/2014/main" id="{5A440847-36D1-4E77-97EE-D3A080B140B3}"/>
               </a:ext>
             </a:extLst>
           </p:cNvPr>
@@ -7982,7 +8086,7 @@
           <p:cNvPr id="7" name="TextBox 6">
             <a:extLst xmlns:a="http://schemas.openxmlformats.org/drawingml/2006/main">
               <a:ext uri="{FF2B5EF4-FFF2-40B4-BE49-F238E27FC236}">
-                <a16:creationId xmlns:a16="http://schemas.microsoft.com/office/drawing/2014/main" id="{ED7B7ECF-FCD5-4F64-ABDC-C477AE0672E8}"/>
+                <a16:creationId xmlns:a16="http://schemas.microsoft.com/office/drawing/2014/main" id="{57B0E7E2-2FD5-4B01-A724-660B7C446609}"/>
               </a:ext>
             </a:extLst>
           </p:cNvPr>
@@ -8105,7 +8209,7 @@
           <p:cNvPr id="8" name="Rounded Rectangle 7">
             <a:extLst xmlns:a="http://schemas.openxmlformats.org/drawingml/2006/main">
               <a:ext uri="{FF2B5EF4-FFF2-40B4-BE49-F238E27FC236}">
-                <a16:creationId xmlns:a16="http://schemas.microsoft.com/office/drawing/2014/main" id="{D51C0D9C-BA24-4223-A825-A6C4F73571F5}"/>
+                <a16:creationId xmlns:a16="http://schemas.microsoft.com/office/drawing/2014/main" id="{BE50C756-5468-4EB8-8C1B-DAD07582A560}"/>
               </a:ext>
             </a:extLst>
           </p:cNvPr>
@@ -8160,7 +8264,7 @@
           <p:cNvPr id="9" name="TextBox 8">
             <a:extLst xmlns:a="http://schemas.openxmlformats.org/drawingml/2006/main">
               <a:ext uri="{FF2B5EF4-FFF2-40B4-BE49-F238E27FC236}">
-                <a16:creationId xmlns:a16="http://schemas.microsoft.com/office/drawing/2014/main" id="{B79350EC-6311-47E5-A746-DE0681D431AA}"/>
+                <a16:creationId xmlns:a16="http://schemas.microsoft.com/office/drawing/2014/main" id="{FE8E9DDC-53CE-42B0-BE1E-B3B603C033CD}"/>
               </a:ext>
             </a:extLst>
           </p:cNvPr>
@@ -8302,7 +8406,7 @@
           <p:cNvPr id="10" name="Rounded Rectangle 9">
             <a:extLst xmlns:a="http://schemas.openxmlformats.org/drawingml/2006/main">
               <a:ext uri="{FF2B5EF4-FFF2-40B4-BE49-F238E27FC236}">
-                <a16:creationId xmlns:a16="http://schemas.microsoft.com/office/drawing/2014/main" id="{D35160D4-940D-4639-B780-243E0D8CF1FC}"/>
+                <a16:creationId xmlns:a16="http://schemas.microsoft.com/office/drawing/2014/main" id="{BEF7CB82-B488-4730-B7DC-58FC6590A789}"/>
               </a:ext>
             </a:extLst>
           </p:cNvPr>
@@ -8357,7 +8461,7 @@
           <p:cNvPr id="11" name="TextBox 10">
             <a:extLst xmlns:a="http://schemas.openxmlformats.org/drawingml/2006/main">
               <a:ext uri="{FF2B5EF4-FFF2-40B4-BE49-F238E27FC236}">
-                <a16:creationId xmlns:a16="http://schemas.microsoft.com/office/drawing/2014/main" id="{4081F1EB-BFFB-43FD-91EB-F535DF6D55B3}"/>
+                <a16:creationId xmlns:a16="http://schemas.microsoft.com/office/drawing/2014/main" id="{034A021A-C113-4C34-AA37-AA73124234F8}"/>
               </a:ext>
             </a:extLst>
           </p:cNvPr>
@@ -8459,7 +8563,7 @@
     </p:spTree>
     <p:extLst>
       <p:ext uri="{BB962C8B-B14F-4D97-AF65-F5344CB8AC3E}">
-        <p14:creationId xmlns:p14="http://schemas.microsoft.com/office/powerpoint/2010/main" val="69725368"/>
+        <p14:creationId xmlns:p14="http://schemas.microsoft.com/office/powerpoint/2010/main" val="1138726834"/>
       </p:ext>
     </p:extLst>
   </p:cSld>
@@ -8483,7 +8587,7 @@
           <p:cNvPr id="2" name="Rectangle 1">
             <a:extLst xmlns:a="http://schemas.openxmlformats.org/drawingml/2006/main">
               <a:ext uri="{FF2B5EF4-FFF2-40B4-BE49-F238E27FC236}">
-                <a16:creationId xmlns:a16="http://schemas.microsoft.com/office/drawing/2014/main" id="{807A5DEC-4105-4256-89A0-9AA027AD728B}"/>
+                <a16:creationId xmlns:a16="http://schemas.microsoft.com/office/drawing/2014/main" id="{C06A0E81-112E-4DE7-8A27-D718881C10C7}"/>
               </a:ext>
             </a:extLst>
           </p:cNvPr>
@@ -8536,7 +8640,7 @@
           <p:cNvPr id="3" name="Rectangle 2">
             <a:extLst xmlns:a="http://schemas.openxmlformats.org/drawingml/2006/main">
               <a:ext uri="{FF2B5EF4-FFF2-40B4-BE49-F238E27FC236}">
-                <a16:creationId xmlns:a16="http://schemas.microsoft.com/office/drawing/2014/main" id="{C9249182-2BD9-4955-8D22-A06F98F3CC47}"/>
+                <a16:creationId xmlns:a16="http://schemas.microsoft.com/office/drawing/2014/main" id="{169B8B6B-4ED1-44A5-9892-94B6C92973FF}"/>
               </a:ext>
             </a:extLst>
           </p:cNvPr>
@@ -8589,7 +8693,7 @@
           <p:cNvPr id="4" name="Rectangle 3">
             <a:extLst xmlns:a="http://schemas.openxmlformats.org/drawingml/2006/main">
               <a:ext uri="{FF2B5EF4-FFF2-40B4-BE49-F238E27FC236}">
-                <a16:creationId xmlns:a16="http://schemas.microsoft.com/office/drawing/2014/main" id="{4055747E-B363-4A26-A2D8-7867298C45CC}"/>
+                <a16:creationId xmlns:a16="http://schemas.microsoft.com/office/drawing/2014/main" id="{C8233F66-6D28-4589-AF22-390BB356F0A1}"/>
               </a:ext>
             </a:extLst>
           </p:cNvPr>
@@ -8642,7 +8746,7 @@
           <p:cNvPr id="5" name="TextBox 4">
             <a:extLst xmlns:a="http://schemas.openxmlformats.org/drawingml/2006/main">
               <a:ext uri="{FF2B5EF4-FFF2-40B4-BE49-F238E27FC236}">
-                <a16:creationId xmlns:a16="http://schemas.microsoft.com/office/drawing/2014/main" id="{0B17AF7A-12D6-42A5-8797-AD167445FFDF}"/>
+                <a16:creationId xmlns:a16="http://schemas.microsoft.com/office/drawing/2014/main" id="{2F019A34-6732-436D-AC98-6C05AF962EC5}"/>
               </a:ext>
             </a:extLst>
           </p:cNvPr>
@@ -8705,7 +8809,7 @@
           <p:cNvPr id="6" name="Rounded Rectangle 5">
             <a:extLst xmlns:a="http://schemas.openxmlformats.org/drawingml/2006/main">
               <a:ext uri="{FF2B5EF4-FFF2-40B4-BE49-F238E27FC236}">
-                <a16:creationId xmlns:a16="http://schemas.microsoft.com/office/drawing/2014/main" id="{EAA0C771-1860-4683-8345-301BBDFD9845}"/>
+                <a16:creationId xmlns:a16="http://schemas.microsoft.com/office/drawing/2014/main" id="{D6C863BE-087A-40A8-A986-CB8123E9AE1E}"/>
               </a:ext>
             </a:extLst>
           </p:cNvPr>
@@ -8760,7 +8864,7 @@
           <p:cNvPr id="7" name="TextBox 6">
             <a:extLst xmlns:a="http://schemas.openxmlformats.org/drawingml/2006/main">
               <a:ext uri="{FF2B5EF4-FFF2-40B4-BE49-F238E27FC236}">
-                <a16:creationId xmlns:a16="http://schemas.microsoft.com/office/drawing/2014/main" id="{024FFE8C-7998-46F1-B833-F55EF0AC0A7A}"/>
+                <a16:creationId xmlns:a16="http://schemas.microsoft.com/office/drawing/2014/main" id="{49F5DC73-117B-47A3-9C10-204AC772D1CB}"/>
               </a:ext>
             </a:extLst>
           </p:cNvPr>
@@ -8940,7 +9044,7 @@
           <p:cNvPr id="8" name="Rounded Rectangle 7">
             <a:extLst xmlns:a="http://schemas.openxmlformats.org/drawingml/2006/main">
               <a:ext uri="{FF2B5EF4-FFF2-40B4-BE49-F238E27FC236}">
-                <a16:creationId xmlns:a16="http://schemas.microsoft.com/office/drawing/2014/main" id="{3CC2E2A6-55F2-48C7-A355-D16E737340B4}"/>
+                <a16:creationId xmlns:a16="http://schemas.microsoft.com/office/drawing/2014/main" id="{FD5CAAE9-3FDE-4AFB-AEEC-9AA5BEDEF3D9}"/>
               </a:ext>
             </a:extLst>
           </p:cNvPr>
@@ -8995,7 +9099,7 @@
           <p:cNvPr id="9" name="TextBox 8">
             <a:extLst xmlns:a="http://schemas.openxmlformats.org/drawingml/2006/main">
               <a:ext uri="{FF2B5EF4-FFF2-40B4-BE49-F238E27FC236}">
-                <a16:creationId xmlns:a16="http://schemas.microsoft.com/office/drawing/2014/main" id="{BDD24B2E-A010-4941-823D-BA071175C22F}"/>
+                <a16:creationId xmlns:a16="http://schemas.microsoft.com/office/drawing/2014/main" id="{6BC40961-34E4-4A71-931C-7E6B18A081EC}"/>
               </a:ext>
             </a:extLst>
           </p:cNvPr>
@@ -9154,7 +9258,7 @@
     </p:spTree>
     <p:extLst>
       <p:ext uri="{BB962C8B-B14F-4D97-AF65-F5344CB8AC3E}">
-        <p14:creationId xmlns:p14="http://schemas.microsoft.com/office/powerpoint/2010/main" val="1292470837"/>
+        <p14:creationId xmlns:p14="http://schemas.microsoft.com/office/powerpoint/2010/main" val="1079442881"/>
       </p:ext>
     </p:extLst>
   </p:cSld>
@@ -9178,7 +9282,7 @@
           <p:cNvPr id="2" name="Rectangle 1">
             <a:extLst xmlns:a="http://schemas.openxmlformats.org/drawingml/2006/main">
               <a:ext uri="{FF2B5EF4-FFF2-40B4-BE49-F238E27FC236}">
-                <a16:creationId xmlns:a16="http://schemas.microsoft.com/office/drawing/2014/main" id="{6D2B0BE9-D4E8-4893-A0C1-DC575D4BD09A}"/>
+                <a16:creationId xmlns:a16="http://schemas.microsoft.com/office/drawing/2014/main" id="{95182A3F-28C4-410D-9262-309F509BD214}"/>
               </a:ext>
             </a:extLst>
           </p:cNvPr>
@@ -9231,7 +9335,7 @@
           <p:cNvPr id="3" name="Rectangle 2">
             <a:extLst xmlns:a="http://schemas.openxmlformats.org/drawingml/2006/main">
               <a:ext uri="{FF2B5EF4-FFF2-40B4-BE49-F238E27FC236}">
-                <a16:creationId xmlns:a16="http://schemas.microsoft.com/office/drawing/2014/main" id="{90E7F9A9-6135-4010-8D9E-79B7C395AAC8}"/>
+                <a16:creationId xmlns:a16="http://schemas.microsoft.com/office/drawing/2014/main" id="{981422DF-B182-442C-9414-4883B32DCDFB}"/>
               </a:ext>
             </a:extLst>
           </p:cNvPr>
@@ -9284,7 +9388,7 @@
           <p:cNvPr id="4" name="Rectangle 3">
             <a:extLst xmlns:a="http://schemas.openxmlformats.org/drawingml/2006/main">
               <a:ext uri="{FF2B5EF4-FFF2-40B4-BE49-F238E27FC236}">
-                <a16:creationId xmlns:a16="http://schemas.microsoft.com/office/drawing/2014/main" id="{E01022DF-2A09-45E5-BE77-DBD8E8034336}"/>
+                <a16:creationId xmlns:a16="http://schemas.microsoft.com/office/drawing/2014/main" id="{6B92C33F-C785-4639-931B-A5EF3B377459}"/>
               </a:ext>
             </a:extLst>
           </p:cNvPr>
@@ -9337,7 +9441,7 @@
           <p:cNvPr id="5" name="TextBox 4">
             <a:extLst xmlns:a="http://schemas.openxmlformats.org/drawingml/2006/main">
               <a:ext uri="{FF2B5EF4-FFF2-40B4-BE49-F238E27FC236}">
-                <a16:creationId xmlns:a16="http://schemas.microsoft.com/office/drawing/2014/main" id="{3EDCE2A6-F034-4439-A241-A588C4FC23D8}"/>
+                <a16:creationId xmlns:a16="http://schemas.microsoft.com/office/drawing/2014/main" id="{179ECFD0-8EC1-4FD0-99D8-B08477C86CAD}"/>
               </a:ext>
             </a:extLst>
           </p:cNvPr>
@@ -9400,7 +9504,7 @@
           <p:cNvPr id="6" name="Rounded Rectangle 5">
             <a:extLst xmlns:a="http://schemas.openxmlformats.org/drawingml/2006/main">
               <a:ext uri="{FF2B5EF4-FFF2-40B4-BE49-F238E27FC236}">
-                <a16:creationId xmlns:a16="http://schemas.microsoft.com/office/drawing/2014/main" id="{03B4A867-EE22-42C4-949A-C767D99AAA4C}"/>
+                <a16:creationId xmlns:a16="http://schemas.microsoft.com/office/drawing/2014/main" id="{921E1D20-BA63-48E6-B40A-B49946E776EA}"/>
               </a:ext>
             </a:extLst>
           </p:cNvPr>
@@ -9455,7 +9559,7 @@
           <p:cNvPr id="7" name="TextBox 6">
             <a:extLst xmlns:a="http://schemas.openxmlformats.org/drawingml/2006/main">
               <a:ext uri="{FF2B5EF4-FFF2-40B4-BE49-F238E27FC236}">
-                <a16:creationId xmlns:a16="http://schemas.microsoft.com/office/drawing/2014/main" id="{3E221609-8DC5-4069-A6D7-65B79173458F}"/>
+                <a16:creationId xmlns:a16="http://schemas.microsoft.com/office/drawing/2014/main" id="{60776BB1-2E6E-4D26-B469-6C2415A1186F}"/>
               </a:ext>
             </a:extLst>
           </p:cNvPr>
@@ -9673,7 +9777,7 @@
           <p:cNvPr id="8" name="Rounded Rectangle 7">
             <a:extLst xmlns:a="http://schemas.openxmlformats.org/drawingml/2006/main">
               <a:ext uri="{FF2B5EF4-FFF2-40B4-BE49-F238E27FC236}">
-                <a16:creationId xmlns:a16="http://schemas.microsoft.com/office/drawing/2014/main" id="{F4B96CD1-2DDD-425C-A4D0-19A746C1F3AB}"/>
+                <a16:creationId xmlns:a16="http://schemas.microsoft.com/office/drawing/2014/main" id="{312621E4-B8C6-4A1D-B262-8240B0C24802}"/>
               </a:ext>
             </a:extLst>
           </p:cNvPr>
@@ -9728,7 +9832,7 @@
           <p:cNvPr id="9" name="TextBox 8">
             <a:extLst xmlns:a="http://schemas.openxmlformats.org/drawingml/2006/main">
               <a:ext uri="{FF2B5EF4-FFF2-40B4-BE49-F238E27FC236}">
-                <a16:creationId xmlns:a16="http://schemas.microsoft.com/office/drawing/2014/main" id="{F29BC204-275B-45C9-B46F-CA83548A8566}"/>
+                <a16:creationId xmlns:a16="http://schemas.microsoft.com/office/drawing/2014/main" id="{B1A3EEA3-41C3-4510-8579-FDA265244A24}"/>
               </a:ext>
             </a:extLst>
           </p:cNvPr>
@@ -9963,7 +10067,7 @@
     </p:spTree>
     <p:extLst>
       <p:ext uri="{BB962C8B-B14F-4D97-AF65-F5344CB8AC3E}">
-        <p14:creationId xmlns:p14="http://schemas.microsoft.com/office/powerpoint/2010/main" val="879682298"/>
+        <p14:creationId xmlns:p14="http://schemas.microsoft.com/office/powerpoint/2010/main" val="792679513"/>
       </p:ext>
     </p:extLst>
   </p:cSld>
@@ -9987,7 +10091,7 @@
           <p:cNvPr id="2" name="Rectangle 1">
             <a:extLst xmlns:a="http://schemas.openxmlformats.org/drawingml/2006/main">
               <a:ext uri="{FF2B5EF4-FFF2-40B4-BE49-F238E27FC236}">
-                <a16:creationId xmlns:a16="http://schemas.microsoft.com/office/drawing/2014/main" id="{E86AF65E-95D5-48FE-95E9-A68C2D392529}"/>
+                <a16:creationId xmlns:a16="http://schemas.microsoft.com/office/drawing/2014/main" id="{A132FAFB-DF17-45F9-B613-3637E96ECEAD}"/>
               </a:ext>
             </a:extLst>
           </p:cNvPr>
@@ -10040,7 +10144,7 @@
           <p:cNvPr id="3" name="Rectangle 2">
             <a:extLst xmlns:a="http://schemas.openxmlformats.org/drawingml/2006/main">
               <a:ext uri="{FF2B5EF4-FFF2-40B4-BE49-F238E27FC236}">
-                <a16:creationId xmlns:a16="http://schemas.microsoft.com/office/drawing/2014/main" id="{F4DBB4A8-18CB-4DF8-BB23-D01FDC64E6C2}"/>
+                <a16:creationId xmlns:a16="http://schemas.microsoft.com/office/drawing/2014/main" id="{4886E82B-EF7E-41CB-B679-D491F89AF2FE}"/>
               </a:ext>
             </a:extLst>
           </p:cNvPr>
@@ -10093,7 +10197,7 @@
           <p:cNvPr id="4" name="Rectangle 3">
             <a:extLst xmlns:a="http://schemas.openxmlformats.org/drawingml/2006/main">
               <a:ext uri="{FF2B5EF4-FFF2-40B4-BE49-F238E27FC236}">
-                <a16:creationId xmlns:a16="http://schemas.microsoft.com/office/drawing/2014/main" id="{FC02808A-3F3A-43CB-A3FB-254F6A65C366}"/>
+                <a16:creationId xmlns:a16="http://schemas.microsoft.com/office/drawing/2014/main" id="{A5C31D4C-A91F-4A08-BB71-56E2D45ED978}"/>
               </a:ext>
             </a:extLst>
           </p:cNvPr>
@@ -10146,7 +10250,7 @@
           <p:cNvPr id="5" name="TextBox 4">
             <a:extLst xmlns:a="http://schemas.openxmlformats.org/drawingml/2006/main">
               <a:ext uri="{FF2B5EF4-FFF2-40B4-BE49-F238E27FC236}">
-                <a16:creationId xmlns:a16="http://schemas.microsoft.com/office/drawing/2014/main" id="{A53CCD2F-E0A6-48EA-B3B6-FCBA21F1A69B}"/>
+                <a16:creationId xmlns:a16="http://schemas.microsoft.com/office/drawing/2014/main" id="{5BBD41F0-8473-44C0-811C-45FCF578D892}"/>
               </a:ext>
             </a:extLst>
           </p:cNvPr>
@@ -10209,7 +10313,7 @@
           <p:cNvPr id="6" name="Rounded Rectangle 5">
             <a:extLst xmlns:a="http://schemas.openxmlformats.org/drawingml/2006/main">
               <a:ext uri="{FF2B5EF4-FFF2-40B4-BE49-F238E27FC236}">
-                <a16:creationId xmlns:a16="http://schemas.microsoft.com/office/drawing/2014/main" id="{947EF817-95F5-4678-9C31-3B273DB8C966}"/>
+                <a16:creationId xmlns:a16="http://schemas.microsoft.com/office/drawing/2014/main" id="{4E6E4FD4-D772-4424-B422-D07304E00DD4}"/>
               </a:ext>
             </a:extLst>
           </p:cNvPr>
@@ -10264,7 +10368,7 @@
           <p:cNvPr id="7" name="TextBox 6">
             <a:extLst xmlns:a="http://schemas.openxmlformats.org/drawingml/2006/main">
               <a:ext uri="{FF2B5EF4-FFF2-40B4-BE49-F238E27FC236}">
-                <a16:creationId xmlns:a16="http://schemas.microsoft.com/office/drawing/2014/main" id="{3D7E0AA4-4DAA-4714-9E27-354BD39ABFF3}"/>
+                <a16:creationId xmlns:a16="http://schemas.microsoft.com/office/drawing/2014/main" id="{67D72D16-A572-4C40-9B18-769A5AF34EFF}"/>
               </a:ext>
             </a:extLst>
           </p:cNvPr>
@@ -10647,7 +10751,7 @@
           <p:nvPr/>
         </p:nvPicPr>
         <p:blipFill>
-          <a:blip xmlns:r="http://schemas.openxmlformats.org/officeDocument/2006/relationships" xmlns:a="http://schemas.openxmlformats.org/drawingml/2006/main" r:embed="Rb458d6a1250c4adf"/>
+          <a:blip xmlns:r="http://schemas.openxmlformats.org/officeDocument/2006/relationships" xmlns:a="http://schemas.openxmlformats.org/drawingml/2006/main" r:embed="R291386277bea42d7"/>
           <a:stretch xmlns:a="http://schemas.openxmlformats.org/drawingml/2006/main">
             <a:fillRect l="0" t="0" r="0" b="0"/>
           </a:stretch>
@@ -10667,7 +10771,7 @@
           <p:cNvPr id="9" name="Rounded Rectangle 8">
             <a:extLst xmlns:a="http://schemas.openxmlformats.org/drawingml/2006/main">
               <a:ext uri="{FF2B5EF4-FFF2-40B4-BE49-F238E27FC236}">
-                <a16:creationId xmlns:a16="http://schemas.microsoft.com/office/drawing/2014/main" id="{7D4A5D72-B1C8-4DF6-A87B-4F25769AEF03}"/>
+                <a16:creationId xmlns:a16="http://schemas.microsoft.com/office/drawing/2014/main" id="{F141A053-F0A4-4C4E-B477-10B4033783BA}"/>
               </a:ext>
             </a:extLst>
           </p:cNvPr>
@@ -10722,7 +10826,7 @@
           <p:cNvPr id="10" name="TextBox 9">
             <a:extLst xmlns:a="http://schemas.openxmlformats.org/drawingml/2006/main">
               <a:ext uri="{FF2B5EF4-FFF2-40B4-BE49-F238E27FC236}">
-                <a16:creationId xmlns:a16="http://schemas.microsoft.com/office/drawing/2014/main" id="{4DF0C028-CD25-445E-9736-3A21CBBB23D6}"/>
+                <a16:creationId xmlns:a16="http://schemas.microsoft.com/office/drawing/2014/main" id="{A2CD381C-5BF1-404C-BB86-8223A3B9B1BC}"/>
               </a:ext>
             </a:extLst>
           </p:cNvPr>
@@ -10808,7 +10912,7 @@
     </p:spTree>
     <p:extLst>
       <p:ext uri="{BB962C8B-B14F-4D97-AF65-F5344CB8AC3E}">
-        <p14:creationId xmlns:p14="http://schemas.microsoft.com/office/powerpoint/2010/main" val="286866128"/>
+        <p14:creationId xmlns:p14="http://schemas.microsoft.com/office/powerpoint/2010/main" val="943614126"/>
       </p:ext>
     </p:extLst>
   </p:cSld>
@@ -10832,7 +10936,7 @@
           <p:cNvPr id="2" name="Rectangle 1">
             <a:extLst xmlns:a="http://schemas.openxmlformats.org/drawingml/2006/main">
               <a:ext uri="{FF2B5EF4-FFF2-40B4-BE49-F238E27FC236}">
-                <a16:creationId xmlns:a16="http://schemas.microsoft.com/office/drawing/2014/main" id="{7BA7B7DA-4C17-4D6E-851B-8431FDD16FBF}"/>
+                <a16:creationId xmlns:a16="http://schemas.microsoft.com/office/drawing/2014/main" id="{6E1CACC9-49B5-467B-AB68-DA991D8A02B6}"/>
               </a:ext>
             </a:extLst>
           </p:cNvPr>
@@ -10885,7 +10989,7 @@
           <p:cNvPr id="3" name="Rectangle 2">
             <a:extLst xmlns:a="http://schemas.openxmlformats.org/drawingml/2006/main">
               <a:ext uri="{FF2B5EF4-FFF2-40B4-BE49-F238E27FC236}">
-                <a16:creationId xmlns:a16="http://schemas.microsoft.com/office/drawing/2014/main" id="{CA8947FF-BE31-4883-A97C-DC7B68C0855F}"/>
+                <a16:creationId xmlns:a16="http://schemas.microsoft.com/office/drawing/2014/main" id="{E9B04071-5356-485E-96C6-6D5C63B99BB8}"/>
               </a:ext>
             </a:extLst>
           </p:cNvPr>
@@ -10938,7 +11042,7 @@
           <p:cNvPr id="4" name="Rectangle 3">
             <a:extLst xmlns:a="http://schemas.openxmlformats.org/drawingml/2006/main">
               <a:ext uri="{FF2B5EF4-FFF2-40B4-BE49-F238E27FC236}">
-                <a16:creationId xmlns:a16="http://schemas.microsoft.com/office/drawing/2014/main" id="{7B6EAAE2-C7A1-4308-9F1D-3F5B984EC749}"/>
+                <a16:creationId xmlns:a16="http://schemas.microsoft.com/office/drawing/2014/main" id="{111729A7-A8FC-4014-A6E9-E52B5CE227CC}"/>
               </a:ext>
             </a:extLst>
           </p:cNvPr>
@@ -10991,7 +11095,7 @@
           <p:cNvPr id="5" name="TextBox 4">
             <a:extLst xmlns:a="http://schemas.openxmlformats.org/drawingml/2006/main">
               <a:ext uri="{FF2B5EF4-FFF2-40B4-BE49-F238E27FC236}">
-                <a16:creationId xmlns:a16="http://schemas.microsoft.com/office/drawing/2014/main" id="{FDC6BCF2-7DCD-4042-AEF5-8FDCDFD97D29}"/>
+                <a16:creationId xmlns:a16="http://schemas.microsoft.com/office/drawing/2014/main" id="{852B6993-038B-4FC3-AE08-4991FCD83268}"/>
               </a:ext>
             </a:extLst>
           </p:cNvPr>
@@ -11054,7 +11158,7 @@
           <p:cNvPr id="6" name="Rounded Rectangle 5">
             <a:extLst xmlns:a="http://schemas.openxmlformats.org/drawingml/2006/main">
               <a:ext uri="{FF2B5EF4-FFF2-40B4-BE49-F238E27FC236}">
-                <a16:creationId xmlns:a16="http://schemas.microsoft.com/office/drawing/2014/main" id="{8A5BA445-82C0-47E6-B944-3C78F0C31AB4}"/>
+                <a16:creationId xmlns:a16="http://schemas.microsoft.com/office/drawing/2014/main" id="{100B1B97-249E-4D3E-A059-B084C028B32A}"/>
               </a:ext>
             </a:extLst>
           </p:cNvPr>
@@ -11109,7 +11213,7 @@
           <p:cNvPr id="7" name="TextBox 6">
             <a:extLst xmlns:a="http://schemas.openxmlformats.org/drawingml/2006/main">
               <a:ext uri="{FF2B5EF4-FFF2-40B4-BE49-F238E27FC236}">
-                <a16:creationId xmlns:a16="http://schemas.microsoft.com/office/drawing/2014/main" id="{F9C06B8C-D4BD-4506-AB89-2254EF8BE1A1}"/>
+                <a16:creationId xmlns:a16="http://schemas.microsoft.com/office/drawing/2014/main" id="{07B7AECF-4322-4CF7-8DDE-2B734D98C9DF}"/>
               </a:ext>
             </a:extLst>
           </p:cNvPr>
@@ -11346,7 +11450,7 @@
           <p:cNvPr id="8" name="Rounded Rectangle 7">
             <a:extLst xmlns:a="http://schemas.openxmlformats.org/drawingml/2006/main">
               <a:ext uri="{FF2B5EF4-FFF2-40B4-BE49-F238E27FC236}">
-                <a16:creationId xmlns:a16="http://schemas.microsoft.com/office/drawing/2014/main" id="{B7D42736-A82B-4A72-B746-02B26A4F9D15}"/>
+                <a16:creationId xmlns:a16="http://schemas.microsoft.com/office/drawing/2014/main" id="{C55114E1-519F-4D86-8898-5A18035F05E6}"/>
               </a:ext>
             </a:extLst>
           </p:cNvPr>
@@ -11401,7 +11505,7 @@
           <p:cNvPr id="9" name="TextBox 8">
             <a:extLst xmlns:a="http://schemas.openxmlformats.org/drawingml/2006/main">
               <a:ext uri="{FF2B5EF4-FFF2-40B4-BE49-F238E27FC236}">
-                <a16:creationId xmlns:a16="http://schemas.microsoft.com/office/drawing/2014/main" id="{6BD4EC4E-9ED5-4E27-9CDE-6A281F93C6B5}"/>
+                <a16:creationId xmlns:a16="http://schemas.microsoft.com/office/drawing/2014/main" id="{6AA9C966-5284-45BC-8769-2587DE7B7D36}"/>
               </a:ext>
             </a:extLst>
           </p:cNvPr>
@@ -11413,7 +11517,7 @@
         <p:spPr>
           <a:xfrm xmlns:a="http://schemas.openxmlformats.org/drawingml/2006/main">
             <a:off x="6430975" y="1344168"/>
-            <a:ext cx="4846320" cy="5158740"/>
+            <a:ext cx="4846320" cy="5410200"/>
           </a:xfrm>
           <a:prstGeom xmlns:a="http://schemas.openxmlformats.org/drawingml/2006/main" prst="rect">
             <a:avLst/>
@@ -11517,12 +11621,142 @@
               </a:defRPr>
             </a:pPr>
             <a:r>
-              <a:t>•  Schema So Sánh Đối Chứng Scaffold [DIAGNOSTIC TEST FIXTURE ONLY - NOT CANONICAL NUMERICAL RESULTS]:
-  • Diagnostic Cohort Pairwise Comparison (n=718 views across 440 clusters):
-    • Marginal Views: Single-event Acc = 0.5000 vs Contextual-event Acc = 0.5000 (Delta = +0.0000)
-    • Paired Cohort (278 complete pairs): Single Acc = 0.5000 vs Context Acc = 0.5000 (Delta = +0.00 pp)
-    • Pair Concordance: Both Correct = 139, Single-only Correct = 0, Context-only Correct = 0, Both Incorrect = 139
-    • McNemar Exploratory Test: p_asympt = 1.0000, p_exact = 1.0000</a:t>
+              <a:t>•  Schema So Sánh Đối Chứng Scaffold [DIAGNOSTIC TEST FIXTURE ONLY - NOT CANONICAL NUMERICAL RESULTS]:</a:t>
+            </a:r>
+          </a:p>
+          <a:p xmlns:a="http://schemas.openxmlformats.org/drawingml/2006/main">
+            <a:pPr>
+              <a:spcBef>
+                <a:spcPts val="300"/>
+              </a:spcBef>
+              <a:buNone/>
+              <a:defRPr sz="1150">
+                <a:solidFill>
+                  <a:srgbClr val="0F172A"/>
+                </a:solidFill>
+                <a:latin typeface="Calibri"/>
+                <a:ea typeface="Calibri"/>
+                <a:cs typeface="Calibri"/>
+              </a:defRPr>
+            </a:pPr>
+            <a:r>
+              <a:rPr sz="1150">
+                <a:solidFill>
+                  <a:srgbClr val="0F172A"/>
+                </a:solidFill>
+                <a:latin typeface="Calibri"/>
+                <a:ea typeface="Calibri"/>
+                <a:cs typeface="Calibri"/>
+              </a:rPr>
+              <a:t>  • Diagnostic Cohort Pairwise Comparison (n=718 views across 440 clusters):</a:t>
+            </a:r>
+          </a:p>
+          <a:p xmlns:a="http://schemas.openxmlformats.org/drawingml/2006/main">
+            <a:pPr>
+              <a:spcBef>
+                <a:spcPts val="300"/>
+              </a:spcBef>
+              <a:buNone/>
+              <a:defRPr sz="1150">
+                <a:solidFill>
+                  <a:srgbClr val="0F172A"/>
+                </a:solidFill>
+                <a:latin typeface="Calibri"/>
+                <a:ea typeface="Calibri"/>
+                <a:cs typeface="Calibri"/>
+              </a:defRPr>
+            </a:pPr>
+            <a:r>
+              <a:rPr sz="1150">
+                <a:solidFill>
+                  <a:srgbClr val="0F172A"/>
+                </a:solidFill>
+                <a:latin typeface="Calibri"/>
+                <a:ea typeface="Calibri"/>
+                <a:cs typeface="Calibri"/>
+              </a:rPr>
+              <a:t>    • Marginal Views: Single-event Acc = 0.5000 vs Contextual-event Acc = 0.5000 (Delta = +0.0000)</a:t>
+            </a:r>
+          </a:p>
+          <a:p xmlns:a="http://schemas.openxmlformats.org/drawingml/2006/main">
+            <a:pPr>
+              <a:spcBef>
+                <a:spcPts val="300"/>
+              </a:spcBef>
+              <a:buNone/>
+              <a:defRPr sz="1150">
+                <a:solidFill>
+                  <a:srgbClr val="0F172A"/>
+                </a:solidFill>
+                <a:latin typeface="Calibri"/>
+                <a:ea typeface="Calibri"/>
+                <a:cs typeface="Calibri"/>
+              </a:defRPr>
+            </a:pPr>
+            <a:r>
+              <a:rPr sz="1150">
+                <a:solidFill>
+                  <a:srgbClr val="0F172A"/>
+                </a:solidFill>
+                <a:latin typeface="Calibri"/>
+                <a:ea typeface="Calibri"/>
+                <a:cs typeface="Calibri"/>
+              </a:rPr>
+              <a:t>    • Paired Cohort (278 complete pairs): Single Acc = 0.5000 vs Context Acc = 0.5000 (Delta = +0.00 pp)</a:t>
+            </a:r>
+          </a:p>
+          <a:p xmlns:a="http://schemas.openxmlformats.org/drawingml/2006/main">
+            <a:pPr>
+              <a:spcBef>
+                <a:spcPts val="300"/>
+              </a:spcBef>
+              <a:buNone/>
+              <a:defRPr sz="1150">
+                <a:solidFill>
+                  <a:srgbClr val="0F172A"/>
+                </a:solidFill>
+                <a:latin typeface="Calibri"/>
+                <a:ea typeface="Calibri"/>
+                <a:cs typeface="Calibri"/>
+              </a:defRPr>
+            </a:pPr>
+            <a:r>
+              <a:rPr sz="1150">
+                <a:solidFill>
+                  <a:srgbClr val="0F172A"/>
+                </a:solidFill>
+                <a:latin typeface="Calibri"/>
+                <a:ea typeface="Calibri"/>
+                <a:cs typeface="Calibri"/>
+              </a:rPr>
+              <a:t>    • Pair Concordance: Both Correct = 139, Single-only Correct = 0, Context-only Correct = 0, Both Incorrect = 139</a:t>
+            </a:r>
+          </a:p>
+          <a:p xmlns:a="http://schemas.openxmlformats.org/drawingml/2006/main">
+            <a:pPr>
+              <a:spcBef>
+                <a:spcPts val="300"/>
+              </a:spcBef>
+              <a:buNone/>
+              <a:defRPr sz="1150">
+                <a:solidFill>
+                  <a:srgbClr val="0F172A"/>
+                </a:solidFill>
+                <a:latin typeface="Calibri"/>
+                <a:ea typeface="Calibri"/>
+                <a:cs typeface="Calibri"/>
+              </a:defRPr>
+            </a:pPr>
+            <a:r>
+              <a:rPr sz="1150">
+                <a:solidFill>
+                  <a:srgbClr val="0F172A"/>
+                </a:solidFill>
+                <a:latin typeface="Calibri"/>
+                <a:ea typeface="Calibri"/>
+                <a:cs typeface="Calibri"/>
+              </a:rPr>
+              <a:t>    • McNemar Exploratory Test: p_asympt = 1.0000, p_exact = 1.0000</a:t>
             </a:r>
           </a:p>
           <a:p xmlns:a="http://schemas.openxmlformats.org/drawingml/2006/main">
@@ -11606,7 +11840,7 @@
     </p:spTree>
     <p:extLst>
       <p:ext uri="{BB962C8B-B14F-4D97-AF65-F5344CB8AC3E}">
-        <p14:creationId xmlns:p14="http://schemas.microsoft.com/office/powerpoint/2010/main" val="1355867882"/>
+        <p14:creationId xmlns:p14="http://schemas.microsoft.com/office/powerpoint/2010/main" val="815533390"/>
       </p:ext>
     </p:extLst>
   </p:cSld>
@@ -11630,7 +11864,7 @@
           <p:cNvPr id="2" name="Rectangle 1">
             <a:extLst xmlns:a="http://schemas.openxmlformats.org/drawingml/2006/main">
               <a:ext uri="{FF2B5EF4-FFF2-40B4-BE49-F238E27FC236}">
-                <a16:creationId xmlns:a16="http://schemas.microsoft.com/office/drawing/2014/main" id="{D16BBA1C-E8CD-4C63-BAE6-101EE3B73F24}"/>
+                <a16:creationId xmlns:a16="http://schemas.microsoft.com/office/drawing/2014/main" id="{D442BEAC-C47A-431A-9423-194AA01E1520}"/>
               </a:ext>
             </a:extLst>
           </p:cNvPr>
@@ -11683,7 +11917,7 @@
           <p:cNvPr id="3" name="Rectangle 2">
             <a:extLst xmlns:a="http://schemas.openxmlformats.org/drawingml/2006/main">
               <a:ext uri="{FF2B5EF4-FFF2-40B4-BE49-F238E27FC236}">
-                <a16:creationId xmlns:a16="http://schemas.microsoft.com/office/drawing/2014/main" id="{37B01FA6-B8B3-4A25-8411-4D0BB455BB0D}"/>
+                <a16:creationId xmlns:a16="http://schemas.microsoft.com/office/drawing/2014/main" id="{01D862B2-C822-4617-940B-BBA340FCD56A}"/>
               </a:ext>
             </a:extLst>
           </p:cNvPr>
@@ -11736,7 +11970,7 @@
           <p:cNvPr id="4" name="Rectangle 3">
             <a:extLst xmlns:a="http://schemas.openxmlformats.org/drawingml/2006/main">
               <a:ext uri="{FF2B5EF4-FFF2-40B4-BE49-F238E27FC236}">
-                <a16:creationId xmlns:a16="http://schemas.microsoft.com/office/drawing/2014/main" id="{DE1491BD-1654-4925-AE8E-AAFA97E90987}"/>
+                <a16:creationId xmlns:a16="http://schemas.microsoft.com/office/drawing/2014/main" id="{A0DED8BB-2393-44DE-9C36-489B96DEBA9D}"/>
               </a:ext>
             </a:extLst>
           </p:cNvPr>
@@ -11789,7 +12023,7 @@
           <p:cNvPr id="5" name="TextBox 4">
             <a:extLst xmlns:a="http://schemas.openxmlformats.org/drawingml/2006/main">
               <a:ext uri="{FF2B5EF4-FFF2-40B4-BE49-F238E27FC236}">
-                <a16:creationId xmlns:a16="http://schemas.microsoft.com/office/drawing/2014/main" id="{3AADF7B4-7948-4708-884F-D7CA9BBAB47D}"/>
+                <a16:creationId xmlns:a16="http://schemas.microsoft.com/office/drawing/2014/main" id="{34FC8F9B-5D6B-4FC6-BC32-26D0BA553511}"/>
               </a:ext>
             </a:extLst>
           </p:cNvPr>
@@ -11852,7 +12086,7 @@
           <p:cNvPr id="6" name="Rounded Rectangle 5">
             <a:extLst xmlns:a="http://schemas.openxmlformats.org/drawingml/2006/main">
               <a:ext uri="{FF2B5EF4-FFF2-40B4-BE49-F238E27FC236}">
-                <a16:creationId xmlns:a16="http://schemas.microsoft.com/office/drawing/2014/main" id="{061AA687-3FE8-4DAA-A504-6E29F0EEBDC5}"/>
+                <a16:creationId xmlns:a16="http://schemas.microsoft.com/office/drawing/2014/main" id="{89D84675-38BA-4EFA-828C-44F2BFBC8D83}"/>
               </a:ext>
             </a:extLst>
           </p:cNvPr>
@@ -11907,7 +12141,7 @@
           <p:cNvPr id="7" name="TextBox 6">
             <a:extLst xmlns:a="http://schemas.openxmlformats.org/drawingml/2006/main">
               <a:ext uri="{FF2B5EF4-FFF2-40B4-BE49-F238E27FC236}">
-                <a16:creationId xmlns:a16="http://schemas.microsoft.com/office/drawing/2014/main" id="{E8A21D1E-0C17-4300-AD79-A274BCDB0F6C}"/>
+                <a16:creationId xmlns:a16="http://schemas.microsoft.com/office/drawing/2014/main" id="{B5C69696-62EB-4FE8-8E5B-3CE7A5505AB1}"/>
               </a:ext>
             </a:extLst>
           </p:cNvPr>
@@ -12030,7 +12264,7 @@
           <p:cNvPr id="8" name="Rounded Rectangle 7">
             <a:extLst xmlns:a="http://schemas.openxmlformats.org/drawingml/2006/main">
               <a:ext uri="{FF2B5EF4-FFF2-40B4-BE49-F238E27FC236}">
-                <a16:creationId xmlns:a16="http://schemas.microsoft.com/office/drawing/2014/main" id="{129C3BAD-5DA8-4B19-A160-A1ED6CC0A744}"/>
+                <a16:creationId xmlns:a16="http://schemas.microsoft.com/office/drawing/2014/main" id="{2181D1CA-DF2B-4E5A-82E0-13A90A52F6AC}"/>
               </a:ext>
             </a:extLst>
           </p:cNvPr>
@@ -12085,7 +12319,7 @@
           <p:cNvPr id="9" name="TextBox 8">
             <a:extLst xmlns:a="http://schemas.openxmlformats.org/drawingml/2006/main">
               <a:ext uri="{FF2B5EF4-FFF2-40B4-BE49-F238E27FC236}">
-                <a16:creationId xmlns:a16="http://schemas.microsoft.com/office/drawing/2014/main" id="{AA98C956-425F-47C5-9A84-8D7A216694C9}"/>
+                <a16:creationId xmlns:a16="http://schemas.microsoft.com/office/drawing/2014/main" id="{0014244E-0DF0-432E-880D-8A870CDEC647}"/>
               </a:ext>
             </a:extLst>
           </p:cNvPr>
@@ -12208,7 +12442,7 @@
           <p:cNvPr id="10" name="Rounded Rectangle 9">
             <a:extLst xmlns:a="http://schemas.openxmlformats.org/drawingml/2006/main">
               <a:ext uri="{FF2B5EF4-FFF2-40B4-BE49-F238E27FC236}">
-                <a16:creationId xmlns:a16="http://schemas.microsoft.com/office/drawing/2014/main" id="{A2372D3D-7C3D-4058-BE8E-A56377A3CE7F}"/>
+                <a16:creationId xmlns:a16="http://schemas.microsoft.com/office/drawing/2014/main" id="{55F37545-36BB-4EF9-994D-0F89132CF710}"/>
               </a:ext>
             </a:extLst>
           </p:cNvPr>
@@ -12263,7 +12497,7 @@
           <p:cNvPr id="11" name="TextBox 10">
             <a:extLst xmlns:a="http://schemas.openxmlformats.org/drawingml/2006/main">
               <a:ext uri="{FF2B5EF4-FFF2-40B4-BE49-F238E27FC236}">
-                <a16:creationId xmlns:a16="http://schemas.microsoft.com/office/drawing/2014/main" id="{C5144AD1-14BD-4091-87CE-39F6A57BB4BE}"/>
+                <a16:creationId xmlns:a16="http://schemas.microsoft.com/office/drawing/2014/main" id="{D8994DCB-DE82-401A-BECB-426D3728DBED}"/>
               </a:ext>
             </a:extLst>
           </p:cNvPr>
@@ -12613,7 +12847,7 @@
     </p:spTree>
     <p:extLst>
       <p:ext uri="{BB962C8B-B14F-4D97-AF65-F5344CB8AC3E}">
-        <p14:creationId xmlns:p14="http://schemas.microsoft.com/office/powerpoint/2010/main" val="1273040915"/>
+        <p14:creationId xmlns:p14="http://schemas.microsoft.com/office/powerpoint/2010/main" val="1276896136"/>
       </p:ext>
     </p:extLst>
   </p:cSld>
@@ -12637,7 +12871,7 @@
           <p:cNvPr id="2" name="Rectangle 1">
             <a:extLst xmlns:a="http://schemas.openxmlformats.org/drawingml/2006/main">
               <a:ext uri="{FF2B5EF4-FFF2-40B4-BE49-F238E27FC236}">
-                <a16:creationId xmlns:a16="http://schemas.microsoft.com/office/drawing/2014/main" id="{0FB5042B-D635-4EA3-ABEB-8931641C6D07}"/>
+                <a16:creationId xmlns:a16="http://schemas.microsoft.com/office/drawing/2014/main" id="{A252E5BB-A9D4-410D-A093-08BA6F55BE21}"/>
               </a:ext>
             </a:extLst>
           </p:cNvPr>
@@ -12690,7 +12924,7 @@
           <p:cNvPr id="3" name="Rectangle 2">
             <a:extLst xmlns:a="http://schemas.openxmlformats.org/drawingml/2006/main">
               <a:ext uri="{FF2B5EF4-FFF2-40B4-BE49-F238E27FC236}">
-                <a16:creationId xmlns:a16="http://schemas.microsoft.com/office/drawing/2014/main" id="{AF1D906F-1904-445E-94F0-C9FCE269B4CA}"/>
+                <a16:creationId xmlns:a16="http://schemas.microsoft.com/office/drawing/2014/main" id="{6356DC57-E006-43B8-BF54-EF8BFFDE682D}"/>
               </a:ext>
             </a:extLst>
           </p:cNvPr>
@@ -12743,7 +12977,7 @@
           <p:cNvPr id="4" name="Rectangle 3">
             <a:extLst xmlns:a="http://schemas.openxmlformats.org/drawingml/2006/main">
               <a:ext uri="{FF2B5EF4-FFF2-40B4-BE49-F238E27FC236}">
-                <a16:creationId xmlns:a16="http://schemas.microsoft.com/office/drawing/2014/main" id="{081EB570-0F04-489F-9BF9-34D84167BC50}"/>
+                <a16:creationId xmlns:a16="http://schemas.microsoft.com/office/drawing/2014/main" id="{CFD51A11-3573-4B2E-8D29-57684B95E59D}"/>
               </a:ext>
             </a:extLst>
           </p:cNvPr>
@@ -12796,7 +13030,7 @@
           <p:cNvPr id="5" name="TextBox 4">
             <a:extLst xmlns:a="http://schemas.openxmlformats.org/drawingml/2006/main">
               <a:ext uri="{FF2B5EF4-FFF2-40B4-BE49-F238E27FC236}">
-                <a16:creationId xmlns:a16="http://schemas.microsoft.com/office/drawing/2014/main" id="{47A5B0FD-B3F5-44AF-9E05-520584B7C01E}"/>
+                <a16:creationId xmlns:a16="http://schemas.microsoft.com/office/drawing/2014/main" id="{2D64DE29-D386-4C43-8C7A-580364641692}"/>
               </a:ext>
             </a:extLst>
           </p:cNvPr>
@@ -12859,7 +13093,7 @@
           <p:cNvPr id="6" name="Rounded Rectangle 5">
             <a:extLst xmlns:a="http://schemas.openxmlformats.org/drawingml/2006/main">
               <a:ext uri="{FF2B5EF4-FFF2-40B4-BE49-F238E27FC236}">
-                <a16:creationId xmlns:a16="http://schemas.microsoft.com/office/drawing/2014/main" id="{BBF47052-4C4C-4D04-BA0F-34F75ADBB453}"/>
+                <a16:creationId xmlns:a16="http://schemas.microsoft.com/office/drawing/2014/main" id="{C6CEE4A5-FF18-449B-B288-81C98CB4F61B}"/>
               </a:ext>
             </a:extLst>
           </p:cNvPr>
@@ -12914,7 +13148,7 @@
           <p:cNvPr id="7" name="TextBox 6">
             <a:extLst xmlns:a="http://schemas.openxmlformats.org/drawingml/2006/main">
               <a:ext uri="{FF2B5EF4-FFF2-40B4-BE49-F238E27FC236}">
-                <a16:creationId xmlns:a16="http://schemas.microsoft.com/office/drawing/2014/main" id="{D172AB9E-85A1-497B-9A12-9D32ADD45A70}"/>
+                <a16:creationId xmlns:a16="http://schemas.microsoft.com/office/drawing/2014/main" id="{95F072E9-4D16-4106-B9E9-969B9A6B0676}"/>
               </a:ext>
             </a:extLst>
           </p:cNvPr>
@@ -13378,7 +13612,7 @@
           <p:nvPr/>
         </p:nvPicPr>
         <p:blipFill>
-          <a:blip xmlns:r="http://schemas.openxmlformats.org/officeDocument/2006/relationships" xmlns:a="http://schemas.openxmlformats.org/drawingml/2006/main" r:embed="R6149f2370fac48ed"/>
+          <a:blip xmlns:r="http://schemas.openxmlformats.org/officeDocument/2006/relationships" xmlns:a="http://schemas.openxmlformats.org/drawingml/2006/main" r:embed="R4d1c071bb1004aee"/>
           <a:stretch xmlns:a="http://schemas.openxmlformats.org/drawingml/2006/main">
             <a:fillRect l="0" t="0" r="0" b="0"/>
           </a:stretch>
@@ -13398,7 +13632,7 @@
           <p:cNvPr id="9" name="Rounded Rectangle 8">
             <a:extLst xmlns:a="http://schemas.openxmlformats.org/drawingml/2006/main">
               <a:ext uri="{FF2B5EF4-FFF2-40B4-BE49-F238E27FC236}">
-                <a16:creationId xmlns:a16="http://schemas.microsoft.com/office/drawing/2014/main" id="{4DDBB250-948E-4E3D-9235-F8ADFFC3BA2C}"/>
+                <a16:creationId xmlns:a16="http://schemas.microsoft.com/office/drawing/2014/main" id="{8E18A292-52FE-475C-93C4-E885EF24ADD4}"/>
               </a:ext>
             </a:extLst>
           </p:cNvPr>
@@ -13453,7 +13687,7 @@
           <p:cNvPr id="10" name="TextBox 9">
             <a:extLst xmlns:a="http://schemas.openxmlformats.org/drawingml/2006/main">
               <a:ext uri="{FF2B5EF4-FFF2-40B4-BE49-F238E27FC236}">
-                <a16:creationId xmlns:a16="http://schemas.microsoft.com/office/drawing/2014/main" id="{E2F1F178-2D83-449B-8E65-DAC46C9811B1}"/>
+                <a16:creationId xmlns:a16="http://schemas.microsoft.com/office/drawing/2014/main" id="{2C7AF10E-6399-464E-97B1-E8F9494D9A59}"/>
               </a:ext>
             </a:extLst>
           </p:cNvPr>
@@ -13536,7 +13770,7 @@
     </p:spTree>
     <p:extLst>
       <p:ext uri="{BB962C8B-B14F-4D97-AF65-F5344CB8AC3E}">
-        <p14:creationId xmlns:p14="http://schemas.microsoft.com/office/powerpoint/2010/main" val="1399506064"/>
+        <p14:creationId xmlns:p14="http://schemas.microsoft.com/office/powerpoint/2010/main" val="1517629773"/>
       </p:ext>
     </p:extLst>
   </p:cSld>

</xml_diff>

<commit_message>
fix(presentation): refine slide 9 table layout using flat options and explicit row heights, update reproduction commands, and export presentation_v5
</commit_message>
<xml_diff>
--- a/reports/evidence/fixture_populated_slides.pptx
+++ b/reports/evidence/fixture_populated_slides.pptx
@@ -2,24 +2,24 @@
 <file path=ppt/presentation.xml><?xml version="1.0" encoding="utf-8"?>
 <p:presentation xmlns:p="http://schemas.openxmlformats.org/presentationml/2006/main">
   <p:sldMasterIdLst>
-    <p:sldMasterId xmlns:r="http://schemas.openxmlformats.org/officeDocument/2006/relationships" id="2147483648" r:id="R8d6b25893e074af4"/>
+    <p:sldMasterId xmlns:r="http://schemas.openxmlformats.org/officeDocument/2006/relationships" id="2147483648" r:id="Rebefc75836174f1a"/>
   </p:sldMasterIdLst>
   <p:notesMasterIdLst>
-    <p:notesMasterId xmlns:r="http://schemas.openxmlformats.org/officeDocument/2006/relationships" r:id="Rad28c68a257e481d"/>
+    <p:notesMasterId xmlns:r="http://schemas.openxmlformats.org/officeDocument/2006/relationships" r:id="Ra1d2833b2cc4409a"/>
   </p:notesMasterIdLst>
   <p:sldIdLst>
-    <p:sldId xmlns:r="http://schemas.openxmlformats.org/officeDocument/2006/relationships" id="256" r:id="R42c6b823cba44af3"/>
-    <p:sldId xmlns:r="http://schemas.openxmlformats.org/officeDocument/2006/relationships" id="257" r:id="R5b958a0c8de742fd"/>
-    <p:sldId xmlns:r="http://schemas.openxmlformats.org/officeDocument/2006/relationships" id="258" r:id="R4a5372163aa34f5d"/>
-    <p:sldId xmlns:r="http://schemas.openxmlformats.org/officeDocument/2006/relationships" id="259" r:id="Ra6cb1bd6c3f74bda"/>
-    <p:sldId xmlns:r="http://schemas.openxmlformats.org/officeDocument/2006/relationships" id="260" r:id="Rdb84edd8bf884405"/>
-    <p:sldId xmlns:r="http://schemas.openxmlformats.org/officeDocument/2006/relationships" id="261" r:id="Rff628730bb8347dd"/>
-    <p:sldId xmlns:r="http://schemas.openxmlformats.org/officeDocument/2006/relationships" id="262" r:id="R4a7be51562d84fa7"/>
-    <p:sldId xmlns:r="http://schemas.openxmlformats.org/officeDocument/2006/relationships" id="263" r:id="R435a1c5cad2d4ecd"/>
-    <p:sldId xmlns:r="http://schemas.openxmlformats.org/officeDocument/2006/relationships" id="264" r:id="Rd57917a01a2042d3"/>
-    <p:sldId xmlns:r="http://schemas.openxmlformats.org/officeDocument/2006/relationships" id="265" r:id="R8779158fe52f4724"/>
-    <p:sldId xmlns:r="http://schemas.openxmlformats.org/officeDocument/2006/relationships" id="266" r:id="R060768c3dbed4d8c"/>
-    <p:sldId xmlns:r="http://schemas.openxmlformats.org/officeDocument/2006/relationships" id="267" r:id="Rc73977ae20f7430e"/>
+    <p:sldId xmlns:r="http://schemas.openxmlformats.org/officeDocument/2006/relationships" id="256" r:id="R3f5a8671a3d8424d"/>
+    <p:sldId xmlns:r="http://schemas.openxmlformats.org/officeDocument/2006/relationships" id="257" r:id="Rf70e6d0425594080"/>
+    <p:sldId xmlns:r="http://schemas.openxmlformats.org/officeDocument/2006/relationships" id="258" r:id="R7d16815bfa3545b5"/>
+    <p:sldId xmlns:r="http://schemas.openxmlformats.org/officeDocument/2006/relationships" id="259" r:id="R0b8ee83ebe4b4a4e"/>
+    <p:sldId xmlns:r="http://schemas.openxmlformats.org/officeDocument/2006/relationships" id="260" r:id="R7a537e5bcc794282"/>
+    <p:sldId xmlns:r="http://schemas.openxmlformats.org/officeDocument/2006/relationships" id="261" r:id="R1e7201fcbfb14516"/>
+    <p:sldId xmlns:r="http://schemas.openxmlformats.org/officeDocument/2006/relationships" id="262" r:id="Rfdc486169bf54441"/>
+    <p:sldId xmlns:r="http://schemas.openxmlformats.org/officeDocument/2006/relationships" id="263" r:id="R8d1937e3c6b145f3"/>
+    <p:sldId xmlns:r="http://schemas.openxmlformats.org/officeDocument/2006/relationships" id="264" r:id="R839f58f7306d4df3"/>
+    <p:sldId xmlns:r="http://schemas.openxmlformats.org/officeDocument/2006/relationships" id="265" r:id="R4d0eb1bed2d3486e"/>
+    <p:sldId xmlns:r="http://schemas.openxmlformats.org/officeDocument/2006/relationships" id="266" r:id="Rb89fdf37a91e47e4"/>
+    <p:sldId xmlns:r="http://schemas.openxmlformats.org/officeDocument/2006/relationships" id="267" r:id="Rd51a58807c1f4791"/>
   </p:sldIdLst>
   <p:sldSz cx="12191695" cy="6858000"/>
   <p:notesSz cx="6858000" cy="9144000"/>
@@ -1577,7 +1577,7 @@
           <p:cNvPr id="2" name="Title 1">
             <a:extLst xmlns:a="http://schemas.openxmlformats.org/drawingml/2006/main">
               <a:ext uri="{FF2B5EF4-FFF2-40B4-BE49-F238E27FC236}">
-                <a16:creationId xmlns:a16="http://schemas.microsoft.com/office/drawing/2014/main" id="{A133F466-B639-41BC-8ACC-FAE823FC8C4D}"/>
+                <a16:creationId xmlns:a16="http://schemas.microsoft.com/office/drawing/2014/main" id="{A5F65FD0-18D3-40A1-81D2-7DD331BA1459}"/>
               </a:ext>
             </a:extLst>
           </p:cNvPr>
@@ -1610,7 +1610,7 @@
           <p:cNvPr id="3" name="Subtitle 2">
             <a:extLst xmlns:a="http://schemas.openxmlformats.org/drawingml/2006/main">
               <a:ext uri="{FF2B5EF4-FFF2-40B4-BE49-F238E27FC236}">
-                <a16:creationId xmlns:a16="http://schemas.microsoft.com/office/drawing/2014/main" id="{DA373217-AB0A-49A7-B904-4696B4DFED50}"/>
+                <a16:creationId xmlns:a16="http://schemas.microsoft.com/office/drawing/2014/main" id="{CFD99702-E94B-4719-8127-BF1E1D645188}"/>
               </a:ext>
             </a:extLst>
           </p:cNvPr>
@@ -1734,7 +1734,7 @@
           <p:cNvPr id="4" name="Date Placeholder 3">
             <a:extLst xmlns:a="http://schemas.openxmlformats.org/drawingml/2006/main">
               <a:ext uri="{FF2B5EF4-FFF2-40B4-BE49-F238E27FC236}">
-                <a16:creationId xmlns:a16="http://schemas.microsoft.com/office/drawing/2014/main" id="{D0580FEB-F164-4CCC-8032-E45F321DA265}"/>
+                <a16:creationId xmlns:a16="http://schemas.microsoft.com/office/drawing/2014/main" id="{FA94C1BE-ECB6-4513-A15F-75A1C4B5AB71}"/>
               </a:ext>
             </a:extLst>
           </p:cNvPr>
@@ -1762,7 +1762,7 @@
           <p:cNvPr id="5" name="Footer Placeholder 4">
             <a:extLst xmlns:a="http://schemas.openxmlformats.org/drawingml/2006/main">
               <a:ext uri="{FF2B5EF4-FFF2-40B4-BE49-F238E27FC236}">
-                <a16:creationId xmlns:a16="http://schemas.microsoft.com/office/drawing/2014/main" id="{6FF2872C-0A5E-44B5-8891-AE35E6F4A67E}"/>
+                <a16:creationId xmlns:a16="http://schemas.microsoft.com/office/drawing/2014/main" id="{96B2A07E-A8E9-46C3-9B24-A73BA9C75C38}"/>
               </a:ext>
             </a:extLst>
           </p:cNvPr>
@@ -1787,7 +1787,7 @@
           <p:cNvPr id="6" name="Slide Number Placeholder 5">
             <a:extLst xmlns:a="http://schemas.openxmlformats.org/drawingml/2006/main">
               <a:ext uri="{FF2B5EF4-FFF2-40B4-BE49-F238E27FC236}">
-                <a16:creationId xmlns:a16="http://schemas.microsoft.com/office/drawing/2014/main" id="{637C316B-7131-4A4E-9ED5-69903DD69BC3}"/>
+                <a16:creationId xmlns:a16="http://schemas.microsoft.com/office/drawing/2014/main" id="{035E55D6-25E6-4D1C-8B83-1614A4DB5D0B}"/>
               </a:ext>
             </a:extLst>
           </p:cNvPr>
@@ -1832,7 +1832,7 @@
           <p:cNvPr id="2" name="Title 1">
             <a:extLst xmlns:a="http://schemas.openxmlformats.org/drawingml/2006/main">
               <a:ext uri="{FF2B5EF4-FFF2-40B4-BE49-F238E27FC236}">
-                <a16:creationId xmlns:a16="http://schemas.microsoft.com/office/drawing/2014/main" id="{6AC86A5F-9017-43EB-8A8C-2090B226599F}"/>
+                <a16:creationId xmlns:a16="http://schemas.microsoft.com/office/drawing/2014/main" id="{FAA4B837-300D-426B-A7C3-E148738F313D}"/>
               </a:ext>
             </a:extLst>
           </p:cNvPr>
@@ -1860,7 +1860,7 @@
           <p:cNvPr id="3" name="Vertical Text Placeholder 2">
             <a:extLst xmlns:a="http://schemas.openxmlformats.org/drawingml/2006/main">
               <a:ext uri="{FF2B5EF4-FFF2-40B4-BE49-F238E27FC236}">
-                <a16:creationId xmlns:a16="http://schemas.microsoft.com/office/drawing/2014/main" id="{47F06A0B-3CCB-4B68-AD43-D02B5E88FC73}"/>
+                <a16:creationId xmlns:a16="http://schemas.microsoft.com/office/drawing/2014/main" id="{84D15B48-8FD4-4D43-8878-D2C96FF5CCA8}"/>
               </a:ext>
             </a:extLst>
           </p:cNvPr>
@@ -1923,7 +1923,7 @@
           <p:cNvPr id="4" name="Date Placeholder 3">
             <a:extLst xmlns:a="http://schemas.openxmlformats.org/drawingml/2006/main">
               <a:ext uri="{FF2B5EF4-FFF2-40B4-BE49-F238E27FC236}">
-                <a16:creationId xmlns:a16="http://schemas.microsoft.com/office/drawing/2014/main" id="{B4B8FE75-78D7-4ACE-B284-2116E4DC2265}"/>
+                <a16:creationId xmlns:a16="http://schemas.microsoft.com/office/drawing/2014/main" id="{CDE0F18A-C1D2-4CB4-8E4D-3361546269A0}"/>
               </a:ext>
             </a:extLst>
           </p:cNvPr>
@@ -1951,7 +1951,7 @@
           <p:cNvPr id="5" name="Footer Placeholder 4">
             <a:extLst xmlns:a="http://schemas.openxmlformats.org/drawingml/2006/main">
               <a:ext uri="{FF2B5EF4-FFF2-40B4-BE49-F238E27FC236}">
-                <a16:creationId xmlns:a16="http://schemas.microsoft.com/office/drawing/2014/main" id="{55452CF7-DE64-4678-AC53-A9B9BA13FA42}"/>
+                <a16:creationId xmlns:a16="http://schemas.microsoft.com/office/drawing/2014/main" id="{DBEAA1F0-3328-48D2-9977-8B9A38BD874E}"/>
               </a:ext>
             </a:extLst>
           </p:cNvPr>
@@ -1976,7 +1976,7 @@
           <p:cNvPr id="6" name="Slide Number Placeholder 5">
             <a:extLst xmlns:a="http://schemas.openxmlformats.org/drawingml/2006/main">
               <a:ext uri="{FF2B5EF4-FFF2-40B4-BE49-F238E27FC236}">
-                <a16:creationId xmlns:a16="http://schemas.microsoft.com/office/drawing/2014/main" id="{6FA67FAB-BBC6-4EFE-ACF3-82EB5BBDB7A9}"/>
+                <a16:creationId xmlns:a16="http://schemas.microsoft.com/office/drawing/2014/main" id="{AC2A07CA-2E6D-4BE6-970C-3517401E911B}"/>
               </a:ext>
             </a:extLst>
           </p:cNvPr>
@@ -2021,7 +2021,7 @@
           <p:cNvPr id="2" name="Vertical Title 1">
             <a:extLst xmlns:a="http://schemas.openxmlformats.org/drawingml/2006/main">
               <a:ext uri="{FF2B5EF4-FFF2-40B4-BE49-F238E27FC236}">
-                <a16:creationId xmlns:a16="http://schemas.microsoft.com/office/drawing/2014/main" id="{89CF581A-5C2A-4CC0-A77B-A20ADD18B5E8}"/>
+                <a16:creationId xmlns:a16="http://schemas.microsoft.com/office/drawing/2014/main" id="{8EEBDC85-5C83-415B-9209-8107668138E8}"/>
               </a:ext>
             </a:extLst>
           </p:cNvPr>
@@ -2054,7 +2054,7 @@
           <p:cNvPr id="3" name="Vertical Text Placeholder 2">
             <a:extLst xmlns:a="http://schemas.openxmlformats.org/drawingml/2006/main">
               <a:ext uri="{FF2B5EF4-FFF2-40B4-BE49-F238E27FC236}">
-                <a16:creationId xmlns:a16="http://schemas.microsoft.com/office/drawing/2014/main" id="{F5EEF56B-CEE6-4008-BECA-30F618CAE9B4}"/>
+                <a16:creationId xmlns:a16="http://schemas.microsoft.com/office/drawing/2014/main" id="{2B1CA8F1-A9A7-4D6F-8BFD-84F21BAD6AD6}"/>
               </a:ext>
             </a:extLst>
           </p:cNvPr>
@@ -2122,7 +2122,7 @@
           <p:cNvPr id="4" name="Date Placeholder 3">
             <a:extLst xmlns:a="http://schemas.openxmlformats.org/drawingml/2006/main">
               <a:ext uri="{FF2B5EF4-FFF2-40B4-BE49-F238E27FC236}">
-                <a16:creationId xmlns:a16="http://schemas.microsoft.com/office/drawing/2014/main" id="{C559B771-4A62-4E27-BF8A-4FFDBFB5281F}"/>
+                <a16:creationId xmlns:a16="http://schemas.microsoft.com/office/drawing/2014/main" id="{FA6A1A75-8BC2-4D0A-BBA8-43DDA347B40A}"/>
               </a:ext>
             </a:extLst>
           </p:cNvPr>
@@ -2150,7 +2150,7 @@
           <p:cNvPr id="5" name="Footer Placeholder 4">
             <a:extLst xmlns:a="http://schemas.openxmlformats.org/drawingml/2006/main">
               <a:ext uri="{FF2B5EF4-FFF2-40B4-BE49-F238E27FC236}">
-                <a16:creationId xmlns:a16="http://schemas.microsoft.com/office/drawing/2014/main" id="{451B23B1-FF4D-49AE-A67A-1573AB962FBD}"/>
+                <a16:creationId xmlns:a16="http://schemas.microsoft.com/office/drawing/2014/main" id="{738281CF-6176-403A-9169-4DAB269AA885}"/>
               </a:ext>
             </a:extLst>
           </p:cNvPr>
@@ -2175,7 +2175,7 @@
           <p:cNvPr id="6" name="Slide Number Placeholder 5">
             <a:extLst xmlns:a="http://schemas.openxmlformats.org/drawingml/2006/main">
               <a:ext uri="{FF2B5EF4-FFF2-40B4-BE49-F238E27FC236}">
-                <a16:creationId xmlns:a16="http://schemas.microsoft.com/office/drawing/2014/main" id="{50DF5C2A-919B-4E54-88EC-642916104508}"/>
+                <a16:creationId xmlns:a16="http://schemas.microsoft.com/office/drawing/2014/main" id="{38EBC3A9-2CD4-47AF-8E58-3E0D972B4703}"/>
               </a:ext>
             </a:extLst>
           </p:cNvPr>
@@ -2220,7 +2220,7 @@
           <p:cNvPr id="2" name="Title 1">
             <a:extLst xmlns:a="http://schemas.openxmlformats.org/drawingml/2006/main">
               <a:ext uri="{FF2B5EF4-FFF2-40B4-BE49-F238E27FC236}">
-                <a16:creationId xmlns:a16="http://schemas.microsoft.com/office/drawing/2014/main" id="{8AA9D3DC-D92A-4836-B460-50FC688DB91C}"/>
+                <a16:creationId xmlns:a16="http://schemas.microsoft.com/office/drawing/2014/main" id="{B67B8D94-4688-4146-BFE8-EDBD54BBD5A0}"/>
               </a:ext>
             </a:extLst>
           </p:cNvPr>
@@ -2248,7 +2248,7 @@
           <p:cNvPr id="3" name="Content Placeholder 2">
             <a:extLst xmlns:a="http://schemas.openxmlformats.org/drawingml/2006/main">
               <a:ext uri="{FF2B5EF4-FFF2-40B4-BE49-F238E27FC236}">
-                <a16:creationId xmlns:a16="http://schemas.microsoft.com/office/drawing/2014/main" id="{5AE5AB4E-EAB4-4A5B-980C-3B2F32E37BAB}"/>
+                <a16:creationId xmlns:a16="http://schemas.microsoft.com/office/drawing/2014/main" id="{5E8833FC-E042-461C-9FBE-4B0839EF442A}"/>
               </a:ext>
             </a:extLst>
           </p:cNvPr>
@@ -2311,7 +2311,7 @@
           <p:cNvPr id="4" name="Date Placeholder 3">
             <a:extLst xmlns:a="http://schemas.openxmlformats.org/drawingml/2006/main">
               <a:ext uri="{FF2B5EF4-FFF2-40B4-BE49-F238E27FC236}">
-                <a16:creationId xmlns:a16="http://schemas.microsoft.com/office/drawing/2014/main" id="{B2AF3671-6169-41CA-BA67-44B599A3F299}"/>
+                <a16:creationId xmlns:a16="http://schemas.microsoft.com/office/drawing/2014/main" id="{1FF78225-5405-48B3-9720-3260F6036473}"/>
               </a:ext>
             </a:extLst>
           </p:cNvPr>
@@ -2339,7 +2339,7 @@
           <p:cNvPr id="5" name="Footer Placeholder 4">
             <a:extLst xmlns:a="http://schemas.openxmlformats.org/drawingml/2006/main">
               <a:ext uri="{FF2B5EF4-FFF2-40B4-BE49-F238E27FC236}">
-                <a16:creationId xmlns:a16="http://schemas.microsoft.com/office/drawing/2014/main" id="{6BE774CD-FCED-47ED-91D9-9347105ED8A5}"/>
+                <a16:creationId xmlns:a16="http://schemas.microsoft.com/office/drawing/2014/main" id="{C9508622-9065-4DD5-9E19-9BD0C5ACC8A6}"/>
               </a:ext>
             </a:extLst>
           </p:cNvPr>
@@ -2364,7 +2364,7 @@
           <p:cNvPr id="6" name="Slide Number Placeholder 5">
             <a:extLst xmlns:a="http://schemas.openxmlformats.org/drawingml/2006/main">
               <a:ext uri="{FF2B5EF4-FFF2-40B4-BE49-F238E27FC236}">
-                <a16:creationId xmlns:a16="http://schemas.microsoft.com/office/drawing/2014/main" id="{79332BA4-793E-474B-8560-DACFB220136F}"/>
+                <a16:creationId xmlns:a16="http://schemas.microsoft.com/office/drawing/2014/main" id="{7213BA54-BFA8-4ACF-AF21-404BB1F401C9}"/>
               </a:ext>
             </a:extLst>
           </p:cNvPr>
@@ -2409,7 +2409,7 @@
           <p:cNvPr id="2" name="Title 1">
             <a:extLst xmlns:a="http://schemas.openxmlformats.org/drawingml/2006/main">
               <a:ext uri="{FF2B5EF4-FFF2-40B4-BE49-F238E27FC236}">
-                <a16:creationId xmlns:a16="http://schemas.microsoft.com/office/drawing/2014/main" id="{43EA7274-B8E5-4B4B-ADC5-6DB26AC0D3E7}"/>
+                <a16:creationId xmlns:a16="http://schemas.microsoft.com/office/drawing/2014/main" id="{B2B74632-442F-4355-B638-9405A2AA8E14}"/>
               </a:ext>
             </a:extLst>
           </p:cNvPr>
@@ -2447,7 +2447,7 @@
           <p:cNvPr id="3" name="Text Placeholder 2">
             <a:extLst xmlns:a="http://schemas.openxmlformats.org/drawingml/2006/main">
               <a:ext uri="{FF2B5EF4-FFF2-40B4-BE49-F238E27FC236}">
-                <a16:creationId xmlns:a16="http://schemas.microsoft.com/office/drawing/2014/main" id="{84D2F316-EC02-41E3-BBDE-050400B34E6D}"/>
+                <a16:creationId xmlns:a16="http://schemas.microsoft.com/office/drawing/2014/main" id="{C0240103-CAE5-4C62-9D8F-1A20D33CE43D}"/>
               </a:ext>
             </a:extLst>
           </p:cNvPr>
@@ -2573,7 +2573,7 @@
           <p:cNvPr id="4" name="Date Placeholder 3">
             <a:extLst xmlns:a="http://schemas.openxmlformats.org/drawingml/2006/main">
               <a:ext uri="{FF2B5EF4-FFF2-40B4-BE49-F238E27FC236}">
-                <a16:creationId xmlns:a16="http://schemas.microsoft.com/office/drawing/2014/main" id="{6C325968-D9F3-4DA4-8CD8-1223698BC0E9}"/>
+                <a16:creationId xmlns:a16="http://schemas.microsoft.com/office/drawing/2014/main" id="{3CF1F627-0305-4FD7-9BB2-66E1F7D8A181}"/>
               </a:ext>
             </a:extLst>
           </p:cNvPr>
@@ -2601,7 +2601,7 @@
           <p:cNvPr id="5" name="Footer Placeholder 4">
             <a:extLst xmlns:a="http://schemas.openxmlformats.org/drawingml/2006/main">
               <a:ext uri="{FF2B5EF4-FFF2-40B4-BE49-F238E27FC236}">
-                <a16:creationId xmlns:a16="http://schemas.microsoft.com/office/drawing/2014/main" id="{590FE396-4D15-46D1-AE80-C807C5DC9CB4}"/>
+                <a16:creationId xmlns:a16="http://schemas.microsoft.com/office/drawing/2014/main" id="{2D54A19D-BD09-4155-8B7A-6623FF02CFFE}"/>
               </a:ext>
             </a:extLst>
           </p:cNvPr>
@@ -2626,7 +2626,7 @@
           <p:cNvPr id="6" name="Slide Number Placeholder 5">
             <a:extLst xmlns:a="http://schemas.openxmlformats.org/drawingml/2006/main">
               <a:ext uri="{FF2B5EF4-FFF2-40B4-BE49-F238E27FC236}">
-                <a16:creationId xmlns:a16="http://schemas.microsoft.com/office/drawing/2014/main" id="{43A3FFC4-CF92-4D2A-8A3C-E8523763A8B7}"/>
+                <a16:creationId xmlns:a16="http://schemas.microsoft.com/office/drawing/2014/main" id="{5069A511-726E-4BF2-BD17-1FC39AFA88BC}"/>
               </a:ext>
             </a:extLst>
           </p:cNvPr>
@@ -2671,7 +2671,7 @@
           <p:cNvPr id="2" name="Title 1">
             <a:extLst xmlns:a="http://schemas.openxmlformats.org/drawingml/2006/main">
               <a:ext uri="{FF2B5EF4-FFF2-40B4-BE49-F238E27FC236}">
-                <a16:creationId xmlns:a16="http://schemas.microsoft.com/office/drawing/2014/main" id="{1C7EDC5D-F0D4-4209-BDA4-B9D9DFD3E306}"/>
+                <a16:creationId xmlns:a16="http://schemas.microsoft.com/office/drawing/2014/main" id="{1A81C51C-F18E-4EEB-9F1A-2CAA2BF50D3A}"/>
               </a:ext>
             </a:extLst>
           </p:cNvPr>
@@ -2699,7 +2699,7 @@
           <p:cNvPr id="3" name="Content Placeholder 2">
             <a:extLst xmlns:a="http://schemas.openxmlformats.org/drawingml/2006/main">
               <a:ext uri="{FF2B5EF4-FFF2-40B4-BE49-F238E27FC236}">
-                <a16:creationId xmlns:a16="http://schemas.microsoft.com/office/drawing/2014/main" id="{1C7CF480-57F1-453C-9B6C-BCDDEE0EA606}"/>
+                <a16:creationId xmlns:a16="http://schemas.microsoft.com/office/drawing/2014/main" id="{FE2BDF15-6368-499D-B841-E23549123689}"/>
               </a:ext>
             </a:extLst>
           </p:cNvPr>
@@ -2804,7 +2804,7 @@
           <p:cNvPr id="4" name="Content Placeholder 3">
             <a:extLst xmlns:a="http://schemas.openxmlformats.org/drawingml/2006/main">
               <a:ext uri="{FF2B5EF4-FFF2-40B4-BE49-F238E27FC236}">
-                <a16:creationId xmlns:a16="http://schemas.microsoft.com/office/drawing/2014/main" id="{5883344A-9CF3-4539-856B-FB11292D8E0A}"/>
+                <a16:creationId xmlns:a16="http://schemas.microsoft.com/office/drawing/2014/main" id="{0C8B2580-A070-4E6C-A841-4BC6FD9744AD}"/>
               </a:ext>
             </a:extLst>
           </p:cNvPr>
@@ -2909,7 +2909,7 @@
           <p:cNvPr id="5" name="Date Placeholder 4">
             <a:extLst xmlns:a="http://schemas.openxmlformats.org/drawingml/2006/main">
               <a:ext uri="{FF2B5EF4-FFF2-40B4-BE49-F238E27FC236}">
-                <a16:creationId xmlns:a16="http://schemas.microsoft.com/office/drawing/2014/main" id="{012FE445-5E05-48AE-81BC-7A2ACCC731D2}"/>
+                <a16:creationId xmlns:a16="http://schemas.microsoft.com/office/drawing/2014/main" id="{7A3A53CD-7EA0-4DFC-B5A9-A6FCAEB41334}"/>
               </a:ext>
             </a:extLst>
           </p:cNvPr>
@@ -2937,7 +2937,7 @@
           <p:cNvPr id="6" name="Footer Placeholder 5">
             <a:extLst xmlns:a="http://schemas.openxmlformats.org/drawingml/2006/main">
               <a:ext uri="{FF2B5EF4-FFF2-40B4-BE49-F238E27FC236}">
-                <a16:creationId xmlns:a16="http://schemas.microsoft.com/office/drawing/2014/main" id="{D79F8EFE-D762-48F9-BBDC-262DF99C6C08}"/>
+                <a16:creationId xmlns:a16="http://schemas.microsoft.com/office/drawing/2014/main" id="{ACEC179D-4D00-4FFC-AA83-CAEBD38B6D02}"/>
               </a:ext>
             </a:extLst>
           </p:cNvPr>
@@ -2962,7 +2962,7 @@
           <p:cNvPr id="7" name="Slide Number Placeholder 6">
             <a:extLst xmlns:a="http://schemas.openxmlformats.org/drawingml/2006/main">
               <a:ext uri="{FF2B5EF4-FFF2-40B4-BE49-F238E27FC236}">
-                <a16:creationId xmlns:a16="http://schemas.microsoft.com/office/drawing/2014/main" id="{DDCA9C43-32C1-4D9E-A7B1-BD5A40A23D63}"/>
+                <a16:creationId xmlns:a16="http://schemas.microsoft.com/office/drawing/2014/main" id="{37E75401-1A84-410A-90F7-B528D1662277}"/>
               </a:ext>
             </a:extLst>
           </p:cNvPr>
@@ -3007,7 +3007,7 @@
           <p:cNvPr id="2" name="Title 1">
             <a:extLst xmlns:a="http://schemas.openxmlformats.org/drawingml/2006/main">
               <a:ext uri="{FF2B5EF4-FFF2-40B4-BE49-F238E27FC236}">
-                <a16:creationId xmlns:a16="http://schemas.microsoft.com/office/drawing/2014/main" id="{D7FDAED5-4B53-4AE8-882E-6E277E23B7BF}"/>
+                <a16:creationId xmlns:a16="http://schemas.microsoft.com/office/drawing/2014/main" id="{650BAE0C-5CF6-40D3-BC14-575E7EF316FA}"/>
               </a:ext>
             </a:extLst>
           </p:cNvPr>
@@ -3040,7 +3040,7 @@
           <p:cNvPr id="3" name="Text Placeholder 2">
             <a:extLst xmlns:a="http://schemas.openxmlformats.org/drawingml/2006/main">
               <a:ext uri="{FF2B5EF4-FFF2-40B4-BE49-F238E27FC236}">
-                <a16:creationId xmlns:a16="http://schemas.microsoft.com/office/drawing/2014/main" id="{F79BE1E1-AD4C-4127-B8A1-D7412A120124}"/>
+                <a16:creationId xmlns:a16="http://schemas.microsoft.com/office/drawing/2014/main" id="{A403E099-C5C3-4478-BF9A-885D0F62F739}"/>
               </a:ext>
             </a:extLst>
           </p:cNvPr>
@@ -3112,7 +3112,7 @@
           <p:cNvPr id="4" name="Content Placeholder 3">
             <a:extLst xmlns:a="http://schemas.openxmlformats.org/drawingml/2006/main">
               <a:ext uri="{FF2B5EF4-FFF2-40B4-BE49-F238E27FC236}">
-                <a16:creationId xmlns:a16="http://schemas.microsoft.com/office/drawing/2014/main" id="{82285AE6-3FA2-491A-9966-C5B4F03D8743}"/>
+                <a16:creationId xmlns:a16="http://schemas.microsoft.com/office/drawing/2014/main" id="{41D7E936-D5B4-4A85-A1FF-18A8EEAC19F1}"/>
               </a:ext>
             </a:extLst>
           </p:cNvPr>
@@ -3217,7 +3217,7 @@
           <p:cNvPr id="5" name="Text Placeholder 4">
             <a:extLst xmlns:a="http://schemas.openxmlformats.org/drawingml/2006/main">
               <a:ext uri="{FF2B5EF4-FFF2-40B4-BE49-F238E27FC236}">
-                <a16:creationId xmlns:a16="http://schemas.microsoft.com/office/drawing/2014/main" id="{C250DB89-0C43-4101-BBD3-0C4E7FB6028C}"/>
+                <a16:creationId xmlns:a16="http://schemas.microsoft.com/office/drawing/2014/main" id="{59DA8200-7B6E-4D1D-AED5-38A72D0D1B35}"/>
               </a:ext>
             </a:extLst>
           </p:cNvPr>
@@ -3289,7 +3289,7 @@
           <p:cNvPr id="6" name="Content Placeholder 5">
             <a:extLst xmlns:a="http://schemas.openxmlformats.org/drawingml/2006/main">
               <a:ext uri="{FF2B5EF4-FFF2-40B4-BE49-F238E27FC236}">
-                <a16:creationId xmlns:a16="http://schemas.microsoft.com/office/drawing/2014/main" id="{4DBA596F-29F1-428F-904D-8699B0790ECA}"/>
+                <a16:creationId xmlns:a16="http://schemas.microsoft.com/office/drawing/2014/main" id="{38AB1871-58AA-47C0-B71D-97A8C3FDE63B}"/>
               </a:ext>
             </a:extLst>
           </p:cNvPr>
@@ -3394,7 +3394,7 @@
           <p:cNvPr id="7" name="Date Placeholder 6">
             <a:extLst xmlns:a="http://schemas.openxmlformats.org/drawingml/2006/main">
               <a:ext uri="{FF2B5EF4-FFF2-40B4-BE49-F238E27FC236}">
-                <a16:creationId xmlns:a16="http://schemas.microsoft.com/office/drawing/2014/main" id="{CEE2D3D0-9215-4EAF-88E5-88F811DFE4D2}"/>
+                <a16:creationId xmlns:a16="http://schemas.microsoft.com/office/drawing/2014/main" id="{87644B2C-B3CB-4127-9930-5ECC249D2903}"/>
               </a:ext>
             </a:extLst>
           </p:cNvPr>
@@ -3422,7 +3422,7 @@
           <p:cNvPr id="8" name="Footer Placeholder 7">
             <a:extLst xmlns:a="http://schemas.openxmlformats.org/drawingml/2006/main">
               <a:ext uri="{FF2B5EF4-FFF2-40B4-BE49-F238E27FC236}">
-                <a16:creationId xmlns:a16="http://schemas.microsoft.com/office/drawing/2014/main" id="{7A83A992-49F2-42BE-B219-D34FBB703CD9}"/>
+                <a16:creationId xmlns:a16="http://schemas.microsoft.com/office/drawing/2014/main" id="{07AEB394-16FD-4B8D-B139-B0D95B73635A}"/>
               </a:ext>
             </a:extLst>
           </p:cNvPr>
@@ -3447,7 +3447,7 @@
           <p:cNvPr id="9" name="Slide Number Placeholder 8">
             <a:extLst xmlns:a="http://schemas.openxmlformats.org/drawingml/2006/main">
               <a:ext uri="{FF2B5EF4-FFF2-40B4-BE49-F238E27FC236}">
-                <a16:creationId xmlns:a16="http://schemas.microsoft.com/office/drawing/2014/main" id="{B632F2B8-B245-4E0D-9443-FBDCA661AB2B}"/>
+                <a16:creationId xmlns:a16="http://schemas.microsoft.com/office/drawing/2014/main" id="{049C5653-B8EB-4584-ADD4-30B9DD7175B6}"/>
               </a:ext>
             </a:extLst>
           </p:cNvPr>
@@ -3492,7 +3492,7 @@
           <p:cNvPr id="2" name="Title 1">
             <a:extLst xmlns:a="http://schemas.openxmlformats.org/drawingml/2006/main">
               <a:ext uri="{FF2B5EF4-FFF2-40B4-BE49-F238E27FC236}">
-                <a16:creationId xmlns:a16="http://schemas.microsoft.com/office/drawing/2014/main" id="{093E1C0B-8698-49B7-B9E6-3A1CDD58586E}"/>
+                <a16:creationId xmlns:a16="http://schemas.microsoft.com/office/drawing/2014/main" id="{9A79C238-B0B7-42BA-8E33-58FE3FD83561}"/>
               </a:ext>
             </a:extLst>
           </p:cNvPr>
@@ -3520,7 +3520,7 @@
           <p:cNvPr id="3" name="Date Placeholder 2">
             <a:extLst xmlns:a="http://schemas.openxmlformats.org/drawingml/2006/main">
               <a:ext uri="{FF2B5EF4-FFF2-40B4-BE49-F238E27FC236}">
-                <a16:creationId xmlns:a16="http://schemas.microsoft.com/office/drawing/2014/main" id="{C7ED8F34-FDB4-4938-BEE9-07B8E15B8C89}"/>
+                <a16:creationId xmlns:a16="http://schemas.microsoft.com/office/drawing/2014/main" id="{4A7B3E59-6FB6-4119-86F1-82F068CAF057}"/>
               </a:ext>
             </a:extLst>
           </p:cNvPr>
@@ -3548,7 +3548,7 @@
           <p:cNvPr id="4" name="Footer Placeholder 3">
             <a:extLst xmlns:a="http://schemas.openxmlformats.org/drawingml/2006/main">
               <a:ext uri="{FF2B5EF4-FFF2-40B4-BE49-F238E27FC236}">
-                <a16:creationId xmlns:a16="http://schemas.microsoft.com/office/drawing/2014/main" id="{8E7D0772-4796-4BF3-AFE8-9E9F1AB984E4}"/>
+                <a16:creationId xmlns:a16="http://schemas.microsoft.com/office/drawing/2014/main" id="{2910D873-D102-4A33-8958-2F1DD1A472E5}"/>
               </a:ext>
             </a:extLst>
           </p:cNvPr>
@@ -3573,7 +3573,7 @@
           <p:cNvPr id="5" name="Slide Number Placeholder 4">
             <a:extLst xmlns:a="http://schemas.openxmlformats.org/drawingml/2006/main">
               <a:ext uri="{FF2B5EF4-FFF2-40B4-BE49-F238E27FC236}">
-                <a16:creationId xmlns:a16="http://schemas.microsoft.com/office/drawing/2014/main" id="{F53A675C-9509-4E38-8268-A0A2EE8F4720}"/>
+                <a16:creationId xmlns:a16="http://schemas.microsoft.com/office/drawing/2014/main" id="{21F38A83-DCB0-42E8-B8E8-E613A1001756}"/>
               </a:ext>
             </a:extLst>
           </p:cNvPr>
@@ -3618,7 +3618,7 @@
           <p:cNvPr id="2" name="Date Placeholder 1">
             <a:extLst xmlns:a="http://schemas.openxmlformats.org/drawingml/2006/main">
               <a:ext uri="{FF2B5EF4-FFF2-40B4-BE49-F238E27FC236}">
-                <a16:creationId xmlns:a16="http://schemas.microsoft.com/office/drawing/2014/main" id="{DB290794-0FD3-44A0-94F6-ECB0D589398C}"/>
+                <a16:creationId xmlns:a16="http://schemas.microsoft.com/office/drawing/2014/main" id="{A4260A55-751B-4755-9CEF-81C147005B5D}"/>
               </a:ext>
             </a:extLst>
           </p:cNvPr>
@@ -3646,7 +3646,7 @@
           <p:cNvPr id="3" name="Footer Placeholder 2">
             <a:extLst xmlns:a="http://schemas.openxmlformats.org/drawingml/2006/main">
               <a:ext uri="{FF2B5EF4-FFF2-40B4-BE49-F238E27FC236}">
-                <a16:creationId xmlns:a16="http://schemas.microsoft.com/office/drawing/2014/main" id="{F5E61D68-4944-40BE-9049-59B5333A6AF6}"/>
+                <a16:creationId xmlns:a16="http://schemas.microsoft.com/office/drawing/2014/main" id="{8348BB24-5C21-4318-8DEF-23F8E2C65856}"/>
               </a:ext>
             </a:extLst>
           </p:cNvPr>
@@ -3671,7 +3671,7 @@
           <p:cNvPr id="4" name="Slide Number Placeholder 3">
             <a:extLst xmlns:a="http://schemas.openxmlformats.org/drawingml/2006/main">
               <a:ext uri="{FF2B5EF4-FFF2-40B4-BE49-F238E27FC236}">
-                <a16:creationId xmlns:a16="http://schemas.microsoft.com/office/drawing/2014/main" id="{E290B1D7-42FC-42CC-95BF-AE973818EB29}"/>
+                <a16:creationId xmlns:a16="http://schemas.microsoft.com/office/drawing/2014/main" id="{BE83BFA9-CBC7-4A9F-B92A-3277AF05F268}"/>
               </a:ext>
             </a:extLst>
           </p:cNvPr>
@@ -3716,7 +3716,7 @@
           <p:cNvPr id="2" name="Title 1">
             <a:extLst xmlns:a="http://schemas.openxmlformats.org/drawingml/2006/main">
               <a:ext uri="{FF2B5EF4-FFF2-40B4-BE49-F238E27FC236}">
-                <a16:creationId xmlns:a16="http://schemas.microsoft.com/office/drawing/2014/main" id="{56B77538-8A66-4F05-A1B9-D7F591020720}"/>
+                <a16:creationId xmlns:a16="http://schemas.microsoft.com/office/drawing/2014/main" id="{B845A60D-DBFB-4C16-9CA2-DE225AA19252}"/>
               </a:ext>
             </a:extLst>
           </p:cNvPr>
@@ -3754,7 +3754,7 @@
           <p:cNvPr id="3" name="Content Placeholder 2">
             <a:extLst xmlns:a="http://schemas.openxmlformats.org/drawingml/2006/main">
               <a:ext uri="{FF2B5EF4-FFF2-40B4-BE49-F238E27FC236}">
-                <a16:creationId xmlns:a16="http://schemas.microsoft.com/office/drawing/2014/main" id="{058153D6-5207-418F-99AE-DB5BE657C9AA}"/>
+                <a16:creationId xmlns:a16="http://schemas.microsoft.com/office/drawing/2014/main" id="{E193F75F-C310-4633-900B-6E4627C49819}"/>
               </a:ext>
             </a:extLst>
           </p:cNvPr>
@@ -3859,7 +3859,7 @@
           <p:cNvPr id="4" name="Text Placeholder 3">
             <a:extLst xmlns:a="http://schemas.openxmlformats.org/drawingml/2006/main">
               <a:ext uri="{FF2B5EF4-FFF2-40B4-BE49-F238E27FC236}">
-                <a16:creationId xmlns:a16="http://schemas.microsoft.com/office/drawing/2014/main" id="{C9A0B03A-B9FB-48AE-8B68-CFF68421FDCF}"/>
+                <a16:creationId xmlns:a16="http://schemas.microsoft.com/office/drawing/2014/main" id="{4CDF1625-6F25-4C65-BC9E-8D92AE1E8E04}"/>
               </a:ext>
             </a:extLst>
           </p:cNvPr>
@@ -3931,7 +3931,7 @@
           <p:cNvPr id="5" name="Date Placeholder 4">
             <a:extLst xmlns:a="http://schemas.openxmlformats.org/drawingml/2006/main">
               <a:ext uri="{FF2B5EF4-FFF2-40B4-BE49-F238E27FC236}">
-                <a16:creationId xmlns:a16="http://schemas.microsoft.com/office/drawing/2014/main" id="{6D56352C-F680-4128-A7A8-299C839E6B8F}"/>
+                <a16:creationId xmlns:a16="http://schemas.microsoft.com/office/drawing/2014/main" id="{C3B515C6-37D6-453A-80CA-B7EAE8E86679}"/>
               </a:ext>
             </a:extLst>
           </p:cNvPr>
@@ -3959,7 +3959,7 @@
           <p:cNvPr id="6" name="Footer Placeholder 5">
             <a:extLst xmlns:a="http://schemas.openxmlformats.org/drawingml/2006/main">
               <a:ext uri="{FF2B5EF4-FFF2-40B4-BE49-F238E27FC236}">
-                <a16:creationId xmlns:a16="http://schemas.microsoft.com/office/drawing/2014/main" id="{7E7DCF77-319C-4051-8718-4463A7AEFCBE}"/>
+                <a16:creationId xmlns:a16="http://schemas.microsoft.com/office/drawing/2014/main" id="{612F0E3A-D0C7-4B78-A435-CBFF0648D2B8}"/>
               </a:ext>
             </a:extLst>
           </p:cNvPr>
@@ -3984,7 +3984,7 @@
           <p:cNvPr id="7" name="Slide Number Placeholder 6">
             <a:extLst xmlns:a="http://schemas.openxmlformats.org/drawingml/2006/main">
               <a:ext uri="{FF2B5EF4-FFF2-40B4-BE49-F238E27FC236}">
-                <a16:creationId xmlns:a16="http://schemas.microsoft.com/office/drawing/2014/main" id="{3F4D9C68-C95D-4D81-A048-F28F04D2BF18}"/>
+                <a16:creationId xmlns:a16="http://schemas.microsoft.com/office/drawing/2014/main" id="{CE2E0C7F-E08A-42DE-846D-CEE02EBB29EC}"/>
               </a:ext>
             </a:extLst>
           </p:cNvPr>
@@ -4029,7 +4029,7 @@
           <p:cNvPr id="2" name="Title 1">
             <a:extLst xmlns:a="http://schemas.openxmlformats.org/drawingml/2006/main">
               <a:ext uri="{FF2B5EF4-FFF2-40B4-BE49-F238E27FC236}">
-                <a16:creationId xmlns:a16="http://schemas.microsoft.com/office/drawing/2014/main" id="{C5C862B3-81FA-46FE-9237-86811C51A94A}"/>
+                <a16:creationId xmlns:a16="http://schemas.microsoft.com/office/drawing/2014/main" id="{BCDA3500-A98E-42D7-915C-C4B94E996C15}"/>
               </a:ext>
             </a:extLst>
           </p:cNvPr>
@@ -4067,7 +4067,7 @@
           <p:cNvPr id="3" name="Picture Placeholder 2">
             <a:extLst xmlns:a="http://schemas.openxmlformats.org/drawingml/2006/main">
               <a:ext uri="{FF2B5EF4-FFF2-40B4-BE49-F238E27FC236}">
-                <a16:creationId xmlns:a16="http://schemas.microsoft.com/office/drawing/2014/main" id="{779183DC-7EDB-4B20-B78D-927482FD686F}"/>
+                <a16:creationId xmlns:a16="http://schemas.microsoft.com/office/drawing/2014/main" id="{306C3FB7-879D-40F3-9EA3-F1E4C8096319}"/>
               </a:ext>
             </a:extLst>
           </p:cNvPr>
@@ -4134,7 +4134,7 @@
           <p:cNvPr id="4" name="Text Placeholder 3">
             <a:extLst xmlns:a="http://schemas.openxmlformats.org/drawingml/2006/main">
               <a:ext uri="{FF2B5EF4-FFF2-40B4-BE49-F238E27FC236}">
-                <a16:creationId xmlns:a16="http://schemas.microsoft.com/office/drawing/2014/main" id="{33B1BC80-21E0-4F34-8437-FD301269BBF6}"/>
+                <a16:creationId xmlns:a16="http://schemas.microsoft.com/office/drawing/2014/main" id="{9A405AC1-9650-494E-B486-6AE02AA47C55}"/>
               </a:ext>
             </a:extLst>
           </p:cNvPr>
@@ -4206,7 +4206,7 @@
           <p:cNvPr id="5" name="Date Placeholder 4">
             <a:extLst xmlns:a="http://schemas.openxmlformats.org/drawingml/2006/main">
               <a:ext uri="{FF2B5EF4-FFF2-40B4-BE49-F238E27FC236}">
-                <a16:creationId xmlns:a16="http://schemas.microsoft.com/office/drawing/2014/main" id="{A29C85A6-A25F-4037-B447-115BF41CA24E}"/>
+                <a16:creationId xmlns:a16="http://schemas.microsoft.com/office/drawing/2014/main" id="{073E8210-4201-4218-9B6A-7F9D8789808B}"/>
               </a:ext>
             </a:extLst>
           </p:cNvPr>
@@ -4234,7 +4234,7 @@
           <p:cNvPr id="6" name="Footer Placeholder 5">
             <a:extLst xmlns:a="http://schemas.openxmlformats.org/drawingml/2006/main">
               <a:ext uri="{FF2B5EF4-FFF2-40B4-BE49-F238E27FC236}">
-                <a16:creationId xmlns:a16="http://schemas.microsoft.com/office/drawing/2014/main" id="{9930E315-EED6-4EA0-9FF5-4736C7929A33}"/>
+                <a16:creationId xmlns:a16="http://schemas.microsoft.com/office/drawing/2014/main" id="{B71F4330-5262-4D4D-85B7-6CC100333AE1}"/>
               </a:ext>
             </a:extLst>
           </p:cNvPr>
@@ -4259,7 +4259,7 @@
           <p:cNvPr id="7" name="Slide Number Placeholder 6">
             <a:extLst xmlns:a="http://schemas.openxmlformats.org/drawingml/2006/main">
               <a:ext uri="{FF2B5EF4-FFF2-40B4-BE49-F238E27FC236}">
-                <a16:creationId xmlns:a16="http://schemas.microsoft.com/office/drawing/2014/main" id="{5C637C4E-F129-4F46-BF28-64E2DD128D8D}"/>
+                <a16:creationId xmlns:a16="http://schemas.microsoft.com/office/drawing/2014/main" id="{1D504ADB-B612-4E95-A5D8-13BDAC41BD07}"/>
               </a:ext>
             </a:extLst>
           </p:cNvPr>
@@ -4309,7 +4309,7 @@
           <p:cNvPr id="2" name="Title Placeholder 1">
             <a:extLst xmlns:a="http://schemas.openxmlformats.org/drawingml/2006/main">
               <a:ext uri="{FF2B5EF4-FFF2-40B4-BE49-F238E27FC236}">
-                <a16:creationId xmlns:a16="http://schemas.microsoft.com/office/drawing/2014/main" id="{ECD6DF1E-9BC0-49D1-817A-87D81EAF2FFF}"/>
+                <a16:creationId xmlns:a16="http://schemas.microsoft.com/office/drawing/2014/main" id="{1FC9767C-250C-4495-9E87-57F5E055A207}"/>
               </a:ext>
             </a:extLst>
           </p:cNvPr>
@@ -4347,7 +4347,7 @@
           <p:cNvPr id="3" name="Text Placeholder 2">
             <a:extLst xmlns:a="http://schemas.openxmlformats.org/drawingml/2006/main">
               <a:ext uri="{FF2B5EF4-FFF2-40B4-BE49-F238E27FC236}">
-                <a16:creationId xmlns:a16="http://schemas.microsoft.com/office/drawing/2014/main" id="{9970E215-33B6-47F0-B301-2F166D27808D}"/>
+                <a16:creationId xmlns:a16="http://schemas.microsoft.com/office/drawing/2014/main" id="{E8594496-FF93-47D6-8431-1D7A177736D4}"/>
               </a:ext>
             </a:extLst>
           </p:cNvPr>
@@ -4420,7 +4420,7 @@
           <p:cNvPr id="4" name="Date Placeholder 3">
             <a:extLst xmlns:a="http://schemas.openxmlformats.org/drawingml/2006/main">
               <a:ext uri="{FF2B5EF4-FFF2-40B4-BE49-F238E27FC236}">
-                <a16:creationId xmlns:a16="http://schemas.microsoft.com/office/drawing/2014/main" id="{80971FA2-06F4-46C9-AA6D-D5DB77EEEC42}"/>
+                <a16:creationId xmlns:a16="http://schemas.microsoft.com/office/drawing/2014/main" id="{C3A523DF-00DB-4B51-B915-7654C6061530}"/>
               </a:ext>
             </a:extLst>
           </p:cNvPr>
@@ -4467,7 +4467,7 @@
           <p:cNvPr id="5" name="Footer Placeholder 4">
             <a:extLst xmlns:a="http://schemas.openxmlformats.org/drawingml/2006/main">
               <a:ext uri="{FF2B5EF4-FFF2-40B4-BE49-F238E27FC236}">
-                <a16:creationId xmlns:a16="http://schemas.microsoft.com/office/drawing/2014/main" id="{7211908E-1A9A-4654-9BCE-853212201D1F}"/>
+                <a16:creationId xmlns:a16="http://schemas.microsoft.com/office/drawing/2014/main" id="{86BDB433-D7B3-46F8-AD63-518BCB96CC60}"/>
               </a:ext>
             </a:extLst>
           </p:cNvPr>
@@ -4511,7 +4511,7 @@
           <p:cNvPr id="6" name="Slide Number Placeholder 5">
             <a:extLst xmlns:a="http://schemas.openxmlformats.org/drawingml/2006/main">
               <a:ext uri="{FF2B5EF4-FFF2-40B4-BE49-F238E27FC236}">
-                <a16:creationId xmlns:a16="http://schemas.microsoft.com/office/drawing/2014/main" id="{4638E421-4D94-4DF3-8CCE-F05D679D2E1E}"/>
+                <a16:creationId xmlns:a16="http://schemas.microsoft.com/office/drawing/2014/main" id="{1FFDEB83-1840-48E2-B4C1-025730A72DEB}"/>
               </a:ext>
             </a:extLst>
           </p:cNvPr>
@@ -4557,17 +4557,17 @@
   </p:cSld>
   <p:clrMap bg1="lt1" tx1="dk1" bg2="lt2" tx2="dk2" accent1="accent1" accent2="accent2" accent3="accent3" accent4="accent4" accent5="accent5" accent6="accent6" hlink="hlink" folHlink="folHlink"/>
   <p:sldLayoutIdLst>
-    <p:sldLayoutId xmlns:r="http://schemas.openxmlformats.org/officeDocument/2006/relationships" id="2147483649" r:id="Rcee08fda37f045c6"/>
-    <p:sldLayoutId xmlns:r="http://schemas.openxmlformats.org/officeDocument/2006/relationships" id="2147483650" r:id="R36791f7eeb2e4dcf"/>
-    <p:sldLayoutId xmlns:r="http://schemas.openxmlformats.org/officeDocument/2006/relationships" id="2147483651" r:id="Rcab5b21f4fc6489b"/>
-    <p:sldLayoutId xmlns:r="http://schemas.openxmlformats.org/officeDocument/2006/relationships" id="2147483652" r:id="Rac861a4775e14913"/>
-    <p:sldLayoutId xmlns:r="http://schemas.openxmlformats.org/officeDocument/2006/relationships" id="2147483653" r:id="Ra503fe8c42294942"/>
-    <p:sldLayoutId xmlns:r="http://schemas.openxmlformats.org/officeDocument/2006/relationships" id="2147483654" r:id="Rf1fbbcf196c34e8d"/>
-    <p:sldLayoutId xmlns:r="http://schemas.openxmlformats.org/officeDocument/2006/relationships" id="2147483655" r:id="R4efa0766c79d49ba"/>
-    <p:sldLayoutId xmlns:r="http://schemas.openxmlformats.org/officeDocument/2006/relationships" id="2147483656" r:id="Ree8d71ff7b8042a2"/>
-    <p:sldLayoutId xmlns:r="http://schemas.openxmlformats.org/officeDocument/2006/relationships" id="2147483657" r:id="R0634b1ee1cf44fd1"/>
-    <p:sldLayoutId xmlns:r="http://schemas.openxmlformats.org/officeDocument/2006/relationships" id="2147483658" r:id="R7a2db39534734c15"/>
-    <p:sldLayoutId xmlns:r="http://schemas.openxmlformats.org/officeDocument/2006/relationships" id="2147483659" r:id="R7fa461af172741a9"/>
+    <p:sldLayoutId xmlns:r="http://schemas.openxmlformats.org/officeDocument/2006/relationships" id="2147483649" r:id="R6fbba830e2bf44f3"/>
+    <p:sldLayoutId xmlns:r="http://schemas.openxmlformats.org/officeDocument/2006/relationships" id="2147483650" r:id="Rcf53c79d937c43fd"/>
+    <p:sldLayoutId xmlns:r="http://schemas.openxmlformats.org/officeDocument/2006/relationships" id="2147483651" r:id="R6828dca130a14e71"/>
+    <p:sldLayoutId xmlns:r="http://schemas.openxmlformats.org/officeDocument/2006/relationships" id="2147483652" r:id="R655df3797908481c"/>
+    <p:sldLayoutId xmlns:r="http://schemas.openxmlformats.org/officeDocument/2006/relationships" id="2147483653" r:id="R165ab68bd1a9462e"/>
+    <p:sldLayoutId xmlns:r="http://schemas.openxmlformats.org/officeDocument/2006/relationships" id="2147483654" r:id="Rbe9c1803ed3a484e"/>
+    <p:sldLayoutId xmlns:r="http://schemas.openxmlformats.org/officeDocument/2006/relationships" id="2147483655" r:id="R62378c32967c40f9"/>
+    <p:sldLayoutId xmlns:r="http://schemas.openxmlformats.org/officeDocument/2006/relationships" id="2147483656" r:id="Rb464b537dd924951"/>
+    <p:sldLayoutId xmlns:r="http://schemas.openxmlformats.org/officeDocument/2006/relationships" id="2147483657" r:id="Rb7e5dac8e8864181"/>
+    <p:sldLayoutId xmlns:r="http://schemas.openxmlformats.org/officeDocument/2006/relationships" id="2147483658" r:id="R42536b05d6904da3"/>
+    <p:sldLayoutId xmlns:r="http://schemas.openxmlformats.org/officeDocument/2006/relationships" id="2147483659" r:id="R03348f632aee40c2"/>
   </p:sldLayoutIdLst>
   <p:txStyles>
     <p:titleStyle>
@@ -5113,7 +5113,7 @@
           <p:cNvPr id="2" name="Rectangle 1">
             <a:extLst xmlns:a="http://schemas.openxmlformats.org/drawingml/2006/main">
               <a:ext uri="{FF2B5EF4-FFF2-40B4-BE49-F238E27FC236}">
-                <a16:creationId xmlns:a16="http://schemas.microsoft.com/office/drawing/2014/main" id="{E0DBA1F5-EDAD-49E2-BEF0-0A387BA12739}"/>
+                <a16:creationId xmlns:a16="http://schemas.microsoft.com/office/drawing/2014/main" id="{B959BA56-CF1D-4BBA-BF72-05061A0B98C7}"/>
               </a:ext>
             </a:extLst>
           </p:cNvPr>
@@ -5166,7 +5166,7 @@
           <p:cNvPr id="3" name="Rectangle 2">
             <a:extLst xmlns:a="http://schemas.openxmlformats.org/drawingml/2006/main">
               <a:ext uri="{FF2B5EF4-FFF2-40B4-BE49-F238E27FC236}">
-                <a16:creationId xmlns:a16="http://schemas.microsoft.com/office/drawing/2014/main" id="{1EF05680-7F28-4037-AAD0-1330D6D18E97}"/>
+                <a16:creationId xmlns:a16="http://schemas.microsoft.com/office/drawing/2014/main" id="{E03CA2F5-909C-4654-97E4-CFC2F363E2C7}"/>
               </a:ext>
             </a:extLst>
           </p:cNvPr>
@@ -5219,7 +5219,7 @@
           <p:cNvPr id="4" name="TextBox 3">
             <a:extLst xmlns:a="http://schemas.openxmlformats.org/drawingml/2006/main">
               <a:ext uri="{FF2B5EF4-FFF2-40B4-BE49-F238E27FC236}">
-                <a16:creationId xmlns:a16="http://schemas.microsoft.com/office/drawing/2014/main" id="{7039D2C1-E2AF-42AB-B240-3A507C7378F3}"/>
+                <a16:creationId xmlns:a16="http://schemas.microsoft.com/office/drawing/2014/main" id="{E60BEA90-4AE9-4815-8122-47B63F250575}"/>
               </a:ext>
             </a:extLst>
           </p:cNvPr>
@@ -5321,7 +5321,7 @@
     </p:spTree>
     <p:extLst>
       <p:ext uri="{BB962C8B-B14F-4D97-AF65-F5344CB8AC3E}">
-        <p14:creationId xmlns:p14="http://schemas.microsoft.com/office/powerpoint/2010/main" val="2028931425"/>
+        <p14:creationId xmlns:p14="http://schemas.microsoft.com/office/powerpoint/2010/main" val="747883721"/>
       </p:ext>
     </p:extLst>
   </p:cSld>
@@ -5345,7 +5345,7 @@
           <p:cNvPr id="2" name="Rectangle 1">
             <a:extLst xmlns:a="http://schemas.openxmlformats.org/drawingml/2006/main">
               <a:ext uri="{FF2B5EF4-FFF2-40B4-BE49-F238E27FC236}">
-                <a16:creationId xmlns:a16="http://schemas.microsoft.com/office/drawing/2014/main" id="{2F9AD40C-D0CD-4F33-9B6A-B54B129D2C07}"/>
+                <a16:creationId xmlns:a16="http://schemas.microsoft.com/office/drawing/2014/main" id="{D035EBE8-53DD-45B4-88A8-DC99A6640FEC}"/>
               </a:ext>
             </a:extLst>
           </p:cNvPr>
@@ -5398,7 +5398,7 @@
           <p:cNvPr id="3" name="Rectangle 2">
             <a:extLst xmlns:a="http://schemas.openxmlformats.org/drawingml/2006/main">
               <a:ext uri="{FF2B5EF4-FFF2-40B4-BE49-F238E27FC236}">
-                <a16:creationId xmlns:a16="http://schemas.microsoft.com/office/drawing/2014/main" id="{A8A3AAB7-03C7-4D9F-A1F5-D9FF055BB660}"/>
+                <a16:creationId xmlns:a16="http://schemas.microsoft.com/office/drawing/2014/main" id="{4CD44846-3032-4665-A874-9DB23538852C}"/>
               </a:ext>
             </a:extLst>
           </p:cNvPr>
@@ -5451,7 +5451,7 @@
           <p:cNvPr id="4" name="Rectangle 3">
             <a:extLst xmlns:a="http://schemas.openxmlformats.org/drawingml/2006/main">
               <a:ext uri="{FF2B5EF4-FFF2-40B4-BE49-F238E27FC236}">
-                <a16:creationId xmlns:a16="http://schemas.microsoft.com/office/drawing/2014/main" id="{4558FC54-9D35-4A64-A0B1-DB641395266D}"/>
+                <a16:creationId xmlns:a16="http://schemas.microsoft.com/office/drawing/2014/main" id="{541B6A31-FE42-4FDC-BD2F-28666C6A4AF8}"/>
               </a:ext>
             </a:extLst>
           </p:cNvPr>
@@ -5504,7 +5504,7 @@
           <p:cNvPr id="5" name="TextBox 4">
             <a:extLst xmlns:a="http://schemas.openxmlformats.org/drawingml/2006/main">
               <a:ext uri="{FF2B5EF4-FFF2-40B4-BE49-F238E27FC236}">
-                <a16:creationId xmlns:a16="http://schemas.microsoft.com/office/drawing/2014/main" id="{BF2EDFCE-6FDE-4620-924E-58DD16177C36}"/>
+                <a16:creationId xmlns:a16="http://schemas.microsoft.com/office/drawing/2014/main" id="{201C9F79-B2CE-4488-B86D-42A035D4B0E3}"/>
               </a:ext>
             </a:extLst>
           </p:cNvPr>
@@ -5567,7 +5567,7 @@
           <p:cNvPr id="6" name="Rounded Rectangle 5">
             <a:extLst xmlns:a="http://schemas.openxmlformats.org/drawingml/2006/main">
               <a:ext uri="{FF2B5EF4-FFF2-40B4-BE49-F238E27FC236}">
-                <a16:creationId xmlns:a16="http://schemas.microsoft.com/office/drawing/2014/main" id="{361592C9-D48C-415B-8467-F12C9D394E76}"/>
+                <a16:creationId xmlns:a16="http://schemas.microsoft.com/office/drawing/2014/main" id="{369C9FB8-3F1B-484C-82B2-7E43D80A6041}"/>
               </a:ext>
             </a:extLst>
           </p:cNvPr>
@@ -5622,7 +5622,7 @@
           <p:cNvPr id="7" name="TextBox 6">
             <a:extLst xmlns:a="http://schemas.openxmlformats.org/drawingml/2006/main">
               <a:ext uri="{FF2B5EF4-FFF2-40B4-BE49-F238E27FC236}">
-                <a16:creationId xmlns:a16="http://schemas.microsoft.com/office/drawing/2014/main" id="{1539E09D-42D1-46F0-9DAD-EBA61E566E26}"/>
+                <a16:creationId xmlns:a16="http://schemas.microsoft.com/office/drawing/2014/main" id="{EB7D4578-8594-416E-B8F7-9F861D1E7A49}"/>
               </a:ext>
             </a:extLst>
           </p:cNvPr>
@@ -5726,7 +5726,7 @@
           <p:cNvPr id="8" name="Rounded Rectangle 7">
             <a:extLst xmlns:a="http://schemas.openxmlformats.org/drawingml/2006/main">
               <a:ext uri="{FF2B5EF4-FFF2-40B4-BE49-F238E27FC236}">
-                <a16:creationId xmlns:a16="http://schemas.microsoft.com/office/drawing/2014/main" id="{252B45E2-C014-482A-BD80-D3D25CAD3AC9}"/>
+                <a16:creationId xmlns:a16="http://schemas.microsoft.com/office/drawing/2014/main" id="{9CE6973E-3518-4EE3-A2D7-994A0E635478}"/>
               </a:ext>
             </a:extLst>
           </p:cNvPr>
@@ -5781,7 +5781,7 @@
           <p:cNvPr id="9" name="TextBox 8">
             <a:extLst xmlns:a="http://schemas.openxmlformats.org/drawingml/2006/main">
               <a:ext uri="{FF2B5EF4-FFF2-40B4-BE49-F238E27FC236}">
-                <a16:creationId xmlns:a16="http://schemas.microsoft.com/office/drawing/2014/main" id="{97EA0682-ED7A-4A4B-877D-703C755C57A0}"/>
+                <a16:creationId xmlns:a16="http://schemas.microsoft.com/office/drawing/2014/main" id="{E0C36BE4-7CA5-458D-9FB0-5B698D16067D}"/>
               </a:ext>
             </a:extLst>
           </p:cNvPr>
@@ -5866,7 +5866,7 @@
           <p:cNvPr id="10" name="Rounded Rectangle 9">
             <a:extLst xmlns:a="http://schemas.openxmlformats.org/drawingml/2006/main">
               <a:ext uri="{FF2B5EF4-FFF2-40B4-BE49-F238E27FC236}">
-                <a16:creationId xmlns:a16="http://schemas.microsoft.com/office/drawing/2014/main" id="{9300663A-57F7-4BB5-9CC8-F033FB0F66B0}"/>
+                <a16:creationId xmlns:a16="http://schemas.microsoft.com/office/drawing/2014/main" id="{CA95DEB7-E756-4724-B9F8-C29E83263C12}"/>
               </a:ext>
             </a:extLst>
           </p:cNvPr>
@@ -5921,7 +5921,7 @@
           <p:cNvPr id="11" name="TextBox 10">
             <a:extLst xmlns:a="http://schemas.openxmlformats.org/drawingml/2006/main">
               <a:ext uri="{FF2B5EF4-FFF2-40B4-BE49-F238E27FC236}">
-                <a16:creationId xmlns:a16="http://schemas.microsoft.com/office/drawing/2014/main" id="{1D826F69-571F-4FD0-B867-E52F10851802}"/>
+                <a16:creationId xmlns:a16="http://schemas.microsoft.com/office/drawing/2014/main" id="{B5477A4D-0990-4359-B0BF-9E1814D8F50B}"/>
               </a:ext>
             </a:extLst>
           </p:cNvPr>
@@ -6023,7 +6023,7 @@
     </p:spTree>
     <p:extLst>
       <p:ext uri="{BB962C8B-B14F-4D97-AF65-F5344CB8AC3E}">
-        <p14:creationId xmlns:p14="http://schemas.microsoft.com/office/powerpoint/2010/main" val="733324667"/>
+        <p14:creationId xmlns:p14="http://schemas.microsoft.com/office/powerpoint/2010/main" val="1704285524"/>
       </p:ext>
     </p:extLst>
   </p:cSld>
@@ -6047,7 +6047,7 @@
           <p:cNvPr id="2" name="Rectangle 1">
             <a:extLst xmlns:a="http://schemas.openxmlformats.org/drawingml/2006/main">
               <a:ext uri="{FF2B5EF4-FFF2-40B4-BE49-F238E27FC236}">
-                <a16:creationId xmlns:a16="http://schemas.microsoft.com/office/drawing/2014/main" id="{49B8E7FD-4EA8-4904-9272-81ACBAFE91C1}"/>
+                <a16:creationId xmlns:a16="http://schemas.microsoft.com/office/drawing/2014/main" id="{2FFABAE1-FF17-47D0-9C48-F05D44B445F4}"/>
               </a:ext>
             </a:extLst>
           </p:cNvPr>
@@ -6100,7 +6100,7 @@
           <p:cNvPr id="3" name="Rectangle 2">
             <a:extLst xmlns:a="http://schemas.openxmlformats.org/drawingml/2006/main">
               <a:ext uri="{FF2B5EF4-FFF2-40B4-BE49-F238E27FC236}">
-                <a16:creationId xmlns:a16="http://schemas.microsoft.com/office/drawing/2014/main" id="{220BB2E2-7BCD-4650-8C7B-FDCDC1728D78}"/>
+                <a16:creationId xmlns:a16="http://schemas.microsoft.com/office/drawing/2014/main" id="{E27E8A66-3F9A-40AA-AA0C-9EFBDFBF7FD1}"/>
               </a:ext>
             </a:extLst>
           </p:cNvPr>
@@ -6153,7 +6153,7 @@
           <p:cNvPr id="4" name="Rectangle 3">
             <a:extLst xmlns:a="http://schemas.openxmlformats.org/drawingml/2006/main">
               <a:ext uri="{FF2B5EF4-FFF2-40B4-BE49-F238E27FC236}">
-                <a16:creationId xmlns:a16="http://schemas.microsoft.com/office/drawing/2014/main" id="{38A5135E-D1BE-4854-A8CD-0755E90558BF}"/>
+                <a16:creationId xmlns:a16="http://schemas.microsoft.com/office/drawing/2014/main" id="{919A8047-8884-42B9-81E8-1815DF8B0DC3}"/>
               </a:ext>
             </a:extLst>
           </p:cNvPr>
@@ -6206,7 +6206,7 @@
           <p:cNvPr id="5" name="TextBox 4">
             <a:extLst xmlns:a="http://schemas.openxmlformats.org/drawingml/2006/main">
               <a:ext uri="{FF2B5EF4-FFF2-40B4-BE49-F238E27FC236}">
-                <a16:creationId xmlns:a16="http://schemas.microsoft.com/office/drawing/2014/main" id="{881FC1C7-8E00-44B5-A3D9-7F1125CF73D2}"/>
+                <a16:creationId xmlns:a16="http://schemas.microsoft.com/office/drawing/2014/main" id="{543EEE72-DEDE-4489-B2CD-A1F67E8ED7F5}"/>
               </a:ext>
             </a:extLst>
           </p:cNvPr>
@@ -6269,7 +6269,7 @@
           <p:cNvPr id="6" name="Rounded Rectangle 5">
             <a:extLst xmlns:a="http://schemas.openxmlformats.org/drawingml/2006/main">
               <a:ext uri="{FF2B5EF4-FFF2-40B4-BE49-F238E27FC236}">
-                <a16:creationId xmlns:a16="http://schemas.microsoft.com/office/drawing/2014/main" id="{D09A8FEA-5DDD-4469-9473-2F1ACBA8D9DC}"/>
+                <a16:creationId xmlns:a16="http://schemas.microsoft.com/office/drawing/2014/main" id="{B9F91D04-F16A-434B-84B3-CA801F111095}"/>
               </a:ext>
             </a:extLst>
           </p:cNvPr>
@@ -6324,7 +6324,7 @@
           <p:cNvPr id="7" name="TextBox 6">
             <a:extLst xmlns:a="http://schemas.openxmlformats.org/drawingml/2006/main">
               <a:ext uri="{FF2B5EF4-FFF2-40B4-BE49-F238E27FC236}">
-                <a16:creationId xmlns:a16="http://schemas.microsoft.com/office/drawing/2014/main" id="{120FB8D9-C369-46E8-876F-997B1DF8E8CE}"/>
+                <a16:creationId xmlns:a16="http://schemas.microsoft.com/office/drawing/2014/main" id="{99A98039-C969-434E-A561-AC2F6095A8BB}"/>
               </a:ext>
             </a:extLst>
           </p:cNvPr>
@@ -6523,7 +6523,7 @@
           <p:cNvPr id="8" name="Rounded Rectangle 7">
             <a:extLst xmlns:a="http://schemas.openxmlformats.org/drawingml/2006/main">
               <a:ext uri="{FF2B5EF4-FFF2-40B4-BE49-F238E27FC236}">
-                <a16:creationId xmlns:a16="http://schemas.microsoft.com/office/drawing/2014/main" id="{8A14E537-EA72-46DD-9E26-33372B364A01}"/>
+                <a16:creationId xmlns:a16="http://schemas.microsoft.com/office/drawing/2014/main" id="{834515B1-FA97-48DA-BC78-59A4E2D0CADB}"/>
               </a:ext>
             </a:extLst>
           </p:cNvPr>
@@ -6578,7 +6578,7 @@
           <p:cNvPr id="9" name="TextBox 8">
             <a:extLst xmlns:a="http://schemas.openxmlformats.org/drawingml/2006/main">
               <a:ext uri="{FF2B5EF4-FFF2-40B4-BE49-F238E27FC236}">
-                <a16:creationId xmlns:a16="http://schemas.microsoft.com/office/drawing/2014/main" id="{7C852D77-A1D4-4F0C-B18B-203BCFAB24A8}"/>
+                <a16:creationId xmlns:a16="http://schemas.microsoft.com/office/drawing/2014/main" id="{1ED0C34F-3BE1-4104-9DFC-C75BC952D566}"/>
               </a:ext>
             </a:extLst>
           </p:cNvPr>
@@ -6699,7 +6699,7 @@
     </p:spTree>
     <p:extLst>
       <p:ext uri="{BB962C8B-B14F-4D97-AF65-F5344CB8AC3E}">
-        <p14:creationId xmlns:p14="http://schemas.microsoft.com/office/powerpoint/2010/main" val="2009182731"/>
+        <p14:creationId xmlns:p14="http://schemas.microsoft.com/office/powerpoint/2010/main" val="1331033048"/>
       </p:ext>
     </p:extLst>
   </p:cSld>
@@ -6723,7 +6723,7 @@
           <p:cNvPr id="2" name="Rectangle 1">
             <a:extLst xmlns:a="http://schemas.openxmlformats.org/drawingml/2006/main">
               <a:ext uri="{FF2B5EF4-FFF2-40B4-BE49-F238E27FC236}">
-                <a16:creationId xmlns:a16="http://schemas.microsoft.com/office/drawing/2014/main" id="{209929C7-D563-4E95-B7E8-B863E661347B}"/>
+                <a16:creationId xmlns:a16="http://schemas.microsoft.com/office/drawing/2014/main" id="{0BB52EC8-E2E4-4C5B-AD9C-34AA3201A407}"/>
               </a:ext>
             </a:extLst>
           </p:cNvPr>
@@ -6776,7 +6776,7 @@
           <p:cNvPr id="3" name="Rectangle 2">
             <a:extLst xmlns:a="http://schemas.openxmlformats.org/drawingml/2006/main">
               <a:ext uri="{FF2B5EF4-FFF2-40B4-BE49-F238E27FC236}">
-                <a16:creationId xmlns:a16="http://schemas.microsoft.com/office/drawing/2014/main" id="{21FFB2B4-5B74-45E1-95E2-2AF326FE3C9D}"/>
+                <a16:creationId xmlns:a16="http://schemas.microsoft.com/office/drawing/2014/main" id="{2A541938-7315-4F3B-B40E-D4C80FCC3527}"/>
               </a:ext>
             </a:extLst>
           </p:cNvPr>
@@ -6829,7 +6829,7 @@
           <p:cNvPr id="4" name="TextBox 3">
             <a:extLst xmlns:a="http://schemas.openxmlformats.org/drawingml/2006/main">
               <a:ext uri="{FF2B5EF4-FFF2-40B4-BE49-F238E27FC236}">
-                <a16:creationId xmlns:a16="http://schemas.microsoft.com/office/drawing/2014/main" id="{6F661533-EF29-400D-AACC-19304E41D1AF}"/>
+                <a16:creationId xmlns:a16="http://schemas.microsoft.com/office/drawing/2014/main" id="{5F149EF5-3AB6-4FEB-9594-C48DA41E8A71}"/>
               </a:ext>
             </a:extLst>
           </p:cNvPr>
@@ -7007,7 +7007,7 @@
     </p:spTree>
     <p:extLst>
       <p:ext uri="{BB962C8B-B14F-4D97-AF65-F5344CB8AC3E}">
-        <p14:creationId xmlns:p14="http://schemas.microsoft.com/office/powerpoint/2010/main" val="2022037832"/>
+        <p14:creationId xmlns:p14="http://schemas.microsoft.com/office/powerpoint/2010/main" val="635446557"/>
       </p:ext>
     </p:extLst>
   </p:cSld>
@@ -7031,7 +7031,7 @@
           <p:cNvPr id="2" name="Rectangle 1">
             <a:extLst xmlns:a="http://schemas.openxmlformats.org/drawingml/2006/main">
               <a:ext uri="{FF2B5EF4-FFF2-40B4-BE49-F238E27FC236}">
-                <a16:creationId xmlns:a16="http://schemas.microsoft.com/office/drawing/2014/main" id="{3CFD2998-13E2-4E2A-B29F-4B57AC0E7273}"/>
+                <a16:creationId xmlns:a16="http://schemas.microsoft.com/office/drawing/2014/main" id="{A7AC01FD-E0BE-4CA2-9728-D1692C7CAAAC}"/>
               </a:ext>
             </a:extLst>
           </p:cNvPr>
@@ -7084,7 +7084,7 @@
           <p:cNvPr id="3" name="Rectangle 2">
             <a:extLst xmlns:a="http://schemas.openxmlformats.org/drawingml/2006/main">
               <a:ext uri="{FF2B5EF4-FFF2-40B4-BE49-F238E27FC236}">
-                <a16:creationId xmlns:a16="http://schemas.microsoft.com/office/drawing/2014/main" id="{D726062E-DFB9-4844-BBE5-EB0EFBE1959C}"/>
+                <a16:creationId xmlns:a16="http://schemas.microsoft.com/office/drawing/2014/main" id="{6CC34BA4-B19C-4589-88DA-4E1B06762FF2}"/>
               </a:ext>
             </a:extLst>
           </p:cNvPr>
@@ -7137,7 +7137,7 @@
           <p:cNvPr id="4" name="Rectangle 3">
             <a:extLst xmlns:a="http://schemas.openxmlformats.org/drawingml/2006/main">
               <a:ext uri="{FF2B5EF4-FFF2-40B4-BE49-F238E27FC236}">
-                <a16:creationId xmlns:a16="http://schemas.microsoft.com/office/drawing/2014/main" id="{D9CB8954-CE97-4062-BBD2-A32747E89514}"/>
+                <a16:creationId xmlns:a16="http://schemas.microsoft.com/office/drawing/2014/main" id="{2B2E2DBE-53DE-46CA-A2FE-AF81E63281D7}"/>
               </a:ext>
             </a:extLst>
           </p:cNvPr>
@@ -7190,7 +7190,7 @@
           <p:cNvPr id="5" name="TextBox 4">
             <a:extLst xmlns:a="http://schemas.openxmlformats.org/drawingml/2006/main">
               <a:ext uri="{FF2B5EF4-FFF2-40B4-BE49-F238E27FC236}">
-                <a16:creationId xmlns:a16="http://schemas.microsoft.com/office/drawing/2014/main" id="{E9E63F22-0F57-48DD-B138-B2ADFF331DAA}"/>
+                <a16:creationId xmlns:a16="http://schemas.microsoft.com/office/drawing/2014/main" id="{AA7DD74E-589F-4D6E-ACBE-AD1FB904E681}"/>
               </a:ext>
             </a:extLst>
           </p:cNvPr>
@@ -7253,7 +7253,7 @@
           <p:cNvPr id="6" name="Rounded Rectangle 5">
             <a:extLst xmlns:a="http://schemas.openxmlformats.org/drawingml/2006/main">
               <a:ext uri="{FF2B5EF4-FFF2-40B4-BE49-F238E27FC236}">
-                <a16:creationId xmlns:a16="http://schemas.microsoft.com/office/drawing/2014/main" id="{87EC5E4D-1D46-4EC2-83FF-4A5876E6AA30}"/>
+                <a16:creationId xmlns:a16="http://schemas.microsoft.com/office/drawing/2014/main" id="{4011CF02-8CDC-4560-814B-3DF01DA5CB27}"/>
               </a:ext>
             </a:extLst>
           </p:cNvPr>
@@ -7308,7 +7308,7 @@
           <p:cNvPr id="7" name="TextBox 6">
             <a:extLst xmlns:a="http://schemas.openxmlformats.org/drawingml/2006/main">
               <a:ext uri="{FF2B5EF4-FFF2-40B4-BE49-F238E27FC236}">
-                <a16:creationId xmlns:a16="http://schemas.microsoft.com/office/drawing/2014/main" id="{F112B2E7-3E64-460E-9B26-3A85056ACE0D}"/>
+                <a16:creationId xmlns:a16="http://schemas.microsoft.com/office/drawing/2014/main" id="{96BA2453-E1DB-467A-B761-6586ACE30EEB}"/>
               </a:ext>
             </a:extLst>
           </p:cNvPr>
@@ -7412,7 +7412,7 @@
           <p:cNvPr id="8" name="Rounded Rectangle 7">
             <a:extLst xmlns:a="http://schemas.openxmlformats.org/drawingml/2006/main">
               <a:ext uri="{FF2B5EF4-FFF2-40B4-BE49-F238E27FC236}">
-                <a16:creationId xmlns:a16="http://schemas.microsoft.com/office/drawing/2014/main" id="{362923ED-6233-4087-9469-09D5AD9D3114}"/>
+                <a16:creationId xmlns:a16="http://schemas.microsoft.com/office/drawing/2014/main" id="{BE34707B-5640-4432-98F4-BB8D9766398D}"/>
               </a:ext>
             </a:extLst>
           </p:cNvPr>
@@ -7467,7 +7467,7 @@
           <p:cNvPr id="9" name="TextBox 8">
             <a:extLst xmlns:a="http://schemas.openxmlformats.org/drawingml/2006/main">
               <a:ext uri="{FF2B5EF4-FFF2-40B4-BE49-F238E27FC236}">
-                <a16:creationId xmlns:a16="http://schemas.microsoft.com/office/drawing/2014/main" id="{899587D2-F8CF-4CB5-B1C7-DA4F684372AF}"/>
+                <a16:creationId xmlns:a16="http://schemas.microsoft.com/office/drawing/2014/main" id="{4C1E83E0-1E31-4190-82AD-F6539C12E080}"/>
               </a:ext>
             </a:extLst>
           </p:cNvPr>
@@ -7571,7 +7571,7 @@
           <p:cNvPr id="10" name="Rounded Rectangle 9">
             <a:extLst xmlns:a="http://schemas.openxmlformats.org/drawingml/2006/main">
               <a:ext uri="{FF2B5EF4-FFF2-40B4-BE49-F238E27FC236}">
-                <a16:creationId xmlns:a16="http://schemas.microsoft.com/office/drawing/2014/main" id="{F105BCBF-A08D-4411-AEC1-B48043FA6B45}"/>
+                <a16:creationId xmlns:a16="http://schemas.microsoft.com/office/drawing/2014/main" id="{8AAE9A99-093F-466F-8395-A38F016D77F0}"/>
               </a:ext>
             </a:extLst>
           </p:cNvPr>
@@ -7626,7 +7626,7 @@
           <p:cNvPr id="11" name="TextBox 10">
             <a:extLst xmlns:a="http://schemas.openxmlformats.org/drawingml/2006/main">
               <a:ext uri="{FF2B5EF4-FFF2-40B4-BE49-F238E27FC236}">
-                <a16:creationId xmlns:a16="http://schemas.microsoft.com/office/drawing/2014/main" id="{CF6422EA-E120-497D-B573-304557CE7825}"/>
+                <a16:creationId xmlns:a16="http://schemas.microsoft.com/office/drawing/2014/main" id="{99B55F59-54F1-4FB9-8401-146AA8BC7239}"/>
               </a:ext>
             </a:extLst>
           </p:cNvPr>
@@ -7785,7 +7785,7 @@
     </p:spTree>
     <p:extLst>
       <p:ext uri="{BB962C8B-B14F-4D97-AF65-F5344CB8AC3E}">
-        <p14:creationId xmlns:p14="http://schemas.microsoft.com/office/powerpoint/2010/main" val="1654501419"/>
+        <p14:creationId xmlns:p14="http://schemas.microsoft.com/office/powerpoint/2010/main" val="1056427338"/>
       </p:ext>
     </p:extLst>
   </p:cSld>
@@ -7809,7 +7809,7 @@
           <p:cNvPr id="2" name="Rectangle 1">
             <a:extLst xmlns:a="http://schemas.openxmlformats.org/drawingml/2006/main">
               <a:ext uri="{FF2B5EF4-FFF2-40B4-BE49-F238E27FC236}">
-                <a16:creationId xmlns:a16="http://schemas.microsoft.com/office/drawing/2014/main" id="{1ED8B4B8-ED80-49DE-8465-0CA06781B361}"/>
+                <a16:creationId xmlns:a16="http://schemas.microsoft.com/office/drawing/2014/main" id="{C8841C0A-8121-43F1-93A7-332460336295}"/>
               </a:ext>
             </a:extLst>
           </p:cNvPr>
@@ -7862,7 +7862,7 @@
           <p:cNvPr id="3" name="Rectangle 2">
             <a:extLst xmlns:a="http://schemas.openxmlformats.org/drawingml/2006/main">
               <a:ext uri="{FF2B5EF4-FFF2-40B4-BE49-F238E27FC236}">
-                <a16:creationId xmlns:a16="http://schemas.microsoft.com/office/drawing/2014/main" id="{685B1301-9721-4C77-9913-7D7BF334C8EF}"/>
+                <a16:creationId xmlns:a16="http://schemas.microsoft.com/office/drawing/2014/main" id="{ACBA789D-266C-46C4-A3A0-3A6D4EC0AB6A}"/>
               </a:ext>
             </a:extLst>
           </p:cNvPr>
@@ -7915,7 +7915,7 @@
           <p:cNvPr id="4" name="Rectangle 3">
             <a:extLst xmlns:a="http://schemas.openxmlformats.org/drawingml/2006/main">
               <a:ext uri="{FF2B5EF4-FFF2-40B4-BE49-F238E27FC236}">
-                <a16:creationId xmlns:a16="http://schemas.microsoft.com/office/drawing/2014/main" id="{7CB6E120-966A-4C87-B20E-73D1633CCC06}"/>
+                <a16:creationId xmlns:a16="http://schemas.microsoft.com/office/drawing/2014/main" id="{C4790685-BFFF-4697-9F29-2FC59E31D121}"/>
               </a:ext>
             </a:extLst>
           </p:cNvPr>
@@ -7968,7 +7968,7 @@
           <p:cNvPr id="5" name="TextBox 4">
             <a:extLst xmlns:a="http://schemas.openxmlformats.org/drawingml/2006/main">
               <a:ext uri="{FF2B5EF4-FFF2-40B4-BE49-F238E27FC236}">
-                <a16:creationId xmlns:a16="http://schemas.microsoft.com/office/drawing/2014/main" id="{C7F5A2F4-00AA-4875-B042-ECAE6DC17291}"/>
+                <a16:creationId xmlns:a16="http://schemas.microsoft.com/office/drawing/2014/main" id="{2D9861AB-3B2E-4344-A5DA-BF2C24F3FEDA}"/>
               </a:ext>
             </a:extLst>
           </p:cNvPr>
@@ -8031,7 +8031,7 @@
           <p:cNvPr id="6" name="Rounded Rectangle 5">
             <a:extLst xmlns:a="http://schemas.openxmlformats.org/drawingml/2006/main">
               <a:ext uri="{FF2B5EF4-FFF2-40B4-BE49-F238E27FC236}">
-                <a16:creationId xmlns:a16="http://schemas.microsoft.com/office/drawing/2014/main" id="{5A440847-36D1-4E77-97EE-D3A080B140B3}"/>
+                <a16:creationId xmlns:a16="http://schemas.microsoft.com/office/drawing/2014/main" id="{98D1B0AD-3396-419F-AC44-1A621FCB296A}"/>
               </a:ext>
             </a:extLst>
           </p:cNvPr>
@@ -8086,7 +8086,7 @@
           <p:cNvPr id="7" name="TextBox 6">
             <a:extLst xmlns:a="http://schemas.openxmlformats.org/drawingml/2006/main">
               <a:ext uri="{FF2B5EF4-FFF2-40B4-BE49-F238E27FC236}">
-                <a16:creationId xmlns:a16="http://schemas.microsoft.com/office/drawing/2014/main" id="{57B0E7E2-2FD5-4B01-A724-660B7C446609}"/>
+                <a16:creationId xmlns:a16="http://schemas.microsoft.com/office/drawing/2014/main" id="{306C2415-F573-4A41-8AAB-F155FF9274F9}"/>
               </a:ext>
             </a:extLst>
           </p:cNvPr>
@@ -8209,7 +8209,7 @@
           <p:cNvPr id="8" name="Rounded Rectangle 7">
             <a:extLst xmlns:a="http://schemas.openxmlformats.org/drawingml/2006/main">
               <a:ext uri="{FF2B5EF4-FFF2-40B4-BE49-F238E27FC236}">
-                <a16:creationId xmlns:a16="http://schemas.microsoft.com/office/drawing/2014/main" id="{BE50C756-5468-4EB8-8C1B-DAD07582A560}"/>
+                <a16:creationId xmlns:a16="http://schemas.microsoft.com/office/drawing/2014/main" id="{FBD03D21-1E70-438C-ACB7-0FEEE1CEAFFF}"/>
               </a:ext>
             </a:extLst>
           </p:cNvPr>
@@ -8264,7 +8264,7 @@
           <p:cNvPr id="9" name="TextBox 8">
             <a:extLst xmlns:a="http://schemas.openxmlformats.org/drawingml/2006/main">
               <a:ext uri="{FF2B5EF4-FFF2-40B4-BE49-F238E27FC236}">
-                <a16:creationId xmlns:a16="http://schemas.microsoft.com/office/drawing/2014/main" id="{FE8E9DDC-53CE-42B0-BE1E-B3B603C033CD}"/>
+                <a16:creationId xmlns:a16="http://schemas.microsoft.com/office/drawing/2014/main" id="{87849F11-5B1A-42DD-B840-7DBCCB7C78D0}"/>
               </a:ext>
             </a:extLst>
           </p:cNvPr>
@@ -8406,7 +8406,7 @@
           <p:cNvPr id="10" name="Rounded Rectangle 9">
             <a:extLst xmlns:a="http://schemas.openxmlformats.org/drawingml/2006/main">
               <a:ext uri="{FF2B5EF4-FFF2-40B4-BE49-F238E27FC236}">
-                <a16:creationId xmlns:a16="http://schemas.microsoft.com/office/drawing/2014/main" id="{BEF7CB82-B488-4730-B7DC-58FC6590A789}"/>
+                <a16:creationId xmlns:a16="http://schemas.microsoft.com/office/drawing/2014/main" id="{543CB129-0D2D-4A90-BBFE-A8AA966953DA}"/>
               </a:ext>
             </a:extLst>
           </p:cNvPr>
@@ -8461,7 +8461,7 @@
           <p:cNvPr id="11" name="TextBox 10">
             <a:extLst xmlns:a="http://schemas.openxmlformats.org/drawingml/2006/main">
               <a:ext uri="{FF2B5EF4-FFF2-40B4-BE49-F238E27FC236}">
-                <a16:creationId xmlns:a16="http://schemas.microsoft.com/office/drawing/2014/main" id="{034A021A-C113-4C34-AA37-AA73124234F8}"/>
+                <a16:creationId xmlns:a16="http://schemas.microsoft.com/office/drawing/2014/main" id="{726D0067-9579-48ED-ACC0-A386053B2A38}"/>
               </a:ext>
             </a:extLst>
           </p:cNvPr>
@@ -8563,7 +8563,7 @@
     </p:spTree>
     <p:extLst>
       <p:ext uri="{BB962C8B-B14F-4D97-AF65-F5344CB8AC3E}">
-        <p14:creationId xmlns:p14="http://schemas.microsoft.com/office/powerpoint/2010/main" val="1138726834"/>
+        <p14:creationId xmlns:p14="http://schemas.microsoft.com/office/powerpoint/2010/main" val="959810390"/>
       </p:ext>
     </p:extLst>
   </p:cSld>
@@ -8587,7 +8587,7 @@
           <p:cNvPr id="2" name="Rectangle 1">
             <a:extLst xmlns:a="http://schemas.openxmlformats.org/drawingml/2006/main">
               <a:ext uri="{FF2B5EF4-FFF2-40B4-BE49-F238E27FC236}">
-                <a16:creationId xmlns:a16="http://schemas.microsoft.com/office/drawing/2014/main" id="{C06A0E81-112E-4DE7-8A27-D718881C10C7}"/>
+                <a16:creationId xmlns:a16="http://schemas.microsoft.com/office/drawing/2014/main" id="{1D192B5B-44D2-4E94-B034-C88E3D06D7D0}"/>
               </a:ext>
             </a:extLst>
           </p:cNvPr>
@@ -8640,7 +8640,7 @@
           <p:cNvPr id="3" name="Rectangle 2">
             <a:extLst xmlns:a="http://schemas.openxmlformats.org/drawingml/2006/main">
               <a:ext uri="{FF2B5EF4-FFF2-40B4-BE49-F238E27FC236}">
-                <a16:creationId xmlns:a16="http://schemas.microsoft.com/office/drawing/2014/main" id="{169B8B6B-4ED1-44A5-9892-94B6C92973FF}"/>
+                <a16:creationId xmlns:a16="http://schemas.microsoft.com/office/drawing/2014/main" id="{46C6F833-C7C4-498F-8B00-2E6B5D433EDF}"/>
               </a:ext>
             </a:extLst>
           </p:cNvPr>
@@ -8693,7 +8693,7 @@
           <p:cNvPr id="4" name="Rectangle 3">
             <a:extLst xmlns:a="http://schemas.openxmlformats.org/drawingml/2006/main">
               <a:ext uri="{FF2B5EF4-FFF2-40B4-BE49-F238E27FC236}">
-                <a16:creationId xmlns:a16="http://schemas.microsoft.com/office/drawing/2014/main" id="{C8233F66-6D28-4589-AF22-390BB356F0A1}"/>
+                <a16:creationId xmlns:a16="http://schemas.microsoft.com/office/drawing/2014/main" id="{A5FC2171-3405-42CB-841D-16B599E543C5}"/>
               </a:ext>
             </a:extLst>
           </p:cNvPr>
@@ -8746,7 +8746,7 @@
           <p:cNvPr id="5" name="TextBox 4">
             <a:extLst xmlns:a="http://schemas.openxmlformats.org/drawingml/2006/main">
               <a:ext uri="{FF2B5EF4-FFF2-40B4-BE49-F238E27FC236}">
-                <a16:creationId xmlns:a16="http://schemas.microsoft.com/office/drawing/2014/main" id="{2F019A34-6732-436D-AC98-6C05AF962EC5}"/>
+                <a16:creationId xmlns:a16="http://schemas.microsoft.com/office/drawing/2014/main" id="{3488690E-6EDA-4B87-B6CF-9FD154DA6C3C}"/>
               </a:ext>
             </a:extLst>
           </p:cNvPr>
@@ -8809,7 +8809,7 @@
           <p:cNvPr id="6" name="Rounded Rectangle 5">
             <a:extLst xmlns:a="http://schemas.openxmlformats.org/drawingml/2006/main">
               <a:ext uri="{FF2B5EF4-FFF2-40B4-BE49-F238E27FC236}">
-                <a16:creationId xmlns:a16="http://schemas.microsoft.com/office/drawing/2014/main" id="{D6C863BE-087A-40A8-A986-CB8123E9AE1E}"/>
+                <a16:creationId xmlns:a16="http://schemas.microsoft.com/office/drawing/2014/main" id="{EC891EDF-7372-4FF4-A822-5FD38EEA920E}"/>
               </a:ext>
             </a:extLst>
           </p:cNvPr>
@@ -8864,7 +8864,7 @@
           <p:cNvPr id="7" name="TextBox 6">
             <a:extLst xmlns:a="http://schemas.openxmlformats.org/drawingml/2006/main">
               <a:ext uri="{FF2B5EF4-FFF2-40B4-BE49-F238E27FC236}">
-                <a16:creationId xmlns:a16="http://schemas.microsoft.com/office/drawing/2014/main" id="{49F5DC73-117B-47A3-9C10-204AC772D1CB}"/>
+                <a16:creationId xmlns:a16="http://schemas.microsoft.com/office/drawing/2014/main" id="{7F89C87D-F1F9-42B8-A504-B5CCA3B2044A}"/>
               </a:ext>
             </a:extLst>
           </p:cNvPr>
@@ -9044,7 +9044,7 @@
           <p:cNvPr id="8" name="Rounded Rectangle 7">
             <a:extLst xmlns:a="http://schemas.openxmlformats.org/drawingml/2006/main">
               <a:ext uri="{FF2B5EF4-FFF2-40B4-BE49-F238E27FC236}">
-                <a16:creationId xmlns:a16="http://schemas.microsoft.com/office/drawing/2014/main" id="{FD5CAAE9-3FDE-4AFB-AEEC-9AA5BEDEF3D9}"/>
+                <a16:creationId xmlns:a16="http://schemas.microsoft.com/office/drawing/2014/main" id="{BE91E602-8DB9-4F0D-97FD-14CE432E1DD1}"/>
               </a:ext>
             </a:extLst>
           </p:cNvPr>
@@ -9099,7 +9099,7 @@
           <p:cNvPr id="9" name="TextBox 8">
             <a:extLst xmlns:a="http://schemas.openxmlformats.org/drawingml/2006/main">
               <a:ext uri="{FF2B5EF4-FFF2-40B4-BE49-F238E27FC236}">
-                <a16:creationId xmlns:a16="http://schemas.microsoft.com/office/drawing/2014/main" id="{6BC40961-34E4-4A71-931C-7E6B18A081EC}"/>
+                <a16:creationId xmlns:a16="http://schemas.microsoft.com/office/drawing/2014/main" id="{44493409-4010-4B74-891D-4FF6A13E0B50}"/>
               </a:ext>
             </a:extLst>
           </p:cNvPr>
@@ -9258,7 +9258,7 @@
     </p:spTree>
     <p:extLst>
       <p:ext uri="{BB962C8B-B14F-4D97-AF65-F5344CB8AC3E}">
-        <p14:creationId xmlns:p14="http://schemas.microsoft.com/office/powerpoint/2010/main" val="1079442881"/>
+        <p14:creationId xmlns:p14="http://schemas.microsoft.com/office/powerpoint/2010/main" val="1800285656"/>
       </p:ext>
     </p:extLst>
   </p:cSld>
@@ -9282,7 +9282,7 @@
           <p:cNvPr id="2" name="Rectangle 1">
             <a:extLst xmlns:a="http://schemas.openxmlformats.org/drawingml/2006/main">
               <a:ext uri="{FF2B5EF4-FFF2-40B4-BE49-F238E27FC236}">
-                <a16:creationId xmlns:a16="http://schemas.microsoft.com/office/drawing/2014/main" id="{95182A3F-28C4-410D-9262-309F509BD214}"/>
+                <a16:creationId xmlns:a16="http://schemas.microsoft.com/office/drawing/2014/main" id="{73C25C0E-13F2-41AC-83C7-2A720201EA8B}"/>
               </a:ext>
             </a:extLst>
           </p:cNvPr>
@@ -9335,7 +9335,7 @@
           <p:cNvPr id="3" name="Rectangle 2">
             <a:extLst xmlns:a="http://schemas.openxmlformats.org/drawingml/2006/main">
               <a:ext uri="{FF2B5EF4-FFF2-40B4-BE49-F238E27FC236}">
-                <a16:creationId xmlns:a16="http://schemas.microsoft.com/office/drawing/2014/main" id="{981422DF-B182-442C-9414-4883B32DCDFB}"/>
+                <a16:creationId xmlns:a16="http://schemas.microsoft.com/office/drawing/2014/main" id="{608ACB25-B67A-4075-97D7-F378711056A7}"/>
               </a:ext>
             </a:extLst>
           </p:cNvPr>
@@ -9388,7 +9388,7 @@
           <p:cNvPr id="4" name="Rectangle 3">
             <a:extLst xmlns:a="http://schemas.openxmlformats.org/drawingml/2006/main">
               <a:ext uri="{FF2B5EF4-FFF2-40B4-BE49-F238E27FC236}">
-                <a16:creationId xmlns:a16="http://schemas.microsoft.com/office/drawing/2014/main" id="{6B92C33F-C785-4639-931B-A5EF3B377459}"/>
+                <a16:creationId xmlns:a16="http://schemas.microsoft.com/office/drawing/2014/main" id="{E1836714-478B-4758-8DB7-73B834C1AF1E}"/>
               </a:ext>
             </a:extLst>
           </p:cNvPr>
@@ -9441,7 +9441,7 @@
           <p:cNvPr id="5" name="TextBox 4">
             <a:extLst xmlns:a="http://schemas.openxmlformats.org/drawingml/2006/main">
               <a:ext uri="{FF2B5EF4-FFF2-40B4-BE49-F238E27FC236}">
-                <a16:creationId xmlns:a16="http://schemas.microsoft.com/office/drawing/2014/main" id="{179ECFD0-8EC1-4FD0-99D8-B08477C86CAD}"/>
+                <a16:creationId xmlns:a16="http://schemas.microsoft.com/office/drawing/2014/main" id="{9EC1CE0E-7802-4D66-B7F3-5ECF84544B74}"/>
               </a:ext>
             </a:extLst>
           </p:cNvPr>
@@ -9504,7 +9504,7 @@
           <p:cNvPr id="6" name="Rounded Rectangle 5">
             <a:extLst xmlns:a="http://schemas.openxmlformats.org/drawingml/2006/main">
               <a:ext uri="{FF2B5EF4-FFF2-40B4-BE49-F238E27FC236}">
-                <a16:creationId xmlns:a16="http://schemas.microsoft.com/office/drawing/2014/main" id="{921E1D20-BA63-48E6-B40A-B49946E776EA}"/>
+                <a16:creationId xmlns:a16="http://schemas.microsoft.com/office/drawing/2014/main" id="{20F0CE78-A157-40B1-9997-D04A368A76B0}"/>
               </a:ext>
             </a:extLst>
           </p:cNvPr>
@@ -9559,7 +9559,7 @@
           <p:cNvPr id="7" name="TextBox 6">
             <a:extLst xmlns:a="http://schemas.openxmlformats.org/drawingml/2006/main">
               <a:ext uri="{FF2B5EF4-FFF2-40B4-BE49-F238E27FC236}">
-                <a16:creationId xmlns:a16="http://schemas.microsoft.com/office/drawing/2014/main" id="{60776BB1-2E6E-4D26-B469-6C2415A1186F}"/>
+                <a16:creationId xmlns:a16="http://schemas.microsoft.com/office/drawing/2014/main" id="{80ED5C56-902F-4DE7-87A8-51AD1278BD5D}"/>
               </a:ext>
             </a:extLst>
           </p:cNvPr>
@@ -9777,7 +9777,7 @@
           <p:cNvPr id="8" name="Rounded Rectangle 7">
             <a:extLst xmlns:a="http://schemas.openxmlformats.org/drawingml/2006/main">
               <a:ext uri="{FF2B5EF4-FFF2-40B4-BE49-F238E27FC236}">
-                <a16:creationId xmlns:a16="http://schemas.microsoft.com/office/drawing/2014/main" id="{312621E4-B8C6-4A1D-B262-8240B0C24802}"/>
+                <a16:creationId xmlns:a16="http://schemas.microsoft.com/office/drawing/2014/main" id="{0D166698-49CD-4FD7-8428-6B25784EDE55}"/>
               </a:ext>
             </a:extLst>
           </p:cNvPr>
@@ -9832,7 +9832,7 @@
           <p:cNvPr id="9" name="TextBox 8">
             <a:extLst xmlns:a="http://schemas.openxmlformats.org/drawingml/2006/main">
               <a:ext uri="{FF2B5EF4-FFF2-40B4-BE49-F238E27FC236}">
-                <a16:creationId xmlns:a16="http://schemas.microsoft.com/office/drawing/2014/main" id="{B1A3EEA3-41C3-4510-8579-FDA265244A24}"/>
+                <a16:creationId xmlns:a16="http://schemas.microsoft.com/office/drawing/2014/main" id="{15362817-4121-4F9E-BBC7-7D29120F8A7F}"/>
               </a:ext>
             </a:extLst>
           </p:cNvPr>
@@ -10067,7 +10067,7 @@
     </p:spTree>
     <p:extLst>
       <p:ext uri="{BB962C8B-B14F-4D97-AF65-F5344CB8AC3E}">
-        <p14:creationId xmlns:p14="http://schemas.microsoft.com/office/powerpoint/2010/main" val="792679513"/>
+        <p14:creationId xmlns:p14="http://schemas.microsoft.com/office/powerpoint/2010/main" val="790596602"/>
       </p:ext>
     </p:extLst>
   </p:cSld>
@@ -10091,7 +10091,7 @@
           <p:cNvPr id="2" name="Rectangle 1">
             <a:extLst xmlns:a="http://schemas.openxmlformats.org/drawingml/2006/main">
               <a:ext uri="{FF2B5EF4-FFF2-40B4-BE49-F238E27FC236}">
-                <a16:creationId xmlns:a16="http://schemas.microsoft.com/office/drawing/2014/main" id="{A132FAFB-DF17-45F9-B613-3637E96ECEAD}"/>
+                <a16:creationId xmlns:a16="http://schemas.microsoft.com/office/drawing/2014/main" id="{4CA6AE8B-D4C7-4E5F-AC64-0A3C067FE971}"/>
               </a:ext>
             </a:extLst>
           </p:cNvPr>
@@ -10144,7 +10144,7 @@
           <p:cNvPr id="3" name="Rectangle 2">
             <a:extLst xmlns:a="http://schemas.openxmlformats.org/drawingml/2006/main">
               <a:ext uri="{FF2B5EF4-FFF2-40B4-BE49-F238E27FC236}">
-                <a16:creationId xmlns:a16="http://schemas.microsoft.com/office/drawing/2014/main" id="{4886E82B-EF7E-41CB-B679-D491F89AF2FE}"/>
+                <a16:creationId xmlns:a16="http://schemas.microsoft.com/office/drawing/2014/main" id="{FFED41CC-2C50-4C61-A973-0B117D47086D}"/>
               </a:ext>
             </a:extLst>
           </p:cNvPr>
@@ -10197,7 +10197,7 @@
           <p:cNvPr id="4" name="Rectangle 3">
             <a:extLst xmlns:a="http://schemas.openxmlformats.org/drawingml/2006/main">
               <a:ext uri="{FF2B5EF4-FFF2-40B4-BE49-F238E27FC236}">
-                <a16:creationId xmlns:a16="http://schemas.microsoft.com/office/drawing/2014/main" id="{A5C31D4C-A91F-4A08-BB71-56E2D45ED978}"/>
+                <a16:creationId xmlns:a16="http://schemas.microsoft.com/office/drawing/2014/main" id="{3DA338A1-9970-4A2C-9CF5-F341174EF037}"/>
               </a:ext>
             </a:extLst>
           </p:cNvPr>
@@ -10250,7 +10250,7 @@
           <p:cNvPr id="5" name="TextBox 4">
             <a:extLst xmlns:a="http://schemas.openxmlformats.org/drawingml/2006/main">
               <a:ext uri="{FF2B5EF4-FFF2-40B4-BE49-F238E27FC236}">
-                <a16:creationId xmlns:a16="http://schemas.microsoft.com/office/drawing/2014/main" id="{5BBD41F0-8473-44C0-811C-45FCF578D892}"/>
+                <a16:creationId xmlns:a16="http://schemas.microsoft.com/office/drawing/2014/main" id="{9A663EF1-2EC3-4BF7-98FD-A559B2AA3362}"/>
               </a:ext>
             </a:extLst>
           </p:cNvPr>
@@ -10313,7 +10313,7 @@
           <p:cNvPr id="6" name="Rounded Rectangle 5">
             <a:extLst xmlns:a="http://schemas.openxmlformats.org/drawingml/2006/main">
               <a:ext uri="{FF2B5EF4-FFF2-40B4-BE49-F238E27FC236}">
-                <a16:creationId xmlns:a16="http://schemas.microsoft.com/office/drawing/2014/main" id="{4E6E4FD4-D772-4424-B422-D07304E00DD4}"/>
+                <a16:creationId xmlns:a16="http://schemas.microsoft.com/office/drawing/2014/main" id="{7CB293FC-B124-43E0-B637-AE7B23DEAF3C}"/>
               </a:ext>
             </a:extLst>
           </p:cNvPr>
@@ -10368,7 +10368,7 @@
           <p:cNvPr id="7" name="TextBox 6">
             <a:extLst xmlns:a="http://schemas.openxmlformats.org/drawingml/2006/main">
               <a:ext uri="{FF2B5EF4-FFF2-40B4-BE49-F238E27FC236}">
-                <a16:creationId xmlns:a16="http://schemas.microsoft.com/office/drawing/2014/main" id="{67D72D16-A572-4C40-9B18-769A5AF34EFF}"/>
+                <a16:creationId xmlns:a16="http://schemas.microsoft.com/office/drawing/2014/main" id="{C1BD8FF2-B41F-49E9-B636-F7DEBA374647}"/>
               </a:ext>
             </a:extLst>
           </p:cNvPr>
@@ -10751,7 +10751,7 @@
           <p:nvPr/>
         </p:nvPicPr>
         <p:blipFill>
-          <a:blip xmlns:r="http://schemas.openxmlformats.org/officeDocument/2006/relationships" xmlns:a="http://schemas.openxmlformats.org/drawingml/2006/main" r:embed="R291386277bea42d7"/>
+          <a:blip xmlns:r="http://schemas.openxmlformats.org/officeDocument/2006/relationships" xmlns:a="http://schemas.openxmlformats.org/drawingml/2006/main" r:embed="Rf8ca018465404876"/>
           <a:stretch xmlns:a="http://schemas.openxmlformats.org/drawingml/2006/main">
             <a:fillRect l="0" t="0" r="0" b="0"/>
           </a:stretch>
@@ -10771,7 +10771,7 @@
           <p:cNvPr id="9" name="Rounded Rectangle 8">
             <a:extLst xmlns:a="http://schemas.openxmlformats.org/drawingml/2006/main">
               <a:ext uri="{FF2B5EF4-FFF2-40B4-BE49-F238E27FC236}">
-                <a16:creationId xmlns:a16="http://schemas.microsoft.com/office/drawing/2014/main" id="{F141A053-F0A4-4C4E-B477-10B4033783BA}"/>
+                <a16:creationId xmlns:a16="http://schemas.microsoft.com/office/drawing/2014/main" id="{B8742DAB-DFAB-4305-8723-704851E29B11}"/>
               </a:ext>
             </a:extLst>
           </p:cNvPr>
@@ -10826,7 +10826,7 @@
           <p:cNvPr id="10" name="TextBox 9">
             <a:extLst xmlns:a="http://schemas.openxmlformats.org/drawingml/2006/main">
               <a:ext uri="{FF2B5EF4-FFF2-40B4-BE49-F238E27FC236}">
-                <a16:creationId xmlns:a16="http://schemas.microsoft.com/office/drawing/2014/main" id="{A2CD381C-5BF1-404C-BB86-8223A3B9B1BC}"/>
+                <a16:creationId xmlns:a16="http://schemas.microsoft.com/office/drawing/2014/main" id="{B8BB598D-CE33-4722-BC7B-E736F03F7EDE}"/>
               </a:ext>
             </a:extLst>
           </p:cNvPr>
@@ -10912,7 +10912,7 @@
     </p:spTree>
     <p:extLst>
       <p:ext uri="{BB962C8B-B14F-4D97-AF65-F5344CB8AC3E}">
-        <p14:creationId xmlns:p14="http://schemas.microsoft.com/office/powerpoint/2010/main" val="943614126"/>
+        <p14:creationId xmlns:p14="http://schemas.microsoft.com/office/powerpoint/2010/main" val="1574508850"/>
       </p:ext>
     </p:extLst>
   </p:cSld>
@@ -10936,7 +10936,7 @@
           <p:cNvPr id="2" name="Rectangle 1">
             <a:extLst xmlns:a="http://schemas.openxmlformats.org/drawingml/2006/main">
               <a:ext uri="{FF2B5EF4-FFF2-40B4-BE49-F238E27FC236}">
-                <a16:creationId xmlns:a16="http://schemas.microsoft.com/office/drawing/2014/main" id="{6E1CACC9-49B5-467B-AB68-DA991D8A02B6}"/>
+                <a16:creationId xmlns:a16="http://schemas.microsoft.com/office/drawing/2014/main" id="{EF749E31-DF2B-4CE2-B277-C8D5EDCE3DAD}"/>
               </a:ext>
             </a:extLst>
           </p:cNvPr>
@@ -10989,7 +10989,7 @@
           <p:cNvPr id="3" name="Rectangle 2">
             <a:extLst xmlns:a="http://schemas.openxmlformats.org/drawingml/2006/main">
               <a:ext uri="{FF2B5EF4-FFF2-40B4-BE49-F238E27FC236}">
-                <a16:creationId xmlns:a16="http://schemas.microsoft.com/office/drawing/2014/main" id="{E9B04071-5356-485E-96C6-6D5C63B99BB8}"/>
+                <a16:creationId xmlns:a16="http://schemas.microsoft.com/office/drawing/2014/main" id="{BB8176D1-A685-4159-BAA6-EA67002F8B0F}"/>
               </a:ext>
             </a:extLst>
           </p:cNvPr>
@@ -11042,7 +11042,7 @@
           <p:cNvPr id="4" name="Rectangle 3">
             <a:extLst xmlns:a="http://schemas.openxmlformats.org/drawingml/2006/main">
               <a:ext uri="{FF2B5EF4-FFF2-40B4-BE49-F238E27FC236}">
-                <a16:creationId xmlns:a16="http://schemas.microsoft.com/office/drawing/2014/main" id="{111729A7-A8FC-4014-A6E9-E52B5CE227CC}"/>
+                <a16:creationId xmlns:a16="http://schemas.microsoft.com/office/drawing/2014/main" id="{72134F25-7D33-430E-871E-C2BAFA5A641C}"/>
               </a:ext>
             </a:extLst>
           </p:cNvPr>
@@ -11095,7 +11095,7 @@
           <p:cNvPr id="5" name="TextBox 4">
             <a:extLst xmlns:a="http://schemas.openxmlformats.org/drawingml/2006/main">
               <a:ext uri="{FF2B5EF4-FFF2-40B4-BE49-F238E27FC236}">
-                <a16:creationId xmlns:a16="http://schemas.microsoft.com/office/drawing/2014/main" id="{852B6993-038B-4FC3-AE08-4991FCD83268}"/>
+                <a16:creationId xmlns:a16="http://schemas.microsoft.com/office/drawing/2014/main" id="{534A1B69-23AE-4926-BE62-625E12541ED2}"/>
               </a:ext>
             </a:extLst>
           </p:cNvPr>
@@ -11158,7 +11158,7 @@
           <p:cNvPr id="6" name="Rounded Rectangle 5">
             <a:extLst xmlns:a="http://schemas.openxmlformats.org/drawingml/2006/main">
               <a:ext uri="{FF2B5EF4-FFF2-40B4-BE49-F238E27FC236}">
-                <a16:creationId xmlns:a16="http://schemas.microsoft.com/office/drawing/2014/main" id="{100B1B97-249E-4D3E-A059-B084C028B32A}"/>
+                <a16:creationId xmlns:a16="http://schemas.microsoft.com/office/drawing/2014/main" id="{70FE6936-B067-4C94-B924-95E7E5A7771F}"/>
               </a:ext>
             </a:extLst>
           </p:cNvPr>
@@ -11213,7 +11213,7 @@
           <p:cNvPr id="7" name="TextBox 6">
             <a:extLst xmlns:a="http://schemas.openxmlformats.org/drawingml/2006/main">
               <a:ext uri="{FF2B5EF4-FFF2-40B4-BE49-F238E27FC236}">
-                <a16:creationId xmlns:a16="http://schemas.microsoft.com/office/drawing/2014/main" id="{07B7AECF-4322-4CF7-8DDE-2B734D98C9DF}"/>
+                <a16:creationId xmlns:a16="http://schemas.microsoft.com/office/drawing/2014/main" id="{A0C64D86-DC0F-44A1-A36A-A52831514462}"/>
               </a:ext>
             </a:extLst>
           </p:cNvPr>
@@ -11450,7 +11450,7 @@
           <p:cNvPr id="8" name="Rounded Rectangle 7">
             <a:extLst xmlns:a="http://schemas.openxmlformats.org/drawingml/2006/main">
               <a:ext uri="{FF2B5EF4-FFF2-40B4-BE49-F238E27FC236}">
-                <a16:creationId xmlns:a16="http://schemas.microsoft.com/office/drawing/2014/main" id="{C55114E1-519F-4D86-8898-5A18035F05E6}"/>
+                <a16:creationId xmlns:a16="http://schemas.microsoft.com/office/drawing/2014/main" id="{4D696FF7-697F-4BBE-8AC7-21428916BE2E}"/>
               </a:ext>
             </a:extLst>
           </p:cNvPr>
@@ -11505,7 +11505,7 @@
           <p:cNvPr id="9" name="TextBox 8">
             <a:extLst xmlns:a="http://schemas.openxmlformats.org/drawingml/2006/main">
               <a:ext uri="{FF2B5EF4-FFF2-40B4-BE49-F238E27FC236}">
-                <a16:creationId xmlns:a16="http://schemas.microsoft.com/office/drawing/2014/main" id="{6AA9C966-5284-45BC-8769-2587DE7B7D36}"/>
+                <a16:creationId xmlns:a16="http://schemas.microsoft.com/office/drawing/2014/main" id="{A406CCC3-16F4-4801-B427-A743D4CD20E5}"/>
               </a:ext>
             </a:extLst>
           </p:cNvPr>
@@ -11840,7 +11840,7 @@
     </p:spTree>
     <p:extLst>
       <p:ext uri="{BB962C8B-B14F-4D97-AF65-F5344CB8AC3E}">
-        <p14:creationId xmlns:p14="http://schemas.microsoft.com/office/powerpoint/2010/main" val="815533390"/>
+        <p14:creationId xmlns:p14="http://schemas.microsoft.com/office/powerpoint/2010/main" val="814644868"/>
       </p:ext>
     </p:extLst>
   </p:cSld>
@@ -11864,7 +11864,7 @@
           <p:cNvPr id="2" name="Rectangle 1">
             <a:extLst xmlns:a="http://schemas.openxmlformats.org/drawingml/2006/main">
               <a:ext uri="{FF2B5EF4-FFF2-40B4-BE49-F238E27FC236}">
-                <a16:creationId xmlns:a16="http://schemas.microsoft.com/office/drawing/2014/main" id="{D442BEAC-C47A-431A-9423-194AA01E1520}"/>
+                <a16:creationId xmlns:a16="http://schemas.microsoft.com/office/drawing/2014/main" id="{36197B92-FC50-4BE9-84BD-3756AC9ED8ED}"/>
               </a:ext>
             </a:extLst>
           </p:cNvPr>
@@ -11917,7 +11917,7 @@
           <p:cNvPr id="3" name="Rectangle 2">
             <a:extLst xmlns:a="http://schemas.openxmlformats.org/drawingml/2006/main">
               <a:ext uri="{FF2B5EF4-FFF2-40B4-BE49-F238E27FC236}">
-                <a16:creationId xmlns:a16="http://schemas.microsoft.com/office/drawing/2014/main" id="{01D862B2-C822-4617-940B-BBA340FCD56A}"/>
+                <a16:creationId xmlns:a16="http://schemas.microsoft.com/office/drawing/2014/main" id="{A265C8AC-CDA5-45D8-872F-B01EF59D4FA6}"/>
               </a:ext>
             </a:extLst>
           </p:cNvPr>
@@ -11970,7 +11970,7 @@
           <p:cNvPr id="4" name="Rectangle 3">
             <a:extLst xmlns:a="http://schemas.openxmlformats.org/drawingml/2006/main">
               <a:ext uri="{FF2B5EF4-FFF2-40B4-BE49-F238E27FC236}">
-                <a16:creationId xmlns:a16="http://schemas.microsoft.com/office/drawing/2014/main" id="{A0DED8BB-2393-44DE-9C36-489B96DEBA9D}"/>
+                <a16:creationId xmlns:a16="http://schemas.microsoft.com/office/drawing/2014/main" id="{67224D6E-37FC-4917-92F2-2CEC50164682}"/>
               </a:ext>
             </a:extLst>
           </p:cNvPr>
@@ -12023,7 +12023,7 @@
           <p:cNvPr id="5" name="TextBox 4">
             <a:extLst xmlns:a="http://schemas.openxmlformats.org/drawingml/2006/main">
               <a:ext uri="{FF2B5EF4-FFF2-40B4-BE49-F238E27FC236}">
-                <a16:creationId xmlns:a16="http://schemas.microsoft.com/office/drawing/2014/main" id="{34FC8F9B-5D6B-4FC6-BC32-26D0BA553511}"/>
+                <a16:creationId xmlns:a16="http://schemas.microsoft.com/office/drawing/2014/main" id="{E5BEDA46-FB4D-44B2-8344-1F3FA1C56DFA}"/>
               </a:ext>
             </a:extLst>
           </p:cNvPr>
@@ -12086,7 +12086,7 @@
           <p:cNvPr id="6" name="Rounded Rectangle 5">
             <a:extLst xmlns:a="http://schemas.openxmlformats.org/drawingml/2006/main">
               <a:ext uri="{FF2B5EF4-FFF2-40B4-BE49-F238E27FC236}">
-                <a16:creationId xmlns:a16="http://schemas.microsoft.com/office/drawing/2014/main" id="{89D84675-38BA-4EFA-828C-44F2BFBC8D83}"/>
+                <a16:creationId xmlns:a16="http://schemas.microsoft.com/office/drawing/2014/main" id="{7DF6A05E-2962-4C5D-9DA5-C67EBA4C1EF2}"/>
               </a:ext>
             </a:extLst>
           </p:cNvPr>
@@ -12141,7 +12141,7 @@
           <p:cNvPr id="7" name="TextBox 6">
             <a:extLst xmlns:a="http://schemas.openxmlformats.org/drawingml/2006/main">
               <a:ext uri="{FF2B5EF4-FFF2-40B4-BE49-F238E27FC236}">
-                <a16:creationId xmlns:a16="http://schemas.microsoft.com/office/drawing/2014/main" id="{B5C69696-62EB-4FE8-8E5B-3CE7A5505AB1}"/>
+                <a16:creationId xmlns:a16="http://schemas.microsoft.com/office/drawing/2014/main" id="{117D281B-769C-4B40-9E0E-7ADAB76DFEF0}"/>
               </a:ext>
             </a:extLst>
           </p:cNvPr>
@@ -12264,7 +12264,7 @@
           <p:cNvPr id="8" name="Rounded Rectangle 7">
             <a:extLst xmlns:a="http://schemas.openxmlformats.org/drawingml/2006/main">
               <a:ext uri="{FF2B5EF4-FFF2-40B4-BE49-F238E27FC236}">
-                <a16:creationId xmlns:a16="http://schemas.microsoft.com/office/drawing/2014/main" id="{2181D1CA-DF2B-4E5A-82E0-13A90A52F6AC}"/>
+                <a16:creationId xmlns:a16="http://schemas.microsoft.com/office/drawing/2014/main" id="{AD8C3C66-D82C-4A2D-A406-3CDB90BA53B0}"/>
               </a:ext>
             </a:extLst>
           </p:cNvPr>
@@ -12319,7 +12319,7 @@
           <p:cNvPr id="9" name="TextBox 8">
             <a:extLst xmlns:a="http://schemas.openxmlformats.org/drawingml/2006/main">
               <a:ext uri="{FF2B5EF4-FFF2-40B4-BE49-F238E27FC236}">
-                <a16:creationId xmlns:a16="http://schemas.microsoft.com/office/drawing/2014/main" id="{0014244E-0DF0-432E-880D-8A870CDEC647}"/>
+                <a16:creationId xmlns:a16="http://schemas.microsoft.com/office/drawing/2014/main" id="{B5266489-C9B8-46CC-8143-993526F6790E}"/>
               </a:ext>
             </a:extLst>
           </p:cNvPr>
@@ -12442,7 +12442,7 @@
           <p:cNvPr id="10" name="Rounded Rectangle 9">
             <a:extLst xmlns:a="http://schemas.openxmlformats.org/drawingml/2006/main">
               <a:ext uri="{FF2B5EF4-FFF2-40B4-BE49-F238E27FC236}">
-                <a16:creationId xmlns:a16="http://schemas.microsoft.com/office/drawing/2014/main" id="{55F37545-36BB-4EF9-994D-0F89132CF710}"/>
+                <a16:creationId xmlns:a16="http://schemas.microsoft.com/office/drawing/2014/main" id="{5728ADA4-C967-467E-AC84-A56B9398D81E}"/>
               </a:ext>
             </a:extLst>
           </p:cNvPr>
@@ -12497,7 +12497,7 @@
           <p:cNvPr id="11" name="TextBox 10">
             <a:extLst xmlns:a="http://schemas.openxmlformats.org/drawingml/2006/main">
               <a:ext uri="{FF2B5EF4-FFF2-40B4-BE49-F238E27FC236}">
-                <a16:creationId xmlns:a16="http://schemas.microsoft.com/office/drawing/2014/main" id="{D8994DCB-DE82-401A-BECB-426D3728DBED}"/>
+                <a16:creationId xmlns:a16="http://schemas.microsoft.com/office/drawing/2014/main" id="{BEB37232-BC02-4E02-B428-B5DC86A7F808}"/>
               </a:ext>
             </a:extLst>
           </p:cNvPr>
@@ -12847,7 +12847,7 @@
     </p:spTree>
     <p:extLst>
       <p:ext uri="{BB962C8B-B14F-4D97-AF65-F5344CB8AC3E}">
-        <p14:creationId xmlns:p14="http://schemas.microsoft.com/office/powerpoint/2010/main" val="1276896136"/>
+        <p14:creationId xmlns:p14="http://schemas.microsoft.com/office/powerpoint/2010/main" val="154989256"/>
       </p:ext>
     </p:extLst>
   </p:cSld>
@@ -12871,7 +12871,7 @@
           <p:cNvPr id="2" name="Rectangle 1">
             <a:extLst xmlns:a="http://schemas.openxmlformats.org/drawingml/2006/main">
               <a:ext uri="{FF2B5EF4-FFF2-40B4-BE49-F238E27FC236}">
-                <a16:creationId xmlns:a16="http://schemas.microsoft.com/office/drawing/2014/main" id="{A252E5BB-A9D4-410D-A093-08BA6F55BE21}"/>
+                <a16:creationId xmlns:a16="http://schemas.microsoft.com/office/drawing/2014/main" id="{8D28292C-D21B-4B40-854D-EEA25083F92F}"/>
               </a:ext>
             </a:extLst>
           </p:cNvPr>
@@ -12924,7 +12924,7 @@
           <p:cNvPr id="3" name="Rectangle 2">
             <a:extLst xmlns:a="http://schemas.openxmlformats.org/drawingml/2006/main">
               <a:ext uri="{FF2B5EF4-FFF2-40B4-BE49-F238E27FC236}">
-                <a16:creationId xmlns:a16="http://schemas.microsoft.com/office/drawing/2014/main" id="{6356DC57-E006-43B8-BF54-EF8BFFDE682D}"/>
+                <a16:creationId xmlns:a16="http://schemas.microsoft.com/office/drawing/2014/main" id="{5F58E0FD-EFE6-400F-80FE-1747392F6CDC}"/>
               </a:ext>
             </a:extLst>
           </p:cNvPr>
@@ -12977,7 +12977,7 @@
           <p:cNvPr id="4" name="Rectangle 3">
             <a:extLst xmlns:a="http://schemas.openxmlformats.org/drawingml/2006/main">
               <a:ext uri="{FF2B5EF4-FFF2-40B4-BE49-F238E27FC236}">
-                <a16:creationId xmlns:a16="http://schemas.microsoft.com/office/drawing/2014/main" id="{CFD51A11-3573-4B2E-8D29-57684B95E59D}"/>
+                <a16:creationId xmlns:a16="http://schemas.microsoft.com/office/drawing/2014/main" id="{6BFEF9BB-1D00-4C27-9BDB-D1169294BD63}"/>
               </a:ext>
             </a:extLst>
           </p:cNvPr>
@@ -13030,7 +13030,7 @@
           <p:cNvPr id="5" name="TextBox 4">
             <a:extLst xmlns:a="http://schemas.openxmlformats.org/drawingml/2006/main">
               <a:ext uri="{FF2B5EF4-FFF2-40B4-BE49-F238E27FC236}">
-                <a16:creationId xmlns:a16="http://schemas.microsoft.com/office/drawing/2014/main" id="{2D64DE29-D386-4C43-8C7A-580364641692}"/>
+                <a16:creationId xmlns:a16="http://schemas.microsoft.com/office/drawing/2014/main" id="{15CB8889-BD42-4A57-8759-B3955D40DD19}"/>
               </a:ext>
             </a:extLst>
           </p:cNvPr>
@@ -13093,7 +13093,7 @@
           <p:cNvPr id="6" name="Rounded Rectangle 5">
             <a:extLst xmlns:a="http://schemas.openxmlformats.org/drawingml/2006/main">
               <a:ext uri="{FF2B5EF4-FFF2-40B4-BE49-F238E27FC236}">
-                <a16:creationId xmlns:a16="http://schemas.microsoft.com/office/drawing/2014/main" id="{C6CEE4A5-FF18-449B-B288-81C98CB4F61B}"/>
+                <a16:creationId xmlns:a16="http://schemas.microsoft.com/office/drawing/2014/main" id="{34975B01-D92D-45C2-BE88-487F21B95A54}"/>
               </a:ext>
             </a:extLst>
           </p:cNvPr>
@@ -13148,7 +13148,7 @@
           <p:cNvPr id="7" name="TextBox 6">
             <a:extLst xmlns:a="http://schemas.openxmlformats.org/drawingml/2006/main">
               <a:ext uri="{FF2B5EF4-FFF2-40B4-BE49-F238E27FC236}">
-                <a16:creationId xmlns:a16="http://schemas.microsoft.com/office/drawing/2014/main" id="{95F072E9-4D16-4106-B9E9-969B9A6B0676}"/>
+                <a16:creationId xmlns:a16="http://schemas.microsoft.com/office/drawing/2014/main" id="{4893621C-C620-4095-B126-79EDCD09B4CD}"/>
               </a:ext>
             </a:extLst>
           </p:cNvPr>
@@ -13612,7 +13612,7 @@
           <p:nvPr/>
         </p:nvPicPr>
         <p:blipFill>
-          <a:blip xmlns:r="http://schemas.openxmlformats.org/officeDocument/2006/relationships" xmlns:a="http://schemas.openxmlformats.org/drawingml/2006/main" r:embed="R4d1c071bb1004aee"/>
+          <a:blip xmlns:r="http://schemas.openxmlformats.org/officeDocument/2006/relationships" xmlns:a="http://schemas.openxmlformats.org/drawingml/2006/main" r:embed="R58da3dcd2ff14277"/>
           <a:stretch xmlns:a="http://schemas.openxmlformats.org/drawingml/2006/main">
             <a:fillRect l="0" t="0" r="0" b="0"/>
           </a:stretch>
@@ -13632,7 +13632,7 @@
           <p:cNvPr id="9" name="Rounded Rectangle 8">
             <a:extLst xmlns:a="http://schemas.openxmlformats.org/drawingml/2006/main">
               <a:ext uri="{FF2B5EF4-FFF2-40B4-BE49-F238E27FC236}">
-                <a16:creationId xmlns:a16="http://schemas.microsoft.com/office/drawing/2014/main" id="{8E18A292-52FE-475C-93C4-E885EF24ADD4}"/>
+                <a16:creationId xmlns:a16="http://schemas.microsoft.com/office/drawing/2014/main" id="{386CC619-F029-481F-BF92-EC25D11F687A}"/>
               </a:ext>
             </a:extLst>
           </p:cNvPr>
@@ -13687,7 +13687,7 @@
           <p:cNvPr id="10" name="TextBox 9">
             <a:extLst xmlns:a="http://schemas.openxmlformats.org/drawingml/2006/main">
               <a:ext uri="{FF2B5EF4-FFF2-40B4-BE49-F238E27FC236}">
-                <a16:creationId xmlns:a16="http://schemas.microsoft.com/office/drawing/2014/main" id="{2C7AF10E-6399-464E-97B1-E8F9494D9A59}"/>
+                <a16:creationId xmlns:a16="http://schemas.microsoft.com/office/drawing/2014/main" id="{ECBFEA72-0D73-4D75-BEF1-391478E99CA4}"/>
               </a:ext>
             </a:extLst>
           </p:cNvPr>
@@ -13770,7 +13770,7 @@
     </p:spTree>
     <p:extLst>
       <p:ext uri="{BB962C8B-B14F-4D97-AF65-F5344CB8AC3E}">
-        <p14:creationId xmlns:p14="http://schemas.microsoft.com/office/powerpoint/2010/main" val="1517629773"/>
+        <p14:creationId xmlns:p14="http://schemas.microsoft.com/office/powerpoint/2010/main" val="1182244350"/>
       </p:ext>
     </p:extLst>
   </p:cSld>

</xml_diff>

<commit_message>
fix(report): harden single-buffer digest validation, complete OMML equations, and seal report figures
</commit_message>
<xml_diff>
--- a/reports/evidence/fixture_populated_slides.pptx
+++ b/reports/evidence/fixture_populated_slides.pptx
@@ -2,24 +2,24 @@
 <file path=ppt/presentation.xml><?xml version="1.0" encoding="utf-8"?>
 <p:presentation xmlns:p="http://schemas.openxmlformats.org/presentationml/2006/main">
   <p:sldMasterIdLst>
-    <p:sldMasterId xmlns:r="http://schemas.openxmlformats.org/officeDocument/2006/relationships" id="2147483648" r:id="Rebefc75836174f1a"/>
+    <p:sldMasterId xmlns:r="http://schemas.openxmlformats.org/officeDocument/2006/relationships" id="2147483648" r:id="Rad193556d3a24043"/>
   </p:sldMasterIdLst>
   <p:notesMasterIdLst>
-    <p:notesMasterId xmlns:r="http://schemas.openxmlformats.org/officeDocument/2006/relationships" r:id="Ra1d2833b2cc4409a"/>
+    <p:notesMasterId xmlns:r="http://schemas.openxmlformats.org/officeDocument/2006/relationships" r:id="Rae59f90e512047c4"/>
   </p:notesMasterIdLst>
   <p:sldIdLst>
-    <p:sldId xmlns:r="http://schemas.openxmlformats.org/officeDocument/2006/relationships" id="256" r:id="R3f5a8671a3d8424d"/>
-    <p:sldId xmlns:r="http://schemas.openxmlformats.org/officeDocument/2006/relationships" id="257" r:id="Rf70e6d0425594080"/>
-    <p:sldId xmlns:r="http://schemas.openxmlformats.org/officeDocument/2006/relationships" id="258" r:id="R7d16815bfa3545b5"/>
-    <p:sldId xmlns:r="http://schemas.openxmlformats.org/officeDocument/2006/relationships" id="259" r:id="R0b8ee83ebe4b4a4e"/>
-    <p:sldId xmlns:r="http://schemas.openxmlformats.org/officeDocument/2006/relationships" id="260" r:id="R7a537e5bcc794282"/>
-    <p:sldId xmlns:r="http://schemas.openxmlformats.org/officeDocument/2006/relationships" id="261" r:id="R1e7201fcbfb14516"/>
-    <p:sldId xmlns:r="http://schemas.openxmlformats.org/officeDocument/2006/relationships" id="262" r:id="Rfdc486169bf54441"/>
-    <p:sldId xmlns:r="http://schemas.openxmlformats.org/officeDocument/2006/relationships" id="263" r:id="R8d1937e3c6b145f3"/>
-    <p:sldId xmlns:r="http://schemas.openxmlformats.org/officeDocument/2006/relationships" id="264" r:id="R839f58f7306d4df3"/>
-    <p:sldId xmlns:r="http://schemas.openxmlformats.org/officeDocument/2006/relationships" id="265" r:id="R4d0eb1bed2d3486e"/>
-    <p:sldId xmlns:r="http://schemas.openxmlformats.org/officeDocument/2006/relationships" id="266" r:id="Rb89fdf37a91e47e4"/>
-    <p:sldId xmlns:r="http://schemas.openxmlformats.org/officeDocument/2006/relationships" id="267" r:id="Rd51a58807c1f4791"/>
+    <p:sldId xmlns:r="http://schemas.openxmlformats.org/officeDocument/2006/relationships" id="256" r:id="Rcc9c892b1037460a"/>
+    <p:sldId xmlns:r="http://schemas.openxmlformats.org/officeDocument/2006/relationships" id="257" r:id="R5f7abd7c19844605"/>
+    <p:sldId xmlns:r="http://schemas.openxmlformats.org/officeDocument/2006/relationships" id="258" r:id="Rde46eecd609142c3"/>
+    <p:sldId xmlns:r="http://schemas.openxmlformats.org/officeDocument/2006/relationships" id="259" r:id="Rb5c44db43b1646b6"/>
+    <p:sldId xmlns:r="http://schemas.openxmlformats.org/officeDocument/2006/relationships" id="260" r:id="Re2c626d611974eb1"/>
+    <p:sldId xmlns:r="http://schemas.openxmlformats.org/officeDocument/2006/relationships" id="261" r:id="Rade29e1ba1a94c3b"/>
+    <p:sldId xmlns:r="http://schemas.openxmlformats.org/officeDocument/2006/relationships" id="262" r:id="R77ff31063a504293"/>
+    <p:sldId xmlns:r="http://schemas.openxmlformats.org/officeDocument/2006/relationships" id="263" r:id="R5c63f84e44554873"/>
+    <p:sldId xmlns:r="http://schemas.openxmlformats.org/officeDocument/2006/relationships" id="264" r:id="R7e39eb70558c4468"/>
+    <p:sldId xmlns:r="http://schemas.openxmlformats.org/officeDocument/2006/relationships" id="265" r:id="R7fed64784d3a4690"/>
+    <p:sldId xmlns:r="http://schemas.openxmlformats.org/officeDocument/2006/relationships" id="266" r:id="Rb2f6197246b64be9"/>
+    <p:sldId xmlns:r="http://schemas.openxmlformats.org/officeDocument/2006/relationships" id="267" r:id="Re74b63756aaf48b2"/>
   </p:sldIdLst>
   <p:sldSz cx="12191695" cy="6858000"/>
   <p:notesSz cx="6858000" cy="9144000"/>
@@ -1577,7 +1577,7 @@
           <p:cNvPr id="2" name="Title 1">
             <a:extLst xmlns:a="http://schemas.openxmlformats.org/drawingml/2006/main">
               <a:ext uri="{FF2B5EF4-FFF2-40B4-BE49-F238E27FC236}">
-                <a16:creationId xmlns:a16="http://schemas.microsoft.com/office/drawing/2014/main" id="{A5F65FD0-18D3-40A1-81D2-7DD331BA1459}"/>
+                <a16:creationId xmlns:a16="http://schemas.microsoft.com/office/drawing/2014/main" id="{54F03B12-7243-448A-88C2-02F6D3329074}"/>
               </a:ext>
             </a:extLst>
           </p:cNvPr>
@@ -1610,7 +1610,7 @@
           <p:cNvPr id="3" name="Subtitle 2">
             <a:extLst xmlns:a="http://schemas.openxmlformats.org/drawingml/2006/main">
               <a:ext uri="{FF2B5EF4-FFF2-40B4-BE49-F238E27FC236}">
-                <a16:creationId xmlns:a16="http://schemas.microsoft.com/office/drawing/2014/main" id="{CFD99702-E94B-4719-8127-BF1E1D645188}"/>
+                <a16:creationId xmlns:a16="http://schemas.microsoft.com/office/drawing/2014/main" id="{1F0B98F5-CCB6-4EF4-BC77-98FBEC6B8400}"/>
               </a:ext>
             </a:extLst>
           </p:cNvPr>
@@ -1734,7 +1734,7 @@
           <p:cNvPr id="4" name="Date Placeholder 3">
             <a:extLst xmlns:a="http://schemas.openxmlformats.org/drawingml/2006/main">
               <a:ext uri="{FF2B5EF4-FFF2-40B4-BE49-F238E27FC236}">
-                <a16:creationId xmlns:a16="http://schemas.microsoft.com/office/drawing/2014/main" id="{FA94C1BE-ECB6-4513-A15F-75A1C4B5AB71}"/>
+                <a16:creationId xmlns:a16="http://schemas.microsoft.com/office/drawing/2014/main" id="{4E98A180-8205-49FA-A964-7DFB1BD7F934}"/>
               </a:ext>
             </a:extLst>
           </p:cNvPr>
@@ -1762,7 +1762,7 @@
           <p:cNvPr id="5" name="Footer Placeholder 4">
             <a:extLst xmlns:a="http://schemas.openxmlformats.org/drawingml/2006/main">
               <a:ext uri="{FF2B5EF4-FFF2-40B4-BE49-F238E27FC236}">
-                <a16:creationId xmlns:a16="http://schemas.microsoft.com/office/drawing/2014/main" id="{96B2A07E-A8E9-46C3-9B24-A73BA9C75C38}"/>
+                <a16:creationId xmlns:a16="http://schemas.microsoft.com/office/drawing/2014/main" id="{89745A15-F5AD-4980-86AD-5F5048B325B1}"/>
               </a:ext>
             </a:extLst>
           </p:cNvPr>
@@ -1787,7 +1787,7 @@
           <p:cNvPr id="6" name="Slide Number Placeholder 5">
             <a:extLst xmlns:a="http://schemas.openxmlformats.org/drawingml/2006/main">
               <a:ext uri="{FF2B5EF4-FFF2-40B4-BE49-F238E27FC236}">
-                <a16:creationId xmlns:a16="http://schemas.microsoft.com/office/drawing/2014/main" id="{035E55D6-25E6-4D1C-8B83-1614A4DB5D0B}"/>
+                <a16:creationId xmlns:a16="http://schemas.microsoft.com/office/drawing/2014/main" id="{536241BB-B505-4C99-87C1-54448B613B03}"/>
               </a:ext>
             </a:extLst>
           </p:cNvPr>
@@ -1832,7 +1832,7 @@
           <p:cNvPr id="2" name="Title 1">
             <a:extLst xmlns:a="http://schemas.openxmlformats.org/drawingml/2006/main">
               <a:ext uri="{FF2B5EF4-FFF2-40B4-BE49-F238E27FC236}">
-                <a16:creationId xmlns:a16="http://schemas.microsoft.com/office/drawing/2014/main" id="{FAA4B837-300D-426B-A7C3-E148738F313D}"/>
+                <a16:creationId xmlns:a16="http://schemas.microsoft.com/office/drawing/2014/main" id="{C7D1DFCA-9CBF-427A-8341-1322B7689BC3}"/>
               </a:ext>
             </a:extLst>
           </p:cNvPr>
@@ -1860,7 +1860,7 @@
           <p:cNvPr id="3" name="Vertical Text Placeholder 2">
             <a:extLst xmlns:a="http://schemas.openxmlformats.org/drawingml/2006/main">
               <a:ext uri="{FF2B5EF4-FFF2-40B4-BE49-F238E27FC236}">
-                <a16:creationId xmlns:a16="http://schemas.microsoft.com/office/drawing/2014/main" id="{84D15B48-8FD4-4D43-8878-D2C96FF5CCA8}"/>
+                <a16:creationId xmlns:a16="http://schemas.microsoft.com/office/drawing/2014/main" id="{FA95821D-F9E5-41BE-96E8-CD331914B726}"/>
               </a:ext>
             </a:extLst>
           </p:cNvPr>
@@ -1923,7 +1923,7 @@
           <p:cNvPr id="4" name="Date Placeholder 3">
             <a:extLst xmlns:a="http://schemas.openxmlformats.org/drawingml/2006/main">
               <a:ext uri="{FF2B5EF4-FFF2-40B4-BE49-F238E27FC236}">
-                <a16:creationId xmlns:a16="http://schemas.microsoft.com/office/drawing/2014/main" id="{CDE0F18A-C1D2-4CB4-8E4D-3361546269A0}"/>
+                <a16:creationId xmlns:a16="http://schemas.microsoft.com/office/drawing/2014/main" id="{77AD88F8-A90B-4771-9850-FBF17603F88F}"/>
               </a:ext>
             </a:extLst>
           </p:cNvPr>
@@ -1951,7 +1951,7 @@
           <p:cNvPr id="5" name="Footer Placeholder 4">
             <a:extLst xmlns:a="http://schemas.openxmlformats.org/drawingml/2006/main">
               <a:ext uri="{FF2B5EF4-FFF2-40B4-BE49-F238E27FC236}">
-                <a16:creationId xmlns:a16="http://schemas.microsoft.com/office/drawing/2014/main" id="{DBEAA1F0-3328-48D2-9977-8B9A38BD874E}"/>
+                <a16:creationId xmlns:a16="http://schemas.microsoft.com/office/drawing/2014/main" id="{0421DF10-94EC-4736-99C5-CFEFA5C80D0D}"/>
               </a:ext>
             </a:extLst>
           </p:cNvPr>
@@ -1976,7 +1976,7 @@
           <p:cNvPr id="6" name="Slide Number Placeholder 5">
             <a:extLst xmlns:a="http://schemas.openxmlformats.org/drawingml/2006/main">
               <a:ext uri="{FF2B5EF4-FFF2-40B4-BE49-F238E27FC236}">
-                <a16:creationId xmlns:a16="http://schemas.microsoft.com/office/drawing/2014/main" id="{AC2A07CA-2E6D-4BE6-970C-3517401E911B}"/>
+                <a16:creationId xmlns:a16="http://schemas.microsoft.com/office/drawing/2014/main" id="{C1BFB7AF-DCB3-40F8-A33B-B7956606F6AE}"/>
               </a:ext>
             </a:extLst>
           </p:cNvPr>
@@ -2021,7 +2021,7 @@
           <p:cNvPr id="2" name="Vertical Title 1">
             <a:extLst xmlns:a="http://schemas.openxmlformats.org/drawingml/2006/main">
               <a:ext uri="{FF2B5EF4-FFF2-40B4-BE49-F238E27FC236}">
-                <a16:creationId xmlns:a16="http://schemas.microsoft.com/office/drawing/2014/main" id="{8EEBDC85-5C83-415B-9209-8107668138E8}"/>
+                <a16:creationId xmlns:a16="http://schemas.microsoft.com/office/drawing/2014/main" id="{6E67F6A4-15A5-44A2-9E14-51F4FDD7D415}"/>
               </a:ext>
             </a:extLst>
           </p:cNvPr>
@@ -2054,7 +2054,7 @@
           <p:cNvPr id="3" name="Vertical Text Placeholder 2">
             <a:extLst xmlns:a="http://schemas.openxmlformats.org/drawingml/2006/main">
               <a:ext uri="{FF2B5EF4-FFF2-40B4-BE49-F238E27FC236}">
-                <a16:creationId xmlns:a16="http://schemas.microsoft.com/office/drawing/2014/main" id="{2B1CA8F1-A9A7-4D6F-8BFD-84F21BAD6AD6}"/>
+                <a16:creationId xmlns:a16="http://schemas.microsoft.com/office/drawing/2014/main" id="{FA2DD4EF-A13C-44A9-ABEB-0F2F1250BF08}"/>
               </a:ext>
             </a:extLst>
           </p:cNvPr>
@@ -2122,7 +2122,7 @@
           <p:cNvPr id="4" name="Date Placeholder 3">
             <a:extLst xmlns:a="http://schemas.openxmlformats.org/drawingml/2006/main">
               <a:ext uri="{FF2B5EF4-FFF2-40B4-BE49-F238E27FC236}">
-                <a16:creationId xmlns:a16="http://schemas.microsoft.com/office/drawing/2014/main" id="{FA6A1A75-8BC2-4D0A-BBA8-43DDA347B40A}"/>
+                <a16:creationId xmlns:a16="http://schemas.microsoft.com/office/drawing/2014/main" id="{D4F3688D-A622-485A-BB2E-77C2FD2191EF}"/>
               </a:ext>
             </a:extLst>
           </p:cNvPr>
@@ -2150,7 +2150,7 @@
           <p:cNvPr id="5" name="Footer Placeholder 4">
             <a:extLst xmlns:a="http://schemas.openxmlformats.org/drawingml/2006/main">
               <a:ext uri="{FF2B5EF4-FFF2-40B4-BE49-F238E27FC236}">
-                <a16:creationId xmlns:a16="http://schemas.microsoft.com/office/drawing/2014/main" id="{738281CF-6176-403A-9169-4DAB269AA885}"/>
+                <a16:creationId xmlns:a16="http://schemas.microsoft.com/office/drawing/2014/main" id="{E4CAB964-8CB8-4F35-B710-1198079477B4}"/>
               </a:ext>
             </a:extLst>
           </p:cNvPr>
@@ -2175,7 +2175,7 @@
           <p:cNvPr id="6" name="Slide Number Placeholder 5">
             <a:extLst xmlns:a="http://schemas.openxmlformats.org/drawingml/2006/main">
               <a:ext uri="{FF2B5EF4-FFF2-40B4-BE49-F238E27FC236}">
-                <a16:creationId xmlns:a16="http://schemas.microsoft.com/office/drawing/2014/main" id="{38EBC3A9-2CD4-47AF-8E58-3E0D972B4703}"/>
+                <a16:creationId xmlns:a16="http://schemas.microsoft.com/office/drawing/2014/main" id="{2A2AEFAD-1A4D-454B-8158-989801E56293}"/>
               </a:ext>
             </a:extLst>
           </p:cNvPr>
@@ -2220,7 +2220,7 @@
           <p:cNvPr id="2" name="Title 1">
             <a:extLst xmlns:a="http://schemas.openxmlformats.org/drawingml/2006/main">
               <a:ext uri="{FF2B5EF4-FFF2-40B4-BE49-F238E27FC236}">
-                <a16:creationId xmlns:a16="http://schemas.microsoft.com/office/drawing/2014/main" id="{B67B8D94-4688-4146-BFE8-EDBD54BBD5A0}"/>
+                <a16:creationId xmlns:a16="http://schemas.microsoft.com/office/drawing/2014/main" id="{9B6FF9FF-875F-4312-BACA-D5B9D77ED431}"/>
               </a:ext>
             </a:extLst>
           </p:cNvPr>
@@ -2248,7 +2248,7 @@
           <p:cNvPr id="3" name="Content Placeholder 2">
             <a:extLst xmlns:a="http://schemas.openxmlformats.org/drawingml/2006/main">
               <a:ext uri="{FF2B5EF4-FFF2-40B4-BE49-F238E27FC236}">
-                <a16:creationId xmlns:a16="http://schemas.microsoft.com/office/drawing/2014/main" id="{5E8833FC-E042-461C-9FBE-4B0839EF442A}"/>
+                <a16:creationId xmlns:a16="http://schemas.microsoft.com/office/drawing/2014/main" id="{F4FA4164-6232-4B36-B23F-1526994C253E}"/>
               </a:ext>
             </a:extLst>
           </p:cNvPr>
@@ -2311,7 +2311,7 @@
           <p:cNvPr id="4" name="Date Placeholder 3">
             <a:extLst xmlns:a="http://schemas.openxmlformats.org/drawingml/2006/main">
               <a:ext uri="{FF2B5EF4-FFF2-40B4-BE49-F238E27FC236}">
-                <a16:creationId xmlns:a16="http://schemas.microsoft.com/office/drawing/2014/main" id="{1FF78225-5405-48B3-9720-3260F6036473}"/>
+                <a16:creationId xmlns:a16="http://schemas.microsoft.com/office/drawing/2014/main" id="{4A16A9CB-5307-4C46-B356-F105A17754ED}"/>
               </a:ext>
             </a:extLst>
           </p:cNvPr>
@@ -2339,7 +2339,7 @@
           <p:cNvPr id="5" name="Footer Placeholder 4">
             <a:extLst xmlns:a="http://schemas.openxmlformats.org/drawingml/2006/main">
               <a:ext uri="{FF2B5EF4-FFF2-40B4-BE49-F238E27FC236}">
-                <a16:creationId xmlns:a16="http://schemas.microsoft.com/office/drawing/2014/main" id="{C9508622-9065-4DD5-9E19-9BD0C5ACC8A6}"/>
+                <a16:creationId xmlns:a16="http://schemas.microsoft.com/office/drawing/2014/main" id="{1BDBAEE5-BFAD-426B-B62E-A257A07D0BBC}"/>
               </a:ext>
             </a:extLst>
           </p:cNvPr>
@@ -2364,7 +2364,7 @@
           <p:cNvPr id="6" name="Slide Number Placeholder 5">
             <a:extLst xmlns:a="http://schemas.openxmlformats.org/drawingml/2006/main">
               <a:ext uri="{FF2B5EF4-FFF2-40B4-BE49-F238E27FC236}">
-                <a16:creationId xmlns:a16="http://schemas.microsoft.com/office/drawing/2014/main" id="{7213BA54-BFA8-4ACF-AF21-404BB1F401C9}"/>
+                <a16:creationId xmlns:a16="http://schemas.microsoft.com/office/drawing/2014/main" id="{6765877F-ED6F-4DBE-B4AE-ABE584F3DB6D}"/>
               </a:ext>
             </a:extLst>
           </p:cNvPr>
@@ -2409,7 +2409,7 @@
           <p:cNvPr id="2" name="Title 1">
             <a:extLst xmlns:a="http://schemas.openxmlformats.org/drawingml/2006/main">
               <a:ext uri="{FF2B5EF4-FFF2-40B4-BE49-F238E27FC236}">
-                <a16:creationId xmlns:a16="http://schemas.microsoft.com/office/drawing/2014/main" id="{B2B74632-442F-4355-B638-9405A2AA8E14}"/>
+                <a16:creationId xmlns:a16="http://schemas.microsoft.com/office/drawing/2014/main" id="{0B8F94E9-93FD-4FB8-B0B0-5840F12F4A2D}"/>
               </a:ext>
             </a:extLst>
           </p:cNvPr>
@@ -2447,7 +2447,7 @@
           <p:cNvPr id="3" name="Text Placeholder 2">
             <a:extLst xmlns:a="http://schemas.openxmlformats.org/drawingml/2006/main">
               <a:ext uri="{FF2B5EF4-FFF2-40B4-BE49-F238E27FC236}">
-                <a16:creationId xmlns:a16="http://schemas.microsoft.com/office/drawing/2014/main" id="{C0240103-CAE5-4C62-9D8F-1A20D33CE43D}"/>
+                <a16:creationId xmlns:a16="http://schemas.microsoft.com/office/drawing/2014/main" id="{8D5DD8E8-5C51-4DF8-B705-2C05039744DF}"/>
               </a:ext>
             </a:extLst>
           </p:cNvPr>
@@ -2573,7 +2573,7 @@
           <p:cNvPr id="4" name="Date Placeholder 3">
             <a:extLst xmlns:a="http://schemas.openxmlformats.org/drawingml/2006/main">
               <a:ext uri="{FF2B5EF4-FFF2-40B4-BE49-F238E27FC236}">
-                <a16:creationId xmlns:a16="http://schemas.microsoft.com/office/drawing/2014/main" id="{3CF1F627-0305-4FD7-9BB2-66E1F7D8A181}"/>
+                <a16:creationId xmlns:a16="http://schemas.microsoft.com/office/drawing/2014/main" id="{ED3F615D-DA01-4272-8928-CCBFB406F4EA}"/>
               </a:ext>
             </a:extLst>
           </p:cNvPr>
@@ -2601,7 +2601,7 @@
           <p:cNvPr id="5" name="Footer Placeholder 4">
             <a:extLst xmlns:a="http://schemas.openxmlformats.org/drawingml/2006/main">
               <a:ext uri="{FF2B5EF4-FFF2-40B4-BE49-F238E27FC236}">
-                <a16:creationId xmlns:a16="http://schemas.microsoft.com/office/drawing/2014/main" id="{2D54A19D-BD09-4155-8B7A-6623FF02CFFE}"/>
+                <a16:creationId xmlns:a16="http://schemas.microsoft.com/office/drawing/2014/main" id="{A4090429-29F5-49AD-88D6-583C4633462A}"/>
               </a:ext>
             </a:extLst>
           </p:cNvPr>
@@ -2626,7 +2626,7 @@
           <p:cNvPr id="6" name="Slide Number Placeholder 5">
             <a:extLst xmlns:a="http://schemas.openxmlformats.org/drawingml/2006/main">
               <a:ext uri="{FF2B5EF4-FFF2-40B4-BE49-F238E27FC236}">
-                <a16:creationId xmlns:a16="http://schemas.microsoft.com/office/drawing/2014/main" id="{5069A511-726E-4BF2-BD17-1FC39AFA88BC}"/>
+                <a16:creationId xmlns:a16="http://schemas.microsoft.com/office/drawing/2014/main" id="{EF5261B8-D77A-4C4C-B5C5-D3450E605F40}"/>
               </a:ext>
             </a:extLst>
           </p:cNvPr>
@@ -2671,7 +2671,7 @@
           <p:cNvPr id="2" name="Title 1">
             <a:extLst xmlns:a="http://schemas.openxmlformats.org/drawingml/2006/main">
               <a:ext uri="{FF2B5EF4-FFF2-40B4-BE49-F238E27FC236}">
-                <a16:creationId xmlns:a16="http://schemas.microsoft.com/office/drawing/2014/main" id="{1A81C51C-F18E-4EEB-9F1A-2CAA2BF50D3A}"/>
+                <a16:creationId xmlns:a16="http://schemas.microsoft.com/office/drawing/2014/main" id="{65D0AB67-EA38-48B9-B15C-891E6E734EE9}"/>
               </a:ext>
             </a:extLst>
           </p:cNvPr>
@@ -2699,7 +2699,7 @@
           <p:cNvPr id="3" name="Content Placeholder 2">
             <a:extLst xmlns:a="http://schemas.openxmlformats.org/drawingml/2006/main">
               <a:ext uri="{FF2B5EF4-FFF2-40B4-BE49-F238E27FC236}">
-                <a16:creationId xmlns:a16="http://schemas.microsoft.com/office/drawing/2014/main" id="{FE2BDF15-6368-499D-B841-E23549123689}"/>
+                <a16:creationId xmlns:a16="http://schemas.microsoft.com/office/drawing/2014/main" id="{7C3DF601-7173-4BA9-88F9-02A362EE87D4}"/>
               </a:ext>
             </a:extLst>
           </p:cNvPr>
@@ -2804,7 +2804,7 @@
           <p:cNvPr id="4" name="Content Placeholder 3">
             <a:extLst xmlns:a="http://schemas.openxmlformats.org/drawingml/2006/main">
               <a:ext uri="{FF2B5EF4-FFF2-40B4-BE49-F238E27FC236}">
-                <a16:creationId xmlns:a16="http://schemas.microsoft.com/office/drawing/2014/main" id="{0C8B2580-A070-4E6C-A841-4BC6FD9744AD}"/>
+                <a16:creationId xmlns:a16="http://schemas.microsoft.com/office/drawing/2014/main" id="{6459DD36-18BD-4CFF-9B5C-77CCCF7AFE9D}"/>
               </a:ext>
             </a:extLst>
           </p:cNvPr>
@@ -2909,7 +2909,7 @@
           <p:cNvPr id="5" name="Date Placeholder 4">
             <a:extLst xmlns:a="http://schemas.openxmlformats.org/drawingml/2006/main">
               <a:ext uri="{FF2B5EF4-FFF2-40B4-BE49-F238E27FC236}">
-                <a16:creationId xmlns:a16="http://schemas.microsoft.com/office/drawing/2014/main" id="{7A3A53CD-7EA0-4DFC-B5A9-A6FCAEB41334}"/>
+                <a16:creationId xmlns:a16="http://schemas.microsoft.com/office/drawing/2014/main" id="{30C3ED9A-9EF5-4249-B52D-0671CDB6917D}"/>
               </a:ext>
             </a:extLst>
           </p:cNvPr>
@@ -2937,7 +2937,7 @@
           <p:cNvPr id="6" name="Footer Placeholder 5">
             <a:extLst xmlns:a="http://schemas.openxmlformats.org/drawingml/2006/main">
               <a:ext uri="{FF2B5EF4-FFF2-40B4-BE49-F238E27FC236}">
-                <a16:creationId xmlns:a16="http://schemas.microsoft.com/office/drawing/2014/main" id="{ACEC179D-4D00-4FFC-AA83-CAEBD38B6D02}"/>
+                <a16:creationId xmlns:a16="http://schemas.microsoft.com/office/drawing/2014/main" id="{01B6A607-6782-4F74-9970-241E2833ACE8}"/>
               </a:ext>
             </a:extLst>
           </p:cNvPr>
@@ -2962,7 +2962,7 @@
           <p:cNvPr id="7" name="Slide Number Placeholder 6">
             <a:extLst xmlns:a="http://schemas.openxmlformats.org/drawingml/2006/main">
               <a:ext uri="{FF2B5EF4-FFF2-40B4-BE49-F238E27FC236}">
-                <a16:creationId xmlns:a16="http://schemas.microsoft.com/office/drawing/2014/main" id="{37E75401-1A84-410A-90F7-B528D1662277}"/>
+                <a16:creationId xmlns:a16="http://schemas.microsoft.com/office/drawing/2014/main" id="{3BEF2BBF-8480-4C35-A8B3-11D980E3C776}"/>
               </a:ext>
             </a:extLst>
           </p:cNvPr>
@@ -3007,7 +3007,7 @@
           <p:cNvPr id="2" name="Title 1">
             <a:extLst xmlns:a="http://schemas.openxmlformats.org/drawingml/2006/main">
               <a:ext uri="{FF2B5EF4-FFF2-40B4-BE49-F238E27FC236}">
-                <a16:creationId xmlns:a16="http://schemas.microsoft.com/office/drawing/2014/main" id="{650BAE0C-5CF6-40D3-BC14-575E7EF316FA}"/>
+                <a16:creationId xmlns:a16="http://schemas.microsoft.com/office/drawing/2014/main" id="{1771B203-4114-4AA9-B583-13CECB511466}"/>
               </a:ext>
             </a:extLst>
           </p:cNvPr>
@@ -3040,7 +3040,7 @@
           <p:cNvPr id="3" name="Text Placeholder 2">
             <a:extLst xmlns:a="http://schemas.openxmlformats.org/drawingml/2006/main">
               <a:ext uri="{FF2B5EF4-FFF2-40B4-BE49-F238E27FC236}">
-                <a16:creationId xmlns:a16="http://schemas.microsoft.com/office/drawing/2014/main" id="{A403E099-C5C3-4478-BF9A-885D0F62F739}"/>
+                <a16:creationId xmlns:a16="http://schemas.microsoft.com/office/drawing/2014/main" id="{BD1F1253-BC65-46A8-A8A6-D5ABE0761314}"/>
               </a:ext>
             </a:extLst>
           </p:cNvPr>
@@ -3112,7 +3112,7 @@
           <p:cNvPr id="4" name="Content Placeholder 3">
             <a:extLst xmlns:a="http://schemas.openxmlformats.org/drawingml/2006/main">
               <a:ext uri="{FF2B5EF4-FFF2-40B4-BE49-F238E27FC236}">
-                <a16:creationId xmlns:a16="http://schemas.microsoft.com/office/drawing/2014/main" id="{41D7E936-D5B4-4A85-A1FF-18A8EEAC19F1}"/>
+                <a16:creationId xmlns:a16="http://schemas.microsoft.com/office/drawing/2014/main" id="{DD080C5C-8879-476C-9C7C-E9ECD5D4F1B4}"/>
               </a:ext>
             </a:extLst>
           </p:cNvPr>
@@ -3217,7 +3217,7 @@
           <p:cNvPr id="5" name="Text Placeholder 4">
             <a:extLst xmlns:a="http://schemas.openxmlformats.org/drawingml/2006/main">
               <a:ext uri="{FF2B5EF4-FFF2-40B4-BE49-F238E27FC236}">
-                <a16:creationId xmlns:a16="http://schemas.microsoft.com/office/drawing/2014/main" id="{59DA8200-7B6E-4D1D-AED5-38A72D0D1B35}"/>
+                <a16:creationId xmlns:a16="http://schemas.microsoft.com/office/drawing/2014/main" id="{B8E739A5-BEA5-4412-B0B0-881BA71D2666}"/>
               </a:ext>
             </a:extLst>
           </p:cNvPr>
@@ -3289,7 +3289,7 @@
           <p:cNvPr id="6" name="Content Placeholder 5">
             <a:extLst xmlns:a="http://schemas.openxmlformats.org/drawingml/2006/main">
               <a:ext uri="{FF2B5EF4-FFF2-40B4-BE49-F238E27FC236}">
-                <a16:creationId xmlns:a16="http://schemas.microsoft.com/office/drawing/2014/main" id="{38AB1871-58AA-47C0-B71D-97A8C3FDE63B}"/>
+                <a16:creationId xmlns:a16="http://schemas.microsoft.com/office/drawing/2014/main" id="{94AFA5E1-EBA2-4BE6-897F-0EDACC7A559D}"/>
               </a:ext>
             </a:extLst>
           </p:cNvPr>
@@ -3394,7 +3394,7 @@
           <p:cNvPr id="7" name="Date Placeholder 6">
             <a:extLst xmlns:a="http://schemas.openxmlformats.org/drawingml/2006/main">
               <a:ext uri="{FF2B5EF4-FFF2-40B4-BE49-F238E27FC236}">
-                <a16:creationId xmlns:a16="http://schemas.microsoft.com/office/drawing/2014/main" id="{87644B2C-B3CB-4127-9930-5ECC249D2903}"/>
+                <a16:creationId xmlns:a16="http://schemas.microsoft.com/office/drawing/2014/main" id="{B82B7635-EB43-4B61-B55C-557C64B3861A}"/>
               </a:ext>
             </a:extLst>
           </p:cNvPr>
@@ -3422,7 +3422,7 @@
           <p:cNvPr id="8" name="Footer Placeholder 7">
             <a:extLst xmlns:a="http://schemas.openxmlformats.org/drawingml/2006/main">
               <a:ext uri="{FF2B5EF4-FFF2-40B4-BE49-F238E27FC236}">
-                <a16:creationId xmlns:a16="http://schemas.microsoft.com/office/drawing/2014/main" id="{07AEB394-16FD-4B8D-B139-B0D95B73635A}"/>
+                <a16:creationId xmlns:a16="http://schemas.microsoft.com/office/drawing/2014/main" id="{F77AF853-0FE2-457B-BBC9-A5DC373B519C}"/>
               </a:ext>
             </a:extLst>
           </p:cNvPr>
@@ -3447,7 +3447,7 @@
           <p:cNvPr id="9" name="Slide Number Placeholder 8">
             <a:extLst xmlns:a="http://schemas.openxmlformats.org/drawingml/2006/main">
               <a:ext uri="{FF2B5EF4-FFF2-40B4-BE49-F238E27FC236}">
-                <a16:creationId xmlns:a16="http://schemas.microsoft.com/office/drawing/2014/main" id="{049C5653-B8EB-4584-ADD4-30B9DD7175B6}"/>
+                <a16:creationId xmlns:a16="http://schemas.microsoft.com/office/drawing/2014/main" id="{4DC66136-37E8-4AB7-8E13-9BAF9B1D4D0F}"/>
               </a:ext>
             </a:extLst>
           </p:cNvPr>
@@ -3492,7 +3492,7 @@
           <p:cNvPr id="2" name="Title 1">
             <a:extLst xmlns:a="http://schemas.openxmlformats.org/drawingml/2006/main">
               <a:ext uri="{FF2B5EF4-FFF2-40B4-BE49-F238E27FC236}">
-                <a16:creationId xmlns:a16="http://schemas.microsoft.com/office/drawing/2014/main" id="{9A79C238-B0B7-42BA-8E33-58FE3FD83561}"/>
+                <a16:creationId xmlns:a16="http://schemas.microsoft.com/office/drawing/2014/main" id="{FE82D91A-4923-431C-9C83-65755454D9B0}"/>
               </a:ext>
             </a:extLst>
           </p:cNvPr>
@@ -3520,7 +3520,7 @@
           <p:cNvPr id="3" name="Date Placeholder 2">
             <a:extLst xmlns:a="http://schemas.openxmlformats.org/drawingml/2006/main">
               <a:ext uri="{FF2B5EF4-FFF2-40B4-BE49-F238E27FC236}">
-                <a16:creationId xmlns:a16="http://schemas.microsoft.com/office/drawing/2014/main" id="{4A7B3E59-6FB6-4119-86F1-82F068CAF057}"/>
+                <a16:creationId xmlns:a16="http://schemas.microsoft.com/office/drawing/2014/main" id="{A409104B-C479-4F0F-861C-39AEC7101BA2}"/>
               </a:ext>
             </a:extLst>
           </p:cNvPr>
@@ -3548,7 +3548,7 @@
           <p:cNvPr id="4" name="Footer Placeholder 3">
             <a:extLst xmlns:a="http://schemas.openxmlformats.org/drawingml/2006/main">
               <a:ext uri="{FF2B5EF4-FFF2-40B4-BE49-F238E27FC236}">
-                <a16:creationId xmlns:a16="http://schemas.microsoft.com/office/drawing/2014/main" id="{2910D873-D102-4A33-8958-2F1DD1A472E5}"/>
+                <a16:creationId xmlns:a16="http://schemas.microsoft.com/office/drawing/2014/main" id="{078156E6-499A-41C4-B6C5-B638A6B5A2DC}"/>
               </a:ext>
             </a:extLst>
           </p:cNvPr>
@@ -3573,7 +3573,7 @@
           <p:cNvPr id="5" name="Slide Number Placeholder 4">
             <a:extLst xmlns:a="http://schemas.openxmlformats.org/drawingml/2006/main">
               <a:ext uri="{FF2B5EF4-FFF2-40B4-BE49-F238E27FC236}">
-                <a16:creationId xmlns:a16="http://schemas.microsoft.com/office/drawing/2014/main" id="{21F38A83-DCB0-42E8-B8E8-E613A1001756}"/>
+                <a16:creationId xmlns:a16="http://schemas.microsoft.com/office/drawing/2014/main" id="{F9D4F3F0-FF4B-4406-B3EB-3C7A8AB9416C}"/>
               </a:ext>
             </a:extLst>
           </p:cNvPr>
@@ -3618,7 +3618,7 @@
           <p:cNvPr id="2" name="Date Placeholder 1">
             <a:extLst xmlns:a="http://schemas.openxmlformats.org/drawingml/2006/main">
               <a:ext uri="{FF2B5EF4-FFF2-40B4-BE49-F238E27FC236}">
-                <a16:creationId xmlns:a16="http://schemas.microsoft.com/office/drawing/2014/main" id="{A4260A55-751B-4755-9CEF-81C147005B5D}"/>
+                <a16:creationId xmlns:a16="http://schemas.microsoft.com/office/drawing/2014/main" id="{10B339A7-EE3B-4235-8F3C-FB2E336E764D}"/>
               </a:ext>
             </a:extLst>
           </p:cNvPr>
@@ -3646,7 +3646,7 @@
           <p:cNvPr id="3" name="Footer Placeholder 2">
             <a:extLst xmlns:a="http://schemas.openxmlformats.org/drawingml/2006/main">
               <a:ext uri="{FF2B5EF4-FFF2-40B4-BE49-F238E27FC236}">
-                <a16:creationId xmlns:a16="http://schemas.microsoft.com/office/drawing/2014/main" id="{8348BB24-5C21-4318-8DEF-23F8E2C65856}"/>
+                <a16:creationId xmlns:a16="http://schemas.microsoft.com/office/drawing/2014/main" id="{74E2F900-7F59-4976-A79F-2E8A4C58FE81}"/>
               </a:ext>
             </a:extLst>
           </p:cNvPr>
@@ -3671,7 +3671,7 @@
           <p:cNvPr id="4" name="Slide Number Placeholder 3">
             <a:extLst xmlns:a="http://schemas.openxmlformats.org/drawingml/2006/main">
               <a:ext uri="{FF2B5EF4-FFF2-40B4-BE49-F238E27FC236}">
-                <a16:creationId xmlns:a16="http://schemas.microsoft.com/office/drawing/2014/main" id="{BE83BFA9-CBC7-4A9F-B92A-3277AF05F268}"/>
+                <a16:creationId xmlns:a16="http://schemas.microsoft.com/office/drawing/2014/main" id="{BB1C555D-9D60-4CC3-8062-073E8EFCE9D4}"/>
               </a:ext>
             </a:extLst>
           </p:cNvPr>
@@ -3716,7 +3716,7 @@
           <p:cNvPr id="2" name="Title 1">
             <a:extLst xmlns:a="http://schemas.openxmlformats.org/drawingml/2006/main">
               <a:ext uri="{FF2B5EF4-FFF2-40B4-BE49-F238E27FC236}">
-                <a16:creationId xmlns:a16="http://schemas.microsoft.com/office/drawing/2014/main" id="{B845A60D-DBFB-4C16-9CA2-DE225AA19252}"/>
+                <a16:creationId xmlns:a16="http://schemas.microsoft.com/office/drawing/2014/main" id="{65BF5BF5-96D6-4DDB-8D64-201B0319C415}"/>
               </a:ext>
             </a:extLst>
           </p:cNvPr>
@@ -3754,7 +3754,7 @@
           <p:cNvPr id="3" name="Content Placeholder 2">
             <a:extLst xmlns:a="http://schemas.openxmlformats.org/drawingml/2006/main">
               <a:ext uri="{FF2B5EF4-FFF2-40B4-BE49-F238E27FC236}">
-                <a16:creationId xmlns:a16="http://schemas.microsoft.com/office/drawing/2014/main" id="{E193F75F-C310-4633-900B-6E4627C49819}"/>
+                <a16:creationId xmlns:a16="http://schemas.microsoft.com/office/drawing/2014/main" id="{541736E2-53F5-4245-9CC4-C72306035975}"/>
               </a:ext>
             </a:extLst>
           </p:cNvPr>
@@ -3859,7 +3859,7 @@
           <p:cNvPr id="4" name="Text Placeholder 3">
             <a:extLst xmlns:a="http://schemas.openxmlformats.org/drawingml/2006/main">
               <a:ext uri="{FF2B5EF4-FFF2-40B4-BE49-F238E27FC236}">
-                <a16:creationId xmlns:a16="http://schemas.microsoft.com/office/drawing/2014/main" id="{4CDF1625-6F25-4C65-BC9E-8D92AE1E8E04}"/>
+                <a16:creationId xmlns:a16="http://schemas.microsoft.com/office/drawing/2014/main" id="{A504811D-462D-4183-85CC-C845CD704427}"/>
               </a:ext>
             </a:extLst>
           </p:cNvPr>
@@ -3931,7 +3931,7 @@
           <p:cNvPr id="5" name="Date Placeholder 4">
             <a:extLst xmlns:a="http://schemas.openxmlformats.org/drawingml/2006/main">
               <a:ext uri="{FF2B5EF4-FFF2-40B4-BE49-F238E27FC236}">
-                <a16:creationId xmlns:a16="http://schemas.microsoft.com/office/drawing/2014/main" id="{C3B515C6-37D6-453A-80CA-B7EAE8E86679}"/>
+                <a16:creationId xmlns:a16="http://schemas.microsoft.com/office/drawing/2014/main" id="{76F552F3-8440-4A26-AFDD-9CD497B7F20A}"/>
               </a:ext>
             </a:extLst>
           </p:cNvPr>
@@ -3959,7 +3959,7 @@
           <p:cNvPr id="6" name="Footer Placeholder 5">
             <a:extLst xmlns:a="http://schemas.openxmlformats.org/drawingml/2006/main">
               <a:ext uri="{FF2B5EF4-FFF2-40B4-BE49-F238E27FC236}">
-                <a16:creationId xmlns:a16="http://schemas.microsoft.com/office/drawing/2014/main" id="{612F0E3A-D0C7-4B78-A435-CBFF0648D2B8}"/>
+                <a16:creationId xmlns:a16="http://schemas.microsoft.com/office/drawing/2014/main" id="{8F0F0DD5-C925-4C03-A1BB-0FCDCAF0D54E}"/>
               </a:ext>
             </a:extLst>
           </p:cNvPr>
@@ -3984,7 +3984,7 @@
           <p:cNvPr id="7" name="Slide Number Placeholder 6">
             <a:extLst xmlns:a="http://schemas.openxmlformats.org/drawingml/2006/main">
               <a:ext uri="{FF2B5EF4-FFF2-40B4-BE49-F238E27FC236}">
-                <a16:creationId xmlns:a16="http://schemas.microsoft.com/office/drawing/2014/main" id="{CE2E0C7F-E08A-42DE-846D-CEE02EBB29EC}"/>
+                <a16:creationId xmlns:a16="http://schemas.microsoft.com/office/drawing/2014/main" id="{EB2F0106-24DE-4605-A6CF-8F1B970F65F7}"/>
               </a:ext>
             </a:extLst>
           </p:cNvPr>
@@ -4029,7 +4029,7 @@
           <p:cNvPr id="2" name="Title 1">
             <a:extLst xmlns:a="http://schemas.openxmlformats.org/drawingml/2006/main">
               <a:ext uri="{FF2B5EF4-FFF2-40B4-BE49-F238E27FC236}">
-                <a16:creationId xmlns:a16="http://schemas.microsoft.com/office/drawing/2014/main" id="{BCDA3500-A98E-42D7-915C-C4B94E996C15}"/>
+                <a16:creationId xmlns:a16="http://schemas.microsoft.com/office/drawing/2014/main" id="{24C4E417-A32D-4800-827A-34884CCDDA0F}"/>
               </a:ext>
             </a:extLst>
           </p:cNvPr>
@@ -4067,7 +4067,7 @@
           <p:cNvPr id="3" name="Picture Placeholder 2">
             <a:extLst xmlns:a="http://schemas.openxmlformats.org/drawingml/2006/main">
               <a:ext uri="{FF2B5EF4-FFF2-40B4-BE49-F238E27FC236}">
-                <a16:creationId xmlns:a16="http://schemas.microsoft.com/office/drawing/2014/main" id="{306C3FB7-879D-40F3-9EA3-F1E4C8096319}"/>
+                <a16:creationId xmlns:a16="http://schemas.microsoft.com/office/drawing/2014/main" id="{CBC4BB2B-314B-4E65-AA34-BA530E8CCA11}"/>
               </a:ext>
             </a:extLst>
           </p:cNvPr>
@@ -4134,7 +4134,7 @@
           <p:cNvPr id="4" name="Text Placeholder 3">
             <a:extLst xmlns:a="http://schemas.openxmlformats.org/drawingml/2006/main">
               <a:ext uri="{FF2B5EF4-FFF2-40B4-BE49-F238E27FC236}">
-                <a16:creationId xmlns:a16="http://schemas.microsoft.com/office/drawing/2014/main" id="{9A405AC1-9650-494E-B486-6AE02AA47C55}"/>
+                <a16:creationId xmlns:a16="http://schemas.microsoft.com/office/drawing/2014/main" id="{8C932EE7-4699-4B80-AEC3-7B55C3C24E5A}"/>
               </a:ext>
             </a:extLst>
           </p:cNvPr>
@@ -4206,7 +4206,7 @@
           <p:cNvPr id="5" name="Date Placeholder 4">
             <a:extLst xmlns:a="http://schemas.openxmlformats.org/drawingml/2006/main">
               <a:ext uri="{FF2B5EF4-FFF2-40B4-BE49-F238E27FC236}">
-                <a16:creationId xmlns:a16="http://schemas.microsoft.com/office/drawing/2014/main" id="{073E8210-4201-4218-9B6A-7F9D8789808B}"/>
+                <a16:creationId xmlns:a16="http://schemas.microsoft.com/office/drawing/2014/main" id="{958A5D28-233D-4D00-B50F-9FFB511AF003}"/>
               </a:ext>
             </a:extLst>
           </p:cNvPr>
@@ -4234,7 +4234,7 @@
           <p:cNvPr id="6" name="Footer Placeholder 5">
             <a:extLst xmlns:a="http://schemas.openxmlformats.org/drawingml/2006/main">
               <a:ext uri="{FF2B5EF4-FFF2-40B4-BE49-F238E27FC236}">
-                <a16:creationId xmlns:a16="http://schemas.microsoft.com/office/drawing/2014/main" id="{B71F4330-5262-4D4D-85B7-6CC100333AE1}"/>
+                <a16:creationId xmlns:a16="http://schemas.microsoft.com/office/drawing/2014/main" id="{683B2D78-E206-415A-9DB3-D7F30E9A2AA1}"/>
               </a:ext>
             </a:extLst>
           </p:cNvPr>
@@ -4259,7 +4259,7 @@
           <p:cNvPr id="7" name="Slide Number Placeholder 6">
             <a:extLst xmlns:a="http://schemas.openxmlformats.org/drawingml/2006/main">
               <a:ext uri="{FF2B5EF4-FFF2-40B4-BE49-F238E27FC236}">
-                <a16:creationId xmlns:a16="http://schemas.microsoft.com/office/drawing/2014/main" id="{1D504ADB-B612-4E95-A5D8-13BDAC41BD07}"/>
+                <a16:creationId xmlns:a16="http://schemas.microsoft.com/office/drawing/2014/main" id="{DECC86F9-BA55-4203-BCAE-21176AF7C8DF}"/>
               </a:ext>
             </a:extLst>
           </p:cNvPr>
@@ -4309,7 +4309,7 @@
           <p:cNvPr id="2" name="Title Placeholder 1">
             <a:extLst xmlns:a="http://schemas.openxmlformats.org/drawingml/2006/main">
               <a:ext uri="{FF2B5EF4-FFF2-40B4-BE49-F238E27FC236}">
-                <a16:creationId xmlns:a16="http://schemas.microsoft.com/office/drawing/2014/main" id="{1FC9767C-250C-4495-9E87-57F5E055A207}"/>
+                <a16:creationId xmlns:a16="http://schemas.microsoft.com/office/drawing/2014/main" id="{4F8E3EC9-0615-4052-A1A0-0B6DBC975779}"/>
               </a:ext>
             </a:extLst>
           </p:cNvPr>
@@ -4347,7 +4347,7 @@
           <p:cNvPr id="3" name="Text Placeholder 2">
             <a:extLst xmlns:a="http://schemas.openxmlformats.org/drawingml/2006/main">
               <a:ext uri="{FF2B5EF4-FFF2-40B4-BE49-F238E27FC236}">
-                <a16:creationId xmlns:a16="http://schemas.microsoft.com/office/drawing/2014/main" id="{E8594496-FF93-47D6-8431-1D7A177736D4}"/>
+                <a16:creationId xmlns:a16="http://schemas.microsoft.com/office/drawing/2014/main" id="{728292A3-0B46-4068-B388-0DFE8A6E885A}"/>
               </a:ext>
             </a:extLst>
           </p:cNvPr>
@@ -4420,7 +4420,7 @@
           <p:cNvPr id="4" name="Date Placeholder 3">
             <a:extLst xmlns:a="http://schemas.openxmlformats.org/drawingml/2006/main">
               <a:ext uri="{FF2B5EF4-FFF2-40B4-BE49-F238E27FC236}">
-                <a16:creationId xmlns:a16="http://schemas.microsoft.com/office/drawing/2014/main" id="{C3A523DF-00DB-4B51-B915-7654C6061530}"/>
+                <a16:creationId xmlns:a16="http://schemas.microsoft.com/office/drawing/2014/main" id="{0AA98101-8C6E-4D03-8ACB-9EC0212C229D}"/>
               </a:ext>
             </a:extLst>
           </p:cNvPr>
@@ -4467,7 +4467,7 @@
           <p:cNvPr id="5" name="Footer Placeholder 4">
             <a:extLst xmlns:a="http://schemas.openxmlformats.org/drawingml/2006/main">
               <a:ext uri="{FF2B5EF4-FFF2-40B4-BE49-F238E27FC236}">
-                <a16:creationId xmlns:a16="http://schemas.microsoft.com/office/drawing/2014/main" id="{86BDB433-D7B3-46F8-AD63-518BCB96CC60}"/>
+                <a16:creationId xmlns:a16="http://schemas.microsoft.com/office/drawing/2014/main" id="{DF1139C0-215D-4529-A960-4B8E369FA920}"/>
               </a:ext>
             </a:extLst>
           </p:cNvPr>
@@ -4511,7 +4511,7 @@
           <p:cNvPr id="6" name="Slide Number Placeholder 5">
             <a:extLst xmlns:a="http://schemas.openxmlformats.org/drawingml/2006/main">
               <a:ext uri="{FF2B5EF4-FFF2-40B4-BE49-F238E27FC236}">
-                <a16:creationId xmlns:a16="http://schemas.microsoft.com/office/drawing/2014/main" id="{1FFDEB83-1840-48E2-B4C1-025730A72DEB}"/>
+                <a16:creationId xmlns:a16="http://schemas.microsoft.com/office/drawing/2014/main" id="{B904CB97-9792-464E-804B-BFCA0CA69BCE}"/>
               </a:ext>
             </a:extLst>
           </p:cNvPr>
@@ -4557,17 +4557,17 @@
   </p:cSld>
   <p:clrMap bg1="lt1" tx1="dk1" bg2="lt2" tx2="dk2" accent1="accent1" accent2="accent2" accent3="accent3" accent4="accent4" accent5="accent5" accent6="accent6" hlink="hlink" folHlink="folHlink"/>
   <p:sldLayoutIdLst>
-    <p:sldLayoutId xmlns:r="http://schemas.openxmlformats.org/officeDocument/2006/relationships" id="2147483649" r:id="R6fbba830e2bf44f3"/>
-    <p:sldLayoutId xmlns:r="http://schemas.openxmlformats.org/officeDocument/2006/relationships" id="2147483650" r:id="Rcf53c79d937c43fd"/>
-    <p:sldLayoutId xmlns:r="http://schemas.openxmlformats.org/officeDocument/2006/relationships" id="2147483651" r:id="R6828dca130a14e71"/>
-    <p:sldLayoutId xmlns:r="http://schemas.openxmlformats.org/officeDocument/2006/relationships" id="2147483652" r:id="R655df3797908481c"/>
-    <p:sldLayoutId xmlns:r="http://schemas.openxmlformats.org/officeDocument/2006/relationships" id="2147483653" r:id="R165ab68bd1a9462e"/>
-    <p:sldLayoutId xmlns:r="http://schemas.openxmlformats.org/officeDocument/2006/relationships" id="2147483654" r:id="Rbe9c1803ed3a484e"/>
-    <p:sldLayoutId xmlns:r="http://schemas.openxmlformats.org/officeDocument/2006/relationships" id="2147483655" r:id="R62378c32967c40f9"/>
-    <p:sldLayoutId xmlns:r="http://schemas.openxmlformats.org/officeDocument/2006/relationships" id="2147483656" r:id="Rb464b537dd924951"/>
-    <p:sldLayoutId xmlns:r="http://schemas.openxmlformats.org/officeDocument/2006/relationships" id="2147483657" r:id="Rb7e5dac8e8864181"/>
-    <p:sldLayoutId xmlns:r="http://schemas.openxmlformats.org/officeDocument/2006/relationships" id="2147483658" r:id="R42536b05d6904da3"/>
-    <p:sldLayoutId xmlns:r="http://schemas.openxmlformats.org/officeDocument/2006/relationships" id="2147483659" r:id="R03348f632aee40c2"/>
+    <p:sldLayoutId xmlns:r="http://schemas.openxmlformats.org/officeDocument/2006/relationships" id="2147483649" r:id="R641dd68c061a4b22"/>
+    <p:sldLayoutId xmlns:r="http://schemas.openxmlformats.org/officeDocument/2006/relationships" id="2147483650" r:id="Rfbf963db5127439b"/>
+    <p:sldLayoutId xmlns:r="http://schemas.openxmlformats.org/officeDocument/2006/relationships" id="2147483651" r:id="R852e0b58281543cb"/>
+    <p:sldLayoutId xmlns:r="http://schemas.openxmlformats.org/officeDocument/2006/relationships" id="2147483652" r:id="Rd2cde7f02ed24c8b"/>
+    <p:sldLayoutId xmlns:r="http://schemas.openxmlformats.org/officeDocument/2006/relationships" id="2147483653" r:id="R6d4a82764a5343c5"/>
+    <p:sldLayoutId xmlns:r="http://schemas.openxmlformats.org/officeDocument/2006/relationships" id="2147483654" r:id="Rc8ae4e508c0c4a1e"/>
+    <p:sldLayoutId xmlns:r="http://schemas.openxmlformats.org/officeDocument/2006/relationships" id="2147483655" r:id="Rc187c0f60af04c4b"/>
+    <p:sldLayoutId xmlns:r="http://schemas.openxmlformats.org/officeDocument/2006/relationships" id="2147483656" r:id="Rafc82f9c3e824a0e"/>
+    <p:sldLayoutId xmlns:r="http://schemas.openxmlformats.org/officeDocument/2006/relationships" id="2147483657" r:id="R98bbe1c0d0c349ef"/>
+    <p:sldLayoutId xmlns:r="http://schemas.openxmlformats.org/officeDocument/2006/relationships" id="2147483658" r:id="Rb2ca8a53f286496e"/>
+    <p:sldLayoutId xmlns:r="http://schemas.openxmlformats.org/officeDocument/2006/relationships" id="2147483659" r:id="R3b0f731575a84a89"/>
   </p:sldLayoutIdLst>
   <p:txStyles>
     <p:titleStyle>
@@ -5113,7 +5113,7 @@
           <p:cNvPr id="2" name="Rectangle 1">
             <a:extLst xmlns:a="http://schemas.openxmlformats.org/drawingml/2006/main">
               <a:ext uri="{FF2B5EF4-FFF2-40B4-BE49-F238E27FC236}">
-                <a16:creationId xmlns:a16="http://schemas.microsoft.com/office/drawing/2014/main" id="{B959BA56-CF1D-4BBA-BF72-05061A0B98C7}"/>
+                <a16:creationId xmlns:a16="http://schemas.microsoft.com/office/drawing/2014/main" id="{42A5012E-F501-4884-B8D0-FD957C04F95D}"/>
               </a:ext>
             </a:extLst>
           </p:cNvPr>
@@ -5166,7 +5166,7 @@
           <p:cNvPr id="3" name="Rectangle 2">
             <a:extLst xmlns:a="http://schemas.openxmlformats.org/drawingml/2006/main">
               <a:ext uri="{FF2B5EF4-FFF2-40B4-BE49-F238E27FC236}">
-                <a16:creationId xmlns:a16="http://schemas.microsoft.com/office/drawing/2014/main" id="{E03CA2F5-909C-4654-97E4-CFC2F363E2C7}"/>
+                <a16:creationId xmlns:a16="http://schemas.microsoft.com/office/drawing/2014/main" id="{9EAE6E70-B8C4-41EF-8738-9F0A781BC292}"/>
               </a:ext>
             </a:extLst>
           </p:cNvPr>
@@ -5219,7 +5219,7 @@
           <p:cNvPr id="4" name="TextBox 3">
             <a:extLst xmlns:a="http://schemas.openxmlformats.org/drawingml/2006/main">
               <a:ext uri="{FF2B5EF4-FFF2-40B4-BE49-F238E27FC236}">
-                <a16:creationId xmlns:a16="http://schemas.microsoft.com/office/drawing/2014/main" id="{E60BEA90-4AE9-4815-8122-47B63F250575}"/>
+                <a16:creationId xmlns:a16="http://schemas.microsoft.com/office/drawing/2014/main" id="{AA60827C-175F-470F-8B6C-34160D524180}"/>
               </a:ext>
             </a:extLst>
           </p:cNvPr>
@@ -5321,7 +5321,7 @@
     </p:spTree>
     <p:extLst>
       <p:ext uri="{BB962C8B-B14F-4D97-AF65-F5344CB8AC3E}">
-        <p14:creationId xmlns:p14="http://schemas.microsoft.com/office/powerpoint/2010/main" val="747883721"/>
+        <p14:creationId xmlns:p14="http://schemas.microsoft.com/office/powerpoint/2010/main" val="609045976"/>
       </p:ext>
     </p:extLst>
   </p:cSld>
@@ -5345,7 +5345,7 @@
           <p:cNvPr id="2" name="Rectangle 1">
             <a:extLst xmlns:a="http://schemas.openxmlformats.org/drawingml/2006/main">
               <a:ext uri="{FF2B5EF4-FFF2-40B4-BE49-F238E27FC236}">
-                <a16:creationId xmlns:a16="http://schemas.microsoft.com/office/drawing/2014/main" id="{D035EBE8-53DD-45B4-88A8-DC99A6640FEC}"/>
+                <a16:creationId xmlns:a16="http://schemas.microsoft.com/office/drawing/2014/main" id="{5D2EAB22-A4A0-4DCF-AE9F-BA3CD9B6E43E}"/>
               </a:ext>
             </a:extLst>
           </p:cNvPr>
@@ -5398,7 +5398,7 @@
           <p:cNvPr id="3" name="Rectangle 2">
             <a:extLst xmlns:a="http://schemas.openxmlformats.org/drawingml/2006/main">
               <a:ext uri="{FF2B5EF4-FFF2-40B4-BE49-F238E27FC236}">
-                <a16:creationId xmlns:a16="http://schemas.microsoft.com/office/drawing/2014/main" id="{4CD44846-3032-4665-A874-9DB23538852C}"/>
+                <a16:creationId xmlns:a16="http://schemas.microsoft.com/office/drawing/2014/main" id="{6C34AC09-DD31-4C56-93DE-847575808F57}"/>
               </a:ext>
             </a:extLst>
           </p:cNvPr>
@@ -5451,7 +5451,7 @@
           <p:cNvPr id="4" name="Rectangle 3">
             <a:extLst xmlns:a="http://schemas.openxmlformats.org/drawingml/2006/main">
               <a:ext uri="{FF2B5EF4-FFF2-40B4-BE49-F238E27FC236}">
-                <a16:creationId xmlns:a16="http://schemas.microsoft.com/office/drawing/2014/main" id="{541B6A31-FE42-4FDC-BD2F-28666C6A4AF8}"/>
+                <a16:creationId xmlns:a16="http://schemas.microsoft.com/office/drawing/2014/main" id="{4AE62ED8-F209-458D-A331-B2CA33B62325}"/>
               </a:ext>
             </a:extLst>
           </p:cNvPr>
@@ -5504,7 +5504,7 @@
           <p:cNvPr id="5" name="TextBox 4">
             <a:extLst xmlns:a="http://schemas.openxmlformats.org/drawingml/2006/main">
               <a:ext uri="{FF2B5EF4-FFF2-40B4-BE49-F238E27FC236}">
-                <a16:creationId xmlns:a16="http://schemas.microsoft.com/office/drawing/2014/main" id="{201C9F79-B2CE-4488-B86D-42A035D4B0E3}"/>
+                <a16:creationId xmlns:a16="http://schemas.microsoft.com/office/drawing/2014/main" id="{3D8567FE-475C-4C26-841A-7A645CF6DA16}"/>
               </a:ext>
             </a:extLst>
           </p:cNvPr>
@@ -5567,7 +5567,7 @@
           <p:cNvPr id="6" name="Rounded Rectangle 5">
             <a:extLst xmlns:a="http://schemas.openxmlformats.org/drawingml/2006/main">
               <a:ext uri="{FF2B5EF4-FFF2-40B4-BE49-F238E27FC236}">
-                <a16:creationId xmlns:a16="http://schemas.microsoft.com/office/drawing/2014/main" id="{369C9FB8-3F1B-484C-82B2-7E43D80A6041}"/>
+                <a16:creationId xmlns:a16="http://schemas.microsoft.com/office/drawing/2014/main" id="{92312E06-7A06-4D14-9023-F0E3E9244882}"/>
               </a:ext>
             </a:extLst>
           </p:cNvPr>
@@ -5622,7 +5622,7 @@
           <p:cNvPr id="7" name="TextBox 6">
             <a:extLst xmlns:a="http://schemas.openxmlformats.org/drawingml/2006/main">
               <a:ext uri="{FF2B5EF4-FFF2-40B4-BE49-F238E27FC236}">
-                <a16:creationId xmlns:a16="http://schemas.microsoft.com/office/drawing/2014/main" id="{EB7D4578-8594-416E-B8F7-9F861D1E7A49}"/>
+                <a16:creationId xmlns:a16="http://schemas.microsoft.com/office/drawing/2014/main" id="{73B08BCB-9D70-4FA8-A4CA-A74A06F8AEE6}"/>
               </a:ext>
             </a:extLst>
           </p:cNvPr>
@@ -5726,7 +5726,7 @@
           <p:cNvPr id="8" name="Rounded Rectangle 7">
             <a:extLst xmlns:a="http://schemas.openxmlformats.org/drawingml/2006/main">
               <a:ext uri="{FF2B5EF4-FFF2-40B4-BE49-F238E27FC236}">
-                <a16:creationId xmlns:a16="http://schemas.microsoft.com/office/drawing/2014/main" id="{9CE6973E-3518-4EE3-A2D7-994A0E635478}"/>
+                <a16:creationId xmlns:a16="http://schemas.microsoft.com/office/drawing/2014/main" id="{E9B2F661-FAB9-4FDB-89F7-5030E06C08A0}"/>
               </a:ext>
             </a:extLst>
           </p:cNvPr>
@@ -5781,7 +5781,7 @@
           <p:cNvPr id="9" name="TextBox 8">
             <a:extLst xmlns:a="http://schemas.openxmlformats.org/drawingml/2006/main">
               <a:ext uri="{FF2B5EF4-FFF2-40B4-BE49-F238E27FC236}">
-                <a16:creationId xmlns:a16="http://schemas.microsoft.com/office/drawing/2014/main" id="{E0C36BE4-7CA5-458D-9FB0-5B698D16067D}"/>
+                <a16:creationId xmlns:a16="http://schemas.microsoft.com/office/drawing/2014/main" id="{F60E2F55-5208-4A6F-BAA0-2135F27E8BCC}"/>
               </a:ext>
             </a:extLst>
           </p:cNvPr>
@@ -5866,7 +5866,7 @@
           <p:cNvPr id="10" name="Rounded Rectangle 9">
             <a:extLst xmlns:a="http://schemas.openxmlformats.org/drawingml/2006/main">
               <a:ext uri="{FF2B5EF4-FFF2-40B4-BE49-F238E27FC236}">
-                <a16:creationId xmlns:a16="http://schemas.microsoft.com/office/drawing/2014/main" id="{CA95DEB7-E756-4724-B9F8-C29E83263C12}"/>
+                <a16:creationId xmlns:a16="http://schemas.microsoft.com/office/drawing/2014/main" id="{995070CC-715E-47D0-89E4-609179D903AA}"/>
               </a:ext>
             </a:extLst>
           </p:cNvPr>
@@ -5921,7 +5921,7 @@
           <p:cNvPr id="11" name="TextBox 10">
             <a:extLst xmlns:a="http://schemas.openxmlformats.org/drawingml/2006/main">
               <a:ext uri="{FF2B5EF4-FFF2-40B4-BE49-F238E27FC236}">
-                <a16:creationId xmlns:a16="http://schemas.microsoft.com/office/drawing/2014/main" id="{B5477A4D-0990-4359-B0BF-9E1814D8F50B}"/>
+                <a16:creationId xmlns:a16="http://schemas.microsoft.com/office/drawing/2014/main" id="{C9A92EC7-6C46-482D-8718-096498CBCF17}"/>
               </a:ext>
             </a:extLst>
           </p:cNvPr>
@@ -6023,7 +6023,7 @@
     </p:spTree>
     <p:extLst>
       <p:ext uri="{BB962C8B-B14F-4D97-AF65-F5344CB8AC3E}">
-        <p14:creationId xmlns:p14="http://schemas.microsoft.com/office/powerpoint/2010/main" val="1704285524"/>
+        <p14:creationId xmlns:p14="http://schemas.microsoft.com/office/powerpoint/2010/main" val="2140585371"/>
       </p:ext>
     </p:extLst>
   </p:cSld>
@@ -6047,7 +6047,7 @@
           <p:cNvPr id="2" name="Rectangle 1">
             <a:extLst xmlns:a="http://schemas.openxmlformats.org/drawingml/2006/main">
               <a:ext uri="{FF2B5EF4-FFF2-40B4-BE49-F238E27FC236}">
-                <a16:creationId xmlns:a16="http://schemas.microsoft.com/office/drawing/2014/main" id="{2FFABAE1-FF17-47D0-9C48-F05D44B445F4}"/>
+                <a16:creationId xmlns:a16="http://schemas.microsoft.com/office/drawing/2014/main" id="{17842A66-40FC-4CD3-B676-049C67B4A9AD}"/>
               </a:ext>
             </a:extLst>
           </p:cNvPr>
@@ -6100,7 +6100,7 @@
           <p:cNvPr id="3" name="Rectangle 2">
             <a:extLst xmlns:a="http://schemas.openxmlformats.org/drawingml/2006/main">
               <a:ext uri="{FF2B5EF4-FFF2-40B4-BE49-F238E27FC236}">
-                <a16:creationId xmlns:a16="http://schemas.microsoft.com/office/drawing/2014/main" id="{E27E8A66-3F9A-40AA-AA0C-9EFBDFBF7FD1}"/>
+                <a16:creationId xmlns:a16="http://schemas.microsoft.com/office/drawing/2014/main" id="{B12877F0-783C-4760-A681-2CB718917F3D}"/>
               </a:ext>
             </a:extLst>
           </p:cNvPr>
@@ -6153,7 +6153,7 @@
           <p:cNvPr id="4" name="Rectangle 3">
             <a:extLst xmlns:a="http://schemas.openxmlformats.org/drawingml/2006/main">
               <a:ext uri="{FF2B5EF4-FFF2-40B4-BE49-F238E27FC236}">
-                <a16:creationId xmlns:a16="http://schemas.microsoft.com/office/drawing/2014/main" id="{919A8047-8884-42B9-81E8-1815DF8B0DC3}"/>
+                <a16:creationId xmlns:a16="http://schemas.microsoft.com/office/drawing/2014/main" id="{2E233975-CEDA-4E56-B82C-A6F08F9FC944}"/>
               </a:ext>
             </a:extLst>
           </p:cNvPr>
@@ -6206,7 +6206,7 @@
           <p:cNvPr id="5" name="TextBox 4">
             <a:extLst xmlns:a="http://schemas.openxmlformats.org/drawingml/2006/main">
               <a:ext uri="{FF2B5EF4-FFF2-40B4-BE49-F238E27FC236}">
-                <a16:creationId xmlns:a16="http://schemas.microsoft.com/office/drawing/2014/main" id="{543EEE72-DEDE-4489-B2CD-A1F67E8ED7F5}"/>
+                <a16:creationId xmlns:a16="http://schemas.microsoft.com/office/drawing/2014/main" id="{78168635-ED8F-4C47-80E5-D7EB8098B03C}"/>
               </a:ext>
             </a:extLst>
           </p:cNvPr>
@@ -6269,7 +6269,7 @@
           <p:cNvPr id="6" name="Rounded Rectangle 5">
             <a:extLst xmlns:a="http://schemas.openxmlformats.org/drawingml/2006/main">
               <a:ext uri="{FF2B5EF4-FFF2-40B4-BE49-F238E27FC236}">
-                <a16:creationId xmlns:a16="http://schemas.microsoft.com/office/drawing/2014/main" id="{B9F91D04-F16A-434B-84B3-CA801F111095}"/>
+                <a16:creationId xmlns:a16="http://schemas.microsoft.com/office/drawing/2014/main" id="{A30A2A98-01C6-4C34-A9D5-DE9B4E2A6FBE}"/>
               </a:ext>
             </a:extLst>
           </p:cNvPr>
@@ -6324,7 +6324,7 @@
           <p:cNvPr id="7" name="TextBox 6">
             <a:extLst xmlns:a="http://schemas.openxmlformats.org/drawingml/2006/main">
               <a:ext uri="{FF2B5EF4-FFF2-40B4-BE49-F238E27FC236}">
-                <a16:creationId xmlns:a16="http://schemas.microsoft.com/office/drawing/2014/main" id="{99A98039-C969-434E-A561-AC2F6095A8BB}"/>
+                <a16:creationId xmlns:a16="http://schemas.microsoft.com/office/drawing/2014/main" id="{5F25891C-5EF6-4C89-928A-7D6BC6237C1A}"/>
               </a:ext>
             </a:extLst>
           </p:cNvPr>
@@ -6523,7 +6523,7 @@
           <p:cNvPr id="8" name="Rounded Rectangle 7">
             <a:extLst xmlns:a="http://schemas.openxmlformats.org/drawingml/2006/main">
               <a:ext uri="{FF2B5EF4-FFF2-40B4-BE49-F238E27FC236}">
-                <a16:creationId xmlns:a16="http://schemas.microsoft.com/office/drawing/2014/main" id="{834515B1-FA97-48DA-BC78-59A4E2D0CADB}"/>
+                <a16:creationId xmlns:a16="http://schemas.microsoft.com/office/drawing/2014/main" id="{C2DF8B07-5A2D-4F19-931B-202A37760045}"/>
               </a:ext>
             </a:extLst>
           </p:cNvPr>
@@ -6578,7 +6578,7 @@
           <p:cNvPr id="9" name="TextBox 8">
             <a:extLst xmlns:a="http://schemas.openxmlformats.org/drawingml/2006/main">
               <a:ext uri="{FF2B5EF4-FFF2-40B4-BE49-F238E27FC236}">
-                <a16:creationId xmlns:a16="http://schemas.microsoft.com/office/drawing/2014/main" id="{1ED0C34F-3BE1-4104-9DFC-C75BC952D566}"/>
+                <a16:creationId xmlns:a16="http://schemas.microsoft.com/office/drawing/2014/main" id="{4C690AC6-FC56-43CF-812F-0687775AD0E1}"/>
               </a:ext>
             </a:extLst>
           </p:cNvPr>
@@ -6699,7 +6699,7 @@
     </p:spTree>
     <p:extLst>
       <p:ext uri="{BB962C8B-B14F-4D97-AF65-F5344CB8AC3E}">
-        <p14:creationId xmlns:p14="http://schemas.microsoft.com/office/powerpoint/2010/main" val="1331033048"/>
+        <p14:creationId xmlns:p14="http://schemas.microsoft.com/office/powerpoint/2010/main" val="1162553579"/>
       </p:ext>
     </p:extLst>
   </p:cSld>
@@ -6723,7 +6723,7 @@
           <p:cNvPr id="2" name="Rectangle 1">
             <a:extLst xmlns:a="http://schemas.openxmlformats.org/drawingml/2006/main">
               <a:ext uri="{FF2B5EF4-FFF2-40B4-BE49-F238E27FC236}">
-                <a16:creationId xmlns:a16="http://schemas.microsoft.com/office/drawing/2014/main" id="{0BB52EC8-E2E4-4C5B-AD9C-34AA3201A407}"/>
+                <a16:creationId xmlns:a16="http://schemas.microsoft.com/office/drawing/2014/main" id="{4DEF8083-370F-47C0-AD0B-92A4B1D6A465}"/>
               </a:ext>
             </a:extLst>
           </p:cNvPr>
@@ -6776,7 +6776,7 @@
           <p:cNvPr id="3" name="Rectangle 2">
             <a:extLst xmlns:a="http://schemas.openxmlformats.org/drawingml/2006/main">
               <a:ext uri="{FF2B5EF4-FFF2-40B4-BE49-F238E27FC236}">
-                <a16:creationId xmlns:a16="http://schemas.microsoft.com/office/drawing/2014/main" id="{2A541938-7315-4F3B-B40E-D4C80FCC3527}"/>
+                <a16:creationId xmlns:a16="http://schemas.microsoft.com/office/drawing/2014/main" id="{008AE4E3-F502-4856-81E6-2DCC055E972B}"/>
               </a:ext>
             </a:extLst>
           </p:cNvPr>
@@ -6829,7 +6829,7 @@
           <p:cNvPr id="4" name="TextBox 3">
             <a:extLst xmlns:a="http://schemas.openxmlformats.org/drawingml/2006/main">
               <a:ext uri="{FF2B5EF4-FFF2-40B4-BE49-F238E27FC236}">
-                <a16:creationId xmlns:a16="http://schemas.microsoft.com/office/drawing/2014/main" id="{5F149EF5-3AB6-4FEB-9594-C48DA41E8A71}"/>
+                <a16:creationId xmlns:a16="http://schemas.microsoft.com/office/drawing/2014/main" id="{89E30DA1-D715-4954-A75C-B7004E9A6ED6}"/>
               </a:ext>
             </a:extLst>
           </p:cNvPr>
@@ -7007,7 +7007,7 @@
     </p:spTree>
     <p:extLst>
       <p:ext uri="{BB962C8B-B14F-4D97-AF65-F5344CB8AC3E}">
-        <p14:creationId xmlns:p14="http://schemas.microsoft.com/office/powerpoint/2010/main" val="635446557"/>
+        <p14:creationId xmlns:p14="http://schemas.microsoft.com/office/powerpoint/2010/main" val="1298610414"/>
       </p:ext>
     </p:extLst>
   </p:cSld>
@@ -7031,7 +7031,7 @@
           <p:cNvPr id="2" name="Rectangle 1">
             <a:extLst xmlns:a="http://schemas.openxmlformats.org/drawingml/2006/main">
               <a:ext uri="{FF2B5EF4-FFF2-40B4-BE49-F238E27FC236}">
-                <a16:creationId xmlns:a16="http://schemas.microsoft.com/office/drawing/2014/main" id="{A7AC01FD-E0BE-4CA2-9728-D1692C7CAAAC}"/>
+                <a16:creationId xmlns:a16="http://schemas.microsoft.com/office/drawing/2014/main" id="{7D1D252F-6EEF-43AF-B6AE-B413AEE39718}"/>
               </a:ext>
             </a:extLst>
           </p:cNvPr>
@@ -7084,7 +7084,7 @@
           <p:cNvPr id="3" name="Rectangle 2">
             <a:extLst xmlns:a="http://schemas.openxmlformats.org/drawingml/2006/main">
               <a:ext uri="{FF2B5EF4-FFF2-40B4-BE49-F238E27FC236}">
-                <a16:creationId xmlns:a16="http://schemas.microsoft.com/office/drawing/2014/main" id="{6CC34BA4-B19C-4589-88DA-4E1B06762FF2}"/>
+                <a16:creationId xmlns:a16="http://schemas.microsoft.com/office/drawing/2014/main" id="{56F170BA-C51C-4049-842B-A1A2FE9C880E}"/>
               </a:ext>
             </a:extLst>
           </p:cNvPr>
@@ -7137,7 +7137,7 @@
           <p:cNvPr id="4" name="Rectangle 3">
             <a:extLst xmlns:a="http://schemas.openxmlformats.org/drawingml/2006/main">
               <a:ext uri="{FF2B5EF4-FFF2-40B4-BE49-F238E27FC236}">
-                <a16:creationId xmlns:a16="http://schemas.microsoft.com/office/drawing/2014/main" id="{2B2E2DBE-53DE-46CA-A2FE-AF81E63281D7}"/>
+                <a16:creationId xmlns:a16="http://schemas.microsoft.com/office/drawing/2014/main" id="{D46F4130-8D2F-4B27-B5C0-E55E4303EF45}"/>
               </a:ext>
             </a:extLst>
           </p:cNvPr>
@@ -7190,7 +7190,7 @@
           <p:cNvPr id="5" name="TextBox 4">
             <a:extLst xmlns:a="http://schemas.openxmlformats.org/drawingml/2006/main">
               <a:ext uri="{FF2B5EF4-FFF2-40B4-BE49-F238E27FC236}">
-                <a16:creationId xmlns:a16="http://schemas.microsoft.com/office/drawing/2014/main" id="{AA7DD74E-589F-4D6E-ACBE-AD1FB904E681}"/>
+                <a16:creationId xmlns:a16="http://schemas.microsoft.com/office/drawing/2014/main" id="{BB754FD9-B1CD-4092-86FC-CBA92E02A1FC}"/>
               </a:ext>
             </a:extLst>
           </p:cNvPr>
@@ -7253,7 +7253,7 @@
           <p:cNvPr id="6" name="Rounded Rectangle 5">
             <a:extLst xmlns:a="http://schemas.openxmlformats.org/drawingml/2006/main">
               <a:ext uri="{FF2B5EF4-FFF2-40B4-BE49-F238E27FC236}">
-                <a16:creationId xmlns:a16="http://schemas.microsoft.com/office/drawing/2014/main" id="{4011CF02-8CDC-4560-814B-3DF01DA5CB27}"/>
+                <a16:creationId xmlns:a16="http://schemas.microsoft.com/office/drawing/2014/main" id="{7D1713FB-5752-458D-886A-6D2BC6A382DE}"/>
               </a:ext>
             </a:extLst>
           </p:cNvPr>
@@ -7308,7 +7308,7 @@
           <p:cNvPr id="7" name="TextBox 6">
             <a:extLst xmlns:a="http://schemas.openxmlformats.org/drawingml/2006/main">
               <a:ext uri="{FF2B5EF4-FFF2-40B4-BE49-F238E27FC236}">
-                <a16:creationId xmlns:a16="http://schemas.microsoft.com/office/drawing/2014/main" id="{96BA2453-E1DB-467A-B761-6586ACE30EEB}"/>
+                <a16:creationId xmlns:a16="http://schemas.microsoft.com/office/drawing/2014/main" id="{F5BC63CD-E050-4EE2-9DF5-6868909330D5}"/>
               </a:ext>
             </a:extLst>
           </p:cNvPr>
@@ -7412,7 +7412,7 @@
           <p:cNvPr id="8" name="Rounded Rectangle 7">
             <a:extLst xmlns:a="http://schemas.openxmlformats.org/drawingml/2006/main">
               <a:ext uri="{FF2B5EF4-FFF2-40B4-BE49-F238E27FC236}">
-                <a16:creationId xmlns:a16="http://schemas.microsoft.com/office/drawing/2014/main" id="{BE34707B-5640-4432-98F4-BB8D9766398D}"/>
+                <a16:creationId xmlns:a16="http://schemas.microsoft.com/office/drawing/2014/main" id="{C4497437-C3F5-4568-8C68-EBF5EA1A9695}"/>
               </a:ext>
             </a:extLst>
           </p:cNvPr>
@@ -7467,7 +7467,7 @@
           <p:cNvPr id="9" name="TextBox 8">
             <a:extLst xmlns:a="http://schemas.openxmlformats.org/drawingml/2006/main">
               <a:ext uri="{FF2B5EF4-FFF2-40B4-BE49-F238E27FC236}">
-                <a16:creationId xmlns:a16="http://schemas.microsoft.com/office/drawing/2014/main" id="{4C1E83E0-1E31-4190-82AD-F6539C12E080}"/>
+                <a16:creationId xmlns:a16="http://schemas.microsoft.com/office/drawing/2014/main" id="{929CD155-B89A-40E4-94B1-E7A34312C4C1}"/>
               </a:ext>
             </a:extLst>
           </p:cNvPr>
@@ -7571,7 +7571,7 @@
           <p:cNvPr id="10" name="Rounded Rectangle 9">
             <a:extLst xmlns:a="http://schemas.openxmlformats.org/drawingml/2006/main">
               <a:ext uri="{FF2B5EF4-FFF2-40B4-BE49-F238E27FC236}">
-                <a16:creationId xmlns:a16="http://schemas.microsoft.com/office/drawing/2014/main" id="{8AAE9A99-093F-466F-8395-A38F016D77F0}"/>
+                <a16:creationId xmlns:a16="http://schemas.microsoft.com/office/drawing/2014/main" id="{AC1BB927-667A-4E29-B694-AAE00F95F802}"/>
               </a:ext>
             </a:extLst>
           </p:cNvPr>
@@ -7626,7 +7626,7 @@
           <p:cNvPr id="11" name="TextBox 10">
             <a:extLst xmlns:a="http://schemas.openxmlformats.org/drawingml/2006/main">
               <a:ext uri="{FF2B5EF4-FFF2-40B4-BE49-F238E27FC236}">
-                <a16:creationId xmlns:a16="http://schemas.microsoft.com/office/drawing/2014/main" id="{99B55F59-54F1-4FB9-8401-146AA8BC7239}"/>
+                <a16:creationId xmlns:a16="http://schemas.microsoft.com/office/drawing/2014/main" id="{1C4EC508-D28D-4AFB-A25D-384808A9A8F3}"/>
               </a:ext>
             </a:extLst>
           </p:cNvPr>
@@ -7785,7 +7785,7 @@
     </p:spTree>
     <p:extLst>
       <p:ext uri="{BB962C8B-B14F-4D97-AF65-F5344CB8AC3E}">
-        <p14:creationId xmlns:p14="http://schemas.microsoft.com/office/powerpoint/2010/main" val="1056427338"/>
+        <p14:creationId xmlns:p14="http://schemas.microsoft.com/office/powerpoint/2010/main" val="678296405"/>
       </p:ext>
     </p:extLst>
   </p:cSld>
@@ -7809,7 +7809,7 @@
           <p:cNvPr id="2" name="Rectangle 1">
             <a:extLst xmlns:a="http://schemas.openxmlformats.org/drawingml/2006/main">
               <a:ext uri="{FF2B5EF4-FFF2-40B4-BE49-F238E27FC236}">
-                <a16:creationId xmlns:a16="http://schemas.microsoft.com/office/drawing/2014/main" id="{C8841C0A-8121-43F1-93A7-332460336295}"/>
+                <a16:creationId xmlns:a16="http://schemas.microsoft.com/office/drawing/2014/main" id="{224C11A0-358B-45CD-A664-E7E9D24277B3}"/>
               </a:ext>
             </a:extLst>
           </p:cNvPr>
@@ -7862,7 +7862,7 @@
           <p:cNvPr id="3" name="Rectangle 2">
             <a:extLst xmlns:a="http://schemas.openxmlformats.org/drawingml/2006/main">
               <a:ext uri="{FF2B5EF4-FFF2-40B4-BE49-F238E27FC236}">
-                <a16:creationId xmlns:a16="http://schemas.microsoft.com/office/drawing/2014/main" id="{ACBA789D-266C-46C4-A3A0-3A6D4EC0AB6A}"/>
+                <a16:creationId xmlns:a16="http://schemas.microsoft.com/office/drawing/2014/main" id="{606EB0B7-F878-439A-B8F0-E7F479FE0681}"/>
               </a:ext>
             </a:extLst>
           </p:cNvPr>
@@ -7915,7 +7915,7 @@
           <p:cNvPr id="4" name="Rectangle 3">
             <a:extLst xmlns:a="http://schemas.openxmlformats.org/drawingml/2006/main">
               <a:ext uri="{FF2B5EF4-FFF2-40B4-BE49-F238E27FC236}">
-                <a16:creationId xmlns:a16="http://schemas.microsoft.com/office/drawing/2014/main" id="{C4790685-BFFF-4697-9F29-2FC59E31D121}"/>
+                <a16:creationId xmlns:a16="http://schemas.microsoft.com/office/drawing/2014/main" id="{9DA8F699-2E7A-419A-A538-22CE67E2E651}"/>
               </a:ext>
             </a:extLst>
           </p:cNvPr>
@@ -7968,7 +7968,7 @@
           <p:cNvPr id="5" name="TextBox 4">
             <a:extLst xmlns:a="http://schemas.openxmlformats.org/drawingml/2006/main">
               <a:ext uri="{FF2B5EF4-FFF2-40B4-BE49-F238E27FC236}">
-                <a16:creationId xmlns:a16="http://schemas.microsoft.com/office/drawing/2014/main" id="{2D9861AB-3B2E-4344-A5DA-BF2C24F3FEDA}"/>
+                <a16:creationId xmlns:a16="http://schemas.microsoft.com/office/drawing/2014/main" id="{E7966DE4-0441-4832-A6B8-8116F7EDA7E5}"/>
               </a:ext>
             </a:extLst>
           </p:cNvPr>
@@ -8031,7 +8031,7 @@
           <p:cNvPr id="6" name="Rounded Rectangle 5">
             <a:extLst xmlns:a="http://schemas.openxmlformats.org/drawingml/2006/main">
               <a:ext uri="{FF2B5EF4-FFF2-40B4-BE49-F238E27FC236}">
-                <a16:creationId xmlns:a16="http://schemas.microsoft.com/office/drawing/2014/main" id="{98D1B0AD-3396-419F-AC44-1A621FCB296A}"/>
+                <a16:creationId xmlns:a16="http://schemas.microsoft.com/office/drawing/2014/main" id="{7CF9904A-AC49-4D8D-8687-75828AA94497}"/>
               </a:ext>
             </a:extLst>
           </p:cNvPr>
@@ -8086,7 +8086,7 @@
           <p:cNvPr id="7" name="TextBox 6">
             <a:extLst xmlns:a="http://schemas.openxmlformats.org/drawingml/2006/main">
               <a:ext uri="{FF2B5EF4-FFF2-40B4-BE49-F238E27FC236}">
-                <a16:creationId xmlns:a16="http://schemas.microsoft.com/office/drawing/2014/main" id="{306C2415-F573-4A41-8AAB-F155FF9274F9}"/>
+                <a16:creationId xmlns:a16="http://schemas.microsoft.com/office/drawing/2014/main" id="{D23664B5-9EC3-46D6-9166-F04B6FCA6039}"/>
               </a:ext>
             </a:extLst>
           </p:cNvPr>
@@ -8209,7 +8209,7 @@
           <p:cNvPr id="8" name="Rounded Rectangle 7">
             <a:extLst xmlns:a="http://schemas.openxmlformats.org/drawingml/2006/main">
               <a:ext uri="{FF2B5EF4-FFF2-40B4-BE49-F238E27FC236}">
-                <a16:creationId xmlns:a16="http://schemas.microsoft.com/office/drawing/2014/main" id="{FBD03D21-1E70-438C-ACB7-0FEEE1CEAFFF}"/>
+                <a16:creationId xmlns:a16="http://schemas.microsoft.com/office/drawing/2014/main" id="{D1782C88-7C96-4CF5-85EB-5CFAA31A3ECF}"/>
               </a:ext>
             </a:extLst>
           </p:cNvPr>
@@ -8264,7 +8264,7 @@
           <p:cNvPr id="9" name="TextBox 8">
             <a:extLst xmlns:a="http://schemas.openxmlformats.org/drawingml/2006/main">
               <a:ext uri="{FF2B5EF4-FFF2-40B4-BE49-F238E27FC236}">
-                <a16:creationId xmlns:a16="http://schemas.microsoft.com/office/drawing/2014/main" id="{87849F11-5B1A-42DD-B840-7DBCCB7C78D0}"/>
+                <a16:creationId xmlns:a16="http://schemas.microsoft.com/office/drawing/2014/main" id="{7C043E09-E320-4771-AFB2-5C86F8715538}"/>
               </a:ext>
             </a:extLst>
           </p:cNvPr>
@@ -8406,7 +8406,7 @@
           <p:cNvPr id="10" name="Rounded Rectangle 9">
             <a:extLst xmlns:a="http://schemas.openxmlformats.org/drawingml/2006/main">
               <a:ext uri="{FF2B5EF4-FFF2-40B4-BE49-F238E27FC236}">
-                <a16:creationId xmlns:a16="http://schemas.microsoft.com/office/drawing/2014/main" id="{543CB129-0D2D-4A90-BBFE-A8AA966953DA}"/>
+                <a16:creationId xmlns:a16="http://schemas.microsoft.com/office/drawing/2014/main" id="{C06F1E25-0708-41BE-A67A-50BFFBEF0168}"/>
               </a:ext>
             </a:extLst>
           </p:cNvPr>
@@ -8461,7 +8461,7 @@
           <p:cNvPr id="11" name="TextBox 10">
             <a:extLst xmlns:a="http://schemas.openxmlformats.org/drawingml/2006/main">
               <a:ext uri="{FF2B5EF4-FFF2-40B4-BE49-F238E27FC236}">
-                <a16:creationId xmlns:a16="http://schemas.microsoft.com/office/drawing/2014/main" id="{726D0067-9579-48ED-ACC0-A386053B2A38}"/>
+                <a16:creationId xmlns:a16="http://schemas.microsoft.com/office/drawing/2014/main" id="{C59B51A3-DF5A-44C4-95BE-30212002EDB7}"/>
               </a:ext>
             </a:extLst>
           </p:cNvPr>
@@ -8563,7 +8563,7 @@
     </p:spTree>
     <p:extLst>
       <p:ext uri="{BB962C8B-B14F-4D97-AF65-F5344CB8AC3E}">
-        <p14:creationId xmlns:p14="http://schemas.microsoft.com/office/powerpoint/2010/main" val="959810390"/>
+        <p14:creationId xmlns:p14="http://schemas.microsoft.com/office/powerpoint/2010/main" val="222286338"/>
       </p:ext>
     </p:extLst>
   </p:cSld>
@@ -8587,7 +8587,7 @@
           <p:cNvPr id="2" name="Rectangle 1">
             <a:extLst xmlns:a="http://schemas.openxmlformats.org/drawingml/2006/main">
               <a:ext uri="{FF2B5EF4-FFF2-40B4-BE49-F238E27FC236}">
-                <a16:creationId xmlns:a16="http://schemas.microsoft.com/office/drawing/2014/main" id="{1D192B5B-44D2-4E94-B034-C88E3D06D7D0}"/>
+                <a16:creationId xmlns:a16="http://schemas.microsoft.com/office/drawing/2014/main" id="{479CA8E0-4ED1-4A84-BA9E-2E2102742059}"/>
               </a:ext>
             </a:extLst>
           </p:cNvPr>
@@ -8640,7 +8640,7 @@
           <p:cNvPr id="3" name="Rectangle 2">
             <a:extLst xmlns:a="http://schemas.openxmlformats.org/drawingml/2006/main">
               <a:ext uri="{FF2B5EF4-FFF2-40B4-BE49-F238E27FC236}">
-                <a16:creationId xmlns:a16="http://schemas.microsoft.com/office/drawing/2014/main" id="{46C6F833-C7C4-498F-8B00-2E6B5D433EDF}"/>
+                <a16:creationId xmlns:a16="http://schemas.microsoft.com/office/drawing/2014/main" id="{70AADF4C-9EA9-4244-B947-4B92B0858DDF}"/>
               </a:ext>
             </a:extLst>
           </p:cNvPr>
@@ -8693,7 +8693,7 @@
           <p:cNvPr id="4" name="Rectangle 3">
             <a:extLst xmlns:a="http://schemas.openxmlformats.org/drawingml/2006/main">
               <a:ext uri="{FF2B5EF4-FFF2-40B4-BE49-F238E27FC236}">
-                <a16:creationId xmlns:a16="http://schemas.microsoft.com/office/drawing/2014/main" id="{A5FC2171-3405-42CB-841D-16B599E543C5}"/>
+                <a16:creationId xmlns:a16="http://schemas.microsoft.com/office/drawing/2014/main" id="{B30F3FD5-E8FB-4528-862D-D584ABE6C450}"/>
               </a:ext>
             </a:extLst>
           </p:cNvPr>
@@ -8746,7 +8746,7 @@
           <p:cNvPr id="5" name="TextBox 4">
             <a:extLst xmlns:a="http://schemas.openxmlformats.org/drawingml/2006/main">
               <a:ext uri="{FF2B5EF4-FFF2-40B4-BE49-F238E27FC236}">
-                <a16:creationId xmlns:a16="http://schemas.microsoft.com/office/drawing/2014/main" id="{3488690E-6EDA-4B87-B6CF-9FD154DA6C3C}"/>
+                <a16:creationId xmlns:a16="http://schemas.microsoft.com/office/drawing/2014/main" id="{AA0E46BA-735A-4B77-93E8-397616F1DCC2}"/>
               </a:ext>
             </a:extLst>
           </p:cNvPr>
@@ -8809,7 +8809,7 @@
           <p:cNvPr id="6" name="Rounded Rectangle 5">
             <a:extLst xmlns:a="http://schemas.openxmlformats.org/drawingml/2006/main">
               <a:ext uri="{FF2B5EF4-FFF2-40B4-BE49-F238E27FC236}">
-                <a16:creationId xmlns:a16="http://schemas.microsoft.com/office/drawing/2014/main" id="{EC891EDF-7372-4FF4-A822-5FD38EEA920E}"/>
+                <a16:creationId xmlns:a16="http://schemas.microsoft.com/office/drawing/2014/main" id="{9B3F83B5-C07B-430A-9FB0-C360C8E37C71}"/>
               </a:ext>
             </a:extLst>
           </p:cNvPr>
@@ -8864,7 +8864,7 @@
           <p:cNvPr id="7" name="TextBox 6">
             <a:extLst xmlns:a="http://schemas.openxmlformats.org/drawingml/2006/main">
               <a:ext uri="{FF2B5EF4-FFF2-40B4-BE49-F238E27FC236}">
-                <a16:creationId xmlns:a16="http://schemas.microsoft.com/office/drawing/2014/main" id="{7F89C87D-F1F9-42B8-A504-B5CCA3B2044A}"/>
+                <a16:creationId xmlns:a16="http://schemas.microsoft.com/office/drawing/2014/main" id="{14F297D0-5251-464C-A7C8-A1A03B927C2E}"/>
               </a:ext>
             </a:extLst>
           </p:cNvPr>
@@ -9044,7 +9044,7 @@
           <p:cNvPr id="8" name="Rounded Rectangle 7">
             <a:extLst xmlns:a="http://schemas.openxmlformats.org/drawingml/2006/main">
               <a:ext uri="{FF2B5EF4-FFF2-40B4-BE49-F238E27FC236}">
-                <a16:creationId xmlns:a16="http://schemas.microsoft.com/office/drawing/2014/main" id="{BE91E602-8DB9-4F0D-97FD-14CE432E1DD1}"/>
+                <a16:creationId xmlns:a16="http://schemas.microsoft.com/office/drawing/2014/main" id="{C5B3F7F0-D934-4570-ACBA-EDB812C71352}"/>
               </a:ext>
             </a:extLst>
           </p:cNvPr>
@@ -9099,7 +9099,7 @@
           <p:cNvPr id="9" name="TextBox 8">
             <a:extLst xmlns:a="http://schemas.openxmlformats.org/drawingml/2006/main">
               <a:ext uri="{FF2B5EF4-FFF2-40B4-BE49-F238E27FC236}">
-                <a16:creationId xmlns:a16="http://schemas.microsoft.com/office/drawing/2014/main" id="{44493409-4010-4B74-891D-4FF6A13E0B50}"/>
+                <a16:creationId xmlns:a16="http://schemas.microsoft.com/office/drawing/2014/main" id="{7C9052A8-4691-47C0-A96C-19936091A760}"/>
               </a:ext>
             </a:extLst>
           </p:cNvPr>
@@ -9258,7 +9258,7 @@
     </p:spTree>
     <p:extLst>
       <p:ext uri="{BB962C8B-B14F-4D97-AF65-F5344CB8AC3E}">
-        <p14:creationId xmlns:p14="http://schemas.microsoft.com/office/powerpoint/2010/main" val="1800285656"/>
+        <p14:creationId xmlns:p14="http://schemas.microsoft.com/office/powerpoint/2010/main" val="1386526191"/>
       </p:ext>
     </p:extLst>
   </p:cSld>
@@ -9282,7 +9282,7 @@
           <p:cNvPr id="2" name="Rectangle 1">
             <a:extLst xmlns:a="http://schemas.openxmlformats.org/drawingml/2006/main">
               <a:ext uri="{FF2B5EF4-FFF2-40B4-BE49-F238E27FC236}">
-                <a16:creationId xmlns:a16="http://schemas.microsoft.com/office/drawing/2014/main" id="{73C25C0E-13F2-41AC-83C7-2A720201EA8B}"/>
+                <a16:creationId xmlns:a16="http://schemas.microsoft.com/office/drawing/2014/main" id="{6B790C6F-807E-4710-B10E-A9B9FCDB8FC0}"/>
               </a:ext>
             </a:extLst>
           </p:cNvPr>
@@ -9335,7 +9335,7 @@
           <p:cNvPr id="3" name="Rectangle 2">
             <a:extLst xmlns:a="http://schemas.openxmlformats.org/drawingml/2006/main">
               <a:ext uri="{FF2B5EF4-FFF2-40B4-BE49-F238E27FC236}">
-                <a16:creationId xmlns:a16="http://schemas.microsoft.com/office/drawing/2014/main" id="{608ACB25-B67A-4075-97D7-F378711056A7}"/>
+                <a16:creationId xmlns:a16="http://schemas.microsoft.com/office/drawing/2014/main" id="{B0691EEE-F69E-4461-B4B9-9CC38746EAD5}"/>
               </a:ext>
             </a:extLst>
           </p:cNvPr>
@@ -9388,7 +9388,7 @@
           <p:cNvPr id="4" name="Rectangle 3">
             <a:extLst xmlns:a="http://schemas.openxmlformats.org/drawingml/2006/main">
               <a:ext uri="{FF2B5EF4-FFF2-40B4-BE49-F238E27FC236}">
-                <a16:creationId xmlns:a16="http://schemas.microsoft.com/office/drawing/2014/main" id="{E1836714-478B-4758-8DB7-73B834C1AF1E}"/>
+                <a16:creationId xmlns:a16="http://schemas.microsoft.com/office/drawing/2014/main" id="{372EADA5-AD91-49B1-98E3-CA6534C20E87}"/>
               </a:ext>
             </a:extLst>
           </p:cNvPr>
@@ -9441,7 +9441,7 @@
           <p:cNvPr id="5" name="TextBox 4">
             <a:extLst xmlns:a="http://schemas.openxmlformats.org/drawingml/2006/main">
               <a:ext uri="{FF2B5EF4-FFF2-40B4-BE49-F238E27FC236}">
-                <a16:creationId xmlns:a16="http://schemas.microsoft.com/office/drawing/2014/main" id="{9EC1CE0E-7802-4D66-B7F3-5ECF84544B74}"/>
+                <a16:creationId xmlns:a16="http://schemas.microsoft.com/office/drawing/2014/main" id="{25C6C941-B141-4AE2-B478-C4D9894E2A36}"/>
               </a:ext>
             </a:extLst>
           </p:cNvPr>
@@ -9504,7 +9504,7 @@
           <p:cNvPr id="6" name="Rounded Rectangle 5">
             <a:extLst xmlns:a="http://schemas.openxmlformats.org/drawingml/2006/main">
               <a:ext uri="{FF2B5EF4-FFF2-40B4-BE49-F238E27FC236}">
-                <a16:creationId xmlns:a16="http://schemas.microsoft.com/office/drawing/2014/main" id="{20F0CE78-A157-40B1-9997-D04A368A76B0}"/>
+                <a16:creationId xmlns:a16="http://schemas.microsoft.com/office/drawing/2014/main" id="{2310B402-8C30-41EE-85DD-AF91AFAEB133}"/>
               </a:ext>
             </a:extLst>
           </p:cNvPr>
@@ -9559,7 +9559,7 @@
           <p:cNvPr id="7" name="TextBox 6">
             <a:extLst xmlns:a="http://schemas.openxmlformats.org/drawingml/2006/main">
               <a:ext uri="{FF2B5EF4-FFF2-40B4-BE49-F238E27FC236}">
-                <a16:creationId xmlns:a16="http://schemas.microsoft.com/office/drawing/2014/main" id="{80ED5C56-902F-4DE7-87A8-51AD1278BD5D}"/>
+                <a16:creationId xmlns:a16="http://schemas.microsoft.com/office/drawing/2014/main" id="{87BC02AB-0220-4E04-B930-FD4076BEDE92}"/>
               </a:ext>
             </a:extLst>
           </p:cNvPr>
@@ -9777,7 +9777,7 @@
           <p:cNvPr id="8" name="Rounded Rectangle 7">
             <a:extLst xmlns:a="http://schemas.openxmlformats.org/drawingml/2006/main">
               <a:ext uri="{FF2B5EF4-FFF2-40B4-BE49-F238E27FC236}">
-                <a16:creationId xmlns:a16="http://schemas.microsoft.com/office/drawing/2014/main" id="{0D166698-49CD-4FD7-8428-6B25784EDE55}"/>
+                <a16:creationId xmlns:a16="http://schemas.microsoft.com/office/drawing/2014/main" id="{4F52DC95-E164-4E74-8218-B65458F8FD3C}"/>
               </a:ext>
             </a:extLst>
           </p:cNvPr>
@@ -9832,7 +9832,7 @@
           <p:cNvPr id="9" name="TextBox 8">
             <a:extLst xmlns:a="http://schemas.openxmlformats.org/drawingml/2006/main">
               <a:ext uri="{FF2B5EF4-FFF2-40B4-BE49-F238E27FC236}">
-                <a16:creationId xmlns:a16="http://schemas.microsoft.com/office/drawing/2014/main" id="{15362817-4121-4F9E-BBC7-7D29120F8A7F}"/>
+                <a16:creationId xmlns:a16="http://schemas.microsoft.com/office/drawing/2014/main" id="{9F305A22-BA44-4373-AA0C-C43118865D70}"/>
               </a:ext>
             </a:extLst>
           </p:cNvPr>
@@ -10067,7 +10067,7 @@
     </p:spTree>
     <p:extLst>
       <p:ext uri="{BB962C8B-B14F-4D97-AF65-F5344CB8AC3E}">
-        <p14:creationId xmlns:p14="http://schemas.microsoft.com/office/powerpoint/2010/main" val="790596602"/>
+        <p14:creationId xmlns:p14="http://schemas.microsoft.com/office/powerpoint/2010/main" val="1135468343"/>
       </p:ext>
     </p:extLst>
   </p:cSld>
@@ -10091,7 +10091,7 @@
           <p:cNvPr id="2" name="Rectangle 1">
             <a:extLst xmlns:a="http://schemas.openxmlformats.org/drawingml/2006/main">
               <a:ext uri="{FF2B5EF4-FFF2-40B4-BE49-F238E27FC236}">
-                <a16:creationId xmlns:a16="http://schemas.microsoft.com/office/drawing/2014/main" id="{4CA6AE8B-D4C7-4E5F-AC64-0A3C067FE971}"/>
+                <a16:creationId xmlns:a16="http://schemas.microsoft.com/office/drawing/2014/main" id="{DAA75F01-47E4-42BC-8621-52B8271A46C2}"/>
               </a:ext>
             </a:extLst>
           </p:cNvPr>
@@ -10144,7 +10144,7 @@
           <p:cNvPr id="3" name="Rectangle 2">
             <a:extLst xmlns:a="http://schemas.openxmlformats.org/drawingml/2006/main">
               <a:ext uri="{FF2B5EF4-FFF2-40B4-BE49-F238E27FC236}">
-                <a16:creationId xmlns:a16="http://schemas.microsoft.com/office/drawing/2014/main" id="{FFED41CC-2C50-4C61-A973-0B117D47086D}"/>
+                <a16:creationId xmlns:a16="http://schemas.microsoft.com/office/drawing/2014/main" id="{5B4DECA0-AADE-4A99-8F0A-3812BE01C345}"/>
               </a:ext>
             </a:extLst>
           </p:cNvPr>
@@ -10197,7 +10197,7 @@
           <p:cNvPr id="4" name="Rectangle 3">
             <a:extLst xmlns:a="http://schemas.openxmlformats.org/drawingml/2006/main">
               <a:ext uri="{FF2B5EF4-FFF2-40B4-BE49-F238E27FC236}">
-                <a16:creationId xmlns:a16="http://schemas.microsoft.com/office/drawing/2014/main" id="{3DA338A1-9970-4A2C-9CF5-F341174EF037}"/>
+                <a16:creationId xmlns:a16="http://schemas.microsoft.com/office/drawing/2014/main" id="{2BD3CD5C-30C7-4189-A8A2-DA9A7E952418}"/>
               </a:ext>
             </a:extLst>
           </p:cNvPr>
@@ -10250,7 +10250,7 @@
           <p:cNvPr id="5" name="TextBox 4">
             <a:extLst xmlns:a="http://schemas.openxmlformats.org/drawingml/2006/main">
               <a:ext uri="{FF2B5EF4-FFF2-40B4-BE49-F238E27FC236}">
-                <a16:creationId xmlns:a16="http://schemas.microsoft.com/office/drawing/2014/main" id="{9A663EF1-2EC3-4BF7-98FD-A559B2AA3362}"/>
+                <a16:creationId xmlns:a16="http://schemas.microsoft.com/office/drawing/2014/main" id="{7E24B770-25CF-438B-9BF8-4D19106C0207}"/>
               </a:ext>
             </a:extLst>
           </p:cNvPr>
@@ -10313,7 +10313,7 @@
           <p:cNvPr id="6" name="Rounded Rectangle 5">
             <a:extLst xmlns:a="http://schemas.openxmlformats.org/drawingml/2006/main">
               <a:ext uri="{FF2B5EF4-FFF2-40B4-BE49-F238E27FC236}">
-                <a16:creationId xmlns:a16="http://schemas.microsoft.com/office/drawing/2014/main" id="{7CB293FC-B124-43E0-B637-AE7B23DEAF3C}"/>
+                <a16:creationId xmlns:a16="http://schemas.microsoft.com/office/drawing/2014/main" id="{7DCDA2A5-B3F9-449E-A5A3-CB20A1AEAA37}"/>
               </a:ext>
             </a:extLst>
           </p:cNvPr>
@@ -10368,7 +10368,7 @@
           <p:cNvPr id="7" name="TextBox 6">
             <a:extLst xmlns:a="http://schemas.openxmlformats.org/drawingml/2006/main">
               <a:ext uri="{FF2B5EF4-FFF2-40B4-BE49-F238E27FC236}">
-                <a16:creationId xmlns:a16="http://schemas.microsoft.com/office/drawing/2014/main" id="{C1BD8FF2-B41F-49E9-B636-F7DEBA374647}"/>
+                <a16:creationId xmlns:a16="http://schemas.microsoft.com/office/drawing/2014/main" id="{201A21A8-2240-46EB-853A-6506C87F4FDD}"/>
               </a:ext>
             </a:extLst>
           </p:cNvPr>
@@ -10751,7 +10751,7 @@
           <p:nvPr/>
         </p:nvPicPr>
         <p:blipFill>
-          <a:blip xmlns:r="http://schemas.openxmlformats.org/officeDocument/2006/relationships" xmlns:a="http://schemas.openxmlformats.org/drawingml/2006/main" r:embed="Rf8ca018465404876"/>
+          <a:blip xmlns:r="http://schemas.openxmlformats.org/officeDocument/2006/relationships" xmlns:a="http://schemas.openxmlformats.org/drawingml/2006/main" r:embed="Rb7b31adc7fa445e6"/>
           <a:stretch xmlns:a="http://schemas.openxmlformats.org/drawingml/2006/main">
             <a:fillRect l="0" t="0" r="0" b="0"/>
           </a:stretch>
@@ -10771,7 +10771,7 @@
           <p:cNvPr id="9" name="Rounded Rectangle 8">
             <a:extLst xmlns:a="http://schemas.openxmlformats.org/drawingml/2006/main">
               <a:ext uri="{FF2B5EF4-FFF2-40B4-BE49-F238E27FC236}">
-                <a16:creationId xmlns:a16="http://schemas.microsoft.com/office/drawing/2014/main" id="{B8742DAB-DFAB-4305-8723-704851E29B11}"/>
+                <a16:creationId xmlns:a16="http://schemas.microsoft.com/office/drawing/2014/main" id="{D832EA41-84DA-4368-8870-76E5E9D0D612}"/>
               </a:ext>
             </a:extLst>
           </p:cNvPr>
@@ -10826,7 +10826,7 @@
           <p:cNvPr id="10" name="TextBox 9">
             <a:extLst xmlns:a="http://schemas.openxmlformats.org/drawingml/2006/main">
               <a:ext uri="{FF2B5EF4-FFF2-40B4-BE49-F238E27FC236}">
-                <a16:creationId xmlns:a16="http://schemas.microsoft.com/office/drawing/2014/main" id="{B8BB598D-CE33-4722-BC7B-E736F03F7EDE}"/>
+                <a16:creationId xmlns:a16="http://schemas.microsoft.com/office/drawing/2014/main" id="{59484C2A-FCDA-47A9-8A57-CFF15D9CAB86}"/>
               </a:ext>
             </a:extLst>
           </p:cNvPr>
@@ -10912,7 +10912,7 @@
     </p:spTree>
     <p:extLst>
       <p:ext uri="{BB962C8B-B14F-4D97-AF65-F5344CB8AC3E}">
-        <p14:creationId xmlns:p14="http://schemas.microsoft.com/office/powerpoint/2010/main" val="1574508850"/>
+        <p14:creationId xmlns:p14="http://schemas.microsoft.com/office/powerpoint/2010/main" val="927002700"/>
       </p:ext>
     </p:extLst>
   </p:cSld>
@@ -10936,7 +10936,7 @@
           <p:cNvPr id="2" name="Rectangle 1">
             <a:extLst xmlns:a="http://schemas.openxmlformats.org/drawingml/2006/main">
               <a:ext uri="{FF2B5EF4-FFF2-40B4-BE49-F238E27FC236}">
-                <a16:creationId xmlns:a16="http://schemas.microsoft.com/office/drawing/2014/main" id="{EF749E31-DF2B-4CE2-B277-C8D5EDCE3DAD}"/>
+                <a16:creationId xmlns:a16="http://schemas.microsoft.com/office/drawing/2014/main" id="{A66094EF-C050-4A23-827E-0BC0E74964CE}"/>
               </a:ext>
             </a:extLst>
           </p:cNvPr>
@@ -10989,7 +10989,7 @@
           <p:cNvPr id="3" name="Rectangle 2">
             <a:extLst xmlns:a="http://schemas.openxmlformats.org/drawingml/2006/main">
               <a:ext uri="{FF2B5EF4-FFF2-40B4-BE49-F238E27FC236}">
-                <a16:creationId xmlns:a16="http://schemas.microsoft.com/office/drawing/2014/main" id="{BB8176D1-A685-4159-BAA6-EA67002F8B0F}"/>
+                <a16:creationId xmlns:a16="http://schemas.microsoft.com/office/drawing/2014/main" id="{FC31F347-FE41-48D8-8AB1-84057D0C5822}"/>
               </a:ext>
             </a:extLst>
           </p:cNvPr>
@@ -11042,7 +11042,7 @@
           <p:cNvPr id="4" name="Rectangle 3">
             <a:extLst xmlns:a="http://schemas.openxmlformats.org/drawingml/2006/main">
               <a:ext uri="{FF2B5EF4-FFF2-40B4-BE49-F238E27FC236}">
-                <a16:creationId xmlns:a16="http://schemas.microsoft.com/office/drawing/2014/main" id="{72134F25-7D33-430E-871E-C2BAFA5A641C}"/>
+                <a16:creationId xmlns:a16="http://schemas.microsoft.com/office/drawing/2014/main" id="{325ACE00-949F-4B31-8561-72971106865F}"/>
               </a:ext>
             </a:extLst>
           </p:cNvPr>
@@ -11095,7 +11095,7 @@
           <p:cNvPr id="5" name="TextBox 4">
             <a:extLst xmlns:a="http://schemas.openxmlformats.org/drawingml/2006/main">
               <a:ext uri="{FF2B5EF4-FFF2-40B4-BE49-F238E27FC236}">
-                <a16:creationId xmlns:a16="http://schemas.microsoft.com/office/drawing/2014/main" id="{534A1B69-23AE-4926-BE62-625E12541ED2}"/>
+                <a16:creationId xmlns:a16="http://schemas.microsoft.com/office/drawing/2014/main" id="{034F361C-6299-40E2-8293-1B7844AB6063}"/>
               </a:ext>
             </a:extLst>
           </p:cNvPr>
@@ -11158,7 +11158,7 @@
           <p:cNvPr id="6" name="Rounded Rectangle 5">
             <a:extLst xmlns:a="http://schemas.openxmlformats.org/drawingml/2006/main">
               <a:ext uri="{FF2B5EF4-FFF2-40B4-BE49-F238E27FC236}">
-                <a16:creationId xmlns:a16="http://schemas.microsoft.com/office/drawing/2014/main" id="{70FE6936-B067-4C94-B924-95E7E5A7771F}"/>
+                <a16:creationId xmlns:a16="http://schemas.microsoft.com/office/drawing/2014/main" id="{E4127776-E111-4BFB-96C7-230A84DD9EF6}"/>
               </a:ext>
             </a:extLst>
           </p:cNvPr>
@@ -11213,7 +11213,7 @@
           <p:cNvPr id="7" name="TextBox 6">
             <a:extLst xmlns:a="http://schemas.openxmlformats.org/drawingml/2006/main">
               <a:ext uri="{FF2B5EF4-FFF2-40B4-BE49-F238E27FC236}">
-                <a16:creationId xmlns:a16="http://schemas.microsoft.com/office/drawing/2014/main" id="{A0C64D86-DC0F-44A1-A36A-A52831514462}"/>
+                <a16:creationId xmlns:a16="http://schemas.microsoft.com/office/drawing/2014/main" id="{473BC672-1F93-4522-8941-D6610F92FA5A}"/>
               </a:ext>
             </a:extLst>
           </p:cNvPr>
@@ -11450,7 +11450,7 @@
           <p:cNvPr id="8" name="Rounded Rectangle 7">
             <a:extLst xmlns:a="http://schemas.openxmlformats.org/drawingml/2006/main">
               <a:ext uri="{FF2B5EF4-FFF2-40B4-BE49-F238E27FC236}">
-                <a16:creationId xmlns:a16="http://schemas.microsoft.com/office/drawing/2014/main" id="{4D696FF7-697F-4BBE-8AC7-21428916BE2E}"/>
+                <a16:creationId xmlns:a16="http://schemas.microsoft.com/office/drawing/2014/main" id="{D3F16271-7EEA-44DC-9A88-293528D6A5A6}"/>
               </a:ext>
             </a:extLst>
           </p:cNvPr>
@@ -11505,7 +11505,7 @@
           <p:cNvPr id="9" name="TextBox 8">
             <a:extLst xmlns:a="http://schemas.openxmlformats.org/drawingml/2006/main">
               <a:ext uri="{FF2B5EF4-FFF2-40B4-BE49-F238E27FC236}">
-                <a16:creationId xmlns:a16="http://schemas.microsoft.com/office/drawing/2014/main" id="{A406CCC3-16F4-4801-B427-A743D4CD20E5}"/>
+                <a16:creationId xmlns:a16="http://schemas.microsoft.com/office/drawing/2014/main" id="{93D78E6A-B868-4C81-9615-189A3AA28C33}"/>
               </a:ext>
             </a:extLst>
           </p:cNvPr>
@@ -11840,7 +11840,7 @@
     </p:spTree>
     <p:extLst>
       <p:ext uri="{BB962C8B-B14F-4D97-AF65-F5344CB8AC3E}">
-        <p14:creationId xmlns:p14="http://schemas.microsoft.com/office/powerpoint/2010/main" val="814644868"/>
+        <p14:creationId xmlns:p14="http://schemas.microsoft.com/office/powerpoint/2010/main" val="43847148"/>
       </p:ext>
     </p:extLst>
   </p:cSld>
@@ -11864,7 +11864,7 @@
           <p:cNvPr id="2" name="Rectangle 1">
             <a:extLst xmlns:a="http://schemas.openxmlformats.org/drawingml/2006/main">
               <a:ext uri="{FF2B5EF4-FFF2-40B4-BE49-F238E27FC236}">
-                <a16:creationId xmlns:a16="http://schemas.microsoft.com/office/drawing/2014/main" id="{36197B92-FC50-4BE9-84BD-3756AC9ED8ED}"/>
+                <a16:creationId xmlns:a16="http://schemas.microsoft.com/office/drawing/2014/main" id="{E0C9DB31-0896-410A-A6DD-8D8FF5F64E6A}"/>
               </a:ext>
             </a:extLst>
           </p:cNvPr>
@@ -11917,7 +11917,7 @@
           <p:cNvPr id="3" name="Rectangle 2">
             <a:extLst xmlns:a="http://schemas.openxmlformats.org/drawingml/2006/main">
               <a:ext uri="{FF2B5EF4-FFF2-40B4-BE49-F238E27FC236}">
-                <a16:creationId xmlns:a16="http://schemas.microsoft.com/office/drawing/2014/main" id="{A265C8AC-CDA5-45D8-872F-B01EF59D4FA6}"/>
+                <a16:creationId xmlns:a16="http://schemas.microsoft.com/office/drawing/2014/main" id="{A233B85C-F72C-4A33-92A4-FEC071F3FBB9}"/>
               </a:ext>
             </a:extLst>
           </p:cNvPr>
@@ -11970,7 +11970,7 @@
           <p:cNvPr id="4" name="Rectangle 3">
             <a:extLst xmlns:a="http://schemas.openxmlformats.org/drawingml/2006/main">
               <a:ext uri="{FF2B5EF4-FFF2-40B4-BE49-F238E27FC236}">
-                <a16:creationId xmlns:a16="http://schemas.microsoft.com/office/drawing/2014/main" id="{67224D6E-37FC-4917-92F2-2CEC50164682}"/>
+                <a16:creationId xmlns:a16="http://schemas.microsoft.com/office/drawing/2014/main" id="{84B4329E-BE9B-44A6-B5EF-35E8824E6AC3}"/>
               </a:ext>
             </a:extLst>
           </p:cNvPr>
@@ -12023,7 +12023,7 @@
           <p:cNvPr id="5" name="TextBox 4">
             <a:extLst xmlns:a="http://schemas.openxmlformats.org/drawingml/2006/main">
               <a:ext uri="{FF2B5EF4-FFF2-40B4-BE49-F238E27FC236}">
-                <a16:creationId xmlns:a16="http://schemas.microsoft.com/office/drawing/2014/main" id="{E5BEDA46-FB4D-44B2-8344-1F3FA1C56DFA}"/>
+                <a16:creationId xmlns:a16="http://schemas.microsoft.com/office/drawing/2014/main" id="{ED50E690-E393-47D9-BB8C-604CCFE8EB1F}"/>
               </a:ext>
             </a:extLst>
           </p:cNvPr>
@@ -12086,7 +12086,7 @@
           <p:cNvPr id="6" name="Rounded Rectangle 5">
             <a:extLst xmlns:a="http://schemas.openxmlformats.org/drawingml/2006/main">
               <a:ext uri="{FF2B5EF4-FFF2-40B4-BE49-F238E27FC236}">
-                <a16:creationId xmlns:a16="http://schemas.microsoft.com/office/drawing/2014/main" id="{7DF6A05E-2962-4C5D-9DA5-C67EBA4C1EF2}"/>
+                <a16:creationId xmlns:a16="http://schemas.microsoft.com/office/drawing/2014/main" id="{41703622-104E-41F4-8A7B-DD5A6D201509}"/>
               </a:ext>
             </a:extLst>
           </p:cNvPr>
@@ -12141,7 +12141,7 @@
           <p:cNvPr id="7" name="TextBox 6">
             <a:extLst xmlns:a="http://schemas.openxmlformats.org/drawingml/2006/main">
               <a:ext uri="{FF2B5EF4-FFF2-40B4-BE49-F238E27FC236}">
-                <a16:creationId xmlns:a16="http://schemas.microsoft.com/office/drawing/2014/main" id="{117D281B-769C-4B40-9E0E-7ADAB76DFEF0}"/>
+                <a16:creationId xmlns:a16="http://schemas.microsoft.com/office/drawing/2014/main" id="{06CE1CCD-824D-4F3F-8F0D-8512D3991EE8}"/>
               </a:ext>
             </a:extLst>
           </p:cNvPr>
@@ -12264,7 +12264,7 @@
           <p:cNvPr id="8" name="Rounded Rectangle 7">
             <a:extLst xmlns:a="http://schemas.openxmlformats.org/drawingml/2006/main">
               <a:ext uri="{FF2B5EF4-FFF2-40B4-BE49-F238E27FC236}">
-                <a16:creationId xmlns:a16="http://schemas.microsoft.com/office/drawing/2014/main" id="{AD8C3C66-D82C-4A2D-A406-3CDB90BA53B0}"/>
+                <a16:creationId xmlns:a16="http://schemas.microsoft.com/office/drawing/2014/main" id="{02415EC1-84CC-4D01-9E2C-3F5F6DAC4289}"/>
               </a:ext>
             </a:extLst>
           </p:cNvPr>
@@ -12319,7 +12319,7 @@
           <p:cNvPr id="9" name="TextBox 8">
             <a:extLst xmlns:a="http://schemas.openxmlformats.org/drawingml/2006/main">
               <a:ext uri="{FF2B5EF4-FFF2-40B4-BE49-F238E27FC236}">
-                <a16:creationId xmlns:a16="http://schemas.microsoft.com/office/drawing/2014/main" id="{B5266489-C9B8-46CC-8143-993526F6790E}"/>
+                <a16:creationId xmlns:a16="http://schemas.microsoft.com/office/drawing/2014/main" id="{349115A2-991B-4EB0-8A1C-4DBDDA8890D7}"/>
               </a:ext>
             </a:extLst>
           </p:cNvPr>
@@ -12442,7 +12442,7 @@
           <p:cNvPr id="10" name="Rounded Rectangle 9">
             <a:extLst xmlns:a="http://schemas.openxmlformats.org/drawingml/2006/main">
               <a:ext uri="{FF2B5EF4-FFF2-40B4-BE49-F238E27FC236}">
-                <a16:creationId xmlns:a16="http://schemas.microsoft.com/office/drawing/2014/main" id="{5728ADA4-C967-467E-AC84-A56B9398D81E}"/>
+                <a16:creationId xmlns:a16="http://schemas.microsoft.com/office/drawing/2014/main" id="{2C9FB04E-1655-43C9-8970-A1E0A9E36CDD}"/>
               </a:ext>
             </a:extLst>
           </p:cNvPr>
@@ -12497,7 +12497,7 @@
           <p:cNvPr id="11" name="TextBox 10">
             <a:extLst xmlns:a="http://schemas.openxmlformats.org/drawingml/2006/main">
               <a:ext uri="{FF2B5EF4-FFF2-40B4-BE49-F238E27FC236}">
-                <a16:creationId xmlns:a16="http://schemas.microsoft.com/office/drawing/2014/main" id="{BEB37232-BC02-4E02-B428-B5DC86A7F808}"/>
+                <a16:creationId xmlns:a16="http://schemas.microsoft.com/office/drawing/2014/main" id="{1AC050B2-7F2E-4301-A3A2-29641A38CA9E}"/>
               </a:ext>
             </a:extLst>
           </p:cNvPr>
@@ -12847,7 +12847,7 @@
     </p:spTree>
     <p:extLst>
       <p:ext uri="{BB962C8B-B14F-4D97-AF65-F5344CB8AC3E}">
-        <p14:creationId xmlns:p14="http://schemas.microsoft.com/office/powerpoint/2010/main" val="154989256"/>
+        <p14:creationId xmlns:p14="http://schemas.microsoft.com/office/powerpoint/2010/main" val="2130239381"/>
       </p:ext>
     </p:extLst>
   </p:cSld>
@@ -12871,7 +12871,7 @@
           <p:cNvPr id="2" name="Rectangle 1">
             <a:extLst xmlns:a="http://schemas.openxmlformats.org/drawingml/2006/main">
               <a:ext uri="{FF2B5EF4-FFF2-40B4-BE49-F238E27FC236}">
-                <a16:creationId xmlns:a16="http://schemas.microsoft.com/office/drawing/2014/main" id="{8D28292C-D21B-4B40-854D-EEA25083F92F}"/>
+                <a16:creationId xmlns:a16="http://schemas.microsoft.com/office/drawing/2014/main" id="{A72AD196-45A2-4454-960B-5466D33267D6}"/>
               </a:ext>
             </a:extLst>
           </p:cNvPr>
@@ -12924,7 +12924,7 @@
           <p:cNvPr id="3" name="Rectangle 2">
             <a:extLst xmlns:a="http://schemas.openxmlformats.org/drawingml/2006/main">
               <a:ext uri="{FF2B5EF4-FFF2-40B4-BE49-F238E27FC236}">
-                <a16:creationId xmlns:a16="http://schemas.microsoft.com/office/drawing/2014/main" id="{5F58E0FD-EFE6-400F-80FE-1747392F6CDC}"/>
+                <a16:creationId xmlns:a16="http://schemas.microsoft.com/office/drawing/2014/main" id="{4E0D622C-80B6-4AC9-A859-DDA40A8BF15A}"/>
               </a:ext>
             </a:extLst>
           </p:cNvPr>
@@ -12977,7 +12977,7 @@
           <p:cNvPr id="4" name="Rectangle 3">
             <a:extLst xmlns:a="http://schemas.openxmlformats.org/drawingml/2006/main">
               <a:ext uri="{FF2B5EF4-FFF2-40B4-BE49-F238E27FC236}">
-                <a16:creationId xmlns:a16="http://schemas.microsoft.com/office/drawing/2014/main" id="{6BFEF9BB-1D00-4C27-9BDB-D1169294BD63}"/>
+                <a16:creationId xmlns:a16="http://schemas.microsoft.com/office/drawing/2014/main" id="{5F3F4070-EEBF-4CCE-8621-B67EAB3225CB}"/>
               </a:ext>
             </a:extLst>
           </p:cNvPr>
@@ -13030,7 +13030,7 @@
           <p:cNvPr id="5" name="TextBox 4">
             <a:extLst xmlns:a="http://schemas.openxmlformats.org/drawingml/2006/main">
               <a:ext uri="{FF2B5EF4-FFF2-40B4-BE49-F238E27FC236}">
-                <a16:creationId xmlns:a16="http://schemas.microsoft.com/office/drawing/2014/main" id="{15CB8889-BD42-4A57-8759-B3955D40DD19}"/>
+                <a16:creationId xmlns:a16="http://schemas.microsoft.com/office/drawing/2014/main" id="{28B98CD6-F55C-4C4D-88A1-9CF12F70E71B}"/>
               </a:ext>
             </a:extLst>
           </p:cNvPr>
@@ -13093,7 +13093,7 @@
           <p:cNvPr id="6" name="Rounded Rectangle 5">
             <a:extLst xmlns:a="http://schemas.openxmlformats.org/drawingml/2006/main">
               <a:ext uri="{FF2B5EF4-FFF2-40B4-BE49-F238E27FC236}">
-                <a16:creationId xmlns:a16="http://schemas.microsoft.com/office/drawing/2014/main" id="{34975B01-D92D-45C2-BE88-487F21B95A54}"/>
+                <a16:creationId xmlns:a16="http://schemas.microsoft.com/office/drawing/2014/main" id="{99F3482E-63EF-4DB0-B895-5DA01A9A53FB}"/>
               </a:ext>
             </a:extLst>
           </p:cNvPr>
@@ -13148,7 +13148,7 @@
           <p:cNvPr id="7" name="TextBox 6">
             <a:extLst xmlns:a="http://schemas.openxmlformats.org/drawingml/2006/main">
               <a:ext uri="{FF2B5EF4-FFF2-40B4-BE49-F238E27FC236}">
-                <a16:creationId xmlns:a16="http://schemas.microsoft.com/office/drawing/2014/main" id="{4893621C-C620-4095-B126-79EDCD09B4CD}"/>
+                <a16:creationId xmlns:a16="http://schemas.microsoft.com/office/drawing/2014/main" id="{095118F2-5B36-45AB-84CF-41692014427A}"/>
               </a:ext>
             </a:extLst>
           </p:cNvPr>
@@ -13612,7 +13612,7 @@
           <p:nvPr/>
         </p:nvPicPr>
         <p:blipFill>
-          <a:blip xmlns:r="http://schemas.openxmlformats.org/officeDocument/2006/relationships" xmlns:a="http://schemas.openxmlformats.org/drawingml/2006/main" r:embed="R58da3dcd2ff14277"/>
+          <a:blip xmlns:r="http://schemas.openxmlformats.org/officeDocument/2006/relationships" xmlns:a="http://schemas.openxmlformats.org/drawingml/2006/main" r:embed="R538ba8edd3b54af9"/>
           <a:stretch xmlns:a="http://schemas.openxmlformats.org/drawingml/2006/main">
             <a:fillRect l="0" t="0" r="0" b="0"/>
           </a:stretch>
@@ -13632,7 +13632,7 @@
           <p:cNvPr id="9" name="Rounded Rectangle 8">
             <a:extLst xmlns:a="http://schemas.openxmlformats.org/drawingml/2006/main">
               <a:ext uri="{FF2B5EF4-FFF2-40B4-BE49-F238E27FC236}">
-                <a16:creationId xmlns:a16="http://schemas.microsoft.com/office/drawing/2014/main" id="{386CC619-F029-481F-BF92-EC25D11F687A}"/>
+                <a16:creationId xmlns:a16="http://schemas.microsoft.com/office/drawing/2014/main" id="{71B48DA7-709C-44ED-AD42-93564DBA5A8E}"/>
               </a:ext>
             </a:extLst>
           </p:cNvPr>
@@ -13687,7 +13687,7 @@
           <p:cNvPr id="10" name="TextBox 9">
             <a:extLst xmlns:a="http://schemas.openxmlformats.org/drawingml/2006/main">
               <a:ext uri="{FF2B5EF4-FFF2-40B4-BE49-F238E27FC236}">
-                <a16:creationId xmlns:a16="http://schemas.microsoft.com/office/drawing/2014/main" id="{ECBFEA72-0D73-4D75-BEF1-391478E99CA4}"/>
+                <a16:creationId xmlns:a16="http://schemas.microsoft.com/office/drawing/2014/main" id="{676C7DEA-AC78-4A90-9290-0ADD7D15C00F}"/>
               </a:ext>
             </a:extLst>
           </p:cNvPr>
@@ -13770,7 +13770,7 @@
     </p:spTree>
     <p:extLst>
       <p:ext uri="{BB962C8B-B14F-4D97-AF65-F5344CB8AC3E}">
-        <p14:creationId xmlns:p14="http://schemas.microsoft.com/office/powerpoint/2010/main" val="1182244350"/>
+        <p14:creationId xmlns:p14="http://schemas.microsoft.com/office/powerpoint/2010/main" val="1328505445"/>
       </p:ext>
     </p:extLst>
   </p:cSld>

</xml_diff>